<commit_message>
Pulido final de entrega TFG
</commit_message>
<xml_diff>
--- a/docs/presentacion-defensa-final.pptx
+++ b/docs/presentacion-defensa-final.pptx
@@ -145,7 +145,7 @@
           <p:cNvPr id="2" name="Título 1">
             <a:extLst>
               <a:ext uri="{FF2B5EF4-FFF2-40B4-BE49-F238E27FC236}">
-                <a16:creationId xmlns:a16="http://schemas.microsoft.com/office/drawing/2014/main" id="{8A5EB480-DEC5-C3C4-FC91-56B94A297B09}"/>
+                <a16:creationId xmlns:a16="http://schemas.microsoft.com/office/drawing/2014/main" id="{14520BF6-50DF-2297-F823-27E9AF3C658B}"/>
               </a:ext>
             </a:extLst>
           </p:cNvPr>
@@ -182,7 +182,7 @@
           <p:cNvPr id="3" name="Subtítulo 2">
             <a:extLst>
               <a:ext uri="{FF2B5EF4-FFF2-40B4-BE49-F238E27FC236}">
-                <a16:creationId xmlns:a16="http://schemas.microsoft.com/office/drawing/2014/main" id="{55BB0717-386E-2BAE-689E-01483B08D561}"/>
+                <a16:creationId xmlns:a16="http://schemas.microsoft.com/office/drawing/2014/main" id="{98F46696-B39F-384D-0391-86DA3DD9D885}"/>
               </a:ext>
             </a:extLst>
           </p:cNvPr>
@@ -252,7 +252,7 @@
           <p:cNvPr id="4" name="Marcador de fecha 3">
             <a:extLst>
               <a:ext uri="{FF2B5EF4-FFF2-40B4-BE49-F238E27FC236}">
-                <a16:creationId xmlns:a16="http://schemas.microsoft.com/office/drawing/2014/main" id="{E66B6547-D969-3C7D-7C70-D8187A053A6E}"/>
+                <a16:creationId xmlns:a16="http://schemas.microsoft.com/office/drawing/2014/main" id="{F521A54D-03E2-E814-B8E3-052113C1EB98}"/>
               </a:ext>
             </a:extLst>
           </p:cNvPr>
@@ -268,9 +268,9 @@
           <a:bodyPr/>
           <a:lstStyle/>
           <a:p>
-            <a:fld id="{E9A21FD9-3D2E-4368-8C20-26695743AB37}" type="datetimeFigureOut">
+            <a:fld id="{4C2FCEDC-9044-4CE9-9B98-47C3FC2B7CBE}" type="datetimeFigureOut">
               <a:rPr lang="es-ES" smtClean="0"/>
-              <a:t>26/04/2026</a:t>
+              <a:t>03/05/2026</a:t>
             </a:fld>
             <a:endParaRPr lang="es-ES"/>
           </a:p>
@@ -281,7 +281,7 @@
           <p:cNvPr id="5" name="Marcador de pie de página 4">
             <a:extLst>
               <a:ext uri="{FF2B5EF4-FFF2-40B4-BE49-F238E27FC236}">
-                <a16:creationId xmlns:a16="http://schemas.microsoft.com/office/drawing/2014/main" id="{0AF08FB6-42D1-99BC-250A-5EF422A65A85}"/>
+                <a16:creationId xmlns:a16="http://schemas.microsoft.com/office/drawing/2014/main" id="{0E3FBE31-D78F-CF12-E520-A27FF1218135}"/>
               </a:ext>
             </a:extLst>
           </p:cNvPr>
@@ -306,7 +306,7 @@
           <p:cNvPr id="6" name="Marcador de número de diapositiva 5">
             <a:extLst>
               <a:ext uri="{FF2B5EF4-FFF2-40B4-BE49-F238E27FC236}">
-                <a16:creationId xmlns:a16="http://schemas.microsoft.com/office/drawing/2014/main" id="{BC1BAEDC-6C91-AC94-93DF-F9E045FF5A64}"/>
+                <a16:creationId xmlns:a16="http://schemas.microsoft.com/office/drawing/2014/main" id="{A3E30B18-D605-436F-D91E-DFDED3CBD08E}"/>
               </a:ext>
             </a:extLst>
           </p:cNvPr>
@@ -322,7 +322,7 @@
           <a:bodyPr/>
           <a:lstStyle/>
           <a:p>
-            <a:fld id="{8C9473E1-ACD5-4C35-8A08-9B6197486DC4}" type="slidenum">
+            <a:fld id="{FA455040-64EB-4938-BD0A-2F141374B058}" type="slidenum">
               <a:rPr lang="es-ES" smtClean="0"/>
               <a:t>‹Nº›</a:t>
             </a:fld>
@@ -333,7 +333,7 @@
     </p:spTree>
     <p:extLst>
       <p:ext uri="{BB962C8B-B14F-4D97-AF65-F5344CB8AC3E}">
-        <p14:creationId xmlns:p14="http://schemas.microsoft.com/office/powerpoint/2010/main" val="1571128345"/>
+        <p14:creationId xmlns:p14="http://schemas.microsoft.com/office/powerpoint/2010/main" val="67602867"/>
       </p:ext>
     </p:extLst>
   </p:cSld>
@@ -365,7 +365,7 @@
           <p:cNvPr id="2" name="Título 1">
             <a:extLst>
               <a:ext uri="{FF2B5EF4-FFF2-40B4-BE49-F238E27FC236}">
-                <a16:creationId xmlns:a16="http://schemas.microsoft.com/office/drawing/2014/main" id="{182ED962-0D8C-4A08-AAD8-558308B505CA}"/>
+                <a16:creationId xmlns:a16="http://schemas.microsoft.com/office/drawing/2014/main" id="{3AD5E6A8-1750-5EC9-A393-57EA8E7BBFDF}"/>
               </a:ext>
             </a:extLst>
           </p:cNvPr>
@@ -393,7 +393,7 @@
           <p:cNvPr id="3" name="Marcador de texto vertical 2">
             <a:extLst>
               <a:ext uri="{FF2B5EF4-FFF2-40B4-BE49-F238E27FC236}">
-                <a16:creationId xmlns:a16="http://schemas.microsoft.com/office/drawing/2014/main" id="{4EED9AED-962D-1346-2492-015940118D76}"/>
+                <a16:creationId xmlns:a16="http://schemas.microsoft.com/office/drawing/2014/main" id="{B921C21D-7B88-C5A2-240C-799ECF1059C5}"/>
               </a:ext>
             </a:extLst>
           </p:cNvPr>
@@ -450,7 +450,7 @@
           <p:cNvPr id="4" name="Marcador de fecha 3">
             <a:extLst>
               <a:ext uri="{FF2B5EF4-FFF2-40B4-BE49-F238E27FC236}">
-                <a16:creationId xmlns:a16="http://schemas.microsoft.com/office/drawing/2014/main" id="{4ADD12A7-907D-630B-72BC-375AFA392D10}"/>
+                <a16:creationId xmlns:a16="http://schemas.microsoft.com/office/drawing/2014/main" id="{D2CD7A92-37B5-140F-D025-ECA6E7B455AF}"/>
               </a:ext>
             </a:extLst>
           </p:cNvPr>
@@ -466,9 +466,9 @@
           <a:bodyPr/>
           <a:lstStyle/>
           <a:p>
-            <a:fld id="{E9A21FD9-3D2E-4368-8C20-26695743AB37}" type="datetimeFigureOut">
+            <a:fld id="{4C2FCEDC-9044-4CE9-9B98-47C3FC2B7CBE}" type="datetimeFigureOut">
               <a:rPr lang="es-ES" smtClean="0"/>
-              <a:t>26/04/2026</a:t>
+              <a:t>03/05/2026</a:t>
             </a:fld>
             <a:endParaRPr lang="es-ES"/>
           </a:p>
@@ -479,7 +479,7 @@
           <p:cNvPr id="5" name="Marcador de pie de página 4">
             <a:extLst>
               <a:ext uri="{FF2B5EF4-FFF2-40B4-BE49-F238E27FC236}">
-                <a16:creationId xmlns:a16="http://schemas.microsoft.com/office/drawing/2014/main" id="{99B2E9CE-0D6D-7EAE-C31C-20512F914E48}"/>
+                <a16:creationId xmlns:a16="http://schemas.microsoft.com/office/drawing/2014/main" id="{95A190D1-42A8-A1D8-D443-540E1F49DCF6}"/>
               </a:ext>
             </a:extLst>
           </p:cNvPr>
@@ -504,7 +504,7 @@
           <p:cNvPr id="6" name="Marcador de número de diapositiva 5">
             <a:extLst>
               <a:ext uri="{FF2B5EF4-FFF2-40B4-BE49-F238E27FC236}">
-                <a16:creationId xmlns:a16="http://schemas.microsoft.com/office/drawing/2014/main" id="{5EAF2095-AB5B-669E-9614-2B980E8D0849}"/>
+                <a16:creationId xmlns:a16="http://schemas.microsoft.com/office/drawing/2014/main" id="{A8B18A69-E5F2-DCFE-8ADB-41F850148898}"/>
               </a:ext>
             </a:extLst>
           </p:cNvPr>
@@ -520,7 +520,7 @@
           <a:bodyPr/>
           <a:lstStyle/>
           <a:p>
-            <a:fld id="{8C9473E1-ACD5-4C35-8A08-9B6197486DC4}" type="slidenum">
+            <a:fld id="{FA455040-64EB-4938-BD0A-2F141374B058}" type="slidenum">
               <a:rPr lang="es-ES" smtClean="0"/>
               <a:t>‹Nº›</a:t>
             </a:fld>
@@ -531,7 +531,7 @@
     </p:spTree>
     <p:extLst>
       <p:ext uri="{BB962C8B-B14F-4D97-AF65-F5344CB8AC3E}">
-        <p14:creationId xmlns:p14="http://schemas.microsoft.com/office/powerpoint/2010/main" val="3461546694"/>
+        <p14:creationId xmlns:p14="http://schemas.microsoft.com/office/powerpoint/2010/main" val="1609294027"/>
       </p:ext>
     </p:extLst>
   </p:cSld>
@@ -563,7 +563,7 @@
           <p:cNvPr id="2" name="Título vertical 1">
             <a:extLst>
               <a:ext uri="{FF2B5EF4-FFF2-40B4-BE49-F238E27FC236}">
-                <a16:creationId xmlns:a16="http://schemas.microsoft.com/office/drawing/2014/main" id="{17CD9183-9B69-979E-9BEA-391C0B5930BA}"/>
+                <a16:creationId xmlns:a16="http://schemas.microsoft.com/office/drawing/2014/main" id="{75840964-855F-D0FD-896B-8144F70EA365}"/>
               </a:ext>
             </a:extLst>
           </p:cNvPr>
@@ -596,7 +596,7 @@
           <p:cNvPr id="3" name="Marcador de texto vertical 2">
             <a:extLst>
               <a:ext uri="{FF2B5EF4-FFF2-40B4-BE49-F238E27FC236}">
-                <a16:creationId xmlns:a16="http://schemas.microsoft.com/office/drawing/2014/main" id="{5C82B82F-BD36-B175-8087-F741BF369F1A}"/>
+                <a16:creationId xmlns:a16="http://schemas.microsoft.com/office/drawing/2014/main" id="{A3AE056C-439C-855B-AF51-5A9F29CE6B93}"/>
               </a:ext>
             </a:extLst>
           </p:cNvPr>
@@ -658,7 +658,7 @@
           <p:cNvPr id="4" name="Marcador de fecha 3">
             <a:extLst>
               <a:ext uri="{FF2B5EF4-FFF2-40B4-BE49-F238E27FC236}">
-                <a16:creationId xmlns:a16="http://schemas.microsoft.com/office/drawing/2014/main" id="{0F245ACE-E50D-958D-D7A7-18430EC83477}"/>
+                <a16:creationId xmlns:a16="http://schemas.microsoft.com/office/drawing/2014/main" id="{36BF8A3D-7A2D-6648-D62C-25F6B46289A8}"/>
               </a:ext>
             </a:extLst>
           </p:cNvPr>
@@ -674,9 +674,9 @@
           <a:bodyPr/>
           <a:lstStyle/>
           <a:p>
-            <a:fld id="{E9A21FD9-3D2E-4368-8C20-26695743AB37}" type="datetimeFigureOut">
+            <a:fld id="{4C2FCEDC-9044-4CE9-9B98-47C3FC2B7CBE}" type="datetimeFigureOut">
               <a:rPr lang="es-ES" smtClean="0"/>
-              <a:t>26/04/2026</a:t>
+              <a:t>03/05/2026</a:t>
             </a:fld>
             <a:endParaRPr lang="es-ES"/>
           </a:p>
@@ -687,7 +687,7 @@
           <p:cNvPr id="5" name="Marcador de pie de página 4">
             <a:extLst>
               <a:ext uri="{FF2B5EF4-FFF2-40B4-BE49-F238E27FC236}">
-                <a16:creationId xmlns:a16="http://schemas.microsoft.com/office/drawing/2014/main" id="{9ADF135B-BA58-FB6A-B85D-A48D720D5E5C}"/>
+                <a16:creationId xmlns:a16="http://schemas.microsoft.com/office/drawing/2014/main" id="{DC70276C-43FB-88E4-2086-97342C35C152}"/>
               </a:ext>
             </a:extLst>
           </p:cNvPr>
@@ -712,7 +712,7 @@
           <p:cNvPr id="6" name="Marcador de número de diapositiva 5">
             <a:extLst>
               <a:ext uri="{FF2B5EF4-FFF2-40B4-BE49-F238E27FC236}">
-                <a16:creationId xmlns:a16="http://schemas.microsoft.com/office/drawing/2014/main" id="{5CA8D54A-43FF-EBF0-8AEF-DA38C61E591A}"/>
+                <a16:creationId xmlns:a16="http://schemas.microsoft.com/office/drawing/2014/main" id="{CA31B267-6F1B-18E6-467A-1A3941FF0653}"/>
               </a:ext>
             </a:extLst>
           </p:cNvPr>
@@ -728,7 +728,7 @@
           <a:bodyPr/>
           <a:lstStyle/>
           <a:p>
-            <a:fld id="{8C9473E1-ACD5-4C35-8A08-9B6197486DC4}" type="slidenum">
+            <a:fld id="{FA455040-64EB-4938-BD0A-2F141374B058}" type="slidenum">
               <a:rPr lang="es-ES" smtClean="0"/>
               <a:t>‹Nº›</a:t>
             </a:fld>
@@ -739,7 +739,7 @@
     </p:spTree>
     <p:extLst>
       <p:ext uri="{BB962C8B-B14F-4D97-AF65-F5344CB8AC3E}">
-        <p14:creationId xmlns:p14="http://schemas.microsoft.com/office/powerpoint/2010/main" val="3483083709"/>
+        <p14:creationId xmlns:p14="http://schemas.microsoft.com/office/powerpoint/2010/main" val="2247917887"/>
       </p:ext>
     </p:extLst>
   </p:cSld>
@@ -771,7 +771,7 @@
           <p:cNvPr id="2" name="Título 1">
             <a:extLst>
               <a:ext uri="{FF2B5EF4-FFF2-40B4-BE49-F238E27FC236}">
-                <a16:creationId xmlns:a16="http://schemas.microsoft.com/office/drawing/2014/main" id="{04FFDA04-2776-B5CC-85E3-80C7DD8714BD}"/>
+                <a16:creationId xmlns:a16="http://schemas.microsoft.com/office/drawing/2014/main" id="{CC7F7FB4-1229-D34A-77AF-BF3813789FD9}"/>
               </a:ext>
             </a:extLst>
           </p:cNvPr>
@@ -799,7 +799,7 @@
           <p:cNvPr id="3" name="Marcador de contenido 2">
             <a:extLst>
               <a:ext uri="{FF2B5EF4-FFF2-40B4-BE49-F238E27FC236}">
-                <a16:creationId xmlns:a16="http://schemas.microsoft.com/office/drawing/2014/main" id="{C26C8F6E-756C-AC40-2FC0-8D14D67968DC}"/>
+                <a16:creationId xmlns:a16="http://schemas.microsoft.com/office/drawing/2014/main" id="{863BA5A2-7A07-1376-15A5-6F42E11F6E53}"/>
               </a:ext>
             </a:extLst>
           </p:cNvPr>
@@ -856,7 +856,7 @@
           <p:cNvPr id="4" name="Marcador de fecha 3">
             <a:extLst>
               <a:ext uri="{FF2B5EF4-FFF2-40B4-BE49-F238E27FC236}">
-                <a16:creationId xmlns:a16="http://schemas.microsoft.com/office/drawing/2014/main" id="{3736CB90-7A87-B34E-96E0-ECDFAF56CC7A}"/>
+                <a16:creationId xmlns:a16="http://schemas.microsoft.com/office/drawing/2014/main" id="{C25829E9-04FF-9CE2-3482-CC194A8B1CDE}"/>
               </a:ext>
             </a:extLst>
           </p:cNvPr>
@@ -872,9 +872,9 @@
           <a:bodyPr/>
           <a:lstStyle/>
           <a:p>
-            <a:fld id="{E9A21FD9-3D2E-4368-8C20-26695743AB37}" type="datetimeFigureOut">
+            <a:fld id="{4C2FCEDC-9044-4CE9-9B98-47C3FC2B7CBE}" type="datetimeFigureOut">
               <a:rPr lang="es-ES" smtClean="0"/>
-              <a:t>26/04/2026</a:t>
+              <a:t>03/05/2026</a:t>
             </a:fld>
             <a:endParaRPr lang="es-ES"/>
           </a:p>
@@ -885,7 +885,7 @@
           <p:cNvPr id="5" name="Marcador de pie de página 4">
             <a:extLst>
               <a:ext uri="{FF2B5EF4-FFF2-40B4-BE49-F238E27FC236}">
-                <a16:creationId xmlns:a16="http://schemas.microsoft.com/office/drawing/2014/main" id="{808AD3EC-5443-A82A-0065-F7B72D0BBC26}"/>
+                <a16:creationId xmlns:a16="http://schemas.microsoft.com/office/drawing/2014/main" id="{159C5EA7-77E5-90A3-24E3-5C5FD17FE594}"/>
               </a:ext>
             </a:extLst>
           </p:cNvPr>
@@ -910,7 +910,7 @@
           <p:cNvPr id="6" name="Marcador de número de diapositiva 5">
             <a:extLst>
               <a:ext uri="{FF2B5EF4-FFF2-40B4-BE49-F238E27FC236}">
-                <a16:creationId xmlns:a16="http://schemas.microsoft.com/office/drawing/2014/main" id="{423D0EE1-C49F-F382-541A-12E879E483DC}"/>
+                <a16:creationId xmlns:a16="http://schemas.microsoft.com/office/drawing/2014/main" id="{7FDFEBC3-F147-ADAF-67F6-781A244D8083}"/>
               </a:ext>
             </a:extLst>
           </p:cNvPr>
@@ -926,7 +926,7 @@
           <a:bodyPr/>
           <a:lstStyle/>
           <a:p>
-            <a:fld id="{8C9473E1-ACD5-4C35-8A08-9B6197486DC4}" type="slidenum">
+            <a:fld id="{FA455040-64EB-4938-BD0A-2F141374B058}" type="slidenum">
               <a:rPr lang="es-ES" smtClean="0"/>
               <a:t>‹Nº›</a:t>
             </a:fld>
@@ -937,7 +937,7 @@
     </p:spTree>
     <p:extLst>
       <p:ext uri="{BB962C8B-B14F-4D97-AF65-F5344CB8AC3E}">
-        <p14:creationId xmlns:p14="http://schemas.microsoft.com/office/powerpoint/2010/main" val="1844142941"/>
+        <p14:creationId xmlns:p14="http://schemas.microsoft.com/office/powerpoint/2010/main" val="1386335863"/>
       </p:ext>
     </p:extLst>
   </p:cSld>
@@ -969,7 +969,7 @@
           <p:cNvPr id="2" name="Título 1">
             <a:extLst>
               <a:ext uri="{FF2B5EF4-FFF2-40B4-BE49-F238E27FC236}">
-                <a16:creationId xmlns:a16="http://schemas.microsoft.com/office/drawing/2014/main" id="{0997D86D-619D-25E3-B00A-DE41A85CF299}"/>
+                <a16:creationId xmlns:a16="http://schemas.microsoft.com/office/drawing/2014/main" id="{DE5414F1-2CF3-271D-507D-0CD25B56D05A}"/>
               </a:ext>
             </a:extLst>
           </p:cNvPr>
@@ -1006,7 +1006,7 @@
           <p:cNvPr id="3" name="Marcador de texto 2">
             <a:extLst>
               <a:ext uri="{FF2B5EF4-FFF2-40B4-BE49-F238E27FC236}">
-                <a16:creationId xmlns:a16="http://schemas.microsoft.com/office/drawing/2014/main" id="{C34E0891-BE16-CEB3-4DC2-B35A29BB3B86}"/>
+                <a16:creationId xmlns:a16="http://schemas.microsoft.com/office/drawing/2014/main" id="{46A8B74D-C2AD-1A1D-E067-0CEAE4B24D78}"/>
               </a:ext>
             </a:extLst>
           </p:cNvPr>
@@ -1131,7 +1131,7 @@
           <p:cNvPr id="4" name="Marcador de fecha 3">
             <a:extLst>
               <a:ext uri="{FF2B5EF4-FFF2-40B4-BE49-F238E27FC236}">
-                <a16:creationId xmlns:a16="http://schemas.microsoft.com/office/drawing/2014/main" id="{2F6EC919-9F49-1EEA-5867-7CE18DAB7834}"/>
+                <a16:creationId xmlns:a16="http://schemas.microsoft.com/office/drawing/2014/main" id="{4504D0B2-F503-CE55-82B7-4C0965C717D2}"/>
               </a:ext>
             </a:extLst>
           </p:cNvPr>
@@ -1147,9 +1147,9 @@
           <a:bodyPr/>
           <a:lstStyle/>
           <a:p>
-            <a:fld id="{E9A21FD9-3D2E-4368-8C20-26695743AB37}" type="datetimeFigureOut">
+            <a:fld id="{4C2FCEDC-9044-4CE9-9B98-47C3FC2B7CBE}" type="datetimeFigureOut">
               <a:rPr lang="es-ES" smtClean="0"/>
-              <a:t>26/04/2026</a:t>
+              <a:t>03/05/2026</a:t>
             </a:fld>
             <a:endParaRPr lang="es-ES"/>
           </a:p>
@@ -1160,7 +1160,7 @@
           <p:cNvPr id="5" name="Marcador de pie de página 4">
             <a:extLst>
               <a:ext uri="{FF2B5EF4-FFF2-40B4-BE49-F238E27FC236}">
-                <a16:creationId xmlns:a16="http://schemas.microsoft.com/office/drawing/2014/main" id="{0ED8D286-60E6-5B2C-130B-29EE9910C5D7}"/>
+                <a16:creationId xmlns:a16="http://schemas.microsoft.com/office/drawing/2014/main" id="{E53D71DB-C58C-48D1-0AB9-6B08DDB678BA}"/>
               </a:ext>
             </a:extLst>
           </p:cNvPr>
@@ -1185,7 +1185,7 @@
           <p:cNvPr id="6" name="Marcador de número de diapositiva 5">
             <a:extLst>
               <a:ext uri="{FF2B5EF4-FFF2-40B4-BE49-F238E27FC236}">
-                <a16:creationId xmlns:a16="http://schemas.microsoft.com/office/drawing/2014/main" id="{6FF1E479-BCB7-0C9F-66F5-EA0A16EA8C19}"/>
+                <a16:creationId xmlns:a16="http://schemas.microsoft.com/office/drawing/2014/main" id="{564B6DB3-904F-D11F-1501-C456D1A764BF}"/>
               </a:ext>
             </a:extLst>
           </p:cNvPr>
@@ -1201,7 +1201,7 @@
           <a:bodyPr/>
           <a:lstStyle/>
           <a:p>
-            <a:fld id="{8C9473E1-ACD5-4C35-8A08-9B6197486DC4}" type="slidenum">
+            <a:fld id="{FA455040-64EB-4938-BD0A-2F141374B058}" type="slidenum">
               <a:rPr lang="es-ES" smtClean="0"/>
               <a:t>‹Nº›</a:t>
             </a:fld>
@@ -1212,7 +1212,7 @@
     </p:spTree>
     <p:extLst>
       <p:ext uri="{BB962C8B-B14F-4D97-AF65-F5344CB8AC3E}">
-        <p14:creationId xmlns:p14="http://schemas.microsoft.com/office/powerpoint/2010/main" val="2329922855"/>
+        <p14:creationId xmlns:p14="http://schemas.microsoft.com/office/powerpoint/2010/main" val="1690316791"/>
       </p:ext>
     </p:extLst>
   </p:cSld>
@@ -1244,7 +1244,7 @@
           <p:cNvPr id="2" name="Título 1">
             <a:extLst>
               <a:ext uri="{FF2B5EF4-FFF2-40B4-BE49-F238E27FC236}">
-                <a16:creationId xmlns:a16="http://schemas.microsoft.com/office/drawing/2014/main" id="{AB997114-6B15-1EBB-E423-63656AC95A65}"/>
+                <a16:creationId xmlns:a16="http://schemas.microsoft.com/office/drawing/2014/main" id="{DBE663BC-5B9E-9C07-627C-337DADEF8BEB}"/>
               </a:ext>
             </a:extLst>
           </p:cNvPr>
@@ -1272,7 +1272,7 @@
           <p:cNvPr id="3" name="Marcador de contenido 2">
             <a:extLst>
               <a:ext uri="{FF2B5EF4-FFF2-40B4-BE49-F238E27FC236}">
-                <a16:creationId xmlns:a16="http://schemas.microsoft.com/office/drawing/2014/main" id="{05D041A0-997C-8C58-5C1B-FA2A62237AA1}"/>
+                <a16:creationId xmlns:a16="http://schemas.microsoft.com/office/drawing/2014/main" id="{D705ED80-D4D4-9750-E78C-80BFC9A5E5B6}"/>
               </a:ext>
             </a:extLst>
           </p:cNvPr>
@@ -1334,7 +1334,7 @@
           <p:cNvPr id="4" name="Marcador de contenido 3">
             <a:extLst>
               <a:ext uri="{FF2B5EF4-FFF2-40B4-BE49-F238E27FC236}">
-                <a16:creationId xmlns:a16="http://schemas.microsoft.com/office/drawing/2014/main" id="{63506DD0-4742-7C02-6C84-F9E6859FD616}"/>
+                <a16:creationId xmlns:a16="http://schemas.microsoft.com/office/drawing/2014/main" id="{8904686E-C7BC-9060-88D3-0CC035F727F2}"/>
               </a:ext>
             </a:extLst>
           </p:cNvPr>
@@ -1396,7 +1396,7 @@
           <p:cNvPr id="5" name="Marcador de fecha 4">
             <a:extLst>
               <a:ext uri="{FF2B5EF4-FFF2-40B4-BE49-F238E27FC236}">
-                <a16:creationId xmlns:a16="http://schemas.microsoft.com/office/drawing/2014/main" id="{012A0A34-3C7C-C6CC-6476-B47EE61E4AA7}"/>
+                <a16:creationId xmlns:a16="http://schemas.microsoft.com/office/drawing/2014/main" id="{BFC2EDC6-CF57-00CB-A202-1114FDC2D5AF}"/>
               </a:ext>
             </a:extLst>
           </p:cNvPr>
@@ -1412,9 +1412,9 @@
           <a:bodyPr/>
           <a:lstStyle/>
           <a:p>
-            <a:fld id="{E9A21FD9-3D2E-4368-8C20-26695743AB37}" type="datetimeFigureOut">
+            <a:fld id="{4C2FCEDC-9044-4CE9-9B98-47C3FC2B7CBE}" type="datetimeFigureOut">
               <a:rPr lang="es-ES" smtClean="0"/>
-              <a:t>26/04/2026</a:t>
+              <a:t>03/05/2026</a:t>
             </a:fld>
             <a:endParaRPr lang="es-ES"/>
           </a:p>
@@ -1425,7 +1425,7 @@
           <p:cNvPr id="6" name="Marcador de pie de página 5">
             <a:extLst>
               <a:ext uri="{FF2B5EF4-FFF2-40B4-BE49-F238E27FC236}">
-                <a16:creationId xmlns:a16="http://schemas.microsoft.com/office/drawing/2014/main" id="{8BCBE9DF-C08D-B4BE-C2BB-93842A22A14F}"/>
+                <a16:creationId xmlns:a16="http://schemas.microsoft.com/office/drawing/2014/main" id="{83CB32A1-EF88-7138-A04F-D0878B260890}"/>
               </a:ext>
             </a:extLst>
           </p:cNvPr>
@@ -1450,7 +1450,7 @@
           <p:cNvPr id="7" name="Marcador de número de diapositiva 6">
             <a:extLst>
               <a:ext uri="{FF2B5EF4-FFF2-40B4-BE49-F238E27FC236}">
-                <a16:creationId xmlns:a16="http://schemas.microsoft.com/office/drawing/2014/main" id="{5447A1D6-CD66-A9C6-77FF-D6083E1A3974}"/>
+                <a16:creationId xmlns:a16="http://schemas.microsoft.com/office/drawing/2014/main" id="{2999C9EC-4AA9-B1CB-EF06-AB35323EB721}"/>
               </a:ext>
             </a:extLst>
           </p:cNvPr>
@@ -1466,7 +1466,7 @@
           <a:bodyPr/>
           <a:lstStyle/>
           <a:p>
-            <a:fld id="{8C9473E1-ACD5-4C35-8A08-9B6197486DC4}" type="slidenum">
+            <a:fld id="{FA455040-64EB-4938-BD0A-2F141374B058}" type="slidenum">
               <a:rPr lang="es-ES" smtClean="0"/>
               <a:t>‹Nº›</a:t>
             </a:fld>
@@ -1477,7 +1477,7 @@
     </p:spTree>
     <p:extLst>
       <p:ext uri="{BB962C8B-B14F-4D97-AF65-F5344CB8AC3E}">
-        <p14:creationId xmlns:p14="http://schemas.microsoft.com/office/powerpoint/2010/main" val="817680457"/>
+        <p14:creationId xmlns:p14="http://schemas.microsoft.com/office/powerpoint/2010/main" val="3570076365"/>
       </p:ext>
     </p:extLst>
   </p:cSld>
@@ -1509,7 +1509,7 @@
           <p:cNvPr id="2" name="Título 1">
             <a:extLst>
               <a:ext uri="{FF2B5EF4-FFF2-40B4-BE49-F238E27FC236}">
-                <a16:creationId xmlns:a16="http://schemas.microsoft.com/office/drawing/2014/main" id="{F3B3FA77-43CC-FB96-9C32-E8B9552BA627}"/>
+                <a16:creationId xmlns:a16="http://schemas.microsoft.com/office/drawing/2014/main" id="{E03CC908-E5C1-CEF5-A879-93634D35393C}"/>
               </a:ext>
             </a:extLst>
           </p:cNvPr>
@@ -1542,7 +1542,7 @@
           <p:cNvPr id="3" name="Marcador de texto 2">
             <a:extLst>
               <a:ext uri="{FF2B5EF4-FFF2-40B4-BE49-F238E27FC236}">
-                <a16:creationId xmlns:a16="http://schemas.microsoft.com/office/drawing/2014/main" id="{EE73F12C-0345-A12A-4CBD-538D4340B533}"/>
+                <a16:creationId xmlns:a16="http://schemas.microsoft.com/office/drawing/2014/main" id="{B826B4F6-DB26-7919-9F13-3746D56F8077}"/>
               </a:ext>
             </a:extLst>
           </p:cNvPr>
@@ -1613,7 +1613,7 @@
           <p:cNvPr id="4" name="Marcador de contenido 3">
             <a:extLst>
               <a:ext uri="{FF2B5EF4-FFF2-40B4-BE49-F238E27FC236}">
-                <a16:creationId xmlns:a16="http://schemas.microsoft.com/office/drawing/2014/main" id="{29888DB4-B17B-DC89-4260-9C935D3EE52D}"/>
+                <a16:creationId xmlns:a16="http://schemas.microsoft.com/office/drawing/2014/main" id="{90B83327-6C33-B4F1-B3B2-6DC44117ECC3}"/>
               </a:ext>
             </a:extLst>
           </p:cNvPr>
@@ -1675,7 +1675,7 @@
           <p:cNvPr id="5" name="Marcador de texto 4">
             <a:extLst>
               <a:ext uri="{FF2B5EF4-FFF2-40B4-BE49-F238E27FC236}">
-                <a16:creationId xmlns:a16="http://schemas.microsoft.com/office/drawing/2014/main" id="{1F36DB20-2213-20BD-8D2B-0CFB60B03B0F}"/>
+                <a16:creationId xmlns:a16="http://schemas.microsoft.com/office/drawing/2014/main" id="{8AC3ADDE-805C-EE97-782B-07FB53D319D7}"/>
               </a:ext>
             </a:extLst>
           </p:cNvPr>
@@ -1746,7 +1746,7 @@
           <p:cNvPr id="6" name="Marcador de contenido 5">
             <a:extLst>
               <a:ext uri="{FF2B5EF4-FFF2-40B4-BE49-F238E27FC236}">
-                <a16:creationId xmlns:a16="http://schemas.microsoft.com/office/drawing/2014/main" id="{2BB80C80-5A3D-4BCC-3DC7-97E7F554F35E}"/>
+                <a16:creationId xmlns:a16="http://schemas.microsoft.com/office/drawing/2014/main" id="{CEB31B4A-A0A3-C5FB-7C4B-EEE5C4FEAD85}"/>
               </a:ext>
             </a:extLst>
           </p:cNvPr>
@@ -1808,7 +1808,7 @@
           <p:cNvPr id="7" name="Marcador de fecha 6">
             <a:extLst>
               <a:ext uri="{FF2B5EF4-FFF2-40B4-BE49-F238E27FC236}">
-                <a16:creationId xmlns:a16="http://schemas.microsoft.com/office/drawing/2014/main" id="{353EC15E-6989-29F4-C877-9963A86439F8}"/>
+                <a16:creationId xmlns:a16="http://schemas.microsoft.com/office/drawing/2014/main" id="{4408E452-08C9-4EE7-B468-49F265E99194}"/>
               </a:ext>
             </a:extLst>
           </p:cNvPr>
@@ -1824,9 +1824,9 @@
           <a:bodyPr/>
           <a:lstStyle/>
           <a:p>
-            <a:fld id="{E9A21FD9-3D2E-4368-8C20-26695743AB37}" type="datetimeFigureOut">
+            <a:fld id="{4C2FCEDC-9044-4CE9-9B98-47C3FC2B7CBE}" type="datetimeFigureOut">
               <a:rPr lang="es-ES" smtClean="0"/>
-              <a:t>26/04/2026</a:t>
+              <a:t>03/05/2026</a:t>
             </a:fld>
             <a:endParaRPr lang="es-ES"/>
           </a:p>
@@ -1837,7 +1837,7 @@
           <p:cNvPr id="8" name="Marcador de pie de página 7">
             <a:extLst>
               <a:ext uri="{FF2B5EF4-FFF2-40B4-BE49-F238E27FC236}">
-                <a16:creationId xmlns:a16="http://schemas.microsoft.com/office/drawing/2014/main" id="{68BCE858-5138-0BF9-2737-32BEC6554D6B}"/>
+                <a16:creationId xmlns:a16="http://schemas.microsoft.com/office/drawing/2014/main" id="{47A68166-41F9-CB59-BD97-57372E5CFBDB}"/>
               </a:ext>
             </a:extLst>
           </p:cNvPr>
@@ -1862,7 +1862,7 @@
           <p:cNvPr id="9" name="Marcador de número de diapositiva 8">
             <a:extLst>
               <a:ext uri="{FF2B5EF4-FFF2-40B4-BE49-F238E27FC236}">
-                <a16:creationId xmlns:a16="http://schemas.microsoft.com/office/drawing/2014/main" id="{152A129B-1B94-183F-5467-AA28581CB304}"/>
+                <a16:creationId xmlns:a16="http://schemas.microsoft.com/office/drawing/2014/main" id="{34D1EC27-8CDD-BA3D-A6AE-BE6AFD289E63}"/>
               </a:ext>
             </a:extLst>
           </p:cNvPr>
@@ -1878,7 +1878,7 @@
           <a:bodyPr/>
           <a:lstStyle/>
           <a:p>
-            <a:fld id="{8C9473E1-ACD5-4C35-8A08-9B6197486DC4}" type="slidenum">
+            <a:fld id="{FA455040-64EB-4938-BD0A-2F141374B058}" type="slidenum">
               <a:rPr lang="es-ES" smtClean="0"/>
               <a:t>‹Nº›</a:t>
             </a:fld>
@@ -1889,7 +1889,7 @@
     </p:spTree>
     <p:extLst>
       <p:ext uri="{BB962C8B-B14F-4D97-AF65-F5344CB8AC3E}">
-        <p14:creationId xmlns:p14="http://schemas.microsoft.com/office/powerpoint/2010/main" val="4279236031"/>
+        <p14:creationId xmlns:p14="http://schemas.microsoft.com/office/powerpoint/2010/main" val="350675883"/>
       </p:ext>
     </p:extLst>
   </p:cSld>
@@ -1921,7 +1921,7 @@
           <p:cNvPr id="2" name="Título 1">
             <a:extLst>
               <a:ext uri="{FF2B5EF4-FFF2-40B4-BE49-F238E27FC236}">
-                <a16:creationId xmlns:a16="http://schemas.microsoft.com/office/drawing/2014/main" id="{B2670B23-6655-4BDB-082D-AADE1FC6A924}"/>
+                <a16:creationId xmlns:a16="http://schemas.microsoft.com/office/drawing/2014/main" id="{C9E85820-A6F7-7243-B57B-7332B33C90CA}"/>
               </a:ext>
             </a:extLst>
           </p:cNvPr>
@@ -1949,7 +1949,7 @@
           <p:cNvPr id="3" name="Marcador de fecha 2">
             <a:extLst>
               <a:ext uri="{FF2B5EF4-FFF2-40B4-BE49-F238E27FC236}">
-                <a16:creationId xmlns:a16="http://schemas.microsoft.com/office/drawing/2014/main" id="{261962D4-D76F-9075-6177-ED404CA37F9C}"/>
+                <a16:creationId xmlns:a16="http://schemas.microsoft.com/office/drawing/2014/main" id="{7E0154A4-5BC7-6EB6-D6B1-527BD0398C34}"/>
               </a:ext>
             </a:extLst>
           </p:cNvPr>
@@ -1965,9 +1965,9 @@
           <a:bodyPr/>
           <a:lstStyle/>
           <a:p>
-            <a:fld id="{E9A21FD9-3D2E-4368-8C20-26695743AB37}" type="datetimeFigureOut">
+            <a:fld id="{4C2FCEDC-9044-4CE9-9B98-47C3FC2B7CBE}" type="datetimeFigureOut">
               <a:rPr lang="es-ES" smtClean="0"/>
-              <a:t>26/04/2026</a:t>
+              <a:t>03/05/2026</a:t>
             </a:fld>
             <a:endParaRPr lang="es-ES"/>
           </a:p>
@@ -1978,7 +1978,7 @@
           <p:cNvPr id="4" name="Marcador de pie de página 3">
             <a:extLst>
               <a:ext uri="{FF2B5EF4-FFF2-40B4-BE49-F238E27FC236}">
-                <a16:creationId xmlns:a16="http://schemas.microsoft.com/office/drawing/2014/main" id="{D429EF47-7C74-6D1C-FD59-AAB40BF146B7}"/>
+                <a16:creationId xmlns:a16="http://schemas.microsoft.com/office/drawing/2014/main" id="{7CB8E482-2611-E330-DE3B-302B164EAD00}"/>
               </a:ext>
             </a:extLst>
           </p:cNvPr>
@@ -2003,7 +2003,7 @@
           <p:cNvPr id="5" name="Marcador de número de diapositiva 4">
             <a:extLst>
               <a:ext uri="{FF2B5EF4-FFF2-40B4-BE49-F238E27FC236}">
-                <a16:creationId xmlns:a16="http://schemas.microsoft.com/office/drawing/2014/main" id="{236A5273-ADB8-8A1D-B65C-2C400A2098C2}"/>
+                <a16:creationId xmlns:a16="http://schemas.microsoft.com/office/drawing/2014/main" id="{15010C12-ABDF-64F8-9A2F-DB978E624999}"/>
               </a:ext>
             </a:extLst>
           </p:cNvPr>
@@ -2019,7 +2019,7 @@
           <a:bodyPr/>
           <a:lstStyle/>
           <a:p>
-            <a:fld id="{8C9473E1-ACD5-4C35-8A08-9B6197486DC4}" type="slidenum">
+            <a:fld id="{FA455040-64EB-4938-BD0A-2F141374B058}" type="slidenum">
               <a:rPr lang="es-ES" smtClean="0"/>
               <a:t>‹Nº›</a:t>
             </a:fld>
@@ -2030,7 +2030,7 @@
     </p:spTree>
     <p:extLst>
       <p:ext uri="{BB962C8B-B14F-4D97-AF65-F5344CB8AC3E}">
-        <p14:creationId xmlns:p14="http://schemas.microsoft.com/office/powerpoint/2010/main" val="2070411445"/>
+        <p14:creationId xmlns:p14="http://schemas.microsoft.com/office/powerpoint/2010/main" val="1224215804"/>
       </p:ext>
     </p:extLst>
   </p:cSld>
@@ -2062,7 +2062,7 @@
           <p:cNvPr id="2" name="Marcador de fecha 1">
             <a:extLst>
               <a:ext uri="{FF2B5EF4-FFF2-40B4-BE49-F238E27FC236}">
-                <a16:creationId xmlns:a16="http://schemas.microsoft.com/office/drawing/2014/main" id="{E3047F5C-54F4-A516-2859-8BC1A96613EB}"/>
+                <a16:creationId xmlns:a16="http://schemas.microsoft.com/office/drawing/2014/main" id="{3EACCB39-82B8-8C9F-06E2-22D517129A11}"/>
               </a:ext>
             </a:extLst>
           </p:cNvPr>
@@ -2078,9 +2078,9 @@
           <a:bodyPr/>
           <a:lstStyle/>
           <a:p>
-            <a:fld id="{E9A21FD9-3D2E-4368-8C20-26695743AB37}" type="datetimeFigureOut">
+            <a:fld id="{4C2FCEDC-9044-4CE9-9B98-47C3FC2B7CBE}" type="datetimeFigureOut">
               <a:rPr lang="es-ES" smtClean="0"/>
-              <a:t>26/04/2026</a:t>
+              <a:t>03/05/2026</a:t>
             </a:fld>
             <a:endParaRPr lang="es-ES"/>
           </a:p>
@@ -2091,7 +2091,7 @@
           <p:cNvPr id="3" name="Marcador de pie de página 2">
             <a:extLst>
               <a:ext uri="{FF2B5EF4-FFF2-40B4-BE49-F238E27FC236}">
-                <a16:creationId xmlns:a16="http://schemas.microsoft.com/office/drawing/2014/main" id="{668089C3-1A26-6AB3-A988-939B09B615C9}"/>
+                <a16:creationId xmlns:a16="http://schemas.microsoft.com/office/drawing/2014/main" id="{0D9201FD-ED74-2DBA-1AA8-C4A007550BCC}"/>
               </a:ext>
             </a:extLst>
           </p:cNvPr>
@@ -2116,7 +2116,7 @@
           <p:cNvPr id="4" name="Marcador de número de diapositiva 3">
             <a:extLst>
               <a:ext uri="{FF2B5EF4-FFF2-40B4-BE49-F238E27FC236}">
-                <a16:creationId xmlns:a16="http://schemas.microsoft.com/office/drawing/2014/main" id="{A8CDF64B-0F25-8B14-746B-15B4D1AD7C61}"/>
+                <a16:creationId xmlns:a16="http://schemas.microsoft.com/office/drawing/2014/main" id="{24D3BAC7-93A7-5672-D1C5-E3E71F032DCB}"/>
               </a:ext>
             </a:extLst>
           </p:cNvPr>
@@ -2132,7 +2132,7 @@
           <a:bodyPr/>
           <a:lstStyle/>
           <a:p>
-            <a:fld id="{8C9473E1-ACD5-4C35-8A08-9B6197486DC4}" type="slidenum">
+            <a:fld id="{FA455040-64EB-4938-BD0A-2F141374B058}" type="slidenum">
               <a:rPr lang="es-ES" smtClean="0"/>
               <a:t>‹Nº›</a:t>
             </a:fld>
@@ -2143,7 +2143,7 @@
     </p:spTree>
     <p:extLst>
       <p:ext uri="{BB962C8B-B14F-4D97-AF65-F5344CB8AC3E}">
-        <p14:creationId xmlns:p14="http://schemas.microsoft.com/office/powerpoint/2010/main" val="594007607"/>
+        <p14:creationId xmlns:p14="http://schemas.microsoft.com/office/powerpoint/2010/main" val="4054716001"/>
       </p:ext>
     </p:extLst>
   </p:cSld>
@@ -2175,7 +2175,7 @@
           <p:cNvPr id="2" name="Título 1">
             <a:extLst>
               <a:ext uri="{FF2B5EF4-FFF2-40B4-BE49-F238E27FC236}">
-                <a16:creationId xmlns:a16="http://schemas.microsoft.com/office/drawing/2014/main" id="{2067B5C6-2F3F-4B8F-1318-00895920FFD2}"/>
+                <a16:creationId xmlns:a16="http://schemas.microsoft.com/office/drawing/2014/main" id="{C0EDB4C5-3ECF-6920-7B36-DF068E9BD24F}"/>
               </a:ext>
             </a:extLst>
           </p:cNvPr>
@@ -2212,7 +2212,7 @@
           <p:cNvPr id="3" name="Marcador de contenido 2">
             <a:extLst>
               <a:ext uri="{FF2B5EF4-FFF2-40B4-BE49-F238E27FC236}">
-                <a16:creationId xmlns:a16="http://schemas.microsoft.com/office/drawing/2014/main" id="{DEFA258A-8838-D586-ECAB-040892484C84}"/>
+                <a16:creationId xmlns:a16="http://schemas.microsoft.com/office/drawing/2014/main" id="{572392A1-B3B9-720F-3DB6-14F60160E8EB}"/>
               </a:ext>
             </a:extLst>
           </p:cNvPr>
@@ -2302,7 +2302,7 @@
           <p:cNvPr id="4" name="Marcador de texto 3">
             <a:extLst>
               <a:ext uri="{FF2B5EF4-FFF2-40B4-BE49-F238E27FC236}">
-                <a16:creationId xmlns:a16="http://schemas.microsoft.com/office/drawing/2014/main" id="{ABC00231-3927-2760-A0E0-A17E70E3B15D}"/>
+                <a16:creationId xmlns:a16="http://schemas.microsoft.com/office/drawing/2014/main" id="{7734D3AD-E46F-6EC2-F46C-2FF7B30C6994}"/>
               </a:ext>
             </a:extLst>
           </p:cNvPr>
@@ -2373,7 +2373,7 @@
           <p:cNvPr id="5" name="Marcador de fecha 4">
             <a:extLst>
               <a:ext uri="{FF2B5EF4-FFF2-40B4-BE49-F238E27FC236}">
-                <a16:creationId xmlns:a16="http://schemas.microsoft.com/office/drawing/2014/main" id="{2860C513-F127-20CC-D608-D88B6EC53A35}"/>
+                <a16:creationId xmlns:a16="http://schemas.microsoft.com/office/drawing/2014/main" id="{FB14517E-B3BD-0D3C-6A94-3B90219143DF}"/>
               </a:ext>
             </a:extLst>
           </p:cNvPr>
@@ -2389,9 +2389,9 @@
           <a:bodyPr/>
           <a:lstStyle/>
           <a:p>
-            <a:fld id="{E9A21FD9-3D2E-4368-8C20-26695743AB37}" type="datetimeFigureOut">
+            <a:fld id="{4C2FCEDC-9044-4CE9-9B98-47C3FC2B7CBE}" type="datetimeFigureOut">
               <a:rPr lang="es-ES" smtClean="0"/>
-              <a:t>26/04/2026</a:t>
+              <a:t>03/05/2026</a:t>
             </a:fld>
             <a:endParaRPr lang="es-ES"/>
           </a:p>
@@ -2402,7 +2402,7 @@
           <p:cNvPr id="6" name="Marcador de pie de página 5">
             <a:extLst>
               <a:ext uri="{FF2B5EF4-FFF2-40B4-BE49-F238E27FC236}">
-                <a16:creationId xmlns:a16="http://schemas.microsoft.com/office/drawing/2014/main" id="{93CD3B2C-CEC7-0C65-AA1B-8E576AFB538C}"/>
+                <a16:creationId xmlns:a16="http://schemas.microsoft.com/office/drawing/2014/main" id="{DCEF152B-2711-C76A-7FF2-44C9674FE403}"/>
               </a:ext>
             </a:extLst>
           </p:cNvPr>
@@ -2427,7 +2427,7 @@
           <p:cNvPr id="7" name="Marcador de número de diapositiva 6">
             <a:extLst>
               <a:ext uri="{FF2B5EF4-FFF2-40B4-BE49-F238E27FC236}">
-                <a16:creationId xmlns:a16="http://schemas.microsoft.com/office/drawing/2014/main" id="{01165E22-7BD0-7019-3050-390FB9A4C195}"/>
+                <a16:creationId xmlns:a16="http://schemas.microsoft.com/office/drawing/2014/main" id="{D4FFDE10-204E-F3EF-2071-1B56E88BDE2A}"/>
               </a:ext>
             </a:extLst>
           </p:cNvPr>
@@ -2443,7 +2443,7 @@
           <a:bodyPr/>
           <a:lstStyle/>
           <a:p>
-            <a:fld id="{8C9473E1-ACD5-4C35-8A08-9B6197486DC4}" type="slidenum">
+            <a:fld id="{FA455040-64EB-4938-BD0A-2F141374B058}" type="slidenum">
               <a:rPr lang="es-ES" smtClean="0"/>
               <a:t>‹Nº›</a:t>
             </a:fld>
@@ -2454,7 +2454,7 @@
     </p:spTree>
     <p:extLst>
       <p:ext uri="{BB962C8B-B14F-4D97-AF65-F5344CB8AC3E}">
-        <p14:creationId xmlns:p14="http://schemas.microsoft.com/office/powerpoint/2010/main" val="1732418181"/>
+        <p14:creationId xmlns:p14="http://schemas.microsoft.com/office/powerpoint/2010/main" val="3998045903"/>
       </p:ext>
     </p:extLst>
   </p:cSld>
@@ -2486,7 +2486,7 @@
           <p:cNvPr id="2" name="Título 1">
             <a:extLst>
               <a:ext uri="{FF2B5EF4-FFF2-40B4-BE49-F238E27FC236}">
-                <a16:creationId xmlns:a16="http://schemas.microsoft.com/office/drawing/2014/main" id="{8E3F31E4-C35B-4424-11B1-ABB821BD60C3}"/>
+                <a16:creationId xmlns:a16="http://schemas.microsoft.com/office/drawing/2014/main" id="{3AA8CF42-36BB-9334-F14E-4D949FBAD8BC}"/>
               </a:ext>
             </a:extLst>
           </p:cNvPr>
@@ -2523,7 +2523,7 @@
           <p:cNvPr id="3" name="Marcador de posición de imagen 2">
             <a:extLst>
               <a:ext uri="{FF2B5EF4-FFF2-40B4-BE49-F238E27FC236}">
-                <a16:creationId xmlns:a16="http://schemas.microsoft.com/office/drawing/2014/main" id="{69F6A52B-66A3-3130-24E3-8762E98BE185}"/>
+                <a16:creationId xmlns:a16="http://schemas.microsoft.com/office/drawing/2014/main" id="{26BE6D79-08C1-93E5-B9DB-F06661E980F1}"/>
               </a:ext>
             </a:extLst>
           </p:cNvPr>
@@ -2590,7 +2590,7 @@
           <p:cNvPr id="4" name="Marcador de texto 3">
             <a:extLst>
               <a:ext uri="{FF2B5EF4-FFF2-40B4-BE49-F238E27FC236}">
-                <a16:creationId xmlns:a16="http://schemas.microsoft.com/office/drawing/2014/main" id="{0495D7D6-65C1-B59E-8BA3-F4170CAA0970}"/>
+                <a16:creationId xmlns:a16="http://schemas.microsoft.com/office/drawing/2014/main" id="{DF8E9D0B-0273-71E5-0CF8-EA4D093947AE}"/>
               </a:ext>
             </a:extLst>
           </p:cNvPr>
@@ -2661,7 +2661,7 @@
           <p:cNvPr id="5" name="Marcador de fecha 4">
             <a:extLst>
               <a:ext uri="{FF2B5EF4-FFF2-40B4-BE49-F238E27FC236}">
-                <a16:creationId xmlns:a16="http://schemas.microsoft.com/office/drawing/2014/main" id="{B19DB33F-B765-D7A9-3A73-45B3DBECAE14}"/>
+                <a16:creationId xmlns:a16="http://schemas.microsoft.com/office/drawing/2014/main" id="{4A3FEBCA-709F-400A-4481-04364F16A33F}"/>
               </a:ext>
             </a:extLst>
           </p:cNvPr>
@@ -2677,9 +2677,9 @@
           <a:bodyPr/>
           <a:lstStyle/>
           <a:p>
-            <a:fld id="{E9A21FD9-3D2E-4368-8C20-26695743AB37}" type="datetimeFigureOut">
+            <a:fld id="{4C2FCEDC-9044-4CE9-9B98-47C3FC2B7CBE}" type="datetimeFigureOut">
               <a:rPr lang="es-ES" smtClean="0"/>
-              <a:t>26/04/2026</a:t>
+              <a:t>03/05/2026</a:t>
             </a:fld>
             <a:endParaRPr lang="es-ES"/>
           </a:p>
@@ -2690,7 +2690,7 @@
           <p:cNvPr id="6" name="Marcador de pie de página 5">
             <a:extLst>
               <a:ext uri="{FF2B5EF4-FFF2-40B4-BE49-F238E27FC236}">
-                <a16:creationId xmlns:a16="http://schemas.microsoft.com/office/drawing/2014/main" id="{F40A8D8A-4006-3DB3-2762-C13B510FD02E}"/>
+                <a16:creationId xmlns:a16="http://schemas.microsoft.com/office/drawing/2014/main" id="{E5A5451B-237C-7B8C-5431-994A0E6E0587}"/>
               </a:ext>
             </a:extLst>
           </p:cNvPr>
@@ -2715,7 +2715,7 @@
           <p:cNvPr id="7" name="Marcador de número de diapositiva 6">
             <a:extLst>
               <a:ext uri="{FF2B5EF4-FFF2-40B4-BE49-F238E27FC236}">
-                <a16:creationId xmlns:a16="http://schemas.microsoft.com/office/drawing/2014/main" id="{63C68661-42AC-8B5A-B1C0-A1E855DEE207}"/>
+                <a16:creationId xmlns:a16="http://schemas.microsoft.com/office/drawing/2014/main" id="{D0919129-C80C-8DE9-692F-08D344413FF2}"/>
               </a:ext>
             </a:extLst>
           </p:cNvPr>
@@ -2731,7 +2731,7 @@
           <a:bodyPr/>
           <a:lstStyle/>
           <a:p>
-            <a:fld id="{8C9473E1-ACD5-4C35-8A08-9B6197486DC4}" type="slidenum">
+            <a:fld id="{FA455040-64EB-4938-BD0A-2F141374B058}" type="slidenum">
               <a:rPr lang="es-ES" smtClean="0"/>
               <a:t>‹Nº›</a:t>
             </a:fld>
@@ -2742,7 +2742,7 @@
     </p:spTree>
     <p:extLst>
       <p:ext uri="{BB962C8B-B14F-4D97-AF65-F5344CB8AC3E}">
-        <p14:creationId xmlns:p14="http://schemas.microsoft.com/office/powerpoint/2010/main" val="1342182854"/>
+        <p14:creationId xmlns:p14="http://schemas.microsoft.com/office/powerpoint/2010/main" val="1456792909"/>
       </p:ext>
     </p:extLst>
   </p:cSld>
@@ -2779,7 +2779,7 @@
           <p:cNvPr id="2" name="Marcador de título 1">
             <a:extLst>
               <a:ext uri="{FF2B5EF4-FFF2-40B4-BE49-F238E27FC236}">
-                <a16:creationId xmlns:a16="http://schemas.microsoft.com/office/drawing/2014/main" id="{CED63532-6A17-45F5-F584-67C03E1814F7}"/>
+                <a16:creationId xmlns:a16="http://schemas.microsoft.com/office/drawing/2014/main" id="{72BDA274-ABD2-45F1-8B59-5CBF2D7BC3DB}"/>
               </a:ext>
             </a:extLst>
           </p:cNvPr>
@@ -2817,7 +2817,7 @@
           <p:cNvPr id="3" name="Marcador de texto 2">
             <a:extLst>
               <a:ext uri="{FF2B5EF4-FFF2-40B4-BE49-F238E27FC236}">
-                <a16:creationId xmlns:a16="http://schemas.microsoft.com/office/drawing/2014/main" id="{ED8D958A-06FE-0E98-1692-31A0F14B1418}"/>
+                <a16:creationId xmlns:a16="http://schemas.microsoft.com/office/drawing/2014/main" id="{2CCDAE57-13BC-3791-6B16-B5FB925694F1}"/>
               </a:ext>
             </a:extLst>
           </p:cNvPr>
@@ -2884,7 +2884,7 @@
           <p:cNvPr id="4" name="Marcador de fecha 3">
             <a:extLst>
               <a:ext uri="{FF2B5EF4-FFF2-40B4-BE49-F238E27FC236}">
-                <a16:creationId xmlns:a16="http://schemas.microsoft.com/office/drawing/2014/main" id="{A41FD606-3ED4-26A3-C14D-B6CD736C95A6}"/>
+                <a16:creationId xmlns:a16="http://schemas.microsoft.com/office/drawing/2014/main" id="{2DB65BDD-59E9-3DFA-98D7-FB785E6E1A5C}"/>
               </a:ext>
             </a:extLst>
           </p:cNvPr>
@@ -2918,9 +2918,9 @@
             </a:lvl1pPr>
           </a:lstStyle>
           <a:p>
-            <a:fld id="{E9A21FD9-3D2E-4368-8C20-26695743AB37}" type="datetimeFigureOut">
+            <a:fld id="{4C2FCEDC-9044-4CE9-9B98-47C3FC2B7CBE}" type="datetimeFigureOut">
               <a:rPr lang="es-ES" smtClean="0"/>
-              <a:t>26/04/2026</a:t>
+              <a:t>03/05/2026</a:t>
             </a:fld>
             <a:endParaRPr lang="es-ES"/>
           </a:p>
@@ -2931,7 +2931,7 @@
           <p:cNvPr id="5" name="Marcador de pie de página 4">
             <a:extLst>
               <a:ext uri="{FF2B5EF4-FFF2-40B4-BE49-F238E27FC236}">
-                <a16:creationId xmlns:a16="http://schemas.microsoft.com/office/drawing/2014/main" id="{9D113F70-2101-941F-88A6-1970A8260413}"/>
+                <a16:creationId xmlns:a16="http://schemas.microsoft.com/office/drawing/2014/main" id="{48D1ECEF-F739-A79C-F532-FA358AEE6AB1}"/>
               </a:ext>
             </a:extLst>
           </p:cNvPr>
@@ -2974,7 +2974,7 @@
           <p:cNvPr id="6" name="Marcador de número de diapositiva 5">
             <a:extLst>
               <a:ext uri="{FF2B5EF4-FFF2-40B4-BE49-F238E27FC236}">
-                <a16:creationId xmlns:a16="http://schemas.microsoft.com/office/drawing/2014/main" id="{443CADB4-6D70-2096-09CC-61EEE22C3F4B}"/>
+                <a16:creationId xmlns:a16="http://schemas.microsoft.com/office/drawing/2014/main" id="{F426DB04-DF97-8610-4C8F-B8F9C581DA88}"/>
               </a:ext>
             </a:extLst>
           </p:cNvPr>
@@ -3008,7 +3008,7 @@
             </a:lvl1pPr>
           </a:lstStyle>
           <a:p>
-            <a:fld id="{8C9473E1-ACD5-4C35-8A08-9B6197486DC4}" type="slidenum">
+            <a:fld id="{FA455040-64EB-4938-BD0A-2F141374B058}" type="slidenum">
               <a:rPr lang="es-ES" smtClean="0"/>
               <a:t>‹Nº›</a:t>
             </a:fld>
@@ -3019,7 +3019,7 @@
     </p:spTree>
     <p:extLst>
       <p:ext uri="{BB962C8B-B14F-4D97-AF65-F5344CB8AC3E}">
-        <p14:creationId xmlns:p14="http://schemas.microsoft.com/office/powerpoint/2010/main" val="2370292710"/>
+        <p14:creationId xmlns:p14="http://schemas.microsoft.com/office/powerpoint/2010/main" val="1833905126"/>
       </p:ext>
     </p:extLst>
   </p:cSld>
@@ -3350,7 +3350,7 @@
           <p:cNvPr id="2" name="Rectángulo: esquinas redondeadas 1">
             <a:extLst>
               <a:ext uri="{FF2B5EF4-FFF2-40B4-BE49-F238E27FC236}">
-                <a16:creationId xmlns:a16="http://schemas.microsoft.com/office/drawing/2014/main" id="{DED4EA02-6BEA-A264-1DF2-EB4D8187DD0A}"/>
+                <a16:creationId xmlns:a16="http://schemas.microsoft.com/office/drawing/2014/main" id="{3A87E732-A74F-B6EB-E66F-824695ECDAD7}"/>
               </a:ext>
             </a:extLst>
           </p:cNvPr>
@@ -3404,7 +3404,7 @@
           <p:cNvPr id="3" name="CuadroTexto 2">
             <a:extLst>
               <a:ext uri="{FF2B5EF4-FFF2-40B4-BE49-F238E27FC236}">
-                <a16:creationId xmlns:a16="http://schemas.microsoft.com/office/drawing/2014/main" id="{8CCF2BD0-144C-34ED-5757-D0CBCF714DC3}"/>
+                <a16:creationId xmlns:a16="http://schemas.microsoft.com/office/drawing/2014/main" id="{8177A55E-A698-F1FC-7F42-C096EB1B4D0A}"/>
               </a:ext>
             </a:extLst>
           </p:cNvPr>
@@ -3444,7 +3444,7 @@
           <p:cNvPr id="4" name="CuadroTexto 3">
             <a:extLst>
               <a:ext uri="{FF2B5EF4-FFF2-40B4-BE49-F238E27FC236}">
-                <a16:creationId xmlns:a16="http://schemas.microsoft.com/office/drawing/2014/main" id="{7A79E0CE-666A-117E-88AC-5C25D203306A}"/>
+                <a16:creationId xmlns:a16="http://schemas.microsoft.com/office/drawing/2014/main" id="{1B049C5D-2CED-583F-FF27-E567D7CE3AF2}"/>
               </a:ext>
             </a:extLst>
           </p:cNvPr>
@@ -3484,7 +3484,7 @@
           <p:cNvPr id="5" name="CuadroTexto 4">
             <a:extLst>
               <a:ext uri="{FF2B5EF4-FFF2-40B4-BE49-F238E27FC236}">
-                <a16:creationId xmlns:a16="http://schemas.microsoft.com/office/drawing/2014/main" id="{D641F6C4-C337-D327-E55D-E4BD22755774}"/>
+                <a16:creationId xmlns:a16="http://schemas.microsoft.com/office/drawing/2014/main" id="{88CEB650-E9C2-7DA1-8A94-AA40324B5435}"/>
               </a:ext>
             </a:extLst>
           </p:cNvPr>
@@ -3524,7 +3524,7 @@
           <p:cNvPr id="6" name="CuadroTexto 5">
             <a:extLst>
               <a:ext uri="{FF2B5EF4-FFF2-40B4-BE49-F238E27FC236}">
-                <a16:creationId xmlns:a16="http://schemas.microsoft.com/office/drawing/2014/main" id="{133F218C-EF17-EF6A-5F8E-47618B995C56}"/>
+                <a16:creationId xmlns:a16="http://schemas.microsoft.com/office/drawing/2014/main" id="{F3235407-906C-72DB-F6B2-20A5A967C08D}"/>
               </a:ext>
             </a:extLst>
           </p:cNvPr>
@@ -3575,7 +3575,7 @@
           <p:cNvPr id="8" name="Imagen 7">
             <a:extLst>
               <a:ext uri="{FF2B5EF4-FFF2-40B4-BE49-F238E27FC236}">
-                <a16:creationId xmlns:a16="http://schemas.microsoft.com/office/drawing/2014/main" id="{7094F3C0-6DE7-42AA-F395-8BD6F5F50E48}"/>
+                <a16:creationId xmlns:a16="http://schemas.microsoft.com/office/drawing/2014/main" id="{0083AF39-753F-82C3-BB50-8A1FB5E262D5}"/>
               </a:ext>
             </a:extLst>
           </p:cNvPr>
@@ -3614,7 +3614,7 @@
     </p:spTree>
     <p:extLst>
       <p:ext uri="{BB962C8B-B14F-4D97-AF65-F5344CB8AC3E}">
-        <p14:creationId xmlns:p14="http://schemas.microsoft.com/office/powerpoint/2010/main" val="4126762379"/>
+        <p14:creationId xmlns:p14="http://schemas.microsoft.com/office/powerpoint/2010/main" val="323598477"/>
       </p:ext>
     </p:extLst>
   </p:cSld>
@@ -3654,7 +3654,7 @@
           <p:cNvPr id="2" name="CuadroTexto 1">
             <a:extLst>
               <a:ext uri="{FF2B5EF4-FFF2-40B4-BE49-F238E27FC236}">
-                <a16:creationId xmlns:a16="http://schemas.microsoft.com/office/drawing/2014/main" id="{C6E923DE-D116-8E40-FE2B-544382AE0460}"/>
+                <a16:creationId xmlns:a16="http://schemas.microsoft.com/office/drawing/2014/main" id="{EFF17161-752D-DFC6-8F7A-78AA8340249B}"/>
               </a:ext>
             </a:extLst>
           </p:cNvPr>
@@ -3694,7 +3694,7 @@
           <p:cNvPr id="3" name="CuadroTexto 2">
             <a:extLst>
               <a:ext uri="{FF2B5EF4-FFF2-40B4-BE49-F238E27FC236}">
-                <a16:creationId xmlns:a16="http://schemas.microsoft.com/office/drawing/2014/main" id="{F76CEF37-5696-1531-6109-25F8B6FD1134}"/>
+                <a16:creationId xmlns:a16="http://schemas.microsoft.com/office/drawing/2014/main" id="{7771ACBD-5214-CB0D-5CB8-19C5FE1BAC36}"/>
               </a:ext>
             </a:extLst>
           </p:cNvPr>
@@ -3734,7 +3734,7 @@
           <p:cNvPr id="4" name="CuadroTexto 3">
             <a:extLst>
               <a:ext uri="{FF2B5EF4-FFF2-40B4-BE49-F238E27FC236}">
-                <a16:creationId xmlns:a16="http://schemas.microsoft.com/office/drawing/2014/main" id="{14FEA111-3DE2-F4CE-8461-2D88FB66CEB3}"/>
+                <a16:creationId xmlns:a16="http://schemas.microsoft.com/office/drawing/2014/main" id="{54035EEF-CEBE-FB37-73ED-64053A4A976C}"/>
               </a:ext>
             </a:extLst>
           </p:cNvPr>
@@ -3774,7 +3774,7 @@
           <p:cNvPr id="5" name="Rectángulo: esquinas redondeadas 4">
             <a:extLst>
               <a:ext uri="{FF2B5EF4-FFF2-40B4-BE49-F238E27FC236}">
-                <a16:creationId xmlns:a16="http://schemas.microsoft.com/office/drawing/2014/main" id="{04D97DEE-7D6C-6366-01CA-17C91C7E1F3E}"/>
+                <a16:creationId xmlns:a16="http://schemas.microsoft.com/office/drawing/2014/main" id="{BE2C502C-DA3E-2EEF-1B69-8A6E497945A5}"/>
               </a:ext>
             </a:extLst>
           </p:cNvPr>
@@ -3835,7 +3835,7 @@
           <p:cNvPr id="6" name="CuadroTexto 5">
             <a:extLst>
               <a:ext uri="{FF2B5EF4-FFF2-40B4-BE49-F238E27FC236}">
-                <a16:creationId xmlns:a16="http://schemas.microsoft.com/office/drawing/2014/main" id="{6955EE78-F254-0C3E-9E60-D65CD3BDE80C}"/>
+                <a16:creationId xmlns:a16="http://schemas.microsoft.com/office/drawing/2014/main" id="{4B0F2D69-8F12-4284-DC0E-494CC9D83910}"/>
               </a:ext>
             </a:extLst>
           </p:cNvPr>
@@ -3886,7 +3886,7 @@
           <p:cNvPr id="7" name="CuadroTexto 6">
             <a:extLst>
               <a:ext uri="{FF2B5EF4-FFF2-40B4-BE49-F238E27FC236}">
-                <a16:creationId xmlns:a16="http://schemas.microsoft.com/office/drawing/2014/main" id="{9CDE44C5-002D-48AA-456B-05F10EB92F7A}"/>
+                <a16:creationId xmlns:a16="http://schemas.microsoft.com/office/drawing/2014/main" id="{817D8DAF-DF0A-E03D-2632-C856659B5A34}"/>
               </a:ext>
             </a:extLst>
           </p:cNvPr>
@@ -3926,7 +3926,7 @@
           <p:cNvPr id="8" name="CuadroTexto 7">
             <a:extLst>
               <a:ext uri="{FF2B5EF4-FFF2-40B4-BE49-F238E27FC236}">
-                <a16:creationId xmlns:a16="http://schemas.microsoft.com/office/drawing/2014/main" id="{7D853C4D-A8C1-7502-6598-18E7E78D93F9}"/>
+                <a16:creationId xmlns:a16="http://schemas.microsoft.com/office/drawing/2014/main" id="{1C10F4D8-3E03-D17D-D6CC-527AA1D32B96}"/>
               </a:ext>
             </a:extLst>
           </p:cNvPr>
@@ -4025,7 +4025,7 @@
     </p:spTree>
     <p:extLst>
       <p:ext uri="{BB962C8B-B14F-4D97-AF65-F5344CB8AC3E}">
-        <p14:creationId xmlns:p14="http://schemas.microsoft.com/office/powerpoint/2010/main" val="558313188"/>
+        <p14:creationId xmlns:p14="http://schemas.microsoft.com/office/powerpoint/2010/main" val="1589886555"/>
       </p:ext>
     </p:extLst>
   </p:cSld>
@@ -4065,7 +4065,7 @@
           <p:cNvPr id="2" name="CuadroTexto 1">
             <a:extLst>
               <a:ext uri="{FF2B5EF4-FFF2-40B4-BE49-F238E27FC236}">
-                <a16:creationId xmlns:a16="http://schemas.microsoft.com/office/drawing/2014/main" id="{924C088C-05DE-32BC-8F3D-22AC13974013}"/>
+                <a16:creationId xmlns:a16="http://schemas.microsoft.com/office/drawing/2014/main" id="{4573553B-DABF-2373-C4B1-2F06D96A4314}"/>
               </a:ext>
             </a:extLst>
           </p:cNvPr>
@@ -4105,7 +4105,7 @@
           <p:cNvPr id="3" name="CuadroTexto 2">
             <a:extLst>
               <a:ext uri="{FF2B5EF4-FFF2-40B4-BE49-F238E27FC236}">
-                <a16:creationId xmlns:a16="http://schemas.microsoft.com/office/drawing/2014/main" id="{EB131004-05A6-4D1B-AA9D-04474D15AA87}"/>
+                <a16:creationId xmlns:a16="http://schemas.microsoft.com/office/drawing/2014/main" id="{9AF28A3B-E6EC-4494-0840-9464369FA657}"/>
               </a:ext>
             </a:extLst>
           </p:cNvPr>
@@ -4145,7 +4145,7 @@
           <p:cNvPr id="4" name="CuadroTexto 3">
             <a:extLst>
               <a:ext uri="{FF2B5EF4-FFF2-40B4-BE49-F238E27FC236}">
-                <a16:creationId xmlns:a16="http://schemas.microsoft.com/office/drawing/2014/main" id="{CD192C9E-EA2C-19A8-58B8-B895678AEEFF}"/>
+                <a16:creationId xmlns:a16="http://schemas.microsoft.com/office/drawing/2014/main" id="{9687D3D1-A0B0-5F38-7837-D1E7B62534F6}"/>
               </a:ext>
             </a:extLst>
           </p:cNvPr>
@@ -4185,7 +4185,7 @@
           <p:cNvPr id="5" name="Rectángulo: esquinas redondeadas 4">
             <a:extLst>
               <a:ext uri="{FF2B5EF4-FFF2-40B4-BE49-F238E27FC236}">
-                <a16:creationId xmlns:a16="http://schemas.microsoft.com/office/drawing/2014/main" id="{2A7C52F6-E23D-2618-E2C5-E29A3DBDA4F1}"/>
+                <a16:creationId xmlns:a16="http://schemas.microsoft.com/office/drawing/2014/main" id="{FFEA8B83-3615-8230-D7CE-2634922F651D}"/>
               </a:ext>
             </a:extLst>
           </p:cNvPr>
@@ -4246,7 +4246,7 @@
           <p:cNvPr id="6" name="CuadroTexto 5">
             <a:extLst>
               <a:ext uri="{FF2B5EF4-FFF2-40B4-BE49-F238E27FC236}">
-                <a16:creationId xmlns:a16="http://schemas.microsoft.com/office/drawing/2014/main" id="{936F0955-DDCF-BC78-8863-E1668C897FA6}"/>
+                <a16:creationId xmlns:a16="http://schemas.microsoft.com/office/drawing/2014/main" id="{9C00006F-6CCE-8D7E-5115-DE6842B3E2F4}"/>
               </a:ext>
             </a:extLst>
           </p:cNvPr>
@@ -4294,7 +4294,7 @@
           <p:cNvPr id="7" name="CuadroTexto 6">
             <a:extLst>
               <a:ext uri="{FF2B5EF4-FFF2-40B4-BE49-F238E27FC236}">
-                <a16:creationId xmlns:a16="http://schemas.microsoft.com/office/drawing/2014/main" id="{6BCD15C8-3877-49A9-EB29-10E1FB0306F9}"/>
+                <a16:creationId xmlns:a16="http://schemas.microsoft.com/office/drawing/2014/main" id="{FF0FDDA5-30F4-230D-6563-3F4495A28F51}"/>
               </a:ext>
             </a:extLst>
           </p:cNvPr>
@@ -4334,7 +4334,7 @@
           <p:cNvPr id="8" name="CuadroTexto 7">
             <a:extLst>
               <a:ext uri="{FF2B5EF4-FFF2-40B4-BE49-F238E27FC236}">
-                <a16:creationId xmlns:a16="http://schemas.microsoft.com/office/drawing/2014/main" id="{A600925E-51DE-CF19-7258-F3520E8F4FCB}"/>
+                <a16:creationId xmlns:a16="http://schemas.microsoft.com/office/drawing/2014/main" id="{68F77224-2EDC-3ECF-2BC9-0DFA65E8A5DA}"/>
               </a:ext>
             </a:extLst>
           </p:cNvPr>
@@ -4433,7 +4433,7 @@
     </p:spTree>
     <p:extLst>
       <p:ext uri="{BB962C8B-B14F-4D97-AF65-F5344CB8AC3E}">
-        <p14:creationId xmlns:p14="http://schemas.microsoft.com/office/powerpoint/2010/main" val="2487272628"/>
+        <p14:creationId xmlns:p14="http://schemas.microsoft.com/office/powerpoint/2010/main" val="4206735405"/>
       </p:ext>
     </p:extLst>
   </p:cSld>
@@ -4473,7 +4473,7 @@
           <p:cNvPr id="2" name="CuadroTexto 1">
             <a:extLst>
               <a:ext uri="{FF2B5EF4-FFF2-40B4-BE49-F238E27FC236}">
-                <a16:creationId xmlns:a16="http://schemas.microsoft.com/office/drawing/2014/main" id="{97185A8C-1EC1-0BD9-7F9C-070080BA2E2C}"/>
+                <a16:creationId xmlns:a16="http://schemas.microsoft.com/office/drawing/2014/main" id="{797A3F06-C125-14CA-F808-DA81DE1F3910}"/>
               </a:ext>
             </a:extLst>
           </p:cNvPr>
@@ -4513,7 +4513,7 @@
           <p:cNvPr id="3" name="CuadroTexto 2">
             <a:extLst>
               <a:ext uri="{FF2B5EF4-FFF2-40B4-BE49-F238E27FC236}">
-                <a16:creationId xmlns:a16="http://schemas.microsoft.com/office/drawing/2014/main" id="{A9AA94AC-9D51-2E38-30B3-D31E6189795B}"/>
+                <a16:creationId xmlns:a16="http://schemas.microsoft.com/office/drawing/2014/main" id="{88228733-60FB-3A89-BB9F-9DC1E7825519}"/>
               </a:ext>
             </a:extLst>
           </p:cNvPr>
@@ -4553,7 +4553,7 @@
           <p:cNvPr id="4" name="CuadroTexto 3">
             <a:extLst>
               <a:ext uri="{FF2B5EF4-FFF2-40B4-BE49-F238E27FC236}">
-                <a16:creationId xmlns:a16="http://schemas.microsoft.com/office/drawing/2014/main" id="{8AE375A4-7841-20EE-4DBB-D796858703EC}"/>
+                <a16:creationId xmlns:a16="http://schemas.microsoft.com/office/drawing/2014/main" id="{A2F35359-1E67-EB0E-E9F0-D88BBB410D3B}"/>
               </a:ext>
             </a:extLst>
           </p:cNvPr>
@@ -4593,7 +4593,7 @@
           <p:cNvPr id="5" name="Rectángulo: esquinas redondeadas 4">
             <a:extLst>
               <a:ext uri="{FF2B5EF4-FFF2-40B4-BE49-F238E27FC236}">
-                <a16:creationId xmlns:a16="http://schemas.microsoft.com/office/drawing/2014/main" id="{4B028AC3-08E7-CD92-81DF-28D09737B51C}"/>
+                <a16:creationId xmlns:a16="http://schemas.microsoft.com/office/drawing/2014/main" id="{2ABA5F54-B668-33BB-A181-50BE0832C347}"/>
               </a:ext>
             </a:extLst>
           </p:cNvPr>
@@ -4654,7 +4654,7 @@
           <p:cNvPr id="6" name="CuadroTexto 5">
             <a:extLst>
               <a:ext uri="{FF2B5EF4-FFF2-40B4-BE49-F238E27FC236}">
-                <a16:creationId xmlns:a16="http://schemas.microsoft.com/office/drawing/2014/main" id="{60E5A7F9-59D4-F29F-31F8-3004D92C4420}"/>
+                <a16:creationId xmlns:a16="http://schemas.microsoft.com/office/drawing/2014/main" id="{1061B647-6399-0BF7-A438-5D7F80ECCFA6}"/>
               </a:ext>
             </a:extLst>
           </p:cNvPr>
@@ -4705,7 +4705,7 @@
           <p:cNvPr id="7" name="CuadroTexto 6">
             <a:extLst>
               <a:ext uri="{FF2B5EF4-FFF2-40B4-BE49-F238E27FC236}">
-                <a16:creationId xmlns:a16="http://schemas.microsoft.com/office/drawing/2014/main" id="{70C3CE94-8389-4300-7E2F-899E5B8DE5AB}"/>
+                <a16:creationId xmlns:a16="http://schemas.microsoft.com/office/drawing/2014/main" id="{4D6501EB-E31C-8F8F-D7AB-194E9BE3B6CC}"/>
               </a:ext>
             </a:extLst>
           </p:cNvPr>
@@ -4751,7 +4751,7 @@
           <p:cNvPr id="8" name="CuadroTexto 7">
             <a:extLst>
               <a:ext uri="{FF2B5EF4-FFF2-40B4-BE49-F238E27FC236}">
-                <a16:creationId xmlns:a16="http://schemas.microsoft.com/office/drawing/2014/main" id="{9A7DEAC4-B20F-46B3-C058-729A04D9FFA6}"/>
+                <a16:creationId xmlns:a16="http://schemas.microsoft.com/office/drawing/2014/main" id="{88F1B60E-4A0D-3142-F96B-77EB398FD58D}"/>
               </a:ext>
             </a:extLst>
           </p:cNvPr>
@@ -4850,7 +4850,7 @@
     </p:spTree>
     <p:extLst>
       <p:ext uri="{BB962C8B-B14F-4D97-AF65-F5344CB8AC3E}">
-        <p14:creationId xmlns:p14="http://schemas.microsoft.com/office/powerpoint/2010/main" val="888581515"/>
+        <p14:creationId xmlns:p14="http://schemas.microsoft.com/office/powerpoint/2010/main" val="665728788"/>
       </p:ext>
     </p:extLst>
   </p:cSld>
@@ -4890,7 +4890,7 @@
           <p:cNvPr id="2" name="CuadroTexto 1">
             <a:extLst>
               <a:ext uri="{FF2B5EF4-FFF2-40B4-BE49-F238E27FC236}">
-                <a16:creationId xmlns:a16="http://schemas.microsoft.com/office/drawing/2014/main" id="{734B25AB-4FF2-4928-911C-B7C57E0C5443}"/>
+                <a16:creationId xmlns:a16="http://schemas.microsoft.com/office/drawing/2014/main" id="{31F888FA-E479-36C2-3253-A40D180F6B9D}"/>
               </a:ext>
             </a:extLst>
           </p:cNvPr>
@@ -4930,7 +4930,7 @@
           <p:cNvPr id="3" name="CuadroTexto 2">
             <a:extLst>
               <a:ext uri="{FF2B5EF4-FFF2-40B4-BE49-F238E27FC236}">
-                <a16:creationId xmlns:a16="http://schemas.microsoft.com/office/drawing/2014/main" id="{94B854D2-17BD-3E1D-0F74-719E41E603EF}"/>
+                <a16:creationId xmlns:a16="http://schemas.microsoft.com/office/drawing/2014/main" id="{2043BC74-EA82-F301-6246-FDB8AF785F02}"/>
               </a:ext>
             </a:extLst>
           </p:cNvPr>
@@ -4970,7 +4970,7 @@
           <p:cNvPr id="4" name="CuadroTexto 3">
             <a:extLst>
               <a:ext uri="{FF2B5EF4-FFF2-40B4-BE49-F238E27FC236}">
-                <a16:creationId xmlns:a16="http://schemas.microsoft.com/office/drawing/2014/main" id="{72864871-2CB6-206F-2425-C9AF565C8CC1}"/>
+                <a16:creationId xmlns:a16="http://schemas.microsoft.com/office/drawing/2014/main" id="{358A8D91-CA74-64B4-F3C0-38CEC8759F63}"/>
               </a:ext>
             </a:extLst>
           </p:cNvPr>
@@ -5010,7 +5010,7 @@
           <p:cNvPr id="5" name="Rectángulo: esquinas redondeadas 4">
             <a:extLst>
               <a:ext uri="{FF2B5EF4-FFF2-40B4-BE49-F238E27FC236}">
-                <a16:creationId xmlns:a16="http://schemas.microsoft.com/office/drawing/2014/main" id="{37EA8DB2-FEC9-BF7D-5595-846AF61C3041}"/>
+                <a16:creationId xmlns:a16="http://schemas.microsoft.com/office/drawing/2014/main" id="{9E45E7FC-8E97-33E1-3540-D58933AAAF6D}"/>
               </a:ext>
             </a:extLst>
           </p:cNvPr>
@@ -5071,7 +5071,7 @@
           <p:cNvPr id="6" name="CuadroTexto 5">
             <a:extLst>
               <a:ext uri="{FF2B5EF4-FFF2-40B4-BE49-F238E27FC236}">
-                <a16:creationId xmlns:a16="http://schemas.microsoft.com/office/drawing/2014/main" id="{155D067B-8425-72D6-4973-B43E739254BD}"/>
+                <a16:creationId xmlns:a16="http://schemas.microsoft.com/office/drawing/2014/main" id="{9B4AFF21-AF6B-9C00-D92E-06E9EAE94C33}"/>
               </a:ext>
             </a:extLst>
           </p:cNvPr>
@@ -5118,7 +5118,7 @@
           <p:cNvPr id="7" name="CuadroTexto 6">
             <a:extLst>
               <a:ext uri="{FF2B5EF4-FFF2-40B4-BE49-F238E27FC236}">
-                <a16:creationId xmlns:a16="http://schemas.microsoft.com/office/drawing/2014/main" id="{3FE1C216-489E-FFDD-8A44-7E9763F59BCE}"/>
+                <a16:creationId xmlns:a16="http://schemas.microsoft.com/office/drawing/2014/main" id="{512B4B7A-5E28-C83D-7063-E13ED908CAE2}"/>
               </a:ext>
             </a:extLst>
           </p:cNvPr>
@@ -5158,7 +5158,7 @@
           <p:cNvPr id="8" name="CuadroTexto 7">
             <a:extLst>
               <a:ext uri="{FF2B5EF4-FFF2-40B4-BE49-F238E27FC236}">
-                <a16:creationId xmlns:a16="http://schemas.microsoft.com/office/drawing/2014/main" id="{67CB88EA-B58E-A1C2-3E7C-B18D05A9F2D0}"/>
+                <a16:creationId xmlns:a16="http://schemas.microsoft.com/office/drawing/2014/main" id="{F18A1F40-267C-F464-F5FA-48A8D9FA05F5}"/>
               </a:ext>
             </a:extLst>
           </p:cNvPr>
@@ -5257,7 +5257,7 @@
     </p:spTree>
     <p:extLst>
       <p:ext uri="{BB962C8B-B14F-4D97-AF65-F5344CB8AC3E}">
-        <p14:creationId xmlns:p14="http://schemas.microsoft.com/office/powerpoint/2010/main" val="1304558557"/>
+        <p14:creationId xmlns:p14="http://schemas.microsoft.com/office/powerpoint/2010/main" val="3818227780"/>
       </p:ext>
     </p:extLst>
   </p:cSld>
@@ -5297,7 +5297,7 @@
           <p:cNvPr id="2" name="CuadroTexto 1">
             <a:extLst>
               <a:ext uri="{FF2B5EF4-FFF2-40B4-BE49-F238E27FC236}">
-                <a16:creationId xmlns:a16="http://schemas.microsoft.com/office/drawing/2014/main" id="{1AD9DDF5-299C-1C9B-758F-5EC8AEC24D70}"/>
+                <a16:creationId xmlns:a16="http://schemas.microsoft.com/office/drawing/2014/main" id="{CD31769B-D50B-4D46-596E-824E05542689}"/>
               </a:ext>
             </a:extLst>
           </p:cNvPr>
@@ -5337,7 +5337,7 @@
           <p:cNvPr id="3" name="CuadroTexto 2">
             <a:extLst>
               <a:ext uri="{FF2B5EF4-FFF2-40B4-BE49-F238E27FC236}">
-                <a16:creationId xmlns:a16="http://schemas.microsoft.com/office/drawing/2014/main" id="{F0C3B06D-749F-BC1A-931F-3D83BDE5BD6B}"/>
+                <a16:creationId xmlns:a16="http://schemas.microsoft.com/office/drawing/2014/main" id="{CCD0648F-B027-269A-32DB-E6EF0D98BE2E}"/>
               </a:ext>
             </a:extLst>
           </p:cNvPr>
@@ -5377,7 +5377,7 @@
           <p:cNvPr id="4" name="Rectángulo: esquinas redondeadas 3">
             <a:extLst>
               <a:ext uri="{FF2B5EF4-FFF2-40B4-BE49-F238E27FC236}">
-                <a16:creationId xmlns:a16="http://schemas.microsoft.com/office/drawing/2014/main" id="{270C2D5B-D0D4-5425-8988-AB6EE52B5A98}"/>
+                <a16:creationId xmlns:a16="http://schemas.microsoft.com/office/drawing/2014/main" id="{05323D74-0809-F041-1991-F47D324AAE66}"/>
               </a:ext>
             </a:extLst>
           </p:cNvPr>
@@ -5431,7 +5431,7 @@
           <p:cNvPr id="5" name="CuadroTexto 4">
             <a:extLst>
               <a:ext uri="{FF2B5EF4-FFF2-40B4-BE49-F238E27FC236}">
-                <a16:creationId xmlns:a16="http://schemas.microsoft.com/office/drawing/2014/main" id="{6A2AFB7D-75C3-BBE0-A026-F39BE2105CA7}"/>
+                <a16:creationId xmlns:a16="http://schemas.microsoft.com/office/drawing/2014/main" id="{19FD36BB-8B0F-8260-F854-CE25B3BE151D}"/>
               </a:ext>
             </a:extLst>
           </p:cNvPr>
@@ -5471,7 +5471,7 @@
           <p:cNvPr id="6" name="CuadroTexto 5">
             <a:extLst>
               <a:ext uri="{FF2B5EF4-FFF2-40B4-BE49-F238E27FC236}">
-                <a16:creationId xmlns:a16="http://schemas.microsoft.com/office/drawing/2014/main" id="{2C7D97F0-0C38-69B5-E0BA-15553FF71E82}"/>
+                <a16:creationId xmlns:a16="http://schemas.microsoft.com/office/drawing/2014/main" id="{749F936C-8F52-D8B3-651A-2F50AC0E2CFE}"/>
               </a:ext>
             </a:extLst>
           </p:cNvPr>
@@ -5511,7 +5511,7 @@
           <p:cNvPr id="7" name="Rectángulo: esquinas redondeadas 6">
             <a:extLst>
               <a:ext uri="{FF2B5EF4-FFF2-40B4-BE49-F238E27FC236}">
-                <a16:creationId xmlns:a16="http://schemas.microsoft.com/office/drawing/2014/main" id="{79C9E807-2054-9127-9429-6A409660F897}"/>
+                <a16:creationId xmlns:a16="http://schemas.microsoft.com/office/drawing/2014/main" id="{2E662721-1E9D-0984-CE8B-8DC58443971E}"/>
               </a:ext>
             </a:extLst>
           </p:cNvPr>
@@ -5565,7 +5565,7 @@
           <p:cNvPr id="8" name="CuadroTexto 7">
             <a:extLst>
               <a:ext uri="{FF2B5EF4-FFF2-40B4-BE49-F238E27FC236}">
-                <a16:creationId xmlns:a16="http://schemas.microsoft.com/office/drawing/2014/main" id="{9D0ABFFB-CCEB-455A-F2B1-087C18C7B2A9}"/>
+                <a16:creationId xmlns:a16="http://schemas.microsoft.com/office/drawing/2014/main" id="{565C60D7-E94E-2709-BC4F-CA701626F5A7}"/>
               </a:ext>
             </a:extLst>
           </p:cNvPr>
@@ -5605,7 +5605,7 @@
           <p:cNvPr id="9" name="CuadroTexto 8">
             <a:extLst>
               <a:ext uri="{FF2B5EF4-FFF2-40B4-BE49-F238E27FC236}">
-                <a16:creationId xmlns:a16="http://schemas.microsoft.com/office/drawing/2014/main" id="{4CE1E8D2-908B-B924-4561-A58049C07588}"/>
+                <a16:creationId xmlns:a16="http://schemas.microsoft.com/office/drawing/2014/main" id="{46B65B74-4E32-132A-F7C2-9DF6FF7C9195}"/>
               </a:ext>
             </a:extLst>
           </p:cNvPr>
@@ -5645,7 +5645,7 @@
           <p:cNvPr id="10" name="Rectángulo: esquinas redondeadas 9">
             <a:extLst>
               <a:ext uri="{FF2B5EF4-FFF2-40B4-BE49-F238E27FC236}">
-                <a16:creationId xmlns:a16="http://schemas.microsoft.com/office/drawing/2014/main" id="{D414E786-40AA-D662-0B77-F572547661D0}"/>
+                <a16:creationId xmlns:a16="http://schemas.microsoft.com/office/drawing/2014/main" id="{AC38B38F-4B3F-2732-CA5C-D7CE72E85242}"/>
               </a:ext>
             </a:extLst>
           </p:cNvPr>
@@ -5699,7 +5699,7 @@
           <p:cNvPr id="11" name="CuadroTexto 10">
             <a:extLst>
               <a:ext uri="{FF2B5EF4-FFF2-40B4-BE49-F238E27FC236}">
-                <a16:creationId xmlns:a16="http://schemas.microsoft.com/office/drawing/2014/main" id="{1BCD2E6E-7FEE-9A40-9323-7FD475EB68BB}"/>
+                <a16:creationId xmlns:a16="http://schemas.microsoft.com/office/drawing/2014/main" id="{6CE4B240-3200-1EEC-2CCD-0BDFF263A3F4}"/>
               </a:ext>
             </a:extLst>
           </p:cNvPr>
@@ -5739,7 +5739,7 @@
           <p:cNvPr id="12" name="CuadroTexto 11">
             <a:extLst>
               <a:ext uri="{FF2B5EF4-FFF2-40B4-BE49-F238E27FC236}">
-                <a16:creationId xmlns:a16="http://schemas.microsoft.com/office/drawing/2014/main" id="{6D255B9C-B357-1798-C60F-572D7CD3538E}"/>
+                <a16:creationId xmlns:a16="http://schemas.microsoft.com/office/drawing/2014/main" id="{14B6F759-BFC5-BA11-6711-993345E8C3F5}"/>
               </a:ext>
             </a:extLst>
           </p:cNvPr>
@@ -5779,7 +5779,7 @@
           <p:cNvPr id="13" name="Rectángulo: esquinas redondeadas 12">
             <a:extLst>
               <a:ext uri="{FF2B5EF4-FFF2-40B4-BE49-F238E27FC236}">
-                <a16:creationId xmlns:a16="http://schemas.microsoft.com/office/drawing/2014/main" id="{0FED11A9-1E12-9168-F777-EC51BB9F3F37}"/>
+                <a16:creationId xmlns:a16="http://schemas.microsoft.com/office/drawing/2014/main" id="{257B8291-E5A6-D9FE-11E2-4B20000CB7BD}"/>
               </a:ext>
             </a:extLst>
           </p:cNvPr>
@@ -5833,7 +5833,7 @@
           <p:cNvPr id="14" name="CuadroTexto 13">
             <a:extLst>
               <a:ext uri="{FF2B5EF4-FFF2-40B4-BE49-F238E27FC236}">
-                <a16:creationId xmlns:a16="http://schemas.microsoft.com/office/drawing/2014/main" id="{183A1DAA-7D1C-F6EB-BE83-0FB8BFFAA23F}"/>
+                <a16:creationId xmlns:a16="http://schemas.microsoft.com/office/drawing/2014/main" id="{25AF199E-81BB-FB28-1F57-D67B331E9C36}"/>
               </a:ext>
             </a:extLst>
           </p:cNvPr>
@@ -5873,7 +5873,7 @@
           <p:cNvPr id="15" name="CuadroTexto 14">
             <a:extLst>
               <a:ext uri="{FF2B5EF4-FFF2-40B4-BE49-F238E27FC236}">
-                <a16:creationId xmlns:a16="http://schemas.microsoft.com/office/drawing/2014/main" id="{8812EE9E-4B00-1AB3-A5DD-A1394BB7A1F0}"/>
+                <a16:creationId xmlns:a16="http://schemas.microsoft.com/office/drawing/2014/main" id="{57D39FE6-519B-EF22-F752-AB318B1CE041}"/>
               </a:ext>
             </a:extLst>
           </p:cNvPr>
@@ -5913,7 +5913,7 @@
           <p:cNvPr id="16" name="CuadroTexto 15">
             <a:extLst>
               <a:ext uri="{FF2B5EF4-FFF2-40B4-BE49-F238E27FC236}">
-                <a16:creationId xmlns:a16="http://schemas.microsoft.com/office/drawing/2014/main" id="{EA17FC3F-07E6-E91A-3C1A-7C5016118CBC}"/>
+                <a16:creationId xmlns:a16="http://schemas.microsoft.com/office/drawing/2014/main" id="{62190035-646C-6478-68E4-A18655287021}"/>
               </a:ext>
             </a:extLst>
           </p:cNvPr>
@@ -5996,7 +5996,7 @@
           <p:cNvPr id="17" name="CuadroTexto 16">
             <a:extLst>
               <a:ext uri="{FF2B5EF4-FFF2-40B4-BE49-F238E27FC236}">
-                <a16:creationId xmlns:a16="http://schemas.microsoft.com/office/drawing/2014/main" id="{EA2211E6-0A5B-B7B5-5914-37FD30B6155B}"/>
+                <a16:creationId xmlns:a16="http://schemas.microsoft.com/office/drawing/2014/main" id="{1B32A1F7-1071-61D7-CF27-1042C0759C47}"/>
               </a:ext>
             </a:extLst>
           </p:cNvPr>
@@ -6034,7 +6034,7 @@
     </p:spTree>
     <p:extLst>
       <p:ext uri="{BB962C8B-B14F-4D97-AF65-F5344CB8AC3E}">
-        <p14:creationId xmlns:p14="http://schemas.microsoft.com/office/powerpoint/2010/main" val="2648277465"/>
+        <p14:creationId xmlns:p14="http://schemas.microsoft.com/office/powerpoint/2010/main" val="701091883"/>
       </p:ext>
     </p:extLst>
   </p:cSld>
@@ -6074,7 +6074,7 @@
           <p:cNvPr id="2" name="CuadroTexto 1">
             <a:extLst>
               <a:ext uri="{FF2B5EF4-FFF2-40B4-BE49-F238E27FC236}">
-                <a16:creationId xmlns:a16="http://schemas.microsoft.com/office/drawing/2014/main" id="{83BC56A0-6199-C19D-B500-7EF3395CBC77}"/>
+                <a16:creationId xmlns:a16="http://schemas.microsoft.com/office/drawing/2014/main" id="{A8EDEE22-43E9-E198-66BF-8002977B584A}"/>
               </a:ext>
             </a:extLst>
           </p:cNvPr>
@@ -6114,7 +6114,7 @@
           <p:cNvPr id="3" name="CuadroTexto 2">
             <a:extLst>
               <a:ext uri="{FF2B5EF4-FFF2-40B4-BE49-F238E27FC236}">
-                <a16:creationId xmlns:a16="http://schemas.microsoft.com/office/drawing/2014/main" id="{7E0D7E40-7583-3E61-2823-3EB085419767}"/>
+                <a16:creationId xmlns:a16="http://schemas.microsoft.com/office/drawing/2014/main" id="{11915613-87DA-92AD-06CC-7444AEF5F78F}"/>
               </a:ext>
             </a:extLst>
           </p:cNvPr>
@@ -6154,7 +6154,7 @@
           <p:cNvPr id="4" name="CuadroTexto 3">
             <a:extLst>
               <a:ext uri="{FF2B5EF4-FFF2-40B4-BE49-F238E27FC236}">
-                <a16:creationId xmlns:a16="http://schemas.microsoft.com/office/drawing/2014/main" id="{3AC3F5FB-FC13-3765-101C-9A41C302052D}"/>
+                <a16:creationId xmlns:a16="http://schemas.microsoft.com/office/drawing/2014/main" id="{611DF2B7-D5FC-B61C-4A49-849A9E4629DE}"/>
               </a:ext>
             </a:extLst>
           </p:cNvPr>
@@ -6194,7 +6194,7 @@
           <p:cNvPr id="5" name="Rectángulo: esquinas redondeadas 4">
             <a:extLst>
               <a:ext uri="{FF2B5EF4-FFF2-40B4-BE49-F238E27FC236}">
-                <a16:creationId xmlns:a16="http://schemas.microsoft.com/office/drawing/2014/main" id="{5D3D4F96-4348-744B-BC6B-39900F810CB6}"/>
+                <a16:creationId xmlns:a16="http://schemas.microsoft.com/office/drawing/2014/main" id="{F4C4393D-1784-C48B-DE96-8175E054650D}"/>
               </a:ext>
             </a:extLst>
           </p:cNvPr>
@@ -6248,7 +6248,7 @@
           <p:cNvPr id="6" name="CuadroTexto 5">
             <a:extLst>
               <a:ext uri="{FF2B5EF4-FFF2-40B4-BE49-F238E27FC236}">
-                <a16:creationId xmlns:a16="http://schemas.microsoft.com/office/drawing/2014/main" id="{89DDA9F9-08F7-1758-264E-B41935A6A6D6}"/>
+                <a16:creationId xmlns:a16="http://schemas.microsoft.com/office/drawing/2014/main" id="{C6B46110-8EE8-EFF1-88CB-3B1B54DF4A7E}"/>
               </a:ext>
             </a:extLst>
           </p:cNvPr>
@@ -6288,7 +6288,7 @@
           <p:cNvPr id="7" name="CuadroTexto 6">
             <a:extLst>
               <a:ext uri="{FF2B5EF4-FFF2-40B4-BE49-F238E27FC236}">
-                <a16:creationId xmlns:a16="http://schemas.microsoft.com/office/drawing/2014/main" id="{8E1C0560-176E-69A9-7BD8-5C1FA97D2DCA}"/>
+                <a16:creationId xmlns:a16="http://schemas.microsoft.com/office/drawing/2014/main" id="{FCFCC93C-65E7-0A9C-29FE-633D9707033F}"/>
               </a:ext>
             </a:extLst>
           </p:cNvPr>
@@ -6328,7 +6328,7 @@
           <p:cNvPr id="8" name="CuadroTexto 7">
             <a:extLst>
               <a:ext uri="{FF2B5EF4-FFF2-40B4-BE49-F238E27FC236}">
-                <a16:creationId xmlns:a16="http://schemas.microsoft.com/office/drawing/2014/main" id="{C914FAD8-3974-02AC-DBEE-B0E9438C83E8}"/>
+                <a16:creationId xmlns:a16="http://schemas.microsoft.com/office/drawing/2014/main" id="{963D4D41-69F1-3679-0F46-1DC6D4BB8609}"/>
               </a:ext>
             </a:extLst>
           </p:cNvPr>
@@ -6427,7 +6427,7 @@
     </p:spTree>
     <p:extLst>
       <p:ext uri="{BB962C8B-B14F-4D97-AF65-F5344CB8AC3E}">
-        <p14:creationId xmlns:p14="http://schemas.microsoft.com/office/powerpoint/2010/main" val="2249659752"/>
+        <p14:creationId xmlns:p14="http://schemas.microsoft.com/office/powerpoint/2010/main" val="2483162841"/>
       </p:ext>
     </p:extLst>
   </p:cSld>
@@ -6467,7 +6467,7 @@
           <p:cNvPr id="2" name="CuadroTexto 1">
             <a:extLst>
               <a:ext uri="{FF2B5EF4-FFF2-40B4-BE49-F238E27FC236}">
-                <a16:creationId xmlns:a16="http://schemas.microsoft.com/office/drawing/2014/main" id="{6A977C69-2B71-237A-5E81-77596293E329}"/>
+                <a16:creationId xmlns:a16="http://schemas.microsoft.com/office/drawing/2014/main" id="{3B01466F-135F-00F1-699E-2F6274383697}"/>
               </a:ext>
             </a:extLst>
           </p:cNvPr>
@@ -6507,7 +6507,7 @@
           <p:cNvPr id="3" name="CuadroTexto 2">
             <a:extLst>
               <a:ext uri="{FF2B5EF4-FFF2-40B4-BE49-F238E27FC236}">
-                <a16:creationId xmlns:a16="http://schemas.microsoft.com/office/drawing/2014/main" id="{4C83F2DD-7CAB-A2A4-28E4-C3796172BF92}"/>
+                <a16:creationId xmlns:a16="http://schemas.microsoft.com/office/drawing/2014/main" id="{90BC9E3E-5C25-C777-B1EA-CC20A5A5234C}"/>
               </a:ext>
             </a:extLst>
           </p:cNvPr>
@@ -6547,7 +6547,7 @@
           <p:cNvPr id="4" name="CuadroTexto 3">
             <a:extLst>
               <a:ext uri="{FF2B5EF4-FFF2-40B4-BE49-F238E27FC236}">
-                <a16:creationId xmlns:a16="http://schemas.microsoft.com/office/drawing/2014/main" id="{F64076DE-2100-F9AA-C059-A0165F46DC90}"/>
+                <a16:creationId xmlns:a16="http://schemas.microsoft.com/office/drawing/2014/main" id="{6B034E60-2FF6-7C58-1CAE-8F09999EE08D}"/>
               </a:ext>
             </a:extLst>
           </p:cNvPr>
@@ -6666,7 +6666,7 @@
           <p:cNvPr id="5" name="Rectángulo: esquinas redondeadas 4">
             <a:extLst>
               <a:ext uri="{FF2B5EF4-FFF2-40B4-BE49-F238E27FC236}">
-                <a16:creationId xmlns:a16="http://schemas.microsoft.com/office/drawing/2014/main" id="{65DDA8C8-8B2A-FD93-3F95-5153FF60765E}"/>
+                <a16:creationId xmlns:a16="http://schemas.microsoft.com/office/drawing/2014/main" id="{C962B3AA-44C4-8A3E-E185-66D2E6DA9D9A}"/>
               </a:ext>
             </a:extLst>
           </p:cNvPr>
@@ -6720,7 +6720,7 @@
           <p:cNvPr id="6" name="CuadroTexto 5">
             <a:extLst>
               <a:ext uri="{FF2B5EF4-FFF2-40B4-BE49-F238E27FC236}">
-                <a16:creationId xmlns:a16="http://schemas.microsoft.com/office/drawing/2014/main" id="{C38F232F-EF10-A3D3-CB75-E641EC0DA9D5}"/>
+                <a16:creationId xmlns:a16="http://schemas.microsoft.com/office/drawing/2014/main" id="{0E61F719-5B40-A228-90BC-A0F4809D4B2D}"/>
               </a:ext>
             </a:extLst>
           </p:cNvPr>
@@ -6760,7 +6760,7 @@
           <p:cNvPr id="7" name="CuadroTexto 6">
             <a:extLst>
               <a:ext uri="{FF2B5EF4-FFF2-40B4-BE49-F238E27FC236}">
-                <a16:creationId xmlns:a16="http://schemas.microsoft.com/office/drawing/2014/main" id="{6FFB2152-F8EA-0244-347D-2E194B38A89F}"/>
+                <a16:creationId xmlns:a16="http://schemas.microsoft.com/office/drawing/2014/main" id="{AEE36208-22C8-A255-5CDF-6E33285538B6}"/>
               </a:ext>
             </a:extLst>
           </p:cNvPr>
@@ -6798,7 +6798,7 @@
     </p:spTree>
     <p:extLst>
       <p:ext uri="{BB962C8B-B14F-4D97-AF65-F5344CB8AC3E}">
-        <p14:creationId xmlns:p14="http://schemas.microsoft.com/office/powerpoint/2010/main" val="87446812"/>
+        <p14:creationId xmlns:p14="http://schemas.microsoft.com/office/powerpoint/2010/main" val="3048276671"/>
       </p:ext>
     </p:extLst>
   </p:cSld>
@@ -6838,7 +6838,7 @@
           <p:cNvPr id="2" name="CuadroTexto 1">
             <a:extLst>
               <a:ext uri="{FF2B5EF4-FFF2-40B4-BE49-F238E27FC236}">
-                <a16:creationId xmlns:a16="http://schemas.microsoft.com/office/drawing/2014/main" id="{32FE5A12-90F8-7D38-1400-C037B7FC56C7}"/>
+                <a16:creationId xmlns:a16="http://schemas.microsoft.com/office/drawing/2014/main" id="{CAA47B8B-73CA-F7E8-AD7A-AF3746C5F085}"/>
               </a:ext>
             </a:extLst>
           </p:cNvPr>
@@ -6878,7 +6878,7 @@
           <p:cNvPr id="3" name="CuadroTexto 2">
             <a:extLst>
               <a:ext uri="{FF2B5EF4-FFF2-40B4-BE49-F238E27FC236}">
-                <a16:creationId xmlns:a16="http://schemas.microsoft.com/office/drawing/2014/main" id="{52E5DD95-61D5-0FCB-DB6B-F6D83A2D2EA3}"/>
+                <a16:creationId xmlns:a16="http://schemas.microsoft.com/office/drawing/2014/main" id="{21352095-37FF-7FAF-3B7B-07BDCD6102E9}"/>
               </a:ext>
             </a:extLst>
           </p:cNvPr>
@@ -6918,7 +6918,7 @@
           <p:cNvPr id="4" name="CuadroTexto 3">
             <a:extLst>
               <a:ext uri="{FF2B5EF4-FFF2-40B4-BE49-F238E27FC236}">
-                <a16:creationId xmlns:a16="http://schemas.microsoft.com/office/drawing/2014/main" id="{19CB6F29-63B2-5EFA-4962-F0E1BF095FFE}"/>
+                <a16:creationId xmlns:a16="http://schemas.microsoft.com/office/drawing/2014/main" id="{36D4E0D8-10B9-E8E1-32AD-0F896586F572}"/>
               </a:ext>
             </a:extLst>
           </p:cNvPr>
@@ -6958,7 +6958,7 @@
           <p:cNvPr id="5" name="CuadroTexto 4">
             <a:extLst>
               <a:ext uri="{FF2B5EF4-FFF2-40B4-BE49-F238E27FC236}">
-                <a16:creationId xmlns:a16="http://schemas.microsoft.com/office/drawing/2014/main" id="{7057661D-9905-2FF9-7F3A-59BEB93B9947}"/>
+                <a16:creationId xmlns:a16="http://schemas.microsoft.com/office/drawing/2014/main" id="{40E9AAA9-408A-C011-AA05-C0047807AA96}"/>
               </a:ext>
             </a:extLst>
           </p:cNvPr>
@@ -7041,7 +7041,7 @@
           <p:cNvPr id="6" name="CuadroTexto 5">
             <a:extLst>
               <a:ext uri="{FF2B5EF4-FFF2-40B4-BE49-F238E27FC236}">
-                <a16:creationId xmlns:a16="http://schemas.microsoft.com/office/drawing/2014/main" id="{D7F05108-CA1B-A8EB-66E3-7CFF258015C7}"/>
+                <a16:creationId xmlns:a16="http://schemas.microsoft.com/office/drawing/2014/main" id="{CDFC56CD-F488-C8A2-2F73-1E1C82428919}"/>
               </a:ext>
             </a:extLst>
           </p:cNvPr>
@@ -7079,7 +7079,7 @@
     </p:spTree>
     <p:extLst>
       <p:ext uri="{BB962C8B-B14F-4D97-AF65-F5344CB8AC3E}">
-        <p14:creationId xmlns:p14="http://schemas.microsoft.com/office/powerpoint/2010/main" val="2232254612"/>
+        <p14:creationId xmlns:p14="http://schemas.microsoft.com/office/powerpoint/2010/main" val="1348730599"/>
       </p:ext>
     </p:extLst>
   </p:cSld>
@@ -7119,7 +7119,7 @@
           <p:cNvPr id="2" name="CuadroTexto 1">
             <a:extLst>
               <a:ext uri="{FF2B5EF4-FFF2-40B4-BE49-F238E27FC236}">
-                <a16:creationId xmlns:a16="http://schemas.microsoft.com/office/drawing/2014/main" id="{F79F1282-CF39-0930-9A05-344BCA0A17CE}"/>
+                <a16:creationId xmlns:a16="http://schemas.microsoft.com/office/drawing/2014/main" id="{D66F771D-844A-8A8A-1619-F262A4D39AA6}"/>
               </a:ext>
             </a:extLst>
           </p:cNvPr>
@@ -7159,7 +7159,7 @@
           <p:cNvPr id="3" name="CuadroTexto 2">
             <a:extLst>
               <a:ext uri="{FF2B5EF4-FFF2-40B4-BE49-F238E27FC236}">
-                <a16:creationId xmlns:a16="http://schemas.microsoft.com/office/drawing/2014/main" id="{CFAB9BAC-003E-318D-5484-8F806E5C49A4}"/>
+                <a16:creationId xmlns:a16="http://schemas.microsoft.com/office/drawing/2014/main" id="{AA0E707B-611E-F1AC-59DD-8C8448C234F9}"/>
               </a:ext>
             </a:extLst>
           </p:cNvPr>
@@ -7199,7 +7199,7 @@
           <p:cNvPr id="4" name="CuadroTexto 3">
             <a:extLst>
               <a:ext uri="{FF2B5EF4-FFF2-40B4-BE49-F238E27FC236}">
-                <a16:creationId xmlns:a16="http://schemas.microsoft.com/office/drawing/2014/main" id="{1F1A325E-957E-8185-77DE-C31F65EE7742}"/>
+                <a16:creationId xmlns:a16="http://schemas.microsoft.com/office/drawing/2014/main" id="{B273184F-ED8D-917C-985D-945732CFBA6D}"/>
               </a:ext>
             </a:extLst>
           </p:cNvPr>
@@ -7239,7 +7239,7 @@
           <p:cNvPr id="5" name="CuadroTexto 4">
             <a:extLst>
               <a:ext uri="{FF2B5EF4-FFF2-40B4-BE49-F238E27FC236}">
-                <a16:creationId xmlns:a16="http://schemas.microsoft.com/office/drawing/2014/main" id="{D8459745-0D6D-1621-55F1-880FD5C08BDC}"/>
+                <a16:creationId xmlns:a16="http://schemas.microsoft.com/office/drawing/2014/main" id="{1915B90E-BCE6-2D2C-6A00-56E4BEF8136F}"/>
               </a:ext>
             </a:extLst>
           </p:cNvPr>
@@ -7340,7 +7340,7 @@
           <p:cNvPr id="6" name="Rectángulo: esquinas redondeadas 5">
             <a:extLst>
               <a:ext uri="{FF2B5EF4-FFF2-40B4-BE49-F238E27FC236}">
-                <a16:creationId xmlns:a16="http://schemas.microsoft.com/office/drawing/2014/main" id="{E56AB671-7EBE-D66D-8636-8E3648846053}"/>
+                <a16:creationId xmlns:a16="http://schemas.microsoft.com/office/drawing/2014/main" id="{E3A242DE-AEFC-85A9-F6C5-D682491C8B55}"/>
               </a:ext>
             </a:extLst>
           </p:cNvPr>
@@ -7394,7 +7394,7 @@
           <p:cNvPr id="7" name="CuadroTexto 6">
             <a:extLst>
               <a:ext uri="{FF2B5EF4-FFF2-40B4-BE49-F238E27FC236}">
-                <a16:creationId xmlns:a16="http://schemas.microsoft.com/office/drawing/2014/main" id="{AB5C10D5-5A1F-196F-C105-4CD38F89BDA9}"/>
+                <a16:creationId xmlns:a16="http://schemas.microsoft.com/office/drawing/2014/main" id="{527E0B3B-A3CA-87F8-63E9-9D3A94567C78}"/>
               </a:ext>
             </a:extLst>
           </p:cNvPr>
@@ -7434,7 +7434,7 @@
           <p:cNvPr id="8" name="CuadroTexto 7">
             <a:extLst>
               <a:ext uri="{FF2B5EF4-FFF2-40B4-BE49-F238E27FC236}">
-                <a16:creationId xmlns:a16="http://schemas.microsoft.com/office/drawing/2014/main" id="{E9006636-8EC1-3112-DA77-AFE0F0559BC9}"/>
+                <a16:creationId xmlns:a16="http://schemas.microsoft.com/office/drawing/2014/main" id="{3EFBDDF0-1C89-E748-AE70-101E2A8D77B7}"/>
               </a:ext>
             </a:extLst>
           </p:cNvPr>
@@ -7472,7 +7472,7 @@
     </p:spTree>
     <p:extLst>
       <p:ext uri="{BB962C8B-B14F-4D97-AF65-F5344CB8AC3E}">
-        <p14:creationId xmlns:p14="http://schemas.microsoft.com/office/powerpoint/2010/main" val="3430339781"/>
+        <p14:creationId xmlns:p14="http://schemas.microsoft.com/office/powerpoint/2010/main" val="3051785877"/>
       </p:ext>
     </p:extLst>
   </p:cSld>
@@ -7512,7 +7512,7 @@
           <p:cNvPr id="2" name="CuadroTexto 1">
             <a:extLst>
               <a:ext uri="{FF2B5EF4-FFF2-40B4-BE49-F238E27FC236}">
-                <a16:creationId xmlns:a16="http://schemas.microsoft.com/office/drawing/2014/main" id="{8102CF5D-A8B2-F602-544C-D0D07D409CBE}"/>
+                <a16:creationId xmlns:a16="http://schemas.microsoft.com/office/drawing/2014/main" id="{636B7FD3-1393-5D89-5B28-09F9F173D23E}"/>
               </a:ext>
             </a:extLst>
           </p:cNvPr>
@@ -7552,7 +7552,7 @@
           <p:cNvPr id="3" name="CuadroTexto 2">
             <a:extLst>
               <a:ext uri="{FF2B5EF4-FFF2-40B4-BE49-F238E27FC236}">
-                <a16:creationId xmlns:a16="http://schemas.microsoft.com/office/drawing/2014/main" id="{5377035A-ED9B-B6E7-DFCC-5191FC3F5121}"/>
+                <a16:creationId xmlns:a16="http://schemas.microsoft.com/office/drawing/2014/main" id="{53F41C42-779D-C24A-7748-50A142FE32C0}"/>
               </a:ext>
             </a:extLst>
           </p:cNvPr>
@@ -7592,7 +7592,7 @@
           <p:cNvPr id="4" name="Rectángulo: esquinas redondeadas 3">
             <a:extLst>
               <a:ext uri="{FF2B5EF4-FFF2-40B4-BE49-F238E27FC236}">
-                <a16:creationId xmlns:a16="http://schemas.microsoft.com/office/drawing/2014/main" id="{93C19167-55BB-FE32-F49A-008FA3056082}"/>
+                <a16:creationId xmlns:a16="http://schemas.microsoft.com/office/drawing/2014/main" id="{09A8808C-9454-C366-AE0D-FB3DD96BEE04}"/>
               </a:ext>
             </a:extLst>
           </p:cNvPr>
@@ -7646,7 +7646,7 @@
           <p:cNvPr id="5" name="CuadroTexto 4">
             <a:extLst>
               <a:ext uri="{FF2B5EF4-FFF2-40B4-BE49-F238E27FC236}">
-                <a16:creationId xmlns:a16="http://schemas.microsoft.com/office/drawing/2014/main" id="{DC08BC56-DA41-2C62-D237-6F623EA2FB60}"/>
+                <a16:creationId xmlns:a16="http://schemas.microsoft.com/office/drawing/2014/main" id="{E955CF94-8241-1786-EF6F-E855D247F4CC}"/>
               </a:ext>
             </a:extLst>
           </p:cNvPr>
@@ -7686,7 +7686,7 @@
           <p:cNvPr id="6" name="CuadroTexto 5">
             <a:extLst>
               <a:ext uri="{FF2B5EF4-FFF2-40B4-BE49-F238E27FC236}">
-                <a16:creationId xmlns:a16="http://schemas.microsoft.com/office/drawing/2014/main" id="{24BD4EF2-0FF2-CEB6-7035-B36C29E26061}"/>
+                <a16:creationId xmlns:a16="http://schemas.microsoft.com/office/drawing/2014/main" id="{225FD148-BF6E-CB4D-57D2-9E2214759528}"/>
               </a:ext>
             </a:extLst>
           </p:cNvPr>
@@ -7726,7 +7726,7 @@
           <p:cNvPr id="7" name="Rectángulo: esquinas redondeadas 6">
             <a:extLst>
               <a:ext uri="{FF2B5EF4-FFF2-40B4-BE49-F238E27FC236}">
-                <a16:creationId xmlns:a16="http://schemas.microsoft.com/office/drawing/2014/main" id="{F39DCFA7-327D-5C67-963F-CA96C9CDA483}"/>
+                <a16:creationId xmlns:a16="http://schemas.microsoft.com/office/drawing/2014/main" id="{93199024-54D7-0743-9E32-A3E116F97E72}"/>
               </a:ext>
             </a:extLst>
           </p:cNvPr>
@@ -7780,7 +7780,7 @@
           <p:cNvPr id="8" name="CuadroTexto 7">
             <a:extLst>
               <a:ext uri="{FF2B5EF4-FFF2-40B4-BE49-F238E27FC236}">
-                <a16:creationId xmlns:a16="http://schemas.microsoft.com/office/drawing/2014/main" id="{9C3EDE71-F7A1-70A2-2B83-B51AEE509A6D}"/>
+                <a16:creationId xmlns:a16="http://schemas.microsoft.com/office/drawing/2014/main" id="{951C0E31-4E5A-F800-7EBD-DAB5664930F2}"/>
               </a:ext>
             </a:extLst>
           </p:cNvPr>
@@ -7820,7 +7820,7 @@
           <p:cNvPr id="9" name="CuadroTexto 8">
             <a:extLst>
               <a:ext uri="{FF2B5EF4-FFF2-40B4-BE49-F238E27FC236}">
-                <a16:creationId xmlns:a16="http://schemas.microsoft.com/office/drawing/2014/main" id="{19E534A0-BF94-CB21-95FE-55905DA6AF47}"/>
+                <a16:creationId xmlns:a16="http://schemas.microsoft.com/office/drawing/2014/main" id="{EA031D46-0FAC-63CC-B25A-E58D125ADB95}"/>
               </a:ext>
             </a:extLst>
           </p:cNvPr>
@@ -7860,7 +7860,7 @@
           <p:cNvPr id="10" name="Rectángulo: esquinas redondeadas 9">
             <a:extLst>
               <a:ext uri="{FF2B5EF4-FFF2-40B4-BE49-F238E27FC236}">
-                <a16:creationId xmlns:a16="http://schemas.microsoft.com/office/drawing/2014/main" id="{AB46A34D-43C8-1F34-305D-9F344085BE16}"/>
+                <a16:creationId xmlns:a16="http://schemas.microsoft.com/office/drawing/2014/main" id="{B8981CA7-A9DA-FD1F-C526-13A952BE22D2}"/>
               </a:ext>
             </a:extLst>
           </p:cNvPr>
@@ -7914,7 +7914,7 @@
           <p:cNvPr id="11" name="CuadroTexto 10">
             <a:extLst>
               <a:ext uri="{FF2B5EF4-FFF2-40B4-BE49-F238E27FC236}">
-                <a16:creationId xmlns:a16="http://schemas.microsoft.com/office/drawing/2014/main" id="{0D24BB83-B771-BB35-1FEF-B1E61EA78524}"/>
+                <a16:creationId xmlns:a16="http://schemas.microsoft.com/office/drawing/2014/main" id="{FD029213-F952-0DDD-A7B1-58D1A75E1C35}"/>
               </a:ext>
             </a:extLst>
           </p:cNvPr>
@@ -7954,7 +7954,7 @@
           <p:cNvPr id="12" name="CuadroTexto 11">
             <a:extLst>
               <a:ext uri="{FF2B5EF4-FFF2-40B4-BE49-F238E27FC236}">
-                <a16:creationId xmlns:a16="http://schemas.microsoft.com/office/drawing/2014/main" id="{DE8B2ECC-91BD-8D8A-7FDC-C9D7C640EC42}"/>
+                <a16:creationId xmlns:a16="http://schemas.microsoft.com/office/drawing/2014/main" id="{637BC3FE-0C17-AD8F-C01A-229033F77416}"/>
               </a:ext>
             </a:extLst>
           </p:cNvPr>
@@ -7994,7 +7994,7 @@
           <p:cNvPr id="13" name="Rectángulo: esquinas redondeadas 12">
             <a:extLst>
               <a:ext uri="{FF2B5EF4-FFF2-40B4-BE49-F238E27FC236}">
-                <a16:creationId xmlns:a16="http://schemas.microsoft.com/office/drawing/2014/main" id="{F4BD3E8C-D8E9-CCD6-EAC4-A0A3C674087D}"/>
+                <a16:creationId xmlns:a16="http://schemas.microsoft.com/office/drawing/2014/main" id="{7DF30922-9107-776D-3018-6A86AA3D6E40}"/>
               </a:ext>
             </a:extLst>
           </p:cNvPr>
@@ -8048,7 +8048,7 @@
           <p:cNvPr id="14" name="CuadroTexto 13">
             <a:extLst>
               <a:ext uri="{FF2B5EF4-FFF2-40B4-BE49-F238E27FC236}">
-                <a16:creationId xmlns:a16="http://schemas.microsoft.com/office/drawing/2014/main" id="{61508E45-19E6-E543-7BEA-48F37415429D}"/>
+                <a16:creationId xmlns:a16="http://schemas.microsoft.com/office/drawing/2014/main" id="{5E3B5AC8-5916-8714-C52E-8C39DC8077EA}"/>
               </a:ext>
             </a:extLst>
           </p:cNvPr>
@@ -8088,7 +8088,7 @@
           <p:cNvPr id="15" name="CuadroTexto 14">
             <a:extLst>
               <a:ext uri="{FF2B5EF4-FFF2-40B4-BE49-F238E27FC236}">
-                <a16:creationId xmlns:a16="http://schemas.microsoft.com/office/drawing/2014/main" id="{A9712C04-C18D-5F91-AA09-B4F771A0F2AE}"/>
+                <a16:creationId xmlns:a16="http://schemas.microsoft.com/office/drawing/2014/main" id="{7D90F14A-D89D-B40D-7E84-52EABEF1A787}"/>
               </a:ext>
             </a:extLst>
           </p:cNvPr>
@@ -8126,7 +8126,7 @@
     </p:spTree>
     <p:extLst>
       <p:ext uri="{BB962C8B-B14F-4D97-AF65-F5344CB8AC3E}">
-        <p14:creationId xmlns:p14="http://schemas.microsoft.com/office/powerpoint/2010/main" val="1188991897"/>
+        <p14:creationId xmlns:p14="http://schemas.microsoft.com/office/powerpoint/2010/main" val="3508173636"/>
       </p:ext>
     </p:extLst>
   </p:cSld>
@@ -8166,7 +8166,7 @@
           <p:cNvPr id="2" name="CuadroTexto 1">
             <a:extLst>
               <a:ext uri="{FF2B5EF4-FFF2-40B4-BE49-F238E27FC236}">
-                <a16:creationId xmlns:a16="http://schemas.microsoft.com/office/drawing/2014/main" id="{D9F9E01F-987D-C557-46CE-5BFA55DE4926}"/>
+                <a16:creationId xmlns:a16="http://schemas.microsoft.com/office/drawing/2014/main" id="{3B53BFB5-E3E0-B286-B406-150DBBCC870F}"/>
               </a:ext>
             </a:extLst>
           </p:cNvPr>
@@ -8206,7 +8206,7 @@
           <p:cNvPr id="3" name="CuadroTexto 2">
             <a:extLst>
               <a:ext uri="{FF2B5EF4-FFF2-40B4-BE49-F238E27FC236}">
-                <a16:creationId xmlns:a16="http://schemas.microsoft.com/office/drawing/2014/main" id="{64760B98-9D19-6368-974F-2254126C9C13}"/>
+                <a16:creationId xmlns:a16="http://schemas.microsoft.com/office/drawing/2014/main" id="{4A18F661-8504-FF24-794C-DEB98DE8811E}"/>
               </a:ext>
             </a:extLst>
           </p:cNvPr>
@@ -8246,7 +8246,7 @@
           <p:cNvPr id="4" name="CuadroTexto 3">
             <a:extLst>
               <a:ext uri="{FF2B5EF4-FFF2-40B4-BE49-F238E27FC236}">
-                <a16:creationId xmlns:a16="http://schemas.microsoft.com/office/drawing/2014/main" id="{D7BB10BA-4D7A-E13E-B18F-EE7C55973A81}"/>
+                <a16:creationId xmlns:a16="http://schemas.microsoft.com/office/drawing/2014/main" id="{474815DA-F3A7-AB78-4388-EC3336FFFA42}"/>
               </a:ext>
             </a:extLst>
           </p:cNvPr>
@@ -8286,7 +8286,7 @@
           <p:cNvPr id="6" name="Imagen 5">
             <a:extLst>
               <a:ext uri="{FF2B5EF4-FFF2-40B4-BE49-F238E27FC236}">
-                <a16:creationId xmlns:a16="http://schemas.microsoft.com/office/drawing/2014/main" id="{6DCCBB1E-47E7-1DA6-E4D1-2AB1FAAC7016}"/>
+                <a16:creationId xmlns:a16="http://schemas.microsoft.com/office/drawing/2014/main" id="{17606F8B-DB37-5589-BE9B-56D891B9004E}"/>
               </a:ext>
             </a:extLst>
           </p:cNvPr>
@@ -8327,7 +8327,7 @@
           <p:cNvPr id="7" name="CuadroTexto 6">
             <a:extLst>
               <a:ext uri="{FF2B5EF4-FFF2-40B4-BE49-F238E27FC236}">
-                <a16:creationId xmlns:a16="http://schemas.microsoft.com/office/drawing/2014/main" id="{E7BA3F35-0CF1-365A-F279-30E9CDFF97DF}"/>
+                <a16:creationId xmlns:a16="http://schemas.microsoft.com/office/drawing/2014/main" id="{564781DF-542B-126E-AFFB-E71F3C2FEFF7}"/>
               </a:ext>
             </a:extLst>
           </p:cNvPr>
@@ -8444,7 +8444,7 @@
     </p:spTree>
     <p:extLst>
       <p:ext uri="{BB962C8B-B14F-4D97-AF65-F5344CB8AC3E}">
-        <p14:creationId xmlns:p14="http://schemas.microsoft.com/office/powerpoint/2010/main" val="1834935555"/>
+        <p14:creationId xmlns:p14="http://schemas.microsoft.com/office/powerpoint/2010/main" val="3250483006"/>
       </p:ext>
     </p:extLst>
   </p:cSld>
@@ -8484,7 +8484,7 @@
           <p:cNvPr id="2" name="CuadroTexto 1">
             <a:extLst>
               <a:ext uri="{FF2B5EF4-FFF2-40B4-BE49-F238E27FC236}">
-                <a16:creationId xmlns:a16="http://schemas.microsoft.com/office/drawing/2014/main" id="{4C0B66EA-084D-585F-B23B-A10967107D10}"/>
+                <a16:creationId xmlns:a16="http://schemas.microsoft.com/office/drawing/2014/main" id="{83A0BADC-A61B-8DCF-868B-4B0627F917C5}"/>
               </a:ext>
             </a:extLst>
           </p:cNvPr>
@@ -8524,7 +8524,7 @@
           <p:cNvPr id="3" name="CuadroTexto 2">
             <a:extLst>
               <a:ext uri="{FF2B5EF4-FFF2-40B4-BE49-F238E27FC236}">
-                <a16:creationId xmlns:a16="http://schemas.microsoft.com/office/drawing/2014/main" id="{20C858BA-3918-B1B7-5271-E5BEF67FCE8D}"/>
+                <a16:creationId xmlns:a16="http://schemas.microsoft.com/office/drawing/2014/main" id="{B77C57D6-4B7F-A8F4-C15A-BE6C5EEDE134}"/>
               </a:ext>
             </a:extLst>
           </p:cNvPr>
@@ -8564,7 +8564,7 @@
           <p:cNvPr id="5" name="Imagen 4">
             <a:extLst>
               <a:ext uri="{FF2B5EF4-FFF2-40B4-BE49-F238E27FC236}">
-                <a16:creationId xmlns:a16="http://schemas.microsoft.com/office/drawing/2014/main" id="{05A08FDD-5CD7-0E1E-05BF-116B1EA345E7}"/>
+                <a16:creationId xmlns:a16="http://schemas.microsoft.com/office/drawing/2014/main" id="{C278ECE0-4371-D756-05E7-2F4D5C7651A8}"/>
               </a:ext>
             </a:extLst>
           </p:cNvPr>
@@ -8605,7 +8605,7 @@
           <p:cNvPr id="6" name="CuadroTexto 5">
             <a:extLst>
               <a:ext uri="{FF2B5EF4-FFF2-40B4-BE49-F238E27FC236}">
-                <a16:creationId xmlns:a16="http://schemas.microsoft.com/office/drawing/2014/main" id="{8F3C56D3-0158-5879-CD7C-9DE53E89FBD8}"/>
+                <a16:creationId xmlns:a16="http://schemas.microsoft.com/office/drawing/2014/main" id="{03CD8241-1366-6491-F780-48534F0B21A4}"/>
               </a:ext>
             </a:extLst>
           </p:cNvPr>
@@ -8645,7 +8645,7 @@
           <p:cNvPr id="7" name="CuadroTexto 6">
             <a:extLst>
               <a:ext uri="{FF2B5EF4-FFF2-40B4-BE49-F238E27FC236}">
-                <a16:creationId xmlns:a16="http://schemas.microsoft.com/office/drawing/2014/main" id="{F5B700DD-EF8E-A18A-CC58-19279B8B9ADF}"/>
+                <a16:creationId xmlns:a16="http://schemas.microsoft.com/office/drawing/2014/main" id="{72A47E0A-4FF4-201D-6F6E-2CC8BB1FA1AE}"/>
               </a:ext>
             </a:extLst>
           </p:cNvPr>
@@ -8744,7 +8744,7 @@
     </p:spTree>
     <p:extLst>
       <p:ext uri="{BB962C8B-B14F-4D97-AF65-F5344CB8AC3E}">
-        <p14:creationId xmlns:p14="http://schemas.microsoft.com/office/powerpoint/2010/main" val="3172759158"/>
+        <p14:creationId xmlns:p14="http://schemas.microsoft.com/office/powerpoint/2010/main" val="3309798934"/>
       </p:ext>
     </p:extLst>
   </p:cSld>
@@ -8784,7 +8784,7 @@
           <p:cNvPr id="2" name="CuadroTexto 1">
             <a:extLst>
               <a:ext uri="{FF2B5EF4-FFF2-40B4-BE49-F238E27FC236}">
-                <a16:creationId xmlns:a16="http://schemas.microsoft.com/office/drawing/2014/main" id="{8095D627-0DED-D2F5-04A6-8B1A3C771A3E}"/>
+                <a16:creationId xmlns:a16="http://schemas.microsoft.com/office/drawing/2014/main" id="{DECB3CC9-B2AF-884D-2AB3-040BD637FF04}"/>
               </a:ext>
             </a:extLst>
           </p:cNvPr>
@@ -8824,7 +8824,7 @@
           <p:cNvPr id="3" name="CuadroTexto 2">
             <a:extLst>
               <a:ext uri="{FF2B5EF4-FFF2-40B4-BE49-F238E27FC236}">
-                <a16:creationId xmlns:a16="http://schemas.microsoft.com/office/drawing/2014/main" id="{BD5AACBD-EC6B-96A3-57FD-5B2984258722}"/>
+                <a16:creationId xmlns:a16="http://schemas.microsoft.com/office/drawing/2014/main" id="{E0ADE18F-5D82-9966-D525-D6A900E12156}"/>
               </a:ext>
             </a:extLst>
           </p:cNvPr>
@@ -8864,7 +8864,7 @@
           <p:cNvPr id="4" name="CuadroTexto 3">
             <a:extLst>
               <a:ext uri="{FF2B5EF4-FFF2-40B4-BE49-F238E27FC236}">
-                <a16:creationId xmlns:a16="http://schemas.microsoft.com/office/drawing/2014/main" id="{1851A165-9507-CF05-7AB0-0FAB3001E044}"/>
+                <a16:creationId xmlns:a16="http://schemas.microsoft.com/office/drawing/2014/main" id="{88AEFA1B-178F-870D-0317-45F8298E0A57}"/>
               </a:ext>
             </a:extLst>
           </p:cNvPr>
@@ -8904,7 +8904,7 @@
           <p:cNvPr id="6" name="Imagen 5">
             <a:extLst>
               <a:ext uri="{FF2B5EF4-FFF2-40B4-BE49-F238E27FC236}">
-                <a16:creationId xmlns:a16="http://schemas.microsoft.com/office/drawing/2014/main" id="{4AD6CE01-9208-4F88-E2BE-79C30F531AD6}"/>
+                <a16:creationId xmlns:a16="http://schemas.microsoft.com/office/drawing/2014/main" id="{5A73259E-6524-4B88-6FB4-673FDE73CBE3}"/>
               </a:ext>
             </a:extLst>
           </p:cNvPr>
@@ -8945,7 +8945,7 @@
           <p:cNvPr id="7" name="Rectángulo: esquinas redondeadas 6">
             <a:extLst>
               <a:ext uri="{FF2B5EF4-FFF2-40B4-BE49-F238E27FC236}">
-                <a16:creationId xmlns:a16="http://schemas.microsoft.com/office/drawing/2014/main" id="{558A14B5-28F9-D445-33A9-5222D6E09D28}"/>
+                <a16:creationId xmlns:a16="http://schemas.microsoft.com/office/drawing/2014/main" id="{5EC5033A-540D-3307-6171-549F21CA20A1}"/>
               </a:ext>
             </a:extLst>
           </p:cNvPr>
@@ -8999,7 +8999,7 @@
           <p:cNvPr id="8" name="CuadroTexto 7">
             <a:extLst>
               <a:ext uri="{FF2B5EF4-FFF2-40B4-BE49-F238E27FC236}">
-                <a16:creationId xmlns:a16="http://schemas.microsoft.com/office/drawing/2014/main" id="{DEC97CD0-A452-8DB1-FD4C-DE5C118181A9}"/>
+                <a16:creationId xmlns:a16="http://schemas.microsoft.com/office/drawing/2014/main" id="{21007BA7-9FFB-DCB4-1D97-C744AE45798E}"/>
               </a:ext>
             </a:extLst>
           </p:cNvPr>
@@ -9039,7 +9039,7 @@
           <p:cNvPr id="9" name="CuadroTexto 8">
             <a:extLst>
               <a:ext uri="{FF2B5EF4-FFF2-40B4-BE49-F238E27FC236}">
-                <a16:creationId xmlns:a16="http://schemas.microsoft.com/office/drawing/2014/main" id="{1E30FCFA-A334-B671-8BAC-2ACC755A66E5}"/>
+                <a16:creationId xmlns:a16="http://schemas.microsoft.com/office/drawing/2014/main" id="{A1DC66D2-1CB2-5133-3694-5E86CEAD394C}"/>
               </a:ext>
             </a:extLst>
           </p:cNvPr>
@@ -9079,7 +9079,7 @@
           <p:cNvPr id="10" name="Rectángulo: esquinas redondeadas 9">
             <a:extLst>
               <a:ext uri="{FF2B5EF4-FFF2-40B4-BE49-F238E27FC236}">
-                <a16:creationId xmlns:a16="http://schemas.microsoft.com/office/drawing/2014/main" id="{13B8CA52-724C-14CD-9D81-4874AEEF19CA}"/>
+                <a16:creationId xmlns:a16="http://schemas.microsoft.com/office/drawing/2014/main" id="{8FBF2FC0-F7F6-66F8-3FD5-89033FE35041}"/>
               </a:ext>
             </a:extLst>
           </p:cNvPr>
@@ -9133,7 +9133,7 @@
           <p:cNvPr id="11" name="CuadroTexto 10">
             <a:extLst>
               <a:ext uri="{FF2B5EF4-FFF2-40B4-BE49-F238E27FC236}">
-                <a16:creationId xmlns:a16="http://schemas.microsoft.com/office/drawing/2014/main" id="{BA96A11B-9419-E6FB-A43D-6D758208A627}"/>
+                <a16:creationId xmlns:a16="http://schemas.microsoft.com/office/drawing/2014/main" id="{FE4D34F5-1380-3F07-15C9-DC8E7A5A6E38}"/>
               </a:ext>
             </a:extLst>
           </p:cNvPr>
@@ -9173,7 +9173,7 @@
           <p:cNvPr id="12" name="CuadroTexto 11">
             <a:extLst>
               <a:ext uri="{FF2B5EF4-FFF2-40B4-BE49-F238E27FC236}">
-                <a16:creationId xmlns:a16="http://schemas.microsoft.com/office/drawing/2014/main" id="{1539EB69-7084-165D-C856-74EEBC0B351F}"/>
+                <a16:creationId xmlns:a16="http://schemas.microsoft.com/office/drawing/2014/main" id="{4A22DDC2-2FA9-86F2-D8A4-587D847AA58C}"/>
               </a:ext>
             </a:extLst>
           </p:cNvPr>
@@ -9213,7 +9213,7 @@
           <p:cNvPr id="13" name="Rectángulo: esquinas redondeadas 12">
             <a:extLst>
               <a:ext uri="{FF2B5EF4-FFF2-40B4-BE49-F238E27FC236}">
-                <a16:creationId xmlns:a16="http://schemas.microsoft.com/office/drawing/2014/main" id="{EB327542-0B26-7772-C0F4-ABA8079202AB}"/>
+                <a16:creationId xmlns:a16="http://schemas.microsoft.com/office/drawing/2014/main" id="{0230A069-2E64-05BB-7CD7-CC6D167E8205}"/>
               </a:ext>
             </a:extLst>
           </p:cNvPr>
@@ -9267,7 +9267,7 @@
           <p:cNvPr id="14" name="CuadroTexto 13">
             <a:extLst>
               <a:ext uri="{FF2B5EF4-FFF2-40B4-BE49-F238E27FC236}">
-                <a16:creationId xmlns:a16="http://schemas.microsoft.com/office/drawing/2014/main" id="{C760CE69-8E84-AA02-E372-1FA31F2D6E0A}"/>
+                <a16:creationId xmlns:a16="http://schemas.microsoft.com/office/drawing/2014/main" id="{B723A12F-CBDE-299B-6334-523292289C3B}"/>
               </a:ext>
             </a:extLst>
           </p:cNvPr>
@@ -9307,7 +9307,7 @@
           <p:cNvPr id="15" name="CuadroTexto 14">
             <a:extLst>
               <a:ext uri="{FF2B5EF4-FFF2-40B4-BE49-F238E27FC236}">
-                <a16:creationId xmlns:a16="http://schemas.microsoft.com/office/drawing/2014/main" id="{A41DA389-F831-0FB8-2195-73988D607916}"/>
+                <a16:creationId xmlns:a16="http://schemas.microsoft.com/office/drawing/2014/main" id="{60FF19A0-920B-49AB-F4C5-D29D6AE915CC}"/>
               </a:ext>
             </a:extLst>
           </p:cNvPr>
@@ -9345,7 +9345,7 @@
     </p:spTree>
     <p:extLst>
       <p:ext uri="{BB962C8B-B14F-4D97-AF65-F5344CB8AC3E}">
-        <p14:creationId xmlns:p14="http://schemas.microsoft.com/office/powerpoint/2010/main" val="552193992"/>
+        <p14:creationId xmlns:p14="http://schemas.microsoft.com/office/powerpoint/2010/main" val="2650554057"/>
       </p:ext>
     </p:extLst>
   </p:cSld>
@@ -9385,7 +9385,7 @@
           <p:cNvPr id="2" name="CuadroTexto 1">
             <a:extLst>
               <a:ext uri="{FF2B5EF4-FFF2-40B4-BE49-F238E27FC236}">
-                <a16:creationId xmlns:a16="http://schemas.microsoft.com/office/drawing/2014/main" id="{F6DC624F-570B-5514-29B2-4BD5452AA458}"/>
+                <a16:creationId xmlns:a16="http://schemas.microsoft.com/office/drawing/2014/main" id="{21222F39-FC80-9898-FA18-297D95C93417}"/>
               </a:ext>
             </a:extLst>
           </p:cNvPr>
@@ -9425,7 +9425,7 @@
           <p:cNvPr id="3" name="CuadroTexto 2">
             <a:extLst>
               <a:ext uri="{FF2B5EF4-FFF2-40B4-BE49-F238E27FC236}">
-                <a16:creationId xmlns:a16="http://schemas.microsoft.com/office/drawing/2014/main" id="{DBADECAD-845D-687E-ED29-95892FB36FFB}"/>
+                <a16:creationId xmlns:a16="http://schemas.microsoft.com/office/drawing/2014/main" id="{74E41328-CB24-DC7F-9329-F8F14BFA94F9}"/>
               </a:ext>
             </a:extLst>
           </p:cNvPr>
@@ -9465,7 +9465,7 @@
           <p:cNvPr id="5" name="Imagen 4">
             <a:extLst>
               <a:ext uri="{FF2B5EF4-FFF2-40B4-BE49-F238E27FC236}">
-                <a16:creationId xmlns:a16="http://schemas.microsoft.com/office/drawing/2014/main" id="{2AAA1BD7-8721-C4EE-98D7-59F31438D324}"/>
+                <a16:creationId xmlns:a16="http://schemas.microsoft.com/office/drawing/2014/main" id="{859D7CB8-323C-EF68-B400-3B8A93AE32AF}"/>
               </a:ext>
             </a:extLst>
           </p:cNvPr>
@@ -9488,8 +9488,8 @@
         </p:blipFill>
         <p:spPr>
           <a:xfrm>
-            <a:off x="1255362" y="1778000"/>
-            <a:ext cx="5502977" cy="4089400"/>
+            <a:off x="609600" y="1911747"/>
+            <a:ext cx="6794500" cy="3821906"/>
           </a:xfrm>
           <a:prstGeom prst="rect">
             <a:avLst/>
@@ -9506,7 +9506,7 @@
           <p:cNvPr id="6" name="CuadroTexto 5">
             <a:extLst>
               <a:ext uri="{FF2B5EF4-FFF2-40B4-BE49-F238E27FC236}">
-                <a16:creationId xmlns:a16="http://schemas.microsoft.com/office/drawing/2014/main" id="{A891BB2D-8A49-6C6C-B4C7-746AF0A5C7DA}"/>
+                <a16:creationId xmlns:a16="http://schemas.microsoft.com/office/drawing/2014/main" id="{5265ACBE-4637-D99D-5B00-E4FBEDC15BF3}"/>
               </a:ext>
             </a:extLst>
           </p:cNvPr>
@@ -9605,7 +9605,7 @@
     </p:spTree>
     <p:extLst>
       <p:ext uri="{BB962C8B-B14F-4D97-AF65-F5344CB8AC3E}">
-        <p14:creationId xmlns:p14="http://schemas.microsoft.com/office/powerpoint/2010/main" val="1551878589"/>
+        <p14:creationId xmlns:p14="http://schemas.microsoft.com/office/powerpoint/2010/main" val="1221587346"/>
       </p:ext>
     </p:extLst>
   </p:cSld>
@@ -9645,7 +9645,7 @@
           <p:cNvPr id="2" name="CuadroTexto 1">
             <a:extLst>
               <a:ext uri="{FF2B5EF4-FFF2-40B4-BE49-F238E27FC236}">
-                <a16:creationId xmlns:a16="http://schemas.microsoft.com/office/drawing/2014/main" id="{6AE3F5B9-FC61-F650-E736-1FBDA21C5A35}"/>
+                <a16:creationId xmlns:a16="http://schemas.microsoft.com/office/drawing/2014/main" id="{7EB3A68E-3279-060F-AECA-5DE13003702F}"/>
               </a:ext>
             </a:extLst>
           </p:cNvPr>
@@ -9685,7 +9685,7 @@
           <p:cNvPr id="3" name="CuadroTexto 2">
             <a:extLst>
               <a:ext uri="{FF2B5EF4-FFF2-40B4-BE49-F238E27FC236}">
-                <a16:creationId xmlns:a16="http://schemas.microsoft.com/office/drawing/2014/main" id="{51F36350-96B8-A6ED-A1D9-11FC69774523}"/>
+                <a16:creationId xmlns:a16="http://schemas.microsoft.com/office/drawing/2014/main" id="{DF4D926D-60E2-B416-864D-E04AB57B7ECD}"/>
               </a:ext>
             </a:extLst>
           </p:cNvPr>
@@ -9725,7 +9725,7 @@
           <p:cNvPr id="4" name="CuadroTexto 3">
             <a:extLst>
               <a:ext uri="{FF2B5EF4-FFF2-40B4-BE49-F238E27FC236}">
-                <a16:creationId xmlns:a16="http://schemas.microsoft.com/office/drawing/2014/main" id="{AE8D12A9-7D05-7900-79F3-827C8D8003A0}"/>
+                <a16:creationId xmlns:a16="http://schemas.microsoft.com/office/drawing/2014/main" id="{FB19245F-FFC7-BDAB-495E-0D7D17C72884}"/>
               </a:ext>
             </a:extLst>
           </p:cNvPr>
@@ -9765,7 +9765,7 @@
           <p:cNvPr id="6" name="Imagen 5">
             <a:extLst>
               <a:ext uri="{FF2B5EF4-FFF2-40B4-BE49-F238E27FC236}">
-                <a16:creationId xmlns:a16="http://schemas.microsoft.com/office/drawing/2014/main" id="{41534564-ACE1-B230-C5E1-0B8142A7CC76}"/>
+                <a16:creationId xmlns:a16="http://schemas.microsoft.com/office/drawing/2014/main" id="{1C30C189-9923-156D-3024-F088E9BE2611}"/>
               </a:ext>
             </a:extLst>
           </p:cNvPr>
@@ -9806,7 +9806,7 @@
           <p:cNvPr id="7" name="Rectángulo: esquinas redondeadas 6">
             <a:extLst>
               <a:ext uri="{FF2B5EF4-FFF2-40B4-BE49-F238E27FC236}">
-                <a16:creationId xmlns:a16="http://schemas.microsoft.com/office/drawing/2014/main" id="{9C61D247-B210-5407-C651-B8B328DCE8F0}"/>
+                <a16:creationId xmlns:a16="http://schemas.microsoft.com/office/drawing/2014/main" id="{E4D502B2-61E4-2133-B17C-16808FCB3E1D}"/>
               </a:ext>
             </a:extLst>
           </p:cNvPr>
@@ -9860,7 +9860,7 @@
           <p:cNvPr id="8" name="CuadroTexto 7">
             <a:extLst>
               <a:ext uri="{FF2B5EF4-FFF2-40B4-BE49-F238E27FC236}">
-                <a16:creationId xmlns:a16="http://schemas.microsoft.com/office/drawing/2014/main" id="{134E52FC-4AC6-F979-6870-634DB73985E6}"/>
+                <a16:creationId xmlns:a16="http://schemas.microsoft.com/office/drawing/2014/main" id="{348A6364-E459-498F-8A31-14E893D14003}"/>
               </a:ext>
             </a:extLst>
           </p:cNvPr>
@@ -9900,7 +9900,7 @@
           <p:cNvPr id="9" name="CuadroTexto 8">
             <a:extLst>
               <a:ext uri="{FF2B5EF4-FFF2-40B4-BE49-F238E27FC236}">
-                <a16:creationId xmlns:a16="http://schemas.microsoft.com/office/drawing/2014/main" id="{91CC3839-3DF0-0DFC-8C91-0B35A64D180F}"/>
+                <a16:creationId xmlns:a16="http://schemas.microsoft.com/office/drawing/2014/main" id="{E488D5A9-4B9D-A8F7-1245-94C48B29EE86}"/>
               </a:ext>
             </a:extLst>
           </p:cNvPr>
@@ -9938,7 +9938,7 @@
     </p:spTree>
     <p:extLst>
       <p:ext uri="{BB962C8B-B14F-4D97-AF65-F5344CB8AC3E}">
-        <p14:creationId xmlns:p14="http://schemas.microsoft.com/office/powerpoint/2010/main" val="2332594847"/>
+        <p14:creationId xmlns:p14="http://schemas.microsoft.com/office/powerpoint/2010/main" val="2867785587"/>
       </p:ext>
     </p:extLst>
   </p:cSld>
@@ -9978,7 +9978,7 @@
           <p:cNvPr id="2" name="CuadroTexto 1">
             <a:extLst>
               <a:ext uri="{FF2B5EF4-FFF2-40B4-BE49-F238E27FC236}">
-                <a16:creationId xmlns:a16="http://schemas.microsoft.com/office/drawing/2014/main" id="{4C9D0D19-0594-F6DD-C876-3630DC5FAED4}"/>
+                <a16:creationId xmlns:a16="http://schemas.microsoft.com/office/drawing/2014/main" id="{56D933A8-E66E-3E19-EEC8-5E6C2E671291}"/>
               </a:ext>
             </a:extLst>
           </p:cNvPr>
@@ -10018,7 +10018,7 @@
           <p:cNvPr id="3" name="CuadroTexto 2">
             <a:extLst>
               <a:ext uri="{FF2B5EF4-FFF2-40B4-BE49-F238E27FC236}">
-                <a16:creationId xmlns:a16="http://schemas.microsoft.com/office/drawing/2014/main" id="{DFF1DA6C-954E-DA96-051F-584C7A182051}"/>
+                <a16:creationId xmlns:a16="http://schemas.microsoft.com/office/drawing/2014/main" id="{AEA54564-7BAC-9E71-A8E6-75283E4B6DDF}"/>
               </a:ext>
             </a:extLst>
           </p:cNvPr>
@@ -10058,7 +10058,7 @@
           <p:cNvPr id="5" name="Imagen 4">
             <a:extLst>
               <a:ext uri="{FF2B5EF4-FFF2-40B4-BE49-F238E27FC236}">
-                <a16:creationId xmlns:a16="http://schemas.microsoft.com/office/drawing/2014/main" id="{CBFD4C94-ABB9-2AFF-A68C-57CE7FD58330}"/>
+                <a16:creationId xmlns:a16="http://schemas.microsoft.com/office/drawing/2014/main" id="{1AE85FD6-E094-AD69-5AE3-DF369205340A}"/>
               </a:ext>
             </a:extLst>
           </p:cNvPr>
@@ -10081,8 +10081,8 @@
         </p:blipFill>
         <p:spPr>
           <a:xfrm>
-            <a:off x="1637431" y="1841500"/>
-            <a:ext cx="2897338" cy="3810000"/>
+            <a:off x="609600" y="2353468"/>
+            <a:ext cx="4953000" cy="2786063"/>
           </a:xfrm>
           <a:prstGeom prst="rect">
             <a:avLst/>
@@ -10099,7 +10099,7 @@
           <p:cNvPr id="7" name="Imagen 6">
             <a:extLst>
               <a:ext uri="{FF2B5EF4-FFF2-40B4-BE49-F238E27FC236}">
-                <a16:creationId xmlns:a16="http://schemas.microsoft.com/office/drawing/2014/main" id="{EBAE5865-7838-FE08-B7A2-A33BB175A773}"/>
+                <a16:creationId xmlns:a16="http://schemas.microsoft.com/office/drawing/2014/main" id="{8CDA435B-5E63-87ED-264F-D4E406CB827B}"/>
               </a:ext>
             </a:extLst>
           </p:cNvPr>
@@ -10140,7 +10140,7 @@
           <p:cNvPr id="8" name="CuadroTexto 7">
             <a:extLst>
               <a:ext uri="{FF2B5EF4-FFF2-40B4-BE49-F238E27FC236}">
-                <a16:creationId xmlns:a16="http://schemas.microsoft.com/office/drawing/2014/main" id="{1540CCD0-9E66-E4BA-1492-28B6D68935A7}"/>
+                <a16:creationId xmlns:a16="http://schemas.microsoft.com/office/drawing/2014/main" id="{B9C0675F-533F-3706-087F-011B14C783C6}"/>
               </a:ext>
             </a:extLst>
           </p:cNvPr>
@@ -10180,7 +10180,7 @@
           <p:cNvPr id="9" name="CuadroTexto 8">
             <a:extLst>
               <a:ext uri="{FF2B5EF4-FFF2-40B4-BE49-F238E27FC236}">
-                <a16:creationId xmlns:a16="http://schemas.microsoft.com/office/drawing/2014/main" id="{2CE82424-98C6-89F0-7F68-F5D73E31D933}"/>
+                <a16:creationId xmlns:a16="http://schemas.microsoft.com/office/drawing/2014/main" id="{C37EE253-038B-C62D-1B13-B8E0DE08994E}"/>
               </a:ext>
             </a:extLst>
           </p:cNvPr>
@@ -10218,7 +10218,7 @@
     </p:spTree>
     <p:extLst>
       <p:ext uri="{BB962C8B-B14F-4D97-AF65-F5344CB8AC3E}">
-        <p14:creationId xmlns:p14="http://schemas.microsoft.com/office/powerpoint/2010/main" val="621463475"/>
+        <p14:creationId xmlns:p14="http://schemas.microsoft.com/office/powerpoint/2010/main" val="456950129"/>
       </p:ext>
     </p:extLst>
   </p:cSld>

</xml_diff>

<commit_message>
Retire web monitor in favor of desktop ops
</commit_message>
<xml_diff>
--- a/docs/presentacion-defensa-final.pptx
+++ b/docs/presentacion-defensa-final.pptx
@@ -146,7 +146,7 @@
           <p:cNvPr id="2" name="Título 1">
             <a:extLst>
               <a:ext uri="{FF2B5EF4-FFF2-40B4-BE49-F238E27FC236}">
-                <a16:creationId xmlns:a16="http://schemas.microsoft.com/office/drawing/2014/main" id="{A8E5A7B3-DB98-1D89-F899-AEC08AFD8477}"/>
+                <a16:creationId xmlns:a16="http://schemas.microsoft.com/office/drawing/2014/main" id="{DEC54974-BA2D-DEDD-C4EA-D896F5C0B032}"/>
               </a:ext>
             </a:extLst>
           </p:cNvPr>
@@ -183,7 +183,7 @@
           <p:cNvPr id="3" name="Subtítulo 2">
             <a:extLst>
               <a:ext uri="{FF2B5EF4-FFF2-40B4-BE49-F238E27FC236}">
-                <a16:creationId xmlns:a16="http://schemas.microsoft.com/office/drawing/2014/main" id="{A3B5CC5E-E153-4CC1-0813-8C99F904C13C}"/>
+                <a16:creationId xmlns:a16="http://schemas.microsoft.com/office/drawing/2014/main" id="{8A47899D-3FD5-4A89-FA44-5DBCD877ADF0}"/>
               </a:ext>
             </a:extLst>
           </p:cNvPr>
@@ -253,7 +253,7 @@
           <p:cNvPr id="4" name="Marcador de fecha 3">
             <a:extLst>
               <a:ext uri="{FF2B5EF4-FFF2-40B4-BE49-F238E27FC236}">
-                <a16:creationId xmlns:a16="http://schemas.microsoft.com/office/drawing/2014/main" id="{008A4332-47F2-93D2-AB2C-A89BCEA66F02}"/>
+                <a16:creationId xmlns:a16="http://schemas.microsoft.com/office/drawing/2014/main" id="{7A60B31B-B9C0-C336-2A57-A6E6BBB4C264}"/>
               </a:ext>
             </a:extLst>
           </p:cNvPr>
@@ -269,9 +269,9 @@
           <a:bodyPr/>
           <a:lstStyle/>
           <a:p>
-            <a:fld id="{1DDB0E9B-2144-47A1-BEC6-FBFA1BF47B9A}" type="datetimeFigureOut">
+            <a:fld id="{AB9C1A0A-BF9E-48A0-991D-0EB02B84C89C}" type="datetimeFigureOut">
               <a:rPr lang="es-ES" smtClean="0"/>
-              <a:t>18/05/2026</a:t>
+              <a:t>19/05/2026</a:t>
             </a:fld>
             <a:endParaRPr lang="es-ES"/>
           </a:p>
@@ -282,7 +282,7 @@
           <p:cNvPr id="5" name="Marcador de pie de página 4">
             <a:extLst>
               <a:ext uri="{FF2B5EF4-FFF2-40B4-BE49-F238E27FC236}">
-                <a16:creationId xmlns:a16="http://schemas.microsoft.com/office/drawing/2014/main" id="{12D96030-1D67-E65E-DB5F-CBD17F2EC1A2}"/>
+                <a16:creationId xmlns:a16="http://schemas.microsoft.com/office/drawing/2014/main" id="{C9CF83EF-85BC-63EA-D2FA-C6A3E8F94D70}"/>
               </a:ext>
             </a:extLst>
           </p:cNvPr>
@@ -307,7 +307,7 @@
           <p:cNvPr id="6" name="Marcador de número de diapositiva 5">
             <a:extLst>
               <a:ext uri="{FF2B5EF4-FFF2-40B4-BE49-F238E27FC236}">
-                <a16:creationId xmlns:a16="http://schemas.microsoft.com/office/drawing/2014/main" id="{30DA5BFA-B198-26BC-2677-BF1D00FE1712}"/>
+                <a16:creationId xmlns:a16="http://schemas.microsoft.com/office/drawing/2014/main" id="{D7DCD0F0-F06F-9ADD-8E63-6562F65952C3}"/>
               </a:ext>
             </a:extLst>
           </p:cNvPr>
@@ -323,7 +323,7 @@
           <a:bodyPr/>
           <a:lstStyle/>
           <a:p>
-            <a:fld id="{C3804229-7FF9-4687-89EB-F65AD4937D3E}" type="slidenum">
+            <a:fld id="{B3465923-C01A-429D-BF48-FE1C1E8CA486}" type="slidenum">
               <a:rPr lang="es-ES" smtClean="0"/>
               <a:t>‹Nº›</a:t>
             </a:fld>
@@ -334,7 +334,7 @@
     </p:spTree>
     <p:extLst>
       <p:ext uri="{BB962C8B-B14F-4D97-AF65-F5344CB8AC3E}">
-        <p14:creationId xmlns:p14="http://schemas.microsoft.com/office/powerpoint/2010/main" val="1083882594"/>
+        <p14:creationId xmlns:p14="http://schemas.microsoft.com/office/powerpoint/2010/main" val="962639868"/>
       </p:ext>
     </p:extLst>
   </p:cSld>
@@ -366,7 +366,7 @@
           <p:cNvPr id="2" name="Título 1">
             <a:extLst>
               <a:ext uri="{FF2B5EF4-FFF2-40B4-BE49-F238E27FC236}">
-                <a16:creationId xmlns:a16="http://schemas.microsoft.com/office/drawing/2014/main" id="{82E8C88B-F2F7-DCC3-43AD-182093FB763F}"/>
+                <a16:creationId xmlns:a16="http://schemas.microsoft.com/office/drawing/2014/main" id="{AFE84534-547B-71A0-B679-9C0F624EB5AA}"/>
               </a:ext>
             </a:extLst>
           </p:cNvPr>
@@ -394,7 +394,7 @@
           <p:cNvPr id="3" name="Marcador de texto vertical 2">
             <a:extLst>
               <a:ext uri="{FF2B5EF4-FFF2-40B4-BE49-F238E27FC236}">
-                <a16:creationId xmlns:a16="http://schemas.microsoft.com/office/drawing/2014/main" id="{F6A99770-1608-2015-FCD2-10F0095BA86E}"/>
+                <a16:creationId xmlns:a16="http://schemas.microsoft.com/office/drawing/2014/main" id="{43EAF322-BC57-4BEE-65E7-C16B7C6AC12A}"/>
               </a:ext>
             </a:extLst>
           </p:cNvPr>
@@ -451,7 +451,7 @@
           <p:cNvPr id="4" name="Marcador de fecha 3">
             <a:extLst>
               <a:ext uri="{FF2B5EF4-FFF2-40B4-BE49-F238E27FC236}">
-                <a16:creationId xmlns:a16="http://schemas.microsoft.com/office/drawing/2014/main" id="{9FEBF4A6-FF26-2B06-F6DF-EC0ECEF6A622}"/>
+                <a16:creationId xmlns:a16="http://schemas.microsoft.com/office/drawing/2014/main" id="{66F5F553-D299-15A6-CA75-45D65513160F}"/>
               </a:ext>
             </a:extLst>
           </p:cNvPr>
@@ -467,9 +467,9 @@
           <a:bodyPr/>
           <a:lstStyle/>
           <a:p>
-            <a:fld id="{1DDB0E9B-2144-47A1-BEC6-FBFA1BF47B9A}" type="datetimeFigureOut">
+            <a:fld id="{AB9C1A0A-BF9E-48A0-991D-0EB02B84C89C}" type="datetimeFigureOut">
               <a:rPr lang="es-ES" smtClean="0"/>
-              <a:t>18/05/2026</a:t>
+              <a:t>19/05/2026</a:t>
             </a:fld>
             <a:endParaRPr lang="es-ES"/>
           </a:p>
@@ -480,7 +480,7 @@
           <p:cNvPr id="5" name="Marcador de pie de página 4">
             <a:extLst>
               <a:ext uri="{FF2B5EF4-FFF2-40B4-BE49-F238E27FC236}">
-                <a16:creationId xmlns:a16="http://schemas.microsoft.com/office/drawing/2014/main" id="{496AC5AF-FE7B-7662-BB85-20692911A91F}"/>
+                <a16:creationId xmlns:a16="http://schemas.microsoft.com/office/drawing/2014/main" id="{B75CDBA8-0711-42FF-A9DE-0C266E33842F}"/>
               </a:ext>
             </a:extLst>
           </p:cNvPr>
@@ -505,7 +505,7 @@
           <p:cNvPr id="6" name="Marcador de número de diapositiva 5">
             <a:extLst>
               <a:ext uri="{FF2B5EF4-FFF2-40B4-BE49-F238E27FC236}">
-                <a16:creationId xmlns:a16="http://schemas.microsoft.com/office/drawing/2014/main" id="{3E231EBB-0FBA-13B3-A8AE-F84AC191D54D}"/>
+                <a16:creationId xmlns:a16="http://schemas.microsoft.com/office/drawing/2014/main" id="{790520F7-6A37-AAFB-22CF-3F8D5458DFC6}"/>
               </a:ext>
             </a:extLst>
           </p:cNvPr>
@@ -521,7 +521,7 @@
           <a:bodyPr/>
           <a:lstStyle/>
           <a:p>
-            <a:fld id="{C3804229-7FF9-4687-89EB-F65AD4937D3E}" type="slidenum">
+            <a:fld id="{B3465923-C01A-429D-BF48-FE1C1E8CA486}" type="slidenum">
               <a:rPr lang="es-ES" smtClean="0"/>
               <a:t>‹Nº›</a:t>
             </a:fld>
@@ -532,7 +532,7 @@
     </p:spTree>
     <p:extLst>
       <p:ext uri="{BB962C8B-B14F-4D97-AF65-F5344CB8AC3E}">
-        <p14:creationId xmlns:p14="http://schemas.microsoft.com/office/powerpoint/2010/main" val="1963189776"/>
+        <p14:creationId xmlns:p14="http://schemas.microsoft.com/office/powerpoint/2010/main" val="4038845907"/>
       </p:ext>
     </p:extLst>
   </p:cSld>
@@ -564,7 +564,7 @@
           <p:cNvPr id="2" name="Título vertical 1">
             <a:extLst>
               <a:ext uri="{FF2B5EF4-FFF2-40B4-BE49-F238E27FC236}">
-                <a16:creationId xmlns:a16="http://schemas.microsoft.com/office/drawing/2014/main" id="{D6CCA69A-2F73-48F2-359C-114F96970F53}"/>
+                <a16:creationId xmlns:a16="http://schemas.microsoft.com/office/drawing/2014/main" id="{DE4D055C-5670-F16A-6CC3-B33FD87A646E}"/>
               </a:ext>
             </a:extLst>
           </p:cNvPr>
@@ -597,7 +597,7 @@
           <p:cNvPr id="3" name="Marcador de texto vertical 2">
             <a:extLst>
               <a:ext uri="{FF2B5EF4-FFF2-40B4-BE49-F238E27FC236}">
-                <a16:creationId xmlns:a16="http://schemas.microsoft.com/office/drawing/2014/main" id="{B8C87A4B-0718-0903-3B9D-D76B968B51EA}"/>
+                <a16:creationId xmlns:a16="http://schemas.microsoft.com/office/drawing/2014/main" id="{370278FE-F21E-EF15-4C2C-1A5678C55A93}"/>
               </a:ext>
             </a:extLst>
           </p:cNvPr>
@@ -659,7 +659,7 @@
           <p:cNvPr id="4" name="Marcador de fecha 3">
             <a:extLst>
               <a:ext uri="{FF2B5EF4-FFF2-40B4-BE49-F238E27FC236}">
-                <a16:creationId xmlns:a16="http://schemas.microsoft.com/office/drawing/2014/main" id="{FBD75856-D348-4226-A7DA-F4133464896F}"/>
+                <a16:creationId xmlns:a16="http://schemas.microsoft.com/office/drawing/2014/main" id="{1CAC1D2A-64B6-78B0-815C-FE8E11F2E04D}"/>
               </a:ext>
             </a:extLst>
           </p:cNvPr>
@@ -675,9 +675,9 @@
           <a:bodyPr/>
           <a:lstStyle/>
           <a:p>
-            <a:fld id="{1DDB0E9B-2144-47A1-BEC6-FBFA1BF47B9A}" type="datetimeFigureOut">
+            <a:fld id="{AB9C1A0A-BF9E-48A0-991D-0EB02B84C89C}" type="datetimeFigureOut">
               <a:rPr lang="es-ES" smtClean="0"/>
-              <a:t>18/05/2026</a:t>
+              <a:t>19/05/2026</a:t>
             </a:fld>
             <a:endParaRPr lang="es-ES"/>
           </a:p>
@@ -688,7 +688,7 @@
           <p:cNvPr id="5" name="Marcador de pie de página 4">
             <a:extLst>
               <a:ext uri="{FF2B5EF4-FFF2-40B4-BE49-F238E27FC236}">
-                <a16:creationId xmlns:a16="http://schemas.microsoft.com/office/drawing/2014/main" id="{0412906B-0B33-CB15-7EB5-7D302BC4864C}"/>
+                <a16:creationId xmlns:a16="http://schemas.microsoft.com/office/drawing/2014/main" id="{8D64ABB7-CEE7-B824-3FC7-57ACF3EDBEF1}"/>
               </a:ext>
             </a:extLst>
           </p:cNvPr>
@@ -713,7 +713,7 @@
           <p:cNvPr id="6" name="Marcador de número de diapositiva 5">
             <a:extLst>
               <a:ext uri="{FF2B5EF4-FFF2-40B4-BE49-F238E27FC236}">
-                <a16:creationId xmlns:a16="http://schemas.microsoft.com/office/drawing/2014/main" id="{9F564A54-F270-B7FE-A36E-ABC6E2628DFC}"/>
+                <a16:creationId xmlns:a16="http://schemas.microsoft.com/office/drawing/2014/main" id="{89A95BCA-06D3-E659-4D09-2D2373482A8E}"/>
               </a:ext>
             </a:extLst>
           </p:cNvPr>
@@ -729,7 +729,7 @@
           <a:bodyPr/>
           <a:lstStyle/>
           <a:p>
-            <a:fld id="{C3804229-7FF9-4687-89EB-F65AD4937D3E}" type="slidenum">
+            <a:fld id="{B3465923-C01A-429D-BF48-FE1C1E8CA486}" type="slidenum">
               <a:rPr lang="es-ES" smtClean="0"/>
               <a:t>‹Nº›</a:t>
             </a:fld>
@@ -740,7 +740,7 @@
     </p:spTree>
     <p:extLst>
       <p:ext uri="{BB962C8B-B14F-4D97-AF65-F5344CB8AC3E}">
-        <p14:creationId xmlns:p14="http://schemas.microsoft.com/office/powerpoint/2010/main" val="308810823"/>
+        <p14:creationId xmlns:p14="http://schemas.microsoft.com/office/powerpoint/2010/main" val="1352709287"/>
       </p:ext>
     </p:extLst>
   </p:cSld>
@@ -772,7 +772,7 @@
           <p:cNvPr id="2" name="Título 1">
             <a:extLst>
               <a:ext uri="{FF2B5EF4-FFF2-40B4-BE49-F238E27FC236}">
-                <a16:creationId xmlns:a16="http://schemas.microsoft.com/office/drawing/2014/main" id="{BA58301A-E34A-93A9-0EE8-5E6C6C335532}"/>
+                <a16:creationId xmlns:a16="http://schemas.microsoft.com/office/drawing/2014/main" id="{92B77EEA-82FC-9F37-0FD4-F2BDEFAAAC8D}"/>
               </a:ext>
             </a:extLst>
           </p:cNvPr>
@@ -800,7 +800,7 @@
           <p:cNvPr id="3" name="Marcador de contenido 2">
             <a:extLst>
               <a:ext uri="{FF2B5EF4-FFF2-40B4-BE49-F238E27FC236}">
-                <a16:creationId xmlns:a16="http://schemas.microsoft.com/office/drawing/2014/main" id="{1F8593C7-26A1-78E2-69F6-BD574A29BC21}"/>
+                <a16:creationId xmlns:a16="http://schemas.microsoft.com/office/drawing/2014/main" id="{B4C850AE-C979-AACE-243F-5CB284D2CC96}"/>
               </a:ext>
             </a:extLst>
           </p:cNvPr>
@@ -857,7 +857,7 @@
           <p:cNvPr id="4" name="Marcador de fecha 3">
             <a:extLst>
               <a:ext uri="{FF2B5EF4-FFF2-40B4-BE49-F238E27FC236}">
-                <a16:creationId xmlns:a16="http://schemas.microsoft.com/office/drawing/2014/main" id="{3609F172-327B-CBF2-F971-57E7C15590D7}"/>
+                <a16:creationId xmlns:a16="http://schemas.microsoft.com/office/drawing/2014/main" id="{0F4129A5-5E8A-92C4-9C72-FBED8CB35704}"/>
               </a:ext>
             </a:extLst>
           </p:cNvPr>
@@ -873,9 +873,9 @@
           <a:bodyPr/>
           <a:lstStyle/>
           <a:p>
-            <a:fld id="{1DDB0E9B-2144-47A1-BEC6-FBFA1BF47B9A}" type="datetimeFigureOut">
+            <a:fld id="{AB9C1A0A-BF9E-48A0-991D-0EB02B84C89C}" type="datetimeFigureOut">
               <a:rPr lang="es-ES" smtClean="0"/>
-              <a:t>18/05/2026</a:t>
+              <a:t>19/05/2026</a:t>
             </a:fld>
             <a:endParaRPr lang="es-ES"/>
           </a:p>
@@ -886,7 +886,7 @@
           <p:cNvPr id="5" name="Marcador de pie de página 4">
             <a:extLst>
               <a:ext uri="{FF2B5EF4-FFF2-40B4-BE49-F238E27FC236}">
-                <a16:creationId xmlns:a16="http://schemas.microsoft.com/office/drawing/2014/main" id="{319C2CBD-DEAA-5EA7-C39D-4B230AB17DD1}"/>
+                <a16:creationId xmlns:a16="http://schemas.microsoft.com/office/drawing/2014/main" id="{B37C3BFC-1B17-7AD1-80C7-9515311EBF1F}"/>
               </a:ext>
             </a:extLst>
           </p:cNvPr>
@@ -911,7 +911,7 @@
           <p:cNvPr id="6" name="Marcador de número de diapositiva 5">
             <a:extLst>
               <a:ext uri="{FF2B5EF4-FFF2-40B4-BE49-F238E27FC236}">
-                <a16:creationId xmlns:a16="http://schemas.microsoft.com/office/drawing/2014/main" id="{5F4C82BB-CCC2-3BF9-5E6D-91C9698EE400}"/>
+                <a16:creationId xmlns:a16="http://schemas.microsoft.com/office/drawing/2014/main" id="{7A5567DB-4CDF-7698-7AA0-C554F337E4CE}"/>
               </a:ext>
             </a:extLst>
           </p:cNvPr>
@@ -927,7 +927,7 @@
           <a:bodyPr/>
           <a:lstStyle/>
           <a:p>
-            <a:fld id="{C3804229-7FF9-4687-89EB-F65AD4937D3E}" type="slidenum">
+            <a:fld id="{B3465923-C01A-429D-BF48-FE1C1E8CA486}" type="slidenum">
               <a:rPr lang="es-ES" smtClean="0"/>
               <a:t>‹Nº›</a:t>
             </a:fld>
@@ -938,7 +938,7 @@
     </p:spTree>
     <p:extLst>
       <p:ext uri="{BB962C8B-B14F-4D97-AF65-F5344CB8AC3E}">
-        <p14:creationId xmlns:p14="http://schemas.microsoft.com/office/powerpoint/2010/main" val="271624322"/>
+        <p14:creationId xmlns:p14="http://schemas.microsoft.com/office/powerpoint/2010/main" val="741971230"/>
       </p:ext>
     </p:extLst>
   </p:cSld>
@@ -970,7 +970,7 @@
           <p:cNvPr id="2" name="Título 1">
             <a:extLst>
               <a:ext uri="{FF2B5EF4-FFF2-40B4-BE49-F238E27FC236}">
-                <a16:creationId xmlns:a16="http://schemas.microsoft.com/office/drawing/2014/main" id="{B0843CB4-4338-B537-F980-EA3217DF0E27}"/>
+                <a16:creationId xmlns:a16="http://schemas.microsoft.com/office/drawing/2014/main" id="{7BC3F6F4-D80B-C1BB-227F-C03E5E048E6E}"/>
               </a:ext>
             </a:extLst>
           </p:cNvPr>
@@ -1007,7 +1007,7 @@
           <p:cNvPr id="3" name="Marcador de texto 2">
             <a:extLst>
               <a:ext uri="{FF2B5EF4-FFF2-40B4-BE49-F238E27FC236}">
-                <a16:creationId xmlns:a16="http://schemas.microsoft.com/office/drawing/2014/main" id="{C610A105-7FAF-036D-185F-D6E29BB9582A}"/>
+                <a16:creationId xmlns:a16="http://schemas.microsoft.com/office/drawing/2014/main" id="{87B172BB-7E5F-A4E2-217D-2B059083E554}"/>
               </a:ext>
             </a:extLst>
           </p:cNvPr>
@@ -1132,7 +1132,7 @@
           <p:cNvPr id="4" name="Marcador de fecha 3">
             <a:extLst>
               <a:ext uri="{FF2B5EF4-FFF2-40B4-BE49-F238E27FC236}">
-                <a16:creationId xmlns:a16="http://schemas.microsoft.com/office/drawing/2014/main" id="{0FB8FFD8-6642-3AAA-05D7-101DE947EADB}"/>
+                <a16:creationId xmlns:a16="http://schemas.microsoft.com/office/drawing/2014/main" id="{E907FA87-7F86-8183-E1EF-2A9AF0EA92CA}"/>
               </a:ext>
             </a:extLst>
           </p:cNvPr>
@@ -1148,9 +1148,9 @@
           <a:bodyPr/>
           <a:lstStyle/>
           <a:p>
-            <a:fld id="{1DDB0E9B-2144-47A1-BEC6-FBFA1BF47B9A}" type="datetimeFigureOut">
+            <a:fld id="{AB9C1A0A-BF9E-48A0-991D-0EB02B84C89C}" type="datetimeFigureOut">
               <a:rPr lang="es-ES" smtClean="0"/>
-              <a:t>18/05/2026</a:t>
+              <a:t>19/05/2026</a:t>
             </a:fld>
             <a:endParaRPr lang="es-ES"/>
           </a:p>
@@ -1161,7 +1161,7 @@
           <p:cNvPr id="5" name="Marcador de pie de página 4">
             <a:extLst>
               <a:ext uri="{FF2B5EF4-FFF2-40B4-BE49-F238E27FC236}">
-                <a16:creationId xmlns:a16="http://schemas.microsoft.com/office/drawing/2014/main" id="{F7383495-DBAC-C793-E0B1-2CA391BBB2DE}"/>
+                <a16:creationId xmlns:a16="http://schemas.microsoft.com/office/drawing/2014/main" id="{071A7589-02BA-C1C3-69B5-29607B14D7B6}"/>
               </a:ext>
             </a:extLst>
           </p:cNvPr>
@@ -1186,7 +1186,7 @@
           <p:cNvPr id="6" name="Marcador de número de diapositiva 5">
             <a:extLst>
               <a:ext uri="{FF2B5EF4-FFF2-40B4-BE49-F238E27FC236}">
-                <a16:creationId xmlns:a16="http://schemas.microsoft.com/office/drawing/2014/main" id="{50B46BD9-82AB-168B-18ED-3666A11F17D2}"/>
+                <a16:creationId xmlns:a16="http://schemas.microsoft.com/office/drawing/2014/main" id="{F522CDD7-3053-0DFD-CBA5-11D5E492DD83}"/>
               </a:ext>
             </a:extLst>
           </p:cNvPr>
@@ -1202,7 +1202,7 @@
           <a:bodyPr/>
           <a:lstStyle/>
           <a:p>
-            <a:fld id="{C3804229-7FF9-4687-89EB-F65AD4937D3E}" type="slidenum">
+            <a:fld id="{B3465923-C01A-429D-BF48-FE1C1E8CA486}" type="slidenum">
               <a:rPr lang="es-ES" smtClean="0"/>
               <a:t>‹Nº›</a:t>
             </a:fld>
@@ -1213,7 +1213,7 @@
     </p:spTree>
     <p:extLst>
       <p:ext uri="{BB962C8B-B14F-4D97-AF65-F5344CB8AC3E}">
-        <p14:creationId xmlns:p14="http://schemas.microsoft.com/office/powerpoint/2010/main" val="283459610"/>
+        <p14:creationId xmlns:p14="http://schemas.microsoft.com/office/powerpoint/2010/main" val="970898443"/>
       </p:ext>
     </p:extLst>
   </p:cSld>
@@ -1245,7 +1245,7 @@
           <p:cNvPr id="2" name="Título 1">
             <a:extLst>
               <a:ext uri="{FF2B5EF4-FFF2-40B4-BE49-F238E27FC236}">
-                <a16:creationId xmlns:a16="http://schemas.microsoft.com/office/drawing/2014/main" id="{A6B6829B-26C7-40A3-0CD7-3B4A4213545C}"/>
+                <a16:creationId xmlns:a16="http://schemas.microsoft.com/office/drawing/2014/main" id="{84E1C9FE-8E6C-6103-9CD2-6BFB8A35C03C}"/>
               </a:ext>
             </a:extLst>
           </p:cNvPr>
@@ -1273,7 +1273,7 @@
           <p:cNvPr id="3" name="Marcador de contenido 2">
             <a:extLst>
               <a:ext uri="{FF2B5EF4-FFF2-40B4-BE49-F238E27FC236}">
-                <a16:creationId xmlns:a16="http://schemas.microsoft.com/office/drawing/2014/main" id="{C14E2ED6-9A55-433D-7730-CD0C8AB7A179}"/>
+                <a16:creationId xmlns:a16="http://schemas.microsoft.com/office/drawing/2014/main" id="{40BE22F8-F11E-2617-8DDE-BC25BF2E1586}"/>
               </a:ext>
             </a:extLst>
           </p:cNvPr>
@@ -1335,7 +1335,7 @@
           <p:cNvPr id="4" name="Marcador de contenido 3">
             <a:extLst>
               <a:ext uri="{FF2B5EF4-FFF2-40B4-BE49-F238E27FC236}">
-                <a16:creationId xmlns:a16="http://schemas.microsoft.com/office/drawing/2014/main" id="{52351AF7-016A-52D6-1F8A-E87D7419ED37}"/>
+                <a16:creationId xmlns:a16="http://schemas.microsoft.com/office/drawing/2014/main" id="{059EDAFD-C4AA-A7DA-0144-0B0957FC354C}"/>
               </a:ext>
             </a:extLst>
           </p:cNvPr>
@@ -1397,7 +1397,7 @@
           <p:cNvPr id="5" name="Marcador de fecha 4">
             <a:extLst>
               <a:ext uri="{FF2B5EF4-FFF2-40B4-BE49-F238E27FC236}">
-                <a16:creationId xmlns:a16="http://schemas.microsoft.com/office/drawing/2014/main" id="{F1FDFD63-C6D8-D2A5-8CA3-38683E9E3FDB}"/>
+                <a16:creationId xmlns:a16="http://schemas.microsoft.com/office/drawing/2014/main" id="{1E15B96B-28C3-475D-E3D7-9F4B7C10726C}"/>
               </a:ext>
             </a:extLst>
           </p:cNvPr>
@@ -1413,9 +1413,9 @@
           <a:bodyPr/>
           <a:lstStyle/>
           <a:p>
-            <a:fld id="{1DDB0E9B-2144-47A1-BEC6-FBFA1BF47B9A}" type="datetimeFigureOut">
+            <a:fld id="{AB9C1A0A-BF9E-48A0-991D-0EB02B84C89C}" type="datetimeFigureOut">
               <a:rPr lang="es-ES" smtClean="0"/>
-              <a:t>18/05/2026</a:t>
+              <a:t>19/05/2026</a:t>
             </a:fld>
             <a:endParaRPr lang="es-ES"/>
           </a:p>
@@ -1426,7 +1426,7 @@
           <p:cNvPr id="6" name="Marcador de pie de página 5">
             <a:extLst>
               <a:ext uri="{FF2B5EF4-FFF2-40B4-BE49-F238E27FC236}">
-                <a16:creationId xmlns:a16="http://schemas.microsoft.com/office/drawing/2014/main" id="{846A1384-02F1-C06A-7E34-25130922EE4C}"/>
+                <a16:creationId xmlns:a16="http://schemas.microsoft.com/office/drawing/2014/main" id="{8F648C4D-4C4E-BF09-1C47-79A8CD5B17AA}"/>
               </a:ext>
             </a:extLst>
           </p:cNvPr>
@@ -1451,7 +1451,7 @@
           <p:cNvPr id="7" name="Marcador de número de diapositiva 6">
             <a:extLst>
               <a:ext uri="{FF2B5EF4-FFF2-40B4-BE49-F238E27FC236}">
-                <a16:creationId xmlns:a16="http://schemas.microsoft.com/office/drawing/2014/main" id="{D1C3B1EA-F757-9D55-1AC4-5FB6CBFDDBFE}"/>
+                <a16:creationId xmlns:a16="http://schemas.microsoft.com/office/drawing/2014/main" id="{E80DF2E6-58DE-5F43-20DB-5D39F5BBBABB}"/>
               </a:ext>
             </a:extLst>
           </p:cNvPr>
@@ -1467,7 +1467,7 @@
           <a:bodyPr/>
           <a:lstStyle/>
           <a:p>
-            <a:fld id="{C3804229-7FF9-4687-89EB-F65AD4937D3E}" type="slidenum">
+            <a:fld id="{B3465923-C01A-429D-BF48-FE1C1E8CA486}" type="slidenum">
               <a:rPr lang="es-ES" smtClean="0"/>
               <a:t>‹Nº›</a:t>
             </a:fld>
@@ -1478,7 +1478,7 @@
     </p:spTree>
     <p:extLst>
       <p:ext uri="{BB962C8B-B14F-4D97-AF65-F5344CB8AC3E}">
-        <p14:creationId xmlns:p14="http://schemas.microsoft.com/office/powerpoint/2010/main" val="2447465894"/>
+        <p14:creationId xmlns:p14="http://schemas.microsoft.com/office/powerpoint/2010/main" val="1473574331"/>
       </p:ext>
     </p:extLst>
   </p:cSld>
@@ -1510,7 +1510,7 @@
           <p:cNvPr id="2" name="Título 1">
             <a:extLst>
               <a:ext uri="{FF2B5EF4-FFF2-40B4-BE49-F238E27FC236}">
-                <a16:creationId xmlns:a16="http://schemas.microsoft.com/office/drawing/2014/main" id="{C56C8622-C583-E73F-E2FE-2AD78D859604}"/>
+                <a16:creationId xmlns:a16="http://schemas.microsoft.com/office/drawing/2014/main" id="{E92AB916-AE9D-26D9-28F7-EEAE8FF8B053}"/>
               </a:ext>
             </a:extLst>
           </p:cNvPr>
@@ -1543,7 +1543,7 @@
           <p:cNvPr id="3" name="Marcador de texto 2">
             <a:extLst>
               <a:ext uri="{FF2B5EF4-FFF2-40B4-BE49-F238E27FC236}">
-                <a16:creationId xmlns:a16="http://schemas.microsoft.com/office/drawing/2014/main" id="{6A49F940-56D2-8A35-A8C7-A62030CB846E}"/>
+                <a16:creationId xmlns:a16="http://schemas.microsoft.com/office/drawing/2014/main" id="{BC66CB01-328B-4D7B-2A2A-901DDF0FDAA3}"/>
               </a:ext>
             </a:extLst>
           </p:cNvPr>
@@ -1614,7 +1614,7 @@
           <p:cNvPr id="4" name="Marcador de contenido 3">
             <a:extLst>
               <a:ext uri="{FF2B5EF4-FFF2-40B4-BE49-F238E27FC236}">
-                <a16:creationId xmlns:a16="http://schemas.microsoft.com/office/drawing/2014/main" id="{C51D7EC0-74F4-2C5B-C59C-049BFFA275FB}"/>
+                <a16:creationId xmlns:a16="http://schemas.microsoft.com/office/drawing/2014/main" id="{CA1AD0B3-48E2-FC6C-9471-725BB47630A8}"/>
               </a:ext>
             </a:extLst>
           </p:cNvPr>
@@ -1676,7 +1676,7 @@
           <p:cNvPr id="5" name="Marcador de texto 4">
             <a:extLst>
               <a:ext uri="{FF2B5EF4-FFF2-40B4-BE49-F238E27FC236}">
-                <a16:creationId xmlns:a16="http://schemas.microsoft.com/office/drawing/2014/main" id="{D870369B-DBB9-CB84-BFC9-D652F39756EB}"/>
+                <a16:creationId xmlns:a16="http://schemas.microsoft.com/office/drawing/2014/main" id="{F28D16E9-BEDB-A73C-EBD5-0F9712E94690}"/>
               </a:ext>
             </a:extLst>
           </p:cNvPr>
@@ -1747,7 +1747,7 @@
           <p:cNvPr id="6" name="Marcador de contenido 5">
             <a:extLst>
               <a:ext uri="{FF2B5EF4-FFF2-40B4-BE49-F238E27FC236}">
-                <a16:creationId xmlns:a16="http://schemas.microsoft.com/office/drawing/2014/main" id="{BE78608E-F504-CC1C-8217-8AECAB08255E}"/>
+                <a16:creationId xmlns:a16="http://schemas.microsoft.com/office/drawing/2014/main" id="{907545AB-BEF7-3457-90A3-BE2C72551632}"/>
               </a:ext>
             </a:extLst>
           </p:cNvPr>
@@ -1809,7 +1809,7 @@
           <p:cNvPr id="7" name="Marcador de fecha 6">
             <a:extLst>
               <a:ext uri="{FF2B5EF4-FFF2-40B4-BE49-F238E27FC236}">
-                <a16:creationId xmlns:a16="http://schemas.microsoft.com/office/drawing/2014/main" id="{52B8B12D-2958-7A7E-6005-8AFBAA0B9FD8}"/>
+                <a16:creationId xmlns:a16="http://schemas.microsoft.com/office/drawing/2014/main" id="{65EED2F8-B104-278A-D121-8B6BA5C29BF3}"/>
               </a:ext>
             </a:extLst>
           </p:cNvPr>
@@ -1825,9 +1825,9 @@
           <a:bodyPr/>
           <a:lstStyle/>
           <a:p>
-            <a:fld id="{1DDB0E9B-2144-47A1-BEC6-FBFA1BF47B9A}" type="datetimeFigureOut">
+            <a:fld id="{AB9C1A0A-BF9E-48A0-991D-0EB02B84C89C}" type="datetimeFigureOut">
               <a:rPr lang="es-ES" smtClean="0"/>
-              <a:t>18/05/2026</a:t>
+              <a:t>19/05/2026</a:t>
             </a:fld>
             <a:endParaRPr lang="es-ES"/>
           </a:p>
@@ -1838,7 +1838,7 @@
           <p:cNvPr id="8" name="Marcador de pie de página 7">
             <a:extLst>
               <a:ext uri="{FF2B5EF4-FFF2-40B4-BE49-F238E27FC236}">
-                <a16:creationId xmlns:a16="http://schemas.microsoft.com/office/drawing/2014/main" id="{552F9287-2740-9215-CB24-94B600180010}"/>
+                <a16:creationId xmlns:a16="http://schemas.microsoft.com/office/drawing/2014/main" id="{88AF0901-8B10-FD68-79A6-2E732472EE66}"/>
               </a:ext>
             </a:extLst>
           </p:cNvPr>
@@ -1863,7 +1863,7 @@
           <p:cNvPr id="9" name="Marcador de número de diapositiva 8">
             <a:extLst>
               <a:ext uri="{FF2B5EF4-FFF2-40B4-BE49-F238E27FC236}">
-                <a16:creationId xmlns:a16="http://schemas.microsoft.com/office/drawing/2014/main" id="{2B923351-39C6-10F8-E0C0-1DEB71FB247F}"/>
+                <a16:creationId xmlns:a16="http://schemas.microsoft.com/office/drawing/2014/main" id="{DDFA98F8-B109-C8D4-B883-DF8CD2E5DE92}"/>
               </a:ext>
             </a:extLst>
           </p:cNvPr>
@@ -1879,7 +1879,7 @@
           <a:bodyPr/>
           <a:lstStyle/>
           <a:p>
-            <a:fld id="{C3804229-7FF9-4687-89EB-F65AD4937D3E}" type="slidenum">
+            <a:fld id="{B3465923-C01A-429D-BF48-FE1C1E8CA486}" type="slidenum">
               <a:rPr lang="es-ES" smtClean="0"/>
               <a:t>‹Nº›</a:t>
             </a:fld>
@@ -1890,7 +1890,7 @@
     </p:spTree>
     <p:extLst>
       <p:ext uri="{BB962C8B-B14F-4D97-AF65-F5344CB8AC3E}">
-        <p14:creationId xmlns:p14="http://schemas.microsoft.com/office/powerpoint/2010/main" val="358784349"/>
+        <p14:creationId xmlns:p14="http://schemas.microsoft.com/office/powerpoint/2010/main" val="3846948294"/>
       </p:ext>
     </p:extLst>
   </p:cSld>
@@ -1922,7 +1922,7 @@
           <p:cNvPr id="2" name="Título 1">
             <a:extLst>
               <a:ext uri="{FF2B5EF4-FFF2-40B4-BE49-F238E27FC236}">
-                <a16:creationId xmlns:a16="http://schemas.microsoft.com/office/drawing/2014/main" id="{BAC254E7-7200-2664-1595-101278E1214E}"/>
+                <a16:creationId xmlns:a16="http://schemas.microsoft.com/office/drawing/2014/main" id="{074145F3-8199-D652-0EA9-25539AAC56AA}"/>
               </a:ext>
             </a:extLst>
           </p:cNvPr>
@@ -1950,7 +1950,7 @@
           <p:cNvPr id="3" name="Marcador de fecha 2">
             <a:extLst>
               <a:ext uri="{FF2B5EF4-FFF2-40B4-BE49-F238E27FC236}">
-                <a16:creationId xmlns:a16="http://schemas.microsoft.com/office/drawing/2014/main" id="{9E82FA4E-DD4B-42C6-9BC3-0CD887AA87D7}"/>
+                <a16:creationId xmlns:a16="http://schemas.microsoft.com/office/drawing/2014/main" id="{4457EB84-2E78-A4B6-D3D2-C4FB4D1B5346}"/>
               </a:ext>
             </a:extLst>
           </p:cNvPr>
@@ -1966,9 +1966,9 @@
           <a:bodyPr/>
           <a:lstStyle/>
           <a:p>
-            <a:fld id="{1DDB0E9B-2144-47A1-BEC6-FBFA1BF47B9A}" type="datetimeFigureOut">
+            <a:fld id="{AB9C1A0A-BF9E-48A0-991D-0EB02B84C89C}" type="datetimeFigureOut">
               <a:rPr lang="es-ES" smtClean="0"/>
-              <a:t>18/05/2026</a:t>
+              <a:t>19/05/2026</a:t>
             </a:fld>
             <a:endParaRPr lang="es-ES"/>
           </a:p>
@@ -1979,7 +1979,7 @@
           <p:cNvPr id="4" name="Marcador de pie de página 3">
             <a:extLst>
               <a:ext uri="{FF2B5EF4-FFF2-40B4-BE49-F238E27FC236}">
-                <a16:creationId xmlns:a16="http://schemas.microsoft.com/office/drawing/2014/main" id="{A4B9C0D3-5CF6-CA85-139A-B689AB85CAEB}"/>
+                <a16:creationId xmlns:a16="http://schemas.microsoft.com/office/drawing/2014/main" id="{D97D25ED-0BC3-CF86-49E8-64B39358EBE8}"/>
               </a:ext>
             </a:extLst>
           </p:cNvPr>
@@ -2004,7 +2004,7 @@
           <p:cNvPr id="5" name="Marcador de número de diapositiva 4">
             <a:extLst>
               <a:ext uri="{FF2B5EF4-FFF2-40B4-BE49-F238E27FC236}">
-                <a16:creationId xmlns:a16="http://schemas.microsoft.com/office/drawing/2014/main" id="{2F1573AC-F3ED-7368-9D96-BA78EB9BF847}"/>
+                <a16:creationId xmlns:a16="http://schemas.microsoft.com/office/drawing/2014/main" id="{1B127638-D7CA-147F-C3F0-4BEC62CCD5DD}"/>
               </a:ext>
             </a:extLst>
           </p:cNvPr>
@@ -2020,7 +2020,7 @@
           <a:bodyPr/>
           <a:lstStyle/>
           <a:p>
-            <a:fld id="{C3804229-7FF9-4687-89EB-F65AD4937D3E}" type="slidenum">
+            <a:fld id="{B3465923-C01A-429D-BF48-FE1C1E8CA486}" type="slidenum">
               <a:rPr lang="es-ES" smtClean="0"/>
               <a:t>‹Nº›</a:t>
             </a:fld>
@@ -2031,7 +2031,7 @@
     </p:spTree>
     <p:extLst>
       <p:ext uri="{BB962C8B-B14F-4D97-AF65-F5344CB8AC3E}">
-        <p14:creationId xmlns:p14="http://schemas.microsoft.com/office/powerpoint/2010/main" val="494678653"/>
+        <p14:creationId xmlns:p14="http://schemas.microsoft.com/office/powerpoint/2010/main" val="266854122"/>
       </p:ext>
     </p:extLst>
   </p:cSld>
@@ -2063,7 +2063,7 @@
           <p:cNvPr id="2" name="Marcador de fecha 1">
             <a:extLst>
               <a:ext uri="{FF2B5EF4-FFF2-40B4-BE49-F238E27FC236}">
-                <a16:creationId xmlns:a16="http://schemas.microsoft.com/office/drawing/2014/main" id="{A02D1CE3-AB36-74BD-BABB-158101B7E7F4}"/>
+                <a16:creationId xmlns:a16="http://schemas.microsoft.com/office/drawing/2014/main" id="{277768E8-3F42-6276-86AF-68715D8E9A8D}"/>
               </a:ext>
             </a:extLst>
           </p:cNvPr>
@@ -2079,9 +2079,9 @@
           <a:bodyPr/>
           <a:lstStyle/>
           <a:p>
-            <a:fld id="{1DDB0E9B-2144-47A1-BEC6-FBFA1BF47B9A}" type="datetimeFigureOut">
+            <a:fld id="{AB9C1A0A-BF9E-48A0-991D-0EB02B84C89C}" type="datetimeFigureOut">
               <a:rPr lang="es-ES" smtClean="0"/>
-              <a:t>18/05/2026</a:t>
+              <a:t>19/05/2026</a:t>
             </a:fld>
             <a:endParaRPr lang="es-ES"/>
           </a:p>
@@ -2092,7 +2092,7 @@
           <p:cNvPr id="3" name="Marcador de pie de página 2">
             <a:extLst>
               <a:ext uri="{FF2B5EF4-FFF2-40B4-BE49-F238E27FC236}">
-                <a16:creationId xmlns:a16="http://schemas.microsoft.com/office/drawing/2014/main" id="{047C11AF-D7ED-9035-5AE1-94989847E401}"/>
+                <a16:creationId xmlns:a16="http://schemas.microsoft.com/office/drawing/2014/main" id="{AFC22073-20C1-8832-0253-F179A0226F60}"/>
               </a:ext>
             </a:extLst>
           </p:cNvPr>
@@ -2117,7 +2117,7 @@
           <p:cNvPr id="4" name="Marcador de número de diapositiva 3">
             <a:extLst>
               <a:ext uri="{FF2B5EF4-FFF2-40B4-BE49-F238E27FC236}">
-                <a16:creationId xmlns:a16="http://schemas.microsoft.com/office/drawing/2014/main" id="{F9E9E6E0-BE16-582E-A665-8F31D3A08638}"/>
+                <a16:creationId xmlns:a16="http://schemas.microsoft.com/office/drawing/2014/main" id="{A0702840-060A-E60B-D143-1F1FDA271F8A}"/>
               </a:ext>
             </a:extLst>
           </p:cNvPr>
@@ -2133,7 +2133,7 @@
           <a:bodyPr/>
           <a:lstStyle/>
           <a:p>
-            <a:fld id="{C3804229-7FF9-4687-89EB-F65AD4937D3E}" type="slidenum">
+            <a:fld id="{B3465923-C01A-429D-BF48-FE1C1E8CA486}" type="slidenum">
               <a:rPr lang="es-ES" smtClean="0"/>
               <a:t>‹Nº›</a:t>
             </a:fld>
@@ -2144,7 +2144,7 @@
     </p:spTree>
     <p:extLst>
       <p:ext uri="{BB962C8B-B14F-4D97-AF65-F5344CB8AC3E}">
-        <p14:creationId xmlns:p14="http://schemas.microsoft.com/office/powerpoint/2010/main" val="134897583"/>
+        <p14:creationId xmlns:p14="http://schemas.microsoft.com/office/powerpoint/2010/main" val="1294746670"/>
       </p:ext>
     </p:extLst>
   </p:cSld>
@@ -2176,7 +2176,7 @@
           <p:cNvPr id="2" name="Título 1">
             <a:extLst>
               <a:ext uri="{FF2B5EF4-FFF2-40B4-BE49-F238E27FC236}">
-                <a16:creationId xmlns:a16="http://schemas.microsoft.com/office/drawing/2014/main" id="{235F02F0-C58E-B645-72A4-7FD442F7AA5D}"/>
+                <a16:creationId xmlns:a16="http://schemas.microsoft.com/office/drawing/2014/main" id="{254CCFB2-E81E-F719-766D-D55382D7FD3A}"/>
               </a:ext>
             </a:extLst>
           </p:cNvPr>
@@ -2213,7 +2213,7 @@
           <p:cNvPr id="3" name="Marcador de contenido 2">
             <a:extLst>
               <a:ext uri="{FF2B5EF4-FFF2-40B4-BE49-F238E27FC236}">
-                <a16:creationId xmlns:a16="http://schemas.microsoft.com/office/drawing/2014/main" id="{CBBB3B10-C757-B517-81D5-BC74A178B37C}"/>
+                <a16:creationId xmlns:a16="http://schemas.microsoft.com/office/drawing/2014/main" id="{952FC578-50BC-9A1A-9F42-60BDC233E2A7}"/>
               </a:ext>
             </a:extLst>
           </p:cNvPr>
@@ -2303,7 +2303,7 @@
           <p:cNvPr id="4" name="Marcador de texto 3">
             <a:extLst>
               <a:ext uri="{FF2B5EF4-FFF2-40B4-BE49-F238E27FC236}">
-                <a16:creationId xmlns:a16="http://schemas.microsoft.com/office/drawing/2014/main" id="{2E4CB9BB-404A-10D7-8AEE-2DA003001C8C}"/>
+                <a16:creationId xmlns:a16="http://schemas.microsoft.com/office/drawing/2014/main" id="{FA6805FF-578A-B13E-9A1C-74EB8A8CBF86}"/>
               </a:ext>
             </a:extLst>
           </p:cNvPr>
@@ -2374,7 +2374,7 @@
           <p:cNvPr id="5" name="Marcador de fecha 4">
             <a:extLst>
               <a:ext uri="{FF2B5EF4-FFF2-40B4-BE49-F238E27FC236}">
-                <a16:creationId xmlns:a16="http://schemas.microsoft.com/office/drawing/2014/main" id="{A5F47C2E-AE3D-F82E-2540-B84293B74058}"/>
+                <a16:creationId xmlns:a16="http://schemas.microsoft.com/office/drawing/2014/main" id="{6038623A-9E5A-3228-0571-79279CCE6023}"/>
               </a:ext>
             </a:extLst>
           </p:cNvPr>
@@ -2390,9 +2390,9 @@
           <a:bodyPr/>
           <a:lstStyle/>
           <a:p>
-            <a:fld id="{1DDB0E9B-2144-47A1-BEC6-FBFA1BF47B9A}" type="datetimeFigureOut">
+            <a:fld id="{AB9C1A0A-BF9E-48A0-991D-0EB02B84C89C}" type="datetimeFigureOut">
               <a:rPr lang="es-ES" smtClean="0"/>
-              <a:t>18/05/2026</a:t>
+              <a:t>19/05/2026</a:t>
             </a:fld>
             <a:endParaRPr lang="es-ES"/>
           </a:p>
@@ -2403,7 +2403,7 @@
           <p:cNvPr id="6" name="Marcador de pie de página 5">
             <a:extLst>
               <a:ext uri="{FF2B5EF4-FFF2-40B4-BE49-F238E27FC236}">
-                <a16:creationId xmlns:a16="http://schemas.microsoft.com/office/drawing/2014/main" id="{CEE92FB6-0429-6B91-BBAF-7DABD52E3A7A}"/>
+                <a16:creationId xmlns:a16="http://schemas.microsoft.com/office/drawing/2014/main" id="{E1793859-5ABA-672E-9504-362653336615}"/>
               </a:ext>
             </a:extLst>
           </p:cNvPr>
@@ -2428,7 +2428,7 @@
           <p:cNvPr id="7" name="Marcador de número de diapositiva 6">
             <a:extLst>
               <a:ext uri="{FF2B5EF4-FFF2-40B4-BE49-F238E27FC236}">
-                <a16:creationId xmlns:a16="http://schemas.microsoft.com/office/drawing/2014/main" id="{D819B694-261B-30E6-A277-B6BDA51BBBBA}"/>
+                <a16:creationId xmlns:a16="http://schemas.microsoft.com/office/drawing/2014/main" id="{BC603FE4-4FC9-6622-C43B-7AD3545EAB0D}"/>
               </a:ext>
             </a:extLst>
           </p:cNvPr>
@@ -2444,7 +2444,7 @@
           <a:bodyPr/>
           <a:lstStyle/>
           <a:p>
-            <a:fld id="{C3804229-7FF9-4687-89EB-F65AD4937D3E}" type="slidenum">
+            <a:fld id="{B3465923-C01A-429D-BF48-FE1C1E8CA486}" type="slidenum">
               <a:rPr lang="es-ES" smtClean="0"/>
               <a:t>‹Nº›</a:t>
             </a:fld>
@@ -2455,7 +2455,7 @@
     </p:spTree>
     <p:extLst>
       <p:ext uri="{BB962C8B-B14F-4D97-AF65-F5344CB8AC3E}">
-        <p14:creationId xmlns:p14="http://schemas.microsoft.com/office/powerpoint/2010/main" val="2037122793"/>
+        <p14:creationId xmlns:p14="http://schemas.microsoft.com/office/powerpoint/2010/main" val="4121965106"/>
       </p:ext>
     </p:extLst>
   </p:cSld>
@@ -2487,7 +2487,7 @@
           <p:cNvPr id="2" name="Título 1">
             <a:extLst>
               <a:ext uri="{FF2B5EF4-FFF2-40B4-BE49-F238E27FC236}">
-                <a16:creationId xmlns:a16="http://schemas.microsoft.com/office/drawing/2014/main" id="{F435C9F3-F7AC-D4F7-4303-9BD416C222BD}"/>
+                <a16:creationId xmlns:a16="http://schemas.microsoft.com/office/drawing/2014/main" id="{D27F6048-BB77-75B2-E0F5-556AA73FBDDE}"/>
               </a:ext>
             </a:extLst>
           </p:cNvPr>
@@ -2524,7 +2524,7 @@
           <p:cNvPr id="3" name="Marcador de posición de imagen 2">
             <a:extLst>
               <a:ext uri="{FF2B5EF4-FFF2-40B4-BE49-F238E27FC236}">
-                <a16:creationId xmlns:a16="http://schemas.microsoft.com/office/drawing/2014/main" id="{DA9A112E-451F-50DC-028D-C6F58F570E00}"/>
+                <a16:creationId xmlns:a16="http://schemas.microsoft.com/office/drawing/2014/main" id="{3B4CB789-4CC6-7027-7FB7-32FEDDD1081C}"/>
               </a:ext>
             </a:extLst>
           </p:cNvPr>
@@ -2591,7 +2591,7 @@
           <p:cNvPr id="4" name="Marcador de texto 3">
             <a:extLst>
               <a:ext uri="{FF2B5EF4-FFF2-40B4-BE49-F238E27FC236}">
-                <a16:creationId xmlns:a16="http://schemas.microsoft.com/office/drawing/2014/main" id="{3598B36F-615A-BAC7-C33E-7A99411A85D8}"/>
+                <a16:creationId xmlns:a16="http://schemas.microsoft.com/office/drawing/2014/main" id="{41E7A35C-702C-1D8B-E13C-D710823ABC57}"/>
               </a:ext>
             </a:extLst>
           </p:cNvPr>
@@ -2662,7 +2662,7 @@
           <p:cNvPr id="5" name="Marcador de fecha 4">
             <a:extLst>
               <a:ext uri="{FF2B5EF4-FFF2-40B4-BE49-F238E27FC236}">
-                <a16:creationId xmlns:a16="http://schemas.microsoft.com/office/drawing/2014/main" id="{6723CA87-0035-81EC-0AB8-5A679616BE74}"/>
+                <a16:creationId xmlns:a16="http://schemas.microsoft.com/office/drawing/2014/main" id="{36632614-54E4-2380-00E4-802994933CF2}"/>
               </a:ext>
             </a:extLst>
           </p:cNvPr>
@@ -2678,9 +2678,9 @@
           <a:bodyPr/>
           <a:lstStyle/>
           <a:p>
-            <a:fld id="{1DDB0E9B-2144-47A1-BEC6-FBFA1BF47B9A}" type="datetimeFigureOut">
+            <a:fld id="{AB9C1A0A-BF9E-48A0-991D-0EB02B84C89C}" type="datetimeFigureOut">
               <a:rPr lang="es-ES" smtClean="0"/>
-              <a:t>18/05/2026</a:t>
+              <a:t>19/05/2026</a:t>
             </a:fld>
             <a:endParaRPr lang="es-ES"/>
           </a:p>
@@ -2691,7 +2691,7 @@
           <p:cNvPr id="6" name="Marcador de pie de página 5">
             <a:extLst>
               <a:ext uri="{FF2B5EF4-FFF2-40B4-BE49-F238E27FC236}">
-                <a16:creationId xmlns:a16="http://schemas.microsoft.com/office/drawing/2014/main" id="{C6AE9DA7-03F8-4DBB-3A16-971CF6E63306}"/>
+                <a16:creationId xmlns:a16="http://schemas.microsoft.com/office/drawing/2014/main" id="{E8EA630A-5FCE-62C7-BBCC-041308A8D028}"/>
               </a:ext>
             </a:extLst>
           </p:cNvPr>
@@ -2716,7 +2716,7 @@
           <p:cNvPr id="7" name="Marcador de número de diapositiva 6">
             <a:extLst>
               <a:ext uri="{FF2B5EF4-FFF2-40B4-BE49-F238E27FC236}">
-                <a16:creationId xmlns:a16="http://schemas.microsoft.com/office/drawing/2014/main" id="{BC24F64F-0D50-6B49-18CD-8815D633BE19}"/>
+                <a16:creationId xmlns:a16="http://schemas.microsoft.com/office/drawing/2014/main" id="{F7B00146-435A-13A2-94AE-52EA686AA928}"/>
               </a:ext>
             </a:extLst>
           </p:cNvPr>
@@ -2732,7 +2732,7 @@
           <a:bodyPr/>
           <a:lstStyle/>
           <a:p>
-            <a:fld id="{C3804229-7FF9-4687-89EB-F65AD4937D3E}" type="slidenum">
+            <a:fld id="{B3465923-C01A-429D-BF48-FE1C1E8CA486}" type="slidenum">
               <a:rPr lang="es-ES" smtClean="0"/>
               <a:t>‹Nº›</a:t>
             </a:fld>
@@ -2743,7 +2743,7 @@
     </p:spTree>
     <p:extLst>
       <p:ext uri="{BB962C8B-B14F-4D97-AF65-F5344CB8AC3E}">
-        <p14:creationId xmlns:p14="http://schemas.microsoft.com/office/powerpoint/2010/main" val="4068038534"/>
+        <p14:creationId xmlns:p14="http://schemas.microsoft.com/office/powerpoint/2010/main" val="948003218"/>
       </p:ext>
     </p:extLst>
   </p:cSld>
@@ -2780,7 +2780,7 @@
           <p:cNvPr id="2" name="Marcador de título 1">
             <a:extLst>
               <a:ext uri="{FF2B5EF4-FFF2-40B4-BE49-F238E27FC236}">
-                <a16:creationId xmlns:a16="http://schemas.microsoft.com/office/drawing/2014/main" id="{D6291D40-7C43-5C14-7CF7-845E35E72FA2}"/>
+                <a16:creationId xmlns:a16="http://schemas.microsoft.com/office/drawing/2014/main" id="{73E795E7-988F-6D5A-2223-AFB25A944D0D}"/>
               </a:ext>
             </a:extLst>
           </p:cNvPr>
@@ -2818,7 +2818,7 @@
           <p:cNvPr id="3" name="Marcador de texto 2">
             <a:extLst>
               <a:ext uri="{FF2B5EF4-FFF2-40B4-BE49-F238E27FC236}">
-                <a16:creationId xmlns:a16="http://schemas.microsoft.com/office/drawing/2014/main" id="{1984FB41-5CA9-FF2E-AE6F-0968E6F637E7}"/>
+                <a16:creationId xmlns:a16="http://schemas.microsoft.com/office/drawing/2014/main" id="{3176D17D-F500-CAF0-EB2E-9DD9DFBEFBE3}"/>
               </a:ext>
             </a:extLst>
           </p:cNvPr>
@@ -2885,7 +2885,7 @@
           <p:cNvPr id="4" name="Marcador de fecha 3">
             <a:extLst>
               <a:ext uri="{FF2B5EF4-FFF2-40B4-BE49-F238E27FC236}">
-                <a16:creationId xmlns:a16="http://schemas.microsoft.com/office/drawing/2014/main" id="{E9EB0A9A-7CC2-6295-0FF7-00B213ECEF1E}"/>
+                <a16:creationId xmlns:a16="http://schemas.microsoft.com/office/drawing/2014/main" id="{C8D3EAFA-06BC-8492-B4AD-7465FE9219D9}"/>
               </a:ext>
             </a:extLst>
           </p:cNvPr>
@@ -2919,9 +2919,9 @@
             </a:lvl1pPr>
           </a:lstStyle>
           <a:p>
-            <a:fld id="{1DDB0E9B-2144-47A1-BEC6-FBFA1BF47B9A}" type="datetimeFigureOut">
+            <a:fld id="{AB9C1A0A-BF9E-48A0-991D-0EB02B84C89C}" type="datetimeFigureOut">
               <a:rPr lang="es-ES" smtClean="0"/>
-              <a:t>18/05/2026</a:t>
+              <a:t>19/05/2026</a:t>
             </a:fld>
             <a:endParaRPr lang="es-ES"/>
           </a:p>
@@ -2932,7 +2932,7 @@
           <p:cNvPr id="5" name="Marcador de pie de página 4">
             <a:extLst>
               <a:ext uri="{FF2B5EF4-FFF2-40B4-BE49-F238E27FC236}">
-                <a16:creationId xmlns:a16="http://schemas.microsoft.com/office/drawing/2014/main" id="{60213811-A5C7-C833-63EF-E36585B95687}"/>
+                <a16:creationId xmlns:a16="http://schemas.microsoft.com/office/drawing/2014/main" id="{6A64E50F-701B-BD30-C2B7-F8BB0DFF3D0F}"/>
               </a:ext>
             </a:extLst>
           </p:cNvPr>
@@ -2975,7 +2975,7 @@
           <p:cNvPr id="6" name="Marcador de número de diapositiva 5">
             <a:extLst>
               <a:ext uri="{FF2B5EF4-FFF2-40B4-BE49-F238E27FC236}">
-                <a16:creationId xmlns:a16="http://schemas.microsoft.com/office/drawing/2014/main" id="{6D9F55CE-0126-CDF4-D7BC-0DB15CBA64BE}"/>
+                <a16:creationId xmlns:a16="http://schemas.microsoft.com/office/drawing/2014/main" id="{8911B98D-8394-836F-1E49-B6D987852199}"/>
               </a:ext>
             </a:extLst>
           </p:cNvPr>
@@ -3009,7 +3009,7 @@
             </a:lvl1pPr>
           </a:lstStyle>
           <a:p>
-            <a:fld id="{C3804229-7FF9-4687-89EB-F65AD4937D3E}" type="slidenum">
+            <a:fld id="{B3465923-C01A-429D-BF48-FE1C1E8CA486}" type="slidenum">
               <a:rPr lang="es-ES" smtClean="0"/>
               <a:t>‹Nº›</a:t>
             </a:fld>
@@ -3020,7 +3020,7 @@
     </p:spTree>
     <p:extLst>
       <p:ext uri="{BB962C8B-B14F-4D97-AF65-F5344CB8AC3E}">
-        <p14:creationId xmlns:p14="http://schemas.microsoft.com/office/powerpoint/2010/main" val="236746701"/>
+        <p14:creationId xmlns:p14="http://schemas.microsoft.com/office/powerpoint/2010/main" val="3424308497"/>
       </p:ext>
     </p:extLst>
   </p:cSld>
@@ -3351,7 +3351,7 @@
           <p:cNvPr id="2" name="Rectángulo: esquinas redondeadas 1">
             <a:extLst>
               <a:ext uri="{FF2B5EF4-FFF2-40B4-BE49-F238E27FC236}">
-                <a16:creationId xmlns:a16="http://schemas.microsoft.com/office/drawing/2014/main" id="{A9B68B07-0E42-3D3A-59AB-75D314A35906}"/>
+                <a16:creationId xmlns:a16="http://schemas.microsoft.com/office/drawing/2014/main" id="{8D26A0E0-FB4C-849C-CDCB-FE3596B00D95}"/>
               </a:ext>
             </a:extLst>
           </p:cNvPr>
@@ -3405,7 +3405,7 @@
           <p:cNvPr id="3" name="CuadroTexto 2">
             <a:extLst>
               <a:ext uri="{FF2B5EF4-FFF2-40B4-BE49-F238E27FC236}">
-                <a16:creationId xmlns:a16="http://schemas.microsoft.com/office/drawing/2014/main" id="{8DFB9613-F2EC-9F26-BEDE-17D320311A8E}"/>
+                <a16:creationId xmlns:a16="http://schemas.microsoft.com/office/drawing/2014/main" id="{0C0ABDE1-768B-4E8F-4DF2-1182CD15BFB9}"/>
               </a:ext>
             </a:extLst>
           </p:cNvPr>
@@ -3445,7 +3445,7 @@
           <p:cNvPr id="4" name="CuadroTexto 3">
             <a:extLst>
               <a:ext uri="{FF2B5EF4-FFF2-40B4-BE49-F238E27FC236}">
-                <a16:creationId xmlns:a16="http://schemas.microsoft.com/office/drawing/2014/main" id="{9A48F141-1814-39FD-E775-DA62716C05B7}"/>
+                <a16:creationId xmlns:a16="http://schemas.microsoft.com/office/drawing/2014/main" id="{E9513875-C1AF-3123-1236-18C82A862A02}"/>
               </a:ext>
             </a:extLst>
           </p:cNvPr>
@@ -3485,7 +3485,7 @@
           <p:cNvPr id="5" name="CuadroTexto 4">
             <a:extLst>
               <a:ext uri="{FF2B5EF4-FFF2-40B4-BE49-F238E27FC236}">
-                <a16:creationId xmlns:a16="http://schemas.microsoft.com/office/drawing/2014/main" id="{866FFC5C-8565-D9F3-2B11-D36DA6658618}"/>
+                <a16:creationId xmlns:a16="http://schemas.microsoft.com/office/drawing/2014/main" id="{78CE9AC4-3231-5E43-571C-63C921B839FE}"/>
               </a:ext>
             </a:extLst>
           </p:cNvPr>
@@ -3525,7 +3525,7 @@
           <p:cNvPr id="6" name="CuadroTexto 5">
             <a:extLst>
               <a:ext uri="{FF2B5EF4-FFF2-40B4-BE49-F238E27FC236}">
-                <a16:creationId xmlns:a16="http://schemas.microsoft.com/office/drawing/2014/main" id="{D5176ACD-9518-7C4D-EC15-6D9A1C40E7B5}"/>
+                <a16:creationId xmlns:a16="http://schemas.microsoft.com/office/drawing/2014/main" id="{C269820E-5F1A-E35A-BF32-5F29D2355FF6}"/>
               </a:ext>
             </a:extLst>
           </p:cNvPr>
@@ -3576,7 +3576,7 @@
           <p:cNvPr id="8" name="Imagen 7">
             <a:extLst>
               <a:ext uri="{FF2B5EF4-FFF2-40B4-BE49-F238E27FC236}">
-                <a16:creationId xmlns:a16="http://schemas.microsoft.com/office/drawing/2014/main" id="{884051A0-4E18-9663-2F6E-4AD9BB297378}"/>
+                <a16:creationId xmlns:a16="http://schemas.microsoft.com/office/drawing/2014/main" id="{FEBD596F-2F18-6433-8D13-E18EBF7F6B0C}"/>
               </a:ext>
             </a:extLst>
           </p:cNvPr>
@@ -3615,7 +3615,7 @@
     </p:spTree>
     <p:extLst>
       <p:ext uri="{BB962C8B-B14F-4D97-AF65-F5344CB8AC3E}">
-        <p14:creationId xmlns:p14="http://schemas.microsoft.com/office/powerpoint/2010/main" val="1997840301"/>
+        <p14:creationId xmlns:p14="http://schemas.microsoft.com/office/powerpoint/2010/main" val="2070698356"/>
       </p:ext>
     </p:extLst>
   </p:cSld>
@@ -3655,7 +3655,7 @@
           <p:cNvPr id="2" name="CuadroTexto 1">
             <a:extLst>
               <a:ext uri="{FF2B5EF4-FFF2-40B4-BE49-F238E27FC236}">
-                <a16:creationId xmlns:a16="http://schemas.microsoft.com/office/drawing/2014/main" id="{BB3E3A21-700F-B328-1C85-49F91535B3B3}"/>
+                <a16:creationId xmlns:a16="http://schemas.microsoft.com/office/drawing/2014/main" id="{B53EF905-F911-2F31-FAD0-191A0ABDC738}"/>
               </a:ext>
             </a:extLst>
           </p:cNvPr>
@@ -3695,7 +3695,7 @@
           <p:cNvPr id="3" name="CuadroTexto 2">
             <a:extLst>
               <a:ext uri="{FF2B5EF4-FFF2-40B4-BE49-F238E27FC236}">
-                <a16:creationId xmlns:a16="http://schemas.microsoft.com/office/drawing/2014/main" id="{65C96FD9-FF04-FDF2-A4B6-8814B4AE257E}"/>
+                <a16:creationId xmlns:a16="http://schemas.microsoft.com/office/drawing/2014/main" id="{EAC5B46A-73DC-C0DA-A717-F918A125DF90}"/>
               </a:ext>
             </a:extLst>
           </p:cNvPr>
@@ -3735,7 +3735,7 @@
           <p:cNvPr id="4" name="CuadroTexto 3">
             <a:extLst>
               <a:ext uri="{FF2B5EF4-FFF2-40B4-BE49-F238E27FC236}">
-                <a16:creationId xmlns:a16="http://schemas.microsoft.com/office/drawing/2014/main" id="{6BDC3A2A-272F-7680-1053-39254C9434D6}"/>
+                <a16:creationId xmlns:a16="http://schemas.microsoft.com/office/drawing/2014/main" id="{DD9A8A3D-6BE3-DF76-621E-68EC907B1E31}"/>
               </a:ext>
             </a:extLst>
           </p:cNvPr>
@@ -3775,7 +3775,7 @@
           <p:cNvPr id="5" name="Rectángulo: esquinas redondeadas 4">
             <a:extLst>
               <a:ext uri="{FF2B5EF4-FFF2-40B4-BE49-F238E27FC236}">
-                <a16:creationId xmlns:a16="http://schemas.microsoft.com/office/drawing/2014/main" id="{8FA6FB1C-07D4-3C91-2EBC-7BF26420A85D}"/>
+                <a16:creationId xmlns:a16="http://schemas.microsoft.com/office/drawing/2014/main" id="{10267645-03DD-3F9E-8A5C-ACC0A038705F}"/>
               </a:ext>
             </a:extLst>
           </p:cNvPr>
@@ -3829,7 +3829,7 @@
           <p:cNvPr id="6" name="CuadroTexto 5">
             <a:extLst>
               <a:ext uri="{FF2B5EF4-FFF2-40B4-BE49-F238E27FC236}">
-                <a16:creationId xmlns:a16="http://schemas.microsoft.com/office/drawing/2014/main" id="{CAFA737E-7877-A656-D66A-1719E860F090}"/>
+                <a16:creationId xmlns:a16="http://schemas.microsoft.com/office/drawing/2014/main" id="{D3574122-3348-8DEC-8605-5777C07B6B77}"/>
               </a:ext>
             </a:extLst>
           </p:cNvPr>
@@ -3869,7 +3869,7 @@
           <p:cNvPr id="7" name="CuadroTexto 6">
             <a:extLst>
               <a:ext uri="{FF2B5EF4-FFF2-40B4-BE49-F238E27FC236}">
-                <a16:creationId xmlns:a16="http://schemas.microsoft.com/office/drawing/2014/main" id="{B8E2502A-9E45-73E5-4753-CCC2DCC164AA}"/>
+                <a16:creationId xmlns:a16="http://schemas.microsoft.com/office/drawing/2014/main" id="{DECE2E86-538E-E01B-C1A1-43D459DEDF96}"/>
               </a:ext>
             </a:extLst>
           </p:cNvPr>
@@ -3988,7 +3988,7 @@
           <p:cNvPr id="8" name="Rectángulo: esquinas redondeadas 7">
             <a:extLst>
               <a:ext uri="{FF2B5EF4-FFF2-40B4-BE49-F238E27FC236}">
-                <a16:creationId xmlns:a16="http://schemas.microsoft.com/office/drawing/2014/main" id="{1249BF07-C029-8215-F68E-C663267BFB44}"/>
+                <a16:creationId xmlns:a16="http://schemas.microsoft.com/office/drawing/2014/main" id="{FE4AC941-C4EB-6AA4-CFEF-367570CD132C}"/>
               </a:ext>
             </a:extLst>
           </p:cNvPr>
@@ -4042,7 +4042,7 @@
           <p:cNvPr id="9" name="CuadroTexto 8">
             <a:extLst>
               <a:ext uri="{FF2B5EF4-FFF2-40B4-BE49-F238E27FC236}">
-                <a16:creationId xmlns:a16="http://schemas.microsoft.com/office/drawing/2014/main" id="{76409B55-1FF9-05CA-E20C-E946527B6ECD}"/>
+                <a16:creationId xmlns:a16="http://schemas.microsoft.com/office/drawing/2014/main" id="{DA230D46-A039-48F1-6951-B3907F354812}"/>
               </a:ext>
             </a:extLst>
           </p:cNvPr>
@@ -4082,7 +4082,7 @@
           <p:cNvPr id="10" name="CuadroTexto 9">
             <a:extLst>
               <a:ext uri="{FF2B5EF4-FFF2-40B4-BE49-F238E27FC236}">
-                <a16:creationId xmlns:a16="http://schemas.microsoft.com/office/drawing/2014/main" id="{4CA6F5FF-4D69-355C-34A2-CD3F5AF5358B}"/>
+                <a16:creationId xmlns:a16="http://schemas.microsoft.com/office/drawing/2014/main" id="{F9D1DCA1-02C2-37EC-F365-BF7A1591B8A5}"/>
               </a:ext>
             </a:extLst>
           </p:cNvPr>
@@ -4122,7 +4122,7 @@
           <p:cNvPr id="11" name="Rectángulo: esquinas redondeadas 10">
             <a:extLst>
               <a:ext uri="{FF2B5EF4-FFF2-40B4-BE49-F238E27FC236}">
-                <a16:creationId xmlns:a16="http://schemas.microsoft.com/office/drawing/2014/main" id="{8BFAF78B-1B2B-5291-293E-820940BCE32D}"/>
+                <a16:creationId xmlns:a16="http://schemas.microsoft.com/office/drawing/2014/main" id="{E39B7F81-D49F-313C-4427-E8F19D10EEAC}"/>
               </a:ext>
             </a:extLst>
           </p:cNvPr>
@@ -4176,7 +4176,7 @@
           <p:cNvPr id="12" name="CuadroTexto 11">
             <a:extLst>
               <a:ext uri="{FF2B5EF4-FFF2-40B4-BE49-F238E27FC236}">
-                <a16:creationId xmlns:a16="http://schemas.microsoft.com/office/drawing/2014/main" id="{0F4FC968-FEC4-DA0E-E391-9B756368F5C9}"/>
+                <a16:creationId xmlns:a16="http://schemas.microsoft.com/office/drawing/2014/main" id="{6A87F822-D891-FF4A-0F02-3A44124C393C}"/>
               </a:ext>
             </a:extLst>
           </p:cNvPr>
@@ -4216,7 +4216,7 @@
           <p:cNvPr id="13" name="CuadroTexto 12">
             <a:extLst>
               <a:ext uri="{FF2B5EF4-FFF2-40B4-BE49-F238E27FC236}">
-                <a16:creationId xmlns:a16="http://schemas.microsoft.com/office/drawing/2014/main" id="{0EC0647C-77B4-AF71-3D0D-E54806027063}"/>
+                <a16:creationId xmlns:a16="http://schemas.microsoft.com/office/drawing/2014/main" id="{CBD15F83-4415-9C0B-7155-65874520B084}"/>
               </a:ext>
             </a:extLst>
           </p:cNvPr>
@@ -4256,7 +4256,7 @@
           <p:cNvPr id="14" name="Rectángulo: esquinas redondeadas 13">
             <a:extLst>
               <a:ext uri="{FF2B5EF4-FFF2-40B4-BE49-F238E27FC236}">
-                <a16:creationId xmlns:a16="http://schemas.microsoft.com/office/drawing/2014/main" id="{5D4EC944-4691-ED16-8EC6-081AC36B8E33}"/>
+                <a16:creationId xmlns:a16="http://schemas.microsoft.com/office/drawing/2014/main" id="{E6277D89-DBAA-2D26-1F05-0DDA9C48350B}"/>
               </a:ext>
             </a:extLst>
           </p:cNvPr>
@@ -4310,7 +4310,7 @@
           <p:cNvPr id="15" name="CuadroTexto 14">
             <a:extLst>
               <a:ext uri="{FF2B5EF4-FFF2-40B4-BE49-F238E27FC236}">
-                <a16:creationId xmlns:a16="http://schemas.microsoft.com/office/drawing/2014/main" id="{3BAB85E2-4DE6-012A-94DB-3DD42C13458B}"/>
+                <a16:creationId xmlns:a16="http://schemas.microsoft.com/office/drawing/2014/main" id="{AFBCEB81-C9E4-117B-6E0E-691521121747}"/>
               </a:ext>
             </a:extLst>
           </p:cNvPr>
@@ -4350,7 +4350,7 @@
           <p:cNvPr id="16" name="CuadroTexto 15">
             <a:extLst>
               <a:ext uri="{FF2B5EF4-FFF2-40B4-BE49-F238E27FC236}">
-                <a16:creationId xmlns:a16="http://schemas.microsoft.com/office/drawing/2014/main" id="{89F92D73-D283-698B-4D77-606985933359}"/>
+                <a16:creationId xmlns:a16="http://schemas.microsoft.com/office/drawing/2014/main" id="{6CBE7796-47DA-A9C1-28C3-B31118239767}"/>
               </a:ext>
             </a:extLst>
           </p:cNvPr>
@@ -4390,7 +4390,7 @@
           <p:cNvPr id="17" name="Rectángulo: esquinas redondeadas 16">
             <a:extLst>
               <a:ext uri="{FF2B5EF4-FFF2-40B4-BE49-F238E27FC236}">
-                <a16:creationId xmlns:a16="http://schemas.microsoft.com/office/drawing/2014/main" id="{5D5B2AB5-87B9-B15C-018C-CEBB6F47100B}"/>
+                <a16:creationId xmlns:a16="http://schemas.microsoft.com/office/drawing/2014/main" id="{E412FF78-0457-639A-95B9-F5A764DC1F2E}"/>
               </a:ext>
             </a:extLst>
           </p:cNvPr>
@@ -4444,7 +4444,7 @@
           <p:cNvPr id="18" name="CuadroTexto 17">
             <a:extLst>
               <a:ext uri="{FF2B5EF4-FFF2-40B4-BE49-F238E27FC236}">
-                <a16:creationId xmlns:a16="http://schemas.microsoft.com/office/drawing/2014/main" id="{E9BC1837-93EF-D3CE-2CD8-8F3060F1A27B}"/>
+                <a16:creationId xmlns:a16="http://schemas.microsoft.com/office/drawing/2014/main" id="{101D4939-99A3-2E12-1723-E851F1822DD1}"/>
               </a:ext>
             </a:extLst>
           </p:cNvPr>
@@ -4484,7 +4484,7 @@
           <p:cNvPr id="19" name="CuadroTexto 18">
             <a:extLst>
               <a:ext uri="{FF2B5EF4-FFF2-40B4-BE49-F238E27FC236}">
-                <a16:creationId xmlns:a16="http://schemas.microsoft.com/office/drawing/2014/main" id="{A42F90E0-DE57-5568-4EDF-BABAE0AD47DA}"/>
+                <a16:creationId xmlns:a16="http://schemas.microsoft.com/office/drawing/2014/main" id="{930D73CA-612E-113F-E469-7345AC7385B8}"/>
               </a:ext>
             </a:extLst>
           </p:cNvPr>
@@ -4522,7 +4522,7 @@
     </p:spTree>
     <p:extLst>
       <p:ext uri="{BB962C8B-B14F-4D97-AF65-F5344CB8AC3E}">
-        <p14:creationId xmlns:p14="http://schemas.microsoft.com/office/powerpoint/2010/main" val="3532658494"/>
+        <p14:creationId xmlns:p14="http://schemas.microsoft.com/office/powerpoint/2010/main" val="1085261756"/>
       </p:ext>
     </p:extLst>
   </p:cSld>
@@ -4562,7 +4562,7 @@
           <p:cNvPr id="2" name="CuadroTexto 1">
             <a:extLst>
               <a:ext uri="{FF2B5EF4-FFF2-40B4-BE49-F238E27FC236}">
-                <a16:creationId xmlns:a16="http://schemas.microsoft.com/office/drawing/2014/main" id="{EB6C318D-A379-813A-0988-B1A9761E04CA}"/>
+                <a16:creationId xmlns:a16="http://schemas.microsoft.com/office/drawing/2014/main" id="{39CE2496-B627-360A-0DE6-E28B88385026}"/>
               </a:ext>
             </a:extLst>
           </p:cNvPr>
@@ -4602,7 +4602,7 @@
           <p:cNvPr id="3" name="CuadroTexto 2">
             <a:extLst>
               <a:ext uri="{FF2B5EF4-FFF2-40B4-BE49-F238E27FC236}">
-                <a16:creationId xmlns:a16="http://schemas.microsoft.com/office/drawing/2014/main" id="{3B42BBBE-4372-3EB3-C9B1-28067BAE8AB7}"/>
+                <a16:creationId xmlns:a16="http://schemas.microsoft.com/office/drawing/2014/main" id="{BEAAC5C9-558C-9D42-5BE1-5C7307F83F09}"/>
               </a:ext>
             </a:extLst>
           </p:cNvPr>
@@ -4642,7 +4642,7 @@
           <p:cNvPr id="4" name="CuadroTexto 3">
             <a:extLst>
               <a:ext uri="{FF2B5EF4-FFF2-40B4-BE49-F238E27FC236}">
-                <a16:creationId xmlns:a16="http://schemas.microsoft.com/office/drawing/2014/main" id="{01C176EB-D1AA-B5C4-7F31-C4594402B1B8}"/>
+                <a16:creationId xmlns:a16="http://schemas.microsoft.com/office/drawing/2014/main" id="{B69B89BD-8C1F-4180-61AA-830F085D55A4}"/>
               </a:ext>
             </a:extLst>
           </p:cNvPr>
@@ -4682,7 +4682,7 @@
           <p:cNvPr id="5" name="Rectángulo: esquinas redondeadas 4">
             <a:extLst>
               <a:ext uri="{FF2B5EF4-FFF2-40B4-BE49-F238E27FC236}">
-                <a16:creationId xmlns:a16="http://schemas.microsoft.com/office/drawing/2014/main" id="{0C1FA7CE-AA04-AF8B-B1AE-513BA4BC5676}"/>
+                <a16:creationId xmlns:a16="http://schemas.microsoft.com/office/drawing/2014/main" id="{A18BF32F-543C-4B07-53B5-071EF1D619EA}"/>
               </a:ext>
             </a:extLst>
           </p:cNvPr>
@@ -4736,7 +4736,7 @@
           <p:cNvPr id="6" name="CuadroTexto 5">
             <a:extLst>
               <a:ext uri="{FF2B5EF4-FFF2-40B4-BE49-F238E27FC236}">
-                <a16:creationId xmlns:a16="http://schemas.microsoft.com/office/drawing/2014/main" id="{ECF4DDCD-700B-10A4-0DBB-57683CF91507}"/>
+                <a16:creationId xmlns:a16="http://schemas.microsoft.com/office/drawing/2014/main" id="{7F47EC61-8F1D-2851-871F-131752F80F3C}"/>
               </a:ext>
             </a:extLst>
           </p:cNvPr>
@@ -4776,7 +4776,7 @@
           <p:cNvPr id="7" name="CuadroTexto 6">
             <a:extLst>
               <a:ext uri="{FF2B5EF4-FFF2-40B4-BE49-F238E27FC236}">
-                <a16:creationId xmlns:a16="http://schemas.microsoft.com/office/drawing/2014/main" id="{0B84B0ED-17A7-78DE-80F4-34C88011AC41}"/>
+                <a16:creationId xmlns:a16="http://schemas.microsoft.com/office/drawing/2014/main" id="{EDC65C6E-A3AC-7652-FC0C-195AF025C4A3}"/>
               </a:ext>
             </a:extLst>
           </p:cNvPr>
@@ -4816,7 +4816,7 @@
           <p:cNvPr id="8" name="Rectángulo: esquinas redondeadas 7">
             <a:extLst>
               <a:ext uri="{FF2B5EF4-FFF2-40B4-BE49-F238E27FC236}">
-                <a16:creationId xmlns:a16="http://schemas.microsoft.com/office/drawing/2014/main" id="{FBFBDBF3-96AF-ED49-4CB0-FE9650FF6A2C}"/>
+                <a16:creationId xmlns:a16="http://schemas.microsoft.com/office/drawing/2014/main" id="{E665AABE-9481-7904-707B-8B83BD57F6EE}"/>
               </a:ext>
             </a:extLst>
           </p:cNvPr>
@@ -4870,7 +4870,7 @@
           <p:cNvPr id="9" name="CuadroTexto 8">
             <a:extLst>
               <a:ext uri="{FF2B5EF4-FFF2-40B4-BE49-F238E27FC236}">
-                <a16:creationId xmlns:a16="http://schemas.microsoft.com/office/drawing/2014/main" id="{41887F25-D654-250B-E014-C7C2DCEBE80C}"/>
+                <a16:creationId xmlns:a16="http://schemas.microsoft.com/office/drawing/2014/main" id="{DFE73C81-E429-D3D9-830A-6DB641563943}"/>
               </a:ext>
             </a:extLst>
           </p:cNvPr>
@@ -4910,7 +4910,7 @@
           <p:cNvPr id="10" name="CuadroTexto 9">
             <a:extLst>
               <a:ext uri="{FF2B5EF4-FFF2-40B4-BE49-F238E27FC236}">
-                <a16:creationId xmlns:a16="http://schemas.microsoft.com/office/drawing/2014/main" id="{4D271785-A2ED-8972-3966-D833F2421BC8}"/>
+                <a16:creationId xmlns:a16="http://schemas.microsoft.com/office/drawing/2014/main" id="{B280473F-2B7C-326A-5B51-55325D52D43C}"/>
               </a:ext>
             </a:extLst>
           </p:cNvPr>
@@ -4950,7 +4950,7 @@
           <p:cNvPr id="11" name="Rectángulo: esquinas redondeadas 10">
             <a:extLst>
               <a:ext uri="{FF2B5EF4-FFF2-40B4-BE49-F238E27FC236}">
-                <a16:creationId xmlns:a16="http://schemas.microsoft.com/office/drawing/2014/main" id="{03CB2B5F-3C01-6895-DA2C-4CF6C14AC82C}"/>
+                <a16:creationId xmlns:a16="http://schemas.microsoft.com/office/drawing/2014/main" id="{6C36FDC8-533A-55F0-E957-C6CB5C8B24A9}"/>
               </a:ext>
             </a:extLst>
           </p:cNvPr>
@@ -5004,7 +5004,7 @@
           <p:cNvPr id="12" name="CuadroTexto 11">
             <a:extLst>
               <a:ext uri="{FF2B5EF4-FFF2-40B4-BE49-F238E27FC236}">
-                <a16:creationId xmlns:a16="http://schemas.microsoft.com/office/drawing/2014/main" id="{C880637A-CB1B-5782-D079-ACC2BE9637C5}"/>
+                <a16:creationId xmlns:a16="http://schemas.microsoft.com/office/drawing/2014/main" id="{3A22A1A6-B1CF-A65E-0681-A3C7634201C6}"/>
               </a:ext>
             </a:extLst>
           </p:cNvPr>
@@ -5044,7 +5044,7 @@
           <p:cNvPr id="13" name="CuadroTexto 12">
             <a:extLst>
               <a:ext uri="{FF2B5EF4-FFF2-40B4-BE49-F238E27FC236}">
-                <a16:creationId xmlns:a16="http://schemas.microsoft.com/office/drawing/2014/main" id="{D3DE608D-A0B7-5295-B3CD-640A62ED4713}"/>
+                <a16:creationId xmlns:a16="http://schemas.microsoft.com/office/drawing/2014/main" id="{7495F043-46E0-F646-7CC0-812ADC68107C}"/>
               </a:ext>
             </a:extLst>
           </p:cNvPr>
@@ -5084,7 +5084,7 @@
           <p:cNvPr id="14" name="CuadroTexto 13">
             <a:extLst>
               <a:ext uri="{FF2B5EF4-FFF2-40B4-BE49-F238E27FC236}">
-                <a16:creationId xmlns:a16="http://schemas.microsoft.com/office/drawing/2014/main" id="{72EC6BCA-D704-E1FF-9E90-0AE17FAE0EBB}"/>
+                <a16:creationId xmlns:a16="http://schemas.microsoft.com/office/drawing/2014/main" id="{AABD840C-177C-F59E-E464-A85BC72E47D1}"/>
               </a:ext>
             </a:extLst>
           </p:cNvPr>
@@ -5165,7 +5165,7 @@
     </p:spTree>
     <p:extLst>
       <p:ext uri="{BB962C8B-B14F-4D97-AF65-F5344CB8AC3E}">
-        <p14:creationId xmlns:p14="http://schemas.microsoft.com/office/powerpoint/2010/main" val="3405836489"/>
+        <p14:creationId xmlns:p14="http://schemas.microsoft.com/office/powerpoint/2010/main" val="2291224648"/>
       </p:ext>
     </p:extLst>
   </p:cSld>
@@ -5205,7 +5205,7 @@
           <p:cNvPr id="2" name="CuadroTexto 1">
             <a:extLst>
               <a:ext uri="{FF2B5EF4-FFF2-40B4-BE49-F238E27FC236}">
-                <a16:creationId xmlns:a16="http://schemas.microsoft.com/office/drawing/2014/main" id="{7B9B6B7E-C6B3-B223-1BFD-E8BEC0482E7E}"/>
+                <a16:creationId xmlns:a16="http://schemas.microsoft.com/office/drawing/2014/main" id="{5EB2B62B-0F5C-9FAE-3695-0B8096FE97A4}"/>
               </a:ext>
             </a:extLst>
           </p:cNvPr>
@@ -5245,7 +5245,7 @@
           <p:cNvPr id="3" name="CuadroTexto 2">
             <a:extLst>
               <a:ext uri="{FF2B5EF4-FFF2-40B4-BE49-F238E27FC236}">
-                <a16:creationId xmlns:a16="http://schemas.microsoft.com/office/drawing/2014/main" id="{16DCD38B-33FD-0819-047A-A0BC19FA6012}"/>
+                <a16:creationId xmlns:a16="http://schemas.microsoft.com/office/drawing/2014/main" id="{37CA2F4B-0533-C986-3A02-48FACB2697C0}"/>
               </a:ext>
             </a:extLst>
           </p:cNvPr>
@@ -5285,7 +5285,7 @@
           <p:cNvPr id="4" name="CuadroTexto 3">
             <a:extLst>
               <a:ext uri="{FF2B5EF4-FFF2-40B4-BE49-F238E27FC236}">
-                <a16:creationId xmlns:a16="http://schemas.microsoft.com/office/drawing/2014/main" id="{D99D53E9-606E-E5A8-BEAB-4AAFA0BA4E3E}"/>
+                <a16:creationId xmlns:a16="http://schemas.microsoft.com/office/drawing/2014/main" id="{124CAE04-6D4D-6E66-B65C-2AA45DF48920}"/>
               </a:ext>
             </a:extLst>
           </p:cNvPr>
@@ -5325,7 +5325,7 @@
           <p:cNvPr id="6" name="Imagen 5">
             <a:extLst>
               <a:ext uri="{FF2B5EF4-FFF2-40B4-BE49-F238E27FC236}">
-                <a16:creationId xmlns:a16="http://schemas.microsoft.com/office/drawing/2014/main" id="{2D78C6A8-502A-BF1F-7037-B92D921A1848}"/>
+                <a16:creationId xmlns:a16="http://schemas.microsoft.com/office/drawing/2014/main" id="{A54370F0-A0E6-C709-1CCD-B076CA92098A}"/>
               </a:ext>
             </a:extLst>
           </p:cNvPr>
@@ -5366,7 +5366,7 @@
           <p:cNvPr id="7" name="Rectángulo: esquinas redondeadas 6">
             <a:extLst>
               <a:ext uri="{FF2B5EF4-FFF2-40B4-BE49-F238E27FC236}">
-                <a16:creationId xmlns:a16="http://schemas.microsoft.com/office/drawing/2014/main" id="{4C3F84F1-C002-E42E-6F30-561370E14D4D}"/>
+                <a16:creationId xmlns:a16="http://schemas.microsoft.com/office/drawing/2014/main" id="{0CE70DC4-CFBF-C5FF-EC49-BEC5D22BDA9B}"/>
               </a:ext>
             </a:extLst>
           </p:cNvPr>
@@ -5420,7 +5420,7 @@
           <p:cNvPr id="8" name="CuadroTexto 7">
             <a:extLst>
               <a:ext uri="{FF2B5EF4-FFF2-40B4-BE49-F238E27FC236}">
-                <a16:creationId xmlns:a16="http://schemas.microsoft.com/office/drawing/2014/main" id="{34169844-49DA-44AD-10C8-4E9CB91B3260}"/>
+                <a16:creationId xmlns:a16="http://schemas.microsoft.com/office/drawing/2014/main" id="{7049EA37-A184-7DF4-182D-376712C62E7D}"/>
               </a:ext>
             </a:extLst>
           </p:cNvPr>
@@ -5460,7 +5460,7 @@
           <p:cNvPr id="9" name="CuadroTexto 8">
             <a:extLst>
               <a:ext uri="{FF2B5EF4-FFF2-40B4-BE49-F238E27FC236}">
-                <a16:creationId xmlns:a16="http://schemas.microsoft.com/office/drawing/2014/main" id="{158AF3C4-FC08-AD3B-5C94-74A4CA19B02D}"/>
+                <a16:creationId xmlns:a16="http://schemas.microsoft.com/office/drawing/2014/main" id="{71A22A06-4C0C-1CFA-3D77-69EBA41A267D}"/>
               </a:ext>
             </a:extLst>
           </p:cNvPr>
@@ -5500,7 +5500,7 @@
           <p:cNvPr id="10" name="CuadroTexto 9">
             <a:extLst>
               <a:ext uri="{FF2B5EF4-FFF2-40B4-BE49-F238E27FC236}">
-                <a16:creationId xmlns:a16="http://schemas.microsoft.com/office/drawing/2014/main" id="{5C1DB574-CDEA-B7AF-AB80-5B09A652AB85}"/>
+                <a16:creationId xmlns:a16="http://schemas.microsoft.com/office/drawing/2014/main" id="{89EDC992-F8C1-2C41-EA34-875E1A86BEBC}"/>
               </a:ext>
             </a:extLst>
           </p:cNvPr>
@@ -5599,7 +5599,7 @@
     </p:spTree>
     <p:extLst>
       <p:ext uri="{BB962C8B-B14F-4D97-AF65-F5344CB8AC3E}">
-        <p14:creationId xmlns:p14="http://schemas.microsoft.com/office/powerpoint/2010/main" val="2210462987"/>
+        <p14:creationId xmlns:p14="http://schemas.microsoft.com/office/powerpoint/2010/main" val="3498344873"/>
       </p:ext>
     </p:extLst>
   </p:cSld>
@@ -5639,7 +5639,7 @@
           <p:cNvPr id="2" name="CuadroTexto 1">
             <a:extLst>
               <a:ext uri="{FF2B5EF4-FFF2-40B4-BE49-F238E27FC236}">
-                <a16:creationId xmlns:a16="http://schemas.microsoft.com/office/drawing/2014/main" id="{42D3F0E6-C8A7-090D-EAF0-34D303DC63CB}"/>
+                <a16:creationId xmlns:a16="http://schemas.microsoft.com/office/drawing/2014/main" id="{AADF5E54-0B47-2896-54E3-FE6E770510EF}"/>
               </a:ext>
             </a:extLst>
           </p:cNvPr>
@@ -5679,7 +5679,7 @@
           <p:cNvPr id="3" name="CuadroTexto 2">
             <a:extLst>
               <a:ext uri="{FF2B5EF4-FFF2-40B4-BE49-F238E27FC236}">
-                <a16:creationId xmlns:a16="http://schemas.microsoft.com/office/drawing/2014/main" id="{173FB023-723C-BFD4-D252-82974DA3A6C8}"/>
+                <a16:creationId xmlns:a16="http://schemas.microsoft.com/office/drawing/2014/main" id="{891576B8-16A1-4495-17BF-3AC78195030B}"/>
               </a:ext>
             </a:extLst>
           </p:cNvPr>
@@ -5719,7 +5719,7 @@
           <p:cNvPr id="4" name="CuadroTexto 3">
             <a:extLst>
               <a:ext uri="{FF2B5EF4-FFF2-40B4-BE49-F238E27FC236}">
-                <a16:creationId xmlns:a16="http://schemas.microsoft.com/office/drawing/2014/main" id="{8658B0A6-E10F-F98A-76F7-ED59C2343165}"/>
+                <a16:creationId xmlns:a16="http://schemas.microsoft.com/office/drawing/2014/main" id="{0FD1BC3C-47BB-01C6-455A-6F6A671E45B6}"/>
               </a:ext>
             </a:extLst>
           </p:cNvPr>
@@ -5749,7 +5749,7 @@
                 </a:solidFill>
                 <a:latin typeface="Segoe UI" panose="020B0502040204020203" pitchFamily="34" charset="0"/>
               </a:rPr>
-              <a:t>La parte tecnica ya no depende de varios terminales sueltos: queda centralizada en una sola app.</a:t>
+              <a:t>La parte tecnica ya no depende de varios terminales sueltos ni de una pagina web separada: queda centralizada en una sola app.</a:t>
             </a:r>
           </a:p>
         </p:txBody>
@@ -5759,7 +5759,7 @@
           <p:cNvPr id="6" name="Imagen 5">
             <a:extLst>
               <a:ext uri="{FF2B5EF4-FFF2-40B4-BE49-F238E27FC236}">
-                <a16:creationId xmlns:a16="http://schemas.microsoft.com/office/drawing/2014/main" id="{95488A2C-AD32-68EC-13CD-150018457362}"/>
+                <a16:creationId xmlns:a16="http://schemas.microsoft.com/office/drawing/2014/main" id="{367917A3-75A8-786E-F069-61A34019FAE3}"/>
               </a:ext>
             </a:extLst>
           </p:cNvPr>
@@ -5782,8 +5782,8 @@
         </p:blipFill>
         <p:spPr>
           <a:xfrm>
-            <a:off x="635000" y="2305843"/>
-            <a:ext cx="5461000" cy="3071813"/>
+            <a:off x="635000" y="2342377"/>
+            <a:ext cx="5461000" cy="2998746"/>
           </a:xfrm>
           <a:prstGeom prst="rect">
             <a:avLst/>
@@ -5800,7 +5800,7 @@
           <p:cNvPr id="7" name="CuadroTexto 6">
             <a:extLst>
               <a:ext uri="{FF2B5EF4-FFF2-40B4-BE49-F238E27FC236}">
-                <a16:creationId xmlns:a16="http://schemas.microsoft.com/office/drawing/2014/main" id="{C1933801-18FB-DD6E-590C-18C7B2D41FF3}"/>
+                <a16:creationId xmlns:a16="http://schemas.microsoft.com/office/drawing/2014/main" id="{373B96C4-CCAA-90A8-2D8D-513A151039E8}"/>
               </a:ext>
             </a:extLst>
           </p:cNvPr>
@@ -5855,7 +5855,7 @@
                 </a:solidFill>
                 <a:latin typeface="Segoe UI" panose="020B0502040204020203" pitchFamily="34" charset="0"/>
               </a:rPr>
-              <a:t>Modo cloud para monitor, smoke, logs y reinicios remotos.</a:t>
+              <a:t>Modo cloud para estado, smoke, logs y reinicios remotos.</a:t>
             </a:r>
           </a:p>
           <a:p>
@@ -5917,7 +5917,7 @@
     </p:spTree>
     <p:extLst>
       <p:ext uri="{BB962C8B-B14F-4D97-AF65-F5344CB8AC3E}">
-        <p14:creationId xmlns:p14="http://schemas.microsoft.com/office/powerpoint/2010/main" val="198109559"/>
+        <p14:creationId xmlns:p14="http://schemas.microsoft.com/office/powerpoint/2010/main" val="1503816519"/>
       </p:ext>
     </p:extLst>
   </p:cSld>
@@ -5957,7 +5957,7 @@
           <p:cNvPr id="2" name="CuadroTexto 1">
             <a:extLst>
               <a:ext uri="{FF2B5EF4-FFF2-40B4-BE49-F238E27FC236}">
-                <a16:creationId xmlns:a16="http://schemas.microsoft.com/office/drawing/2014/main" id="{58A8D320-D3D9-D479-857F-592D2A98B6D5}"/>
+                <a16:creationId xmlns:a16="http://schemas.microsoft.com/office/drawing/2014/main" id="{F3430133-8CE9-88BB-A591-7BC0AE2A0DDD}"/>
               </a:ext>
             </a:extLst>
           </p:cNvPr>
@@ -5997,7 +5997,7 @@
           <p:cNvPr id="3" name="CuadroTexto 2">
             <a:extLst>
               <a:ext uri="{FF2B5EF4-FFF2-40B4-BE49-F238E27FC236}">
-                <a16:creationId xmlns:a16="http://schemas.microsoft.com/office/drawing/2014/main" id="{45502EFF-453D-C37B-4866-D796ED1BF587}"/>
+                <a16:creationId xmlns:a16="http://schemas.microsoft.com/office/drawing/2014/main" id="{AEA9BB5A-9ABC-1992-B21F-7371FD34CBB4}"/>
               </a:ext>
             </a:extLst>
           </p:cNvPr>
@@ -6037,7 +6037,7 @@
           <p:cNvPr id="4" name="Rectángulo: esquinas redondeadas 3">
             <a:extLst>
               <a:ext uri="{FF2B5EF4-FFF2-40B4-BE49-F238E27FC236}">
-                <a16:creationId xmlns:a16="http://schemas.microsoft.com/office/drawing/2014/main" id="{0EB9F5AA-9213-DCCA-BFC2-9145D86110F3}"/>
+                <a16:creationId xmlns:a16="http://schemas.microsoft.com/office/drawing/2014/main" id="{50330CCE-5524-BE3B-45F1-DEDCF3A76619}"/>
               </a:ext>
             </a:extLst>
           </p:cNvPr>
@@ -6091,7 +6091,7 @@
           <p:cNvPr id="5" name="CuadroTexto 4">
             <a:extLst>
               <a:ext uri="{FF2B5EF4-FFF2-40B4-BE49-F238E27FC236}">
-                <a16:creationId xmlns:a16="http://schemas.microsoft.com/office/drawing/2014/main" id="{78F637CC-F7B3-7720-B1F3-148835C7B0A3}"/>
+                <a16:creationId xmlns:a16="http://schemas.microsoft.com/office/drawing/2014/main" id="{1D2A64B2-6905-97C5-511E-73058293DD54}"/>
               </a:ext>
             </a:extLst>
           </p:cNvPr>
@@ -6131,7 +6131,7 @@
           <p:cNvPr id="6" name="CuadroTexto 5">
             <a:extLst>
               <a:ext uri="{FF2B5EF4-FFF2-40B4-BE49-F238E27FC236}">
-                <a16:creationId xmlns:a16="http://schemas.microsoft.com/office/drawing/2014/main" id="{C3BF3B7F-00E6-45F1-1BBD-77C5C001A21B}"/>
+                <a16:creationId xmlns:a16="http://schemas.microsoft.com/office/drawing/2014/main" id="{1392E5AB-DD85-70A4-DE0F-CB2EC849E5A2}"/>
               </a:ext>
             </a:extLst>
           </p:cNvPr>
@@ -6171,7 +6171,7 @@
           <p:cNvPr id="7" name="Rectángulo: esquinas redondeadas 6">
             <a:extLst>
               <a:ext uri="{FF2B5EF4-FFF2-40B4-BE49-F238E27FC236}">
-                <a16:creationId xmlns:a16="http://schemas.microsoft.com/office/drawing/2014/main" id="{75ABA86E-3F26-5381-6A09-2098F1B7A76F}"/>
+                <a16:creationId xmlns:a16="http://schemas.microsoft.com/office/drawing/2014/main" id="{ABB172E4-595B-4818-63FB-64A0B92E2278}"/>
               </a:ext>
             </a:extLst>
           </p:cNvPr>
@@ -6225,7 +6225,7 @@
           <p:cNvPr id="8" name="CuadroTexto 7">
             <a:extLst>
               <a:ext uri="{FF2B5EF4-FFF2-40B4-BE49-F238E27FC236}">
-                <a16:creationId xmlns:a16="http://schemas.microsoft.com/office/drawing/2014/main" id="{01C63BFB-98C4-7ED5-773B-9E0E5B0F060A}"/>
+                <a16:creationId xmlns:a16="http://schemas.microsoft.com/office/drawing/2014/main" id="{9166C8F3-81C6-8EEC-CF1A-30A9D05A8D2A}"/>
               </a:ext>
             </a:extLst>
           </p:cNvPr>
@@ -6265,7 +6265,7 @@
           <p:cNvPr id="9" name="CuadroTexto 8">
             <a:extLst>
               <a:ext uri="{FF2B5EF4-FFF2-40B4-BE49-F238E27FC236}">
-                <a16:creationId xmlns:a16="http://schemas.microsoft.com/office/drawing/2014/main" id="{B97B74B2-7776-1E59-2D39-45BF642969E4}"/>
+                <a16:creationId xmlns:a16="http://schemas.microsoft.com/office/drawing/2014/main" id="{CE499E91-418B-4215-3ADE-DEA04F0C1D15}"/>
               </a:ext>
             </a:extLst>
           </p:cNvPr>
@@ -6305,7 +6305,7 @@
           <p:cNvPr id="10" name="Rectángulo: esquinas redondeadas 9">
             <a:extLst>
               <a:ext uri="{FF2B5EF4-FFF2-40B4-BE49-F238E27FC236}">
-                <a16:creationId xmlns:a16="http://schemas.microsoft.com/office/drawing/2014/main" id="{A1D25B25-7532-80F7-A1BC-B653824749E7}"/>
+                <a16:creationId xmlns:a16="http://schemas.microsoft.com/office/drawing/2014/main" id="{853A2DBA-0CA8-E3D3-DDAA-6D31ECEC1F06}"/>
               </a:ext>
             </a:extLst>
           </p:cNvPr>
@@ -6359,7 +6359,7 @@
           <p:cNvPr id="11" name="CuadroTexto 10">
             <a:extLst>
               <a:ext uri="{FF2B5EF4-FFF2-40B4-BE49-F238E27FC236}">
-                <a16:creationId xmlns:a16="http://schemas.microsoft.com/office/drawing/2014/main" id="{4BF23786-17DA-8D81-ACC7-DE506C18099A}"/>
+                <a16:creationId xmlns:a16="http://schemas.microsoft.com/office/drawing/2014/main" id="{29D7216D-962D-40B3-A00F-974B4DE9EC8E}"/>
               </a:ext>
             </a:extLst>
           </p:cNvPr>
@@ -6399,7 +6399,7 @@
           <p:cNvPr id="12" name="CuadroTexto 11">
             <a:extLst>
               <a:ext uri="{FF2B5EF4-FFF2-40B4-BE49-F238E27FC236}">
-                <a16:creationId xmlns:a16="http://schemas.microsoft.com/office/drawing/2014/main" id="{0CCE4AB0-8957-E3DE-AA4F-1766A6C32A75}"/>
+                <a16:creationId xmlns:a16="http://schemas.microsoft.com/office/drawing/2014/main" id="{454119C0-8814-A475-8953-AE96D966C455}"/>
               </a:ext>
             </a:extLst>
           </p:cNvPr>
@@ -6439,7 +6439,7 @@
           <p:cNvPr id="13" name="Rectángulo: esquinas redondeadas 12">
             <a:extLst>
               <a:ext uri="{FF2B5EF4-FFF2-40B4-BE49-F238E27FC236}">
-                <a16:creationId xmlns:a16="http://schemas.microsoft.com/office/drawing/2014/main" id="{2A2CF79F-7B26-6FF9-27BE-288884F83C81}"/>
+                <a16:creationId xmlns:a16="http://schemas.microsoft.com/office/drawing/2014/main" id="{B47F82F8-76A3-7CF0-F92E-2D0310069701}"/>
               </a:ext>
             </a:extLst>
           </p:cNvPr>
@@ -6493,7 +6493,7 @@
           <p:cNvPr id="14" name="CuadroTexto 13">
             <a:extLst>
               <a:ext uri="{FF2B5EF4-FFF2-40B4-BE49-F238E27FC236}">
-                <a16:creationId xmlns:a16="http://schemas.microsoft.com/office/drawing/2014/main" id="{D9E33C67-CB50-BC7D-9ABD-8F6AB00E83ED}"/>
+                <a16:creationId xmlns:a16="http://schemas.microsoft.com/office/drawing/2014/main" id="{ED02E93D-7A42-BD7A-43B8-420A5927D2DE}"/>
               </a:ext>
             </a:extLst>
           </p:cNvPr>
@@ -6533,7 +6533,7 @@
           <p:cNvPr id="15" name="CuadroTexto 14">
             <a:extLst>
               <a:ext uri="{FF2B5EF4-FFF2-40B4-BE49-F238E27FC236}">
-                <a16:creationId xmlns:a16="http://schemas.microsoft.com/office/drawing/2014/main" id="{A7459030-4D23-0822-8CD0-1B97AE0B84BC}"/>
+                <a16:creationId xmlns:a16="http://schemas.microsoft.com/office/drawing/2014/main" id="{81D2B069-110C-FD48-F253-00EF4E48E793}"/>
               </a:ext>
             </a:extLst>
           </p:cNvPr>
@@ -6573,7 +6573,7 @@
           <p:cNvPr id="16" name="CuadroTexto 15">
             <a:extLst>
               <a:ext uri="{FF2B5EF4-FFF2-40B4-BE49-F238E27FC236}">
-                <a16:creationId xmlns:a16="http://schemas.microsoft.com/office/drawing/2014/main" id="{458ACC12-BE56-02A8-3685-6CEB8BF8C5BB}"/>
+                <a16:creationId xmlns:a16="http://schemas.microsoft.com/office/drawing/2014/main" id="{12158504-D060-9EA0-221B-41A981AF51C2}"/>
               </a:ext>
             </a:extLst>
           </p:cNvPr>
@@ -6628,7 +6628,7 @@
                 </a:solidFill>
                 <a:latin typeface="Segoe UI" panose="020B0502040204020203" pitchFamily="34" charset="0"/>
               </a:rPr>
-              <a:t>Verificados correo, rechazo, URLs publicas, chat, monitor legacy y app de escritorio.</a:t>
+              <a:t>Verificados correo, rechazo, URLs publicas, chat y consola tecnica de escritorio.</a:t>
             </a:r>
           </a:p>
           <a:p>
@@ -6656,7 +6656,7 @@
           <p:cNvPr id="17" name="CuadroTexto 16">
             <a:extLst>
               <a:ext uri="{FF2B5EF4-FFF2-40B4-BE49-F238E27FC236}">
-                <a16:creationId xmlns:a16="http://schemas.microsoft.com/office/drawing/2014/main" id="{865254E5-511B-D601-A467-89263CA473C4}"/>
+                <a16:creationId xmlns:a16="http://schemas.microsoft.com/office/drawing/2014/main" id="{1510BF8C-088D-0F57-AC6A-E090829EA2CB}"/>
               </a:ext>
             </a:extLst>
           </p:cNvPr>
@@ -6694,7 +6694,7 @@
     </p:spTree>
     <p:extLst>
       <p:ext uri="{BB962C8B-B14F-4D97-AF65-F5344CB8AC3E}">
-        <p14:creationId xmlns:p14="http://schemas.microsoft.com/office/powerpoint/2010/main" val="4151966672"/>
+        <p14:creationId xmlns:p14="http://schemas.microsoft.com/office/powerpoint/2010/main" val="2217278504"/>
       </p:ext>
     </p:extLst>
   </p:cSld>
@@ -6734,7 +6734,7 @@
           <p:cNvPr id="2" name="CuadroTexto 1">
             <a:extLst>
               <a:ext uri="{FF2B5EF4-FFF2-40B4-BE49-F238E27FC236}">
-                <a16:creationId xmlns:a16="http://schemas.microsoft.com/office/drawing/2014/main" id="{5196CABB-6C82-094D-72E5-EAA8E0A9070B}"/>
+                <a16:creationId xmlns:a16="http://schemas.microsoft.com/office/drawing/2014/main" id="{AE97D073-59E3-5409-CF6C-C97B6296295A}"/>
               </a:ext>
             </a:extLst>
           </p:cNvPr>
@@ -6774,7 +6774,7 @@
           <p:cNvPr id="3" name="CuadroTexto 2">
             <a:extLst>
               <a:ext uri="{FF2B5EF4-FFF2-40B4-BE49-F238E27FC236}">
-                <a16:creationId xmlns:a16="http://schemas.microsoft.com/office/drawing/2014/main" id="{7DA1A7FB-DDF9-4965-7F17-B1761287B81A}"/>
+                <a16:creationId xmlns:a16="http://schemas.microsoft.com/office/drawing/2014/main" id="{B9C7F614-5499-76E6-C427-B77D4FC82F1B}"/>
               </a:ext>
             </a:extLst>
           </p:cNvPr>
@@ -6814,7 +6814,7 @@
           <p:cNvPr id="4" name="CuadroTexto 3">
             <a:extLst>
               <a:ext uri="{FF2B5EF4-FFF2-40B4-BE49-F238E27FC236}">
-                <a16:creationId xmlns:a16="http://schemas.microsoft.com/office/drawing/2014/main" id="{724B5627-82BD-3649-F968-C05ED6EAC3EB}"/>
+                <a16:creationId xmlns:a16="http://schemas.microsoft.com/office/drawing/2014/main" id="{37568BDC-19A1-B02B-11CC-CCD27F9083CE}"/>
               </a:ext>
             </a:extLst>
           </p:cNvPr>
@@ -6854,7 +6854,7 @@
           <p:cNvPr id="5" name="Rectángulo: esquinas redondeadas 4">
             <a:extLst>
               <a:ext uri="{FF2B5EF4-FFF2-40B4-BE49-F238E27FC236}">
-                <a16:creationId xmlns:a16="http://schemas.microsoft.com/office/drawing/2014/main" id="{2A49FF86-1A50-3660-9AB2-CC6B73910ACA}"/>
+                <a16:creationId xmlns:a16="http://schemas.microsoft.com/office/drawing/2014/main" id="{58FA41B2-903B-E960-4D4C-7649F102C072}"/>
               </a:ext>
             </a:extLst>
           </p:cNvPr>
@@ -6908,7 +6908,7 @@
           <p:cNvPr id="6" name="CuadroTexto 5">
             <a:extLst>
               <a:ext uri="{FF2B5EF4-FFF2-40B4-BE49-F238E27FC236}">
-                <a16:creationId xmlns:a16="http://schemas.microsoft.com/office/drawing/2014/main" id="{38BB3FBC-878F-C284-3984-DE711FA9AA3B}"/>
+                <a16:creationId xmlns:a16="http://schemas.microsoft.com/office/drawing/2014/main" id="{1D07C734-D680-766C-EEDF-F6D166A0306A}"/>
               </a:ext>
             </a:extLst>
           </p:cNvPr>
@@ -6948,7 +6948,7 @@
           <p:cNvPr id="7" name="CuadroTexto 6">
             <a:extLst>
               <a:ext uri="{FF2B5EF4-FFF2-40B4-BE49-F238E27FC236}">
-                <a16:creationId xmlns:a16="http://schemas.microsoft.com/office/drawing/2014/main" id="{705339D7-AE6F-CF6D-6835-7E5D280AF18C}"/>
+                <a16:creationId xmlns:a16="http://schemas.microsoft.com/office/drawing/2014/main" id="{BA9B237C-E4F3-61B4-E479-E549D931655B}"/>
               </a:ext>
             </a:extLst>
           </p:cNvPr>
@@ -6978,7 +6978,7 @@
                 </a:solidFill>
                 <a:latin typeface="Segoe UI" panose="020B0502040204020203" pitchFamily="34" charset="0"/>
               </a:rPr>
-              <a:t>La misma base sirve panel interno, portal externo, documentacion y la shell legacy.</a:t>
+              <a:t>La misma base sirve panel interno, portal externo y documentacion; la operacion tecnica se hace desde Agora Desktop.</a:t>
             </a:r>
           </a:p>
         </p:txBody>
@@ -6988,7 +6988,7 @@
           <p:cNvPr id="8" name="Rectángulo: esquinas redondeadas 7">
             <a:extLst>
               <a:ext uri="{FF2B5EF4-FFF2-40B4-BE49-F238E27FC236}">
-                <a16:creationId xmlns:a16="http://schemas.microsoft.com/office/drawing/2014/main" id="{8F0D1F64-5173-E6B0-2867-D732AF7FFA5F}"/>
+                <a16:creationId xmlns:a16="http://schemas.microsoft.com/office/drawing/2014/main" id="{DD42DE42-5955-D968-3FEC-2E1E9579A8C8}"/>
               </a:ext>
             </a:extLst>
           </p:cNvPr>
@@ -7042,7 +7042,7 @@
           <p:cNvPr id="9" name="CuadroTexto 8">
             <a:extLst>
               <a:ext uri="{FF2B5EF4-FFF2-40B4-BE49-F238E27FC236}">
-                <a16:creationId xmlns:a16="http://schemas.microsoft.com/office/drawing/2014/main" id="{4F197C26-BD49-5A86-7F1B-13A8F78E15EB}"/>
+                <a16:creationId xmlns:a16="http://schemas.microsoft.com/office/drawing/2014/main" id="{468B4253-FCBE-C837-4133-F7E478500FFB}"/>
               </a:ext>
             </a:extLst>
           </p:cNvPr>
@@ -7082,7 +7082,7 @@
           <p:cNvPr id="10" name="CuadroTexto 9">
             <a:extLst>
               <a:ext uri="{FF2B5EF4-FFF2-40B4-BE49-F238E27FC236}">
-                <a16:creationId xmlns:a16="http://schemas.microsoft.com/office/drawing/2014/main" id="{2F541267-B2E0-D780-2E45-4F992941AE9E}"/>
+                <a16:creationId xmlns:a16="http://schemas.microsoft.com/office/drawing/2014/main" id="{077F98AF-71D3-B7AA-A7BE-7F6AAB5DF75D}"/>
               </a:ext>
             </a:extLst>
           </p:cNvPr>
@@ -7122,7 +7122,7 @@
           <p:cNvPr id="11" name="CuadroTexto 10">
             <a:extLst>
               <a:ext uri="{FF2B5EF4-FFF2-40B4-BE49-F238E27FC236}">
-                <a16:creationId xmlns:a16="http://schemas.microsoft.com/office/drawing/2014/main" id="{1DB4DA62-221D-CA65-54CA-4FD5B8E97F3A}"/>
+                <a16:creationId xmlns:a16="http://schemas.microsoft.com/office/drawing/2014/main" id="{C1E5AB4E-15F6-D17F-8080-4724F36ADDC3}"/>
               </a:ext>
             </a:extLst>
           </p:cNvPr>
@@ -7162,7 +7162,7 @@
           <p:cNvPr id="12" name="CuadroTexto 11">
             <a:extLst>
               <a:ext uri="{FF2B5EF4-FFF2-40B4-BE49-F238E27FC236}">
-                <a16:creationId xmlns:a16="http://schemas.microsoft.com/office/drawing/2014/main" id="{502AC56E-84CB-EED9-95FE-6AB1C6B812B7}"/>
+                <a16:creationId xmlns:a16="http://schemas.microsoft.com/office/drawing/2014/main" id="{780F215D-46DF-AAAC-31BC-41213A603EF7}"/>
               </a:ext>
             </a:extLst>
           </p:cNvPr>
@@ -7243,7 +7243,7 @@
     </p:spTree>
     <p:extLst>
       <p:ext uri="{BB962C8B-B14F-4D97-AF65-F5344CB8AC3E}">
-        <p14:creationId xmlns:p14="http://schemas.microsoft.com/office/powerpoint/2010/main" val="262939549"/>
+        <p14:creationId xmlns:p14="http://schemas.microsoft.com/office/powerpoint/2010/main" val="3246461230"/>
       </p:ext>
     </p:extLst>
   </p:cSld>
@@ -7283,7 +7283,7 @@
           <p:cNvPr id="2" name="CuadroTexto 1">
             <a:extLst>
               <a:ext uri="{FF2B5EF4-FFF2-40B4-BE49-F238E27FC236}">
-                <a16:creationId xmlns:a16="http://schemas.microsoft.com/office/drawing/2014/main" id="{7F633AEB-C8E3-38F3-865A-AEFD904A6358}"/>
+                <a16:creationId xmlns:a16="http://schemas.microsoft.com/office/drawing/2014/main" id="{A4D3AD77-828F-E3E7-87B2-01EBE2689D0E}"/>
               </a:ext>
             </a:extLst>
           </p:cNvPr>
@@ -7323,7 +7323,7 @@
           <p:cNvPr id="3" name="CuadroTexto 2">
             <a:extLst>
               <a:ext uri="{FF2B5EF4-FFF2-40B4-BE49-F238E27FC236}">
-                <a16:creationId xmlns:a16="http://schemas.microsoft.com/office/drawing/2014/main" id="{777637BC-466E-38C8-DFF9-62CA4B5DFA28}"/>
+                <a16:creationId xmlns:a16="http://schemas.microsoft.com/office/drawing/2014/main" id="{99FAC8C5-54BD-E621-AF51-DB21D5D6637F}"/>
               </a:ext>
             </a:extLst>
           </p:cNvPr>
@@ -7363,7 +7363,7 @@
           <p:cNvPr id="4" name="CuadroTexto 3">
             <a:extLst>
               <a:ext uri="{FF2B5EF4-FFF2-40B4-BE49-F238E27FC236}">
-                <a16:creationId xmlns:a16="http://schemas.microsoft.com/office/drawing/2014/main" id="{985A282E-F38E-563B-C79A-5CA90EB7D04B}"/>
+                <a16:creationId xmlns:a16="http://schemas.microsoft.com/office/drawing/2014/main" id="{CC040CF0-AD7D-80D0-B96D-A615BCB8C1AD}"/>
               </a:ext>
             </a:extLst>
           </p:cNvPr>
@@ -7403,7 +7403,7 @@
           <p:cNvPr id="5" name="Rectángulo: esquinas redondeadas 4">
             <a:extLst>
               <a:ext uri="{FF2B5EF4-FFF2-40B4-BE49-F238E27FC236}">
-                <a16:creationId xmlns:a16="http://schemas.microsoft.com/office/drawing/2014/main" id="{332F11A3-16C4-FC00-5D74-A8A2B3FFA522}"/>
+                <a16:creationId xmlns:a16="http://schemas.microsoft.com/office/drawing/2014/main" id="{1F2CF240-B952-37B3-8E06-AA83F789C3B2}"/>
               </a:ext>
             </a:extLst>
           </p:cNvPr>
@@ -7457,7 +7457,7 @@
           <p:cNvPr id="6" name="CuadroTexto 5">
             <a:extLst>
               <a:ext uri="{FF2B5EF4-FFF2-40B4-BE49-F238E27FC236}">
-                <a16:creationId xmlns:a16="http://schemas.microsoft.com/office/drawing/2014/main" id="{571884CA-A07F-3CAE-ACA6-985260681AFC}"/>
+                <a16:creationId xmlns:a16="http://schemas.microsoft.com/office/drawing/2014/main" id="{FDD5E688-21C6-A61A-38ED-F2084F038141}"/>
               </a:ext>
             </a:extLst>
           </p:cNvPr>
@@ -7497,7 +7497,7 @@
           <p:cNvPr id="7" name="CuadroTexto 6">
             <a:extLst>
               <a:ext uri="{FF2B5EF4-FFF2-40B4-BE49-F238E27FC236}">
-                <a16:creationId xmlns:a16="http://schemas.microsoft.com/office/drawing/2014/main" id="{5BE67DF1-0FED-E550-864E-0EE8E8C01831}"/>
+                <a16:creationId xmlns:a16="http://schemas.microsoft.com/office/drawing/2014/main" id="{8EC20374-7D60-B373-5141-2B0E4B57A84A}"/>
               </a:ext>
             </a:extLst>
           </p:cNvPr>
@@ -7537,7 +7537,7 @@
           <p:cNvPr id="8" name="Rectángulo: esquinas redondeadas 7">
             <a:extLst>
               <a:ext uri="{FF2B5EF4-FFF2-40B4-BE49-F238E27FC236}">
-                <a16:creationId xmlns:a16="http://schemas.microsoft.com/office/drawing/2014/main" id="{0811625C-B8C8-7299-3317-0B357D650119}"/>
+                <a16:creationId xmlns:a16="http://schemas.microsoft.com/office/drawing/2014/main" id="{84089369-9A7A-35A8-0D6C-894B25FF9795}"/>
               </a:ext>
             </a:extLst>
           </p:cNvPr>
@@ -7591,7 +7591,7 @@
           <p:cNvPr id="9" name="CuadroTexto 8">
             <a:extLst>
               <a:ext uri="{FF2B5EF4-FFF2-40B4-BE49-F238E27FC236}">
-                <a16:creationId xmlns:a16="http://schemas.microsoft.com/office/drawing/2014/main" id="{856F0306-06DF-7A7F-C7BA-F37512E5D503}"/>
+                <a16:creationId xmlns:a16="http://schemas.microsoft.com/office/drawing/2014/main" id="{EEEC2744-B96F-CF63-628C-0EDA09C77340}"/>
               </a:ext>
             </a:extLst>
           </p:cNvPr>
@@ -7631,7 +7631,7 @@
           <p:cNvPr id="10" name="CuadroTexto 9">
             <a:extLst>
               <a:ext uri="{FF2B5EF4-FFF2-40B4-BE49-F238E27FC236}">
-                <a16:creationId xmlns:a16="http://schemas.microsoft.com/office/drawing/2014/main" id="{4103D061-5808-835F-DCB8-6E26A9B76CEF}"/>
+                <a16:creationId xmlns:a16="http://schemas.microsoft.com/office/drawing/2014/main" id="{81B5DCFA-D205-FAE9-F06F-EE173C4DD4F6}"/>
               </a:ext>
             </a:extLst>
           </p:cNvPr>
@@ -7671,7 +7671,7 @@
           <p:cNvPr id="11" name="Rectángulo: esquinas redondeadas 10">
             <a:extLst>
               <a:ext uri="{FF2B5EF4-FFF2-40B4-BE49-F238E27FC236}">
-                <a16:creationId xmlns:a16="http://schemas.microsoft.com/office/drawing/2014/main" id="{A7B72B3E-DC33-B561-CC44-0AD373119C10}"/>
+                <a16:creationId xmlns:a16="http://schemas.microsoft.com/office/drawing/2014/main" id="{1EA7C88D-9F11-A261-C173-0FE8F14772A8}"/>
               </a:ext>
             </a:extLst>
           </p:cNvPr>
@@ -7725,7 +7725,7 @@
           <p:cNvPr id="12" name="CuadroTexto 11">
             <a:extLst>
               <a:ext uri="{FF2B5EF4-FFF2-40B4-BE49-F238E27FC236}">
-                <a16:creationId xmlns:a16="http://schemas.microsoft.com/office/drawing/2014/main" id="{C7A4A240-D87D-25B5-5C1C-1CD3AF2FF11C}"/>
+                <a16:creationId xmlns:a16="http://schemas.microsoft.com/office/drawing/2014/main" id="{6A9BE991-68D7-7A46-3DAD-348D38562250}"/>
               </a:ext>
             </a:extLst>
           </p:cNvPr>
@@ -7765,7 +7765,7 @@
           <p:cNvPr id="13" name="CuadroTexto 12">
             <a:extLst>
               <a:ext uri="{FF2B5EF4-FFF2-40B4-BE49-F238E27FC236}">
-                <a16:creationId xmlns:a16="http://schemas.microsoft.com/office/drawing/2014/main" id="{3B5F7562-D71C-C0FA-2EFC-422D1BB96241}"/>
+                <a16:creationId xmlns:a16="http://schemas.microsoft.com/office/drawing/2014/main" id="{D336450E-CBEE-21AE-587B-B48FB2B794E0}"/>
               </a:ext>
             </a:extLst>
           </p:cNvPr>
@@ -7795,7 +7795,7 @@
                 </a:solidFill>
                 <a:latin typeface="Segoe UI" panose="020B0502040204020203" pitchFamily="34" charset="0"/>
               </a:rPr>
-              <a:t>Decidir si Agora Desktop absorbe por completo la shell web legacy.</a:t>
+              <a:t>Ampliar Agora Desktop con mas automatizacion y soporte operativo sin mezclarlo con negocio.</a:t>
             </a:r>
           </a:p>
         </p:txBody>
@@ -7805,7 +7805,7 @@
           <p:cNvPr id="14" name="CuadroTexto 13">
             <a:extLst>
               <a:ext uri="{FF2B5EF4-FFF2-40B4-BE49-F238E27FC236}">
-                <a16:creationId xmlns:a16="http://schemas.microsoft.com/office/drawing/2014/main" id="{5AB1583C-3074-97A2-1A5B-18B6057525B1}"/>
+                <a16:creationId xmlns:a16="http://schemas.microsoft.com/office/drawing/2014/main" id="{20BEA9F2-2AD8-C4B1-3F63-38965E41D1ED}"/>
               </a:ext>
             </a:extLst>
           </p:cNvPr>
@@ -7868,7 +7868,7 @@
     </p:spTree>
     <p:extLst>
       <p:ext uri="{BB962C8B-B14F-4D97-AF65-F5344CB8AC3E}">
-        <p14:creationId xmlns:p14="http://schemas.microsoft.com/office/powerpoint/2010/main" val="2899166005"/>
+        <p14:creationId xmlns:p14="http://schemas.microsoft.com/office/powerpoint/2010/main" val="3725548532"/>
       </p:ext>
     </p:extLst>
   </p:cSld>
@@ -7908,7 +7908,7 @@
           <p:cNvPr id="2" name="CuadroTexto 1">
             <a:extLst>
               <a:ext uri="{FF2B5EF4-FFF2-40B4-BE49-F238E27FC236}">
-                <a16:creationId xmlns:a16="http://schemas.microsoft.com/office/drawing/2014/main" id="{CF61135F-580E-C819-0791-91AF2067E3C1}"/>
+                <a16:creationId xmlns:a16="http://schemas.microsoft.com/office/drawing/2014/main" id="{C3DC3612-2058-06AC-93C9-ED0D67262948}"/>
               </a:ext>
             </a:extLst>
           </p:cNvPr>
@@ -7948,7 +7948,7 @@
           <p:cNvPr id="3" name="CuadroTexto 2">
             <a:extLst>
               <a:ext uri="{FF2B5EF4-FFF2-40B4-BE49-F238E27FC236}">
-                <a16:creationId xmlns:a16="http://schemas.microsoft.com/office/drawing/2014/main" id="{7CC7C245-2FAB-4F31-20FE-9FE749563D57}"/>
+                <a16:creationId xmlns:a16="http://schemas.microsoft.com/office/drawing/2014/main" id="{28C40224-81C6-4E36-7D5B-9F21B4FEE17C}"/>
               </a:ext>
             </a:extLst>
           </p:cNvPr>
@@ -7988,7 +7988,7 @@
           <p:cNvPr id="4" name="CuadroTexto 3">
             <a:extLst>
               <a:ext uri="{FF2B5EF4-FFF2-40B4-BE49-F238E27FC236}">
-                <a16:creationId xmlns:a16="http://schemas.microsoft.com/office/drawing/2014/main" id="{357ABC16-AB0D-EE8A-14EF-37E39CD730EF}"/>
+                <a16:creationId xmlns:a16="http://schemas.microsoft.com/office/drawing/2014/main" id="{9B5B60DC-A75D-45BE-804F-BC885F6F4CC1}"/>
               </a:ext>
             </a:extLst>
           </p:cNvPr>
@@ -8107,7 +8107,7 @@
           <p:cNvPr id="5" name="Rectángulo: esquinas redondeadas 4">
             <a:extLst>
               <a:ext uri="{FF2B5EF4-FFF2-40B4-BE49-F238E27FC236}">
-                <a16:creationId xmlns:a16="http://schemas.microsoft.com/office/drawing/2014/main" id="{39999316-951B-5CAB-36C3-24D49FFCF643}"/>
+                <a16:creationId xmlns:a16="http://schemas.microsoft.com/office/drawing/2014/main" id="{648C1DE9-6BD5-EBD7-9950-DAE8920F1FF1}"/>
               </a:ext>
             </a:extLst>
           </p:cNvPr>
@@ -8161,7 +8161,7 @@
           <p:cNvPr id="6" name="CuadroTexto 5">
             <a:extLst>
               <a:ext uri="{FF2B5EF4-FFF2-40B4-BE49-F238E27FC236}">
-                <a16:creationId xmlns:a16="http://schemas.microsoft.com/office/drawing/2014/main" id="{612F9E92-CDB7-87E4-9D52-9B136F4C6443}"/>
+                <a16:creationId xmlns:a16="http://schemas.microsoft.com/office/drawing/2014/main" id="{D36B12BC-610E-1351-D73C-368B4B1AC1CD}"/>
               </a:ext>
             </a:extLst>
           </p:cNvPr>
@@ -8201,7 +8201,7 @@
           <p:cNvPr id="7" name="CuadroTexto 6">
             <a:extLst>
               <a:ext uri="{FF2B5EF4-FFF2-40B4-BE49-F238E27FC236}">
-                <a16:creationId xmlns:a16="http://schemas.microsoft.com/office/drawing/2014/main" id="{1D8153D6-86E3-766B-D147-F91159556FE8}"/>
+                <a16:creationId xmlns:a16="http://schemas.microsoft.com/office/drawing/2014/main" id="{CB1052AB-829B-F3AE-5AE2-1F6026116D3D}"/>
               </a:ext>
             </a:extLst>
           </p:cNvPr>
@@ -8239,7 +8239,7 @@
     </p:spTree>
     <p:extLst>
       <p:ext uri="{BB962C8B-B14F-4D97-AF65-F5344CB8AC3E}">
-        <p14:creationId xmlns:p14="http://schemas.microsoft.com/office/powerpoint/2010/main" val="1501258835"/>
+        <p14:creationId xmlns:p14="http://schemas.microsoft.com/office/powerpoint/2010/main" val="1362884170"/>
       </p:ext>
     </p:extLst>
   </p:cSld>
@@ -8279,7 +8279,7 @@
           <p:cNvPr id="2" name="CuadroTexto 1">
             <a:extLst>
               <a:ext uri="{FF2B5EF4-FFF2-40B4-BE49-F238E27FC236}">
-                <a16:creationId xmlns:a16="http://schemas.microsoft.com/office/drawing/2014/main" id="{0751393D-4816-16A5-E38D-53548AC7220C}"/>
+                <a16:creationId xmlns:a16="http://schemas.microsoft.com/office/drawing/2014/main" id="{BA0FAC90-46C1-F43B-6044-79E44BD0FB48}"/>
               </a:ext>
             </a:extLst>
           </p:cNvPr>
@@ -8319,7 +8319,7 @@
           <p:cNvPr id="3" name="CuadroTexto 2">
             <a:extLst>
               <a:ext uri="{FF2B5EF4-FFF2-40B4-BE49-F238E27FC236}">
-                <a16:creationId xmlns:a16="http://schemas.microsoft.com/office/drawing/2014/main" id="{850BEDA8-F92B-B057-F39D-ADF6E9E10AB3}"/>
+                <a16:creationId xmlns:a16="http://schemas.microsoft.com/office/drawing/2014/main" id="{FBFEF832-13B0-1285-9F0B-8C1528AD7B98}"/>
               </a:ext>
             </a:extLst>
           </p:cNvPr>
@@ -8359,7 +8359,7 @@
           <p:cNvPr id="4" name="CuadroTexto 3">
             <a:extLst>
               <a:ext uri="{FF2B5EF4-FFF2-40B4-BE49-F238E27FC236}">
-                <a16:creationId xmlns:a16="http://schemas.microsoft.com/office/drawing/2014/main" id="{193BA8D5-7A9E-BAE3-A221-878D8AF96B9C}"/>
+                <a16:creationId xmlns:a16="http://schemas.microsoft.com/office/drawing/2014/main" id="{A975764C-8698-FBD2-A0AF-D6D4D70C13B7}"/>
               </a:ext>
             </a:extLst>
           </p:cNvPr>
@@ -8399,7 +8399,7 @@
           <p:cNvPr id="5" name="CuadroTexto 4">
             <a:extLst>
               <a:ext uri="{FF2B5EF4-FFF2-40B4-BE49-F238E27FC236}">
-                <a16:creationId xmlns:a16="http://schemas.microsoft.com/office/drawing/2014/main" id="{35F15734-46C2-69C6-5023-A197B05A5019}"/>
+                <a16:creationId xmlns:a16="http://schemas.microsoft.com/office/drawing/2014/main" id="{A51DC6F8-9DAE-639A-2D06-7950D96433A1}"/>
               </a:ext>
             </a:extLst>
           </p:cNvPr>
@@ -8482,7 +8482,7 @@
           <p:cNvPr id="6" name="CuadroTexto 5">
             <a:extLst>
               <a:ext uri="{FF2B5EF4-FFF2-40B4-BE49-F238E27FC236}">
-                <a16:creationId xmlns:a16="http://schemas.microsoft.com/office/drawing/2014/main" id="{2104C127-2FD0-AE74-977D-4AD83BE56564}"/>
+                <a16:creationId xmlns:a16="http://schemas.microsoft.com/office/drawing/2014/main" id="{D89D9B40-7C2B-6D34-46BD-BA660C281D6C}"/>
               </a:ext>
             </a:extLst>
           </p:cNvPr>
@@ -8520,7 +8520,7 @@
     </p:spTree>
     <p:extLst>
       <p:ext uri="{BB962C8B-B14F-4D97-AF65-F5344CB8AC3E}">
-        <p14:creationId xmlns:p14="http://schemas.microsoft.com/office/powerpoint/2010/main" val="799824649"/>
+        <p14:creationId xmlns:p14="http://schemas.microsoft.com/office/powerpoint/2010/main" val="4157162791"/>
       </p:ext>
     </p:extLst>
   </p:cSld>
@@ -8560,7 +8560,7 @@
           <p:cNvPr id="2" name="CuadroTexto 1">
             <a:extLst>
               <a:ext uri="{FF2B5EF4-FFF2-40B4-BE49-F238E27FC236}">
-                <a16:creationId xmlns:a16="http://schemas.microsoft.com/office/drawing/2014/main" id="{7BC4A996-C0DC-0661-E17E-8ED31D136F34}"/>
+                <a16:creationId xmlns:a16="http://schemas.microsoft.com/office/drawing/2014/main" id="{DDF56AC7-7911-E2BF-6CC8-50571390860A}"/>
               </a:ext>
             </a:extLst>
           </p:cNvPr>
@@ -8600,7 +8600,7 @@
           <p:cNvPr id="3" name="CuadroTexto 2">
             <a:extLst>
               <a:ext uri="{FF2B5EF4-FFF2-40B4-BE49-F238E27FC236}">
-                <a16:creationId xmlns:a16="http://schemas.microsoft.com/office/drawing/2014/main" id="{53D14285-670D-8745-1CD0-505DD2D0BC25}"/>
+                <a16:creationId xmlns:a16="http://schemas.microsoft.com/office/drawing/2014/main" id="{4DACE98E-D820-9E94-C264-77DF6C4CC2D0}"/>
               </a:ext>
             </a:extLst>
           </p:cNvPr>
@@ -8640,7 +8640,7 @@
           <p:cNvPr id="4" name="CuadroTexto 3">
             <a:extLst>
               <a:ext uri="{FF2B5EF4-FFF2-40B4-BE49-F238E27FC236}">
-                <a16:creationId xmlns:a16="http://schemas.microsoft.com/office/drawing/2014/main" id="{3F327E35-6509-576A-0D37-8F7EA77DB923}"/>
+                <a16:creationId xmlns:a16="http://schemas.microsoft.com/office/drawing/2014/main" id="{0E355E7C-61B8-B4B6-062F-AEE7AA8F3A2E}"/>
               </a:ext>
             </a:extLst>
           </p:cNvPr>
@@ -8680,7 +8680,7 @@
           <p:cNvPr id="5" name="CuadroTexto 4">
             <a:extLst>
               <a:ext uri="{FF2B5EF4-FFF2-40B4-BE49-F238E27FC236}">
-                <a16:creationId xmlns:a16="http://schemas.microsoft.com/office/drawing/2014/main" id="{F303F56F-1DE5-334F-E711-665F5FA30246}"/>
+                <a16:creationId xmlns:a16="http://schemas.microsoft.com/office/drawing/2014/main" id="{0C6AFCC8-F7F9-CD3D-7C00-AE222E696E86}"/>
               </a:ext>
             </a:extLst>
           </p:cNvPr>
@@ -8781,7 +8781,7 @@
           <p:cNvPr id="6" name="Rectángulo: esquinas redondeadas 5">
             <a:extLst>
               <a:ext uri="{FF2B5EF4-FFF2-40B4-BE49-F238E27FC236}">
-                <a16:creationId xmlns:a16="http://schemas.microsoft.com/office/drawing/2014/main" id="{17543611-9206-78E5-230B-C3BC42460A5C}"/>
+                <a16:creationId xmlns:a16="http://schemas.microsoft.com/office/drawing/2014/main" id="{36B6F8E0-E615-808A-AE2B-459EA13B7754}"/>
               </a:ext>
             </a:extLst>
           </p:cNvPr>
@@ -8835,7 +8835,7 @@
           <p:cNvPr id="7" name="CuadroTexto 6">
             <a:extLst>
               <a:ext uri="{FF2B5EF4-FFF2-40B4-BE49-F238E27FC236}">
-                <a16:creationId xmlns:a16="http://schemas.microsoft.com/office/drawing/2014/main" id="{F939EC5F-EB7F-DD90-6838-8B99D7D26098}"/>
+                <a16:creationId xmlns:a16="http://schemas.microsoft.com/office/drawing/2014/main" id="{A8189235-ECAA-6164-31A7-4E28D358B8AD}"/>
               </a:ext>
             </a:extLst>
           </p:cNvPr>
@@ -8875,7 +8875,7 @@
           <p:cNvPr id="8" name="CuadroTexto 7">
             <a:extLst>
               <a:ext uri="{FF2B5EF4-FFF2-40B4-BE49-F238E27FC236}">
-                <a16:creationId xmlns:a16="http://schemas.microsoft.com/office/drawing/2014/main" id="{2140C953-3759-A7F5-DAA6-AB2EE8DFC2B6}"/>
+                <a16:creationId xmlns:a16="http://schemas.microsoft.com/office/drawing/2014/main" id="{DDB71B71-AA2A-A750-F9FF-835945CF0CC0}"/>
               </a:ext>
             </a:extLst>
           </p:cNvPr>
@@ -8913,7 +8913,7 @@
     </p:spTree>
     <p:extLst>
       <p:ext uri="{BB962C8B-B14F-4D97-AF65-F5344CB8AC3E}">
-        <p14:creationId xmlns:p14="http://schemas.microsoft.com/office/powerpoint/2010/main" val="2782718717"/>
+        <p14:creationId xmlns:p14="http://schemas.microsoft.com/office/powerpoint/2010/main" val="3731850306"/>
       </p:ext>
     </p:extLst>
   </p:cSld>
@@ -8953,7 +8953,7 @@
           <p:cNvPr id="2" name="CuadroTexto 1">
             <a:extLst>
               <a:ext uri="{FF2B5EF4-FFF2-40B4-BE49-F238E27FC236}">
-                <a16:creationId xmlns:a16="http://schemas.microsoft.com/office/drawing/2014/main" id="{6D860636-5B88-65EB-66C8-525E9B1C5029}"/>
+                <a16:creationId xmlns:a16="http://schemas.microsoft.com/office/drawing/2014/main" id="{6AAB2597-D46F-DC71-2F5D-8B25AD7F5E96}"/>
               </a:ext>
             </a:extLst>
           </p:cNvPr>
@@ -8993,7 +8993,7 @@
           <p:cNvPr id="3" name="CuadroTexto 2">
             <a:extLst>
               <a:ext uri="{FF2B5EF4-FFF2-40B4-BE49-F238E27FC236}">
-                <a16:creationId xmlns:a16="http://schemas.microsoft.com/office/drawing/2014/main" id="{E73E6A14-075B-6C57-E09D-688C309193E6}"/>
+                <a16:creationId xmlns:a16="http://schemas.microsoft.com/office/drawing/2014/main" id="{5B0BFD7C-8183-3CF0-551B-72C4115A75D0}"/>
               </a:ext>
             </a:extLst>
           </p:cNvPr>
@@ -9033,7 +9033,7 @@
           <p:cNvPr id="4" name="Rectángulo: esquinas redondeadas 3">
             <a:extLst>
               <a:ext uri="{FF2B5EF4-FFF2-40B4-BE49-F238E27FC236}">
-                <a16:creationId xmlns:a16="http://schemas.microsoft.com/office/drawing/2014/main" id="{07AF75E8-38D7-18EA-3A3F-1E7C53957F73}"/>
+                <a16:creationId xmlns:a16="http://schemas.microsoft.com/office/drawing/2014/main" id="{5ACFF23C-810F-5790-7D24-C53279CEBFB7}"/>
               </a:ext>
             </a:extLst>
           </p:cNvPr>
@@ -9087,7 +9087,7 @@
           <p:cNvPr id="5" name="CuadroTexto 4">
             <a:extLst>
               <a:ext uri="{FF2B5EF4-FFF2-40B4-BE49-F238E27FC236}">
-                <a16:creationId xmlns:a16="http://schemas.microsoft.com/office/drawing/2014/main" id="{F952830A-94B6-5754-B734-F9BBA633C170}"/>
+                <a16:creationId xmlns:a16="http://schemas.microsoft.com/office/drawing/2014/main" id="{5FB3D499-5187-1BDF-4588-99C5D6332F04}"/>
               </a:ext>
             </a:extLst>
           </p:cNvPr>
@@ -9127,7 +9127,7 @@
           <p:cNvPr id="6" name="CuadroTexto 5">
             <a:extLst>
               <a:ext uri="{FF2B5EF4-FFF2-40B4-BE49-F238E27FC236}">
-                <a16:creationId xmlns:a16="http://schemas.microsoft.com/office/drawing/2014/main" id="{4352CCE7-B113-CDC9-3A6B-DB1FC63637ED}"/>
+                <a16:creationId xmlns:a16="http://schemas.microsoft.com/office/drawing/2014/main" id="{A90DAC83-A0C8-BD46-CF8F-8FCE3D48137D}"/>
               </a:ext>
             </a:extLst>
           </p:cNvPr>
@@ -9167,7 +9167,7 @@
           <p:cNvPr id="7" name="Rectángulo: esquinas redondeadas 6">
             <a:extLst>
               <a:ext uri="{FF2B5EF4-FFF2-40B4-BE49-F238E27FC236}">
-                <a16:creationId xmlns:a16="http://schemas.microsoft.com/office/drawing/2014/main" id="{EBFD86C3-8FE0-F47C-76BF-F5F3DA212EC3}"/>
+                <a16:creationId xmlns:a16="http://schemas.microsoft.com/office/drawing/2014/main" id="{91CAEE8A-4BB9-F904-5B9C-2A8358F24A0C}"/>
               </a:ext>
             </a:extLst>
           </p:cNvPr>
@@ -9221,7 +9221,7 @@
           <p:cNvPr id="8" name="CuadroTexto 7">
             <a:extLst>
               <a:ext uri="{FF2B5EF4-FFF2-40B4-BE49-F238E27FC236}">
-                <a16:creationId xmlns:a16="http://schemas.microsoft.com/office/drawing/2014/main" id="{6DA1BC90-8ADD-C160-177E-BDFDF9BF41D7}"/>
+                <a16:creationId xmlns:a16="http://schemas.microsoft.com/office/drawing/2014/main" id="{989F4701-DED3-63D5-604F-BD99DA9C461F}"/>
               </a:ext>
             </a:extLst>
           </p:cNvPr>
@@ -9261,7 +9261,7 @@
           <p:cNvPr id="9" name="CuadroTexto 8">
             <a:extLst>
               <a:ext uri="{FF2B5EF4-FFF2-40B4-BE49-F238E27FC236}">
-                <a16:creationId xmlns:a16="http://schemas.microsoft.com/office/drawing/2014/main" id="{CF218EFD-8AC8-6D5D-514C-DDFA96414C7B}"/>
+                <a16:creationId xmlns:a16="http://schemas.microsoft.com/office/drawing/2014/main" id="{59E830CB-5452-93D8-1B37-4A6C6438CD90}"/>
               </a:ext>
             </a:extLst>
           </p:cNvPr>
@@ -9301,7 +9301,7 @@
           <p:cNvPr id="10" name="Rectángulo: esquinas redondeadas 9">
             <a:extLst>
               <a:ext uri="{FF2B5EF4-FFF2-40B4-BE49-F238E27FC236}">
-                <a16:creationId xmlns:a16="http://schemas.microsoft.com/office/drawing/2014/main" id="{67EC4629-F2E7-0F54-0CF6-7300799CA813}"/>
+                <a16:creationId xmlns:a16="http://schemas.microsoft.com/office/drawing/2014/main" id="{2D6F1CA5-94D8-2603-631E-BD4AC7C7EBD1}"/>
               </a:ext>
             </a:extLst>
           </p:cNvPr>
@@ -9355,7 +9355,7 @@
           <p:cNvPr id="11" name="CuadroTexto 10">
             <a:extLst>
               <a:ext uri="{FF2B5EF4-FFF2-40B4-BE49-F238E27FC236}">
-                <a16:creationId xmlns:a16="http://schemas.microsoft.com/office/drawing/2014/main" id="{46F8E751-6AB2-7BE2-E9EF-0168332DF2AC}"/>
+                <a16:creationId xmlns:a16="http://schemas.microsoft.com/office/drawing/2014/main" id="{3A663033-27A2-3610-6B2D-7F359410D3C7}"/>
               </a:ext>
             </a:extLst>
           </p:cNvPr>
@@ -9395,7 +9395,7 @@
           <p:cNvPr id="12" name="CuadroTexto 11">
             <a:extLst>
               <a:ext uri="{FF2B5EF4-FFF2-40B4-BE49-F238E27FC236}">
-                <a16:creationId xmlns:a16="http://schemas.microsoft.com/office/drawing/2014/main" id="{D234A87B-E86D-5B5C-9A5A-B4AC9EC2DA71}"/>
+                <a16:creationId xmlns:a16="http://schemas.microsoft.com/office/drawing/2014/main" id="{5CC91123-17E1-FCBA-E28D-24E2E13D265D}"/>
               </a:ext>
             </a:extLst>
           </p:cNvPr>
@@ -9435,7 +9435,7 @@
           <p:cNvPr id="13" name="Rectángulo: esquinas redondeadas 12">
             <a:extLst>
               <a:ext uri="{FF2B5EF4-FFF2-40B4-BE49-F238E27FC236}">
-                <a16:creationId xmlns:a16="http://schemas.microsoft.com/office/drawing/2014/main" id="{D42F7469-EE53-A828-98A4-3CF2E1277762}"/>
+                <a16:creationId xmlns:a16="http://schemas.microsoft.com/office/drawing/2014/main" id="{B5DB876D-AC76-BBF4-BA80-FB66462E361B}"/>
               </a:ext>
             </a:extLst>
           </p:cNvPr>
@@ -9489,7 +9489,7 @@
           <p:cNvPr id="14" name="CuadroTexto 13">
             <a:extLst>
               <a:ext uri="{FF2B5EF4-FFF2-40B4-BE49-F238E27FC236}">
-                <a16:creationId xmlns:a16="http://schemas.microsoft.com/office/drawing/2014/main" id="{F60BBF21-3D4D-94FA-3519-4D64AAC54A71}"/>
+                <a16:creationId xmlns:a16="http://schemas.microsoft.com/office/drawing/2014/main" id="{7F44A214-6240-E986-C66F-ECF824B30C93}"/>
               </a:ext>
             </a:extLst>
           </p:cNvPr>
@@ -9529,7 +9529,7 @@
           <p:cNvPr id="15" name="CuadroTexto 14">
             <a:extLst>
               <a:ext uri="{FF2B5EF4-FFF2-40B4-BE49-F238E27FC236}">
-                <a16:creationId xmlns:a16="http://schemas.microsoft.com/office/drawing/2014/main" id="{4D56B5AF-74E7-D2F9-212A-B052B5521A6F}"/>
+                <a16:creationId xmlns:a16="http://schemas.microsoft.com/office/drawing/2014/main" id="{610B48E6-11A1-611D-CE0A-7C67FBD0FDAF}"/>
               </a:ext>
             </a:extLst>
           </p:cNvPr>
@@ -9567,7 +9567,7 @@
     </p:spTree>
     <p:extLst>
       <p:ext uri="{BB962C8B-B14F-4D97-AF65-F5344CB8AC3E}">
-        <p14:creationId xmlns:p14="http://schemas.microsoft.com/office/powerpoint/2010/main" val="2920862296"/>
+        <p14:creationId xmlns:p14="http://schemas.microsoft.com/office/powerpoint/2010/main" val="2054924816"/>
       </p:ext>
     </p:extLst>
   </p:cSld>
@@ -9607,7 +9607,7 @@
           <p:cNvPr id="2" name="CuadroTexto 1">
             <a:extLst>
               <a:ext uri="{FF2B5EF4-FFF2-40B4-BE49-F238E27FC236}">
-                <a16:creationId xmlns:a16="http://schemas.microsoft.com/office/drawing/2014/main" id="{928A9E5C-1A80-0CAB-CDFE-C6322207A13A}"/>
+                <a16:creationId xmlns:a16="http://schemas.microsoft.com/office/drawing/2014/main" id="{B00CF1E5-9882-84D1-A36B-F9975948F1C6}"/>
               </a:ext>
             </a:extLst>
           </p:cNvPr>
@@ -9647,7 +9647,7 @@
           <p:cNvPr id="3" name="CuadroTexto 2">
             <a:extLst>
               <a:ext uri="{FF2B5EF4-FFF2-40B4-BE49-F238E27FC236}">
-                <a16:creationId xmlns:a16="http://schemas.microsoft.com/office/drawing/2014/main" id="{796BA637-4BC9-9863-06B2-643CF9089114}"/>
+                <a16:creationId xmlns:a16="http://schemas.microsoft.com/office/drawing/2014/main" id="{1B084417-75B2-1CA6-8C4F-EDF1A9BF7DBA}"/>
               </a:ext>
             </a:extLst>
           </p:cNvPr>
@@ -9687,7 +9687,7 @@
           <p:cNvPr id="4" name="CuadroTexto 3">
             <a:extLst>
               <a:ext uri="{FF2B5EF4-FFF2-40B4-BE49-F238E27FC236}">
-                <a16:creationId xmlns:a16="http://schemas.microsoft.com/office/drawing/2014/main" id="{F3E28275-3FDB-C476-1898-8C59DA2BEAD2}"/>
+                <a16:creationId xmlns:a16="http://schemas.microsoft.com/office/drawing/2014/main" id="{2314A682-2146-998E-587D-E8B92A72BFEC}"/>
               </a:ext>
             </a:extLst>
           </p:cNvPr>
@@ -9727,7 +9727,7 @@
           <p:cNvPr id="6" name="Imagen 5">
             <a:extLst>
               <a:ext uri="{FF2B5EF4-FFF2-40B4-BE49-F238E27FC236}">
-                <a16:creationId xmlns:a16="http://schemas.microsoft.com/office/drawing/2014/main" id="{CC39E8F7-737C-9985-4F61-E7041E46D350}"/>
+                <a16:creationId xmlns:a16="http://schemas.microsoft.com/office/drawing/2014/main" id="{3C9AB106-711F-8883-918A-0B752336D248}"/>
               </a:ext>
             </a:extLst>
           </p:cNvPr>
@@ -9750,8 +9750,8 @@
         </p:blipFill>
         <p:spPr>
           <a:xfrm>
-            <a:off x="812022" y="2006600"/>
-            <a:ext cx="6427756" cy="3937000"/>
+            <a:off x="787400" y="2196774"/>
+            <a:ext cx="6477000" cy="3556652"/>
           </a:xfrm>
           <a:prstGeom prst="rect">
             <a:avLst/>
@@ -9768,7 +9768,7 @@
           <p:cNvPr id="7" name="CuadroTexto 6">
             <a:extLst>
               <a:ext uri="{FF2B5EF4-FFF2-40B4-BE49-F238E27FC236}">
-                <a16:creationId xmlns:a16="http://schemas.microsoft.com/office/drawing/2014/main" id="{912DDBBC-7C3C-A465-43FB-7E293FA4767D}"/>
+                <a16:creationId xmlns:a16="http://schemas.microsoft.com/office/drawing/2014/main" id="{BFF87F8D-632E-0E66-12F6-BCED179951DD}"/>
               </a:ext>
             </a:extLst>
           </p:cNvPr>
@@ -9885,7 +9885,7 @@
     </p:spTree>
     <p:extLst>
       <p:ext uri="{BB962C8B-B14F-4D97-AF65-F5344CB8AC3E}">
-        <p14:creationId xmlns:p14="http://schemas.microsoft.com/office/powerpoint/2010/main" val="1820082989"/>
+        <p14:creationId xmlns:p14="http://schemas.microsoft.com/office/powerpoint/2010/main" val="1561485036"/>
       </p:ext>
     </p:extLst>
   </p:cSld>
@@ -9925,7 +9925,7 @@
           <p:cNvPr id="2" name="CuadroTexto 1">
             <a:extLst>
               <a:ext uri="{FF2B5EF4-FFF2-40B4-BE49-F238E27FC236}">
-                <a16:creationId xmlns:a16="http://schemas.microsoft.com/office/drawing/2014/main" id="{7FEB5C7E-1CD1-8EAE-8422-6816165B0386}"/>
+                <a16:creationId xmlns:a16="http://schemas.microsoft.com/office/drawing/2014/main" id="{73CF5C9E-9ECB-3DD5-6D4F-A407C7C0ED49}"/>
               </a:ext>
             </a:extLst>
           </p:cNvPr>
@@ -9965,7 +9965,7 @@
           <p:cNvPr id="3" name="CuadroTexto 2">
             <a:extLst>
               <a:ext uri="{FF2B5EF4-FFF2-40B4-BE49-F238E27FC236}">
-                <a16:creationId xmlns:a16="http://schemas.microsoft.com/office/drawing/2014/main" id="{2A721D04-6A57-D719-681A-DB43A374A36C}"/>
+                <a16:creationId xmlns:a16="http://schemas.microsoft.com/office/drawing/2014/main" id="{0491214E-0C65-5F9E-16EE-1A317A0FB4E8}"/>
               </a:ext>
             </a:extLst>
           </p:cNvPr>
@@ -10005,7 +10005,7 @@
           <p:cNvPr id="5" name="Imagen 4">
             <a:extLst>
               <a:ext uri="{FF2B5EF4-FFF2-40B4-BE49-F238E27FC236}">
-                <a16:creationId xmlns:a16="http://schemas.microsoft.com/office/drawing/2014/main" id="{5249F826-C292-4ED7-2FEF-1A71CFC9B977}"/>
+                <a16:creationId xmlns:a16="http://schemas.microsoft.com/office/drawing/2014/main" id="{DAE1B80D-AE78-6905-6235-AB2486E053B4}"/>
               </a:ext>
             </a:extLst>
           </p:cNvPr>
@@ -10046,7 +10046,7 @@
           <p:cNvPr id="6" name="CuadroTexto 5">
             <a:extLst>
               <a:ext uri="{FF2B5EF4-FFF2-40B4-BE49-F238E27FC236}">
-                <a16:creationId xmlns:a16="http://schemas.microsoft.com/office/drawing/2014/main" id="{16D37AAB-DA47-E103-DC95-339465F7F373}"/>
+                <a16:creationId xmlns:a16="http://schemas.microsoft.com/office/drawing/2014/main" id="{FE454F16-1D60-5900-7AD6-BD4EEB8BB38D}"/>
               </a:ext>
             </a:extLst>
           </p:cNvPr>
@@ -10086,7 +10086,7 @@
           <p:cNvPr id="7" name="CuadroTexto 6">
             <a:extLst>
               <a:ext uri="{FF2B5EF4-FFF2-40B4-BE49-F238E27FC236}">
-                <a16:creationId xmlns:a16="http://schemas.microsoft.com/office/drawing/2014/main" id="{1EB8936E-9522-D541-2858-EEF4AFA6CBBB}"/>
+                <a16:creationId xmlns:a16="http://schemas.microsoft.com/office/drawing/2014/main" id="{93694235-5164-8076-25CE-63B5F4A19767}"/>
               </a:ext>
             </a:extLst>
           </p:cNvPr>
@@ -10185,7 +10185,7 @@
     </p:spTree>
     <p:extLst>
       <p:ext uri="{BB962C8B-B14F-4D97-AF65-F5344CB8AC3E}">
-        <p14:creationId xmlns:p14="http://schemas.microsoft.com/office/powerpoint/2010/main" val="1695852921"/>
+        <p14:creationId xmlns:p14="http://schemas.microsoft.com/office/powerpoint/2010/main" val="2548476343"/>
       </p:ext>
     </p:extLst>
   </p:cSld>
@@ -10225,7 +10225,7 @@
           <p:cNvPr id="2" name="CuadroTexto 1">
             <a:extLst>
               <a:ext uri="{FF2B5EF4-FFF2-40B4-BE49-F238E27FC236}">
-                <a16:creationId xmlns:a16="http://schemas.microsoft.com/office/drawing/2014/main" id="{1A9E1F0B-BDF1-4C18-FA1E-DBB85328D07A}"/>
+                <a16:creationId xmlns:a16="http://schemas.microsoft.com/office/drawing/2014/main" id="{4CCBF99B-D613-FA12-9C8A-6D8075887DF4}"/>
               </a:ext>
             </a:extLst>
           </p:cNvPr>
@@ -10265,7 +10265,7 @@
           <p:cNvPr id="3" name="CuadroTexto 2">
             <a:extLst>
               <a:ext uri="{FF2B5EF4-FFF2-40B4-BE49-F238E27FC236}">
-                <a16:creationId xmlns:a16="http://schemas.microsoft.com/office/drawing/2014/main" id="{39928138-6B23-8A2C-7358-B7535E8F0854}"/>
+                <a16:creationId xmlns:a16="http://schemas.microsoft.com/office/drawing/2014/main" id="{243A3967-F235-BEB6-A9A9-0C204031D56C}"/>
               </a:ext>
             </a:extLst>
           </p:cNvPr>
@@ -10305,7 +10305,7 @@
           <p:cNvPr id="4" name="CuadroTexto 3">
             <a:extLst>
               <a:ext uri="{FF2B5EF4-FFF2-40B4-BE49-F238E27FC236}">
-                <a16:creationId xmlns:a16="http://schemas.microsoft.com/office/drawing/2014/main" id="{7AABE39B-449B-8D65-C4D7-25CEE13E48F6}"/>
+                <a16:creationId xmlns:a16="http://schemas.microsoft.com/office/drawing/2014/main" id="{75B1EF6C-E4F6-9647-687F-3CA25CCEDA32}"/>
               </a:ext>
             </a:extLst>
           </p:cNvPr>
@@ -10345,7 +10345,7 @@
           <p:cNvPr id="6" name="Imagen 5">
             <a:extLst>
               <a:ext uri="{FF2B5EF4-FFF2-40B4-BE49-F238E27FC236}">
-                <a16:creationId xmlns:a16="http://schemas.microsoft.com/office/drawing/2014/main" id="{8C45D29C-D2B7-5774-D729-E54533DB20B2}"/>
+                <a16:creationId xmlns:a16="http://schemas.microsoft.com/office/drawing/2014/main" id="{0C4C337B-4936-585C-0416-47FA306F1B16}"/>
               </a:ext>
             </a:extLst>
           </p:cNvPr>
@@ -10386,7 +10386,7 @@
           <p:cNvPr id="7" name="Rectángulo: esquinas redondeadas 6">
             <a:extLst>
               <a:ext uri="{FF2B5EF4-FFF2-40B4-BE49-F238E27FC236}">
-                <a16:creationId xmlns:a16="http://schemas.microsoft.com/office/drawing/2014/main" id="{36C118CA-7706-AA24-4B94-3CA0DAFB12A2}"/>
+                <a16:creationId xmlns:a16="http://schemas.microsoft.com/office/drawing/2014/main" id="{95311EDC-1A2C-CDBE-CECF-C96DC6623FE5}"/>
               </a:ext>
             </a:extLst>
           </p:cNvPr>
@@ -10440,7 +10440,7 @@
           <p:cNvPr id="8" name="CuadroTexto 7">
             <a:extLst>
               <a:ext uri="{FF2B5EF4-FFF2-40B4-BE49-F238E27FC236}">
-                <a16:creationId xmlns:a16="http://schemas.microsoft.com/office/drawing/2014/main" id="{A0FF7F01-F678-7332-D01A-A4E9C34AFC55}"/>
+                <a16:creationId xmlns:a16="http://schemas.microsoft.com/office/drawing/2014/main" id="{8DD254F0-0569-7FA3-77EB-BAA24FF8113D}"/>
               </a:ext>
             </a:extLst>
           </p:cNvPr>
@@ -10480,7 +10480,7 @@
           <p:cNvPr id="9" name="CuadroTexto 8">
             <a:extLst>
               <a:ext uri="{FF2B5EF4-FFF2-40B4-BE49-F238E27FC236}">
-                <a16:creationId xmlns:a16="http://schemas.microsoft.com/office/drawing/2014/main" id="{E281DD0F-E1B5-A30A-6FEE-E6609C36C48F}"/>
+                <a16:creationId xmlns:a16="http://schemas.microsoft.com/office/drawing/2014/main" id="{634E3904-911B-D57D-4B7B-A09895F73D32}"/>
               </a:ext>
             </a:extLst>
           </p:cNvPr>
@@ -10520,7 +10520,7 @@
           <p:cNvPr id="10" name="Rectángulo: esquinas redondeadas 9">
             <a:extLst>
               <a:ext uri="{FF2B5EF4-FFF2-40B4-BE49-F238E27FC236}">
-                <a16:creationId xmlns:a16="http://schemas.microsoft.com/office/drawing/2014/main" id="{592470D7-DB12-70A1-8C2C-634DFFF87A3D}"/>
+                <a16:creationId xmlns:a16="http://schemas.microsoft.com/office/drawing/2014/main" id="{8AE624A3-0614-02E0-0F30-1AE23EB98776}"/>
               </a:ext>
             </a:extLst>
           </p:cNvPr>
@@ -10574,7 +10574,7 @@
           <p:cNvPr id="11" name="CuadroTexto 10">
             <a:extLst>
               <a:ext uri="{FF2B5EF4-FFF2-40B4-BE49-F238E27FC236}">
-                <a16:creationId xmlns:a16="http://schemas.microsoft.com/office/drawing/2014/main" id="{BB9A8C2D-2C15-65D6-34F4-EFF35D086C9D}"/>
+                <a16:creationId xmlns:a16="http://schemas.microsoft.com/office/drawing/2014/main" id="{93DBD568-99F4-558D-B372-3422623ED7F5}"/>
               </a:ext>
             </a:extLst>
           </p:cNvPr>
@@ -10614,7 +10614,7 @@
           <p:cNvPr id="12" name="CuadroTexto 11">
             <a:extLst>
               <a:ext uri="{FF2B5EF4-FFF2-40B4-BE49-F238E27FC236}">
-                <a16:creationId xmlns:a16="http://schemas.microsoft.com/office/drawing/2014/main" id="{8BCEFA69-B51E-6BDA-ADD9-96914115396A}"/>
+                <a16:creationId xmlns:a16="http://schemas.microsoft.com/office/drawing/2014/main" id="{B9792F97-BD91-8F4B-B7E6-2A7A2B088498}"/>
               </a:ext>
             </a:extLst>
           </p:cNvPr>
@@ -10654,7 +10654,7 @@
           <p:cNvPr id="13" name="Rectángulo: esquinas redondeadas 12">
             <a:extLst>
               <a:ext uri="{FF2B5EF4-FFF2-40B4-BE49-F238E27FC236}">
-                <a16:creationId xmlns:a16="http://schemas.microsoft.com/office/drawing/2014/main" id="{CDECFDD1-B17D-1525-32F1-FB7E618F070B}"/>
+                <a16:creationId xmlns:a16="http://schemas.microsoft.com/office/drawing/2014/main" id="{A96305F9-22DA-CECB-E7E2-F1D4752C8E88}"/>
               </a:ext>
             </a:extLst>
           </p:cNvPr>
@@ -10708,7 +10708,7 @@
           <p:cNvPr id="14" name="CuadroTexto 13">
             <a:extLst>
               <a:ext uri="{FF2B5EF4-FFF2-40B4-BE49-F238E27FC236}">
-                <a16:creationId xmlns:a16="http://schemas.microsoft.com/office/drawing/2014/main" id="{342B069A-FED2-C970-BDFF-4266530C47B1}"/>
+                <a16:creationId xmlns:a16="http://schemas.microsoft.com/office/drawing/2014/main" id="{A3036D62-8AF8-71F6-7714-3D71EF962E77}"/>
               </a:ext>
             </a:extLst>
           </p:cNvPr>
@@ -10748,7 +10748,7 @@
           <p:cNvPr id="15" name="CuadroTexto 14">
             <a:extLst>
               <a:ext uri="{FF2B5EF4-FFF2-40B4-BE49-F238E27FC236}">
-                <a16:creationId xmlns:a16="http://schemas.microsoft.com/office/drawing/2014/main" id="{0344A2AC-07E9-1E86-FAE7-94698EE3F95A}"/>
+                <a16:creationId xmlns:a16="http://schemas.microsoft.com/office/drawing/2014/main" id="{FE26A294-69A6-3EA2-CDFC-AEDCBFB4FE72}"/>
               </a:ext>
             </a:extLst>
           </p:cNvPr>
@@ -10786,7 +10786,7 @@
     </p:spTree>
     <p:extLst>
       <p:ext uri="{BB962C8B-B14F-4D97-AF65-F5344CB8AC3E}">
-        <p14:creationId xmlns:p14="http://schemas.microsoft.com/office/powerpoint/2010/main" val="444641734"/>
+        <p14:creationId xmlns:p14="http://schemas.microsoft.com/office/powerpoint/2010/main" val="682710152"/>
       </p:ext>
     </p:extLst>
   </p:cSld>
@@ -10826,7 +10826,7 @@
           <p:cNvPr id="2" name="CuadroTexto 1">
             <a:extLst>
               <a:ext uri="{FF2B5EF4-FFF2-40B4-BE49-F238E27FC236}">
-                <a16:creationId xmlns:a16="http://schemas.microsoft.com/office/drawing/2014/main" id="{6CE89E96-8080-E632-7DF5-66335AFC344D}"/>
+                <a16:creationId xmlns:a16="http://schemas.microsoft.com/office/drawing/2014/main" id="{C8526C7C-7F36-1F36-B098-CEBCE3916988}"/>
               </a:ext>
             </a:extLst>
           </p:cNvPr>
@@ -10866,7 +10866,7 @@
           <p:cNvPr id="3" name="CuadroTexto 2">
             <a:extLst>
               <a:ext uri="{FF2B5EF4-FFF2-40B4-BE49-F238E27FC236}">
-                <a16:creationId xmlns:a16="http://schemas.microsoft.com/office/drawing/2014/main" id="{73E058A5-6A40-A02A-622D-78A676D3D767}"/>
+                <a16:creationId xmlns:a16="http://schemas.microsoft.com/office/drawing/2014/main" id="{1BF120A3-159A-D241-747C-B27F5AF2C4F7}"/>
               </a:ext>
             </a:extLst>
           </p:cNvPr>
@@ -10906,7 +10906,7 @@
           <p:cNvPr id="5" name="Imagen 4">
             <a:extLst>
               <a:ext uri="{FF2B5EF4-FFF2-40B4-BE49-F238E27FC236}">
-                <a16:creationId xmlns:a16="http://schemas.microsoft.com/office/drawing/2014/main" id="{63C7D728-633E-1564-7E9C-6BAEC3FE609E}"/>
+                <a16:creationId xmlns:a16="http://schemas.microsoft.com/office/drawing/2014/main" id="{BF10EABB-4CE5-12E1-2136-83BB85DEC781}"/>
               </a:ext>
             </a:extLst>
           </p:cNvPr>
@@ -10947,7 +10947,7 @@
           <p:cNvPr id="6" name="CuadroTexto 5">
             <a:extLst>
               <a:ext uri="{FF2B5EF4-FFF2-40B4-BE49-F238E27FC236}">
-                <a16:creationId xmlns:a16="http://schemas.microsoft.com/office/drawing/2014/main" id="{5715EE4E-A1C6-1C3D-CE17-162C1B0133F9}"/>
+                <a16:creationId xmlns:a16="http://schemas.microsoft.com/office/drawing/2014/main" id="{CD1F0883-D8B9-2E22-202D-0A67982F9561}"/>
               </a:ext>
             </a:extLst>
           </p:cNvPr>
@@ -11046,7 +11046,7 @@
     </p:spTree>
     <p:extLst>
       <p:ext uri="{BB962C8B-B14F-4D97-AF65-F5344CB8AC3E}">
-        <p14:creationId xmlns:p14="http://schemas.microsoft.com/office/powerpoint/2010/main" val="1844937628"/>
+        <p14:creationId xmlns:p14="http://schemas.microsoft.com/office/powerpoint/2010/main" val="2840323761"/>
       </p:ext>
     </p:extLst>
   </p:cSld>
@@ -11086,7 +11086,7 @@
           <p:cNvPr id="2" name="CuadroTexto 1">
             <a:extLst>
               <a:ext uri="{FF2B5EF4-FFF2-40B4-BE49-F238E27FC236}">
-                <a16:creationId xmlns:a16="http://schemas.microsoft.com/office/drawing/2014/main" id="{4D154D3C-0CC9-334A-8C60-D074F7E3F248}"/>
+                <a16:creationId xmlns:a16="http://schemas.microsoft.com/office/drawing/2014/main" id="{D90B48C7-75E2-7233-F8AA-29C8EEBDAEB1}"/>
               </a:ext>
             </a:extLst>
           </p:cNvPr>
@@ -11126,7 +11126,7 @@
           <p:cNvPr id="3" name="CuadroTexto 2">
             <a:extLst>
               <a:ext uri="{FF2B5EF4-FFF2-40B4-BE49-F238E27FC236}">
-                <a16:creationId xmlns:a16="http://schemas.microsoft.com/office/drawing/2014/main" id="{057691EC-32BD-3270-563E-C99F26EC5CDB}"/>
+                <a16:creationId xmlns:a16="http://schemas.microsoft.com/office/drawing/2014/main" id="{1A9766DC-1F20-1D12-E634-CE6B986FF7BB}"/>
               </a:ext>
             </a:extLst>
           </p:cNvPr>
@@ -11166,7 +11166,7 @@
           <p:cNvPr id="4" name="CuadroTexto 3">
             <a:extLst>
               <a:ext uri="{FF2B5EF4-FFF2-40B4-BE49-F238E27FC236}">
-                <a16:creationId xmlns:a16="http://schemas.microsoft.com/office/drawing/2014/main" id="{B2B226B4-6E16-EF50-554E-5E2D3FEC44DD}"/>
+                <a16:creationId xmlns:a16="http://schemas.microsoft.com/office/drawing/2014/main" id="{86B4A59F-FEE4-F93D-75F8-DF07877C923E}"/>
               </a:ext>
             </a:extLst>
           </p:cNvPr>
@@ -11206,7 +11206,7 @@
           <p:cNvPr id="6" name="Imagen 5">
             <a:extLst>
               <a:ext uri="{FF2B5EF4-FFF2-40B4-BE49-F238E27FC236}">
-                <a16:creationId xmlns:a16="http://schemas.microsoft.com/office/drawing/2014/main" id="{098F6E69-6ADB-CD03-7C1D-43010B0BB91E}"/>
+                <a16:creationId xmlns:a16="http://schemas.microsoft.com/office/drawing/2014/main" id="{255106AF-20D9-DF0B-FDD5-2C136CBA7427}"/>
               </a:ext>
             </a:extLst>
           </p:cNvPr>
@@ -11247,7 +11247,7 @@
           <p:cNvPr id="7" name="Rectángulo: esquinas redondeadas 6">
             <a:extLst>
               <a:ext uri="{FF2B5EF4-FFF2-40B4-BE49-F238E27FC236}">
-                <a16:creationId xmlns:a16="http://schemas.microsoft.com/office/drawing/2014/main" id="{570AADC6-9A6A-D148-5E95-7C44264CAD7C}"/>
+                <a16:creationId xmlns:a16="http://schemas.microsoft.com/office/drawing/2014/main" id="{5202FD18-0355-7146-3EBE-A846FBAC2C23}"/>
               </a:ext>
             </a:extLst>
           </p:cNvPr>
@@ -11301,7 +11301,7 @@
           <p:cNvPr id="8" name="CuadroTexto 7">
             <a:extLst>
               <a:ext uri="{FF2B5EF4-FFF2-40B4-BE49-F238E27FC236}">
-                <a16:creationId xmlns:a16="http://schemas.microsoft.com/office/drawing/2014/main" id="{923DD8F0-9855-49F5-BE46-AC1BFDD9BF08}"/>
+                <a16:creationId xmlns:a16="http://schemas.microsoft.com/office/drawing/2014/main" id="{C96D24EC-4409-1E20-190F-4FC7BDC4705F}"/>
               </a:ext>
             </a:extLst>
           </p:cNvPr>
@@ -11341,7 +11341,7 @@
           <p:cNvPr id="9" name="CuadroTexto 8">
             <a:extLst>
               <a:ext uri="{FF2B5EF4-FFF2-40B4-BE49-F238E27FC236}">
-                <a16:creationId xmlns:a16="http://schemas.microsoft.com/office/drawing/2014/main" id="{48AA1450-6C4C-3BBC-C570-3F75D447FE05}"/>
+                <a16:creationId xmlns:a16="http://schemas.microsoft.com/office/drawing/2014/main" id="{1D793C89-ECDB-35EC-F819-FEB290F7A142}"/>
               </a:ext>
             </a:extLst>
           </p:cNvPr>
@@ -11379,7 +11379,7 @@
     </p:spTree>
     <p:extLst>
       <p:ext uri="{BB962C8B-B14F-4D97-AF65-F5344CB8AC3E}">
-        <p14:creationId xmlns:p14="http://schemas.microsoft.com/office/powerpoint/2010/main" val="1123479016"/>
+        <p14:creationId xmlns:p14="http://schemas.microsoft.com/office/powerpoint/2010/main" val="236568225"/>
       </p:ext>
     </p:extLst>
   </p:cSld>
@@ -11419,7 +11419,7 @@
           <p:cNvPr id="2" name="CuadroTexto 1">
             <a:extLst>
               <a:ext uri="{FF2B5EF4-FFF2-40B4-BE49-F238E27FC236}">
-                <a16:creationId xmlns:a16="http://schemas.microsoft.com/office/drawing/2014/main" id="{64968A2A-D52D-6028-C97A-6F360F1AA37B}"/>
+                <a16:creationId xmlns:a16="http://schemas.microsoft.com/office/drawing/2014/main" id="{8E8FE010-8AAF-D77A-6FE3-A432594F744F}"/>
               </a:ext>
             </a:extLst>
           </p:cNvPr>
@@ -11459,7 +11459,7 @@
           <p:cNvPr id="3" name="CuadroTexto 2">
             <a:extLst>
               <a:ext uri="{FF2B5EF4-FFF2-40B4-BE49-F238E27FC236}">
-                <a16:creationId xmlns:a16="http://schemas.microsoft.com/office/drawing/2014/main" id="{1EE95117-2191-150D-CEAB-AD181B5215E5}"/>
+                <a16:creationId xmlns:a16="http://schemas.microsoft.com/office/drawing/2014/main" id="{85DD18C2-C5F8-BD47-72A7-CE0CB63325F1}"/>
               </a:ext>
             </a:extLst>
           </p:cNvPr>
@@ -11499,7 +11499,7 @@
           <p:cNvPr id="4" name="CuadroTexto 3">
             <a:extLst>
               <a:ext uri="{FF2B5EF4-FFF2-40B4-BE49-F238E27FC236}">
-                <a16:creationId xmlns:a16="http://schemas.microsoft.com/office/drawing/2014/main" id="{5C1F3077-79E0-9100-D8E6-B1A7602DE670}"/>
+                <a16:creationId xmlns:a16="http://schemas.microsoft.com/office/drawing/2014/main" id="{EDB07F75-413F-95A5-9FAF-BE68D811BCC1}"/>
               </a:ext>
             </a:extLst>
           </p:cNvPr>
@@ -11539,7 +11539,7 @@
           <p:cNvPr id="5" name="Rectángulo: esquinas redondeadas 4">
             <a:extLst>
               <a:ext uri="{FF2B5EF4-FFF2-40B4-BE49-F238E27FC236}">
-                <a16:creationId xmlns:a16="http://schemas.microsoft.com/office/drawing/2014/main" id="{A9C28EFF-5544-FF9F-1F73-40ED012101D8}"/>
+                <a16:creationId xmlns:a16="http://schemas.microsoft.com/office/drawing/2014/main" id="{17C06495-A4E4-1550-2896-9DA0D0108873}"/>
               </a:ext>
             </a:extLst>
           </p:cNvPr>
@@ -11593,7 +11593,7 @@
           <p:cNvPr id="6" name="CuadroTexto 5">
             <a:extLst>
               <a:ext uri="{FF2B5EF4-FFF2-40B4-BE49-F238E27FC236}">
-                <a16:creationId xmlns:a16="http://schemas.microsoft.com/office/drawing/2014/main" id="{AE59955A-D259-8761-3DD0-BA61871AA08D}"/>
+                <a16:creationId xmlns:a16="http://schemas.microsoft.com/office/drawing/2014/main" id="{42EFF471-8EFC-84EC-BCB5-3096366249FD}"/>
               </a:ext>
             </a:extLst>
           </p:cNvPr>
@@ -11633,7 +11633,7 @@
           <p:cNvPr id="7" name="CuadroTexto 6">
             <a:extLst>
               <a:ext uri="{FF2B5EF4-FFF2-40B4-BE49-F238E27FC236}">
-                <a16:creationId xmlns:a16="http://schemas.microsoft.com/office/drawing/2014/main" id="{9C22FA5F-E4D3-5F6D-D8FB-AE53312B5CEE}"/>
+                <a16:creationId xmlns:a16="http://schemas.microsoft.com/office/drawing/2014/main" id="{36DAEDEA-D504-B0E3-6717-DC1BDC86404A}"/>
               </a:ext>
             </a:extLst>
           </p:cNvPr>
@@ -11673,7 +11673,7 @@
           <p:cNvPr id="8" name="Rectángulo: esquinas redondeadas 7">
             <a:extLst>
               <a:ext uri="{FF2B5EF4-FFF2-40B4-BE49-F238E27FC236}">
-                <a16:creationId xmlns:a16="http://schemas.microsoft.com/office/drawing/2014/main" id="{272A3DE5-BCF8-196E-7B96-8600265D8F7C}"/>
+                <a16:creationId xmlns:a16="http://schemas.microsoft.com/office/drawing/2014/main" id="{1BA7AAAC-B458-3E5B-461A-2FD52BE81980}"/>
               </a:ext>
             </a:extLst>
           </p:cNvPr>
@@ -11727,7 +11727,7 @@
           <p:cNvPr id="9" name="CuadroTexto 8">
             <a:extLst>
               <a:ext uri="{FF2B5EF4-FFF2-40B4-BE49-F238E27FC236}">
-                <a16:creationId xmlns:a16="http://schemas.microsoft.com/office/drawing/2014/main" id="{CF66ECF2-AABE-B148-59ED-90F7BB781B9A}"/>
+                <a16:creationId xmlns:a16="http://schemas.microsoft.com/office/drawing/2014/main" id="{2743EDE1-291D-83D0-5EC5-20CBC69A6DA4}"/>
               </a:ext>
             </a:extLst>
           </p:cNvPr>
@@ -11767,7 +11767,7 @@
           <p:cNvPr id="10" name="CuadroTexto 9">
             <a:extLst>
               <a:ext uri="{FF2B5EF4-FFF2-40B4-BE49-F238E27FC236}">
-                <a16:creationId xmlns:a16="http://schemas.microsoft.com/office/drawing/2014/main" id="{161EF2D3-A939-0A2B-2126-EE03D1BB6432}"/>
+                <a16:creationId xmlns:a16="http://schemas.microsoft.com/office/drawing/2014/main" id="{F4240100-1FDE-723F-3EEE-A537BB373D6F}"/>
               </a:ext>
             </a:extLst>
           </p:cNvPr>
@@ -11807,7 +11807,7 @@
           <p:cNvPr id="11" name="Rectángulo: esquinas redondeadas 10">
             <a:extLst>
               <a:ext uri="{FF2B5EF4-FFF2-40B4-BE49-F238E27FC236}">
-                <a16:creationId xmlns:a16="http://schemas.microsoft.com/office/drawing/2014/main" id="{D14D23F2-88B8-7160-AB9F-31DC093D925A}"/>
+                <a16:creationId xmlns:a16="http://schemas.microsoft.com/office/drawing/2014/main" id="{D802EDA8-4287-0BAC-408C-2404BCC2D9EF}"/>
               </a:ext>
             </a:extLst>
           </p:cNvPr>
@@ -11861,7 +11861,7 @@
           <p:cNvPr id="12" name="CuadroTexto 11">
             <a:extLst>
               <a:ext uri="{FF2B5EF4-FFF2-40B4-BE49-F238E27FC236}">
-                <a16:creationId xmlns:a16="http://schemas.microsoft.com/office/drawing/2014/main" id="{82D69466-A8D3-7070-D0EA-4F23BE7919F8}"/>
+                <a16:creationId xmlns:a16="http://schemas.microsoft.com/office/drawing/2014/main" id="{010E48B9-43AA-1CDE-BD8D-A06072EB02FF}"/>
               </a:ext>
             </a:extLst>
           </p:cNvPr>
@@ -11901,7 +11901,7 @@
           <p:cNvPr id="13" name="CuadroTexto 12">
             <a:extLst>
               <a:ext uri="{FF2B5EF4-FFF2-40B4-BE49-F238E27FC236}">
-                <a16:creationId xmlns:a16="http://schemas.microsoft.com/office/drawing/2014/main" id="{49F2ECC3-24B4-3134-3946-D3E3424D7892}"/>
+                <a16:creationId xmlns:a16="http://schemas.microsoft.com/office/drawing/2014/main" id="{C33D04DF-D4DB-920E-8E59-9BA968219784}"/>
               </a:ext>
             </a:extLst>
           </p:cNvPr>
@@ -11941,7 +11941,7 @@
           <p:cNvPr id="14" name="Rectángulo: esquinas redondeadas 13">
             <a:extLst>
               <a:ext uri="{FF2B5EF4-FFF2-40B4-BE49-F238E27FC236}">
-                <a16:creationId xmlns:a16="http://schemas.microsoft.com/office/drawing/2014/main" id="{860C01C8-C1AD-5CCE-801A-743786CC699D}"/>
+                <a16:creationId xmlns:a16="http://schemas.microsoft.com/office/drawing/2014/main" id="{A0AA643C-F3E5-D18C-91F2-2DAA1A4FA014}"/>
               </a:ext>
             </a:extLst>
           </p:cNvPr>
@@ -11995,7 +11995,7 @@
           <p:cNvPr id="15" name="CuadroTexto 14">
             <a:extLst>
               <a:ext uri="{FF2B5EF4-FFF2-40B4-BE49-F238E27FC236}">
-                <a16:creationId xmlns:a16="http://schemas.microsoft.com/office/drawing/2014/main" id="{2533663A-B044-598C-EBB1-1BA5E26D4737}"/>
+                <a16:creationId xmlns:a16="http://schemas.microsoft.com/office/drawing/2014/main" id="{0080C4FD-0FBC-6437-20BE-F5B8B213E917}"/>
               </a:ext>
             </a:extLst>
           </p:cNvPr>
@@ -12035,7 +12035,7 @@
           <p:cNvPr id="16" name="CuadroTexto 15">
             <a:extLst>
               <a:ext uri="{FF2B5EF4-FFF2-40B4-BE49-F238E27FC236}">
-                <a16:creationId xmlns:a16="http://schemas.microsoft.com/office/drawing/2014/main" id="{D5978AA5-938B-6A0D-B27B-170DF9BDE389}"/>
+                <a16:creationId xmlns:a16="http://schemas.microsoft.com/office/drawing/2014/main" id="{9C6CAE58-62EF-43B8-DD30-6B325291064C}"/>
               </a:ext>
             </a:extLst>
           </p:cNvPr>
@@ -12075,7 +12075,7 @@
           <p:cNvPr id="17" name="Rectángulo: esquinas redondeadas 16">
             <a:extLst>
               <a:ext uri="{FF2B5EF4-FFF2-40B4-BE49-F238E27FC236}">
-                <a16:creationId xmlns:a16="http://schemas.microsoft.com/office/drawing/2014/main" id="{A18D4FCF-962D-604B-58E3-5E8BD78D3EE6}"/>
+                <a16:creationId xmlns:a16="http://schemas.microsoft.com/office/drawing/2014/main" id="{6731DF98-6AED-5524-51E0-924ECE61238F}"/>
               </a:ext>
             </a:extLst>
           </p:cNvPr>
@@ -12129,7 +12129,7 @@
           <p:cNvPr id="18" name="CuadroTexto 17">
             <a:extLst>
               <a:ext uri="{FF2B5EF4-FFF2-40B4-BE49-F238E27FC236}">
-                <a16:creationId xmlns:a16="http://schemas.microsoft.com/office/drawing/2014/main" id="{B422D8D1-1F94-B9D7-2452-5A8F751785C2}"/>
+                <a16:creationId xmlns:a16="http://schemas.microsoft.com/office/drawing/2014/main" id="{39EF097E-AF1A-0F6F-554C-A59448AD9CCF}"/>
               </a:ext>
             </a:extLst>
           </p:cNvPr>
@@ -12169,7 +12169,7 @@
           <p:cNvPr id="19" name="CuadroTexto 18">
             <a:extLst>
               <a:ext uri="{FF2B5EF4-FFF2-40B4-BE49-F238E27FC236}">
-                <a16:creationId xmlns:a16="http://schemas.microsoft.com/office/drawing/2014/main" id="{B42A556D-F0D2-84CA-9CC4-11D4CBD4F6DE}"/>
+                <a16:creationId xmlns:a16="http://schemas.microsoft.com/office/drawing/2014/main" id="{19DF365D-C7F0-598F-EC66-AC5AAB5B0A7F}"/>
               </a:ext>
             </a:extLst>
           </p:cNvPr>
@@ -12209,7 +12209,7 @@
           <p:cNvPr id="20" name="Rectángulo: esquinas redondeadas 19">
             <a:extLst>
               <a:ext uri="{FF2B5EF4-FFF2-40B4-BE49-F238E27FC236}">
-                <a16:creationId xmlns:a16="http://schemas.microsoft.com/office/drawing/2014/main" id="{D398D3A8-CBC7-258D-3BF8-AA6D1DB0B1CA}"/>
+                <a16:creationId xmlns:a16="http://schemas.microsoft.com/office/drawing/2014/main" id="{669B39C3-1217-FE7E-C31D-618BC248FBEA}"/>
               </a:ext>
             </a:extLst>
           </p:cNvPr>
@@ -12263,7 +12263,7 @@
           <p:cNvPr id="21" name="CuadroTexto 20">
             <a:extLst>
               <a:ext uri="{FF2B5EF4-FFF2-40B4-BE49-F238E27FC236}">
-                <a16:creationId xmlns:a16="http://schemas.microsoft.com/office/drawing/2014/main" id="{6C7F5FD2-A784-AD4C-F9B7-C056966DA94B}"/>
+                <a16:creationId xmlns:a16="http://schemas.microsoft.com/office/drawing/2014/main" id="{AF0D5959-5B01-4D0B-3964-25ADBEB33461}"/>
               </a:ext>
             </a:extLst>
           </p:cNvPr>
@@ -12303,7 +12303,7 @@
           <p:cNvPr id="22" name="CuadroTexto 21">
             <a:extLst>
               <a:ext uri="{FF2B5EF4-FFF2-40B4-BE49-F238E27FC236}">
-                <a16:creationId xmlns:a16="http://schemas.microsoft.com/office/drawing/2014/main" id="{35D94D5F-0FFF-3914-5A04-39DCD1679264}"/>
+                <a16:creationId xmlns:a16="http://schemas.microsoft.com/office/drawing/2014/main" id="{CA8B7B50-67E3-B823-CBBD-B7BDA19192B7}"/>
               </a:ext>
             </a:extLst>
           </p:cNvPr>
@@ -12341,7 +12341,7 @@
     </p:spTree>
     <p:extLst>
       <p:ext uri="{BB962C8B-B14F-4D97-AF65-F5344CB8AC3E}">
-        <p14:creationId xmlns:p14="http://schemas.microsoft.com/office/powerpoint/2010/main" val="2432627001"/>
+        <p14:creationId xmlns:p14="http://schemas.microsoft.com/office/powerpoint/2010/main" val="922881415"/>
       </p:ext>
     </p:extLst>
   </p:cSld>

</xml_diff>

<commit_message>
Refresh final docs for desktop cloud ops
</commit_message>
<xml_diff>
--- a/docs/presentacion-defensa-final.pptx
+++ b/docs/presentacion-defensa-final.pptx
@@ -146,7 +146,7 @@
           <p:cNvPr id="2" name="Título 1">
             <a:extLst>
               <a:ext uri="{FF2B5EF4-FFF2-40B4-BE49-F238E27FC236}">
-                <a16:creationId xmlns:a16="http://schemas.microsoft.com/office/drawing/2014/main" id="{DEC54974-BA2D-DEDD-C4EA-D896F5C0B032}"/>
+                <a16:creationId xmlns:a16="http://schemas.microsoft.com/office/drawing/2014/main" id="{8A6B0814-BF45-E573-A6DD-089C6E430088}"/>
               </a:ext>
             </a:extLst>
           </p:cNvPr>
@@ -183,7 +183,7 @@
           <p:cNvPr id="3" name="Subtítulo 2">
             <a:extLst>
               <a:ext uri="{FF2B5EF4-FFF2-40B4-BE49-F238E27FC236}">
-                <a16:creationId xmlns:a16="http://schemas.microsoft.com/office/drawing/2014/main" id="{8A47899D-3FD5-4A89-FA44-5DBCD877ADF0}"/>
+                <a16:creationId xmlns:a16="http://schemas.microsoft.com/office/drawing/2014/main" id="{59A3F60D-381D-A44B-0A93-8C52096248EC}"/>
               </a:ext>
             </a:extLst>
           </p:cNvPr>
@@ -253,7 +253,7 @@
           <p:cNvPr id="4" name="Marcador de fecha 3">
             <a:extLst>
               <a:ext uri="{FF2B5EF4-FFF2-40B4-BE49-F238E27FC236}">
-                <a16:creationId xmlns:a16="http://schemas.microsoft.com/office/drawing/2014/main" id="{7A60B31B-B9C0-C336-2A57-A6E6BBB4C264}"/>
+                <a16:creationId xmlns:a16="http://schemas.microsoft.com/office/drawing/2014/main" id="{89A48920-AADB-D026-B9B2-9DA509FB0A60}"/>
               </a:ext>
             </a:extLst>
           </p:cNvPr>
@@ -269,7 +269,7 @@
           <a:bodyPr/>
           <a:lstStyle/>
           <a:p>
-            <a:fld id="{AB9C1A0A-BF9E-48A0-991D-0EB02B84C89C}" type="datetimeFigureOut">
+            <a:fld id="{5EA62A27-1D85-48AD-90C3-37B244257CF0}" type="datetimeFigureOut">
               <a:rPr lang="es-ES" smtClean="0"/>
               <a:t>19/05/2026</a:t>
             </a:fld>
@@ -282,7 +282,7 @@
           <p:cNvPr id="5" name="Marcador de pie de página 4">
             <a:extLst>
               <a:ext uri="{FF2B5EF4-FFF2-40B4-BE49-F238E27FC236}">
-                <a16:creationId xmlns:a16="http://schemas.microsoft.com/office/drawing/2014/main" id="{C9CF83EF-85BC-63EA-D2FA-C6A3E8F94D70}"/>
+                <a16:creationId xmlns:a16="http://schemas.microsoft.com/office/drawing/2014/main" id="{58A59491-3B6A-48C9-5EEB-7EB818871F5B}"/>
               </a:ext>
             </a:extLst>
           </p:cNvPr>
@@ -307,7 +307,7 @@
           <p:cNvPr id="6" name="Marcador de número de diapositiva 5">
             <a:extLst>
               <a:ext uri="{FF2B5EF4-FFF2-40B4-BE49-F238E27FC236}">
-                <a16:creationId xmlns:a16="http://schemas.microsoft.com/office/drawing/2014/main" id="{D7DCD0F0-F06F-9ADD-8E63-6562F65952C3}"/>
+                <a16:creationId xmlns:a16="http://schemas.microsoft.com/office/drawing/2014/main" id="{DD81804F-C69B-B021-BB20-0F4660F398D0}"/>
               </a:ext>
             </a:extLst>
           </p:cNvPr>
@@ -323,7 +323,7 @@
           <a:bodyPr/>
           <a:lstStyle/>
           <a:p>
-            <a:fld id="{B3465923-C01A-429D-BF48-FE1C1E8CA486}" type="slidenum">
+            <a:fld id="{357192D4-5BD9-41C8-9EE5-942CB5B156C9}" type="slidenum">
               <a:rPr lang="es-ES" smtClean="0"/>
               <a:t>‹Nº›</a:t>
             </a:fld>
@@ -334,7 +334,7 @@
     </p:spTree>
     <p:extLst>
       <p:ext uri="{BB962C8B-B14F-4D97-AF65-F5344CB8AC3E}">
-        <p14:creationId xmlns:p14="http://schemas.microsoft.com/office/powerpoint/2010/main" val="962639868"/>
+        <p14:creationId xmlns:p14="http://schemas.microsoft.com/office/powerpoint/2010/main" val="1680099888"/>
       </p:ext>
     </p:extLst>
   </p:cSld>
@@ -366,7 +366,7 @@
           <p:cNvPr id="2" name="Título 1">
             <a:extLst>
               <a:ext uri="{FF2B5EF4-FFF2-40B4-BE49-F238E27FC236}">
-                <a16:creationId xmlns:a16="http://schemas.microsoft.com/office/drawing/2014/main" id="{AFE84534-547B-71A0-B679-9C0F624EB5AA}"/>
+                <a16:creationId xmlns:a16="http://schemas.microsoft.com/office/drawing/2014/main" id="{FDABD5DC-78B2-1D43-6817-084E7D311BE4}"/>
               </a:ext>
             </a:extLst>
           </p:cNvPr>
@@ -394,7 +394,7 @@
           <p:cNvPr id="3" name="Marcador de texto vertical 2">
             <a:extLst>
               <a:ext uri="{FF2B5EF4-FFF2-40B4-BE49-F238E27FC236}">
-                <a16:creationId xmlns:a16="http://schemas.microsoft.com/office/drawing/2014/main" id="{43EAF322-BC57-4BEE-65E7-C16B7C6AC12A}"/>
+                <a16:creationId xmlns:a16="http://schemas.microsoft.com/office/drawing/2014/main" id="{683029C5-5484-68D1-9988-6F026988B4D3}"/>
               </a:ext>
             </a:extLst>
           </p:cNvPr>
@@ -451,7 +451,7 @@
           <p:cNvPr id="4" name="Marcador de fecha 3">
             <a:extLst>
               <a:ext uri="{FF2B5EF4-FFF2-40B4-BE49-F238E27FC236}">
-                <a16:creationId xmlns:a16="http://schemas.microsoft.com/office/drawing/2014/main" id="{66F5F553-D299-15A6-CA75-45D65513160F}"/>
+                <a16:creationId xmlns:a16="http://schemas.microsoft.com/office/drawing/2014/main" id="{D40ACC64-DF2E-FB98-BEE2-33C18881B76B}"/>
               </a:ext>
             </a:extLst>
           </p:cNvPr>
@@ -467,7 +467,7 @@
           <a:bodyPr/>
           <a:lstStyle/>
           <a:p>
-            <a:fld id="{AB9C1A0A-BF9E-48A0-991D-0EB02B84C89C}" type="datetimeFigureOut">
+            <a:fld id="{5EA62A27-1D85-48AD-90C3-37B244257CF0}" type="datetimeFigureOut">
               <a:rPr lang="es-ES" smtClean="0"/>
               <a:t>19/05/2026</a:t>
             </a:fld>
@@ -480,7 +480,7 @@
           <p:cNvPr id="5" name="Marcador de pie de página 4">
             <a:extLst>
               <a:ext uri="{FF2B5EF4-FFF2-40B4-BE49-F238E27FC236}">
-                <a16:creationId xmlns:a16="http://schemas.microsoft.com/office/drawing/2014/main" id="{B75CDBA8-0711-42FF-A9DE-0C266E33842F}"/>
+                <a16:creationId xmlns:a16="http://schemas.microsoft.com/office/drawing/2014/main" id="{00E13036-6346-F20B-D4DD-22038DD9C5DB}"/>
               </a:ext>
             </a:extLst>
           </p:cNvPr>
@@ -505,7 +505,7 @@
           <p:cNvPr id="6" name="Marcador de número de diapositiva 5">
             <a:extLst>
               <a:ext uri="{FF2B5EF4-FFF2-40B4-BE49-F238E27FC236}">
-                <a16:creationId xmlns:a16="http://schemas.microsoft.com/office/drawing/2014/main" id="{790520F7-6A37-AAFB-22CF-3F8D5458DFC6}"/>
+                <a16:creationId xmlns:a16="http://schemas.microsoft.com/office/drawing/2014/main" id="{7B602EB5-B081-CE0E-966B-C70200BEEF97}"/>
               </a:ext>
             </a:extLst>
           </p:cNvPr>
@@ -521,7 +521,7 @@
           <a:bodyPr/>
           <a:lstStyle/>
           <a:p>
-            <a:fld id="{B3465923-C01A-429D-BF48-FE1C1E8CA486}" type="slidenum">
+            <a:fld id="{357192D4-5BD9-41C8-9EE5-942CB5B156C9}" type="slidenum">
               <a:rPr lang="es-ES" smtClean="0"/>
               <a:t>‹Nº›</a:t>
             </a:fld>
@@ -532,7 +532,7 @@
     </p:spTree>
     <p:extLst>
       <p:ext uri="{BB962C8B-B14F-4D97-AF65-F5344CB8AC3E}">
-        <p14:creationId xmlns:p14="http://schemas.microsoft.com/office/powerpoint/2010/main" val="4038845907"/>
+        <p14:creationId xmlns:p14="http://schemas.microsoft.com/office/powerpoint/2010/main" val="2447015768"/>
       </p:ext>
     </p:extLst>
   </p:cSld>
@@ -564,7 +564,7 @@
           <p:cNvPr id="2" name="Título vertical 1">
             <a:extLst>
               <a:ext uri="{FF2B5EF4-FFF2-40B4-BE49-F238E27FC236}">
-                <a16:creationId xmlns:a16="http://schemas.microsoft.com/office/drawing/2014/main" id="{DE4D055C-5670-F16A-6CC3-B33FD87A646E}"/>
+                <a16:creationId xmlns:a16="http://schemas.microsoft.com/office/drawing/2014/main" id="{D4A42644-ABFA-58B7-9710-0C222F7690F7}"/>
               </a:ext>
             </a:extLst>
           </p:cNvPr>
@@ -597,7 +597,7 @@
           <p:cNvPr id="3" name="Marcador de texto vertical 2">
             <a:extLst>
               <a:ext uri="{FF2B5EF4-FFF2-40B4-BE49-F238E27FC236}">
-                <a16:creationId xmlns:a16="http://schemas.microsoft.com/office/drawing/2014/main" id="{370278FE-F21E-EF15-4C2C-1A5678C55A93}"/>
+                <a16:creationId xmlns:a16="http://schemas.microsoft.com/office/drawing/2014/main" id="{602D70CA-E9E5-7B05-1516-9406222EE311}"/>
               </a:ext>
             </a:extLst>
           </p:cNvPr>
@@ -659,7 +659,7 @@
           <p:cNvPr id="4" name="Marcador de fecha 3">
             <a:extLst>
               <a:ext uri="{FF2B5EF4-FFF2-40B4-BE49-F238E27FC236}">
-                <a16:creationId xmlns:a16="http://schemas.microsoft.com/office/drawing/2014/main" id="{1CAC1D2A-64B6-78B0-815C-FE8E11F2E04D}"/>
+                <a16:creationId xmlns:a16="http://schemas.microsoft.com/office/drawing/2014/main" id="{9232D4B7-CBA2-CC7D-E399-72CB728BBE05}"/>
               </a:ext>
             </a:extLst>
           </p:cNvPr>
@@ -675,7 +675,7 @@
           <a:bodyPr/>
           <a:lstStyle/>
           <a:p>
-            <a:fld id="{AB9C1A0A-BF9E-48A0-991D-0EB02B84C89C}" type="datetimeFigureOut">
+            <a:fld id="{5EA62A27-1D85-48AD-90C3-37B244257CF0}" type="datetimeFigureOut">
               <a:rPr lang="es-ES" smtClean="0"/>
               <a:t>19/05/2026</a:t>
             </a:fld>
@@ -688,7 +688,7 @@
           <p:cNvPr id="5" name="Marcador de pie de página 4">
             <a:extLst>
               <a:ext uri="{FF2B5EF4-FFF2-40B4-BE49-F238E27FC236}">
-                <a16:creationId xmlns:a16="http://schemas.microsoft.com/office/drawing/2014/main" id="{8D64ABB7-CEE7-B824-3FC7-57ACF3EDBEF1}"/>
+                <a16:creationId xmlns:a16="http://schemas.microsoft.com/office/drawing/2014/main" id="{323BAB20-BD10-B4FA-2237-2D47800633F3}"/>
               </a:ext>
             </a:extLst>
           </p:cNvPr>
@@ -713,7 +713,7 @@
           <p:cNvPr id="6" name="Marcador de número de diapositiva 5">
             <a:extLst>
               <a:ext uri="{FF2B5EF4-FFF2-40B4-BE49-F238E27FC236}">
-                <a16:creationId xmlns:a16="http://schemas.microsoft.com/office/drawing/2014/main" id="{89A95BCA-06D3-E659-4D09-2D2373482A8E}"/>
+                <a16:creationId xmlns:a16="http://schemas.microsoft.com/office/drawing/2014/main" id="{F3F63C59-FBCF-9096-30B2-872FBE51DFA4}"/>
               </a:ext>
             </a:extLst>
           </p:cNvPr>
@@ -729,7 +729,7 @@
           <a:bodyPr/>
           <a:lstStyle/>
           <a:p>
-            <a:fld id="{B3465923-C01A-429D-BF48-FE1C1E8CA486}" type="slidenum">
+            <a:fld id="{357192D4-5BD9-41C8-9EE5-942CB5B156C9}" type="slidenum">
               <a:rPr lang="es-ES" smtClean="0"/>
               <a:t>‹Nº›</a:t>
             </a:fld>
@@ -740,7 +740,7 @@
     </p:spTree>
     <p:extLst>
       <p:ext uri="{BB962C8B-B14F-4D97-AF65-F5344CB8AC3E}">
-        <p14:creationId xmlns:p14="http://schemas.microsoft.com/office/powerpoint/2010/main" val="1352709287"/>
+        <p14:creationId xmlns:p14="http://schemas.microsoft.com/office/powerpoint/2010/main" val="406580436"/>
       </p:ext>
     </p:extLst>
   </p:cSld>
@@ -772,7 +772,7 @@
           <p:cNvPr id="2" name="Título 1">
             <a:extLst>
               <a:ext uri="{FF2B5EF4-FFF2-40B4-BE49-F238E27FC236}">
-                <a16:creationId xmlns:a16="http://schemas.microsoft.com/office/drawing/2014/main" id="{92B77EEA-82FC-9F37-0FD4-F2BDEFAAAC8D}"/>
+                <a16:creationId xmlns:a16="http://schemas.microsoft.com/office/drawing/2014/main" id="{9EA4115C-5D06-4D7C-B8EC-F9D77664F195}"/>
               </a:ext>
             </a:extLst>
           </p:cNvPr>
@@ -800,7 +800,7 @@
           <p:cNvPr id="3" name="Marcador de contenido 2">
             <a:extLst>
               <a:ext uri="{FF2B5EF4-FFF2-40B4-BE49-F238E27FC236}">
-                <a16:creationId xmlns:a16="http://schemas.microsoft.com/office/drawing/2014/main" id="{B4C850AE-C979-AACE-243F-5CB284D2CC96}"/>
+                <a16:creationId xmlns:a16="http://schemas.microsoft.com/office/drawing/2014/main" id="{C78EC942-61D9-112C-287C-90292BD32500}"/>
               </a:ext>
             </a:extLst>
           </p:cNvPr>
@@ -857,7 +857,7 @@
           <p:cNvPr id="4" name="Marcador de fecha 3">
             <a:extLst>
               <a:ext uri="{FF2B5EF4-FFF2-40B4-BE49-F238E27FC236}">
-                <a16:creationId xmlns:a16="http://schemas.microsoft.com/office/drawing/2014/main" id="{0F4129A5-5E8A-92C4-9C72-FBED8CB35704}"/>
+                <a16:creationId xmlns:a16="http://schemas.microsoft.com/office/drawing/2014/main" id="{25ED1F93-2489-6D68-93DB-F2D5E5952375}"/>
               </a:ext>
             </a:extLst>
           </p:cNvPr>
@@ -873,7 +873,7 @@
           <a:bodyPr/>
           <a:lstStyle/>
           <a:p>
-            <a:fld id="{AB9C1A0A-BF9E-48A0-991D-0EB02B84C89C}" type="datetimeFigureOut">
+            <a:fld id="{5EA62A27-1D85-48AD-90C3-37B244257CF0}" type="datetimeFigureOut">
               <a:rPr lang="es-ES" smtClean="0"/>
               <a:t>19/05/2026</a:t>
             </a:fld>
@@ -886,7 +886,7 @@
           <p:cNvPr id="5" name="Marcador de pie de página 4">
             <a:extLst>
               <a:ext uri="{FF2B5EF4-FFF2-40B4-BE49-F238E27FC236}">
-                <a16:creationId xmlns:a16="http://schemas.microsoft.com/office/drawing/2014/main" id="{B37C3BFC-1B17-7AD1-80C7-9515311EBF1F}"/>
+                <a16:creationId xmlns:a16="http://schemas.microsoft.com/office/drawing/2014/main" id="{17CE7D42-E5A1-356C-3F58-B627C49AA99F}"/>
               </a:ext>
             </a:extLst>
           </p:cNvPr>
@@ -911,7 +911,7 @@
           <p:cNvPr id="6" name="Marcador de número de diapositiva 5">
             <a:extLst>
               <a:ext uri="{FF2B5EF4-FFF2-40B4-BE49-F238E27FC236}">
-                <a16:creationId xmlns:a16="http://schemas.microsoft.com/office/drawing/2014/main" id="{7A5567DB-4CDF-7698-7AA0-C554F337E4CE}"/>
+                <a16:creationId xmlns:a16="http://schemas.microsoft.com/office/drawing/2014/main" id="{0FEFE665-0B92-8F3C-FF33-3B8D22EB1153}"/>
               </a:ext>
             </a:extLst>
           </p:cNvPr>
@@ -927,7 +927,7 @@
           <a:bodyPr/>
           <a:lstStyle/>
           <a:p>
-            <a:fld id="{B3465923-C01A-429D-BF48-FE1C1E8CA486}" type="slidenum">
+            <a:fld id="{357192D4-5BD9-41C8-9EE5-942CB5B156C9}" type="slidenum">
               <a:rPr lang="es-ES" smtClean="0"/>
               <a:t>‹Nº›</a:t>
             </a:fld>
@@ -938,7 +938,7 @@
     </p:spTree>
     <p:extLst>
       <p:ext uri="{BB962C8B-B14F-4D97-AF65-F5344CB8AC3E}">
-        <p14:creationId xmlns:p14="http://schemas.microsoft.com/office/powerpoint/2010/main" val="741971230"/>
+        <p14:creationId xmlns:p14="http://schemas.microsoft.com/office/powerpoint/2010/main" val="1104774924"/>
       </p:ext>
     </p:extLst>
   </p:cSld>
@@ -970,7 +970,7 @@
           <p:cNvPr id="2" name="Título 1">
             <a:extLst>
               <a:ext uri="{FF2B5EF4-FFF2-40B4-BE49-F238E27FC236}">
-                <a16:creationId xmlns:a16="http://schemas.microsoft.com/office/drawing/2014/main" id="{7BC3F6F4-D80B-C1BB-227F-C03E5E048E6E}"/>
+                <a16:creationId xmlns:a16="http://schemas.microsoft.com/office/drawing/2014/main" id="{028D4A99-9A29-200B-6DD7-FACD52DCDD13}"/>
               </a:ext>
             </a:extLst>
           </p:cNvPr>
@@ -1007,7 +1007,7 @@
           <p:cNvPr id="3" name="Marcador de texto 2">
             <a:extLst>
               <a:ext uri="{FF2B5EF4-FFF2-40B4-BE49-F238E27FC236}">
-                <a16:creationId xmlns:a16="http://schemas.microsoft.com/office/drawing/2014/main" id="{87B172BB-7E5F-A4E2-217D-2B059083E554}"/>
+                <a16:creationId xmlns:a16="http://schemas.microsoft.com/office/drawing/2014/main" id="{993EBD5B-4058-DD2F-D0AB-1FD2A62C2E46}"/>
               </a:ext>
             </a:extLst>
           </p:cNvPr>
@@ -1132,7 +1132,7 @@
           <p:cNvPr id="4" name="Marcador de fecha 3">
             <a:extLst>
               <a:ext uri="{FF2B5EF4-FFF2-40B4-BE49-F238E27FC236}">
-                <a16:creationId xmlns:a16="http://schemas.microsoft.com/office/drawing/2014/main" id="{E907FA87-7F86-8183-E1EF-2A9AF0EA92CA}"/>
+                <a16:creationId xmlns:a16="http://schemas.microsoft.com/office/drawing/2014/main" id="{6C9DC1F3-D5E5-CCDC-9020-669CCE68476D}"/>
               </a:ext>
             </a:extLst>
           </p:cNvPr>
@@ -1148,7 +1148,7 @@
           <a:bodyPr/>
           <a:lstStyle/>
           <a:p>
-            <a:fld id="{AB9C1A0A-BF9E-48A0-991D-0EB02B84C89C}" type="datetimeFigureOut">
+            <a:fld id="{5EA62A27-1D85-48AD-90C3-37B244257CF0}" type="datetimeFigureOut">
               <a:rPr lang="es-ES" smtClean="0"/>
               <a:t>19/05/2026</a:t>
             </a:fld>
@@ -1161,7 +1161,7 @@
           <p:cNvPr id="5" name="Marcador de pie de página 4">
             <a:extLst>
               <a:ext uri="{FF2B5EF4-FFF2-40B4-BE49-F238E27FC236}">
-                <a16:creationId xmlns:a16="http://schemas.microsoft.com/office/drawing/2014/main" id="{071A7589-02BA-C1C3-69B5-29607B14D7B6}"/>
+                <a16:creationId xmlns:a16="http://schemas.microsoft.com/office/drawing/2014/main" id="{EB357624-B5DB-F2A1-7FA2-7C221A5F314B}"/>
               </a:ext>
             </a:extLst>
           </p:cNvPr>
@@ -1186,7 +1186,7 @@
           <p:cNvPr id="6" name="Marcador de número de diapositiva 5">
             <a:extLst>
               <a:ext uri="{FF2B5EF4-FFF2-40B4-BE49-F238E27FC236}">
-                <a16:creationId xmlns:a16="http://schemas.microsoft.com/office/drawing/2014/main" id="{F522CDD7-3053-0DFD-CBA5-11D5E492DD83}"/>
+                <a16:creationId xmlns:a16="http://schemas.microsoft.com/office/drawing/2014/main" id="{750C7AE2-5B81-9A50-05AC-1B614CC70971}"/>
               </a:ext>
             </a:extLst>
           </p:cNvPr>
@@ -1202,7 +1202,7 @@
           <a:bodyPr/>
           <a:lstStyle/>
           <a:p>
-            <a:fld id="{B3465923-C01A-429D-BF48-FE1C1E8CA486}" type="slidenum">
+            <a:fld id="{357192D4-5BD9-41C8-9EE5-942CB5B156C9}" type="slidenum">
               <a:rPr lang="es-ES" smtClean="0"/>
               <a:t>‹Nº›</a:t>
             </a:fld>
@@ -1213,7 +1213,7 @@
     </p:spTree>
     <p:extLst>
       <p:ext uri="{BB962C8B-B14F-4D97-AF65-F5344CB8AC3E}">
-        <p14:creationId xmlns:p14="http://schemas.microsoft.com/office/powerpoint/2010/main" val="970898443"/>
+        <p14:creationId xmlns:p14="http://schemas.microsoft.com/office/powerpoint/2010/main" val="4052687921"/>
       </p:ext>
     </p:extLst>
   </p:cSld>
@@ -1245,7 +1245,7 @@
           <p:cNvPr id="2" name="Título 1">
             <a:extLst>
               <a:ext uri="{FF2B5EF4-FFF2-40B4-BE49-F238E27FC236}">
-                <a16:creationId xmlns:a16="http://schemas.microsoft.com/office/drawing/2014/main" id="{84E1C9FE-8E6C-6103-9CD2-6BFB8A35C03C}"/>
+                <a16:creationId xmlns:a16="http://schemas.microsoft.com/office/drawing/2014/main" id="{1A68C001-776F-00A0-A9A3-C5FC6137A0A3}"/>
               </a:ext>
             </a:extLst>
           </p:cNvPr>
@@ -1273,7 +1273,7 @@
           <p:cNvPr id="3" name="Marcador de contenido 2">
             <a:extLst>
               <a:ext uri="{FF2B5EF4-FFF2-40B4-BE49-F238E27FC236}">
-                <a16:creationId xmlns:a16="http://schemas.microsoft.com/office/drawing/2014/main" id="{40BE22F8-F11E-2617-8DDE-BC25BF2E1586}"/>
+                <a16:creationId xmlns:a16="http://schemas.microsoft.com/office/drawing/2014/main" id="{00E2DC49-A2BE-ECC8-0798-6178D2DC12B9}"/>
               </a:ext>
             </a:extLst>
           </p:cNvPr>
@@ -1335,7 +1335,7 @@
           <p:cNvPr id="4" name="Marcador de contenido 3">
             <a:extLst>
               <a:ext uri="{FF2B5EF4-FFF2-40B4-BE49-F238E27FC236}">
-                <a16:creationId xmlns:a16="http://schemas.microsoft.com/office/drawing/2014/main" id="{059EDAFD-C4AA-A7DA-0144-0B0957FC354C}"/>
+                <a16:creationId xmlns:a16="http://schemas.microsoft.com/office/drawing/2014/main" id="{9659D0DA-D6BE-FBD5-4AAA-FDDE91CC4908}"/>
               </a:ext>
             </a:extLst>
           </p:cNvPr>
@@ -1397,7 +1397,7 @@
           <p:cNvPr id="5" name="Marcador de fecha 4">
             <a:extLst>
               <a:ext uri="{FF2B5EF4-FFF2-40B4-BE49-F238E27FC236}">
-                <a16:creationId xmlns:a16="http://schemas.microsoft.com/office/drawing/2014/main" id="{1E15B96B-28C3-475D-E3D7-9F4B7C10726C}"/>
+                <a16:creationId xmlns:a16="http://schemas.microsoft.com/office/drawing/2014/main" id="{F2A06CC8-F91D-7586-85D6-F5C5668B2226}"/>
               </a:ext>
             </a:extLst>
           </p:cNvPr>
@@ -1413,7 +1413,7 @@
           <a:bodyPr/>
           <a:lstStyle/>
           <a:p>
-            <a:fld id="{AB9C1A0A-BF9E-48A0-991D-0EB02B84C89C}" type="datetimeFigureOut">
+            <a:fld id="{5EA62A27-1D85-48AD-90C3-37B244257CF0}" type="datetimeFigureOut">
               <a:rPr lang="es-ES" smtClean="0"/>
               <a:t>19/05/2026</a:t>
             </a:fld>
@@ -1426,7 +1426,7 @@
           <p:cNvPr id="6" name="Marcador de pie de página 5">
             <a:extLst>
               <a:ext uri="{FF2B5EF4-FFF2-40B4-BE49-F238E27FC236}">
-                <a16:creationId xmlns:a16="http://schemas.microsoft.com/office/drawing/2014/main" id="{8F648C4D-4C4E-BF09-1C47-79A8CD5B17AA}"/>
+                <a16:creationId xmlns:a16="http://schemas.microsoft.com/office/drawing/2014/main" id="{0A1CA324-ED71-21AE-613B-F8A58D66EDC9}"/>
               </a:ext>
             </a:extLst>
           </p:cNvPr>
@@ -1451,7 +1451,7 @@
           <p:cNvPr id="7" name="Marcador de número de diapositiva 6">
             <a:extLst>
               <a:ext uri="{FF2B5EF4-FFF2-40B4-BE49-F238E27FC236}">
-                <a16:creationId xmlns:a16="http://schemas.microsoft.com/office/drawing/2014/main" id="{E80DF2E6-58DE-5F43-20DB-5D39F5BBBABB}"/>
+                <a16:creationId xmlns:a16="http://schemas.microsoft.com/office/drawing/2014/main" id="{826749BC-6AAC-7FA0-BBB3-6F22C2074C11}"/>
               </a:ext>
             </a:extLst>
           </p:cNvPr>
@@ -1467,7 +1467,7 @@
           <a:bodyPr/>
           <a:lstStyle/>
           <a:p>
-            <a:fld id="{B3465923-C01A-429D-BF48-FE1C1E8CA486}" type="slidenum">
+            <a:fld id="{357192D4-5BD9-41C8-9EE5-942CB5B156C9}" type="slidenum">
               <a:rPr lang="es-ES" smtClean="0"/>
               <a:t>‹Nº›</a:t>
             </a:fld>
@@ -1478,7 +1478,7 @@
     </p:spTree>
     <p:extLst>
       <p:ext uri="{BB962C8B-B14F-4D97-AF65-F5344CB8AC3E}">
-        <p14:creationId xmlns:p14="http://schemas.microsoft.com/office/powerpoint/2010/main" val="1473574331"/>
+        <p14:creationId xmlns:p14="http://schemas.microsoft.com/office/powerpoint/2010/main" val="3573210095"/>
       </p:ext>
     </p:extLst>
   </p:cSld>
@@ -1510,7 +1510,7 @@
           <p:cNvPr id="2" name="Título 1">
             <a:extLst>
               <a:ext uri="{FF2B5EF4-FFF2-40B4-BE49-F238E27FC236}">
-                <a16:creationId xmlns:a16="http://schemas.microsoft.com/office/drawing/2014/main" id="{E92AB916-AE9D-26D9-28F7-EEAE8FF8B053}"/>
+                <a16:creationId xmlns:a16="http://schemas.microsoft.com/office/drawing/2014/main" id="{A5E95328-B4B6-9ACB-B687-8EA3D3874DB6}"/>
               </a:ext>
             </a:extLst>
           </p:cNvPr>
@@ -1543,7 +1543,7 @@
           <p:cNvPr id="3" name="Marcador de texto 2">
             <a:extLst>
               <a:ext uri="{FF2B5EF4-FFF2-40B4-BE49-F238E27FC236}">
-                <a16:creationId xmlns:a16="http://schemas.microsoft.com/office/drawing/2014/main" id="{BC66CB01-328B-4D7B-2A2A-901DDF0FDAA3}"/>
+                <a16:creationId xmlns:a16="http://schemas.microsoft.com/office/drawing/2014/main" id="{381CAD59-CAA5-D3D0-5485-F0368B6E46AE}"/>
               </a:ext>
             </a:extLst>
           </p:cNvPr>
@@ -1614,7 +1614,7 @@
           <p:cNvPr id="4" name="Marcador de contenido 3">
             <a:extLst>
               <a:ext uri="{FF2B5EF4-FFF2-40B4-BE49-F238E27FC236}">
-                <a16:creationId xmlns:a16="http://schemas.microsoft.com/office/drawing/2014/main" id="{CA1AD0B3-48E2-FC6C-9471-725BB47630A8}"/>
+                <a16:creationId xmlns:a16="http://schemas.microsoft.com/office/drawing/2014/main" id="{82B8E0C2-AAE9-83BD-B746-56796B3B9C21}"/>
               </a:ext>
             </a:extLst>
           </p:cNvPr>
@@ -1676,7 +1676,7 @@
           <p:cNvPr id="5" name="Marcador de texto 4">
             <a:extLst>
               <a:ext uri="{FF2B5EF4-FFF2-40B4-BE49-F238E27FC236}">
-                <a16:creationId xmlns:a16="http://schemas.microsoft.com/office/drawing/2014/main" id="{F28D16E9-BEDB-A73C-EBD5-0F9712E94690}"/>
+                <a16:creationId xmlns:a16="http://schemas.microsoft.com/office/drawing/2014/main" id="{E55150E5-F565-FA62-3459-87167636DD3F}"/>
               </a:ext>
             </a:extLst>
           </p:cNvPr>
@@ -1747,7 +1747,7 @@
           <p:cNvPr id="6" name="Marcador de contenido 5">
             <a:extLst>
               <a:ext uri="{FF2B5EF4-FFF2-40B4-BE49-F238E27FC236}">
-                <a16:creationId xmlns:a16="http://schemas.microsoft.com/office/drawing/2014/main" id="{907545AB-BEF7-3457-90A3-BE2C72551632}"/>
+                <a16:creationId xmlns:a16="http://schemas.microsoft.com/office/drawing/2014/main" id="{947F2CB0-A358-148D-6C1F-7CF84C0B2AA6}"/>
               </a:ext>
             </a:extLst>
           </p:cNvPr>
@@ -1809,7 +1809,7 @@
           <p:cNvPr id="7" name="Marcador de fecha 6">
             <a:extLst>
               <a:ext uri="{FF2B5EF4-FFF2-40B4-BE49-F238E27FC236}">
-                <a16:creationId xmlns:a16="http://schemas.microsoft.com/office/drawing/2014/main" id="{65EED2F8-B104-278A-D121-8B6BA5C29BF3}"/>
+                <a16:creationId xmlns:a16="http://schemas.microsoft.com/office/drawing/2014/main" id="{8057AC04-7560-E3A7-A831-FB4DFF69F072}"/>
               </a:ext>
             </a:extLst>
           </p:cNvPr>
@@ -1825,7 +1825,7 @@
           <a:bodyPr/>
           <a:lstStyle/>
           <a:p>
-            <a:fld id="{AB9C1A0A-BF9E-48A0-991D-0EB02B84C89C}" type="datetimeFigureOut">
+            <a:fld id="{5EA62A27-1D85-48AD-90C3-37B244257CF0}" type="datetimeFigureOut">
               <a:rPr lang="es-ES" smtClean="0"/>
               <a:t>19/05/2026</a:t>
             </a:fld>
@@ -1838,7 +1838,7 @@
           <p:cNvPr id="8" name="Marcador de pie de página 7">
             <a:extLst>
               <a:ext uri="{FF2B5EF4-FFF2-40B4-BE49-F238E27FC236}">
-                <a16:creationId xmlns:a16="http://schemas.microsoft.com/office/drawing/2014/main" id="{88AF0901-8B10-FD68-79A6-2E732472EE66}"/>
+                <a16:creationId xmlns:a16="http://schemas.microsoft.com/office/drawing/2014/main" id="{EA59DA2E-8572-9B68-793C-55E5FD9AB535}"/>
               </a:ext>
             </a:extLst>
           </p:cNvPr>
@@ -1863,7 +1863,7 @@
           <p:cNvPr id="9" name="Marcador de número de diapositiva 8">
             <a:extLst>
               <a:ext uri="{FF2B5EF4-FFF2-40B4-BE49-F238E27FC236}">
-                <a16:creationId xmlns:a16="http://schemas.microsoft.com/office/drawing/2014/main" id="{DDFA98F8-B109-C8D4-B883-DF8CD2E5DE92}"/>
+                <a16:creationId xmlns:a16="http://schemas.microsoft.com/office/drawing/2014/main" id="{E85E1E7C-FB27-5478-B7CC-B2D9E4DC9CFC}"/>
               </a:ext>
             </a:extLst>
           </p:cNvPr>
@@ -1879,7 +1879,7 @@
           <a:bodyPr/>
           <a:lstStyle/>
           <a:p>
-            <a:fld id="{B3465923-C01A-429D-BF48-FE1C1E8CA486}" type="slidenum">
+            <a:fld id="{357192D4-5BD9-41C8-9EE5-942CB5B156C9}" type="slidenum">
               <a:rPr lang="es-ES" smtClean="0"/>
               <a:t>‹Nº›</a:t>
             </a:fld>
@@ -1890,7 +1890,7 @@
     </p:spTree>
     <p:extLst>
       <p:ext uri="{BB962C8B-B14F-4D97-AF65-F5344CB8AC3E}">
-        <p14:creationId xmlns:p14="http://schemas.microsoft.com/office/powerpoint/2010/main" val="3846948294"/>
+        <p14:creationId xmlns:p14="http://schemas.microsoft.com/office/powerpoint/2010/main" val="1082468512"/>
       </p:ext>
     </p:extLst>
   </p:cSld>
@@ -1922,7 +1922,7 @@
           <p:cNvPr id="2" name="Título 1">
             <a:extLst>
               <a:ext uri="{FF2B5EF4-FFF2-40B4-BE49-F238E27FC236}">
-                <a16:creationId xmlns:a16="http://schemas.microsoft.com/office/drawing/2014/main" id="{074145F3-8199-D652-0EA9-25539AAC56AA}"/>
+                <a16:creationId xmlns:a16="http://schemas.microsoft.com/office/drawing/2014/main" id="{1DCF473E-51F7-D4A4-404E-56FC61F961C2}"/>
               </a:ext>
             </a:extLst>
           </p:cNvPr>
@@ -1950,7 +1950,7 @@
           <p:cNvPr id="3" name="Marcador de fecha 2">
             <a:extLst>
               <a:ext uri="{FF2B5EF4-FFF2-40B4-BE49-F238E27FC236}">
-                <a16:creationId xmlns:a16="http://schemas.microsoft.com/office/drawing/2014/main" id="{4457EB84-2E78-A4B6-D3D2-C4FB4D1B5346}"/>
+                <a16:creationId xmlns:a16="http://schemas.microsoft.com/office/drawing/2014/main" id="{DC2BF4BF-32DA-9453-FCF1-4E82CF0476F8}"/>
               </a:ext>
             </a:extLst>
           </p:cNvPr>
@@ -1966,7 +1966,7 @@
           <a:bodyPr/>
           <a:lstStyle/>
           <a:p>
-            <a:fld id="{AB9C1A0A-BF9E-48A0-991D-0EB02B84C89C}" type="datetimeFigureOut">
+            <a:fld id="{5EA62A27-1D85-48AD-90C3-37B244257CF0}" type="datetimeFigureOut">
               <a:rPr lang="es-ES" smtClean="0"/>
               <a:t>19/05/2026</a:t>
             </a:fld>
@@ -1979,7 +1979,7 @@
           <p:cNvPr id="4" name="Marcador de pie de página 3">
             <a:extLst>
               <a:ext uri="{FF2B5EF4-FFF2-40B4-BE49-F238E27FC236}">
-                <a16:creationId xmlns:a16="http://schemas.microsoft.com/office/drawing/2014/main" id="{D97D25ED-0BC3-CF86-49E8-64B39358EBE8}"/>
+                <a16:creationId xmlns:a16="http://schemas.microsoft.com/office/drawing/2014/main" id="{13F41BD4-0A83-52D5-8B71-1E1B3DC8C9BD}"/>
               </a:ext>
             </a:extLst>
           </p:cNvPr>
@@ -2004,7 +2004,7 @@
           <p:cNvPr id="5" name="Marcador de número de diapositiva 4">
             <a:extLst>
               <a:ext uri="{FF2B5EF4-FFF2-40B4-BE49-F238E27FC236}">
-                <a16:creationId xmlns:a16="http://schemas.microsoft.com/office/drawing/2014/main" id="{1B127638-D7CA-147F-C3F0-4BEC62CCD5DD}"/>
+                <a16:creationId xmlns:a16="http://schemas.microsoft.com/office/drawing/2014/main" id="{12BB15A4-C317-4292-367F-A35A34F7E9E0}"/>
               </a:ext>
             </a:extLst>
           </p:cNvPr>
@@ -2020,7 +2020,7 @@
           <a:bodyPr/>
           <a:lstStyle/>
           <a:p>
-            <a:fld id="{B3465923-C01A-429D-BF48-FE1C1E8CA486}" type="slidenum">
+            <a:fld id="{357192D4-5BD9-41C8-9EE5-942CB5B156C9}" type="slidenum">
               <a:rPr lang="es-ES" smtClean="0"/>
               <a:t>‹Nº›</a:t>
             </a:fld>
@@ -2031,7 +2031,7 @@
     </p:spTree>
     <p:extLst>
       <p:ext uri="{BB962C8B-B14F-4D97-AF65-F5344CB8AC3E}">
-        <p14:creationId xmlns:p14="http://schemas.microsoft.com/office/powerpoint/2010/main" val="266854122"/>
+        <p14:creationId xmlns:p14="http://schemas.microsoft.com/office/powerpoint/2010/main" val="843809289"/>
       </p:ext>
     </p:extLst>
   </p:cSld>
@@ -2063,7 +2063,7 @@
           <p:cNvPr id="2" name="Marcador de fecha 1">
             <a:extLst>
               <a:ext uri="{FF2B5EF4-FFF2-40B4-BE49-F238E27FC236}">
-                <a16:creationId xmlns:a16="http://schemas.microsoft.com/office/drawing/2014/main" id="{277768E8-3F42-6276-86AF-68715D8E9A8D}"/>
+                <a16:creationId xmlns:a16="http://schemas.microsoft.com/office/drawing/2014/main" id="{BB770DBA-80A6-D082-CE82-4104E8F6A619}"/>
               </a:ext>
             </a:extLst>
           </p:cNvPr>
@@ -2079,7 +2079,7 @@
           <a:bodyPr/>
           <a:lstStyle/>
           <a:p>
-            <a:fld id="{AB9C1A0A-BF9E-48A0-991D-0EB02B84C89C}" type="datetimeFigureOut">
+            <a:fld id="{5EA62A27-1D85-48AD-90C3-37B244257CF0}" type="datetimeFigureOut">
               <a:rPr lang="es-ES" smtClean="0"/>
               <a:t>19/05/2026</a:t>
             </a:fld>
@@ -2092,7 +2092,7 @@
           <p:cNvPr id="3" name="Marcador de pie de página 2">
             <a:extLst>
               <a:ext uri="{FF2B5EF4-FFF2-40B4-BE49-F238E27FC236}">
-                <a16:creationId xmlns:a16="http://schemas.microsoft.com/office/drawing/2014/main" id="{AFC22073-20C1-8832-0253-F179A0226F60}"/>
+                <a16:creationId xmlns:a16="http://schemas.microsoft.com/office/drawing/2014/main" id="{ED8222E9-DDE3-B1D4-E6BA-2BBE6D5CAABC}"/>
               </a:ext>
             </a:extLst>
           </p:cNvPr>
@@ -2117,7 +2117,7 @@
           <p:cNvPr id="4" name="Marcador de número de diapositiva 3">
             <a:extLst>
               <a:ext uri="{FF2B5EF4-FFF2-40B4-BE49-F238E27FC236}">
-                <a16:creationId xmlns:a16="http://schemas.microsoft.com/office/drawing/2014/main" id="{A0702840-060A-E60B-D143-1F1FDA271F8A}"/>
+                <a16:creationId xmlns:a16="http://schemas.microsoft.com/office/drawing/2014/main" id="{5B05FE56-9D48-9873-839E-6DA6555E7DCD}"/>
               </a:ext>
             </a:extLst>
           </p:cNvPr>
@@ -2133,7 +2133,7 @@
           <a:bodyPr/>
           <a:lstStyle/>
           <a:p>
-            <a:fld id="{B3465923-C01A-429D-BF48-FE1C1E8CA486}" type="slidenum">
+            <a:fld id="{357192D4-5BD9-41C8-9EE5-942CB5B156C9}" type="slidenum">
               <a:rPr lang="es-ES" smtClean="0"/>
               <a:t>‹Nº›</a:t>
             </a:fld>
@@ -2144,7 +2144,7 @@
     </p:spTree>
     <p:extLst>
       <p:ext uri="{BB962C8B-B14F-4D97-AF65-F5344CB8AC3E}">
-        <p14:creationId xmlns:p14="http://schemas.microsoft.com/office/powerpoint/2010/main" val="1294746670"/>
+        <p14:creationId xmlns:p14="http://schemas.microsoft.com/office/powerpoint/2010/main" val="2185951776"/>
       </p:ext>
     </p:extLst>
   </p:cSld>
@@ -2176,7 +2176,7 @@
           <p:cNvPr id="2" name="Título 1">
             <a:extLst>
               <a:ext uri="{FF2B5EF4-FFF2-40B4-BE49-F238E27FC236}">
-                <a16:creationId xmlns:a16="http://schemas.microsoft.com/office/drawing/2014/main" id="{254CCFB2-E81E-F719-766D-D55382D7FD3A}"/>
+                <a16:creationId xmlns:a16="http://schemas.microsoft.com/office/drawing/2014/main" id="{4BE62A58-AF8A-3FB8-EA0A-1ABF9C4B8B69}"/>
               </a:ext>
             </a:extLst>
           </p:cNvPr>
@@ -2213,7 +2213,7 @@
           <p:cNvPr id="3" name="Marcador de contenido 2">
             <a:extLst>
               <a:ext uri="{FF2B5EF4-FFF2-40B4-BE49-F238E27FC236}">
-                <a16:creationId xmlns:a16="http://schemas.microsoft.com/office/drawing/2014/main" id="{952FC578-50BC-9A1A-9F42-60BDC233E2A7}"/>
+                <a16:creationId xmlns:a16="http://schemas.microsoft.com/office/drawing/2014/main" id="{1A83C48F-EE56-D384-1B9C-B1E1C5E07EF4}"/>
               </a:ext>
             </a:extLst>
           </p:cNvPr>
@@ -2303,7 +2303,7 @@
           <p:cNvPr id="4" name="Marcador de texto 3">
             <a:extLst>
               <a:ext uri="{FF2B5EF4-FFF2-40B4-BE49-F238E27FC236}">
-                <a16:creationId xmlns:a16="http://schemas.microsoft.com/office/drawing/2014/main" id="{FA6805FF-578A-B13E-9A1C-74EB8A8CBF86}"/>
+                <a16:creationId xmlns:a16="http://schemas.microsoft.com/office/drawing/2014/main" id="{062B874F-BC36-715D-D132-8FD325459989}"/>
               </a:ext>
             </a:extLst>
           </p:cNvPr>
@@ -2374,7 +2374,7 @@
           <p:cNvPr id="5" name="Marcador de fecha 4">
             <a:extLst>
               <a:ext uri="{FF2B5EF4-FFF2-40B4-BE49-F238E27FC236}">
-                <a16:creationId xmlns:a16="http://schemas.microsoft.com/office/drawing/2014/main" id="{6038623A-9E5A-3228-0571-79279CCE6023}"/>
+                <a16:creationId xmlns:a16="http://schemas.microsoft.com/office/drawing/2014/main" id="{E80A516C-DDEA-C052-9308-F388DDF0178F}"/>
               </a:ext>
             </a:extLst>
           </p:cNvPr>
@@ -2390,7 +2390,7 @@
           <a:bodyPr/>
           <a:lstStyle/>
           <a:p>
-            <a:fld id="{AB9C1A0A-BF9E-48A0-991D-0EB02B84C89C}" type="datetimeFigureOut">
+            <a:fld id="{5EA62A27-1D85-48AD-90C3-37B244257CF0}" type="datetimeFigureOut">
               <a:rPr lang="es-ES" smtClean="0"/>
               <a:t>19/05/2026</a:t>
             </a:fld>
@@ -2403,7 +2403,7 @@
           <p:cNvPr id="6" name="Marcador de pie de página 5">
             <a:extLst>
               <a:ext uri="{FF2B5EF4-FFF2-40B4-BE49-F238E27FC236}">
-                <a16:creationId xmlns:a16="http://schemas.microsoft.com/office/drawing/2014/main" id="{E1793859-5ABA-672E-9504-362653336615}"/>
+                <a16:creationId xmlns:a16="http://schemas.microsoft.com/office/drawing/2014/main" id="{2957D22E-3E4E-3BA1-E165-39275168A942}"/>
               </a:ext>
             </a:extLst>
           </p:cNvPr>
@@ -2428,7 +2428,7 @@
           <p:cNvPr id="7" name="Marcador de número de diapositiva 6">
             <a:extLst>
               <a:ext uri="{FF2B5EF4-FFF2-40B4-BE49-F238E27FC236}">
-                <a16:creationId xmlns:a16="http://schemas.microsoft.com/office/drawing/2014/main" id="{BC603FE4-4FC9-6622-C43B-7AD3545EAB0D}"/>
+                <a16:creationId xmlns:a16="http://schemas.microsoft.com/office/drawing/2014/main" id="{E9CD3F2A-5D76-4B7C-3D0E-CC8CE2B8C370}"/>
               </a:ext>
             </a:extLst>
           </p:cNvPr>
@@ -2444,7 +2444,7 @@
           <a:bodyPr/>
           <a:lstStyle/>
           <a:p>
-            <a:fld id="{B3465923-C01A-429D-BF48-FE1C1E8CA486}" type="slidenum">
+            <a:fld id="{357192D4-5BD9-41C8-9EE5-942CB5B156C9}" type="slidenum">
               <a:rPr lang="es-ES" smtClean="0"/>
               <a:t>‹Nº›</a:t>
             </a:fld>
@@ -2455,7 +2455,7 @@
     </p:spTree>
     <p:extLst>
       <p:ext uri="{BB962C8B-B14F-4D97-AF65-F5344CB8AC3E}">
-        <p14:creationId xmlns:p14="http://schemas.microsoft.com/office/powerpoint/2010/main" val="4121965106"/>
+        <p14:creationId xmlns:p14="http://schemas.microsoft.com/office/powerpoint/2010/main" val="2092824997"/>
       </p:ext>
     </p:extLst>
   </p:cSld>
@@ -2487,7 +2487,7 @@
           <p:cNvPr id="2" name="Título 1">
             <a:extLst>
               <a:ext uri="{FF2B5EF4-FFF2-40B4-BE49-F238E27FC236}">
-                <a16:creationId xmlns:a16="http://schemas.microsoft.com/office/drawing/2014/main" id="{D27F6048-BB77-75B2-E0F5-556AA73FBDDE}"/>
+                <a16:creationId xmlns:a16="http://schemas.microsoft.com/office/drawing/2014/main" id="{B4EA0205-E1B1-D315-A143-01A9D00CFD7A}"/>
               </a:ext>
             </a:extLst>
           </p:cNvPr>
@@ -2524,7 +2524,7 @@
           <p:cNvPr id="3" name="Marcador de posición de imagen 2">
             <a:extLst>
               <a:ext uri="{FF2B5EF4-FFF2-40B4-BE49-F238E27FC236}">
-                <a16:creationId xmlns:a16="http://schemas.microsoft.com/office/drawing/2014/main" id="{3B4CB789-4CC6-7027-7FB7-32FEDDD1081C}"/>
+                <a16:creationId xmlns:a16="http://schemas.microsoft.com/office/drawing/2014/main" id="{5BADC2F0-6160-7416-B388-A10C87991244}"/>
               </a:ext>
             </a:extLst>
           </p:cNvPr>
@@ -2591,7 +2591,7 @@
           <p:cNvPr id="4" name="Marcador de texto 3">
             <a:extLst>
               <a:ext uri="{FF2B5EF4-FFF2-40B4-BE49-F238E27FC236}">
-                <a16:creationId xmlns:a16="http://schemas.microsoft.com/office/drawing/2014/main" id="{41E7A35C-702C-1D8B-E13C-D710823ABC57}"/>
+                <a16:creationId xmlns:a16="http://schemas.microsoft.com/office/drawing/2014/main" id="{3FC8B46F-1A24-D909-BB46-D0EA7E06A1A4}"/>
               </a:ext>
             </a:extLst>
           </p:cNvPr>
@@ -2662,7 +2662,7 @@
           <p:cNvPr id="5" name="Marcador de fecha 4">
             <a:extLst>
               <a:ext uri="{FF2B5EF4-FFF2-40B4-BE49-F238E27FC236}">
-                <a16:creationId xmlns:a16="http://schemas.microsoft.com/office/drawing/2014/main" id="{36632614-54E4-2380-00E4-802994933CF2}"/>
+                <a16:creationId xmlns:a16="http://schemas.microsoft.com/office/drawing/2014/main" id="{0247D9DE-E2CE-52AC-CCDB-87BE83C4EAE6}"/>
               </a:ext>
             </a:extLst>
           </p:cNvPr>
@@ -2678,7 +2678,7 @@
           <a:bodyPr/>
           <a:lstStyle/>
           <a:p>
-            <a:fld id="{AB9C1A0A-BF9E-48A0-991D-0EB02B84C89C}" type="datetimeFigureOut">
+            <a:fld id="{5EA62A27-1D85-48AD-90C3-37B244257CF0}" type="datetimeFigureOut">
               <a:rPr lang="es-ES" smtClean="0"/>
               <a:t>19/05/2026</a:t>
             </a:fld>
@@ -2691,7 +2691,7 @@
           <p:cNvPr id="6" name="Marcador de pie de página 5">
             <a:extLst>
               <a:ext uri="{FF2B5EF4-FFF2-40B4-BE49-F238E27FC236}">
-                <a16:creationId xmlns:a16="http://schemas.microsoft.com/office/drawing/2014/main" id="{E8EA630A-5FCE-62C7-BBCC-041308A8D028}"/>
+                <a16:creationId xmlns:a16="http://schemas.microsoft.com/office/drawing/2014/main" id="{10FEF411-C3D2-F204-D11D-12BEC439EB07}"/>
               </a:ext>
             </a:extLst>
           </p:cNvPr>
@@ -2716,7 +2716,7 @@
           <p:cNvPr id="7" name="Marcador de número de diapositiva 6">
             <a:extLst>
               <a:ext uri="{FF2B5EF4-FFF2-40B4-BE49-F238E27FC236}">
-                <a16:creationId xmlns:a16="http://schemas.microsoft.com/office/drawing/2014/main" id="{F7B00146-435A-13A2-94AE-52EA686AA928}"/>
+                <a16:creationId xmlns:a16="http://schemas.microsoft.com/office/drawing/2014/main" id="{504D838E-8580-34E0-3EB7-1118DCC31235}"/>
               </a:ext>
             </a:extLst>
           </p:cNvPr>
@@ -2732,7 +2732,7 @@
           <a:bodyPr/>
           <a:lstStyle/>
           <a:p>
-            <a:fld id="{B3465923-C01A-429D-BF48-FE1C1E8CA486}" type="slidenum">
+            <a:fld id="{357192D4-5BD9-41C8-9EE5-942CB5B156C9}" type="slidenum">
               <a:rPr lang="es-ES" smtClean="0"/>
               <a:t>‹Nº›</a:t>
             </a:fld>
@@ -2743,7 +2743,7 @@
     </p:spTree>
     <p:extLst>
       <p:ext uri="{BB962C8B-B14F-4D97-AF65-F5344CB8AC3E}">
-        <p14:creationId xmlns:p14="http://schemas.microsoft.com/office/powerpoint/2010/main" val="948003218"/>
+        <p14:creationId xmlns:p14="http://schemas.microsoft.com/office/powerpoint/2010/main" val="1370303788"/>
       </p:ext>
     </p:extLst>
   </p:cSld>
@@ -2780,7 +2780,7 @@
           <p:cNvPr id="2" name="Marcador de título 1">
             <a:extLst>
               <a:ext uri="{FF2B5EF4-FFF2-40B4-BE49-F238E27FC236}">
-                <a16:creationId xmlns:a16="http://schemas.microsoft.com/office/drawing/2014/main" id="{73E795E7-988F-6D5A-2223-AFB25A944D0D}"/>
+                <a16:creationId xmlns:a16="http://schemas.microsoft.com/office/drawing/2014/main" id="{72786C14-7D58-E4B6-34F2-327E67DD1DA7}"/>
               </a:ext>
             </a:extLst>
           </p:cNvPr>
@@ -2818,7 +2818,7 @@
           <p:cNvPr id="3" name="Marcador de texto 2">
             <a:extLst>
               <a:ext uri="{FF2B5EF4-FFF2-40B4-BE49-F238E27FC236}">
-                <a16:creationId xmlns:a16="http://schemas.microsoft.com/office/drawing/2014/main" id="{3176D17D-F500-CAF0-EB2E-9DD9DFBEFBE3}"/>
+                <a16:creationId xmlns:a16="http://schemas.microsoft.com/office/drawing/2014/main" id="{97AEFCDE-9BDE-1271-E379-25AE01116B23}"/>
               </a:ext>
             </a:extLst>
           </p:cNvPr>
@@ -2885,7 +2885,7 @@
           <p:cNvPr id="4" name="Marcador de fecha 3">
             <a:extLst>
               <a:ext uri="{FF2B5EF4-FFF2-40B4-BE49-F238E27FC236}">
-                <a16:creationId xmlns:a16="http://schemas.microsoft.com/office/drawing/2014/main" id="{C8D3EAFA-06BC-8492-B4AD-7465FE9219D9}"/>
+                <a16:creationId xmlns:a16="http://schemas.microsoft.com/office/drawing/2014/main" id="{2C386A11-5809-CF73-C86F-4A15E6AD7B55}"/>
               </a:ext>
             </a:extLst>
           </p:cNvPr>
@@ -2919,7 +2919,7 @@
             </a:lvl1pPr>
           </a:lstStyle>
           <a:p>
-            <a:fld id="{AB9C1A0A-BF9E-48A0-991D-0EB02B84C89C}" type="datetimeFigureOut">
+            <a:fld id="{5EA62A27-1D85-48AD-90C3-37B244257CF0}" type="datetimeFigureOut">
               <a:rPr lang="es-ES" smtClean="0"/>
               <a:t>19/05/2026</a:t>
             </a:fld>
@@ -2932,7 +2932,7 @@
           <p:cNvPr id="5" name="Marcador de pie de página 4">
             <a:extLst>
               <a:ext uri="{FF2B5EF4-FFF2-40B4-BE49-F238E27FC236}">
-                <a16:creationId xmlns:a16="http://schemas.microsoft.com/office/drawing/2014/main" id="{6A64E50F-701B-BD30-C2B7-F8BB0DFF3D0F}"/>
+                <a16:creationId xmlns:a16="http://schemas.microsoft.com/office/drawing/2014/main" id="{0FCD38D0-3C3E-52AC-389B-35B51C2CE478}"/>
               </a:ext>
             </a:extLst>
           </p:cNvPr>
@@ -2975,7 +2975,7 @@
           <p:cNvPr id="6" name="Marcador de número de diapositiva 5">
             <a:extLst>
               <a:ext uri="{FF2B5EF4-FFF2-40B4-BE49-F238E27FC236}">
-                <a16:creationId xmlns:a16="http://schemas.microsoft.com/office/drawing/2014/main" id="{8911B98D-8394-836F-1E49-B6D987852199}"/>
+                <a16:creationId xmlns:a16="http://schemas.microsoft.com/office/drawing/2014/main" id="{E52B3E20-F6CA-0C98-43CD-121A885307B9}"/>
               </a:ext>
             </a:extLst>
           </p:cNvPr>
@@ -3009,7 +3009,7 @@
             </a:lvl1pPr>
           </a:lstStyle>
           <a:p>
-            <a:fld id="{B3465923-C01A-429D-BF48-FE1C1E8CA486}" type="slidenum">
+            <a:fld id="{357192D4-5BD9-41C8-9EE5-942CB5B156C9}" type="slidenum">
               <a:rPr lang="es-ES" smtClean="0"/>
               <a:t>‹Nº›</a:t>
             </a:fld>
@@ -3020,7 +3020,7 @@
     </p:spTree>
     <p:extLst>
       <p:ext uri="{BB962C8B-B14F-4D97-AF65-F5344CB8AC3E}">
-        <p14:creationId xmlns:p14="http://schemas.microsoft.com/office/powerpoint/2010/main" val="3424308497"/>
+        <p14:creationId xmlns:p14="http://schemas.microsoft.com/office/powerpoint/2010/main" val="3537115536"/>
       </p:ext>
     </p:extLst>
   </p:cSld>
@@ -3351,7 +3351,7 @@
           <p:cNvPr id="2" name="Rectángulo: esquinas redondeadas 1">
             <a:extLst>
               <a:ext uri="{FF2B5EF4-FFF2-40B4-BE49-F238E27FC236}">
-                <a16:creationId xmlns:a16="http://schemas.microsoft.com/office/drawing/2014/main" id="{8D26A0E0-FB4C-849C-CDCB-FE3596B00D95}"/>
+                <a16:creationId xmlns:a16="http://schemas.microsoft.com/office/drawing/2014/main" id="{D205D9E9-2B2A-8449-3280-81D4BA71935C}"/>
               </a:ext>
             </a:extLst>
           </p:cNvPr>
@@ -3405,7 +3405,7 @@
           <p:cNvPr id="3" name="CuadroTexto 2">
             <a:extLst>
               <a:ext uri="{FF2B5EF4-FFF2-40B4-BE49-F238E27FC236}">
-                <a16:creationId xmlns:a16="http://schemas.microsoft.com/office/drawing/2014/main" id="{0C0ABDE1-768B-4E8F-4DF2-1182CD15BFB9}"/>
+                <a16:creationId xmlns:a16="http://schemas.microsoft.com/office/drawing/2014/main" id="{8CD26C4F-EB69-6F68-D6A8-EFDFAAB9A2EE}"/>
               </a:ext>
             </a:extLst>
           </p:cNvPr>
@@ -3445,7 +3445,7 @@
           <p:cNvPr id="4" name="CuadroTexto 3">
             <a:extLst>
               <a:ext uri="{FF2B5EF4-FFF2-40B4-BE49-F238E27FC236}">
-                <a16:creationId xmlns:a16="http://schemas.microsoft.com/office/drawing/2014/main" id="{E9513875-C1AF-3123-1236-18C82A862A02}"/>
+                <a16:creationId xmlns:a16="http://schemas.microsoft.com/office/drawing/2014/main" id="{6594C209-D7CD-32E9-0092-BEEDDDE630D1}"/>
               </a:ext>
             </a:extLst>
           </p:cNvPr>
@@ -3485,7 +3485,7 @@
           <p:cNvPr id="5" name="CuadroTexto 4">
             <a:extLst>
               <a:ext uri="{FF2B5EF4-FFF2-40B4-BE49-F238E27FC236}">
-                <a16:creationId xmlns:a16="http://schemas.microsoft.com/office/drawing/2014/main" id="{78CE9AC4-3231-5E43-571C-63C921B839FE}"/>
+                <a16:creationId xmlns:a16="http://schemas.microsoft.com/office/drawing/2014/main" id="{0010246E-364B-3BEC-B71E-FE18CDB86658}"/>
               </a:ext>
             </a:extLst>
           </p:cNvPr>
@@ -3525,7 +3525,7 @@
           <p:cNvPr id="6" name="CuadroTexto 5">
             <a:extLst>
               <a:ext uri="{FF2B5EF4-FFF2-40B4-BE49-F238E27FC236}">
-                <a16:creationId xmlns:a16="http://schemas.microsoft.com/office/drawing/2014/main" id="{C269820E-5F1A-E35A-BF32-5F29D2355FF6}"/>
+                <a16:creationId xmlns:a16="http://schemas.microsoft.com/office/drawing/2014/main" id="{2C422221-3442-CE74-2513-F43623CAB150}"/>
               </a:ext>
             </a:extLst>
           </p:cNvPr>
@@ -3576,7 +3576,7 @@
           <p:cNvPr id="8" name="Imagen 7">
             <a:extLst>
               <a:ext uri="{FF2B5EF4-FFF2-40B4-BE49-F238E27FC236}">
-                <a16:creationId xmlns:a16="http://schemas.microsoft.com/office/drawing/2014/main" id="{FEBD596F-2F18-6433-8D13-E18EBF7F6B0C}"/>
+                <a16:creationId xmlns:a16="http://schemas.microsoft.com/office/drawing/2014/main" id="{7A6C684F-BE85-6DFF-BFD5-BD4E0258C0E8}"/>
               </a:ext>
             </a:extLst>
           </p:cNvPr>
@@ -3615,7 +3615,7 @@
     </p:spTree>
     <p:extLst>
       <p:ext uri="{BB962C8B-B14F-4D97-AF65-F5344CB8AC3E}">
-        <p14:creationId xmlns:p14="http://schemas.microsoft.com/office/powerpoint/2010/main" val="2070698356"/>
+        <p14:creationId xmlns:p14="http://schemas.microsoft.com/office/powerpoint/2010/main" val="1724773751"/>
       </p:ext>
     </p:extLst>
   </p:cSld>
@@ -3655,7 +3655,7 @@
           <p:cNvPr id="2" name="CuadroTexto 1">
             <a:extLst>
               <a:ext uri="{FF2B5EF4-FFF2-40B4-BE49-F238E27FC236}">
-                <a16:creationId xmlns:a16="http://schemas.microsoft.com/office/drawing/2014/main" id="{B53EF905-F911-2F31-FAD0-191A0ABDC738}"/>
+                <a16:creationId xmlns:a16="http://schemas.microsoft.com/office/drawing/2014/main" id="{98AAE408-EF69-259D-BAA6-33ED04A04C57}"/>
               </a:ext>
             </a:extLst>
           </p:cNvPr>
@@ -3695,7 +3695,7 @@
           <p:cNvPr id="3" name="CuadroTexto 2">
             <a:extLst>
               <a:ext uri="{FF2B5EF4-FFF2-40B4-BE49-F238E27FC236}">
-                <a16:creationId xmlns:a16="http://schemas.microsoft.com/office/drawing/2014/main" id="{EAC5B46A-73DC-C0DA-A717-F918A125DF90}"/>
+                <a16:creationId xmlns:a16="http://schemas.microsoft.com/office/drawing/2014/main" id="{D086D1C7-C914-B072-1836-0199861C2628}"/>
               </a:ext>
             </a:extLst>
           </p:cNvPr>
@@ -3735,7 +3735,7 @@
           <p:cNvPr id="4" name="CuadroTexto 3">
             <a:extLst>
               <a:ext uri="{FF2B5EF4-FFF2-40B4-BE49-F238E27FC236}">
-                <a16:creationId xmlns:a16="http://schemas.microsoft.com/office/drawing/2014/main" id="{DD9A8A3D-6BE3-DF76-621E-68EC907B1E31}"/>
+                <a16:creationId xmlns:a16="http://schemas.microsoft.com/office/drawing/2014/main" id="{CDF96AA8-6440-8183-2342-0628F8D93C1A}"/>
               </a:ext>
             </a:extLst>
           </p:cNvPr>
@@ -3775,7 +3775,7 @@
           <p:cNvPr id="5" name="Rectángulo: esquinas redondeadas 4">
             <a:extLst>
               <a:ext uri="{FF2B5EF4-FFF2-40B4-BE49-F238E27FC236}">
-                <a16:creationId xmlns:a16="http://schemas.microsoft.com/office/drawing/2014/main" id="{10267645-03DD-3F9E-8A5C-ACC0A038705F}"/>
+                <a16:creationId xmlns:a16="http://schemas.microsoft.com/office/drawing/2014/main" id="{72C7F4DA-D661-40BE-C733-D0CFC5C5D4DF}"/>
               </a:ext>
             </a:extLst>
           </p:cNvPr>
@@ -3829,7 +3829,7 @@
           <p:cNvPr id="6" name="CuadroTexto 5">
             <a:extLst>
               <a:ext uri="{FF2B5EF4-FFF2-40B4-BE49-F238E27FC236}">
-                <a16:creationId xmlns:a16="http://schemas.microsoft.com/office/drawing/2014/main" id="{D3574122-3348-8DEC-8605-5777C07B6B77}"/>
+                <a16:creationId xmlns:a16="http://schemas.microsoft.com/office/drawing/2014/main" id="{8DBAA4C0-2D71-CAC0-B5DE-D0FBDD24023B}"/>
               </a:ext>
             </a:extLst>
           </p:cNvPr>
@@ -3869,7 +3869,7 @@
           <p:cNvPr id="7" name="CuadroTexto 6">
             <a:extLst>
               <a:ext uri="{FF2B5EF4-FFF2-40B4-BE49-F238E27FC236}">
-                <a16:creationId xmlns:a16="http://schemas.microsoft.com/office/drawing/2014/main" id="{DECE2E86-538E-E01B-C1A1-43D459DEDF96}"/>
+                <a16:creationId xmlns:a16="http://schemas.microsoft.com/office/drawing/2014/main" id="{2F5E01B1-602E-9AAB-E81C-2CD851951762}"/>
               </a:ext>
             </a:extLst>
           </p:cNvPr>
@@ -3988,7 +3988,7 @@
           <p:cNvPr id="8" name="Rectángulo: esquinas redondeadas 7">
             <a:extLst>
               <a:ext uri="{FF2B5EF4-FFF2-40B4-BE49-F238E27FC236}">
-                <a16:creationId xmlns:a16="http://schemas.microsoft.com/office/drawing/2014/main" id="{FE4AC941-C4EB-6AA4-CFEF-367570CD132C}"/>
+                <a16:creationId xmlns:a16="http://schemas.microsoft.com/office/drawing/2014/main" id="{B951AA5D-2568-173E-3564-B6188845BFAB}"/>
               </a:ext>
             </a:extLst>
           </p:cNvPr>
@@ -4042,7 +4042,7 @@
           <p:cNvPr id="9" name="CuadroTexto 8">
             <a:extLst>
               <a:ext uri="{FF2B5EF4-FFF2-40B4-BE49-F238E27FC236}">
-                <a16:creationId xmlns:a16="http://schemas.microsoft.com/office/drawing/2014/main" id="{DA230D46-A039-48F1-6951-B3907F354812}"/>
+                <a16:creationId xmlns:a16="http://schemas.microsoft.com/office/drawing/2014/main" id="{A718BDB6-8A2A-59D7-94D9-1ABB0C32B839}"/>
               </a:ext>
             </a:extLst>
           </p:cNvPr>
@@ -4082,7 +4082,7 @@
           <p:cNvPr id="10" name="CuadroTexto 9">
             <a:extLst>
               <a:ext uri="{FF2B5EF4-FFF2-40B4-BE49-F238E27FC236}">
-                <a16:creationId xmlns:a16="http://schemas.microsoft.com/office/drawing/2014/main" id="{F9D1DCA1-02C2-37EC-F365-BF7A1591B8A5}"/>
+                <a16:creationId xmlns:a16="http://schemas.microsoft.com/office/drawing/2014/main" id="{C3202201-B8E7-16DA-060E-49AFEAAA9BBA}"/>
               </a:ext>
             </a:extLst>
           </p:cNvPr>
@@ -4122,7 +4122,7 @@
           <p:cNvPr id="11" name="Rectángulo: esquinas redondeadas 10">
             <a:extLst>
               <a:ext uri="{FF2B5EF4-FFF2-40B4-BE49-F238E27FC236}">
-                <a16:creationId xmlns:a16="http://schemas.microsoft.com/office/drawing/2014/main" id="{E39B7F81-D49F-313C-4427-E8F19D10EEAC}"/>
+                <a16:creationId xmlns:a16="http://schemas.microsoft.com/office/drawing/2014/main" id="{19370CEA-D01B-E710-52C7-F1754B5DF4BD}"/>
               </a:ext>
             </a:extLst>
           </p:cNvPr>
@@ -4176,7 +4176,7 @@
           <p:cNvPr id="12" name="CuadroTexto 11">
             <a:extLst>
               <a:ext uri="{FF2B5EF4-FFF2-40B4-BE49-F238E27FC236}">
-                <a16:creationId xmlns:a16="http://schemas.microsoft.com/office/drawing/2014/main" id="{6A87F822-D891-FF4A-0F02-3A44124C393C}"/>
+                <a16:creationId xmlns:a16="http://schemas.microsoft.com/office/drawing/2014/main" id="{F9ED67AE-12C2-53C7-385C-8F3B9E9C1C06}"/>
               </a:ext>
             </a:extLst>
           </p:cNvPr>
@@ -4216,7 +4216,7 @@
           <p:cNvPr id="13" name="CuadroTexto 12">
             <a:extLst>
               <a:ext uri="{FF2B5EF4-FFF2-40B4-BE49-F238E27FC236}">
-                <a16:creationId xmlns:a16="http://schemas.microsoft.com/office/drawing/2014/main" id="{CBD15F83-4415-9C0B-7155-65874520B084}"/>
+                <a16:creationId xmlns:a16="http://schemas.microsoft.com/office/drawing/2014/main" id="{938D04B1-01AA-9D2C-F15B-DFF6B72BEBF0}"/>
               </a:ext>
             </a:extLst>
           </p:cNvPr>
@@ -4256,7 +4256,7 @@
           <p:cNvPr id="14" name="Rectángulo: esquinas redondeadas 13">
             <a:extLst>
               <a:ext uri="{FF2B5EF4-FFF2-40B4-BE49-F238E27FC236}">
-                <a16:creationId xmlns:a16="http://schemas.microsoft.com/office/drawing/2014/main" id="{E6277D89-DBAA-2D26-1F05-0DDA9C48350B}"/>
+                <a16:creationId xmlns:a16="http://schemas.microsoft.com/office/drawing/2014/main" id="{61A4F89D-7193-1ED4-7F96-DE96ED033F1D}"/>
               </a:ext>
             </a:extLst>
           </p:cNvPr>
@@ -4310,7 +4310,7 @@
           <p:cNvPr id="15" name="CuadroTexto 14">
             <a:extLst>
               <a:ext uri="{FF2B5EF4-FFF2-40B4-BE49-F238E27FC236}">
-                <a16:creationId xmlns:a16="http://schemas.microsoft.com/office/drawing/2014/main" id="{AFBCEB81-C9E4-117B-6E0E-691521121747}"/>
+                <a16:creationId xmlns:a16="http://schemas.microsoft.com/office/drawing/2014/main" id="{364A9D98-FAC5-DD14-0376-22899E9C74B4}"/>
               </a:ext>
             </a:extLst>
           </p:cNvPr>
@@ -4350,7 +4350,7 @@
           <p:cNvPr id="16" name="CuadroTexto 15">
             <a:extLst>
               <a:ext uri="{FF2B5EF4-FFF2-40B4-BE49-F238E27FC236}">
-                <a16:creationId xmlns:a16="http://schemas.microsoft.com/office/drawing/2014/main" id="{6CBE7796-47DA-A9C1-28C3-B31118239767}"/>
+                <a16:creationId xmlns:a16="http://schemas.microsoft.com/office/drawing/2014/main" id="{5A4CDBA9-9DAC-8B1F-16A9-301C5313FD4B}"/>
               </a:ext>
             </a:extLst>
           </p:cNvPr>
@@ -4390,7 +4390,7 @@
           <p:cNvPr id="17" name="Rectángulo: esquinas redondeadas 16">
             <a:extLst>
               <a:ext uri="{FF2B5EF4-FFF2-40B4-BE49-F238E27FC236}">
-                <a16:creationId xmlns:a16="http://schemas.microsoft.com/office/drawing/2014/main" id="{E412FF78-0457-639A-95B9-F5A764DC1F2E}"/>
+                <a16:creationId xmlns:a16="http://schemas.microsoft.com/office/drawing/2014/main" id="{658C09E8-6A59-E416-E38F-35F2C3BE7A31}"/>
               </a:ext>
             </a:extLst>
           </p:cNvPr>
@@ -4444,7 +4444,7 @@
           <p:cNvPr id="18" name="CuadroTexto 17">
             <a:extLst>
               <a:ext uri="{FF2B5EF4-FFF2-40B4-BE49-F238E27FC236}">
-                <a16:creationId xmlns:a16="http://schemas.microsoft.com/office/drawing/2014/main" id="{101D4939-99A3-2E12-1723-E851F1822DD1}"/>
+                <a16:creationId xmlns:a16="http://schemas.microsoft.com/office/drawing/2014/main" id="{4E03C3C2-56D3-8B47-CBB2-B8C6BB906DE5}"/>
               </a:ext>
             </a:extLst>
           </p:cNvPr>
@@ -4484,7 +4484,7 @@
           <p:cNvPr id="19" name="CuadroTexto 18">
             <a:extLst>
               <a:ext uri="{FF2B5EF4-FFF2-40B4-BE49-F238E27FC236}">
-                <a16:creationId xmlns:a16="http://schemas.microsoft.com/office/drawing/2014/main" id="{930D73CA-612E-113F-E469-7345AC7385B8}"/>
+                <a16:creationId xmlns:a16="http://schemas.microsoft.com/office/drawing/2014/main" id="{BA8A35CA-E482-34AF-FE89-1AF1BABFD828}"/>
               </a:ext>
             </a:extLst>
           </p:cNvPr>
@@ -4522,7 +4522,7 @@
     </p:spTree>
     <p:extLst>
       <p:ext uri="{BB962C8B-B14F-4D97-AF65-F5344CB8AC3E}">
-        <p14:creationId xmlns:p14="http://schemas.microsoft.com/office/powerpoint/2010/main" val="1085261756"/>
+        <p14:creationId xmlns:p14="http://schemas.microsoft.com/office/powerpoint/2010/main" val="239697957"/>
       </p:ext>
     </p:extLst>
   </p:cSld>
@@ -4562,7 +4562,7 @@
           <p:cNvPr id="2" name="CuadroTexto 1">
             <a:extLst>
               <a:ext uri="{FF2B5EF4-FFF2-40B4-BE49-F238E27FC236}">
-                <a16:creationId xmlns:a16="http://schemas.microsoft.com/office/drawing/2014/main" id="{39CE2496-B627-360A-0DE6-E28B88385026}"/>
+                <a16:creationId xmlns:a16="http://schemas.microsoft.com/office/drawing/2014/main" id="{6F1E9EC0-F667-4B56-359D-972CD20039E1}"/>
               </a:ext>
             </a:extLst>
           </p:cNvPr>
@@ -4602,7 +4602,7 @@
           <p:cNvPr id="3" name="CuadroTexto 2">
             <a:extLst>
               <a:ext uri="{FF2B5EF4-FFF2-40B4-BE49-F238E27FC236}">
-                <a16:creationId xmlns:a16="http://schemas.microsoft.com/office/drawing/2014/main" id="{BEAAC5C9-558C-9D42-5BE1-5C7307F83F09}"/>
+                <a16:creationId xmlns:a16="http://schemas.microsoft.com/office/drawing/2014/main" id="{15DCCC73-4BD4-AE87-0667-46774F68DE5A}"/>
               </a:ext>
             </a:extLst>
           </p:cNvPr>
@@ -4642,7 +4642,7 @@
           <p:cNvPr id="4" name="CuadroTexto 3">
             <a:extLst>
               <a:ext uri="{FF2B5EF4-FFF2-40B4-BE49-F238E27FC236}">
-                <a16:creationId xmlns:a16="http://schemas.microsoft.com/office/drawing/2014/main" id="{B69B89BD-8C1F-4180-61AA-830F085D55A4}"/>
+                <a16:creationId xmlns:a16="http://schemas.microsoft.com/office/drawing/2014/main" id="{21A5879C-26AE-E6A0-295B-83A024344107}"/>
               </a:ext>
             </a:extLst>
           </p:cNvPr>
@@ -4682,7 +4682,7 @@
           <p:cNvPr id="5" name="Rectángulo: esquinas redondeadas 4">
             <a:extLst>
               <a:ext uri="{FF2B5EF4-FFF2-40B4-BE49-F238E27FC236}">
-                <a16:creationId xmlns:a16="http://schemas.microsoft.com/office/drawing/2014/main" id="{A18BF32F-543C-4B07-53B5-071EF1D619EA}"/>
+                <a16:creationId xmlns:a16="http://schemas.microsoft.com/office/drawing/2014/main" id="{A2FED42F-BB72-4BBF-D508-E0FD37612B99}"/>
               </a:ext>
             </a:extLst>
           </p:cNvPr>
@@ -4736,7 +4736,7 @@
           <p:cNvPr id="6" name="CuadroTexto 5">
             <a:extLst>
               <a:ext uri="{FF2B5EF4-FFF2-40B4-BE49-F238E27FC236}">
-                <a16:creationId xmlns:a16="http://schemas.microsoft.com/office/drawing/2014/main" id="{7F47EC61-8F1D-2851-871F-131752F80F3C}"/>
+                <a16:creationId xmlns:a16="http://schemas.microsoft.com/office/drawing/2014/main" id="{52F9094C-B5EA-4D0E-AFCF-A07B6E20E5C6}"/>
               </a:ext>
             </a:extLst>
           </p:cNvPr>
@@ -4776,7 +4776,7 @@
           <p:cNvPr id="7" name="CuadroTexto 6">
             <a:extLst>
               <a:ext uri="{FF2B5EF4-FFF2-40B4-BE49-F238E27FC236}">
-                <a16:creationId xmlns:a16="http://schemas.microsoft.com/office/drawing/2014/main" id="{EDC65C6E-A3AC-7652-FC0C-195AF025C4A3}"/>
+                <a16:creationId xmlns:a16="http://schemas.microsoft.com/office/drawing/2014/main" id="{2EBD63C4-9FE0-B826-1C14-DFD65B38CCF5}"/>
               </a:ext>
             </a:extLst>
           </p:cNvPr>
@@ -4816,7 +4816,7 @@
           <p:cNvPr id="8" name="Rectángulo: esquinas redondeadas 7">
             <a:extLst>
               <a:ext uri="{FF2B5EF4-FFF2-40B4-BE49-F238E27FC236}">
-                <a16:creationId xmlns:a16="http://schemas.microsoft.com/office/drawing/2014/main" id="{E665AABE-9481-7904-707B-8B83BD57F6EE}"/>
+                <a16:creationId xmlns:a16="http://schemas.microsoft.com/office/drawing/2014/main" id="{91A17B97-0060-DCF1-D36A-4D61DA7C94FE}"/>
               </a:ext>
             </a:extLst>
           </p:cNvPr>
@@ -4870,7 +4870,7 @@
           <p:cNvPr id="9" name="CuadroTexto 8">
             <a:extLst>
               <a:ext uri="{FF2B5EF4-FFF2-40B4-BE49-F238E27FC236}">
-                <a16:creationId xmlns:a16="http://schemas.microsoft.com/office/drawing/2014/main" id="{DFE73C81-E429-D3D9-830A-6DB641563943}"/>
+                <a16:creationId xmlns:a16="http://schemas.microsoft.com/office/drawing/2014/main" id="{1BCAE38A-E9B9-C367-4FB0-9D291BB46725}"/>
               </a:ext>
             </a:extLst>
           </p:cNvPr>
@@ -4910,7 +4910,7 @@
           <p:cNvPr id="10" name="CuadroTexto 9">
             <a:extLst>
               <a:ext uri="{FF2B5EF4-FFF2-40B4-BE49-F238E27FC236}">
-                <a16:creationId xmlns:a16="http://schemas.microsoft.com/office/drawing/2014/main" id="{B280473F-2B7C-326A-5B51-55325D52D43C}"/>
+                <a16:creationId xmlns:a16="http://schemas.microsoft.com/office/drawing/2014/main" id="{9D4FE66D-3B12-E967-6482-E6D8B4D660CA}"/>
               </a:ext>
             </a:extLst>
           </p:cNvPr>
@@ -4950,7 +4950,7 @@
           <p:cNvPr id="11" name="Rectángulo: esquinas redondeadas 10">
             <a:extLst>
               <a:ext uri="{FF2B5EF4-FFF2-40B4-BE49-F238E27FC236}">
-                <a16:creationId xmlns:a16="http://schemas.microsoft.com/office/drawing/2014/main" id="{6C36FDC8-533A-55F0-E957-C6CB5C8B24A9}"/>
+                <a16:creationId xmlns:a16="http://schemas.microsoft.com/office/drawing/2014/main" id="{8F23661F-2B82-5F38-1D07-61D5D3F3D5C8}"/>
               </a:ext>
             </a:extLst>
           </p:cNvPr>
@@ -5004,7 +5004,7 @@
           <p:cNvPr id="12" name="CuadroTexto 11">
             <a:extLst>
               <a:ext uri="{FF2B5EF4-FFF2-40B4-BE49-F238E27FC236}">
-                <a16:creationId xmlns:a16="http://schemas.microsoft.com/office/drawing/2014/main" id="{3A22A1A6-B1CF-A65E-0681-A3C7634201C6}"/>
+                <a16:creationId xmlns:a16="http://schemas.microsoft.com/office/drawing/2014/main" id="{997A0180-7500-75A2-C478-5D938FDD5E26}"/>
               </a:ext>
             </a:extLst>
           </p:cNvPr>
@@ -5044,7 +5044,7 @@
           <p:cNvPr id="13" name="CuadroTexto 12">
             <a:extLst>
               <a:ext uri="{FF2B5EF4-FFF2-40B4-BE49-F238E27FC236}">
-                <a16:creationId xmlns:a16="http://schemas.microsoft.com/office/drawing/2014/main" id="{7495F043-46E0-F646-7CC0-812ADC68107C}"/>
+                <a16:creationId xmlns:a16="http://schemas.microsoft.com/office/drawing/2014/main" id="{274E05EA-CCC9-48DA-6D32-AB0A437C2C5F}"/>
               </a:ext>
             </a:extLst>
           </p:cNvPr>
@@ -5084,7 +5084,7 @@
           <p:cNvPr id="14" name="CuadroTexto 13">
             <a:extLst>
               <a:ext uri="{FF2B5EF4-FFF2-40B4-BE49-F238E27FC236}">
-                <a16:creationId xmlns:a16="http://schemas.microsoft.com/office/drawing/2014/main" id="{AABD840C-177C-F59E-E464-A85BC72E47D1}"/>
+                <a16:creationId xmlns:a16="http://schemas.microsoft.com/office/drawing/2014/main" id="{F6B10B3E-18A4-45B7-ABE4-6A2D870E6727}"/>
               </a:ext>
             </a:extLst>
           </p:cNvPr>
@@ -5165,7 +5165,7 @@
     </p:spTree>
     <p:extLst>
       <p:ext uri="{BB962C8B-B14F-4D97-AF65-F5344CB8AC3E}">
-        <p14:creationId xmlns:p14="http://schemas.microsoft.com/office/powerpoint/2010/main" val="2291224648"/>
+        <p14:creationId xmlns:p14="http://schemas.microsoft.com/office/powerpoint/2010/main" val="2479140049"/>
       </p:ext>
     </p:extLst>
   </p:cSld>
@@ -5205,7 +5205,7 @@
           <p:cNvPr id="2" name="CuadroTexto 1">
             <a:extLst>
               <a:ext uri="{FF2B5EF4-FFF2-40B4-BE49-F238E27FC236}">
-                <a16:creationId xmlns:a16="http://schemas.microsoft.com/office/drawing/2014/main" id="{5EB2B62B-0F5C-9FAE-3695-0B8096FE97A4}"/>
+                <a16:creationId xmlns:a16="http://schemas.microsoft.com/office/drawing/2014/main" id="{03DB7E78-8B3E-11AC-2762-22C0BCF78BAD}"/>
               </a:ext>
             </a:extLst>
           </p:cNvPr>
@@ -5245,7 +5245,7 @@
           <p:cNvPr id="3" name="CuadroTexto 2">
             <a:extLst>
               <a:ext uri="{FF2B5EF4-FFF2-40B4-BE49-F238E27FC236}">
-                <a16:creationId xmlns:a16="http://schemas.microsoft.com/office/drawing/2014/main" id="{37CA2F4B-0533-C986-3A02-48FACB2697C0}"/>
+                <a16:creationId xmlns:a16="http://schemas.microsoft.com/office/drawing/2014/main" id="{E09E744C-5809-A687-BBE4-A99858670EF8}"/>
               </a:ext>
             </a:extLst>
           </p:cNvPr>
@@ -5285,7 +5285,7 @@
           <p:cNvPr id="4" name="CuadroTexto 3">
             <a:extLst>
               <a:ext uri="{FF2B5EF4-FFF2-40B4-BE49-F238E27FC236}">
-                <a16:creationId xmlns:a16="http://schemas.microsoft.com/office/drawing/2014/main" id="{124CAE04-6D4D-6E66-B65C-2AA45DF48920}"/>
+                <a16:creationId xmlns:a16="http://schemas.microsoft.com/office/drawing/2014/main" id="{0EDE0FD2-2286-1920-8DC6-28BF35E55E70}"/>
               </a:ext>
             </a:extLst>
           </p:cNvPr>
@@ -5325,7 +5325,7 @@
           <p:cNvPr id="6" name="Imagen 5">
             <a:extLst>
               <a:ext uri="{FF2B5EF4-FFF2-40B4-BE49-F238E27FC236}">
-                <a16:creationId xmlns:a16="http://schemas.microsoft.com/office/drawing/2014/main" id="{A54370F0-A0E6-C709-1CCD-B076CA92098A}"/>
+                <a16:creationId xmlns:a16="http://schemas.microsoft.com/office/drawing/2014/main" id="{7D235ABE-6CE1-ED99-5A52-2C162FF8ACB3}"/>
               </a:ext>
             </a:extLst>
           </p:cNvPr>
@@ -5366,7 +5366,7 @@
           <p:cNvPr id="7" name="Rectángulo: esquinas redondeadas 6">
             <a:extLst>
               <a:ext uri="{FF2B5EF4-FFF2-40B4-BE49-F238E27FC236}">
-                <a16:creationId xmlns:a16="http://schemas.microsoft.com/office/drawing/2014/main" id="{0CE70DC4-CFBF-C5FF-EC49-BEC5D22BDA9B}"/>
+                <a16:creationId xmlns:a16="http://schemas.microsoft.com/office/drawing/2014/main" id="{78BC451A-3875-5BF9-9443-0E4BFD8AE8B6}"/>
               </a:ext>
             </a:extLst>
           </p:cNvPr>
@@ -5420,7 +5420,7 @@
           <p:cNvPr id="8" name="CuadroTexto 7">
             <a:extLst>
               <a:ext uri="{FF2B5EF4-FFF2-40B4-BE49-F238E27FC236}">
-                <a16:creationId xmlns:a16="http://schemas.microsoft.com/office/drawing/2014/main" id="{7049EA37-A184-7DF4-182D-376712C62E7D}"/>
+                <a16:creationId xmlns:a16="http://schemas.microsoft.com/office/drawing/2014/main" id="{CC57963F-9EC0-4099-7B7B-4EB80102A431}"/>
               </a:ext>
             </a:extLst>
           </p:cNvPr>
@@ -5460,7 +5460,7 @@
           <p:cNvPr id="9" name="CuadroTexto 8">
             <a:extLst>
               <a:ext uri="{FF2B5EF4-FFF2-40B4-BE49-F238E27FC236}">
-                <a16:creationId xmlns:a16="http://schemas.microsoft.com/office/drawing/2014/main" id="{71A22A06-4C0C-1CFA-3D77-69EBA41A267D}"/>
+                <a16:creationId xmlns:a16="http://schemas.microsoft.com/office/drawing/2014/main" id="{3E5C9C25-024E-58A9-F6C5-CDD9E7C0AB05}"/>
               </a:ext>
             </a:extLst>
           </p:cNvPr>
@@ -5500,7 +5500,7 @@
           <p:cNvPr id="10" name="CuadroTexto 9">
             <a:extLst>
               <a:ext uri="{FF2B5EF4-FFF2-40B4-BE49-F238E27FC236}">
-                <a16:creationId xmlns:a16="http://schemas.microsoft.com/office/drawing/2014/main" id="{89EDC992-F8C1-2C41-EA34-875E1A86BEBC}"/>
+                <a16:creationId xmlns:a16="http://schemas.microsoft.com/office/drawing/2014/main" id="{93C8ED2A-C773-D0D2-D196-68E99818FABC}"/>
               </a:ext>
             </a:extLst>
           </p:cNvPr>
@@ -5599,7 +5599,7 @@
     </p:spTree>
     <p:extLst>
       <p:ext uri="{BB962C8B-B14F-4D97-AF65-F5344CB8AC3E}">
-        <p14:creationId xmlns:p14="http://schemas.microsoft.com/office/powerpoint/2010/main" val="3498344873"/>
+        <p14:creationId xmlns:p14="http://schemas.microsoft.com/office/powerpoint/2010/main" val="660871041"/>
       </p:ext>
     </p:extLst>
   </p:cSld>
@@ -5639,7 +5639,7 @@
           <p:cNvPr id="2" name="CuadroTexto 1">
             <a:extLst>
               <a:ext uri="{FF2B5EF4-FFF2-40B4-BE49-F238E27FC236}">
-                <a16:creationId xmlns:a16="http://schemas.microsoft.com/office/drawing/2014/main" id="{AADF5E54-0B47-2896-54E3-FE6E770510EF}"/>
+                <a16:creationId xmlns:a16="http://schemas.microsoft.com/office/drawing/2014/main" id="{7CEBF6AB-5197-355B-1FA4-C2D234A4110F}"/>
               </a:ext>
             </a:extLst>
           </p:cNvPr>
@@ -5679,7 +5679,7 @@
           <p:cNvPr id="3" name="CuadroTexto 2">
             <a:extLst>
               <a:ext uri="{FF2B5EF4-FFF2-40B4-BE49-F238E27FC236}">
-                <a16:creationId xmlns:a16="http://schemas.microsoft.com/office/drawing/2014/main" id="{891576B8-16A1-4495-17BF-3AC78195030B}"/>
+                <a16:creationId xmlns:a16="http://schemas.microsoft.com/office/drawing/2014/main" id="{7A32CA94-D527-C72B-8325-6DCAEB806FD0}"/>
               </a:ext>
             </a:extLst>
           </p:cNvPr>
@@ -5719,7 +5719,7 @@
           <p:cNvPr id="4" name="CuadroTexto 3">
             <a:extLst>
               <a:ext uri="{FF2B5EF4-FFF2-40B4-BE49-F238E27FC236}">
-                <a16:creationId xmlns:a16="http://schemas.microsoft.com/office/drawing/2014/main" id="{0FD1BC3C-47BB-01C6-455A-6F6A671E45B6}"/>
+                <a16:creationId xmlns:a16="http://schemas.microsoft.com/office/drawing/2014/main" id="{F2235965-61F5-523C-968F-6345D6A076C2}"/>
               </a:ext>
             </a:extLst>
           </p:cNvPr>
@@ -5759,7 +5759,7 @@
           <p:cNvPr id="6" name="Imagen 5">
             <a:extLst>
               <a:ext uri="{FF2B5EF4-FFF2-40B4-BE49-F238E27FC236}">
-                <a16:creationId xmlns:a16="http://schemas.microsoft.com/office/drawing/2014/main" id="{367917A3-75A8-786E-F069-61A34019FAE3}"/>
+                <a16:creationId xmlns:a16="http://schemas.microsoft.com/office/drawing/2014/main" id="{3458D1CA-BD6B-4DEE-EC2D-DBAC79354BF9}"/>
               </a:ext>
             </a:extLst>
           </p:cNvPr>
@@ -5800,7 +5800,7 @@
           <p:cNvPr id="7" name="CuadroTexto 6">
             <a:extLst>
               <a:ext uri="{FF2B5EF4-FFF2-40B4-BE49-F238E27FC236}">
-                <a16:creationId xmlns:a16="http://schemas.microsoft.com/office/drawing/2014/main" id="{373B96C4-CCAA-90A8-2D8D-513A151039E8}"/>
+                <a16:creationId xmlns:a16="http://schemas.microsoft.com/office/drawing/2014/main" id="{DFB509E2-596F-AAC5-7A2E-4DE33DB60014}"/>
               </a:ext>
             </a:extLst>
           </p:cNvPr>
@@ -5917,7 +5917,7 @@
     </p:spTree>
     <p:extLst>
       <p:ext uri="{BB962C8B-B14F-4D97-AF65-F5344CB8AC3E}">
-        <p14:creationId xmlns:p14="http://schemas.microsoft.com/office/powerpoint/2010/main" val="1503816519"/>
+        <p14:creationId xmlns:p14="http://schemas.microsoft.com/office/powerpoint/2010/main" val="311254604"/>
       </p:ext>
     </p:extLst>
   </p:cSld>
@@ -5957,7 +5957,7 @@
           <p:cNvPr id="2" name="CuadroTexto 1">
             <a:extLst>
               <a:ext uri="{FF2B5EF4-FFF2-40B4-BE49-F238E27FC236}">
-                <a16:creationId xmlns:a16="http://schemas.microsoft.com/office/drawing/2014/main" id="{F3430133-8CE9-88BB-A591-7BC0AE2A0DDD}"/>
+                <a16:creationId xmlns:a16="http://schemas.microsoft.com/office/drawing/2014/main" id="{28FD96AE-D367-0414-763C-D30FE2713BBF}"/>
               </a:ext>
             </a:extLst>
           </p:cNvPr>
@@ -5997,7 +5997,7 @@
           <p:cNvPr id="3" name="CuadroTexto 2">
             <a:extLst>
               <a:ext uri="{FF2B5EF4-FFF2-40B4-BE49-F238E27FC236}">
-                <a16:creationId xmlns:a16="http://schemas.microsoft.com/office/drawing/2014/main" id="{AEA9BB5A-9ABC-1992-B21F-7371FD34CBB4}"/>
+                <a16:creationId xmlns:a16="http://schemas.microsoft.com/office/drawing/2014/main" id="{9CACD615-673E-68DD-6605-F0C87DC5F3BC}"/>
               </a:ext>
             </a:extLst>
           </p:cNvPr>
@@ -6037,7 +6037,7 @@
           <p:cNvPr id="4" name="Rectángulo: esquinas redondeadas 3">
             <a:extLst>
               <a:ext uri="{FF2B5EF4-FFF2-40B4-BE49-F238E27FC236}">
-                <a16:creationId xmlns:a16="http://schemas.microsoft.com/office/drawing/2014/main" id="{50330CCE-5524-BE3B-45F1-DEDCF3A76619}"/>
+                <a16:creationId xmlns:a16="http://schemas.microsoft.com/office/drawing/2014/main" id="{8E0C63F5-D5D9-6EC9-1D0F-97E31CC5C01F}"/>
               </a:ext>
             </a:extLst>
           </p:cNvPr>
@@ -6091,7 +6091,7 @@
           <p:cNvPr id="5" name="CuadroTexto 4">
             <a:extLst>
               <a:ext uri="{FF2B5EF4-FFF2-40B4-BE49-F238E27FC236}">
-                <a16:creationId xmlns:a16="http://schemas.microsoft.com/office/drawing/2014/main" id="{1D2A64B2-6905-97C5-511E-73058293DD54}"/>
+                <a16:creationId xmlns:a16="http://schemas.microsoft.com/office/drawing/2014/main" id="{8E3DDE59-0A1C-2DF0-F70F-323A93ED1DCF}"/>
               </a:ext>
             </a:extLst>
           </p:cNvPr>
@@ -6131,7 +6131,7 @@
           <p:cNvPr id="6" name="CuadroTexto 5">
             <a:extLst>
               <a:ext uri="{FF2B5EF4-FFF2-40B4-BE49-F238E27FC236}">
-                <a16:creationId xmlns:a16="http://schemas.microsoft.com/office/drawing/2014/main" id="{1392E5AB-DD85-70A4-DE0F-CB2EC849E5A2}"/>
+                <a16:creationId xmlns:a16="http://schemas.microsoft.com/office/drawing/2014/main" id="{EE378B01-6BA6-86A4-4F17-E9FEA64A95E6}"/>
               </a:ext>
             </a:extLst>
           </p:cNvPr>
@@ -6171,7 +6171,7 @@
           <p:cNvPr id="7" name="Rectángulo: esquinas redondeadas 6">
             <a:extLst>
               <a:ext uri="{FF2B5EF4-FFF2-40B4-BE49-F238E27FC236}">
-                <a16:creationId xmlns:a16="http://schemas.microsoft.com/office/drawing/2014/main" id="{ABB172E4-595B-4818-63FB-64A0B92E2278}"/>
+                <a16:creationId xmlns:a16="http://schemas.microsoft.com/office/drawing/2014/main" id="{8EE1CCE0-2338-4500-C634-21A04B3AF65A}"/>
               </a:ext>
             </a:extLst>
           </p:cNvPr>
@@ -6225,7 +6225,7 @@
           <p:cNvPr id="8" name="CuadroTexto 7">
             <a:extLst>
               <a:ext uri="{FF2B5EF4-FFF2-40B4-BE49-F238E27FC236}">
-                <a16:creationId xmlns:a16="http://schemas.microsoft.com/office/drawing/2014/main" id="{9166C8F3-81C6-8EEC-CF1A-30A9D05A8D2A}"/>
+                <a16:creationId xmlns:a16="http://schemas.microsoft.com/office/drawing/2014/main" id="{4F23986E-CC36-D0E2-A5CB-48C70AC53935}"/>
               </a:ext>
             </a:extLst>
           </p:cNvPr>
@@ -6265,7 +6265,7 @@
           <p:cNvPr id="9" name="CuadroTexto 8">
             <a:extLst>
               <a:ext uri="{FF2B5EF4-FFF2-40B4-BE49-F238E27FC236}">
-                <a16:creationId xmlns:a16="http://schemas.microsoft.com/office/drawing/2014/main" id="{CE499E91-418B-4215-3ADE-DEA04F0C1D15}"/>
+                <a16:creationId xmlns:a16="http://schemas.microsoft.com/office/drawing/2014/main" id="{6ECC1234-7648-5BF2-17C8-CFA69A67254D}"/>
               </a:ext>
             </a:extLst>
           </p:cNvPr>
@@ -6305,7 +6305,7 @@
           <p:cNvPr id="10" name="Rectángulo: esquinas redondeadas 9">
             <a:extLst>
               <a:ext uri="{FF2B5EF4-FFF2-40B4-BE49-F238E27FC236}">
-                <a16:creationId xmlns:a16="http://schemas.microsoft.com/office/drawing/2014/main" id="{853A2DBA-0CA8-E3D3-DDAA-6D31ECEC1F06}"/>
+                <a16:creationId xmlns:a16="http://schemas.microsoft.com/office/drawing/2014/main" id="{3AB075FD-EADE-71FA-8BC1-E0A3D54430C3}"/>
               </a:ext>
             </a:extLst>
           </p:cNvPr>
@@ -6359,7 +6359,7 @@
           <p:cNvPr id="11" name="CuadroTexto 10">
             <a:extLst>
               <a:ext uri="{FF2B5EF4-FFF2-40B4-BE49-F238E27FC236}">
-                <a16:creationId xmlns:a16="http://schemas.microsoft.com/office/drawing/2014/main" id="{29D7216D-962D-40B3-A00F-974B4DE9EC8E}"/>
+                <a16:creationId xmlns:a16="http://schemas.microsoft.com/office/drawing/2014/main" id="{539C3D89-7AF7-DA66-C54C-10F62C7AA264}"/>
               </a:ext>
             </a:extLst>
           </p:cNvPr>
@@ -6399,7 +6399,7 @@
           <p:cNvPr id="12" name="CuadroTexto 11">
             <a:extLst>
               <a:ext uri="{FF2B5EF4-FFF2-40B4-BE49-F238E27FC236}">
-                <a16:creationId xmlns:a16="http://schemas.microsoft.com/office/drawing/2014/main" id="{454119C0-8814-A475-8953-AE96D966C455}"/>
+                <a16:creationId xmlns:a16="http://schemas.microsoft.com/office/drawing/2014/main" id="{AC7C1ADE-DAA9-F727-DA5D-FB4A5DBDBE8F}"/>
               </a:ext>
             </a:extLst>
           </p:cNvPr>
@@ -6439,7 +6439,7 @@
           <p:cNvPr id="13" name="Rectángulo: esquinas redondeadas 12">
             <a:extLst>
               <a:ext uri="{FF2B5EF4-FFF2-40B4-BE49-F238E27FC236}">
-                <a16:creationId xmlns:a16="http://schemas.microsoft.com/office/drawing/2014/main" id="{B47F82F8-76A3-7CF0-F92E-2D0310069701}"/>
+                <a16:creationId xmlns:a16="http://schemas.microsoft.com/office/drawing/2014/main" id="{024337F6-C3C6-F30A-6583-BFFAD9BCD1D7}"/>
               </a:ext>
             </a:extLst>
           </p:cNvPr>
@@ -6493,7 +6493,7 @@
           <p:cNvPr id="14" name="CuadroTexto 13">
             <a:extLst>
               <a:ext uri="{FF2B5EF4-FFF2-40B4-BE49-F238E27FC236}">
-                <a16:creationId xmlns:a16="http://schemas.microsoft.com/office/drawing/2014/main" id="{ED02E93D-7A42-BD7A-43B8-420A5927D2DE}"/>
+                <a16:creationId xmlns:a16="http://schemas.microsoft.com/office/drawing/2014/main" id="{ACCF68A8-F6F2-70CC-5887-C54A1EAEAE18}"/>
               </a:ext>
             </a:extLst>
           </p:cNvPr>
@@ -6533,7 +6533,7 @@
           <p:cNvPr id="15" name="CuadroTexto 14">
             <a:extLst>
               <a:ext uri="{FF2B5EF4-FFF2-40B4-BE49-F238E27FC236}">
-                <a16:creationId xmlns:a16="http://schemas.microsoft.com/office/drawing/2014/main" id="{81D2B069-110C-FD48-F253-00EF4E48E793}"/>
+                <a16:creationId xmlns:a16="http://schemas.microsoft.com/office/drawing/2014/main" id="{D832274A-EBF8-9206-36A4-2913CDE82274}"/>
               </a:ext>
             </a:extLst>
           </p:cNvPr>
@@ -6573,7 +6573,7 @@
           <p:cNvPr id="16" name="CuadroTexto 15">
             <a:extLst>
               <a:ext uri="{FF2B5EF4-FFF2-40B4-BE49-F238E27FC236}">
-                <a16:creationId xmlns:a16="http://schemas.microsoft.com/office/drawing/2014/main" id="{12158504-D060-9EA0-221B-41A981AF51C2}"/>
+                <a16:creationId xmlns:a16="http://schemas.microsoft.com/office/drawing/2014/main" id="{C79D19F7-80E7-224C-A8F0-5FA014DB7486}"/>
               </a:ext>
             </a:extLst>
           </p:cNvPr>
@@ -6656,7 +6656,7 @@
           <p:cNvPr id="17" name="CuadroTexto 16">
             <a:extLst>
               <a:ext uri="{FF2B5EF4-FFF2-40B4-BE49-F238E27FC236}">
-                <a16:creationId xmlns:a16="http://schemas.microsoft.com/office/drawing/2014/main" id="{1510BF8C-088D-0F57-AC6A-E090829EA2CB}"/>
+                <a16:creationId xmlns:a16="http://schemas.microsoft.com/office/drawing/2014/main" id="{8E3042E1-1D68-59B5-C091-3A18487C2D4F}"/>
               </a:ext>
             </a:extLst>
           </p:cNvPr>
@@ -6694,7 +6694,7 @@
     </p:spTree>
     <p:extLst>
       <p:ext uri="{BB962C8B-B14F-4D97-AF65-F5344CB8AC3E}">
-        <p14:creationId xmlns:p14="http://schemas.microsoft.com/office/powerpoint/2010/main" val="2217278504"/>
+        <p14:creationId xmlns:p14="http://schemas.microsoft.com/office/powerpoint/2010/main" val="2401975934"/>
       </p:ext>
     </p:extLst>
   </p:cSld>
@@ -6734,7 +6734,7 @@
           <p:cNvPr id="2" name="CuadroTexto 1">
             <a:extLst>
               <a:ext uri="{FF2B5EF4-FFF2-40B4-BE49-F238E27FC236}">
-                <a16:creationId xmlns:a16="http://schemas.microsoft.com/office/drawing/2014/main" id="{AE97D073-59E3-5409-CF6C-C97B6296295A}"/>
+                <a16:creationId xmlns:a16="http://schemas.microsoft.com/office/drawing/2014/main" id="{C38F03E6-8663-E337-8584-3E34D8AF0123}"/>
               </a:ext>
             </a:extLst>
           </p:cNvPr>
@@ -6774,7 +6774,7 @@
           <p:cNvPr id="3" name="CuadroTexto 2">
             <a:extLst>
               <a:ext uri="{FF2B5EF4-FFF2-40B4-BE49-F238E27FC236}">
-                <a16:creationId xmlns:a16="http://schemas.microsoft.com/office/drawing/2014/main" id="{B9C7F614-5499-76E6-C427-B77D4FC82F1B}"/>
+                <a16:creationId xmlns:a16="http://schemas.microsoft.com/office/drawing/2014/main" id="{D7669304-2C55-A4E6-F092-CCF7B482F334}"/>
               </a:ext>
             </a:extLst>
           </p:cNvPr>
@@ -6814,7 +6814,7 @@
           <p:cNvPr id="4" name="CuadroTexto 3">
             <a:extLst>
               <a:ext uri="{FF2B5EF4-FFF2-40B4-BE49-F238E27FC236}">
-                <a16:creationId xmlns:a16="http://schemas.microsoft.com/office/drawing/2014/main" id="{37568BDC-19A1-B02B-11CC-CCD27F9083CE}"/>
+                <a16:creationId xmlns:a16="http://schemas.microsoft.com/office/drawing/2014/main" id="{9FFB00EA-D6CD-F919-F770-4771792CD503}"/>
               </a:ext>
             </a:extLst>
           </p:cNvPr>
@@ -6854,7 +6854,7 @@
           <p:cNvPr id="5" name="Rectángulo: esquinas redondeadas 4">
             <a:extLst>
               <a:ext uri="{FF2B5EF4-FFF2-40B4-BE49-F238E27FC236}">
-                <a16:creationId xmlns:a16="http://schemas.microsoft.com/office/drawing/2014/main" id="{58FA41B2-903B-E960-4D4C-7649F102C072}"/>
+                <a16:creationId xmlns:a16="http://schemas.microsoft.com/office/drawing/2014/main" id="{775C0131-DC1E-0995-3E0A-AF28EEBD93FF}"/>
               </a:ext>
             </a:extLst>
           </p:cNvPr>
@@ -6908,7 +6908,7 @@
           <p:cNvPr id="6" name="CuadroTexto 5">
             <a:extLst>
               <a:ext uri="{FF2B5EF4-FFF2-40B4-BE49-F238E27FC236}">
-                <a16:creationId xmlns:a16="http://schemas.microsoft.com/office/drawing/2014/main" id="{1D07C734-D680-766C-EEDF-F6D166A0306A}"/>
+                <a16:creationId xmlns:a16="http://schemas.microsoft.com/office/drawing/2014/main" id="{131B2301-D864-05E7-D62E-A28673A18ACB}"/>
               </a:ext>
             </a:extLst>
           </p:cNvPr>
@@ -6948,7 +6948,7 @@
           <p:cNvPr id="7" name="CuadroTexto 6">
             <a:extLst>
               <a:ext uri="{FF2B5EF4-FFF2-40B4-BE49-F238E27FC236}">
-                <a16:creationId xmlns:a16="http://schemas.microsoft.com/office/drawing/2014/main" id="{BA9B237C-E4F3-61B4-E479-E549D931655B}"/>
+                <a16:creationId xmlns:a16="http://schemas.microsoft.com/office/drawing/2014/main" id="{09A2E840-415C-A105-E2E4-F36E50BEC8C1}"/>
               </a:ext>
             </a:extLst>
           </p:cNvPr>
@@ -6988,7 +6988,7 @@
           <p:cNvPr id="8" name="Rectángulo: esquinas redondeadas 7">
             <a:extLst>
               <a:ext uri="{FF2B5EF4-FFF2-40B4-BE49-F238E27FC236}">
-                <a16:creationId xmlns:a16="http://schemas.microsoft.com/office/drawing/2014/main" id="{DD42DE42-5955-D968-3FEC-2E1E9579A8C8}"/>
+                <a16:creationId xmlns:a16="http://schemas.microsoft.com/office/drawing/2014/main" id="{B96C461D-0C13-B400-DE65-C8C17E1EDAEF}"/>
               </a:ext>
             </a:extLst>
           </p:cNvPr>
@@ -7042,7 +7042,7 @@
           <p:cNvPr id="9" name="CuadroTexto 8">
             <a:extLst>
               <a:ext uri="{FF2B5EF4-FFF2-40B4-BE49-F238E27FC236}">
-                <a16:creationId xmlns:a16="http://schemas.microsoft.com/office/drawing/2014/main" id="{468B4253-FCBE-C837-4133-F7E478500FFB}"/>
+                <a16:creationId xmlns:a16="http://schemas.microsoft.com/office/drawing/2014/main" id="{61C24002-41E3-D09E-6180-F7D4F214AD45}"/>
               </a:ext>
             </a:extLst>
           </p:cNvPr>
@@ -7082,7 +7082,7 @@
           <p:cNvPr id="10" name="CuadroTexto 9">
             <a:extLst>
               <a:ext uri="{FF2B5EF4-FFF2-40B4-BE49-F238E27FC236}">
-                <a16:creationId xmlns:a16="http://schemas.microsoft.com/office/drawing/2014/main" id="{077F98AF-71D3-B7AA-A7BE-7F6AAB5DF75D}"/>
+                <a16:creationId xmlns:a16="http://schemas.microsoft.com/office/drawing/2014/main" id="{F52D2E50-3C75-1DDF-25F3-8D7CB733BCCD}"/>
               </a:ext>
             </a:extLst>
           </p:cNvPr>
@@ -7122,7 +7122,7 @@
           <p:cNvPr id="11" name="CuadroTexto 10">
             <a:extLst>
               <a:ext uri="{FF2B5EF4-FFF2-40B4-BE49-F238E27FC236}">
-                <a16:creationId xmlns:a16="http://schemas.microsoft.com/office/drawing/2014/main" id="{C1E5AB4E-15F6-D17F-8080-4724F36ADDC3}"/>
+                <a16:creationId xmlns:a16="http://schemas.microsoft.com/office/drawing/2014/main" id="{9ECD6467-C862-5541-7997-A449E19DE802}"/>
               </a:ext>
             </a:extLst>
           </p:cNvPr>
@@ -7162,7 +7162,7 @@
           <p:cNvPr id="12" name="CuadroTexto 11">
             <a:extLst>
               <a:ext uri="{FF2B5EF4-FFF2-40B4-BE49-F238E27FC236}">
-                <a16:creationId xmlns:a16="http://schemas.microsoft.com/office/drawing/2014/main" id="{780F215D-46DF-AAAC-31BC-41213A603EF7}"/>
+                <a16:creationId xmlns:a16="http://schemas.microsoft.com/office/drawing/2014/main" id="{F4EAA11C-71BC-04F4-33B8-98949E8CD521}"/>
               </a:ext>
             </a:extLst>
           </p:cNvPr>
@@ -7243,7 +7243,7 @@
     </p:spTree>
     <p:extLst>
       <p:ext uri="{BB962C8B-B14F-4D97-AF65-F5344CB8AC3E}">
-        <p14:creationId xmlns:p14="http://schemas.microsoft.com/office/powerpoint/2010/main" val="3246461230"/>
+        <p14:creationId xmlns:p14="http://schemas.microsoft.com/office/powerpoint/2010/main" val="3749847170"/>
       </p:ext>
     </p:extLst>
   </p:cSld>
@@ -7283,7 +7283,7 @@
           <p:cNvPr id="2" name="CuadroTexto 1">
             <a:extLst>
               <a:ext uri="{FF2B5EF4-FFF2-40B4-BE49-F238E27FC236}">
-                <a16:creationId xmlns:a16="http://schemas.microsoft.com/office/drawing/2014/main" id="{A4D3AD77-828F-E3E7-87B2-01EBE2689D0E}"/>
+                <a16:creationId xmlns:a16="http://schemas.microsoft.com/office/drawing/2014/main" id="{20508CD6-6468-D198-6001-C125F543EE51}"/>
               </a:ext>
             </a:extLst>
           </p:cNvPr>
@@ -7323,7 +7323,7 @@
           <p:cNvPr id="3" name="CuadroTexto 2">
             <a:extLst>
               <a:ext uri="{FF2B5EF4-FFF2-40B4-BE49-F238E27FC236}">
-                <a16:creationId xmlns:a16="http://schemas.microsoft.com/office/drawing/2014/main" id="{99FAC8C5-54BD-E621-AF51-DB21D5D6637F}"/>
+                <a16:creationId xmlns:a16="http://schemas.microsoft.com/office/drawing/2014/main" id="{53A3F14B-A356-0585-8C75-B8A0FD06430D}"/>
               </a:ext>
             </a:extLst>
           </p:cNvPr>
@@ -7363,7 +7363,7 @@
           <p:cNvPr id="4" name="CuadroTexto 3">
             <a:extLst>
               <a:ext uri="{FF2B5EF4-FFF2-40B4-BE49-F238E27FC236}">
-                <a16:creationId xmlns:a16="http://schemas.microsoft.com/office/drawing/2014/main" id="{CC040CF0-AD7D-80D0-B96D-A615BCB8C1AD}"/>
+                <a16:creationId xmlns:a16="http://schemas.microsoft.com/office/drawing/2014/main" id="{6E49CF37-C0F0-5094-6378-3E4859EACAB8}"/>
               </a:ext>
             </a:extLst>
           </p:cNvPr>
@@ -7403,7 +7403,7 @@
           <p:cNvPr id="5" name="Rectángulo: esquinas redondeadas 4">
             <a:extLst>
               <a:ext uri="{FF2B5EF4-FFF2-40B4-BE49-F238E27FC236}">
-                <a16:creationId xmlns:a16="http://schemas.microsoft.com/office/drawing/2014/main" id="{1F2CF240-B952-37B3-8E06-AA83F789C3B2}"/>
+                <a16:creationId xmlns:a16="http://schemas.microsoft.com/office/drawing/2014/main" id="{0A731536-B4DF-AFA1-DA9C-FC63CF39A62B}"/>
               </a:ext>
             </a:extLst>
           </p:cNvPr>
@@ -7457,7 +7457,7 @@
           <p:cNvPr id="6" name="CuadroTexto 5">
             <a:extLst>
               <a:ext uri="{FF2B5EF4-FFF2-40B4-BE49-F238E27FC236}">
-                <a16:creationId xmlns:a16="http://schemas.microsoft.com/office/drawing/2014/main" id="{FDD5E688-21C6-A61A-38ED-F2084F038141}"/>
+                <a16:creationId xmlns:a16="http://schemas.microsoft.com/office/drawing/2014/main" id="{99C73E3B-28FC-3EEF-8394-3690362BFA4C}"/>
               </a:ext>
             </a:extLst>
           </p:cNvPr>
@@ -7497,7 +7497,7 @@
           <p:cNvPr id="7" name="CuadroTexto 6">
             <a:extLst>
               <a:ext uri="{FF2B5EF4-FFF2-40B4-BE49-F238E27FC236}">
-                <a16:creationId xmlns:a16="http://schemas.microsoft.com/office/drawing/2014/main" id="{8EC20374-7D60-B373-5141-2B0E4B57A84A}"/>
+                <a16:creationId xmlns:a16="http://schemas.microsoft.com/office/drawing/2014/main" id="{05BB407F-34E6-33CE-ECE6-E7917496A74D}"/>
               </a:ext>
             </a:extLst>
           </p:cNvPr>
@@ -7537,7 +7537,7 @@
           <p:cNvPr id="8" name="Rectángulo: esquinas redondeadas 7">
             <a:extLst>
               <a:ext uri="{FF2B5EF4-FFF2-40B4-BE49-F238E27FC236}">
-                <a16:creationId xmlns:a16="http://schemas.microsoft.com/office/drawing/2014/main" id="{84089369-9A7A-35A8-0D6C-894B25FF9795}"/>
+                <a16:creationId xmlns:a16="http://schemas.microsoft.com/office/drawing/2014/main" id="{DB83EC71-8DCE-6D32-C673-B47194A22729}"/>
               </a:ext>
             </a:extLst>
           </p:cNvPr>
@@ -7591,7 +7591,7 @@
           <p:cNvPr id="9" name="CuadroTexto 8">
             <a:extLst>
               <a:ext uri="{FF2B5EF4-FFF2-40B4-BE49-F238E27FC236}">
-                <a16:creationId xmlns:a16="http://schemas.microsoft.com/office/drawing/2014/main" id="{EEEC2744-B96F-CF63-628C-0EDA09C77340}"/>
+                <a16:creationId xmlns:a16="http://schemas.microsoft.com/office/drawing/2014/main" id="{E08A1FC8-58B3-9590-68E1-40717831FB84}"/>
               </a:ext>
             </a:extLst>
           </p:cNvPr>
@@ -7631,7 +7631,7 @@
           <p:cNvPr id="10" name="CuadroTexto 9">
             <a:extLst>
               <a:ext uri="{FF2B5EF4-FFF2-40B4-BE49-F238E27FC236}">
-                <a16:creationId xmlns:a16="http://schemas.microsoft.com/office/drawing/2014/main" id="{81B5DCFA-D205-FAE9-F06F-EE173C4DD4F6}"/>
+                <a16:creationId xmlns:a16="http://schemas.microsoft.com/office/drawing/2014/main" id="{085BA0E7-B0B5-2E7A-A585-03D27E5375DF}"/>
               </a:ext>
             </a:extLst>
           </p:cNvPr>
@@ -7671,7 +7671,7 @@
           <p:cNvPr id="11" name="Rectángulo: esquinas redondeadas 10">
             <a:extLst>
               <a:ext uri="{FF2B5EF4-FFF2-40B4-BE49-F238E27FC236}">
-                <a16:creationId xmlns:a16="http://schemas.microsoft.com/office/drawing/2014/main" id="{1EA7C88D-9F11-A261-C173-0FE8F14772A8}"/>
+                <a16:creationId xmlns:a16="http://schemas.microsoft.com/office/drawing/2014/main" id="{6031C002-AC0B-8471-4EDA-05DB9C42AAB3}"/>
               </a:ext>
             </a:extLst>
           </p:cNvPr>
@@ -7725,7 +7725,7 @@
           <p:cNvPr id="12" name="CuadroTexto 11">
             <a:extLst>
               <a:ext uri="{FF2B5EF4-FFF2-40B4-BE49-F238E27FC236}">
-                <a16:creationId xmlns:a16="http://schemas.microsoft.com/office/drawing/2014/main" id="{6A9BE991-68D7-7A46-3DAD-348D38562250}"/>
+                <a16:creationId xmlns:a16="http://schemas.microsoft.com/office/drawing/2014/main" id="{BEF38A84-BC89-66DB-3F38-42F3AC9B73D4}"/>
               </a:ext>
             </a:extLst>
           </p:cNvPr>
@@ -7765,7 +7765,7 @@
           <p:cNvPr id="13" name="CuadroTexto 12">
             <a:extLst>
               <a:ext uri="{FF2B5EF4-FFF2-40B4-BE49-F238E27FC236}">
-                <a16:creationId xmlns:a16="http://schemas.microsoft.com/office/drawing/2014/main" id="{D336450E-CBEE-21AE-587B-B48FB2B794E0}"/>
+                <a16:creationId xmlns:a16="http://schemas.microsoft.com/office/drawing/2014/main" id="{45FD6878-A574-ECCD-F34F-68126FF04248}"/>
               </a:ext>
             </a:extLst>
           </p:cNvPr>
@@ -7805,7 +7805,7 @@
           <p:cNvPr id="14" name="CuadroTexto 13">
             <a:extLst>
               <a:ext uri="{FF2B5EF4-FFF2-40B4-BE49-F238E27FC236}">
-                <a16:creationId xmlns:a16="http://schemas.microsoft.com/office/drawing/2014/main" id="{20BEA9F2-2AD8-C4B1-3F63-38965E41D1ED}"/>
+                <a16:creationId xmlns:a16="http://schemas.microsoft.com/office/drawing/2014/main" id="{05788005-402F-E948-3B31-51A2E3F487E4}"/>
               </a:ext>
             </a:extLst>
           </p:cNvPr>
@@ -7868,7 +7868,7 @@
     </p:spTree>
     <p:extLst>
       <p:ext uri="{BB962C8B-B14F-4D97-AF65-F5344CB8AC3E}">
-        <p14:creationId xmlns:p14="http://schemas.microsoft.com/office/powerpoint/2010/main" val="3725548532"/>
+        <p14:creationId xmlns:p14="http://schemas.microsoft.com/office/powerpoint/2010/main" val="1748892430"/>
       </p:ext>
     </p:extLst>
   </p:cSld>
@@ -7908,7 +7908,7 @@
           <p:cNvPr id="2" name="CuadroTexto 1">
             <a:extLst>
               <a:ext uri="{FF2B5EF4-FFF2-40B4-BE49-F238E27FC236}">
-                <a16:creationId xmlns:a16="http://schemas.microsoft.com/office/drawing/2014/main" id="{C3DC3612-2058-06AC-93C9-ED0D67262948}"/>
+                <a16:creationId xmlns:a16="http://schemas.microsoft.com/office/drawing/2014/main" id="{43215732-2E6D-AB1D-FFB4-12A7886A87E4}"/>
               </a:ext>
             </a:extLst>
           </p:cNvPr>
@@ -7948,7 +7948,7 @@
           <p:cNvPr id="3" name="CuadroTexto 2">
             <a:extLst>
               <a:ext uri="{FF2B5EF4-FFF2-40B4-BE49-F238E27FC236}">
-                <a16:creationId xmlns:a16="http://schemas.microsoft.com/office/drawing/2014/main" id="{28C40224-81C6-4E36-7D5B-9F21B4FEE17C}"/>
+                <a16:creationId xmlns:a16="http://schemas.microsoft.com/office/drawing/2014/main" id="{5D98BB5E-EC7D-5564-5D12-236DDDD63197}"/>
               </a:ext>
             </a:extLst>
           </p:cNvPr>
@@ -7988,7 +7988,7 @@
           <p:cNvPr id="4" name="CuadroTexto 3">
             <a:extLst>
               <a:ext uri="{FF2B5EF4-FFF2-40B4-BE49-F238E27FC236}">
-                <a16:creationId xmlns:a16="http://schemas.microsoft.com/office/drawing/2014/main" id="{9B5B60DC-A75D-45BE-804F-BC885F6F4CC1}"/>
+                <a16:creationId xmlns:a16="http://schemas.microsoft.com/office/drawing/2014/main" id="{7D676BF3-C9F4-2AB6-082C-716A5D2638F2}"/>
               </a:ext>
             </a:extLst>
           </p:cNvPr>
@@ -8107,7 +8107,7 @@
           <p:cNvPr id="5" name="Rectángulo: esquinas redondeadas 4">
             <a:extLst>
               <a:ext uri="{FF2B5EF4-FFF2-40B4-BE49-F238E27FC236}">
-                <a16:creationId xmlns:a16="http://schemas.microsoft.com/office/drawing/2014/main" id="{648C1DE9-6BD5-EBD7-9950-DAE8920F1FF1}"/>
+                <a16:creationId xmlns:a16="http://schemas.microsoft.com/office/drawing/2014/main" id="{8F097D6B-2939-4359-E9E7-729A7B3B29F4}"/>
               </a:ext>
             </a:extLst>
           </p:cNvPr>
@@ -8161,7 +8161,7 @@
           <p:cNvPr id="6" name="CuadroTexto 5">
             <a:extLst>
               <a:ext uri="{FF2B5EF4-FFF2-40B4-BE49-F238E27FC236}">
-                <a16:creationId xmlns:a16="http://schemas.microsoft.com/office/drawing/2014/main" id="{D36B12BC-610E-1351-D73C-368B4B1AC1CD}"/>
+                <a16:creationId xmlns:a16="http://schemas.microsoft.com/office/drawing/2014/main" id="{1AD83F5D-CFDF-120C-0FDD-91EDA33F66D7}"/>
               </a:ext>
             </a:extLst>
           </p:cNvPr>
@@ -8201,7 +8201,7 @@
           <p:cNvPr id="7" name="CuadroTexto 6">
             <a:extLst>
               <a:ext uri="{FF2B5EF4-FFF2-40B4-BE49-F238E27FC236}">
-                <a16:creationId xmlns:a16="http://schemas.microsoft.com/office/drawing/2014/main" id="{CB1052AB-829B-F3AE-5AE2-1F6026116D3D}"/>
+                <a16:creationId xmlns:a16="http://schemas.microsoft.com/office/drawing/2014/main" id="{463B6C04-9057-138B-9F0D-B95AEC196576}"/>
               </a:ext>
             </a:extLst>
           </p:cNvPr>
@@ -8239,7 +8239,7 @@
     </p:spTree>
     <p:extLst>
       <p:ext uri="{BB962C8B-B14F-4D97-AF65-F5344CB8AC3E}">
-        <p14:creationId xmlns:p14="http://schemas.microsoft.com/office/powerpoint/2010/main" val="1362884170"/>
+        <p14:creationId xmlns:p14="http://schemas.microsoft.com/office/powerpoint/2010/main" val="2899676087"/>
       </p:ext>
     </p:extLst>
   </p:cSld>
@@ -8279,7 +8279,7 @@
           <p:cNvPr id="2" name="CuadroTexto 1">
             <a:extLst>
               <a:ext uri="{FF2B5EF4-FFF2-40B4-BE49-F238E27FC236}">
-                <a16:creationId xmlns:a16="http://schemas.microsoft.com/office/drawing/2014/main" id="{BA0FAC90-46C1-F43B-6044-79E44BD0FB48}"/>
+                <a16:creationId xmlns:a16="http://schemas.microsoft.com/office/drawing/2014/main" id="{4A8EE9DF-5270-70E8-C162-AE5DD01AB92F}"/>
               </a:ext>
             </a:extLst>
           </p:cNvPr>
@@ -8319,7 +8319,7 @@
           <p:cNvPr id="3" name="CuadroTexto 2">
             <a:extLst>
               <a:ext uri="{FF2B5EF4-FFF2-40B4-BE49-F238E27FC236}">
-                <a16:creationId xmlns:a16="http://schemas.microsoft.com/office/drawing/2014/main" id="{FBFEF832-13B0-1285-9F0B-8C1528AD7B98}"/>
+                <a16:creationId xmlns:a16="http://schemas.microsoft.com/office/drawing/2014/main" id="{9D13068E-19B9-EDD4-657E-7276DAF3F2F6}"/>
               </a:ext>
             </a:extLst>
           </p:cNvPr>
@@ -8359,7 +8359,7 @@
           <p:cNvPr id="4" name="CuadroTexto 3">
             <a:extLst>
               <a:ext uri="{FF2B5EF4-FFF2-40B4-BE49-F238E27FC236}">
-                <a16:creationId xmlns:a16="http://schemas.microsoft.com/office/drawing/2014/main" id="{A975764C-8698-FBD2-A0AF-D6D4D70C13B7}"/>
+                <a16:creationId xmlns:a16="http://schemas.microsoft.com/office/drawing/2014/main" id="{BB66D7E4-32FB-EDB8-A063-5BC70E531AEF}"/>
               </a:ext>
             </a:extLst>
           </p:cNvPr>
@@ -8399,7 +8399,7 @@
           <p:cNvPr id="5" name="CuadroTexto 4">
             <a:extLst>
               <a:ext uri="{FF2B5EF4-FFF2-40B4-BE49-F238E27FC236}">
-                <a16:creationId xmlns:a16="http://schemas.microsoft.com/office/drawing/2014/main" id="{A51DC6F8-9DAE-639A-2D06-7950D96433A1}"/>
+                <a16:creationId xmlns:a16="http://schemas.microsoft.com/office/drawing/2014/main" id="{F3C64D0F-89E4-FEB1-086C-F4917583C4F2}"/>
               </a:ext>
             </a:extLst>
           </p:cNvPr>
@@ -8482,7 +8482,7 @@
           <p:cNvPr id="6" name="CuadroTexto 5">
             <a:extLst>
               <a:ext uri="{FF2B5EF4-FFF2-40B4-BE49-F238E27FC236}">
-                <a16:creationId xmlns:a16="http://schemas.microsoft.com/office/drawing/2014/main" id="{D89D9B40-7C2B-6D34-46BD-BA660C281D6C}"/>
+                <a16:creationId xmlns:a16="http://schemas.microsoft.com/office/drawing/2014/main" id="{5E9AC572-B987-9EA5-C85B-687DEA4EEBE1}"/>
               </a:ext>
             </a:extLst>
           </p:cNvPr>
@@ -8520,7 +8520,7 @@
     </p:spTree>
     <p:extLst>
       <p:ext uri="{BB962C8B-B14F-4D97-AF65-F5344CB8AC3E}">
-        <p14:creationId xmlns:p14="http://schemas.microsoft.com/office/powerpoint/2010/main" val="4157162791"/>
+        <p14:creationId xmlns:p14="http://schemas.microsoft.com/office/powerpoint/2010/main" val="3000088455"/>
       </p:ext>
     </p:extLst>
   </p:cSld>
@@ -8560,7 +8560,7 @@
           <p:cNvPr id="2" name="CuadroTexto 1">
             <a:extLst>
               <a:ext uri="{FF2B5EF4-FFF2-40B4-BE49-F238E27FC236}">
-                <a16:creationId xmlns:a16="http://schemas.microsoft.com/office/drawing/2014/main" id="{DDF56AC7-7911-E2BF-6CC8-50571390860A}"/>
+                <a16:creationId xmlns:a16="http://schemas.microsoft.com/office/drawing/2014/main" id="{97A99495-7698-35C9-F519-3509243DF9B7}"/>
               </a:ext>
             </a:extLst>
           </p:cNvPr>
@@ -8600,7 +8600,7 @@
           <p:cNvPr id="3" name="CuadroTexto 2">
             <a:extLst>
               <a:ext uri="{FF2B5EF4-FFF2-40B4-BE49-F238E27FC236}">
-                <a16:creationId xmlns:a16="http://schemas.microsoft.com/office/drawing/2014/main" id="{4DACE98E-D820-9E94-C264-77DF6C4CC2D0}"/>
+                <a16:creationId xmlns:a16="http://schemas.microsoft.com/office/drawing/2014/main" id="{6473AEC7-F891-C8CF-F621-F8AB92A8A3AA}"/>
               </a:ext>
             </a:extLst>
           </p:cNvPr>
@@ -8640,7 +8640,7 @@
           <p:cNvPr id="4" name="CuadroTexto 3">
             <a:extLst>
               <a:ext uri="{FF2B5EF4-FFF2-40B4-BE49-F238E27FC236}">
-                <a16:creationId xmlns:a16="http://schemas.microsoft.com/office/drawing/2014/main" id="{0E355E7C-61B8-B4B6-062F-AEE7AA8F3A2E}"/>
+                <a16:creationId xmlns:a16="http://schemas.microsoft.com/office/drawing/2014/main" id="{CBC3D1CE-C197-78B9-9A60-0A88E3B8E328}"/>
               </a:ext>
             </a:extLst>
           </p:cNvPr>
@@ -8680,7 +8680,7 @@
           <p:cNvPr id="5" name="CuadroTexto 4">
             <a:extLst>
               <a:ext uri="{FF2B5EF4-FFF2-40B4-BE49-F238E27FC236}">
-                <a16:creationId xmlns:a16="http://schemas.microsoft.com/office/drawing/2014/main" id="{0C6AFCC8-F7F9-CD3D-7C00-AE222E696E86}"/>
+                <a16:creationId xmlns:a16="http://schemas.microsoft.com/office/drawing/2014/main" id="{E0FB9D0D-9935-C4CD-A639-878E061C4E37}"/>
               </a:ext>
             </a:extLst>
           </p:cNvPr>
@@ -8781,7 +8781,7 @@
           <p:cNvPr id="6" name="Rectángulo: esquinas redondeadas 5">
             <a:extLst>
               <a:ext uri="{FF2B5EF4-FFF2-40B4-BE49-F238E27FC236}">
-                <a16:creationId xmlns:a16="http://schemas.microsoft.com/office/drawing/2014/main" id="{36B6F8E0-E615-808A-AE2B-459EA13B7754}"/>
+                <a16:creationId xmlns:a16="http://schemas.microsoft.com/office/drawing/2014/main" id="{2379AFE7-7192-0690-5CFC-6D21DABC384B}"/>
               </a:ext>
             </a:extLst>
           </p:cNvPr>
@@ -8835,7 +8835,7 @@
           <p:cNvPr id="7" name="CuadroTexto 6">
             <a:extLst>
               <a:ext uri="{FF2B5EF4-FFF2-40B4-BE49-F238E27FC236}">
-                <a16:creationId xmlns:a16="http://schemas.microsoft.com/office/drawing/2014/main" id="{A8189235-ECAA-6164-31A7-4E28D358B8AD}"/>
+                <a16:creationId xmlns:a16="http://schemas.microsoft.com/office/drawing/2014/main" id="{4CDFD10E-68AA-CD60-D127-C2BDC01E1210}"/>
               </a:ext>
             </a:extLst>
           </p:cNvPr>
@@ -8875,7 +8875,7 @@
           <p:cNvPr id="8" name="CuadroTexto 7">
             <a:extLst>
               <a:ext uri="{FF2B5EF4-FFF2-40B4-BE49-F238E27FC236}">
-                <a16:creationId xmlns:a16="http://schemas.microsoft.com/office/drawing/2014/main" id="{DDB71B71-AA2A-A750-F9FF-835945CF0CC0}"/>
+                <a16:creationId xmlns:a16="http://schemas.microsoft.com/office/drawing/2014/main" id="{F0B2DE3F-31A5-C76F-97EE-CF45D9539F16}"/>
               </a:ext>
             </a:extLst>
           </p:cNvPr>
@@ -8913,7 +8913,7 @@
     </p:spTree>
     <p:extLst>
       <p:ext uri="{BB962C8B-B14F-4D97-AF65-F5344CB8AC3E}">
-        <p14:creationId xmlns:p14="http://schemas.microsoft.com/office/powerpoint/2010/main" val="3731850306"/>
+        <p14:creationId xmlns:p14="http://schemas.microsoft.com/office/powerpoint/2010/main" val="1700853319"/>
       </p:ext>
     </p:extLst>
   </p:cSld>
@@ -8953,7 +8953,7 @@
           <p:cNvPr id="2" name="CuadroTexto 1">
             <a:extLst>
               <a:ext uri="{FF2B5EF4-FFF2-40B4-BE49-F238E27FC236}">
-                <a16:creationId xmlns:a16="http://schemas.microsoft.com/office/drawing/2014/main" id="{6AAB2597-D46F-DC71-2F5D-8B25AD7F5E96}"/>
+                <a16:creationId xmlns:a16="http://schemas.microsoft.com/office/drawing/2014/main" id="{F47EE030-9113-F839-0500-8CD8FF63BCF0}"/>
               </a:ext>
             </a:extLst>
           </p:cNvPr>
@@ -8993,7 +8993,7 @@
           <p:cNvPr id="3" name="CuadroTexto 2">
             <a:extLst>
               <a:ext uri="{FF2B5EF4-FFF2-40B4-BE49-F238E27FC236}">
-                <a16:creationId xmlns:a16="http://schemas.microsoft.com/office/drawing/2014/main" id="{5B0BFD7C-8183-3CF0-551B-72C4115A75D0}"/>
+                <a16:creationId xmlns:a16="http://schemas.microsoft.com/office/drawing/2014/main" id="{E8C524AC-4C67-81BF-7CCF-69FF8BD63A89}"/>
               </a:ext>
             </a:extLst>
           </p:cNvPr>
@@ -9033,7 +9033,7 @@
           <p:cNvPr id="4" name="Rectángulo: esquinas redondeadas 3">
             <a:extLst>
               <a:ext uri="{FF2B5EF4-FFF2-40B4-BE49-F238E27FC236}">
-                <a16:creationId xmlns:a16="http://schemas.microsoft.com/office/drawing/2014/main" id="{5ACFF23C-810F-5790-7D24-C53279CEBFB7}"/>
+                <a16:creationId xmlns:a16="http://schemas.microsoft.com/office/drawing/2014/main" id="{183502EE-D18B-B6A8-0611-2FB4423E8FD7}"/>
               </a:ext>
             </a:extLst>
           </p:cNvPr>
@@ -9087,7 +9087,7 @@
           <p:cNvPr id="5" name="CuadroTexto 4">
             <a:extLst>
               <a:ext uri="{FF2B5EF4-FFF2-40B4-BE49-F238E27FC236}">
-                <a16:creationId xmlns:a16="http://schemas.microsoft.com/office/drawing/2014/main" id="{5FB3D499-5187-1BDF-4588-99C5D6332F04}"/>
+                <a16:creationId xmlns:a16="http://schemas.microsoft.com/office/drawing/2014/main" id="{4F6B2FD9-691B-2B4F-0E7E-1E1921951509}"/>
               </a:ext>
             </a:extLst>
           </p:cNvPr>
@@ -9127,7 +9127,7 @@
           <p:cNvPr id="6" name="CuadroTexto 5">
             <a:extLst>
               <a:ext uri="{FF2B5EF4-FFF2-40B4-BE49-F238E27FC236}">
-                <a16:creationId xmlns:a16="http://schemas.microsoft.com/office/drawing/2014/main" id="{A90DAC83-A0C8-BD46-CF8F-8FCE3D48137D}"/>
+                <a16:creationId xmlns:a16="http://schemas.microsoft.com/office/drawing/2014/main" id="{378FE75E-5B02-6B68-D4F4-DD7679DC86A6}"/>
               </a:ext>
             </a:extLst>
           </p:cNvPr>
@@ -9167,7 +9167,7 @@
           <p:cNvPr id="7" name="Rectángulo: esquinas redondeadas 6">
             <a:extLst>
               <a:ext uri="{FF2B5EF4-FFF2-40B4-BE49-F238E27FC236}">
-                <a16:creationId xmlns:a16="http://schemas.microsoft.com/office/drawing/2014/main" id="{91CAEE8A-4BB9-F904-5B9C-2A8358F24A0C}"/>
+                <a16:creationId xmlns:a16="http://schemas.microsoft.com/office/drawing/2014/main" id="{F70DB089-39D2-93F2-93E1-36918E2B0A52}"/>
               </a:ext>
             </a:extLst>
           </p:cNvPr>
@@ -9221,7 +9221,7 @@
           <p:cNvPr id="8" name="CuadroTexto 7">
             <a:extLst>
               <a:ext uri="{FF2B5EF4-FFF2-40B4-BE49-F238E27FC236}">
-                <a16:creationId xmlns:a16="http://schemas.microsoft.com/office/drawing/2014/main" id="{989F4701-DED3-63D5-604F-BD99DA9C461F}"/>
+                <a16:creationId xmlns:a16="http://schemas.microsoft.com/office/drawing/2014/main" id="{6896B342-D52E-797F-C4D1-8C77FA9387B7}"/>
               </a:ext>
             </a:extLst>
           </p:cNvPr>
@@ -9261,7 +9261,7 @@
           <p:cNvPr id="9" name="CuadroTexto 8">
             <a:extLst>
               <a:ext uri="{FF2B5EF4-FFF2-40B4-BE49-F238E27FC236}">
-                <a16:creationId xmlns:a16="http://schemas.microsoft.com/office/drawing/2014/main" id="{59E830CB-5452-93D8-1B37-4A6C6438CD90}"/>
+                <a16:creationId xmlns:a16="http://schemas.microsoft.com/office/drawing/2014/main" id="{98602FF3-714F-AA57-D40E-86781CE18B46}"/>
               </a:ext>
             </a:extLst>
           </p:cNvPr>
@@ -9301,7 +9301,7 @@
           <p:cNvPr id="10" name="Rectángulo: esquinas redondeadas 9">
             <a:extLst>
               <a:ext uri="{FF2B5EF4-FFF2-40B4-BE49-F238E27FC236}">
-                <a16:creationId xmlns:a16="http://schemas.microsoft.com/office/drawing/2014/main" id="{2D6F1CA5-94D8-2603-631E-BD4AC7C7EBD1}"/>
+                <a16:creationId xmlns:a16="http://schemas.microsoft.com/office/drawing/2014/main" id="{2018F7BD-80CB-AE7F-1AD1-5F348FD4E479}"/>
               </a:ext>
             </a:extLst>
           </p:cNvPr>
@@ -9355,7 +9355,7 @@
           <p:cNvPr id="11" name="CuadroTexto 10">
             <a:extLst>
               <a:ext uri="{FF2B5EF4-FFF2-40B4-BE49-F238E27FC236}">
-                <a16:creationId xmlns:a16="http://schemas.microsoft.com/office/drawing/2014/main" id="{3A663033-27A2-3610-6B2D-7F359410D3C7}"/>
+                <a16:creationId xmlns:a16="http://schemas.microsoft.com/office/drawing/2014/main" id="{241ECDB7-FDE8-B2B7-EF09-E3AF19A6F71C}"/>
               </a:ext>
             </a:extLst>
           </p:cNvPr>
@@ -9395,7 +9395,7 @@
           <p:cNvPr id="12" name="CuadroTexto 11">
             <a:extLst>
               <a:ext uri="{FF2B5EF4-FFF2-40B4-BE49-F238E27FC236}">
-                <a16:creationId xmlns:a16="http://schemas.microsoft.com/office/drawing/2014/main" id="{5CC91123-17E1-FCBA-E28D-24E2E13D265D}"/>
+                <a16:creationId xmlns:a16="http://schemas.microsoft.com/office/drawing/2014/main" id="{AAC34014-78F3-3DA1-D8BE-B59827995065}"/>
               </a:ext>
             </a:extLst>
           </p:cNvPr>
@@ -9435,7 +9435,7 @@
           <p:cNvPr id="13" name="Rectángulo: esquinas redondeadas 12">
             <a:extLst>
               <a:ext uri="{FF2B5EF4-FFF2-40B4-BE49-F238E27FC236}">
-                <a16:creationId xmlns:a16="http://schemas.microsoft.com/office/drawing/2014/main" id="{B5DB876D-AC76-BBF4-BA80-FB66462E361B}"/>
+                <a16:creationId xmlns:a16="http://schemas.microsoft.com/office/drawing/2014/main" id="{211940CC-D8B5-390B-5A36-C4840E35938B}"/>
               </a:ext>
             </a:extLst>
           </p:cNvPr>
@@ -9489,7 +9489,7 @@
           <p:cNvPr id="14" name="CuadroTexto 13">
             <a:extLst>
               <a:ext uri="{FF2B5EF4-FFF2-40B4-BE49-F238E27FC236}">
-                <a16:creationId xmlns:a16="http://schemas.microsoft.com/office/drawing/2014/main" id="{7F44A214-6240-E986-C66F-ECF824B30C93}"/>
+                <a16:creationId xmlns:a16="http://schemas.microsoft.com/office/drawing/2014/main" id="{B7289F20-C8BB-3595-F15B-4E2880ED0960}"/>
               </a:ext>
             </a:extLst>
           </p:cNvPr>
@@ -9529,7 +9529,7 @@
           <p:cNvPr id="15" name="CuadroTexto 14">
             <a:extLst>
               <a:ext uri="{FF2B5EF4-FFF2-40B4-BE49-F238E27FC236}">
-                <a16:creationId xmlns:a16="http://schemas.microsoft.com/office/drawing/2014/main" id="{610B48E6-11A1-611D-CE0A-7C67FBD0FDAF}"/>
+                <a16:creationId xmlns:a16="http://schemas.microsoft.com/office/drawing/2014/main" id="{AD5FDCD2-CF71-63AC-BF34-7A984AFA6773}"/>
               </a:ext>
             </a:extLst>
           </p:cNvPr>
@@ -9567,7 +9567,7 @@
     </p:spTree>
     <p:extLst>
       <p:ext uri="{BB962C8B-B14F-4D97-AF65-F5344CB8AC3E}">
-        <p14:creationId xmlns:p14="http://schemas.microsoft.com/office/powerpoint/2010/main" val="2054924816"/>
+        <p14:creationId xmlns:p14="http://schemas.microsoft.com/office/powerpoint/2010/main" val="532801573"/>
       </p:ext>
     </p:extLst>
   </p:cSld>
@@ -9607,7 +9607,7 @@
           <p:cNvPr id="2" name="CuadroTexto 1">
             <a:extLst>
               <a:ext uri="{FF2B5EF4-FFF2-40B4-BE49-F238E27FC236}">
-                <a16:creationId xmlns:a16="http://schemas.microsoft.com/office/drawing/2014/main" id="{B00CF1E5-9882-84D1-A36B-F9975948F1C6}"/>
+                <a16:creationId xmlns:a16="http://schemas.microsoft.com/office/drawing/2014/main" id="{02C763EB-133E-A78A-1CB0-1107BA8FDB07}"/>
               </a:ext>
             </a:extLst>
           </p:cNvPr>
@@ -9647,7 +9647,7 @@
           <p:cNvPr id="3" name="CuadroTexto 2">
             <a:extLst>
               <a:ext uri="{FF2B5EF4-FFF2-40B4-BE49-F238E27FC236}">
-                <a16:creationId xmlns:a16="http://schemas.microsoft.com/office/drawing/2014/main" id="{1B084417-75B2-1CA6-8C4F-EDF1A9BF7DBA}"/>
+                <a16:creationId xmlns:a16="http://schemas.microsoft.com/office/drawing/2014/main" id="{4DDA0427-728B-B593-D27C-E87F5A662BB1}"/>
               </a:ext>
             </a:extLst>
           </p:cNvPr>
@@ -9687,7 +9687,7 @@
           <p:cNvPr id="4" name="CuadroTexto 3">
             <a:extLst>
               <a:ext uri="{FF2B5EF4-FFF2-40B4-BE49-F238E27FC236}">
-                <a16:creationId xmlns:a16="http://schemas.microsoft.com/office/drawing/2014/main" id="{2314A682-2146-998E-587D-E8B92A72BFEC}"/>
+                <a16:creationId xmlns:a16="http://schemas.microsoft.com/office/drawing/2014/main" id="{4117148E-9BE1-AD74-94C9-056B7A8F40BA}"/>
               </a:ext>
             </a:extLst>
           </p:cNvPr>
@@ -9727,7 +9727,7 @@
           <p:cNvPr id="6" name="Imagen 5">
             <a:extLst>
               <a:ext uri="{FF2B5EF4-FFF2-40B4-BE49-F238E27FC236}">
-                <a16:creationId xmlns:a16="http://schemas.microsoft.com/office/drawing/2014/main" id="{3C9AB106-711F-8883-918A-0B752336D248}"/>
+                <a16:creationId xmlns:a16="http://schemas.microsoft.com/office/drawing/2014/main" id="{B4278C2D-D007-0FAB-0454-E696414CB426}"/>
               </a:ext>
             </a:extLst>
           </p:cNvPr>
@@ -9768,7 +9768,7 @@
           <p:cNvPr id="7" name="CuadroTexto 6">
             <a:extLst>
               <a:ext uri="{FF2B5EF4-FFF2-40B4-BE49-F238E27FC236}">
-                <a16:creationId xmlns:a16="http://schemas.microsoft.com/office/drawing/2014/main" id="{BFF87F8D-632E-0E66-12F6-BCED179951DD}"/>
+                <a16:creationId xmlns:a16="http://schemas.microsoft.com/office/drawing/2014/main" id="{F6E86348-1442-E11C-BF6E-F3E0C27223E0}"/>
               </a:ext>
             </a:extLst>
           </p:cNvPr>
@@ -9885,7 +9885,7 @@
     </p:spTree>
     <p:extLst>
       <p:ext uri="{BB962C8B-B14F-4D97-AF65-F5344CB8AC3E}">
-        <p14:creationId xmlns:p14="http://schemas.microsoft.com/office/powerpoint/2010/main" val="1561485036"/>
+        <p14:creationId xmlns:p14="http://schemas.microsoft.com/office/powerpoint/2010/main" val="3055323459"/>
       </p:ext>
     </p:extLst>
   </p:cSld>
@@ -9925,7 +9925,7 @@
           <p:cNvPr id="2" name="CuadroTexto 1">
             <a:extLst>
               <a:ext uri="{FF2B5EF4-FFF2-40B4-BE49-F238E27FC236}">
-                <a16:creationId xmlns:a16="http://schemas.microsoft.com/office/drawing/2014/main" id="{73CF5C9E-9ECB-3DD5-6D4F-A407C7C0ED49}"/>
+                <a16:creationId xmlns:a16="http://schemas.microsoft.com/office/drawing/2014/main" id="{6A55F792-719B-4933-0A82-79DA36A75C66}"/>
               </a:ext>
             </a:extLst>
           </p:cNvPr>
@@ -9965,7 +9965,7 @@
           <p:cNvPr id="3" name="CuadroTexto 2">
             <a:extLst>
               <a:ext uri="{FF2B5EF4-FFF2-40B4-BE49-F238E27FC236}">
-                <a16:creationId xmlns:a16="http://schemas.microsoft.com/office/drawing/2014/main" id="{0491214E-0C65-5F9E-16EE-1A317A0FB4E8}"/>
+                <a16:creationId xmlns:a16="http://schemas.microsoft.com/office/drawing/2014/main" id="{2E49A66F-CB1D-8525-2172-BAF6AB440E2B}"/>
               </a:ext>
             </a:extLst>
           </p:cNvPr>
@@ -10005,7 +10005,7 @@
           <p:cNvPr id="5" name="Imagen 4">
             <a:extLst>
               <a:ext uri="{FF2B5EF4-FFF2-40B4-BE49-F238E27FC236}">
-                <a16:creationId xmlns:a16="http://schemas.microsoft.com/office/drawing/2014/main" id="{DAE1B80D-AE78-6905-6235-AB2486E053B4}"/>
+                <a16:creationId xmlns:a16="http://schemas.microsoft.com/office/drawing/2014/main" id="{CF1E2096-6DE4-2AA4-BC44-C2719EB4F519}"/>
               </a:ext>
             </a:extLst>
           </p:cNvPr>
@@ -10046,7 +10046,7 @@
           <p:cNvPr id="6" name="CuadroTexto 5">
             <a:extLst>
               <a:ext uri="{FF2B5EF4-FFF2-40B4-BE49-F238E27FC236}">
-                <a16:creationId xmlns:a16="http://schemas.microsoft.com/office/drawing/2014/main" id="{FE454F16-1D60-5900-7AD6-BD4EEB8BB38D}"/>
+                <a16:creationId xmlns:a16="http://schemas.microsoft.com/office/drawing/2014/main" id="{2D2B4C86-D810-64D8-4A85-90CC19F2C751}"/>
               </a:ext>
             </a:extLst>
           </p:cNvPr>
@@ -10086,7 +10086,7 @@
           <p:cNvPr id="7" name="CuadroTexto 6">
             <a:extLst>
               <a:ext uri="{FF2B5EF4-FFF2-40B4-BE49-F238E27FC236}">
-                <a16:creationId xmlns:a16="http://schemas.microsoft.com/office/drawing/2014/main" id="{93694235-5164-8076-25CE-63B5F4A19767}"/>
+                <a16:creationId xmlns:a16="http://schemas.microsoft.com/office/drawing/2014/main" id="{2685FCED-4FC2-BF16-CB15-0DD8D2E263EB}"/>
               </a:ext>
             </a:extLst>
           </p:cNvPr>
@@ -10185,7 +10185,7 @@
     </p:spTree>
     <p:extLst>
       <p:ext uri="{BB962C8B-B14F-4D97-AF65-F5344CB8AC3E}">
-        <p14:creationId xmlns:p14="http://schemas.microsoft.com/office/powerpoint/2010/main" val="2548476343"/>
+        <p14:creationId xmlns:p14="http://schemas.microsoft.com/office/powerpoint/2010/main" val="2739586334"/>
       </p:ext>
     </p:extLst>
   </p:cSld>
@@ -10225,7 +10225,7 @@
           <p:cNvPr id="2" name="CuadroTexto 1">
             <a:extLst>
               <a:ext uri="{FF2B5EF4-FFF2-40B4-BE49-F238E27FC236}">
-                <a16:creationId xmlns:a16="http://schemas.microsoft.com/office/drawing/2014/main" id="{4CCBF99B-D613-FA12-9C8A-6D8075887DF4}"/>
+                <a16:creationId xmlns:a16="http://schemas.microsoft.com/office/drawing/2014/main" id="{CE2F9C66-1DF0-AA26-FDED-651C2EB88C0A}"/>
               </a:ext>
             </a:extLst>
           </p:cNvPr>
@@ -10265,7 +10265,7 @@
           <p:cNvPr id="3" name="CuadroTexto 2">
             <a:extLst>
               <a:ext uri="{FF2B5EF4-FFF2-40B4-BE49-F238E27FC236}">
-                <a16:creationId xmlns:a16="http://schemas.microsoft.com/office/drawing/2014/main" id="{243A3967-F235-BEB6-A9A9-0C204031D56C}"/>
+                <a16:creationId xmlns:a16="http://schemas.microsoft.com/office/drawing/2014/main" id="{BB4629B6-4913-02FD-22C5-F6B0C32BD709}"/>
               </a:ext>
             </a:extLst>
           </p:cNvPr>
@@ -10305,7 +10305,7 @@
           <p:cNvPr id="4" name="CuadroTexto 3">
             <a:extLst>
               <a:ext uri="{FF2B5EF4-FFF2-40B4-BE49-F238E27FC236}">
-                <a16:creationId xmlns:a16="http://schemas.microsoft.com/office/drawing/2014/main" id="{75B1EF6C-E4F6-9647-687F-3CA25CCEDA32}"/>
+                <a16:creationId xmlns:a16="http://schemas.microsoft.com/office/drawing/2014/main" id="{89B0F4DE-C0A7-A7EE-1CA2-F3A03BCD4C50}"/>
               </a:ext>
             </a:extLst>
           </p:cNvPr>
@@ -10345,7 +10345,7 @@
           <p:cNvPr id="6" name="Imagen 5">
             <a:extLst>
               <a:ext uri="{FF2B5EF4-FFF2-40B4-BE49-F238E27FC236}">
-                <a16:creationId xmlns:a16="http://schemas.microsoft.com/office/drawing/2014/main" id="{0C4C337B-4936-585C-0416-47FA306F1B16}"/>
+                <a16:creationId xmlns:a16="http://schemas.microsoft.com/office/drawing/2014/main" id="{56A3FCBC-E07E-66C5-C566-583C15F6E59B}"/>
               </a:ext>
             </a:extLst>
           </p:cNvPr>
@@ -10386,7 +10386,7 @@
           <p:cNvPr id="7" name="Rectángulo: esquinas redondeadas 6">
             <a:extLst>
               <a:ext uri="{FF2B5EF4-FFF2-40B4-BE49-F238E27FC236}">
-                <a16:creationId xmlns:a16="http://schemas.microsoft.com/office/drawing/2014/main" id="{95311EDC-1A2C-CDBE-CECF-C96DC6623FE5}"/>
+                <a16:creationId xmlns:a16="http://schemas.microsoft.com/office/drawing/2014/main" id="{AE163F4D-D493-53CB-D135-CCB3C639FD66}"/>
               </a:ext>
             </a:extLst>
           </p:cNvPr>
@@ -10440,7 +10440,7 @@
           <p:cNvPr id="8" name="CuadroTexto 7">
             <a:extLst>
               <a:ext uri="{FF2B5EF4-FFF2-40B4-BE49-F238E27FC236}">
-                <a16:creationId xmlns:a16="http://schemas.microsoft.com/office/drawing/2014/main" id="{8DD254F0-0569-7FA3-77EB-BAA24FF8113D}"/>
+                <a16:creationId xmlns:a16="http://schemas.microsoft.com/office/drawing/2014/main" id="{5E2B6364-4DB1-AE6A-0D78-80A02A8AA6BD}"/>
               </a:ext>
             </a:extLst>
           </p:cNvPr>
@@ -10480,7 +10480,7 @@
           <p:cNvPr id="9" name="CuadroTexto 8">
             <a:extLst>
               <a:ext uri="{FF2B5EF4-FFF2-40B4-BE49-F238E27FC236}">
-                <a16:creationId xmlns:a16="http://schemas.microsoft.com/office/drawing/2014/main" id="{634E3904-911B-D57D-4B7B-A09895F73D32}"/>
+                <a16:creationId xmlns:a16="http://schemas.microsoft.com/office/drawing/2014/main" id="{1A64EE55-B20E-4844-D32D-4F73259ACA22}"/>
               </a:ext>
             </a:extLst>
           </p:cNvPr>
@@ -10520,7 +10520,7 @@
           <p:cNvPr id="10" name="Rectángulo: esquinas redondeadas 9">
             <a:extLst>
               <a:ext uri="{FF2B5EF4-FFF2-40B4-BE49-F238E27FC236}">
-                <a16:creationId xmlns:a16="http://schemas.microsoft.com/office/drawing/2014/main" id="{8AE624A3-0614-02E0-0F30-1AE23EB98776}"/>
+                <a16:creationId xmlns:a16="http://schemas.microsoft.com/office/drawing/2014/main" id="{231982D3-0988-2594-A592-4D0C6D87671F}"/>
               </a:ext>
             </a:extLst>
           </p:cNvPr>
@@ -10574,7 +10574,7 @@
           <p:cNvPr id="11" name="CuadroTexto 10">
             <a:extLst>
               <a:ext uri="{FF2B5EF4-FFF2-40B4-BE49-F238E27FC236}">
-                <a16:creationId xmlns:a16="http://schemas.microsoft.com/office/drawing/2014/main" id="{93DBD568-99F4-558D-B372-3422623ED7F5}"/>
+                <a16:creationId xmlns:a16="http://schemas.microsoft.com/office/drawing/2014/main" id="{3925F191-B401-B60F-B76D-5E7E042AA08A}"/>
               </a:ext>
             </a:extLst>
           </p:cNvPr>
@@ -10614,7 +10614,7 @@
           <p:cNvPr id="12" name="CuadroTexto 11">
             <a:extLst>
               <a:ext uri="{FF2B5EF4-FFF2-40B4-BE49-F238E27FC236}">
-                <a16:creationId xmlns:a16="http://schemas.microsoft.com/office/drawing/2014/main" id="{B9792F97-BD91-8F4B-B7E6-2A7A2B088498}"/>
+                <a16:creationId xmlns:a16="http://schemas.microsoft.com/office/drawing/2014/main" id="{17504DA1-D9C3-AF90-A7A9-F274FCD16B03}"/>
               </a:ext>
             </a:extLst>
           </p:cNvPr>
@@ -10654,7 +10654,7 @@
           <p:cNvPr id="13" name="Rectángulo: esquinas redondeadas 12">
             <a:extLst>
               <a:ext uri="{FF2B5EF4-FFF2-40B4-BE49-F238E27FC236}">
-                <a16:creationId xmlns:a16="http://schemas.microsoft.com/office/drawing/2014/main" id="{A96305F9-22DA-CECB-E7E2-F1D4752C8E88}"/>
+                <a16:creationId xmlns:a16="http://schemas.microsoft.com/office/drawing/2014/main" id="{1C302DFF-C064-5ED9-A3A6-5955EFF7003E}"/>
               </a:ext>
             </a:extLst>
           </p:cNvPr>
@@ -10708,7 +10708,7 @@
           <p:cNvPr id="14" name="CuadroTexto 13">
             <a:extLst>
               <a:ext uri="{FF2B5EF4-FFF2-40B4-BE49-F238E27FC236}">
-                <a16:creationId xmlns:a16="http://schemas.microsoft.com/office/drawing/2014/main" id="{A3036D62-8AF8-71F6-7714-3D71EF962E77}"/>
+                <a16:creationId xmlns:a16="http://schemas.microsoft.com/office/drawing/2014/main" id="{4208011F-4DB1-E672-7A4D-4B7B41415603}"/>
               </a:ext>
             </a:extLst>
           </p:cNvPr>
@@ -10748,7 +10748,7 @@
           <p:cNvPr id="15" name="CuadroTexto 14">
             <a:extLst>
               <a:ext uri="{FF2B5EF4-FFF2-40B4-BE49-F238E27FC236}">
-                <a16:creationId xmlns:a16="http://schemas.microsoft.com/office/drawing/2014/main" id="{FE26A294-69A6-3EA2-CDFC-AEDCBFB4FE72}"/>
+                <a16:creationId xmlns:a16="http://schemas.microsoft.com/office/drawing/2014/main" id="{706D95B7-07CF-B39A-C8EB-290DAADF0404}"/>
               </a:ext>
             </a:extLst>
           </p:cNvPr>
@@ -10786,7 +10786,7 @@
     </p:spTree>
     <p:extLst>
       <p:ext uri="{BB962C8B-B14F-4D97-AF65-F5344CB8AC3E}">
-        <p14:creationId xmlns:p14="http://schemas.microsoft.com/office/powerpoint/2010/main" val="682710152"/>
+        <p14:creationId xmlns:p14="http://schemas.microsoft.com/office/powerpoint/2010/main" val="537032938"/>
       </p:ext>
     </p:extLst>
   </p:cSld>
@@ -10826,7 +10826,7 @@
           <p:cNvPr id="2" name="CuadroTexto 1">
             <a:extLst>
               <a:ext uri="{FF2B5EF4-FFF2-40B4-BE49-F238E27FC236}">
-                <a16:creationId xmlns:a16="http://schemas.microsoft.com/office/drawing/2014/main" id="{C8526C7C-7F36-1F36-B098-CEBCE3916988}"/>
+                <a16:creationId xmlns:a16="http://schemas.microsoft.com/office/drawing/2014/main" id="{0D271AAC-A832-5E08-C88A-93FF0DEC3547}"/>
               </a:ext>
             </a:extLst>
           </p:cNvPr>
@@ -10866,7 +10866,7 @@
           <p:cNvPr id="3" name="CuadroTexto 2">
             <a:extLst>
               <a:ext uri="{FF2B5EF4-FFF2-40B4-BE49-F238E27FC236}">
-                <a16:creationId xmlns:a16="http://schemas.microsoft.com/office/drawing/2014/main" id="{1BF120A3-159A-D241-747C-B27F5AF2C4F7}"/>
+                <a16:creationId xmlns:a16="http://schemas.microsoft.com/office/drawing/2014/main" id="{AD9944CF-079F-0D18-83A8-3B08688E2314}"/>
               </a:ext>
             </a:extLst>
           </p:cNvPr>
@@ -10906,7 +10906,7 @@
           <p:cNvPr id="5" name="Imagen 4">
             <a:extLst>
               <a:ext uri="{FF2B5EF4-FFF2-40B4-BE49-F238E27FC236}">
-                <a16:creationId xmlns:a16="http://schemas.microsoft.com/office/drawing/2014/main" id="{BF10EABB-4CE5-12E1-2136-83BB85DEC781}"/>
+                <a16:creationId xmlns:a16="http://schemas.microsoft.com/office/drawing/2014/main" id="{5C2C4B73-58CA-A5C3-34D3-2BBBA5E9B5D4}"/>
               </a:ext>
             </a:extLst>
           </p:cNvPr>
@@ -10947,7 +10947,7 @@
           <p:cNvPr id="6" name="CuadroTexto 5">
             <a:extLst>
               <a:ext uri="{FF2B5EF4-FFF2-40B4-BE49-F238E27FC236}">
-                <a16:creationId xmlns:a16="http://schemas.microsoft.com/office/drawing/2014/main" id="{CD1F0883-D8B9-2E22-202D-0A67982F9561}"/>
+                <a16:creationId xmlns:a16="http://schemas.microsoft.com/office/drawing/2014/main" id="{1F1B8C47-7AA5-402F-9DE9-2E84691C3AC7}"/>
               </a:ext>
             </a:extLst>
           </p:cNvPr>
@@ -11046,7 +11046,7 @@
     </p:spTree>
     <p:extLst>
       <p:ext uri="{BB962C8B-B14F-4D97-AF65-F5344CB8AC3E}">
-        <p14:creationId xmlns:p14="http://schemas.microsoft.com/office/powerpoint/2010/main" val="2840323761"/>
+        <p14:creationId xmlns:p14="http://schemas.microsoft.com/office/powerpoint/2010/main" val="47247134"/>
       </p:ext>
     </p:extLst>
   </p:cSld>
@@ -11086,7 +11086,7 @@
           <p:cNvPr id="2" name="CuadroTexto 1">
             <a:extLst>
               <a:ext uri="{FF2B5EF4-FFF2-40B4-BE49-F238E27FC236}">
-                <a16:creationId xmlns:a16="http://schemas.microsoft.com/office/drawing/2014/main" id="{D90B48C7-75E2-7233-F8AA-29C8EEBDAEB1}"/>
+                <a16:creationId xmlns:a16="http://schemas.microsoft.com/office/drawing/2014/main" id="{42D22E14-F2E0-12FB-23AD-8C06856A5CEC}"/>
               </a:ext>
             </a:extLst>
           </p:cNvPr>
@@ -11126,7 +11126,7 @@
           <p:cNvPr id="3" name="CuadroTexto 2">
             <a:extLst>
               <a:ext uri="{FF2B5EF4-FFF2-40B4-BE49-F238E27FC236}">
-                <a16:creationId xmlns:a16="http://schemas.microsoft.com/office/drawing/2014/main" id="{1A9766DC-1F20-1D12-E634-CE6B986FF7BB}"/>
+                <a16:creationId xmlns:a16="http://schemas.microsoft.com/office/drawing/2014/main" id="{FA9CFA21-8403-29AD-04BC-F190C18F9982}"/>
               </a:ext>
             </a:extLst>
           </p:cNvPr>
@@ -11166,7 +11166,7 @@
           <p:cNvPr id="4" name="CuadroTexto 3">
             <a:extLst>
               <a:ext uri="{FF2B5EF4-FFF2-40B4-BE49-F238E27FC236}">
-                <a16:creationId xmlns:a16="http://schemas.microsoft.com/office/drawing/2014/main" id="{86B4A59F-FEE4-F93D-75F8-DF07877C923E}"/>
+                <a16:creationId xmlns:a16="http://schemas.microsoft.com/office/drawing/2014/main" id="{EA134C0F-CB10-D821-49F7-39624C8868CA}"/>
               </a:ext>
             </a:extLst>
           </p:cNvPr>
@@ -11206,7 +11206,7 @@
           <p:cNvPr id="6" name="Imagen 5">
             <a:extLst>
               <a:ext uri="{FF2B5EF4-FFF2-40B4-BE49-F238E27FC236}">
-                <a16:creationId xmlns:a16="http://schemas.microsoft.com/office/drawing/2014/main" id="{255106AF-20D9-DF0B-FDD5-2C136CBA7427}"/>
+                <a16:creationId xmlns:a16="http://schemas.microsoft.com/office/drawing/2014/main" id="{9CB5DA02-DAA9-B8B0-2EF1-31F9B92ED5B2}"/>
               </a:ext>
             </a:extLst>
           </p:cNvPr>
@@ -11247,7 +11247,7 @@
           <p:cNvPr id="7" name="Rectángulo: esquinas redondeadas 6">
             <a:extLst>
               <a:ext uri="{FF2B5EF4-FFF2-40B4-BE49-F238E27FC236}">
-                <a16:creationId xmlns:a16="http://schemas.microsoft.com/office/drawing/2014/main" id="{5202FD18-0355-7146-3EBE-A846FBAC2C23}"/>
+                <a16:creationId xmlns:a16="http://schemas.microsoft.com/office/drawing/2014/main" id="{62987D9B-3E4E-70FC-9478-5CB4BD439987}"/>
               </a:ext>
             </a:extLst>
           </p:cNvPr>
@@ -11301,7 +11301,7 @@
           <p:cNvPr id="8" name="CuadroTexto 7">
             <a:extLst>
               <a:ext uri="{FF2B5EF4-FFF2-40B4-BE49-F238E27FC236}">
-                <a16:creationId xmlns:a16="http://schemas.microsoft.com/office/drawing/2014/main" id="{C96D24EC-4409-1E20-190F-4FC7BDC4705F}"/>
+                <a16:creationId xmlns:a16="http://schemas.microsoft.com/office/drawing/2014/main" id="{E68A74AC-0594-A8D8-4023-EEE74A3322B7}"/>
               </a:ext>
             </a:extLst>
           </p:cNvPr>
@@ -11341,7 +11341,7 @@
           <p:cNvPr id="9" name="CuadroTexto 8">
             <a:extLst>
               <a:ext uri="{FF2B5EF4-FFF2-40B4-BE49-F238E27FC236}">
-                <a16:creationId xmlns:a16="http://schemas.microsoft.com/office/drawing/2014/main" id="{1D793C89-ECDB-35EC-F819-FEB290F7A142}"/>
+                <a16:creationId xmlns:a16="http://schemas.microsoft.com/office/drawing/2014/main" id="{50FEE87D-4813-369E-CDF0-D3B7AE81E5BB}"/>
               </a:ext>
             </a:extLst>
           </p:cNvPr>
@@ -11379,7 +11379,7 @@
     </p:spTree>
     <p:extLst>
       <p:ext uri="{BB962C8B-B14F-4D97-AF65-F5344CB8AC3E}">
-        <p14:creationId xmlns:p14="http://schemas.microsoft.com/office/powerpoint/2010/main" val="236568225"/>
+        <p14:creationId xmlns:p14="http://schemas.microsoft.com/office/powerpoint/2010/main" val="1678548499"/>
       </p:ext>
     </p:extLst>
   </p:cSld>
@@ -11419,7 +11419,7 @@
           <p:cNvPr id="2" name="CuadroTexto 1">
             <a:extLst>
               <a:ext uri="{FF2B5EF4-FFF2-40B4-BE49-F238E27FC236}">
-                <a16:creationId xmlns:a16="http://schemas.microsoft.com/office/drawing/2014/main" id="{8E8FE010-8AAF-D77A-6FE3-A432594F744F}"/>
+                <a16:creationId xmlns:a16="http://schemas.microsoft.com/office/drawing/2014/main" id="{88CDCCD6-2EF4-0F24-586E-5203F93C424A}"/>
               </a:ext>
             </a:extLst>
           </p:cNvPr>
@@ -11459,7 +11459,7 @@
           <p:cNvPr id="3" name="CuadroTexto 2">
             <a:extLst>
               <a:ext uri="{FF2B5EF4-FFF2-40B4-BE49-F238E27FC236}">
-                <a16:creationId xmlns:a16="http://schemas.microsoft.com/office/drawing/2014/main" id="{85DD18C2-C5F8-BD47-72A7-CE0CB63325F1}"/>
+                <a16:creationId xmlns:a16="http://schemas.microsoft.com/office/drawing/2014/main" id="{F798B586-C962-DBEA-4D8E-83B718B7CBA1}"/>
               </a:ext>
             </a:extLst>
           </p:cNvPr>
@@ -11499,7 +11499,7 @@
           <p:cNvPr id="4" name="CuadroTexto 3">
             <a:extLst>
               <a:ext uri="{FF2B5EF4-FFF2-40B4-BE49-F238E27FC236}">
-                <a16:creationId xmlns:a16="http://schemas.microsoft.com/office/drawing/2014/main" id="{EDB07F75-413F-95A5-9FAF-BE68D811BCC1}"/>
+                <a16:creationId xmlns:a16="http://schemas.microsoft.com/office/drawing/2014/main" id="{BBD29CD5-2995-DEEE-7EB2-5087A0CA9DE9}"/>
               </a:ext>
             </a:extLst>
           </p:cNvPr>
@@ -11539,7 +11539,7 @@
           <p:cNvPr id="5" name="Rectángulo: esquinas redondeadas 4">
             <a:extLst>
               <a:ext uri="{FF2B5EF4-FFF2-40B4-BE49-F238E27FC236}">
-                <a16:creationId xmlns:a16="http://schemas.microsoft.com/office/drawing/2014/main" id="{17C06495-A4E4-1550-2896-9DA0D0108873}"/>
+                <a16:creationId xmlns:a16="http://schemas.microsoft.com/office/drawing/2014/main" id="{17CEA027-1CF4-64D0-C7A3-4234DEF651E7}"/>
               </a:ext>
             </a:extLst>
           </p:cNvPr>
@@ -11593,7 +11593,7 @@
           <p:cNvPr id="6" name="CuadroTexto 5">
             <a:extLst>
               <a:ext uri="{FF2B5EF4-FFF2-40B4-BE49-F238E27FC236}">
-                <a16:creationId xmlns:a16="http://schemas.microsoft.com/office/drawing/2014/main" id="{42EFF471-8EFC-84EC-BCB5-3096366249FD}"/>
+                <a16:creationId xmlns:a16="http://schemas.microsoft.com/office/drawing/2014/main" id="{CC1888A3-3A4F-1D68-A197-FDF057B2C713}"/>
               </a:ext>
             </a:extLst>
           </p:cNvPr>
@@ -11633,7 +11633,7 @@
           <p:cNvPr id="7" name="CuadroTexto 6">
             <a:extLst>
               <a:ext uri="{FF2B5EF4-FFF2-40B4-BE49-F238E27FC236}">
-                <a16:creationId xmlns:a16="http://schemas.microsoft.com/office/drawing/2014/main" id="{36DAEDEA-D504-B0E3-6717-DC1BDC86404A}"/>
+                <a16:creationId xmlns:a16="http://schemas.microsoft.com/office/drawing/2014/main" id="{1793028D-CA88-DB07-AD8E-8D4F835B7B10}"/>
               </a:ext>
             </a:extLst>
           </p:cNvPr>
@@ -11673,7 +11673,7 @@
           <p:cNvPr id="8" name="Rectángulo: esquinas redondeadas 7">
             <a:extLst>
               <a:ext uri="{FF2B5EF4-FFF2-40B4-BE49-F238E27FC236}">
-                <a16:creationId xmlns:a16="http://schemas.microsoft.com/office/drawing/2014/main" id="{1BA7AAAC-B458-3E5B-461A-2FD52BE81980}"/>
+                <a16:creationId xmlns:a16="http://schemas.microsoft.com/office/drawing/2014/main" id="{4A558677-C866-62A1-1E71-993B4D95E4F2}"/>
               </a:ext>
             </a:extLst>
           </p:cNvPr>
@@ -11727,7 +11727,7 @@
           <p:cNvPr id="9" name="CuadroTexto 8">
             <a:extLst>
               <a:ext uri="{FF2B5EF4-FFF2-40B4-BE49-F238E27FC236}">
-                <a16:creationId xmlns:a16="http://schemas.microsoft.com/office/drawing/2014/main" id="{2743EDE1-291D-83D0-5EC5-20CBC69A6DA4}"/>
+                <a16:creationId xmlns:a16="http://schemas.microsoft.com/office/drawing/2014/main" id="{9C67C9A2-9611-E597-A0F4-5F4AF9F0CC03}"/>
               </a:ext>
             </a:extLst>
           </p:cNvPr>
@@ -11767,7 +11767,7 @@
           <p:cNvPr id="10" name="CuadroTexto 9">
             <a:extLst>
               <a:ext uri="{FF2B5EF4-FFF2-40B4-BE49-F238E27FC236}">
-                <a16:creationId xmlns:a16="http://schemas.microsoft.com/office/drawing/2014/main" id="{F4240100-1FDE-723F-3EEE-A537BB373D6F}"/>
+                <a16:creationId xmlns:a16="http://schemas.microsoft.com/office/drawing/2014/main" id="{C138F767-6F11-A4C3-0626-D4CC43D28120}"/>
               </a:ext>
             </a:extLst>
           </p:cNvPr>
@@ -11807,7 +11807,7 @@
           <p:cNvPr id="11" name="Rectángulo: esquinas redondeadas 10">
             <a:extLst>
               <a:ext uri="{FF2B5EF4-FFF2-40B4-BE49-F238E27FC236}">
-                <a16:creationId xmlns:a16="http://schemas.microsoft.com/office/drawing/2014/main" id="{D802EDA8-4287-0BAC-408C-2404BCC2D9EF}"/>
+                <a16:creationId xmlns:a16="http://schemas.microsoft.com/office/drawing/2014/main" id="{BCAD6787-FAA2-14F0-8B25-0946EB1A5B29}"/>
               </a:ext>
             </a:extLst>
           </p:cNvPr>
@@ -11861,7 +11861,7 @@
           <p:cNvPr id="12" name="CuadroTexto 11">
             <a:extLst>
               <a:ext uri="{FF2B5EF4-FFF2-40B4-BE49-F238E27FC236}">
-                <a16:creationId xmlns:a16="http://schemas.microsoft.com/office/drawing/2014/main" id="{010E48B9-43AA-1CDE-BD8D-A06072EB02FF}"/>
+                <a16:creationId xmlns:a16="http://schemas.microsoft.com/office/drawing/2014/main" id="{0AA20422-DC77-CC23-8DC0-1D6A3F3CFA2C}"/>
               </a:ext>
             </a:extLst>
           </p:cNvPr>
@@ -11901,7 +11901,7 @@
           <p:cNvPr id="13" name="CuadroTexto 12">
             <a:extLst>
               <a:ext uri="{FF2B5EF4-FFF2-40B4-BE49-F238E27FC236}">
-                <a16:creationId xmlns:a16="http://schemas.microsoft.com/office/drawing/2014/main" id="{C33D04DF-D4DB-920E-8E59-9BA968219784}"/>
+                <a16:creationId xmlns:a16="http://schemas.microsoft.com/office/drawing/2014/main" id="{3E5312E2-4CD1-2151-1BA8-B07624168BB7}"/>
               </a:ext>
             </a:extLst>
           </p:cNvPr>
@@ -11941,7 +11941,7 @@
           <p:cNvPr id="14" name="Rectángulo: esquinas redondeadas 13">
             <a:extLst>
               <a:ext uri="{FF2B5EF4-FFF2-40B4-BE49-F238E27FC236}">
-                <a16:creationId xmlns:a16="http://schemas.microsoft.com/office/drawing/2014/main" id="{A0AA643C-F3E5-D18C-91F2-2DAA1A4FA014}"/>
+                <a16:creationId xmlns:a16="http://schemas.microsoft.com/office/drawing/2014/main" id="{E81C0679-D03A-6A0D-332A-86A1B1AEC437}"/>
               </a:ext>
             </a:extLst>
           </p:cNvPr>
@@ -11995,7 +11995,7 @@
           <p:cNvPr id="15" name="CuadroTexto 14">
             <a:extLst>
               <a:ext uri="{FF2B5EF4-FFF2-40B4-BE49-F238E27FC236}">
-                <a16:creationId xmlns:a16="http://schemas.microsoft.com/office/drawing/2014/main" id="{0080C4FD-0FBC-6437-20BE-F5B8B213E917}"/>
+                <a16:creationId xmlns:a16="http://schemas.microsoft.com/office/drawing/2014/main" id="{439ED77F-300D-7747-038C-C7235A53130F}"/>
               </a:ext>
             </a:extLst>
           </p:cNvPr>
@@ -12035,7 +12035,7 @@
           <p:cNvPr id="16" name="CuadroTexto 15">
             <a:extLst>
               <a:ext uri="{FF2B5EF4-FFF2-40B4-BE49-F238E27FC236}">
-                <a16:creationId xmlns:a16="http://schemas.microsoft.com/office/drawing/2014/main" id="{9C6CAE58-62EF-43B8-DD30-6B325291064C}"/>
+                <a16:creationId xmlns:a16="http://schemas.microsoft.com/office/drawing/2014/main" id="{38DF6048-8027-8105-AB0D-6A129451598C}"/>
               </a:ext>
             </a:extLst>
           </p:cNvPr>
@@ -12075,7 +12075,7 @@
           <p:cNvPr id="17" name="Rectángulo: esquinas redondeadas 16">
             <a:extLst>
               <a:ext uri="{FF2B5EF4-FFF2-40B4-BE49-F238E27FC236}">
-                <a16:creationId xmlns:a16="http://schemas.microsoft.com/office/drawing/2014/main" id="{6731DF98-6AED-5524-51E0-924ECE61238F}"/>
+                <a16:creationId xmlns:a16="http://schemas.microsoft.com/office/drawing/2014/main" id="{48D4A248-2DAC-2D2D-40DA-A0C272FB9D70}"/>
               </a:ext>
             </a:extLst>
           </p:cNvPr>
@@ -12129,7 +12129,7 @@
           <p:cNvPr id="18" name="CuadroTexto 17">
             <a:extLst>
               <a:ext uri="{FF2B5EF4-FFF2-40B4-BE49-F238E27FC236}">
-                <a16:creationId xmlns:a16="http://schemas.microsoft.com/office/drawing/2014/main" id="{39EF097E-AF1A-0F6F-554C-A59448AD9CCF}"/>
+                <a16:creationId xmlns:a16="http://schemas.microsoft.com/office/drawing/2014/main" id="{2CAEF4FC-B0DA-6EF8-C78D-8022D75BDCAD}"/>
               </a:ext>
             </a:extLst>
           </p:cNvPr>
@@ -12169,7 +12169,7 @@
           <p:cNvPr id="19" name="CuadroTexto 18">
             <a:extLst>
               <a:ext uri="{FF2B5EF4-FFF2-40B4-BE49-F238E27FC236}">
-                <a16:creationId xmlns:a16="http://schemas.microsoft.com/office/drawing/2014/main" id="{19DF365D-C7F0-598F-EC66-AC5AAB5B0A7F}"/>
+                <a16:creationId xmlns:a16="http://schemas.microsoft.com/office/drawing/2014/main" id="{380BBCD7-8522-81A5-53E1-E99DCD41D98F}"/>
               </a:ext>
             </a:extLst>
           </p:cNvPr>
@@ -12209,7 +12209,7 @@
           <p:cNvPr id="20" name="Rectángulo: esquinas redondeadas 19">
             <a:extLst>
               <a:ext uri="{FF2B5EF4-FFF2-40B4-BE49-F238E27FC236}">
-                <a16:creationId xmlns:a16="http://schemas.microsoft.com/office/drawing/2014/main" id="{669B39C3-1217-FE7E-C31D-618BC248FBEA}"/>
+                <a16:creationId xmlns:a16="http://schemas.microsoft.com/office/drawing/2014/main" id="{7FC02C4D-DBFF-D14A-7FC5-DF3BBB26A494}"/>
               </a:ext>
             </a:extLst>
           </p:cNvPr>
@@ -12263,7 +12263,7 @@
           <p:cNvPr id="21" name="CuadroTexto 20">
             <a:extLst>
               <a:ext uri="{FF2B5EF4-FFF2-40B4-BE49-F238E27FC236}">
-                <a16:creationId xmlns:a16="http://schemas.microsoft.com/office/drawing/2014/main" id="{AF0D5959-5B01-4D0B-3964-25ADBEB33461}"/>
+                <a16:creationId xmlns:a16="http://schemas.microsoft.com/office/drawing/2014/main" id="{81735565-1B92-5540-5026-4E57A8C43268}"/>
               </a:ext>
             </a:extLst>
           </p:cNvPr>
@@ -12303,7 +12303,7 @@
           <p:cNvPr id="22" name="CuadroTexto 21">
             <a:extLst>
               <a:ext uri="{FF2B5EF4-FFF2-40B4-BE49-F238E27FC236}">
-                <a16:creationId xmlns:a16="http://schemas.microsoft.com/office/drawing/2014/main" id="{CA8B7B50-67E3-B823-CBBD-B7BDA19192B7}"/>
+                <a16:creationId xmlns:a16="http://schemas.microsoft.com/office/drawing/2014/main" id="{772E63E3-B570-3617-DDA5-F26E392E9721}"/>
               </a:ext>
             </a:extLst>
           </p:cNvPr>
@@ -12341,7 +12341,7 @@
     </p:spTree>
     <p:extLst>
       <p:ext uri="{BB962C8B-B14F-4D97-AF65-F5344CB8AC3E}">
-        <p14:creationId xmlns:p14="http://schemas.microsoft.com/office/powerpoint/2010/main" val="922881415"/>
+        <p14:creationId xmlns:p14="http://schemas.microsoft.com/office/powerpoint/2010/main" val="1093037199"/>
       </p:ext>
     </p:extLst>
   </p:cSld>

</xml_diff>

<commit_message>
Finalize validation and defense materials
</commit_message>
<xml_diff>
--- a/docs/presentacion-defensa-final.pptx
+++ b/docs/presentacion-defensa-final.pptx
@@ -146,7 +146,7 @@
           <p:cNvPr id="2" name="Título 1">
             <a:extLst>
               <a:ext uri="{FF2B5EF4-FFF2-40B4-BE49-F238E27FC236}">
-                <a16:creationId xmlns:a16="http://schemas.microsoft.com/office/drawing/2014/main" id="{8A6B0814-BF45-E573-A6DD-089C6E430088}"/>
+                <a16:creationId xmlns:a16="http://schemas.microsoft.com/office/drawing/2014/main" id="{42059031-D005-033F-527C-2532EAFDFE18}"/>
               </a:ext>
             </a:extLst>
           </p:cNvPr>
@@ -183,7 +183,7 @@
           <p:cNvPr id="3" name="Subtítulo 2">
             <a:extLst>
               <a:ext uri="{FF2B5EF4-FFF2-40B4-BE49-F238E27FC236}">
-                <a16:creationId xmlns:a16="http://schemas.microsoft.com/office/drawing/2014/main" id="{59A3F60D-381D-A44B-0A93-8C52096248EC}"/>
+                <a16:creationId xmlns:a16="http://schemas.microsoft.com/office/drawing/2014/main" id="{7151C16C-7DD0-8D00-A6C2-83E337E6DC55}"/>
               </a:ext>
             </a:extLst>
           </p:cNvPr>
@@ -253,7 +253,7 @@
           <p:cNvPr id="4" name="Marcador de fecha 3">
             <a:extLst>
               <a:ext uri="{FF2B5EF4-FFF2-40B4-BE49-F238E27FC236}">
-                <a16:creationId xmlns:a16="http://schemas.microsoft.com/office/drawing/2014/main" id="{89A48920-AADB-D026-B9B2-9DA509FB0A60}"/>
+                <a16:creationId xmlns:a16="http://schemas.microsoft.com/office/drawing/2014/main" id="{FE6FB086-1FAA-53BE-9924-178890CA8D97}"/>
               </a:ext>
             </a:extLst>
           </p:cNvPr>
@@ -269,9 +269,9 @@
           <a:bodyPr/>
           <a:lstStyle/>
           <a:p>
-            <a:fld id="{5EA62A27-1D85-48AD-90C3-37B244257CF0}" type="datetimeFigureOut">
+            <a:fld id="{9835FBA3-5475-4EC2-B841-90BC3B1D7D90}" type="datetimeFigureOut">
               <a:rPr lang="es-ES" smtClean="0"/>
-              <a:t>19/05/2026</a:t>
+              <a:t>22/05/2026</a:t>
             </a:fld>
             <a:endParaRPr lang="es-ES"/>
           </a:p>
@@ -282,7 +282,7 @@
           <p:cNvPr id="5" name="Marcador de pie de página 4">
             <a:extLst>
               <a:ext uri="{FF2B5EF4-FFF2-40B4-BE49-F238E27FC236}">
-                <a16:creationId xmlns:a16="http://schemas.microsoft.com/office/drawing/2014/main" id="{58A59491-3B6A-48C9-5EEB-7EB818871F5B}"/>
+                <a16:creationId xmlns:a16="http://schemas.microsoft.com/office/drawing/2014/main" id="{883E1A23-60DF-8CF4-4D5A-FE5F192807DC}"/>
               </a:ext>
             </a:extLst>
           </p:cNvPr>
@@ -307,7 +307,7 @@
           <p:cNvPr id="6" name="Marcador de número de diapositiva 5">
             <a:extLst>
               <a:ext uri="{FF2B5EF4-FFF2-40B4-BE49-F238E27FC236}">
-                <a16:creationId xmlns:a16="http://schemas.microsoft.com/office/drawing/2014/main" id="{DD81804F-C69B-B021-BB20-0F4660F398D0}"/>
+                <a16:creationId xmlns:a16="http://schemas.microsoft.com/office/drawing/2014/main" id="{5FC06098-BE92-3166-B3FF-BB3D6B629F1B}"/>
               </a:ext>
             </a:extLst>
           </p:cNvPr>
@@ -323,7 +323,7 @@
           <a:bodyPr/>
           <a:lstStyle/>
           <a:p>
-            <a:fld id="{357192D4-5BD9-41C8-9EE5-942CB5B156C9}" type="slidenum">
+            <a:fld id="{96B8D56F-A2A2-43A0-8CA7-B1F0D0BAB8F0}" type="slidenum">
               <a:rPr lang="es-ES" smtClean="0"/>
               <a:t>‹Nº›</a:t>
             </a:fld>
@@ -334,7 +334,7 @@
     </p:spTree>
     <p:extLst>
       <p:ext uri="{BB962C8B-B14F-4D97-AF65-F5344CB8AC3E}">
-        <p14:creationId xmlns:p14="http://schemas.microsoft.com/office/powerpoint/2010/main" val="1680099888"/>
+        <p14:creationId xmlns:p14="http://schemas.microsoft.com/office/powerpoint/2010/main" val="1496105625"/>
       </p:ext>
     </p:extLst>
   </p:cSld>
@@ -366,7 +366,7 @@
           <p:cNvPr id="2" name="Título 1">
             <a:extLst>
               <a:ext uri="{FF2B5EF4-FFF2-40B4-BE49-F238E27FC236}">
-                <a16:creationId xmlns:a16="http://schemas.microsoft.com/office/drawing/2014/main" id="{FDABD5DC-78B2-1D43-6817-084E7D311BE4}"/>
+                <a16:creationId xmlns:a16="http://schemas.microsoft.com/office/drawing/2014/main" id="{BD306D51-8173-C58C-B3E7-ABF0DFCA1D23}"/>
               </a:ext>
             </a:extLst>
           </p:cNvPr>
@@ -394,7 +394,7 @@
           <p:cNvPr id="3" name="Marcador de texto vertical 2">
             <a:extLst>
               <a:ext uri="{FF2B5EF4-FFF2-40B4-BE49-F238E27FC236}">
-                <a16:creationId xmlns:a16="http://schemas.microsoft.com/office/drawing/2014/main" id="{683029C5-5484-68D1-9988-6F026988B4D3}"/>
+                <a16:creationId xmlns:a16="http://schemas.microsoft.com/office/drawing/2014/main" id="{62D32270-BCDC-E7C3-8E2C-768709CDED75}"/>
               </a:ext>
             </a:extLst>
           </p:cNvPr>
@@ -451,7 +451,7 @@
           <p:cNvPr id="4" name="Marcador de fecha 3">
             <a:extLst>
               <a:ext uri="{FF2B5EF4-FFF2-40B4-BE49-F238E27FC236}">
-                <a16:creationId xmlns:a16="http://schemas.microsoft.com/office/drawing/2014/main" id="{D40ACC64-DF2E-FB98-BEE2-33C18881B76B}"/>
+                <a16:creationId xmlns:a16="http://schemas.microsoft.com/office/drawing/2014/main" id="{6E3FA4E6-A1B5-50BD-5294-F37E568BE673}"/>
               </a:ext>
             </a:extLst>
           </p:cNvPr>
@@ -467,9 +467,9 @@
           <a:bodyPr/>
           <a:lstStyle/>
           <a:p>
-            <a:fld id="{5EA62A27-1D85-48AD-90C3-37B244257CF0}" type="datetimeFigureOut">
+            <a:fld id="{9835FBA3-5475-4EC2-B841-90BC3B1D7D90}" type="datetimeFigureOut">
               <a:rPr lang="es-ES" smtClean="0"/>
-              <a:t>19/05/2026</a:t>
+              <a:t>22/05/2026</a:t>
             </a:fld>
             <a:endParaRPr lang="es-ES"/>
           </a:p>
@@ -480,7 +480,7 @@
           <p:cNvPr id="5" name="Marcador de pie de página 4">
             <a:extLst>
               <a:ext uri="{FF2B5EF4-FFF2-40B4-BE49-F238E27FC236}">
-                <a16:creationId xmlns:a16="http://schemas.microsoft.com/office/drawing/2014/main" id="{00E13036-6346-F20B-D4DD-22038DD9C5DB}"/>
+                <a16:creationId xmlns:a16="http://schemas.microsoft.com/office/drawing/2014/main" id="{768C7386-B9E3-2184-B862-9C5190870FFC}"/>
               </a:ext>
             </a:extLst>
           </p:cNvPr>
@@ -505,7 +505,7 @@
           <p:cNvPr id="6" name="Marcador de número de diapositiva 5">
             <a:extLst>
               <a:ext uri="{FF2B5EF4-FFF2-40B4-BE49-F238E27FC236}">
-                <a16:creationId xmlns:a16="http://schemas.microsoft.com/office/drawing/2014/main" id="{7B602EB5-B081-CE0E-966B-C70200BEEF97}"/>
+                <a16:creationId xmlns:a16="http://schemas.microsoft.com/office/drawing/2014/main" id="{D8DFF596-B1AB-1310-787F-3A0960306EA0}"/>
               </a:ext>
             </a:extLst>
           </p:cNvPr>
@@ -521,7 +521,7 @@
           <a:bodyPr/>
           <a:lstStyle/>
           <a:p>
-            <a:fld id="{357192D4-5BD9-41C8-9EE5-942CB5B156C9}" type="slidenum">
+            <a:fld id="{96B8D56F-A2A2-43A0-8CA7-B1F0D0BAB8F0}" type="slidenum">
               <a:rPr lang="es-ES" smtClean="0"/>
               <a:t>‹Nº›</a:t>
             </a:fld>
@@ -532,7 +532,7 @@
     </p:spTree>
     <p:extLst>
       <p:ext uri="{BB962C8B-B14F-4D97-AF65-F5344CB8AC3E}">
-        <p14:creationId xmlns:p14="http://schemas.microsoft.com/office/powerpoint/2010/main" val="2447015768"/>
+        <p14:creationId xmlns:p14="http://schemas.microsoft.com/office/powerpoint/2010/main" val="3173428753"/>
       </p:ext>
     </p:extLst>
   </p:cSld>
@@ -564,7 +564,7 @@
           <p:cNvPr id="2" name="Título vertical 1">
             <a:extLst>
               <a:ext uri="{FF2B5EF4-FFF2-40B4-BE49-F238E27FC236}">
-                <a16:creationId xmlns:a16="http://schemas.microsoft.com/office/drawing/2014/main" id="{D4A42644-ABFA-58B7-9710-0C222F7690F7}"/>
+                <a16:creationId xmlns:a16="http://schemas.microsoft.com/office/drawing/2014/main" id="{668F0699-4FB4-04B4-D93F-03A917E8398C}"/>
               </a:ext>
             </a:extLst>
           </p:cNvPr>
@@ -597,7 +597,7 @@
           <p:cNvPr id="3" name="Marcador de texto vertical 2">
             <a:extLst>
               <a:ext uri="{FF2B5EF4-FFF2-40B4-BE49-F238E27FC236}">
-                <a16:creationId xmlns:a16="http://schemas.microsoft.com/office/drawing/2014/main" id="{602D70CA-E9E5-7B05-1516-9406222EE311}"/>
+                <a16:creationId xmlns:a16="http://schemas.microsoft.com/office/drawing/2014/main" id="{6D784313-848C-71FB-5349-2423CBF41DCB}"/>
               </a:ext>
             </a:extLst>
           </p:cNvPr>
@@ -659,7 +659,7 @@
           <p:cNvPr id="4" name="Marcador de fecha 3">
             <a:extLst>
               <a:ext uri="{FF2B5EF4-FFF2-40B4-BE49-F238E27FC236}">
-                <a16:creationId xmlns:a16="http://schemas.microsoft.com/office/drawing/2014/main" id="{9232D4B7-CBA2-CC7D-E399-72CB728BBE05}"/>
+                <a16:creationId xmlns:a16="http://schemas.microsoft.com/office/drawing/2014/main" id="{BC8121BE-A98A-F3AA-B5AA-600E444987A5}"/>
               </a:ext>
             </a:extLst>
           </p:cNvPr>
@@ -675,9 +675,9 @@
           <a:bodyPr/>
           <a:lstStyle/>
           <a:p>
-            <a:fld id="{5EA62A27-1D85-48AD-90C3-37B244257CF0}" type="datetimeFigureOut">
+            <a:fld id="{9835FBA3-5475-4EC2-B841-90BC3B1D7D90}" type="datetimeFigureOut">
               <a:rPr lang="es-ES" smtClean="0"/>
-              <a:t>19/05/2026</a:t>
+              <a:t>22/05/2026</a:t>
             </a:fld>
             <a:endParaRPr lang="es-ES"/>
           </a:p>
@@ -688,7 +688,7 @@
           <p:cNvPr id="5" name="Marcador de pie de página 4">
             <a:extLst>
               <a:ext uri="{FF2B5EF4-FFF2-40B4-BE49-F238E27FC236}">
-                <a16:creationId xmlns:a16="http://schemas.microsoft.com/office/drawing/2014/main" id="{323BAB20-BD10-B4FA-2237-2D47800633F3}"/>
+                <a16:creationId xmlns:a16="http://schemas.microsoft.com/office/drawing/2014/main" id="{FB3D6D49-535B-3B15-0DAC-F06C08FECDC4}"/>
               </a:ext>
             </a:extLst>
           </p:cNvPr>
@@ -713,7 +713,7 @@
           <p:cNvPr id="6" name="Marcador de número de diapositiva 5">
             <a:extLst>
               <a:ext uri="{FF2B5EF4-FFF2-40B4-BE49-F238E27FC236}">
-                <a16:creationId xmlns:a16="http://schemas.microsoft.com/office/drawing/2014/main" id="{F3F63C59-FBCF-9096-30B2-872FBE51DFA4}"/>
+                <a16:creationId xmlns:a16="http://schemas.microsoft.com/office/drawing/2014/main" id="{FE43E37E-E97A-9F12-B131-28CC09EB01A9}"/>
               </a:ext>
             </a:extLst>
           </p:cNvPr>
@@ -729,7 +729,7 @@
           <a:bodyPr/>
           <a:lstStyle/>
           <a:p>
-            <a:fld id="{357192D4-5BD9-41C8-9EE5-942CB5B156C9}" type="slidenum">
+            <a:fld id="{96B8D56F-A2A2-43A0-8CA7-B1F0D0BAB8F0}" type="slidenum">
               <a:rPr lang="es-ES" smtClean="0"/>
               <a:t>‹Nº›</a:t>
             </a:fld>
@@ -740,7 +740,7 @@
     </p:spTree>
     <p:extLst>
       <p:ext uri="{BB962C8B-B14F-4D97-AF65-F5344CB8AC3E}">
-        <p14:creationId xmlns:p14="http://schemas.microsoft.com/office/powerpoint/2010/main" val="406580436"/>
+        <p14:creationId xmlns:p14="http://schemas.microsoft.com/office/powerpoint/2010/main" val="764455321"/>
       </p:ext>
     </p:extLst>
   </p:cSld>
@@ -772,7 +772,7 @@
           <p:cNvPr id="2" name="Título 1">
             <a:extLst>
               <a:ext uri="{FF2B5EF4-FFF2-40B4-BE49-F238E27FC236}">
-                <a16:creationId xmlns:a16="http://schemas.microsoft.com/office/drawing/2014/main" id="{9EA4115C-5D06-4D7C-B8EC-F9D77664F195}"/>
+                <a16:creationId xmlns:a16="http://schemas.microsoft.com/office/drawing/2014/main" id="{52D8F515-57CD-7DBC-3D4C-239575297B07}"/>
               </a:ext>
             </a:extLst>
           </p:cNvPr>
@@ -800,7 +800,7 @@
           <p:cNvPr id="3" name="Marcador de contenido 2">
             <a:extLst>
               <a:ext uri="{FF2B5EF4-FFF2-40B4-BE49-F238E27FC236}">
-                <a16:creationId xmlns:a16="http://schemas.microsoft.com/office/drawing/2014/main" id="{C78EC942-61D9-112C-287C-90292BD32500}"/>
+                <a16:creationId xmlns:a16="http://schemas.microsoft.com/office/drawing/2014/main" id="{8350FE39-63BD-D9B8-1666-A34EA3767007}"/>
               </a:ext>
             </a:extLst>
           </p:cNvPr>
@@ -857,7 +857,7 @@
           <p:cNvPr id="4" name="Marcador de fecha 3">
             <a:extLst>
               <a:ext uri="{FF2B5EF4-FFF2-40B4-BE49-F238E27FC236}">
-                <a16:creationId xmlns:a16="http://schemas.microsoft.com/office/drawing/2014/main" id="{25ED1F93-2489-6D68-93DB-F2D5E5952375}"/>
+                <a16:creationId xmlns:a16="http://schemas.microsoft.com/office/drawing/2014/main" id="{7AEE7F05-89E6-9588-62F7-49D45E1C6BD7}"/>
               </a:ext>
             </a:extLst>
           </p:cNvPr>
@@ -873,9 +873,9 @@
           <a:bodyPr/>
           <a:lstStyle/>
           <a:p>
-            <a:fld id="{5EA62A27-1D85-48AD-90C3-37B244257CF0}" type="datetimeFigureOut">
+            <a:fld id="{9835FBA3-5475-4EC2-B841-90BC3B1D7D90}" type="datetimeFigureOut">
               <a:rPr lang="es-ES" smtClean="0"/>
-              <a:t>19/05/2026</a:t>
+              <a:t>22/05/2026</a:t>
             </a:fld>
             <a:endParaRPr lang="es-ES"/>
           </a:p>
@@ -886,7 +886,7 @@
           <p:cNvPr id="5" name="Marcador de pie de página 4">
             <a:extLst>
               <a:ext uri="{FF2B5EF4-FFF2-40B4-BE49-F238E27FC236}">
-                <a16:creationId xmlns:a16="http://schemas.microsoft.com/office/drawing/2014/main" id="{17CE7D42-E5A1-356C-3F58-B627C49AA99F}"/>
+                <a16:creationId xmlns:a16="http://schemas.microsoft.com/office/drawing/2014/main" id="{CD0D6C44-66D1-D0F3-A664-59E365E86072}"/>
               </a:ext>
             </a:extLst>
           </p:cNvPr>
@@ -911,7 +911,7 @@
           <p:cNvPr id="6" name="Marcador de número de diapositiva 5">
             <a:extLst>
               <a:ext uri="{FF2B5EF4-FFF2-40B4-BE49-F238E27FC236}">
-                <a16:creationId xmlns:a16="http://schemas.microsoft.com/office/drawing/2014/main" id="{0FEFE665-0B92-8F3C-FF33-3B8D22EB1153}"/>
+                <a16:creationId xmlns:a16="http://schemas.microsoft.com/office/drawing/2014/main" id="{D6562176-8E15-94A2-29E4-2DA37DAD83BC}"/>
               </a:ext>
             </a:extLst>
           </p:cNvPr>
@@ -927,7 +927,7 @@
           <a:bodyPr/>
           <a:lstStyle/>
           <a:p>
-            <a:fld id="{357192D4-5BD9-41C8-9EE5-942CB5B156C9}" type="slidenum">
+            <a:fld id="{96B8D56F-A2A2-43A0-8CA7-B1F0D0BAB8F0}" type="slidenum">
               <a:rPr lang="es-ES" smtClean="0"/>
               <a:t>‹Nº›</a:t>
             </a:fld>
@@ -938,7 +938,7 @@
     </p:spTree>
     <p:extLst>
       <p:ext uri="{BB962C8B-B14F-4D97-AF65-F5344CB8AC3E}">
-        <p14:creationId xmlns:p14="http://schemas.microsoft.com/office/powerpoint/2010/main" val="1104774924"/>
+        <p14:creationId xmlns:p14="http://schemas.microsoft.com/office/powerpoint/2010/main" val="87129758"/>
       </p:ext>
     </p:extLst>
   </p:cSld>
@@ -970,7 +970,7 @@
           <p:cNvPr id="2" name="Título 1">
             <a:extLst>
               <a:ext uri="{FF2B5EF4-FFF2-40B4-BE49-F238E27FC236}">
-                <a16:creationId xmlns:a16="http://schemas.microsoft.com/office/drawing/2014/main" id="{028D4A99-9A29-200B-6DD7-FACD52DCDD13}"/>
+                <a16:creationId xmlns:a16="http://schemas.microsoft.com/office/drawing/2014/main" id="{89CAF63F-9D1A-D067-ADA4-3D4FD9ABC134}"/>
               </a:ext>
             </a:extLst>
           </p:cNvPr>
@@ -1007,7 +1007,7 @@
           <p:cNvPr id="3" name="Marcador de texto 2">
             <a:extLst>
               <a:ext uri="{FF2B5EF4-FFF2-40B4-BE49-F238E27FC236}">
-                <a16:creationId xmlns:a16="http://schemas.microsoft.com/office/drawing/2014/main" id="{993EBD5B-4058-DD2F-D0AB-1FD2A62C2E46}"/>
+                <a16:creationId xmlns:a16="http://schemas.microsoft.com/office/drawing/2014/main" id="{8C293125-11DB-977A-26FC-657AEE91324B}"/>
               </a:ext>
             </a:extLst>
           </p:cNvPr>
@@ -1032,7 +1032,7 @@
               <a:defRPr sz="2400">
                 <a:solidFill>
                   <a:schemeClr val="tx1">
-                    <a:tint val="82000"/>
+                    <a:tint val="75000"/>
                   </a:schemeClr>
                 </a:solidFill>
               </a:defRPr>
@@ -1042,7 +1042,7 @@
               <a:defRPr sz="2000">
                 <a:solidFill>
                   <a:schemeClr val="tx1">
-                    <a:tint val="82000"/>
+                    <a:tint val="75000"/>
                   </a:schemeClr>
                 </a:solidFill>
               </a:defRPr>
@@ -1052,7 +1052,7 @@
               <a:defRPr sz="1800">
                 <a:solidFill>
                   <a:schemeClr val="tx1">
-                    <a:tint val="82000"/>
+                    <a:tint val="75000"/>
                   </a:schemeClr>
                 </a:solidFill>
               </a:defRPr>
@@ -1062,7 +1062,7 @@
               <a:defRPr sz="1600">
                 <a:solidFill>
                   <a:schemeClr val="tx1">
-                    <a:tint val="82000"/>
+                    <a:tint val="75000"/>
                   </a:schemeClr>
                 </a:solidFill>
               </a:defRPr>
@@ -1072,7 +1072,7 @@
               <a:defRPr sz="1600">
                 <a:solidFill>
                   <a:schemeClr val="tx1">
-                    <a:tint val="82000"/>
+                    <a:tint val="75000"/>
                   </a:schemeClr>
                 </a:solidFill>
               </a:defRPr>
@@ -1082,7 +1082,7 @@
               <a:defRPr sz="1600">
                 <a:solidFill>
                   <a:schemeClr val="tx1">
-                    <a:tint val="82000"/>
+                    <a:tint val="75000"/>
                   </a:schemeClr>
                 </a:solidFill>
               </a:defRPr>
@@ -1092,7 +1092,7 @@
               <a:defRPr sz="1600">
                 <a:solidFill>
                   <a:schemeClr val="tx1">
-                    <a:tint val="82000"/>
+                    <a:tint val="75000"/>
                   </a:schemeClr>
                 </a:solidFill>
               </a:defRPr>
@@ -1102,7 +1102,7 @@
               <a:defRPr sz="1600">
                 <a:solidFill>
                   <a:schemeClr val="tx1">
-                    <a:tint val="82000"/>
+                    <a:tint val="75000"/>
                   </a:schemeClr>
                 </a:solidFill>
               </a:defRPr>
@@ -1112,7 +1112,7 @@
               <a:defRPr sz="1600">
                 <a:solidFill>
                   <a:schemeClr val="tx1">
-                    <a:tint val="82000"/>
+                    <a:tint val="75000"/>
                   </a:schemeClr>
                 </a:solidFill>
               </a:defRPr>
@@ -1132,7 +1132,7 @@
           <p:cNvPr id="4" name="Marcador de fecha 3">
             <a:extLst>
               <a:ext uri="{FF2B5EF4-FFF2-40B4-BE49-F238E27FC236}">
-                <a16:creationId xmlns:a16="http://schemas.microsoft.com/office/drawing/2014/main" id="{6C9DC1F3-D5E5-CCDC-9020-669CCE68476D}"/>
+                <a16:creationId xmlns:a16="http://schemas.microsoft.com/office/drawing/2014/main" id="{FE6765E1-76E4-3BD3-54A5-6945A371A7C2}"/>
               </a:ext>
             </a:extLst>
           </p:cNvPr>
@@ -1148,9 +1148,9 @@
           <a:bodyPr/>
           <a:lstStyle/>
           <a:p>
-            <a:fld id="{5EA62A27-1D85-48AD-90C3-37B244257CF0}" type="datetimeFigureOut">
+            <a:fld id="{9835FBA3-5475-4EC2-B841-90BC3B1D7D90}" type="datetimeFigureOut">
               <a:rPr lang="es-ES" smtClean="0"/>
-              <a:t>19/05/2026</a:t>
+              <a:t>22/05/2026</a:t>
             </a:fld>
             <a:endParaRPr lang="es-ES"/>
           </a:p>
@@ -1161,7 +1161,7 @@
           <p:cNvPr id="5" name="Marcador de pie de página 4">
             <a:extLst>
               <a:ext uri="{FF2B5EF4-FFF2-40B4-BE49-F238E27FC236}">
-                <a16:creationId xmlns:a16="http://schemas.microsoft.com/office/drawing/2014/main" id="{EB357624-B5DB-F2A1-7FA2-7C221A5F314B}"/>
+                <a16:creationId xmlns:a16="http://schemas.microsoft.com/office/drawing/2014/main" id="{41CD489E-74B7-9355-AED2-98A117A8FA8C}"/>
               </a:ext>
             </a:extLst>
           </p:cNvPr>
@@ -1186,7 +1186,7 @@
           <p:cNvPr id="6" name="Marcador de número de diapositiva 5">
             <a:extLst>
               <a:ext uri="{FF2B5EF4-FFF2-40B4-BE49-F238E27FC236}">
-                <a16:creationId xmlns:a16="http://schemas.microsoft.com/office/drawing/2014/main" id="{750C7AE2-5B81-9A50-05AC-1B614CC70971}"/>
+                <a16:creationId xmlns:a16="http://schemas.microsoft.com/office/drawing/2014/main" id="{C579FC5E-83F4-9070-F1AD-CABEC30003C5}"/>
               </a:ext>
             </a:extLst>
           </p:cNvPr>
@@ -1202,7 +1202,7 @@
           <a:bodyPr/>
           <a:lstStyle/>
           <a:p>
-            <a:fld id="{357192D4-5BD9-41C8-9EE5-942CB5B156C9}" type="slidenum">
+            <a:fld id="{96B8D56F-A2A2-43A0-8CA7-B1F0D0BAB8F0}" type="slidenum">
               <a:rPr lang="es-ES" smtClean="0"/>
               <a:t>‹Nº›</a:t>
             </a:fld>
@@ -1213,7 +1213,7 @@
     </p:spTree>
     <p:extLst>
       <p:ext uri="{BB962C8B-B14F-4D97-AF65-F5344CB8AC3E}">
-        <p14:creationId xmlns:p14="http://schemas.microsoft.com/office/powerpoint/2010/main" val="4052687921"/>
+        <p14:creationId xmlns:p14="http://schemas.microsoft.com/office/powerpoint/2010/main" val="3470828759"/>
       </p:ext>
     </p:extLst>
   </p:cSld>
@@ -1245,7 +1245,7 @@
           <p:cNvPr id="2" name="Título 1">
             <a:extLst>
               <a:ext uri="{FF2B5EF4-FFF2-40B4-BE49-F238E27FC236}">
-                <a16:creationId xmlns:a16="http://schemas.microsoft.com/office/drawing/2014/main" id="{1A68C001-776F-00A0-A9A3-C5FC6137A0A3}"/>
+                <a16:creationId xmlns:a16="http://schemas.microsoft.com/office/drawing/2014/main" id="{0723E889-42FE-AAE2-FD9B-D46615EC2921}"/>
               </a:ext>
             </a:extLst>
           </p:cNvPr>
@@ -1273,7 +1273,7 @@
           <p:cNvPr id="3" name="Marcador de contenido 2">
             <a:extLst>
               <a:ext uri="{FF2B5EF4-FFF2-40B4-BE49-F238E27FC236}">
-                <a16:creationId xmlns:a16="http://schemas.microsoft.com/office/drawing/2014/main" id="{00E2DC49-A2BE-ECC8-0798-6178D2DC12B9}"/>
+                <a16:creationId xmlns:a16="http://schemas.microsoft.com/office/drawing/2014/main" id="{29DC9890-8552-BC1F-A811-E8447EBA79B1}"/>
               </a:ext>
             </a:extLst>
           </p:cNvPr>
@@ -1335,7 +1335,7 @@
           <p:cNvPr id="4" name="Marcador de contenido 3">
             <a:extLst>
               <a:ext uri="{FF2B5EF4-FFF2-40B4-BE49-F238E27FC236}">
-                <a16:creationId xmlns:a16="http://schemas.microsoft.com/office/drawing/2014/main" id="{9659D0DA-D6BE-FBD5-4AAA-FDDE91CC4908}"/>
+                <a16:creationId xmlns:a16="http://schemas.microsoft.com/office/drawing/2014/main" id="{ADC1DE10-CBFE-A5B5-E50D-5F4A032A97A7}"/>
               </a:ext>
             </a:extLst>
           </p:cNvPr>
@@ -1397,7 +1397,7 @@
           <p:cNvPr id="5" name="Marcador de fecha 4">
             <a:extLst>
               <a:ext uri="{FF2B5EF4-FFF2-40B4-BE49-F238E27FC236}">
-                <a16:creationId xmlns:a16="http://schemas.microsoft.com/office/drawing/2014/main" id="{F2A06CC8-F91D-7586-85D6-F5C5668B2226}"/>
+                <a16:creationId xmlns:a16="http://schemas.microsoft.com/office/drawing/2014/main" id="{8572ABA5-0A0C-5646-43BD-F215AC9EBFCD}"/>
               </a:ext>
             </a:extLst>
           </p:cNvPr>
@@ -1413,9 +1413,9 @@
           <a:bodyPr/>
           <a:lstStyle/>
           <a:p>
-            <a:fld id="{5EA62A27-1D85-48AD-90C3-37B244257CF0}" type="datetimeFigureOut">
+            <a:fld id="{9835FBA3-5475-4EC2-B841-90BC3B1D7D90}" type="datetimeFigureOut">
               <a:rPr lang="es-ES" smtClean="0"/>
-              <a:t>19/05/2026</a:t>
+              <a:t>22/05/2026</a:t>
             </a:fld>
             <a:endParaRPr lang="es-ES"/>
           </a:p>
@@ -1426,7 +1426,7 @@
           <p:cNvPr id="6" name="Marcador de pie de página 5">
             <a:extLst>
               <a:ext uri="{FF2B5EF4-FFF2-40B4-BE49-F238E27FC236}">
-                <a16:creationId xmlns:a16="http://schemas.microsoft.com/office/drawing/2014/main" id="{0A1CA324-ED71-21AE-613B-F8A58D66EDC9}"/>
+                <a16:creationId xmlns:a16="http://schemas.microsoft.com/office/drawing/2014/main" id="{4902B53A-25F7-4386-F7F2-8D668F480001}"/>
               </a:ext>
             </a:extLst>
           </p:cNvPr>
@@ -1451,7 +1451,7 @@
           <p:cNvPr id="7" name="Marcador de número de diapositiva 6">
             <a:extLst>
               <a:ext uri="{FF2B5EF4-FFF2-40B4-BE49-F238E27FC236}">
-                <a16:creationId xmlns:a16="http://schemas.microsoft.com/office/drawing/2014/main" id="{826749BC-6AAC-7FA0-BBB3-6F22C2074C11}"/>
+                <a16:creationId xmlns:a16="http://schemas.microsoft.com/office/drawing/2014/main" id="{B7C05165-9A70-E739-43B0-ABCC852AF1D2}"/>
               </a:ext>
             </a:extLst>
           </p:cNvPr>
@@ -1467,7 +1467,7 @@
           <a:bodyPr/>
           <a:lstStyle/>
           <a:p>
-            <a:fld id="{357192D4-5BD9-41C8-9EE5-942CB5B156C9}" type="slidenum">
+            <a:fld id="{96B8D56F-A2A2-43A0-8CA7-B1F0D0BAB8F0}" type="slidenum">
               <a:rPr lang="es-ES" smtClean="0"/>
               <a:t>‹Nº›</a:t>
             </a:fld>
@@ -1478,7 +1478,7 @@
     </p:spTree>
     <p:extLst>
       <p:ext uri="{BB962C8B-B14F-4D97-AF65-F5344CB8AC3E}">
-        <p14:creationId xmlns:p14="http://schemas.microsoft.com/office/powerpoint/2010/main" val="3573210095"/>
+        <p14:creationId xmlns:p14="http://schemas.microsoft.com/office/powerpoint/2010/main" val="795092294"/>
       </p:ext>
     </p:extLst>
   </p:cSld>
@@ -1510,7 +1510,7 @@
           <p:cNvPr id="2" name="Título 1">
             <a:extLst>
               <a:ext uri="{FF2B5EF4-FFF2-40B4-BE49-F238E27FC236}">
-                <a16:creationId xmlns:a16="http://schemas.microsoft.com/office/drawing/2014/main" id="{A5E95328-B4B6-9ACB-B687-8EA3D3874DB6}"/>
+                <a16:creationId xmlns:a16="http://schemas.microsoft.com/office/drawing/2014/main" id="{C96C73B9-025C-53EA-AC30-0915BB284A60}"/>
               </a:ext>
             </a:extLst>
           </p:cNvPr>
@@ -1543,7 +1543,7 @@
           <p:cNvPr id="3" name="Marcador de texto 2">
             <a:extLst>
               <a:ext uri="{FF2B5EF4-FFF2-40B4-BE49-F238E27FC236}">
-                <a16:creationId xmlns:a16="http://schemas.microsoft.com/office/drawing/2014/main" id="{381CAD59-CAA5-D3D0-5485-F0368B6E46AE}"/>
+                <a16:creationId xmlns:a16="http://schemas.microsoft.com/office/drawing/2014/main" id="{B9948733-248B-D7B4-47BC-C180F0B0D8AC}"/>
               </a:ext>
             </a:extLst>
           </p:cNvPr>
@@ -1614,7 +1614,7 @@
           <p:cNvPr id="4" name="Marcador de contenido 3">
             <a:extLst>
               <a:ext uri="{FF2B5EF4-FFF2-40B4-BE49-F238E27FC236}">
-                <a16:creationId xmlns:a16="http://schemas.microsoft.com/office/drawing/2014/main" id="{82B8E0C2-AAE9-83BD-B746-56796B3B9C21}"/>
+                <a16:creationId xmlns:a16="http://schemas.microsoft.com/office/drawing/2014/main" id="{95CD6CCE-6DCF-F78A-40FF-40D0A74D8547}"/>
               </a:ext>
             </a:extLst>
           </p:cNvPr>
@@ -1676,7 +1676,7 @@
           <p:cNvPr id="5" name="Marcador de texto 4">
             <a:extLst>
               <a:ext uri="{FF2B5EF4-FFF2-40B4-BE49-F238E27FC236}">
-                <a16:creationId xmlns:a16="http://schemas.microsoft.com/office/drawing/2014/main" id="{E55150E5-F565-FA62-3459-87167636DD3F}"/>
+                <a16:creationId xmlns:a16="http://schemas.microsoft.com/office/drawing/2014/main" id="{07764DD9-26E9-2D25-FDE9-E9BF7098D8DE}"/>
               </a:ext>
             </a:extLst>
           </p:cNvPr>
@@ -1747,7 +1747,7 @@
           <p:cNvPr id="6" name="Marcador de contenido 5">
             <a:extLst>
               <a:ext uri="{FF2B5EF4-FFF2-40B4-BE49-F238E27FC236}">
-                <a16:creationId xmlns:a16="http://schemas.microsoft.com/office/drawing/2014/main" id="{947F2CB0-A358-148D-6C1F-7CF84C0B2AA6}"/>
+                <a16:creationId xmlns:a16="http://schemas.microsoft.com/office/drawing/2014/main" id="{C01CD537-2D04-6254-7654-5BE03193D978}"/>
               </a:ext>
             </a:extLst>
           </p:cNvPr>
@@ -1809,7 +1809,7 @@
           <p:cNvPr id="7" name="Marcador de fecha 6">
             <a:extLst>
               <a:ext uri="{FF2B5EF4-FFF2-40B4-BE49-F238E27FC236}">
-                <a16:creationId xmlns:a16="http://schemas.microsoft.com/office/drawing/2014/main" id="{8057AC04-7560-E3A7-A831-FB4DFF69F072}"/>
+                <a16:creationId xmlns:a16="http://schemas.microsoft.com/office/drawing/2014/main" id="{0CEDF0AE-0300-3394-5CD6-5226575D730B}"/>
               </a:ext>
             </a:extLst>
           </p:cNvPr>
@@ -1825,9 +1825,9 @@
           <a:bodyPr/>
           <a:lstStyle/>
           <a:p>
-            <a:fld id="{5EA62A27-1D85-48AD-90C3-37B244257CF0}" type="datetimeFigureOut">
+            <a:fld id="{9835FBA3-5475-4EC2-B841-90BC3B1D7D90}" type="datetimeFigureOut">
               <a:rPr lang="es-ES" smtClean="0"/>
-              <a:t>19/05/2026</a:t>
+              <a:t>22/05/2026</a:t>
             </a:fld>
             <a:endParaRPr lang="es-ES"/>
           </a:p>
@@ -1838,7 +1838,7 @@
           <p:cNvPr id="8" name="Marcador de pie de página 7">
             <a:extLst>
               <a:ext uri="{FF2B5EF4-FFF2-40B4-BE49-F238E27FC236}">
-                <a16:creationId xmlns:a16="http://schemas.microsoft.com/office/drawing/2014/main" id="{EA59DA2E-8572-9B68-793C-55E5FD9AB535}"/>
+                <a16:creationId xmlns:a16="http://schemas.microsoft.com/office/drawing/2014/main" id="{2BCB35A2-E749-9AFA-8214-08569E13580C}"/>
               </a:ext>
             </a:extLst>
           </p:cNvPr>
@@ -1863,7 +1863,7 @@
           <p:cNvPr id="9" name="Marcador de número de diapositiva 8">
             <a:extLst>
               <a:ext uri="{FF2B5EF4-FFF2-40B4-BE49-F238E27FC236}">
-                <a16:creationId xmlns:a16="http://schemas.microsoft.com/office/drawing/2014/main" id="{E85E1E7C-FB27-5478-B7CC-B2D9E4DC9CFC}"/>
+                <a16:creationId xmlns:a16="http://schemas.microsoft.com/office/drawing/2014/main" id="{2D836A66-1100-864F-4759-0AE448374357}"/>
               </a:ext>
             </a:extLst>
           </p:cNvPr>
@@ -1879,7 +1879,7 @@
           <a:bodyPr/>
           <a:lstStyle/>
           <a:p>
-            <a:fld id="{357192D4-5BD9-41C8-9EE5-942CB5B156C9}" type="slidenum">
+            <a:fld id="{96B8D56F-A2A2-43A0-8CA7-B1F0D0BAB8F0}" type="slidenum">
               <a:rPr lang="es-ES" smtClean="0"/>
               <a:t>‹Nº›</a:t>
             </a:fld>
@@ -1890,7 +1890,7 @@
     </p:spTree>
     <p:extLst>
       <p:ext uri="{BB962C8B-B14F-4D97-AF65-F5344CB8AC3E}">
-        <p14:creationId xmlns:p14="http://schemas.microsoft.com/office/powerpoint/2010/main" val="1082468512"/>
+        <p14:creationId xmlns:p14="http://schemas.microsoft.com/office/powerpoint/2010/main" val="1275045235"/>
       </p:ext>
     </p:extLst>
   </p:cSld>
@@ -1922,7 +1922,7 @@
           <p:cNvPr id="2" name="Título 1">
             <a:extLst>
               <a:ext uri="{FF2B5EF4-FFF2-40B4-BE49-F238E27FC236}">
-                <a16:creationId xmlns:a16="http://schemas.microsoft.com/office/drawing/2014/main" id="{1DCF473E-51F7-D4A4-404E-56FC61F961C2}"/>
+                <a16:creationId xmlns:a16="http://schemas.microsoft.com/office/drawing/2014/main" id="{27C4182B-C525-0ECF-9468-3CF5D2D79442}"/>
               </a:ext>
             </a:extLst>
           </p:cNvPr>
@@ -1950,7 +1950,7 @@
           <p:cNvPr id="3" name="Marcador de fecha 2">
             <a:extLst>
               <a:ext uri="{FF2B5EF4-FFF2-40B4-BE49-F238E27FC236}">
-                <a16:creationId xmlns:a16="http://schemas.microsoft.com/office/drawing/2014/main" id="{DC2BF4BF-32DA-9453-FCF1-4E82CF0476F8}"/>
+                <a16:creationId xmlns:a16="http://schemas.microsoft.com/office/drawing/2014/main" id="{ED6E5E95-C57A-8E5A-D875-6901DB0553D1}"/>
               </a:ext>
             </a:extLst>
           </p:cNvPr>
@@ -1966,9 +1966,9 @@
           <a:bodyPr/>
           <a:lstStyle/>
           <a:p>
-            <a:fld id="{5EA62A27-1D85-48AD-90C3-37B244257CF0}" type="datetimeFigureOut">
+            <a:fld id="{9835FBA3-5475-4EC2-B841-90BC3B1D7D90}" type="datetimeFigureOut">
               <a:rPr lang="es-ES" smtClean="0"/>
-              <a:t>19/05/2026</a:t>
+              <a:t>22/05/2026</a:t>
             </a:fld>
             <a:endParaRPr lang="es-ES"/>
           </a:p>
@@ -1979,7 +1979,7 @@
           <p:cNvPr id="4" name="Marcador de pie de página 3">
             <a:extLst>
               <a:ext uri="{FF2B5EF4-FFF2-40B4-BE49-F238E27FC236}">
-                <a16:creationId xmlns:a16="http://schemas.microsoft.com/office/drawing/2014/main" id="{13F41BD4-0A83-52D5-8B71-1E1B3DC8C9BD}"/>
+                <a16:creationId xmlns:a16="http://schemas.microsoft.com/office/drawing/2014/main" id="{3D2D9EAB-FC7D-A384-F3AD-52D6CABF777D}"/>
               </a:ext>
             </a:extLst>
           </p:cNvPr>
@@ -2004,7 +2004,7 @@
           <p:cNvPr id="5" name="Marcador de número de diapositiva 4">
             <a:extLst>
               <a:ext uri="{FF2B5EF4-FFF2-40B4-BE49-F238E27FC236}">
-                <a16:creationId xmlns:a16="http://schemas.microsoft.com/office/drawing/2014/main" id="{12BB15A4-C317-4292-367F-A35A34F7E9E0}"/>
+                <a16:creationId xmlns:a16="http://schemas.microsoft.com/office/drawing/2014/main" id="{0C4F2829-150F-B0E0-F6C7-73E414895259}"/>
               </a:ext>
             </a:extLst>
           </p:cNvPr>
@@ -2020,7 +2020,7 @@
           <a:bodyPr/>
           <a:lstStyle/>
           <a:p>
-            <a:fld id="{357192D4-5BD9-41C8-9EE5-942CB5B156C9}" type="slidenum">
+            <a:fld id="{96B8D56F-A2A2-43A0-8CA7-B1F0D0BAB8F0}" type="slidenum">
               <a:rPr lang="es-ES" smtClean="0"/>
               <a:t>‹Nº›</a:t>
             </a:fld>
@@ -2031,7 +2031,7 @@
     </p:spTree>
     <p:extLst>
       <p:ext uri="{BB962C8B-B14F-4D97-AF65-F5344CB8AC3E}">
-        <p14:creationId xmlns:p14="http://schemas.microsoft.com/office/powerpoint/2010/main" val="843809289"/>
+        <p14:creationId xmlns:p14="http://schemas.microsoft.com/office/powerpoint/2010/main" val="2710967507"/>
       </p:ext>
     </p:extLst>
   </p:cSld>
@@ -2063,7 +2063,7 @@
           <p:cNvPr id="2" name="Marcador de fecha 1">
             <a:extLst>
               <a:ext uri="{FF2B5EF4-FFF2-40B4-BE49-F238E27FC236}">
-                <a16:creationId xmlns:a16="http://schemas.microsoft.com/office/drawing/2014/main" id="{BB770DBA-80A6-D082-CE82-4104E8F6A619}"/>
+                <a16:creationId xmlns:a16="http://schemas.microsoft.com/office/drawing/2014/main" id="{2DD91837-7567-4939-7FEA-FC09C5EAA023}"/>
               </a:ext>
             </a:extLst>
           </p:cNvPr>
@@ -2079,9 +2079,9 @@
           <a:bodyPr/>
           <a:lstStyle/>
           <a:p>
-            <a:fld id="{5EA62A27-1D85-48AD-90C3-37B244257CF0}" type="datetimeFigureOut">
+            <a:fld id="{9835FBA3-5475-4EC2-B841-90BC3B1D7D90}" type="datetimeFigureOut">
               <a:rPr lang="es-ES" smtClean="0"/>
-              <a:t>19/05/2026</a:t>
+              <a:t>22/05/2026</a:t>
             </a:fld>
             <a:endParaRPr lang="es-ES"/>
           </a:p>
@@ -2092,7 +2092,7 @@
           <p:cNvPr id="3" name="Marcador de pie de página 2">
             <a:extLst>
               <a:ext uri="{FF2B5EF4-FFF2-40B4-BE49-F238E27FC236}">
-                <a16:creationId xmlns:a16="http://schemas.microsoft.com/office/drawing/2014/main" id="{ED8222E9-DDE3-B1D4-E6BA-2BBE6D5CAABC}"/>
+                <a16:creationId xmlns:a16="http://schemas.microsoft.com/office/drawing/2014/main" id="{FCFD4570-8133-CD03-C0EC-9A24EAE0F65B}"/>
               </a:ext>
             </a:extLst>
           </p:cNvPr>
@@ -2117,7 +2117,7 @@
           <p:cNvPr id="4" name="Marcador de número de diapositiva 3">
             <a:extLst>
               <a:ext uri="{FF2B5EF4-FFF2-40B4-BE49-F238E27FC236}">
-                <a16:creationId xmlns:a16="http://schemas.microsoft.com/office/drawing/2014/main" id="{5B05FE56-9D48-9873-839E-6DA6555E7DCD}"/>
+                <a16:creationId xmlns:a16="http://schemas.microsoft.com/office/drawing/2014/main" id="{8527FAC1-FAB6-6815-FB0D-D15FCC738F45}"/>
               </a:ext>
             </a:extLst>
           </p:cNvPr>
@@ -2133,7 +2133,7 @@
           <a:bodyPr/>
           <a:lstStyle/>
           <a:p>
-            <a:fld id="{357192D4-5BD9-41C8-9EE5-942CB5B156C9}" type="slidenum">
+            <a:fld id="{96B8D56F-A2A2-43A0-8CA7-B1F0D0BAB8F0}" type="slidenum">
               <a:rPr lang="es-ES" smtClean="0"/>
               <a:t>‹Nº›</a:t>
             </a:fld>
@@ -2144,7 +2144,7 @@
     </p:spTree>
     <p:extLst>
       <p:ext uri="{BB962C8B-B14F-4D97-AF65-F5344CB8AC3E}">
-        <p14:creationId xmlns:p14="http://schemas.microsoft.com/office/powerpoint/2010/main" val="2185951776"/>
+        <p14:creationId xmlns:p14="http://schemas.microsoft.com/office/powerpoint/2010/main" val="1816769203"/>
       </p:ext>
     </p:extLst>
   </p:cSld>
@@ -2176,7 +2176,7 @@
           <p:cNvPr id="2" name="Título 1">
             <a:extLst>
               <a:ext uri="{FF2B5EF4-FFF2-40B4-BE49-F238E27FC236}">
-                <a16:creationId xmlns:a16="http://schemas.microsoft.com/office/drawing/2014/main" id="{4BE62A58-AF8A-3FB8-EA0A-1ABF9C4B8B69}"/>
+                <a16:creationId xmlns:a16="http://schemas.microsoft.com/office/drawing/2014/main" id="{A44F0AE0-8905-F645-6E6E-FCD033F6F627}"/>
               </a:ext>
             </a:extLst>
           </p:cNvPr>
@@ -2213,7 +2213,7 @@
           <p:cNvPr id="3" name="Marcador de contenido 2">
             <a:extLst>
               <a:ext uri="{FF2B5EF4-FFF2-40B4-BE49-F238E27FC236}">
-                <a16:creationId xmlns:a16="http://schemas.microsoft.com/office/drawing/2014/main" id="{1A83C48F-EE56-D384-1B9C-B1E1C5E07EF4}"/>
+                <a16:creationId xmlns:a16="http://schemas.microsoft.com/office/drawing/2014/main" id="{57BFF8D5-C89A-F933-4530-5ADAB9F742A9}"/>
               </a:ext>
             </a:extLst>
           </p:cNvPr>
@@ -2303,7 +2303,7 @@
           <p:cNvPr id="4" name="Marcador de texto 3">
             <a:extLst>
               <a:ext uri="{FF2B5EF4-FFF2-40B4-BE49-F238E27FC236}">
-                <a16:creationId xmlns:a16="http://schemas.microsoft.com/office/drawing/2014/main" id="{062B874F-BC36-715D-D132-8FD325459989}"/>
+                <a16:creationId xmlns:a16="http://schemas.microsoft.com/office/drawing/2014/main" id="{4BCA8D70-883A-D5E4-2B4B-1810DB39E673}"/>
               </a:ext>
             </a:extLst>
           </p:cNvPr>
@@ -2374,7 +2374,7 @@
           <p:cNvPr id="5" name="Marcador de fecha 4">
             <a:extLst>
               <a:ext uri="{FF2B5EF4-FFF2-40B4-BE49-F238E27FC236}">
-                <a16:creationId xmlns:a16="http://schemas.microsoft.com/office/drawing/2014/main" id="{E80A516C-DDEA-C052-9308-F388DDF0178F}"/>
+                <a16:creationId xmlns:a16="http://schemas.microsoft.com/office/drawing/2014/main" id="{4B680A9D-2C64-1081-0D49-51EC41D594C2}"/>
               </a:ext>
             </a:extLst>
           </p:cNvPr>
@@ -2390,9 +2390,9 @@
           <a:bodyPr/>
           <a:lstStyle/>
           <a:p>
-            <a:fld id="{5EA62A27-1D85-48AD-90C3-37B244257CF0}" type="datetimeFigureOut">
+            <a:fld id="{9835FBA3-5475-4EC2-B841-90BC3B1D7D90}" type="datetimeFigureOut">
               <a:rPr lang="es-ES" smtClean="0"/>
-              <a:t>19/05/2026</a:t>
+              <a:t>22/05/2026</a:t>
             </a:fld>
             <a:endParaRPr lang="es-ES"/>
           </a:p>
@@ -2403,7 +2403,7 @@
           <p:cNvPr id="6" name="Marcador de pie de página 5">
             <a:extLst>
               <a:ext uri="{FF2B5EF4-FFF2-40B4-BE49-F238E27FC236}">
-                <a16:creationId xmlns:a16="http://schemas.microsoft.com/office/drawing/2014/main" id="{2957D22E-3E4E-3BA1-E165-39275168A942}"/>
+                <a16:creationId xmlns:a16="http://schemas.microsoft.com/office/drawing/2014/main" id="{F2B5EFD7-9DED-D583-9B50-BEA7D34D042A}"/>
               </a:ext>
             </a:extLst>
           </p:cNvPr>
@@ -2428,7 +2428,7 @@
           <p:cNvPr id="7" name="Marcador de número de diapositiva 6">
             <a:extLst>
               <a:ext uri="{FF2B5EF4-FFF2-40B4-BE49-F238E27FC236}">
-                <a16:creationId xmlns:a16="http://schemas.microsoft.com/office/drawing/2014/main" id="{E9CD3F2A-5D76-4B7C-3D0E-CC8CE2B8C370}"/>
+                <a16:creationId xmlns:a16="http://schemas.microsoft.com/office/drawing/2014/main" id="{637B4225-39A8-868E-FDB2-0A5EEF744E22}"/>
               </a:ext>
             </a:extLst>
           </p:cNvPr>
@@ -2444,7 +2444,7 @@
           <a:bodyPr/>
           <a:lstStyle/>
           <a:p>
-            <a:fld id="{357192D4-5BD9-41C8-9EE5-942CB5B156C9}" type="slidenum">
+            <a:fld id="{96B8D56F-A2A2-43A0-8CA7-B1F0D0BAB8F0}" type="slidenum">
               <a:rPr lang="es-ES" smtClean="0"/>
               <a:t>‹Nº›</a:t>
             </a:fld>
@@ -2455,7 +2455,7 @@
     </p:spTree>
     <p:extLst>
       <p:ext uri="{BB962C8B-B14F-4D97-AF65-F5344CB8AC3E}">
-        <p14:creationId xmlns:p14="http://schemas.microsoft.com/office/powerpoint/2010/main" val="2092824997"/>
+        <p14:creationId xmlns:p14="http://schemas.microsoft.com/office/powerpoint/2010/main" val="3365838627"/>
       </p:ext>
     </p:extLst>
   </p:cSld>
@@ -2487,7 +2487,7 @@
           <p:cNvPr id="2" name="Título 1">
             <a:extLst>
               <a:ext uri="{FF2B5EF4-FFF2-40B4-BE49-F238E27FC236}">
-                <a16:creationId xmlns:a16="http://schemas.microsoft.com/office/drawing/2014/main" id="{B4EA0205-E1B1-D315-A143-01A9D00CFD7A}"/>
+                <a16:creationId xmlns:a16="http://schemas.microsoft.com/office/drawing/2014/main" id="{5D364949-16BE-E78B-82D2-3C2315B3F1B5}"/>
               </a:ext>
             </a:extLst>
           </p:cNvPr>
@@ -2524,7 +2524,7 @@
           <p:cNvPr id="3" name="Marcador de posición de imagen 2">
             <a:extLst>
               <a:ext uri="{FF2B5EF4-FFF2-40B4-BE49-F238E27FC236}">
-                <a16:creationId xmlns:a16="http://schemas.microsoft.com/office/drawing/2014/main" id="{5BADC2F0-6160-7416-B388-A10C87991244}"/>
+                <a16:creationId xmlns:a16="http://schemas.microsoft.com/office/drawing/2014/main" id="{7B02907C-1396-B908-FAA2-098E7C14FB8C}"/>
               </a:ext>
             </a:extLst>
           </p:cNvPr>
@@ -2591,7 +2591,7 @@
           <p:cNvPr id="4" name="Marcador de texto 3">
             <a:extLst>
               <a:ext uri="{FF2B5EF4-FFF2-40B4-BE49-F238E27FC236}">
-                <a16:creationId xmlns:a16="http://schemas.microsoft.com/office/drawing/2014/main" id="{3FC8B46F-1A24-D909-BB46-D0EA7E06A1A4}"/>
+                <a16:creationId xmlns:a16="http://schemas.microsoft.com/office/drawing/2014/main" id="{202D4E07-4280-8163-7063-884D2EB9971D}"/>
               </a:ext>
             </a:extLst>
           </p:cNvPr>
@@ -2662,7 +2662,7 @@
           <p:cNvPr id="5" name="Marcador de fecha 4">
             <a:extLst>
               <a:ext uri="{FF2B5EF4-FFF2-40B4-BE49-F238E27FC236}">
-                <a16:creationId xmlns:a16="http://schemas.microsoft.com/office/drawing/2014/main" id="{0247D9DE-E2CE-52AC-CCDB-87BE83C4EAE6}"/>
+                <a16:creationId xmlns:a16="http://schemas.microsoft.com/office/drawing/2014/main" id="{33950C08-5F43-D53F-61D2-7B45976E8487}"/>
               </a:ext>
             </a:extLst>
           </p:cNvPr>
@@ -2678,9 +2678,9 @@
           <a:bodyPr/>
           <a:lstStyle/>
           <a:p>
-            <a:fld id="{5EA62A27-1D85-48AD-90C3-37B244257CF0}" type="datetimeFigureOut">
+            <a:fld id="{9835FBA3-5475-4EC2-B841-90BC3B1D7D90}" type="datetimeFigureOut">
               <a:rPr lang="es-ES" smtClean="0"/>
-              <a:t>19/05/2026</a:t>
+              <a:t>22/05/2026</a:t>
             </a:fld>
             <a:endParaRPr lang="es-ES"/>
           </a:p>
@@ -2691,7 +2691,7 @@
           <p:cNvPr id="6" name="Marcador de pie de página 5">
             <a:extLst>
               <a:ext uri="{FF2B5EF4-FFF2-40B4-BE49-F238E27FC236}">
-                <a16:creationId xmlns:a16="http://schemas.microsoft.com/office/drawing/2014/main" id="{10FEF411-C3D2-F204-D11D-12BEC439EB07}"/>
+                <a16:creationId xmlns:a16="http://schemas.microsoft.com/office/drawing/2014/main" id="{E05AC3F4-2958-63F6-B084-4216A2F411A0}"/>
               </a:ext>
             </a:extLst>
           </p:cNvPr>
@@ -2716,7 +2716,7 @@
           <p:cNvPr id="7" name="Marcador de número de diapositiva 6">
             <a:extLst>
               <a:ext uri="{FF2B5EF4-FFF2-40B4-BE49-F238E27FC236}">
-                <a16:creationId xmlns:a16="http://schemas.microsoft.com/office/drawing/2014/main" id="{504D838E-8580-34E0-3EB7-1118DCC31235}"/>
+                <a16:creationId xmlns:a16="http://schemas.microsoft.com/office/drawing/2014/main" id="{EF6B1B05-4540-9367-33A0-D11C94E2699D}"/>
               </a:ext>
             </a:extLst>
           </p:cNvPr>
@@ -2732,7 +2732,7 @@
           <a:bodyPr/>
           <a:lstStyle/>
           <a:p>
-            <a:fld id="{357192D4-5BD9-41C8-9EE5-942CB5B156C9}" type="slidenum">
+            <a:fld id="{96B8D56F-A2A2-43A0-8CA7-B1F0D0BAB8F0}" type="slidenum">
               <a:rPr lang="es-ES" smtClean="0"/>
               <a:t>‹Nº›</a:t>
             </a:fld>
@@ -2743,7 +2743,7 @@
     </p:spTree>
     <p:extLst>
       <p:ext uri="{BB962C8B-B14F-4D97-AF65-F5344CB8AC3E}">
-        <p14:creationId xmlns:p14="http://schemas.microsoft.com/office/powerpoint/2010/main" val="1370303788"/>
+        <p14:creationId xmlns:p14="http://schemas.microsoft.com/office/powerpoint/2010/main" val="4142256132"/>
       </p:ext>
     </p:extLst>
   </p:cSld>
@@ -2780,7 +2780,7 @@
           <p:cNvPr id="2" name="Marcador de título 1">
             <a:extLst>
               <a:ext uri="{FF2B5EF4-FFF2-40B4-BE49-F238E27FC236}">
-                <a16:creationId xmlns:a16="http://schemas.microsoft.com/office/drawing/2014/main" id="{72786C14-7D58-E4B6-34F2-327E67DD1DA7}"/>
+                <a16:creationId xmlns:a16="http://schemas.microsoft.com/office/drawing/2014/main" id="{35D39D35-3453-AC02-5303-ADD3F6B54AED}"/>
               </a:ext>
             </a:extLst>
           </p:cNvPr>
@@ -2818,7 +2818,7 @@
           <p:cNvPr id="3" name="Marcador de texto 2">
             <a:extLst>
               <a:ext uri="{FF2B5EF4-FFF2-40B4-BE49-F238E27FC236}">
-                <a16:creationId xmlns:a16="http://schemas.microsoft.com/office/drawing/2014/main" id="{97AEFCDE-9BDE-1271-E379-25AE01116B23}"/>
+                <a16:creationId xmlns:a16="http://schemas.microsoft.com/office/drawing/2014/main" id="{63420041-04F8-C26A-0991-3AD4B3DAFD54}"/>
               </a:ext>
             </a:extLst>
           </p:cNvPr>
@@ -2885,7 +2885,7 @@
           <p:cNvPr id="4" name="Marcador de fecha 3">
             <a:extLst>
               <a:ext uri="{FF2B5EF4-FFF2-40B4-BE49-F238E27FC236}">
-                <a16:creationId xmlns:a16="http://schemas.microsoft.com/office/drawing/2014/main" id="{2C386A11-5809-CF73-C86F-4A15E6AD7B55}"/>
+                <a16:creationId xmlns:a16="http://schemas.microsoft.com/office/drawing/2014/main" id="{04166FF0-A09C-78EE-3785-892DA5DB1317}"/>
               </a:ext>
             </a:extLst>
           </p:cNvPr>
@@ -2912,16 +2912,16 @@
               <a:defRPr sz="1200">
                 <a:solidFill>
                   <a:schemeClr val="tx1">
-                    <a:tint val="82000"/>
+                    <a:tint val="75000"/>
                   </a:schemeClr>
                 </a:solidFill>
               </a:defRPr>
             </a:lvl1pPr>
           </a:lstStyle>
           <a:p>
-            <a:fld id="{5EA62A27-1D85-48AD-90C3-37B244257CF0}" type="datetimeFigureOut">
+            <a:fld id="{9835FBA3-5475-4EC2-B841-90BC3B1D7D90}" type="datetimeFigureOut">
               <a:rPr lang="es-ES" smtClean="0"/>
-              <a:t>19/05/2026</a:t>
+              <a:t>22/05/2026</a:t>
             </a:fld>
             <a:endParaRPr lang="es-ES"/>
           </a:p>
@@ -2932,7 +2932,7 @@
           <p:cNvPr id="5" name="Marcador de pie de página 4">
             <a:extLst>
               <a:ext uri="{FF2B5EF4-FFF2-40B4-BE49-F238E27FC236}">
-                <a16:creationId xmlns:a16="http://schemas.microsoft.com/office/drawing/2014/main" id="{0FCD38D0-3C3E-52AC-389B-35B51C2CE478}"/>
+                <a16:creationId xmlns:a16="http://schemas.microsoft.com/office/drawing/2014/main" id="{95A76A51-3BB4-56F2-A015-086631DA7069}"/>
               </a:ext>
             </a:extLst>
           </p:cNvPr>
@@ -2959,7 +2959,7 @@
               <a:defRPr sz="1200">
                 <a:solidFill>
                   <a:schemeClr val="tx1">
-                    <a:tint val="82000"/>
+                    <a:tint val="75000"/>
                   </a:schemeClr>
                 </a:solidFill>
               </a:defRPr>
@@ -2975,7 +2975,7 @@
           <p:cNvPr id="6" name="Marcador de número de diapositiva 5">
             <a:extLst>
               <a:ext uri="{FF2B5EF4-FFF2-40B4-BE49-F238E27FC236}">
-                <a16:creationId xmlns:a16="http://schemas.microsoft.com/office/drawing/2014/main" id="{E52B3E20-F6CA-0C98-43CD-121A885307B9}"/>
+                <a16:creationId xmlns:a16="http://schemas.microsoft.com/office/drawing/2014/main" id="{67FBF8BC-5BAE-1E68-ED65-7CE445BB80D2}"/>
               </a:ext>
             </a:extLst>
           </p:cNvPr>
@@ -3002,14 +3002,14 @@
               <a:defRPr sz="1200">
                 <a:solidFill>
                   <a:schemeClr val="tx1">
-                    <a:tint val="82000"/>
+                    <a:tint val="75000"/>
                   </a:schemeClr>
                 </a:solidFill>
               </a:defRPr>
             </a:lvl1pPr>
           </a:lstStyle>
           <a:p>
-            <a:fld id="{357192D4-5BD9-41C8-9EE5-942CB5B156C9}" type="slidenum">
+            <a:fld id="{96B8D56F-A2A2-43A0-8CA7-B1F0D0BAB8F0}" type="slidenum">
               <a:rPr lang="es-ES" smtClean="0"/>
               <a:t>‹Nº›</a:t>
             </a:fld>
@@ -3020,7 +3020,7 @@
     </p:spTree>
     <p:extLst>
       <p:ext uri="{BB962C8B-B14F-4D97-AF65-F5344CB8AC3E}">
-        <p14:creationId xmlns:p14="http://schemas.microsoft.com/office/powerpoint/2010/main" val="3537115536"/>
+        <p14:creationId xmlns:p14="http://schemas.microsoft.com/office/powerpoint/2010/main" val="3254596532"/>
       </p:ext>
     </p:extLst>
   </p:cSld>
@@ -3351,7 +3351,7 @@
           <p:cNvPr id="2" name="Rectángulo: esquinas redondeadas 1">
             <a:extLst>
               <a:ext uri="{FF2B5EF4-FFF2-40B4-BE49-F238E27FC236}">
-                <a16:creationId xmlns:a16="http://schemas.microsoft.com/office/drawing/2014/main" id="{D205D9E9-2B2A-8449-3280-81D4BA71935C}"/>
+                <a16:creationId xmlns:a16="http://schemas.microsoft.com/office/drawing/2014/main" id="{CA12C00C-31B8-57BA-AE1B-7F0B6DDD5033}"/>
               </a:ext>
             </a:extLst>
           </p:cNvPr>
@@ -3405,7 +3405,7 @@
           <p:cNvPr id="3" name="CuadroTexto 2">
             <a:extLst>
               <a:ext uri="{FF2B5EF4-FFF2-40B4-BE49-F238E27FC236}">
-                <a16:creationId xmlns:a16="http://schemas.microsoft.com/office/drawing/2014/main" id="{8CD26C4F-EB69-6F68-D6A8-EFDFAAB9A2EE}"/>
+                <a16:creationId xmlns:a16="http://schemas.microsoft.com/office/drawing/2014/main" id="{38694A69-AED5-9D5A-6CAF-BEA870CD3C25}"/>
               </a:ext>
             </a:extLst>
           </p:cNvPr>
@@ -3445,7 +3445,7 @@
           <p:cNvPr id="4" name="CuadroTexto 3">
             <a:extLst>
               <a:ext uri="{FF2B5EF4-FFF2-40B4-BE49-F238E27FC236}">
-                <a16:creationId xmlns:a16="http://schemas.microsoft.com/office/drawing/2014/main" id="{6594C209-D7CD-32E9-0092-BEEDDDE630D1}"/>
+                <a16:creationId xmlns:a16="http://schemas.microsoft.com/office/drawing/2014/main" id="{4E2A4B0B-DFF1-F818-1C09-6E54098339A1}"/>
               </a:ext>
             </a:extLst>
           </p:cNvPr>
@@ -3485,7 +3485,7 @@
           <p:cNvPr id="5" name="CuadroTexto 4">
             <a:extLst>
               <a:ext uri="{FF2B5EF4-FFF2-40B4-BE49-F238E27FC236}">
-                <a16:creationId xmlns:a16="http://schemas.microsoft.com/office/drawing/2014/main" id="{0010246E-364B-3BEC-B71E-FE18CDB86658}"/>
+                <a16:creationId xmlns:a16="http://schemas.microsoft.com/office/drawing/2014/main" id="{A54BA1BA-F4BA-9AE1-5D5D-9053E0635E3B}"/>
               </a:ext>
             </a:extLst>
           </p:cNvPr>
@@ -3525,7 +3525,7 @@
           <p:cNvPr id="6" name="CuadroTexto 5">
             <a:extLst>
               <a:ext uri="{FF2B5EF4-FFF2-40B4-BE49-F238E27FC236}">
-                <a16:creationId xmlns:a16="http://schemas.microsoft.com/office/drawing/2014/main" id="{2C422221-3442-CE74-2513-F43623CAB150}"/>
+                <a16:creationId xmlns:a16="http://schemas.microsoft.com/office/drawing/2014/main" id="{38C02F9F-A59F-E971-B686-AB6159C2730C}"/>
               </a:ext>
             </a:extLst>
           </p:cNvPr>
@@ -3576,7 +3576,7 @@
           <p:cNvPr id="8" name="Imagen 7">
             <a:extLst>
               <a:ext uri="{FF2B5EF4-FFF2-40B4-BE49-F238E27FC236}">
-                <a16:creationId xmlns:a16="http://schemas.microsoft.com/office/drawing/2014/main" id="{7A6C684F-BE85-6DFF-BFD5-BD4E0258C0E8}"/>
+                <a16:creationId xmlns:a16="http://schemas.microsoft.com/office/drawing/2014/main" id="{4DE0169B-C9B0-5450-F4DA-2530A2097BB1}"/>
               </a:ext>
             </a:extLst>
           </p:cNvPr>
@@ -3615,7 +3615,7 @@
     </p:spTree>
     <p:extLst>
       <p:ext uri="{BB962C8B-B14F-4D97-AF65-F5344CB8AC3E}">
-        <p14:creationId xmlns:p14="http://schemas.microsoft.com/office/powerpoint/2010/main" val="1724773751"/>
+        <p14:creationId xmlns:p14="http://schemas.microsoft.com/office/powerpoint/2010/main" val="1507221563"/>
       </p:ext>
     </p:extLst>
   </p:cSld>
@@ -3655,7 +3655,7 @@
           <p:cNvPr id="2" name="CuadroTexto 1">
             <a:extLst>
               <a:ext uri="{FF2B5EF4-FFF2-40B4-BE49-F238E27FC236}">
-                <a16:creationId xmlns:a16="http://schemas.microsoft.com/office/drawing/2014/main" id="{98AAE408-EF69-259D-BAA6-33ED04A04C57}"/>
+                <a16:creationId xmlns:a16="http://schemas.microsoft.com/office/drawing/2014/main" id="{6401F12A-9BD6-9813-B0F8-BFA0D273FA7E}"/>
               </a:ext>
             </a:extLst>
           </p:cNvPr>
@@ -3695,7 +3695,7 @@
           <p:cNvPr id="3" name="CuadroTexto 2">
             <a:extLst>
               <a:ext uri="{FF2B5EF4-FFF2-40B4-BE49-F238E27FC236}">
-                <a16:creationId xmlns:a16="http://schemas.microsoft.com/office/drawing/2014/main" id="{D086D1C7-C914-B072-1836-0199861C2628}"/>
+                <a16:creationId xmlns:a16="http://schemas.microsoft.com/office/drawing/2014/main" id="{A44A9632-27FC-CA47-4923-739611D3D20C}"/>
               </a:ext>
             </a:extLst>
           </p:cNvPr>
@@ -3735,7 +3735,7 @@
           <p:cNvPr id="4" name="CuadroTexto 3">
             <a:extLst>
               <a:ext uri="{FF2B5EF4-FFF2-40B4-BE49-F238E27FC236}">
-                <a16:creationId xmlns:a16="http://schemas.microsoft.com/office/drawing/2014/main" id="{CDF96AA8-6440-8183-2342-0628F8D93C1A}"/>
+                <a16:creationId xmlns:a16="http://schemas.microsoft.com/office/drawing/2014/main" id="{219469AF-74E0-545A-7EE2-3321F726B710}"/>
               </a:ext>
             </a:extLst>
           </p:cNvPr>
@@ -3775,7 +3775,7 @@
           <p:cNvPr id="5" name="Rectángulo: esquinas redondeadas 4">
             <a:extLst>
               <a:ext uri="{FF2B5EF4-FFF2-40B4-BE49-F238E27FC236}">
-                <a16:creationId xmlns:a16="http://schemas.microsoft.com/office/drawing/2014/main" id="{72C7F4DA-D661-40BE-C733-D0CFC5C5D4DF}"/>
+                <a16:creationId xmlns:a16="http://schemas.microsoft.com/office/drawing/2014/main" id="{1711DDAD-F082-BCA4-9ED1-837EFA9EB665}"/>
               </a:ext>
             </a:extLst>
           </p:cNvPr>
@@ -3829,7 +3829,7 @@
           <p:cNvPr id="6" name="CuadroTexto 5">
             <a:extLst>
               <a:ext uri="{FF2B5EF4-FFF2-40B4-BE49-F238E27FC236}">
-                <a16:creationId xmlns:a16="http://schemas.microsoft.com/office/drawing/2014/main" id="{8DBAA4C0-2D71-CAC0-B5DE-D0FBDD24023B}"/>
+                <a16:creationId xmlns:a16="http://schemas.microsoft.com/office/drawing/2014/main" id="{76A13E2F-B7DB-09AE-0DEA-611461763BA0}"/>
               </a:ext>
             </a:extLst>
           </p:cNvPr>
@@ -3869,7 +3869,7 @@
           <p:cNvPr id="7" name="CuadroTexto 6">
             <a:extLst>
               <a:ext uri="{FF2B5EF4-FFF2-40B4-BE49-F238E27FC236}">
-                <a16:creationId xmlns:a16="http://schemas.microsoft.com/office/drawing/2014/main" id="{2F5E01B1-602E-9AAB-E81C-2CD851951762}"/>
+                <a16:creationId xmlns:a16="http://schemas.microsoft.com/office/drawing/2014/main" id="{57C53391-5E60-7DB8-BF96-2A8BD44BB41B}"/>
               </a:ext>
             </a:extLst>
           </p:cNvPr>
@@ -3988,7 +3988,7 @@
           <p:cNvPr id="8" name="Rectángulo: esquinas redondeadas 7">
             <a:extLst>
               <a:ext uri="{FF2B5EF4-FFF2-40B4-BE49-F238E27FC236}">
-                <a16:creationId xmlns:a16="http://schemas.microsoft.com/office/drawing/2014/main" id="{B951AA5D-2568-173E-3564-B6188845BFAB}"/>
+                <a16:creationId xmlns:a16="http://schemas.microsoft.com/office/drawing/2014/main" id="{F3EA4F40-A00D-4014-B74E-E0942500B6D5}"/>
               </a:ext>
             </a:extLst>
           </p:cNvPr>
@@ -4042,7 +4042,7 @@
           <p:cNvPr id="9" name="CuadroTexto 8">
             <a:extLst>
               <a:ext uri="{FF2B5EF4-FFF2-40B4-BE49-F238E27FC236}">
-                <a16:creationId xmlns:a16="http://schemas.microsoft.com/office/drawing/2014/main" id="{A718BDB6-8A2A-59D7-94D9-1ABB0C32B839}"/>
+                <a16:creationId xmlns:a16="http://schemas.microsoft.com/office/drawing/2014/main" id="{105FA132-06B5-98AA-2252-642A93FC30F0}"/>
               </a:ext>
             </a:extLst>
           </p:cNvPr>
@@ -4082,7 +4082,7 @@
           <p:cNvPr id="10" name="CuadroTexto 9">
             <a:extLst>
               <a:ext uri="{FF2B5EF4-FFF2-40B4-BE49-F238E27FC236}">
-                <a16:creationId xmlns:a16="http://schemas.microsoft.com/office/drawing/2014/main" id="{C3202201-B8E7-16DA-060E-49AFEAAA9BBA}"/>
+                <a16:creationId xmlns:a16="http://schemas.microsoft.com/office/drawing/2014/main" id="{F6DF0045-A309-75DB-E583-BC19BE3DBE6F}"/>
               </a:ext>
             </a:extLst>
           </p:cNvPr>
@@ -4122,7 +4122,7 @@
           <p:cNvPr id="11" name="Rectángulo: esquinas redondeadas 10">
             <a:extLst>
               <a:ext uri="{FF2B5EF4-FFF2-40B4-BE49-F238E27FC236}">
-                <a16:creationId xmlns:a16="http://schemas.microsoft.com/office/drawing/2014/main" id="{19370CEA-D01B-E710-52C7-F1754B5DF4BD}"/>
+                <a16:creationId xmlns:a16="http://schemas.microsoft.com/office/drawing/2014/main" id="{9D2E0A56-6D22-4A0F-E246-95645F83C1B2}"/>
               </a:ext>
             </a:extLst>
           </p:cNvPr>
@@ -4176,7 +4176,7 @@
           <p:cNvPr id="12" name="CuadroTexto 11">
             <a:extLst>
               <a:ext uri="{FF2B5EF4-FFF2-40B4-BE49-F238E27FC236}">
-                <a16:creationId xmlns:a16="http://schemas.microsoft.com/office/drawing/2014/main" id="{F9ED67AE-12C2-53C7-385C-8F3B9E9C1C06}"/>
+                <a16:creationId xmlns:a16="http://schemas.microsoft.com/office/drawing/2014/main" id="{9508AFE7-8CFD-0FF6-B5D8-6A1F1ABFF0B8}"/>
               </a:ext>
             </a:extLst>
           </p:cNvPr>
@@ -4216,7 +4216,7 @@
           <p:cNvPr id="13" name="CuadroTexto 12">
             <a:extLst>
               <a:ext uri="{FF2B5EF4-FFF2-40B4-BE49-F238E27FC236}">
-                <a16:creationId xmlns:a16="http://schemas.microsoft.com/office/drawing/2014/main" id="{938D04B1-01AA-9D2C-F15B-DFF6B72BEBF0}"/>
+                <a16:creationId xmlns:a16="http://schemas.microsoft.com/office/drawing/2014/main" id="{B30D510A-3075-BACE-8938-17866590C4C0}"/>
               </a:ext>
             </a:extLst>
           </p:cNvPr>
@@ -4256,7 +4256,7 @@
           <p:cNvPr id="14" name="Rectángulo: esquinas redondeadas 13">
             <a:extLst>
               <a:ext uri="{FF2B5EF4-FFF2-40B4-BE49-F238E27FC236}">
-                <a16:creationId xmlns:a16="http://schemas.microsoft.com/office/drawing/2014/main" id="{61A4F89D-7193-1ED4-7F96-DE96ED033F1D}"/>
+                <a16:creationId xmlns:a16="http://schemas.microsoft.com/office/drawing/2014/main" id="{DDB74B9A-DC97-8FB9-3B55-1CE9D0431FC9}"/>
               </a:ext>
             </a:extLst>
           </p:cNvPr>
@@ -4310,7 +4310,7 @@
           <p:cNvPr id="15" name="CuadroTexto 14">
             <a:extLst>
               <a:ext uri="{FF2B5EF4-FFF2-40B4-BE49-F238E27FC236}">
-                <a16:creationId xmlns:a16="http://schemas.microsoft.com/office/drawing/2014/main" id="{364A9D98-FAC5-DD14-0376-22899E9C74B4}"/>
+                <a16:creationId xmlns:a16="http://schemas.microsoft.com/office/drawing/2014/main" id="{5C09EDE9-1D72-935B-4F1D-208CB3808437}"/>
               </a:ext>
             </a:extLst>
           </p:cNvPr>
@@ -4350,7 +4350,7 @@
           <p:cNvPr id="16" name="CuadroTexto 15">
             <a:extLst>
               <a:ext uri="{FF2B5EF4-FFF2-40B4-BE49-F238E27FC236}">
-                <a16:creationId xmlns:a16="http://schemas.microsoft.com/office/drawing/2014/main" id="{5A4CDBA9-9DAC-8B1F-16A9-301C5313FD4B}"/>
+                <a16:creationId xmlns:a16="http://schemas.microsoft.com/office/drawing/2014/main" id="{5504C2AB-32D7-51B0-8D8D-63B622801529}"/>
               </a:ext>
             </a:extLst>
           </p:cNvPr>
@@ -4390,7 +4390,7 @@
           <p:cNvPr id="17" name="Rectángulo: esquinas redondeadas 16">
             <a:extLst>
               <a:ext uri="{FF2B5EF4-FFF2-40B4-BE49-F238E27FC236}">
-                <a16:creationId xmlns:a16="http://schemas.microsoft.com/office/drawing/2014/main" id="{658C09E8-6A59-E416-E38F-35F2C3BE7A31}"/>
+                <a16:creationId xmlns:a16="http://schemas.microsoft.com/office/drawing/2014/main" id="{4B58F593-AD63-B552-0688-7DB6DAF48C2E}"/>
               </a:ext>
             </a:extLst>
           </p:cNvPr>
@@ -4444,7 +4444,7 @@
           <p:cNvPr id="18" name="CuadroTexto 17">
             <a:extLst>
               <a:ext uri="{FF2B5EF4-FFF2-40B4-BE49-F238E27FC236}">
-                <a16:creationId xmlns:a16="http://schemas.microsoft.com/office/drawing/2014/main" id="{4E03C3C2-56D3-8B47-CBB2-B8C6BB906DE5}"/>
+                <a16:creationId xmlns:a16="http://schemas.microsoft.com/office/drawing/2014/main" id="{307EEDE5-3F42-E0C3-85B0-EEEEDBBE1196}"/>
               </a:ext>
             </a:extLst>
           </p:cNvPr>
@@ -4484,7 +4484,7 @@
           <p:cNvPr id="19" name="CuadroTexto 18">
             <a:extLst>
               <a:ext uri="{FF2B5EF4-FFF2-40B4-BE49-F238E27FC236}">
-                <a16:creationId xmlns:a16="http://schemas.microsoft.com/office/drawing/2014/main" id="{BA8A35CA-E482-34AF-FE89-1AF1BABFD828}"/>
+                <a16:creationId xmlns:a16="http://schemas.microsoft.com/office/drawing/2014/main" id="{9C9DC3D6-AFBF-D787-D231-DD172FA254D4}"/>
               </a:ext>
             </a:extLst>
           </p:cNvPr>
@@ -4522,7 +4522,7 @@
     </p:spTree>
     <p:extLst>
       <p:ext uri="{BB962C8B-B14F-4D97-AF65-F5344CB8AC3E}">
-        <p14:creationId xmlns:p14="http://schemas.microsoft.com/office/powerpoint/2010/main" val="239697957"/>
+        <p14:creationId xmlns:p14="http://schemas.microsoft.com/office/powerpoint/2010/main" val="3163905367"/>
       </p:ext>
     </p:extLst>
   </p:cSld>
@@ -4562,7 +4562,7 @@
           <p:cNvPr id="2" name="CuadroTexto 1">
             <a:extLst>
               <a:ext uri="{FF2B5EF4-FFF2-40B4-BE49-F238E27FC236}">
-                <a16:creationId xmlns:a16="http://schemas.microsoft.com/office/drawing/2014/main" id="{6F1E9EC0-F667-4B56-359D-972CD20039E1}"/>
+                <a16:creationId xmlns:a16="http://schemas.microsoft.com/office/drawing/2014/main" id="{335F3ACD-6D7E-558F-DCCC-3153F82008B0}"/>
               </a:ext>
             </a:extLst>
           </p:cNvPr>
@@ -4602,7 +4602,7 @@
           <p:cNvPr id="3" name="CuadroTexto 2">
             <a:extLst>
               <a:ext uri="{FF2B5EF4-FFF2-40B4-BE49-F238E27FC236}">
-                <a16:creationId xmlns:a16="http://schemas.microsoft.com/office/drawing/2014/main" id="{15DCCC73-4BD4-AE87-0667-46774F68DE5A}"/>
+                <a16:creationId xmlns:a16="http://schemas.microsoft.com/office/drawing/2014/main" id="{69B93B46-68C3-01DA-F96E-996FF02A0DDC}"/>
               </a:ext>
             </a:extLst>
           </p:cNvPr>
@@ -4642,7 +4642,7 @@
           <p:cNvPr id="4" name="CuadroTexto 3">
             <a:extLst>
               <a:ext uri="{FF2B5EF4-FFF2-40B4-BE49-F238E27FC236}">
-                <a16:creationId xmlns:a16="http://schemas.microsoft.com/office/drawing/2014/main" id="{21A5879C-26AE-E6A0-295B-83A024344107}"/>
+                <a16:creationId xmlns:a16="http://schemas.microsoft.com/office/drawing/2014/main" id="{409939A8-2448-44CA-16EA-FE600681691A}"/>
               </a:ext>
             </a:extLst>
           </p:cNvPr>
@@ -4682,7 +4682,7 @@
           <p:cNvPr id="5" name="Rectángulo: esquinas redondeadas 4">
             <a:extLst>
               <a:ext uri="{FF2B5EF4-FFF2-40B4-BE49-F238E27FC236}">
-                <a16:creationId xmlns:a16="http://schemas.microsoft.com/office/drawing/2014/main" id="{A2FED42F-BB72-4BBF-D508-E0FD37612B99}"/>
+                <a16:creationId xmlns:a16="http://schemas.microsoft.com/office/drawing/2014/main" id="{FE36CB12-3F6B-8C73-109F-8925106B4365}"/>
               </a:ext>
             </a:extLst>
           </p:cNvPr>
@@ -4736,7 +4736,7 @@
           <p:cNvPr id="6" name="CuadroTexto 5">
             <a:extLst>
               <a:ext uri="{FF2B5EF4-FFF2-40B4-BE49-F238E27FC236}">
-                <a16:creationId xmlns:a16="http://schemas.microsoft.com/office/drawing/2014/main" id="{52F9094C-B5EA-4D0E-AFCF-A07B6E20E5C6}"/>
+                <a16:creationId xmlns:a16="http://schemas.microsoft.com/office/drawing/2014/main" id="{8064C8B6-4FC8-72DF-DB7D-38C0B54EEB90}"/>
               </a:ext>
             </a:extLst>
           </p:cNvPr>
@@ -4776,7 +4776,7 @@
           <p:cNvPr id="7" name="CuadroTexto 6">
             <a:extLst>
               <a:ext uri="{FF2B5EF4-FFF2-40B4-BE49-F238E27FC236}">
-                <a16:creationId xmlns:a16="http://schemas.microsoft.com/office/drawing/2014/main" id="{2EBD63C4-9FE0-B826-1C14-DFD65B38CCF5}"/>
+                <a16:creationId xmlns:a16="http://schemas.microsoft.com/office/drawing/2014/main" id="{34FBAB40-7507-AABA-BD78-3A210EDF719B}"/>
               </a:ext>
             </a:extLst>
           </p:cNvPr>
@@ -4816,7 +4816,7 @@
           <p:cNvPr id="8" name="Rectángulo: esquinas redondeadas 7">
             <a:extLst>
               <a:ext uri="{FF2B5EF4-FFF2-40B4-BE49-F238E27FC236}">
-                <a16:creationId xmlns:a16="http://schemas.microsoft.com/office/drawing/2014/main" id="{91A17B97-0060-DCF1-D36A-4D61DA7C94FE}"/>
+                <a16:creationId xmlns:a16="http://schemas.microsoft.com/office/drawing/2014/main" id="{5066D45E-EB66-0063-7ABA-758AC6A4EC3A}"/>
               </a:ext>
             </a:extLst>
           </p:cNvPr>
@@ -4870,7 +4870,7 @@
           <p:cNvPr id="9" name="CuadroTexto 8">
             <a:extLst>
               <a:ext uri="{FF2B5EF4-FFF2-40B4-BE49-F238E27FC236}">
-                <a16:creationId xmlns:a16="http://schemas.microsoft.com/office/drawing/2014/main" id="{1BCAE38A-E9B9-C367-4FB0-9D291BB46725}"/>
+                <a16:creationId xmlns:a16="http://schemas.microsoft.com/office/drawing/2014/main" id="{CEA7E78D-7589-43E1-79CE-8B4EA40E8A4A}"/>
               </a:ext>
             </a:extLst>
           </p:cNvPr>
@@ -4910,7 +4910,7 @@
           <p:cNvPr id="10" name="CuadroTexto 9">
             <a:extLst>
               <a:ext uri="{FF2B5EF4-FFF2-40B4-BE49-F238E27FC236}">
-                <a16:creationId xmlns:a16="http://schemas.microsoft.com/office/drawing/2014/main" id="{9D4FE66D-3B12-E967-6482-E6D8B4D660CA}"/>
+                <a16:creationId xmlns:a16="http://schemas.microsoft.com/office/drawing/2014/main" id="{92F702A2-5CEB-7576-A787-8A61EFA2127E}"/>
               </a:ext>
             </a:extLst>
           </p:cNvPr>
@@ -4950,7 +4950,7 @@
           <p:cNvPr id="11" name="Rectángulo: esquinas redondeadas 10">
             <a:extLst>
               <a:ext uri="{FF2B5EF4-FFF2-40B4-BE49-F238E27FC236}">
-                <a16:creationId xmlns:a16="http://schemas.microsoft.com/office/drawing/2014/main" id="{8F23661F-2B82-5F38-1D07-61D5D3F3D5C8}"/>
+                <a16:creationId xmlns:a16="http://schemas.microsoft.com/office/drawing/2014/main" id="{0F3E7393-FB97-F29D-F9BB-FBBFB5EDC115}"/>
               </a:ext>
             </a:extLst>
           </p:cNvPr>
@@ -5004,7 +5004,7 @@
           <p:cNvPr id="12" name="CuadroTexto 11">
             <a:extLst>
               <a:ext uri="{FF2B5EF4-FFF2-40B4-BE49-F238E27FC236}">
-                <a16:creationId xmlns:a16="http://schemas.microsoft.com/office/drawing/2014/main" id="{997A0180-7500-75A2-C478-5D938FDD5E26}"/>
+                <a16:creationId xmlns:a16="http://schemas.microsoft.com/office/drawing/2014/main" id="{D1DF95A3-3B8C-BBCB-440D-FF242319D753}"/>
               </a:ext>
             </a:extLst>
           </p:cNvPr>
@@ -5044,7 +5044,7 @@
           <p:cNvPr id="13" name="CuadroTexto 12">
             <a:extLst>
               <a:ext uri="{FF2B5EF4-FFF2-40B4-BE49-F238E27FC236}">
-                <a16:creationId xmlns:a16="http://schemas.microsoft.com/office/drawing/2014/main" id="{274E05EA-CCC9-48DA-6D32-AB0A437C2C5F}"/>
+                <a16:creationId xmlns:a16="http://schemas.microsoft.com/office/drawing/2014/main" id="{E96EBE17-31C8-2466-B02D-8F17579092DD}"/>
               </a:ext>
             </a:extLst>
           </p:cNvPr>
@@ -5068,13 +5068,13 @@
           <a:lstStyle/>
           <a:p>
             <a:r>
-              <a:rPr lang="es-ES" sz="1000">
+              <a:rPr lang="es-ES" sz="900">
                 <a:solidFill>
                   <a:srgbClr val="F6F8FC"/>
                 </a:solidFill>
                 <a:latin typeface="Consolas" panose="020B0609020204030204" pitchFamily="49" charset="0"/>
               </a:rPr>
-              <a:t>https://agora.34.175...</a:t>
+              <a:t>https://agora.34.175.225.98...</a:t>
             </a:r>
           </a:p>
         </p:txBody>
@@ -5084,7 +5084,7 @@
           <p:cNvPr id="14" name="CuadroTexto 13">
             <a:extLst>
               <a:ext uri="{FF2B5EF4-FFF2-40B4-BE49-F238E27FC236}">
-                <a16:creationId xmlns:a16="http://schemas.microsoft.com/office/drawing/2014/main" id="{F6B10B3E-18A4-45B7-ABE4-6A2D870E6727}"/>
+                <a16:creationId xmlns:a16="http://schemas.microsoft.com/office/drawing/2014/main" id="{618D0947-2F0A-2FE3-C043-548405AC1F5D}"/>
               </a:ext>
             </a:extLst>
           </p:cNvPr>
@@ -5165,7 +5165,7 @@
     </p:spTree>
     <p:extLst>
       <p:ext uri="{BB962C8B-B14F-4D97-AF65-F5344CB8AC3E}">
-        <p14:creationId xmlns:p14="http://schemas.microsoft.com/office/powerpoint/2010/main" val="2479140049"/>
+        <p14:creationId xmlns:p14="http://schemas.microsoft.com/office/powerpoint/2010/main" val="1478726641"/>
       </p:ext>
     </p:extLst>
   </p:cSld>
@@ -5205,7 +5205,7 @@
           <p:cNvPr id="2" name="CuadroTexto 1">
             <a:extLst>
               <a:ext uri="{FF2B5EF4-FFF2-40B4-BE49-F238E27FC236}">
-                <a16:creationId xmlns:a16="http://schemas.microsoft.com/office/drawing/2014/main" id="{03DB7E78-8B3E-11AC-2762-22C0BCF78BAD}"/>
+                <a16:creationId xmlns:a16="http://schemas.microsoft.com/office/drawing/2014/main" id="{ED226011-882C-5D32-E9F7-E07A5A18B3EE}"/>
               </a:ext>
             </a:extLst>
           </p:cNvPr>
@@ -5245,7 +5245,7 @@
           <p:cNvPr id="3" name="CuadroTexto 2">
             <a:extLst>
               <a:ext uri="{FF2B5EF4-FFF2-40B4-BE49-F238E27FC236}">
-                <a16:creationId xmlns:a16="http://schemas.microsoft.com/office/drawing/2014/main" id="{E09E744C-5809-A687-BBE4-A99858670EF8}"/>
+                <a16:creationId xmlns:a16="http://schemas.microsoft.com/office/drawing/2014/main" id="{6EBBE66B-C209-06AB-7B21-134AF129D97E}"/>
               </a:ext>
             </a:extLst>
           </p:cNvPr>
@@ -5285,7 +5285,7 @@
           <p:cNvPr id="4" name="CuadroTexto 3">
             <a:extLst>
               <a:ext uri="{FF2B5EF4-FFF2-40B4-BE49-F238E27FC236}">
-                <a16:creationId xmlns:a16="http://schemas.microsoft.com/office/drawing/2014/main" id="{0EDE0FD2-2286-1920-8DC6-28BF35E55E70}"/>
+                <a16:creationId xmlns:a16="http://schemas.microsoft.com/office/drawing/2014/main" id="{9B7CD03D-62F3-7881-498F-DFEEF490B40D}"/>
               </a:ext>
             </a:extLst>
           </p:cNvPr>
@@ -5325,7 +5325,7 @@
           <p:cNvPr id="6" name="Imagen 5">
             <a:extLst>
               <a:ext uri="{FF2B5EF4-FFF2-40B4-BE49-F238E27FC236}">
-                <a16:creationId xmlns:a16="http://schemas.microsoft.com/office/drawing/2014/main" id="{7D235ABE-6CE1-ED99-5A52-2C162FF8ACB3}"/>
+                <a16:creationId xmlns:a16="http://schemas.microsoft.com/office/drawing/2014/main" id="{6FD68646-2437-6E7B-BC5A-E81618CDDD5C}"/>
               </a:ext>
             </a:extLst>
           </p:cNvPr>
@@ -5366,7 +5366,7 @@
           <p:cNvPr id="7" name="Rectángulo: esquinas redondeadas 6">
             <a:extLst>
               <a:ext uri="{FF2B5EF4-FFF2-40B4-BE49-F238E27FC236}">
-                <a16:creationId xmlns:a16="http://schemas.microsoft.com/office/drawing/2014/main" id="{78BC451A-3875-5BF9-9443-0E4BFD8AE8B6}"/>
+                <a16:creationId xmlns:a16="http://schemas.microsoft.com/office/drawing/2014/main" id="{DBFDBCC1-E1EF-D77B-8FE3-CE19CEAE6F0F}"/>
               </a:ext>
             </a:extLst>
           </p:cNvPr>
@@ -5420,7 +5420,7 @@
           <p:cNvPr id="8" name="CuadroTexto 7">
             <a:extLst>
               <a:ext uri="{FF2B5EF4-FFF2-40B4-BE49-F238E27FC236}">
-                <a16:creationId xmlns:a16="http://schemas.microsoft.com/office/drawing/2014/main" id="{CC57963F-9EC0-4099-7B7B-4EB80102A431}"/>
+                <a16:creationId xmlns:a16="http://schemas.microsoft.com/office/drawing/2014/main" id="{70ACC945-01BD-D4E7-6294-F7EF4B534FDF}"/>
               </a:ext>
             </a:extLst>
           </p:cNvPr>
@@ -5460,7 +5460,7 @@
           <p:cNvPr id="9" name="CuadroTexto 8">
             <a:extLst>
               <a:ext uri="{FF2B5EF4-FFF2-40B4-BE49-F238E27FC236}">
-                <a16:creationId xmlns:a16="http://schemas.microsoft.com/office/drawing/2014/main" id="{3E5C9C25-024E-58A9-F6C5-CDD9E7C0AB05}"/>
+                <a16:creationId xmlns:a16="http://schemas.microsoft.com/office/drawing/2014/main" id="{F7AC6533-69F5-F6BB-1B20-2EADCB7D8E47}"/>
               </a:ext>
             </a:extLst>
           </p:cNvPr>
@@ -5500,7 +5500,7 @@
           <p:cNvPr id="10" name="CuadroTexto 9">
             <a:extLst>
               <a:ext uri="{FF2B5EF4-FFF2-40B4-BE49-F238E27FC236}">
-                <a16:creationId xmlns:a16="http://schemas.microsoft.com/office/drawing/2014/main" id="{93C8ED2A-C773-D0D2-D196-68E99818FABC}"/>
+                <a16:creationId xmlns:a16="http://schemas.microsoft.com/office/drawing/2014/main" id="{20213126-36BE-9D61-BB6F-48D2DAA61D48}"/>
               </a:ext>
             </a:extLst>
           </p:cNvPr>
@@ -5599,7 +5599,7 @@
     </p:spTree>
     <p:extLst>
       <p:ext uri="{BB962C8B-B14F-4D97-AF65-F5344CB8AC3E}">
-        <p14:creationId xmlns:p14="http://schemas.microsoft.com/office/powerpoint/2010/main" val="660871041"/>
+        <p14:creationId xmlns:p14="http://schemas.microsoft.com/office/powerpoint/2010/main" val="1591126200"/>
       </p:ext>
     </p:extLst>
   </p:cSld>
@@ -5639,7 +5639,7 @@
           <p:cNvPr id="2" name="CuadroTexto 1">
             <a:extLst>
               <a:ext uri="{FF2B5EF4-FFF2-40B4-BE49-F238E27FC236}">
-                <a16:creationId xmlns:a16="http://schemas.microsoft.com/office/drawing/2014/main" id="{7CEBF6AB-5197-355B-1FA4-C2D234A4110F}"/>
+                <a16:creationId xmlns:a16="http://schemas.microsoft.com/office/drawing/2014/main" id="{F0FEA101-1787-D34F-EBCE-81821753563A}"/>
               </a:ext>
             </a:extLst>
           </p:cNvPr>
@@ -5679,7 +5679,7 @@
           <p:cNvPr id="3" name="CuadroTexto 2">
             <a:extLst>
               <a:ext uri="{FF2B5EF4-FFF2-40B4-BE49-F238E27FC236}">
-                <a16:creationId xmlns:a16="http://schemas.microsoft.com/office/drawing/2014/main" id="{7A32CA94-D527-C72B-8325-6DCAEB806FD0}"/>
+                <a16:creationId xmlns:a16="http://schemas.microsoft.com/office/drawing/2014/main" id="{0BE57B89-4ECA-778F-091E-780B6A53E81A}"/>
               </a:ext>
             </a:extLst>
           </p:cNvPr>
@@ -5719,7 +5719,7 @@
           <p:cNvPr id="4" name="CuadroTexto 3">
             <a:extLst>
               <a:ext uri="{FF2B5EF4-FFF2-40B4-BE49-F238E27FC236}">
-                <a16:creationId xmlns:a16="http://schemas.microsoft.com/office/drawing/2014/main" id="{F2235965-61F5-523C-968F-6345D6A076C2}"/>
+                <a16:creationId xmlns:a16="http://schemas.microsoft.com/office/drawing/2014/main" id="{D8359D4C-15E0-EF2F-320C-1AECD8A8143D}"/>
               </a:ext>
             </a:extLst>
           </p:cNvPr>
@@ -5759,7 +5759,7 @@
           <p:cNvPr id="6" name="Imagen 5">
             <a:extLst>
               <a:ext uri="{FF2B5EF4-FFF2-40B4-BE49-F238E27FC236}">
-                <a16:creationId xmlns:a16="http://schemas.microsoft.com/office/drawing/2014/main" id="{3458D1CA-BD6B-4DEE-EC2D-DBAC79354BF9}"/>
+                <a16:creationId xmlns:a16="http://schemas.microsoft.com/office/drawing/2014/main" id="{E368E9F4-87A0-5B38-0FA9-F674CD3CCE24}"/>
               </a:ext>
             </a:extLst>
           </p:cNvPr>
@@ -5782,8 +5782,8 @@
         </p:blipFill>
         <p:spPr>
           <a:xfrm>
-            <a:off x="635000" y="2342377"/>
-            <a:ext cx="5461000" cy="2998746"/>
+            <a:off x="538560" y="1879600"/>
+            <a:ext cx="5679281" cy="4038600"/>
           </a:xfrm>
           <a:prstGeom prst="rect">
             <a:avLst/>
@@ -5800,7 +5800,7 @@
           <p:cNvPr id="7" name="CuadroTexto 6">
             <a:extLst>
               <a:ext uri="{FF2B5EF4-FFF2-40B4-BE49-F238E27FC236}">
-                <a16:creationId xmlns:a16="http://schemas.microsoft.com/office/drawing/2014/main" id="{DFB509E2-596F-AAC5-7A2E-4DE33DB60014}"/>
+                <a16:creationId xmlns:a16="http://schemas.microsoft.com/office/drawing/2014/main" id="{D8ED3307-E8D5-7A56-34A1-97FA5618ED28}"/>
               </a:ext>
             </a:extLst>
           </p:cNvPr>
@@ -5917,7 +5917,7 @@
     </p:spTree>
     <p:extLst>
       <p:ext uri="{BB962C8B-B14F-4D97-AF65-F5344CB8AC3E}">
-        <p14:creationId xmlns:p14="http://schemas.microsoft.com/office/powerpoint/2010/main" val="311254604"/>
+        <p14:creationId xmlns:p14="http://schemas.microsoft.com/office/powerpoint/2010/main" val="4092572609"/>
       </p:ext>
     </p:extLst>
   </p:cSld>
@@ -5957,7 +5957,7 @@
           <p:cNvPr id="2" name="CuadroTexto 1">
             <a:extLst>
               <a:ext uri="{FF2B5EF4-FFF2-40B4-BE49-F238E27FC236}">
-                <a16:creationId xmlns:a16="http://schemas.microsoft.com/office/drawing/2014/main" id="{28FD96AE-D367-0414-763C-D30FE2713BBF}"/>
+                <a16:creationId xmlns:a16="http://schemas.microsoft.com/office/drawing/2014/main" id="{EC079CF6-847E-B171-8FC9-EE51868AA9FC}"/>
               </a:ext>
             </a:extLst>
           </p:cNvPr>
@@ -5997,7 +5997,7 @@
           <p:cNvPr id="3" name="CuadroTexto 2">
             <a:extLst>
               <a:ext uri="{FF2B5EF4-FFF2-40B4-BE49-F238E27FC236}">
-                <a16:creationId xmlns:a16="http://schemas.microsoft.com/office/drawing/2014/main" id="{9CACD615-673E-68DD-6605-F0C87DC5F3BC}"/>
+                <a16:creationId xmlns:a16="http://schemas.microsoft.com/office/drawing/2014/main" id="{C313C642-87F1-721E-4386-6FE868113DC6}"/>
               </a:ext>
             </a:extLst>
           </p:cNvPr>
@@ -6037,7 +6037,7 @@
           <p:cNvPr id="4" name="Rectángulo: esquinas redondeadas 3">
             <a:extLst>
               <a:ext uri="{FF2B5EF4-FFF2-40B4-BE49-F238E27FC236}">
-                <a16:creationId xmlns:a16="http://schemas.microsoft.com/office/drawing/2014/main" id="{8E0C63F5-D5D9-6EC9-1D0F-97E31CC5C01F}"/>
+                <a16:creationId xmlns:a16="http://schemas.microsoft.com/office/drawing/2014/main" id="{85BECDB7-B362-8231-9619-F2E5D58A1005}"/>
               </a:ext>
             </a:extLst>
           </p:cNvPr>
@@ -6091,7 +6091,7 @@
           <p:cNvPr id="5" name="CuadroTexto 4">
             <a:extLst>
               <a:ext uri="{FF2B5EF4-FFF2-40B4-BE49-F238E27FC236}">
-                <a16:creationId xmlns:a16="http://schemas.microsoft.com/office/drawing/2014/main" id="{8E3DDE59-0A1C-2DF0-F70F-323A93ED1DCF}"/>
+                <a16:creationId xmlns:a16="http://schemas.microsoft.com/office/drawing/2014/main" id="{3E29C3F1-5EA6-5F0B-438B-8715970D4802}"/>
               </a:ext>
             </a:extLst>
           </p:cNvPr>
@@ -6121,7 +6121,7 @@
                 </a:solidFill>
                 <a:latin typeface="Segoe UI" panose="020B0502040204020203" pitchFamily="34" charset="0"/>
               </a:rPr>
-              <a:t>101</a:t>
+              <a:t>110</a:t>
             </a:r>
           </a:p>
         </p:txBody>
@@ -6131,7 +6131,7 @@
           <p:cNvPr id="6" name="CuadroTexto 5">
             <a:extLst>
               <a:ext uri="{FF2B5EF4-FFF2-40B4-BE49-F238E27FC236}">
-                <a16:creationId xmlns:a16="http://schemas.microsoft.com/office/drawing/2014/main" id="{EE378B01-6BA6-86A4-4F17-E9FEA64A95E6}"/>
+                <a16:creationId xmlns:a16="http://schemas.microsoft.com/office/drawing/2014/main" id="{7D0116EA-CA58-8658-8A63-448B22684393}"/>
               </a:ext>
             </a:extLst>
           </p:cNvPr>
@@ -6171,7 +6171,7 @@
           <p:cNvPr id="7" name="Rectángulo: esquinas redondeadas 6">
             <a:extLst>
               <a:ext uri="{FF2B5EF4-FFF2-40B4-BE49-F238E27FC236}">
-                <a16:creationId xmlns:a16="http://schemas.microsoft.com/office/drawing/2014/main" id="{8EE1CCE0-2338-4500-C634-21A04B3AF65A}"/>
+                <a16:creationId xmlns:a16="http://schemas.microsoft.com/office/drawing/2014/main" id="{FE84D8D8-90E1-8533-7204-D3D2A4BF27ED}"/>
               </a:ext>
             </a:extLst>
           </p:cNvPr>
@@ -6225,7 +6225,7 @@
           <p:cNvPr id="8" name="CuadroTexto 7">
             <a:extLst>
               <a:ext uri="{FF2B5EF4-FFF2-40B4-BE49-F238E27FC236}">
-                <a16:creationId xmlns:a16="http://schemas.microsoft.com/office/drawing/2014/main" id="{4F23986E-CC36-D0E2-A5CB-48C70AC53935}"/>
+                <a16:creationId xmlns:a16="http://schemas.microsoft.com/office/drawing/2014/main" id="{E87F0B20-E7AC-6505-CF65-3BA1DF35B8D6}"/>
               </a:ext>
             </a:extLst>
           </p:cNvPr>
@@ -6255,7 +6255,7 @@
                 </a:solidFill>
                 <a:latin typeface="Segoe UI" panose="020B0502040204020203" pitchFamily="34" charset="0"/>
               </a:rPr>
-              <a:t>567</a:t>
+              <a:t>628</a:t>
             </a:r>
           </a:p>
         </p:txBody>
@@ -6265,7 +6265,7 @@
           <p:cNvPr id="9" name="CuadroTexto 8">
             <a:extLst>
               <a:ext uri="{FF2B5EF4-FFF2-40B4-BE49-F238E27FC236}">
-                <a16:creationId xmlns:a16="http://schemas.microsoft.com/office/drawing/2014/main" id="{6ECC1234-7648-5BF2-17C8-CFA69A67254D}"/>
+                <a16:creationId xmlns:a16="http://schemas.microsoft.com/office/drawing/2014/main" id="{2C214E30-597D-FEC0-05E2-F3AC74E7DEB8}"/>
               </a:ext>
             </a:extLst>
           </p:cNvPr>
@@ -6305,7 +6305,7 @@
           <p:cNvPr id="10" name="Rectángulo: esquinas redondeadas 9">
             <a:extLst>
               <a:ext uri="{FF2B5EF4-FFF2-40B4-BE49-F238E27FC236}">
-                <a16:creationId xmlns:a16="http://schemas.microsoft.com/office/drawing/2014/main" id="{3AB075FD-EADE-71FA-8BC1-E0A3D54430C3}"/>
+                <a16:creationId xmlns:a16="http://schemas.microsoft.com/office/drawing/2014/main" id="{98FCAEE6-CF8C-4E2F-0F19-93531F6094D9}"/>
               </a:ext>
             </a:extLst>
           </p:cNvPr>
@@ -6359,7 +6359,7 @@
           <p:cNvPr id="11" name="CuadroTexto 10">
             <a:extLst>
               <a:ext uri="{FF2B5EF4-FFF2-40B4-BE49-F238E27FC236}">
-                <a16:creationId xmlns:a16="http://schemas.microsoft.com/office/drawing/2014/main" id="{539C3D89-7AF7-DA66-C54C-10F62C7AA264}"/>
+                <a16:creationId xmlns:a16="http://schemas.microsoft.com/office/drawing/2014/main" id="{C9DD5221-CB77-3946-945B-ED03C56B4F18}"/>
               </a:ext>
             </a:extLst>
           </p:cNvPr>
@@ -6399,7 +6399,7 @@
           <p:cNvPr id="12" name="CuadroTexto 11">
             <a:extLst>
               <a:ext uri="{FF2B5EF4-FFF2-40B4-BE49-F238E27FC236}">
-                <a16:creationId xmlns:a16="http://schemas.microsoft.com/office/drawing/2014/main" id="{AC7C1ADE-DAA9-F727-DA5D-FB4A5DBDBE8F}"/>
+                <a16:creationId xmlns:a16="http://schemas.microsoft.com/office/drawing/2014/main" id="{56A59FD6-B3A1-CD70-9DE0-3E8780A7FAA4}"/>
               </a:ext>
             </a:extLst>
           </p:cNvPr>
@@ -6439,7 +6439,7 @@
           <p:cNvPr id="13" name="Rectángulo: esquinas redondeadas 12">
             <a:extLst>
               <a:ext uri="{FF2B5EF4-FFF2-40B4-BE49-F238E27FC236}">
-                <a16:creationId xmlns:a16="http://schemas.microsoft.com/office/drawing/2014/main" id="{024337F6-C3C6-F30A-6583-BFFAD9BCD1D7}"/>
+                <a16:creationId xmlns:a16="http://schemas.microsoft.com/office/drawing/2014/main" id="{0B1F8AD1-7F45-EF05-0EFE-43C74B89FCF5}"/>
               </a:ext>
             </a:extLst>
           </p:cNvPr>
@@ -6493,7 +6493,7 @@
           <p:cNvPr id="14" name="CuadroTexto 13">
             <a:extLst>
               <a:ext uri="{FF2B5EF4-FFF2-40B4-BE49-F238E27FC236}">
-                <a16:creationId xmlns:a16="http://schemas.microsoft.com/office/drawing/2014/main" id="{ACCF68A8-F6F2-70CC-5887-C54A1EAEAE18}"/>
+                <a16:creationId xmlns:a16="http://schemas.microsoft.com/office/drawing/2014/main" id="{3F364583-14F5-A4A3-5040-F37EDCE902B2}"/>
               </a:ext>
             </a:extLst>
           </p:cNvPr>
@@ -6533,7 +6533,7 @@
           <p:cNvPr id="15" name="CuadroTexto 14">
             <a:extLst>
               <a:ext uri="{FF2B5EF4-FFF2-40B4-BE49-F238E27FC236}">
-                <a16:creationId xmlns:a16="http://schemas.microsoft.com/office/drawing/2014/main" id="{D832274A-EBF8-9206-36A4-2913CDE82274}"/>
+                <a16:creationId xmlns:a16="http://schemas.microsoft.com/office/drawing/2014/main" id="{CF160FCF-4064-F354-0757-E15C94A23CEA}"/>
               </a:ext>
             </a:extLst>
           </p:cNvPr>
@@ -6573,7 +6573,7 @@
           <p:cNvPr id="16" name="CuadroTexto 15">
             <a:extLst>
               <a:ext uri="{FF2B5EF4-FFF2-40B4-BE49-F238E27FC236}">
-                <a16:creationId xmlns:a16="http://schemas.microsoft.com/office/drawing/2014/main" id="{C79D19F7-80E7-224C-A8F0-5FA014DB7486}"/>
+                <a16:creationId xmlns:a16="http://schemas.microsoft.com/office/drawing/2014/main" id="{F42B4C6B-081C-983E-4721-C578D827C133}"/>
               </a:ext>
             </a:extLst>
           </p:cNvPr>
@@ -6656,7 +6656,7 @@
           <p:cNvPr id="17" name="CuadroTexto 16">
             <a:extLst>
               <a:ext uri="{FF2B5EF4-FFF2-40B4-BE49-F238E27FC236}">
-                <a16:creationId xmlns:a16="http://schemas.microsoft.com/office/drawing/2014/main" id="{8E3042E1-1D68-59B5-C091-3A18487C2D4F}"/>
+                <a16:creationId xmlns:a16="http://schemas.microsoft.com/office/drawing/2014/main" id="{DDAC2496-CB21-BB79-6A8F-1736264AA6EB}"/>
               </a:ext>
             </a:extLst>
           </p:cNvPr>
@@ -6694,7 +6694,7 @@
     </p:spTree>
     <p:extLst>
       <p:ext uri="{BB962C8B-B14F-4D97-AF65-F5344CB8AC3E}">
-        <p14:creationId xmlns:p14="http://schemas.microsoft.com/office/powerpoint/2010/main" val="2401975934"/>
+        <p14:creationId xmlns:p14="http://schemas.microsoft.com/office/powerpoint/2010/main" val="759711986"/>
       </p:ext>
     </p:extLst>
   </p:cSld>
@@ -6734,7 +6734,7 @@
           <p:cNvPr id="2" name="CuadroTexto 1">
             <a:extLst>
               <a:ext uri="{FF2B5EF4-FFF2-40B4-BE49-F238E27FC236}">
-                <a16:creationId xmlns:a16="http://schemas.microsoft.com/office/drawing/2014/main" id="{C38F03E6-8663-E337-8584-3E34D8AF0123}"/>
+                <a16:creationId xmlns:a16="http://schemas.microsoft.com/office/drawing/2014/main" id="{5F0FB4CF-CD89-070F-975D-674DF1115C7B}"/>
               </a:ext>
             </a:extLst>
           </p:cNvPr>
@@ -6774,7 +6774,7 @@
           <p:cNvPr id="3" name="CuadroTexto 2">
             <a:extLst>
               <a:ext uri="{FF2B5EF4-FFF2-40B4-BE49-F238E27FC236}">
-                <a16:creationId xmlns:a16="http://schemas.microsoft.com/office/drawing/2014/main" id="{D7669304-2C55-A4E6-F092-CCF7B482F334}"/>
+                <a16:creationId xmlns:a16="http://schemas.microsoft.com/office/drawing/2014/main" id="{5C7F7206-889E-083C-0320-557B21F7B36B}"/>
               </a:ext>
             </a:extLst>
           </p:cNvPr>
@@ -6814,7 +6814,7 @@
           <p:cNvPr id="4" name="CuadroTexto 3">
             <a:extLst>
               <a:ext uri="{FF2B5EF4-FFF2-40B4-BE49-F238E27FC236}">
-                <a16:creationId xmlns:a16="http://schemas.microsoft.com/office/drawing/2014/main" id="{9FFB00EA-D6CD-F919-F770-4771792CD503}"/>
+                <a16:creationId xmlns:a16="http://schemas.microsoft.com/office/drawing/2014/main" id="{B1BC3496-DE1B-F1DC-BE3A-CA6209C02ADB}"/>
               </a:ext>
             </a:extLst>
           </p:cNvPr>
@@ -6854,7 +6854,7 @@
           <p:cNvPr id="5" name="Rectángulo: esquinas redondeadas 4">
             <a:extLst>
               <a:ext uri="{FF2B5EF4-FFF2-40B4-BE49-F238E27FC236}">
-                <a16:creationId xmlns:a16="http://schemas.microsoft.com/office/drawing/2014/main" id="{775C0131-DC1E-0995-3E0A-AF28EEBD93FF}"/>
+                <a16:creationId xmlns:a16="http://schemas.microsoft.com/office/drawing/2014/main" id="{63E13D95-BD0D-3E84-2634-A940742D71A5}"/>
               </a:ext>
             </a:extLst>
           </p:cNvPr>
@@ -6908,7 +6908,7 @@
           <p:cNvPr id="6" name="CuadroTexto 5">
             <a:extLst>
               <a:ext uri="{FF2B5EF4-FFF2-40B4-BE49-F238E27FC236}">
-                <a16:creationId xmlns:a16="http://schemas.microsoft.com/office/drawing/2014/main" id="{131B2301-D864-05E7-D62E-A28673A18ACB}"/>
+                <a16:creationId xmlns:a16="http://schemas.microsoft.com/office/drawing/2014/main" id="{4E7E188B-4D9F-3058-AD3A-65F08844F2E9}"/>
               </a:ext>
             </a:extLst>
           </p:cNvPr>
@@ -6938,7 +6938,7 @@
                 </a:solidFill>
                 <a:latin typeface="Consolas" panose="020B0609020204030204" pitchFamily="49" charset="0"/>
               </a:rPr>
-              <a:t>https://agora.34.175.224.87.nip.io/app   |   https://agora.34.175.224.87.nip.io/externo</a:t>
+              <a:t>\https://agora.34.175.225.98.nip.io/app   |   https://agora.34.175.225.98.nip.io/externo\</a:t>
             </a:r>
           </a:p>
         </p:txBody>
@@ -6948,7 +6948,7 @@
           <p:cNvPr id="7" name="CuadroTexto 6">
             <a:extLst>
               <a:ext uri="{FF2B5EF4-FFF2-40B4-BE49-F238E27FC236}">
-                <a16:creationId xmlns:a16="http://schemas.microsoft.com/office/drawing/2014/main" id="{09A2E840-415C-A105-E2E4-F36E50BEC8C1}"/>
+                <a16:creationId xmlns:a16="http://schemas.microsoft.com/office/drawing/2014/main" id="{BF17D35A-B719-4E36-CAF5-9BF82D8F1071}"/>
               </a:ext>
             </a:extLst>
           </p:cNvPr>
@@ -6988,7 +6988,7 @@
           <p:cNvPr id="8" name="Rectángulo: esquinas redondeadas 7">
             <a:extLst>
               <a:ext uri="{FF2B5EF4-FFF2-40B4-BE49-F238E27FC236}">
-                <a16:creationId xmlns:a16="http://schemas.microsoft.com/office/drawing/2014/main" id="{B96C461D-0C13-B400-DE65-C8C17E1EDAEF}"/>
+                <a16:creationId xmlns:a16="http://schemas.microsoft.com/office/drawing/2014/main" id="{777739E0-3CDD-0B09-60EB-C69716BC7E69}"/>
               </a:ext>
             </a:extLst>
           </p:cNvPr>
@@ -7042,7 +7042,7 @@
           <p:cNvPr id="9" name="CuadroTexto 8">
             <a:extLst>
               <a:ext uri="{FF2B5EF4-FFF2-40B4-BE49-F238E27FC236}">
-                <a16:creationId xmlns:a16="http://schemas.microsoft.com/office/drawing/2014/main" id="{61C24002-41E3-D09E-6180-F7D4F214AD45}"/>
+                <a16:creationId xmlns:a16="http://schemas.microsoft.com/office/drawing/2014/main" id="{7051E15C-4CDE-E078-CF5F-A8410C9D6F57}"/>
               </a:ext>
             </a:extLst>
           </p:cNvPr>
@@ -7082,7 +7082,7 @@
           <p:cNvPr id="10" name="CuadroTexto 9">
             <a:extLst>
               <a:ext uri="{FF2B5EF4-FFF2-40B4-BE49-F238E27FC236}">
-                <a16:creationId xmlns:a16="http://schemas.microsoft.com/office/drawing/2014/main" id="{F52D2E50-3C75-1DDF-25F3-8D7CB733BCCD}"/>
+                <a16:creationId xmlns:a16="http://schemas.microsoft.com/office/drawing/2014/main" id="{1B9FCC05-FE2F-3DDE-EB22-D8A363E94EDD}"/>
               </a:ext>
             </a:extLst>
           </p:cNvPr>
@@ -7122,7 +7122,7 @@
           <p:cNvPr id="11" name="CuadroTexto 10">
             <a:extLst>
               <a:ext uri="{FF2B5EF4-FFF2-40B4-BE49-F238E27FC236}">
-                <a16:creationId xmlns:a16="http://schemas.microsoft.com/office/drawing/2014/main" id="{9ECD6467-C862-5541-7997-A449E19DE802}"/>
+                <a16:creationId xmlns:a16="http://schemas.microsoft.com/office/drawing/2014/main" id="{089B4889-BC9D-173C-5933-8C4A572F9949}"/>
               </a:ext>
             </a:extLst>
           </p:cNvPr>
@@ -7162,7 +7162,7 @@
           <p:cNvPr id="12" name="CuadroTexto 11">
             <a:extLst>
               <a:ext uri="{FF2B5EF4-FFF2-40B4-BE49-F238E27FC236}">
-                <a16:creationId xmlns:a16="http://schemas.microsoft.com/office/drawing/2014/main" id="{F4EAA11C-71BC-04F4-33B8-98949E8CD521}"/>
+                <a16:creationId xmlns:a16="http://schemas.microsoft.com/office/drawing/2014/main" id="{2F05B17B-A3B5-A69E-0981-D3466A3B8E1B}"/>
               </a:ext>
             </a:extLst>
           </p:cNvPr>
@@ -7243,7 +7243,7 @@
     </p:spTree>
     <p:extLst>
       <p:ext uri="{BB962C8B-B14F-4D97-AF65-F5344CB8AC3E}">
-        <p14:creationId xmlns:p14="http://schemas.microsoft.com/office/powerpoint/2010/main" val="3749847170"/>
+        <p14:creationId xmlns:p14="http://schemas.microsoft.com/office/powerpoint/2010/main" val="3028307808"/>
       </p:ext>
     </p:extLst>
   </p:cSld>
@@ -7283,7 +7283,7 @@
           <p:cNvPr id="2" name="CuadroTexto 1">
             <a:extLst>
               <a:ext uri="{FF2B5EF4-FFF2-40B4-BE49-F238E27FC236}">
-                <a16:creationId xmlns:a16="http://schemas.microsoft.com/office/drawing/2014/main" id="{20508CD6-6468-D198-6001-C125F543EE51}"/>
+                <a16:creationId xmlns:a16="http://schemas.microsoft.com/office/drawing/2014/main" id="{8E51F231-1E7D-E7AD-827B-E4C65A6DCF35}"/>
               </a:ext>
             </a:extLst>
           </p:cNvPr>
@@ -7313,7 +7313,7 @@
                 </a:solidFill>
                 <a:latin typeface="Segoe UI" panose="020B0502040204020203" pitchFamily="34" charset="0"/>
               </a:rPr>
-              <a:t>15 / MEJORAS FUTURAS</a:t>
+              <a:t>15 / ALCANCE Y FUTURO</a:t>
             </a:r>
           </a:p>
         </p:txBody>
@@ -7323,7 +7323,7 @@
           <p:cNvPr id="3" name="CuadroTexto 2">
             <a:extLst>
               <a:ext uri="{FF2B5EF4-FFF2-40B4-BE49-F238E27FC236}">
-                <a16:creationId xmlns:a16="http://schemas.microsoft.com/office/drawing/2014/main" id="{53A3F14B-A356-0585-8C75-B8A0FD06430D}"/>
+                <a16:creationId xmlns:a16="http://schemas.microsoft.com/office/drawing/2014/main" id="{D6A07F55-8824-6286-A146-199FCAA61FFB}"/>
               </a:ext>
             </a:extLst>
           </p:cNvPr>
@@ -7353,7 +7353,7 @@
                 </a:solidFill>
                 <a:latin typeface="Segoe UI" panose="020B0502040204020203" pitchFamily="34" charset="0"/>
               </a:rPr>
-              <a:t>Que endureceria despues de esta entrega</a:t>
+              <a:t>Que queda cerrado y que se deja para despues</a:t>
             </a:r>
           </a:p>
         </p:txBody>
@@ -7363,7 +7363,7 @@
           <p:cNvPr id="4" name="CuadroTexto 3">
             <a:extLst>
               <a:ext uri="{FF2B5EF4-FFF2-40B4-BE49-F238E27FC236}">
-                <a16:creationId xmlns:a16="http://schemas.microsoft.com/office/drawing/2014/main" id="{6E49CF37-C0F0-5094-6378-3E4859EACAB8}"/>
+                <a16:creationId xmlns:a16="http://schemas.microsoft.com/office/drawing/2014/main" id="{078925B0-E651-5AE9-EFB4-EA603AB409C8}"/>
               </a:ext>
             </a:extLst>
           </p:cNvPr>
@@ -7393,7 +7393,7 @@
                 </a:solidFill>
                 <a:latin typeface="Segoe UI" panose="020B0502040204020203" pitchFamily="34" charset="0"/>
               </a:rPr>
-              <a:t>El nucleo ya esta cerrado; lo siguiente ya no es supervivencia de la demo, sino evolucion del producto.</a:t>
+              <a:t>El nucleo funcional y tecnico ya esta entregado; las mejoras futuras endurecen o amplian, pero no bloquean la defensa.</a:t>
             </a:r>
           </a:p>
         </p:txBody>
@@ -7403,7 +7403,7 @@
           <p:cNvPr id="5" name="Rectángulo: esquinas redondeadas 4">
             <a:extLst>
               <a:ext uri="{FF2B5EF4-FFF2-40B4-BE49-F238E27FC236}">
-                <a16:creationId xmlns:a16="http://schemas.microsoft.com/office/drawing/2014/main" id="{0A731536-B4DF-AFA1-DA9C-FC63CF39A62B}"/>
+                <a16:creationId xmlns:a16="http://schemas.microsoft.com/office/drawing/2014/main" id="{AA852CD0-3EE1-5723-C376-C21446197A0A}"/>
               </a:ext>
             </a:extLst>
           </p:cNvPr>
@@ -7412,18 +7412,18 @@
         </p:nvSpPr>
         <p:spPr>
           <a:xfrm>
-            <a:off x="711200" y="2235200"/>
-            <a:ext cx="3200400" cy="2235200"/>
+            <a:off x="711200" y="2159000"/>
+            <a:ext cx="3429000" cy="2717800"/>
           </a:xfrm>
           <a:prstGeom prst="roundRect">
             <a:avLst/>
           </a:prstGeom>
           <a:solidFill>
-            <a:srgbClr val="F7FAFC"/>
+            <a:srgbClr val="1D2430"/>
           </a:solidFill>
           <a:ln w="12700">
             <a:solidFill>
-              <a:srgbClr val="DDE5EE"/>
+              <a:srgbClr val="424E60"/>
             </a:solidFill>
           </a:ln>
         </p:spPr>
@@ -7457,37 +7457,37 @@
           <p:cNvPr id="6" name="CuadroTexto 5">
             <a:extLst>
               <a:ext uri="{FF2B5EF4-FFF2-40B4-BE49-F238E27FC236}">
-                <a16:creationId xmlns:a16="http://schemas.microsoft.com/office/drawing/2014/main" id="{99C73E3B-28FC-3EEF-8394-3690362BFA4C}"/>
-              </a:ext>
-            </a:extLst>
-          </p:cNvPr>
-          <p:cNvSpPr txBox="1"/>
-          <p:nvPr/>
-        </p:nvSpPr>
-        <p:spPr>
-          <a:xfrm>
-            <a:off x="965200" y="2489200"/>
-            <a:ext cx="2413000" cy="369332"/>
-          </a:xfrm>
-          <a:prstGeom prst="rect">
-            <a:avLst/>
-          </a:prstGeom>
-          <a:noFill/>
-        </p:spPr>
-        <p:txBody>
-          <a:bodyPr vert="horz" wrap="square" lIns="0" tIns="0" rIns="0" bIns="0" rtlCol="0">
-            <a:noAutofit/>
-          </a:bodyPr>
-          <a:lstStyle/>
-          <a:p>
-            <a:r>
-              <a:rPr lang="es-ES" sz="2100" b="1">
-                <a:solidFill>
-                  <a:srgbClr val="41A772"/>
-                </a:solidFill>
-                <a:latin typeface="Segoe UI" panose="020B0502040204020203" pitchFamily="34" charset="0"/>
-              </a:rPr>
-              <a:t>Dominio propio</a:t>
+                <a16:creationId xmlns:a16="http://schemas.microsoft.com/office/drawing/2014/main" id="{2DE079E2-AE49-42F3-66A0-AAA119027BDB}"/>
+              </a:ext>
+            </a:extLst>
+          </p:cNvPr>
+          <p:cNvSpPr txBox="1"/>
+          <p:nvPr/>
+        </p:nvSpPr>
+        <p:spPr>
+          <a:xfrm>
+            <a:off x="1016000" y="2438400"/>
+            <a:ext cx="2667000" cy="369332"/>
+          </a:xfrm>
+          <a:prstGeom prst="rect">
+            <a:avLst/>
+          </a:prstGeom>
+          <a:noFill/>
+        </p:spPr>
+        <p:txBody>
+          <a:bodyPr vert="horz" wrap="square" lIns="0" tIns="0" rIns="0" bIns="0" rtlCol="0">
+            <a:noAutofit/>
+          </a:bodyPr>
+          <a:lstStyle/>
+          <a:p>
+            <a:r>
+              <a:rPr lang="es-ES" sz="2000" b="1">
+                <a:solidFill>
+                  <a:srgbClr val="DBA14D"/>
+                </a:solidFill>
+                <a:latin typeface="Segoe UI" panose="020B0502040204020203" pitchFamily="34" charset="0"/>
+              </a:rPr>
+              <a:t>Cerrado en esta entrega</a:t>
             </a:r>
           </a:p>
         </p:txBody>
@@ -7497,37 +7497,98 @@
           <p:cNvPr id="7" name="CuadroTexto 6">
             <a:extLst>
               <a:ext uri="{FF2B5EF4-FFF2-40B4-BE49-F238E27FC236}">
-                <a16:creationId xmlns:a16="http://schemas.microsoft.com/office/drawing/2014/main" id="{05BB407F-34E6-33CE-ECE6-E7917496A74D}"/>
-              </a:ext>
-            </a:extLst>
-          </p:cNvPr>
-          <p:cNvSpPr txBox="1"/>
-          <p:nvPr/>
-        </p:nvSpPr>
-        <p:spPr>
-          <a:xfrm>
-            <a:off x="965200" y="2997200"/>
-            <a:ext cx="2667000" cy="369332"/>
-          </a:xfrm>
-          <a:prstGeom prst="rect">
-            <a:avLst/>
-          </a:prstGeom>
-          <a:noFill/>
-        </p:spPr>
-        <p:txBody>
-          <a:bodyPr vert="horz" wrap="square" lIns="0" tIns="0" rIns="0" bIns="0" rtlCol="0">
-            <a:noAutofit/>
-          </a:bodyPr>
-          <a:lstStyle/>
-          <a:p>
+                <a16:creationId xmlns:a16="http://schemas.microsoft.com/office/drawing/2014/main" id="{36F98B91-B093-46C9-3661-843B002CF8BB}"/>
+              </a:ext>
+            </a:extLst>
+          </p:cNvPr>
+          <p:cNvSpPr txBox="1"/>
+          <p:nvPr/>
+        </p:nvSpPr>
+        <p:spPr>
+          <a:xfrm>
+            <a:off x="1041400" y="2946400"/>
+            <a:ext cx="2692400" cy="369332"/>
+          </a:xfrm>
+          <a:prstGeom prst="rect">
+            <a:avLst/>
+          </a:prstGeom>
+          <a:noFill/>
+        </p:spPr>
+        <p:txBody>
+          <a:bodyPr vert="horz" wrap="square" lIns="0" tIns="0" rIns="0" bIns="0" rtlCol="0">
+            <a:noAutofit/>
+          </a:bodyPr>
+          <a:lstStyle/>
+          <a:p>
+            <a:pPr marL="342900" indent="-342900">
+              <a:spcAft>
+                <a:spcPts val="1000"/>
+              </a:spcAft>
+              <a:buFont typeface="+mj-lt"/>
+              <a:buChar char="•"/>
+            </a:pPr>
             <a:r>
               <a:rPr lang="es-ES" sz="1400">
                 <a:solidFill>
-                  <a:srgbClr val="1F2937"/>
-                </a:solidFill>
-                <a:latin typeface="Segoe UI" panose="020B0502040204020203" pitchFamily="34" charset="0"/>
-              </a:rPr>
-              <a:t>Sustituir nip.io por dominio institucional y reforzar politicas TLS.</a:t>
+                  <a:srgbClr val="F6F8FC"/>
+                </a:solidFill>
+                <a:latin typeface="Segoe UI" panose="020B0502040204020203" pitchFamily="34" charset="0"/>
+              </a:rPr>
+              <a:t>Portales /app y /externo bajo HTTPS.</a:t>
+            </a:r>
+          </a:p>
+          <a:p>
+            <a:pPr marL="342900" indent="-342900">
+              <a:spcAft>
+                <a:spcPts val="1000"/>
+              </a:spcAft>
+              <a:buFont typeface="+mj-lt"/>
+              <a:buChar char="•"/>
+            </a:pPr>
+            <a:r>
+              <a:rPr lang="es-ES" sz="1400">
+                <a:solidFill>
+                  <a:srgbClr val="F6F8FC"/>
+                </a:solidFill>
+                <a:latin typeface="Segoe UI" panose="020B0502040204020203" pitchFamily="34" charset="0"/>
+              </a:rPr>
+              <a:t>Correo real, documentos, chat y exportacion.</a:t>
+            </a:r>
+          </a:p>
+          <a:p>
+            <a:pPr marL="342900" indent="-342900">
+              <a:spcAft>
+                <a:spcPts val="1000"/>
+              </a:spcAft>
+              <a:buFont typeface="+mj-lt"/>
+              <a:buChar char="•"/>
+            </a:pPr>
+            <a:r>
+              <a:rPr lang="es-ES" sz="1400">
+                <a:solidFill>
+                  <a:srgbClr val="F6F8FC"/>
+                </a:solidFill>
+                <a:latin typeface="Segoe UI" panose="020B0502040204020203" pitchFamily="34" charset="0"/>
+              </a:rPr>
+              <a:t>Agora Desktop local/cloud como consola tecnica.</a:t>
+            </a:r>
+          </a:p>
+          <a:p>
+            <a:pPr marL="342900" indent="-342900">
+              <a:spcAft>
+                <a:spcPts val="1000"/>
+              </a:spcAft>
+              <a:buFont typeface="+mj-lt"/>
+              <a:buChar char="•"/>
+            </a:pPr>
+            <a:r>
+              <a:rPr lang="es-ES" sz="1400">
+                <a:solidFill>
+                  <a:srgbClr val="F6F8FC"/>
+                </a:solidFill>
+                <a:latin typeface="Segoe UI" panose="020B0502040204020203" pitchFamily="34" charset="0"/>
+              </a:rPr>
+              <a:t>VM publica con arranque automatico y URL efectiva visible.</a:t>
             </a:r>
           </a:p>
         </p:txBody>
@@ -7537,7 +7598,7 @@
           <p:cNvPr id="8" name="Rectángulo: esquinas redondeadas 7">
             <a:extLst>
               <a:ext uri="{FF2B5EF4-FFF2-40B4-BE49-F238E27FC236}">
-                <a16:creationId xmlns:a16="http://schemas.microsoft.com/office/drawing/2014/main" id="{DB83EC71-8DCE-6D32-C673-B47194A22729}"/>
+                <a16:creationId xmlns:a16="http://schemas.microsoft.com/office/drawing/2014/main" id="{74C16484-179F-948D-1235-7EF55B1AC959}"/>
               </a:ext>
             </a:extLst>
           </p:cNvPr>
@@ -7546,8 +7607,8 @@
         </p:nvSpPr>
         <p:spPr>
           <a:xfrm>
-            <a:off x="4495800" y="2235200"/>
-            <a:ext cx="3200400" cy="2235200"/>
+            <a:off x="4521200" y="2235200"/>
+            <a:ext cx="3098800" cy="1219200"/>
           </a:xfrm>
           <a:prstGeom prst="roundRect">
             <a:avLst/>
@@ -7591,37 +7652,37 @@
           <p:cNvPr id="9" name="CuadroTexto 8">
             <a:extLst>
               <a:ext uri="{FF2B5EF4-FFF2-40B4-BE49-F238E27FC236}">
-                <a16:creationId xmlns:a16="http://schemas.microsoft.com/office/drawing/2014/main" id="{E08A1FC8-58B3-9590-68E1-40717831FB84}"/>
-              </a:ext>
-            </a:extLst>
-          </p:cNvPr>
-          <p:cNvSpPr txBox="1"/>
-          <p:nvPr/>
-        </p:nvSpPr>
-        <p:spPr>
-          <a:xfrm>
-            <a:off x="4749800" y="2489200"/>
-            <a:ext cx="2413000" cy="369332"/>
-          </a:xfrm>
-          <a:prstGeom prst="rect">
-            <a:avLst/>
-          </a:prstGeom>
-          <a:noFill/>
-        </p:spPr>
-        <p:txBody>
-          <a:bodyPr vert="horz" wrap="square" lIns="0" tIns="0" rIns="0" bIns="0" rtlCol="0">
-            <a:noAutofit/>
-          </a:bodyPr>
-          <a:lstStyle/>
-          <a:p>
-            <a:r>
-              <a:rPr lang="es-ES" sz="2100" b="1">
-                <a:solidFill>
-                  <a:srgbClr val="49B1D2"/>
-                </a:solidFill>
-                <a:latin typeface="Segoe UI" panose="020B0502040204020203" pitchFamily="34" charset="0"/>
-              </a:rPr>
-              <a:t>Servicios gestionados</a:t>
+                <a16:creationId xmlns:a16="http://schemas.microsoft.com/office/drawing/2014/main" id="{851C70E0-2004-1722-7EA1-48395F4ABB40}"/>
+              </a:ext>
+            </a:extLst>
+          </p:cNvPr>
+          <p:cNvSpPr txBox="1"/>
+          <p:nvPr/>
+        </p:nvSpPr>
+        <p:spPr>
+          <a:xfrm>
+            <a:off x="4749800" y="2413000"/>
+            <a:ext cx="2387600" cy="369332"/>
+          </a:xfrm>
+          <a:prstGeom prst="rect">
+            <a:avLst/>
+          </a:prstGeom>
+          <a:noFill/>
+        </p:spPr>
+        <p:txBody>
+          <a:bodyPr vert="horz" wrap="square" lIns="0" tIns="0" rIns="0" bIns="0" rtlCol="0">
+            <a:noAutofit/>
+          </a:bodyPr>
+          <a:lstStyle/>
+          <a:p>
+            <a:r>
+              <a:rPr lang="es-ES" b="1">
+                <a:solidFill>
+                  <a:srgbClr val="41A772"/>
+                </a:solidFill>
+                <a:latin typeface="Segoe UI" panose="020B0502040204020203" pitchFamily="34" charset="0"/>
+              </a:rPr>
+              <a:t>Dominio propio</a:t>
             </a:r>
           </a:p>
         </p:txBody>
@@ -7631,37 +7692,37 @@
           <p:cNvPr id="10" name="CuadroTexto 9">
             <a:extLst>
               <a:ext uri="{FF2B5EF4-FFF2-40B4-BE49-F238E27FC236}">
-                <a16:creationId xmlns:a16="http://schemas.microsoft.com/office/drawing/2014/main" id="{085BA0E7-B0B5-2E7A-A585-03D27E5375DF}"/>
-              </a:ext>
-            </a:extLst>
-          </p:cNvPr>
-          <p:cNvSpPr txBox="1"/>
-          <p:nvPr/>
-        </p:nvSpPr>
-        <p:spPr>
-          <a:xfrm>
-            <a:off x="4749800" y="2997200"/>
-            <a:ext cx="2667000" cy="369332"/>
-          </a:xfrm>
-          <a:prstGeom prst="rect">
-            <a:avLst/>
-          </a:prstGeom>
-          <a:noFill/>
-        </p:spPr>
-        <p:txBody>
-          <a:bodyPr vert="horz" wrap="square" lIns="0" tIns="0" rIns="0" bIns="0" rtlCol="0">
-            <a:noAutofit/>
-          </a:bodyPr>
-          <a:lstStyle/>
-          <a:p>
-            <a:r>
-              <a:rPr lang="es-ES" sz="1400">
+                <a16:creationId xmlns:a16="http://schemas.microsoft.com/office/drawing/2014/main" id="{945528F9-0721-F0D3-0105-E496A9E7C058}"/>
+              </a:ext>
+            </a:extLst>
+          </p:cNvPr>
+          <p:cNvSpPr txBox="1"/>
+          <p:nvPr/>
+        </p:nvSpPr>
+        <p:spPr>
+          <a:xfrm>
+            <a:off x="4749800" y="2768600"/>
+            <a:ext cx="2540000" cy="369332"/>
+          </a:xfrm>
+          <a:prstGeom prst="rect">
+            <a:avLst/>
+          </a:prstGeom>
+          <a:noFill/>
+        </p:spPr>
+        <p:txBody>
+          <a:bodyPr vert="horz" wrap="square" lIns="0" tIns="0" rIns="0" bIns="0" rtlCol="0">
+            <a:noAutofit/>
+          </a:bodyPr>
+          <a:lstStyle/>
+          <a:p>
+            <a:r>
+              <a:rPr lang="es-ES" sz="1300">
                 <a:solidFill>
                   <a:srgbClr val="1F2937"/>
                 </a:solidFill>
                 <a:latin typeface="Segoe UI" panose="020B0502040204020203" pitchFamily="34" charset="0"/>
               </a:rPr>
-              <a:t>Mover documentos, backups y observabilidad a piezas gestionadas.</a:t>
+              <a:t>Sustituir nip.io por dominio institucional y reforzar TLS.</a:t>
             </a:r>
           </a:p>
         </p:txBody>
@@ -7671,7 +7732,7 @@
           <p:cNvPr id="11" name="Rectángulo: esquinas redondeadas 10">
             <a:extLst>
               <a:ext uri="{FF2B5EF4-FFF2-40B4-BE49-F238E27FC236}">
-                <a16:creationId xmlns:a16="http://schemas.microsoft.com/office/drawing/2014/main" id="{6031C002-AC0B-8471-4EDA-05DB9C42AAB3}"/>
+                <a16:creationId xmlns:a16="http://schemas.microsoft.com/office/drawing/2014/main" id="{B550BF39-F121-99FE-187D-A38C3EC382E5}"/>
               </a:ext>
             </a:extLst>
           </p:cNvPr>
@@ -7680,8 +7741,8 @@
         </p:nvSpPr>
         <p:spPr>
           <a:xfrm>
-            <a:off x="8280400" y="2235200"/>
-            <a:ext cx="3200400" cy="2235200"/>
+            <a:off x="7975600" y="2235200"/>
+            <a:ext cx="3098800" cy="1219200"/>
           </a:xfrm>
           <a:prstGeom prst="roundRect">
             <a:avLst/>
@@ -7725,31 +7786,165 @@
           <p:cNvPr id="12" name="CuadroTexto 11">
             <a:extLst>
               <a:ext uri="{FF2B5EF4-FFF2-40B4-BE49-F238E27FC236}">
-                <a16:creationId xmlns:a16="http://schemas.microsoft.com/office/drawing/2014/main" id="{BEF38A84-BC89-66DB-3F38-42F3AC9B73D4}"/>
-              </a:ext>
-            </a:extLst>
-          </p:cNvPr>
-          <p:cNvSpPr txBox="1"/>
-          <p:nvPr/>
-        </p:nvSpPr>
-        <p:spPr>
-          <a:xfrm>
-            <a:off x="8534400" y="2489200"/>
-            <a:ext cx="2413000" cy="369332"/>
-          </a:xfrm>
-          <a:prstGeom prst="rect">
-            <a:avLst/>
-          </a:prstGeom>
-          <a:noFill/>
-        </p:spPr>
-        <p:txBody>
-          <a:bodyPr vert="horz" wrap="square" lIns="0" tIns="0" rIns="0" bIns="0" rtlCol="0">
-            <a:noAutofit/>
-          </a:bodyPr>
-          <a:lstStyle/>
-          <a:p>
-            <a:r>
-              <a:rPr lang="es-ES" sz="2100" b="1">
+                <a16:creationId xmlns:a16="http://schemas.microsoft.com/office/drawing/2014/main" id="{CACB2135-DC71-12CE-5D2E-A01E7101CA06}"/>
+              </a:ext>
+            </a:extLst>
+          </p:cNvPr>
+          <p:cNvSpPr txBox="1"/>
+          <p:nvPr/>
+        </p:nvSpPr>
+        <p:spPr>
+          <a:xfrm>
+            <a:off x="8204200" y="2413000"/>
+            <a:ext cx="2387600" cy="369332"/>
+          </a:xfrm>
+          <a:prstGeom prst="rect">
+            <a:avLst/>
+          </a:prstGeom>
+          <a:noFill/>
+        </p:spPr>
+        <p:txBody>
+          <a:bodyPr vert="horz" wrap="square" lIns="0" tIns="0" rIns="0" bIns="0" rtlCol="0">
+            <a:noAutofit/>
+          </a:bodyPr>
+          <a:lstStyle/>
+          <a:p>
+            <a:r>
+              <a:rPr lang="es-ES" b="1">
+                <a:solidFill>
+                  <a:srgbClr val="49B1D2"/>
+                </a:solidFill>
+                <a:latin typeface="Segoe UI" panose="020B0502040204020203" pitchFamily="34" charset="0"/>
+              </a:rPr>
+              <a:t>Servicios gestionados</a:t>
+            </a:r>
+          </a:p>
+        </p:txBody>
+      </p:sp>
+      <p:sp>
+        <p:nvSpPr>
+          <p:cNvPr id="13" name="CuadroTexto 12">
+            <a:extLst>
+              <a:ext uri="{FF2B5EF4-FFF2-40B4-BE49-F238E27FC236}">
+                <a16:creationId xmlns:a16="http://schemas.microsoft.com/office/drawing/2014/main" id="{E7E33394-9BF3-B256-128E-9B844C9D4A76}"/>
+              </a:ext>
+            </a:extLst>
+          </p:cNvPr>
+          <p:cNvSpPr txBox="1"/>
+          <p:nvPr/>
+        </p:nvSpPr>
+        <p:spPr>
+          <a:xfrm>
+            <a:off x="8204200" y="2768600"/>
+            <a:ext cx="2540000" cy="369332"/>
+          </a:xfrm>
+          <a:prstGeom prst="rect">
+            <a:avLst/>
+          </a:prstGeom>
+          <a:noFill/>
+        </p:spPr>
+        <p:txBody>
+          <a:bodyPr vert="horz" wrap="square" lIns="0" tIns="0" rIns="0" bIns="0" rtlCol="0">
+            <a:noAutofit/>
+          </a:bodyPr>
+          <a:lstStyle/>
+          <a:p>
+            <a:r>
+              <a:rPr lang="es-ES" sz="1300">
+                <a:solidFill>
+                  <a:srgbClr val="1F2937"/>
+                </a:solidFill>
+                <a:latin typeface="Segoe UI" panose="020B0502040204020203" pitchFamily="34" charset="0"/>
+              </a:rPr>
+              <a:t>Mover documentos, backups y observabilidad a piezas gestionadas.</a:t>
+            </a:r>
+          </a:p>
+        </p:txBody>
+      </p:sp>
+      <p:sp>
+        <p:nvSpPr>
+          <p:cNvPr id="14" name="Rectángulo: esquinas redondeadas 13">
+            <a:extLst>
+              <a:ext uri="{FF2B5EF4-FFF2-40B4-BE49-F238E27FC236}">
+                <a16:creationId xmlns:a16="http://schemas.microsoft.com/office/drawing/2014/main" id="{74F87670-A0B0-8C8D-8B45-F97D1FF83B13}"/>
+              </a:ext>
+            </a:extLst>
+          </p:cNvPr>
+          <p:cNvSpPr/>
+          <p:nvPr/>
+        </p:nvSpPr>
+        <p:spPr>
+          <a:xfrm>
+            <a:off x="4521200" y="3733800"/>
+            <a:ext cx="3098800" cy="1219200"/>
+          </a:xfrm>
+          <a:prstGeom prst="roundRect">
+            <a:avLst/>
+          </a:prstGeom>
+          <a:solidFill>
+            <a:srgbClr val="F7FAFC"/>
+          </a:solidFill>
+          <a:ln w="12700">
+            <a:solidFill>
+              <a:srgbClr val="DDE5EE"/>
+            </a:solidFill>
+          </a:ln>
+        </p:spPr>
+        <p:style>
+          <a:lnRef idx="2">
+            <a:schemeClr val="accent1">
+              <a:shade val="15000"/>
+            </a:schemeClr>
+          </a:lnRef>
+          <a:fillRef idx="1">
+            <a:schemeClr val="accent1"/>
+          </a:fillRef>
+          <a:effectRef idx="0">
+            <a:schemeClr val="accent1"/>
+          </a:effectRef>
+          <a:fontRef idx="minor">
+            <a:schemeClr val="lt1"/>
+          </a:fontRef>
+        </p:style>
+        <p:txBody>
+          <a:bodyPr rtlCol="0" anchor="ctr"/>
+          <a:lstStyle/>
+          <a:p>
+            <a:pPr algn="ctr"/>
+            <a:endParaRPr lang="es-ES"/>
+          </a:p>
+        </p:txBody>
+      </p:sp>
+      <p:sp>
+        <p:nvSpPr>
+          <p:cNvPr id="15" name="CuadroTexto 14">
+            <a:extLst>
+              <a:ext uri="{FF2B5EF4-FFF2-40B4-BE49-F238E27FC236}">
+                <a16:creationId xmlns:a16="http://schemas.microsoft.com/office/drawing/2014/main" id="{FF959876-15DF-D6F2-74ED-3C3464558EF5}"/>
+              </a:ext>
+            </a:extLst>
+          </p:cNvPr>
+          <p:cNvSpPr txBox="1"/>
+          <p:nvPr/>
+        </p:nvSpPr>
+        <p:spPr>
+          <a:xfrm>
+            <a:off x="4749800" y="3911600"/>
+            <a:ext cx="2387600" cy="369332"/>
+          </a:xfrm>
+          <a:prstGeom prst="rect">
+            <a:avLst/>
+          </a:prstGeom>
+          <a:noFill/>
+        </p:spPr>
+        <p:txBody>
+          <a:bodyPr vert="horz" wrap="square" lIns="0" tIns="0" rIns="0" bIns="0" rtlCol="0">
+            <a:noAutofit/>
+          </a:bodyPr>
+          <a:lstStyle/>
+          <a:p>
+            <a:r>
+              <a:rPr lang="es-ES" b="1">
                 <a:solidFill>
                   <a:srgbClr val="DBA14D"/>
                 </a:solidFill>
@@ -7762,59 +7957,59 @@
       </p:sp>
       <p:sp>
         <p:nvSpPr>
-          <p:cNvPr id="13" name="CuadroTexto 12">
-            <a:extLst>
-              <a:ext uri="{FF2B5EF4-FFF2-40B4-BE49-F238E27FC236}">
-                <a16:creationId xmlns:a16="http://schemas.microsoft.com/office/drawing/2014/main" id="{45FD6878-A574-ECCD-F34F-68126FF04248}"/>
-              </a:ext>
-            </a:extLst>
-          </p:cNvPr>
-          <p:cNvSpPr txBox="1"/>
-          <p:nvPr/>
-        </p:nvSpPr>
-        <p:spPr>
-          <a:xfrm>
-            <a:off x="8534400" y="2997200"/>
-            <a:ext cx="2667000" cy="369332"/>
-          </a:xfrm>
-          <a:prstGeom prst="rect">
-            <a:avLst/>
-          </a:prstGeom>
-          <a:noFill/>
-        </p:spPr>
-        <p:txBody>
-          <a:bodyPr vert="horz" wrap="square" lIns="0" tIns="0" rIns="0" bIns="0" rtlCol="0">
-            <a:noAutofit/>
-          </a:bodyPr>
-          <a:lstStyle/>
-          <a:p>
-            <a:r>
-              <a:rPr lang="es-ES" sz="1400">
+          <p:cNvPr id="16" name="CuadroTexto 15">
+            <a:extLst>
+              <a:ext uri="{FF2B5EF4-FFF2-40B4-BE49-F238E27FC236}">
+                <a16:creationId xmlns:a16="http://schemas.microsoft.com/office/drawing/2014/main" id="{D0E17913-F8FB-67D2-AE0E-5139B0B29B4D}"/>
+              </a:ext>
+            </a:extLst>
+          </p:cNvPr>
+          <p:cNvSpPr txBox="1"/>
+          <p:nvPr/>
+        </p:nvSpPr>
+        <p:spPr>
+          <a:xfrm>
+            <a:off x="4749800" y="4267200"/>
+            <a:ext cx="2540000" cy="369332"/>
+          </a:xfrm>
+          <a:prstGeom prst="rect">
+            <a:avLst/>
+          </a:prstGeom>
+          <a:noFill/>
+        </p:spPr>
+        <p:txBody>
+          <a:bodyPr vert="horz" wrap="square" lIns="0" tIns="0" rIns="0" bIns="0" rtlCol="0">
+            <a:noAutofit/>
+          </a:bodyPr>
+          <a:lstStyle/>
+          <a:p>
+            <a:r>
+              <a:rPr lang="es-ES" sz="1300">
                 <a:solidFill>
                   <a:srgbClr val="1F2937"/>
                 </a:solidFill>
                 <a:latin typeface="Segoe UI" panose="020B0502040204020203" pitchFamily="34" charset="0"/>
               </a:rPr>
-              <a:t>Ampliar Agora Desktop con mas automatizacion y soporte operativo sin mezclarlo con negocio.</a:t>
-            </a:r>
-          </a:p>
-        </p:txBody>
-      </p:sp>
-      <p:sp>
-        <p:nvSpPr>
-          <p:cNvPr id="14" name="CuadroTexto 13">
-            <a:extLst>
-              <a:ext uri="{FF2B5EF4-FFF2-40B4-BE49-F238E27FC236}">
-                <a16:creationId xmlns:a16="http://schemas.microsoft.com/office/drawing/2014/main" id="{05788005-402F-E948-3B31-51A2E3F487E4}"/>
-              </a:ext>
-            </a:extLst>
-          </p:cNvPr>
-          <p:cNvSpPr txBox="1"/>
-          <p:nvPr/>
-        </p:nvSpPr>
-        <p:spPr>
-          <a:xfrm>
-            <a:off x="1117600" y="4978400"/>
+              <a:t>Ampliar Agora Desktop sin mezclar soporte con negocio.</a:t>
+            </a:r>
+          </a:p>
+        </p:txBody>
+      </p:sp>
+      <p:sp>
+        <p:nvSpPr>
+          <p:cNvPr id="17" name="CuadroTexto 16">
+            <a:extLst>
+              <a:ext uri="{FF2B5EF4-FFF2-40B4-BE49-F238E27FC236}">
+                <a16:creationId xmlns:a16="http://schemas.microsoft.com/office/drawing/2014/main" id="{B378EAFC-3006-CD25-E501-646865FCD7EF}"/>
+              </a:ext>
+            </a:extLst>
+          </p:cNvPr>
+          <p:cNvSpPr txBox="1"/>
+          <p:nvPr/>
+        </p:nvSpPr>
+        <p:spPr>
+          <a:xfrm>
+            <a:off x="1016000" y="5257800"/>
             <a:ext cx="9652000" cy="369332"/>
           </a:xfrm>
           <a:prstGeom prst="rect">
@@ -7842,7 +8037,7 @@
                 </a:solidFill>
                 <a:latin typeface="Segoe UI" panose="020B0502040204020203" pitchFamily="34" charset="0"/>
               </a:rPr>
-              <a:t>Mantendria PostgreSQL en servidor y endureceria automatizacion, dominio y observabilidad.</a:t>
+              <a:t>La prioridad futura no es anadir modulos sin control, sino endurecer despliegue, seguridad y soporte.</a:t>
             </a:r>
           </a:p>
           <a:p>
@@ -7860,7 +8055,7 @@
                 </a:solidFill>
                 <a:latin typeface="Segoe UI" panose="020B0502040204020203" pitchFamily="34" charset="0"/>
               </a:rPr>
-              <a:t>No meteria nuevas funciones secundarias sin cerrar antes seguridad, pruebas y operacion.</a:t>
+              <a:t>Las funciones secundarias quedan identificadas para justificar con claridad el recorte de alcance.</a:t>
             </a:r>
           </a:p>
         </p:txBody>
@@ -7868,7 +8063,7 @@
     </p:spTree>
     <p:extLst>
       <p:ext uri="{BB962C8B-B14F-4D97-AF65-F5344CB8AC3E}">
-        <p14:creationId xmlns:p14="http://schemas.microsoft.com/office/powerpoint/2010/main" val="1748892430"/>
+        <p14:creationId xmlns:p14="http://schemas.microsoft.com/office/powerpoint/2010/main" val="1522264340"/>
       </p:ext>
     </p:extLst>
   </p:cSld>
@@ -7908,7 +8103,7 @@
           <p:cNvPr id="2" name="CuadroTexto 1">
             <a:extLst>
               <a:ext uri="{FF2B5EF4-FFF2-40B4-BE49-F238E27FC236}">
-                <a16:creationId xmlns:a16="http://schemas.microsoft.com/office/drawing/2014/main" id="{43215732-2E6D-AB1D-FFB4-12A7886A87E4}"/>
+                <a16:creationId xmlns:a16="http://schemas.microsoft.com/office/drawing/2014/main" id="{8069A607-44EF-AE13-4F64-E9B2D84C16DE}"/>
               </a:ext>
             </a:extLst>
           </p:cNvPr>
@@ -7948,7 +8143,7 @@
           <p:cNvPr id="3" name="CuadroTexto 2">
             <a:extLst>
               <a:ext uri="{FF2B5EF4-FFF2-40B4-BE49-F238E27FC236}">
-                <a16:creationId xmlns:a16="http://schemas.microsoft.com/office/drawing/2014/main" id="{5D98BB5E-EC7D-5564-5D12-236DDDD63197}"/>
+                <a16:creationId xmlns:a16="http://schemas.microsoft.com/office/drawing/2014/main" id="{99A40C62-02FE-C640-BD1E-90404F80B611}"/>
               </a:ext>
             </a:extLst>
           </p:cNvPr>
@@ -7988,7 +8183,7 @@
           <p:cNvPr id="4" name="CuadroTexto 3">
             <a:extLst>
               <a:ext uri="{FF2B5EF4-FFF2-40B4-BE49-F238E27FC236}">
-                <a16:creationId xmlns:a16="http://schemas.microsoft.com/office/drawing/2014/main" id="{7D676BF3-C9F4-2AB6-082C-716A5D2638F2}"/>
+                <a16:creationId xmlns:a16="http://schemas.microsoft.com/office/drawing/2014/main" id="{601787B8-5160-C0C1-1826-57FA5A07D3FB}"/>
               </a:ext>
             </a:extLst>
           </p:cNvPr>
@@ -8107,7 +8302,7 @@
           <p:cNvPr id="5" name="Rectángulo: esquinas redondeadas 4">
             <a:extLst>
               <a:ext uri="{FF2B5EF4-FFF2-40B4-BE49-F238E27FC236}">
-                <a16:creationId xmlns:a16="http://schemas.microsoft.com/office/drawing/2014/main" id="{8F097D6B-2939-4359-E9E7-729A7B3B29F4}"/>
+                <a16:creationId xmlns:a16="http://schemas.microsoft.com/office/drawing/2014/main" id="{4F55DC18-479C-7B46-E29B-BFFB7497920C}"/>
               </a:ext>
             </a:extLst>
           </p:cNvPr>
@@ -8161,7 +8356,7 @@
           <p:cNvPr id="6" name="CuadroTexto 5">
             <a:extLst>
               <a:ext uri="{FF2B5EF4-FFF2-40B4-BE49-F238E27FC236}">
-                <a16:creationId xmlns:a16="http://schemas.microsoft.com/office/drawing/2014/main" id="{1AD83F5D-CFDF-120C-0FDD-91EDA33F66D7}"/>
+                <a16:creationId xmlns:a16="http://schemas.microsoft.com/office/drawing/2014/main" id="{634E4C24-1246-CA54-8DEA-08216E760F0A}"/>
               </a:ext>
             </a:extLst>
           </p:cNvPr>
@@ -8201,7 +8396,7 @@
           <p:cNvPr id="7" name="CuadroTexto 6">
             <a:extLst>
               <a:ext uri="{FF2B5EF4-FFF2-40B4-BE49-F238E27FC236}">
-                <a16:creationId xmlns:a16="http://schemas.microsoft.com/office/drawing/2014/main" id="{463B6C04-9057-138B-9F0D-B95AEC196576}"/>
+                <a16:creationId xmlns:a16="http://schemas.microsoft.com/office/drawing/2014/main" id="{439A1E91-491A-279E-8A09-581774AD200B}"/>
               </a:ext>
             </a:extLst>
           </p:cNvPr>
@@ -8239,7 +8434,7 @@
     </p:spTree>
     <p:extLst>
       <p:ext uri="{BB962C8B-B14F-4D97-AF65-F5344CB8AC3E}">
-        <p14:creationId xmlns:p14="http://schemas.microsoft.com/office/powerpoint/2010/main" val="2899676087"/>
+        <p14:creationId xmlns:p14="http://schemas.microsoft.com/office/powerpoint/2010/main" val="4160943323"/>
       </p:ext>
     </p:extLst>
   </p:cSld>
@@ -8279,7 +8474,7 @@
           <p:cNvPr id="2" name="CuadroTexto 1">
             <a:extLst>
               <a:ext uri="{FF2B5EF4-FFF2-40B4-BE49-F238E27FC236}">
-                <a16:creationId xmlns:a16="http://schemas.microsoft.com/office/drawing/2014/main" id="{4A8EE9DF-5270-70E8-C162-AE5DD01AB92F}"/>
+                <a16:creationId xmlns:a16="http://schemas.microsoft.com/office/drawing/2014/main" id="{5B170C3C-125F-D818-9099-2A01248F5CD8}"/>
               </a:ext>
             </a:extLst>
           </p:cNvPr>
@@ -8319,7 +8514,7 @@
           <p:cNvPr id="3" name="CuadroTexto 2">
             <a:extLst>
               <a:ext uri="{FF2B5EF4-FFF2-40B4-BE49-F238E27FC236}">
-                <a16:creationId xmlns:a16="http://schemas.microsoft.com/office/drawing/2014/main" id="{9D13068E-19B9-EDD4-657E-7276DAF3F2F6}"/>
+                <a16:creationId xmlns:a16="http://schemas.microsoft.com/office/drawing/2014/main" id="{C6462AC4-4513-67D4-328B-184046AC558C}"/>
               </a:ext>
             </a:extLst>
           </p:cNvPr>
@@ -8359,7 +8554,7 @@
           <p:cNvPr id="4" name="CuadroTexto 3">
             <a:extLst>
               <a:ext uri="{FF2B5EF4-FFF2-40B4-BE49-F238E27FC236}">
-                <a16:creationId xmlns:a16="http://schemas.microsoft.com/office/drawing/2014/main" id="{BB66D7E4-32FB-EDB8-A063-5BC70E531AEF}"/>
+                <a16:creationId xmlns:a16="http://schemas.microsoft.com/office/drawing/2014/main" id="{B2DCA2D6-AEFB-3994-FA2E-D9BA73A9A5DF}"/>
               </a:ext>
             </a:extLst>
           </p:cNvPr>
@@ -8399,7 +8594,7 @@
           <p:cNvPr id="5" name="CuadroTexto 4">
             <a:extLst>
               <a:ext uri="{FF2B5EF4-FFF2-40B4-BE49-F238E27FC236}">
-                <a16:creationId xmlns:a16="http://schemas.microsoft.com/office/drawing/2014/main" id="{F3C64D0F-89E4-FEB1-086C-F4917583C4F2}"/>
+                <a16:creationId xmlns:a16="http://schemas.microsoft.com/office/drawing/2014/main" id="{9ECA0BE7-DC2E-2E0E-C7D7-53526AC36FF1}"/>
               </a:ext>
             </a:extLst>
           </p:cNvPr>
@@ -8482,7 +8677,7 @@
           <p:cNvPr id="6" name="CuadroTexto 5">
             <a:extLst>
               <a:ext uri="{FF2B5EF4-FFF2-40B4-BE49-F238E27FC236}">
-                <a16:creationId xmlns:a16="http://schemas.microsoft.com/office/drawing/2014/main" id="{5E9AC572-B987-9EA5-C85B-687DEA4EEBE1}"/>
+                <a16:creationId xmlns:a16="http://schemas.microsoft.com/office/drawing/2014/main" id="{8E5B1483-6593-DFB2-7D9A-8932703E00E6}"/>
               </a:ext>
             </a:extLst>
           </p:cNvPr>
@@ -8520,7 +8715,7 @@
     </p:spTree>
     <p:extLst>
       <p:ext uri="{BB962C8B-B14F-4D97-AF65-F5344CB8AC3E}">
-        <p14:creationId xmlns:p14="http://schemas.microsoft.com/office/powerpoint/2010/main" val="3000088455"/>
+        <p14:creationId xmlns:p14="http://schemas.microsoft.com/office/powerpoint/2010/main" val="3551999054"/>
       </p:ext>
     </p:extLst>
   </p:cSld>
@@ -8560,7 +8755,7 @@
           <p:cNvPr id="2" name="CuadroTexto 1">
             <a:extLst>
               <a:ext uri="{FF2B5EF4-FFF2-40B4-BE49-F238E27FC236}">
-                <a16:creationId xmlns:a16="http://schemas.microsoft.com/office/drawing/2014/main" id="{97A99495-7698-35C9-F519-3509243DF9B7}"/>
+                <a16:creationId xmlns:a16="http://schemas.microsoft.com/office/drawing/2014/main" id="{96B59D31-B9DC-D760-A623-8B14531379E7}"/>
               </a:ext>
             </a:extLst>
           </p:cNvPr>
@@ -8600,7 +8795,7 @@
           <p:cNvPr id="3" name="CuadroTexto 2">
             <a:extLst>
               <a:ext uri="{FF2B5EF4-FFF2-40B4-BE49-F238E27FC236}">
-                <a16:creationId xmlns:a16="http://schemas.microsoft.com/office/drawing/2014/main" id="{6473AEC7-F891-C8CF-F621-F8AB92A8A3AA}"/>
+                <a16:creationId xmlns:a16="http://schemas.microsoft.com/office/drawing/2014/main" id="{B252884E-54A6-C4A4-C9AA-79C2474013B4}"/>
               </a:ext>
             </a:extLst>
           </p:cNvPr>
@@ -8640,7 +8835,7 @@
           <p:cNvPr id="4" name="CuadroTexto 3">
             <a:extLst>
               <a:ext uri="{FF2B5EF4-FFF2-40B4-BE49-F238E27FC236}">
-                <a16:creationId xmlns:a16="http://schemas.microsoft.com/office/drawing/2014/main" id="{CBC3D1CE-C197-78B9-9A60-0A88E3B8E328}"/>
+                <a16:creationId xmlns:a16="http://schemas.microsoft.com/office/drawing/2014/main" id="{F383C05F-D800-EA0C-FD31-D2B4376E4045}"/>
               </a:ext>
             </a:extLst>
           </p:cNvPr>
@@ -8680,7 +8875,7 @@
           <p:cNvPr id="5" name="CuadroTexto 4">
             <a:extLst>
               <a:ext uri="{FF2B5EF4-FFF2-40B4-BE49-F238E27FC236}">
-                <a16:creationId xmlns:a16="http://schemas.microsoft.com/office/drawing/2014/main" id="{E0FB9D0D-9935-C4CD-A639-878E061C4E37}"/>
+                <a16:creationId xmlns:a16="http://schemas.microsoft.com/office/drawing/2014/main" id="{8D7DC599-150E-F713-3725-C263E8FEE87A}"/>
               </a:ext>
             </a:extLst>
           </p:cNvPr>
@@ -8781,7 +8976,7 @@
           <p:cNvPr id="6" name="Rectángulo: esquinas redondeadas 5">
             <a:extLst>
               <a:ext uri="{FF2B5EF4-FFF2-40B4-BE49-F238E27FC236}">
-                <a16:creationId xmlns:a16="http://schemas.microsoft.com/office/drawing/2014/main" id="{2379AFE7-7192-0690-5CFC-6D21DABC384B}"/>
+                <a16:creationId xmlns:a16="http://schemas.microsoft.com/office/drawing/2014/main" id="{E507C1D7-4307-CC2D-472B-B68D55694694}"/>
               </a:ext>
             </a:extLst>
           </p:cNvPr>
@@ -8835,7 +9030,7 @@
           <p:cNvPr id="7" name="CuadroTexto 6">
             <a:extLst>
               <a:ext uri="{FF2B5EF4-FFF2-40B4-BE49-F238E27FC236}">
-                <a16:creationId xmlns:a16="http://schemas.microsoft.com/office/drawing/2014/main" id="{4CDFD10E-68AA-CD60-D127-C2BDC01E1210}"/>
+                <a16:creationId xmlns:a16="http://schemas.microsoft.com/office/drawing/2014/main" id="{86F03797-4F39-A9A2-7DD6-11568179228C}"/>
               </a:ext>
             </a:extLst>
           </p:cNvPr>
@@ -8875,7 +9070,7 @@
           <p:cNvPr id="8" name="CuadroTexto 7">
             <a:extLst>
               <a:ext uri="{FF2B5EF4-FFF2-40B4-BE49-F238E27FC236}">
-                <a16:creationId xmlns:a16="http://schemas.microsoft.com/office/drawing/2014/main" id="{F0B2DE3F-31A5-C76F-97EE-CF45D9539F16}"/>
+                <a16:creationId xmlns:a16="http://schemas.microsoft.com/office/drawing/2014/main" id="{A5FC4BE5-DFE4-7689-BE27-E9882E191B66}"/>
               </a:ext>
             </a:extLst>
           </p:cNvPr>
@@ -8913,7 +9108,7 @@
     </p:spTree>
     <p:extLst>
       <p:ext uri="{BB962C8B-B14F-4D97-AF65-F5344CB8AC3E}">
-        <p14:creationId xmlns:p14="http://schemas.microsoft.com/office/powerpoint/2010/main" val="1700853319"/>
+        <p14:creationId xmlns:p14="http://schemas.microsoft.com/office/powerpoint/2010/main" val="534607492"/>
       </p:ext>
     </p:extLst>
   </p:cSld>
@@ -8953,7 +9148,7 @@
           <p:cNvPr id="2" name="CuadroTexto 1">
             <a:extLst>
               <a:ext uri="{FF2B5EF4-FFF2-40B4-BE49-F238E27FC236}">
-                <a16:creationId xmlns:a16="http://schemas.microsoft.com/office/drawing/2014/main" id="{F47EE030-9113-F839-0500-8CD8FF63BCF0}"/>
+                <a16:creationId xmlns:a16="http://schemas.microsoft.com/office/drawing/2014/main" id="{B241425E-B117-BD72-C001-C78EACF704A6}"/>
               </a:ext>
             </a:extLst>
           </p:cNvPr>
@@ -8993,7 +9188,7 @@
           <p:cNvPr id="3" name="CuadroTexto 2">
             <a:extLst>
               <a:ext uri="{FF2B5EF4-FFF2-40B4-BE49-F238E27FC236}">
-                <a16:creationId xmlns:a16="http://schemas.microsoft.com/office/drawing/2014/main" id="{E8C524AC-4C67-81BF-7CCF-69FF8BD63A89}"/>
+                <a16:creationId xmlns:a16="http://schemas.microsoft.com/office/drawing/2014/main" id="{4F66F0AF-F511-E88E-DC69-E191BC124F50}"/>
               </a:ext>
             </a:extLst>
           </p:cNvPr>
@@ -9033,7 +9228,7 @@
           <p:cNvPr id="4" name="Rectángulo: esquinas redondeadas 3">
             <a:extLst>
               <a:ext uri="{FF2B5EF4-FFF2-40B4-BE49-F238E27FC236}">
-                <a16:creationId xmlns:a16="http://schemas.microsoft.com/office/drawing/2014/main" id="{183502EE-D18B-B6A8-0611-2FB4423E8FD7}"/>
+                <a16:creationId xmlns:a16="http://schemas.microsoft.com/office/drawing/2014/main" id="{DF6727A9-78DB-0557-20DD-B8EB7AF51AA6}"/>
               </a:ext>
             </a:extLst>
           </p:cNvPr>
@@ -9087,7 +9282,7 @@
           <p:cNvPr id="5" name="CuadroTexto 4">
             <a:extLst>
               <a:ext uri="{FF2B5EF4-FFF2-40B4-BE49-F238E27FC236}">
-                <a16:creationId xmlns:a16="http://schemas.microsoft.com/office/drawing/2014/main" id="{4F6B2FD9-691B-2B4F-0E7E-1E1921951509}"/>
+                <a16:creationId xmlns:a16="http://schemas.microsoft.com/office/drawing/2014/main" id="{D2FE1F28-F6C0-E5FA-79B4-B95CF15496BE}"/>
               </a:ext>
             </a:extLst>
           </p:cNvPr>
@@ -9127,7 +9322,7 @@
           <p:cNvPr id="6" name="CuadroTexto 5">
             <a:extLst>
               <a:ext uri="{FF2B5EF4-FFF2-40B4-BE49-F238E27FC236}">
-                <a16:creationId xmlns:a16="http://schemas.microsoft.com/office/drawing/2014/main" id="{378FE75E-5B02-6B68-D4F4-DD7679DC86A6}"/>
+                <a16:creationId xmlns:a16="http://schemas.microsoft.com/office/drawing/2014/main" id="{7E44E7F3-F077-3094-A294-5BD32C8BB583}"/>
               </a:ext>
             </a:extLst>
           </p:cNvPr>
@@ -9167,7 +9362,7 @@
           <p:cNvPr id="7" name="Rectángulo: esquinas redondeadas 6">
             <a:extLst>
               <a:ext uri="{FF2B5EF4-FFF2-40B4-BE49-F238E27FC236}">
-                <a16:creationId xmlns:a16="http://schemas.microsoft.com/office/drawing/2014/main" id="{F70DB089-39D2-93F2-93E1-36918E2B0A52}"/>
+                <a16:creationId xmlns:a16="http://schemas.microsoft.com/office/drawing/2014/main" id="{5D920454-09FC-2587-F0DE-D0A7DF7EA35E}"/>
               </a:ext>
             </a:extLst>
           </p:cNvPr>
@@ -9221,7 +9416,7 @@
           <p:cNvPr id="8" name="CuadroTexto 7">
             <a:extLst>
               <a:ext uri="{FF2B5EF4-FFF2-40B4-BE49-F238E27FC236}">
-                <a16:creationId xmlns:a16="http://schemas.microsoft.com/office/drawing/2014/main" id="{6896B342-D52E-797F-C4D1-8C77FA9387B7}"/>
+                <a16:creationId xmlns:a16="http://schemas.microsoft.com/office/drawing/2014/main" id="{9E21D43D-16AD-F5F6-BDFB-84B3AA0B59D1}"/>
               </a:ext>
             </a:extLst>
           </p:cNvPr>
@@ -9261,7 +9456,7 @@
           <p:cNvPr id="9" name="CuadroTexto 8">
             <a:extLst>
               <a:ext uri="{FF2B5EF4-FFF2-40B4-BE49-F238E27FC236}">
-                <a16:creationId xmlns:a16="http://schemas.microsoft.com/office/drawing/2014/main" id="{98602FF3-714F-AA57-D40E-86781CE18B46}"/>
+                <a16:creationId xmlns:a16="http://schemas.microsoft.com/office/drawing/2014/main" id="{2122C4B1-94B8-A693-9DA5-AB18AA191273}"/>
               </a:ext>
             </a:extLst>
           </p:cNvPr>
@@ -9301,7 +9496,7 @@
           <p:cNvPr id="10" name="Rectángulo: esquinas redondeadas 9">
             <a:extLst>
               <a:ext uri="{FF2B5EF4-FFF2-40B4-BE49-F238E27FC236}">
-                <a16:creationId xmlns:a16="http://schemas.microsoft.com/office/drawing/2014/main" id="{2018F7BD-80CB-AE7F-1AD1-5F348FD4E479}"/>
+                <a16:creationId xmlns:a16="http://schemas.microsoft.com/office/drawing/2014/main" id="{7B9BC611-C26C-96E2-D235-63F14F631CC1}"/>
               </a:ext>
             </a:extLst>
           </p:cNvPr>
@@ -9355,7 +9550,7 @@
           <p:cNvPr id="11" name="CuadroTexto 10">
             <a:extLst>
               <a:ext uri="{FF2B5EF4-FFF2-40B4-BE49-F238E27FC236}">
-                <a16:creationId xmlns:a16="http://schemas.microsoft.com/office/drawing/2014/main" id="{241ECDB7-FDE8-B2B7-EF09-E3AF19A6F71C}"/>
+                <a16:creationId xmlns:a16="http://schemas.microsoft.com/office/drawing/2014/main" id="{1C30CB73-ABC6-44CC-565E-93634F9E011C}"/>
               </a:ext>
             </a:extLst>
           </p:cNvPr>
@@ -9395,7 +9590,7 @@
           <p:cNvPr id="12" name="CuadroTexto 11">
             <a:extLst>
               <a:ext uri="{FF2B5EF4-FFF2-40B4-BE49-F238E27FC236}">
-                <a16:creationId xmlns:a16="http://schemas.microsoft.com/office/drawing/2014/main" id="{AAC34014-78F3-3DA1-D8BE-B59827995065}"/>
+                <a16:creationId xmlns:a16="http://schemas.microsoft.com/office/drawing/2014/main" id="{917968D9-A624-0ACE-9308-6E8A18865E52}"/>
               </a:ext>
             </a:extLst>
           </p:cNvPr>
@@ -9435,7 +9630,7 @@
           <p:cNvPr id="13" name="Rectángulo: esquinas redondeadas 12">
             <a:extLst>
               <a:ext uri="{FF2B5EF4-FFF2-40B4-BE49-F238E27FC236}">
-                <a16:creationId xmlns:a16="http://schemas.microsoft.com/office/drawing/2014/main" id="{211940CC-D8B5-390B-5A36-C4840E35938B}"/>
+                <a16:creationId xmlns:a16="http://schemas.microsoft.com/office/drawing/2014/main" id="{6257EB0C-D9D0-C184-6E5B-8BC484D52FC8}"/>
               </a:ext>
             </a:extLst>
           </p:cNvPr>
@@ -9489,7 +9684,7 @@
           <p:cNvPr id="14" name="CuadroTexto 13">
             <a:extLst>
               <a:ext uri="{FF2B5EF4-FFF2-40B4-BE49-F238E27FC236}">
-                <a16:creationId xmlns:a16="http://schemas.microsoft.com/office/drawing/2014/main" id="{B7289F20-C8BB-3595-F15B-4E2880ED0960}"/>
+                <a16:creationId xmlns:a16="http://schemas.microsoft.com/office/drawing/2014/main" id="{700A1AEA-3EC4-5724-0CEF-FA2ECD0BC3A8}"/>
               </a:ext>
             </a:extLst>
           </p:cNvPr>
@@ -9529,7 +9724,7 @@
           <p:cNvPr id="15" name="CuadroTexto 14">
             <a:extLst>
               <a:ext uri="{FF2B5EF4-FFF2-40B4-BE49-F238E27FC236}">
-                <a16:creationId xmlns:a16="http://schemas.microsoft.com/office/drawing/2014/main" id="{AD5FDCD2-CF71-63AC-BF34-7A984AFA6773}"/>
+                <a16:creationId xmlns:a16="http://schemas.microsoft.com/office/drawing/2014/main" id="{4D9E5A2C-6A0C-B66E-456E-3AEC7D0D06FD}"/>
               </a:ext>
             </a:extLst>
           </p:cNvPr>
@@ -9567,7 +9762,7 @@
     </p:spTree>
     <p:extLst>
       <p:ext uri="{BB962C8B-B14F-4D97-AF65-F5344CB8AC3E}">
-        <p14:creationId xmlns:p14="http://schemas.microsoft.com/office/powerpoint/2010/main" val="532801573"/>
+        <p14:creationId xmlns:p14="http://schemas.microsoft.com/office/powerpoint/2010/main" val="58776312"/>
       </p:ext>
     </p:extLst>
   </p:cSld>
@@ -9607,7 +9802,7 @@
           <p:cNvPr id="2" name="CuadroTexto 1">
             <a:extLst>
               <a:ext uri="{FF2B5EF4-FFF2-40B4-BE49-F238E27FC236}">
-                <a16:creationId xmlns:a16="http://schemas.microsoft.com/office/drawing/2014/main" id="{02C763EB-133E-A78A-1CB0-1107BA8FDB07}"/>
+                <a16:creationId xmlns:a16="http://schemas.microsoft.com/office/drawing/2014/main" id="{CD6894B9-7A09-9B95-3443-33E8638F14FF}"/>
               </a:ext>
             </a:extLst>
           </p:cNvPr>
@@ -9647,7 +9842,7 @@
           <p:cNvPr id="3" name="CuadroTexto 2">
             <a:extLst>
               <a:ext uri="{FF2B5EF4-FFF2-40B4-BE49-F238E27FC236}">
-                <a16:creationId xmlns:a16="http://schemas.microsoft.com/office/drawing/2014/main" id="{4DDA0427-728B-B593-D27C-E87F5A662BB1}"/>
+                <a16:creationId xmlns:a16="http://schemas.microsoft.com/office/drawing/2014/main" id="{724071AC-9EBD-DC2D-76A6-0CFCFD103EBA}"/>
               </a:ext>
             </a:extLst>
           </p:cNvPr>
@@ -9687,7 +9882,7 @@
           <p:cNvPr id="4" name="CuadroTexto 3">
             <a:extLst>
               <a:ext uri="{FF2B5EF4-FFF2-40B4-BE49-F238E27FC236}">
-                <a16:creationId xmlns:a16="http://schemas.microsoft.com/office/drawing/2014/main" id="{4117148E-9BE1-AD74-94C9-056B7A8F40BA}"/>
+                <a16:creationId xmlns:a16="http://schemas.microsoft.com/office/drawing/2014/main" id="{956B5DDA-6B1D-C10D-D5B4-82EB3A0A89FB}"/>
               </a:ext>
             </a:extLst>
           </p:cNvPr>
@@ -9717,7 +9912,7 @@
                 </a:solidFill>
                 <a:latin typeface="Segoe UI" panose="020B0502040204020203" pitchFamily="34" charset="0"/>
               </a:rPr>
-              <a:t>La misma URL publica sirve los dos portales, la documentacion y el monitor legacy, mientras el escritorio opera por API y SSH.</a:t>
+              <a:t>La URL publica termina en una VM con HTTPS, persistencia real y una consola tecnica de escritorio separada del flujo funcional.</a:t>
             </a:r>
           </a:p>
         </p:txBody>
@@ -9727,7 +9922,7 @@
           <p:cNvPr id="6" name="Imagen 5">
             <a:extLst>
               <a:ext uri="{FF2B5EF4-FFF2-40B4-BE49-F238E27FC236}">
-                <a16:creationId xmlns:a16="http://schemas.microsoft.com/office/drawing/2014/main" id="{B4278C2D-D007-0FAB-0454-E696414CB426}"/>
+                <a16:creationId xmlns:a16="http://schemas.microsoft.com/office/drawing/2014/main" id="{A96BE8CE-6DD6-ED45-A0AD-47E5EFE33617}"/>
               </a:ext>
             </a:extLst>
           </p:cNvPr>
@@ -9750,8 +9945,8 @@
         </p:blipFill>
         <p:spPr>
           <a:xfrm>
-            <a:off x="787400" y="2196774"/>
-            <a:ext cx="6477000" cy="3556652"/>
+            <a:off x="1023078" y="1854200"/>
+            <a:ext cx="6183443" cy="4191000"/>
           </a:xfrm>
           <a:prstGeom prst="rect">
             <a:avLst/>
@@ -9768,7 +9963,7 @@
           <p:cNvPr id="7" name="CuadroTexto 6">
             <a:extLst>
               <a:ext uri="{FF2B5EF4-FFF2-40B4-BE49-F238E27FC236}">
-                <a16:creationId xmlns:a16="http://schemas.microsoft.com/office/drawing/2014/main" id="{F6E86348-1442-E11C-BF6E-F3E0C27223E0}"/>
+                <a16:creationId xmlns:a16="http://schemas.microsoft.com/office/drawing/2014/main" id="{6B58FB45-5211-D9EC-048A-E18C9E3845B2}"/>
               </a:ext>
             </a:extLst>
           </p:cNvPr>
@@ -9877,7 +10072,7 @@
                 </a:solidFill>
                 <a:latin typeface="Segoe UI" panose="020B0502040204020203" pitchFamily="34" charset="0"/>
               </a:rPr>
-              <a:t>La shell web de monitor queda en legacy.</a:t>
+              <a:t>La operacion tecnica queda fuera del flujo web principal.</a:t>
             </a:r>
           </a:p>
         </p:txBody>
@@ -9885,7 +10080,7 @@
     </p:spTree>
     <p:extLst>
       <p:ext uri="{BB962C8B-B14F-4D97-AF65-F5344CB8AC3E}">
-        <p14:creationId xmlns:p14="http://schemas.microsoft.com/office/powerpoint/2010/main" val="3055323459"/>
+        <p14:creationId xmlns:p14="http://schemas.microsoft.com/office/powerpoint/2010/main" val="1522771249"/>
       </p:ext>
     </p:extLst>
   </p:cSld>
@@ -9925,7 +10120,7 @@
           <p:cNvPr id="2" name="CuadroTexto 1">
             <a:extLst>
               <a:ext uri="{FF2B5EF4-FFF2-40B4-BE49-F238E27FC236}">
-                <a16:creationId xmlns:a16="http://schemas.microsoft.com/office/drawing/2014/main" id="{6A55F792-719B-4933-0A82-79DA36A75C66}"/>
+                <a16:creationId xmlns:a16="http://schemas.microsoft.com/office/drawing/2014/main" id="{6B937256-65C2-D3F4-12CB-5C1F28970552}"/>
               </a:ext>
             </a:extLst>
           </p:cNvPr>
@@ -9965,7 +10160,7 @@
           <p:cNvPr id="3" name="CuadroTexto 2">
             <a:extLst>
               <a:ext uri="{FF2B5EF4-FFF2-40B4-BE49-F238E27FC236}">
-                <a16:creationId xmlns:a16="http://schemas.microsoft.com/office/drawing/2014/main" id="{2E49A66F-CB1D-8525-2172-BAF6AB440E2B}"/>
+                <a16:creationId xmlns:a16="http://schemas.microsoft.com/office/drawing/2014/main" id="{3D1DA558-0C53-9A96-0172-9248F5125B1A}"/>
               </a:ext>
             </a:extLst>
           </p:cNvPr>
@@ -10005,7 +10200,7 @@
           <p:cNvPr id="5" name="Imagen 4">
             <a:extLst>
               <a:ext uri="{FF2B5EF4-FFF2-40B4-BE49-F238E27FC236}">
-                <a16:creationId xmlns:a16="http://schemas.microsoft.com/office/drawing/2014/main" id="{CF1E2096-6DE4-2AA4-BC44-C2719EB4F519}"/>
+                <a16:creationId xmlns:a16="http://schemas.microsoft.com/office/drawing/2014/main" id="{B08FC2B9-DF8B-C8FD-E903-70C4CCAE42D0}"/>
               </a:ext>
             </a:extLst>
           </p:cNvPr>
@@ -10028,8 +10223,8 @@
         </p:blipFill>
         <p:spPr>
           <a:xfrm>
-            <a:off x="584200" y="2016478"/>
-            <a:ext cx="5969000" cy="3714044"/>
+            <a:off x="584200" y="1784350"/>
+            <a:ext cx="5969000" cy="4178300"/>
           </a:xfrm>
           <a:prstGeom prst="rect">
             <a:avLst/>
@@ -10046,7 +10241,7 @@
           <p:cNvPr id="6" name="CuadroTexto 5">
             <a:extLst>
               <a:ext uri="{FF2B5EF4-FFF2-40B4-BE49-F238E27FC236}">
-                <a16:creationId xmlns:a16="http://schemas.microsoft.com/office/drawing/2014/main" id="{2D2B4C86-D810-64D8-4A85-90CC19F2C751}"/>
+                <a16:creationId xmlns:a16="http://schemas.microsoft.com/office/drawing/2014/main" id="{77C21CA9-0A5D-01A1-051D-CB7C862EF4EA}"/>
               </a:ext>
             </a:extLst>
           </p:cNvPr>
@@ -10086,7 +10281,7 @@
           <p:cNvPr id="7" name="CuadroTexto 6">
             <a:extLst>
               <a:ext uri="{FF2B5EF4-FFF2-40B4-BE49-F238E27FC236}">
-                <a16:creationId xmlns:a16="http://schemas.microsoft.com/office/drawing/2014/main" id="{2685FCED-4FC2-BF16-CB15-0DD8D2E263EB}"/>
+                <a16:creationId xmlns:a16="http://schemas.microsoft.com/office/drawing/2014/main" id="{22A5F55E-01D6-0AF1-E583-370E61672D15}"/>
               </a:ext>
             </a:extLst>
           </p:cNvPr>
@@ -10185,7 +10380,7 @@
     </p:spTree>
     <p:extLst>
       <p:ext uri="{BB962C8B-B14F-4D97-AF65-F5344CB8AC3E}">
-        <p14:creationId xmlns:p14="http://schemas.microsoft.com/office/powerpoint/2010/main" val="2739586334"/>
+        <p14:creationId xmlns:p14="http://schemas.microsoft.com/office/powerpoint/2010/main" val="2474189906"/>
       </p:ext>
     </p:extLst>
   </p:cSld>
@@ -10225,7 +10420,7 @@
           <p:cNvPr id="2" name="CuadroTexto 1">
             <a:extLst>
               <a:ext uri="{FF2B5EF4-FFF2-40B4-BE49-F238E27FC236}">
-                <a16:creationId xmlns:a16="http://schemas.microsoft.com/office/drawing/2014/main" id="{CE2F9C66-1DF0-AA26-FDED-651C2EB88C0A}"/>
+                <a16:creationId xmlns:a16="http://schemas.microsoft.com/office/drawing/2014/main" id="{DE924B84-F47B-DC01-D66B-8597F0544946}"/>
               </a:ext>
             </a:extLst>
           </p:cNvPr>
@@ -10265,7 +10460,7 @@
           <p:cNvPr id="3" name="CuadroTexto 2">
             <a:extLst>
               <a:ext uri="{FF2B5EF4-FFF2-40B4-BE49-F238E27FC236}">
-                <a16:creationId xmlns:a16="http://schemas.microsoft.com/office/drawing/2014/main" id="{BB4629B6-4913-02FD-22C5-F6B0C32BD709}"/>
+                <a16:creationId xmlns:a16="http://schemas.microsoft.com/office/drawing/2014/main" id="{5CCD5A62-B1D5-86D1-E2E2-6856DBFD033A}"/>
               </a:ext>
             </a:extLst>
           </p:cNvPr>
@@ -10305,7 +10500,7 @@
           <p:cNvPr id="4" name="CuadroTexto 3">
             <a:extLst>
               <a:ext uri="{FF2B5EF4-FFF2-40B4-BE49-F238E27FC236}">
-                <a16:creationId xmlns:a16="http://schemas.microsoft.com/office/drawing/2014/main" id="{89B0F4DE-C0A7-A7EE-1CA2-F3A03BCD4C50}"/>
+                <a16:creationId xmlns:a16="http://schemas.microsoft.com/office/drawing/2014/main" id="{6237BC69-FB99-BB6B-A6CF-E358ACAB9EE2}"/>
               </a:ext>
             </a:extLst>
           </p:cNvPr>
@@ -10345,7 +10540,7 @@
           <p:cNvPr id="6" name="Imagen 5">
             <a:extLst>
               <a:ext uri="{FF2B5EF4-FFF2-40B4-BE49-F238E27FC236}">
-                <a16:creationId xmlns:a16="http://schemas.microsoft.com/office/drawing/2014/main" id="{56A3FCBC-E07E-66C5-C566-583C15F6E59B}"/>
+                <a16:creationId xmlns:a16="http://schemas.microsoft.com/office/drawing/2014/main" id="{0C211F6E-0CB9-616B-D161-7A43066C0FE4}"/>
               </a:ext>
             </a:extLst>
           </p:cNvPr>
@@ -10386,7 +10581,7 @@
           <p:cNvPr id="7" name="Rectángulo: esquinas redondeadas 6">
             <a:extLst>
               <a:ext uri="{FF2B5EF4-FFF2-40B4-BE49-F238E27FC236}">
-                <a16:creationId xmlns:a16="http://schemas.microsoft.com/office/drawing/2014/main" id="{AE163F4D-D493-53CB-D135-CCB3C639FD66}"/>
+                <a16:creationId xmlns:a16="http://schemas.microsoft.com/office/drawing/2014/main" id="{1D4C2ECB-527E-C92D-2CF7-C4A0507F42D2}"/>
               </a:ext>
             </a:extLst>
           </p:cNvPr>
@@ -10440,7 +10635,7 @@
           <p:cNvPr id="8" name="CuadroTexto 7">
             <a:extLst>
               <a:ext uri="{FF2B5EF4-FFF2-40B4-BE49-F238E27FC236}">
-                <a16:creationId xmlns:a16="http://schemas.microsoft.com/office/drawing/2014/main" id="{5E2B6364-4DB1-AE6A-0D78-80A02A8AA6BD}"/>
+                <a16:creationId xmlns:a16="http://schemas.microsoft.com/office/drawing/2014/main" id="{0B705E7E-0D0B-D236-87BF-F998B6142B05}"/>
               </a:ext>
             </a:extLst>
           </p:cNvPr>
@@ -10480,7 +10675,7 @@
           <p:cNvPr id="9" name="CuadroTexto 8">
             <a:extLst>
               <a:ext uri="{FF2B5EF4-FFF2-40B4-BE49-F238E27FC236}">
-                <a16:creationId xmlns:a16="http://schemas.microsoft.com/office/drawing/2014/main" id="{1A64EE55-B20E-4844-D32D-4F73259ACA22}"/>
+                <a16:creationId xmlns:a16="http://schemas.microsoft.com/office/drawing/2014/main" id="{19ED82ED-2EFC-6CC0-F648-303E0681C4C1}"/>
               </a:ext>
             </a:extLst>
           </p:cNvPr>
@@ -10520,7 +10715,7 @@
           <p:cNvPr id="10" name="Rectángulo: esquinas redondeadas 9">
             <a:extLst>
               <a:ext uri="{FF2B5EF4-FFF2-40B4-BE49-F238E27FC236}">
-                <a16:creationId xmlns:a16="http://schemas.microsoft.com/office/drawing/2014/main" id="{231982D3-0988-2594-A592-4D0C6D87671F}"/>
+                <a16:creationId xmlns:a16="http://schemas.microsoft.com/office/drawing/2014/main" id="{1DE4E781-9C1B-E4B5-FD86-D174387B19A1}"/>
               </a:ext>
             </a:extLst>
           </p:cNvPr>
@@ -10574,7 +10769,7 @@
           <p:cNvPr id="11" name="CuadroTexto 10">
             <a:extLst>
               <a:ext uri="{FF2B5EF4-FFF2-40B4-BE49-F238E27FC236}">
-                <a16:creationId xmlns:a16="http://schemas.microsoft.com/office/drawing/2014/main" id="{3925F191-B401-B60F-B76D-5E7E042AA08A}"/>
+                <a16:creationId xmlns:a16="http://schemas.microsoft.com/office/drawing/2014/main" id="{F03CE05D-E38E-6F32-0775-3951BDF6BF85}"/>
               </a:ext>
             </a:extLst>
           </p:cNvPr>
@@ -10614,7 +10809,7 @@
           <p:cNvPr id="12" name="CuadroTexto 11">
             <a:extLst>
               <a:ext uri="{FF2B5EF4-FFF2-40B4-BE49-F238E27FC236}">
-                <a16:creationId xmlns:a16="http://schemas.microsoft.com/office/drawing/2014/main" id="{17504DA1-D9C3-AF90-A7A9-F274FCD16B03}"/>
+                <a16:creationId xmlns:a16="http://schemas.microsoft.com/office/drawing/2014/main" id="{0CAFEFC4-6D7F-6657-1D86-B897FCC65027}"/>
               </a:ext>
             </a:extLst>
           </p:cNvPr>
@@ -10654,7 +10849,7 @@
           <p:cNvPr id="13" name="Rectángulo: esquinas redondeadas 12">
             <a:extLst>
               <a:ext uri="{FF2B5EF4-FFF2-40B4-BE49-F238E27FC236}">
-                <a16:creationId xmlns:a16="http://schemas.microsoft.com/office/drawing/2014/main" id="{1C302DFF-C064-5ED9-A3A6-5955EFF7003E}"/>
+                <a16:creationId xmlns:a16="http://schemas.microsoft.com/office/drawing/2014/main" id="{C0694DD7-D23F-964D-BDC0-D9661DFF88CB}"/>
               </a:ext>
             </a:extLst>
           </p:cNvPr>
@@ -10708,7 +10903,7 @@
           <p:cNvPr id="14" name="CuadroTexto 13">
             <a:extLst>
               <a:ext uri="{FF2B5EF4-FFF2-40B4-BE49-F238E27FC236}">
-                <a16:creationId xmlns:a16="http://schemas.microsoft.com/office/drawing/2014/main" id="{4208011F-4DB1-E672-7A4D-4B7B41415603}"/>
+                <a16:creationId xmlns:a16="http://schemas.microsoft.com/office/drawing/2014/main" id="{4F53BB6E-3CE6-BE1D-D40F-FBBE7A1F69DA}"/>
               </a:ext>
             </a:extLst>
           </p:cNvPr>
@@ -10748,7 +10943,7 @@
           <p:cNvPr id="15" name="CuadroTexto 14">
             <a:extLst>
               <a:ext uri="{FF2B5EF4-FFF2-40B4-BE49-F238E27FC236}">
-                <a16:creationId xmlns:a16="http://schemas.microsoft.com/office/drawing/2014/main" id="{706D95B7-07CF-B39A-C8EB-290DAADF0404}"/>
+                <a16:creationId xmlns:a16="http://schemas.microsoft.com/office/drawing/2014/main" id="{7647B05A-A1B2-4D0D-33A7-57439AFD4287}"/>
               </a:ext>
             </a:extLst>
           </p:cNvPr>
@@ -10786,7 +10981,7 @@
     </p:spTree>
     <p:extLst>
       <p:ext uri="{BB962C8B-B14F-4D97-AF65-F5344CB8AC3E}">
-        <p14:creationId xmlns:p14="http://schemas.microsoft.com/office/powerpoint/2010/main" val="537032938"/>
+        <p14:creationId xmlns:p14="http://schemas.microsoft.com/office/powerpoint/2010/main" val="415349331"/>
       </p:ext>
     </p:extLst>
   </p:cSld>
@@ -10826,7 +11021,7 @@
           <p:cNvPr id="2" name="CuadroTexto 1">
             <a:extLst>
               <a:ext uri="{FF2B5EF4-FFF2-40B4-BE49-F238E27FC236}">
-                <a16:creationId xmlns:a16="http://schemas.microsoft.com/office/drawing/2014/main" id="{0D271AAC-A832-5E08-C88A-93FF0DEC3547}"/>
+                <a16:creationId xmlns:a16="http://schemas.microsoft.com/office/drawing/2014/main" id="{033B6185-2DF4-B3B1-8E9A-F2D4F92F2A18}"/>
               </a:ext>
             </a:extLst>
           </p:cNvPr>
@@ -10866,7 +11061,7 @@
           <p:cNvPr id="3" name="CuadroTexto 2">
             <a:extLst>
               <a:ext uri="{FF2B5EF4-FFF2-40B4-BE49-F238E27FC236}">
-                <a16:creationId xmlns:a16="http://schemas.microsoft.com/office/drawing/2014/main" id="{AD9944CF-079F-0D18-83A8-3B08688E2314}"/>
+                <a16:creationId xmlns:a16="http://schemas.microsoft.com/office/drawing/2014/main" id="{43215777-F41E-4C87-F27F-5ED5F66E3244}"/>
               </a:ext>
             </a:extLst>
           </p:cNvPr>
@@ -10906,7 +11101,7 @@
           <p:cNvPr id="5" name="Imagen 4">
             <a:extLst>
               <a:ext uri="{FF2B5EF4-FFF2-40B4-BE49-F238E27FC236}">
-                <a16:creationId xmlns:a16="http://schemas.microsoft.com/office/drawing/2014/main" id="{5C2C4B73-58CA-A5C3-34D3-2BBBA5E9B5D4}"/>
+                <a16:creationId xmlns:a16="http://schemas.microsoft.com/office/drawing/2014/main" id="{EB9A3945-4CA6-082C-858F-D90AA64C8AEC}"/>
               </a:ext>
             </a:extLst>
           </p:cNvPr>
@@ -10947,7 +11142,7 @@
           <p:cNvPr id="6" name="CuadroTexto 5">
             <a:extLst>
               <a:ext uri="{FF2B5EF4-FFF2-40B4-BE49-F238E27FC236}">
-                <a16:creationId xmlns:a16="http://schemas.microsoft.com/office/drawing/2014/main" id="{1F1B8C47-7AA5-402F-9DE9-2E84691C3AC7}"/>
+                <a16:creationId xmlns:a16="http://schemas.microsoft.com/office/drawing/2014/main" id="{A48C1D83-A83C-BF1F-70C9-21016D01D0C7}"/>
               </a:ext>
             </a:extLst>
           </p:cNvPr>
@@ -11046,7 +11241,7 @@
     </p:spTree>
     <p:extLst>
       <p:ext uri="{BB962C8B-B14F-4D97-AF65-F5344CB8AC3E}">
-        <p14:creationId xmlns:p14="http://schemas.microsoft.com/office/powerpoint/2010/main" val="47247134"/>
+        <p14:creationId xmlns:p14="http://schemas.microsoft.com/office/powerpoint/2010/main" val="3417312891"/>
       </p:ext>
     </p:extLst>
   </p:cSld>
@@ -11086,7 +11281,7 @@
           <p:cNvPr id="2" name="CuadroTexto 1">
             <a:extLst>
               <a:ext uri="{FF2B5EF4-FFF2-40B4-BE49-F238E27FC236}">
-                <a16:creationId xmlns:a16="http://schemas.microsoft.com/office/drawing/2014/main" id="{42D22E14-F2E0-12FB-23AD-8C06856A5CEC}"/>
+                <a16:creationId xmlns:a16="http://schemas.microsoft.com/office/drawing/2014/main" id="{2F0FD4DE-A572-69EC-1608-A148201CE7E2}"/>
               </a:ext>
             </a:extLst>
           </p:cNvPr>
@@ -11126,7 +11321,7 @@
           <p:cNvPr id="3" name="CuadroTexto 2">
             <a:extLst>
               <a:ext uri="{FF2B5EF4-FFF2-40B4-BE49-F238E27FC236}">
-                <a16:creationId xmlns:a16="http://schemas.microsoft.com/office/drawing/2014/main" id="{FA9CFA21-8403-29AD-04BC-F190C18F9982}"/>
+                <a16:creationId xmlns:a16="http://schemas.microsoft.com/office/drawing/2014/main" id="{54C9808F-684E-9BD9-488C-77D40B2CD85F}"/>
               </a:ext>
             </a:extLst>
           </p:cNvPr>
@@ -11166,7 +11361,7 @@
           <p:cNvPr id="4" name="CuadroTexto 3">
             <a:extLst>
               <a:ext uri="{FF2B5EF4-FFF2-40B4-BE49-F238E27FC236}">
-                <a16:creationId xmlns:a16="http://schemas.microsoft.com/office/drawing/2014/main" id="{EA134C0F-CB10-D821-49F7-39624C8868CA}"/>
+                <a16:creationId xmlns:a16="http://schemas.microsoft.com/office/drawing/2014/main" id="{628DD375-7F2F-94BA-46C2-EF4033BBC827}"/>
               </a:ext>
             </a:extLst>
           </p:cNvPr>
@@ -11206,7 +11401,7 @@
           <p:cNvPr id="6" name="Imagen 5">
             <a:extLst>
               <a:ext uri="{FF2B5EF4-FFF2-40B4-BE49-F238E27FC236}">
-                <a16:creationId xmlns:a16="http://schemas.microsoft.com/office/drawing/2014/main" id="{9CB5DA02-DAA9-B8B0-2EF1-31F9B92ED5B2}"/>
+                <a16:creationId xmlns:a16="http://schemas.microsoft.com/office/drawing/2014/main" id="{95C57F26-8802-0313-AE41-98E1383A3C8F}"/>
               </a:ext>
             </a:extLst>
           </p:cNvPr>
@@ -11247,7 +11442,7 @@
           <p:cNvPr id="7" name="Rectángulo: esquinas redondeadas 6">
             <a:extLst>
               <a:ext uri="{FF2B5EF4-FFF2-40B4-BE49-F238E27FC236}">
-                <a16:creationId xmlns:a16="http://schemas.microsoft.com/office/drawing/2014/main" id="{62987D9B-3E4E-70FC-9478-5CB4BD439987}"/>
+                <a16:creationId xmlns:a16="http://schemas.microsoft.com/office/drawing/2014/main" id="{A0B5CC5D-89EF-79C9-4AF4-E897D2E70ACB}"/>
               </a:ext>
             </a:extLst>
           </p:cNvPr>
@@ -11301,7 +11496,7 @@
           <p:cNvPr id="8" name="CuadroTexto 7">
             <a:extLst>
               <a:ext uri="{FF2B5EF4-FFF2-40B4-BE49-F238E27FC236}">
-                <a16:creationId xmlns:a16="http://schemas.microsoft.com/office/drawing/2014/main" id="{E68A74AC-0594-A8D8-4023-EEE74A3322B7}"/>
+                <a16:creationId xmlns:a16="http://schemas.microsoft.com/office/drawing/2014/main" id="{DB8DFE88-AC85-6507-44A3-331D75BCEE55}"/>
               </a:ext>
             </a:extLst>
           </p:cNvPr>
@@ -11341,7 +11536,7 @@
           <p:cNvPr id="9" name="CuadroTexto 8">
             <a:extLst>
               <a:ext uri="{FF2B5EF4-FFF2-40B4-BE49-F238E27FC236}">
-                <a16:creationId xmlns:a16="http://schemas.microsoft.com/office/drawing/2014/main" id="{50FEE87D-4813-369E-CDF0-D3B7AE81E5BB}"/>
+                <a16:creationId xmlns:a16="http://schemas.microsoft.com/office/drawing/2014/main" id="{8D288753-8414-2AC0-F936-58787869B2F6}"/>
               </a:ext>
             </a:extLst>
           </p:cNvPr>
@@ -11379,7 +11574,7 @@
     </p:spTree>
     <p:extLst>
       <p:ext uri="{BB962C8B-B14F-4D97-AF65-F5344CB8AC3E}">
-        <p14:creationId xmlns:p14="http://schemas.microsoft.com/office/powerpoint/2010/main" val="1678548499"/>
+        <p14:creationId xmlns:p14="http://schemas.microsoft.com/office/powerpoint/2010/main" val="1965659088"/>
       </p:ext>
     </p:extLst>
   </p:cSld>
@@ -11419,7 +11614,7 @@
           <p:cNvPr id="2" name="CuadroTexto 1">
             <a:extLst>
               <a:ext uri="{FF2B5EF4-FFF2-40B4-BE49-F238E27FC236}">
-                <a16:creationId xmlns:a16="http://schemas.microsoft.com/office/drawing/2014/main" id="{88CDCCD6-2EF4-0F24-586E-5203F93C424A}"/>
+                <a16:creationId xmlns:a16="http://schemas.microsoft.com/office/drawing/2014/main" id="{180B07DD-CC23-8706-3431-86AD8212814B}"/>
               </a:ext>
             </a:extLst>
           </p:cNvPr>
@@ -11459,7 +11654,7 @@
           <p:cNvPr id="3" name="CuadroTexto 2">
             <a:extLst>
               <a:ext uri="{FF2B5EF4-FFF2-40B4-BE49-F238E27FC236}">
-                <a16:creationId xmlns:a16="http://schemas.microsoft.com/office/drawing/2014/main" id="{F798B586-C962-DBEA-4D8E-83B718B7CBA1}"/>
+                <a16:creationId xmlns:a16="http://schemas.microsoft.com/office/drawing/2014/main" id="{728EEFA2-265D-AC07-5F82-F0037E3AC657}"/>
               </a:ext>
             </a:extLst>
           </p:cNvPr>
@@ -11499,7 +11694,7 @@
           <p:cNvPr id="4" name="CuadroTexto 3">
             <a:extLst>
               <a:ext uri="{FF2B5EF4-FFF2-40B4-BE49-F238E27FC236}">
-                <a16:creationId xmlns:a16="http://schemas.microsoft.com/office/drawing/2014/main" id="{BBD29CD5-2995-DEEE-7EB2-5087A0CA9DE9}"/>
+                <a16:creationId xmlns:a16="http://schemas.microsoft.com/office/drawing/2014/main" id="{BA9C0075-714F-CC23-DC53-DBA99F67999C}"/>
               </a:ext>
             </a:extLst>
           </p:cNvPr>
@@ -11539,7 +11734,7 @@
           <p:cNvPr id="5" name="Rectángulo: esquinas redondeadas 4">
             <a:extLst>
               <a:ext uri="{FF2B5EF4-FFF2-40B4-BE49-F238E27FC236}">
-                <a16:creationId xmlns:a16="http://schemas.microsoft.com/office/drawing/2014/main" id="{17CEA027-1CF4-64D0-C7A3-4234DEF651E7}"/>
+                <a16:creationId xmlns:a16="http://schemas.microsoft.com/office/drawing/2014/main" id="{60C19EB6-6556-325A-BC62-46F8CCBB7F3D}"/>
               </a:ext>
             </a:extLst>
           </p:cNvPr>
@@ -11593,7 +11788,7 @@
           <p:cNvPr id="6" name="CuadroTexto 5">
             <a:extLst>
               <a:ext uri="{FF2B5EF4-FFF2-40B4-BE49-F238E27FC236}">
-                <a16:creationId xmlns:a16="http://schemas.microsoft.com/office/drawing/2014/main" id="{CC1888A3-3A4F-1D68-A197-FDF057B2C713}"/>
+                <a16:creationId xmlns:a16="http://schemas.microsoft.com/office/drawing/2014/main" id="{CC6FC31A-C276-07A6-83B1-ECA11B3FD75E}"/>
               </a:ext>
             </a:extLst>
           </p:cNvPr>
@@ -11633,7 +11828,7 @@
           <p:cNvPr id="7" name="CuadroTexto 6">
             <a:extLst>
               <a:ext uri="{FF2B5EF4-FFF2-40B4-BE49-F238E27FC236}">
-                <a16:creationId xmlns:a16="http://schemas.microsoft.com/office/drawing/2014/main" id="{1793028D-CA88-DB07-AD8E-8D4F835B7B10}"/>
+                <a16:creationId xmlns:a16="http://schemas.microsoft.com/office/drawing/2014/main" id="{6B54BA2B-08B6-BE01-F079-60061C08C708}"/>
               </a:ext>
             </a:extLst>
           </p:cNvPr>
@@ -11673,7 +11868,7 @@
           <p:cNvPr id="8" name="Rectángulo: esquinas redondeadas 7">
             <a:extLst>
               <a:ext uri="{FF2B5EF4-FFF2-40B4-BE49-F238E27FC236}">
-                <a16:creationId xmlns:a16="http://schemas.microsoft.com/office/drawing/2014/main" id="{4A558677-C866-62A1-1E71-993B4D95E4F2}"/>
+                <a16:creationId xmlns:a16="http://schemas.microsoft.com/office/drawing/2014/main" id="{DEBF0AD2-CDF2-F01F-70D1-E91CD7A7DD7B}"/>
               </a:ext>
             </a:extLst>
           </p:cNvPr>
@@ -11727,7 +11922,7 @@
           <p:cNvPr id="9" name="CuadroTexto 8">
             <a:extLst>
               <a:ext uri="{FF2B5EF4-FFF2-40B4-BE49-F238E27FC236}">
-                <a16:creationId xmlns:a16="http://schemas.microsoft.com/office/drawing/2014/main" id="{9C67C9A2-9611-E597-A0F4-5F4AF9F0CC03}"/>
+                <a16:creationId xmlns:a16="http://schemas.microsoft.com/office/drawing/2014/main" id="{68967BEB-B7E1-E56D-8A03-786CB7503607}"/>
               </a:ext>
             </a:extLst>
           </p:cNvPr>
@@ -11767,7 +11962,7 @@
           <p:cNvPr id="10" name="CuadroTexto 9">
             <a:extLst>
               <a:ext uri="{FF2B5EF4-FFF2-40B4-BE49-F238E27FC236}">
-                <a16:creationId xmlns:a16="http://schemas.microsoft.com/office/drawing/2014/main" id="{C138F767-6F11-A4C3-0626-D4CC43D28120}"/>
+                <a16:creationId xmlns:a16="http://schemas.microsoft.com/office/drawing/2014/main" id="{8E3F8F6D-FD23-7789-E9ED-1063D1A95BCD}"/>
               </a:ext>
             </a:extLst>
           </p:cNvPr>
@@ -11807,7 +12002,7 @@
           <p:cNvPr id="11" name="Rectángulo: esquinas redondeadas 10">
             <a:extLst>
               <a:ext uri="{FF2B5EF4-FFF2-40B4-BE49-F238E27FC236}">
-                <a16:creationId xmlns:a16="http://schemas.microsoft.com/office/drawing/2014/main" id="{BCAD6787-FAA2-14F0-8B25-0946EB1A5B29}"/>
+                <a16:creationId xmlns:a16="http://schemas.microsoft.com/office/drawing/2014/main" id="{3333A217-60C6-F9DA-7DE5-3273F9DFAE2B}"/>
               </a:ext>
             </a:extLst>
           </p:cNvPr>
@@ -11861,7 +12056,7 @@
           <p:cNvPr id="12" name="CuadroTexto 11">
             <a:extLst>
               <a:ext uri="{FF2B5EF4-FFF2-40B4-BE49-F238E27FC236}">
-                <a16:creationId xmlns:a16="http://schemas.microsoft.com/office/drawing/2014/main" id="{0AA20422-DC77-CC23-8DC0-1D6A3F3CFA2C}"/>
+                <a16:creationId xmlns:a16="http://schemas.microsoft.com/office/drawing/2014/main" id="{1ED88DF8-8179-2C5F-A0A9-73DBD73DCDE0}"/>
               </a:ext>
             </a:extLst>
           </p:cNvPr>
@@ -11901,7 +12096,7 @@
           <p:cNvPr id="13" name="CuadroTexto 12">
             <a:extLst>
               <a:ext uri="{FF2B5EF4-FFF2-40B4-BE49-F238E27FC236}">
-                <a16:creationId xmlns:a16="http://schemas.microsoft.com/office/drawing/2014/main" id="{3E5312E2-4CD1-2151-1BA8-B07624168BB7}"/>
+                <a16:creationId xmlns:a16="http://schemas.microsoft.com/office/drawing/2014/main" id="{3B112D6E-CB2E-0EFB-19C3-9726970F7664}"/>
               </a:ext>
             </a:extLst>
           </p:cNvPr>
@@ -11941,7 +12136,7 @@
           <p:cNvPr id="14" name="Rectángulo: esquinas redondeadas 13">
             <a:extLst>
               <a:ext uri="{FF2B5EF4-FFF2-40B4-BE49-F238E27FC236}">
-                <a16:creationId xmlns:a16="http://schemas.microsoft.com/office/drawing/2014/main" id="{E81C0679-D03A-6A0D-332A-86A1B1AEC437}"/>
+                <a16:creationId xmlns:a16="http://schemas.microsoft.com/office/drawing/2014/main" id="{D842ED75-80EE-6CE7-5FA0-6BC71FE444A2}"/>
               </a:ext>
             </a:extLst>
           </p:cNvPr>
@@ -11995,7 +12190,7 @@
           <p:cNvPr id="15" name="CuadroTexto 14">
             <a:extLst>
               <a:ext uri="{FF2B5EF4-FFF2-40B4-BE49-F238E27FC236}">
-                <a16:creationId xmlns:a16="http://schemas.microsoft.com/office/drawing/2014/main" id="{439ED77F-300D-7747-038C-C7235A53130F}"/>
+                <a16:creationId xmlns:a16="http://schemas.microsoft.com/office/drawing/2014/main" id="{314AF3F0-407F-5076-6C71-0534F90D1895}"/>
               </a:ext>
             </a:extLst>
           </p:cNvPr>
@@ -12035,7 +12230,7 @@
           <p:cNvPr id="16" name="CuadroTexto 15">
             <a:extLst>
               <a:ext uri="{FF2B5EF4-FFF2-40B4-BE49-F238E27FC236}">
-                <a16:creationId xmlns:a16="http://schemas.microsoft.com/office/drawing/2014/main" id="{38DF6048-8027-8105-AB0D-6A129451598C}"/>
+                <a16:creationId xmlns:a16="http://schemas.microsoft.com/office/drawing/2014/main" id="{C0BA1C4D-F3EC-3959-933A-B3D1DADBB214}"/>
               </a:ext>
             </a:extLst>
           </p:cNvPr>
@@ -12075,7 +12270,7 @@
           <p:cNvPr id="17" name="Rectángulo: esquinas redondeadas 16">
             <a:extLst>
               <a:ext uri="{FF2B5EF4-FFF2-40B4-BE49-F238E27FC236}">
-                <a16:creationId xmlns:a16="http://schemas.microsoft.com/office/drawing/2014/main" id="{48D4A248-2DAC-2D2D-40DA-A0C272FB9D70}"/>
+                <a16:creationId xmlns:a16="http://schemas.microsoft.com/office/drawing/2014/main" id="{BE43186C-06C5-4633-B185-1519E17A5942}"/>
               </a:ext>
             </a:extLst>
           </p:cNvPr>
@@ -12129,7 +12324,7 @@
           <p:cNvPr id="18" name="CuadroTexto 17">
             <a:extLst>
               <a:ext uri="{FF2B5EF4-FFF2-40B4-BE49-F238E27FC236}">
-                <a16:creationId xmlns:a16="http://schemas.microsoft.com/office/drawing/2014/main" id="{2CAEF4FC-B0DA-6EF8-C78D-8022D75BDCAD}"/>
+                <a16:creationId xmlns:a16="http://schemas.microsoft.com/office/drawing/2014/main" id="{348EC1A2-FF8F-191C-74D6-0CA65E360857}"/>
               </a:ext>
             </a:extLst>
           </p:cNvPr>
@@ -12169,7 +12364,7 @@
           <p:cNvPr id="19" name="CuadroTexto 18">
             <a:extLst>
               <a:ext uri="{FF2B5EF4-FFF2-40B4-BE49-F238E27FC236}">
-                <a16:creationId xmlns:a16="http://schemas.microsoft.com/office/drawing/2014/main" id="{380BBCD7-8522-81A5-53E1-E99DCD41D98F}"/>
+                <a16:creationId xmlns:a16="http://schemas.microsoft.com/office/drawing/2014/main" id="{347B51CF-EB24-88AC-F4AC-00F45C4C5859}"/>
               </a:ext>
             </a:extLst>
           </p:cNvPr>
@@ -12209,7 +12404,7 @@
           <p:cNvPr id="20" name="Rectángulo: esquinas redondeadas 19">
             <a:extLst>
               <a:ext uri="{FF2B5EF4-FFF2-40B4-BE49-F238E27FC236}">
-                <a16:creationId xmlns:a16="http://schemas.microsoft.com/office/drawing/2014/main" id="{7FC02C4D-DBFF-D14A-7FC5-DF3BBB26A494}"/>
+                <a16:creationId xmlns:a16="http://schemas.microsoft.com/office/drawing/2014/main" id="{4F3917CC-2989-10E3-5A63-461C4CADE5B8}"/>
               </a:ext>
             </a:extLst>
           </p:cNvPr>
@@ -12263,7 +12458,7 @@
           <p:cNvPr id="21" name="CuadroTexto 20">
             <a:extLst>
               <a:ext uri="{FF2B5EF4-FFF2-40B4-BE49-F238E27FC236}">
-                <a16:creationId xmlns:a16="http://schemas.microsoft.com/office/drawing/2014/main" id="{81735565-1B92-5540-5026-4E57A8C43268}"/>
+                <a16:creationId xmlns:a16="http://schemas.microsoft.com/office/drawing/2014/main" id="{3AF1EBAA-28C0-396A-C89C-E8851E4224F6}"/>
               </a:ext>
             </a:extLst>
           </p:cNvPr>
@@ -12303,7 +12498,7 @@
           <p:cNvPr id="22" name="CuadroTexto 21">
             <a:extLst>
               <a:ext uri="{FF2B5EF4-FFF2-40B4-BE49-F238E27FC236}">
-                <a16:creationId xmlns:a16="http://schemas.microsoft.com/office/drawing/2014/main" id="{772E63E3-B570-3617-DDA5-F26E392E9721}"/>
+                <a16:creationId xmlns:a16="http://schemas.microsoft.com/office/drawing/2014/main" id="{CC5F6D84-BE3E-CD72-653E-18210851BA33}"/>
               </a:ext>
             </a:extLst>
           </p:cNvPr>
@@ -12341,7 +12536,7 @@
     </p:spTree>
     <p:extLst>
       <p:ext uri="{BB962C8B-B14F-4D97-AF65-F5344CB8AC3E}">
-        <p14:creationId xmlns:p14="http://schemas.microsoft.com/office/powerpoint/2010/main" val="1093037199"/>
+        <p14:creationId xmlns:p14="http://schemas.microsoft.com/office/powerpoint/2010/main" val="2556743298"/>
       </p:ext>
     </p:extLst>
   </p:cSld>
@@ -12362,39 +12557,39 @@
         <a:sysClr val="window" lastClr="FFFFFF"/>
       </a:lt1>
       <a:dk2>
-        <a:srgbClr val="0E2841"/>
+        <a:srgbClr val="44546A"/>
       </a:dk2>
       <a:lt2>
-        <a:srgbClr val="E8E8E8"/>
+        <a:srgbClr val="E7E6E6"/>
       </a:lt2>
       <a:accent1>
-        <a:srgbClr val="156082"/>
+        <a:srgbClr val="4472C4"/>
       </a:accent1>
       <a:accent2>
-        <a:srgbClr val="E97132"/>
+        <a:srgbClr val="ED7D31"/>
       </a:accent2>
       <a:accent3>
-        <a:srgbClr val="196B24"/>
+        <a:srgbClr val="A5A5A5"/>
       </a:accent3>
       <a:accent4>
-        <a:srgbClr val="0F9ED5"/>
+        <a:srgbClr val="FFC000"/>
       </a:accent4>
       <a:accent5>
-        <a:srgbClr val="A02B93"/>
+        <a:srgbClr val="5B9BD5"/>
       </a:accent5>
       <a:accent6>
-        <a:srgbClr val="4EA72E"/>
+        <a:srgbClr val="70AD47"/>
       </a:accent6>
       <a:hlink>
-        <a:srgbClr val="467886"/>
+        <a:srgbClr val="0563C1"/>
       </a:hlink>
       <a:folHlink>
-        <a:srgbClr val="96607D"/>
+        <a:srgbClr val="954F72"/>
       </a:folHlink>
     </a:clrScheme>
     <a:fontScheme name="Office">
       <a:majorFont>
-        <a:latin typeface="Aptos Display" panose="02110004020202020204"/>
+        <a:latin typeface="Calibri Light" panose="020F0302020204030204"/>
         <a:ea typeface=""/>
         <a:cs typeface=""/>
         <a:font script="Jpan" typeface="游ゴシック Light"/>
@@ -12446,7 +12641,7 @@
         <a:font script="Tfng" typeface="Ebrima"/>
       </a:majorFont>
       <a:minorFont>
-        <a:latin typeface="Aptos" panose="02110004020202020204"/>
+        <a:latin typeface="Calibri" panose="020F0502020204030204"/>
         <a:ea typeface=""/>
         <a:cs typeface=""/>
         <a:font script="Jpan" typeface="游ゴシック"/>
@@ -12557,6 +12752,13 @@
         </a:gradFill>
       </a:fillStyleLst>
       <a:lnStyleLst>
+        <a:ln w="6350" cap="flat" cmpd="sng" algn="ctr">
+          <a:solidFill>
+            <a:schemeClr val="phClr"/>
+          </a:solidFill>
+          <a:prstDash val="solid"/>
+          <a:miter lim="800000"/>
+        </a:ln>
         <a:ln w="12700" cap="flat" cmpd="sng" algn="ctr">
           <a:solidFill>
             <a:schemeClr val="phClr"/>
@@ -12565,13 +12767,6 @@
           <a:miter lim="800000"/>
         </a:ln>
         <a:ln w="19050" cap="flat" cmpd="sng" algn="ctr">
-          <a:solidFill>
-            <a:schemeClr val="phClr"/>
-          </a:solidFill>
-          <a:prstDash val="solid"/>
-          <a:miter lim="800000"/>
-        </a:ln>
-        <a:ln w="25400" cap="flat" cmpd="sng" algn="ctr">
           <a:solidFill>
             <a:schemeClr val="phClr"/>
           </a:solidFill>
@@ -12636,31 +12831,11 @@
       </a:bgFillStyleLst>
     </a:fmtScheme>
   </a:themeElements>
-  <a:objectDefaults>
-    <a:lnDef>
-      <a:spPr/>
-      <a:bodyPr/>
-      <a:lstStyle/>
-      <a:style>
-        <a:lnRef idx="2">
-          <a:schemeClr val="accent1"/>
-        </a:lnRef>
-        <a:fillRef idx="0">
-          <a:schemeClr val="accent1"/>
-        </a:fillRef>
-        <a:effectRef idx="1">
-          <a:schemeClr val="accent1"/>
-        </a:effectRef>
-        <a:fontRef idx="minor">
-          <a:schemeClr val="tx1"/>
-        </a:fontRef>
-      </a:style>
-    </a:lnDef>
-  </a:objectDefaults>
+  <a:objectDefaults/>
   <a:extraClrSchemeLst/>
   <a:extLst>
     <a:ext uri="{05A4C25C-085E-4340-85A3-A5531E510DB2}">
-      <thm15:themeFamily xmlns:thm15="http://schemas.microsoft.com/office/thememl/2012/main" name="Office Theme" id="{2E142A2C-CD16-42D6-873A-C26D2A0506FA}" vid="{1BDDFF52-6CD6-40A5-AB3C-68EB2F1E4D0A}"/>
+      <thm15:themeFamily xmlns:thm15="http://schemas.microsoft.com/office/thememl/2012/main" name="Office Theme" id="{62F939B6-93AF-4DB8-9C6B-D6C7DFDC589F}" vid="{4A3C46E8-61CC-4603-A589-7422A47A8E4A}"/>
     </a:ext>
   </a:extLst>
 </a:theme>

</xml_diff>

<commit_message>
Refresh final defense assets and delivery docs
</commit_message>
<xml_diff>
--- a/docs/presentacion-defensa-final.pptx
+++ b/docs/presentacion-defensa-final.pptx
@@ -146,7 +146,7 @@
           <p:cNvPr id="2" name="Título 1">
             <a:extLst>
               <a:ext uri="{FF2B5EF4-FFF2-40B4-BE49-F238E27FC236}">
-                <a16:creationId xmlns:a16="http://schemas.microsoft.com/office/drawing/2014/main" id="{42059031-D005-033F-527C-2532EAFDFE18}"/>
+                <a16:creationId xmlns:a16="http://schemas.microsoft.com/office/drawing/2014/main" id="{F747E9A5-A69C-AF31-D358-E9AF2C95B4F2}"/>
               </a:ext>
             </a:extLst>
           </p:cNvPr>
@@ -183,7 +183,7 @@
           <p:cNvPr id="3" name="Subtítulo 2">
             <a:extLst>
               <a:ext uri="{FF2B5EF4-FFF2-40B4-BE49-F238E27FC236}">
-                <a16:creationId xmlns:a16="http://schemas.microsoft.com/office/drawing/2014/main" id="{7151C16C-7DD0-8D00-A6C2-83E337E6DC55}"/>
+                <a16:creationId xmlns:a16="http://schemas.microsoft.com/office/drawing/2014/main" id="{9611385A-0F7B-2109-1713-B5B2D2EDC792}"/>
               </a:ext>
             </a:extLst>
           </p:cNvPr>
@@ -253,7 +253,7 @@
           <p:cNvPr id="4" name="Marcador de fecha 3">
             <a:extLst>
               <a:ext uri="{FF2B5EF4-FFF2-40B4-BE49-F238E27FC236}">
-                <a16:creationId xmlns:a16="http://schemas.microsoft.com/office/drawing/2014/main" id="{FE6FB086-1FAA-53BE-9924-178890CA8D97}"/>
+                <a16:creationId xmlns:a16="http://schemas.microsoft.com/office/drawing/2014/main" id="{C52BBF9F-F302-7E77-541C-38E060120F29}"/>
               </a:ext>
             </a:extLst>
           </p:cNvPr>
@@ -269,9 +269,9 @@
           <a:bodyPr/>
           <a:lstStyle/>
           <a:p>
-            <a:fld id="{9835FBA3-5475-4EC2-B841-90BC3B1D7D90}" type="datetimeFigureOut">
+            <a:fld id="{7DF9D857-2BC1-4ECA-A48E-C0419EF44063}" type="datetimeFigureOut">
               <a:rPr lang="es-ES" smtClean="0"/>
-              <a:t>22/05/2026</a:t>
+              <a:t>27/05/2026</a:t>
             </a:fld>
             <a:endParaRPr lang="es-ES"/>
           </a:p>
@@ -282,7 +282,7 @@
           <p:cNvPr id="5" name="Marcador de pie de página 4">
             <a:extLst>
               <a:ext uri="{FF2B5EF4-FFF2-40B4-BE49-F238E27FC236}">
-                <a16:creationId xmlns:a16="http://schemas.microsoft.com/office/drawing/2014/main" id="{883E1A23-60DF-8CF4-4D5A-FE5F192807DC}"/>
+                <a16:creationId xmlns:a16="http://schemas.microsoft.com/office/drawing/2014/main" id="{93E919BF-FBDE-8D86-3269-B333EDF00920}"/>
               </a:ext>
             </a:extLst>
           </p:cNvPr>
@@ -307,7 +307,7 @@
           <p:cNvPr id="6" name="Marcador de número de diapositiva 5">
             <a:extLst>
               <a:ext uri="{FF2B5EF4-FFF2-40B4-BE49-F238E27FC236}">
-                <a16:creationId xmlns:a16="http://schemas.microsoft.com/office/drawing/2014/main" id="{5FC06098-BE92-3166-B3FF-BB3D6B629F1B}"/>
+                <a16:creationId xmlns:a16="http://schemas.microsoft.com/office/drawing/2014/main" id="{8A557309-3833-7F7A-228A-CF7BFD6250BE}"/>
               </a:ext>
             </a:extLst>
           </p:cNvPr>
@@ -323,7 +323,7 @@
           <a:bodyPr/>
           <a:lstStyle/>
           <a:p>
-            <a:fld id="{96B8D56F-A2A2-43A0-8CA7-B1F0D0BAB8F0}" type="slidenum">
+            <a:fld id="{AA515A41-34E0-4B8A-BFF5-025DE5A27467}" type="slidenum">
               <a:rPr lang="es-ES" smtClean="0"/>
               <a:t>‹Nº›</a:t>
             </a:fld>
@@ -334,7 +334,7 @@
     </p:spTree>
     <p:extLst>
       <p:ext uri="{BB962C8B-B14F-4D97-AF65-F5344CB8AC3E}">
-        <p14:creationId xmlns:p14="http://schemas.microsoft.com/office/powerpoint/2010/main" val="1496105625"/>
+        <p14:creationId xmlns:p14="http://schemas.microsoft.com/office/powerpoint/2010/main" val="1096258657"/>
       </p:ext>
     </p:extLst>
   </p:cSld>
@@ -366,7 +366,7 @@
           <p:cNvPr id="2" name="Título 1">
             <a:extLst>
               <a:ext uri="{FF2B5EF4-FFF2-40B4-BE49-F238E27FC236}">
-                <a16:creationId xmlns:a16="http://schemas.microsoft.com/office/drawing/2014/main" id="{BD306D51-8173-C58C-B3E7-ABF0DFCA1D23}"/>
+                <a16:creationId xmlns:a16="http://schemas.microsoft.com/office/drawing/2014/main" id="{54E1A38A-0F12-FD41-A2C0-70604426A558}"/>
               </a:ext>
             </a:extLst>
           </p:cNvPr>
@@ -394,7 +394,7 @@
           <p:cNvPr id="3" name="Marcador de texto vertical 2">
             <a:extLst>
               <a:ext uri="{FF2B5EF4-FFF2-40B4-BE49-F238E27FC236}">
-                <a16:creationId xmlns:a16="http://schemas.microsoft.com/office/drawing/2014/main" id="{62D32270-BCDC-E7C3-8E2C-768709CDED75}"/>
+                <a16:creationId xmlns:a16="http://schemas.microsoft.com/office/drawing/2014/main" id="{DBE13BC4-A7FA-7D61-9FFB-D416C20899A3}"/>
               </a:ext>
             </a:extLst>
           </p:cNvPr>
@@ -451,7 +451,7 @@
           <p:cNvPr id="4" name="Marcador de fecha 3">
             <a:extLst>
               <a:ext uri="{FF2B5EF4-FFF2-40B4-BE49-F238E27FC236}">
-                <a16:creationId xmlns:a16="http://schemas.microsoft.com/office/drawing/2014/main" id="{6E3FA4E6-A1B5-50BD-5294-F37E568BE673}"/>
+                <a16:creationId xmlns:a16="http://schemas.microsoft.com/office/drawing/2014/main" id="{70B0F91E-D46E-5A6F-E9C1-DDC7DA6F64B7}"/>
               </a:ext>
             </a:extLst>
           </p:cNvPr>
@@ -467,9 +467,9 @@
           <a:bodyPr/>
           <a:lstStyle/>
           <a:p>
-            <a:fld id="{9835FBA3-5475-4EC2-B841-90BC3B1D7D90}" type="datetimeFigureOut">
+            <a:fld id="{7DF9D857-2BC1-4ECA-A48E-C0419EF44063}" type="datetimeFigureOut">
               <a:rPr lang="es-ES" smtClean="0"/>
-              <a:t>22/05/2026</a:t>
+              <a:t>27/05/2026</a:t>
             </a:fld>
             <a:endParaRPr lang="es-ES"/>
           </a:p>
@@ -480,7 +480,7 @@
           <p:cNvPr id="5" name="Marcador de pie de página 4">
             <a:extLst>
               <a:ext uri="{FF2B5EF4-FFF2-40B4-BE49-F238E27FC236}">
-                <a16:creationId xmlns:a16="http://schemas.microsoft.com/office/drawing/2014/main" id="{768C7386-B9E3-2184-B862-9C5190870FFC}"/>
+                <a16:creationId xmlns:a16="http://schemas.microsoft.com/office/drawing/2014/main" id="{E4906C85-F32C-8D4E-692B-EA7A9BE8DB65}"/>
               </a:ext>
             </a:extLst>
           </p:cNvPr>
@@ -505,7 +505,7 @@
           <p:cNvPr id="6" name="Marcador de número de diapositiva 5">
             <a:extLst>
               <a:ext uri="{FF2B5EF4-FFF2-40B4-BE49-F238E27FC236}">
-                <a16:creationId xmlns:a16="http://schemas.microsoft.com/office/drawing/2014/main" id="{D8DFF596-B1AB-1310-787F-3A0960306EA0}"/>
+                <a16:creationId xmlns:a16="http://schemas.microsoft.com/office/drawing/2014/main" id="{F9B679B1-8A4E-00F6-E432-D501D8B369C0}"/>
               </a:ext>
             </a:extLst>
           </p:cNvPr>
@@ -521,7 +521,7 @@
           <a:bodyPr/>
           <a:lstStyle/>
           <a:p>
-            <a:fld id="{96B8D56F-A2A2-43A0-8CA7-B1F0D0BAB8F0}" type="slidenum">
+            <a:fld id="{AA515A41-34E0-4B8A-BFF5-025DE5A27467}" type="slidenum">
               <a:rPr lang="es-ES" smtClean="0"/>
               <a:t>‹Nº›</a:t>
             </a:fld>
@@ -532,7 +532,7 @@
     </p:spTree>
     <p:extLst>
       <p:ext uri="{BB962C8B-B14F-4D97-AF65-F5344CB8AC3E}">
-        <p14:creationId xmlns:p14="http://schemas.microsoft.com/office/powerpoint/2010/main" val="3173428753"/>
+        <p14:creationId xmlns:p14="http://schemas.microsoft.com/office/powerpoint/2010/main" val="3866775877"/>
       </p:ext>
     </p:extLst>
   </p:cSld>
@@ -564,7 +564,7 @@
           <p:cNvPr id="2" name="Título vertical 1">
             <a:extLst>
               <a:ext uri="{FF2B5EF4-FFF2-40B4-BE49-F238E27FC236}">
-                <a16:creationId xmlns:a16="http://schemas.microsoft.com/office/drawing/2014/main" id="{668F0699-4FB4-04B4-D93F-03A917E8398C}"/>
+                <a16:creationId xmlns:a16="http://schemas.microsoft.com/office/drawing/2014/main" id="{3969AAB8-257F-573C-1745-C77C65247482}"/>
               </a:ext>
             </a:extLst>
           </p:cNvPr>
@@ -597,7 +597,7 @@
           <p:cNvPr id="3" name="Marcador de texto vertical 2">
             <a:extLst>
               <a:ext uri="{FF2B5EF4-FFF2-40B4-BE49-F238E27FC236}">
-                <a16:creationId xmlns:a16="http://schemas.microsoft.com/office/drawing/2014/main" id="{6D784313-848C-71FB-5349-2423CBF41DCB}"/>
+                <a16:creationId xmlns:a16="http://schemas.microsoft.com/office/drawing/2014/main" id="{CDC5E29F-8D9E-0979-F474-63AF8DA8314D}"/>
               </a:ext>
             </a:extLst>
           </p:cNvPr>
@@ -659,7 +659,7 @@
           <p:cNvPr id="4" name="Marcador de fecha 3">
             <a:extLst>
               <a:ext uri="{FF2B5EF4-FFF2-40B4-BE49-F238E27FC236}">
-                <a16:creationId xmlns:a16="http://schemas.microsoft.com/office/drawing/2014/main" id="{BC8121BE-A98A-F3AA-B5AA-600E444987A5}"/>
+                <a16:creationId xmlns:a16="http://schemas.microsoft.com/office/drawing/2014/main" id="{82311995-F201-2E73-7F41-F18FC3BC97B8}"/>
               </a:ext>
             </a:extLst>
           </p:cNvPr>
@@ -675,9 +675,9 @@
           <a:bodyPr/>
           <a:lstStyle/>
           <a:p>
-            <a:fld id="{9835FBA3-5475-4EC2-B841-90BC3B1D7D90}" type="datetimeFigureOut">
+            <a:fld id="{7DF9D857-2BC1-4ECA-A48E-C0419EF44063}" type="datetimeFigureOut">
               <a:rPr lang="es-ES" smtClean="0"/>
-              <a:t>22/05/2026</a:t>
+              <a:t>27/05/2026</a:t>
             </a:fld>
             <a:endParaRPr lang="es-ES"/>
           </a:p>
@@ -688,7 +688,7 @@
           <p:cNvPr id="5" name="Marcador de pie de página 4">
             <a:extLst>
               <a:ext uri="{FF2B5EF4-FFF2-40B4-BE49-F238E27FC236}">
-                <a16:creationId xmlns:a16="http://schemas.microsoft.com/office/drawing/2014/main" id="{FB3D6D49-535B-3B15-0DAC-F06C08FECDC4}"/>
+                <a16:creationId xmlns:a16="http://schemas.microsoft.com/office/drawing/2014/main" id="{5BE549F1-05B4-D110-36F4-2856D96123C9}"/>
               </a:ext>
             </a:extLst>
           </p:cNvPr>
@@ -713,7 +713,7 @@
           <p:cNvPr id="6" name="Marcador de número de diapositiva 5">
             <a:extLst>
               <a:ext uri="{FF2B5EF4-FFF2-40B4-BE49-F238E27FC236}">
-                <a16:creationId xmlns:a16="http://schemas.microsoft.com/office/drawing/2014/main" id="{FE43E37E-E97A-9F12-B131-28CC09EB01A9}"/>
+                <a16:creationId xmlns:a16="http://schemas.microsoft.com/office/drawing/2014/main" id="{0119D8FD-3460-7AB5-D3B2-D050CDEFF9B8}"/>
               </a:ext>
             </a:extLst>
           </p:cNvPr>
@@ -729,7 +729,7 @@
           <a:bodyPr/>
           <a:lstStyle/>
           <a:p>
-            <a:fld id="{96B8D56F-A2A2-43A0-8CA7-B1F0D0BAB8F0}" type="slidenum">
+            <a:fld id="{AA515A41-34E0-4B8A-BFF5-025DE5A27467}" type="slidenum">
               <a:rPr lang="es-ES" smtClean="0"/>
               <a:t>‹Nº›</a:t>
             </a:fld>
@@ -740,7 +740,7 @@
     </p:spTree>
     <p:extLst>
       <p:ext uri="{BB962C8B-B14F-4D97-AF65-F5344CB8AC3E}">
-        <p14:creationId xmlns:p14="http://schemas.microsoft.com/office/powerpoint/2010/main" val="764455321"/>
+        <p14:creationId xmlns:p14="http://schemas.microsoft.com/office/powerpoint/2010/main" val="2594176324"/>
       </p:ext>
     </p:extLst>
   </p:cSld>
@@ -772,7 +772,7 @@
           <p:cNvPr id="2" name="Título 1">
             <a:extLst>
               <a:ext uri="{FF2B5EF4-FFF2-40B4-BE49-F238E27FC236}">
-                <a16:creationId xmlns:a16="http://schemas.microsoft.com/office/drawing/2014/main" id="{52D8F515-57CD-7DBC-3D4C-239575297B07}"/>
+                <a16:creationId xmlns:a16="http://schemas.microsoft.com/office/drawing/2014/main" id="{A657B3D1-9F17-9857-C23E-0FF9659FD909}"/>
               </a:ext>
             </a:extLst>
           </p:cNvPr>
@@ -800,7 +800,7 @@
           <p:cNvPr id="3" name="Marcador de contenido 2">
             <a:extLst>
               <a:ext uri="{FF2B5EF4-FFF2-40B4-BE49-F238E27FC236}">
-                <a16:creationId xmlns:a16="http://schemas.microsoft.com/office/drawing/2014/main" id="{8350FE39-63BD-D9B8-1666-A34EA3767007}"/>
+                <a16:creationId xmlns:a16="http://schemas.microsoft.com/office/drawing/2014/main" id="{CCC8DB27-0B8D-3DFD-F444-147E77A62E3F}"/>
               </a:ext>
             </a:extLst>
           </p:cNvPr>
@@ -857,7 +857,7 @@
           <p:cNvPr id="4" name="Marcador de fecha 3">
             <a:extLst>
               <a:ext uri="{FF2B5EF4-FFF2-40B4-BE49-F238E27FC236}">
-                <a16:creationId xmlns:a16="http://schemas.microsoft.com/office/drawing/2014/main" id="{7AEE7F05-89E6-9588-62F7-49D45E1C6BD7}"/>
+                <a16:creationId xmlns:a16="http://schemas.microsoft.com/office/drawing/2014/main" id="{3F9DB092-AE36-B1AA-99F0-4ECC974B29D3}"/>
               </a:ext>
             </a:extLst>
           </p:cNvPr>
@@ -873,9 +873,9 @@
           <a:bodyPr/>
           <a:lstStyle/>
           <a:p>
-            <a:fld id="{9835FBA3-5475-4EC2-B841-90BC3B1D7D90}" type="datetimeFigureOut">
+            <a:fld id="{7DF9D857-2BC1-4ECA-A48E-C0419EF44063}" type="datetimeFigureOut">
               <a:rPr lang="es-ES" smtClean="0"/>
-              <a:t>22/05/2026</a:t>
+              <a:t>27/05/2026</a:t>
             </a:fld>
             <a:endParaRPr lang="es-ES"/>
           </a:p>
@@ -886,7 +886,7 @@
           <p:cNvPr id="5" name="Marcador de pie de página 4">
             <a:extLst>
               <a:ext uri="{FF2B5EF4-FFF2-40B4-BE49-F238E27FC236}">
-                <a16:creationId xmlns:a16="http://schemas.microsoft.com/office/drawing/2014/main" id="{CD0D6C44-66D1-D0F3-A664-59E365E86072}"/>
+                <a16:creationId xmlns:a16="http://schemas.microsoft.com/office/drawing/2014/main" id="{48D9DE15-B473-06DB-601C-09CE6D7B00A2}"/>
               </a:ext>
             </a:extLst>
           </p:cNvPr>
@@ -911,7 +911,7 @@
           <p:cNvPr id="6" name="Marcador de número de diapositiva 5">
             <a:extLst>
               <a:ext uri="{FF2B5EF4-FFF2-40B4-BE49-F238E27FC236}">
-                <a16:creationId xmlns:a16="http://schemas.microsoft.com/office/drawing/2014/main" id="{D6562176-8E15-94A2-29E4-2DA37DAD83BC}"/>
+                <a16:creationId xmlns:a16="http://schemas.microsoft.com/office/drawing/2014/main" id="{811C6BA2-83FB-199D-78F2-AC5FCF809BFB}"/>
               </a:ext>
             </a:extLst>
           </p:cNvPr>
@@ -927,7 +927,7 @@
           <a:bodyPr/>
           <a:lstStyle/>
           <a:p>
-            <a:fld id="{96B8D56F-A2A2-43A0-8CA7-B1F0D0BAB8F0}" type="slidenum">
+            <a:fld id="{AA515A41-34E0-4B8A-BFF5-025DE5A27467}" type="slidenum">
               <a:rPr lang="es-ES" smtClean="0"/>
               <a:t>‹Nº›</a:t>
             </a:fld>
@@ -938,7 +938,7 @@
     </p:spTree>
     <p:extLst>
       <p:ext uri="{BB962C8B-B14F-4D97-AF65-F5344CB8AC3E}">
-        <p14:creationId xmlns:p14="http://schemas.microsoft.com/office/powerpoint/2010/main" val="87129758"/>
+        <p14:creationId xmlns:p14="http://schemas.microsoft.com/office/powerpoint/2010/main" val="174078382"/>
       </p:ext>
     </p:extLst>
   </p:cSld>
@@ -970,7 +970,7 @@
           <p:cNvPr id="2" name="Título 1">
             <a:extLst>
               <a:ext uri="{FF2B5EF4-FFF2-40B4-BE49-F238E27FC236}">
-                <a16:creationId xmlns:a16="http://schemas.microsoft.com/office/drawing/2014/main" id="{89CAF63F-9D1A-D067-ADA4-3D4FD9ABC134}"/>
+                <a16:creationId xmlns:a16="http://schemas.microsoft.com/office/drawing/2014/main" id="{9FEE0E53-739A-5E14-2265-63E08A962888}"/>
               </a:ext>
             </a:extLst>
           </p:cNvPr>
@@ -1007,7 +1007,7 @@
           <p:cNvPr id="3" name="Marcador de texto 2">
             <a:extLst>
               <a:ext uri="{FF2B5EF4-FFF2-40B4-BE49-F238E27FC236}">
-                <a16:creationId xmlns:a16="http://schemas.microsoft.com/office/drawing/2014/main" id="{8C293125-11DB-977A-26FC-657AEE91324B}"/>
+                <a16:creationId xmlns:a16="http://schemas.microsoft.com/office/drawing/2014/main" id="{3CF09E20-BB42-9D1C-9A16-C9727455D13D}"/>
               </a:ext>
             </a:extLst>
           </p:cNvPr>
@@ -1132,7 +1132,7 @@
           <p:cNvPr id="4" name="Marcador de fecha 3">
             <a:extLst>
               <a:ext uri="{FF2B5EF4-FFF2-40B4-BE49-F238E27FC236}">
-                <a16:creationId xmlns:a16="http://schemas.microsoft.com/office/drawing/2014/main" id="{FE6765E1-76E4-3BD3-54A5-6945A371A7C2}"/>
+                <a16:creationId xmlns:a16="http://schemas.microsoft.com/office/drawing/2014/main" id="{6D43DD57-7FE4-C155-4E7A-0401C12069F9}"/>
               </a:ext>
             </a:extLst>
           </p:cNvPr>
@@ -1148,9 +1148,9 @@
           <a:bodyPr/>
           <a:lstStyle/>
           <a:p>
-            <a:fld id="{9835FBA3-5475-4EC2-B841-90BC3B1D7D90}" type="datetimeFigureOut">
+            <a:fld id="{7DF9D857-2BC1-4ECA-A48E-C0419EF44063}" type="datetimeFigureOut">
               <a:rPr lang="es-ES" smtClean="0"/>
-              <a:t>22/05/2026</a:t>
+              <a:t>27/05/2026</a:t>
             </a:fld>
             <a:endParaRPr lang="es-ES"/>
           </a:p>
@@ -1161,7 +1161,7 @@
           <p:cNvPr id="5" name="Marcador de pie de página 4">
             <a:extLst>
               <a:ext uri="{FF2B5EF4-FFF2-40B4-BE49-F238E27FC236}">
-                <a16:creationId xmlns:a16="http://schemas.microsoft.com/office/drawing/2014/main" id="{41CD489E-74B7-9355-AED2-98A117A8FA8C}"/>
+                <a16:creationId xmlns:a16="http://schemas.microsoft.com/office/drawing/2014/main" id="{2DCB3593-8C1B-01A6-64F0-1F8662C0C058}"/>
               </a:ext>
             </a:extLst>
           </p:cNvPr>
@@ -1186,7 +1186,7 @@
           <p:cNvPr id="6" name="Marcador de número de diapositiva 5">
             <a:extLst>
               <a:ext uri="{FF2B5EF4-FFF2-40B4-BE49-F238E27FC236}">
-                <a16:creationId xmlns:a16="http://schemas.microsoft.com/office/drawing/2014/main" id="{C579FC5E-83F4-9070-F1AD-CABEC30003C5}"/>
+                <a16:creationId xmlns:a16="http://schemas.microsoft.com/office/drawing/2014/main" id="{E396AEC0-2558-3D0F-B016-A6852FB7E0A8}"/>
               </a:ext>
             </a:extLst>
           </p:cNvPr>
@@ -1202,7 +1202,7 @@
           <a:bodyPr/>
           <a:lstStyle/>
           <a:p>
-            <a:fld id="{96B8D56F-A2A2-43A0-8CA7-B1F0D0BAB8F0}" type="slidenum">
+            <a:fld id="{AA515A41-34E0-4B8A-BFF5-025DE5A27467}" type="slidenum">
               <a:rPr lang="es-ES" smtClean="0"/>
               <a:t>‹Nº›</a:t>
             </a:fld>
@@ -1213,7 +1213,7 @@
     </p:spTree>
     <p:extLst>
       <p:ext uri="{BB962C8B-B14F-4D97-AF65-F5344CB8AC3E}">
-        <p14:creationId xmlns:p14="http://schemas.microsoft.com/office/powerpoint/2010/main" val="3470828759"/>
+        <p14:creationId xmlns:p14="http://schemas.microsoft.com/office/powerpoint/2010/main" val="3538564462"/>
       </p:ext>
     </p:extLst>
   </p:cSld>
@@ -1245,7 +1245,7 @@
           <p:cNvPr id="2" name="Título 1">
             <a:extLst>
               <a:ext uri="{FF2B5EF4-FFF2-40B4-BE49-F238E27FC236}">
-                <a16:creationId xmlns:a16="http://schemas.microsoft.com/office/drawing/2014/main" id="{0723E889-42FE-AAE2-FD9B-D46615EC2921}"/>
+                <a16:creationId xmlns:a16="http://schemas.microsoft.com/office/drawing/2014/main" id="{0386B269-1F9B-096D-4156-1A9A9FDDC953}"/>
               </a:ext>
             </a:extLst>
           </p:cNvPr>
@@ -1273,7 +1273,7 @@
           <p:cNvPr id="3" name="Marcador de contenido 2">
             <a:extLst>
               <a:ext uri="{FF2B5EF4-FFF2-40B4-BE49-F238E27FC236}">
-                <a16:creationId xmlns:a16="http://schemas.microsoft.com/office/drawing/2014/main" id="{29DC9890-8552-BC1F-A811-E8447EBA79B1}"/>
+                <a16:creationId xmlns:a16="http://schemas.microsoft.com/office/drawing/2014/main" id="{3691497C-0160-D7CC-5A2C-37BA9EFFA3D7}"/>
               </a:ext>
             </a:extLst>
           </p:cNvPr>
@@ -1335,7 +1335,7 @@
           <p:cNvPr id="4" name="Marcador de contenido 3">
             <a:extLst>
               <a:ext uri="{FF2B5EF4-FFF2-40B4-BE49-F238E27FC236}">
-                <a16:creationId xmlns:a16="http://schemas.microsoft.com/office/drawing/2014/main" id="{ADC1DE10-CBFE-A5B5-E50D-5F4A032A97A7}"/>
+                <a16:creationId xmlns:a16="http://schemas.microsoft.com/office/drawing/2014/main" id="{F7CE6F9C-0984-7B61-D31C-4FC486CBDBFD}"/>
               </a:ext>
             </a:extLst>
           </p:cNvPr>
@@ -1397,7 +1397,7 @@
           <p:cNvPr id="5" name="Marcador de fecha 4">
             <a:extLst>
               <a:ext uri="{FF2B5EF4-FFF2-40B4-BE49-F238E27FC236}">
-                <a16:creationId xmlns:a16="http://schemas.microsoft.com/office/drawing/2014/main" id="{8572ABA5-0A0C-5646-43BD-F215AC9EBFCD}"/>
+                <a16:creationId xmlns:a16="http://schemas.microsoft.com/office/drawing/2014/main" id="{D587CFF8-9155-5D3D-5C77-4353055CC059}"/>
               </a:ext>
             </a:extLst>
           </p:cNvPr>
@@ -1413,9 +1413,9 @@
           <a:bodyPr/>
           <a:lstStyle/>
           <a:p>
-            <a:fld id="{9835FBA3-5475-4EC2-B841-90BC3B1D7D90}" type="datetimeFigureOut">
+            <a:fld id="{7DF9D857-2BC1-4ECA-A48E-C0419EF44063}" type="datetimeFigureOut">
               <a:rPr lang="es-ES" smtClean="0"/>
-              <a:t>22/05/2026</a:t>
+              <a:t>27/05/2026</a:t>
             </a:fld>
             <a:endParaRPr lang="es-ES"/>
           </a:p>
@@ -1426,7 +1426,7 @@
           <p:cNvPr id="6" name="Marcador de pie de página 5">
             <a:extLst>
               <a:ext uri="{FF2B5EF4-FFF2-40B4-BE49-F238E27FC236}">
-                <a16:creationId xmlns:a16="http://schemas.microsoft.com/office/drawing/2014/main" id="{4902B53A-25F7-4386-F7F2-8D668F480001}"/>
+                <a16:creationId xmlns:a16="http://schemas.microsoft.com/office/drawing/2014/main" id="{02A4965C-5C15-5E1C-997E-BE1FE0D87CCA}"/>
               </a:ext>
             </a:extLst>
           </p:cNvPr>
@@ -1451,7 +1451,7 @@
           <p:cNvPr id="7" name="Marcador de número de diapositiva 6">
             <a:extLst>
               <a:ext uri="{FF2B5EF4-FFF2-40B4-BE49-F238E27FC236}">
-                <a16:creationId xmlns:a16="http://schemas.microsoft.com/office/drawing/2014/main" id="{B7C05165-9A70-E739-43B0-ABCC852AF1D2}"/>
+                <a16:creationId xmlns:a16="http://schemas.microsoft.com/office/drawing/2014/main" id="{678C03CE-F840-8305-FCDB-505111302E04}"/>
               </a:ext>
             </a:extLst>
           </p:cNvPr>
@@ -1467,7 +1467,7 @@
           <a:bodyPr/>
           <a:lstStyle/>
           <a:p>
-            <a:fld id="{96B8D56F-A2A2-43A0-8CA7-B1F0D0BAB8F0}" type="slidenum">
+            <a:fld id="{AA515A41-34E0-4B8A-BFF5-025DE5A27467}" type="slidenum">
               <a:rPr lang="es-ES" smtClean="0"/>
               <a:t>‹Nº›</a:t>
             </a:fld>
@@ -1478,7 +1478,7 @@
     </p:spTree>
     <p:extLst>
       <p:ext uri="{BB962C8B-B14F-4D97-AF65-F5344CB8AC3E}">
-        <p14:creationId xmlns:p14="http://schemas.microsoft.com/office/powerpoint/2010/main" val="795092294"/>
+        <p14:creationId xmlns:p14="http://schemas.microsoft.com/office/powerpoint/2010/main" val="1591076314"/>
       </p:ext>
     </p:extLst>
   </p:cSld>
@@ -1510,7 +1510,7 @@
           <p:cNvPr id="2" name="Título 1">
             <a:extLst>
               <a:ext uri="{FF2B5EF4-FFF2-40B4-BE49-F238E27FC236}">
-                <a16:creationId xmlns:a16="http://schemas.microsoft.com/office/drawing/2014/main" id="{C96C73B9-025C-53EA-AC30-0915BB284A60}"/>
+                <a16:creationId xmlns:a16="http://schemas.microsoft.com/office/drawing/2014/main" id="{C95FE9DA-633C-A7A3-4DF1-9E0CE4AD708E}"/>
               </a:ext>
             </a:extLst>
           </p:cNvPr>
@@ -1543,7 +1543,7 @@
           <p:cNvPr id="3" name="Marcador de texto 2">
             <a:extLst>
               <a:ext uri="{FF2B5EF4-FFF2-40B4-BE49-F238E27FC236}">
-                <a16:creationId xmlns:a16="http://schemas.microsoft.com/office/drawing/2014/main" id="{B9948733-248B-D7B4-47BC-C180F0B0D8AC}"/>
+                <a16:creationId xmlns:a16="http://schemas.microsoft.com/office/drawing/2014/main" id="{A9C3C829-0D26-0D9D-61AB-5F9AE070EB70}"/>
               </a:ext>
             </a:extLst>
           </p:cNvPr>
@@ -1614,7 +1614,7 @@
           <p:cNvPr id="4" name="Marcador de contenido 3">
             <a:extLst>
               <a:ext uri="{FF2B5EF4-FFF2-40B4-BE49-F238E27FC236}">
-                <a16:creationId xmlns:a16="http://schemas.microsoft.com/office/drawing/2014/main" id="{95CD6CCE-6DCF-F78A-40FF-40D0A74D8547}"/>
+                <a16:creationId xmlns:a16="http://schemas.microsoft.com/office/drawing/2014/main" id="{ECC82072-9276-3394-D5C3-5CAAC1625396}"/>
               </a:ext>
             </a:extLst>
           </p:cNvPr>
@@ -1676,7 +1676,7 @@
           <p:cNvPr id="5" name="Marcador de texto 4">
             <a:extLst>
               <a:ext uri="{FF2B5EF4-FFF2-40B4-BE49-F238E27FC236}">
-                <a16:creationId xmlns:a16="http://schemas.microsoft.com/office/drawing/2014/main" id="{07764DD9-26E9-2D25-FDE9-E9BF7098D8DE}"/>
+                <a16:creationId xmlns:a16="http://schemas.microsoft.com/office/drawing/2014/main" id="{9B68160E-CD31-5543-6D4B-9AB56CEFC07B}"/>
               </a:ext>
             </a:extLst>
           </p:cNvPr>
@@ -1747,7 +1747,7 @@
           <p:cNvPr id="6" name="Marcador de contenido 5">
             <a:extLst>
               <a:ext uri="{FF2B5EF4-FFF2-40B4-BE49-F238E27FC236}">
-                <a16:creationId xmlns:a16="http://schemas.microsoft.com/office/drawing/2014/main" id="{C01CD537-2D04-6254-7654-5BE03193D978}"/>
+                <a16:creationId xmlns:a16="http://schemas.microsoft.com/office/drawing/2014/main" id="{F8B5504F-2A8D-DF35-1794-1632E2A34FE8}"/>
               </a:ext>
             </a:extLst>
           </p:cNvPr>
@@ -1809,7 +1809,7 @@
           <p:cNvPr id="7" name="Marcador de fecha 6">
             <a:extLst>
               <a:ext uri="{FF2B5EF4-FFF2-40B4-BE49-F238E27FC236}">
-                <a16:creationId xmlns:a16="http://schemas.microsoft.com/office/drawing/2014/main" id="{0CEDF0AE-0300-3394-5CD6-5226575D730B}"/>
+                <a16:creationId xmlns:a16="http://schemas.microsoft.com/office/drawing/2014/main" id="{FD8E17A6-0FA9-0BBD-E0F3-37EE6389BCE7}"/>
               </a:ext>
             </a:extLst>
           </p:cNvPr>
@@ -1825,9 +1825,9 @@
           <a:bodyPr/>
           <a:lstStyle/>
           <a:p>
-            <a:fld id="{9835FBA3-5475-4EC2-B841-90BC3B1D7D90}" type="datetimeFigureOut">
+            <a:fld id="{7DF9D857-2BC1-4ECA-A48E-C0419EF44063}" type="datetimeFigureOut">
               <a:rPr lang="es-ES" smtClean="0"/>
-              <a:t>22/05/2026</a:t>
+              <a:t>27/05/2026</a:t>
             </a:fld>
             <a:endParaRPr lang="es-ES"/>
           </a:p>
@@ -1838,7 +1838,7 @@
           <p:cNvPr id="8" name="Marcador de pie de página 7">
             <a:extLst>
               <a:ext uri="{FF2B5EF4-FFF2-40B4-BE49-F238E27FC236}">
-                <a16:creationId xmlns:a16="http://schemas.microsoft.com/office/drawing/2014/main" id="{2BCB35A2-E749-9AFA-8214-08569E13580C}"/>
+                <a16:creationId xmlns:a16="http://schemas.microsoft.com/office/drawing/2014/main" id="{D099D6E1-9F08-46D6-96E0-6556CA612323}"/>
               </a:ext>
             </a:extLst>
           </p:cNvPr>
@@ -1863,7 +1863,7 @@
           <p:cNvPr id="9" name="Marcador de número de diapositiva 8">
             <a:extLst>
               <a:ext uri="{FF2B5EF4-FFF2-40B4-BE49-F238E27FC236}">
-                <a16:creationId xmlns:a16="http://schemas.microsoft.com/office/drawing/2014/main" id="{2D836A66-1100-864F-4759-0AE448374357}"/>
+                <a16:creationId xmlns:a16="http://schemas.microsoft.com/office/drawing/2014/main" id="{CDDD4F92-CAEB-BB19-55E3-6ED1365B570E}"/>
               </a:ext>
             </a:extLst>
           </p:cNvPr>
@@ -1879,7 +1879,7 @@
           <a:bodyPr/>
           <a:lstStyle/>
           <a:p>
-            <a:fld id="{96B8D56F-A2A2-43A0-8CA7-B1F0D0BAB8F0}" type="slidenum">
+            <a:fld id="{AA515A41-34E0-4B8A-BFF5-025DE5A27467}" type="slidenum">
               <a:rPr lang="es-ES" smtClean="0"/>
               <a:t>‹Nº›</a:t>
             </a:fld>
@@ -1890,7 +1890,7 @@
     </p:spTree>
     <p:extLst>
       <p:ext uri="{BB962C8B-B14F-4D97-AF65-F5344CB8AC3E}">
-        <p14:creationId xmlns:p14="http://schemas.microsoft.com/office/powerpoint/2010/main" val="1275045235"/>
+        <p14:creationId xmlns:p14="http://schemas.microsoft.com/office/powerpoint/2010/main" val="4236326680"/>
       </p:ext>
     </p:extLst>
   </p:cSld>
@@ -1922,7 +1922,7 @@
           <p:cNvPr id="2" name="Título 1">
             <a:extLst>
               <a:ext uri="{FF2B5EF4-FFF2-40B4-BE49-F238E27FC236}">
-                <a16:creationId xmlns:a16="http://schemas.microsoft.com/office/drawing/2014/main" id="{27C4182B-C525-0ECF-9468-3CF5D2D79442}"/>
+                <a16:creationId xmlns:a16="http://schemas.microsoft.com/office/drawing/2014/main" id="{884F9C25-1F3D-22F8-B89F-96D23B7D2CD0}"/>
               </a:ext>
             </a:extLst>
           </p:cNvPr>
@@ -1950,7 +1950,7 @@
           <p:cNvPr id="3" name="Marcador de fecha 2">
             <a:extLst>
               <a:ext uri="{FF2B5EF4-FFF2-40B4-BE49-F238E27FC236}">
-                <a16:creationId xmlns:a16="http://schemas.microsoft.com/office/drawing/2014/main" id="{ED6E5E95-C57A-8E5A-D875-6901DB0553D1}"/>
+                <a16:creationId xmlns:a16="http://schemas.microsoft.com/office/drawing/2014/main" id="{B2711B9A-4C75-FF47-7BB5-1B3C8E570852}"/>
               </a:ext>
             </a:extLst>
           </p:cNvPr>
@@ -1966,9 +1966,9 @@
           <a:bodyPr/>
           <a:lstStyle/>
           <a:p>
-            <a:fld id="{9835FBA3-5475-4EC2-B841-90BC3B1D7D90}" type="datetimeFigureOut">
+            <a:fld id="{7DF9D857-2BC1-4ECA-A48E-C0419EF44063}" type="datetimeFigureOut">
               <a:rPr lang="es-ES" smtClean="0"/>
-              <a:t>22/05/2026</a:t>
+              <a:t>27/05/2026</a:t>
             </a:fld>
             <a:endParaRPr lang="es-ES"/>
           </a:p>
@@ -1979,7 +1979,7 @@
           <p:cNvPr id="4" name="Marcador de pie de página 3">
             <a:extLst>
               <a:ext uri="{FF2B5EF4-FFF2-40B4-BE49-F238E27FC236}">
-                <a16:creationId xmlns:a16="http://schemas.microsoft.com/office/drawing/2014/main" id="{3D2D9EAB-FC7D-A384-F3AD-52D6CABF777D}"/>
+                <a16:creationId xmlns:a16="http://schemas.microsoft.com/office/drawing/2014/main" id="{2F47A31C-E4CB-E1DD-F41C-1BED88159EE5}"/>
               </a:ext>
             </a:extLst>
           </p:cNvPr>
@@ -2004,7 +2004,7 @@
           <p:cNvPr id="5" name="Marcador de número de diapositiva 4">
             <a:extLst>
               <a:ext uri="{FF2B5EF4-FFF2-40B4-BE49-F238E27FC236}">
-                <a16:creationId xmlns:a16="http://schemas.microsoft.com/office/drawing/2014/main" id="{0C4F2829-150F-B0E0-F6C7-73E414895259}"/>
+                <a16:creationId xmlns:a16="http://schemas.microsoft.com/office/drawing/2014/main" id="{16B7C687-FEF9-3605-F982-EC5CAED7B379}"/>
               </a:ext>
             </a:extLst>
           </p:cNvPr>
@@ -2020,7 +2020,7 @@
           <a:bodyPr/>
           <a:lstStyle/>
           <a:p>
-            <a:fld id="{96B8D56F-A2A2-43A0-8CA7-B1F0D0BAB8F0}" type="slidenum">
+            <a:fld id="{AA515A41-34E0-4B8A-BFF5-025DE5A27467}" type="slidenum">
               <a:rPr lang="es-ES" smtClean="0"/>
               <a:t>‹Nº›</a:t>
             </a:fld>
@@ -2031,7 +2031,7 @@
     </p:spTree>
     <p:extLst>
       <p:ext uri="{BB962C8B-B14F-4D97-AF65-F5344CB8AC3E}">
-        <p14:creationId xmlns:p14="http://schemas.microsoft.com/office/powerpoint/2010/main" val="2710967507"/>
+        <p14:creationId xmlns:p14="http://schemas.microsoft.com/office/powerpoint/2010/main" val="3260201284"/>
       </p:ext>
     </p:extLst>
   </p:cSld>
@@ -2063,7 +2063,7 @@
           <p:cNvPr id="2" name="Marcador de fecha 1">
             <a:extLst>
               <a:ext uri="{FF2B5EF4-FFF2-40B4-BE49-F238E27FC236}">
-                <a16:creationId xmlns:a16="http://schemas.microsoft.com/office/drawing/2014/main" id="{2DD91837-7567-4939-7FEA-FC09C5EAA023}"/>
+                <a16:creationId xmlns:a16="http://schemas.microsoft.com/office/drawing/2014/main" id="{DB0FDAD9-4A92-C1D0-A3D0-ACA1C4661747}"/>
               </a:ext>
             </a:extLst>
           </p:cNvPr>
@@ -2079,9 +2079,9 @@
           <a:bodyPr/>
           <a:lstStyle/>
           <a:p>
-            <a:fld id="{9835FBA3-5475-4EC2-B841-90BC3B1D7D90}" type="datetimeFigureOut">
+            <a:fld id="{7DF9D857-2BC1-4ECA-A48E-C0419EF44063}" type="datetimeFigureOut">
               <a:rPr lang="es-ES" smtClean="0"/>
-              <a:t>22/05/2026</a:t>
+              <a:t>27/05/2026</a:t>
             </a:fld>
             <a:endParaRPr lang="es-ES"/>
           </a:p>
@@ -2092,7 +2092,7 @@
           <p:cNvPr id="3" name="Marcador de pie de página 2">
             <a:extLst>
               <a:ext uri="{FF2B5EF4-FFF2-40B4-BE49-F238E27FC236}">
-                <a16:creationId xmlns:a16="http://schemas.microsoft.com/office/drawing/2014/main" id="{FCFD4570-8133-CD03-C0EC-9A24EAE0F65B}"/>
+                <a16:creationId xmlns:a16="http://schemas.microsoft.com/office/drawing/2014/main" id="{78DAC3A3-A540-E223-C38E-27A344B554DD}"/>
               </a:ext>
             </a:extLst>
           </p:cNvPr>
@@ -2117,7 +2117,7 @@
           <p:cNvPr id="4" name="Marcador de número de diapositiva 3">
             <a:extLst>
               <a:ext uri="{FF2B5EF4-FFF2-40B4-BE49-F238E27FC236}">
-                <a16:creationId xmlns:a16="http://schemas.microsoft.com/office/drawing/2014/main" id="{8527FAC1-FAB6-6815-FB0D-D15FCC738F45}"/>
+                <a16:creationId xmlns:a16="http://schemas.microsoft.com/office/drawing/2014/main" id="{1CD94074-9280-3579-4C1D-855C59DC39FA}"/>
               </a:ext>
             </a:extLst>
           </p:cNvPr>
@@ -2133,7 +2133,7 @@
           <a:bodyPr/>
           <a:lstStyle/>
           <a:p>
-            <a:fld id="{96B8D56F-A2A2-43A0-8CA7-B1F0D0BAB8F0}" type="slidenum">
+            <a:fld id="{AA515A41-34E0-4B8A-BFF5-025DE5A27467}" type="slidenum">
               <a:rPr lang="es-ES" smtClean="0"/>
               <a:t>‹Nº›</a:t>
             </a:fld>
@@ -2144,7 +2144,7 @@
     </p:spTree>
     <p:extLst>
       <p:ext uri="{BB962C8B-B14F-4D97-AF65-F5344CB8AC3E}">
-        <p14:creationId xmlns:p14="http://schemas.microsoft.com/office/powerpoint/2010/main" val="1816769203"/>
+        <p14:creationId xmlns:p14="http://schemas.microsoft.com/office/powerpoint/2010/main" val="1212894350"/>
       </p:ext>
     </p:extLst>
   </p:cSld>
@@ -2176,7 +2176,7 @@
           <p:cNvPr id="2" name="Título 1">
             <a:extLst>
               <a:ext uri="{FF2B5EF4-FFF2-40B4-BE49-F238E27FC236}">
-                <a16:creationId xmlns:a16="http://schemas.microsoft.com/office/drawing/2014/main" id="{A44F0AE0-8905-F645-6E6E-FCD033F6F627}"/>
+                <a16:creationId xmlns:a16="http://schemas.microsoft.com/office/drawing/2014/main" id="{D58CEA0C-21DD-F6F8-8819-BE70E8156DD5}"/>
               </a:ext>
             </a:extLst>
           </p:cNvPr>
@@ -2213,7 +2213,7 @@
           <p:cNvPr id="3" name="Marcador de contenido 2">
             <a:extLst>
               <a:ext uri="{FF2B5EF4-FFF2-40B4-BE49-F238E27FC236}">
-                <a16:creationId xmlns:a16="http://schemas.microsoft.com/office/drawing/2014/main" id="{57BFF8D5-C89A-F933-4530-5ADAB9F742A9}"/>
+                <a16:creationId xmlns:a16="http://schemas.microsoft.com/office/drawing/2014/main" id="{975D4CDC-5E20-6184-0817-E4D1431B23DC}"/>
               </a:ext>
             </a:extLst>
           </p:cNvPr>
@@ -2303,7 +2303,7 @@
           <p:cNvPr id="4" name="Marcador de texto 3">
             <a:extLst>
               <a:ext uri="{FF2B5EF4-FFF2-40B4-BE49-F238E27FC236}">
-                <a16:creationId xmlns:a16="http://schemas.microsoft.com/office/drawing/2014/main" id="{4BCA8D70-883A-D5E4-2B4B-1810DB39E673}"/>
+                <a16:creationId xmlns:a16="http://schemas.microsoft.com/office/drawing/2014/main" id="{9026DAA0-0D63-F341-DAB4-1363FC8700DD}"/>
               </a:ext>
             </a:extLst>
           </p:cNvPr>
@@ -2374,7 +2374,7 @@
           <p:cNvPr id="5" name="Marcador de fecha 4">
             <a:extLst>
               <a:ext uri="{FF2B5EF4-FFF2-40B4-BE49-F238E27FC236}">
-                <a16:creationId xmlns:a16="http://schemas.microsoft.com/office/drawing/2014/main" id="{4B680A9D-2C64-1081-0D49-51EC41D594C2}"/>
+                <a16:creationId xmlns:a16="http://schemas.microsoft.com/office/drawing/2014/main" id="{85516AEC-CDDC-1B47-9445-739BD483DD5A}"/>
               </a:ext>
             </a:extLst>
           </p:cNvPr>
@@ -2390,9 +2390,9 @@
           <a:bodyPr/>
           <a:lstStyle/>
           <a:p>
-            <a:fld id="{9835FBA3-5475-4EC2-B841-90BC3B1D7D90}" type="datetimeFigureOut">
+            <a:fld id="{7DF9D857-2BC1-4ECA-A48E-C0419EF44063}" type="datetimeFigureOut">
               <a:rPr lang="es-ES" smtClean="0"/>
-              <a:t>22/05/2026</a:t>
+              <a:t>27/05/2026</a:t>
             </a:fld>
             <a:endParaRPr lang="es-ES"/>
           </a:p>
@@ -2403,7 +2403,7 @@
           <p:cNvPr id="6" name="Marcador de pie de página 5">
             <a:extLst>
               <a:ext uri="{FF2B5EF4-FFF2-40B4-BE49-F238E27FC236}">
-                <a16:creationId xmlns:a16="http://schemas.microsoft.com/office/drawing/2014/main" id="{F2B5EFD7-9DED-D583-9B50-BEA7D34D042A}"/>
+                <a16:creationId xmlns:a16="http://schemas.microsoft.com/office/drawing/2014/main" id="{0F08CD5C-5F2F-DC4C-A211-1DC6C7EBEC23}"/>
               </a:ext>
             </a:extLst>
           </p:cNvPr>
@@ -2428,7 +2428,7 @@
           <p:cNvPr id="7" name="Marcador de número de diapositiva 6">
             <a:extLst>
               <a:ext uri="{FF2B5EF4-FFF2-40B4-BE49-F238E27FC236}">
-                <a16:creationId xmlns:a16="http://schemas.microsoft.com/office/drawing/2014/main" id="{637B4225-39A8-868E-FDB2-0A5EEF744E22}"/>
+                <a16:creationId xmlns:a16="http://schemas.microsoft.com/office/drawing/2014/main" id="{A63278E3-E554-B691-9150-EBD0E07AAEB0}"/>
               </a:ext>
             </a:extLst>
           </p:cNvPr>
@@ -2444,7 +2444,7 @@
           <a:bodyPr/>
           <a:lstStyle/>
           <a:p>
-            <a:fld id="{96B8D56F-A2A2-43A0-8CA7-B1F0D0BAB8F0}" type="slidenum">
+            <a:fld id="{AA515A41-34E0-4B8A-BFF5-025DE5A27467}" type="slidenum">
               <a:rPr lang="es-ES" smtClean="0"/>
               <a:t>‹Nº›</a:t>
             </a:fld>
@@ -2455,7 +2455,7 @@
     </p:spTree>
     <p:extLst>
       <p:ext uri="{BB962C8B-B14F-4D97-AF65-F5344CB8AC3E}">
-        <p14:creationId xmlns:p14="http://schemas.microsoft.com/office/powerpoint/2010/main" val="3365838627"/>
+        <p14:creationId xmlns:p14="http://schemas.microsoft.com/office/powerpoint/2010/main" val="1711597664"/>
       </p:ext>
     </p:extLst>
   </p:cSld>
@@ -2487,7 +2487,7 @@
           <p:cNvPr id="2" name="Título 1">
             <a:extLst>
               <a:ext uri="{FF2B5EF4-FFF2-40B4-BE49-F238E27FC236}">
-                <a16:creationId xmlns:a16="http://schemas.microsoft.com/office/drawing/2014/main" id="{5D364949-16BE-E78B-82D2-3C2315B3F1B5}"/>
+                <a16:creationId xmlns:a16="http://schemas.microsoft.com/office/drawing/2014/main" id="{5173EBA9-B5DD-C451-9DAC-E0671C51718C}"/>
               </a:ext>
             </a:extLst>
           </p:cNvPr>
@@ -2524,7 +2524,7 @@
           <p:cNvPr id="3" name="Marcador de posición de imagen 2">
             <a:extLst>
               <a:ext uri="{FF2B5EF4-FFF2-40B4-BE49-F238E27FC236}">
-                <a16:creationId xmlns:a16="http://schemas.microsoft.com/office/drawing/2014/main" id="{7B02907C-1396-B908-FAA2-098E7C14FB8C}"/>
+                <a16:creationId xmlns:a16="http://schemas.microsoft.com/office/drawing/2014/main" id="{075FE7A7-3579-29CB-6626-32B86D7CD458}"/>
               </a:ext>
             </a:extLst>
           </p:cNvPr>
@@ -2591,7 +2591,7 @@
           <p:cNvPr id="4" name="Marcador de texto 3">
             <a:extLst>
               <a:ext uri="{FF2B5EF4-FFF2-40B4-BE49-F238E27FC236}">
-                <a16:creationId xmlns:a16="http://schemas.microsoft.com/office/drawing/2014/main" id="{202D4E07-4280-8163-7063-884D2EB9971D}"/>
+                <a16:creationId xmlns:a16="http://schemas.microsoft.com/office/drawing/2014/main" id="{FFDC52D3-3B9E-D021-B186-A7D215CF68BC}"/>
               </a:ext>
             </a:extLst>
           </p:cNvPr>
@@ -2662,7 +2662,7 @@
           <p:cNvPr id="5" name="Marcador de fecha 4">
             <a:extLst>
               <a:ext uri="{FF2B5EF4-FFF2-40B4-BE49-F238E27FC236}">
-                <a16:creationId xmlns:a16="http://schemas.microsoft.com/office/drawing/2014/main" id="{33950C08-5F43-D53F-61D2-7B45976E8487}"/>
+                <a16:creationId xmlns:a16="http://schemas.microsoft.com/office/drawing/2014/main" id="{7ADF918E-3472-BC36-6C7A-61CD37CA4365}"/>
               </a:ext>
             </a:extLst>
           </p:cNvPr>
@@ -2678,9 +2678,9 @@
           <a:bodyPr/>
           <a:lstStyle/>
           <a:p>
-            <a:fld id="{9835FBA3-5475-4EC2-B841-90BC3B1D7D90}" type="datetimeFigureOut">
+            <a:fld id="{7DF9D857-2BC1-4ECA-A48E-C0419EF44063}" type="datetimeFigureOut">
               <a:rPr lang="es-ES" smtClean="0"/>
-              <a:t>22/05/2026</a:t>
+              <a:t>27/05/2026</a:t>
             </a:fld>
             <a:endParaRPr lang="es-ES"/>
           </a:p>
@@ -2691,7 +2691,7 @@
           <p:cNvPr id="6" name="Marcador de pie de página 5">
             <a:extLst>
               <a:ext uri="{FF2B5EF4-FFF2-40B4-BE49-F238E27FC236}">
-                <a16:creationId xmlns:a16="http://schemas.microsoft.com/office/drawing/2014/main" id="{E05AC3F4-2958-63F6-B084-4216A2F411A0}"/>
+                <a16:creationId xmlns:a16="http://schemas.microsoft.com/office/drawing/2014/main" id="{F4D56AFF-FE8D-2F54-334E-0D5B0BE2285D}"/>
               </a:ext>
             </a:extLst>
           </p:cNvPr>
@@ -2716,7 +2716,7 @@
           <p:cNvPr id="7" name="Marcador de número de diapositiva 6">
             <a:extLst>
               <a:ext uri="{FF2B5EF4-FFF2-40B4-BE49-F238E27FC236}">
-                <a16:creationId xmlns:a16="http://schemas.microsoft.com/office/drawing/2014/main" id="{EF6B1B05-4540-9367-33A0-D11C94E2699D}"/>
+                <a16:creationId xmlns:a16="http://schemas.microsoft.com/office/drawing/2014/main" id="{FF2B3460-EE14-4FAE-4406-AE566619A3C8}"/>
               </a:ext>
             </a:extLst>
           </p:cNvPr>
@@ -2732,7 +2732,7 @@
           <a:bodyPr/>
           <a:lstStyle/>
           <a:p>
-            <a:fld id="{96B8D56F-A2A2-43A0-8CA7-B1F0D0BAB8F0}" type="slidenum">
+            <a:fld id="{AA515A41-34E0-4B8A-BFF5-025DE5A27467}" type="slidenum">
               <a:rPr lang="es-ES" smtClean="0"/>
               <a:t>‹Nº›</a:t>
             </a:fld>
@@ -2743,7 +2743,7 @@
     </p:spTree>
     <p:extLst>
       <p:ext uri="{BB962C8B-B14F-4D97-AF65-F5344CB8AC3E}">
-        <p14:creationId xmlns:p14="http://schemas.microsoft.com/office/powerpoint/2010/main" val="4142256132"/>
+        <p14:creationId xmlns:p14="http://schemas.microsoft.com/office/powerpoint/2010/main" val="1685687157"/>
       </p:ext>
     </p:extLst>
   </p:cSld>
@@ -2780,7 +2780,7 @@
           <p:cNvPr id="2" name="Marcador de título 1">
             <a:extLst>
               <a:ext uri="{FF2B5EF4-FFF2-40B4-BE49-F238E27FC236}">
-                <a16:creationId xmlns:a16="http://schemas.microsoft.com/office/drawing/2014/main" id="{35D39D35-3453-AC02-5303-ADD3F6B54AED}"/>
+                <a16:creationId xmlns:a16="http://schemas.microsoft.com/office/drawing/2014/main" id="{1F4A310F-44E4-321F-FA92-1D7F528B3A33}"/>
               </a:ext>
             </a:extLst>
           </p:cNvPr>
@@ -2818,7 +2818,7 @@
           <p:cNvPr id="3" name="Marcador de texto 2">
             <a:extLst>
               <a:ext uri="{FF2B5EF4-FFF2-40B4-BE49-F238E27FC236}">
-                <a16:creationId xmlns:a16="http://schemas.microsoft.com/office/drawing/2014/main" id="{63420041-04F8-C26A-0991-3AD4B3DAFD54}"/>
+                <a16:creationId xmlns:a16="http://schemas.microsoft.com/office/drawing/2014/main" id="{44C6DACB-4F5D-7A99-4C6D-90BEAD91EF84}"/>
               </a:ext>
             </a:extLst>
           </p:cNvPr>
@@ -2885,7 +2885,7 @@
           <p:cNvPr id="4" name="Marcador de fecha 3">
             <a:extLst>
               <a:ext uri="{FF2B5EF4-FFF2-40B4-BE49-F238E27FC236}">
-                <a16:creationId xmlns:a16="http://schemas.microsoft.com/office/drawing/2014/main" id="{04166FF0-A09C-78EE-3785-892DA5DB1317}"/>
+                <a16:creationId xmlns:a16="http://schemas.microsoft.com/office/drawing/2014/main" id="{1EE25504-6BDA-1385-EAB0-0848FA6168AE}"/>
               </a:ext>
             </a:extLst>
           </p:cNvPr>
@@ -2919,9 +2919,9 @@
             </a:lvl1pPr>
           </a:lstStyle>
           <a:p>
-            <a:fld id="{9835FBA3-5475-4EC2-B841-90BC3B1D7D90}" type="datetimeFigureOut">
+            <a:fld id="{7DF9D857-2BC1-4ECA-A48E-C0419EF44063}" type="datetimeFigureOut">
               <a:rPr lang="es-ES" smtClean="0"/>
-              <a:t>22/05/2026</a:t>
+              <a:t>27/05/2026</a:t>
             </a:fld>
             <a:endParaRPr lang="es-ES"/>
           </a:p>
@@ -2932,7 +2932,7 @@
           <p:cNvPr id="5" name="Marcador de pie de página 4">
             <a:extLst>
               <a:ext uri="{FF2B5EF4-FFF2-40B4-BE49-F238E27FC236}">
-                <a16:creationId xmlns:a16="http://schemas.microsoft.com/office/drawing/2014/main" id="{95A76A51-3BB4-56F2-A015-086631DA7069}"/>
+                <a16:creationId xmlns:a16="http://schemas.microsoft.com/office/drawing/2014/main" id="{AF456258-1A26-2EB6-2580-AEFB2B83FC43}"/>
               </a:ext>
             </a:extLst>
           </p:cNvPr>
@@ -2975,7 +2975,7 @@
           <p:cNvPr id="6" name="Marcador de número de diapositiva 5">
             <a:extLst>
               <a:ext uri="{FF2B5EF4-FFF2-40B4-BE49-F238E27FC236}">
-                <a16:creationId xmlns:a16="http://schemas.microsoft.com/office/drawing/2014/main" id="{67FBF8BC-5BAE-1E68-ED65-7CE445BB80D2}"/>
+                <a16:creationId xmlns:a16="http://schemas.microsoft.com/office/drawing/2014/main" id="{5AB82232-6D7E-9E91-8165-3E10466B2909}"/>
               </a:ext>
             </a:extLst>
           </p:cNvPr>
@@ -3009,7 +3009,7 @@
             </a:lvl1pPr>
           </a:lstStyle>
           <a:p>
-            <a:fld id="{96B8D56F-A2A2-43A0-8CA7-B1F0D0BAB8F0}" type="slidenum">
+            <a:fld id="{AA515A41-34E0-4B8A-BFF5-025DE5A27467}" type="slidenum">
               <a:rPr lang="es-ES" smtClean="0"/>
               <a:t>‹Nº›</a:t>
             </a:fld>
@@ -3020,7 +3020,7 @@
     </p:spTree>
     <p:extLst>
       <p:ext uri="{BB962C8B-B14F-4D97-AF65-F5344CB8AC3E}">
-        <p14:creationId xmlns:p14="http://schemas.microsoft.com/office/powerpoint/2010/main" val="3254596532"/>
+        <p14:creationId xmlns:p14="http://schemas.microsoft.com/office/powerpoint/2010/main" val="534919433"/>
       </p:ext>
     </p:extLst>
   </p:cSld>
@@ -3351,7 +3351,7 @@
           <p:cNvPr id="2" name="Rectángulo: esquinas redondeadas 1">
             <a:extLst>
               <a:ext uri="{FF2B5EF4-FFF2-40B4-BE49-F238E27FC236}">
-                <a16:creationId xmlns:a16="http://schemas.microsoft.com/office/drawing/2014/main" id="{CA12C00C-31B8-57BA-AE1B-7F0B6DDD5033}"/>
+                <a16:creationId xmlns:a16="http://schemas.microsoft.com/office/drawing/2014/main" id="{5C21021A-731D-BD7C-8102-3890FC965641}"/>
               </a:ext>
             </a:extLst>
           </p:cNvPr>
@@ -3405,7 +3405,7 @@
           <p:cNvPr id="3" name="CuadroTexto 2">
             <a:extLst>
               <a:ext uri="{FF2B5EF4-FFF2-40B4-BE49-F238E27FC236}">
-                <a16:creationId xmlns:a16="http://schemas.microsoft.com/office/drawing/2014/main" id="{38694A69-AED5-9D5A-6CAF-BEA870CD3C25}"/>
+                <a16:creationId xmlns:a16="http://schemas.microsoft.com/office/drawing/2014/main" id="{B53EB162-B404-27F8-366A-9668BE3F0E0B}"/>
               </a:ext>
             </a:extLst>
           </p:cNvPr>
@@ -3445,7 +3445,7 @@
           <p:cNvPr id="4" name="CuadroTexto 3">
             <a:extLst>
               <a:ext uri="{FF2B5EF4-FFF2-40B4-BE49-F238E27FC236}">
-                <a16:creationId xmlns:a16="http://schemas.microsoft.com/office/drawing/2014/main" id="{4E2A4B0B-DFF1-F818-1C09-6E54098339A1}"/>
+                <a16:creationId xmlns:a16="http://schemas.microsoft.com/office/drawing/2014/main" id="{39048014-6286-8C34-EB02-8F37C4F05425}"/>
               </a:ext>
             </a:extLst>
           </p:cNvPr>
@@ -3485,7 +3485,7 @@
           <p:cNvPr id="5" name="CuadroTexto 4">
             <a:extLst>
               <a:ext uri="{FF2B5EF4-FFF2-40B4-BE49-F238E27FC236}">
-                <a16:creationId xmlns:a16="http://schemas.microsoft.com/office/drawing/2014/main" id="{A54BA1BA-F4BA-9AE1-5D5D-9053E0635E3B}"/>
+                <a16:creationId xmlns:a16="http://schemas.microsoft.com/office/drawing/2014/main" id="{EA0EFDAC-DB66-0A51-CCDA-ABD4BB8BBA11}"/>
               </a:ext>
             </a:extLst>
           </p:cNvPr>
@@ -3525,7 +3525,7 @@
           <p:cNvPr id="6" name="CuadroTexto 5">
             <a:extLst>
               <a:ext uri="{FF2B5EF4-FFF2-40B4-BE49-F238E27FC236}">
-                <a16:creationId xmlns:a16="http://schemas.microsoft.com/office/drawing/2014/main" id="{38C02F9F-A59F-E971-B686-AB6159C2730C}"/>
+                <a16:creationId xmlns:a16="http://schemas.microsoft.com/office/drawing/2014/main" id="{6DF1A827-FF03-4481-F1DD-A3D36674FD4B}"/>
               </a:ext>
             </a:extLst>
           </p:cNvPr>
@@ -3576,7 +3576,7 @@
           <p:cNvPr id="8" name="Imagen 7">
             <a:extLst>
               <a:ext uri="{FF2B5EF4-FFF2-40B4-BE49-F238E27FC236}">
-                <a16:creationId xmlns:a16="http://schemas.microsoft.com/office/drawing/2014/main" id="{4DE0169B-C9B0-5450-F4DA-2530A2097BB1}"/>
+                <a16:creationId xmlns:a16="http://schemas.microsoft.com/office/drawing/2014/main" id="{CCDA0E7A-E6D7-1D80-8DFB-CC867396DDB2}"/>
               </a:ext>
             </a:extLst>
           </p:cNvPr>
@@ -3615,7 +3615,7 @@
     </p:spTree>
     <p:extLst>
       <p:ext uri="{BB962C8B-B14F-4D97-AF65-F5344CB8AC3E}">
-        <p14:creationId xmlns:p14="http://schemas.microsoft.com/office/powerpoint/2010/main" val="1507221563"/>
+        <p14:creationId xmlns:p14="http://schemas.microsoft.com/office/powerpoint/2010/main" val="2577456464"/>
       </p:ext>
     </p:extLst>
   </p:cSld>
@@ -3655,7 +3655,7 @@
           <p:cNvPr id="2" name="CuadroTexto 1">
             <a:extLst>
               <a:ext uri="{FF2B5EF4-FFF2-40B4-BE49-F238E27FC236}">
-                <a16:creationId xmlns:a16="http://schemas.microsoft.com/office/drawing/2014/main" id="{6401F12A-9BD6-9813-B0F8-BFA0D273FA7E}"/>
+                <a16:creationId xmlns:a16="http://schemas.microsoft.com/office/drawing/2014/main" id="{2DAFACFB-80D7-5FD8-2363-C08A84230F60}"/>
               </a:ext>
             </a:extLst>
           </p:cNvPr>
@@ -3695,7 +3695,7 @@
           <p:cNvPr id="3" name="CuadroTexto 2">
             <a:extLst>
               <a:ext uri="{FF2B5EF4-FFF2-40B4-BE49-F238E27FC236}">
-                <a16:creationId xmlns:a16="http://schemas.microsoft.com/office/drawing/2014/main" id="{A44A9632-27FC-CA47-4923-739611D3D20C}"/>
+                <a16:creationId xmlns:a16="http://schemas.microsoft.com/office/drawing/2014/main" id="{2BE4E9F7-7ADD-BB4E-C2CF-68611E371028}"/>
               </a:ext>
             </a:extLst>
           </p:cNvPr>
@@ -3735,7 +3735,7 @@
           <p:cNvPr id="4" name="CuadroTexto 3">
             <a:extLst>
               <a:ext uri="{FF2B5EF4-FFF2-40B4-BE49-F238E27FC236}">
-                <a16:creationId xmlns:a16="http://schemas.microsoft.com/office/drawing/2014/main" id="{219469AF-74E0-545A-7EE2-3321F726B710}"/>
+                <a16:creationId xmlns:a16="http://schemas.microsoft.com/office/drawing/2014/main" id="{ADECF87B-9681-5FC8-B46E-90823A3D70E6}"/>
               </a:ext>
             </a:extLst>
           </p:cNvPr>
@@ -3775,7 +3775,7 @@
           <p:cNvPr id="5" name="Rectángulo: esquinas redondeadas 4">
             <a:extLst>
               <a:ext uri="{FF2B5EF4-FFF2-40B4-BE49-F238E27FC236}">
-                <a16:creationId xmlns:a16="http://schemas.microsoft.com/office/drawing/2014/main" id="{1711DDAD-F082-BCA4-9ED1-837EFA9EB665}"/>
+                <a16:creationId xmlns:a16="http://schemas.microsoft.com/office/drawing/2014/main" id="{6D1AEA64-2F0E-FD31-1E48-81AA0EE5224C}"/>
               </a:ext>
             </a:extLst>
           </p:cNvPr>
@@ -3829,7 +3829,7 @@
           <p:cNvPr id="6" name="CuadroTexto 5">
             <a:extLst>
               <a:ext uri="{FF2B5EF4-FFF2-40B4-BE49-F238E27FC236}">
-                <a16:creationId xmlns:a16="http://schemas.microsoft.com/office/drawing/2014/main" id="{76A13E2F-B7DB-09AE-0DEA-611461763BA0}"/>
+                <a16:creationId xmlns:a16="http://schemas.microsoft.com/office/drawing/2014/main" id="{CF410CEA-58BF-683F-FA42-462212E14AAD}"/>
               </a:ext>
             </a:extLst>
           </p:cNvPr>
@@ -3869,7 +3869,7 @@
           <p:cNvPr id="7" name="CuadroTexto 6">
             <a:extLst>
               <a:ext uri="{FF2B5EF4-FFF2-40B4-BE49-F238E27FC236}">
-                <a16:creationId xmlns:a16="http://schemas.microsoft.com/office/drawing/2014/main" id="{57C53391-5E60-7DB8-BF96-2A8BD44BB41B}"/>
+                <a16:creationId xmlns:a16="http://schemas.microsoft.com/office/drawing/2014/main" id="{58372610-7914-4758-2055-CF56C828BEEE}"/>
               </a:ext>
             </a:extLst>
           </p:cNvPr>
@@ -3988,7 +3988,7 @@
           <p:cNvPr id="8" name="Rectángulo: esquinas redondeadas 7">
             <a:extLst>
               <a:ext uri="{FF2B5EF4-FFF2-40B4-BE49-F238E27FC236}">
-                <a16:creationId xmlns:a16="http://schemas.microsoft.com/office/drawing/2014/main" id="{F3EA4F40-A00D-4014-B74E-E0942500B6D5}"/>
+                <a16:creationId xmlns:a16="http://schemas.microsoft.com/office/drawing/2014/main" id="{5833D4F6-6461-6404-5CC8-A8AF549C4DF2}"/>
               </a:ext>
             </a:extLst>
           </p:cNvPr>
@@ -4042,7 +4042,7 @@
           <p:cNvPr id="9" name="CuadroTexto 8">
             <a:extLst>
               <a:ext uri="{FF2B5EF4-FFF2-40B4-BE49-F238E27FC236}">
-                <a16:creationId xmlns:a16="http://schemas.microsoft.com/office/drawing/2014/main" id="{105FA132-06B5-98AA-2252-642A93FC30F0}"/>
+                <a16:creationId xmlns:a16="http://schemas.microsoft.com/office/drawing/2014/main" id="{B86E8B70-9A97-A59B-3BF2-43F7B273C367}"/>
               </a:ext>
             </a:extLst>
           </p:cNvPr>
@@ -4082,7 +4082,7 @@
           <p:cNvPr id="10" name="CuadroTexto 9">
             <a:extLst>
               <a:ext uri="{FF2B5EF4-FFF2-40B4-BE49-F238E27FC236}">
-                <a16:creationId xmlns:a16="http://schemas.microsoft.com/office/drawing/2014/main" id="{F6DF0045-A309-75DB-E583-BC19BE3DBE6F}"/>
+                <a16:creationId xmlns:a16="http://schemas.microsoft.com/office/drawing/2014/main" id="{836AD5C9-DA30-BD9E-D349-51EFD08D301A}"/>
               </a:ext>
             </a:extLst>
           </p:cNvPr>
@@ -4122,7 +4122,7 @@
           <p:cNvPr id="11" name="Rectángulo: esquinas redondeadas 10">
             <a:extLst>
               <a:ext uri="{FF2B5EF4-FFF2-40B4-BE49-F238E27FC236}">
-                <a16:creationId xmlns:a16="http://schemas.microsoft.com/office/drawing/2014/main" id="{9D2E0A56-6D22-4A0F-E246-95645F83C1B2}"/>
+                <a16:creationId xmlns:a16="http://schemas.microsoft.com/office/drawing/2014/main" id="{B6486B53-C0B3-3CEC-50CD-AD6DFDCD8DB7}"/>
               </a:ext>
             </a:extLst>
           </p:cNvPr>
@@ -4176,7 +4176,7 @@
           <p:cNvPr id="12" name="CuadroTexto 11">
             <a:extLst>
               <a:ext uri="{FF2B5EF4-FFF2-40B4-BE49-F238E27FC236}">
-                <a16:creationId xmlns:a16="http://schemas.microsoft.com/office/drawing/2014/main" id="{9508AFE7-8CFD-0FF6-B5D8-6A1F1ABFF0B8}"/>
+                <a16:creationId xmlns:a16="http://schemas.microsoft.com/office/drawing/2014/main" id="{B9E83C5C-D7AA-0B77-A468-718A426FADC8}"/>
               </a:ext>
             </a:extLst>
           </p:cNvPr>
@@ -4216,7 +4216,7 @@
           <p:cNvPr id="13" name="CuadroTexto 12">
             <a:extLst>
               <a:ext uri="{FF2B5EF4-FFF2-40B4-BE49-F238E27FC236}">
-                <a16:creationId xmlns:a16="http://schemas.microsoft.com/office/drawing/2014/main" id="{B30D510A-3075-BACE-8938-17866590C4C0}"/>
+                <a16:creationId xmlns:a16="http://schemas.microsoft.com/office/drawing/2014/main" id="{1330EEA6-2376-81FB-AE65-3B8744BB9603}"/>
               </a:ext>
             </a:extLst>
           </p:cNvPr>
@@ -4256,7 +4256,7 @@
           <p:cNvPr id="14" name="Rectángulo: esquinas redondeadas 13">
             <a:extLst>
               <a:ext uri="{FF2B5EF4-FFF2-40B4-BE49-F238E27FC236}">
-                <a16:creationId xmlns:a16="http://schemas.microsoft.com/office/drawing/2014/main" id="{DDB74B9A-DC97-8FB9-3B55-1CE9D0431FC9}"/>
+                <a16:creationId xmlns:a16="http://schemas.microsoft.com/office/drawing/2014/main" id="{1FDF2267-131A-C751-687C-166852FF3B52}"/>
               </a:ext>
             </a:extLst>
           </p:cNvPr>
@@ -4310,7 +4310,7 @@
           <p:cNvPr id="15" name="CuadroTexto 14">
             <a:extLst>
               <a:ext uri="{FF2B5EF4-FFF2-40B4-BE49-F238E27FC236}">
-                <a16:creationId xmlns:a16="http://schemas.microsoft.com/office/drawing/2014/main" id="{5C09EDE9-1D72-935B-4F1D-208CB3808437}"/>
+                <a16:creationId xmlns:a16="http://schemas.microsoft.com/office/drawing/2014/main" id="{CCB386C5-F39C-3FC0-0F45-51A2612BCF1B}"/>
               </a:ext>
             </a:extLst>
           </p:cNvPr>
@@ -4350,7 +4350,7 @@
           <p:cNvPr id="16" name="CuadroTexto 15">
             <a:extLst>
               <a:ext uri="{FF2B5EF4-FFF2-40B4-BE49-F238E27FC236}">
-                <a16:creationId xmlns:a16="http://schemas.microsoft.com/office/drawing/2014/main" id="{5504C2AB-32D7-51B0-8D8D-63B622801529}"/>
+                <a16:creationId xmlns:a16="http://schemas.microsoft.com/office/drawing/2014/main" id="{72DDCB08-4518-EB21-7ACD-F5FDF90651E0}"/>
               </a:ext>
             </a:extLst>
           </p:cNvPr>
@@ -4390,7 +4390,7 @@
           <p:cNvPr id="17" name="Rectángulo: esquinas redondeadas 16">
             <a:extLst>
               <a:ext uri="{FF2B5EF4-FFF2-40B4-BE49-F238E27FC236}">
-                <a16:creationId xmlns:a16="http://schemas.microsoft.com/office/drawing/2014/main" id="{4B58F593-AD63-B552-0688-7DB6DAF48C2E}"/>
+                <a16:creationId xmlns:a16="http://schemas.microsoft.com/office/drawing/2014/main" id="{A320F2B7-174C-1027-38D7-ECFF71D80656}"/>
               </a:ext>
             </a:extLst>
           </p:cNvPr>
@@ -4444,7 +4444,7 @@
           <p:cNvPr id="18" name="CuadroTexto 17">
             <a:extLst>
               <a:ext uri="{FF2B5EF4-FFF2-40B4-BE49-F238E27FC236}">
-                <a16:creationId xmlns:a16="http://schemas.microsoft.com/office/drawing/2014/main" id="{307EEDE5-3F42-E0C3-85B0-EEEEDBBE1196}"/>
+                <a16:creationId xmlns:a16="http://schemas.microsoft.com/office/drawing/2014/main" id="{FB53001C-A200-2209-3614-1259FBB90E1D}"/>
               </a:ext>
             </a:extLst>
           </p:cNvPr>
@@ -4484,7 +4484,7 @@
           <p:cNvPr id="19" name="CuadroTexto 18">
             <a:extLst>
               <a:ext uri="{FF2B5EF4-FFF2-40B4-BE49-F238E27FC236}">
-                <a16:creationId xmlns:a16="http://schemas.microsoft.com/office/drawing/2014/main" id="{9C9DC3D6-AFBF-D787-D231-DD172FA254D4}"/>
+                <a16:creationId xmlns:a16="http://schemas.microsoft.com/office/drawing/2014/main" id="{B71A4644-3886-B7F2-8B3F-ADB935E517C2}"/>
               </a:ext>
             </a:extLst>
           </p:cNvPr>
@@ -4522,7 +4522,7 @@
     </p:spTree>
     <p:extLst>
       <p:ext uri="{BB962C8B-B14F-4D97-AF65-F5344CB8AC3E}">
-        <p14:creationId xmlns:p14="http://schemas.microsoft.com/office/powerpoint/2010/main" val="3163905367"/>
+        <p14:creationId xmlns:p14="http://schemas.microsoft.com/office/powerpoint/2010/main" val="3510644319"/>
       </p:ext>
     </p:extLst>
   </p:cSld>
@@ -4562,7 +4562,7 @@
           <p:cNvPr id="2" name="CuadroTexto 1">
             <a:extLst>
               <a:ext uri="{FF2B5EF4-FFF2-40B4-BE49-F238E27FC236}">
-                <a16:creationId xmlns:a16="http://schemas.microsoft.com/office/drawing/2014/main" id="{335F3ACD-6D7E-558F-DCCC-3153F82008B0}"/>
+                <a16:creationId xmlns:a16="http://schemas.microsoft.com/office/drawing/2014/main" id="{7CEEDE5F-50BB-0917-399B-C8FB6165E00C}"/>
               </a:ext>
             </a:extLst>
           </p:cNvPr>
@@ -4602,7 +4602,7 @@
           <p:cNvPr id="3" name="CuadroTexto 2">
             <a:extLst>
               <a:ext uri="{FF2B5EF4-FFF2-40B4-BE49-F238E27FC236}">
-                <a16:creationId xmlns:a16="http://schemas.microsoft.com/office/drawing/2014/main" id="{69B93B46-68C3-01DA-F96E-996FF02A0DDC}"/>
+                <a16:creationId xmlns:a16="http://schemas.microsoft.com/office/drawing/2014/main" id="{23804E9C-6A0D-07F4-AB1E-A3F992B98FA4}"/>
               </a:ext>
             </a:extLst>
           </p:cNvPr>
@@ -4642,7 +4642,7 @@
           <p:cNvPr id="4" name="CuadroTexto 3">
             <a:extLst>
               <a:ext uri="{FF2B5EF4-FFF2-40B4-BE49-F238E27FC236}">
-                <a16:creationId xmlns:a16="http://schemas.microsoft.com/office/drawing/2014/main" id="{409939A8-2448-44CA-16EA-FE600681691A}"/>
+                <a16:creationId xmlns:a16="http://schemas.microsoft.com/office/drawing/2014/main" id="{E9394BCA-BA92-1008-BE68-D26ED27277C6}"/>
               </a:ext>
             </a:extLst>
           </p:cNvPr>
@@ -4682,7 +4682,7 @@
           <p:cNvPr id="5" name="Rectángulo: esquinas redondeadas 4">
             <a:extLst>
               <a:ext uri="{FF2B5EF4-FFF2-40B4-BE49-F238E27FC236}">
-                <a16:creationId xmlns:a16="http://schemas.microsoft.com/office/drawing/2014/main" id="{FE36CB12-3F6B-8C73-109F-8925106B4365}"/>
+                <a16:creationId xmlns:a16="http://schemas.microsoft.com/office/drawing/2014/main" id="{0A08D243-A7CA-D48E-592D-D1455304947E}"/>
               </a:ext>
             </a:extLst>
           </p:cNvPr>
@@ -4736,7 +4736,7 @@
           <p:cNvPr id="6" name="CuadroTexto 5">
             <a:extLst>
               <a:ext uri="{FF2B5EF4-FFF2-40B4-BE49-F238E27FC236}">
-                <a16:creationId xmlns:a16="http://schemas.microsoft.com/office/drawing/2014/main" id="{8064C8B6-4FC8-72DF-DB7D-38C0B54EEB90}"/>
+                <a16:creationId xmlns:a16="http://schemas.microsoft.com/office/drawing/2014/main" id="{5FC70503-32F7-AB23-6077-DB168DA4F5EE}"/>
               </a:ext>
             </a:extLst>
           </p:cNvPr>
@@ -4776,7 +4776,7 @@
           <p:cNvPr id="7" name="CuadroTexto 6">
             <a:extLst>
               <a:ext uri="{FF2B5EF4-FFF2-40B4-BE49-F238E27FC236}">
-                <a16:creationId xmlns:a16="http://schemas.microsoft.com/office/drawing/2014/main" id="{34FBAB40-7507-AABA-BD78-3A210EDF719B}"/>
+                <a16:creationId xmlns:a16="http://schemas.microsoft.com/office/drawing/2014/main" id="{0A6A47F9-1C47-765B-E66E-F0E29EB720CC}"/>
               </a:ext>
             </a:extLst>
           </p:cNvPr>
@@ -4816,7 +4816,7 @@
           <p:cNvPr id="8" name="Rectángulo: esquinas redondeadas 7">
             <a:extLst>
               <a:ext uri="{FF2B5EF4-FFF2-40B4-BE49-F238E27FC236}">
-                <a16:creationId xmlns:a16="http://schemas.microsoft.com/office/drawing/2014/main" id="{5066D45E-EB66-0063-7ABA-758AC6A4EC3A}"/>
+                <a16:creationId xmlns:a16="http://schemas.microsoft.com/office/drawing/2014/main" id="{4E3EC0F7-D648-EAAB-3301-1960AE2E2FA6}"/>
               </a:ext>
             </a:extLst>
           </p:cNvPr>
@@ -4870,7 +4870,7 @@
           <p:cNvPr id="9" name="CuadroTexto 8">
             <a:extLst>
               <a:ext uri="{FF2B5EF4-FFF2-40B4-BE49-F238E27FC236}">
-                <a16:creationId xmlns:a16="http://schemas.microsoft.com/office/drawing/2014/main" id="{CEA7E78D-7589-43E1-79CE-8B4EA40E8A4A}"/>
+                <a16:creationId xmlns:a16="http://schemas.microsoft.com/office/drawing/2014/main" id="{C8BF4BF4-695A-D88E-1F0F-1EB784C5D477}"/>
               </a:ext>
             </a:extLst>
           </p:cNvPr>
@@ -4910,7 +4910,7 @@
           <p:cNvPr id="10" name="CuadroTexto 9">
             <a:extLst>
               <a:ext uri="{FF2B5EF4-FFF2-40B4-BE49-F238E27FC236}">
-                <a16:creationId xmlns:a16="http://schemas.microsoft.com/office/drawing/2014/main" id="{92F702A2-5CEB-7576-A787-8A61EFA2127E}"/>
+                <a16:creationId xmlns:a16="http://schemas.microsoft.com/office/drawing/2014/main" id="{8F00DB8B-7F11-3273-5889-9453992EA05C}"/>
               </a:ext>
             </a:extLst>
           </p:cNvPr>
@@ -4950,7 +4950,7 @@
           <p:cNvPr id="11" name="Rectángulo: esquinas redondeadas 10">
             <a:extLst>
               <a:ext uri="{FF2B5EF4-FFF2-40B4-BE49-F238E27FC236}">
-                <a16:creationId xmlns:a16="http://schemas.microsoft.com/office/drawing/2014/main" id="{0F3E7393-FB97-F29D-F9BB-FBBFB5EDC115}"/>
+                <a16:creationId xmlns:a16="http://schemas.microsoft.com/office/drawing/2014/main" id="{4711F600-0351-B6A8-7F18-D27788BD4C54}"/>
               </a:ext>
             </a:extLst>
           </p:cNvPr>
@@ -5004,7 +5004,7 @@
           <p:cNvPr id="12" name="CuadroTexto 11">
             <a:extLst>
               <a:ext uri="{FF2B5EF4-FFF2-40B4-BE49-F238E27FC236}">
-                <a16:creationId xmlns:a16="http://schemas.microsoft.com/office/drawing/2014/main" id="{D1DF95A3-3B8C-BBCB-440D-FF242319D753}"/>
+                <a16:creationId xmlns:a16="http://schemas.microsoft.com/office/drawing/2014/main" id="{A6138A3E-6C95-0782-580B-B7ED3EDDCC21}"/>
               </a:ext>
             </a:extLst>
           </p:cNvPr>
@@ -5044,7 +5044,7 @@
           <p:cNvPr id="13" name="CuadroTexto 12">
             <a:extLst>
               <a:ext uri="{FF2B5EF4-FFF2-40B4-BE49-F238E27FC236}">
-                <a16:creationId xmlns:a16="http://schemas.microsoft.com/office/drawing/2014/main" id="{E96EBE17-31C8-2466-B02D-8F17579092DD}"/>
+                <a16:creationId xmlns:a16="http://schemas.microsoft.com/office/drawing/2014/main" id="{5C48DFCA-94A5-8E0A-C947-1CDD1AB1A164}"/>
               </a:ext>
             </a:extLst>
           </p:cNvPr>
@@ -5084,7 +5084,7 @@
           <p:cNvPr id="14" name="CuadroTexto 13">
             <a:extLst>
               <a:ext uri="{FF2B5EF4-FFF2-40B4-BE49-F238E27FC236}">
-                <a16:creationId xmlns:a16="http://schemas.microsoft.com/office/drawing/2014/main" id="{618D0947-2F0A-2FE3-C043-548405AC1F5D}"/>
+                <a16:creationId xmlns:a16="http://schemas.microsoft.com/office/drawing/2014/main" id="{EE5CC75F-F5EF-31C9-EC42-68947BF0DFDB}"/>
               </a:ext>
             </a:extLst>
           </p:cNvPr>
@@ -5165,7 +5165,7 @@
     </p:spTree>
     <p:extLst>
       <p:ext uri="{BB962C8B-B14F-4D97-AF65-F5344CB8AC3E}">
-        <p14:creationId xmlns:p14="http://schemas.microsoft.com/office/powerpoint/2010/main" val="1478726641"/>
+        <p14:creationId xmlns:p14="http://schemas.microsoft.com/office/powerpoint/2010/main" val="2469724980"/>
       </p:ext>
     </p:extLst>
   </p:cSld>
@@ -5205,7 +5205,7 @@
           <p:cNvPr id="2" name="CuadroTexto 1">
             <a:extLst>
               <a:ext uri="{FF2B5EF4-FFF2-40B4-BE49-F238E27FC236}">
-                <a16:creationId xmlns:a16="http://schemas.microsoft.com/office/drawing/2014/main" id="{ED226011-882C-5D32-E9F7-E07A5A18B3EE}"/>
+                <a16:creationId xmlns:a16="http://schemas.microsoft.com/office/drawing/2014/main" id="{7B7D82D7-B708-D180-EFB4-6C21EF8B331C}"/>
               </a:ext>
             </a:extLst>
           </p:cNvPr>
@@ -5245,7 +5245,7 @@
           <p:cNvPr id="3" name="CuadroTexto 2">
             <a:extLst>
               <a:ext uri="{FF2B5EF4-FFF2-40B4-BE49-F238E27FC236}">
-                <a16:creationId xmlns:a16="http://schemas.microsoft.com/office/drawing/2014/main" id="{6EBBE66B-C209-06AB-7B21-134AF129D97E}"/>
+                <a16:creationId xmlns:a16="http://schemas.microsoft.com/office/drawing/2014/main" id="{6FADF928-4261-2380-B043-AEF1226E6AF9}"/>
               </a:ext>
             </a:extLst>
           </p:cNvPr>
@@ -5285,7 +5285,7 @@
           <p:cNvPr id="4" name="CuadroTexto 3">
             <a:extLst>
               <a:ext uri="{FF2B5EF4-FFF2-40B4-BE49-F238E27FC236}">
-                <a16:creationId xmlns:a16="http://schemas.microsoft.com/office/drawing/2014/main" id="{9B7CD03D-62F3-7881-498F-DFEEF490B40D}"/>
+                <a16:creationId xmlns:a16="http://schemas.microsoft.com/office/drawing/2014/main" id="{C0E91017-F843-F648-311B-F90979922D69}"/>
               </a:ext>
             </a:extLst>
           </p:cNvPr>
@@ -5325,7 +5325,7 @@
           <p:cNvPr id="6" name="Imagen 5">
             <a:extLst>
               <a:ext uri="{FF2B5EF4-FFF2-40B4-BE49-F238E27FC236}">
-                <a16:creationId xmlns:a16="http://schemas.microsoft.com/office/drawing/2014/main" id="{6FD68646-2437-6E7B-BC5A-E81618CDDD5C}"/>
+                <a16:creationId xmlns:a16="http://schemas.microsoft.com/office/drawing/2014/main" id="{EFCDCC7E-691C-B01A-77BD-D8B6B8C710B0}"/>
               </a:ext>
             </a:extLst>
           </p:cNvPr>
@@ -5366,7 +5366,7 @@
           <p:cNvPr id="7" name="Rectángulo: esquinas redondeadas 6">
             <a:extLst>
               <a:ext uri="{FF2B5EF4-FFF2-40B4-BE49-F238E27FC236}">
-                <a16:creationId xmlns:a16="http://schemas.microsoft.com/office/drawing/2014/main" id="{DBFDBCC1-E1EF-D77B-8FE3-CE19CEAE6F0F}"/>
+                <a16:creationId xmlns:a16="http://schemas.microsoft.com/office/drawing/2014/main" id="{353A1019-86EF-FDFC-F858-663ED918FAF0}"/>
               </a:ext>
             </a:extLst>
           </p:cNvPr>
@@ -5420,7 +5420,7 @@
           <p:cNvPr id="8" name="CuadroTexto 7">
             <a:extLst>
               <a:ext uri="{FF2B5EF4-FFF2-40B4-BE49-F238E27FC236}">
-                <a16:creationId xmlns:a16="http://schemas.microsoft.com/office/drawing/2014/main" id="{70ACC945-01BD-D4E7-6294-F7EF4B534FDF}"/>
+                <a16:creationId xmlns:a16="http://schemas.microsoft.com/office/drawing/2014/main" id="{6CE17BF1-6AD2-F32C-9450-44ACDA473674}"/>
               </a:ext>
             </a:extLst>
           </p:cNvPr>
@@ -5460,7 +5460,7 @@
           <p:cNvPr id="9" name="CuadroTexto 8">
             <a:extLst>
               <a:ext uri="{FF2B5EF4-FFF2-40B4-BE49-F238E27FC236}">
-                <a16:creationId xmlns:a16="http://schemas.microsoft.com/office/drawing/2014/main" id="{F7AC6533-69F5-F6BB-1B20-2EADCB7D8E47}"/>
+                <a16:creationId xmlns:a16="http://schemas.microsoft.com/office/drawing/2014/main" id="{BA4A0975-109E-4A3F-4B54-EFDA114C070B}"/>
               </a:ext>
             </a:extLst>
           </p:cNvPr>
@@ -5500,7 +5500,7 @@
           <p:cNvPr id="10" name="CuadroTexto 9">
             <a:extLst>
               <a:ext uri="{FF2B5EF4-FFF2-40B4-BE49-F238E27FC236}">
-                <a16:creationId xmlns:a16="http://schemas.microsoft.com/office/drawing/2014/main" id="{20213126-36BE-9D61-BB6F-48D2DAA61D48}"/>
+                <a16:creationId xmlns:a16="http://schemas.microsoft.com/office/drawing/2014/main" id="{5ABF088D-72A3-3D27-051A-1B4A038ED58F}"/>
               </a:ext>
             </a:extLst>
           </p:cNvPr>
@@ -5599,7 +5599,7 @@
     </p:spTree>
     <p:extLst>
       <p:ext uri="{BB962C8B-B14F-4D97-AF65-F5344CB8AC3E}">
-        <p14:creationId xmlns:p14="http://schemas.microsoft.com/office/powerpoint/2010/main" val="1591126200"/>
+        <p14:creationId xmlns:p14="http://schemas.microsoft.com/office/powerpoint/2010/main" val="3632644678"/>
       </p:ext>
     </p:extLst>
   </p:cSld>
@@ -5639,7 +5639,7 @@
           <p:cNvPr id="2" name="CuadroTexto 1">
             <a:extLst>
               <a:ext uri="{FF2B5EF4-FFF2-40B4-BE49-F238E27FC236}">
-                <a16:creationId xmlns:a16="http://schemas.microsoft.com/office/drawing/2014/main" id="{F0FEA101-1787-D34F-EBCE-81821753563A}"/>
+                <a16:creationId xmlns:a16="http://schemas.microsoft.com/office/drawing/2014/main" id="{F6A78540-E163-B045-AC3A-A21791E4B814}"/>
               </a:ext>
             </a:extLst>
           </p:cNvPr>
@@ -5679,7 +5679,7 @@
           <p:cNvPr id="3" name="CuadroTexto 2">
             <a:extLst>
               <a:ext uri="{FF2B5EF4-FFF2-40B4-BE49-F238E27FC236}">
-                <a16:creationId xmlns:a16="http://schemas.microsoft.com/office/drawing/2014/main" id="{0BE57B89-4ECA-778F-091E-780B6A53E81A}"/>
+                <a16:creationId xmlns:a16="http://schemas.microsoft.com/office/drawing/2014/main" id="{B24BB97B-08C7-2FD3-87D1-4D571DA1EB59}"/>
               </a:ext>
             </a:extLst>
           </p:cNvPr>
@@ -5719,7 +5719,7 @@
           <p:cNvPr id="4" name="CuadroTexto 3">
             <a:extLst>
               <a:ext uri="{FF2B5EF4-FFF2-40B4-BE49-F238E27FC236}">
-                <a16:creationId xmlns:a16="http://schemas.microsoft.com/office/drawing/2014/main" id="{D8359D4C-15E0-EF2F-320C-1AECD8A8143D}"/>
+                <a16:creationId xmlns:a16="http://schemas.microsoft.com/office/drawing/2014/main" id="{5515BA48-9782-B0B0-ABA3-86A36CC8BA90}"/>
               </a:ext>
             </a:extLst>
           </p:cNvPr>
@@ -5759,7 +5759,7 @@
           <p:cNvPr id="6" name="Imagen 5">
             <a:extLst>
               <a:ext uri="{FF2B5EF4-FFF2-40B4-BE49-F238E27FC236}">
-                <a16:creationId xmlns:a16="http://schemas.microsoft.com/office/drawing/2014/main" id="{E368E9F4-87A0-5B38-0FA9-F674CD3CCE24}"/>
+                <a16:creationId xmlns:a16="http://schemas.microsoft.com/office/drawing/2014/main" id="{B1D285CA-55C4-F977-7CF5-70DB4D2C5CA7}"/>
               </a:ext>
             </a:extLst>
           </p:cNvPr>
@@ -5782,8 +5782,8 @@
         </p:blipFill>
         <p:spPr>
           <a:xfrm>
-            <a:off x="538560" y="1879600"/>
-            <a:ext cx="5679281" cy="4038600"/>
+            <a:off x="1387471" y="1879600"/>
+            <a:ext cx="3981459" cy="4038600"/>
           </a:xfrm>
           <a:prstGeom prst="rect">
             <a:avLst/>
@@ -5800,7 +5800,7 @@
           <p:cNvPr id="7" name="CuadroTexto 6">
             <a:extLst>
               <a:ext uri="{FF2B5EF4-FFF2-40B4-BE49-F238E27FC236}">
-                <a16:creationId xmlns:a16="http://schemas.microsoft.com/office/drawing/2014/main" id="{D8ED3307-E8D5-7A56-34A1-97FA5618ED28}"/>
+                <a16:creationId xmlns:a16="http://schemas.microsoft.com/office/drawing/2014/main" id="{31E57BAD-3F1E-06EE-E8B0-E17A430D6065}"/>
               </a:ext>
             </a:extLst>
           </p:cNvPr>
@@ -5917,7 +5917,7 @@
     </p:spTree>
     <p:extLst>
       <p:ext uri="{BB962C8B-B14F-4D97-AF65-F5344CB8AC3E}">
-        <p14:creationId xmlns:p14="http://schemas.microsoft.com/office/powerpoint/2010/main" val="4092572609"/>
+        <p14:creationId xmlns:p14="http://schemas.microsoft.com/office/powerpoint/2010/main" val="3572334078"/>
       </p:ext>
     </p:extLst>
   </p:cSld>
@@ -5957,7 +5957,7 @@
           <p:cNvPr id="2" name="CuadroTexto 1">
             <a:extLst>
               <a:ext uri="{FF2B5EF4-FFF2-40B4-BE49-F238E27FC236}">
-                <a16:creationId xmlns:a16="http://schemas.microsoft.com/office/drawing/2014/main" id="{EC079CF6-847E-B171-8FC9-EE51868AA9FC}"/>
+                <a16:creationId xmlns:a16="http://schemas.microsoft.com/office/drawing/2014/main" id="{15AE60CF-E363-2B77-E838-C415AFE35984}"/>
               </a:ext>
             </a:extLst>
           </p:cNvPr>
@@ -5997,7 +5997,7 @@
           <p:cNvPr id="3" name="CuadroTexto 2">
             <a:extLst>
               <a:ext uri="{FF2B5EF4-FFF2-40B4-BE49-F238E27FC236}">
-                <a16:creationId xmlns:a16="http://schemas.microsoft.com/office/drawing/2014/main" id="{C313C642-87F1-721E-4386-6FE868113DC6}"/>
+                <a16:creationId xmlns:a16="http://schemas.microsoft.com/office/drawing/2014/main" id="{6345F1B8-1C3A-3B10-C5A6-DE1CB265F91C}"/>
               </a:ext>
             </a:extLst>
           </p:cNvPr>
@@ -6037,7 +6037,7 @@
           <p:cNvPr id="4" name="Rectángulo: esquinas redondeadas 3">
             <a:extLst>
               <a:ext uri="{FF2B5EF4-FFF2-40B4-BE49-F238E27FC236}">
-                <a16:creationId xmlns:a16="http://schemas.microsoft.com/office/drawing/2014/main" id="{85BECDB7-B362-8231-9619-F2E5D58A1005}"/>
+                <a16:creationId xmlns:a16="http://schemas.microsoft.com/office/drawing/2014/main" id="{D0A90649-836B-F320-C443-410EE1435B1E}"/>
               </a:ext>
             </a:extLst>
           </p:cNvPr>
@@ -6091,7 +6091,7 @@
           <p:cNvPr id="5" name="CuadroTexto 4">
             <a:extLst>
               <a:ext uri="{FF2B5EF4-FFF2-40B4-BE49-F238E27FC236}">
-                <a16:creationId xmlns:a16="http://schemas.microsoft.com/office/drawing/2014/main" id="{3E29C3F1-5EA6-5F0B-438B-8715970D4802}"/>
+                <a16:creationId xmlns:a16="http://schemas.microsoft.com/office/drawing/2014/main" id="{8A32F3C5-F477-675B-904F-367B449B30C3}"/>
               </a:ext>
             </a:extLst>
           </p:cNvPr>
@@ -6131,7 +6131,7 @@
           <p:cNvPr id="6" name="CuadroTexto 5">
             <a:extLst>
               <a:ext uri="{FF2B5EF4-FFF2-40B4-BE49-F238E27FC236}">
-                <a16:creationId xmlns:a16="http://schemas.microsoft.com/office/drawing/2014/main" id="{7D0116EA-CA58-8658-8A63-448B22684393}"/>
+                <a16:creationId xmlns:a16="http://schemas.microsoft.com/office/drawing/2014/main" id="{E04E598E-D48E-B088-0D0B-9388D2FC5F4A}"/>
               </a:ext>
             </a:extLst>
           </p:cNvPr>
@@ -6171,7 +6171,7 @@
           <p:cNvPr id="7" name="Rectángulo: esquinas redondeadas 6">
             <a:extLst>
               <a:ext uri="{FF2B5EF4-FFF2-40B4-BE49-F238E27FC236}">
-                <a16:creationId xmlns:a16="http://schemas.microsoft.com/office/drawing/2014/main" id="{FE84D8D8-90E1-8533-7204-D3D2A4BF27ED}"/>
+                <a16:creationId xmlns:a16="http://schemas.microsoft.com/office/drawing/2014/main" id="{BE6487A0-3224-A6D8-B359-0197FDA6444F}"/>
               </a:ext>
             </a:extLst>
           </p:cNvPr>
@@ -6225,7 +6225,7 @@
           <p:cNvPr id="8" name="CuadroTexto 7">
             <a:extLst>
               <a:ext uri="{FF2B5EF4-FFF2-40B4-BE49-F238E27FC236}">
-                <a16:creationId xmlns:a16="http://schemas.microsoft.com/office/drawing/2014/main" id="{E87F0B20-E7AC-6505-CF65-3BA1DF35B8D6}"/>
+                <a16:creationId xmlns:a16="http://schemas.microsoft.com/office/drawing/2014/main" id="{05614C6C-273F-16ED-15D0-483983C97A65}"/>
               </a:ext>
             </a:extLst>
           </p:cNvPr>
@@ -6265,7 +6265,7 @@
           <p:cNvPr id="9" name="CuadroTexto 8">
             <a:extLst>
               <a:ext uri="{FF2B5EF4-FFF2-40B4-BE49-F238E27FC236}">
-                <a16:creationId xmlns:a16="http://schemas.microsoft.com/office/drawing/2014/main" id="{2C214E30-597D-FEC0-05E2-F3AC74E7DEB8}"/>
+                <a16:creationId xmlns:a16="http://schemas.microsoft.com/office/drawing/2014/main" id="{68077E7A-068F-2D77-2B1B-E8861C37ADB6}"/>
               </a:ext>
             </a:extLst>
           </p:cNvPr>
@@ -6305,7 +6305,7 @@
           <p:cNvPr id="10" name="Rectángulo: esquinas redondeadas 9">
             <a:extLst>
               <a:ext uri="{FF2B5EF4-FFF2-40B4-BE49-F238E27FC236}">
-                <a16:creationId xmlns:a16="http://schemas.microsoft.com/office/drawing/2014/main" id="{98FCAEE6-CF8C-4E2F-0F19-93531F6094D9}"/>
+                <a16:creationId xmlns:a16="http://schemas.microsoft.com/office/drawing/2014/main" id="{305A896B-439F-8186-6897-B359BC044784}"/>
               </a:ext>
             </a:extLst>
           </p:cNvPr>
@@ -6359,7 +6359,7 @@
           <p:cNvPr id="11" name="CuadroTexto 10">
             <a:extLst>
               <a:ext uri="{FF2B5EF4-FFF2-40B4-BE49-F238E27FC236}">
-                <a16:creationId xmlns:a16="http://schemas.microsoft.com/office/drawing/2014/main" id="{C9DD5221-CB77-3946-945B-ED03C56B4F18}"/>
+                <a16:creationId xmlns:a16="http://schemas.microsoft.com/office/drawing/2014/main" id="{FADC988E-5836-9656-712D-3215B31FE7BF}"/>
               </a:ext>
             </a:extLst>
           </p:cNvPr>
@@ -6399,7 +6399,7 @@
           <p:cNvPr id="12" name="CuadroTexto 11">
             <a:extLst>
               <a:ext uri="{FF2B5EF4-FFF2-40B4-BE49-F238E27FC236}">
-                <a16:creationId xmlns:a16="http://schemas.microsoft.com/office/drawing/2014/main" id="{56A59FD6-B3A1-CD70-9DE0-3E8780A7FAA4}"/>
+                <a16:creationId xmlns:a16="http://schemas.microsoft.com/office/drawing/2014/main" id="{D21C7DB2-EE2A-0A1F-4162-D417B0F42D11}"/>
               </a:ext>
             </a:extLst>
           </p:cNvPr>
@@ -6439,7 +6439,7 @@
           <p:cNvPr id="13" name="Rectángulo: esquinas redondeadas 12">
             <a:extLst>
               <a:ext uri="{FF2B5EF4-FFF2-40B4-BE49-F238E27FC236}">
-                <a16:creationId xmlns:a16="http://schemas.microsoft.com/office/drawing/2014/main" id="{0B1F8AD1-7F45-EF05-0EFE-43C74B89FCF5}"/>
+                <a16:creationId xmlns:a16="http://schemas.microsoft.com/office/drawing/2014/main" id="{6B5B5511-EA4D-2EE1-1213-81E93F30634A}"/>
               </a:ext>
             </a:extLst>
           </p:cNvPr>
@@ -6493,7 +6493,7 @@
           <p:cNvPr id="14" name="CuadroTexto 13">
             <a:extLst>
               <a:ext uri="{FF2B5EF4-FFF2-40B4-BE49-F238E27FC236}">
-                <a16:creationId xmlns:a16="http://schemas.microsoft.com/office/drawing/2014/main" id="{3F364583-14F5-A4A3-5040-F37EDCE902B2}"/>
+                <a16:creationId xmlns:a16="http://schemas.microsoft.com/office/drawing/2014/main" id="{DEA772EB-F063-0849-8BFF-693972605AC4}"/>
               </a:ext>
             </a:extLst>
           </p:cNvPr>
@@ -6533,7 +6533,7 @@
           <p:cNvPr id="15" name="CuadroTexto 14">
             <a:extLst>
               <a:ext uri="{FF2B5EF4-FFF2-40B4-BE49-F238E27FC236}">
-                <a16:creationId xmlns:a16="http://schemas.microsoft.com/office/drawing/2014/main" id="{CF160FCF-4064-F354-0757-E15C94A23CEA}"/>
+                <a16:creationId xmlns:a16="http://schemas.microsoft.com/office/drawing/2014/main" id="{2A8E837A-F4C8-C811-0E70-980D4A2F5CEF}"/>
               </a:ext>
             </a:extLst>
           </p:cNvPr>
@@ -6573,7 +6573,7 @@
           <p:cNvPr id="16" name="CuadroTexto 15">
             <a:extLst>
               <a:ext uri="{FF2B5EF4-FFF2-40B4-BE49-F238E27FC236}">
-                <a16:creationId xmlns:a16="http://schemas.microsoft.com/office/drawing/2014/main" id="{F42B4C6B-081C-983E-4721-C578D827C133}"/>
+                <a16:creationId xmlns:a16="http://schemas.microsoft.com/office/drawing/2014/main" id="{FEB59DB2-FCAD-9268-E5F8-4DF8C6FC3CFA}"/>
               </a:ext>
             </a:extLst>
           </p:cNvPr>
@@ -6656,7 +6656,7 @@
           <p:cNvPr id="17" name="CuadroTexto 16">
             <a:extLst>
               <a:ext uri="{FF2B5EF4-FFF2-40B4-BE49-F238E27FC236}">
-                <a16:creationId xmlns:a16="http://schemas.microsoft.com/office/drawing/2014/main" id="{DDAC2496-CB21-BB79-6A8F-1736264AA6EB}"/>
+                <a16:creationId xmlns:a16="http://schemas.microsoft.com/office/drawing/2014/main" id="{E23E7F99-4563-27D9-DD28-122A6E1B635A}"/>
               </a:ext>
             </a:extLst>
           </p:cNvPr>
@@ -6694,7 +6694,7 @@
     </p:spTree>
     <p:extLst>
       <p:ext uri="{BB962C8B-B14F-4D97-AF65-F5344CB8AC3E}">
-        <p14:creationId xmlns:p14="http://schemas.microsoft.com/office/powerpoint/2010/main" val="759711986"/>
+        <p14:creationId xmlns:p14="http://schemas.microsoft.com/office/powerpoint/2010/main" val="1833900103"/>
       </p:ext>
     </p:extLst>
   </p:cSld>
@@ -6734,7 +6734,7 @@
           <p:cNvPr id="2" name="CuadroTexto 1">
             <a:extLst>
               <a:ext uri="{FF2B5EF4-FFF2-40B4-BE49-F238E27FC236}">
-                <a16:creationId xmlns:a16="http://schemas.microsoft.com/office/drawing/2014/main" id="{5F0FB4CF-CD89-070F-975D-674DF1115C7B}"/>
+                <a16:creationId xmlns:a16="http://schemas.microsoft.com/office/drawing/2014/main" id="{B3F4C206-8459-F939-248A-3FB31B3C47E2}"/>
               </a:ext>
             </a:extLst>
           </p:cNvPr>
@@ -6774,7 +6774,7 @@
           <p:cNvPr id="3" name="CuadroTexto 2">
             <a:extLst>
               <a:ext uri="{FF2B5EF4-FFF2-40B4-BE49-F238E27FC236}">
-                <a16:creationId xmlns:a16="http://schemas.microsoft.com/office/drawing/2014/main" id="{5C7F7206-889E-083C-0320-557B21F7B36B}"/>
+                <a16:creationId xmlns:a16="http://schemas.microsoft.com/office/drawing/2014/main" id="{3536A14B-98AD-330D-E3A2-5F9C5FECCDBE}"/>
               </a:ext>
             </a:extLst>
           </p:cNvPr>
@@ -6814,7 +6814,7 @@
           <p:cNvPr id="4" name="CuadroTexto 3">
             <a:extLst>
               <a:ext uri="{FF2B5EF4-FFF2-40B4-BE49-F238E27FC236}">
-                <a16:creationId xmlns:a16="http://schemas.microsoft.com/office/drawing/2014/main" id="{B1BC3496-DE1B-F1DC-BE3A-CA6209C02ADB}"/>
+                <a16:creationId xmlns:a16="http://schemas.microsoft.com/office/drawing/2014/main" id="{123D2F72-8993-A09C-30B6-5CF217848F11}"/>
               </a:ext>
             </a:extLst>
           </p:cNvPr>
@@ -6854,7 +6854,7 @@
           <p:cNvPr id="5" name="Rectángulo: esquinas redondeadas 4">
             <a:extLst>
               <a:ext uri="{FF2B5EF4-FFF2-40B4-BE49-F238E27FC236}">
-                <a16:creationId xmlns:a16="http://schemas.microsoft.com/office/drawing/2014/main" id="{63E13D95-BD0D-3E84-2634-A940742D71A5}"/>
+                <a16:creationId xmlns:a16="http://schemas.microsoft.com/office/drawing/2014/main" id="{A16CFE9C-F638-2584-7F3C-213C43EF5B70}"/>
               </a:ext>
             </a:extLst>
           </p:cNvPr>
@@ -6908,7 +6908,7 @@
           <p:cNvPr id="6" name="CuadroTexto 5">
             <a:extLst>
               <a:ext uri="{FF2B5EF4-FFF2-40B4-BE49-F238E27FC236}">
-                <a16:creationId xmlns:a16="http://schemas.microsoft.com/office/drawing/2014/main" id="{4E7E188B-4D9F-3058-AD3A-65F08844F2E9}"/>
+                <a16:creationId xmlns:a16="http://schemas.microsoft.com/office/drawing/2014/main" id="{7854F5D6-9D86-50AB-E2B3-EB4E442655C9}"/>
               </a:ext>
             </a:extLst>
           </p:cNvPr>
@@ -6948,7 +6948,7 @@
           <p:cNvPr id="7" name="CuadroTexto 6">
             <a:extLst>
               <a:ext uri="{FF2B5EF4-FFF2-40B4-BE49-F238E27FC236}">
-                <a16:creationId xmlns:a16="http://schemas.microsoft.com/office/drawing/2014/main" id="{BF17D35A-B719-4E36-CAF5-9BF82D8F1071}"/>
+                <a16:creationId xmlns:a16="http://schemas.microsoft.com/office/drawing/2014/main" id="{E19AF8D8-CD8A-01CD-7F41-07B8C580CB33}"/>
               </a:ext>
             </a:extLst>
           </p:cNvPr>
@@ -6988,7 +6988,7 @@
           <p:cNvPr id="8" name="Rectángulo: esquinas redondeadas 7">
             <a:extLst>
               <a:ext uri="{FF2B5EF4-FFF2-40B4-BE49-F238E27FC236}">
-                <a16:creationId xmlns:a16="http://schemas.microsoft.com/office/drawing/2014/main" id="{777739E0-3CDD-0B09-60EB-C69716BC7E69}"/>
+                <a16:creationId xmlns:a16="http://schemas.microsoft.com/office/drawing/2014/main" id="{2A074F37-BF29-B61B-C7A0-718A5DEC485C}"/>
               </a:ext>
             </a:extLst>
           </p:cNvPr>
@@ -7042,7 +7042,7 @@
           <p:cNvPr id="9" name="CuadroTexto 8">
             <a:extLst>
               <a:ext uri="{FF2B5EF4-FFF2-40B4-BE49-F238E27FC236}">
-                <a16:creationId xmlns:a16="http://schemas.microsoft.com/office/drawing/2014/main" id="{7051E15C-4CDE-E078-CF5F-A8410C9D6F57}"/>
+                <a16:creationId xmlns:a16="http://schemas.microsoft.com/office/drawing/2014/main" id="{B2AC185B-6514-73F1-A3E5-E984F68B9902}"/>
               </a:ext>
             </a:extLst>
           </p:cNvPr>
@@ -7082,7 +7082,7 @@
           <p:cNvPr id="10" name="CuadroTexto 9">
             <a:extLst>
               <a:ext uri="{FF2B5EF4-FFF2-40B4-BE49-F238E27FC236}">
-                <a16:creationId xmlns:a16="http://schemas.microsoft.com/office/drawing/2014/main" id="{1B9FCC05-FE2F-3DDE-EB22-D8A363E94EDD}"/>
+                <a16:creationId xmlns:a16="http://schemas.microsoft.com/office/drawing/2014/main" id="{D8D14FB8-A2EC-B48D-803C-8DCBB99BEF42}"/>
               </a:ext>
             </a:extLst>
           </p:cNvPr>
@@ -7122,7 +7122,7 @@
           <p:cNvPr id="11" name="CuadroTexto 10">
             <a:extLst>
               <a:ext uri="{FF2B5EF4-FFF2-40B4-BE49-F238E27FC236}">
-                <a16:creationId xmlns:a16="http://schemas.microsoft.com/office/drawing/2014/main" id="{089B4889-BC9D-173C-5933-8C4A572F9949}"/>
+                <a16:creationId xmlns:a16="http://schemas.microsoft.com/office/drawing/2014/main" id="{64F3486F-329C-AFD2-5979-CCFAC7EA8CAE}"/>
               </a:ext>
             </a:extLst>
           </p:cNvPr>
@@ -7162,7 +7162,7 @@
           <p:cNvPr id="12" name="CuadroTexto 11">
             <a:extLst>
               <a:ext uri="{FF2B5EF4-FFF2-40B4-BE49-F238E27FC236}">
-                <a16:creationId xmlns:a16="http://schemas.microsoft.com/office/drawing/2014/main" id="{2F05B17B-A3B5-A69E-0981-D3466A3B8E1B}"/>
+                <a16:creationId xmlns:a16="http://schemas.microsoft.com/office/drawing/2014/main" id="{8D511053-1A70-2E09-E182-03F420080343}"/>
               </a:ext>
             </a:extLst>
           </p:cNvPr>
@@ -7243,7 +7243,7 @@
     </p:spTree>
     <p:extLst>
       <p:ext uri="{BB962C8B-B14F-4D97-AF65-F5344CB8AC3E}">
-        <p14:creationId xmlns:p14="http://schemas.microsoft.com/office/powerpoint/2010/main" val="3028307808"/>
+        <p14:creationId xmlns:p14="http://schemas.microsoft.com/office/powerpoint/2010/main" val="4148631519"/>
       </p:ext>
     </p:extLst>
   </p:cSld>
@@ -7283,7 +7283,7 @@
           <p:cNvPr id="2" name="CuadroTexto 1">
             <a:extLst>
               <a:ext uri="{FF2B5EF4-FFF2-40B4-BE49-F238E27FC236}">
-                <a16:creationId xmlns:a16="http://schemas.microsoft.com/office/drawing/2014/main" id="{8E51F231-1E7D-E7AD-827B-E4C65A6DCF35}"/>
+                <a16:creationId xmlns:a16="http://schemas.microsoft.com/office/drawing/2014/main" id="{0B5CBCEC-03B0-5983-7141-BA1810FA18B9}"/>
               </a:ext>
             </a:extLst>
           </p:cNvPr>
@@ -7323,7 +7323,7 @@
           <p:cNvPr id="3" name="CuadroTexto 2">
             <a:extLst>
               <a:ext uri="{FF2B5EF4-FFF2-40B4-BE49-F238E27FC236}">
-                <a16:creationId xmlns:a16="http://schemas.microsoft.com/office/drawing/2014/main" id="{D6A07F55-8824-6286-A146-199FCAA61FFB}"/>
+                <a16:creationId xmlns:a16="http://schemas.microsoft.com/office/drawing/2014/main" id="{A776B045-5ED7-50C1-623F-C7BB99EA0949}"/>
               </a:ext>
             </a:extLst>
           </p:cNvPr>
@@ -7363,7 +7363,7 @@
           <p:cNvPr id="4" name="CuadroTexto 3">
             <a:extLst>
               <a:ext uri="{FF2B5EF4-FFF2-40B4-BE49-F238E27FC236}">
-                <a16:creationId xmlns:a16="http://schemas.microsoft.com/office/drawing/2014/main" id="{078925B0-E651-5AE9-EFB4-EA603AB409C8}"/>
+                <a16:creationId xmlns:a16="http://schemas.microsoft.com/office/drawing/2014/main" id="{1B2033FE-0561-28AC-FCA8-AB0CBF99D9A4}"/>
               </a:ext>
             </a:extLst>
           </p:cNvPr>
@@ -7403,7 +7403,7 @@
           <p:cNvPr id="5" name="Rectángulo: esquinas redondeadas 4">
             <a:extLst>
               <a:ext uri="{FF2B5EF4-FFF2-40B4-BE49-F238E27FC236}">
-                <a16:creationId xmlns:a16="http://schemas.microsoft.com/office/drawing/2014/main" id="{AA852CD0-3EE1-5723-C376-C21446197A0A}"/>
+                <a16:creationId xmlns:a16="http://schemas.microsoft.com/office/drawing/2014/main" id="{B28BC6F7-336F-F92E-29E5-C7676A1C0506}"/>
               </a:ext>
             </a:extLst>
           </p:cNvPr>
@@ -7457,7 +7457,7 @@
           <p:cNvPr id="6" name="CuadroTexto 5">
             <a:extLst>
               <a:ext uri="{FF2B5EF4-FFF2-40B4-BE49-F238E27FC236}">
-                <a16:creationId xmlns:a16="http://schemas.microsoft.com/office/drawing/2014/main" id="{2DE079E2-AE49-42F3-66A0-AAA119027BDB}"/>
+                <a16:creationId xmlns:a16="http://schemas.microsoft.com/office/drawing/2014/main" id="{B616075B-EBFC-AF2A-D441-CA625A64DB9E}"/>
               </a:ext>
             </a:extLst>
           </p:cNvPr>
@@ -7497,7 +7497,7 @@
           <p:cNvPr id="7" name="CuadroTexto 6">
             <a:extLst>
               <a:ext uri="{FF2B5EF4-FFF2-40B4-BE49-F238E27FC236}">
-                <a16:creationId xmlns:a16="http://schemas.microsoft.com/office/drawing/2014/main" id="{36F98B91-B093-46C9-3661-843B002CF8BB}"/>
+                <a16:creationId xmlns:a16="http://schemas.microsoft.com/office/drawing/2014/main" id="{B33A05D1-2367-AE95-42A7-15FE4AFB453E}"/>
               </a:ext>
             </a:extLst>
           </p:cNvPr>
@@ -7598,7 +7598,7 @@
           <p:cNvPr id="8" name="Rectángulo: esquinas redondeadas 7">
             <a:extLst>
               <a:ext uri="{FF2B5EF4-FFF2-40B4-BE49-F238E27FC236}">
-                <a16:creationId xmlns:a16="http://schemas.microsoft.com/office/drawing/2014/main" id="{74C16484-179F-948D-1235-7EF55B1AC959}"/>
+                <a16:creationId xmlns:a16="http://schemas.microsoft.com/office/drawing/2014/main" id="{85120959-4246-3FE9-1B92-CE3BC5DEB55A}"/>
               </a:ext>
             </a:extLst>
           </p:cNvPr>
@@ -7652,7 +7652,7 @@
           <p:cNvPr id="9" name="CuadroTexto 8">
             <a:extLst>
               <a:ext uri="{FF2B5EF4-FFF2-40B4-BE49-F238E27FC236}">
-                <a16:creationId xmlns:a16="http://schemas.microsoft.com/office/drawing/2014/main" id="{851C70E0-2004-1722-7EA1-48395F4ABB40}"/>
+                <a16:creationId xmlns:a16="http://schemas.microsoft.com/office/drawing/2014/main" id="{D5E495AE-6705-AF48-3376-84A0E6C5C1E5}"/>
               </a:ext>
             </a:extLst>
           </p:cNvPr>
@@ -7692,7 +7692,7 @@
           <p:cNvPr id="10" name="CuadroTexto 9">
             <a:extLst>
               <a:ext uri="{FF2B5EF4-FFF2-40B4-BE49-F238E27FC236}">
-                <a16:creationId xmlns:a16="http://schemas.microsoft.com/office/drawing/2014/main" id="{945528F9-0721-F0D3-0105-E496A9E7C058}"/>
+                <a16:creationId xmlns:a16="http://schemas.microsoft.com/office/drawing/2014/main" id="{6693FBB9-0DB6-D935-E315-EF7815C19D0D}"/>
               </a:ext>
             </a:extLst>
           </p:cNvPr>
@@ -7732,7 +7732,7 @@
           <p:cNvPr id="11" name="Rectángulo: esquinas redondeadas 10">
             <a:extLst>
               <a:ext uri="{FF2B5EF4-FFF2-40B4-BE49-F238E27FC236}">
-                <a16:creationId xmlns:a16="http://schemas.microsoft.com/office/drawing/2014/main" id="{B550BF39-F121-99FE-187D-A38C3EC382E5}"/>
+                <a16:creationId xmlns:a16="http://schemas.microsoft.com/office/drawing/2014/main" id="{26EF31EE-7914-1FBB-C311-57DDB8C76FA7}"/>
               </a:ext>
             </a:extLst>
           </p:cNvPr>
@@ -7786,7 +7786,7 @@
           <p:cNvPr id="12" name="CuadroTexto 11">
             <a:extLst>
               <a:ext uri="{FF2B5EF4-FFF2-40B4-BE49-F238E27FC236}">
-                <a16:creationId xmlns:a16="http://schemas.microsoft.com/office/drawing/2014/main" id="{CACB2135-DC71-12CE-5D2E-A01E7101CA06}"/>
+                <a16:creationId xmlns:a16="http://schemas.microsoft.com/office/drawing/2014/main" id="{69B47D44-C6F5-7496-9F88-919F244828B7}"/>
               </a:ext>
             </a:extLst>
           </p:cNvPr>
@@ -7826,7 +7826,7 @@
           <p:cNvPr id="13" name="CuadroTexto 12">
             <a:extLst>
               <a:ext uri="{FF2B5EF4-FFF2-40B4-BE49-F238E27FC236}">
-                <a16:creationId xmlns:a16="http://schemas.microsoft.com/office/drawing/2014/main" id="{E7E33394-9BF3-B256-128E-9B844C9D4A76}"/>
+                <a16:creationId xmlns:a16="http://schemas.microsoft.com/office/drawing/2014/main" id="{D1AE0AD6-88DE-6861-29B6-748240F58BB0}"/>
               </a:ext>
             </a:extLst>
           </p:cNvPr>
@@ -7866,7 +7866,7 @@
           <p:cNvPr id="14" name="Rectángulo: esquinas redondeadas 13">
             <a:extLst>
               <a:ext uri="{FF2B5EF4-FFF2-40B4-BE49-F238E27FC236}">
-                <a16:creationId xmlns:a16="http://schemas.microsoft.com/office/drawing/2014/main" id="{74F87670-A0B0-8C8D-8B45-F97D1FF83B13}"/>
+                <a16:creationId xmlns:a16="http://schemas.microsoft.com/office/drawing/2014/main" id="{CFA353E8-3014-76E1-58B0-D739ED35FBF6}"/>
               </a:ext>
             </a:extLst>
           </p:cNvPr>
@@ -7920,7 +7920,7 @@
           <p:cNvPr id="15" name="CuadroTexto 14">
             <a:extLst>
               <a:ext uri="{FF2B5EF4-FFF2-40B4-BE49-F238E27FC236}">
-                <a16:creationId xmlns:a16="http://schemas.microsoft.com/office/drawing/2014/main" id="{FF959876-15DF-D6F2-74ED-3C3464558EF5}"/>
+                <a16:creationId xmlns:a16="http://schemas.microsoft.com/office/drawing/2014/main" id="{84183F15-1129-087E-1A27-21B234E62411}"/>
               </a:ext>
             </a:extLst>
           </p:cNvPr>
@@ -7960,7 +7960,7 @@
           <p:cNvPr id="16" name="CuadroTexto 15">
             <a:extLst>
               <a:ext uri="{FF2B5EF4-FFF2-40B4-BE49-F238E27FC236}">
-                <a16:creationId xmlns:a16="http://schemas.microsoft.com/office/drawing/2014/main" id="{D0E17913-F8FB-67D2-AE0E-5139B0B29B4D}"/>
+                <a16:creationId xmlns:a16="http://schemas.microsoft.com/office/drawing/2014/main" id="{1BBB3881-FAA5-224E-B2A1-C0CE0CB227F4}"/>
               </a:ext>
             </a:extLst>
           </p:cNvPr>
@@ -8000,7 +8000,7 @@
           <p:cNvPr id="17" name="CuadroTexto 16">
             <a:extLst>
               <a:ext uri="{FF2B5EF4-FFF2-40B4-BE49-F238E27FC236}">
-                <a16:creationId xmlns:a16="http://schemas.microsoft.com/office/drawing/2014/main" id="{B378EAFC-3006-CD25-E501-646865FCD7EF}"/>
+                <a16:creationId xmlns:a16="http://schemas.microsoft.com/office/drawing/2014/main" id="{433E648D-304F-1E51-8C24-192548D7542B}"/>
               </a:ext>
             </a:extLst>
           </p:cNvPr>
@@ -8063,7 +8063,7 @@
     </p:spTree>
     <p:extLst>
       <p:ext uri="{BB962C8B-B14F-4D97-AF65-F5344CB8AC3E}">
-        <p14:creationId xmlns:p14="http://schemas.microsoft.com/office/powerpoint/2010/main" val="1522264340"/>
+        <p14:creationId xmlns:p14="http://schemas.microsoft.com/office/powerpoint/2010/main" val="4288348950"/>
       </p:ext>
     </p:extLst>
   </p:cSld>
@@ -8103,7 +8103,7 @@
           <p:cNvPr id="2" name="CuadroTexto 1">
             <a:extLst>
               <a:ext uri="{FF2B5EF4-FFF2-40B4-BE49-F238E27FC236}">
-                <a16:creationId xmlns:a16="http://schemas.microsoft.com/office/drawing/2014/main" id="{8069A607-44EF-AE13-4F64-E9B2D84C16DE}"/>
+                <a16:creationId xmlns:a16="http://schemas.microsoft.com/office/drawing/2014/main" id="{D3A5D2F9-AF48-EBB4-7F27-9300C0C11E38}"/>
               </a:ext>
             </a:extLst>
           </p:cNvPr>
@@ -8143,7 +8143,7 @@
           <p:cNvPr id="3" name="CuadroTexto 2">
             <a:extLst>
               <a:ext uri="{FF2B5EF4-FFF2-40B4-BE49-F238E27FC236}">
-                <a16:creationId xmlns:a16="http://schemas.microsoft.com/office/drawing/2014/main" id="{99A40C62-02FE-C640-BD1E-90404F80B611}"/>
+                <a16:creationId xmlns:a16="http://schemas.microsoft.com/office/drawing/2014/main" id="{205E0E42-9ED7-0158-57C0-58EFCAD1EE35}"/>
               </a:ext>
             </a:extLst>
           </p:cNvPr>
@@ -8183,7 +8183,7 @@
           <p:cNvPr id="4" name="CuadroTexto 3">
             <a:extLst>
               <a:ext uri="{FF2B5EF4-FFF2-40B4-BE49-F238E27FC236}">
-                <a16:creationId xmlns:a16="http://schemas.microsoft.com/office/drawing/2014/main" id="{601787B8-5160-C0C1-1826-57FA5A07D3FB}"/>
+                <a16:creationId xmlns:a16="http://schemas.microsoft.com/office/drawing/2014/main" id="{FB0A7C40-A46C-523E-8A41-1419EA7C2BD7}"/>
               </a:ext>
             </a:extLst>
           </p:cNvPr>
@@ -8302,7 +8302,7 @@
           <p:cNvPr id="5" name="Rectángulo: esquinas redondeadas 4">
             <a:extLst>
               <a:ext uri="{FF2B5EF4-FFF2-40B4-BE49-F238E27FC236}">
-                <a16:creationId xmlns:a16="http://schemas.microsoft.com/office/drawing/2014/main" id="{4F55DC18-479C-7B46-E29B-BFFB7497920C}"/>
+                <a16:creationId xmlns:a16="http://schemas.microsoft.com/office/drawing/2014/main" id="{CCFF1FD8-4B20-AF2A-7061-A654004E9755}"/>
               </a:ext>
             </a:extLst>
           </p:cNvPr>
@@ -8356,7 +8356,7 @@
           <p:cNvPr id="6" name="CuadroTexto 5">
             <a:extLst>
               <a:ext uri="{FF2B5EF4-FFF2-40B4-BE49-F238E27FC236}">
-                <a16:creationId xmlns:a16="http://schemas.microsoft.com/office/drawing/2014/main" id="{634E4C24-1246-CA54-8DEA-08216E760F0A}"/>
+                <a16:creationId xmlns:a16="http://schemas.microsoft.com/office/drawing/2014/main" id="{7014CB03-D51D-37C3-75A1-85002D142207}"/>
               </a:ext>
             </a:extLst>
           </p:cNvPr>
@@ -8396,7 +8396,7 @@
           <p:cNvPr id="7" name="CuadroTexto 6">
             <a:extLst>
               <a:ext uri="{FF2B5EF4-FFF2-40B4-BE49-F238E27FC236}">
-                <a16:creationId xmlns:a16="http://schemas.microsoft.com/office/drawing/2014/main" id="{439A1E91-491A-279E-8A09-581774AD200B}"/>
+                <a16:creationId xmlns:a16="http://schemas.microsoft.com/office/drawing/2014/main" id="{006BCA0E-8AB9-A855-0D30-3D091A3A4418}"/>
               </a:ext>
             </a:extLst>
           </p:cNvPr>
@@ -8434,7 +8434,7 @@
     </p:spTree>
     <p:extLst>
       <p:ext uri="{BB962C8B-B14F-4D97-AF65-F5344CB8AC3E}">
-        <p14:creationId xmlns:p14="http://schemas.microsoft.com/office/powerpoint/2010/main" val="4160943323"/>
+        <p14:creationId xmlns:p14="http://schemas.microsoft.com/office/powerpoint/2010/main" val="990444058"/>
       </p:ext>
     </p:extLst>
   </p:cSld>
@@ -8474,7 +8474,7 @@
           <p:cNvPr id="2" name="CuadroTexto 1">
             <a:extLst>
               <a:ext uri="{FF2B5EF4-FFF2-40B4-BE49-F238E27FC236}">
-                <a16:creationId xmlns:a16="http://schemas.microsoft.com/office/drawing/2014/main" id="{5B170C3C-125F-D818-9099-2A01248F5CD8}"/>
+                <a16:creationId xmlns:a16="http://schemas.microsoft.com/office/drawing/2014/main" id="{036CED16-AF6D-6F19-B5C9-667A760854D0}"/>
               </a:ext>
             </a:extLst>
           </p:cNvPr>
@@ -8514,7 +8514,7 @@
           <p:cNvPr id="3" name="CuadroTexto 2">
             <a:extLst>
               <a:ext uri="{FF2B5EF4-FFF2-40B4-BE49-F238E27FC236}">
-                <a16:creationId xmlns:a16="http://schemas.microsoft.com/office/drawing/2014/main" id="{C6462AC4-4513-67D4-328B-184046AC558C}"/>
+                <a16:creationId xmlns:a16="http://schemas.microsoft.com/office/drawing/2014/main" id="{DFBF3C10-C8F8-D4EA-C929-9C9E13152A42}"/>
               </a:ext>
             </a:extLst>
           </p:cNvPr>
@@ -8554,7 +8554,7 @@
           <p:cNvPr id="4" name="CuadroTexto 3">
             <a:extLst>
               <a:ext uri="{FF2B5EF4-FFF2-40B4-BE49-F238E27FC236}">
-                <a16:creationId xmlns:a16="http://schemas.microsoft.com/office/drawing/2014/main" id="{B2DCA2D6-AEFB-3994-FA2E-D9BA73A9A5DF}"/>
+                <a16:creationId xmlns:a16="http://schemas.microsoft.com/office/drawing/2014/main" id="{7EB16D0E-93DC-A5D4-428C-CB7F5AF93E7B}"/>
               </a:ext>
             </a:extLst>
           </p:cNvPr>
@@ -8594,7 +8594,7 @@
           <p:cNvPr id="5" name="CuadroTexto 4">
             <a:extLst>
               <a:ext uri="{FF2B5EF4-FFF2-40B4-BE49-F238E27FC236}">
-                <a16:creationId xmlns:a16="http://schemas.microsoft.com/office/drawing/2014/main" id="{9ECA0BE7-DC2E-2E0E-C7D7-53526AC36FF1}"/>
+                <a16:creationId xmlns:a16="http://schemas.microsoft.com/office/drawing/2014/main" id="{33F4D4A8-FAE3-468C-B4E0-177E55140173}"/>
               </a:ext>
             </a:extLst>
           </p:cNvPr>
@@ -8677,7 +8677,7 @@
           <p:cNvPr id="6" name="CuadroTexto 5">
             <a:extLst>
               <a:ext uri="{FF2B5EF4-FFF2-40B4-BE49-F238E27FC236}">
-                <a16:creationId xmlns:a16="http://schemas.microsoft.com/office/drawing/2014/main" id="{8E5B1483-6593-DFB2-7D9A-8932703E00E6}"/>
+                <a16:creationId xmlns:a16="http://schemas.microsoft.com/office/drawing/2014/main" id="{C80A97D4-C6A7-C8B0-B201-F15B6F610839}"/>
               </a:ext>
             </a:extLst>
           </p:cNvPr>
@@ -8715,7 +8715,7 @@
     </p:spTree>
     <p:extLst>
       <p:ext uri="{BB962C8B-B14F-4D97-AF65-F5344CB8AC3E}">
-        <p14:creationId xmlns:p14="http://schemas.microsoft.com/office/powerpoint/2010/main" val="3551999054"/>
+        <p14:creationId xmlns:p14="http://schemas.microsoft.com/office/powerpoint/2010/main" val="589655953"/>
       </p:ext>
     </p:extLst>
   </p:cSld>
@@ -8755,7 +8755,7 @@
           <p:cNvPr id="2" name="CuadroTexto 1">
             <a:extLst>
               <a:ext uri="{FF2B5EF4-FFF2-40B4-BE49-F238E27FC236}">
-                <a16:creationId xmlns:a16="http://schemas.microsoft.com/office/drawing/2014/main" id="{96B59D31-B9DC-D760-A623-8B14531379E7}"/>
+                <a16:creationId xmlns:a16="http://schemas.microsoft.com/office/drawing/2014/main" id="{6FBC9830-1087-3B6C-1D91-84C5028059E5}"/>
               </a:ext>
             </a:extLst>
           </p:cNvPr>
@@ -8795,7 +8795,7 @@
           <p:cNvPr id="3" name="CuadroTexto 2">
             <a:extLst>
               <a:ext uri="{FF2B5EF4-FFF2-40B4-BE49-F238E27FC236}">
-                <a16:creationId xmlns:a16="http://schemas.microsoft.com/office/drawing/2014/main" id="{B252884E-54A6-C4A4-C9AA-79C2474013B4}"/>
+                <a16:creationId xmlns:a16="http://schemas.microsoft.com/office/drawing/2014/main" id="{6E9AD559-58E0-8320-53FE-5B82434953C6}"/>
               </a:ext>
             </a:extLst>
           </p:cNvPr>
@@ -8835,7 +8835,7 @@
           <p:cNvPr id="4" name="CuadroTexto 3">
             <a:extLst>
               <a:ext uri="{FF2B5EF4-FFF2-40B4-BE49-F238E27FC236}">
-                <a16:creationId xmlns:a16="http://schemas.microsoft.com/office/drawing/2014/main" id="{F383C05F-D800-EA0C-FD31-D2B4376E4045}"/>
+                <a16:creationId xmlns:a16="http://schemas.microsoft.com/office/drawing/2014/main" id="{3DC3118D-8EA7-9B0F-6B6C-E26B25E6EDEF}"/>
               </a:ext>
             </a:extLst>
           </p:cNvPr>
@@ -8875,7 +8875,7 @@
           <p:cNvPr id="5" name="CuadroTexto 4">
             <a:extLst>
               <a:ext uri="{FF2B5EF4-FFF2-40B4-BE49-F238E27FC236}">
-                <a16:creationId xmlns:a16="http://schemas.microsoft.com/office/drawing/2014/main" id="{8D7DC599-150E-F713-3725-C263E8FEE87A}"/>
+                <a16:creationId xmlns:a16="http://schemas.microsoft.com/office/drawing/2014/main" id="{06A3EF4E-5A23-0B2D-C056-0F90E3CCF8E7}"/>
               </a:ext>
             </a:extLst>
           </p:cNvPr>
@@ -8976,7 +8976,7 @@
           <p:cNvPr id="6" name="Rectángulo: esquinas redondeadas 5">
             <a:extLst>
               <a:ext uri="{FF2B5EF4-FFF2-40B4-BE49-F238E27FC236}">
-                <a16:creationId xmlns:a16="http://schemas.microsoft.com/office/drawing/2014/main" id="{E507C1D7-4307-CC2D-472B-B68D55694694}"/>
+                <a16:creationId xmlns:a16="http://schemas.microsoft.com/office/drawing/2014/main" id="{CA25E428-EEB2-3BA5-A89E-427C511F04C2}"/>
               </a:ext>
             </a:extLst>
           </p:cNvPr>
@@ -9030,7 +9030,7 @@
           <p:cNvPr id="7" name="CuadroTexto 6">
             <a:extLst>
               <a:ext uri="{FF2B5EF4-FFF2-40B4-BE49-F238E27FC236}">
-                <a16:creationId xmlns:a16="http://schemas.microsoft.com/office/drawing/2014/main" id="{86F03797-4F39-A9A2-7DD6-11568179228C}"/>
+                <a16:creationId xmlns:a16="http://schemas.microsoft.com/office/drawing/2014/main" id="{E3893FC0-9260-2BE5-6897-EBCF6E90A79A}"/>
               </a:ext>
             </a:extLst>
           </p:cNvPr>
@@ -9070,7 +9070,7 @@
           <p:cNvPr id="8" name="CuadroTexto 7">
             <a:extLst>
               <a:ext uri="{FF2B5EF4-FFF2-40B4-BE49-F238E27FC236}">
-                <a16:creationId xmlns:a16="http://schemas.microsoft.com/office/drawing/2014/main" id="{A5FC4BE5-DFE4-7689-BE27-E9882E191B66}"/>
+                <a16:creationId xmlns:a16="http://schemas.microsoft.com/office/drawing/2014/main" id="{3D0CC411-B7A5-03FF-536B-94D0CC3F3DF7}"/>
               </a:ext>
             </a:extLst>
           </p:cNvPr>
@@ -9108,7 +9108,7 @@
     </p:spTree>
     <p:extLst>
       <p:ext uri="{BB962C8B-B14F-4D97-AF65-F5344CB8AC3E}">
-        <p14:creationId xmlns:p14="http://schemas.microsoft.com/office/powerpoint/2010/main" val="534607492"/>
+        <p14:creationId xmlns:p14="http://schemas.microsoft.com/office/powerpoint/2010/main" val="1139008739"/>
       </p:ext>
     </p:extLst>
   </p:cSld>
@@ -9148,7 +9148,7 @@
           <p:cNvPr id="2" name="CuadroTexto 1">
             <a:extLst>
               <a:ext uri="{FF2B5EF4-FFF2-40B4-BE49-F238E27FC236}">
-                <a16:creationId xmlns:a16="http://schemas.microsoft.com/office/drawing/2014/main" id="{B241425E-B117-BD72-C001-C78EACF704A6}"/>
+                <a16:creationId xmlns:a16="http://schemas.microsoft.com/office/drawing/2014/main" id="{EB282940-06AF-EACF-B9EF-98EAC4F1730A}"/>
               </a:ext>
             </a:extLst>
           </p:cNvPr>
@@ -9188,7 +9188,7 @@
           <p:cNvPr id="3" name="CuadroTexto 2">
             <a:extLst>
               <a:ext uri="{FF2B5EF4-FFF2-40B4-BE49-F238E27FC236}">
-                <a16:creationId xmlns:a16="http://schemas.microsoft.com/office/drawing/2014/main" id="{4F66F0AF-F511-E88E-DC69-E191BC124F50}"/>
+                <a16:creationId xmlns:a16="http://schemas.microsoft.com/office/drawing/2014/main" id="{15F9AF63-03C5-94BF-46A3-CCE367DA3DF8}"/>
               </a:ext>
             </a:extLst>
           </p:cNvPr>
@@ -9228,7 +9228,7 @@
           <p:cNvPr id="4" name="Rectángulo: esquinas redondeadas 3">
             <a:extLst>
               <a:ext uri="{FF2B5EF4-FFF2-40B4-BE49-F238E27FC236}">
-                <a16:creationId xmlns:a16="http://schemas.microsoft.com/office/drawing/2014/main" id="{DF6727A9-78DB-0557-20DD-B8EB7AF51AA6}"/>
+                <a16:creationId xmlns:a16="http://schemas.microsoft.com/office/drawing/2014/main" id="{9C5A765E-77D2-39CA-9FE8-5236C5063869}"/>
               </a:ext>
             </a:extLst>
           </p:cNvPr>
@@ -9282,7 +9282,7 @@
           <p:cNvPr id="5" name="CuadroTexto 4">
             <a:extLst>
               <a:ext uri="{FF2B5EF4-FFF2-40B4-BE49-F238E27FC236}">
-                <a16:creationId xmlns:a16="http://schemas.microsoft.com/office/drawing/2014/main" id="{D2FE1F28-F6C0-E5FA-79B4-B95CF15496BE}"/>
+                <a16:creationId xmlns:a16="http://schemas.microsoft.com/office/drawing/2014/main" id="{C64D6F7B-282D-42E2-323D-242932C9CF2E}"/>
               </a:ext>
             </a:extLst>
           </p:cNvPr>
@@ -9322,7 +9322,7 @@
           <p:cNvPr id="6" name="CuadroTexto 5">
             <a:extLst>
               <a:ext uri="{FF2B5EF4-FFF2-40B4-BE49-F238E27FC236}">
-                <a16:creationId xmlns:a16="http://schemas.microsoft.com/office/drawing/2014/main" id="{7E44E7F3-F077-3094-A294-5BD32C8BB583}"/>
+                <a16:creationId xmlns:a16="http://schemas.microsoft.com/office/drawing/2014/main" id="{C4A6B74D-5BB0-5B05-A7A4-594010C75DF8}"/>
               </a:ext>
             </a:extLst>
           </p:cNvPr>
@@ -9362,7 +9362,7 @@
           <p:cNvPr id="7" name="Rectángulo: esquinas redondeadas 6">
             <a:extLst>
               <a:ext uri="{FF2B5EF4-FFF2-40B4-BE49-F238E27FC236}">
-                <a16:creationId xmlns:a16="http://schemas.microsoft.com/office/drawing/2014/main" id="{5D920454-09FC-2587-F0DE-D0A7DF7EA35E}"/>
+                <a16:creationId xmlns:a16="http://schemas.microsoft.com/office/drawing/2014/main" id="{A0695082-FAC9-CB18-C611-34ECF60D6DC8}"/>
               </a:ext>
             </a:extLst>
           </p:cNvPr>
@@ -9416,7 +9416,7 @@
           <p:cNvPr id="8" name="CuadroTexto 7">
             <a:extLst>
               <a:ext uri="{FF2B5EF4-FFF2-40B4-BE49-F238E27FC236}">
-                <a16:creationId xmlns:a16="http://schemas.microsoft.com/office/drawing/2014/main" id="{9E21D43D-16AD-F5F6-BDFB-84B3AA0B59D1}"/>
+                <a16:creationId xmlns:a16="http://schemas.microsoft.com/office/drawing/2014/main" id="{F0A03756-DD0A-5590-9EF0-14269100A1B2}"/>
               </a:ext>
             </a:extLst>
           </p:cNvPr>
@@ -9456,7 +9456,7 @@
           <p:cNvPr id="9" name="CuadroTexto 8">
             <a:extLst>
               <a:ext uri="{FF2B5EF4-FFF2-40B4-BE49-F238E27FC236}">
-                <a16:creationId xmlns:a16="http://schemas.microsoft.com/office/drawing/2014/main" id="{2122C4B1-94B8-A693-9DA5-AB18AA191273}"/>
+                <a16:creationId xmlns:a16="http://schemas.microsoft.com/office/drawing/2014/main" id="{FED5F627-064E-D6AE-7EEB-66C69F38AA9B}"/>
               </a:ext>
             </a:extLst>
           </p:cNvPr>
@@ -9496,7 +9496,7 @@
           <p:cNvPr id="10" name="Rectángulo: esquinas redondeadas 9">
             <a:extLst>
               <a:ext uri="{FF2B5EF4-FFF2-40B4-BE49-F238E27FC236}">
-                <a16:creationId xmlns:a16="http://schemas.microsoft.com/office/drawing/2014/main" id="{7B9BC611-C26C-96E2-D235-63F14F631CC1}"/>
+                <a16:creationId xmlns:a16="http://schemas.microsoft.com/office/drawing/2014/main" id="{2E7C599C-C567-24F9-0489-3F12FF1E0B13}"/>
               </a:ext>
             </a:extLst>
           </p:cNvPr>
@@ -9550,7 +9550,7 @@
           <p:cNvPr id="11" name="CuadroTexto 10">
             <a:extLst>
               <a:ext uri="{FF2B5EF4-FFF2-40B4-BE49-F238E27FC236}">
-                <a16:creationId xmlns:a16="http://schemas.microsoft.com/office/drawing/2014/main" id="{1C30CB73-ABC6-44CC-565E-93634F9E011C}"/>
+                <a16:creationId xmlns:a16="http://schemas.microsoft.com/office/drawing/2014/main" id="{9EFB9998-EF49-2DAD-5FF2-22B24B32D283}"/>
               </a:ext>
             </a:extLst>
           </p:cNvPr>
@@ -9590,7 +9590,7 @@
           <p:cNvPr id="12" name="CuadroTexto 11">
             <a:extLst>
               <a:ext uri="{FF2B5EF4-FFF2-40B4-BE49-F238E27FC236}">
-                <a16:creationId xmlns:a16="http://schemas.microsoft.com/office/drawing/2014/main" id="{917968D9-A624-0ACE-9308-6E8A18865E52}"/>
+                <a16:creationId xmlns:a16="http://schemas.microsoft.com/office/drawing/2014/main" id="{4064AAC2-204A-7895-580F-3031DB56C64B}"/>
               </a:ext>
             </a:extLst>
           </p:cNvPr>
@@ -9630,7 +9630,7 @@
           <p:cNvPr id="13" name="Rectángulo: esquinas redondeadas 12">
             <a:extLst>
               <a:ext uri="{FF2B5EF4-FFF2-40B4-BE49-F238E27FC236}">
-                <a16:creationId xmlns:a16="http://schemas.microsoft.com/office/drawing/2014/main" id="{6257EB0C-D9D0-C184-6E5B-8BC484D52FC8}"/>
+                <a16:creationId xmlns:a16="http://schemas.microsoft.com/office/drawing/2014/main" id="{AB38D09A-E356-2F15-46F3-C30A5EF8A291}"/>
               </a:ext>
             </a:extLst>
           </p:cNvPr>
@@ -9684,7 +9684,7 @@
           <p:cNvPr id="14" name="CuadroTexto 13">
             <a:extLst>
               <a:ext uri="{FF2B5EF4-FFF2-40B4-BE49-F238E27FC236}">
-                <a16:creationId xmlns:a16="http://schemas.microsoft.com/office/drawing/2014/main" id="{700A1AEA-3EC4-5724-0CEF-FA2ECD0BC3A8}"/>
+                <a16:creationId xmlns:a16="http://schemas.microsoft.com/office/drawing/2014/main" id="{CFAD3839-418F-29A8-1F51-C8C4180EE654}"/>
               </a:ext>
             </a:extLst>
           </p:cNvPr>
@@ -9724,7 +9724,7 @@
           <p:cNvPr id="15" name="CuadroTexto 14">
             <a:extLst>
               <a:ext uri="{FF2B5EF4-FFF2-40B4-BE49-F238E27FC236}">
-                <a16:creationId xmlns:a16="http://schemas.microsoft.com/office/drawing/2014/main" id="{4D9E5A2C-6A0C-B66E-456E-3AEC7D0D06FD}"/>
+                <a16:creationId xmlns:a16="http://schemas.microsoft.com/office/drawing/2014/main" id="{00AF941E-CE6A-35BA-0296-B0F61132C0ED}"/>
               </a:ext>
             </a:extLst>
           </p:cNvPr>
@@ -9762,7 +9762,7 @@
     </p:spTree>
     <p:extLst>
       <p:ext uri="{BB962C8B-B14F-4D97-AF65-F5344CB8AC3E}">
-        <p14:creationId xmlns:p14="http://schemas.microsoft.com/office/powerpoint/2010/main" val="58776312"/>
+        <p14:creationId xmlns:p14="http://schemas.microsoft.com/office/powerpoint/2010/main" val="3969965129"/>
       </p:ext>
     </p:extLst>
   </p:cSld>
@@ -9802,7 +9802,7 @@
           <p:cNvPr id="2" name="CuadroTexto 1">
             <a:extLst>
               <a:ext uri="{FF2B5EF4-FFF2-40B4-BE49-F238E27FC236}">
-                <a16:creationId xmlns:a16="http://schemas.microsoft.com/office/drawing/2014/main" id="{CD6894B9-7A09-9B95-3443-33E8638F14FF}"/>
+                <a16:creationId xmlns:a16="http://schemas.microsoft.com/office/drawing/2014/main" id="{89A44499-82FA-AD4A-8749-E056379C85C7}"/>
               </a:ext>
             </a:extLst>
           </p:cNvPr>
@@ -9842,7 +9842,7 @@
           <p:cNvPr id="3" name="CuadroTexto 2">
             <a:extLst>
               <a:ext uri="{FF2B5EF4-FFF2-40B4-BE49-F238E27FC236}">
-                <a16:creationId xmlns:a16="http://schemas.microsoft.com/office/drawing/2014/main" id="{724071AC-9EBD-DC2D-76A6-0CFCFD103EBA}"/>
+                <a16:creationId xmlns:a16="http://schemas.microsoft.com/office/drawing/2014/main" id="{01816A9D-F8FB-05A1-3843-06425420EA73}"/>
               </a:ext>
             </a:extLst>
           </p:cNvPr>
@@ -9882,7 +9882,7 @@
           <p:cNvPr id="4" name="CuadroTexto 3">
             <a:extLst>
               <a:ext uri="{FF2B5EF4-FFF2-40B4-BE49-F238E27FC236}">
-                <a16:creationId xmlns:a16="http://schemas.microsoft.com/office/drawing/2014/main" id="{956B5DDA-6B1D-C10D-D5B4-82EB3A0A89FB}"/>
+                <a16:creationId xmlns:a16="http://schemas.microsoft.com/office/drawing/2014/main" id="{0D18DDB0-6236-98AA-7A9D-AF510D6F084F}"/>
               </a:ext>
             </a:extLst>
           </p:cNvPr>
@@ -9922,7 +9922,7 @@
           <p:cNvPr id="6" name="Imagen 5">
             <a:extLst>
               <a:ext uri="{FF2B5EF4-FFF2-40B4-BE49-F238E27FC236}">
-                <a16:creationId xmlns:a16="http://schemas.microsoft.com/office/drawing/2014/main" id="{A96BE8CE-6DD6-ED45-A0AD-47E5EFE33617}"/>
+                <a16:creationId xmlns:a16="http://schemas.microsoft.com/office/drawing/2014/main" id="{2CA841F4-0C11-F86B-BD84-3949EC6B9A82}"/>
               </a:ext>
             </a:extLst>
           </p:cNvPr>
@@ -9963,7 +9963,7 @@
           <p:cNvPr id="7" name="CuadroTexto 6">
             <a:extLst>
               <a:ext uri="{FF2B5EF4-FFF2-40B4-BE49-F238E27FC236}">
-                <a16:creationId xmlns:a16="http://schemas.microsoft.com/office/drawing/2014/main" id="{6B58FB45-5211-D9EC-048A-E18C9E3845B2}"/>
+                <a16:creationId xmlns:a16="http://schemas.microsoft.com/office/drawing/2014/main" id="{4A4A7ECA-E196-B9FD-12A9-8A4BDB89A408}"/>
               </a:ext>
             </a:extLst>
           </p:cNvPr>
@@ -10080,7 +10080,7 @@
     </p:spTree>
     <p:extLst>
       <p:ext uri="{BB962C8B-B14F-4D97-AF65-F5344CB8AC3E}">
-        <p14:creationId xmlns:p14="http://schemas.microsoft.com/office/powerpoint/2010/main" val="1522771249"/>
+        <p14:creationId xmlns:p14="http://schemas.microsoft.com/office/powerpoint/2010/main" val="2886672413"/>
       </p:ext>
     </p:extLst>
   </p:cSld>
@@ -10120,7 +10120,7 @@
           <p:cNvPr id="2" name="CuadroTexto 1">
             <a:extLst>
               <a:ext uri="{FF2B5EF4-FFF2-40B4-BE49-F238E27FC236}">
-                <a16:creationId xmlns:a16="http://schemas.microsoft.com/office/drawing/2014/main" id="{6B937256-65C2-D3F4-12CB-5C1F28970552}"/>
+                <a16:creationId xmlns:a16="http://schemas.microsoft.com/office/drawing/2014/main" id="{9E6DC61B-22FB-E1A2-867F-2CD288BC8FBD}"/>
               </a:ext>
             </a:extLst>
           </p:cNvPr>
@@ -10160,7 +10160,7 @@
           <p:cNvPr id="3" name="CuadroTexto 2">
             <a:extLst>
               <a:ext uri="{FF2B5EF4-FFF2-40B4-BE49-F238E27FC236}">
-                <a16:creationId xmlns:a16="http://schemas.microsoft.com/office/drawing/2014/main" id="{3D1DA558-0C53-9A96-0172-9248F5125B1A}"/>
+                <a16:creationId xmlns:a16="http://schemas.microsoft.com/office/drawing/2014/main" id="{01FE1F73-538C-6D2B-85BA-01E5B4A1B367}"/>
               </a:ext>
             </a:extLst>
           </p:cNvPr>
@@ -10200,7 +10200,7 @@
           <p:cNvPr id="5" name="Imagen 4">
             <a:extLst>
               <a:ext uri="{FF2B5EF4-FFF2-40B4-BE49-F238E27FC236}">
-                <a16:creationId xmlns:a16="http://schemas.microsoft.com/office/drawing/2014/main" id="{B08FC2B9-DF8B-C8FD-E903-70C4CCAE42D0}"/>
+                <a16:creationId xmlns:a16="http://schemas.microsoft.com/office/drawing/2014/main" id="{DFD935C8-1B76-0A55-9A90-29C598D66E32}"/>
               </a:ext>
             </a:extLst>
           </p:cNvPr>
@@ -10241,7 +10241,7 @@
           <p:cNvPr id="6" name="CuadroTexto 5">
             <a:extLst>
               <a:ext uri="{FF2B5EF4-FFF2-40B4-BE49-F238E27FC236}">
-                <a16:creationId xmlns:a16="http://schemas.microsoft.com/office/drawing/2014/main" id="{77C21CA9-0A5D-01A1-051D-CB7C862EF4EA}"/>
+                <a16:creationId xmlns:a16="http://schemas.microsoft.com/office/drawing/2014/main" id="{900F6E40-7E9D-FA0E-85A4-DCF195F305C5}"/>
               </a:ext>
             </a:extLst>
           </p:cNvPr>
@@ -10281,7 +10281,7 @@
           <p:cNvPr id="7" name="CuadroTexto 6">
             <a:extLst>
               <a:ext uri="{FF2B5EF4-FFF2-40B4-BE49-F238E27FC236}">
-                <a16:creationId xmlns:a16="http://schemas.microsoft.com/office/drawing/2014/main" id="{22A5F55E-01D6-0AF1-E583-370E61672D15}"/>
+                <a16:creationId xmlns:a16="http://schemas.microsoft.com/office/drawing/2014/main" id="{D17C8830-9864-5F88-2B81-164A5855DA5F}"/>
               </a:ext>
             </a:extLst>
           </p:cNvPr>
@@ -10380,7 +10380,7 @@
     </p:spTree>
     <p:extLst>
       <p:ext uri="{BB962C8B-B14F-4D97-AF65-F5344CB8AC3E}">
-        <p14:creationId xmlns:p14="http://schemas.microsoft.com/office/powerpoint/2010/main" val="2474189906"/>
+        <p14:creationId xmlns:p14="http://schemas.microsoft.com/office/powerpoint/2010/main" val="197158713"/>
       </p:ext>
     </p:extLst>
   </p:cSld>
@@ -10420,7 +10420,7 @@
           <p:cNvPr id="2" name="CuadroTexto 1">
             <a:extLst>
               <a:ext uri="{FF2B5EF4-FFF2-40B4-BE49-F238E27FC236}">
-                <a16:creationId xmlns:a16="http://schemas.microsoft.com/office/drawing/2014/main" id="{DE924B84-F47B-DC01-D66B-8597F0544946}"/>
+                <a16:creationId xmlns:a16="http://schemas.microsoft.com/office/drawing/2014/main" id="{A4B90C54-59B9-29C1-FAB1-6D06BEC83C67}"/>
               </a:ext>
             </a:extLst>
           </p:cNvPr>
@@ -10460,7 +10460,7 @@
           <p:cNvPr id="3" name="CuadroTexto 2">
             <a:extLst>
               <a:ext uri="{FF2B5EF4-FFF2-40B4-BE49-F238E27FC236}">
-                <a16:creationId xmlns:a16="http://schemas.microsoft.com/office/drawing/2014/main" id="{5CCD5A62-B1D5-86D1-E2E2-6856DBFD033A}"/>
+                <a16:creationId xmlns:a16="http://schemas.microsoft.com/office/drawing/2014/main" id="{B4201F9F-E495-1A34-E813-7CEB643A52E1}"/>
               </a:ext>
             </a:extLst>
           </p:cNvPr>
@@ -10500,7 +10500,7 @@
           <p:cNvPr id="4" name="CuadroTexto 3">
             <a:extLst>
               <a:ext uri="{FF2B5EF4-FFF2-40B4-BE49-F238E27FC236}">
-                <a16:creationId xmlns:a16="http://schemas.microsoft.com/office/drawing/2014/main" id="{6237BC69-FB99-BB6B-A6CF-E358ACAB9EE2}"/>
+                <a16:creationId xmlns:a16="http://schemas.microsoft.com/office/drawing/2014/main" id="{94FC1F65-6350-4E16-6CA9-97F7559A79B2}"/>
               </a:ext>
             </a:extLst>
           </p:cNvPr>
@@ -10540,7 +10540,7 @@
           <p:cNvPr id="6" name="Imagen 5">
             <a:extLst>
               <a:ext uri="{FF2B5EF4-FFF2-40B4-BE49-F238E27FC236}">
-                <a16:creationId xmlns:a16="http://schemas.microsoft.com/office/drawing/2014/main" id="{0C211F6E-0CB9-616B-D161-7A43066C0FE4}"/>
+                <a16:creationId xmlns:a16="http://schemas.microsoft.com/office/drawing/2014/main" id="{18EF20F3-E98B-C65B-5E7B-11E87999C950}"/>
               </a:ext>
             </a:extLst>
           </p:cNvPr>
@@ -10581,7 +10581,7 @@
           <p:cNvPr id="7" name="Rectángulo: esquinas redondeadas 6">
             <a:extLst>
               <a:ext uri="{FF2B5EF4-FFF2-40B4-BE49-F238E27FC236}">
-                <a16:creationId xmlns:a16="http://schemas.microsoft.com/office/drawing/2014/main" id="{1D4C2ECB-527E-C92D-2CF7-C4A0507F42D2}"/>
+                <a16:creationId xmlns:a16="http://schemas.microsoft.com/office/drawing/2014/main" id="{90921B6D-BF60-4A96-32E7-556ABB908AAB}"/>
               </a:ext>
             </a:extLst>
           </p:cNvPr>
@@ -10635,7 +10635,7 @@
           <p:cNvPr id="8" name="CuadroTexto 7">
             <a:extLst>
               <a:ext uri="{FF2B5EF4-FFF2-40B4-BE49-F238E27FC236}">
-                <a16:creationId xmlns:a16="http://schemas.microsoft.com/office/drawing/2014/main" id="{0B705E7E-0D0B-D236-87BF-F998B6142B05}"/>
+                <a16:creationId xmlns:a16="http://schemas.microsoft.com/office/drawing/2014/main" id="{C1D36378-35A6-CE30-0376-63404731523E}"/>
               </a:ext>
             </a:extLst>
           </p:cNvPr>
@@ -10665,7 +10665,7 @@
                 </a:solidFill>
                 <a:latin typeface="Segoe UI" panose="020B0502040204020203" pitchFamily="34" charset="0"/>
               </a:rPr>
-              <a:t>20</a:t>
+              <a:t>3</a:t>
             </a:r>
           </a:p>
         </p:txBody>
@@ -10675,7 +10675,7 @@
           <p:cNvPr id="9" name="CuadroTexto 8">
             <a:extLst>
               <a:ext uri="{FF2B5EF4-FFF2-40B4-BE49-F238E27FC236}">
-                <a16:creationId xmlns:a16="http://schemas.microsoft.com/office/drawing/2014/main" id="{19ED82ED-2EFC-6CC0-F648-303E0681C4C1}"/>
+                <a16:creationId xmlns:a16="http://schemas.microsoft.com/office/drawing/2014/main" id="{29563791-87A4-F2A8-21E7-A2B85BEEDA13}"/>
               </a:ext>
             </a:extLst>
           </p:cNvPr>
@@ -10715,7 +10715,7 @@
           <p:cNvPr id="10" name="Rectángulo: esquinas redondeadas 9">
             <a:extLst>
               <a:ext uri="{FF2B5EF4-FFF2-40B4-BE49-F238E27FC236}">
-                <a16:creationId xmlns:a16="http://schemas.microsoft.com/office/drawing/2014/main" id="{1DE4E781-9C1B-E4B5-FD86-D174387B19A1}"/>
+                <a16:creationId xmlns:a16="http://schemas.microsoft.com/office/drawing/2014/main" id="{A7B22E91-588B-FC7C-0E00-7B1C1C793752}"/>
               </a:ext>
             </a:extLst>
           </p:cNvPr>
@@ -10769,7 +10769,7 @@
           <p:cNvPr id="11" name="CuadroTexto 10">
             <a:extLst>
               <a:ext uri="{FF2B5EF4-FFF2-40B4-BE49-F238E27FC236}">
-                <a16:creationId xmlns:a16="http://schemas.microsoft.com/office/drawing/2014/main" id="{F03CE05D-E38E-6F32-0775-3951BDF6BF85}"/>
+                <a16:creationId xmlns:a16="http://schemas.microsoft.com/office/drawing/2014/main" id="{8196D7ED-BA84-4FF1-2EA1-86A31C7DCA9C}"/>
               </a:ext>
             </a:extLst>
           </p:cNvPr>
@@ -10799,7 +10799,7 @@
                 </a:solidFill>
                 <a:latin typeface="Segoe UI" panose="020B0502040204020203" pitchFamily="34" charset="0"/>
               </a:rPr>
-              <a:t>4</a:t>
+              <a:t>3</a:t>
             </a:r>
           </a:p>
         </p:txBody>
@@ -10809,7 +10809,7 @@
           <p:cNvPr id="12" name="CuadroTexto 11">
             <a:extLst>
               <a:ext uri="{FF2B5EF4-FFF2-40B4-BE49-F238E27FC236}">
-                <a16:creationId xmlns:a16="http://schemas.microsoft.com/office/drawing/2014/main" id="{0CAFEFC4-6D7F-6657-1D86-B897FCC65027}"/>
+                <a16:creationId xmlns:a16="http://schemas.microsoft.com/office/drawing/2014/main" id="{C42F4661-0F9E-E635-545C-CF94776D7859}"/>
               </a:ext>
             </a:extLst>
           </p:cNvPr>
@@ -10849,7 +10849,7 @@
           <p:cNvPr id="13" name="Rectángulo: esquinas redondeadas 12">
             <a:extLst>
               <a:ext uri="{FF2B5EF4-FFF2-40B4-BE49-F238E27FC236}">
-                <a16:creationId xmlns:a16="http://schemas.microsoft.com/office/drawing/2014/main" id="{C0694DD7-D23F-964D-BDC0-D9661DFF88CB}"/>
+                <a16:creationId xmlns:a16="http://schemas.microsoft.com/office/drawing/2014/main" id="{F35086C4-5C5A-A103-567B-81B3845CC0F9}"/>
               </a:ext>
             </a:extLst>
           </p:cNvPr>
@@ -10903,7 +10903,7 @@
           <p:cNvPr id="14" name="CuadroTexto 13">
             <a:extLst>
               <a:ext uri="{FF2B5EF4-FFF2-40B4-BE49-F238E27FC236}">
-                <a16:creationId xmlns:a16="http://schemas.microsoft.com/office/drawing/2014/main" id="{4F53BB6E-3CE6-BE1D-D40F-FBBE7A1F69DA}"/>
+                <a16:creationId xmlns:a16="http://schemas.microsoft.com/office/drawing/2014/main" id="{A624BE0A-6486-09A5-D1F6-BC4DA4479ABB}"/>
               </a:ext>
             </a:extLst>
           </p:cNvPr>
@@ -10943,7 +10943,7 @@
           <p:cNvPr id="15" name="CuadroTexto 14">
             <a:extLst>
               <a:ext uri="{FF2B5EF4-FFF2-40B4-BE49-F238E27FC236}">
-                <a16:creationId xmlns:a16="http://schemas.microsoft.com/office/drawing/2014/main" id="{7647B05A-A1B2-4D0D-33A7-57439AFD4287}"/>
+                <a16:creationId xmlns:a16="http://schemas.microsoft.com/office/drawing/2014/main" id="{464CC48B-2885-0574-D2A6-FD83124CF8D7}"/>
               </a:ext>
             </a:extLst>
           </p:cNvPr>
@@ -10981,7 +10981,7 @@
     </p:spTree>
     <p:extLst>
       <p:ext uri="{BB962C8B-B14F-4D97-AF65-F5344CB8AC3E}">
-        <p14:creationId xmlns:p14="http://schemas.microsoft.com/office/powerpoint/2010/main" val="415349331"/>
+        <p14:creationId xmlns:p14="http://schemas.microsoft.com/office/powerpoint/2010/main" val="1870687457"/>
       </p:ext>
     </p:extLst>
   </p:cSld>
@@ -11021,7 +11021,7 @@
           <p:cNvPr id="2" name="CuadroTexto 1">
             <a:extLst>
               <a:ext uri="{FF2B5EF4-FFF2-40B4-BE49-F238E27FC236}">
-                <a16:creationId xmlns:a16="http://schemas.microsoft.com/office/drawing/2014/main" id="{033B6185-2DF4-B3B1-8E9A-F2D4F92F2A18}"/>
+                <a16:creationId xmlns:a16="http://schemas.microsoft.com/office/drawing/2014/main" id="{DDA2E44B-4012-D66E-6975-B2B82BC52A62}"/>
               </a:ext>
             </a:extLst>
           </p:cNvPr>
@@ -11061,7 +11061,7 @@
           <p:cNvPr id="3" name="CuadroTexto 2">
             <a:extLst>
               <a:ext uri="{FF2B5EF4-FFF2-40B4-BE49-F238E27FC236}">
-                <a16:creationId xmlns:a16="http://schemas.microsoft.com/office/drawing/2014/main" id="{43215777-F41E-4C87-F27F-5ED5F66E3244}"/>
+                <a16:creationId xmlns:a16="http://schemas.microsoft.com/office/drawing/2014/main" id="{93D4E4D9-0C09-D458-F63D-CE83E122ABA4}"/>
               </a:ext>
             </a:extLst>
           </p:cNvPr>
@@ -11101,7 +11101,7 @@
           <p:cNvPr id="5" name="Imagen 4">
             <a:extLst>
               <a:ext uri="{FF2B5EF4-FFF2-40B4-BE49-F238E27FC236}">
-                <a16:creationId xmlns:a16="http://schemas.microsoft.com/office/drawing/2014/main" id="{EB9A3945-4CA6-082C-858F-D90AA64C8AEC}"/>
+                <a16:creationId xmlns:a16="http://schemas.microsoft.com/office/drawing/2014/main" id="{18BEFF83-73E1-6C40-6A3C-93391239A02B}"/>
               </a:ext>
             </a:extLst>
           </p:cNvPr>
@@ -11142,7 +11142,7 @@
           <p:cNvPr id="6" name="CuadroTexto 5">
             <a:extLst>
               <a:ext uri="{FF2B5EF4-FFF2-40B4-BE49-F238E27FC236}">
-                <a16:creationId xmlns:a16="http://schemas.microsoft.com/office/drawing/2014/main" id="{A48C1D83-A83C-BF1F-70C9-21016D01D0C7}"/>
+                <a16:creationId xmlns:a16="http://schemas.microsoft.com/office/drawing/2014/main" id="{6DC0D98C-C30B-C13D-83C8-7ACD64420E8C}"/>
               </a:ext>
             </a:extLst>
           </p:cNvPr>
@@ -11241,7 +11241,7 @@
     </p:spTree>
     <p:extLst>
       <p:ext uri="{BB962C8B-B14F-4D97-AF65-F5344CB8AC3E}">
-        <p14:creationId xmlns:p14="http://schemas.microsoft.com/office/powerpoint/2010/main" val="3417312891"/>
+        <p14:creationId xmlns:p14="http://schemas.microsoft.com/office/powerpoint/2010/main" val="2218698971"/>
       </p:ext>
     </p:extLst>
   </p:cSld>
@@ -11281,7 +11281,7 @@
           <p:cNvPr id="2" name="CuadroTexto 1">
             <a:extLst>
               <a:ext uri="{FF2B5EF4-FFF2-40B4-BE49-F238E27FC236}">
-                <a16:creationId xmlns:a16="http://schemas.microsoft.com/office/drawing/2014/main" id="{2F0FD4DE-A572-69EC-1608-A148201CE7E2}"/>
+                <a16:creationId xmlns:a16="http://schemas.microsoft.com/office/drawing/2014/main" id="{B1C050A0-6921-B6D2-E5BC-322E6A06C535}"/>
               </a:ext>
             </a:extLst>
           </p:cNvPr>
@@ -11321,7 +11321,7 @@
           <p:cNvPr id="3" name="CuadroTexto 2">
             <a:extLst>
               <a:ext uri="{FF2B5EF4-FFF2-40B4-BE49-F238E27FC236}">
-                <a16:creationId xmlns:a16="http://schemas.microsoft.com/office/drawing/2014/main" id="{54C9808F-684E-9BD9-488C-77D40B2CD85F}"/>
+                <a16:creationId xmlns:a16="http://schemas.microsoft.com/office/drawing/2014/main" id="{D1F9578E-E5F3-F489-7A6C-0F09A15693A0}"/>
               </a:ext>
             </a:extLst>
           </p:cNvPr>
@@ -11361,7 +11361,7 @@
           <p:cNvPr id="4" name="CuadroTexto 3">
             <a:extLst>
               <a:ext uri="{FF2B5EF4-FFF2-40B4-BE49-F238E27FC236}">
-                <a16:creationId xmlns:a16="http://schemas.microsoft.com/office/drawing/2014/main" id="{628DD375-7F2F-94BA-46C2-EF4033BBC827}"/>
+                <a16:creationId xmlns:a16="http://schemas.microsoft.com/office/drawing/2014/main" id="{990C8A9D-CD87-1FFD-5E15-65B60B1DBB25}"/>
               </a:ext>
             </a:extLst>
           </p:cNvPr>
@@ -11401,7 +11401,7 @@
           <p:cNvPr id="6" name="Imagen 5">
             <a:extLst>
               <a:ext uri="{FF2B5EF4-FFF2-40B4-BE49-F238E27FC236}">
-                <a16:creationId xmlns:a16="http://schemas.microsoft.com/office/drawing/2014/main" id="{95C57F26-8802-0313-AE41-98E1383A3C8F}"/>
+                <a16:creationId xmlns:a16="http://schemas.microsoft.com/office/drawing/2014/main" id="{F69E3CA6-3A0C-BE56-5837-2AB59D2E3372}"/>
               </a:ext>
             </a:extLst>
           </p:cNvPr>
@@ -11442,7 +11442,7 @@
           <p:cNvPr id="7" name="Rectángulo: esquinas redondeadas 6">
             <a:extLst>
               <a:ext uri="{FF2B5EF4-FFF2-40B4-BE49-F238E27FC236}">
-                <a16:creationId xmlns:a16="http://schemas.microsoft.com/office/drawing/2014/main" id="{A0B5CC5D-89EF-79C9-4AF4-E897D2E70ACB}"/>
+                <a16:creationId xmlns:a16="http://schemas.microsoft.com/office/drawing/2014/main" id="{12E779A8-11E5-B8DE-D05C-84B751D5CE51}"/>
               </a:ext>
             </a:extLst>
           </p:cNvPr>
@@ -11496,7 +11496,7 @@
           <p:cNvPr id="8" name="CuadroTexto 7">
             <a:extLst>
               <a:ext uri="{FF2B5EF4-FFF2-40B4-BE49-F238E27FC236}">
-                <a16:creationId xmlns:a16="http://schemas.microsoft.com/office/drawing/2014/main" id="{DB8DFE88-AC85-6507-44A3-331D75BCEE55}"/>
+                <a16:creationId xmlns:a16="http://schemas.microsoft.com/office/drawing/2014/main" id="{B7F5F231-6468-A042-3C34-FAD44DBFA31F}"/>
               </a:ext>
             </a:extLst>
           </p:cNvPr>
@@ -11536,7 +11536,7 @@
           <p:cNvPr id="9" name="CuadroTexto 8">
             <a:extLst>
               <a:ext uri="{FF2B5EF4-FFF2-40B4-BE49-F238E27FC236}">
-                <a16:creationId xmlns:a16="http://schemas.microsoft.com/office/drawing/2014/main" id="{8D288753-8414-2AC0-F936-58787869B2F6}"/>
+                <a16:creationId xmlns:a16="http://schemas.microsoft.com/office/drawing/2014/main" id="{D84EEE23-CEDA-1DAE-11AC-C5FD47E0FA98}"/>
               </a:ext>
             </a:extLst>
           </p:cNvPr>
@@ -11574,7 +11574,7 @@
     </p:spTree>
     <p:extLst>
       <p:ext uri="{BB962C8B-B14F-4D97-AF65-F5344CB8AC3E}">
-        <p14:creationId xmlns:p14="http://schemas.microsoft.com/office/powerpoint/2010/main" val="1965659088"/>
+        <p14:creationId xmlns:p14="http://schemas.microsoft.com/office/powerpoint/2010/main" val="3688929477"/>
       </p:ext>
     </p:extLst>
   </p:cSld>
@@ -11614,7 +11614,7 @@
           <p:cNvPr id="2" name="CuadroTexto 1">
             <a:extLst>
               <a:ext uri="{FF2B5EF4-FFF2-40B4-BE49-F238E27FC236}">
-                <a16:creationId xmlns:a16="http://schemas.microsoft.com/office/drawing/2014/main" id="{180B07DD-CC23-8706-3431-86AD8212814B}"/>
+                <a16:creationId xmlns:a16="http://schemas.microsoft.com/office/drawing/2014/main" id="{49C87107-47D5-FE8D-53D3-4804744F9A18}"/>
               </a:ext>
             </a:extLst>
           </p:cNvPr>
@@ -11654,7 +11654,7 @@
           <p:cNvPr id="3" name="CuadroTexto 2">
             <a:extLst>
               <a:ext uri="{FF2B5EF4-FFF2-40B4-BE49-F238E27FC236}">
-                <a16:creationId xmlns:a16="http://schemas.microsoft.com/office/drawing/2014/main" id="{728EEFA2-265D-AC07-5F82-F0037E3AC657}"/>
+                <a16:creationId xmlns:a16="http://schemas.microsoft.com/office/drawing/2014/main" id="{A8838B2B-EE8B-4F9D-3A7D-F40AE960843F}"/>
               </a:ext>
             </a:extLst>
           </p:cNvPr>
@@ -11694,7 +11694,7 @@
           <p:cNvPr id="4" name="CuadroTexto 3">
             <a:extLst>
               <a:ext uri="{FF2B5EF4-FFF2-40B4-BE49-F238E27FC236}">
-                <a16:creationId xmlns:a16="http://schemas.microsoft.com/office/drawing/2014/main" id="{BA9C0075-714F-CC23-DC53-DBA99F67999C}"/>
+                <a16:creationId xmlns:a16="http://schemas.microsoft.com/office/drawing/2014/main" id="{5020C065-38A9-66E8-A3E3-560223338CC8}"/>
               </a:ext>
             </a:extLst>
           </p:cNvPr>
@@ -11734,7 +11734,7 @@
           <p:cNvPr id="5" name="Rectángulo: esquinas redondeadas 4">
             <a:extLst>
               <a:ext uri="{FF2B5EF4-FFF2-40B4-BE49-F238E27FC236}">
-                <a16:creationId xmlns:a16="http://schemas.microsoft.com/office/drawing/2014/main" id="{60C19EB6-6556-325A-BC62-46F8CCBB7F3D}"/>
+                <a16:creationId xmlns:a16="http://schemas.microsoft.com/office/drawing/2014/main" id="{CA005563-89EA-808E-66D0-B732EA8AB31E}"/>
               </a:ext>
             </a:extLst>
           </p:cNvPr>
@@ -11788,7 +11788,7 @@
           <p:cNvPr id="6" name="CuadroTexto 5">
             <a:extLst>
               <a:ext uri="{FF2B5EF4-FFF2-40B4-BE49-F238E27FC236}">
-                <a16:creationId xmlns:a16="http://schemas.microsoft.com/office/drawing/2014/main" id="{CC6FC31A-C276-07A6-83B1-ECA11B3FD75E}"/>
+                <a16:creationId xmlns:a16="http://schemas.microsoft.com/office/drawing/2014/main" id="{F3C41619-89A7-4796-5D5B-A388B8F27FDF}"/>
               </a:ext>
             </a:extLst>
           </p:cNvPr>
@@ -11828,7 +11828,7 @@
           <p:cNvPr id="7" name="CuadroTexto 6">
             <a:extLst>
               <a:ext uri="{FF2B5EF4-FFF2-40B4-BE49-F238E27FC236}">
-                <a16:creationId xmlns:a16="http://schemas.microsoft.com/office/drawing/2014/main" id="{6B54BA2B-08B6-BE01-F079-60061C08C708}"/>
+                <a16:creationId xmlns:a16="http://schemas.microsoft.com/office/drawing/2014/main" id="{8751DD6A-2E23-0880-F2B8-F6A50A3459AD}"/>
               </a:ext>
             </a:extLst>
           </p:cNvPr>
@@ -11868,7 +11868,7 @@
           <p:cNvPr id="8" name="Rectángulo: esquinas redondeadas 7">
             <a:extLst>
               <a:ext uri="{FF2B5EF4-FFF2-40B4-BE49-F238E27FC236}">
-                <a16:creationId xmlns:a16="http://schemas.microsoft.com/office/drawing/2014/main" id="{DEBF0AD2-CDF2-F01F-70D1-E91CD7A7DD7B}"/>
+                <a16:creationId xmlns:a16="http://schemas.microsoft.com/office/drawing/2014/main" id="{578B8247-503E-4F06-3EDD-AE07D2D3EB52}"/>
               </a:ext>
             </a:extLst>
           </p:cNvPr>
@@ -11922,7 +11922,7 @@
           <p:cNvPr id="9" name="CuadroTexto 8">
             <a:extLst>
               <a:ext uri="{FF2B5EF4-FFF2-40B4-BE49-F238E27FC236}">
-                <a16:creationId xmlns:a16="http://schemas.microsoft.com/office/drawing/2014/main" id="{68967BEB-B7E1-E56D-8A03-786CB7503607}"/>
+                <a16:creationId xmlns:a16="http://schemas.microsoft.com/office/drawing/2014/main" id="{1232DF11-5F2E-8CA0-850C-E8C964B528F1}"/>
               </a:ext>
             </a:extLst>
           </p:cNvPr>
@@ -11962,7 +11962,7 @@
           <p:cNvPr id="10" name="CuadroTexto 9">
             <a:extLst>
               <a:ext uri="{FF2B5EF4-FFF2-40B4-BE49-F238E27FC236}">
-                <a16:creationId xmlns:a16="http://schemas.microsoft.com/office/drawing/2014/main" id="{8E3F8F6D-FD23-7789-E9ED-1063D1A95BCD}"/>
+                <a16:creationId xmlns:a16="http://schemas.microsoft.com/office/drawing/2014/main" id="{3ACD2940-8FD0-C488-D977-677F9130B1EB}"/>
               </a:ext>
             </a:extLst>
           </p:cNvPr>
@@ -12002,7 +12002,7 @@
           <p:cNvPr id="11" name="Rectángulo: esquinas redondeadas 10">
             <a:extLst>
               <a:ext uri="{FF2B5EF4-FFF2-40B4-BE49-F238E27FC236}">
-                <a16:creationId xmlns:a16="http://schemas.microsoft.com/office/drawing/2014/main" id="{3333A217-60C6-F9DA-7DE5-3273F9DFAE2B}"/>
+                <a16:creationId xmlns:a16="http://schemas.microsoft.com/office/drawing/2014/main" id="{15CBE82E-1E6B-A600-D53B-93CFF6F37C14}"/>
               </a:ext>
             </a:extLst>
           </p:cNvPr>
@@ -12056,7 +12056,7 @@
           <p:cNvPr id="12" name="CuadroTexto 11">
             <a:extLst>
               <a:ext uri="{FF2B5EF4-FFF2-40B4-BE49-F238E27FC236}">
-                <a16:creationId xmlns:a16="http://schemas.microsoft.com/office/drawing/2014/main" id="{1ED88DF8-8179-2C5F-A0A9-73DBD73DCDE0}"/>
+                <a16:creationId xmlns:a16="http://schemas.microsoft.com/office/drawing/2014/main" id="{86DBF4D4-AF3C-1CAE-AAE3-7BC33D03EEB5}"/>
               </a:ext>
             </a:extLst>
           </p:cNvPr>
@@ -12096,7 +12096,7 @@
           <p:cNvPr id="13" name="CuadroTexto 12">
             <a:extLst>
               <a:ext uri="{FF2B5EF4-FFF2-40B4-BE49-F238E27FC236}">
-                <a16:creationId xmlns:a16="http://schemas.microsoft.com/office/drawing/2014/main" id="{3B112D6E-CB2E-0EFB-19C3-9726970F7664}"/>
+                <a16:creationId xmlns:a16="http://schemas.microsoft.com/office/drawing/2014/main" id="{30321472-DAB2-7B8C-BB47-82C42B9E4A11}"/>
               </a:ext>
             </a:extLst>
           </p:cNvPr>
@@ -12136,7 +12136,7 @@
           <p:cNvPr id="14" name="Rectángulo: esquinas redondeadas 13">
             <a:extLst>
               <a:ext uri="{FF2B5EF4-FFF2-40B4-BE49-F238E27FC236}">
-                <a16:creationId xmlns:a16="http://schemas.microsoft.com/office/drawing/2014/main" id="{D842ED75-80EE-6CE7-5FA0-6BC71FE444A2}"/>
+                <a16:creationId xmlns:a16="http://schemas.microsoft.com/office/drawing/2014/main" id="{2AD96489-76F8-B559-03A5-362580CF8A66}"/>
               </a:ext>
             </a:extLst>
           </p:cNvPr>
@@ -12190,7 +12190,7 @@
           <p:cNvPr id="15" name="CuadroTexto 14">
             <a:extLst>
               <a:ext uri="{FF2B5EF4-FFF2-40B4-BE49-F238E27FC236}">
-                <a16:creationId xmlns:a16="http://schemas.microsoft.com/office/drawing/2014/main" id="{314AF3F0-407F-5076-6C71-0534F90D1895}"/>
+                <a16:creationId xmlns:a16="http://schemas.microsoft.com/office/drawing/2014/main" id="{1642DD86-CB6A-421C-E05C-4E3CEC17DC81}"/>
               </a:ext>
             </a:extLst>
           </p:cNvPr>
@@ -12230,7 +12230,7 @@
           <p:cNvPr id="16" name="CuadroTexto 15">
             <a:extLst>
               <a:ext uri="{FF2B5EF4-FFF2-40B4-BE49-F238E27FC236}">
-                <a16:creationId xmlns:a16="http://schemas.microsoft.com/office/drawing/2014/main" id="{C0BA1C4D-F3EC-3959-933A-B3D1DADBB214}"/>
+                <a16:creationId xmlns:a16="http://schemas.microsoft.com/office/drawing/2014/main" id="{F6845773-DC4E-F31C-1C48-67C044F73A55}"/>
               </a:ext>
             </a:extLst>
           </p:cNvPr>
@@ -12270,7 +12270,7 @@
           <p:cNvPr id="17" name="Rectángulo: esquinas redondeadas 16">
             <a:extLst>
               <a:ext uri="{FF2B5EF4-FFF2-40B4-BE49-F238E27FC236}">
-                <a16:creationId xmlns:a16="http://schemas.microsoft.com/office/drawing/2014/main" id="{BE43186C-06C5-4633-B185-1519E17A5942}"/>
+                <a16:creationId xmlns:a16="http://schemas.microsoft.com/office/drawing/2014/main" id="{84B96BE3-B71E-71C8-C5CB-0FDA0651AFB8}"/>
               </a:ext>
             </a:extLst>
           </p:cNvPr>
@@ -12324,7 +12324,7 @@
           <p:cNvPr id="18" name="CuadroTexto 17">
             <a:extLst>
               <a:ext uri="{FF2B5EF4-FFF2-40B4-BE49-F238E27FC236}">
-                <a16:creationId xmlns:a16="http://schemas.microsoft.com/office/drawing/2014/main" id="{348EC1A2-FF8F-191C-74D6-0CA65E360857}"/>
+                <a16:creationId xmlns:a16="http://schemas.microsoft.com/office/drawing/2014/main" id="{7856000A-BCF8-C231-784A-B191622AB285}"/>
               </a:ext>
             </a:extLst>
           </p:cNvPr>
@@ -12364,7 +12364,7 @@
           <p:cNvPr id="19" name="CuadroTexto 18">
             <a:extLst>
               <a:ext uri="{FF2B5EF4-FFF2-40B4-BE49-F238E27FC236}">
-                <a16:creationId xmlns:a16="http://schemas.microsoft.com/office/drawing/2014/main" id="{347B51CF-EB24-88AC-F4AC-00F45C4C5859}"/>
+                <a16:creationId xmlns:a16="http://schemas.microsoft.com/office/drawing/2014/main" id="{8C446BC0-B203-434D-5198-E611C650F74F}"/>
               </a:ext>
             </a:extLst>
           </p:cNvPr>
@@ -12404,7 +12404,7 @@
           <p:cNvPr id="20" name="Rectángulo: esquinas redondeadas 19">
             <a:extLst>
               <a:ext uri="{FF2B5EF4-FFF2-40B4-BE49-F238E27FC236}">
-                <a16:creationId xmlns:a16="http://schemas.microsoft.com/office/drawing/2014/main" id="{4F3917CC-2989-10E3-5A63-461C4CADE5B8}"/>
+                <a16:creationId xmlns:a16="http://schemas.microsoft.com/office/drawing/2014/main" id="{8DF8A7DA-98AC-FCEF-AECF-F42CEBA93481}"/>
               </a:ext>
             </a:extLst>
           </p:cNvPr>
@@ -12458,7 +12458,7 @@
           <p:cNvPr id="21" name="CuadroTexto 20">
             <a:extLst>
               <a:ext uri="{FF2B5EF4-FFF2-40B4-BE49-F238E27FC236}">
-                <a16:creationId xmlns:a16="http://schemas.microsoft.com/office/drawing/2014/main" id="{3AF1EBAA-28C0-396A-C89C-E8851E4224F6}"/>
+                <a16:creationId xmlns:a16="http://schemas.microsoft.com/office/drawing/2014/main" id="{85D7ED3A-36CF-256D-0106-2D9E605346B9}"/>
               </a:ext>
             </a:extLst>
           </p:cNvPr>
@@ -12498,7 +12498,7 @@
           <p:cNvPr id="22" name="CuadroTexto 21">
             <a:extLst>
               <a:ext uri="{FF2B5EF4-FFF2-40B4-BE49-F238E27FC236}">
-                <a16:creationId xmlns:a16="http://schemas.microsoft.com/office/drawing/2014/main" id="{CC5F6D84-BE3E-CD72-653E-18210851BA33}"/>
+                <a16:creationId xmlns:a16="http://schemas.microsoft.com/office/drawing/2014/main" id="{E45EC501-4E58-10A6-A758-C90D025FB9ED}"/>
               </a:ext>
             </a:extLst>
           </p:cNvPr>
@@ -12536,7 +12536,7 @@
     </p:spTree>
     <p:extLst>
       <p:ext uri="{BB962C8B-B14F-4D97-AF65-F5344CB8AC3E}">
-        <p14:creationId xmlns:p14="http://schemas.microsoft.com/office/powerpoint/2010/main" val="2556743298"/>
+        <p14:creationId xmlns:p14="http://schemas.microsoft.com/office/powerpoint/2010/main" val="3281172835"/>
       </p:ext>
     </p:extLst>
   </p:cSld>

</xml_diff>

<commit_message>
Clarify managed storage scope in defense docs
</commit_message>
<xml_diff>
--- a/docs/presentacion-defensa-final.pptx
+++ b/docs/presentacion-defensa-final.pptx
@@ -146,7 +146,7 @@
           <p:cNvPr id="2" name="Título 1">
             <a:extLst>
               <a:ext uri="{FF2B5EF4-FFF2-40B4-BE49-F238E27FC236}">
-                <a16:creationId xmlns:a16="http://schemas.microsoft.com/office/drawing/2014/main" id="{F747E9A5-A69C-AF31-D358-E9AF2C95B4F2}"/>
+                <a16:creationId xmlns:a16="http://schemas.microsoft.com/office/drawing/2014/main" id="{AA1424A8-F5C0-2E5A-7814-8D5A788F2C41}"/>
               </a:ext>
             </a:extLst>
           </p:cNvPr>
@@ -183,7 +183,7 @@
           <p:cNvPr id="3" name="Subtítulo 2">
             <a:extLst>
               <a:ext uri="{FF2B5EF4-FFF2-40B4-BE49-F238E27FC236}">
-                <a16:creationId xmlns:a16="http://schemas.microsoft.com/office/drawing/2014/main" id="{9611385A-0F7B-2109-1713-B5B2D2EDC792}"/>
+                <a16:creationId xmlns:a16="http://schemas.microsoft.com/office/drawing/2014/main" id="{0DC4E564-14D9-30EF-F5A4-D8BE222FAF82}"/>
               </a:ext>
             </a:extLst>
           </p:cNvPr>
@@ -253,7 +253,7 @@
           <p:cNvPr id="4" name="Marcador de fecha 3">
             <a:extLst>
               <a:ext uri="{FF2B5EF4-FFF2-40B4-BE49-F238E27FC236}">
-                <a16:creationId xmlns:a16="http://schemas.microsoft.com/office/drawing/2014/main" id="{C52BBF9F-F302-7E77-541C-38E060120F29}"/>
+                <a16:creationId xmlns:a16="http://schemas.microsoft.com/office/drawing/2014/main" id="{DE26D437-9BD3-D275-C312-7EFE00BC0C02}"/>
               </a:ext>
             </a:extLst>
           </p:cNvPr>
@@ -269,9 +269,9 @@
           <a:bodyPr/>
           <a:lstStyle/>
           <a:p>
-            <a:fld id="{7DF9D857-2BC1-4ECA-A48E-C0419EF44063}" type="datetimeFigureOut">
+            <a:fld id="{3594F67B-593D-4384-8F95-2FBEEBEEB27A}" type="datetimeFigureOut">
               <a:rPr lang="es-ES" smtClean="0"/>
-              <a:t>27/05/2026</a:t>
+              <a:t>01/06/2026</a:t>
             </a:fld>
             <a:endParaRPr lang="es-ES"/>
           </a:p>
@@ -282,7 +282,7 @@
           <p:cNvPr id="5" name="Marcador de pie de página 4">
             <a:extLst>
               <a:ext uri="{FF2B5EF4-FFF2-40B4-BE49-F238E27FC236}">
-                <a16:creationId xmlns:a16="http://schemas.microsoft.com/office/drawing/2014/main" id="{93E919BF-FBDE-8D86-3269-B333EDF00920}"/>
+                <a16:creationId xmlns:a16="http://schemas.microsoft.com/office/drawing/2014/main" id="{5A8AD1E9-22FA-53E1-4A6E-34128EB13376}"/>
               </a:ext>
             </a:extLst>
           </p:cNvPr>
@@ -307,7 +307,7 @@
           <p:cNvPr id="6" name="Marcador de número de diapositiva 5">
             <a:extLst>
               <a:ext uri="{FF2B5EF4-FFF2-40B4-BE49-F238E27FC236}">
-                <a16:creationId xmlns:a16="http://schemas.microsoft.com/office/drawing/2014/main" id="{8A557309-3833-7F7A-228A-CF7BFD6250BE}"/>
+                <a16:creationId xmlns:a16="http://schemas.microsoft.com/office/drawing/2014/main" id="{B8FADB54-69CA-37C3-9538-2AC92ED7D55D}"/>
               </a:ext>
             </a:extLst>
           </p:cNvPr>
@@ -323,7 +323,7 @@
           <a:bodyPr/>
           <a:lstStyle/>
           <a:p>
-            <a:fld id="{AA515A41-34E0-4B8A-BFF5-025DE5A27467}" type="slidenum">
+            <a:fld id="{3E216418-6303-4DF4-80EB-715B8707D44E}" type="slidenum">
               <a:rPr lang="es-ES" smtClean="0"/>
               <a:t>‹Nº›</a:t>
             </a:fld>
@@ -334,7 +334,7 @@
     </p:spTree>
     <p:extLst>
       <p:ext uri="{BB962C8B-B14F-4D97-AF65-F5344CB8AC3E}">
-        <p14:creationId xmlns:p14="http://schemas.microsoft.com/office/powerpoint/2010/main" val="1096258657"/>
+        <p14:creationId xmlns:p14="http://schemas.microsoft.com/office/powerpoint/2010/main" val="2455286512"/>
       </p:ext>
     </p:extLst>
   </p:cSld>
@@ -366,7 +366,7 @@
           <p:cNvPr id="2" name="Título 1">
             <a:extLst>
               <a:ext uri="{FF2B5EF4-FFF2-40B4-BE49-F238E27FC236}">
-                <a16:creationId xmlns:a16="http://schemas.microsoft.com/office/drawing/2014/main" id="{54E1A38A-0F12-FD41-A2C0-70604426A558}"/>
+                <a16:creationId xmlns:a16="http://schemas.microsoft.com/office/drawing/2014/main" id="{57C83AF2-7E6C-0F9E-3C1D-65AA33168D3D}"/>
               </a:ext>
             </a:extLst>
           </p:cNvPr>
@@ -394,7 +394,7 @@
           <p:cNvPr id="3" name="Marcador de texto vertical 2">
             <a:extLst>
               <a:ext uri="{FF2B5EF4-FFF2-40B4-BE49-F238E27FC236}">
-                <a16:creationId xmlns:a16="http://schemas.microsoft.com/office/drawing/2014/main" id="{DBE13BC4-A7FA-7D61-9FFB-D416C20899A3}"/>
+                <a16:creationId xmlns:a16="http://schemas.microsoft.com/office/drawing/2014/main" id="{24546AAA-CAA5-A831-F197-F57E1E3EBDBB}"/>
               </a:ext>
             </a:extLst>
           </p:cNvPr>
@@ -451,7 +451,7 @@
           <p:cNvPr id="4" name="Marcador de fecha 3">
             <a:extLst>
               <a:ext uri="{FF2B5EF4-FFF2-40B4-BE49-F238E27FC236}">
-                <a16:creationId xmlns:a16="http://schemas.microsoft.com/office/drawing/2014/main" id="{70B0F91E-D46E-5A6F-E9C1-DDC7DA6F64B7}"/>
+                <a16:creationId xmlns:a16="http://schemas.microsoft.com/office/drawing/2014/main" id="{93A01D50-6F6A-F01F-DFFE-49C0E92DD415}"/>
               </a:ext>
             </a:extLst>
           </p:cNvPr>
@@ -467,9 +467,9 @@
           <a:bodyPr/>
           <a:lstStyle/>
           <a:p>
-            <a:fld id="{7DF9D857-2BC1-4ECA-A48E-C0419EF44063}" type="datetimeFigureOut">
+            <a:fld id="{3594F67B-593D-4384-8F95-2FBEEBEEB27A}" type="datetimeFigureOut">
               <a:rPr lang="es-ES" smtClean="0"/>
-              <a:t>27/05/2026</a:t>
+              <a:t>01/06/2026</a:t>
             </a:fld>
             <a:endParaRPr lang="es-ES"/>
           </a:p>
@@ -480,7 +480,7 @@
           <p:cNvPr id="5" name="Marcador de pie de página 4">
             <a:extLst>
               <a:ext uri="{FF2B5EF4-FFF2-40B4-BE49-F238E27FC236}">
-                <a16:creationId xmlns:a16="http://schemas.microsoft.com/office/drawing/2014/main" id="{E4906C85-F32C-8D4E-692B-EA7A9BE8DB65}"/>
+                <a16:creationId xmlns:a16="http://schemas.microsoft.com/office/drawing/2014/main" id="{C4CAB07D-DE00-00AA-5692-CB27E034EC36}"/>
               </a:ext>
             </a:extLst>
           </p:cNvPr>
@@ -505,7 +505,7 @@
           <p:cNvPr id="6" name="Marcador de número de diapositiva 5">
             <a:extLst>
               <a:ext uri="{FF2B5EF4-FFF2-40B4-BE49-F238E27FC236}">
-                <a16:creationId xmlns:a16="http://schemas.microsoft.com/office/drawing/2014/main" id="{F9B679B1-8A4E-00F6-E432-D501D8B369C0}"/>
+                <a16:creationId xmlns:a16="http://schemas.microsoft.com/office/drawing/2014/main" id="{AE6F0C28-EA5A-89CE-04EC-17135B274084}"/>
               </a:ext>
             </a:extLst>
           </p:cNvPr>
@@ -521,7 +521,7 @@
           <a:bodyPr/>
           <a:lstStyle/>
           <a:p>
-            <a:fld id="{AA515A41-34E0-4B8A-BFF5-025DE5A27467}" type="slidenum">
+            <a:fld id="{3E216418-6303-4DF4-80EB-715B8707D44E}" type="slidenum">
               <a:rPr lang="es-ES" smtClean="0"/>
               <a:t>‹Nº›</a:t>
             </a:fld>
@@ -532,7 +532,7 @@
     </p:spTree>
     <p:extLst>
       <p:ext uri="{BB962C8B-B14F-4D97-AF65-F5344CB8AC3E}">
-        <p14:creationId xmlns:p14="http://schemas.microsoft.com/office/powerpoint/2010/main" val="3866775877"/>
+        <p14:creationId xmlns:p14="http://schemas.microsoft.com/office/powerpoint/2010/main" val="2549378577"/>
       </p:ext>
     </p:extLst>
   </p:cSld>
@@ -564,7 +564,7 @@
           <p:cNvPr id="2" name="Título vertical 1">
             <a:extLst>
               <a:ext uri="{FF2B5EF4-FFF2-40B4-BE49-F238E27FC236}">
-                <a16:creationId xmlns:a16="http://schemas.microsoft.com/office/drawing/2014/main" id="{3969AAB8-257F-573C-1745-C77C65247482}"/>
+                <a16:creationId xmlns:a16="http://schemas.microsoft.com/office/drawing/2014/main" id="{46AB338E-FEFD-A8AF-18DE-56185C24091F}"/>
               </a:ext>
             </a:extLst>
           </p:cNvPr>
@@ -597,7 +597,7 @@
           <p:cNvPr id="3" name="Marcador de texto vertical 2">
             <a:extLst>
               <a:ext uri="{FF2B5EF4-FFF2-40B4-BE49-F238E27FC236}">
-                <a16:creationId xmlns:a16="http://schemas.microsoft.com/office/drawing/2014/main" id="{CDC5E29F-8D9E-0979-F474-63AF8DA8314D}"/>
+                <a16:creationId xmlns:a16="http://schemas.microsoft.com/office/drawing/2014/main" id="{6088E667-B029-3E92-F0EE-0F45EDC6AEA4}"/>
               </a:ext>
             </a:extLst>
           </p:cNvPr>
@@ -659,7 +659,7 @@
           <p:cNvPr id="4" name="Marcador de fecha 3">
             <a:extLst>
               <a:ext uri="{FF2B5EF4-FFF2-40B4-BE49-F238E27FC236}">
-                <a16:creationId xmlns:a16="http://schemas.microsoft.com/office/drawing/2014/main" id="{82311995-F201-2E73-7F41-F18FC3BC97B8}"/>
+                <a16:creationId xmlns:a16="http://schemas.microsoft.com/office/drawing/2014/main" id="{08F641FF-0C49-5058-E882-C1C66745FFA5}"/>
               </a:ext>
             </a:extLst>
           </p:cNvPr>
@@ -675,9 +675,9 @@
           <a:bodyPr/>
           <a:lstStyle/>
           <a:p>
-            <a:fld id="{7DF9D857-2BC1-4ECA-A48E-C0419EF44063}" type="datetimeFigureOut">
+            <a:fld id="{3594F67B-593D-4384-8F95-2FBEEBEEB27A}" type="datetimeFigureOut">
               <a:rPr lang="es-ES" smtClean="0"/>
-              <a:t>27/05/2026</a:t>
+              <a:t>01/06/2026</a:t>
             </a:fld>
             <a:endParaRPr lang="es-ES"/>
           </a:p>
@@ -688,7 +688,7 @@
           <p:cNvPr id="5" name="Marcador de pie de página 4">
             <a:extLst>
               <a:ext uri="{FF2B5EF4-FFF2-40B4-BE49-F238E27FC236}">
-                <a16:creationId xmlns:a16="http://schemas.microsoft.com/office/drawing/2014/main" id="{5BE549F1-05B4-D110-36F4-2856D96123C9}"/>
+                <a16:creationId xmlns:a16="http://schemas.microsoft.com/office/drawing/2014/main" id="{94E36D7E-FACE-12B9-9203-D1613FBB1191}"/>
               </a:ext>
             </a:extLst>
           </p:cNvPr>
@@ -713,7 +713,7 @@
           <p:cNvPr id="6" name="Marcador de número de diapositiva 5">
             <a:extLst>
               <a:ext uri="{FF2B5EF4-FFF2-40B4-BE49-F238E27FC236}">
-                <a16:creationId xmlns:a16="http://schemas.microsoft.com/office/drawing/2014/main" id="{0119D8FD-3460-7AB5-D3B2-D050CDEFF9B8}"/>
+                <a16:creationId xmlns:a16="http://schemas.microsoft.com/office/drawing/2014/main" id="{E4EEE139-E64A-3F7C-E8BF-6754CBA6B333}"/>
               </a:ext>
             </a:extLst>
           </p:cNvPr>
@@ -729,7 +729,7 @@
           <a:bodyPr/>
           <a:lstStyle/>
           <a:p>
-            <a:fld id="{AA515A41-34E0-4B8A-BFF5-025DE5A27467}" type="slidenum">
+            <a:fld id="{3E216418-6303-4DF4-80EB-715B8707D44E}" type="slidenum">
               <a:rPr lang="es-ES" smtClean="0"/>
               <a:t>‹Nº›</a:t>
             </a:fld>
@@ -740,7 +740,7 @@
     </p:spTree>
     <p:extLst>
       <p:ext uri="{BB962C8B-B14F-4D97-AF65-F5344CB8AC3E}">
-        <p14:creationId xmlns:p14="http://schemas.microsoft.com/office/powerpoint/2010/main" val="2594176324"/>
+        <p14:creationId xmlns:p14="http://schemas.microsoft.com/office/powerpoint/2010/main" val="1238850085"/>
       </p:ext>
     </p:extLst>
   </p:cSld>
@@ -772,7 +772,7 @@
           <p:cNvPr id="2" name="Título 1">
             <a:extLst>
               <a:ext uri="{FF2B5EF4-FFF2-40B4-BE49-F238E27FC236}">
-                <a16:creationId xmlns:a16="http://schemas.microsoft.com/office/drawing/2014/main" id="{A657B3D1-9F17-9857-C23E-0FF9659FD909}"/>
+                <a16:creationId xmlns:a16="http://schemas.microsoft.com/office/drawing/2014/main" id="{E78901D5-99B4-D2C9-591A-7945BF3139AA}"/>
               </a:ext>
             </a:extLst>
           </p:cNvPr>
@@ -800,7 +800,7 @@
           <p:cNvPr id="3" name="Marcador de contenido 2">
             <a:extLst>
               <a:ext uri="{FF2B5EF4-FFF2-40B4-BE49-F238E27FC236}">
-                <a16:creationId xmlns:a16="http://schemas.microsoft.com/office/drawing/2014/main" id="{CCC8DB27-0B8D-3DFD-F444-147E77A62E3F}"/>
+                <a16:creationId xmlns:a16="http://schemas.microsoft.com/office/drawing/2014/main" id="{10654976-33B1-F68D-E6B4-006C837BE16A}"/>
               </a:ext>
             </a:extLst>
           </p:cNvPr>
@@ -857,7 +857,7 @@
           <p:cNvPr id="4" name="Marcador de fecha 3">
             <a:extLst>
               <a:ext uri="{FF2B5EF4-FFF2-40B4-BE49-F238E27FC236}">
-                <a16:creationId xmlns:a16="http://schemas.microsoft.com/office/drawing/2014/main" id="{3F9DB092-AE36-B1AA-99F0-4ECC974B29D3}"/>
+                <a16:creationId xmlns:a16="http://schemas.microsoft.com/office/drawing/2014/main" id="{A35925D9-FDA0-86C7-9E16-CDEEAF7720FF}"/>
               </a:ext>
             </a:extLst>
           </p:cNvPr>
@@ -873,9 +873,9 @@
           <a:bodyPr/>
           <a:lstStyle/>
           <a:p>
-            <a:fld id="{7DF9D857-2BC1-4ECA-A48E-C0419EF44063}" type="datetimeFigureOut">
+            <a:fld id="{3594F67B-593D-4384-8F95-2FBEEBEEB27A}" type="datetimeFigureOut">
               <a:rPr lang="es-ES" smtClean="0"/>
-              <a:t>27/05/2026</a:t>
+              <a:t>01/06/2026</a:t>
             </a:fld>
             <a:endParaRPr lang="es-ES"/>
           </a:p>
@@ -886,7 +886,7 @@
           <p:cNvPr id="5" name="Marcador de pie de página 4">
             <a:extLst>
               <a:ext uri="{FF2B5EF4-FFF2-40B4-BE49-F238E27FC236}">
-                <a16:creationId xmlns:a16="http://schemas.microsoft.com/office/drawing/2014/main" id="{48D9DE15-B473-06DB-601C-09CE6D7B00A2}"/>
+                <a16:creationId xmlns:a16="http://schemas.microsoft.com/office/drawing/2014/main" id="{BAEFEF87-8119-67D1-7B26-1521E2CC6641}"/>
               </a:ext>
             </a:extLst>
           </p:cNvPr>
@@ -911,7 +911,7 @@
           <p:cNvPr id="6" name="Marcador de número de diapositiva 5">
             <a:extLst>
               <a:ext uri="{FF2B5EF4-FFF2-40B4-BE49-F238E27FC236}">
-                <a16:creationId xmlns:a16="http://schemas.microsoft.com/office/drawing/2014/main" id="{811C6BA2-83FB-199D-78F2-AC5FCF809BFB}"/>
+                <a16:creationId xmlns:a16="http://schemas.microsoft.com/office/drawing/2014/main" id="{B3C2EFF3-79AA-17A1-9994-4EEE79A5F9C6}"/>
               </a:ext>
             </a:extLst>
           </p:cNvPr>
@@ -927,7 +927,7 @@
           <a:bodyPr/>
           <a:lstStyle/>
           <a:p>
-            <a:fld id="{AA515A41-34E0-4B8A-BFF5-025DE5A27467}" type="slidenum">
+            <a:fld id="{3E216418-6303-4DF4-80EB-715B8707D44E}" type="slidenum">
               <a:rPr lang="es-ES" smtClean="0"/>
               <a:t>‹Nº›</a:t>
             </a:fld>
@@ -938,7 +938,7 @@
     </p:spTree>
     <p:extLst>
       <p:ext uri="{BB962C8B-B14F-4D97-AF65-F5344CB8AC3E}">
-        <p14:creationId xmlns:p14="http://schemas.microsoft.com/office/powerpoint/2010/main" val="174078382"/>
+        <p14:creationId xmlns:p14="http://schemas.microsoft.com/office/powerpoint/2010/main" val="2033255128"/>
       </p:ext>
     </p:extLst>
   </p:cSld>
@@ -970,7 +970,7 @@
           <p:cNvPr id="2" name="Título 1">
             <a:extLst>
               <a:ext uri="{FF2B5EF4-FFF2-40B4-BE49-F238E27FC236}">
-                <a16:creationId xmlns:a16="http://schemas.microsoft.com/office/drawing/2014/main" id="{9FEE0E53-739A-5E14-2265-63E08A962888}"/>
+                <a16:creationId xmlns:a16="http://schemas.microsoft.com/office/drawing/2014/main" id="{0CB81FE2-7FCE-0707-0361-7ADD3D92D2EA}"/>
               </a:ext>
             </a:extLst>
           </p:cNvPr>
@@ -1007,7 +1007,7 @@
           <p:cNvPr id="3" name="Marcador de texto 2">
             <a:extLst>
               <a:ext uri="{FF2B5EF4-FFF2-40B4-BE49-F238E27FC236}">
-                <a16:creationId xmlns:a16="http://schemas.microsoft.com/office/drawing/2014/main" id="{3CF09E20-BB42-9D1C-9A16-C9727455D13D}"/>
+                <a16:creationId xmlns:a16="http://schemas.microsoft.com/office/drawing/2014/main" id="{76A60D1A-DF2F-E574-0BB9-D3969FF18C85}"/>
               </a:ext>
             </a:extLst>
           </p:cNvPr>
@@ -1132,7 +1132,7 @@
           <p:cNvPr id="4" name="Marcador de fecha 3">
             <a:extLst>
               <a:ext uri="{FF2B5EF4-FFF2-40B4-BE49-F238E27FC236}">
-                <a16:creationId xmlns:a16="http://schemas.microsoft.com/office/drawing/2014/main" id="{6D43DD57-7FE4-C155-4E7A-0401C12069F9}"/>
+                <a16:creationId xmlns:a16="http://schemas.microsoft.com/office/drawing/2014/main" id="{48921F6F-1AF9-E840-E797-167C49AABC30}"/>
               </a:ext>
             </a:extLst>
           </p:cNvPr>
@@ -1148,9 +1148,9 @@
           <a:bodyPr/>
           <a:lstStyle/>
           <a:p>
-            <a:fld id="{7DF9D857-2BC1-4ECA-A48E-C0419EF44063}" type="datetimeFigureOut">
+            <a:fld id="{3594F67B-593D-4384-8F95-2FBEEBEEB27A}" type="datetimeFigureOut">
               <a:rPr lang="es-ES" smtClean="0"/>
-              <a:t>27/05/2026</a:t>
+              <a:t>01/06/2026</a:t>
             </a:fld>
             <a:endParaRPr lang="es-ES"/>
           </a:p>
@@ -1161,7 +1161,7 @@
           <p:cNvPr id="5" name="Marcador de pie de página 4">
             <a:extLst>
               <a:ext uri="{FF2B5EF4-FFF2-40B4-BE49-F238E27FC236}">
-                <a16:creationId xmlns:a16="http://schemas.microsoft.com/office/drawing/2014/main" id="{2DCB3593-8C1B-01A6-64F0-1F8662C0C058}"/>
+                <a16:creationId xmlns:a16="http://schemas.microsoft.com/office/drawing/2014/main" id="{66A560AC-EF8C-A398-E175-A21980745154}"/>
               </a:ext>
             </a:extLst>
           </p:cNvPr>
@@ -1186,7 +1186,7 @@
           <p:cNvPr id="6" name="Marcador de número de diapositiva 5">
             <a:extLst>
               <a:ext uri="{FF2B5EF4-FFF2-40B4-BE49-F238E27FC236}">
-                <a16:creationId xmlns:a16="http://schemas.microsoft.com/office/drawing/2014/main" id="{E396AEC0-2558-3D0F-B016-A6852FB7E0A8}"/>
+                <a16:creationId xmlns:a16="http://schemas.microsoft.com/office/drawing/2014/main" id="{7EDA3FF6-60ED-E272-21BA-E63161F1025A}"/>
               </a:ext>
             </a:extLst>
           </p:cNvPr>
@@ -1202,7 +1202,7 @@
           <a:bodyPr/>
           <a:lstStyle/>
           <a:p>
-            <a:fld id="{AA515A41-34E0-4B8A-BFF5-025DE5A27467}" type="slidenum">
+            <a:fld id="{3E216418-6303-4DF4-80EB-715B8707D44E}" type="slidenum">
               <a:rPr lang="es-ES" smtClean="0"/>
               <a:t>‹Nº›</a:t>
             </a:fld>
@@ -1213,7 +1213,7 @@
     </p:spTree>
     <p:extLst>
       <p:ext uri="{BB962C8B-B14F-4D97-AF65-F5344CB8AC3E}">
-        <p14:creationId xmlns:p14="http://schemas.microsoft.com/office/powerpoint/2010/main" val="3538564462"/>
+        <p14:creationId xmlns:p14="http://schemas.microsoft.com/office/powerpoint/2010/main" val="443343728"/>
       </p:ext>
     </p:extLst>
   </p:cSld>
@@ -1245,7 +1245,7 @@
           <p:cNvPr id="2" name="Título 1">
             <a:extLst>
               <a:ext uri="{FF2B5EF4-FFF2-40B4-BE49-F238E27FC236}">
-                <a16:creationId xmlns:a16="http://schemas.microsoft.com/office/drawing/2014/main" id="{0386B269-1F9B-096D-4156-1A9A9FDDC953}"/>
+                <a16:creationId xmlns:a16="http://schemas.microsoft.com/office/drawing/2014/main" id="{385B08C1-E993-F59D-8651-1EBF9280D8A1}"/>
               </a:ext>
             </a:extLst>
           </p:cNvPr>
@@ -1273,7 +1273,7 @@
           <p:cNvPr id="3" name="Marcador de contenido 2">
             <a:extLst>
               <a:ext uri="{FF2B5EF4-FFF2-40B4-BE49-F238E27FC236}">
-                <a16:creationId xmlns:a16="http://schemas.microsoft.com/office/drawing/2014/main" id="{3691497C-0160-D7CC-5A2C-37BA9EFFA3D7}"/>
+                <a16:creationId xmlns:a16="http://schemas.microsoft.com/office/drawing/2014/main" id="{737DAD8D-0B1F-479E-82AC-904393E28710}"/>
               </a:ext>
             </a:extLst>
           </p:cNvPr>
@@ -1335,7 +1335,7 @@
           <p:cNvPr id="4" name="Marcador de contenido 3">
             <a:extLst>
               <a:ext uri="{FF2B5EF4-FFF2-40B4-BE49-F238E27FC236}">
-                <a16:creationId xmlns:a16="http://schemas.microsoft.com/office/drawing/2014/main" id="{F7CE6F9C-0984-7B61-D31C-4FC486CBDBFD}"/>
+                <a16:creationId xmlns:a16="http://schemas.microsoft.com/office/drawing/2014/main" id="{2D07CEBD-204B-961F-E875-AC71F6165DF7}"/>
               </a:ext>
             </a:extLst>
           </p:cNvPr>
@@ -1397,7 +1397,7 @@
           <p:cNvPr id="5" name="Marcador de fecha 4">
             <a:extLst>
               <a:ext uri="{FF2B5EF4-FFF2-40B4-BE49-F238E27FC236}">
-                <a16:creationId xmlns:a16="http://schemas.microsoft.com/office/drawing/2014/main" id="{D587CFF8-9155-5D3D-5C77-4353055CC059}"/>
+                <a16:creationId xmlns:a16="http://schemas.microsoft.com/office/drawing/2014/main" id="{FF9C0AC7-2DB1-97E6-C226-76FBE8A3A8E2}"/>
               </a:ext>
             </a:extLst>
           </p:cNvPr>
@@ -1413,9 +1413,9 @@
           <a:bodyPr/>
           <a:lstStyle/>
           <a:p>
-            <a:fld id="{7DF9D857-2BC1-4ECA-A48E-C0419EF44063}" type="datetimeFigureOut">
+            <a:fld id="{3594F67B-593D-4384-8F95-2FBEEBEEB27A}" type="datetimeFigureOut">
               <a:rPr lang="es-ES" smtClean="0"/>
-              <a:t>27/05/2026</a:t>
+              <a:t>01/06/2026</a:t>
             </a:fld>
             <a:endParaRPr lang="es-ES"/>
           </a:p>
@@ -1426,7 +1426,7 @@
           <p:cNvPr id="6" name="Marcador de pie de página 5">
             <a:extLst>
               <a:ext uri="{FF2B5EF4-FFF2-40B4-BE49-F238E27FC236}">
-                <a16:creationId xmlns:a16="http://schemas.microsoft.com/office/drawing/2014/main" id="{02A4965C-5C15-5E1C-997E-BE1FE0D87CCA}"/>
+                <a16:creationId xmlns:a16="http://schemas.microsoft.com/office/drawing/2014/main" id="{EDA0DC87-BCEE-DD42-6B44-7CCA524F0E85}"/>
               </a:ext>
             </a:extLst>
           </p:cNvPr>
@@ -1451,7 +1451,7 @@
           <p:cNvPr id="7" name="Marcador de número de diapositiva 6">
             <a:extLst>
               <a:ext uri="{FF2B5EF4-FFF2-40B4-BE49-F238E27FC236}">
-                <a16:creationId xmlns:a16="http://schemas.microsoft.com/office/drawing/2014/main" id="{678C03CE-F840-8305-FCDB-505111302E04}"/>
+                <a16:creationId xmlns:a16="http://schemas.microsoft.com/office/drawing/2014/main" id="{5111691C-B91A-89B6-76AD-43C7853A9116}"/>
               </a:ext>
             </a:extLst>
           </p:cNvPr>
@@ -1467,7 +1467,7 @@
           <a:bodyPr/>
           <a:lstStyle/>
           <a:p>
-            <a:fld id="{AA515A41-34E0-4B8A-BFF5-025DE5A27467}" type="slidenum">
+            <a:fld id="{3E216418-6303-4DF4-80EB-715B8707D44E}" type="slidenum">
               <a:rPr lang="es-ES" smtClean="0"/>
               <a:t>‹Nº›</a:t>
             </a:fld>
@@ -1478,7 +1478,7 @@
     </p:spTree>
     <p:extLst>
       <p:ext uri="{BB962C8B-B14F-4D97-AF65-F5344CB8AC3E}">
-        <p14:creationId xmlns:p14="http://schemas.microsoft.com/office/powerpoint/2010/main" val="1591076314"/>
+        <p14:creationId xmlns:p14="http://schemas.microsoft.com/office/powerpoint/2010/main" val="1145307958"/>
       </p:ext>
     </p:extLst>
   </p:cSld>
@@ -1510,7 +1510,7 @@
           <p:cNvPr id="2" name="Título 1">
             <a:extLst>
               <a:ext uri="{FF2B5EF4-FFF2-40B4-BE49-F238E27FC236}">
-                <a16:creationId xmlns:a16="http://schemas.microsoft.com/office/drawing/2014/main" id="{C95FE9DA-633C-A7A3-4DF1-9E0CE4AD708E}"/>
+                <a16:creationId xmlns:a16="http://schemas.microsoft.com/office/drawing/2014/main" id="{ECA94CD3-0710-86CC-1AB2-F851BA958007}"/>
               </a:ext>
             </a:extLst>
           </p:cNvPr>
@@ -1543,7 +1543,7 @@
           <p:cNvPr id="3" name="Marcador de texto 2">
             <a:extLst>
               <a:ext uri="{FF2B5EF4-FFF2-40B4-BE49-F238E27FC236}">
-                <a16:creationId xmlns:a16="http://schemas.microsoft.com/office/drawing/2014/main" id="{A9C3C829-0D26-0D9D-61AB-5F9AE070EB70}"/>
+                <a16:creationId xmlns:a16="http://schemas.microsoft.com/office/drawing/2014/main" id="{E98A71FB-2B84-8180-1FB3-0700CCD08AE7}"/>
               </a:ext>
             </a:extLst>
           </p:cNvPr>
@@ -1614,7 +1614,7 @@
           <p:cNvPr id="4" name="Marcador de contenido 3">
             <a:extLst>
               <a:ext uri="{FF2B5EF4-FFF2-40B4-BE49-F238E27FC236}">
-                <a16:creationId xmlns:a16="http://schemas.microsoft.com/office/drawing/2014/main" id="{ECC82072-9276-3394-D5C3-5CAAC1625396}"/>
+                <a16:creationId xmlns:a16="http://schemas.microsoft.com/office/drawing/2014/main" id="{284B4773-6CEB-8828-66FA-53DEE6BEBD85}"/>
               </a:ext>
             </a:extLst>
           </p:cNvPr>
@@ -1676,7 +1676,7 @@
           <p:cNvPr id="5" name="Marcador de texto 4">
             <a:extLst>
               <a:ext uri="{FF2B5EF4-FFF2-40B4-BE49-F238E27FC236}">
-                <a16:creationId xmlns:a16="http://schemas.microsoft.com/office/drawing/2014/main" id="{9B68160E-CD31-5543-6D4B-9AB56CEFC07B}"/>
+                <a16:creationId xmlns:a16="http://schemas.microsoft.com/office/drawing/2014/main" id="{569EF8C5-7F81-49BF-21E4-6E07B4334D06}"/>
               </a:ext>
             </a:extLst>
           </p:cNvPr>
@@ -1747,7 +1747,7 @@
           <p:cNvPr id="6" name="Marcador de contenido 5">
             <a:extLst>
               <a:ext uri="{FF2B5EF4-FFF2-40B4-BE49-F238E27FC236}">
-                <a16:creationId xmlns:a16="http://schemas.microsoft.com/office/drawing/2014/main" id="{F8B5504F-2A8D-DF35-1794-1632E2A34FE8}"/>
+                <a16:creationId xmlns:a16="http://schemas.microsoft.com/office/drawing/2014/main" id="{12DB43AB-E1B7-2B01-557F-9048B2D423D0}"/>
               </a:ext>
             </a:extLst>
           </p:cNvPr>
@@ -1809,7 +1809,7 @@
           <p:cNvPr id="7" name="Marcador de fecha 6">
             <a:extLst>
               <a:ext uri="{FF2B5EF4-FFF2-40B4-BE49-F238E27FC236}">
-                <a16:creationId xmlns:a16="http://schemas.microsoft.com/office/drawing/2014/main" id="{FD8E17A6-0FA9-0BBD-E0F3-37EE6389BCE7}"/>
+                <a16:creationId xmlns:a16="http://schemas.microsoft.com/office/drawing/2014/main" id="{27744151-C34B-F7D3-75F9-9183D79F2784}"/>
               </a:ext>
             </a:extLst>
           </p:cNvPr>
@@ -1825,9 +1825,9 @@
           <a:bodyPr/>
           <a:lstStyle/>
           <a:p>
-            <a:fld id="{7DF9D857-2BC1-4ECA-A48E-C0419EF44063}" type="datetimeFigureOut">
+            <a:fld id="{3594F67B-593D-4384-8F95-2FBEEBEEB27A}" type="datetimeFigureOut">
               <a:rPr lang="es-ES" smtClean="0"/>
-              <a:t>27/05/2026</a:t>
+              <a:t>01/06/2026</a:t>
             </a:fld>
             <a:endParaRPr lang="es-ES"/>
           </a:p>
@@ -1838,7 +1838,7 @@
           <p:cNvPr id="8" name="Marcador de pie de página 7">
             <a:extLst>
               <a:ext uri="{FF2B5EF4-FFF2-40B4-BE49-F238E27FC236}">
-                <a16:creationId xmlns:a16="http://schemas.microsoft.com/office/drawing/2014/main" id="{D099D6E1-9F08-46D6-96E0-6556CA612323}"/>
+                <a16:creationId xmlns:a16="http://schemas.microsoft.com/office/drawing/2014/main" id="{4CA972AB-39BB-4DDB-677C-7C2426DABD23}"/>
               </a:ext>
             </a:extLst>
           </p:cNvPr>
@@ -1863,7 +1863,7 @@
           <p:cNvPr id="9" name="Marcador de número de diapositiva 8">
             <a:extLst>
               <a:ext uri="{FF2B5EF4-FFF2-40B4-BE49-F238E27FC236}">
-                <a16:creationId xmlns:a16="http://schemas.microsoft.com/office/drawing/2014/main" id="{CDDD4F92-CAEB-BB19-55E3-6ED1365B570E}"/>
+                <a16:creationId xmlns:a16="http://schemas.microsoft.com/office/drawing/2014/main" id="{EE8B46AC-7FF1-E539-E9A2-5E7B13B5EC29}"/>
               </a:ext>
             </a:extLst>
           </p:cNvPr>
@@ -1879,7 +1879,7 @@
           <a:bodyPr/>
           <a:lstStyle/>
           <a:p>
-            <a:fld id="{AA515A41-34E0-4B8A-BFF5-025DE5A27467}" type="slidenum">
+            <a:fld id="{3E216418-6303-4DF4-80EB-715B8707D44E}" type="slidenum">
               <a:rPr lang="es-ES" smtClean="0"/>
               <a:t>‹Nº›</a:t>
             </a:fld>
@@ -1890,7 +1890,7 @@
     </p:spTree>
     <p:extLst>
       <p:ext uri="{BB962C8B-B14F-4D97-AF65-F5344CB8AC3E}">
-        <p14:creationId xmlns:p14="http://schemas.microsoft.com/office/powerpoint/2010/main" val="4236326680"/>
+        <p14:creationId xmlns:p14="http://schemas.microsoft.com/office/powerpoint/2010/main" val="2920174836"/>
       </p:ext>
     </p:extLst>
   </p:cSld>
@@ -1922,7 +1922,7 @@
           <p:cNvPr id="2" name="Título 1">
             <a:extLst>
               <a:ext uri="{FF2B5EF4-FFF2-40B4-BE49-F238E27FC236}">
-                <a16:creationId xmlns:a16="http://schemas.microsoft.com/office/drawing/2014/main" id="{884F9C25-1F3D-22F8-B89F-96D23B7D2CD0}"/>
+                <a16:creationId xmlns:a16="http://schemas.microsoft.com/office/drawing/2014/main" id="{B95024DB-1CD0-312B-3E29-F0DCB4880364}"/>
               </a:ext>
             </a:extLst>
           </p:cNvPr>
@@ -1950,7 +1950,7 @@
           <p:cNvPr id="3" name="Marcador de fecha 2">
             <a:extLst>
               <a:ext uri="{FF2B5EF4-FFF2-40B4-BE49-F238E27FC236}">
-                <a16:creationId xmlns:a16="http://schemas.microsoft.com/office/drawing/2014/main" id="{B2711B9A-4C75-FF47-7BB5-1B3C8E570852}"/>
+                <a16:creationId xmlns:a16="http://schemas.microsoft.com/office/drawing/2014/main" id="{E693750E-1BE2-EF46-8C03-C8AB0BBAAFDB}"/>
               </a:ext>
             </a:extLst>
           </p:cNvPr>
@@ -1966,9 +1966,9 @@
           <a:bodyPr/>
           <a:lstStyle/>
           <a:p>
-            <a:fld id="{7DF9D857-2BC1-4ECA-A48E-C0419EF44063}" type="datetimeFigureOut">
+            <a:fld id="{3594F67B-593D-4384-8F95-2FBEEBEEB27A}" type="datetimeFigureOut">
               <a:rPr lang="es-ES" smtClean="0"/>
-              <a:t>27/05/2026</a:t>
+              <a:t>01/06/2026</a:t>
             </a:fld>
             <a:endParaRPr lang="es-ES"/>
           </a:p>
@@ -1979,7 +1979,7 @@
           <p:cNvPr id="4" name="Marcador de pie de página 3">
             <a:extLst>
               <a:ext uri="{FF2B5EF4-FFF2-40B4-BE49-F238E27FC236}">
-                <a16:creationId xmlns:a16="http://schemas.microsoft.com/office/drawing/2014/main" id="{2F47A31C-E4CB-E1DD-F41C-1BED88159EE5}"/>
+                <a16:creationId xmlns:a16="http://schemas.microsoft.com/office/drawing/2014/main" id="{000E8E06-FABC-1FB6-2B66-EE56AF013008}"/>
               </a:ext>
             </a:extLst>
           </p:cNvPr>
@@ -2004,7 +2004,7 @@
           <p:cNvPr id="5" name="Marcador de número de diapositiva 4">
             <a:extLst>
               <a:ext uri="{FF2B5EF4-FFF2-40B4-BE49-F238E27FC236}">
-                <a16:creationId xmlns:a16="http://schemas.microsoft.com/office/drawing/2014/main" id="{16B7C687-FEF9-3605-F982-EC5CAED7B379}"/>
+                <a16:creationId xmlns:a16="http://schemas.microsoft.com/office/drawing/2014/main" id="{58A052CE-71D7-F68A-5D06-2099A1659910}"/>
               </a:ext>
             </a:extLst>
           </p:cNvPr>
@@ -2020,7 +2020,7 @@
           <a:bodyPr/>
           <a:lstStyle/>
           <a:p>
-            <a:fld id="{AA515A41-34E0-4B8A-BFF5-025DE5A27467}" type="slidenum">
+            <a:fld id="{3E216418-6303-4DF4-80EB-715B8707D44E}" type="slidenum">
               <a:rPr lang="es-ES" smtClean="0"/>
               <a:t>‹Nº›</a:t>
             </a:fld>
@@ -2031,7 +2031,7 @@
     </p:spTree>
     <p:extLst>
       <p:ext uri="{BB962C8B-B14F-4D97-AF65-F5344CB8AC3E}">
-        <p14:creationId xmlns:p14="http://schemas.microsoft.com/office/powerpoint/2010/main" val="3260201284"/>
+        <p14:creationId xmlns:p14="http://schemas.microsoft.com/office/powerpoint/2010/main" val="686946921"/>
       </p:ext>
     </p:extLst>
   </p:cSld>
@@ -2063,7 +2063,7 @@
           <p:cNvPr id="2" name="Marcador de fecha 1">
             <a:extLst>
               <a:ext uri="{FF2B5EF4-FFF2-40B4-BE49-F238E27FC236}">
-                <a16:creationId xmlns:a16="http://schemas.microsoft.com/office/drawing/2014/main" id="{DB0FDAD9-4A92-C1D0-A3D0-ACA1C4661747}"/>
+                <a16:creationId xmlns:a16="http://schemas.microsoft.com/office/drawing/2014/main" id="{07A54D4B-EB29-606E-D8CF-3C2A3BE2FA51}"/>
               </a:ext>
             </a:extLst>
           </p:cNvPr>
@@ -2079,9 +2079,9 @@
           <a:bodyPr/>
           <a:lstStyle/>
           <a:p>
-            <a:fld id="{7DF9D857-2BC1-4ECA-A48E-C0419EF44063}" type="datetimeFigureOut">
+            <a:fld id="{3594F67B-593D-4384-8F95-2FBEEBEEB27A}" type="datetimeFigureOut">
               <a:rPr lang="es-ES" smtClean="0"/>
-              <a:t>27/05/2026</a:t>
+              <a:t>01/06/2026</a:t>
             </a:fld>
             <a:endParaRPr lang="es-ES"/>
           </a:p>
@@ -2092,7 +2092,7 @@
           <p:cNvPr id="3" name="Marcador de pie de página 2">
             <a:extLst>
               <a:ext uri="{FF2B5EF4-FFF2-40B4-BE49-F238E27FC236}">
-                <a16:creationId xmlns:a16="http://schemas.microsoft.com/office/drawing/2014/main" id="{78DAC3A3-A540-E223-C38E-27A344B554DD}"/>
+                <a16:creationId xmlns:a16="http://schemas.microsoft.com/office/drawing/2014/main" id="{FE4290FF-1038-24E8-33DA-35749590B469}"/>
               </a:ext>
             </a:extLst>
           </p:cNvPr>
@@ -2117,7 +2117,7 @@
           <p:cNvPr id="4" name="Marcador de número de diapositiva 3">
             <a:extLst>
               <a:ext uri="{FF2B5EF4-FFF2-40B4-BE49-F238E27FC236}">
-                <a16:creationId xmlns:a16="http://schemas.microsoft.com/office/drawing/2014/main" id="{1CD94074-9280-3579-4C1D-855C59DC39FA}"/>
+                <a16:creationId xmlns:a16="http://schemas.microsoft.com/office/drawing/2014/main" id="{EC46CCFC-C651-193F-028A-BAFA9435E3EC}"/>
               </a:ext>
             </a:extLst>
           </p:cNvPr>
@@ -2133,7 +2133,7 @@
           <a:bodyPr/>
           <a:lstStyle/>
           <a:p>
-            <a:fld id="{AA515A41-34E0-4B8A-BFF5-025DE5A27467}" type="slidenum">
+            <a:fld id="{3E216418-6303-4DF4-80EB-715B8707D44E}" type="slidenum">
               <a:rPr lang="es-ES" smtClean="0"/>
               <a:t>‹Nº›</a:t>
             </a:fld>
@@ -2144,7 +2144,7 @@
     </p:spTree>
     <p:extLst>
       <p:ext uri="{BB962C8B-B14F-4D97-AF65-F5344CB8AC3E}">
-        <p14:creationId xmlns:p14="http://schemas.microsoft.com/office/powerpoint/2010/main" val="1212894350"/>
+        <p14:creationId xmlns:p14="http://schemas.microsoft.com/office/powerpoint/2010/main" val="178298420"/>
       </p:ext>
     </p:extLst>
   </p:cSld>
@@ -2176,7 +2176,7 @@
           <p:cNvPr id="2" name="Título 1">
             <a:extLst>
               <a:ext uri="{FF2B5EF4-FFF2-40B4-BE49-F238E27FC236}">
-                <a16:creationId xmlns:a16="http://schemas.microsoft.com/office/drawing/2014/main" id="{D58CEA0C-21DD-F6F8-8819-BE70E8156DD5}"/>
+                <a16:creationId xmlns:a16="http://schemas.microsoft.com/office/drawing/2014/main" id="{46B4FA0B-48DB-7AC2-4C1B-451D82DDC18D}"/>
               </a:ext>
             </a:extLst>
           </p:cNvPr>
@@ -2213,7 +2213,7 @@
           <p:cNvPr id="3" name="Marcador de contenido 2">
             <a:extLst>
               <a:ext uri="{FF2B5EF4-FFF2-40B4-BE49-F238E27FC236}">
-                <a16:creationId xmlns:a16="http://schemas.microsoft.com/office/drawing/2014/main" id="{975D4CDC-5E20-6184-0817-E4D1431B23DC}"/>
+                <a16:creationId xmlns:a16="http://schemas.microsoft.com/office/drawing/2014/main" id="{B30A71B3-C987-79F9-8923-060AB45BD232}"/>
               </a:ext>
             </a:extLst>
           </p:cNvPr>
@@ -2303,7 +2303,7 @@
           <p:cNvPr id="4" name="Marcador de texto 3">
             <a:extLst>
               <a:ext uri="{FF2B5EF4-FFF2-40B4-BE49-F238E27FC236}">
-                <a16:creationId xmlns:a16="http://schemas.microsoft.com/office/drawing/2014/main" id="{9026DAA0-0D63-F341-DAB4-1363FC8700DD}"/>
+                <a16:creationId xmlns:a16="http://schemas.microsoft.com/office/drawing/2014/main" id="{5639A1A8-196E-F16B-A24F-D58EAD9507A7}"/>
               </a:ext>
             </a:extLst>
           </p:cNvPr>
@@ -2374,7 +2374,7 @@
           <p:cNvPr id="5" name="Marcador de fecha 4">
             <a:extLst>
               <a:ext uri="{FF2B5EF4-FFF2-40B4-BE49-F238E27FC236}">
-                <a16:creationId xmlns:a16="http://schemas.microsoft.com/office/drawing/2014/main" id="{85516AEC-CDDC-1B47-9445-739BD483DD5A}"/>
+                <a16:creationId xmlns:a16="http://schemas.microsoft.com/office/drawing/2014/main" id="{DD572331-9D4E-4D29-9B46-71E48925D5F2}"/>
               </a:ext>
             </a:extLst>
           </p:cNvPr>
@@ -2390,9 +2390,9 @@
           <a:bodyPr/>
           <a:lstStyle/>
           <a:p>
-            <a:fld id="{7DF9D857-2BC1-4ECA-A48E-C0419EF44063}" type="datetimeFigureOut">
+            <a:fld id="{3594F67B-593D-4384-8F95-2FBEEBEEB27A}" type="datetimeFigureOut">
               <a:rPr lang="es-ES" smtClean="0"/>
-              <a:t>27/05/2026</a:t>
+              <a:t>01/06/2026</a:t>
             </a:fld>
             <a:endParaRPr lang="es-ES"/>
           </a:p>
@@ -2403,7 +2403,7 @@
           <p:cNvPr id="6" name="Marcador de pie de página 5">
             <a:extLst>
               <a:ext uri="{FF2B5EF4-FFF2-40B4-BE49-F238E27FC236}">
-                <a16:creationId xmlns:a16="http://schemas.microsoft.com/office/drawing/2014/main" id="{0F08CD5C-5F2F-DC4C-A211-1DC6C7EBEC23}"/>
+                <a16:creationId xmlns:a16="http://schemas.microsoft.com/office/drawing/2014/main" id="{A7826676-BF9C-EB38-DE94-C20CC5929740}"/>
               </a:ext>
             </a:extLst>
           </p:cNvPr>
@@ -2428,7 +2428,7 @@
           <p:cNvPr id="7" name="Marcador de número de diapositiva 6">
             <a:extLst>
               <a:ext uri="{FF2B5EF4-FFF2-40B4-BE49-F238E27FC236}">
-                <a16:creationId xmlns:a16="http://schemas.microsoft.com/office/drawing/2014/main" id="{A63278E3-E554-B691-9150-EBD0E07AAEB0}"/>
+                <a16:creationId xmlns:a16="http://schemas.microsoft.com/office/drawing/2014/main" id="{7882BAF8-87D6-7467-E7CA-FBCF4CA7AD23}"/>
               </a:ext>
             </a:extLst>
           </p:cNvPr>
@@ -2444,7 +2444,7 @@
           <a:bodyPr/>
           <a:lstStyle/>
           <a:p>
-            <a:fld id="{AA515A41-34E0-4B8A-BFF5-025DE5A27467}" type="slidenum">
+            <a:fld id="{3E216418-6303-4DF4-80EB-715B8707D44E}" type="slidenum">
               <a:rPr lang="es-ES" smtClean="0"/>
               <a:t>‹Nº›</a:t>
             </a:fld>
@@ -2455,7 +2455,7 @@
     </p:spTree>
     <p:extLst>
       <p:ext uri="{BB962C8B-B14F-4D97-AF65-F5344CB8AC3E}">
-        <p14:creationId xmlns:p14="http://schemas.microsoft.com/office/powerpoint/2010/main" val="1711597664"/>
+        <p14:creationId xmlns:p14="http://schemas.microsoft.com/office/powerpoint/2010/main" val="1200091560"/>
       </p:ext>
     </p:extLst>
   </p:cSld>
@@ -2487,7 +2487,7 @@
           <p:cNvPr id="2" name="Título 1">
             <a:extLst>
               <a:ext uri="{FF2B5EF4-FFF2-40B4-BE49-F238E27FC236}">
-                <a16:creationId xmlns:a16="http://schemas.microsoft.com/office/drawing/2014/main" id="{5173EBA9-B5DD-C451-9DAC-E0671C51718C}"/>
+                <a16:creationId xmlns:a16="http://schemas.microsoft.com/office/drawing/2014/main" id="{8B12B5EA-75CA-BB8B-3D35-87E0DAC7E396}"/>
               </a:ext>
             </a:extLst>
           </p:cNvPr>
@@ -2524,7 +2524,7 @@
           <p:cNvPr id="3" name="Marcador de posición de imagen 2">
             <a:extLst>
               <a:ext uri="{FF2B5EF4-FFF2-40B4-BE49-F238E27FC236}">
-                <a16:creationId xmlns:a16="http://schemas.microsoft.com/office/drawing/2014/main" id="{075FE7A7-3579-29CB-6626-32B86D7CD458}"/>
+                <a16:creationId xmlns:a16="http://schemas.microsoft.com/office/drawing/2014/main" id="{B8677383-2743-A849-F31D-A3D47B8A604A}"/>
               </a:ext>
             </a:extLst>
           </p:cNvPr>
@@ -2591,7 +2591,7 @@
           <p:cNvPr id="4" name="Marcador de texto 3">
             <a:extLst>
               <a:ext uri="{FF2B5EF4-FFF2-40B4-BE49-F238E27FC236}">
-                <a16:creationId xmlns:a16="http://schemas.microsoft.com/office/drawing/2014/main" id="{FFDC52D3-3B9E-D021-B186-A7D215CF68BC}"/>
+                <a16:creationId xmlns:a16="http://schemas.microsoft.com/office/drawing/2014/main" id="{18AAFB2E-6E91-D04B-87CA-4CAFEA47CAC4}"/>
               </a:ext>
             </a:extLst>
           </p:cNvPr>
@@ -2662,7 +2662,7 @@
           <p:cNvPr id="5" name="Marcador de fecha 4">
             <a:extLst>
               <a:ext uri="{FF2B5EF4-FFF2-40B4-BE49-F238E27FC236}">
-                <a16:creationId xmlns:a16="http://schemas.microsoft.com/office/drawing/2014/main" id="{7ADF918E-3472-BC36-6C7A-61CD37CA4365}"/>
+                <a16:creationId xmlns:a16="http://schemas.microsoft.com/office/drawing/2014/main" id="{9BD97579-AD36-B586-2CD4-1DFB26382106}"/>
               </a:ext>
             </a:extLst>
           </p:cNvPr>
@@ -2678,9 +2678,9 @@
           <a:bodyPr/>
           <a:lstStyle/>
           <a:p>
-            <a:fld id="{7DF9D857-2BC1-4ECA-A48E-C0419EF44063}" type="datetimeFigureOut">
+            <a:fld id="{3594F67B-593D-4384-8F95-2FBEEBEEB27A}" type="datetimeFigureOut">
               <a:rPr lang="es-ES" smtClean="0"/>
-              <a:t>27/05/2026</a:t>
+              <a:t>01/06/2026</a:t>
             </a:fld>
             <a:endParaRPr lang="es-ES"/>
           </a:p>
@@ -2691,7 +2691,7 @@
           <p:cNvPr id="6" name="Marcador de pie de página 5">
             <a:extLst>
               <a:ext uri="{FF2B5EF4-FFF2-40B4-BE49-F238E27FC236}">
-                <a16:creationId xmlns:a16="http://schemas.microsoft.com/office/drawing/2014/main" id="{F4D56AFF-FE8D-2F54-334E-0D5B0BE2285D}"/>
+                <a16:creationId xmlns:a16="http://schemas.microsoft.com/office/drawing/2014/main" id="{3AA44D61-788E-A726-58E2-54F3A8AA79F6}"/>
               </a:ext>
             </a:extLst>
           </p:cNvPr>
@@ -2716,7 +2716,7 @@
           <p:cNvPr id="7" name="Marcador de número de diapositiva 6">
             <a:extLst>
               <a:ext uri="{FF2B5EF4-FFF2-40B4-BE49-F238E27FC236}">
-                <a16:creationId xmlns:a16="http://schemas.microsoft.com/office/drawing/2014/main" id="{FF2B3460-EE14-4FAE-4406-AE566619A3C8}"/>
+                <a16:creationId xmlns:a16="http://schemas.microsoft.com/office/drawing/2014/main" id="{C69683E1-C1B3-49D0-1914-E51C26683BB7}"/>
               </a:ext>
             </a:extLst>
           </p:cNvPr>
@@ -2732,7 +2732,7 @@
           <a:bodyPr/>
           <a:lstStyle/>
           <a:p>
-            <a:fld id="{AA515A41-34E0-4B8A-BFF5-025DE5A27467}" type="slidenum">
+            <a:fld id="{3E216418-6303-4DF4-80EB-715B8707D44E}" type="slidenum">
               <a:rPr lang="es-ES" smtClean="0"/>
               <a:t>‹Nº›</a:t>
             </a:fld>
@@ -2743,7 +2743,7 @@
     </p:spTree>
     <p:extLst>
       <p:ext uri="{BB962C8B-B14F-4D97-AF65-F5344CB8AC3E}">
-        <p14:creationId xmlns:p14="http://schemas.microsoft.com/office/powerpoint/2010/main" val="1685687157"/>
+        <p14:creationId xmlns:p14="http://schemas.microsoft.com/office/powerpoint/2010/main" val="1442130320"/>
       </p:ext>
     </p:extLst>
   </p:cSld>
@@ -2780,7 +2780,7 @@
           <p:cNvPr id="2" name="Marcador de título 1">
             <a:extLst>
               <a:ext uri="{FF2B5EF4-FFF2-40B4-BE49-F238E27FC236}">
-                <a16:creationId xmlns:a16="http://schemas.microsoft.com/office/drawing/2014/main" id="{1F4A310F-44E4-321F-FA92-1D7F528B3A33}"/>
+                <a16:creationId xmlns:a16="http://schemas.microsoft.com/office/drawing/2014/main" id="{6187FEB4-0BB9-E195-F732-8C7ABE7BF6F0}"/>
               </a:ext>
             </a:extLst>
           </p:cNvPr>
@@ -2818,7 +2818,7 @@
           <p:cNvPr id="3" name="Marcador de texto 2">
             <a:extLst>
               <a:ext uri="{FF2B5EF4-FFF2-40B4-BE49-F238E27FC236}">
-                <a16:creationId xmlns:a16="http://schemas.microsoft.com/office/drawing/2014/main" id="{44C6DACB-4F5D-7A99-4C6D-90BEAD91EF84}"/>
+                <a16:creationId xmlns:a16="http://schemas.microsoft.com/office/drawing/2014/main" id="{9D0936A3-8B0F-0B92-C1B9-28709DF67DD5}"/>
               </a:ext>
             </a:extLst>
           </p:cNvPr>
@@ -2885,7 +2885,7 @@
           <p:cNvPr id="4" name="Marcador de fecha 3">
             <a:extLst>
               <a:ext uri="{FF2B5EF4-FFF2-40B4-BE49-F238E27FC236}">
-                <a16:creationId xmlns:a16="http://schemas.microsoft.com/office/drawing/2014/main" id="{1EE25504-6BDA-1385-EAB0-0848FA6168AE}"/>
+                <a16:creationId xmlns:a16="http://schemas.microsoft.com/office/drawing/2014/main" id="{16135521-3597-C0E8-C2D2-08D76DF2FA08}"/>
               </a:ext>
             </a:extLst>
           </p:cNvPr>
@@ -2919,9 +2919,9 @@
             </a:lvl1pPr>
           </a:lstStyle>
           <a:p>
-            <a:fld id="{7DF9D857-2BC1-4ECA-A48E-C0419EF44063}" type="datetimeFigureOut">
+            <a:fld id="{3594F67B-593D-4384-8F95-2FBEEBEEB27A}" type="datetimeFigureOut">
               <a:rPr lang="es-ES" smtClean="0"/>
-              <a:t>27/05/2026</a:t>
+              <a:t>01/06/2026</a:t>
             </a:fld>
             <a:endParaRPr lang="es-ES"/>
           </a:p>
@@ -2932,7 +2932,7 @@
           <p:cNvPr id="5" name="Marcador de pie de página 4">
             <a:extLst>
               <a:ext uri="{FF2B5EF4-FFF2-40B4-BE49-F238E27FC236}">
-                <a16:creationId xmlns:a16="http://schemas.microsoft.com/office/drawing/2014/main" id="{AF456258-1A26-2EB6-2580-AEFB2B83FC43}"/>
+                <a16:creationId xmlns:a16="http://schemas.microsoft.com/office/drawing/2014/main" id="{7AF63953-D0FE-0737-3EB9-0ECEC8641ABD}"/>
               </a:ext>
             </a:extLst>
           </p:cNvPr>
@@ -2975,7 +2975,7 @@
           <p:cNvPr id="6" name="Marcador de número de diapositiva 5">
             <a:extLst>
               <a:ext uri="{FF2B5EF4-FFF2-40B4-BE49-F238E27FC236}">
-                <a16:creationId xmlns:a16="http://schemas.microsoft.com/office/drawing/2014/main" id="{5AB82232-6D7E-9E91-8165-3E10466B2909}"/>
+                <a16:creationId xmlns:a16="http://schemas.microsoft.com/office/drawing/2014/main" id="{5DDB0455-9A68-BF0F-C35E-57904400E01A}"/>
               </a:ext>
             </a:extLst>
           </p:cNvPr>
@@ -3009,7 +3009,7 @@
             </a:lvl1pPr>
           </a:lstStyle>
           <a:p>
-            <a:fld id="{AA515A41-34E0-4B8A-BFF5-025DE5A27467}" type="slidenum">
+            <a:fld id="{3E216418-6303-4DF4-80EB-715B8707D44E}" type="slidenum">
               <a:rPr lang="es-ES" smtClean="0"/>
               <a:t>‹Nº›</a:t>
             </a:fld>
@@ -3020,7 +3020,7 @@
     </p:spTree>
     <p:extLst>
       <p:ext uri="{BB962C8B-B14F-4D97-AF65-F5344CB8AC3E}">
-        <p14:creationId xmlns:p14="http://schemas.microsoft.com/office/powerpoint/2010/main" val="534919433"/>
+        <p14:creationId xmlns:p14="http://schemas.microsoft.com/office/powerpoint/2010/main" val="3720018694"/>
       </p:ext>
     </p:extLst>
   </p:cSld>
@@ -3351,7 +3351,7 @@
           <p:cNvPr id="2" name="Rectángulo: esquinas redondeadas 1">
             <a:extLst>
               <a:ext uri="{FF2B5EF4-FFF2-40B4-BE49-F238E27FC236}">
-                <a16:creationId xmlns:a16="http://schemas.microsoft.com/office/drawing/2014/main" id="{5C21021A-731D-BD7C-8102-3890FC965641}"/>
+                <a16:creationId xmlns:a16="http://schemas.microsoft.com/office/drawing/2014/main" id="{913392A5-DAD7-00CE-8C62-AF4441EFB2B1}"/>
               </a:ext>
             </a:extLst>
           </p:cNvPr>
@@ -3405,7 +3405,7 @@
           <p:cNvPr id="3" name="CuadroTexto 2">
             <a:extLst>
               <a:ext uri="{FF2B5EF4-FFF2-40B4-BE49-F238E27FC236}">
-                <a16:creationId xmlns:a16="http://schemas.microsoft.com/office/drawing/2014/main" id="{B53EB162-B404-27F8-366A-9668BE3F0E0B}"/>
+                <a16:creationId xmlns:a16="http://schemas.microsoft.com/office/drawing/2014/main" id="{FC6E0A4B-BC99-08BD-5903-28A0EAD657EB}"/>
               </a:ext>
             </a:extLst>
           </p:cNvPr>
@@ -3445,7 +3445,7 @@
           <p:cNvPr id="4" name="CuadroTexto 3">
             <a:extLst>
               <a:ext uri="{FF2B5EF4-FFF2-40B4-BE49-F238E27FC236}">
-                <a16:creationId xmlns:a16="http://schemas.microsoft.com/office/drawing/2014/main" id="{39048014-6286-8C34-EB02-8F37C4F05425}"/>
+                <a16:creationId xmlns:a16="http://schemas.microsoft.com/office/drawing/2014/main" id="{4CB2720E-52A3-DF62-9339-FF6F64BCCA76}"/>
               </a:ext>
             </a:extLst>
           </p:cNvPr>
@@ -3485,7 +3485,7 @@
           <p:cNvPr id="5" name="CuadroTexto 4">
             <a:extLst>
               <a:ext uri="{FF2B5EF4-FFF2-40B4-BE49-F238E27FC236}">
-                <a16:creationId xmlns:a16="http://schemas.microsoft.com/office/drawing/2014/main" id="{EA0EFDAC-DB66-0A51-CCDA-ABD4BB8BBA11}"/>
+                <a16:creationId xmlns:a16="http://schemas.microsoft.com/office/drawing/2014/main" id="{3B9648D0-46DE-E745-F09E-08DC587B28FF}"/>
               </a:ext>
             </a:extLst>
           </p:cNvPr>
@@ -3525,7 +3525,7 @@
           <p:cNvPr id="6" name="CuadroTexto 5">
             <a:extLst>
               <a:ext uri="{FF2B5EF4-FFF2-40B4-BE49-F238E27FC236}">
-                <a16:creationId xmlns:a16="http://schemas.microsoft.com/office/drawing/2014/main" id="{6DF1A827-FF03-4481-F1DD-A3D36674FD4B}"/>
+                <a16:creationId xmlns:a16="http://schemas.microsoft.com/office/drawing/2014/main" id="{54D9DBF7-DC5D-337C-2E1B-DDA58DCDCDCC}"/>
               </a:ext>
             </a:extLst>
           </p:cNvPr>
@@ -3576,7 +3576,7 @@
           <p:cNvPr id="8" name="Imagen 7">
             <a:extLst>
               <a:ext uri="{FF2B5EF4-FFF2-40B4-BE49-F238E27FC236}">
-                <a16:creationId xmlns:a16="http://schemas.microsoft.com/office/drawing/2014/main" id="{CCDA0E7A-E6D7-1D80-8DFB-CC867396DDB2}"/>
+                <a16:creationId xmlns:a16="http://schemas.microsoft.com/office/drawing/2014/main" id="{8B41F678-91DD-15AE-8E90-19E5CC51A651}"/>
               </a:ext>
             </a:extLst>
           </p:cNvPr>
@@ -3615,7 +3615,7 @@
     </p:spTree>
     <p:extLst>
       <p:ext uri="{BB962C8B-B14F-4D97-AF65-F5344CB8AC3E}">
-        <p14:creationId xmlns:p14="http://schemas.microsoft.com/office/powerpoint/2010/main" val="2577456464"/>
+        <p14:creationId xmlns:p14="http://schemas.microsoft.com/office/powerpoint/2010/main" val="1107875203"/>
       </p:ext>
     </p:extLst>
   </p:cSld>
@@ -3655,7 +3655,7 @@
           <p:cNvPr id="2" name="CuadroTexto 1">
             <a:extLst>
               <a:ext uri="{FF2B5EF4-FFF2-40B4-BE49-F238E27FC236}">
-                <a16:creationId xmlns:a16="http://schemas.microsoft.com/office/drawing/2014/main" id="{2DAFACFB-80D7-5FD8-2363-C08A84230F60}"/>
+                <a16:creationId xmlns:a16="http://schemas.microsoft.com/office/drawing/2014/main" id="{BFF9A577-7809-B456-65E0-B104694C7008}"/>
               </a:ext>
             </a:extLst>
           </p:cNvPr>
@@ -3695,7 +3695,7 @@
           <p:cNvPr id="3" name="CuadroTexto 2">
             <a:extLst>
               <a:ext uri="{FF2B5EF4-FFF2-40B4-BE49-F238E27FC236}">
-                <a16:creationId xmlns:a16="http://schemas.microsoft.com/office/drawing/2014/main" id="{2BE4E9F7-7ADD-BB4E-C2CF-68611E371028}"/>
+                <a16:creationId xmlns:a16="http://schemas.microsoft.com/office/drawing/2014/main" id="{2CF00E4E-FC2B-4518-60EE-FB842C64E533}"/>
               </a:ext>
             </a:extLst>
           </p:cNvPr>
@@ -3735,7 +3735,7 @@
           <p:cNvPr id="4" name="CuadroTexto 3">
             <a:extLst>
               <a:ext uri="{FF2B5EF4-FFF2-40B4-BE49-F238E27FC236}">
-                <a16:creationId xmlns:a16="http://schemas.microsoft.com/office/drawing/2014/main" id="{ADECF87B-9681-5FC8-B46E-90823A3D70E6}"/>
+                <a16:creationId xmlns:a16="http://schemas.microsoft.com/office/drawing/2014/main" id="{FFEA32CE-CBDF-069C-11D0-844AA579B72F}"/>
               </a:ext>
             </a:extLst>
           </p:cNvPr>
@@ -3775,7 +3775,7 @@
           <p:cNvPr id="5" name="Rectángulo: esquinas redondeadas 4">
             <a:extLst>
               <a:ext uri="{FF2B5EF4-FFF2-40B4-BE49-F238E27FC236}">
-                <a16:creationId xmlns:a16="http://schemas.microsoft.com/office/drawing/2014/main" id="{6D1AEA64-2F0E-FD31-1E48-81AA0EE5224C}"/>
+                <a16:creationId xmlns:a16="http://schemas.microsoft.com/office/drawing/2014/main" id="{E49EC66D-0653-1C7C-EB5F-EB891CC09A9C}"/>
               </a:ext>
             </a:extLst>
           </p:cNvPr>
@@ -3829,7 +3829,7 @@
           <p:cNvPr id="6" name="CuadroTexto 5">
             <a:extLst>
               <a:ext uri="{FF2B5EF4-FFF2-40B4-BE49-F238E27FC236}">
-                <a16:creationId xmlns:a16="http://schemas.microsoft.com/office/drawing/2014/main" id="{CF410CEA-58BF-683F-FA42-462212E14AAD}"/>
+                <a16:creationId xmlns:a16="http://schemas.microsoft.com/office/drawing/2014/main" id="{F9136EFE-6083-A01B-38C9-54B0B36745A1}"/>
               </a:ext>
             </a:extLst>
           </p:cNvPr>
@@ -3869,7 +3869,7 @@
           <p:cNvPr id="7" name="CuadroTexto 6">
             <a:extLst>
               <a:ext uri="{FF2B5EF4-FFF2-40B4-BE49-F238E27FC236}">
-                <a16:creationId xmlns:a16="http://schemas.microsoft.com/office/drawing/2014/main" id="{58372610-7914-4758-2055-CF56C828BEEE}"/>
+                <a16:creationId xmlns:a16="http://schemas.microsoft.com/office/drawing/2014/main" id="{91E1F0B5-27C6-4230-A446-ED009B09D268}"/>
               </a:ext>
             </a:extLst>
           </p:cNvPr>
@@ -3988,7 +3988,7 @@
           <p:cNvPr id="8" name="Rectángulo: esquinas redondeadas 7">
             <a:extLst>
               <a:ext uri="{FF2B5EF4-FFF2-40B4-BE49-F238E27FC236}">
-                <a16:creationId xmlns:a16="http://schemas.microsoft.com/office/drawing/2014/main" id="{5833D4F6-6461-6404-5CC8-A8AF549C4DF2}"/>
+                <a16:creationId xmlns:a16="http://schemas.microsoft.com/office/drawing/2014/main" id="{673AD033-FB67-0DAF-DBC4-D7A50B83F597}"/>
               </a:ext>
             </a:extLst>
           </p:cNvPr>
@@ -4042,7 +4042,7 @@
           <p:cNvPr id="9" name="CuadroTexto 8">
             <a:extLst>
               <a:ext uri="{FF2B5EF4-FFF2-40B4-BE49-F238E27FC236}">
-                <a16:creationId xmlns:a16="http://schemas.microsoft.com/office/drawing/2014/main" id="{B86E8B70-9A97-A59B-3BF2-43F7B273C367}"/>
+                <a16:creationId xmlns:a16="http://schemas.microsoft.com/office/drawing/2014/main" id="{8CE381C0-EE38-B7EC-66F4-A762995AEE76}"/>
               </a:ext>
             </a:extLst>
           </p:cNvPr>
@@ -4082,7 +4082,7 @@
           <p:cNvPr id="10" name="CuadroTexto 9">
             <a:extLst>
               <a:ext uri="{FF2B5EF4-FFF2-40B4-BE49-F238E27FC236}">
-                <a16:creationId xmlns:a16="http://schemas.microsoft.com/office/drawing/2014/main" id="{836AD5C9-DA30-BD9E-D349-51EFD08D301A}"/>
+                <a16:creationId xmlns:a16="http://schemas.microsoft.com/office/drawing/2014/main" id="{D566BCAC-1BB9-B767-AB27-5C6DFFEB671D}"/>
               </a:ext>
             </a:extLst>
           </p:cNvPr>
@@ -4122,7 +4122,7 @@
           <p:cNvPr id="11" name="Rectángulo: esquinas redondeadas 10">
             <a:extLst>
               <a:ext uri="{FF2B5EF4-FFF2-40B4-BE49-F238E27FC236}">
-                <a16:creationId xmlns:a16="http://schemas.microsoft.com/office/drawing/2014/main" id="{B6486B53-C0B3-3CEC-50CD-AD6DFDCD8DB7}"/>
+                <a16:creationId xmlns:a16="http://schemas.microsoft.com/office/drawing/2014/main" id="{4349613C-8BA6-B55E-01A1-EEE7D4944CA9}"/>
               </a:ext>
             </a:extLst>
           </p:cNvPr>
@@ -4176,7 +4176,7 @@
           <p:cNvPr id="12" name="CuadroTexto 11">
             <a:extLst>
               <a:ext uri="{FF2B5EF4-FFF2-40B4-BE49-F238E27FC236}">
-                <a16:creationId xmlns:a16="http://schemas.microsoft.com/office/drawing/2014/main" id="{B9E83C5C-D7AA-0B77-A468-718A426FADC8}"/>
+                <a16:creationId xmlns:a16="http://schemas.microsoft.com/office/drawing/2014/main" id="{1D755BB5-B2B8-7C57-F3E2-B3BE437D1F66}"/>
               </a:ext>
             </a:extLst>
           </p:cNvPr>
@@ -4216,7 +4216,7 @@
           <p:cNvPr id="13" name="CuadroTexto 12">
             <a:extLst>
               <a:ext uri="{FF2B5EF4-FFF2-40B4-BE49-F238E27FC236}">
-                <a16:creationId xmlns:a16="http://schemas.microsoft.com/office/drawing/2014/main" id="{1330EEA6-2376-81FB-AE65-3B8744BB9603}"/>
+                <a16:creationId xmlns:a16="http://schemas.microsoft.com/office/drawing/2014/main" id="{9E62A85F-BAA2-4BD7-E8B2-6464E3C2CDB9}"/>
               </a:ext>
             </a:extLst>
           </p:cNvPr>
@@ -4256,7 +4256,7 @@
           <p:cNvPr id="14" name="Rectángulo: esquinas redondeadas 13">
             <a:extLst>
               <a:ext uri="{FF2B5EF4-FFF2-40B4-BE49-F238E27FC236}">
-                <a16:creationId xmlns:a16="http://schemas.microsoft.com/office/drawing/2014/main" id="{1FDF2267-131A-C751-687C-166852FF3B52}"/>
+                <a16:creationId xmlns:a16="http://schemas.microsoft.com/office/drawing/2014/main" id="{73E41BDF-47AA-07DD-B88A-F74F4869CF9E}"/>
               </a:ext>
             </a:extLst>
           </p:cNvPr>
@@ -4310,7 +4310,7 @@
           <p:cNvPr id="15" name="CuadroTexto 14">
             <a:extLst>
               <a:ext uri="{FF2B5EF4-FFF2-40B4-BE49-F238E27FC236}">
-                <a16:creationId xmlns:a16="http://schemas.microsoft.com/office/drawing/2014/main" id="{CCB386C5-F39C-3FC0-0F45-51A2612BCF1B}"/>
+                <a16:creationId xmlns:a16="http://schemas.microsoft.com/office/drawing/2014/main" id="{9ABED569-C0E5-4D0F-6C8C-7D13D8419892}"/>
               </a:ext>
             </a:extLst>
           </p:cNvPr>
@@ -4350,7 +4350,7 @@
           <p:cNvPr id="16" name="CuadroTexto 15">
             <a:extLst>
               <a:ext uri="{FF2B5EF4-FFF2-40B4-BE49-F238E27FC236}">
-                <a16:creationId xmlns:a16="http://schemas.microsoft.com/office/drawing/2014/main" id="{72DDCB08-4518-EB21-7ACD-F5FDF90651E0}"/>
+                <a16:creationId xmlns:a16="http://schemas.microsoft.com/office/drawing/2014/main" id="{F6F4A994-C60B-6D2B-0E76-769FF49CFE3D}"/>
               </a:ext>
             </a:extLst>
           </p:cNvPr>
@@ -4390,7 +4390,7 @@
           <p:cNvPr id="17" name="Rectángulo: esquinas redondeadas 16">
             <a:extLst>
               <a:ext uri="{FF2B5EF4-FFF2-40B4-BE49-F238E27FC236}">
-                <a16:creationId xmlns:a16="http://schemas.microsoft.com/office/drawing/2014/main" id="{A320F2B7-174C-1027-38D7-ECFF71D80656}"/>
+                <a16:creationId xmlns:a16="http://schemas.microsoft.com/office/drawing/2014/main" id="{A3D26979-58BF-5A44-A620-D64E00B337E7}"/>
               </a:ext>
             </a:extLst>
           </p:cNvPr>
@@ -4444,7 +4444,7 @@
           <p:cNvPr id="18" name="CuadroTexto 17">
             <a:extLst>
               <a:ext uri="{FF2B5EF4-FFF2-40B4-BE49-F238E27FC236}">
-                <a16:creationId xmlns:a16="http://schemas.microsoft.com/office/drawing/2014/main" id="{FB53001C-A200-2209-3614-1259FBB90E1D}"/>
+                <a16:creationId xmlns:a16="http://schemas.microsoft.com/office/drawing/2014/main" id="{7F1D49D1-E5E0-BD98-D4F3-A13793C5CD0F}"/>
               </a:ext>
             </a:extLst>
           </p:cNvPr>
@@ -4484,7 +4484,7 @@
           <p:cNvPr id="19" name="CuadroTexto 18">
             <a:extLst>
               <a:ext uri="{FF2B5EF4-FFF2-40B4-BE49-F238E27FC236}">
-                <a16:creationId xmlns:a16="http://schemas.microsoft.com/office/drawing/2014/main" id="{B71A4644-3886-B7F2-8B3F-ADB935E517C2}"/>
+                <a16:creationId xmlns:a16="http://schemas.microsoft.com/office/drawing/2014/main" id="{077457B9-C6DC-795E-656F-39386501D72D}"/>
               </a:ext>
             </a:extLst>
           </p:cNvPr>
@@ -4522,7 +4522,7 @@
     </p:spTree>
     <p:extLst>
       <p:ext uri="{BB962C8B-B14F-4D97-AF65-F5344CB8AC3E}">
-        <p14:creationId xmlns:p14="http://schemas.microsoft.com/office/powerpoint/2010/main" val="3510644319"/>
+        <p14:creationId xmlns:p14="http://schemas.microsoft.com/office/powerpoint/2010/main" val="2538126929"/>
       </p:ext>
     </p:extLst>
   </p:cSld>
@@ -4562,7 +4562,7 @@
           <p:cNvPr id="2" name="CuadroTexto 1">
             <a:extLst>
               <a:ext uri="{FF2B5EF4-FFF2-40B4-BE49-F238E27FC236}">
-                <a16:creationId xmlns:a16="http://schemas.microsoft.com/office/drawing/2014/main" id="{7CEEDE5F-50BB-0917-399B-C8FB6165E00C}"/>
+                <a16:creationId xmlns:a16="http://schemas.microsoft.com/office/drawing/2014/main" id="{ED56A351-B102-5B4D-A383-DF5B3A3BE314}"/>
               </a:ext>
             </a:extLst>
           </p:cNvPr>
@@ -4602,7 +4602,7 @@
           <p:cNvPr id="3" name="CuadroTexto 2">
             <a:extLst>
               <a:ext uri="{FF2B5EF4-FFF2-40B4-BE49-F238E27FC236}">
-                <a16:creationId xmlns:a16="http://schemas.microsoft.com/office/drawing/2014/main" id="{23804E9C-6A0D-07F4-AB1E-A3F992B98FA4}"/>
+                <a16:creationId xmlns:a16="http://schemas.microsoft.com/office/drawing/2014/main" id="{2670CB2E-8F4D-116B-70E6-9C0C066832CC}"/>
               </a:ext>
             </a:extLst>
           </p:cNvPr>
@@ -4642,7 +4642,7 @@
           <p:cNvPr id="4" name="CuadroTexto 3">
             <a:extLst>
               <a:ext uri="{FF2B5EF4-FFF2-40B4-BE49-F238E27FC236}">
-                <a16:creationId xmlns:a16="http://schemas.microsoft.com/office/drawing/2014/main" id="{E9394BCA-BA92-1008-BE68-D26ED27277C6}"/>
+                <a16:creationId xmlns:a16="http://schemas.microsoft.com/office/drawing/2014/main" id="{DA09D5B3-3B80-63BC-4B3F-B6122F33107A}"/>
               </a:ext>
             </a:extLst>
           </p:cNvPr>
@@ -4682,7 +4682,7 @@
           <p:cNvPr id="5" name="Rectángulo: esquinas redondeadas 4">
             <a:extLst>
               <a:ext uri="{FF2B5EF4-FFF2-40B4-BE49-F238E27FC236}">
-                <a16:creationId xmlns:a16="http://schemas.microsoft.com/office/drawing/2014/main" id="{0A08D243-A7CA-D48E-592D-D1455304947E}"/>
+                <a16:creationId xmlns:a16="http://schemas.microsoft.com/office/drawing/2014/main" id="{B9A138B7-E719-8DCA-92B9-94B3380E794E}"/>
               </a:ext>
             </a:extLst>
           </p:cNvPr>
@@ -4736,7 +4736,7 @@
           <p:cNvPr id="6" name="CuadroTexto 5">
             <a:extLst>
               <a:ext uri="{FF2B5EF4-FFF2-40B4-BE49-F238E27FC236}">
-                <a16:creationId xmlns:a16="http://schemas.microsoft.com/office/drawing/2014/main" id="{5FC70503-32F7-AB23-6077-DB168DA4F5EE}"/>
+                <a16:creationId xmlns:a16="http://schemas.microsoft.com/office/drawing/2014/main" id="{C73C2268-81FE-ECC0-1CD2-3D72441CFA0C}"/>
               </a:ext>
             </a:extLst>
           </p:cNvPr>
@@ -4776,7 +4776,7 @@
           <p:cNvPr id="7" name="CuadroTexto 6">
             <a:extLst>
               <a:ext uri="{FF2B5EF4-FFF2-40B4-BE49-F238E27FC236}">
-                <a16:creationId xmlns:a16="http://schemas.microsoft.com/office/drawing/2014/main" id="{0A6A47F9-1C47-765B-E66E-F0E29EB720CC}"/>
+                <a16:creationId xmlns:a16="http://schemas.microsoft.com/office/drawing/2014/main" id="{1B5BEF91-F8FF-29D3-58C9-47B8B3BA4396}"/>
               </a:ext>
             </a:extLst>
           </p:cNvPr>
@@ -4816,7 +4816,7 @@
           <p:cNvPr id="8" name="Rectángulo: esquinas redondeadas 7">
             <a:extLst>
               <a:ext uri="{FF2B5EF4-FFF2-40B4-BE49-F238E27FC236}">
-                <a16:creationId xmlns:a16="http://schemas.microsoft.com/office/drawing/2014/main" id="{4E3EC0F7-D648-EAAB-3301-1960AE2E2FA6}"/>
+                <a16:creationId xmlns:a16="http://schemas.microsoft.com/office/drawing/2014/main" id="{8EAE63BD-8508-6082-B985-68EAC8D05A58}"/>
               </a:ext>
             </a:extLst>
           </p:cNvPr>
@@ -4870,7 +4870,7 @@
           <p:cNvPr id="9" name="CuadroTexto 8">
             <a:extLst>
               <a:ext uri="{FF2B5EF4-FFF2-40B4-BE49-F238E27FC236}">
-                <a16:creationId xmlns:a16="http://schemas.microsoft.com/office/drawing/2014/main" id="{C8BF4BF4-695A-D88E-1F0F-1EB784C5D477}"/>
+                <a16:creationId xmlns:a16="http://schemas.microsoft.com/office/drawing/2014/main" id="{46321B82-B264-8C2A-D8F2-A08B52343144}"/>
               </a:ext>
             </a:extLst>
           </p:cNvPr>
@@ -4910,7 +4910,7 @@
           <p:cNvPr id="10" name="CuadroTexto 9">
             <a:extLst>
               <a:ext uri="{FF2B5EF4-FFF2-40B4-BE49-F238E27FC236}">
-                <a16:creationId xmlns:a16="http://schemas.microsoft.com/office/drawing/2014/main" id="{8F00DB8B-7F11-3273-5889-9453992EA05C}"/>
+                <a16:creationId xmlns:a16="http://schemas.microsoft.com/office/drawing/2014/main" id="{EE33E112-80E5-1685-3057-8E9849F6AE39}"/>
               </a:ext>
             </a:extLst>
           </p:cNvPr>
@@ -4950,7 +4950,7 @@
           <p:cNvPr id="11" name="Rectángulo: esquinas redondeadas 10">
             <a:extLst>
               <a:ext uri="{FF2B5EF4-FFF2-40B4-BE49-F238E27FC236}">
-                <a16:creationId xmlns:a16="http://schemas.microsoft.com/office/drawing/2014/main" id="{4711F600-0351-B6A8-7F18-D27788BD4C54}"/>
+                <a16:creationId xmlns:a16="http://schemas.microsoft.com/office/drawing/2014/main" id="{86354808-F438-E51D-16DB-F3443E3F9CC2}"/>
               </a:ext>
             </a:extLst>
           </p:cNvPr>
@@ -5004,7 +5004,7 @@
           <p:cNvPr id="12" name="CuadroTexto 11">
             <a:extLst>
               <a:ext uri="{FF2B5EF4-FFF2-40B4-BE49-F238E27FC236}">
-                <a16:creationId xmlns:a16="http://schemas.microsoft.com/office/drawing/2014/main" id="{A6138A3E-6C95-0782-580B-B7ED3EDDCC21}"/>
+                <a16:creationId xmlns:a16="http://schemas.microsoft.com/office/drawing/2014/main" id="{2DA8EC25-2F26-8D15-BFF5-E4F4A9A6EFA8}"/>
               </a:ext>
             </a:extLst>
           </p:cNvPr>
@@ -5044,7 +5044,7 @@
           <p:cNvPr id="13" name="CuadroTexto 12">
             <a:extLst>
               <a:ext uri="{FF2B5EF4-FFF2-40B4-BE49-F238E27FC236}">
-                <a16:creationId xmlns:a16="http://schemas.microsoft.com/office/drawing/2014/main" id="{5C48DFCA-94A5-8E0A-C947-1CDD1AB1A164}"/>
+                <a16:creationId xmlns:a16="http://schemas.microsoft.com/office/drawing/2014/main" id="{497DB956-BC8F-D0E3-9192-F75F3E0E3313}"/>
               </a:ext>
             </a:extLst>
           </p:cNvPr>
@@ -5084,7 +5084,7 @@
           <p:cNvPr id="14" name="CuadroTexto 13">
             <a:extLst>
               <a:ext uri="{FF2B5EF4-FFF2-40B4-BE49-F238E27FC236}">
-                <a16:creationId xmlns:a16="http://schemas.microsoft.com/office/drawing/2014/main" id="{EE5CC75F-F5EF-31C9-EC42-68947BF0DFDB}"/>
+                <a16:creationId xmlns:a16="http://schemas.microsoft.com/office/drawing/2014/main" id="{C6400640-A15C-E362-2288-AB11C8BE892E}"/>
               </a:ext>
             </a:extLst>
           </p:cNvPr>
@@ -5165,7 +5165,7 @@
     </p:spTree>
     <p:extLst>
       <p:ext uri="{BB962C8B-B14F-4D97-AF65-F5344CB8AC3E}">
-        <p14:creationId xmlns:p14="http://schemas.microsoft.com/office/powerpoint/2010/main" val="2469724980"/>
+        <p14:creationId xmlns:p14="http://schemas.microsoft.com/office/powerpoint/2010/main" val="1063861715"/>
       </p:ext>
     </p:extLst>
   </p:cSld>
@@ -5205,7 +5205,7 @@
           <p:cNvPr id="2" name="CuadroTexto 1">
             <a:extLst>
               <a:ext uri="{FF2B5EF4-FFF2-40B4-BE49-F238E27FC236}">
-                <a16:creationId xmlns:a16="http://schemas.microsoft.com/office/drawing/2014/main" id="{7B7D82D7-B708-D180-EFB4-6C21EF8B331C}"/>
+                <a16:creationId xmlns:a16="http://schemas.microsoft.com/office/drawing/2014/main" id="{6D623C66-C0E9-666B-50D8-442B52D110A7}"/>
               </a:ext>
             </a:extLst>
           </p:cNvPr>
@@ -5245,7 +5245,7 @@
           <p:cNvPr id="3" name="CuadroTexto 2">
             <a:extLst>
               <a:ext uri="{FF2B5EF4-FFF2-40B4-BE49-F238E27FC236}">
-                <a16:creationId xmlns:a16="http://schemas.microsoft.com/office/drawing/2014/main" id="{6FADF928-4261-2380-B043-AEF1226E6AF9}"/>
+                <a16:creationId xmlns:a16="http://schemas.microsoft.com/office/drawing/2014/main" id="{BBC33574-FB23-71CA-1C15-1CCFBBA71A49}"/>
               </a:ext>
             </a:extLst>
           </p:cNvPr>
@@ -5285,7 +5285,7 @@
           <p:cNvPr id="4" name="CuadroTexto 3">
             <a:extLst>
               <a:ext uri="{FF2B5EF4-FFF2-40B4-BE49-F238E27FC236}">
-                <a16:creationId xmlns:a16="http://schemas.microsoft.com/office/drawing/2014/main" id="{C0E91017-F843-F648-311B-F90979922D69}"/>
+                <a16:creationId xmlns:a16="http://schemas.microsoft.com/office/drawing/2014/main" id="{E9408B09-9C32-C084-73F5-F57BA107CFBE}"/>
               </a:ext>
             </a:extLst>
           </p:cNvPr>
@@ -5325,7 +5325,7 @@
           <p:cNvPr id="6" name="Imagen 5">
             <a:extLst>
               <a:ext uri="{FF2B5EF4-FFF2-40B4-BE49-F238E27FC236}">
-                <a16:creationId xmlns:a16="http://schemas.microsoft.com/office/drawing/2014/main" id="{EFCDCC7E-691C-B01A-77BD-D8B6B8C710B0}"/>
+                <a16:creationId xmlns:a16="http://schemas.microsoft.com/office/drawing/2014/main" id="{E85465EB-29AE-3F4E-1B81-FAEE66B1A9AF}"/>
               </a:ext>
             </a:extLst>
           </p:cNvPr>
@@ -5366,7 +5366,7 @@
           <p:cNvPr id="7" name="Rectángulo: esquinas redondeadas 6">
             <a:extLst>
               <a:ext uri="{FF2B5EF4-FFF2-40B4-BE49-F238E27FC236}">
-                <a16:creationId xmlns:a16="http://schemas.microsoft.com/office/drawing/2014/main" id="{353A1019-86EF-FDFC-F858-663ED918FAF0}"/>
+                <a16:creationId xmlns:a16="http://schemas.microsoft.com/office/drawing/2014/main" id="{93990720-3781-3A0B-5DD4-D4484618757A}"/>
               </a:ext>
             </a:extLst>
           </p:cNvPr>
@@ -5420,7 +5420,7 @@
           <p:cNvPr id="8" name="CuadroTexto 7">
             <a:extLst>
               <a:ext uri="{FF2B5EF4-FFF2-40B4-BE49-F238E27FC236}">
-                <a16:creationId xmlns:a16="http://schemas.microsoft.com/office/drawing/2014/main" id="{6CE17BF1-6AD2-F32C-9450-44ACDA473674}"/>
+                <a16:creationId xmlns:a16="http://schemas.microsoft.com/office/drawing/2014/main" id="{93A56DA7-46A1-5FDC-D08B-6288091DAF95}"/>
               </a:ext>
             </a:extLst>
           </p:cNvPr>
@@ -5460,7 +5460,7 @@
           <p:cNvPr id="9" name="CuadroTexto 8">
             <a:extLst>
               <a:ext uri="{FF2B5EF4-FFF2-40B4-BE49-F238E27FC236}">
-                <a16:creationId xmlns:a16="http://schemas.microsoft.com/office/drawing/2014/main" id="{BA4A0975-109E-4A3F-4B54-EFDA114C070B}"/>
+                <a16:creationId xmlns:a16="http://schemas.microsoft.com/office/drawing/2014/main" id="{516CAFB8-7061-34F1-301D-7073284FC6E5}"/>
               </a:ext>
             </a:extLst>
           </p:cNvPr>
@@ -5500,7 +5500,7 @@
           <p:cNvPr id="10" name="CuadroTexto 9">
             <a:extLst>
               <a:ext uri="{FF2B5EF4-FFF2-40B4-BE49-F238E27FC236}">
-                <a16:creationId xmlns:a16="http://schemas.microsoft.com/office/drawing/2014/main" id="{5ABF088D-72A3-3D27-051A-1B4A038ED58F}"/>
+                <a16:creationId xmlns:a16="http://schemas.microsoft.com/office/drawing/2014/main" id="{4D5C3C5A-4CC8-1D18-F06A-F06368F95D48}"/>
               </a:ext>
             </a:extLst>
           </p:cNvPr>
@@ -5599,7 +5599,7 @@
     </p:spTree>
     <p:extLst>
       <p:ext uri="{BB962C8B-B14F-4D97-AF65-F5344CB8AC3E}">
-        <p14:creationId xmlns:p14="http://schemas.microsoft.com/office/powerpoint/2010/main" val="3632644678"/>
+        <p14:creationId xmlns:p14="http://schemas.microsoft.com/office/powerpoint/2010/main" val="2173236996"/>
       </p:ext>
     </p:extLst>
   </p:cSld>
@@ -5639,7 +5639,7 @@
           <p:cNvPr id="2" name="CuadroTexto 1">
             <a:extLst>
               <a:ext uri="{FF2B5EF4-FFF2-40B4-BE49-F238E27FC236}">
-                <a16:creationId xmlns:a16="http://schemas.microsoft.com/office/drawing/2014/main" id="{F6A78540-E163-B045-AC3A-A21791E4B814}"/>
+                <a16:creationId xmlns:a16="http://schemas.microsoft.com/office/drawing/2014/main" id="{87C5D778-627A-D8B9-892C-8DFBFA624FD6}"/>
               </a:ext>
             </a:extLst>
           </p:cNvPr>
@@ -5679,7 +5679,7 @@
           <p:cNvPr id="3" name="CuadroTexto 2">
             <a:extLst>
               <a:ext uri="{FF2B5EF4-FFF2-40B4-BE49-F238E27FC236}">
-                <a16:creationId xmlns:a16="http://schemas.microsoft.com/office/drawing/2014/main" id="{B24BB97B-08C7-2FD3-87D1-4D571DA1EB59}"/>
+                <a16:creationId xmlns:a16="http://schemas.microsoft.com/office/drawing/2014/main" id="{12B2DDDF-55B9-C610-2C1A-020B9355F37C}"/>
               </a:ext>
             </a:extLst>
           </p:cNvPr>
@@ -5719,7 +5719,7 @@
           <p:cNvPr id="4" name="CuadroTexto 3">
             <a:extLst>
               <a:ext uri="{FF2B5EF4-FFF2-40B4-BE49-F238E27FC236}">
-                <a16:creationId xmlns:a16="http://schemas.microsoft.com/office/drawing/2014/main" id="{5515BA48-9782-B0B0-ABA3-86A36CC8BA90}"/>
+                <a16:creationId xmlns:a16="http://schemas.microsoft.com/office/drawing/2014/main" id="{893AB31E-287D-BAAD-3B3E-B5CA52B0C2E7}"/>
               </a:ext>
             </a:extLst>
           </p:cNvPr>
@@ -5759,7 +5759,7 @@
           <p:cNvPr id="6" name="Imagen 5">
             <a:extLst>
               <a:ext uri="{FF2B5EF4-FFF2-40B4-BE49-F238E27FC236}">
-                <a16:creationId xmlns:a16="http://schemas.microsoft.com/office/drawing/2014/main" id="{B1D285CA-55C4-F977-7CF5-70DB4D2C5CA7}"/>
+                <a16:creationId xmlns:a16="http://schemas.microsoft.com/office/drawing/2014/main" id="{03016FCD-FE2A-326C-FC97-3A0EACDFF44A}"/>
               </a:ext>
             </a:extLst>
           </p:cNvPr>
@@ -5800,7 +5800,7 @@
           <p:cNvPr id="7" name="CuadroTexto 6">
             <a:extLst>
               <a:ext uri="{FF2B5EF4-FFF2-40B4-BE49-F238E27FC236}">
-                <a16:creationId xmlns:a16="http://schemas.microsoft.com/office/drawing/2014/main" id="{31E57BAD-3F1E-06EE-E8B0-E17A430D6065}"/>
+                <a16:creationId xmlns:a16="http://schemas.microsoft.com/office/drawing/2014/main" id="{4F1DCC39-6B41-A880-5AC8-72DCCD341F18}"/>
               </a:ext>
             </a:extLst>
           </p:cNvPr>
@@ -5917,7 +5917,7 @@
     </p:spTree>
     <p:extLst>
       <p:ext uri="{BB962C8B-B14F-4D97-AF65-F5344CB8AC3E}">
-        <p14:creationId xmlns:p14="http://schemas.microsoft.com/office/powerpoint/2010/main" val="3572334078"/>
+        <p14:creationId xmlns:p14="http://schemas.microsoft.com/office/powerpoint/2010/main" val="2461408223"/>
       </p:ext>
     </p:extLst>
   </p:cSld>
@@ -5957,7 +5957,7 @@
           <p:cNvPr id="2" name="CuadroTexto 1">
             <a:extLst>
               <a:ext uri="{FF2B5EF4-FFF2-40B4-BE49-F238E27FC236}">
-                <a16:creationId xmlns:a16="http://schemas.microsoft.com/office/drawing/2014/main" id="{15AE60CF-E363-2B77-E838-C415AFE35984}"/>
+                <a16:creationId xmlns:a16="http://schemas.microsoft.com/office/drawing/2014/main" id="{F4BD1C07-8C73-AB07-9157-7A2D8EFA4454}"/>
               </a:ext>
             </a:extLst>
           </p:cNvPr>
@@ -5997,7 +5997,7 @@
           <p:cNvPr id="3" name="CuadroTexto 2">
             <a:extLst>
               <a:ext uri="{FF2B5EF4-FFF2-40B4-BE49-F238E27FC236}">
-                <a16:creationId xmlns:a16="http://schemas.microsoft.com/office/drawing/2014/main" id="{6345F1B8-1C3A-3B10-C5A6-DE1CB265F91C}"/>
+                <a16:creationId xmlns:a16="http://schemas.microsoft.com/office/drawing/2014/main" id="{ED8E57D1-EF7C-A55C-27DE-BA86920BBC9D}"/>
               </a:ext>
             </a:extLst>
           </p:cNvPr>
@@ -6037,7 +6037,7 @@
           <p:cNvPr id="4" name="Rectángulo: esquinas redondeadas 3">
             <a:extLst>
               <a:ext uri="{FF2B5EF4-FFF2-40B4-BE49-F238E27FC236}">
-                <a16:creationId xmlns:a16="http://schemas.microsoft.com/office/drawing/2014/main" id="{D0A90649-836B-F320-C443-410EE1435B1E}"/>
+                <a16:creationId xmlns:a16="http://schemas.microsoft.com/office/drawing/2014/main" id="{1E81567F-652B-E7B7-49A1-134799F305FB}"/>
               </a:ext>
             </a:extLst>
           </p:cNvPr>
@@ -6091,7 +6091,7 @@
           <p:cNvPr id="5" name="CuadroTexto 4">
             <a:extLst>
               <a:ext uri="{FF2B5EF4-FFF2-40B4-BE49-F238E27FC236}">
-                <a16:creationId xmlns:a16="http://schemas.microsoft.com/office/drawing/2014/main" id="{8A32F3C5-F477-675B-904F-367B449B30C3}"/>
+                <a16:creationId xmlns:a16="http://schemas.microsoft.com/office/drawing/2014/main" id="{AAFB9C16-2D81-E590-1201-165E4CE84F1C}"/>
               </a:ext>
             </a:extLst>
           </p:cNvPr>
@@ -6131,7 +6131,7 @@
           <p:cNvPr id="6" name="CuadroTexto 5">
             <a:extLst>
               <a:ext uri="{FF2B5EF4-FFF2-40B4-BE49-F238E27FC236}">
-                <a16:creationId xmlns:a16="http://schemas.microsoft.com/office/drawing/2014/main" id="{E04E598E-D48E-B088-0D0B-9388D2FC5F4A}"/>
+                <a16:creationId xmlns:a16="http://schemas.microsoft.com/office/drawing/2014/main" id="{9E397237-C856-4F07-38B3-5FB0FC870DBB}"/>
               </a:ext>
             </a:extLst>
           </p:cNvPr>
@@ -6171,7 +6171,7 @@
           <p:cNvPr id="7" name="Rectángulo: esquinas redondeadas 6">
             <a:extLst>
               <a:ext uri="{FF2B5EF4-FFF2-40B4-BE49-F238E27FC236}">
-                <a16:creationId xmlns:a16="http://schemas.microsoft.com/office/drawing/2014/main" id="{BE6487A0-3224-A6D8-B359-0197FDA6444F}"/>
+                <a16:creationId xmlns:a16="http://schemas.microsoft.com/office/drawing/2014/main" id="{C4747D4A-D7DD-2CA4-78D6-AE25B89E4E73}"/>
               </a:ext>
             </a:extLst>
           </p:cNvPr>
@@ -6225,7 +6225,7 @@
           <p:cNvPr id="8" name="CuadroTexto 7">
             <a:extLst>
               <a:ext uri="{FF2B5EF4-FFF2-40B4-BE49-F238E27FC236}">
-                <a16:creationId xmlns:a16="http://schemas.microsoft.com/office/drawing/2014/main" id="{05614C6C-273F-16ED-15D0-483983C97A65}"/>
+                <a16:creationId xmlns:a16="http://schemas.microsoft.com/office/drawing/2014/main" id="{DBCE25F4-AEAB-CF41-3D84-F7E7B827F90B}"/>
               </a:ext>
             </a:extLst>
           </p:cNvPr>
@@ -6265,7 +6265,7 @@
           <p:cNvPr id="9" name="CuadroTexto 8">
             <a:extLst>
               <a:ext uri="{FF2B5EF4-FFF2-40B4-BE49-F238E27FC236}">
-                <a16:creationId xmlns:a16="http://schemas.microsoft.com/office/drawing/2014/main" id="{68077E7A-068F-2D77-2B1B-E8861C37ADB6}"/>
+                <a16:creationId xmlns:a16="http://schemas.microsoft.com/office/drawing/2014/main" id="{CAD091DD-616F-4188-68EB-E6F9119A474F}"/>
               </a:ext>
             </a:extLst>
           </p:cNvPr>
@@ -6305,7 +6305,7 @@
           <p:cNvPr id="10" name="Rectángulo: esquinas redondeadas 9">
             <a:extLst>
               <a:ext uri="{FF2B5EF4-FFF2-40B4-BE49-F238E27FC236}">
-                <a16:creationId xmlns:a16="http://schemas.microsoft.com/office/drawing/2014/main" id="{305A896B-439F-8186-6897-B359BC044784}"/>
+                <a16:creationId xmlns:a16="http://schemas.microsoft.com/office/drawing/2014/main" id="{71D529E0-8D97-5540-06D0-68D0B8AEC98E}"/>
               </a:ext>
             </a:extLst>
           </p:cNvPr>
@@ -6359,7 +6359,7 @@
           <p:cNvPr id="11" name="CuadroTexto 10">
             <a:extLst>
               <a:ext uri="{FF2B5EF4-FFF2-40B4-BE49-F238E27FC236}">
-                <a16:creationId xmlns:a16="http://schemas.microsoft.com/office/drawing/2014/main" id="{FADC988E-5836-9656-712D-3215B31FE7BF}"/>
+                <a16:creationId xmlns:a16="http://schemas.microsoft.com/office/drawing/2014/main" id="{1C7A4AAA-6097-E20D-18C0-6E9188E09D05}"/>
               </a:ext>
             </a:extLst>
           </p:cNvPr>
@@ -6399,7 +6399,7 @@
           <p:cNvPr id="12" name="CuadroTexto 11">
             <a:extLst>
               <a:ext uri="{FF2B5EF4-FFF2-40B4-BE49-F238E27FC236}">
-                <a16:creationId xmlns:a16="http://schemas.microsoft.com/office/drawing/2014/main" id="{D21C7DB2-EE2A-0A1F-4162-D417B0F42D11}"/>
+                <a16:creationId xmlns:a16="http://schemas.microsoft.com/office/drawing/2014/main" id="{BEA72C8C-0F35-635A-7DD0-181D55129E10}"/>
               </a:ext>
             </a:extLst>
           </p:cNvPr>
@@ -6439,7 +6439,7 @@
           <p:cNvPr id="13" name="Rectángulo: esquinas redondeadas 12">
             <a:extLst>
               <a:ext uri="{FF2B5EF4-FFF2-40B4-BE49-F238E27FC236}">
-                <a16:creationId xmlns:a16="http://schemas.microsoft.com/office/drawing/2014/main" id="{6B5B5511-EA4D-2EE1-1213-81E93F30634A}"/>
+                <a16:creationId xmlns:a16="http://schemas.microsoft.com/office/drawing/2014/main" id="{AC9ECC78-A1F7-DB6B-75B4-77893B9809B0}"/>
               </a:ext>
             </a:extLst>
           </p:cNvPr>
@@ -6493,7 +6493,7 @@
           <p:cNvPr id="14" name="CuadroTexto 13">
             <a:extLst>
               <a:ext uri="{FF2B5EF4-FFF2-40B4-BE49-F238E27FC236}">
-                <a16:creationId xmlns:a16="http://schemas.microsoft.com/office/drawing/2014/main" id="{DEA772EB-F063-0849-8BFF-693972605AC4}"/>
+                <a16:creationId xmlns:a16="http://schemas.microsoft.com/office/drawing/2014/main" id="{4EF187AC-EEB4-9CA4-8962-5AC17B04124B}"/>
               </a:ext>
             </a:extLst>
           </p:cNvPr>
@@ -6533,7 +6533,7 @@
           <p:cNvPr id="15" name="CuadroTexto 14">
             <a:extLst>
               <a:ext uri="{FF2B5EF4-FFF2-40B4-BE49-F238E27FC236}">
-                <a16:creationId xmlns:a16="http://schemas.microsoft.com/office/drawing/2014/main" id="{2A8E837A-F4C8-C811-0E70-980D4A2F5CEF}"/>
+                <a16:creationId xmlns:a16="http://schemas.microsoft.com/office/drawing/2014/main" id="{AFE852A5-48FC-E608-FF72-E6404035F562}"/>
               </a:ext>
             </a:extLst>
           </p:cNvPr>
@@ -6573,7 +6573,7 @@
           <p:cNvPr id="16" name="CuadroTexto 15">
             <a:extLst>
               <a:ext uri="{FF2B5EF4-FFF2-40B4-BE49-F238E27FC236}">
-                <a16:creationId xmlns:a16="http://schemas.microsoft.com/office/drawing/2014/main" id="{FEB59DB2-FCAD-9268-E5F8-4DF8C6FC3CFA}"/>
+                <a16:creationId xmlns:a16="http://schemas.microsoft.com/office/drawing/2014/main" id="{D947EBFC-CF22-FF91-7F7D-DB44FCE2865A}"/>
               </a:ext>
             </a:extLst>
           </p:cNvPr>
@@ -6656,7 +6656,7 @@
           <p:cNvPr id="17" name="CuadroTexto 16">
             <a:extLst>
               <a:ext uri="{FF2B5EF4-FFF2-40B4-BE49-F238E27FC236}">
-                <a16:creationId xmlns:a16="http://schemas.microsoft.com/office/drawing/2014/main" id="{E23E7F99-4563-27D9-DD28-122A6E1B635A}"/>
+                <a16:creationId xmlns:a16="http://schemas.microsoft.com/office/drawing/2014/main" id="{DE59D7CF-5EEE-653A-1B3E-7080BF304F1F}"/>
               </a:ext>
             </a:extLst>
           </p:cNvPr>
@@ -6694,7 +6694,7 @@
     </p:spTree>
     <p:extLst>
       <p:ext uri="{BB962C8B-B14F-4D97-AF65-F5344CB8AC3E}">
-        <p14:creationId xmlns:p14="http://schemas.microsoft.com/office/powerpoint/2010/main" val="1833900103"/>
+        <p14:creationId xmlns:p14="http://schemas.microsoft.com/office/powerpoint/2010/main" val="1400719236"/>
       </p:ext>
     </p:extLst>
   </p:cSld>
@@ -6734,7 +6734,7 @@
           <p:cNvPr id="2" name="CuadroTexto 1">
             <a:extLst>
               <a:ext uri="{FF2B5EF4-FFF2-40B4-BE49-F238E27FC236}">
-                <a16:creationId xmlns:a16="http://schemas.microsoft.com/office/drawing/2014/main" id="{B3F4C206-8459-F939-248A-3FB31B3C47E2}"/>
+                <a16:creationId xmlns:a16="http://schemas.microsoft.com/office/drawing/2014/main" id="{ABF17A67-0B0E-EA25-5589-0A492FFA42E2}"/>
               </a:ext>
             </a:extLst>
           </p:cNvPr>
@@ -6774,7 +6774,7 @@
           <p:cNvPr id="3" name="CuadroTexto 2">
             <a:extLst>
               <a:ext uri="{FF2B5EF4-FFF2-40B4-BE49-F238E27FC236}">
-                <a16:creationId xmlns:a16="http://schemas.microsoft.com/office/drawing/2014/main" id="{3536A14B-98AD-330D-E3A2-5F9C5FECCDBE}"/>
+                <a16:creationId xmlns:a16="http://schemas.microsoft.com/office/drawing/2014/main" id="{0A274C95-0C30-99B3-F176-753278630DD8}"/>
               </a:ext>
             </a:extLst>
           </p:cNvPr>
@@ -6814,7 +6814,7 @@
           <p:cNvPr id="4" name="CuadroTexto 3">
             <a:extLst>
               <a:ext uri="{FF2B5EF4-FFF2-40B4-BE49-F238E27FC236}">
-                <a16:creationId xmlns:a16="http://schemas.microsoft.com/office/drawing/2014/main" id="{123D2F72-8993-A09C-30B6-5CF217848F11}"/>
+                <a16:creationId xmlns:a16="http://schemas.microsoft.com/office/drawing/2014/main" id="{C7EFE29B-E641-801A-867B-9A9B61747A2B}"/>
               </a:ext>
             </a:extLst>
           </p:cNvPr>
@@ -6854,7 +6854,7 @@
           <p:cNvPr id="5" name="Rectángulo: esquinas redondeadas 4">
             <a:extLst>
               <a:ext uri="{FF2B5EF4-FFF2-40B4-BE49-F238E27FC236}">
-                <a16:creationId xmlns:a16="http://schemas.microsoft.com/office/drawing/2014/main" id="{A16CFE9C-F638-2584-7F3C-213C43EF5B70}"/>
+                <a16:creationId xmlns:a16="http://schemas.microsoft.com/office/drawing/2014/main" id="{8C30D6ED-1DCA-16C0-73C6-E5CFE7DF3A44}"/>
               </a:ext>
             </a:extLst>
           </p:cNvPr>
@@ -6908,7 +6908,7 @@
           <p:cNvPr id="6" name="CuadroTexto 5">
             <a:extLst>
               <a:ext uri="{FF2B5EF4-FFF2-40B4-BE49-F238E27FC236}">
-                <a16:creationId xmlns:a16="http://schemas.microsoft.com/office/drawing/2014/main" id="{7854F5D6-9D86-50AB-E2B3-EB4E442655C9}"/>
+                <a16:creationId xmlns:a16="http://schemas.microsoft.com/office/drawing/2014/main" id="{B57D4764-B415-C028-E655-ADAB442F0F8A}"/>
               </a:ext>
             </a:extLst>
           </p:cNvPr>
@@ -6948,7 +6948,7 @@
           <p:cNvPr id="7" name="CuadroTexto 6">
             <a:extLst>
               <a:ext uri="{FF2B5EF4-FFF2-40B4-BE49-F238E27FC236}">
-                <a16:creationId xmlns:a16="http://schemas.microsoft.com/office/drawing/2014/main" id="{E19AF8D8-CD8A-01CD-7F41-07B8C580CB33}"/>
+                <a16:creationId xmlns:a16="http://schemas.microsoft.com/office/drawing/2014/main" id="{1DBC50A7-BC88-1607-CC8D-DA7ECB6A4335}"/>
               </a:ext>
             </a:extLst>
           </p:cNvPr>
@@ -6988,7 +6988,7 @@
           <p:cNvPr id="8" name="Rectángulo: esquinas redondeadas 7">
             <a:extLst>
               <a:ext uri="{FF2B5EF4-FFF2-40B4-BE49-F238E27FC236}">
-                <a16:creationId xmlns:a16="http://schemas.microsoft.com/office/drawing/2014/main" id="{2A074F37-BF29-B61B-C7A0-718A5DEC485C}"/>
+                <a16:creationId xmlns:a16="http://schemas.microsoft.com/office/drawing/2014/main" id="{A412CBB9-86BD-F288-C59E-D292D6E31DF8}"/>
               </a:ext>
             </a:extLst>
           </p:cNvPr>
@@ -7042,7 +7042,7 @@
           <p:cNvPr id="9" name="CuadroTexto 8">
             <a:extLst>
               <a:ext uri="{FF2B5EF4-FFF2-40B4-BE49-F238E27FC236}">
-                <a16:creationId xmlns:a16="http://schemas.microsoft.com/office/drawing/2014/main" id="{B2AC185B-6514-73F1-A3E5-E984F68B9902}"/>
+                <a16:creationId xmlns:a16="http://schemas.microsoft.com/office/drawing/2014/main" id="{87DBC3C6-18D8-9DD8-58A8-F724AC9963EA}"/>
               </a:ext>
             </a:extLst>
           </p:cNvPr>
@@ -7082,7 +7082,7 @@
           <p:cNvPr id="10" name="CuadroTexto 9">
             <a:extLst>
               <a:ext uri="{FF2B5EF4-FFF2-40B4-BE49-F238E27FC236}">
-                <a16:creationId xmlns:a16="http://schemas.microsoft.com/office/drawing/2014/main" id="{D8D14FB8-A2EC-B48D-803C-8DCBB99BEF42}"/>
+                <a16:creationId xmlns:a16="http://schemas.microsoft.com/office/drawing/2014/main" id="{F610A121-9D29-0E37-DBD6-E822C950A59C}"/>
               </a:ext>
             </a:extLst>
           </p:cNvPr>
@@ -7122,7 +7122,7 @@
           <p:cNvPr id="11" name="CuadroTexto 10">
             <a:extLst>
               <a:ext uri="{FF2B5EF4-FFF2-40B4-BE49-F238E27FC236}">
-                <a16:creationId xmlns:a16="http://schemas.microsoft.com/office/drawing/2014/main" id="{64F3486F-329C-AFD2-5979-CCFAC7EA8CAE}"/>
+                <a16:creationId xmlns:a16="http://schemas.microsoft.com/office/drawing/2014/main" id="{E6BF17B1-3756-F404-2B2E-ACF06D5E42EA}"/>
               </a:ext>
             </a:extLst>
           </p:cNvPr>
@@ -7162,7 +7162,7 @@
           <p:cNvPr id="12" name="CuadroTexto 11">
             <a:extLst>
               <a:ext uri="{FF2B5EF4-FFF2-40B4-BE49-F238E27FC236}">
-                <a16:creationId xmlns:a16="http://schemas.microsoft.com/office/drawing/2014/main" id="{8D511053-1A70-2E09-E182-03F420080343}"/>
+                <a16:creationId xmlns:a16="http://schemas.microsoft.com/office/drawing/2014/main" id="{0DD8FCFA-F0E8-01F2-0399-99379ACDEE09}"/>
               </a:ext>
             </a:extLst>
           </p:cNvPr>
@@ -7243,7 +7243,7 @@
     </p:spTree>
     <p:extLst>
       <p:ext uri="{BB962C8B-B14F-4D97-AF65-F5344CB8AC3E}">
-        <p14:creationId xmlns:p14="http://schemas.microsoft.com/office/powerpoint/2010/main" val="4148631519"/>
+        <p14:creationId xmlns:p14="http://schemas.microsoft.com/office/powerpoint/2010/main" val="2491006121"/>
       </p:ext>
     </p:extLst>
   </p:cSld>
@@ -7283,7 +7283,7 @@
           <p:cNvPr id="2" name="CuadroTexto 1">
             <a:extLst>
               <a:ext uri="{FF2B5EF4-FFF2-40B4-BE49-F238E27FC236}">
-                <a16:creationId xmlns:a16="http://schemas.microsoft.com/office/drawing/2014/main" id="{0B5CBCEC-03B0-5983-7141-BA1810FA18B9}"/>
+                <a16:creationId xmlns:a16="http://schemas.microsoft.com/office/drawing/2014/main" id="{53C97CB9-EBEA-A602-F6CA-DC84323DA427}"/>
               </a:ext>
             </a:extLst>
           </p:cNvPr>
@@ -7323,7 +7323,7 @@
           <p:cNvPr id="3" name="CuadroTexto 2">
             <a:extLst>
               <a:ext uri="{FF2B5EF4-FFF2-40B4-BE49-F238E27FC236}">
-                <a16:creationId xmlns:a16="http://schemas.microsoft.com/office/drawing/2014/main" id="{A776B045-5ED7-50C1-623F-C7BB99EA0949}"/>
+                <a16:creationId xmlns:a16="http://schemas.microsoft.com/office/drawing/2014/main" id="{E581D664-23FF-43C6-CBC8-86E3797A9379}"/>
               </a:ext>
             </a:extLst>
           </p:cNvPr>
@@ -7363,7 +7363,7 @@
           <p:cNvPr id="4" name="CuadroTexto 3">
             <a:extLst>
               <a:ext uri="{FF2B5EF4-FFF2-40B4-BE49-F238E27FC236}">
-                <a16:creationId xmlns:a16="http://schemas.microsoft.com/office/drawing/2014/main" id="{1B2033FE-0561-28AC-FCA8-AB0CBF99D9A4}"/>
+                <a16:creationId xmlns:a16="http://schemas.microsoft.com/office/drawing/2014/main" id="{7F6C04A8-101A-D7A1-012C-3A6C0B6D9938}"/>
               </a:ext>
             </a:extLst>
           </p:cNvPr>
@@ -7403,7 +7403,7 @@
           <p:cNvPr id="5" name="Rectángulo: esquinas redondeadas 4">
             <a:extLst>
               <a:ext uri="{FF2B5EF4-FFF2-40B4-BE49-F238E27FC236}">
-                <a16:creationId xmlns:a16="http://schemas.microsoft.com/office/drawing/2014/main" id="{B28BC6F7-336F-F92E-29E5-C7676A1C0506}"/>
+                <a16:creationId xmlns:a16="http://schemas.microsoft.com/office/drawing/2014/main" id="{05215D6A-3B4E-CF24-A3B9-FDB9687BC3AF}"/>
               </a:ext>
             </a:extLst>
           </p:cNvPr>
@@ -7457,7 +7457,7 @@
           <p:cNvPr id="6" name="CuadroTexto 5">
             <a:extLst>
               <a:ext uri="{FF2B5EF4-FFF2-40B4-BE49-F238E27FC236}">
-                <a16:creationId xmlns:a16="http://schemas.microsoft.com/office/drawing/2014/main" id="{B616075B-EBFC-AF2A-D441-CA625A64DB9E}"/>
+                <a16:creationId xmlns:a16="http://schemas.microsoft.com/office/drawing/2014/main" id="{B56296C0-9628-2A65-B2BC-001D91E62F33}"/>
               </a:ext>
             </a:extLst>
           </p:cNvPr>
@@ -7497,7 +7497,7 @@
           <p:cNvPr id="7" name="CuadroTexto 6">
             <a:extLst>
               <a:ext uri="{FF2B5EF4-FFF2-40B4-BE49-F238E27FC236}">
-                <a16:creationId xmlns:a16="http://schemas.microsoft.com/office/drawing/2014/main" id="{B33A05D1-2367-AE95-42A7-15FE4AFB453E}"/>
+                <a16:creationId xmlns:a16="http://schemas.microsoft.com/office/drawing/2014/main" id="{8B9CF4DA-5114-5AC5-FE1B-72180041CB3C}"/>
               </a:ext>
             </a:extLst>
           </p:cNvPr>
@@ -7598,7 +7598,7 @@
           <p:cNvPr id="8" name="Rectángulo: esquinas redondeadas 7">
             <a:extLst>
               <a:ext uri="{FF2B5EF4-FFF2-40B4-BE49-F238E27FC236}">
-                <a16:creationId xmlns:a16="http://schemas.microsoft.com/office/drawing/2014/main" id="{85120959-4246-3FE9-1B92-CE3BC5DEB55A}"/>
+                <a16:creationId xmlns:a16="http://schemas.microsoft.com/office/drawing/2014/main" id="{A870D57A-E655-BB64-DDEF-4DB115E64C1A}"/>
               </a:ext>
             </a:extLst>
           </p:cNvPr>
@@ -7652,7 +7652,7 @@
           <p:cNvPr id="9" name="CuadroTexto 8">
             <a:extLst>
               <a:ext uri="{FF2B5EF4-FFF2-40B4-BE49-F238E27FC236}">
-                <a16:creationId xmlns:a16="http://schemas.microsoft.com/office/drawing/2014/main" id="{D5E495AE-6705-AF48-3376-84A0E6C5C1E5}"/>
+                <a16:creationId xmlns:a16="http://schemas.microsoft.com/office/drawing/2014/main" id="{31145F61-DB6A-1019-3ADD-6CBDD3AAB061}"/>
               </a:ext>
             </a:extLst>
           </p:cNvPr>
@@ -7692,7 +7692,7 @@
           <p:cNvPr id="10" name="CuadroTexto 9">
             <a:extLst>
               <a:ext uri="{FF2B5EF4-FFF2-40B4-BE49-F238E27FC236}">
-                <a16:creationId xmlns:a16="http://schemas.microsoft.com/office/drawing/2014/main" id="{6693FBB9-0DB6-D935-E315-EF7815C19D0D}"/>
+                <a16:creationId xmlns:a16="http://schemas.microsoft.com/office/drawing/2014/main" id="{9E263D43-1D9A-9059-3C14-B787D57096D2}"/>
               </a:ext>
             </a:extLst>
           </p:cNvPr>
@@ -7732,7 +7732,7 @@
           <p:cNvPr id="11" name="Rectángulo: esquinas redondeadas 10">
             <a:extLst>
               <a:ext uri="{FF2B5EF4-FFF2-40B4-BE49-F238E27FC236}">
-                <a16:creationId xmlns:a16="http://schemas.microsoft.com/office/drawing/2014/main" id="{26EF31EE-7914-1FBB-C311-57DDB8C76FA7}"/>
+                <a16:creationId xmlns:a16="http://schemas.microsoft.com/office/drawing/2014/main" id="{8533D3D5-6554-E904-954F-41CBDCF4A932}"/>
               </a:ext>
             </a:extLst>
           </p:cNvPr>
@@ -7786,7 +7786,7 @@
           <p:cNvPr id="12" name="CuadroTexto 11">
             <a:extLst>
               <a:ext uri="{FF2B5EF4-FFF2-40B4-BE49-F238E27FC236}">
-                <a16:creationId xmlns:a16="http://schemas.microsoft.com/office/drawing/2014/main" id="{69B47D44-C6F5-7496-9F88-919F244828B7}"/>
+                <a16:creationId xmlns:a16="http://schemas.microsoft.com/office/drawing/2014/main" id="{651F9576-A26E-0A25-1466-D465049575E4}"/>
               </a:ext>
             </a:extLst>
           </p:cNvPr>
@@ -7826,7 +7826,7 @@
           <p:cNvPr id="13" name="CuadroTexto 12">
             <a:extLst>
               <a:ext uri="{FF2B5EF4-FFF2-40B4-BE49-F238E27FC236}">
-                <a16:creationId xmlns:a16="http://schemas.microsoft.com/office/drawing/2014/main" id="{D1AE0AD6-88DE-6861-29B6-748240F58BB0}"/>
+                <a16:creationId xmlns:a16="http://schemas.microsoft.com/office/drawing/2014/main" id="{58161CBD-935D-C0BD-9D61-502B2B101D49}"/>
               </a:ext>
             </a:extLst>
           </p:cNvPr>
@@ -7856,7 +7856,7 @@
                 </a:solidFill>
                 <a:latin typeface="Segoe UI" panose="020B0502040204020203" pitchFamily="34" charset="0"/>
               </a:rPr>
-              <a:t>Mover documentos, backups y observabilidad a piezas gestionadas.</a:t>
+              <a:t>Migrar documentos, backups y observabilidad a servicios gestionados fuera de la VM.</a:t>
             </a:r>
           </a:p>
         </p:txBody>
@@ -7866,7 +7866,7 @@
           <p:cNvPr id="14" name="Rectángulo: esquinas redondeadas 13">
             <a:extLst>
               <a:ext uri="{FF2B5EF4-FFF2-40B4-BE49-F238E27FC236}">
-                <a16:creationId xmlns:a16="http://schemas.microsoft.com/office/drawing/2014/main" id="{CFA353E8-3014-76E1-58B0-D739ED35FBF6}"/>
+                <a16:creationId xmlns:a16="http://schemas.microsoft.com/office/drawing/2014/main" id="{8E2CC980-63EB-6A22-FFBD-BC0FDD281A25}"/>
               </a:ext>
             </a:extLst>
           </p:cNvPr>
@@ -7920,7 +7920,7 @@
           <p:cNvPr id="15" name="CuadroTexto 14">
             <a:extLst>
               <a:ext uri="{FF2B5EF4-FFF2-40B4-BE49-F238E27FC236}">
-                <a16:creationId xmlns:a16="http://schemas.microsoft.com/office/drawing/2014/main" id="{84183F15-1129-087E-1A27-21B234E62411}"/>
+                <a16:creationId xmlns:a16="http://schemas.microsoft.com/office/drawing/2014/main" id="{DDF90326-7938-8B98-3223-42C2C1C0D003}"/>
               </a:ext>
             </a:extLst>
           </p:cNvPr>
@@ -7960,7 +7960,7 @@
           <p:cNvPr id="16" name="CuadroTexto 15">
             <a:extLst>
               <a:ext uri="{FF2B5EF4-FFF2-40B4-BE49-F238E27FC236}">
-                <a16:creationId xmlns:a16="http://schemas.microsoft.com/office/drawing/2014/main" id="{1BBB3881-FAA5-224E-B2A1-C0CE0CB227F4}"/>
+                <a16:creationId xmlns:a16="http://schemas.microsoft.com/office/drawing/2014/main" id="{6DE08089-44FC-BA71-6838-474F8F76D64D}"/>
               </a:ext>
             </a:extLst>
           </p:cNvPr>
@@ -8000,7 +8000,7 @@
           <p:cNvPr id="17" name="CuadroTexto 16">
             <a:extLst>
               <a:ext uri="{FF2B5EF4-FFF2-40B4-BE49-F238E27FC236}">
-                <a16:creationId xmlns:a16="http://schemas.microsoft.com/office/drawing/2014/main" id="{433E648D-304F-1E51-8C24-192548D7542B}"/>
+                <a16:creationId xmlns:a16="http://schemas.microsoft.com/office/drawing/2014/main" id="{0B72C3C2-9228-5457-9DB2-CFE0F34DA693}"/>
               </a:ext>
             </a:extLst>
           </p:cNvPr>
@@ -8063,7 +8063,7 @@
     </p:spTree>
     <p:extLst>
       <p:ext uri="{BB962C8B-B14F-4D97-AF65-F5344CB8AC3E}">
-        <p14:creationId xmlns:p14="http://schemas.microsoft.com/office/powerpoint/2010/main" val="4288348950"/>
+        <p14:creationId xmlns:p14="http://schemas.microsoft.com/office/powerpoint/2010/main" val="1384542028"/>
       </p:ext>
     </p:extLst>
   </p:cSld>
@@ -8103,7 +8103,7 @@
           <p:cNvPr id="2" name="CuadroTexto 1">
             <a:extLst>
               <a:ext uri="{FF2B5EF4-FFF2-40B4-BE49-F238E27FC236}">
-                <a16:creationId xmlns:a16="http://schemas.microsoft.com/office/drawing/2014/main" id="{D3A5D2F9-AF48-EBB4-7F27-9300C0C11E38}"/>
+                <a16:creationId xmlns:a16="http://schemas.microsoft.com/office/drawing/2014/main" id="{C363EC2D-827D-E293-58DE-23863F70001B}"/>
               </a:ext>
             </a:extLst>
           </p:cNvPr>
@@ -8143,7 +8143,7 @@
           <p:cNvPr id="3" name="CuadroTexto 2">
             <a:extLst>
               <a:ext uri="{FF2B5EF4-FFF2-40B4-BE49-F238E27FC236}">
-                <a16:creationId xmlns:a16="http://schemas.microsoft.com/office/drawing/2014/main" id="{205E0E42-9ED7-0158-57C0-58EFCAD1EE35}"/>
+                <a16:creationId xmlns:a16="http://schemas.microsoft.com/office/drawing/2014/main" id="{F9FBC11A-D6BF-8030-89B6-9AE9C67C0F63}"/>
               </a:ext>
             </a:extLst>
           </p:cNvPr>
@@ -8183,7 +8183,7 @@
           <p:cNvPr id="4" name="CuadroTexto 3">
             <a:extLst>
               <a:ext uri="{FF2B5EF4-FFF2-40B4-BE49-F238E27FC236}">
-                <a16:creationId xmlns:a16="http://schemas.microsoft.com/office/drawing/2014/main" id="{FB0A7C40-A46C-523E-8A41-1419EA7C2BD7}"/>
+                <a16:creationId xmlns:a16="http://schemas.microsoft.com/office/drawing/2014/main" id="{20132C7E-9033-1B78-6B93-FF6F4B2631BF}"/>
               </a:ext>
             </a:extLst>
           </p:cNvPr>
@@ -8220,7 +8220,7 @@
                 </a:solidFill>
                 <a:latin typeface="Segoe UI" panose="020B0502040204020203" pitchFamily="34" charset="0"/>
               </a:rPr>
-              <a:t>Despliegue permanente completamente automatizado.</a:t>
+              <a:t>Infraestructura mas gestionada y endurecida que la VM actual.</a:t>
             </a:r>
           </a:p>
           <a:p>
@@ -8274,7 +8274,7 @@
                 </a:solidFill>
                 <a:latin typeface="Segoe UI" panose="020B0502040204020203" pitchFamily="34" charset="0"/>
               </a:rPr>
-              <a:t>Almacenamiento documental en nube gestionada.</a:t>
+              <a:t>Migracion del almacenamiento documental a un servicio gestionado independiente.</a:t>
             </a:r>
           </a:p>
           <a:p>
@@ -8302,7 +8302,7 @@
           <p:cNvPr id="5" name="Rectángulo: esquinas redondeadas 4">
             <a:extLst>
               <a:ext uri="{FF2B5EF4-FFF2-40B4-BE49-F238E27FC236}">
-                <a16:creationId xmlns:a16="http://schemas.microsoft.com/office/drawing/2014/main" id="{CCFF1FD8-4B20-AF2A-7061-A654004E9755}"/>
+                <a16:creationId xmlns:a16="http://schemas.microsoft.com/office/drawing/2014/main" id="{619EACEF-9A4A-1501-CE9F-86D27B34DD12}"/>
               </a:ext>
             </a:extLst>
           </p:cNvPr>
@@ -8356,7 +8356,7 @@
           <p:cNvPr id="6" name="CuadroTexto 5">
             <a:extLst>
               <a:ext uri="{FF2B5EF4-FFF2-40B4-BE49-F238E27FC236}">
-                <a16:creationId xmlns:a16="http://schemas.microsoft.com/office/drawing/2014/main" id="{7014CB03-D51D-37C3-75A1-85002D142207}"/>
+                <a16:creationId xmlns:a16="http://schemas.microsoft.com/office/drawing/2014/main" id="{41215060-E82A-9686-21CF-EF8079E946AD}"/>
               </a:ext>
             </a:extLst>
           </p:cNvPr>
@@ -8396,7 +8396,7 @@
           <p:cNvPr id="7" name="CuadroTexto 6">
             <a:extLst>
               <a:ext uri="{FF2B5EF4-FFF2-40B4-BE49-F238E27FC236}">
-                <a16:creationId xmlns:a16="http://schemas.microsoft.com/office/drawing/2014/main" id="{006BCA0E-8AB9-A855-0D30-3D091A3A4418}"/>
+                <a16:creationId xmlns:a16="http://schemas.microsoft.com/office/drawing/2014/main" id="{32F7C57F-33B4-4CB2-581B-B0C785ED2DD7}"/>
               </a:ext>
             </a:extLst>
           </p:cNvPr>
@@ -8434,7 +8434,7 @@
     </p:spTree>
     <p:extLst>
       <p:ext uri="{BB962C8B-B14F-4D97-AF65-F5344CB8AC3E}">
-        <p14:creationId xmlns:p14="http://schemas.microsoft.com/office/powerpoint/2010/main" val="990444058"/>
+        <p14:creationId xmlns:p14="http://schemas.microsoft.com/office/powerpoint/2010/main" val="3973592235"/>
       </p:ext>
     </p:extLst>
   </p:cSld>
@@ -8474,7 +8474,7 @@
           <p:cNvPr id="2" name="CuadroTexto 1">
             <a:extLst>
               <a:ext uri="{FF2B5EF4-FFF2-40B4-BE49-F238E27FC236}">
-                <a16:creationId xmlns:a16="http://schemas.microsoft.com/office/drawing/2014/main" id="{036CED16-AF6D-6F19-B5C9-667A760854D0}"/>
+                <a16:creationId xmlns:a16="http://schemas.microsoft.com/office/drawing/2014/main" id="{92D81F7F-2258-EA64-DCD4-E81A879DD0B5}"/>
               </a:ext>
             </a:extLst>
           </p:cNvPr>
@@ -8514,7 +8514,7 @@
           <p:cNvPr id="3" name="CuadroTexto 2">
             <a:extLst>
               <a:ext uri="{FF2B5EF4-FFF2-40B4-BE49-F238E27FC236}">
-                <a16:creationId xmlns:a16="http://schemas.microsoft.com/office/drawing/2014/main" id="{DFBF3C10-C8F8-D4EA-C929-9C9E13152A42}"/>
+                <a16:creationId xmlns:a16="http://schemas.microsoft.com/office/drawing/2014/main" id="{32C24F13-ABAC-65AE-18F4-D098C3D1CF8C}"/>
               </a:ext>
             </a:extLst>
           </p:cNvPr>
@@ -8554,7 +8554,7 @@
           <p:cNvPr id="4" name="CuadroTexto 3">
             <a:extLst>
               <a:ext uri="{FF2B5EF4-FFF2-40B4-BE49-F238E27FC236}">
-                <a16:creationId xmlns:a16="http://schemas.microsoft.com/office/drawing/2014/main" id="{7EB16D0E-93DC-A5D4-428C-CB7F5AF93E7B}"/>
+                <a16:creationId xmlns:a16="http://schemas.microsoft.com/office/drawing/2014/main" id="{A7F0F976-2ACE-B939-D25D-4720E924E803}"/>
               </a:ext>
             </a:extLst>
           </p:cNvPr>
@@ -8594,7 +8594,7 @@
           <p:cNvPr id="5" name="CuadroTexto 4">
             <a:extLst>
               <a:ext uri="{FF2B5EF4-FFF2-40B4-BE49-F238E27FC236}">
-                <a16:creationId xmlns:a16="http://schemas.microsoft.com/office/drawing/2014/main" id="{33F4D4A8-FAE3-468C-B4E0-177E55140173}"/>
+                <a16:creationId xmlns:a16="http://schemas.microsoft.com/office/drawing/2014/main" id="{BD10D5EB-9330-C924-F312-131A55DD3090}"/>
               </a:ext>
             </a:extLst>
           </p:cNvPr>
@@ -8677,7 +8677,7 @@
           <p:cNvPr id="6" name="CuadroTexto 5">
             <a:extLst>
               <a:ext uri="{FF2B5EF4-FFF2-40B4-BE49-F238E27FC236}">
-                <a16:creationId xmlns:a16="http://schemas.microsoft.com/office/drawing/2014/main" id="{C80A97D4-C6A7-C8B0-B201-F15B6F610839}"/>
+                <a16:creationId xmlns:a16="http://schemas.microsoft.com/office/drawing/2014/main" id="{1F11DC90-BD7F-18DA-454A-5A78D693F6D5}"/>
               </a:ext>
             </a:extLst>
           </p:cNvPr>
@@ -8715,7 +8715,7 @@
     </p:spTree>
     <p:extLst>
       <p:ext uri="{BB962C8B-B14F-4D97-AF65-F5344CB8AC3E}">
-        <p14:creationId xmlns:p14="http://schemas.microsoft.com/office/powerpoint/2010/main" val="589655953"/>
+        <p14:creationId xmlns:p14="http://schemas.microsoft.com/office/powerpoint/2010/main" val="995204594"/>
       </p:ext>
     </p:extLst>
   </p:cSld>
@@ -8755,7 +8755,7 @@
           <p:cNvPr id="2" name="CuadroTexto 1">
             <a:extLst>
               <a:ext uri="{FF2B5EF4-FFF2-40B4-BE49-F238E27FC236}">
-                <a16:creationId xmlns:a16="http://schemas.microsoft.com/office/drawing/2014/main" id="{6FBC9830-1087-3B6C-1D91-84C5028059E5}"/>
+                <a16:creationId xmlns:a16="http://schemas.microsoft.com/office/drawing/2014/main" id="{64E27492-A7A3-0D12-57CD-41E2ED4F21D1}"/>
               </a:ext>
             </a:extLst>
           </p:cNvPr>
@@ -8795,7 +8795,7 @@
           <p:cNvPr id="3" name="CuadroTexto 2">
             <a:extLst>
               <a:ext uri="{FF2B5EF4-FFF2-40B4-BE49-F238E27FC236}">
-                <a16:creationId xmlns:a16="http://schemas.microsoft.com/office/drawing/2014/main" id="{6E9AD559-58E0-8320-53FE-5B82434953C6}"/>
+                <a16:creationId xmlns:a16="http://schemas.microsoft.com/office/drawing/2014/main" id="{E3E06C6C-EEA9-DEEB-FAE9-72DC507AFB52}"/>
               </a:ext>
             </a:extLst>
           </p:cNvPr>
@@ -8835,7 +8835,7 @@
           <p:cNvPr id="4" name="CuadroTexto 3">
             <a:extLst>
               <a:ext uri="{FF2B5EF4-FFF2-40B4-BE49-F238E27FC236}">
-                <a16:creationId xmlns:a16="http://schemas.microsoft.com/office/drawing/2014/main" id="{3DC3118D-8EA7-9B0F-6B6C-E26B25E6EDEF}"/>
+                <a16:creationId xmlns:a16="http://schemas.microsoft.com/office/drawing/2014/main" id="{B5FBA7B2-0364-0349-0B91-A756B41E6A20}"/>
               </a:ext>
             </a:extLst>
           </p:cNvPr>
@@ -8875,7 +8875,7 @@
           <p:cNvPr id="5" name="CuadroTexto 4">
             <a:extLst>
               <a:ext uri="{FF2B5EF4-FFF2-40B4-BE49-F238E27FC236}">
-                <a16:creationId xmlns:a16="http://schemas.microsoft.com/office/drawing/2014/main" id="{06A3EF4E-5A23-0B2D-C056-0F90E3CCF8E7}"/>
+                <a16:creationId xmlns:a16="http://schemas.microsoft.com/office/drawing/2014/main" id="{0F38E413-996F-A107-60F8-A6EFC9312F91}"/>
               </a:ext>
             </a:extLst>
           </p:cNvPr>
@@ -8976,7 +8976,7 @@
           <p:cNvPr id="6" name="Rectángulo: esquinas redondeadas 5">
             <a:extLst>
               <a:ext uri="{FF2B5EF4-FFF2-40B4-BE49-F238E27FC236}">
-                <a16:creationId xmlns:a16="http://schemas.microsoft.com/office/drawing/2014/main" id="{CA25E428-EEB2-3BA5-A89E-427C511F04C2}"/>
+                <a16:creationId xmlns:a16="http://schemas.microsoft.com/office/drawing/2014/main" id="{32893821-8623-6FD0-DD8B-866EFB1DED72}"/>
               </a:ext>
             </a:extLst>
           </p:cNvPr>
@@ -9030,7 +9030,7 @@
           <p:cNvPr id="7" name="CuadroTexto 6">
             <a:extLst>
               <a:ext uri="{FF2B5EF4-FFF2-40B4-BE49-F238E27FC236}">
-                <a16:creationId xmlns:a16="http://schemas.microsoft.com/office/drawing/2014/main" id="{E3893FC0-9260-2BE5-6897-EBCF6E90A79A}"/>
+                <a16:creationId xmlns:a16="http://schemas.microsoft.com/office/drawing/2014/main" id="{82E33C88-4DB7-8906-3FC1-FDB4DBF69075}"/>
               </a:ext>
             </a:extLst>
           </p:cNvPr>
@@ -9070,7 +9070,7 @@
           <p:cNvPr id="8" name="CuadroTexto 7">
             <a:extLst>
               <a:ext uri="{FF2B5EF4-FFF2-40B4-BE49-F238E27FC236}">
-                <a16:creationId xmlns:a16="http://schemas.microsoft.com/office/drawing/2014/main" id="{3D0CC411-B7A5-03FF-536B-94D0CC3F3DF7}"/>
+                <a16:creationId xmlns:a16="http://schemas.microsoft.com/office/drawing/2014/main" id="{DF938DFF-9610-AC69-29B2-7C248A6DF573}"/>
               </a:ext>
             </a:extLst>
           </p:cNvPr>
@@ -9108,7 +9108,7 @@
     </p:spTree>
     <p:extLst>
       <p:ext uri="{BB962C8B-B14F-4D97-AF65-F5344CB8AC3E}">
-        <p14:creationId xmlns:p14="http://schemas.microsoft.com/office/powerpoint/2010/main" val="1139008739"/>
+        <p14:creationId xmlns:p14="http://schemas.microsoft.com/office/powerpoint/2010/main" val="4215167580"/>
       </p:ext>
     </p:extLst>
   </p:cSld>
@@ -9148,7 +9148,7 @@
           <p:cNvPr id="2" name="CuadroTexto 1">
             <a:extLst>
               <a:ext uri="{FF2B5EF4-FFF2-40B4-BE49-F238E27FC236}">
-                <a16:creationId xmlns:a16="http://schemas.microsoft.com/office/drawing/2014/main" id="{EB282940-06AF-EACF-B9EF-98EAC4F1730A}"/>
+                <a16:creationId xmlns:a16="http://schemas.microsoft.com/office/drawing/2014/main" id="{CBEC7AA4-81EF-2469-9784-24AB345E6FCF}"/>
               </a:ext>
             </a:extLst>
           </p:cNvPr>
@@ -9188,7 +9188,7 @@
           <p:cNvPr id="3" name="CuadroTexto 2">
             <a:extLst>
               <a:ext uri="{FF2B5EF4-FFF2-40B4-BE49-F238E27FC236}">
-                <a16:creationId xmlns:a16="http://schemas.microsoft.com/office/drawing/2014/main" id="{15F9AF63-03C5-94BF-46A3-CCE367DA3DF8}"/>
+                <a16:creationId xmlns:a16="http://schemas.microsoft.com/office/drawing/2014/main" id="{ABB9499E-2909-8385-F043-F1110E8C5036}"/>
               </a:ext>
             </a:extLst>
           </p:cNvPr>
@@ -9228,7 +9228,7 @@
           <p:cNvPr id="4" name="Rectángulo: esquinas redondeadas 3">
             <a:extLst>
               <a:ext uri="{FF2B5EF4-FFF2-40B4-BE49-F238E27FC236}">
-                <a16:creationId xmlns:a16="http://schemas.microsoft.com/office/drawing/2014/main" id="{9C5A765E-77D2-39CA-9FE8-5236C5063869}"/>
+                <a16:creationId xmlns:a16="http://schemas.microsoft.com/office/drawing/2014/main" id="{00214D9E-C2DD-EA2E-E4C7-CB32BA3850A5}"/>
               </a:ext>
             </a:extLst>
           </p:cNvPr>
@@ -9282,7 +9282,7 @@
           <p:cNvPr id="5" name="CuadroTexto 4">
             <a:extLst>
               <a:ext uri="{FF2B5EF4-FFF2-40B4-BE49-F238E27FC236}">
-                <a16:creationId xmlns:a16="http://schemas.microsoft.com/office/drawing/2014/main" id="{C64D6F7B-282D-42E2-323D-242932C9CF2E}"/>
+                <a16:creationId xmlns:a16="http://schemas.microsoft.com/office/drawing/2014/main" id="{24D3C474-9CC6-2446-2CAF-0E551791E94E}"/>
               </a:ext>
             </a:extLst>
           </p:cNvPr>
@@ -9322,7 +9322,7 @@
           <p:cNvPr id="6" name="CuadroTexto 5">
             <a:extLst>
               <a:ext uri="{FF2B5EF4-FFF2-40B4-BE49-F238E27FC236}">
-                <a16:creationId xmlns:a16="http://schemas.microsoft.com/office/drawing/2014/main" id="{C4A6B74D-5BB0-5B05-A7A4-594010C75DF8}"/>
+                <a16:creationId xmlns:a16="http://schemas.microsoft.com/office/drawing/2014/main" id="{C798D3C1-A2D5-4986-7C5F-6431932C8381}"/>
               </a:ext>
             </a:extLst>
           </p:cNvPr>
@@ -9362,7 +9362,7 @@
           <p:cNvPr id="7" name="Rectángulo: esquinas redondeadas 6">
             <a:extLst>
               <a:ext uri="{FF2B5EF4-FFF2-40B4-BE49-F238E27FC236}">
-                <a16:creationId xmlns:a16="http://schemas.microsoft.com/office/drawing/2014/main" id="{A0695082-FAC9-CB18-C611-34ECF60D6DC8}"/>
+                <a16:creationId xmlns:a16="http://schemas.microsoft.com/office/drawing/2014/main" id="{B228C5F9-AA92-80A4-74FD-47C8356DD9B2}"/>
               </a:ext>
             </a:extLst>
           </p:cNvPr>
@@ -9416,7 +9416,7 @@
           <p:cNvPr id="8" name="CuadroTexto 7">
             <a:extLst>
               <a:ext uri="{FF2B5EF4-FFF2-40B4-BE49-F238E27FC236}">
-                <a16:creationId xmlns:a16="http://schemas.microsoft.com/office/drawing/2014/main" id="{F0A03756-DD0A-5590-9EF0-14269100A1B2}"/>
+                <a16:creationId xmlns:a16="http://schemas.microsoft.com/office/drawing/2014/main" id="{7AC3E129-5CA3-4EF4-D9A4-7AE8CCDC34E0}"/>
               </a:ext>
             </a:extLst>
           </p:cNvPr>
@@ -9456,7 +9456,7 @@
           <p:cNvPr id="9" name="CuadroTexto 8">
             <a:extLst>
               <a:ext uri="{FF2B5EF4-FFF2-40B4-BE49-F238E27FC236}">
-                <a16:creationId xmlns:a16="http://schemas.microsoft.com/office/drawing/2014/main" id="{FED5F627-064E-D6AE-7EEB-66C69F38AA9B}"/>
+                <a16:creationId xmlns:a16="http://schemas.microsoft.com/office/drawing/2014/main" id="{AC0CFB52-B02C-D7B6-84A3-3809225BF347}"/>
               </a:ext>
             </a:extLst>
           </p:cNvPr>
@@ -9496,7 +9496,7 @@
           <p:cNvPr id="10" name="Rectángulo: esquinas redondeadas 9">
             <a:extLst>
               <a:ext uri="{FF2B5EF4-FFF2-40B4-BE49-F238E27FC236}">
-                <a16:creationId xmlns:a16="http://schemas.microsoft.com/office/drawing/2014/main" id="{2E7C599C-C567-24F9-0489-3F12FF1E0B13}"/>
+                <a16:creationId xmlns:a16="http://schemas.microsoft.com/office/drawing/2014/main" id="{29FE064D-A9BD-AB47-3541-3064BEBD6E1D}"/>
               </a:ext>
             </a:extLst>
           </p:cNvPr>
@@ -9550,7 +9550,7 @@
           <p:cNvPr id="11" name="CuadroTexto 10">
             <a:extLst>
               <a:ext uri="{FF2B5EF4-FFF2-40B4-BE49-F238E27FC236}">
-                <a16:creationId xmlns:a16="http://schemas.microsoft.com/office/drawing/2014/main" id="{9EFB9998-EF49-2DAD-5FF2-22B24B32D283}"/>
+                <a16:creationId xmlns:a16="http://schemas.microsoft.com/office/drawing/2014/main" id="{DEF7B20E-2DF7-2091-9F0F-AD9C6B7653BD}"/>
               </a:ext>
             </a:extLst>
           </p:cNvPr>
@@ -9590,7 +9590,7 @@
           <p:cNvPr id="12" name="CuadroTexto 11">
             <a:extLst>
               <a:ext uri="{FF2B5EF4-FFF2-40B4-BE49-F238E27FC236}">
-                <a16:creationId xmlns:a16="http://schemas.microsoft.com/office/drawing/2014/main" id="{4064AAC2-204A-7895-580F-3031DB56C64B}"/>
+                <a16:creationId xmlns:a16="http://schemas.microsoft.com/office/drawing/2014/main" id="{90867096-A9E8-5AA3-DA5F-E2181B8B5940}"/>
               </a:ext>
             </a:extLst>
           </p:cNvPr>
@@ -9630,7 +9630,7 @@
           <p:cNvPr id="13" name="Rectángulo: esquinas redondeadas 12">
             <a:extLst>
               <a:ext uri="{FF2B5EF4-FFF2-40B4-BE49-F238E27FC236}">
-                <a16:creationId xmlns:a16="http://schemas.microsoft.com/office/drawing/2014/main" id="{AB38D09A-E356-2F15-46F3-C30A5EF8A291}"/>
+                <a16:creationId xmlns:a16="http://schemas.microsoft.com/office/drawing/2014/main" id="{101673A6-FF1D-2843-A844-2FE2E60905B7}"/>
               </a:ext>
             </a:extLst>
           </p:cNvPr>
@@ -9684,7 +9684,7 @@
           <p:cNvPr id="14" name="CuadroTexto 13">
             <a:extLst>
               <a:ext uri="{FF2B5EF4-FFF2-40B4-BE49-F238E27FC236}">
-                <a16:creationId xmlns:a16="http://schemas.microsoft.com/office/drawing/2014/main" id="{CFAD3839-418F-29A8-1F51-C8C4180EE654}"/>
+                <a16:creationId xmlns:a16="http://schemas.microsoft.com/office/drawing/2014/main" id="{21BB2C5F-23EA-F264-6974-9C5B647EC529}"/>
               </a:ext>
             </a:extLst>
           </p:cNvPr>
@@ -9724,7 +9724,7 @@
           <p:cNvPr id="15" name="CuadroTexto 14">
             <a:extLst>
               <a:ext uri="{FF2B5EF4-FFF2-40B4-BE49-F238E27FC236}">
-                <a16:creationId xmlns:a16="http://schemas.microsoft.com/office/drawing/2014/main" id="{00AF941E-CE6A-35BA-0296-B0F61132C0ED}"/>
+                <a16:creationId xmlns:a16="http://schemas.microsoft.com/office/drawing/2014/main" id="{A8A3BF4F-5949-E8B5-5670-23DA30C81D1C}"/>
               </a:ext>
             </a:extLst>
           </p:cNvPr>
@@ -9762,7 +9762,7 @@
     </p:spTree>
     <p:extLst>
       <p:ext uri="{BB962C8B-B14F-4D97-AF65-F5344CB8AC3E}">
-        <p14:creationId xmlns:p14="http://schemas.microsoft.com/office/powerpoint/2010/main" val="3969965129"/>
+        <p14:creationId xmlns:p14="http://schemas.microsoft.com/office/powerpoint/2010/main" val="3051532885"/>
       </p:ext>
     </p:extLst>
   </p:cSld>
@@ -9802,7 +9802,7 @@
           <p:cNvPr id="2" name="CuadroTexto 1">
             <a:extLst>
               <a:ext uri="{FF2B5EF4-FFF2-40B4-BE49-F238E27FC236}">
-                <a16:creationId xmlns:a16="http://schemas.microsoft.com/office/drawing/2014/main" id="{89A44499-82FA-AD4A-8749-E056379C85C7}"/>
+                <a16:creationId xmlns:a16="http://schemas.microsoft.com/office/drawing/2014/main" id="{F9939E1B-1B81-476F-413F-903FA188E0CC}"/>
               </a:ext>
             </a:extLst>
           </p:cNvPr>
@@ -9842,7 +9842,7 @@
           <p:cNvPr id="3" name="CuadroTexto 2">
             <a:extLst>
               <a:ext uri="{FF2B5EF4-FFF2-40B4-BE49-F238E27FC236}">
-                <a16:creationId xmlns:a16="http://schemas.microsoft.com/office/drawing/2014/main" id="{01816A9D-F8FB-05A1-3843-06425420EA73}"/>
+                <a16:creationId xmlns:a16="http://schemas.microsoft.com/office/drawing/2014/main" id="{83AEA742-41F0-5830-6E5B-998840A3683F}"/>
               </a:ext>
             </a:extLst>
           </p:cNvPr>
@@ -9882,7 +9882,7 @@
           <p:cNvPr id="4" name="CuadroTexto 3">
             <a:extLst>
               <a:ext uri="{FF2B5EF4-FFF2-40B4-BE49-F238E27FC236}">
-                <a16:creationId xmlns:a16="http://schemas.microsoft.com/office/drawing/2014/main" id="{0D18DDB0-6236-98AA-7A9D-AF510D6F084F}"/>
+                <a16:creationId xmlns:a16="http://schemas.microsoft.com/office/drawing/2014/main" id="{24626C56-D53D-8E20-1BC8-490C3A909C38}"/>
               </a:ext>
             </a:extLst>
           </p:cNvPr>
@@ -9922,7 +9922,7 @@
           <p:cNvPr id="6" name="Imagen 5">
             <a:extLst>
               <a:ext uri="{FF2B5EF4-FFF2-40B4-BE49-F238E27FC236}">
-                <a16:creationId xmlns:a16="http://schemas.microsoft.com/office/drawing/2014/main" id="{2CA841F4-0C11-F86B-BD84-3949EC6B9A82}"/>
+                <a16:creationId xmlns:a16="http://schemas.microsoft.com/office/drawing/2014/main" id="{B762B756-0677-432F-71D0-BECB80629634}"/>
               </a:ext>
             </a:extLst>
           </p:cNvPr>
@@ -9963,7 +9963,7 @@
           <p:cNvPr id="7" name="CuadroTexto 6">
             <a:extLst>
               <a:ext uri="{FF2B5EF4-FFF2-40B4-BE49-F238E27FC236}">
-                <a16:creationId xmlns:a16="http://schemas.microsoft.com/office/drawing/2014/main" id="{4A4A7ECA-E196-B9FD-12A9-8A4BDB89A408}"/>
+                <a16:creationId xmlns:a16="http://schemas.microsoft.com/office/drawing/2014/main" id="{324DCFCD-49EF-3195-E6FB-8A6238B61883}"/>
               </a:ext>
             </a:extLst>
           </p:cNvPr>
@@ -10080,7 +10080,7 @@
     </p:spTree>
     <p:extLst>
       <p:ext uri="{BB962C8B-B14F-4D97-AF65-F5344CB8AC3E}">
-        <p14:creationId xmlns:p14="http://schemas.microsoft.com/office/powerpoint/2010/main" val="2886672413"/>
+        <p14:creationId xmlns:p14="http://schemas.microsoft.com/office/powerpoint/2010/main" val="2286205627"/>
       </p:ext>
     </p:extLst>
   </p:cSld>
@@ -10120,7 +10120,7 @@
           <p:cNvPr id="2" name="CuadroTexto 1">
             <a:extLst>
               <a:ext uri="{FF2B5EF4-FFF2-40B4-BE49-F238E27FC236}">
-                <a16:creationId xmlns:a16="http://schemas.microsoft.com/office/drawing/2014/main" id="{9E6DC61B-22FB-E1A2-867F-2CD288BC8FBD}"/>
+                <a16:creationId xmlns:a16="http://schemas.microsoft.com/office/drawing/2014/main" id="{8E19BC6A-65AF-E39F-05D5-8CAD3073325C}"/>
               </a:ext>
             </a:extLst>
           </p:cNvPr>
@@ -10160,7 +10160,7 @@
           <p:cNvPr id="3" name="CuadroTexto 2">
             <a:extLst>
               <a:ext uri="{FF2B5EF4-FFF2-40B4-BE49-F238E27FC236}">
-                <a16:creationId xmlns:a16="http://schemas.microsoft.com/office/drawing/2014/main" id="{01FE1F73-538C-6D2B-85BA-01E5B4A1B367}"/>
+                <a16:creationId xmlns:a16="http://schemas.microsoft.com/office/drawing/2014/main" id="{E41AD3E0-72D6-D3DD-F994-1D3CAB682462}"/>
               </a:ext>
             </a:extLst>
           </p:cNvPr>
@@ -10200,7 +10200,7 @@
           <p:cNvPr id="5" name="Imagen 4">
             <a:extLst>
               <a:ext uri="{FF2B5EF4-FFF2-40B4-BE49-F238E27FC236}">
-                <a16:creationId xmlns:a16="http://schemas.microsoft.com/office/drawing/2014/main" id="{DFD935C8-1B76-0A55-9A90-29C598D66E32}"/>
+                <a16:creationId xmlns:a16="http://schemas.microsoft.com/office/drawing/2014/main" id="{DA7B3142-ECBA-E906-D98A-A2E54830F2E0}"/>
               </a:ext>
             </a:extLst>
           </p:cNvPr>
@@ -10241,7 +10241,7 @@
           <p:cNvPr id="6" name="CuadroTexto 5">
             <a:extLst>
               <a:ext uri="{FF2B5EF4-FFF2-40B4-BE49-F238E27FC236}">
-                <a16:creationId xmlns:a16="http://schemas.microsoft.com/office/drawing/2014/main" id="{900F6E40-7E9D-FA0E-85A4-DCF195F305C5}"/>
+                <a16:creationId xmlns:a16="http://schemas.microsoft.com/office/drawing/2014/main" id="{E07A5D5B-CCCB-54C6-625C-8F92B2896F54}"/>
               </a:ext>
             </a:extLst>
           </p:cNvPr>
@@ -10281,7 +10281,7 @@
           <p:cNvPr id="7" name="CuadroTexto 6">
             <a:extLst>
               <a:ext uri="{FF2B5EF4-FFF2-40B4-BE49-F238E27FC236}">
-                <a16:creationId xmlns:a16="http://schemas.microsoft.com/office/drawing/2014/main" id="{D17C8830-9864-5F88-2B81-164A5855DA5F}"/>
+                <a16:creationId xmlns:a16="http://schemas.microsoft.com/office/drawing/2014/main" id="{90F97448-9487-DD3C-59A2-19BEC488E8BE}"/>
               </a:ext>
             </a:extLst>
           </p:cNvPr>
@@ -10380,7 +10380,7 @@
     </p:spTree>
     <p:extLst>
       <p:ext uri="{BB962C8B-B14F-4D97-AF65-F5344CB8AC3E}">
-        <p14:creationId xmlns:p14="http://schemas.microsoft.com/office/powerpoint/2010/main" val="197158713"/>
+        <p14:creationId xmlns:p14="http://schemas.microsoft.com/office/powerpoint/2010/main" val="4129019177"/>
       </p:ext>
     </p:extLst>
   </p:cSld>
@@ -10420,7 +10420,7 @@
           <p:cNvPr id="2" name="CuadroTexto 1">
             <a:extLst>
               <a:ext uri="{FF2B5EF4-FFF2-40B4-BE49-F238E27FC236}">
-                <a16:creationId xmlns:a16="http://schemas.microsoft.com/office/drawing/2014/main" id="{A4B90C54-59B9-29C1-FAB1-6D06BEC83C67}"/>
+                <a16:creationId xmlns:a16="http://schemas.microsoft.com/office/drawing/2014/main" id="{E4A11209-CAC7-C8A5-A2F2-18CA3541D221}"/>
               </a:ext>
             </a:extLst>
           </p:cNvPr>
@@ -10460,7 +10460,7 @@
           <p:cNvPr id="3" name="CuadroTexto 2">
             <a:extLst>
               <a:ext uri="{FF2B5EF4-FFF2-40B4-BE49-F238E27FC236}">
-                <a16:creationId xmlns:a16="http://schemas.microsoft.com/office/drawing/2014/main" id="{B4201F9F-E495-1A34-E813-7CEB643A52E1}"/>
+                <a16:creationId xmlns:a16="http://schemas.microsoft.com/office/drawing/2014/main" id="{EC70755B-C845-6DF4-2939-11EB004A05D0}"/>
               </a:ext>
             </a:extLst>
           </p:cNvPr>
@@ -10500,7 +10500,7 @@
           <p:cNvPr id="4" name="CuadroTexto 3">
             <a:extLst>
               <a:ext uri="{FF2B5EF4-FFF2-40B4-BE49-F238E27FC236}">
-                <a16:creationId xmlns:a16="http://schemas.microsoft.com/office/drawing/2014/main" id="{94FC1F65-6350-4E16-6CA9-97F7559A79B2}"/>
+                <a16:creationId xmlns:a16="http://schemas.microsoft.com/office/drawing/2014/main" id="{742BC8AC-E592-65F1-04AB-FBD809643C13}"/>
               </a:ext>
             </a:extLst>
           </p:cNvPr>
@@ -10540,7 +10540,7 @@
           <p:cNvPr id="6" name="Imagen 5">
             <a:extLst>
               <a:ext uri="{FF2B5EF4-FFF2-40B4-BE49-F238E27FC236}">
-                <a16:creationId xmlns:a16="http://schemas.microsoft.com/office/drawing/2014/main" id="{18EF20F3-E98B-C65B-5E7B-11E87999C950}"/>
+                <a16:creationId xmlns:a16="http://schemas.microsoft.com/office/drawing/2014/main" id="{05A2D297-BAC3-6453-8D8A-E27A4CE36A1E}"/>
               </a:ext>
             </a:extLst>
           </p:cNvPr>
@@ -10581,7 +10581,7 @@
           <p:cNvPr id="7" name="Rectángulo: esquinas redondeadas 6">
             <a:extLst>
               <a:ext uri="{FF2B5EF4-FFF2-40B4-BE49-F238E27FC236}">
-                <a16:creationId xmlns:a16="http://schemas.microsoft.com/office/drawing/2014/main" id="{90921B6D-BF60-4A96-32E7-556ABB908AAB}"/>
+                <a16:creationId xmlns:a16="http://schemas.microsoft.com/office/drawing/2014/main" id="{E9F3FFA1-AFBB-D710-928D-153EBCD7CC42}"/>
               </a:ext>
             </a:extLst>
           </p:cNvPr>
@@ -10635,7 +10635,7 @@
           <p:cNvPr id="8" name="CuadroTexto 7">
             <a:extLst>
               <a:ext uri="{FF2B5EF4-FFF2-40B4-BE49-F238E27FC236}">
-                <a16:creationId xmlns:a16="http://schemas.microsoft.com/office/drawing/2014/main" id="{C1D36378-35A6-CE30-0376-63404731523E}"/>
+                <a16:creationId xmlns:a16="http://schemas.microsoft.com/office/drawing/2014/main" id="{8CE8D4FA-5926-7692-802D-1D74CAF809CC}"/>
               </a:ext>
             </a:extLst>
           </p:cNvPr>
@@ -10675,7 +10675,7 @@
           <p:cNvPr id="9" name="CuadroTexto 8">
             <a:extLst>
               <a:ext uri="{FF2B5EF4-FFF2-40B4-BE49-F238E27FC236}">
-                <a16:creationId xmlns:a16="http://schemas.microsoft.com/office/drawing/2014/main" id="{29563791-87A4-F2A8-21E7-A2B85BEEDA13}"/>
+                <a16:creationId xmlns:a16="http://schemas.microsoft.com/office/drawing/2014/main" id="{AAD28811-FBD8-63EB-67C1-D67092E802BC}"/>
               </a:ext>
             </a:extLst>
           </p:cNvPr>
@@ -10715,7 +10715,7 @@
           <p:cNvPr id="10" name="Rectángulo: esquinas redondeadas 9">
             <a:extLst>
               <a:ext uri="{FF2B5EF4-FFF2-40B4-BE49-F238E27FC236}">
-                <a16:creationId xmlns:a16="http://schemas.microsoft.com/office/drawing/2014/main" id="{A7B22E91-588B-FC7C-0E00-7B1C1C793752}"/>
+                <a16:creationId xmlns:a16="http://schemas.microsoft.com/office/drawing/2014/main" id="{4F13AADD-2FE5-C63F-1C53-993D8C11C3CD}"/>
               </a:ext>
             </a:extLst>
           </p:cNvPr>
@@ -10769,7 +10769,7 @@
           <p:cNvPr id="11" name="CuadroTexto 10">
             <a:extLst>
               <a:ext uri="{FF2B5EF4-FFF2-40B4-BE49-F238E27FC236}">
-                <a16:creationId xmlns:a16="http://schemas.microsoft.com/office/drawing/2014/main" id="{8196D7ED-BA84-4FF1-2EA1-86A31C7DCA9C}"/>
+                <a16:creationId xmlns:a16="http://schemas.microsoft.com/office/drawing/2014/main" id="{D25768D6-11BE-99D0-921E-DD2DCCC6F000}"/>
               </a:ext>
             </a:extLst>
           </p:cNvPr>
@@ -10809,7 +10809,7 @@
           <p:cNvPr id="12" name="CuadroTexto 11">
             <a:extLst>
               <a:ext uri="{FF2B5EF4-FFF2-40B4-BE49-F238E27FC236}">
-                <a16:creationId xmlns:a16="http://schemas.microsoft.com/office/drawing/2014/main" id="{C42F4661-0F9E-E635-545C-CF94776D7859}"/>
+                <a16:creationId xmlns:a16="http://schemas.microsoft.com/office/drawing/2014/main" id="{EE0293A7-6372-1514-929F-4B95306EB22B}"/>
               </a:ext>
             </a:extLst>
           </p:cNvPr>
@@ -10849,7 +10849,7 @@
           <p:cNvPr id="13" name="Rectángulo: esquinas redondeadas 12">
             <a:extLst>
               <a:ext uri="{FF2B5EF4-FFF2-40B4-BE49-F238E27FC236}">
-                <a16:creationId xmlns:a16="http://schemas.microsoft.com/office/drawing/2014/main" id="{F35086C4-5C5A-A103-567B-81B3845CC0F9}"/>
+                <a16:creationId xmlns:a16="http://schemas.microsoft.com/office/drawing/2014/main" id="{42806D98-5D94-B821-EF2B-F62242900F6C}"/>
               </a:ext>
             </a:extLst>
           </p:cNvPr>
@@ -10903,7 +10903,7 @@
           <p:cNvPr id="14" name="CuadroTexto 13">
             <a:extLst>
               <a:ext uri="{FF2B5EF4-FFF2-40B4-BE49-F238E27FC236}">
-                <a16:creationId xmlns:a16="http://schemas.microsoft.com/office/drawing/2014/main" id="{A624BE0A-6486-09A5-D1F6-BC4DA4479ABB}"/>
+                <a16:creationId xmlns:a16="http://schemas.microsoft.com/office/drawing/2014/main" id="{D0893BA7-D647-8606-0E5E-688994CED508}"/>
               </a:ext>
             </a:extLst>
           </p:cNvPr>
@@ -10943,7 +10943,7 @@
           <p:cNvPr id="15" name="CuadroTexto 14">
             <a:extLst>
               <a:ext uri="{FF2B5EF4-FFF2-40B4-BE49-F238E27FC236}">
-                <a16:creationId xmlns:a16="http://schemas.microsoft.com/office/drawing/2014/main" id="{464CC48B-2885-0574-D2A6-FD83124CF8D7}"/>
+                <a16:creationId xmlns:a16="http://schemas.microsoft.com/office/drawing/2014/main" id="{ECB0A65C-F63E-5F80-8260-587DDCD9B03B}"/>
               </a:ext>
             </a:extLst>
           </p:cNvPr>
@@ -10981,7 +10981,7 @@
     </p:spTree>
     <p:extLst>
       <p:ext uri="{BB962C8B-B14F-4D97-AF65-F5344CB8AC3E}">
-        <p14:creationId xmlns:p14="http://schemas.microsoft.com/office/powerpoint/2010/main" val="1870687457"/>
+        <p14:creationId xmlns:p14="http://schemas.microsoft.com/office/powerpoint/2010/main" val="3497341586"/>
       </p:ext>
     </p:extLst>
   </p:cSld>
@@ -11021,7 +11021,7 @@
           <p:cNvPr id="2" name="CuadroTexto 1">
             <a:extLst>
               <a:ext uri="{FF2B5EF4-FFF2-40B4-BE49-F238E27FC236}">
-                <a16:creationId xmlns:a16="http://schemas.microsoft.com/office/drawing/2014/main" id="{DDA2E44B-4012-D66E-6975-B2B82BC52A62}"/>
+                <a16:creationId xmlns:a16="http://schemas.microsoft.com/office/drawing/2014/main" id="{BA79D961-E08F-4858-96FA-A6D8C7A8D870}"/>
               </a:ext>
             </a:extLst>
           </p:cNvPr>
@@ -11061,7 +11061,7 @@
           <p:cNvPr id="3" name="CuadroTexto 2">
             <a:extLst>
               <a:ext uri="{FF2B5EF4-FFF2-40B4-BE49-F238E27FC236}">
-                <a16:creationId xmlns:a16="http://schemas.microsoft.com/office/drawing/2014/main" id="{93D4E4D9-0C09-D458-F63D-CE83E122ABA4}"/>
+                <a16:creationId xmlns:a16="http://schemas.microsoft.com/office/drawing/2014/main" id="{0B1B2539-7EAA-D965-8623-42F44415337C}"/>
               </a:ext>
             </a:extLst>
           </p:cNvPr>
@@ -11101,7 +11101,7 @@
           <p:cNvPr id="5" name="Imagen 4">
             <a:extLst>
               <a:ext uri="{FF2B5EF4-FFF2-40B4-BE49-F238E27FC236}">
-                <a16:creationId xmlns:a16="http://schemas.microsoft.com/office/drawing/2014/main" id="{18BEFF83-73E1-6C40-6A3C-93391239A02B}"/>
+                <a16:creationId xmlns:a16="http://schemas.microsoft.com/office/drawing/2014/main" id="{22AA2E8A-CB30-4029-91C4-1E1CB880F8ED}"/>
               </a:ext>
             </a:extLst>
           </p:cNvPr>
@@ -11142,7 +11142,7 @@
           <p:cNvPr id="6" name="CuadroTexto 5">
             <a:extLst>
               <a:ext uri="{FF2B5EF4-FFF2-40B4-BE49-F238E27FC236}">
-                <a16:creationId xmlns:a16="http://schemas.microsoft.com/office/drawing/2014/main" id="{6DC0D98C-C30B-C13D-83C8-7ACD64420E8C}"/>
+                <a16:creationId xmlns:a16="http://schemas.microsoft.com/office/drawing/2014/main" id="{6DA13D5F-1396-1564-4634-76D19C7A308F}"/>
               </a:ext>
             </a:extLst>
           </p:cNvPr>
@@ -11241,7 +11241,7 @@
     </p:spTree>
     <p:extLst>
       <p:ext uri="{BB962C8B-B14F-4D97-AF65-F5344CB8AC3E}">
-        <p14:creationId xmlns:p14="http://schemas.microsoft.com/office/powerpoint/2010/main" val="2218698971"/>
+        <p14:creationId xmlns:p14="http://schemas.microsoft.com/office/powerpoint/2010/main" val="678131088"/>
       </p:ext>
     </p:extLst>
   </p:cSld>
@@ -11281,7 +11281,7 @@
           <p:cNvPr id="2" name="CuadroTexto 1">
             <a:extLst>
               <a:ext uri="{FF2B5EF4-FFF2-40B4-BE49-F238E27FC236}">
-                <a16:creationId xmlns:a16="http://schemas.microsoft.com/office/drawing/2014/main" id="{B1C050A0-6921-B6D2-E5BC-322E6A06C535}"/>
+                <a16:creationId xmlns:a16="http://schemas.microsoft.com/office/drawing/2014/main" id="{5C7D87DD-29AA-3C83-3C1E-2E4867E61651}"/>
               </a:ext>
             </a:extLst>
           </p:cNvPr>
@@ -11321,7 +11321,7 @@
           <p:cNvPr id="3" name="CuadroTexto 2">
             <a:extLst>
               <a:ext uri="{FF2B5EF4-FFF2-40B4-BE49-F238E27FC236}">
-                <a16:creationId xmlns:a16="http://schemas.microsoft.com/office/drawing/2014/main" id="{D1F9578E-E5F3-F489-7A6C-0F09A15693A0}"/>
+                <a16:creationId xmlns:a16="http://schemas.microsoft.com/office/drawing/2014/main" id="{67FA38A7-5B0E-EC4C-0298-DE5CD5D77697}"/>
               </a:ext>
             </a:extLst>
           </p:cNvPr>
@@ -11361,7 +11361,7 @@
           <p:cNvPr id="4" name="CuadroTexto 3">
             <a:extLst>
               <a:ext uri="{FF2B5EF4-FFF2-40B4-BE49-F238E27FC236}">
-                <a16:creationId xmlns:a16="http://schemas.microsoft.com/office/drawing/2014/main" id="{990C8A9D-CD87-1FFD-5E15-65B60B1DBB25}"/>
+                <a16:creationId xmlns:a16="http://schemas.microsoft.com/office/drawing/2014/main" id="{4132B8C2-F411-3FC4-6FD2-5C9336F710F1}"/>
               </a:ext>
             </a:extLst>
           </p:cNvPr>
@@ -11401,7 +11401,7 @@
           <p:cNvPr id="6" name="Imagen 5">
             <a:extLst>
               <a:ext uri="{FF2B5EF4-FFF2-40B4-BE49-F238E27FC236}">
-                <a16:creationId xmlns:a16="http://schemas.microsoft.com/office/drawing/2014/main" id="{F69E3CA6-3A0C-BE56-5837-2AB59D2E3372}"/>
+                <a16:creationId xmlns:a16="http://schemas.microsoft.com/office/drawing/2014/main" id="{63E56FE5-2A74-A348-92BC-49322CFF666E}"/>
               </a:ext>
             </a:extLst>
           </p:cNvPr>
@@ -11442,7 +11442,7 @@
           <p:cNvPr id="7" name="Rectángulo: esquinas redondeadas 6">
             <a:extLst>
               <a:ext uri="{FF2B5EF4-FFF2-40B4-BE49-F238E27FC236}">
-                <a16:creationId xmlns:a16="http://schemas.microsoft.com/office/drawing/2014/main" id="{12E779A8-11E5-B8DE-D05C-84B751D5CE51}"/>
+                <a16:creationId xmlns:a16="http://schemas.microsoft.com/office/drawing/2014/main" id="{D4FF35B6-A579-E4EF-DD81-7260D14BE468}"/>
               </a:ext>
             </a:extLst>
           </p:cNvPr>
@@ -11496,7 +11496,7 @@
           <p:cNvPr id="8" name="CuadroTexto 7">
             <a:extLst>
               <a:ext uri="{FF2B5EF4-FFF2-40B4-BE49-F238E27FC236}">
-                <a16:creationId xmlns:a16="http://schemas.microsoft.com/office/drawing/2014/main" id="{B7F5F231-6468-A042-3C34-FAD44DBFA31F}"/>
+                <a16:creationId xmlns:a16="http://schemas.microsoft.com/office/drawing/2014/main" id="{4B3CFD33-CF6F-DD39-17F3-EFFA9309B7D8}"/>
               </a:ext>
             </a:extLst>
           </p:cNvPr>
@@ -11536,7 +11536,7 @@
           <p:cNvPr id="9" name="CuadroTexto 8">
             <a:extLst>
               <a:ext uri="{FF2B5EF4-FFF2-40B4-BE49-F238E27FC236}">
-                <a16:creationId xmlns:a16="http://schemas.microsoft.com/office/drawing/2014/main" id="{D84EEE23-CEDA-1DAE-11AC-C5FD47E0FA98}"/>
+                <a16:creationId xmlns:a16="http://schemas.microsoft.com/office/drawing/2014/main" id="{524415CD-C69E-A89C-4E9C-2B561DB05EC9}"/>
               </a:ext>
             </a:extLst>
           </p:cNvPr>
@@ -11574,7 +11574,7 @@
     </p:spTree>
     <p:extLst>
       <p:ext uri="{BB962C8B-B14F-4D97-AF65-F5344CB8AC3E}">
-        <p14:creationId xmlns:p14="http://schemas.microsoft.com/office/powerpoint/2010/main" val="3688929477"/>
+        <p14:creationId xmlns:p14="http://schemas.microsoft.com/office/powerpoint/2010/main" val="1537109807"/>
       </p:ext>
     </p:extLst>
   </p:cSld>
@@ -11614,7 +11614,7 @@
           <p:cNvPr id="2" name="CuadroTexto 1">
             <a:extLst>
               <a:ext uri="{FF2B5EF4-FFF2-40B4-BE49-F238E27FC236}">
-                <a16:creationId xmlns:a16="http://schemas.microsoft.com/office/drawing/2014/main" id="{49C87107-47D5-FE8D-53D3-4804744F9A18}"/>
+                <a16:creationId xmlns:a16="http://schemas.microsoft.com/office/drawing/2014/main" id="{A82CDF45-685F-7AAC-08B4-C42229D107FF}"/>
               </a:ext>
             </a:extLst>
           </p:cNvPr>
@@ -11654,7 +11654,7 @@
           <p:cNvPr id="3" name="CuadroTexto 2">
             <a:extLst>
               <a:ext uri="{FF2B5EF4-FFF2-40B4-BE49-F238E27FC236}">
-                <a16:creationId xmlns:a16="http://schemas.microsoft.com/office/drawing/2014/main" id="{A8838B2B-EE8B-4F9D-3A7D-F40AE960843F}"/>
+                <a16:creationId xmlns:a16="http://schemas.microsoft.com/office/drawing/2014/main" id="{62694766-9C70-301A-7117-01EEAA15FDA1}"/>
               </a:ext>
             </a:extLst>
           </p:cNvPr>
@@ -11694,7 +11694,7 @@
           <p:cNvPr id="4" name="CuadroTexto 3">
             <a:extLst>
               <a:ext uri="{FF2B5EF4-FFF2-40B4-BE49-F238E27FC236}">
-                <a16:creationId xmlns:a16="http://schemas.microsoft.com/office/drawing/2014/main" id="{5020C065-38A9-66E8-A3E3-560223338CC8}"/>
+                <a16:creationId xmlns:a16="http://schemas.microsoft.com/office/drawing/2014/main" id="{3EEA0B73-29BE-2136-E44B-B589317BD148}"/>
               </a:ext>
             </a:extLst>
           </p:cNvPr>
@@ -11734,7 +11734,7 @@
           <p:cNvPr id="5" name="Rectángulo: esquinas redondeadas 4">
             <a:extLst>
               <a:ext uri="{FF2B5EF4-FFF2-40B4-BE49-F238E27FC236}">
-                <a16:creationId xmlns:a16="http://schemas.microsoft.com/office/drawing/2014/main" id="{CA005563-89EA-808E-66D0-B732EA8AB31E}"/>
+                <a16:creationId xmlns:a16="http://schemas.microsoft.com/office/drawing/2014/main" id="{76539E62-22C0-70CC-83B3-841E6281B192}"/>
               </a:ext>
             </a:extLst>
           </p:cNvPr>
@@ -11788,7 +11788,7 @@
           <p:cNvPr id="6" name="CuadroTexto 5">
             <a:extLst>
               <a:ext uri="{FF2B5EF4-FFF2-40B4-BE49-F238E27FC236}">
-                <a16:creationId xmlns:a16="http://schemas.microsoft.com/office/drawing/2014/main" id="{F3C41619-89A7-4796-5D5B-A388B8F27FDF}"/>
+                <a16:creationId xmlns:a16="http://schemas.microsoft.com/office/drawing/2014/main" id="{49AE26AD-3519-5EFA-7ECE-0A0834F2347C}"/>
               </a:ext>
             </a:extLst>
           </p:cNvPr>
@@ -11828,7 +11828,7 @@
           <p:cNvPr id="7" name="CuadroTexto 6">
             <a:extLst>
               <a:ext uri="{FF2B5EF4-FFF2-40B4-BE49-F238E27FC236}">
-                <a16:creationId xmlns:a16="http://schemas.microsoft.com/office/drawing/2014/main" id="{8751DD6A-2E23-0880-F2B8-F6A50A3459AD}"/>
+                <a16:creationId xmlns:a16="http://schemas.microsoft.com/office/drawing/2014/main" id="{E4FA83F1-ED90-227D-7868-A89C5CCCD954}"/>
               </a:ext>
             </a:extLst>
           </p:cNvPr>
@@ -11868,7 +11868,7 @@
           <p:cNvPr id="8" name="Rectángulo: esquinas redondeadas 7">
             <a:extLst>
               <a:ext uri="{FF2B5EF4-FFF2-40B4-BE49-F238E27FC236}">
-                <a16:creationId xmlns:a16="http://schemas.microsoft.com/office/drawing/2014/main" id="{578B8247-503E-4F06-3EDD-AE07D2D3EB52}"/>
+                <a16:creationId xmlns:a16="http://schemas.microsoft.com/office/drawing/2014/main" id="{CD0E7F07-06E8-14CF-56C0-549B3119A75E}"/>
               </a:ext>
             </a:extLst>
           </p:cNvPr>
@@ -11922,7 +11922,7 @@
           <p:cNvPr id="9" name="CuadroTexto 8">
             <a:extLst>
               <a:ext uri="{FF2B5EF4-FFF2-40B4-BE49-F238E27FC236}">
-                <a16:creationId xmlns:a16="http://schemas.microsoft.com/office/drawing/2014/main" id="{1232DF11-5F2E-8CA0-850C-E8C964B528F1}"/>
+                <a16:creationId xmlns:a16="http://schemas.microsoft.com/office/drawing/2014/main" id="{28BB2100-C35C-6C35-E119-EEE46D92A578}"/>
               </a:ext>
             </a:extLst>
           </p:cNvPr>
@@ -11962,7 +11962,7 @@
           <p:cNvPr id="10" name="CuadroTexto 9">
             <a:extLst>
               <a:ext uri="{FF2B5EF4-FFF2-40B4-BE49-F238E27FC236}">
-                <a16:creationId xmlns:a16="http://schemas.microsoft.com/office/drawing/2014/main" id="{3ACD2940-8FD0-C488-D977-677F9130B1EB}"/>
+                <a16:creationId xmlns:a16="http://schemas.microsoft.com/office/drawing/2014/main" id="{C861713D-F9D0-29AE-B9F8-852E6B84D2CD}"/>
               </a:ext>
             </a:extLst>
           </p:cNvPr>
@@ -12002,7 +12002,7 @@
           <p:cNvPr id="11" name="Rectángulo: esquinas redondeadas 10">
             <a:extLst>
               <a:ext uri="{FF2B5EF4-FFF2-40B4-BE49-F238E27FC236}">
-                <a16:creationId xmlns:a16="http://schemas.microsoft.com/office/drawing/2014/main" id="{15CBE82E-1E6B-A600-D53B-93CFF6F37C14}"/>
+                <a16:creationId xmlns:a16="http://schemas.microsoft.com/office/drawing/2014/main" id="{29C698F1-A941-03C9-E5C9-BB90546C39A8}"/>
               </a:ext>
             </a:extLst>
           </p:cNvPr>
@@ -12056,7 +12056,7 @@
           <p:cNvPr id="12" name="CuadroTexto 11">
             <a:extLst>
               <a:ext uri="{FF2B5EF4-FFF2-40B4-BE49-F238E27FC236}">
-                <a16:creationId xmlns:a16="http://schemas.microsoft.com/office/drawing/2014/main" id="{86DBF4D4-AF3C-1CAE-AAE3-7BC33D03EEB5}"/>
+                <a16:creationId xmlns:a16="http://schemas.microsoft.com/office/drawing/2014/main" id="{6AB9EB41-0047-5D02-73E3-79D9681D7C5D}"/>
               </a:ext>
             </a:extLst>
           </p:cNvPr>
@@ -12096,7 +12096,7 @@
           <p:cNvPr id="13" name="CuadroTexto 12">
             <a:extLst>
               <a:ext uri="{FF2B5EF4-FFF2-40B4-BE49-F238E27FC236}">
-                <a16:creationId xmlns:a16="http://schemas.microsoft.com/office/drawing/2014/main" id="{30321472-DAB2-7B8C-BB47-82C42B9E4A11}"/>
+                <a16:creationId xmlns:a16="http://schemas.microsoft.com/office/drawing/2014/main" id="{90880360-89E0-AC87-5EE9-13D356B06051}"/>
               </a:ext>
             </a:extLst>
           </p:cNvPr>
@@ -12136,7 +12136,7 @@
           <p:cNvPr id="14" name="Rectángulo: esquinas redondeadas 13">
             <a:extLst>
               <a:ext uri="{FF2B5EF4-FFF2-40B4-BE49-F238E27FC236}">
-                <a16:creationId xmlns:a16="http://schemas.microsoft.com/office/drawing/2014/main" id="{2AD96489-76F8-B559-03A5-362580CF8A66}"/>
+                <a16:creationId xmlns:a16="http://schemas.microsoft.com/office/drawing/2014/main" id="{F15BF842-35C3-E6AE-0E2D-44A3C8B3B4AE}"/>
               </a:ext>
             </a:extLst>
           </p:cNvPr>
@@ -12190,7 +12190,7 @@
           <p:cNvPr id="15" name="CuadroTexto 14">
             <a:extLst>
               <a:ext uri="{FF2B5EF4-FFF2-40B4-BE49-F238E27FC236}">
-                <a16:creationId xmlns:a16="http://schemas.microsoft.com/office/drawing/2014/main" id="{1642DD86-CB6A-421C-E05C-4E3CEC17DC81}"/>
+                <a16:creationId xmlns:a16="http://schemas.microsoft.com/office/drawing/2014/main" id="{8B3CEDB2-FFC3-471B-A290-01DB236A748C}"/>
               </a:ext>
             </a:extLst>
           </p:cNvPr>
@@ -12230,7 +12230,7 @@
           <p:cNvPr id="16" name="CuadroTexto 15">
             <a:extLst>
               <a:ext uri="{FF2B5EF4-FFF2-40B4-BE49-F238E27FC236}">
-                <a16:creationId xmlns:a16="http://schemas.microsoft.com/office/drawing/2014/main" id="{F6845773-DC4E-F31C-1C48-67C044F73A55}"/>
+                <a16:creationId xmlns:a16="http://schemas.microsoft.com/office/drawing/2014/main" id="{BF7426E8-7C20-5AD0-0D23-49A0DDC3702C}"/>
               </a:ext>
             </a:extLst>
           </p:cNvPr>
@@ -12270,7 +12270,7 @@
           <p:cNvPr id="17" name="Rectángulo: esquinas redondeadas 16">
             <a:extLst>
               <a:ext uri="{FF2B5EF4-FFF2-40B4-BE49-F238E27FC236}">
-                <a16:creationId xmlns:a16="http://schemas.microsoft.com/office/drawing/2014/main" id="{84B96BE3-B71E-71C8-C5CB-0FDA0651AFB8}"/>
+                <a16:creationId xmlns:a16="http://schemas.microsoft.com/office/drawing/2014/main" id="{1ACC399E-2A95-0D97-985F-0B379863B5B7}"/>
               </a:ext>
             </a:extLst>
           </p:cNvPr>
@@ -12324,7 +12324,7 @@
           <p:cNvPr id="18" name="CuadroTexto 17">
             <a:extLst>
               <a:ext uri="{FF2B5EF4-FFF2-40B4-BE49-F238E27FC236}">
-                <a16:creationId xmlns:a16="http://schemas.microsoft.com/office/drawing/2014/main" id="{7856000A-BCF8-C231-784A-B191622AB285}"/>
+                <a16:creationId xmlns:a16="http://schemas.microsoft.com/office/drawing/2014/main" id="{0C2998C9-6035-E014-9090-5565E6E4252B}"/>
               </a:ext>
             </a:extLst>
           </p:cNvPr>
@@ -12364,7 +12364,7 @@
           <p:cNvPr id="19" name="CuadroTexto 18">
             <a:extLst>
               <a:ext uri="{FF2B5EF4-FFF2-40B4-BE49-F238E27FC236}">
-                <a16:creationId xmlns:a16="http://schemas.microsoft.com/office/drawing/2014/main" id="{8C446BC0-B203-434D-5198-E611C650F74F}"/>
+                <a16:creationId xmlns:a16="http://schemas.microsoft.com/office/drawing/2014/main" id="{F87FFE9B-DF91-5AB5-070F-65CFCE153E56}"/>
               </a:ext>
             </a:extLst>
           </p:cNvPr>
@@ -12404,7 +12404,7 @@
           <p:cNvPr id="20" name="Rectángulo: esquinas redondeadas 19">
             <a:extLst>
               <a:ext uri="{FF2B5EF4-FFF2-40B4-BE49-F238E27FC236}">
-                <a16:creationId xmlns:a16="http://schemas.microsoft.com/office/drawing/2014/main" id="{8DF8A7DA-98AC-FCEF-AECF-F42CEBA93481}"/>
+                <a16:creationId xmlns:a16="http://schemas.microsoft.com/office/drawing/2014/main" id="{A04152B9-2D10-1A64-2754-64D85FC68C1C}"/>
               </a:ext>
             </a:extLst>
           </p:cNvPr>
@@ -12458,7 +12458,7 @@
           <p:cNvPr id="21" name="CuadroTexto 20">
             <a:extLst>
               <a:ext uri="{FF2B5EF4-FFF2-40B4-BE49-F238E27FC236}">
-                <a16:creationId xmlns:a16="http://schemas.microsoft.com/office/drawing/2014/main" id="{85D7ED3A-36CF-256D-0106-2D9E605346B9}"/>
+                <a16:creationId xmlns:a16="http://schemas.microsoft.com/office/drawing/2014/main" id="{7253DF80-EF1A-0A04-7EEC-E53257F1D27A}"/>
               </a:ext>
             </a:extLst>
           </p:cNvPr>
@@ -12498,7 +12498,7 @@
           <p:cNvPr id="22" name="CuadroTexto 21">
             <a:extLst>
               <a:ext uri="{FF2B5EF4-FFF2-40B4-BE49-F238E27FC236}">
-                <a16:creationId xmlns:a16="http://schemas.microsoft.com/office/drawing/2014/main" id="{E45EC501-4E58-10A6-A758-C90D025FB9ED}"/>
+                <a16:creationId xmlns:a16="http://schemas.microsoft.com/office/drawing/2014/main" id="{DCDE9C4B-FF72-E33E-A1D5-5C82684DA2DE}"/>
               </a:ext>
             </a:extLst>
           </p:cNvPr>
@@ -12536,7 +12536,7 @@
     </p:spTree>
     <p:extLst>
       <p:ext uri="{BB962C8B-B14F-4D97-AF65-F5344CB8AC3E}">
-        <p14:creationId xmlns:p14="http://schemas.microsoft.com/office/powerpoint/2010/main" val="3281172835"/>
+        <p14:creationId xmlns:p14="http://schemas.microsoft.com/office/powerpoint/2010/main" val="3198014928"/>
       </p:ext>
     </p:extLst>
   </p:cSld>

</xml_diff>

<commit_message>
Update defense presentation cloud URL
</commit_message>
<xml_diff>
--- a/docs/presentacion-defensa-final.pptx
+++ b/docs/presentacion-defensa-final.pptx
@@ -7067,7 +7067,7 @@
                 </a:solidFill>
                 <a:latin typeface="Consolas" panose="020B0609020204030204" pitchFamily="49" charset="0"/>
               </a:rPr>
-              <a:t>https://agora.34.175.157.37...</a:t>
+              <a:t>https://agora.34.175.161.212.nip.io</a:t>
             </a:r>
           </a:p>
         </p:txBody>
@@ -8955,7 +8955,7 @@
                 </a:solidFill>
                 <a:latin typeface="Consolas" panose="020B0609020204030204" pitchFamily="49" charset="0"/>
               </a:rPr>
-              <a:t>\https://agora.34.175.157.37.nip.io/app   |   https://agora.34.175.157.37.nip.io/externo\</a:t>
+              <a:t>https://agora.34.175.161.212.nip.io/app/ | https://agora.34.175.161.212.nip.io/externo/</a:t>
             </a:r>
           </a:p>
         </p:txBody>

</xml_diff>

<commit_message>
Update defense deck public URL
</commit_message>
<xml_diff>
--- a/docs/presentacion-defensa-final.pptx
+++ b/docs/presentacion-defensa-final.pptx
@@ -208,7 +208,7 @@
             </a:lvl1pPr>
           </a:lstStyle>
           <a:p>
-            <a:fld id="{184CBF3D-31FC-4D43-9FFA-B7306C961877}" type="datetimeFigureOut">
+            <a:fld id="{8FBF001C-8709-4ADC-8371-900A171C88AA}" type="datetimeFigureOut">
               <a:rPr lang="es-ES" smtClean="0"/>
               <a:t>04/06/2026</a:t>
             </a:fld>
@@ -366,7 +366,7 @@
             </a:lvl1pPr>
           </a:lstStyle>
           <a:p>
-            <a:fld id="{1C152D8B-9EAE-432B-BDC7-4C9E536786B4}" type="slidenum">
+            <a:fld id="{B93001FF-24BA-4316-B9A8-D8767091175D}" type="slidenum">
               <a:rPr lang="es-ES" smtClean="0"/>
               <a:t>‹Nº›</a:t>
             </a:fld>
@@ -377,7 +377,7 @@
     </p:spTree>
     <p:extLst>
       <p:ext uri="{BB962C8B-B14F-4D97-AF65-F5344CB8AC3E}">
-        <p14:creationId xmlns:p14="http://schemas.microsoft.com/office/powerpoint/2010/main" val="727094697"/>
+        <p14:creationId xmlns:p14="http://schemas.microsoft.com/office/powerpoint/2010/main" val="3743991715"/>
       </p:ext>
     </p:extLst>
   </p:cSld>
@@ -546,7 +546,7 @@
           <a:bodyPr/>
           <a:lstStyle/>
           <a:p>
-            <a:fld id="{1C152D8B-9EAE-432B-BDC7-4C9E536786B4}" type="slidenum">
+            <a:fld id="{B93001FF-24BA-4316-B9A8-D8767091175D}" type="slidenum">
               <a:rPr lang="es-ES" smtClean="0"/>
               <a:t>1</a:t>
             </a:fld>
@@ -557,7 +557,7 @@
     </p:spTree>
     <p:extLst>
       <p:ext uri="{BB962C8B-B14F-4D97-AF65-F5344CB8AC3E}">
-        <p14:creationId xmlns:p14="http://schemas.microsoft.com/office/powerpoint/2010/main" val="2531169814"/>
+        <p14:creationId xmlns:p14="http://schemas.microsoft.com/office/powerpoint/2010/main" val="215697045"/>
       </p:ext>
     </p:extLst>
   </p:cSld>
@@ -636,7 +636,7 @@
           <a:bodyPr/>
           <a:lstStyle/>
           <a:p>
-            <a:fld id="{1C152D8B-9EAE-432B-BDC7-4C9E536786B4}" type="slidenum">
+            <a:fld id="{B93001FF-24BA-4316-B9A8-D8767091175D}" type="slidenum">
               <a:rPr lang="es-ES" smtClean="0"/>
               <a:t>10</a:t>
             </a:fld>
@@ -647,7 +647,7 @@
     </p:spTree>
     <p:extLst>
       <p:ext uri="{BB962C8B-B14F-4D97-AF65-F5344CB8AC3E}">
-        <p14:creationId xmlns:p14="http://schemas.microsoft.com/office/powerpoint/2010/main" val="3836444455"/>
+        <p14:creationId xmlns:p14="http://schemas.microsoft.com/office/powerpoint/2010/main" val="3986796827"/>
       </p:ext>
     </p:extLst>
   </p:cSld>
@@ -726,7 +726,7 @@
           <a:bodyPr/>
           <a:lstStyle/>
           <a:p>
-            <a:fld id="{1C152D8B-9EAE-432B-BDC7-4C9E536786B4}" type="slidenum">
+            <a:fld id="{B93001FF-24BA-4316-B9A8-D8767091175D}" type="slidenum">
               <a:rPr lang="es-ES" smtClean="0"/>
               <a:t>11</a:t>
             </a:fld>
@@ -737,7 +737,7 @@
     </p:spTree>
     <p:extLst>
       <p:ext uri="{BB962C8B-B14F-4D97-AF65-F5344CB8AC3E}">
-        <p14:creationId xmlns:p14="http://schemas.microsoft.com/office/powerpoint/2010/main" val="2570846676"/>
+        <p14:creationId xmlns:p14="http://schemas.microsoft.com/office/powerpoint/2010/main" val="2276064624"/>
       </p:ext>
     </p:extLst>
   </p:cSld>
@@ -816,7 +816,7 @@
           <a:bodyPr/>
           <a:lstStyle/>
           <a:p>
-            <a:fld id="{1C152D8B-9EAE-432B-BDC7-4C9E536786B4}" type="slidenum">
+            <a:fld id="{B93001FF-24BA-4316-B9A8-D8767091175D}" type="slidenum">
               <a:rPr lang="es-ES" smtClean="0"/>
               <a:t>12</a:t>
             </a:fld>
@@ -827,7 +827,7 @@
     </p:spTree>
     <p:extLst>
       <p:ext uri="{BB962C8B-B14F-4D97-AF65-F5344CB8AC3E}">
-        <p14:creationId xmlns:p14="http://schemas.microsoft.com/office/powerpoint/2010/main" val="2681286729"/>
+        <p14:creationId xmlns:p14="http://schemas.microsoft.com/office/powerpoint/2010/main" val="1059339686"/>
       </p:ext>
     </p:extLst>
   </p:cSld>
@@ -906,7 +906,7 @@
           <a:bodyPr/>
           <a:lstStyle/>
           <a:p>
-            <a:fld id="{1C152D8B-9EAE-432B-BDC7-4C9E536786B4}" type="slidenum">
+            <a:fld id="{B93001FF-24BA-4316-B9A8-D8767091175D}" type="slidenum">
               <a:rPr lang="es-ES" smtClean="0"/>
               <a:t>13</a:t>
             </a:fld>
@@ -917,7 +917,7 @@
     </p:spTree>
     <p:extLst>
       <p:ext uri="{BB962C8B-B14F-4D97-AF65-F5344CB8AC3E}">
-        <p14:creationId xmlns:p14="http://schemas.microsoft.com/office/powerpoint/2010/main" val="3551639126"/>
+        <p14:creationId xmlns:p14="http://schemas.microsoft.com/office/powerpoint/2010/main" val="640734711"/>
       </p:ext>
     </p:extLst>
   </p:cSld>
@@ -1003,7 +1003,7 @@
           <a:bodyPr/>
           <a:lstStyle/>
           <a:p>
-            <a:fld id="{1C152D8B-9EAE-432B-BDC7-4C9E536786B4}" type="slidenum">
+            <a:fld id="{B93001FF-24BA-4316-B9A8-D8767091175D}" type="slidenum">
               <a:rPr lang="es-ES" smtClean="0"/>
               <a:t>14</a:t>
             </a:fld>
@@ -1014,7 +1014,7 @@
     </p:spTree>
     <p:extLst>
       <p:ext uri="{BB962C8B-B14F-4D97-AF65-F5344CB8AC3E}">
-        <p14:creationId xmlns:p14="http://schemas.microsoft.com/office/powerpoint/2010/main" val="926103025"/>
+        <p14:creationId xmlns:p14="http://schemas.microsoft.com/office/powerpoint/2010/main" val="2637870448"/>
       </p:ext>
     </p:extLst>
   </p:cSld>
@@ -1093,7 +1093,7 @@
           <a:bodyPr/>
           <a:lstStyle/>
           <a:p>
-            <a:fld id="{1C152D8B-9EAE-432B-BDC7-4C9E536786B4}" type="slidenum">
+            <a:fld id="{B93001FF-24BA-4316-B9A8-D8767091175D}" type="slidenum">
               <a:rPr lang="es-ES" smtClean="0"/>
               <a:t>15</a:t>
             </a:fld>
@@ -1104,7 +1104,7 @@
     </p:spTree>
     <p:extLst>
       <p:ext uri="{BB962C8B-B14F-4D97-AF65-F5344CB8AC3E}">
-        <p14:creationId xmlns:p14="http://schemas.microsoft.com/office/powerpoint/2010/main" val="1322989480"/>
+        <p14:creationId xmlns:p14="http://schemas.microsoft.com/office/powerpoint/2010/main" val="3021342473"/>
       </p:ext>
     </p:extLst>
   </p:cSld>
@@ -1183,7 +1183,7 @@
           <a:bodyPr/>
           <a:lstStyle/>
           <a:p>
-            <a:fld id="{1C152D8B-9EAE-432B-BDC7-4C9E536786B4}" type="slidenum">
+            <a:fld id="{B93001FF-24BA-4316-B9A8-D8767091175D}" type="slidenum">
               <a:rPr lang="es-ES" smtClean="0"/>
               <a:t>16</a:t>
             </a:fld>
@@ -1194,7 +1194,7 @@
     </p:spTree>
     <p:extLst>
       <p:ext uri="{BB962C8B-B14F-4D97-AF65-F5344CB8AC3E}">
-        <p14:creationId xmlns:p14="http://schemas.microsoft.com/office/powerpoint/2010/main" val="1590726781"/>
+        <p14:creationId xmlns:p14="http://schemas.microsoft.com/office/powerpoint/2010/main" val="1484217553"/>
       </p:ext>
     </p:extLst>
   </p:cSld>
@@ -1273,7 +1273,7 @@
           <a:bodyPr/>
           <a:lstStyle/>
           <a:p>
-            <a:fld id="{1C152D8B-9EAE-432B-BDC7-4C9E536786B4}" type="slidenum">
+            <a:fld id="{B93001FF-24BA-4316-B9A8-D8767091175D}" type="slidenum">
               <a:rPr lang="es-ES" smtClean="0"/>
               <a:t>17</a:t>
             </a:fld>
@@ -1284,7 +1284,7 @@
     </p:spTree>
     <p:extLst>
       <p:ext uri="{BB962C8B-B14F-4D97-AF65-F5344CB8AC3E}">
-        <p14:creationId xmlns:p14="http://schemas.microsoft.com/office/powerpoint/2010/main" val="4215061410"/>
+        <p14:creationId xmlns:p14="http://schemas.microsoft.com/office/powerpoint/2010/main" val="3605682471"/>
       </p:ext>
     </p:extLst>
   </p:cSld>
@@ -1363,7 +1363,7 @@
           <a:bodyPr/>
           <a:lstStyle/>
           <a:p>
-            <a:fld id="{1C152D8B-9EAE-432B-BDC7-4C9E536786B4}" type="slidenum">
+            <a:fld id="{B93001FF-24BA-4316-B9A8-D8767091175D}" type="slidenum">
               <a:rPr lang="es-ES" smtClean="0"/>
               <a:t>18</a:t>
             </a:fld>
@@ -1374,7 +1374,7 @@
     </p:spTree>
     <p:extLst>
       <p:ext uri="{BB962C8B-B14F-4D97-AF65-F5344CB8AC3E}">
-        <p14:creationId xmlns:p14="http://schemas.microsoft.com/office/powerpoint/2010/main" val="885315946"/>
+        <p14:creationId xmlns:p14="http://schemas.microsoft.com/office/powerpoint/2010/main" val="1303702541"/>
       </p:ext>
     </p:extLst>
   </p:cSld>
@@ -1452,7 +1452,7 @@
           <a:bodyPr/>
           <a:lstStyle/>
           <a:p>
-            <a:fld id="{1C152D8B-9EAE-432B-BDC7-4C9E536786B4}" type="slidenum">
+            <a:fld id="{B93001FF-24BA-4316-B9A8-D8767091175D}" type="slidenum">
               <a:rPr lang="es-ES" smtClean="0"/>
               <a:t>19</a:t>
             </a:fld>
@@ -1463,7 +1463,7 @@
     </p:spTree>
     <p:extLst>
       <p:ext uri="{BB962C8B-B14F-4D97-AF65-F5344CB8AC3E}">
-        <p14:creationId xmlns:p14="http://schemas.microsoft.com/office/powerpoint/2010/main" val="2634313282"/>
+        <p14:creationId xmlns:p14="http://schemas.microsoft.com/office/powerpoint/2010/main" val="2211849095"/>
       </p:ext>
     </p:extLst>
   </p:cSld>
@@ -1542,7 +1542,7 @@
           <a:bodyPr/>
           <a:lstStyle/>
           <a:p>
-            <a:fld id="{1C152D8B-9EAE-432B-BDC7-4C9E536786B4}" type="slidenum">
+            <a:fld id="{B93001FF-24BA-4316-B9A8-D8767091175D}" type="slidenum">
               <a:rPr lang="es-ES" smtClean="0"/>
               <a:t>2</a:t>
             </a:fld>
@@ -1553,7 +1553,7 @@
     </p:spTree>
     <p:extLst>
       <p:ext uri="{BB962C8B-B14F-4D97-AF65-F5344CB8AC3E}">
-        <p14:creationId xmlns:p14="http://schemas.microsoft.com/office/powerpoint/2010/main" val="457122636"/>
+        <p14:creationId xmlns:p14="http://schemas.microsoft.com/office/powerpoint/2010/main" val="3549670956"/>
       </p:ext>
     </p:extLst>
   </p:cSld>
@@ -1633,7 +1633,7 @@
           <a:bodyPr/>
           <a:lstStyle/>
           <a:p>
-            <a:fld id="{1C152D8B-9EAE-432B-BDC7-4C9E536786B4}" type="slidenum">
+            <a:fld id="{B93001FF-24BA-4316-B9A8-D8767091175D}" type="slidenum">
               <a:rPr lang="es-ES" smtClean="0"/>
               <a:t>3</a:t>
             </a:fld>
@@ -1644,7 +1644,7 @@
     </p:spTree>
     <p:extLst>
       <p:ext uri="{BB962C8B-B14F-4D97-AF65-F5344CB8AC3E}">
-        <p14:creationId xmlns:p14="http://schemas.microsoft.com/office/powerpoint/2010/main" val="502439784"/>
+        <p14:creationId xmlns:p14="http://schemas.microsoft.com/office/powerpoint/2010/main" val="4073137116"/>
       </p:ext>
     </p:extLst>
   </p:cSld>
@@ -1724,7 +1724,7 @@
           <a:bodyPr/>
           <a:lstStyle/>
           <a:p>
-            <a:fld id="{1C152D8B-9EAE-432B-BDC7-4C9E536786B4}" type="slidenum">
+            <a:fld id="{B93001FF-24BA-4316-B9A8-D8767091175D}" type="slidenum">
               <a:rPr lang="es-ES" smtClean="0"/>
               <a:t>4</a:t>
             </a:fld>
@@ -1735,7 +1735,7 @@
     </p:spTree>
     <p:extLst>
       <p:ext uri="{BB962C8B-B14F-4D97-AF65-F5344CB8AC3E}">
-        <p14:creationId xmlns:p14="http://schemas.microsoft.com/office/powerpoint/2010/main" val="1552827984"/>
+        <p14:creationId xmlns:p14="http://schemas.microsoft.com/office/powerpoint/2010/main" val="4051446067"/>
       </p:ext>
     </p:extLst>
   </p:cSld>
@@ -1818,7 +1818,7 @@
           <a:bodyPr/>
           <a:lstStyle/>
           <a:p>
-            <a:fld id="{1C152D8B-9EAE-432B-BDC7-4C9E536786B4}" type="slidenum">
+            <a:fld id="{B93001FF-24BA-4316-B9A8-D8767091175D}" type="slidenum">
               <a:rPr lang="es-ES" smtClean="0"/>
               <a:t>5</a:t>
             </a:fld>
@@ -1829,7 +1829,7 @@
     </p:spTree>
     <p:extLst>
       <p:ext uri="{BB962C8B-B14F-4D97-AF65-F5344CB8AC3E}">
-        <p14:creationId xmlns:p14="http://schemas.microsoft.com/office/powerpoint/2010/main" val="3306427844"/>
+        <p14:creationId xmlns:p14="http://schemas.microsoft.com/office/powerpoint/2010/main" val="1828890381"/>
       </p:ext>
     </p:extLst>
   </p:cSld>
@@ -1908,7 +1908,7 @@
           <a:bodyPr/>
           <a:lstStyle/>
           <a:p>
-            <a:fld id="{1C152D8B-9EAE-432B-BDC7-4C9E536786B4}" type="slidenum">
+            <a:fld id="{B93001FF-24BA-4316-B9A8-D8767091175D}" type="slidenum">
               <a:rPr lang="es-ES" smtClean="0"/>
               <a:t>6</a:t>
             </a:fld>
@@ -1919,7 +1919,7 @@
     </p:spTree>
     <p:extLst>
       <p:ext uri="{BB962C8B-B14F-4D97-AF65-F5344CB8AC3E}">
-        <p14:creationId xmlns:p14="http://schemas.microsoft.com/office/powerpoint/2010/main" val="2298830266"/>
+        <p14:creationId xmlns:p14="http://schemas.microsoft.com/office/powerpoint/2010/main" val="863347273"/>
       </p:ext>
     </p:extLst>
   </p:cSld>
@@ -1999,7 +1999,7 @@
           <a:bodyPr/>
           <a:lstStyle/>
           <a:p>
-            <a:fld id="{1C152D8B-9EAE-432B-BDC7-4C9E536786B4}" type="slidenum">
+            <a:fld id="{B93001FF-24BA-4316-B9A8-D8767091175D}" type="slidenum">
               <a:rPr lang="es-ES" smtClean="0"/>
               <a:t>7</a:t>
             </a:fld>
@@ -2010,7 +2010,7 @@
     </p:spTree>
     <p:extLst>
       <p:ext uri="{BB962C8B-B14F-4D97-AF65-F5344CB8AC3E}">
-        <p14:creationId xmlns:p14="http://schemas.microsoft.com/office/powerpoint/2010/main" val="1874687430"/>
+        <p14:creationId xmlns:p14="http://schemas.microsoft.com/office/powerpoint/2010/main" val="3145180591"/>
       </p:ext>
     </p:extLst>
   </p:cSld>
@@ -2089,7 +2089,7 @@
           <a:bodyPr/>
           <a:lstStyle/>
           <a:p>
-            <a:fld id="{1C152D8B-9EAE-432B-BDC7-4C9E536786B4}" type="slidenum">
+            <a:fld id="{B93001FF-24BA-4316-B9A8-D8767091175D}" type="slidenum">
               <a:rPr lang="es-ES" smtClean="0"/>
               <a:t>8</a:t>
             </a:fld>
@@ -2100,7 +2100,7 @@
     </p:spTree>
     <p:extLst>
       <p:ext uri="{BB962C8B-B14F-4D97-AF65-F5344CB8AC3E}">
-        <p14:creationId xmlns:p14="http://schemas.microsoft.com/office/powerpoint/2010/main" val="2190473250"/>
+        <p14:creationId xmlns:p14="http://schemas.microsoft.com/office/powerpoint/2010/main" val="2676240005"/>
       </p:ext>
     </p:extLst>
   </p:cSld>
@@ -2180,7 +2180,7 @@
           <a:bodyPr/>
           <a:lstStyle/>
           <a:p>
-            <a:fld id="{1C152D8B-9EAE-432B-BDC7-4C9E536786B4}" type="slidenum">
+            <a:fld id="{B93001FF-24BA-4316-B9A8-D8767091175D}" type="slidenum">
               <a:rPr lang="es-ES" smtClean="0"/>
               <a:t>9</a:t>
             </a:fld>
@@ -2191,7 +2191,7 @@
     </p:spTree>
     <p:extLst>
       <p:ext uri="{BB962C8B-B14F-4D97-AF65-F5344CB8AC3E}">
-        <p14:creationId xmlns:p14="http://schemas.microsoft.com/office/powerpoint/2010/main" val="803817503"/>
+        <p14:creationId xmlns:p14="http://schemas.microsoft.com/office/powerpoint/2010/main" val="1482581176"/>
       </p:ext>
     </p:extLst>
   </p:cSld>
@@ -2223,7 +2223,7 @@
           <p:cNvPr id="2" name="Título 1">
             <a:extLst>
               <a:ext uri="{FF2B5EF4-FFF2-40B4-BE49-F238E27FC236}">
-                <a16:creationId xmlns:a16="http://schemas.microsoft.com/office/drawing/2014/main" id="{77B1E083-2DE9-2B66-A143-9DB605A16C68}"/>
+                <a16:creationId xmlns:a16="http://schemas.microsoft.com/office/drawing/2014/main" id="{9FBF71DD-8A1A-3A5C-427E-F42D1B5597E3}"/>
               </a:ext>
             </a:extLst>
           </p:cNvPr>
@@ -2260,7 +2260,7 @@
           <p:cNvPr id="3" name="Subtítulo 2">
             <a:extLst>
               <a:ext uri="{FF2B5EF4-FFF2-40B4-BE49-F238E27FC236}">
-                <a16:creationId xmlns:a16="http://schemas.microsoft.com/office/drawing/2014/main" id="{81E00F32-054B-16E6-F311-F331F3BEE0FA}"/>
+                <a16:creationId xmlns:a16="http://schemas.microsoft.com/office/drawing/2014/main" id="{BFADDF58-6B19-3973-E9CA-309017CC0E93}"/>
               </a:ext>
             </a:extLst>
           </p:cNvPr>
@@ -2330,7 +2330,7 @@
           <p:cNvPr id="4" name="Marcador de fecha 3">
             <a:extLst>
               <a:ext uri="{FF2B5EF4-FFF2-40B4-BE49-F238E27FC236}">
-                <a16:creationId xmlns:a16="http://schemas.microsoft.com/office/drawing/2014/main" id="{C31736F5-F1FB-0962-4D51-EE6301522D0D}"/>
+                <a16:creationId xmlns:a16="http://schemas.microsoft.com/office/drawing/2014/main" id="{34C85AC0-8B5B-D328-C631-062B2A19CD38}"/>
               </a:ext>
             </a:extLst>
           </p:cNvPr>
@@ -2346,7 +2346,7 @@
           <a:bodyPr/>
           <a:lstStyle/>
           <a:p>
-            <a:fld id="{E73BE342-D7DD-451B-AD14-82C868274E08}" type="datetimeFigureOut">
+            <a:fld id="{E2E78F0F-3CEE-4885-8154-F908A2044D66}" type="datetimeFigureOut">
               <a:rPr lang="es-ES" smtClean="0"/>
               <a:t>04/06/2026</a:t>
             </a:fld>
@@ -2359,7 +2359,7 @@
           <p:cNvPr id="5" name="Marcador de pie de página 4">
             <a:extLst>
               <a:ext uri="{FF2B5EF4-FFF2-40B4-BE49-F238E27FC236}">
-                <a16:creationId xmlns:a16="http://schemas.microsoft.com/office/drawing/2014/main" id="{DC41C90E-ECF9-03D2-DC2B-3206ABFC530E}"/>
+                <a16:creationId xmlns:a16="http://schemas.microsoft.com/office/drawing/2014/main" id="{B2AAB737-A507-EDBB-C397-1439D07293A9}"/>
               </a:ext>
             </a:extLst>
           </p:cNvPr>
@@ -2384,7 +2384,7 @@
           <p:cNvPr id="6" name="Marcador de número de diapositiva 5">
             <a:extLst>
               <a:ext uri="{FF2B5EF4-FFF2-40B4-BE49-F238E27FC236}">
-                <a16:creationId xmlns:a16="http://schemas.microsoft.com/office/drawing/2014/main" id="{8AA5A52E-1DEC-3219-5095-916708A6FBA1}"/>
+                <a16:creationId xmlns:a16="http://schemas.microsoft.com/office/drawing/2014/main" id="{2FA276E1-F939-4447-B2B8-98A12AE7E336}"/>
               </a:ext>
             </a:extLst>
           </p:cNvPr>
@@ -2400,7 +2400,7 @@
           <a:bodyPr/>
           <a:lstStyle/>
           <a:p>
-            <a:fld id="{6FD9D725-7506-41FC-8170-7DB91405864C}" type="slidenum">
+            <a:fld id="{46952519-79A0-4158-88E8-8A74092916AE}" type="slidenum">
               <a:rPr lang="es-ES" smtClean="0"/>
               <a:t>‹Nº›</a:t>
             </a:fld>
@@ -2411,7 +2411,7 @@
     </p:spTree>
     <p:extLst>
       <p:ext uri="{BB962C8B-B14F-4D97-AF65-F5344CB8AC3E}">
-        <p14:creationId xmlns:p14="http://schemas.microsoft.com/office/powerpoint/2010/main" val="1441037677"/>
+        <p14:creationId xmlns:p14="http://schemas.microsoft.com/office/powerpoint/2010/main" val="3700646399"/>
       </p:ext>
     </p:extLst>
   </p:cSld>
@@ -2443,7 +2443,7 @@
           <p:cNvPr id="2" name="Título 1">
             <a:extLst>
               <a:ext uri="{FF2B5EF4-FFF2-40B4-BE49-F238E27FC236}">
-                <a16:creationId xmlns:a16="http://schemas.microsoft.com/office/drawing/2014/main" id="{41867CDB-1F48-341B-5341-4D0AB2A31AA6}"/>
+                <a16:creationId xmlns:a16="http://schemas.microsoft.com/office/drawing/2014/main" id="{9B87722E-DE3D-93DD-305E-988CCB27F62B}"/>
               </a:ext>
             </a:extLst>
           </p:cNvPr>
@@ -2471,7 +2471,7 @@
           <p:cNvPr id="3" name="Marcador de texto vertical 2">
             <a:extLst>
               <a:ext uri="{FF2B5EF4-FFF2-40B4-BE49-F238E27FC236}">
-                <a16:creationId xmlns:a16="http://schemas.microsoft.com/office/drawing/2014/main" id="{7A32BECA-B377-581A-AB8F-1C1DF6AAB5C2}"/>
+                <a16:creationId xmlns:a16="http://schemas.microsoft.com/office/drawing/2014/main" id="{52E4C930-243D-C30B-4FD9-28EE9B87F482}"/>
               </a:ext>
             </a:extLst>
           </p:cNvPr>
@@ -2528,7 +2528,7 @@
           <p:cNvPr id="4" name="Marcador de fecha 3">
             <a:extLst>
               <a:ext uri="{FF2B5EF4-FFF2-40B4-BE49-F238E27FC236}">
-                <a16:creationId xmlns:a16="http://schemas.microsoft.com/office/drawing/2014/main" id="{7E62BB1A-B502-B739-92B1-4D8141D845DB}"/>
+                <a16:creationId xmlns:a16="http://schemas.microsoft.com/office/drawing/2014/main" id="{0D8DB55F-BE8D-72C9-A021-31475D03CCF4}"/>
               </a:ext>
             </a:extLst>
           </p:cNvPr>
@@ -2544,7 +2544,7 @@
           <a:bodyPr/>
           <a:lstStyle/>
           <a:p>
-            <a:fld id="{E73BE342-D7DD-451B-AD14-82C868274E08}" type="datetimeFigureOut">
+            <a:fld id="{E2E78F0F-3CEE-4885-8154-F908A2044D66}" type="datetimeFigureOut">
               <a:rPr lang="es-ES" smtClean="0"/>
               <a:t>04/06/2026</a:t>
             </a:fld>
@@ -2557,7 +2557,7 @@
           <p:cNvPr id="5" name="Marcador de pie de página 4">
             <a:extLst>
               <a:ext uri="{FF2B5EF4-FFF2-40B4-BE49-F238E27FC236}">
-                <a16:creationId xmlns:a16="http://schemas.microsoft.com/office/drawing/2014/main" id="{192B4901-016D-D34F-87FF-ABDCC82A6C89}"/>
+                <a16:creationId xmlns:a16="http://schemas.microsoft.com/office/drawing/2014/main" id="{B88FAE5B-20B2-508A-C009-FE1D0EEDAC9A}"/>
               </a:ext>
             </a:extLst>
           </p:cNvPr>
@@ -2582,7 +2582,7 @@
           <p:cNvPr id="6" name="Marcador de número de diapositiva 5">
             <a:extLst>
               <a:ext uri="{FF2B5EF4-FFF2-40B4-BE49-F238E27FC236}">
-                <a16:creationId xmlns:a16="http://schemas.microsoft.com/office/drawing/2014/main" id="{A05B9670-88A5-BCAA-9330-164EB31FBBF0}"/>
+                <a16:creationId xmlns:a16="http://schemas.microsoft.com/office/drawing/2014/main" id="{0B0D45D1-ADB4-98BC-E695-0749FF3367C3}"/>
               </a:ext>
             </a:extLst>
           </p:cNvPr>
@@ -2598,7 +2598,7 @@
           <a:bodyPr/>
           <a:lstStyle/>
           <a:p>
-            <a:fld id="{6FD9D725-7506-41FC-8170-7DB91405864C}" type="slidenum">
+            <a:fld id="{46952519-79A0-4158-88E8-8A74092916AE}" type="slidenum">
               <a:rPr lang="es-ES" smtClean="0"/>
               <a:t>‹Nº›</a:t>
             </a:fld>
@@ -2609,7 +2609,7 @@
     </p:spTree>
     <p:extLst>
       <p:ext uri="{BB962C8B-B14F-4D97-AF65-F5344CB8AC3E}">
-        <p14:creationId xmlns:p14="http://schemas.microsoft.com/office/powerpoint/2010/main" val="49846488"/>
+        <p14:creationId xmlns:p14="http://schemas.microsoft.com/office/powerpoint/2010/main" val="4211537904"/>
       </p:ext>
     </p:extLst>
   </p:cSld>
@@ -2641,7 +2641,7 @@
           <p:cNvPr id="2" name="Título vertical 1">
             <a:extLst>
               <a:ext uri="{FF2B5EF4-FFF2-40B4-BE49-F238E27FC236}">
-                <a16:creationId xmlns:a16="http://schemas.microsoft.com/office/drawing/2014/main" id="{F21DB9FD-B75F-A7CC-1757-D330BD3928E5}"/>
+                <a16:creationId xmlns:a16="http://schemas.microsoft.com/office/drawing/2014/main" id="{AECC615D-0F68-C301-800C-618D72BA3B8C}"/>
               </a:ext>
             </a:extLst>
           </p:cNvPr>
@@ -2674,7 +2674,7 @@
           <p:cNvPr id="3" name="Marcador de texto vertical 2">
             <a:extLst>
               <a:ext uri="{FF2B5EF4-FFF2-40B4-BE49-F238E27FC236}">
-                <a16:creationId xmlns:a16="http://schemas.microsoft.com/office/drawing/2014/main" id="{EE55455F-2F2F-AAE6-8222-C6D24585E8F1}"/>
+                <a16:creationId xmlns:a16="http://schemas.microsoft.com/office/drawing/2014/main" id="{B169D8D1-1646-AF6B-BA39-BCC2DE2C3556}"/>
               </a:ext>
             </a:extLst>
           </p:cNvPr>
@@ -2736,7 +2736,7 @@
           <p:cNvPr id="4" name="Marcador de fecha 3">
             <a:extLst>
               <a:ext uri="{FF2B5EF4-FFF2-40B4-BE49-F238E27FC236}">
-                <a16:creationId xmlns:a16="http://schemas.microsoft.com/office/drawing/2014/main" id="{9E51DF2D-70AB-8B86-7FF7-A41E78099E40}"/>
+                <a16:creationId xmlns:a16="http://schemas.microsoft.com/office/drawing/2014/main" id="{1875E4F4-5197-2569-4397-EBED4D9A3416}"/>
               </a:ext>
             </a:extLst>
           </p:cNvPr>
@@ -2752,7 +2752,7 @@
           <a:bodyPr/>
           <a:lstStyle/>
           <a:p>
-            <a:fld id="{E73BE342-D7DD-451B-AD14-82C868274E08}" type="datetimeFigureOut">
+            <a:fld id="{E2E78F0F-3CEE-4885-8154-F908A2044D66}" type="datetimeFigureOut">
               <a:rPr lang="es-ES" smtClean="0"/>
               <a:t>04/06/2026</a:t>
             </a:fld>
@@ -2765,7 +2765,7 @@
           <p:cNvPr id="5" name="Marcador de pie de página 4">
             <a:extLst>
               <a:ext uri="{FF2B5EF4-FFF2-40B4-BE49-F238E27FC236}">
-                <a16:creationId xmlns:a16="http://schemas.microsoft.com/office/drawing/2014/main" id="{D8888822-40FF-1CC4-D788-FEC572EEE0A6}"/>
+                <a16:creationId xmlns:a16="http://schemas.microsoft.com/office/drawing/2014/main" id="{7943F178-470D-7AF8-678A-CD4E34483A47}"/>
               </a:ext>
             </a:extLst>
           </p:cNvPr>
@@ -2790,7 +2790,7 @@
           <p:cNvPr id="6" name="Marcador de número de diapositiva 5">
             <a:extLst>
               <a:ext uri="{FF2B5EF4-FFF2-40B4-BE49-F238E27FC236}">
-                <a16:creationId xmlns:a16="http://schemas.microsoft.com/office/drawing/2014/main" id="{8264FCCC-F3C9-3B6B-9A23-5431E09E63E8}"/>
+                <a16:creationId xmlns:a16="http://schemas.microsoft.com/office/drawing/2014/main" id="{ED162692-C23F-D191-7BB0-0C6B4F3E4D6B}"/>
               </a:ext>
             </a:extLst>
           </p:cNvPr>
@@ -2806,7 +2806,7 @@
           <a:bodyPr/>
           <a:lstStyle/>
           <a:p>
-            <a:fld id="{6FD9D725-7506-41FC-8170-7DB91405864C}" type="slidenum">
+            <a:fld id="{46952519-79A0-4158-88E8-8A74092916AE}" type="slidenum">
               <a:rPr lang="es-ES" smtClean="0"/>
               <a:t>‹Nº›</a:t>
             </a:fld>
@@ -2817,7 +2817,7 @@
     </p:spTree>
     <p:extLst>
       <p:ext uri="{BB962C8B-B14F-4D97-AF65-F5344CB8AC3E}">
-        <p14:creationId xmlns:p14="http://schemas.microsoft.com/office/powerpoint/2010/main" val="2306049144"/>
+        <p14:creationId xmlns:p14="http://schemas.microsoft.com/office/powerpoint/2010/main" val="1983635389"/>
       </p:ext>
     </p:extLst>
   </p:cSld>
@@ -2849,7 +2849,7 @@
           <p:cNvPr id="2" name="Título 1">
             <a:extLst>
               <a:ext uri="{FF2B5EF4-FFF2-40B4-BE49-F238E27FC236}">
-                <a16:creationId xmlns:a16="http://schemas.microsoft.com/office/drawing/2014/main" id="{78F0B867-BC38-D57F-9E9B-F2B7C39C8734}"/>
+                <a16:creationId xmlns:a16="http://schemas.microsoft.com/office/drawing/2014/main" id="{3C43EFF3-2208-B0F4-F888-B4BFB0EB634F}"/>
               </a:ext>
             </a:extLst>
           </p:cNvPr>
@@ -2877,7 +2877,7 @@
           <p:cNvPr id="3" name="Marcador de contenido 2">
             <a:extLst>
               <a:ext uri="{FF2B5EF4-FFF2-40B4-BE49-F238E27FC236}">
-                <a16:creationId xmlns:a16="http://schemas.microsoft.com/office/drawing/2014/main" id="{23BD71DB-78C8-077E-C610-D9FABB0C0144}"/>
+                <a16:creationId xmlns:a16="http://schemas.microsoft.com/office/drawing/2014/main" id="{03E54055-C46C-7830-17EC-638EDDF01D81}"/>
               </a:ext>
             </a:extLst>
           </p:cNvPr>
@@ -2934,7 +2934,7 @@
           <p:cNvPr id="4" name="Marcador de fecha 3">
             <a:extLst>
               <a:ext uri="{FF2B5EF4-FFF2-40B4-BE49-F238E27FC236}">
-                <a16:creationId xmlns:a16="http://schemas.microsoft.com/office/drawing/2014/main" id="{DB6CE51D-329E-2A7D-2A43-A4B3CF285CEB}"/>
+                <a16:creationId xmlns:a16="http://schemas.microsoft.com/office/drawing/2014/main" id="{AA0298D9-986A-400B-52EA-7C3160091503}"/>
               </a:ext>
             </a:extLst>
           </p:cNvPr>
@@ -2950,7 +2950,7 @@
           <a:bodyPr/>
           <a:lstStyle/>
           <a:p>
-            <a:fld id="{E73BE342-D7DD-451B-AD14-82C868274E08}" type="datetimeFigureOut">
+            <a:fld id="{E2E78F0F-3CEE-4885-8154-F908A2044D66}" type="datetimeFigureOut">
               <a:rPr lang="es-ES" smtClean="0"/>
               <a:t>04/06/2026</a:t>
             </a:fld>
@@ -2963,7 +2963,7 @@
           <p:cNvPr id="5" name="Marcador de pie de página 4">
             <a:extLst>
               <a:ext uri="{FF2B5EF4-FFF2-40B4-BE49-F238E27FC236}">
-                <a16:creationId xmlns:a16="http://schemas.microsoft.com/office/drawing/2014/main" id="{374041EE-3C57-CA92-F014-B564594F62C3}"/>
+                <a16:creationId xmlns:a16="http://schemas.microsoft.com/office/drawing/2014/main" id="{CB7582AF-E854-BF35-6ED9-13FDE1E55E3E}"/>
               </a:ext>
             </a:extLst>
           </p:cNvPr>
@@ -2988,7 +2988,7 @@
           <p:cNvPr id="6" name="Marcador de número de diapositiva 5">
             <a:extLst>
               <a:ext uri="{FF2B5EF4-FFF2-40B4-BE49-F238E27FC236}">
-                <a16:creationId xmlns:a16="http://schemas.microsoft.com/office/drawing/2014/main" id="{28DF99C0-A6A6-B90A-BB15-12E74B0CC724}"/>
+                <a16:creationId xmlns:a16="http://schemas.microsoft.com/office/drawing/2014/main" id="{5EEE6B73-214F-4C3E-DD6B-A9B8041D0CD0}"/>
               </a:ext>
             </a:extLst>
           </p:cNvPr>
@@ -3004,7 +3004,7 @@
           <a:bodyPr/>
           <a:lstStyle/>
           <a:p>
-            <a:fld id="{6FD9D725-7506-41FC-8170-7DB91405864C}" type="slidenum">
+            <a:fld id="{46952519-79A0-4158-88E8-8A74092916AE}" type="slidenum">
               <a:rPr lang="es-ES" smtClean="0"/>
               <a:t>‹Nº›</a:t>
             </a:fld>
@@ -3015,7 +3015,7 @@
     </p:spTree>
     <p:extLst>
       <p:ext uri="{BB962C8B-B14F-4D97-AF65-F5344CB8AC3E}">
-        <p14:creationId xmlns:p14="http://schemas.microsoft.com/office/powerpoint/2010/main" val="1014540448"/>
+        <p14:creationId xmlns:p14="http://schemas.microsoft.com/office/powerpoint/2010/main" val="2648825307"/>
       </p:ext>
     </p:extLst>
   </p:cSld>
@@ -3047,7 +3047,7 @@
           <p:cNvPr id="2" name="Título 1">
             <a:extLst>
               <a:ext uri="{FF2B5EF4-FFF2-40B4-BE49-F238E27FC236}">
-                <a16:creationId xmlns:a16="http://schemas.microsoft.com/office/drawing/2014/main" id="{64AAEF42-BA40-0729-A70C-2A36EE7FD321}"/>
+                <a16:creationId xmlns:a16="http://schemas.microsoft.com/office/drawing/2014/main" id="{82600662-4170-C665-DB06-459359CC2E0D}"/>
               </a:ext>
             </a:extLst>
           </p:cNvPr>
@@ -3084,7 +3084,7 @@
           <p:cNvPr id="3" name="Marcador de texto 2">
             <a:extLst>
               <a:ext uri="{FF2B5EF4-FFF2-40B4-BE49-F238E27FC236}">
-                <a16:creationId xmlns:a16="http://schemas.microsoft.com/office/drawing/2014/main" id="{D3459255-DCD6-F1A0-044F-F4BDF91580A0}"/>
+                <a16:creationId xmlns:a16="http://schemas.microsoft.com/office/drawing/2014/main" id="{34166AF3-60A3-05C2-A67F-6AFFDC1D0DD5}"/>
               </a:ext>
             </a:extLst>
           </p:cNvPr>
@@ -3209,7 +3209,7 @@
           <p:cNvPr id="4" name="Marcador de fecha 3">
             <a:extLst>
               <a:ext uri="{FF2B5EF4-FFF2-40B4-BE49-F238E27FC236}">
-                <a16:creationId xmlns:a16="http://schemas.microsoft.com/office/drawing/2014/main" id="{7146DE2A-AFD4-3C58-4F1A-11539593B747}"/>
+                <a16:creationId xmlns:a16="http://schemas.microsoft.com/office/drawing/2014/main" id="{79B32DD2-B709-32DA-D2BD-C8E3BA72D344}"/>
               </a:ext>
             </a:extLst>
           </p:cNvPr>
@@ -3225,7 +3225,7 @@
           <a:bodyPr/>
           <a:lstStyle/>
           <a:p>
-            <a:fld id="{E73BE342-D7DD-451B-AD14-82C868274E08}" type="datetimeFigureOut">
+            <a:fld id="{E2E78F0F-3CEE-4885-8154-F908A2044D66}" type="datetimeFigureOut">
               <a:rPr lang="es-ES" smtClean="0"/>
               <a:t>04/06/2026</a:t>
             </a:fld>
@@ -3238,7 +3238,7 @@
           <p:cNvPr id="5" name="Marcador de pie de página 4">
             <a:extLst>
               <a:ext uri="{FF2B5EF4-FFF2-40B4-BE49-F238E27FC236}">
-                <a16:creationId xmlns:a16="http://schemas.microsoft.com/office/drawing/2014/main" id="{B27F29A4-4093-3258-0A3C-961B329F6F15}"/>
+                <a16:creationId xmlns:a16="http://schemas.microsoft.com/office/drawing/2014/main" id="{6AAD1399-A6BC-9A87-FD24-194BE9AA3A58}"/>
               </a:ext>
             </a:extLst>
           </p:cNvPr>
@@ -3263,7 +3263,7 @@
           <p:cNvPr id="6" name="Marcador de número de diapositiva 5">
             <a:extLst>
               <a:ext uri="{FF2B5EF4-FFF2-40B4-BE49-F238E27FC236}">
-                <a16:creationId xmlns:a16="http://schemas.microsoft.com/office/drawing/2014/main" id="{A0D340B9-FFE3-A5E5-F6E4-6425C57ECA2B}"/>
+                <a16:creationId xmlns:a16="http://schemas.microsoft.com/office/drawing/2014/main" id="{09E0E06C-E650-4ACD-18CA-DA6363ECDAED}"/>
               </a:ext>
             </a:extLst>
           </p:cNvPr>
@@ -3279,7 +3279,7 @@
           <a:bodyPr/>
           <a:lstStyle/>
           <a:p>
-            <a:fld id="{6FD9D725-7506-41FC-8170-7DB91405864C}" type="slidenum">
+            <a:fld id="{46952519-79A0-4158-88E8-8A74092916AE}" type="slidenum">
               <a:rPr lang="es-ES" smtClean="0"/>
               <a:t>‹Nº›</a:t>
             </a:fld>
@@ -3290,7 +3290,7 @@
     </p:spTree>
     <p:extLst>
       <p:ext uri="{BB962C8B-B14F-4D97-AF65-F5344CB8AC3E}">
-        <p14:creationId xmlns:p14="http://schemas.microsoft.com/office/powerpoint/2010/main" val="3835677720"/>
+        <p14:creationId xmlns:p14="http://schemas.microsoft.com/office/powerpoint/2010/main" val="3597848054"/>
       </p:ext>
     </p:extLst>
   </p:cSld>
@@ -3322,7 +3322,7 @@
           <p:cNvPr id="2" name="Título 1">
             <a:extLst>
               <a:ext uri="{FF2B5EF4-FFF2-40B4-BE49-F238E27FC236}">
-                <a16:creationId xmlns:a16="http://schemas.microsoft.com/office/drawing/2014/main" id="{78B94F00-0D14-904E-B176-36998E6C1E82}"/>
+                <a16:creationId xmlns:a16="http://schemas.microsoft.com/office/drawing/2014/main" id="{C091E38A-B22F-FE8F-9196-E213105FAE2C}"/>
               </a:ext>
             </a:extLst>
           </p:cNvPr>
@@ -3350,7 +3350,7 @@
           <p:cNvPr id="3" name="Marcador de contenido 2">
             <a:extLst>
               <a:ext uri="{FF2B5EF4-FFF2-40B4-BE49-F238E27FC236}">
-                <a16:creationId xmlns:a16="http://schemas.microsoft.com/office/drawing/2014/main" id="{493B5530-113B-AE52-651A-25A41E022961}"/>
+                <a16:creationId xmlns:a16="http://schemas.microsoft.com/office/drawing/2014/main" id="{C6EBF453-E43C-0A02-4091-6C7015F3B9C8}"/>
               </a:ext>
             </a:extLst>
           </p:cNvPr>
@@ -3412,7 +3412,7 @@
           <p:cNvPr id="4" name="Marcador de contenido 3">
             <a:extLst>
               <a:ext uri="{FF2B5EF4-FFF2-40B4-BE49-F238E27FC236}">
-                <a16:creationId xmlns:a16="http://schemas.microsoft.com/office/drawing/2014/main" id="{76A03271-B113-4954-906C-C73BEC104B47}"/>
+                <a16:creationId xmlns:a16="http://schemas.microsoft.com/office/drawing/2014/main" id="{D84394B1-538A-B357-5C7D-854245D3790B}"/>
               </a:ext>
             </a:extLst>
           </p:cNvPr>
@@ -3474,7 +3474,7 @@
           <p:cNvPr id="5" name="Marcador de fecha 4">
             <a:extLst>
               <a:ext uri="{FF2B5EF4-FFF2-40B4-BE49-F238E27FC236}">
-                <a16:creationId xmlns:a16="http://schemas.microsoft.com/office/drawing/2014/main" id="{A1322AE8-BA9D-2446-AD0D-6CBCA19B92C3}"/>
+                <a16:creationId xmlns:a16="http://schemas.microsoft.com/office/drawing/2014/main" id="{053AF158-81A4-ABF2-07DD-AF32BFFEA339}"/>
               </a:ext>
             </a:extLst>
           </p:cNvPr>
@@ -3490,7 +3490,7 @@
           <a:bodyPr/>
           <a:lstStyle/>
           <a:p>
-            <a:fld id="{E73BE342-D7DD-451B-AD14-82C868274E08}" type="datetimeFigureOut">
+            <a:fld id="{E2E78F0F-3CEE-4885-8154-F908A2044D66}" type="datetimeFigureOut">
               <a:rPr lang="es-ES" smtClean="0"/>
               <a:t>04/06/2026</a:t>
             </a:fld>
@@ -3503,7 +3503,7 @@
           <p:cNvPr id="6" name="Marcador de pie de página 5">
             <a:extLst>
               <a:ext uri="{FF2B5EF4-FFF2-40B4-BE49-F238E27FC236}">
-                <a16:creationId xmlns:a16="http://schemas.microsoft.com/office/drawing/2014/main" id="{E8DF4A91-2C26-BF79-7965-3ED466F989D6}"/>
+                <a16:creationId xmlns:a16="http://schemas.microsoft.com/office/drawing/2014/main" id="{3EF9A877-E9AB-59C6-23B3-6C02D30B1008}"/>
               </a:ext>
             </a:extLst>
           </p:cNvPr>
@@ -3528,7 +3528,7 @@
           <p:cNvPr id="7" name="Marcador de número de diapositiva 6">
             <a:extLst>
               <a:ext uri="{FF2B5EF4-FFF2-40B4-BE49-F238E27FC236}">
-                <a16:creationId xmlns:a16="http://schemas.microsoft.com/office/drawing/2014/main" id="{39431834-295F-9433-145C-D49A562923C6}"/>
+                <a16:creationId xmlns:a16="http://schemas.microsoft.com/office/drawing/2014/main" id="{37142DA6-7B1D-6C8A-937D-4C6456E20ADD}"/>
               </a:ext>
             </a:extLst>
           </p:cNvPr>
@@ -3544,7 +3544,7 @@
           <a:bodyPr/>
           <a:lstStyle/>
           <a:p>
-            <a:fld id="{6FD9D725-7506-41FC-8170-7DB91405864C}" type="slidenum">
+            <a:fld id="{46952519-79A0-4158-88E8-8A74092916AE}" type="slidenum">
               <a:rPr lang="es-ES" smtClean="0"/>
               <a:t>‹Nº›</a:t>
             </a:fld>
@@ -3555,7 +3555,7 @@
     </p:spTree>
     <p:extLst>
       <p:ext uri="{BB962C8B-B14F-4D97-AF65-F5344CB8AC3E}">
-        <p14:creationId xmlns:p14="http://schemas.microsoft.com/office/powerpoint/2010/main" val="2053610519"/>
+        <p14:creationId xmlns:p14="http://schemas.microsoft.com/office/powerpoint/2010/main" val="4097542271"/>
       </p:ext>
     </p:extLst>
   </p:cSld>
@@ -3587,7 +3587,7 @@
           <p:cNvPr id="2" name="Título 1">
             <a:extLst>
               <a:ext uri="{FF2B5EF4-FFF2-40B4-BE49-F238E27FC236}">
-                <a16:creationId xmlns:a16="http://schemas.microsoft.com/office/drawing/2014/main" id="{11BCC72D-511D-6920-BE7F-42ED9946CDBF}"/>
+                <a16:creationId xmlns:a16="http://schemas.microsoft.com/office/drawing/2014/main" id="{40028658-5B67-54CA-9D16-337A6BF0447A}"/>
               </a:ext>
             </a:extLst>
           </p:cNvPr>
@@ -3620,7 +3620,7 @@
           <p:cNvPr id="3" name="Marcador de texto 2">
             <a:extLst>
               <a:ext uri="{FF2B5EF4-FFF2-40B4-BE49-F238E27FC236}">
-                <a16:creationId xmlns:a16="http://schemas.microsoft.com/office/drawing/2014/main" id="{1ACBC7BB-CF81-BF60-C0F6-26ED73DB3C79}"/>
+                <a16:creationId xmlns:a16="http://schemas.microsoft.com/office/drawing/2014/main" id="{C465C81D-1ED4-C042-4601-4340ECB3F0FE}"/>
               </a:ext>
             </a:extLst>
           </p:cNvPr>
@@ -3691,7 +3691,7 @@
           <p:cNvPr id="4" name="Marcador de contenido 3">
             <a:extLst>
               <a:ext uri="{FF2B5EF4-FFF2-40B4-BE49-F238E27FC236}">
-                <a16:creationId xmlns:a16="http://schemas.microsoft.com/office/drawing/2014/main" id="{52FE16D2-F39F-089D-193D-3B959E4C2CAB}"/>
+                <a16:creationId xmlns:a16="http://schemas.microsoft.com/office/drawing/2014/main" id="{993A6344-F4A7-D7EF-9C4F-E25595ED966F}"/>
               </a:ext>
             </a:extLst>
           </p:cNvPr>
@@ -3753,7 +3753,7 @@
           <p:cNvPr id="5" name="Marcador de texto 4">
             <a:extLst>
               <a:ext uri="{FF2B5EF4-FFF2-40B4-BE49-F238E27FC236}">
-                <a16:creationId xmlns:a16="http://schemas.microsoft.com/office/drawing/2014/main" id="{341819A4-17FE-1CA8-96A5-F8505CF7C646}"/>
+                <a16:creationId xmlns:a16="http://schemas.microsoft.com/office/drawing/2014/main" id="{81F4BA7A-034E-68E1-7CFA-280FA4E742F0}"/>
               </a:ext>
             </a:extLst>
           </p:cNvPr>
@@ -3824,7 +3824,7 @@
           <p:cNvPr id="6" name="Marcador de contenido 5">
             <a:extLst>
               <a:ext uri="{FF2B5EF4-FFF2-40B4-BE49-F238E27FC236}">
-                <a16:creationId xmlns:a16="http://schemas.microsoft.com/office/drawing/2014/main" id="{826B7E0B-8418-5F0D-6EAA-C376B310D206}"/>
+                <a16:creationId xmlns:a16="http://schemas.microsoft.com/office/drawing/2014/main" id="{6C91CA2C-3974-A4FA-A2C2-491671D417D0}"/>
               </a:ext>
             </a:extLst>
           </p:cNvPr>
@@ -3886,7 +3886,7 @@
           <p:cNvPr id="7" name="Marcador de fecha 6">
             <a:extLst>
               <a:ext uri="{FF2B5EF4-FFF2-40B4-BE49-F238E27FC236}">
-                <a16:creationId xmlns:a16="http://schemas.microsoft.com/office/drawing/2014/main" id="{850D247B-4471-928E-453A-78414DD2F4B5}"/>
+                <a16:creationId xmlns:a16="http://schemas.microsoft.com/office/drawing/2014/main" id="{ECBCD274-D751-F6B5-415C-4DB4215F4E64}"/>
               </a:ext>
             </a:extLst>
           </p:cNvPr>
@@ -3902,7 +3902,7 @@
           <a:bodyPr/>
           <a:lstStyle/>
           <a:p>
-            <a:fld id="{E73BE342-D7DD-451B-AD14-82C868274E08}" type="datetimeFigureOut">
+            <a:fld id="{E2E78F0F-3CEE-4885-8154-F908A2044D66}" type="datetimeFigureOut">
               <a:rPr lang="es-ES" smtClean="0"/>
               <a:t>04/06/2026</a:t>
             </a:fld>
@@ -3915,7 +3915,7 @@
           <p:cNvPr id="8" name="Marcador de pie de página 7">
             <a:extLst>
               <a:ext uri="{FF2B5EF4-FFF2-40B4-BE49-F238E27FC236}">
-                <a16:creationId xmlns:a16="http://schemas.microsoft.com/office/drawing/2014/main" id="{2C42249F-6FFF-5075-6050-3EC420FEE3DE}"/>
+                <a16:creationId xmlns:a16="http://schemas.microsoft.com/office/drawing/2014/main" id="{23F6C764-59B3-F354-F39C-0B698E06CDD6}"/>
               </a:ext>
             </a:extLst>
           </p:cNvPr>
@@ -3940,7 +3940,7 @@
           <p:cNvPr id="9" name="Marcador de número de diapositiva 8">
             <a:extLst>
               <a:ext uri="{FF2B5EF4-FFF2-40B4-BE49-F238E27FC236}">
-                <a16:creationId xmlns:a16="http://schemas.microsoft.com/office/drawing/2014/main" id="{6C79DD70-C5DF-66FC-DFF2-B51B15815202}"/>
+                <a16:creationId xmlns:a16="http://schemas.microsoft.com/office/drawing/2014/main" id="{CE782C0D-E263-D0BA-CF46-A153B3B34B4E}"/>
               </a:ext>
             </a:extLst>
           </p:cNvPr>
@@ -3956,7 +3956,7 @@
           <a:bodyPr/>
           <a:lstStyle/>
           <a:p>
-            <a:fld id="{6FD9D725-7506-41FC-8170-7DB91405864C}" type="slidenum">
+            <a:fld id="{46952519-79A0-4158-88E8-8A74092916AE}" type="slidenum">
               <a:rPr lang="es-ES" smtClean="0"/>
               <a:t>‹Nº›</a:t>
             </a:fld>
@@ -3967,7 +3967,7 @@
     </p:spTree>
     <p:extLst>
       <p:ext uri="{BB962C8B-B14F-4D97-AF65-F5344CB8AC3E}">
-        <p14:creationId xmlns:p14="http://schemas.microsoft.com/office/powerpoint/2010/main" val="1064831127"/>
+        <p14:creationId xmlns:p14="http://schemas.microsoft.com/office/powerpoint/2010/main" val="2707746469"/>
       </p:ext>
     </p:extLst>
   </p:cSld>
@@ -3999,7 +3999,7 @@
           <p:cNvPr id="2" name="Título 1">
             <a:extLst>
               <a:ext uri="{FF2B5EF4-FFF2-40B4-BE49-F238E27FC236}">
-                <a16:creationId xmlns:a16="http://schemas.microsoft.com/office/drawing/2014/main" id="{03F38178-76A4-B331-2A9E-A7659945D3D1}"/>
+                <a16:creationId xmlns:a16="http://schemas.microsoft.com/office/drawing/2014/main" id="{E183BD55-2E13-228A-0225-943327F6E16A}"/>
               </a:ext>
             </a:extLst>
           </p:cNvPr>
@@ -4027,7 +4027,7 @@
           <p:cNvPr id="3" name="Marcador de fecha 2">
             <a:extLst>
               <a:ext uri="{FF2B5EF4-FFF2-40B4-BE49-F238E27FC236}">
-                <a16:creationId xmlns:a16="http://schemas.microsoft.com/office/drawing/2014/main" id="{60200D15-73B5-E260-A357-B362DEA24032}"/>
+                <a16:creationId xmlns:a16="http://schemas.microsoft.com/office/drawing/2014/main" id="{9CAB8DB0-2F1F-1FE4-64A1-D074513EE62C}"/>
               </a:ext>
             </a:extLst>
           </p:cNvPr>
@@ -4043,7 +4043,7 @@
           <a:bodyPr/>
           <a:lstStyle/>
           <a:p>
-            <a:fld id="{E73BE342-D7DD-451B-AD14-82C868274E08}" type="datetimeFigureOut">
+            <a:fld id="{E2E78F0F-3CEE-4885-8154-F908A2044D66}" type="datetimeFigureOut">
               <a:rPr lang="es-ES" smtClean="0"/>
               <a:t>04/06/2026</a:t>
             </a:fld>
@@ -4056,7 +4056,7 @@
           <p:cNvPr id="4" name="Marcador de pie de página 3">
             <a:extLst>
               <a:ext uri="{FF2B5EF4-FFF2-40B4-BE49-F238E27FC236}">
-                <a16:creationId xmlns:a16="http://schemas.microsoft.com/office/drawing/2014/main" id="{760AB9F3-A9CE-DD9B-4978-2DE5D6750B29}"/>
+                <a16:creationId xmlns:a16="http://schemas.microsoft.com/office/drawing/2014/main" id="{CFC9F4EA-37BC-C944-26B4-6A337A988C0A}"/>
               </a:ext>
             </a:extLst>
           </p:cNvPr>
@@ -4081,7 +4081,7 @@
           <p:cNvPr id="5" name="Marcador de número de diapositiva 4">
             <a:extLst>
               <a:ext uri="{FF2B5EF4-FFF2-40B4-BE49-F238E27FC236}">
-                <a16:creationId xmlns:a16="http://schemas.microsoft.com/office/drawing/2014/main" id="{51227177-DC65-A050-3E4B-DF0056169F36}"/>
+                <a16:creationId xmlns:a16="http://schemas.microsoft.com/office/drawing/2014/main" id="{778121AD-8A6E-31E7-7272-C41D8C9050CF}"/>
               </a:ext>
             </a:extLst>
           </p:cNvPr>
@@ -4097,7 +4097,7 @@
           <a:bodyPr/>
           <a:lstStyle/>
           <a:p>
-            <a:fld id="{6FD9D725-7506-41FC-8170-7DB91405864C}" type="slidenum">
+            <a:fld id="{46952519-79A0-4158-88E8-8A74092916AE}" type="slidenum">
               <a:rPr lang="es-ES" smtClean="0"/>
               <a:t>‹Nº›</a:t>
             </a:fld>
@@ -4108,7 +4108,7 @@
     </p:spTree>
     <p:extLst>
       <p:ext uri="{BB962C8B-B14F-4D97-AF65-F5344CB8AC3E}">
-        <p14:creationId xmlns:p14="http://schemas.microsoft.com/office/powerpoint/2010/main" val="3807265449"/>
+        <p14:creationId xmlns:p14="http://schemas.microsoft.com/office/powerpoint/2010/main" val="257178994"/>
       </p:ext>
     </p:extLst>
   </p:cSld>
@@ -4140,7 +4140,7 @@
           <p:cNvPr id="2" name="Marcador de fecha 1">
             <a:extLst>
               <a:ext uri="{FF2B5EF4-FFF2-40B4-BE49-F238E27FC236}">
-                <a16:creationId xmlns:a16="http://schemas.microsoft.com/office/drawing/2014/main" id="{8229C0B0-AE29-C48C-0010-0DE49A901C9E}"/>
+                <a16:creationId xmlns:a16="http://schemas.microsoft.com/office/drawing/2014/main" id="{58A47969-3E1B-ED92-16CC-CE89B8509379}"/>
               </a:ext>
             </a:extLst>
           </p:cNvPr>
@@ -4156,7 +4156,7 @@
           <a:bodyPr/>
           <a:lstStyle/>
           <a:p>
-            <a:fld id="{E73BE342-D7DD-451B-AD14-82C868274E08}" type="datetimeFigureOut">
+            <a:fld id="{E2E78F0F-3CEE-4885-8154-F908A2044D66}" type="datetimeFigureOut">
               <a:rPr lang="es-ES" smtClean="0"/>
               <a:t>04/06/2026</a:t>
             </a:fld>
@@ -4169,7 +4169,7 @@
           <p:cNvPr id="3" name="Marcador de pie de página 2">
             <a:extLst>
               <a:ext uri="{FF2B5EF4-FFF2-40B4-BE49-F238E27FC236}">
-                <a16:creationId xmlns:a16="http://schemas.microsoft.com/office/drawing/2014/main" id="{E76CADEE-B7C9-CCD6-43BE-0F08908D81D2}"/>
+                <a16:creationId xmlns:a16="http://schemas.microsoft.com/office/drawing/2014/main" id="{3BB28542-D8FC-A36E-EF27-65A8B9AE7E41}"/>
               </a:ext>
             </a:extLst>
           </p:cNvPr>
@@ -4194,7 +4194,7 @@
           <p:cNvPr id="4" name="Marcador de número de diapositiva 3">
             <a:extLst>
               <a:ext uri="{FF2B5EF4-FFF2-40B4-BE49-F238E27FC236}">
-                <a16:creationId xmlns:a16="http://schemas.microsoft.com/office/drawing/2014/main" id="{38003F7B-DC8E-12D2-BC5A-66BE8DA89F0C}"/>
+                <a16:creationId xmlns:a16="http://schemas.microsoft.com/office/drawing/2014/main" id="{A2717270-5F7C-D34B-6960-141579127B50}"/>
               </a:ext>
             </a:extLst>
           </p:cNvPr>
@@ -4210,7 +4210,7 @@
           <a:bodyPr/>
           <a:lstStyle/>
           <a:p>
-            <a:fld id="{6FD9D725-7506-41FC-8170-7DB91405864C}" type="slidenum">
+            <a:fld id="{46952519-79A0-4158-88E8-8A74092916AE}" type="slidenum">
               <a:rPr lang="es-ES" smtClean="0"/>
               <a:t>‹Nº›</a:t>
             </a:fld>
@@ -4221,7 +4221,7 @@
     </p:spTree>
     <p:extLst>
       <p:ext uri="{BB962C8B-B14F-4D97-AF65-F5344CB8AC3E}">
-        <p14:creationId xmlns:p14="http://schemas.microsoft.com/office/powerpoint/2010/main" val="3234240892"/>
+        <p14:creationId xmlns:p14="http://schemas.microsoft.com/office/powerpoint/2010/main" val="3366193428"/>
       </p:ext>
     </p:extLst>
   </p:cSld>
@@ -4253,7 +4253,7 @@
           <p:cNvPr id="2" name="Título 1">
             <a:extLst>
               <a:ext uri="{FF2B5EF4-FFF2-40B4-BE49-F238E27FC236}">
-                <a16:creationId xmlns:a16="http://schemas.microsoft.com/office/drawing/2014/main" id="{D6159500-3537-DA4B-C0CA-E54594CAA5E2}"/>
+                <a16:creationId xmlns:a16="http://schemas.microsoft.com/office/drawing/2014/main" id="{E341281F-CD36-D659-86DE-106EE7ED6CCE}"/>
               </a:ext>
             </a:extLst>
           </p:cNvPr>
@@ -4290,7 +4290,7 @@
           <p:cNvPr id="3" name="Marcador de contenido 2">
             <a:extLst>
               <a:ext uri="{FF2B5EF4-FFF2-40B4-BE49-F238E27FC236}">
-                <a16:creationId xmlns:a16="http://schemas.microsoft.com/office/drawing/2014/main" id="{05DD3EF1-7C1C-6D20-6A23-AF2B3129DA22}"/>
+                <a16:creationId xmlns:a16="http://schemas.microsoft.com/office/drawing/2014/main" id="{C224142D-642C-072C-D919-0568B512F890}"/>
               </a:ext>
             </a:extLst>
           </p:cNvPr>
@@ -4380,7 +4380,7 @@
           <p:cNvPr id="4" name="Marcador de texto 3">
             <a:extLst>
               <a:ext uri="{FF2B5EF4-FFF2-40B4-BE49-F238E27FC236}">
-                <a16:creationId xmlns:a16="http://schemas.microsoft.com/office/drawing/2014/main" id="{38F40C2D-2EE1-C28A-2458-77BD1D4201DE}"/>
+                <a16:creationId xmlns:a16="http://schemas.microsoft.com/office/drawing/2014/main" id="{410E3231-6562-4A3D-1446-E510FEB09834}"/>
               </a:ext>
             </a:extLst>
           </p:cNvPr>
@@ -4451,7 +4451,7 @@
           <p:cNvPr id="5" name="Marcador de fecha 4">
             <a:extLst>
               <a:ext uri="{FF2B5EF4-FFF2-40B4-BE49-F238E27FC236}">
-                <a16:creationId xmlns:a16="http://schemas.microsoft.com/office/drawing/2014/main" id="{D6E5CB27-9FB8-2BB8-78C3-418AAE0CB13E}"/>
+                <a16:creationId xmlns:a16="http://schemas.microsoft.com/office/drawing/2014/main" id="{B58E5A2C-8BE0-6D00-FC39-989C48DC0809}"/>
               </a:ext>
             </a:extLst>
           </p:cNvPr>
@@ -4467,7 +4467,7 @@
           <a:bodyPr/>
           <a:lstStyle/>
           <a:p>
-            <a:fld id="{E73BE342-D7DD-451B-AD14-82C868274E08}" type="datetimeFigureOut">
+            <a:fld id="{E2E78F0F-3CEE-4885-8154-F908A2044D66}" type="datetimeFigureOut">
               <a:rPr lang="es-ES" smtClean="0"/>
               <a:t>04/06/2026</a:t>
             </a:fld>
@@ -4480,7 +4480,7 @@
           <p:cNvPr id="6" name="Marcador de pie de página 5">
             <a:extLst>
               <a:ext uri="{FF2B5EF4-FFF2-40B4-BE49-F238E27FC236}">
-                <a16:creationId xmlns:a16="http://schemas.microsoft.com/office/drawing/2014/main" id="{CEF1D832-D974-547E-CB7A-AD9AEE891651}"/>
+                <a16:creationId xmlns:a16="http://schemas.microsoft.com/office/drawing/2014/main" id="{08CC6C97-AE09-1F9D-6F87-BF9F63F88C87}"/>
               </a:ext>
             </a:extLst>
           </p:cNvPr>
@@ -4505,7 +4505,7 @@
           <p:cNvPr id="7" name="Marcador de número de diapositiva 6">
             <a:extLst>
               <a:ext uri="{FF2B5EF4-FFF2-40B4-BE49-F238E27FC236}">
-                <a16:creationId xmlns:a16="http://schemas.microsoft.com/office/drawing/2014/main" id="{4FBAA768-B7D1-1B63-221A-F24EF8217FC0}"/>
+                <a16:creationId xmlns:a16="http://schemas.microsoft.com/office/drawing/2014/main" id="{30F77902-79A8-E248-30B6-A2643EE7E64C}"/>
               </a:ext>
             </a:extLst>
           </p:cNvPr>
@@ -4521,7 +4521,7 @@
           <a:bodyPr/>
           <a:lstStyle/>
           <a:p>
-            <a:fld id="{6FD9D725-7506-41FC-8170-7DB91405864C}" type="slidenum">
+            <a:fld id="{46952519-79A0-4158-88E8-8A74092916AE}" type="slidenum">
               <a:rPr lang="es-ES" smtClean="0"/>
               <a:t>‹Nº›</a:t>
             </a:fld>
@@ -4532,7 +4532,7 @@
     </p:spTree>
     <p:extLst>
       <p:ext uri="{BB962C8B-B14F-4D97-AF65-F5344CB8AC3E}">
-        <p14:creationId xmlns:p14="http://schemas.microsoft.com/office/powerpoint/2010/main" val="403530904"/>
+        <p14:creationId xmlns:p14="http://schemas.microsoft.com/office/powerpoint/2010/main" val="3290236475"/>
       </p:ext>
     </p:extLst>
   </p:cSld>
@@ -4564,7 +4564,7 @@
           <p:cNvPr id="2" name="Título 1">
             <a:extLst>
               <a:ext uri="{FF2B5EF4-FFF2-40B4-BE49-F238E27FC236}">
-                <a16:creationId xmlns:a16="http://schemas.microsoft.com/office/drawing/2014/main" id="{73C02CE7-273B-202F-86A5-660D06F4AADA}"/>
+                <a16:creationId xmlns:a16="http://schemas.microsoft.com/office/drawing/2014/main" id="{91C506FB-5CF0-C432-039B-B97BB2DF1F80}"/>
               </a:ext>
             </a:extLst>
           </p:cNvPr>
@@ -4601,7 +4601,7 @@
           <p:cNvPr id="3" name="Marcador de posición de imagen 2">
             <a:extLst>
               <a:ext uri="{FF2B5EF4-FFF2-40B4-BE49-F238E27FC236}">
-                <a16:creationId xmlns:a16="http://schemas.microsoft.com/office/drawing/2014/main" id="{3C23BBA2-5E06-6DCB-CC7C-50AD283617BC}"/>
+                <a16:creationId xmlns:a16="http://schemas.microsoft.com/office/drawing/2014/main" id="{89C27F13-5815-6B9E-9445-F23A1CA94996}"/>
               </a:ext>
             </a:extLst>
           </p:cNvPr>
@@ -4668,7 +4668,7 @@
           <p:cNvPr id="4" name="Marcador de texto 3">
             <a:extLst>
               <a:ext uri="{FF2B5EF4-FFF2-40B4-BE49-F238E27FC236}">
-                <a16:creationId xmlns:a16="http://schemas.microsoft.com/office/drawing/2014/main" id="{E8B20A7D-D21E-F9D5-92A4-B6A8C00A2681}"/>
+                <a16:creationId xmlns:a16="http://schemas.microsoft.com/office/drawing/2014/main" id="{348BC20F-73A3-FAAD-F67E-B97383B3A84F}"/>
               </a:ext>
             </a:extLst>
           </p:cNvPr>
@@ -4739,7 +4739,7 @@
           <p:cNvPr id="5" name="Marcador de fecha 4">
             <a:extLst>
               <a:ext uri="{FF2B5EF4-FFF2-40B4-BE49-F238E27FC236}">
-                <a16:creationId xmlns:a16="http://schemas.microsoft.com/office/drawing/2014/main" id="{E49C27BD-02C1-2843-D31A-8E3669C129B5}"/>
+                <a16:creationId xmlns:a16="http://schemas.microsoft.com/office/drawing/2014/main" id="{04B25C72-DEF8-D9F8-AC95-584D94CF2399}"/>
               </a:ext>
             </a:extLst>
           </p:cNvPr>
@@ -4755,7 +4755,7 @@
           <a:bodyPr/>
           <a:lstStyle/>
           <a:p>
-            <a:fld id="{E73BE342-D7DD-451B-AD14-82C868274E08}" type="datetimeFigureOut">
+            <a:fld id="{E2E78F0F-3CEE-4885-8154-F908A2044D66}" type="datetimeFigureOut">
               <a:rPr lang="es-ES" smtClean="0"/>
               <a:t>04/06/2026</a:t>
             </a:fld>
@@ -4768,7 +4768,7 @@
           <p:cNvPr id="6" name="Marcador de pie de página 5">
             <a:extLst>
               <a:ext uri="{FF2B5EF4-FFF2-40B4-BE49-F238E27FC236}">
-                <a16:creationId xmlns:a16="http://schemas.microsoft.com/office/drawing/2014/main" id="{E449C1DD-B05C-912E-CED6-22E1EF1F3C0F}"/>
+                <a16:creationId xmlns:a16="http://schemas.microsoft.com/office/drawing/2014/main" id="{80AAEA25-F95A-2D0A-C685-AD30116B1904}"/>
               </a:ext>
             </a:extLst>
           </p:cNvPr>
@@ -4793,7 +4793,7 @@
           <p:cNvPr id="7" name="Marcador de número de diapositiva 6">
             <a:extLst>
               <a:ext uri="{FF2B5EF4-FFF2-40B4-BE49-F238E27FC236}">
-                <a16:creationId xmlns:a16="http://schemas.microsoft.com/office/drawing/2014/main" id="{34B6D4C3-A6C8-D11F-D069-D82929C3090F}"/>
+                <a16:creationId xmlns:a16="http://schemas.microsoft.com/office/drawing/2014/main" id="{1673DFFB-DCB5-059A-0FE4-56B857D72841}"/>
               </a:ext>
             </a:extLst>
           </p:cNvPr>
@@ -4809,7 +4809,7 @@
           <a:bodyPr/>
           <a:lstStyle/>
           <a:p>
-            <a:fld id="{6FD9D725-7506-41FC-8170-7DB91405864C}" type="slidenum">
+            <a:fld id="{46952519-79A0-4158-88E8-8A74092916AE}" type="slidenum">
               <a:rPr lang="es-ES" smtClean="0"/>
               <a:t>‹Nº›</a:t>
             </a:fld>
@@ -4820,7 +4820,7 @@
     </p:spTree>
     <p:extLst>
       <p:ext uri="{BB962C8B-B14F-4D97-AF65-F5344CB8AC3E}">
-        <p14:creationId xmlns:p14="http://schemas.microsoft.com/office/powerpoint/2010/main" val="898962150"/>
+        <p14:creationId xmlns:p14="http://schemas.microsoft.com/office/powerpoint/2010/main" val="1654087475"/>
       </p:ext>
     </p:extLst>
   </p:cSld>
@@ -4857,7 +4857,7 @@
           <p:cNvPr id="2" name="Marcador de título 1">
             <a:extLst>
               <a:ext uri="{FF2B5EF4-FFF2-40B4-BE49-F238E27FC236}">
-                <a16:creationId xmlns:a16="http://schemas.microsoft.com/office/drawing/2014/main" id="{4419D82E-0087-689E-BF57-2BAA82B8D7BB}"/>
+                <a16:creationId xmlns:a16="http://schemas.microsoft.com/office/drawing/2014/main" id="{88310B3C-28D4-62C9-F1BE-20E888886D1E}"/>
               </a:ext>
             </a:extLst>
           </p:cNvPr>
@@ -4895,7 +4895,7 @@
           <p:cNvPr id="3" name="Marcador de texto 2">
             <a:extLst>
               <a:ext uri="{FF2B5EF4-FFF2-40B4-BE49-F238E27FC236}">
-                <a16:creationId xmlns:a16="http://schemas.microsoft.com/office/drawing/2014/main" id="{4FAF4DCC-0BF4-ABD8-441B-4E1DC607AE53}"/>
+                <a16:creationId xmlns:a16="http://schemas.microsoft.com/office/drawing/2014/main" id="{33B3B629-4395-EC08-80FC-6A6764A854F9}"/>
               </a:ext>
             </a:extLst>
           </p:cNvPr>
@@ -4962,7 +4962,7 @@
           <p:cNvPr id="4" name="Marcador de fecha 3">
             <a:extLst>
               <a:ext uri="{FF2B5EF4-FFF2-40B4-BE49-F238E27FC236}">
-                <a16:creationId xmlns:a16="http://schemas.microsoft.com/office/drawing/2014/main" id="{6673BBC5-9DC4-9DE1-BD15-DAD8E6BA7ACB}"/>
+                <a16:creationId xmlns:a16="http://schemas.microsoft.com/office/drawing/2014/main" id="{BC119E05-ADFF-C607-FA6E-6FD98CFD1262}"/>
               </a:ext>
             </a:extLst>
           </p:cNvPr>
@@ -4996,7 +4996,7 @@
             </a:lvl1pPr>
           </a:lstStyle>
           <a:p>
-            <a:fld id="{E73BE342-D7DD-451B-AD14-82C868274E08}" type="datetimeFigureOut">
+            <a:fld id="{E2E78F0F-3CEE-4885-8154-F908A2044D66}" type="datetimeFigureOut">
               <a:rPr lang="es-ES" smtClean="0"/>
               <a:t>04/06/2026</a:t>
             </a:fld>
@@ -5009,7 +5009,7 @@
           <p:cNvPr id="5" name="Marcador de pie de página 4">
             <a:extLst>
               <a:ext uri="{FF2B5EF4-FFF2-40B4-BE49-F238E27FC236}">
-                <a16:creationId xmlns:a16="http://schemas.microsoft.com/office/drawing/2014/main" id="{EB8C28AD-308E-1D2F-9A99-1909B272495D}"/>
+                <a16:creationId xmlns:a16="http://schemas.microsoft.com/office/drawing/2014/main" id="{B224DE56-7325-AD5A-0436-C8500CBF81F0}"/>
               </a:ext>
             </a:extLst>
           </p:cNvPr>
@@ -5052,7 +5052,7 @@
           <p:cNvPr id="6" name="Marcador de número de diapositiva 5">
             <a:extLst>
               <a:ext uri="{FF2B5EF4-FFF2-40B4-BE49-F238E27FC236}">
-                <a16:creationId xmlns:a16="http://schemas.microsoft.com/office/drawing/2014/main" id="{AAB7F528-8CB8-68C6-D78E-044DBB56B50E}"/>
+                <a16:creationId xmlns:a16="http://schemas.microsoft.com/office/drawing/2014/main" id="{71E2069E-B394-5813-CC53-7A97F6409FC9}"/>
               </a:ext>
             </a:extLst>
           </p:cNvPr>
@@ -5086,7 +5086,7 @@
             </a:lvl1pPr>
           </a:lstStyle>
           <a:p>
-            <a:fld id="{6FD9D725-7506-41FC-8170-7DB91405864C}" type="slidenum">
+            <a:fld id="{46952519-79A0-4158-88E8-8A74092916AE}" type="slidenum">
               <a:rPr lang="es-ES" smtClean="0"/>
               <a:t>‹Nº›</a:t>
             </a:fld>
@@ -5097,7 +5097,7 @@
     </p:spTree>
     <p:extLst>
       <p:ext uri="{BB962C8B-B14F-4D97-AF65-F5344CB8AC3E}">
-        <p14:creationId xmlns:p14="http://schemas.microsoft.com/office/powerpoint/2010/main" val="881759497"/>
+        <p14:creationId xmlns:p14="http://schemas.microsoft.com/office/powerpoint/2010/main" val="1101064486"/>
       </p:ext>
     </p:extLst>
   </p:cSld>
@@ -5428,7 +5428,7 @@
           <p:cNvPr id="2" name="Rectángulo: esquinas redondeadas 1">
             <a:extLst>
               <a:ext uri="{FF2B5EF4-FFF2-40B4-BE49-F238E27FC236}">
-                <a16:creationId xmlns:a16="http://schemas.microsoft.com/office/drawing/2014/main" id="{93327B80-5FFB-BBD9-8E99-5E23CE81DD0C}"/>
+                <a16:creationId xmlns:a16="http://schemas.microsoft.com/office/drawing/2014/main" id="{8737DDCC-1875-8BE5-E51F-8A4C0CEA6EA5}"/>
               </a:ext>
             </a:extLst>
           </p:cNvPr>
@@ -5482,7 +5482,7 @@
           <p:cNvPr id="3" name="CuadroTexto 2">
             <a:extLst>
               <a:ext uri="{FF2B5EF4-FFF2-40B4-BE49-F238E27FC236}">
-                <a16:creationId xmlns:a16="http://schemas.microsoft.com/office/drawing/2014/main" id="{44EA39D6-B4DB-7FD6-5373-FAD564E36E25}"/>
+                <a16:creationId xmlns:a16="http://schemas.microsoft.com/office/drawing/2014/main" id="{6DD45364-6171-ADD6-2A3E-345700050954}"/>
               </a:ext>
             </a:extLst>
           </p:cNvPr>
@@ -5522,7 +5522,7 @@
           <p:cNvPr id="4" name="CuadroTexto 3">
             <a:extLst>
               <a:ext uri="{FF2B5EF4-FFF2-40B4-BE49-F238E27FC236}">
-                <a16:creationId xmlns:a16="http://schemas.microsoft.com/office/drawing/2014/main" id="{DDAF5003-B482-51BD-0CFD-BE37C8229055}"/>
+                <a16:creationId xmlns:a16="http://schemas.microsoft.com/office/drawing/2014/main" id="{07654982-0FBC-8954-CBFE-78E53DFA2B22}"/>
               </a:ext>
             </a:extLst>
           </p:cNvPr>
@@ -5562,7 +5562,7 @@
           <p:cNvPr id="5" name="CuadroTexto 4">
             <a:extLst>
               <a:ext uri="{FF2B5EF4-FFF2-40B4-BE49-F238E27FC236}">
-                <a16:creationId xmlns:a16="http://schemas.microsoft.com/office/drawing/2014/main" id="{0A01554D-D835-8E0D-A4D8-E128D009EB83}"/>
+                <a16:creationId xmlns:a16="http://schemas.microsoft.com/office/drawing/2014/main" id="{C61F902F-DB39-AF54-27DD-953366FED8A9}"/>
               </a:ext>
             </a:extLst>
           </p:cNvPr>
@@ -5602,7 +5602,7 @@
           <p:cNvPr id="6" name="CuadroTexto 5">
             <a:extLst>
               <a:ext uri="{FF2B5EF4-FFF2-40B4-BE49-F238E27FC236}">
-                <a16:creationId xmlns:a16="http://schemas.microsoft.com/office/drawing/2014/main" id="{1EA13658-AE0B-761C-101A-CE5DB75CBB50}"/>
+                <a16:creationId xmlns:a16="http://schemas.microsoft.com/office/drawing/2014/main" id="{70F2886B-368E-3156-B869-08353B9C0C0D}"/>
               </a:ext>
             </a:extLst>
           </p:cNvPr>
@@ -5653,7 +5653,7 @@
           <p:cNvPr id="8" name="Imagen 7">
             <a:extLst>
               <a:ext uri="{FF2B5EF4-FFF2-40B4-BE49-F238E27FC236}">
-                <a16:creationId xmlns:a16="http://schemas.microsoft.com/office/drawing/2014/main" id="{718514E0-622E-A1A3-59C9-67CD4DEAEB10}"/>
+                <a16:creationId xmlns:a16="http://schemas.microsoft.com/office/drawing/2014/main" id="{D499C65C-77DE-3433-C918-7C8C67DF1528}"/>
               </a:ext>
             </a:extLst>
           </p:cNvPr>
@@ -5692,7 +5692,7 @@
     </p:spTree>
     <p:extLst>
       <p:ext uri="{BB962C8B-B14F-4D97-AF65-F5344CB8AC3E}">
-        <p14:creationId xmlns:p14="http://schemas.microsoft.com/office/powerpoint/2010/main" val="1422064104"/>
+        <p14:creationId xmlns:p14="http://schemas.microsoft.com/office/powerpoint/2010/main" val="2893945376"/>
       </p:ext>
     </p:extLst>
   </p:cSld>
@@ -5732,7 +5732,7 @@
           <p:cNvPr id="2" name="CuadroTexto 1">
             <a:extLst>
               <a:ext uri="{FF2B5EF4-FFF2-40B4-BE49-F238E27FC236}">
-                <a16:creationId xmlns:a16="http://schemas.microsoft.com/office/drawing/2014/main" id="{3374D3E1-8E05-B726-C5F1-378BF8E59803}"/>
+                <a16:creationId xmlns:a16="http://schemas.microsoft.com/office/drawing/2014/main" id="{5C0E4828-1C29-937D-33E4-1F1429E9E660}"/>
               </a:ext>
             </a:extLst>
           </p:cNvPr>
@@ -5772,7 +5772,7 @@
           <p:cNvPr id="3" name="CuadroTexto 2">
             <a:extLst>
               <a:ext uri="{FF2B5EF4-FFF2-40B4-BE49-F238E27FC236}">
-                <a16:creationId xmlns:a16="http://schemas.microsoft.com/office/drawing/2014/main" id="{778B9665-64C9-ACC9-48C6-E0EFDE306C44}"/>
+                <a16:creationId xmlns:a16="http://schemas.microsoft.com/office/drawing/2014/main" id="{E2D65E2E-9E1F-8B89-45B2-5009ABE00CDA}"/>
               </a:ext>
             </a:extLst>
           </p:cNvPr>
@@ -5812,7 +5812,7 @@
           <p:cNvPr id="4" name="CuadroTexto 3">
             <a:extLst>
               <a:ext uri="{FF2B5EF4-FFF2-40B4-BE49-F238E27FC236}">
-                <a16:creationId xmlns:a16="http://schemas.microsoft.com/office/drawing/2014/main" id="{9BE82840-970E-0071-12E3-958E0A1AEB29}"/>
+                <a16:creationId xmlns:a16="http://schemas.microsoft.com/office/drawing/2014/main" id="{29226C08-5A82-C22F-EB54-B2F993806C81}"/>
               </a:ext>
             </a:extLst>
           </p:cNvPr>
@@ -5852,7 +5852,7 @@
           <p:cNvPr id="5" name="Rectángulo: esquinas redondeadas 4">
             <a:extLst>
               <a:ext uri="{FF2B5EF4-FFF2-40B4-BE49-F238E27FC236}">
-                <a16:creationId xmlns:a16="http://schemas.microsoft.com/office/drawing/2014/main" id="{5645629F-5F2D-D309-C061-C0D87F663F90}"/>
+                <a16:creationId xmlns:a16="http://schemas.microsoft.com/office/drawing/2014/main" id="{28246C8D-8025-6EFC-02D8-B7B512746A2C}"/>
               </a:ext>
             </a:extLst>
           </p:cNvPr>
@@ -5906,7 +5906,7 @@
           <p:cNvPr id="6" name="CuadroTexto 5">
             <a:extLst>
               <a:ext uri="{FF2B5EF4-FFF2-40B4-BE49-F238E27FC236}">
-                <a16:creationId xmlns:a16="http://schemas.microsoft.com/office/drawing/2014/main" id="{B0D80F07-D7E8-B853-9F6F-801C5B25AF9D}"/>
+                <a16:creationId xmlns:a16="http://schemas.microsoft.com/office/drawing/2014/main" id="{66FDA293-01D7-B04A-9013-9E654A575CFC}"/>
               </a:ext>
             </a:extLst>
           </p:cNvPr>
@@ -5946,7 +5946,7 @@
           <p:cNvPr id="7" name="CuadroTexto 6">
             <a:extLst>
               <a:ext uri="{FF2B5EF4-FFF2-40B4-BE49-F238E27FC236}">
-                <a16:creationId xmlns:a16="http://schemas.microsoft.com/office/drawing/2014/main" id="{0D47D3A7-7258-E37D-C44E-EB4D889FF13E}"/>
+                <a16:creationId xmlns:a16="http://schemas.microsoft.com/office/drawing/2014/main" id="{E55B17D5-6E1D-AA9A-A1D4-D5B4E829EC9C}"/>
               </a:ext>
             </a:extLst>
           </p:cNvPr>
@@ -6065,7 +6065,7 @@
           <p:cNvPr id="8" name="Rectángulo: esquinas redondeadas 7">
             <a:extLst>
               <a:ext uri="{FF2B5EF4-FFF2-40B4-BE49-F238E27FC236}">
-                <a16:creationId xmlns:a16="http://schemas.microsoft.com/office/drawing/2014/main" id="{75B6BBD5-D47B-4801-21E3-BE6D8B77347F}"/>
+                <a16:creationId xmlns:a16="http://schemas.microsoft.com/office/drawing/2014/main" id="{583A4A61-D0C8-DBFE-7567-FD84A94DF6D1}"/>
               </a:ext>
             </a:extLst>
           </p:cNvPr>
@@ -6119,7 +6119,7 @@
           <p:cNvPr id="9" name="CuadroTexto 8">
             <a:extLst>
               <a:ext uri="{FF2B5EF4-FFF2-40B4-BE49-F238E27FC236}">
-                <a16:creationId xmlns:a16="http://schemas.microsoft.com/office/drawing/2014/main" id="{265814E6-476A-BA96-BE11-F7C0B58B2AA2}"/>
+                <a16:creationId xmlns:a16="http://schemas.microsoft.com/office/drawing/2014/main" id="{36B1F2E2-A653-03D6-C5BF-E7D7561BE8B7}"/>
               </a:ext>
             </a:extLst>
           </p:cNvPr>
@@ -6159,7 +6159,7 @@
           <p:cNvPr id="10" name="CuadroTexto 9">
             <a:extLst>
               <a:ext uri="{FF2B5EF4-FFF2-40B4-BE49-F238E27FC236}">
-                <a16:creationId xmlns:a16="http://schemas.microsoft.com/office/drawing/2014/main" id="{BE86C99D-973B-6DD4-9BC3-B919BC37CF15}"/>
+                <a16:creationId xmlns:a16="http://schemas.microsoft.com/office/drawing/2014/main" id="{CBB04404-3432-A8DD-0CDD-8B3A1AA4B6B6}"/>
               </a:ext>
             </a:extLst>
           </p:cNvPr>
@@ -6199,7 +6199,7 @@
           <p:cNvPr id="11" name="Rectángulo: esquinas redondeadas 10">
             <a:extLst>
               <a:ext uri="{FF2B5EF4-FFF2-40B4-BE49-F238E27FC236}">
-                <a16:creationId xmlns:a16="http://schemas.microsoft.com/office/drawing/2014/main" id="{15977E5D-B5F7-7CC7-4A73-0667730AD9D6}"/>
+                <a16:creationId xmlns:a16="http://schemas.microsoft.com/office/drawing/2014/main" id="{250A7652-C606-00FA-745C-03DFDA082649}"/>
               </a:ext>
             </a:extLst>
           </p:cNvPr>
@@ -6253,7 +6253,7 @@
           <p:cNvPr id="12" name="CuadroTexto 11">
             <a:extLst>
               <a:ext uri="{FF2B5EF4-FFF2-40B4-BE49-F238E27FC236}">
-                <a16:creationId xmlns:a16="http://schemas.microsoft.com/office/drawing/2014/main" id="{42AF80DE-8F1F-C120-79F6-2001AF2ACA7A}"/>
+                <a16:creationId xmlns:a16="http://schemas.microsoft.com/office/drawing/2014/main" id="{713F77D9-36EB-82B4-2E16-791E0A65AEA6}"/>
               </a:ext>
             </a:extLst>
           </p:cNvPr>
@@ -6293,7 +6293,7 @@
           <p:cNvPr id="13" name="CuadroTexto 12">
             <a:extLst>
               <a:ext uri="{FF2B5EF4-FFF2-40B4-BE49-F238E27FC236}">
-                <a16:creationId xmlns:a16="http://schemas.microsoft.com/office/drawing/2014/main" id="{DB5FDE6D-93F7-CCD6-D34B-33A9BF0DB37B}"/>
+                <a16:creationId xmlns:a16="http://schemas.microsoft.com/office/drawing/2014/main" id="{52E5D48B-CA6F-A798-197D-25A47EA9A5F4}"/>
               </a:ext>
             </a:extLst>
           </p:cNvPr>
@@ -6333,7 +6333,7 @@
           <p:cNvPr id="14" name="Rectángulo: esquinas redondeadas 13">
             <a:extLst>
               <a:ext uri="{FF2B5EF4-FFF2-40B4-BE49-F238E27FC236}">
-                <a16:creationId xmlns:a16="http://schemas.microsoft.com/office/drawing/2014/main" id="{F38068D3-3A9A-2292-32C1-36B0953AEF3D}"/>
+                <a16:creationId xmlns:a16="http://schemas.microsoft.com/office/drawing/2014/main" id="{83415978-DB9A-4F0E-01AD-3FD52A75EE9A}"/>
               </a:ext>
             </a:extLst>
           </p:cNvPr>
@@ -6387,7 +6387,7 @@
           <p:cNvPr id="15" name="CuadroTexto 14">
             <a:extLst>
               <a:ext uri="{FF2B5EF4-FFF2-40B4-BE49-F238E27FC236}">
-                <a16:creationId xmlns:a16="http://schemas.microsoft.com/office/drawing/2014/main" id="{A5B2DF49-6987-A79E-C708-8114F7A6772F}"/>
+                <a16:creationId xmlns:a16="http://schemas.microsoft.com/office/drawing/2014/main" id="{10CC2D39-4B6F-7D89-412F-8E5898BC6A26}"/>
               </a:ext>
             </a:extLst>
           </p:cNvPr>
@@ -6427,7 +6427,7 @@
           <p:cNvPr id="16" name="CuadroTexto 15">
             <a:extLst>
               <a:ext uri="{FF2B5EF4-FFF2-40B4-BE49-F238E27FC236}">
-                <a16:creationId xmlns:a16="http://schemas.microsoft.com/office/drawing/2014/main" id="{5E5CB0A2-3CF0-191E-2E10-BCCDFFF569AD}"/>
+                <a16:creationId xmlns:a16="http://schemas.microsoft.com/office/drawing/2014/main" id="{BE373084-1D6E-2C7D-24EC-F353109D2B6C}"/>
               </a:ext>
             </a:extLst>
           </p:cNvPr>
@@ -6467,7 +6467,7 @@
           <p:cNvPr id="17" name="Rectángulo: esquinas redondeadas 16">
             <a:extLst>
               <a:ext uri="{FF2B5EF4-FFF2-40B4-BE49-F238E27FC236}">
-                <a16:creationId xmlns:a16="http://schemas.microsoft.com/office/drawing/2014/main" id="{1E0BC151-3436-50C9-3ECE-87EFC438422E}"/>
+                <a16:creationId xmlns:a16="http://schemas.microsoft.com/office/drawing/2014/main" id="{A8134A8D-1FC6-953C-45FB-3EB6E5D196DE}"/>
               </a:ext>
             </a:extLst>
           </p:cNvPr>
@@ -6521,7 +6521,7 @@
           <p:cNvPr id="18" name="CuadroTexto 17">
             <a:extLst>
               <a:ext uri="{FF2B5EF4-FFF2-40B4-BE49-F238E27FC236}">
-                <a16:creationId xmlns:a16="http://schemas.microsoft.com/office/drawing/2014/main" id="{DE120990-9474-37D3-4311-ACFE33B3AF97}"/>
+                <a16:creationId xmlns:a16="http://schemas.microsoft.com/office/drawing/2014/main" id="{491CD917-1C2C-5FBA-EB4D-ADEA25ED1180}"/>
               </a:ext>
             </a:extLst>
           </p:cNvPr>
@@ -6561,7 +6561,7 @@
           <p:cNvPr id="19" name="CuadroTexto 18">
             <a:extLst>
               <a:ext uri="{FF2B5EF4-FFF2-40B4-BE49-F238E27FC236}">
-                <a16:creationId xmlns:a16="http://schemas.microsoft.com/office/drawing/2014/main" id="{8751CA69-41EE-3158-CC49-C07B843A509D}"/>
+                <a16:creationId xmlns:a16="http://schemas.microsoft.com/office/drawing/2014/main" id="{99E9EF68-7555-59F0-BC94-1890DCBDA0E5}"/>
               </a:ext>
             </a:extLst>
           </p:cNvPr>
@@ -6599,7 +6599,7 @@
     </p:spTree>
     <p:extLst>
       <p:ext uri="{BB962C8B-B14F-4D97-AF65-F5344CB8AC3E}">
-        <p14:creationId xmlns:p14="http://schemas.microsoft.com/office/powerpoint/2010/main" val="2847701502"/>
+        <p14:creationId xmlns:p14="http://schemas.microsoft.com/office/powerpoint/2010/main" val="178090368"/>
       </p:ext>
     </p:extLst>
   </p:cSld>
@@ -6639,7 +6639,7 @@
           <p:cNvPr id="2" name="CuadroTexto 1">
             <a:extLst>
               <a:ext uri="{FF2B5EF4-FFF2-40B4-BE49-F238E27FC236}">
-                <a16:creationId xmlns:a16="http://schemas.microsoft.com/office/drawing/2014/main" id="{1BFC0396-2A65-7C5C-BD6D-A3CD1F05C574}"/>
+                <a16:creationId xmlns:a16="http://schemas.microsoft.com/office/drawing/2014/main" id="{65AC85FA-F908-4E21-70D9-CF67D755409D}"/>
               </a:ext>
             </a:extLst>
           </p:cNvPr>
@@ -6679,7 +6679,7 @@
           <p:cNvPr id="3" name="CuadroTexto 2">
             <a:extLst>
               <a:ext uri="{FF2B5EF4-FFF2-40B4-BE49-F238E27FC236}">
-                <a16:creationId xmlns:a16="http://schemas.microsoft.com/office/drawing/2014/main" id="{B83C3B01-4369-B14C-3B22-DAAC33E8EC4B}"/>
+                <a16:creationId xmlns:a16="http://schemas.microsoft.com/office/drawing/2014/main" id="{F0F54596-0118-8B63-D32D-7A17BB203100}"/>
               </a:ext>
             </a:extLst>
           </p:cNvPr>
@@ -6719,7 +6719,7 @@
           <p:cNvPr id="4" name="CuadroTexto 3">
             <a:extLst>
               <a:ext uri="{FF2B5EF4-FFF2-40B4-BE49-F238E27FC236}">
-                <a16:creationId xmlns:a16="http://schemas.microsoft.com/office/drawing/2014/main" id="{0ED18EBC-AA24-75AC-831E-459940DC4216}"/>
+                <a16:creationId xmlns:a16="http://schemas.microsoft.com/office/drawing/2014/main" id="{6165C584-4F58-F8C7-88AA-11E962CB6197}"/>
               </a:ext>
             </a:extLst>
           </p:cNvPr>
@@ -6759,7 +6759,7 @@
           <p:cNvPr id="5" name="Rectángulo: esquinas redondeadas 4">
             <a:extLst>
               <a:ext uri="{FF2B5EF4-FFF2-40B4-BE49-F238E27FC236}">
-                <a16:creationId xmlns:a16="http://schemas.microsoft.com/office/drawing/2014/main" id="{3834664E-4D88-FD0E-3B1C-AD58F616C932}"/>
+                <a16:creationId xmlns:a16="http://schemas.microsoft.com/office/drawing/2014/main" id="{13092FAF-37A2-B925-95C1-032895FE96C2}"/>
               </a:ext>
             </a:extLst>
           </p:cNvPr>
@@ -6813,7 +6813,7 @@
           <p:cNvPr id="6" name="CuadroTexto 5">
             <a:extLst>
               <a:ext uri="{FF2B5EF4-FFF2-40B4-BE49-F238E27FC236}">
-                <a16:creationId xmlns:a16="http://schemas.microsoft.com/office/drawing/2014/main" id="{258BB420-ABBF-1933-C98C-9475D272671B}"/>
+                <a16:creationId xmlns:a16="http://schemas.microsoft.com/office/drawing/2014/main" id="{DB589446-30CE-4263-EBCA-7A3DD5093426}"/>
               </a:ext>
             </a:extLst>
           </p:cNvPr>
@@ -6853,7 +6853,7 @@
           <p:cNvPr id="7" name="CuadroTexto 6">
             <a:extLst>
               <a:ext uri="{FF2B5EF4-FFF2-40B4-BE49-F238E27FC236}">
-                <a16:creationId xmlns:a16="http://schemas.microsoft.com/office/drawing/2014/main" id="{9C5FE3DF-3B88-5C06-554E-9829D2837B33}"/>
+                <a16:creationId xmlns:a16="http://schemas.microsoft.com/office/drawing/2014/main" id="{688ECCFA-E19E-E1B3-4097-4BD64C834C71}"/>
               </a:ext>
             </a:extLst>
           </p:cNvPr>
@@ -6893,7 +6893,7 @@
           <p:cNvPr id="8" name="Rectángulo: esquinas redondeadas 7">
             <a:extLst>
               <a:ext uri="{FF2B5EF4-FFF2-40B4-BE49-F238E27FC236}">
-                <a16:creationId xmlns:a16="http://schemas.microsoft.com/office/drawing/2014/main" id="{22BAA209-0796-F4C2-D741-E83A03ADFBF4}"/>
+                <a16:creationId xmlns:a16="http://schemas.microsoft.com/office/drawing/2014/main" id="{BA3AE05E-29E8-E5EA-516B-32AC9B2365C7}"/>
               </a:ext>
             </a:extLst>
           </p:cNvPr>
@@ -6947,7 +6947,7 @@
           <p:cNvPr id="9" name="CuadroTexto 8">
             <a:extLst>
               <a:ext uri="{FF2B5EF4-FFF2-40B4-BE49-F238E27FC236}">
-                <a16:creationId xmlns:a16="http://schemas.microsoft.com/office/drawing/2014/main" id="{5C469DFF-7C0E-9DA5-488E-2FB234357FD4}"/>
+                <a16:creationId xmlns:a16="http://schemas.microsoft.com/office/drawing/2014/main" id="{7E796478-CBB1-ECEB-CE26-BB0E255D469E}"/>
               </a:ext>
             </a:extLst>
           </p:cNvPr>
@@ -6987,7 +6987,7 @@
           <p:cNvPr id="10" name="CuadroTexto 9">
             <a:extLst>
               <a:ext uri="{FF2B5EF4-FFF2-40B4-BE49-F238E27FC236}">
-                <a16:creationId xmlns:a16="http://schemas.microsoft.com/office/drawing/2014/main" id="{6EF2C389-3F2D-C8B6-9EE8-E0DD9D310C2F}"/>
+                <a16:creationId xmlns:a16="http://schemas.microsoft.com/office/drawing/2014/main" id="{C890C099-AC11-E3DB-AD11-92819D6DC2FA}"/>
               </a:ext>
             </a:extLst>
           </p:cNvPr>
@@ -7027,7 +7027,7 @@
           <p:cNvPr id="11" name="Rectángulo: esquinas redondeadas 10">
             <a:extLst>
               <a:ext uri="{FF2B5EF4-FFF2-40B4-BE49-F238E27FC236}">
-                <a16:creationId xmlns:a16="http://schemas.microsoft.com/office/drawing/2014/main" id="{7CBFF513-0955-3716-4F81-8922A478B831}"/>
+                <a16:creationId xmlns:a16="http://schemas.microsoft.com/office/drawing/2014/main" id="{0A633831-79A5-5792-7412-58FC1879EFCA}"/>
               </a:ext>
             </a:extLst>
           </p:cNvPr>
@@ -7081,7 +7081,7 @@
           <p:cNvPr id="12" name="CuadroTexto 11">
             <a:extLst>
               <a:ext uri="{FF2B5EF4-FFF2-40B4-BE49-F238E27FC236}">
-                <a16:creationId xmlns:a16="http://schemas.microsoft.com/office/drawing/2014/main" id="{B7EDB871-3C94-A151-D177-50F2BC7894F4}"/>
+                <a16:creationId xmlns:a16="http://schemas.microsoft.com/office/drawing/2014/main" id="{A6A43BF5-5972-D933-8D9C-DD71DB14BCCC}"/>
               </a:ext>
             </a:extLst>
           </p:cNvPr>
@@ -7121,7 +7121,7 @@
           <p:cNvPr id="13" name="CuadroTexto 12">
             <a:extLst>
               <a:ext uri="{FF2B5EF4-FFF2-40B4-BE49-F238E27FC236}">
-                <a16:creationId xmlns:a16="http://schemas.microsoft.com/office/drawing/2014/main" id="{BF0D9C48-63F6-1D2D-3302-DDAD9CF0D3FB}"/>
+                <a16:creationId xmlns:a16="http://schemas.microsoft.com/office/drawing/2014/main" id="{6FECB936-5543-7540-CFBE-69E6E6DAD718}"/>
               </a:ext>
             </a:extLst>
           </p:cNvPr>
@@ -7151,7 +7151,7 @@
                 </a:solidFill>
                 <a:latin typeface="Consolas" panose="020B0609020204030204" pitchFamily="49" charset="0"/>
               </a:rPr>
-              <a:t>https://agora.34.175.157.37...</a:t>
+              <a:t>https://agora.34.175.161.212...</a:t>
             </a:r>
           </a:p>
         </p:txBody>
@@ -7161,7 +7161,7 @@
           <p:cNvPr id="14" name="CuadroTexto 13">
             <a:extLst>
               <a:ext uri="{FF2B5EF4-FFF2-40B4-BE49-F238E27FC236}">
-                <a16:creationId xmlns:a16="http://schemas.microsoft.com/office/drawing/2014/main" id="{246B6323-66F3-2568-C7A5-F451E28A27DE}"/>
+                <a16:creationId xmlns:a16="http://schemas.microsoft.com/office/drawing/2014/main" id="{57E0B157-C904-5762-B6AD-74A123CF0913}"/>
               </a:ext>
             </a:extLst>
           </p:cNvPr>
@@ -7242,7 +7242,7 @@
     </p:spTree>
     <p:extLst>
       <p:ext uri="{BB962C8B-B14F-4D97-AF65-F5344CB8AC3E}">
-        <p14:creationId xmlns:p14="http://schemas.microsoft.com/office/powerpoint/2010/main" val="2813981965"/>
+        <p14:creationId xmlns:p14="http://schemas.microsoft.com/office/powerpoint/2010/main" val="878860373"/>
       </p:ext>
     </p:extLst>
   </p:cSld>
@@ -7282,7 +7282,7 @@
           <p:cNvPr id="2" name="CuadroTexto 1">
             <a:extLst>
               <a:ext uri="{FF2B5EF4-FFF2-40B4-BE49-F238E27FC236}">
-                <a16:creationId xmlns:a16="http://schemas.microsoft.com/office/drawing/2014/main" id="{B91D7901-1C82-3FC5-C6FA-FB5AB170F64F}"/>
+                <a16:creationId xmlns:a16="http://schemas.microsoft.com/office/drawing/2014/main" id="{0612F822-E741-FF3B-BD34-0C5C21417D43}"/>
               </a:ext>
             </a:extLst>
           </p:cNvPr>
@@ -7322,7 +7322,7 @@
           <p:cNvPr id="3" name="CuadroTexto 2">
             <a:extLst>
               <a:ext uri="{FF2B5EF4-FFF2-40B4-BE49-F238E27FC236}">
-                <a16:creationId xmlns:a16="http://schemas.microsoft.com/office/drawing/2014/main" id="{74A471D8-C86F-26A6-EE8B-6476631940F4}"/>
+                <a16:creationId xmlns:a16="http://schemas.microsoft.com/office/drawing/2014/main" id="{4C09E9DC-8780-0368-E56E-5985A06F3652}"/>
               </a:ext>
             </a:extLst>
           </p:cNvPr>
@@ -7362,7 +7362,7 @@
           <p:cNvPr id="4" name="CuadroTexto 3">
             <a:extLst>
               <a:ext uri="{FF2B5EF4-FFF2-40B4-BE49-F238E27FC236}">
-                <a16:creationId xmlns:a16="http://schemas.microsoft.com/office/drawing/2014/main" id="{9B7B1F44-BB1D-204D-F7D4-73FFC3F9BA51}"/>
+                <a16:creationId xmlns:a16="http://schemas.microsoft.com/office/drawing/2014/main" id="{F23984AB-50E6-4296-5ABE-690D0C1AEB17}"/>
               </a:ext>
             </a:extLst>
           </p:cNvPr>
@@ -7402,7 +7402,7 @@
           <p:cNvPr id="6" name="Imagen 5">
             <a:extLst>
               <a:ext uri="{FF2B5EF4-FFF2-40B4-BE49-F238E27FC236}">
-                <a16:creationId xmlns:a16="http://schemas.microsoft.com/office/drawing/2014/main" id="{F54328A9-F2DC-97F2-E892-FF176FB4BC6D}"/>
+                <a16:creationId xmlns:a16="http://schemas.microsoft.com/office/drawing/2014/main" id="{EFDA7603-6F23-8FDE-4739-4329DCEECAAF}"/>
               </a:ext>
             </a:extLst>
           </p:cNvPr>
@@ -7443,7 +7443,7 @@
           <p:cNvPr id="7" name="Rectángulo: esquinas redondeadas 6">
             <a:extLst>
               <a:ext uri="{FF2B5EF4-FFF2-40B4-BE49-F238E27FC236}">
-                <a16:creationId xmlns:a16="http://schemas.microsoft.com/office/drawing/2014/main" id="{A490637C-CB8F-478E-4789-4A1BEC739ABD}"/>
+                <a16:creationId xmlns:a16="http://schemas.microsoft.com/office/drawing/2014/main" id="{9A15C0D5-FDC4-4504-D1F8-E4A2FE1A3328}"/>
               </a:ext>
             </a:extLst>
           </p:cNvPr>
@@ -7497,7 +7497,7 @@
           <p:cNvPr id="8" name="CuadroTexto 7">
             <a:extLst>
               <a:ext uri="{FF2B5EF4-FFF2-40B4-BE49-F238E27FC236}">
-                <a16:creationId xmlns:a16="http://schemas.microsoft.com/office/drawing/2014/main" id="{92B614AC-4BDC-CCD5-2B2C-433D75FF9369}"/>
+                <a16:creationId xmlns:a16="http://schemas.microsoft.com/office/drawing/2014/main" id="{37FBCE84-8CC1-094A-C428-27ABF7E8A252}"/>
               </a:ext>
             </a:extLst>
           </p:cNvPr>
@@ -7537,7 +7537,7 @@
           <p:cNvPr id="9" name="CuadroTexto 8">
             <a:extLst>
               <a:ext uri="{FF2B5EF4-FFF2-40B4-BE49-F238E27FC236}">
-                <a16:creationId xmlns:a16="http://schemas.microsoft.com/office/drawing/2014/main" id="{B582EB93-4CB8-682C-9364-4EA5465325C8}"/>
+                <a16:creationId xmlns:a16="http://schemas.microsoft.com/office/drawing/2014/main" id="{F4AF7EE7-7911-A572-2C5B-05F715B256F9}"/>
               </a:ext>
             </a:extLst>
           </p:cNvPr>
@@ -7577,7 +7577,7 @@
           <p:cNvPr id="10" name="CuadroTexto 9">
             <a:extLst>
               <a:ext uri="{FF2B5EF4-FFF2-40B4-BE49-F238E27FC236}">
-                <a16:creationId xmlns:a16="http://schemas.microsoft.com/office/drawing/2014/main" id="{4E77CE56-DB0D-3287-003F-E1D94D866C82}"/>
+                <a16:creationId xmlns:a16="http://schemas.microsoft.com/office/drawing/2014/main" id="{A7C95394-2369-55C4-D2CE-2A57DB9AA75F}"/>
               </a:ext>
             </a:extLst>
           </p:cNvPr>
@@ -7676,7 +7676,7 @@
     </p:spTree>
     <p:extLst>
       <p:ext uri="{BB962C8B-B14F-4D97-AF65-F5344CB8AC3E}">
-        <p14:creationId xmlns:p14="http://schemas.microsoft.com/office/powerpoint/2010/main" val="4073910951"/>
+        <p14:creationId xmlns:p14="http://schemas.microsoft.com/office/powerpoint/2010/main" val="3929130074"/>
       </p:ext>
     </p:extLst>
   </p:cSld>
@@ -7716,7 +7716,7 @@
           <p:cNvPr id="2" name="CuadroTexto 1">
             <a:extLst>
               <a:ext uri="{FF2B5EF4-FFF2-40B4-BE49-F238E27FC236}">
-                <a16:creationId xmlns:a16="http://schemas.microsoft.com/office/drawing/2014/main" id="{F2539D70-8596-63F3-175E-E17D9945B91D}"/>
+                <a16:creationId xmlns:a16="http://schemas.microsoft.com/office/drawing/2014/main" id="{665A8073-6239-65F9-1C6C-90322CDDE31D}"/>
               </a:ext>
             </a:extLst>
           </p:cNvPr>
@@ -7756,7 +7756,7 @@
           <p:cNvPr id="3" name="CuadroTexto 2">
             <a:extLst>
               <a:ext uri="{FF2B5EF4-FFF2-40B4-BE49-F238E27FC236}">
-                <a16:creationId xmlns:a16="http://schemas.microsoft.com/office/drawing/2014/main" id="{0B10F546-5F4E-01FF-70A6-C70A8AEF8758}"/>
+                <a16:creationId xmlns:a16="http://schemas.microsoft.com/office/drawing/2014/main" id="{B3B92AC7-9997-EE69-9DB7-898BC6C47F4C}"/>
               </a:ext>
             </a:extLst>
           </p:cNvPr>
@@ -7796,7 +7796,7 @@
           <p:cNvPr id="4" name="CuadroTexto 3">
             <a:extLst>
               <a:ext uri="{FF2B5EF4-FFF2-40B4-BE49-F238E27FC236}">
-                <a16:creationId xmlns:a16="http://schemas.microsoft.com/office/drawing/2014/main" id="{096BBF0C-52CD-6A03-4382-BB69363F4448}"/>
+                <a16:creationId xmlns:a16="http://schemas.microsoft.com/office/drawing/2014/main" id="{F58B302C-CB33-8D5F-76E3-FBC04A0A6D8C}"/>
               </a:ext>
             </a:extLst>
           </p:cNvPr>
@@ -7836,7 +7836,7 @@
           <p:cNvPr id="6" name="Imagen 5">
             <a:extLst>
               <a:ext uri="{FF2B5EF4-FFF2-40B4-BE49-F238E27FC236}">
-                <a16:creationId xmlns:a16="http://schemas.microsoft.com/office/drawing/2014/main" id="{3FFA2FB5-EEA5-084C-86BF-F1CC33208862}"/>
+                <a16:creationId xmlns:a16="http://schemas.microsoft.com/office/drawing/2014/main" id="{04CBA8D3-B8F9-B6B5-A27C-6259828AE60B}"/>
               </a:ext>
             </a:extLst>
           </p:cNvPr>
@@ -7877,7 +7877,7 @@
           <p:cNvPr id="7" name="CuadroTexto 6">
             <a:extLst>
               <a:ext uri="{FF2B5EF4-FFF2-40B4-BE49-F238E27FC236}">
-                <a16:creationId xmlns:a16="http://schemas.microsoft.com/office/drawing/2014/main" id="{A232BE2A-17FF-904C-1DB8-17150B49E093}"/>
+                <a16:creationId xmlns:a16="http://schemas.microsoft.com/office/drawing/2014/main" id="{1833379E-51BC-F9B4-C7BE-852BC8012B08}"/>
               </a:ext>
             </a:extLst>
           </p:cNvPr>
@@ -7994,7 +7994,7 @@
     </p:spTree>
     <p:extLst>
       <p:ext uri="{BB962C8B-B14F-4D97-AF65-F5344CB8AC3E}">
-        <p14:creationId xmlns:p14="http://schemas.microsoft.com/office/powerpoint/2010/main" val="839347778"/>
+        <p14:creationId xmlns:p14="http://schemas.microsoft.com/office/powerpoint/2010/main" val="4243507258"/>
       </p:ext>
     </p:extLst>
   </p:cSld>
@@ -8034,7 +8034,7 @@
           <p:cNvPr id="2" name="CuadroTexto 1">
             <a:extLst>
               <a:ext uri="{FF2B5EF4-FFF2-40B4-BE49-F238E27FC236}">
-                <a16:creationId xmlns:a16="http://schemas.microsoft.com/office/drawing/2014/main" id="{E25FC2C0-B528-39DD-26C0-EB0E75E2CAE2}"/>
+                <a16:creationId xmlns:a16="http://schemas.microsoft.com/office/drawing/2014/main" id="{33C423A3-4388-C51F-DADE-9D4EC766E6E4}"/>
               </a:ext>
             </a:extLst>
           </p:cNvPr>
@@ -8074,7 +8074,7 @@
           <p:cNvPr id="3" name="CuadroTexto 2">
             <a:extLst>
               <a:ext uri="{FF2B5EF4-FFF2-40B4-BE49-F238E27FC236}">
-                <a16:creationId xmlns:a16="http://schemas.microsoft.com/office/drawing/2014/main" id="{C2743FC8-8AD7-156C-D7BA-C70312F3EB8E}"/>
+                <a16:creationId xmlns:a16="http://schemas.microsoft.com/office/drawing/2014/main" id="{A48F09ED-E24D-5D7F-1296-BAE484F0BCB9}"/>
               </a:ext>
             </a:extLst>
           </p:cNvPr>
@@ -8114,7 +8114,7 @@
           <p:cNvPr id="4" name="CuadroTexto 3">
             <a:extLst>
               <a:ext uri="{FF2B5EF4-FFF2-40B4-BE49-F238E27FC236}">
-                <a16:creationId xmlns:a16="http://schemas.microsoft.com/office/drawing/2014/main" id="{237A5FDD-271B-0258-B781-EF925BF153AC}"/>
+                <a16:creationId xmlns:a16="http://schemas.microsoft.com/office/drawing/2014/main" id="{88E90382-8740-CA42-533D-FA81BA70D83E}"/>
               </a:ext>
             </a:extLst>
           </p:cNvPr>
@@ -8154,7 +8154,7 @@
           <p:cNvPr id="5" name="Rectángulo: esquinas redondeadas 4">
             <a:extLst>
               <a:ext uri="{FF2B5EF4-FFF2-40B4-BE49-F238E27FC236}">
-                <a16:creationId xmlns:a16="http://schemas.microsoft.com/office/drawing/2014/main" id="{AAE5D9A1-026D-8FB0-2822-88A7BC77D4D2}"/>
+                <a16:creationId xmlns:a16="http://schemas.microsoft.com/office/drawing/2014/main" id="{2F4359B7-DE60-F526-D194-DF8B0395D0FC}"/>
               </a:ext>
             </a:extLst>
           </p:cNvPr>
@@ -8208,7 +8208,7 @@
           <p:cNvPr id="6" name="CuadroTexto 5">
             <a:extLst>
               <a:ext uri="{FF2B5EF4-FFF2-40B4-BE49-F238E27FC236}">
-                <a16:creationId xmlns:a16="http://schemas.microsoft.com/office/drawing/2014/main" id="{3F359A0A-FEDC-85C1-6A17-0BA8B98A169A}"/>
+                <a16:creationId xmlns:a16="http://schemas.microsoft.com/office/drawing/2014/main" id="{7B670ACA-C49E-DB59-2D32-8E0275FF2D8E}"/>
               </a:ext>
             </a:extLst>
           </p:cNvPr>
@@ -8248,7 +8248,7 @@
           <p:cNvPr id="7" name="CuadroTexto 6">
             <a:extLst>
               <a:ext uri="{FF2B5EF4-FFF2-40B4-BE49-F238E27FC236}">
-                <a16:creationId xmlns:a16="http://schemas.microsoft.com/office/drawing/2014/main" id="{251E5BE7-5D4D-2266-27CD-09E1AAEC6B38}"/>
+                <a16:creationId xmlns:a16="http://schemas.microsoft.com/office/drawing/2014/main" id="{AE94ECD1-A4B1-8766-06E8-2DA31E88299A}"/>
               </a:ext>
             </a:extLst>
           </p:cNvPr>
@@ -8316,7 +8316,7 @@
           <p:cNvPr id="8" name="CuadroTexto 7">
             <a:extLst>
               <a:ext uri="{FF2B5EF4-FFF2-40B4-BE49-F238E27FC236}">
-                <a16:creationId xmlns:a16="http://schemas.microsoft.com/office/drawing/2014/main" id="{A4F51410-5F0E-0A8A-D3B6-DE41A699B232}"/>
+                <a16:creationId xmlns:a16="http://schemas.microsoft.com/office/drawing/2014/main" id="{4689625D-A50E-4153-881E-98905E45F1A3}"/>
               </a:ext>
             </a:extLst>
           </p:cNvPr>
@@ -8381,7 +8381,7 @@
           <p:cNvPr id="9" name="Rectángulo: esquinas redondeadas 8">
             <a:extLst>
               <a:ext uri="{FF2B5EF4-FFF2-40B4-BE49-F238E27FC236}">
-                <a16:creationId xmlns:a16="http://schemas.microsoft.com/office/drawing/2014/main" id="{FEE107C3-F4B8-2BC4-29D9-7F8044D5034D}"/>
+                <a16:creationId xmlns:a16="http://schemas.microsoft.com/office/drawing/2014/main" id="{4C9002FA-1C67-2655-43B6-41BB11D8F819}"/>
               </a:ext>
             </a:extLst>
           </p:cNvPr>
@@ -8435,7 +8435,7 @@
           <p:cNvPr id="10" name="CuadroTexto 9">
             <a:extLst>
               <a:ext uri="{FF2B5EF4-FFF2-40B4-BE49-F238E27FC236}">
-                <a16:creationId xmlns:a16="http://schemas.microsoft.com/office/drawing/2014/main" id="{2C3C4347-38EF-73FB-6C9B-7801430E86AE}"/>
+                <a16:creationId xmlns:a16="http://schemas.microsoft.com/office/drawing/2014/main" id="{25F2CB4D-004F-60FD-B354-33CE6585EB10}"/>
               </a:ext>
             </a:extLst>
           </p:cNvPr>
@@ -8475,7 +8475,7 @@
           <p:cNvPr id="11" name="CuadroTexto 10">
             <a:extLst>
               <a:ext uri="{FF2B5EF4-FFF2-40B4-BE49-F238E27FC236}">
-                <a16:creationId xmlns:a16="http://schemas.microsoft.com/office/drawing/2014/main" id="{46E860FB-D9EB-5565-058A-5DE31EDB5515}"/>
+                <a16:creationId xmlns:a16="http://schemas.microsoft.com/office/drawing/2014/main" id="{D80D563F-D839-D782-7232-C48939CFD72A}"/>
               </a:ext>
             </a:extLst>
           </p:cNvPr>
@@ -8594,7 +8594,7 @@
           <p:cNvPr id="12" name="CuadroTexto 11">
             <a:extLst>
               <a:ext uri="{FF2B5EF4-FFF2-40B4-BE49-F238E27FC236}">
-                <a16:creationId xmlns:a16="http://schemas.microsoft.com/office/drawing/2014/main" id="{CE9489AD-12E3-1F7C-F347-FACE6A2F9C6D}"/>
+                <a16:creationId xmlns:a16="http://schemas.microsoft.com/office/drawing/2014/main" id="{1C487B9B-BA48-A165-770D-45103B967366}"/>
               </a:ext>
             </a:extLst>
           </p:cNvPr>
@@ -8634,7 +8634,7 @@
           <p:cNvPr id="13" name="CuadroTexto 12">
             <a:extLst>
               <a:ext uri="{FF2B5EF4-FFF2-40B4-BE49-F238E27FC236}">
-                <a16:creationId xmlns:a16="http://schemas.microsoft.com/office/drawing/2014/main" id="{6241DFCE-36E5-10DF-4B69-BB4F93D854AE}"/>
+                <a16:creationId xmlns:a16="http://schemas.microsoft.com/office/drawing/2014/main" id="{39EFF52E-0F4E-D6D1-C885-16A79F83F54C}"/>
               </a:ext>
             </a:extLst>
           </p:cNvPr>
@@ -8672,7 +8672,7 @@
     </p:spTree>
     <p:extLst>
       <p:ext uri="{BB962C8B-B14F-4D97-AF65-F5344CB8AC3E}">
-        <p14:creationId xmlns:p14="http://schemas.microsoft.com/office/powerpoint/2010/main" val="2154766140"/>
+        <p14:creationId xmlns:p14="http://schemas.microsoft.com/office/powerpoint/2010/main" val="2832636802"/>
       </p:ext>
     </p:extLst>
   </p:cSld>
@@ -8712,7 +8712,7 @@
           <p:cNvPr id="2" name="CuadroTexto 1">
             <a:extLst>
               <a:ext uri="{FF2B5EF4-FFF2-40B4-BE49-F238E27FC236}">
-                <a16:creationId xmlns:a16="http://schemas.microsoft.com/office/drawing/2014/main" id="{94C8C08F-DA07-3574-7E56-1C38128C8094}"/>
+                <a16:creationId xmlns:a16="http://schemas.microsoft.com/office/drawing/2014/main" id="{C0AF8DE1-B239-16D5-E9CA-03C623C151A9}"/>
               </a:ext>
             </a:extLst>
           </p:cNvPr>
@@ -8752,7 +8752,7 @@
           <p:cNvPr id="3" name="CuadroTexto 2">
             <a:extLst>
               <a:ext uri="{FF2B5EF4-FFF2-40B4-BE49-F238E27FC236}">
-                <a16:creationId xmlns:a16="http://schemas.microsoft.com/office/drawing/2014/main" id="{6C546666-F1F5-1A9F-47FB-1C0977756521}"/>
+                <a16:creationId xmlns:a16="http://schemas.microsoft.com/office/drawing/2014/main" id="{2F093064-14A1-B9A3-BF8C-3FAB78E7AE1E}"/>
               </a:ext>
             </a:extLst>
           </p:cNvPr>
@@ -8792,7 +8792,7 @@
           <p:cNvPr id="4" name="Rectángulo: esquinas redondeadas 3">
             <a:extLst>
               <a:ext uri="{FF2B5EF4-FFF2-40B4-BE49-F238E27FC236}">
-                <a16:creationId xmlns:a16="http://schemas.microsoft.com/office/drawing/2014/main" id="{7FC7EE1C-A41F-C0E7-FBC4-00C39036EE1C}"/>
+                <a16:creationId xmlns:a16="http://schemas.microsoft.com/office/drawing/2014/main" id="{63761DE4-6D25-4140-CE56-872F995317C7}"/>
               </a:ext>
             </a:extLst>
           </p:cNvPr>
@@ -8846,7 +8846,7 @@
           <p:cNvPr id="5" name="CuadroTexto 4">
             <a:extLst>
               <a:ext uri="{FF2B5EF4-FFF2-40B4-BE49-F238E27FC236}">
-                <a16:creationId xmlns:a16="http://schemas.microsoft.com/office/drawing/2014/main" id="{D9A7651D-8E8E-829E-4326-5683A280C00A}"/>
+                <a16:creationId xmlns:a16="http://schemas.microsoft.com/office/drawing/2014/main" id="{0E57D432-7F74-4C12-D53A-5EB9BD8334C9}"/>
               </a:ext>
             </a:extLst>
           </p:cNvPr>
@@ -8886,7 +8886,7 @@
           <p:cNvPr id="6" name="CuadroTexto 5">
             <a:extLst>
               <a:ext uri="{FF2B5EF4-FFF2-40B4-BE49-F238E27FC236}">
-                <a16:creationId xmlns:a16="http://schemas.microsoft.com/office/drawing/2014/main" id="{24E16A61-AD09-EE49-131F-0EAEA67FD3D1}"/>
+                <a16:creationId xmlns:a16="http://schemas.microsoft.com/office/drawing/2014/main" id="{5D498C38-9036-F97F-DE91-B9F00BC7CE9D}"/>
               </a:ext>
             </a:extLst>
           </p:cNvPr>
@@ -8926,7 +8926,7 @@
           <p:cNvPr id="7" name="Rectángulo: esquinas redondeadas 6">
             <a:extLst>
               <a:ext uri="{FF2B5EF4-FFF2-40B4-BE49-F238E27FC236}">
-                <a16:creationId xmlns:a16="http://schemas.microsoft.com/office/drawing/2014/main" id="{BA650A2C-FA88-49E4-B3F8-715DAB52A910}"/>
+                <a16:creationId xmlns:a16="http://schemas.microsoft.com/office/drawing/2014/main" id="{C8DBBF70-4C21-DAF6-D05F-874C7F497F53}"/>
               </a:ext>
             </a:extLst>
           </p:cNvPr>
@@ -8980,7 +8980,7 @@
           <p:cNvPr id="8" name="CuadroTexto 7">
             <a:extLst>
               <a:ext uri="{FF2B5EF4-FFF2-40B4-BE49-F238E27FC236}">
-                <a16:creationId xmlns:a16="http://schemas.microsoft.com/office/drawing/2014/main" id="{03DA1B89-78E3-0C91-20C3-8079917B0478}"/>
+                <a16:creationId xmlns:a16="http://schemas.microsoft.com/office/drawing/2014/main" id="{A526B1A9-4089-5A30-4816-E8C67EB43E97}"/>
               </a:ext>
             </a:extLst>
           </p:cNvPr>
@@ -9020,7 +9020,7 @@
           <p:cNvPr id="9" name="CuadroTexto 8">
             <a:extLst>
               <a:ext uri="{FF2B5EF4-FFF2-40B4-BE49-F238E27FC236}">
-                <a16:creationId xmlns:a16="http://schemas.microsoft.com/office/drawing/2014/main" id="{C6EF62AA-CE2F-BE81-7FD2-771CF8A022B2}"/>
+                <a16:creationId xmlns:a16="http://schemas.microsoft.com/office/drawing/2014/main" id="{3B29706D-9BC8-B098-DE32-38B5805D1DCE}"/>
               </a:ext>
             </a:extLst>
           </p:cNvPr>
@@ -9060,7 +9060,7 @@
           <p:cNvPr id="10" name="Rectángulo: esquinas redondeadas 9">
             <a:extLst>
               <a:ext uri="{FF2B5EF4-FFF2-40B4-BE49-F238E27FC236}">
-                <a16:creationId xmlns:a16="http://schemas.microsoft.com/office/drawing/2014/main" id="{D9739C51-78EB-3175-F5E5-0E7AAF10267B}"/>
+                <a16:creationId xmlns:a16="http://schemas.microsoft.com/office/drawing/2014/main" id="{8A4C206B-7D02-4F76-5F20-62CBEC6B6869}"/>
               </a:ext>
             </a:extLst>
           </p:cNvPr>
@@ -9114,7 +9114,7 @@
           <p:cNvPr id="11" name="CuadroTexto 10">
             <a:extLst>
               <a:ext uri="{FF2B5EF4-FFF2-40B4-BE49-F238E27FC236}">
-                <a16:creationId xmlns:a16="http://schemas.microsoft.com/office/drawing/2014/main" id="{FFF5F859-389D-5F60-50A0-A499C84FB247}"/>
+                <a16:creationId xmlns:a16="http://schemas.microsoft.com/office/drawing/2014/main" id="{64315C01-1D97-E8B7-D926-848F5C4D1060}"/>
               </a:ext>
             </a:extLst>
           </p:cNvPr>
@@ -9154,7 +9154,7 @@
           <p:cNvPr id="12" name="CuadroTexto 11">
             <a:extLst>
               <a:ext uri="{FF2B5EF4-FFF2-40B4-BE49-F238E27FC236}">
-                <a16:creationId xmlns:a16="http://schemas.microsoft.com/office/drawing/2014/main" id="{3B676257-7D7F-8075-E88B-7471C841CCAF}"/>
+                <a16:creationId xmlns:a16="http://schemas.microsoft.com/office/drawing/2014/main" id="{1BB8BE17-E927-0168-99FE-74822B2B6787}"/>
               </a:ext>
             </a:extLst>
           </p:cNvPr>
@@ -9194,7 +9194,7 @@
           <p:cNvPr id="13" name="Rectángulo: esquinas redondeadas 12">
             <a:extLst>
               <a:ext uri="{FF2B5EF4-FFF2-40B4-BE49-F238E27FC236}">
-                <a16:creationId xmlns:a16="http://schemas.microsoft.com/office/drawing/2014/main" id="{E296E1D6-8B6D-CE41-1D54-B0F0459E07D6}"/>
+                <a16:creationId xmlns:a16="http://schemas.microsoft.com/office/drawing/2014/main" id="{C483D33C-3B97-9682-993E-A27AA1109E4C}"/>
               </a:ext>
             </a:extLst>
           </p:cNvPr>
@@ -9248,7 +9248,7 @@
           <p:cNvPr id="14" name="CuadroTexto 13">
             <a:extLst>
               <a:ext uri="{FF2B5EF4-FFF2-40B4-BE49-F238E27FC236}">
-                <a16:creationId xmlns:a16="http://schemas.microsoft.com/office/drawing/2014/main" id="{D372023C-AE65-26A2-BC48-3108E9709B9C}"/>
+                <a16:creationId xmlns:a16="http://schemas.microsoft.com/office/drawing/2014/main" id="{8A47BC40-1740-DD17-DDAD-74215E9C786C}"/>
               </a:ext>
             </a:extLst>
           </p:cNvPr>
@@ -9288,7 +9288,7 @@
           <p:cNvPr id="15" name="CuadroTexto 14">
             <a:extLst>
               <a:ext uri="{FF2B5EF4-FFF2-40B4-BE49-F238E27FC236}">
-                <a16:creationId xmlns:a16="http://schemas.microsoft.com/office/drawing/2014/main" id="{DA52FC83-E274-518D-EED6-3C430243BE8D}"/>
+                <a16:creationId xmlns:a16="http://schemas.microsoft.com/office/drawing/2014/main" id="{CCB5C112-73AA-1592-824D-6B94A154D447}"/>
               </a:ext>
             </a:extLst>
           </p:cNvPr>
@@ -9328,7 +9328,7 @@
           <p:cNvPr id="16" name="CuadroTexto 15">
             <a:extLst>
               <a:ext uri="{FF2B5EF4-FFF2-40B4-BE49-F238E27FC236}">
-                <a16:creationId xmlns:a16="http://schemas.microsoft.com/office/drawing/2014/main" id="{B7480028-461E-048B-F63D-4A54A3C51E8F}"/>
+                <a16:creationId xmlns:a16="http://schemas.microsoft.com/office/drawing/2014/main" id="{C2F7DDF2-1E8B-6D53-9FC1-16DE85B754EA}"/>
               </a:ext>
             </a:extLst>
           </p:cNvPr>
@@ -9411,7 +9411,7 @@
           <p:cNvPr id="17" name="CuadroTexto 16">
             <a:extLst>
               <a:ext uri="{FF2B5EF4-FFF2-40B4-BE49-F238E27FC236}">
-                <a16:creationId xmlns:a16="http://schemas.microsoft.com/office/drawing/2014/main" id="{7E7AF284-79BF-CCE8-8FA7-04F6D55ECC44}"/>
+                <a16:creationId xmlns:a16="http://schemas.microsoft.com/office/drawing/2014/main" id="{DD276DE3-694C-571E-3D3B-4DC79A6A5CC6}"/>
               </a:ext>
             </a:extLst>
           </p:cNvPr>
@@ -9449,7 +9449,7 @@
     </p:spTree>
     <p:extLst>
       <p:ext uri="{BB962C8B-B14F-4D97-AF65-F5344CB8AC3E}">
-        <p14:creationId xmlns:p14="http://schemas.microsoft.com/office/powerpoint/2010/main" val="1930905325"/>
+        <p14:creationId xmlns:p14="http://schemas.microsoft.com/office/powerpoint/2010/main" val="1089190011"/>
       </p:ext>
     </p:extLst>
   </p:cSld>
@@ -9489,7 +9489,7 @@
           <p:cNvPr id="2" name="CuadroTexto 1">
             <a:extLst>
               <a:ext uri="{FF2B5EF4-FFF2-40B4-BE49-F238E27FC236}">
-                <a16:creationId xmlns:a16="http://schemas.microsoft.com/office/drawing/2014/main" id="{9CD16692-9349-D12C-0B61-DEA0E0018975}"/>
+                <a16:creationId xmlns:a16="http://schemas.microsoft.com/office/drawing/2014/main" id="{1287D721-EA82-3258-D9E0-06BF24F3B93A}"/>
               </a:ext>
             </a:extLst>
           </p:cNvPr>
@@ -9529,7 +9529,7 @@
           <p:cNvPr id="3" name="CuadroTexto 2">
             <a:extLst>
               <a:ext uri="{FF2B5EF4-FFF2-40B4-BE49-F238E27FC236}">
-                <a16:creationId xmlns:a16="http://schemas.microsoft.com/office/drawing/2014/main" id="{3FD922E1-5C31-8DDA-F7CA-69AD03218E94}"/>
+                <a16:creationId xmlns:a16="http://schemas.microsoft.com/office/drawing/2014/main" id="{0E527FF5-ACB5-73F1-05A8-B65174048BAD}"/>
               </a:ext>
             </a:extLst>
           </p:cNvPr>
@@ -9569,7 +9569,7 @@
           <p:cNvPr id="4" name="CuadroTexto 3">
             <a:extLst>
               <a:ext uri="{FF2B5EF4-FFF2-40B4-BE49-F238E27FC236}">
-                <a16:creationId xmlns:a16="http://schemas.microsoft.com/office/drawing/2014/main" id="{CFE35FE3-E581-7FCD-E82D-A0E3A7B9E238}"/>
+                <a16:creationId xmlns:a16="http://schemas.microsoft.com/office/drawing/2014/main" id="{2F93B62E-C7D2-9617-F6D3-704940E41714}"/>
               </a:ext>
             </a:extLst>
           </p:cNvPr>
@@ -9609,7 +9609,7 @@
           <p:cNvPr id="5" name="Rectángulo: esquinas redondeadas 4">
             <a:extLst>
               <a:ext uri="{FF2B5EF4-FFF2-40B4-BE49-F238E27FC236}">
-                <a16:creationId xmlns:a16="http://schemas.microsoft.com/office/drawing/2014/main" id="{E3A32F93-A359-D490-CC01-ADFD0900299B}"/>
+                <a16:creationId xmlns:a16="http://schemas.microsoft.com/office/drawing/2014/main" id="{BF712BBC-3C83-CDC9-BFB3-3F0BEE120852}"/>
               </a:ext>
             </a:extLst>
           </p:cNvPr>
@@ -9663,7 +9663,7 @@
           <p:cNvPr id="6" name="CuadroTexto 5">
             <a:extLst>
               <a:ext uri="{FF2B5EF4-FFF2-40B4-BE49-F238E27FC236}">
-                <a16:creationId xmlns:a16="http://schemas.microsoft.com/office/drawing/2014/main" id="{9390BDFF-CFE1-A2BB-1684-E69AEB0856E1}"/>
+                <a16:creationId xmlns:a16="http://schemas.microsoft.com/office/drawing/2014/main" id="{DD15D1A6-5DF5-115E-F6B3-4EBB83269791}"/>
               </a:ext>
             </a:extLst>
           </p:cNvPr>
@@ -9703,7 +9703,7 @@
           <p:cNvPr id="7" name="CuadroTexto 6">
             <a:extLst>
               <a:ext uri="{FF2B5EF4-FFF2-40B4-BE49-F238E27FC236}">
-                <a16:creationId xmlns:a16="http://schemas.microsoft.com/office/drawing/2014/main" id="{23216801-4E90-C34E-BEBE-EF3EC3C998E8}"/>
+                <a16:creationId xmlns:a16="http://schemas.microsoft.com/office/drawing/2014/main" id="{374CE008-3C84-A8F8-324C-522CB7693EB1}"/>
               </a:ext>
             </a:extLst>
           </p:cNvPr>
@@ -9743,7 +9743,7 @@
           <p:cNvPr id="8" name="Rectángulo: esquinas redondeadas 7">
             <a:extLst>
               <a:ext uri="{FF2B5EF4-FFF2-40B4-BE49-F238E27FC236}">
-                <a16:creationId xmlns:a16="http://schemas.microsoft.com/office/drawing/2014/main" id="{34D95524-5FAA-E144-F76B-C9D0CB796B73}"/>
+                <a16:creationId xmlns:a16="http://schemas.microsoft.com/office/drawing/2014/main" id="{39DBD13E-D0FA-3F44-9EE2-1A89282CD510}"/>
               </a:ext>
             </a:extLst>
           </p:cNvPr>
@@ -9797,7 +9797,7 @@
           <p:cNvPr id="9" name="CuadroTexto 8">
             <a:extLst>
               <a:ext uri="{FF2B5EF4-FFF2-40B4-BE49-F238E27FC236}">
-                <a16:creationId xmlns:a16="http://schemas.microsoft.com/office/drawing/2014/main" id="{55773277-763E-6A59-F998-2B4207B842CC}"/>
+                <a16:creationId xmlns:a16="http://schemas.microsoft.com/office/drawing/2014/main" id="{3206CB05-CB6D-D46A-1185-180D4A1AA861}"/>
               </a:ext>
             </a:extLst>
           </p:cNvPr>
@@ -9837,7 +9837,7 @@
           <p:cNvPr id="10" name="CuadroTexto 9">
             <a:extLst>
               <a:ext uri="{FF2B5EF4-FFF2-40B4-BE49-F238E27FC236}">
-                <a16:creationId xmlns:a16="http://schemas.microsoft.com/office/drawing/2014/main" id="{8AA37CAB-75F6-D668-926D-D7AA36B43B4E}"/>
+                <a16:creationId xmlns:a16="http://schemas.microsoft.com/office/drawing/2014/main" id="{FD09B2F5-C6FE-E8EE-FEF4-1AF5DBCC9682}"/>
               </a:ext>
             </a:extLst>
           </p:cNvPr>
@@ -9877,7 +9877,7 @@
           <p:cNvPr id="11" name="CuadroTexto 10">
             <a:extLst>
               <a:ext uri="{FF2B5EF4-FFF2-40B4-BE49-F238E27FC236}">
-                <a16:creationId xmlns:a16="http://schemas.microsoft.com/office/drawing/2014/main" id="{283F3D5C-0DC3-44B7-0423-3BBF09398352}"/>
+                <a16:creationId xmlns:a16="http://schemas.microsoft.com/office/drawing/2014/main" id="{4594DBE3-D6DE-7549-B739-6AC4368FB548}"/>
               </a:ext>
             </a:extLst>
           </p:cNvPr>
@@ -9917,7 +9917,7 @@
           <p:cNvPr id="12" name="CuadroTexto 11">
             <a:extLst>
               <a:ext uri="{FF2B5EF4-FFF2-40B4-BE49-F238E27FC236}">
-                <a16:creationId xmlns:a16="http://schemas.microsoft.com/office/drawing/2014/main" id="{E6F33942-BBCE-0B25-0F22-DE82A4494733}"/>
+                <a16:creationId xmlns:a16="http://schemas.microsoft.com/office/drawing/2014/main" id="{8C067BEA-4AA0-83FA-66EF-CAB7D2066781}"/>
               </a:ext>
             </a:extLst>
           </p:cNvPr>
@@ -9998,7 +9998,7 @@
     </p:spTree>
     <p:extLst>
       <p:ext uri="{BB962C8B-B14F-4D97-AF65-F5344CB8AC3E}">
-        <p14:creationId xmlns:p14="http://schemas.microsoft.com/office/powerpoint/2010/main" val="1254394838"/>
+        <p14:creationId xmlns:p14="http://schemas.microsoft.com/office/powerpoint/2010/main" val="3322175799"/>
       </p:ext>
     </p:extLst>
   </p:cSld>
@@ -10038,7 +10038,7 @@
           <p:cNvPr id="2" name="CuadroTexto 1">
             <a:extLst>
               <a:ext uri="{FF2B5EF4-FFF2-40B4-BE49-F238E27FC236}">
-                <a16:creationId xmlns:a16="http://schemas.microsoft.com/office/drawing/2014/main" id="{56BB0456-1227-3A08-8F8F-3F0ABE6E3E27}"/>
+                <a16:creationId xmlns:a16="http://schemas.microsoft.com/office/drawing/2014/main" id="{2BFAB474-5537-AE3E-3A88-F8567A2A1B9E}"/>
               </a:ext>
             </a:extLst>
           </p:cNvPr>
@@ -10078,7 +10078,7 @@
           <p:cNvPr id="3" name="CuadroTexto 2">
             <a:extLst>
               <a:ext uri="{FF2B5EF4-FFF2-40B4-BE49-F238E27FC236}">
-                <a16:creationId xmlns:a16="http://schemas.microsoft.com/office/drawing/2014/main" id="{4C9E5584-D318-F28E-5BA2-20117BBB5A49}"/>
+                <a16:creationId xmlns:a16="http://schemas.microsoft.com/office/drawing/2014/main" id="{E5C95DB2-EFA2-1525-9158-A95ECCE84CB5}"/>
               </a:ext>
             </a:extLst>
           </p:cNvPr>
@@ -10118,7 +10118,7 @@
           <p:cNvPr id="4" name="CuadroTexto 3">
             <a:extLst>
               <a:ext uri="{FF2B5EF4-FFF2-40B4-BE49-F238E27FC236}">
-                <a16:creationId xmlns:a16="http://schemas.microsoft.com/office/drawing/2014/main" id="{E53D5A42-76ED-61FB-F8AD-CACB3CEBB570}"/>
+                <a16:creationId xmlns:a16="http://schemas.microsoft.com/office/drawing/2014/main" id="{4B0D9C06-0E88-E908-29DD-25F99F08FEE5}"/>
               </a:ext>
             </a:extLst>
           </p:cNvPr>
@@ -10158,7 +10158,7 @@
           <p:cNvPr id="5" name="Rectángulo: esquinas redondeadas 4">
             <a:extLst>
               <a:ext uri="{FF2B5EF4-FFF2-40B4-BE49-F238E27FC236}">
-                <a16:creationId xmlns:a16="http://schemas.microsoft.com/office/drawing/2014/main" id="{B339FB9B-28AA-26A4-F64F-D69FE3C8FC20}"/>
+                <a16:creationId xmlns:a16="http://schemas.microsoft.com/office/drawing/2014/main" id="{78B59249-5894-ADE8-DD01-8256B57A070B}"/>
               </a:ext>
             </a:extLst>
           </p:cNvPr>
@@ -10212,7 +10212,7 @@
           <p:cNvPr id="6" name="CuadroTexto 5">
             <a:extLst>
               <a:ext uri="{FF2B5EF4-FFF2-40B4-BE49-F238E27FC236}">
-                <a16:creationId xmlns:a16="http://schemas.microsoft.com/office/drawing/2014/main" id="{4A14DA3B-170E-6D8E-5F7D-4904D0B98605}"/>
+                <a16:creationId xmlns:a16="http://schemas.microsoft.com/office/drawing/2014/main" id="{908EBB94-E119-2A1B-E721-7AF4C37B22E8}"/>
               </a:ext>
             </a:extLst>
           </p:cNvPr>
@@ -10252,7 +10252,7 @@
           <p:cNvPr id="7" name="CuadroTexto 6">
             <a:extLst>
               <a:ext uri="{FF2B5EF4-FFF2-40B4-BE49-F238E27FC236}">
-                <a16:creationId xmlns:a16="http://schemas.microsoft.com/office/drawing/2014/main" id="{5CF6AC99-8002-219E-1EEC-23FF7BE72F99}"/>
+                <a16:creationId xmlns:a16="http://schemas.microsoft.com/office/drawing/2014/main" id="{82CBC56E-19C3-21B5-E68A-A23A7569E3F0}"/>
               </a:ext>
             </a:extLst>
           </p:cNvPr>
@@ -10353,7 +10353,7 @@
           <p:cNvPr id="8" name="Rectángulo: esquinas redondeadas 7">
             <a:extLst>
               <a:ext uri="{FF2B5EF4-FFF2-40B4-BE49-F238E27FC236}">
-                <a16:creationId xmlns:a16="http://schemas.microsoft.com/office/drawing/2014/main" id="{AD51FB0C-AA30-0C7D-E5F7-BA6ACF8D915F}"/>
+                <a16:creationId xmlns:a16="http://schemas.microsoft.com/office/drawing/2014/main" id="{26B9D7A7-87F7-AEEA-F459-E57B56F911E7}"/>
               </a:ext>
             </a:extLst>
           </p:cNvPr>
@@ -10407,7 +10407,7 @@
           <p:cNvPr id="9" name="CuadroTexto 8">
             <a:extLst>
               <a:ext uri="{FF2B5EF4-FFF2-40B4-BE49-F238E27FC236}">
-                <a16:creationId xmlns:a16="http://schemas.microsoft.com/office/drawing/2014/main" id="{A61C83DA-B798-196F-D2FF-E2B025FD353B}"/>
+                <a16:creationId xmlns:a16="http://schemas.microsoft.com/office/drawing/2014/main" id="{8294099B-B43E-F512-F22F-AB0602A6DB11}"/>
               </a:ext>
             </a:extLst>
           </p:cNvPr>
@@ -10447,7 +10447,7 @@
           <p:cNvPr id="10" name="CuadroTexto 9">
             <a:extLst>
               <a:ext uri="{FF2B5EF4-FFF2-40B4-BE49-F238E27FC236}">
-                <a16:creationId xmlns:a16="http://schemas.microsoft.com/office/drawing/2014/main" id="{BF18BBE8-0B69-7C0A-3FFF-97B340EE099A}"/>
+                <a16:creationId xmlns:a16="http://schemas.microsoft.com/office/drawing/2014/main" id="{5D878BA8-7AE1-A834-15FC-442DB01045D8}"/>
               </a:ext>
             </a:extLst>
           </p:cNvPr>
@@ -10487,7 +10487,7 @@
           <p:cNvPr id="11" name="Rectángulo: esquinas redondeadas 10">
             <a:extLst>
               <a:ext uri="{FF2B5EF4-FFF2-40B4-BE49-F238E27FC236}">
-                <a16:creationId xmlns:a16="http://schemas.microsoft.com/office/drawing/2014/main" id="{F6C38C54-FAAB-03F5-021D-661554B38201}"/>
+                <a16:creationId xmlns:a16="http://schemas.microsoft.com/office/drawing/2014/main" id="{A404FCF0-B147-152A-01F1-D9B2EFEF7A58}"/>
               </a:ext>
             </a:extLst>
           </p:cNvPr>
@@ -10541,7 +10541,7 @@
           <p:cNvPr id="12" name="CuadroTexto 11">
             <a:extLst>
               <a:ext uri="{FF2B5EF4-FFF2-40B4-BE49-F238E27FC236}">
-                <a16:creationId xmlns:a16="http://schemas.microsoft.com/office/drawing/2014/main" id="{5C4F3807-72A4-8E9F-4117-B4B84FC7DE4F}"/>
+                <a16:creationId xmlns:a16="http://schemas.microsoft.com/office/drawing/2014/main" id="{1E0BC87B-6577-4114-4A08-60D7568CD9CB}"/>
               </a:ext>
             </a:extLst>
           </p:cNvPr>
@@ -10581,7 +10581,7 @@
           <p:cNvPr id="13" name="CuadroTexto 12">
             <a:extLst>
               <a:ext uri="{FF2B5EF4-FFF2-40B4-BE49-F238E27FC236}">
-                <a16:creationId xmlns:a16="http://schemas.microsoft.com/office/drawing/2014/main" id="{3B1C3D3B-6E20-6E4D-2F9F-76A4F3FC0219}"/>
+                <a16:creationId xmlns:a16="http://schemas.microsoft.com/office/drawing/2014/main" id="{7F726083-9450-48F8-A946-91D832AD10D5}"/>
               </a:ext>
             </a:extLst>
           </p:cNvPr>
@@ -10621,7 +10621,7 @@
           <p:cNvPr id="14" name="Rectángulo: esquinas redondeadas 13">
             <a:extLst>
               <a:ext uri="{FF2B5EF4-FFF2-40B4-BE49-F238E27FC236}">
-                <a16:creationId xmlns:a16="http://schemas.microsoft.com/office/drawing/2014/main" id="{6EBE8F2A-EB8C-9F9E-B788-E6D9672FEFEE}"/>
+                <a16:creationId xmlns:a16="http://schemas.microsoft.com/office/drawing/2014/main" id="{C6CEFB94-0FC8-0A65-0F70-5BC718D9427E}"/>
               </a:ext>
             </a:extLst>
           </p:cNvPr>
@@ -10675,7 +10675,7 @@
           <p:cNvPr id="15" name="CuadroTexto 14">
             <a:extLst>
               <a:ext uri="{FF2B5EF4-FFF2-40B4-BE49-F238E27FC236}">
-                <a16:creationId xmlns:a16="http://schemas.microsoft.com/office/drawing/2014/main" id="{DD66F528-F585-2390-50A6-80FCD44B2464}"/>
+                <a16:creationId xmlns:a16="http://schemas.microsoft.com/office/drawing/2014/main" id="{AA529624-3471-9FE4-3689-8EDDACC6D9EB}"/>
               </a:ext>
             </a:extLst>
           </p:cNvPr>
@@ -10715,7 +10715,7 @@
           <p:cNvPr id="16" name="CuadroTexto 15">
             <a:extLst>
               <a:ext uri="{FF2B5EF4-FFF2-40B4-BE49-F238E27FC236}">
-                <a16:creationId xmlns:a16="http://schemas.microsoft.com/office/drawing/2014/main" id="{ED18CF76-3399-ACE5-E3D9-475ADB8C8F4A}"/>
+                <a16:creationId xmlns:a16="http://schemas.microsoft.com/office/drawing/2014/main" id="{C60C4DF2-9568-DE37-E9AA-3EDF5FE954E5}"/>
               </a:ext>
             </a:extLst>
           </p:cNvPr>
@@ -10755,7 +10755,7 @@
           <p:cNvPr id="17" name="CuadroTexto 16">
             <a:extLst>
               <a:ext uri="{FF2B5EF4-FFF2-40B4-BE49-F238E27FC236}">
-                <a16:creationId xmlns:a16="http://schemas.microsoft.com/office/drawing/2014/main" id="{69ED621B-D5AA-F344-EE89-13DEC67FAA87}"/>
+                <a16:creationId xmlns:a16="http://schemas.microsoft.com/office/drawing/2014/main" id="{50FE0E10-B25E-2EDB-C0A4-49EA9A613296}"/>
               </a:ext>
             </a:extLst>
           </p:cNvPr>
@@ -10818,7 +10818,7 @@
     </p:spTree>
     <p:extLst>
       <p:ext uri="{BB962C8B-B14F-4D97-AF65-F5344CB8AC3E}">
-        <p14:creationId xmlns:p14="http://schemas.microsoft.com/office/powerpoint/2010/main" val="3825693380"/>
+        <p14:creationId xmlns:p14="http://schemas.microsoft.com/office/powerpoint/2010/main" val="2333461286"/>
       </p:ext>
     </p:extLst>
   </p:cSld>
@@ -10858,7 +10858,7 @@
           <p:cNvPr id="2" name="CuadroTexto 1">
             <a:extLst>
               <a:ext uri="{FF2B5EF4-FFF2-40B4-BE49-F238E27FC236}">
-                <a16:creationId xmlns:a16="http://schemas.microsoft.com/office/drawing/2014/main" id="{C7606941-A505-6ED2-934F-0D1383A3BBD1}"/>
+                <a16:creationId xmlns:a16="http://schemas.microsoft.com/office/drawing/2014/main" id="{EA79CEE5-9CE1-98E4-A3D3-AE8134AA7D3C}"/>
               </a:ext>
             </a:extLst>
           </p:cNvPr>
@@ -10898,7 +10898,7 @@
           <p:cNvPr id="3" name="CuadroTexto 2">
             <a:extLst>
               <a:ext uri="{FF2B5EF4-FFF2-40B4-BE49-F238E27FC236}">
-                <a16:creationId xmlns:a16="http://schemas.microsoft.com/office/drawing/2014/main" id="{B066FCF9-48EC-E54F-1972-7B82A7AB4A5B}"/>
+                <a16:creationId xmlns:a16="http://schemas.microsoft.com/office/drawing/2014/main" id="{E788EFEB-C964-5A83-FEE2-041762E337C4}"/>
               </a:ext>
             </a:extLst>
           </p:cNvPr>
@@ -10938,7 +10938,7 @@
           <p:cNvPr id="4" name="CuadroTexto 3">
             <a:extLst>
               <a:ext uri="{FF2B5EF4-FFF2-40B4-BE49-F238E27FC236}">
-                <a16:creationId xmlns:a16="http://schemas.microsoft.com/office/drawing/2014/main" id="{A023BE0A-D744-FB56-DD43-06413E117DCF}"/>
+                <a16:creationId xmlns:a16="http://schemas.microsoft.com/office/drawing/2014/main" id="{D673B47A-86DA-EE03-3F3A-A073F47A33A6}"/>
               </a:ext>
             </a:extLst>
           </p:cNvPr>
@@ -11057,7 +11057,7 @@
           <p:cNvPr id="5" name="Rectángulo: esquinas redondeadas 4">
             <a:extLst>
               <a:ext uri="{FF2B5EF4-FFF2-40B4-BE49-F238E27FC236}">
-                <a16:creationId xmlns:a16="http://schemas.microsoft.com/office/drawing/2014/main" id="{245CC601-BCA6-6610-E24B-53EE4F1C4E95}"/>
+                <a16:creationId xmlns:a16="http://schemas.microsoft.com/office/drawing/2014/main" id="{1A026D5F-0958-FF6B-DCDB-2285B2E0E37F}"/>
               </a:ext>
             </a:extLst>
           </p:cNvPr>
@@ -11111,7 +11111,7 @@
           <p:cNvPr id="6" name="CuadroTexto 5">
             <a:extLst>
               <a:ext uri="{FF2B5EF4-FFF2-40B4-BE49-F238E27FC236}">
-                <a16:creationId xmlns:a16="http://schemas.microsoft.com/office/drawing/2014/main" id="{62CC5A9E-C9D8-6C9E-2D75-97BD634AF3F4}"/>
+                <a16:creationId xmlns:a16="http://schemas.microsoft.com/office/drawing/2014/main" id="{AD5C79A8-3870-A2E4-BFE6-E2956C2D970B}"/>
               </a:ext>
             </a:extLst>
           </p:cNvPr>
@@ -11151,7 +11151,7 @@
           <p:cNvPr id="7" name="CuadroTexto 6">
             <a:extLst>
               <a:ext uri="{FF2B5EF4-FFF2-40B4-BE49-F238E27FC236}">
-                <a16:creationId xmlns:a16="http://schemas.microsoft.com/office/drawing/2014/main" id="{63F7F66C-48D3-83AB-2669-E70F0B20B922}"/>
+                <a16:creationId xmlns:a16="http://schemas.microsoft.com/office/drawing/2014/main" id="{37426E24-BDCA-5C43-52E9-25868A35AC64}"/>
               </a:ext>
             </a:extLst>
           </p:cNvPr>
@@ -11189,7 +11189,7 @@
     </p:spTree>
     <p:extLst>
       <p:ext uri="{BB962C8B-B14F-4D97-AF65-F5344CB8AC3E}">
-        <p14:creationId xmlns:p14="http://schemas.microsoft.com/office/powerpoint/2010/main" val="4208851980"/>
+        <p14:creationId xmlns:p14="http://schemas.microsoft.com/office/powerpoint/2010/main" val="1747134379"/>
       </p:ext>
     </p:extLst>
   </p:cSld>
@@ -11229,7 +11229,7 @@
           <p:cNvPr id="2" name="CuadroTexto 1">
             <a:extLst>
               <a:ext uri="{FF2B5EF4-FFF2-40B4-BE49-F238E27FC236}">
-                <a16:creationId xmlns:a16="http://schemas.microsoft.com/office/drawing/2014/main" id="{C6A619A8-D1AE-CD0C-B919-E1F9EEA06B2D}"/>
+                <a16:creationId xmlns:a16="http://schemas.microsoft.com/office/drawing/2014/main" id="{EF744A11-C343-6723-E086-73DE22B7C168}"/>
               </a:ext>
             </a:extLst>
           </p:cNvPr>
@@ -11269,7 +11269,7 @@
           <p:cNvPr id="3" name="CuadroTexto 2">
             <a:extLst>
               <a:ext uri="{FF2B5EF4-FFF2-40B4-BE49-F238E27FC236}">
-                <a16:creationId xmlns:a16="http://schemas.microsoft.com/office/drawing/2014/main" id="{6FF3EE67-2D7B-9873-CD21-3552495D1153}"/>
+                <a16:creationId xmlns:a16="http://schemas.microsoft.com/office/drawing/2014/main" id="{DC13B59A-D000-5E03-99D0-45D96061113C}"/>
               </a:ext>
             </a:extLst>
           </p:cNvPr>
@@ -11309,7 +11309,7 @@
           <p:cNvPr id="4" name="CuadroTexto 3">
             <a:extLst>
               <a:ext uri="{FF2B5EF4-FFF2-40B4-BE49-F238E27FC236}">
-                <a16:creationId xmlns:a16="http://schemas.microsoft.com/office/drawing/2014/main" id="{0F8C8FC3-55E8-9635-BD7E-1CF95C71BA25}"/>
+                <a16:creationId xmlns:a16="http://schemas.microsoft.com/office/drawing/2014/main" id="{A32CEDB8-41A5-005B-833E-077646B66155}"/>
               </a:ext>
             </a:extLst>
           </p:cNvPr>
@@ -11349,7 +11349,7 @@
           <p:cNvPr id="5" name="CuadroTexto 4">
             <a:extLst>
               <a:ext uri="{FF2B5EF4-FFF2-40B4-BE49-F238E27FC236}">
-                <a16:creationId xmlns:a16="http://schemas.microsoft.com/office/drawing/2014/main" id="{A15759A4-892C-07B9-7559-C9A94383805B}"/>
+                <a16:creationId xmlns:a16="http://schemas.microsoft.com/office/drawing/2014/main" id="{447555E6-4BB1-4990-9C41-21473E35C63E}"/>
               </a:ext>
             </a:extLst>
           </p:cNvPr>
@@ -11432,7 +11432,7 @@
           <p:cNvPr id="6" name="CuadroTexto 5">
             <a:extLst>
               <a:ext uri="{FF2B5EF4-FFF2-40B4-BE49-F238E27FC236}">
-                <a16:creationId xmlns:a16="http://schemas.microsoft.com/office/drawing/2014/main" id="{4914ECFB-F9E3-4B0D-7C56-1F1EDE0EB29C}"/>
+                <a16:creationId xmlns:a16="http://schemas.microsoft.com/office/drawing/2014/main" id="{2729358B-C002-34E2-3A00-E7052946587F}"/>
               </a:ext>
             </a:extLst>
           </p:cNvPr>
@@ -11470,7 +11470,7 @@
     </p:spTree>
     <p:extLst>
       <p:ext uri="{BB962C8B-B14F-4D97-AF65-F5344CB8AC3E}">
-        <p14:creationId xmlns:p14="http://schemas.microsoft.com/office/powerpoint/2010/main" val="498048314"/>
+        <p14:creationId xmlns:p14="http://schemas.microsoft.com/office/powerpoint/2010/main" val="3265063490"/>
       </p:ext>
     </p:extLst>
   </p:cSld>
@@ -11510,7 +11510,7 @@
           <p:cNvPr id="2" name="CuadroTexto 1">
             <a:extLst>
               <a:ext uri="{FF2B5EF4-FFF2-40B4-BE49-F238E27FC236}">
-                <a16:creationId xmlns:a16="http://schemas.microsoft.com/office/drawing/2014/main" id="{0BE1E661-0DBC-537A-4084-26EA740CF916}"/>
+                <a16:creationId xmlns:a16="http://schemas.microsoft.com/office/drawing/2014/main" id="{9D31483E-2C85-8C65-4A19-D96AB1324755}"/>
               </a:ext>
             </a:extLst>
           </p:cNvPr>
@@ -11550,7 +11550,7 @@
           <p:cNvPr id="3" name="CuadroTexto 2">
             <a:extLst>
               <a:ext uri="{FF2B5EF4-FFF2-40B4-BE49-F238E27FC236}">
-                <a16:creationId xmlns:a16="http://schemas.microsoft.com/office/drawing/2014/main" id="{BB81B3B2-FC76-157F-884B-E70A56B4CF2A}"/>
+                <a16:creationId xmlns:a16="http://schemas.microsoft.com/office/drawing/2014/main" id="{7CAD892E-8DAE-09A7-DFA6-B044161B5F27}"/>
               </a:ext>
             </a:extLst>
           </p:cNvPr>
@@ -11590,7 +11590,7 @@
           <p:cNvPr id="4" name="CuadroTexto 3">
             <a:extLst>
               <a:ext uri="{FF2B5EF4-FFF2-40B4-BE49-F238E27FC236}">
-                <a16:creationId xmlns:a16="http://schemas.microsoft.com/office/drawing/2014/main" id="{8C328DDE-BC6B-0D6E-57F8-61C8DBF75547}"/>
+                <a16:creationId xmlns:a16="http://schemas.microsoft.com/office/drawing/2014/main" id="{7AF4C546-F5E9-829C-3B23-F0B10CF5FADD}"/>
               </a:ext>
             </a:extLst>
           </p:cNvPr>
@@ -11630,7 +11630,7 @@
           <p:cNvPr id="5" name="CuadroTexto 4">
             <a:extLst>
               <a:ext uri="{FF2B5EF4-FFF2-40B4-BE49-F238E27FC236}">
-                <a16:creationId xmlns:a16="http://schemas.microsoft.com/office/drawing/2014/main" id="{E3D5C569-8644-22B8-E6E3-296989C4AE3C}"/>
+                <a16:creationId xmlns:a16="http://schemas.microsoft.com/office/drawing/2014/main" id="{F85DAE1D-40AA-AE71-64C5-646CD238269C}"/>
               </a:ext>
             </a:extLst>
           </p:cNvPr>
@@ -11731,7 +11731,7 @@
           <p:cNvPr id="6" name="Rectángulo: esquinas redondeadas 5">
             <a:extLst>
               <a:ext uri="{FF2B5EF4-FFF2-40B4-BE49-F238E27FC236}">
-                <a16:creationId xmlns:a16="http://schemas.microsoft.com/office/drawing/2014/main" id="{4F40F10B-4E2C-90EF-2580-AE508C9D1AB9}"/>
+                <a16:creationId xmlns:a16="http://schemas.microsoft.com/office/drawing/2014/main" id="{B4CDBDBC-52C3-41B9-7CE8-E3AFDC5E3BE8}"/>
               </a:ext>
             </a:extLst>
           </p:cNvPr>
@@ -11785,7 +11785,7 @@
           <p:cNvPr id="7" name="CuadroTexto 6">
             <a:extLst>
               <a:ext uri="{FF2B5EF4-FFF2-40B4-BE49-F238E27FC236}">
-                <a16:creationId xmlns:a16="http://schemas.microsoft.com/office/drawing/2014/main" id="{2B933355-C9E0-CBB3-945F-28EF401A6442}"/>
+                <a16:creationId xmlns:a16="http://schemas.microsoft.com/office/drawing/2014/main" id="{66251C0E-0AA4-ACCA-7F44-5929BD879372}"/>
               </a:ext>
             </a:extLst>
           </p:cNvPr>
@@ -11825,7 +11825,7 @@
           <p:cNvPr id="8" name="CuadroTexto 7">
             <a:extLst>
               <a:ext uri="{FF2B5EF4-FFF2-40B4-BE49-F238E27FC236}">
-                <a16:creationId xmlns:a16="http://schemas.microsoft.com/office/drawing/2014/main" id="{B26D1F1B-559A-6BFB-6D3D-0A1C0A9B898B}"/>
+                <a16:creationId xmlns:a16="http://schemas.microsoft.com/office/drawing/2014/main" id="{A1AEF440-B0BF-A292-FA35-AEBE6B50C396}"/>
               </a:ext>
             </a:extLst>
           </p:cNvPr>
@@ -11863,7 +11863,7 @@
     </p:spTree>
     <p:extLst>
       <p:ext uri="{BB962C8B-B14F-4D97-AF65-F5344CB8AC3E}">
-        <p14:creationId xmlns:p14="http://schemas.microsoft.com/office/powerpoint/2010/main" val="4178036023"/>
+        <p14:creationId xmlns:p14="http://schemas.microsoft.com/office/powerpoint/2010/main" val="2325976054"/>
       </p:ext>
     </p:extLst>
   </p:cSld>
@@ -11903,7 +11903,7 @@
           <p:cNvPr id="2" name="CuadroTexto 1">
             <a:extLst>
               <a:ext uri="{FF2B5EF4-FFF2-40B4-BE49-F238E27FC236}">
-                <a16:creationId xmlns:a16="http://schemas.microsoft.com/office/drawing/2014/main" id="{92055057-C8DA-79AB-EF91-AE6FA0178976}"/>
+                <a16:creationId xmlns:a16="http://schemas.microsoft.com/office/drawing/2014/main" id="{914F90E5-AF97-D785-06FB-794BA7BCE6A0}"/>
               </a:ext>
             </a:extLst>
           </p:cNvPr>
@@ -11943,7 +11943,7 @@
           <p:cNvPr id="3" name="CuadroTexto 2">
             <a:extLst>
               <a:ext uri="{FF2B5EF4-FFF2-40B4-BE49-F238E27FC236}">
-                <a16:creationId xmlns:a16="http://schemas.microsoft.com/office/drawing/2014/main" id="{F7A8E162-23F0-0809-7ED7-8FF94E5A2373}"/>
+                <a16:creationId xmlns:a16="http://schemas.microsoft.com/office/drawing/2014/main" id="{D3737A6D-B409-8285-C3AC-A2C8D68E7859}"/>
               </a:ext>
             </a:extLst>
           </p:cNvPr>
@@ -11983,7 +11983,7 @@
           <p:cNvPr id="4" name="Rectángulo: esquinas redondeadas 3">
             <a:extLst>
               <a:ext uri="{FF2B5EF4-FFF2-40B4-BE49-F238E27FC236}">
-                <a16:creationId xmlns:a16="http://schemas.microsoft.com/office/drawing/2014/main" id="{796F02E1-F348-5000-9622-9FAD8414425D}"/>
+                <a16:creationId xmlns:a16="http://schemas.microsoft.com/office/drawing/2014/main" id="{6980B74F-F4E2-BF40-1A89-37A56304E0C4}"/>
               </a:ext>
             </a:extLst>
           </p:cNvPr>
@@ -12037,7 +12037,7 @@
           <p:cNvPr id="5" name="CuadroTexto 4">
             <a:extLst>
               <a:ext uri="{FF2B5EF4-FFF2-40B4-BE49-F238E27FC236}">
-                <a16:creationId xmlns:a16="http://schemas.microsoft.com/office/drawing/2014/main" id="{7B80951D-BFF5-44E9-2F70-8EF0EE5DF7A8}"/>
+                <a16:creationId xmlns:a16="http://schemas.microsoft.com/office/drawing/2014/main" id="{82365E2B-888E-0704-705D-62F82829B4E9}"/>
               </a:ext>
             </a:extLst>
           </p:cNvPr>
@@ -12077,7 +12077,7 @@
           <p:cNvPr id="6" name="CuadroTexto 5">
             <a:extLst>
               <a:ext uri="{FF2B5EF4-FFF2-40B4-BE49-F238E27FC236}">
-                <a16:creationId xmlns:a16="http://schemas.microsoft.com/office/drawing/2014/main" id="{350659C4-A8C6-FAA4-0D7E-F43AFC9CFA81}"/>
+                <a16:creationId xmlns:a16="http://schemas.microsoft.com/office/drawing/2014/main" id="{F66D24EC-DA66-5009-499F-7C912E913683}"/>
               </a:ext>
             </a:extLst>
           </p:cNvPr>
@@ -12117,7 +12117,7 @@
           <p:cNvPr id="7" name="Rectángulo: esquinas redondeadas 6">
             <a:extLst>
               <a:ext uri="{FF2B5EF4-FFF2-40B4-BE49-F238E27FC236}">
-                <a16:creationId xmlns:a16="http://schemas.microsoft.com/office/drawing/2014/main" id="{72A01A7E-A8BD-91A2-E523-8570273680B9}"/>
+                <a16:creationId xmlns:a16="http://schemas.microsoft.com/office/drawing/2014/main" id="{8D933886-9395-F781-30F8-EC30D9E56799}"/>
               </a:ext>
             </a:extLst>
           </p:cNvPr>
@@ -12171,7 +12171,7 @@
           <p:cNvPr id="8" name="CuadroTexto 7">
             <a:extLst>
               <a:ext uri="{FF2B5EF4-FFF2-40B4-BE49-F238E27FC236}">
-                <a16:creationId xmlns:a16="http://schemas.microsoft.com/office/drawing/2014/main" id="{69117723-3856-A544-25E0-B4E777AF45DD}"/>
+                <a16:creationId xmlns:a16="http://schemas.microsoft.com/office/drawing/2014/main" id="{E2D7C7C7-0F88-1836-AC98-EF4265C5DAB9}"/>
               </a:ext>
             </a:extLst>
           </p:cNvPr>
@@ -12211,7 +12211,7 @@
           <p:cNvPr id="9" name="CuadroTexto 8">
             <a:extLst>
               <a:ext uri="{FF2B5EF4-FFF2-40B4-BE49-F238E27FC236}">
-                <a16:creationId xmlns:a16="http://schemas.microsoft.com/office/drawing/2014/main" id="{84CFCE9C-3B32-86CC-5655-D311F49CE002}"/>
+                <a16:creationId xmlns:a16="http://schemas.microsoft.com/office/drawing/2014/main" id="{883A05D4-9E45-18AB-A5F2-58255A340A3B}"/>
               </a:ext>
             </a:extLst>
           </p:cNvPr>
@@ -12251,7 +12251,7 @@
           <p:cNvPr id="10" name="Rectángulo: esquinas redondeadas 9">
             <a:extLst>
               <a:ext uri="{FF2B5EF4-FFF2-40B4-BE49-F238E27FC236}">
-                <a16:creationId xmlns:a16="http://schemas.microsoft.com/office/drawing/2014/main" id="{BA277D77-5C5F-8B9B-251A-CC9C17B6440B}"/>
+                <a16:creationId xmlns:a16="http://schemas.microsoft.com/office/drawing/2014/main" id="{507C673D-9B2B-314F-348D-B68062840297}"/>
               </a:ext>
             </a:extLst>
           </p:cNvPr>
@@ -12305,7 +12305,7 @@
           <p:cNvPr id="11" name="CuadroTexto 10">
             <a:extLst>
               <a:ext uri="{FF2B5EF4-FFF2-40B4-BE49-F238E27FC236}">
-                <a16:creationId xmlns:a16="http://schemas.microsoft.com/office/drawing/2014/main" id="{1EFDB26F-C1F0-AB63-ED7F-C933649CD981}"/>
+                <a16:creationId xmlns:a16="http://schemas.microsoft.com/office/drawing/2014/main" id="{900A31FC-F96A-382D-DFE2-9FFD1107F574}"/>
               </a:ext>
             </a:extLst>
           </p:cNvPr>
@@ -12345,7 +12345,7 @@
           <p:cNvPr id="12" name="CuadroTexto 11">
             <a:extLst>
               <a:ext uri="{FF2B5EF4-FFF2-40B4-BE49-F238E27FC236}">
-                <a16:creationId xmlns:a16="http://schemas.microsoft.com/office/drawing/2014/main" id="{30DD3C42-A676-EF40-69F9-016C6DB92A22}"/>
+                <a16:creationId xmlns:a16="http://schemas.microsoft.com/office/drawing/2014/main" id="{13B49E3F-6B25-E002-3F2A-FAADAD6D8AA3}"/>
               </a:ext>
             </a:extLst>
           </p:cNvPr>
@@ -12385,7 +12385,7 @@
           <p:cNvPr id="13" name="Rectángulo: esquinas redondeadas 12">
             <a:extLst>
               <a:ext uri="{FF2B5EF4-FFF2-40B4-BE49-F238E27FC236}">
-                <a16:creationId xmlns:a16="http://schemas.microsoft.com/office/drawing/2014/main" id="{8FCF037B-FBF2-7338-ABC2-8AD7867B3D58}"/>
+                <a16:creationId xmlns:a16="http://schemas.microsoft.com/office/drawing/2014/main" id="{9AC32662-7AB5-FB37-4F3F-89E93363AF70}"/>
               </a:ext>
             </a:extLst>
           </p:cNvPr>
@@ -12439,7 +12439,7 @@
           <p:cNvPr id="14" name="CuadroTexto 13">
             <a:extLst>
               <a:ext uri="{FF2B5EF4-FFF2-40B4-BE49-F238E27FC236}">
-                <a16:creationId xmlns:a16="http://schemas.microsoft.com/office/drawing/2014/main" id="{A3729578-1F10-4838-DA1C-2EB2E6576A7D}"/>
+                <a16:creationId xmlns:a16="http://schemas.microsoft.com/office/drawing/2014/main" id="{50D9F6E2-3856-CC44-AA38-5267404D5EBB}"/>
               </a:ext>
             </a:extLst>
           </p:cNvPr>
@@ -12479,7 +12479,7 @@
           <p:cNvPr id="15" name="CuadroTexto 14">
             <a:extLst>
               <a:ext uri="{FF2B5EF4-FFF2-40B4-BE49-F238E27FC236}">
-                <a16:creationId xmlns:a16="http://schemas.microsoft.com/office/drawing/2014/main" id="{BA022D2B-C257-8254-B8C2-8F54A360DC16}"/>
+                <a16:creationId xmlns:a16="http://schemas.microsoft.com/office/drawing/2014/main" id="{D5E9140C-DE22-64CF-46DF-E381CB60EFC1}"/>
               </a:ext>
             </a:extLst>
           </p:cNvPr>
@@ -12517,7 +12517,7 @@
     </p:spTree>
     <p:extLst>
       <p:ext uri="{BB962C8B-B14F-4D97-AF65-F5344CB8AC3E}">
-        <p14:creationId xmlns:p14="http://schemas.microsoft.com/office/powerpoint/2010/main" val="1266005131"/>
+        <p14:creationId xmlns:p14="http://schemas.microsoft.com/office/powerpoint/2010/main" val="2253844518"/>
       </p:ext>
     </p:extLst>
   </p:cSld>
@@ -12557,7 +12557,7 @@
           <p:cNvPr id="2" name="CuadroTexto 1">
             <a:extLst>
               <a:ext uri="{FF2B5EF4-FFF2-40B4-BE49-F238E27FC236}">
-                <a16:creationId xmlns:a16="http://schemas.microsoft.com/office/drawing/2014/main" id="{9F60450A-9747-ECC7-AEC6-40741233966B}"/>
+                <a16:creationId xmlns:a16="http://schemas.microsoft.com/office/drawing/2014/main" id="{C41A8E3B-3836-4146-9CBB-685DC5F05FB0}"/>
               </a:ext>
             </a:extLst>
           </p:cNvPr>
@@ -12597,7 +12597,7 @@
           <p:cNvPr id="3" name="CuadroTexto 2">
             <a:extLst>
               <a:ext uri="{FF2B5EF4-FFF2-40B4-BE49-F238E27FC236}">
-                <a16:creationId xmlns:a16="http://schemas.microsoft.com/office/drawing/2014/main" id="{5EABC095-A6BF-21F8-9F11-9FC81CB2B6D2}"/>
+                <a16:creationId xmlns:a16="http://schemas.microsoft.com/office/drawing/2014/main" id="{22A4A2EE-242B-4D72-4812-E08B01826E68}"/>
               </a:ext>
             </a:extLst>
           </p:cNvPr>
@@ -12637,7 +12637,7 @@
           <p:cNvPr id="4" name="CuadroTexto 3">
             <a:extLst>
               <a:ext uri="{FF2B5EF4-FFF2-40B4-BE49-F238E27FC236}">
-                <a16:creationId xmlns:a16="http://schemas.microsoft.com/office/drawing/2014/main" id="{8FB4E0A4-6F94-E109-26F0-2D1EDB6BFB6B}"/>
+                <a16:creationId xmlns:a16="http://schemas.microsoft.com/office/drawing/2014/main" id="{66E3AED2-2066-A7CB-A160-F81410B68E3F}"/>
               </a:ext>
             </a:extLst>
           </p:cNvPr>
@@ -12677,7 +12677,7 @@
           <p:cNvPr id="6" name="Imagen 5">
             <a:extLst>
               <a:ext uri="{FF2B5EF4-FFF2-40B4-BE49-F238E27FC236}">
-                <a16:creationId xmlns:a16="http://schemas.microsoft.com/office/drawing/2014/main" id="{07A2F82E-210A-4082-F095-E918C899C5F4}"/>
+                <a16:creationId xmlns:a16="http://schemas.microsoft.com/office/drawing/2014/main" id="{452032AF-DD56-96CA-0694-5A94E77CADEB}"/>
               </a:ext>
             </a:extLst>
           </p:cNvPr>
@@ -12718,7 +12718,7 @@
           <p:cNvPr id="7" name="CuadroTexto 6">
             <a:extLst>
               <a:ext uri="{FF2B5EF4-FFF2-40B4-BE49-F238E27FC236}">
-                <a16:creationId xmlns:a16="http://schemas.microsoft.com/office/drawing/2014/main" id="{7856E164-D00D-F664-5529-90494663A647}"/>
+                <a16:creationId xmlns:a16="http://schemas.microsoft.com/office/drawing/2014/main" id="{96C02AA3-EA5F-1FD3-5E2F-474AC7504862}"/>
               </a:ext>
             </a:extLst>
           </p:cNvPr>
@@ -12835,7 +12835,7 @@
     </p:spTree>
     <p:extLst>
       <p:ext uri="{BB962C8B-B14F-4D97-AF65-F5344CB8AC3E}">
-        <p14:creationId xmlns:p14="http://schemas.microsoft.com/office/powerpoint/2010/main" val="3151849778"/>
+        <p14:creationId xmlns:p14="http://schemas.microsoft.com/office/powerpoint/2010/main" val="158311805"/>
       </p:ext>
     </p:extLst>
   </p:cSld>
@@ -12875,7 +12875,7 @@
           <p:cNvPr id="2" name="CuadroTexto 1">
             <a:extLst>
               <a:ext uri="{FF2B5EF4-FFF2-40B4-BE49-F238E27FC236}">
-                <a16:creationId xmlns:a16="http://schemas.microsoft.com/office/drawing/2014/main" id="{D002DA14-00E1-E92E-3AC0-5C19A9FAA3DC}"/>
+                <a16:creationId xmlns:a16="http://schemas.microsoft.com/office/drawing/2014/main" id="{E951A4B9-C4CD-D3C0-9F74-CEB32CDB269C}"/>
               </a:ext>
             </a:extLst>
           </p:cNvPr>
@@ -12915,7 +12915,7 @@
           <p:cNvPr id="3" name="CuadroTexto 2">
             <a:extLst>
               <a:ext uri="{FF2B5EF4-FFF2-40B4-BE49-F238E27FC236}">
-                <a16:creationId xmlns:a16="http://schemas.microsoft.com/office/drawing/2014/main" id="{006AF4D4-6D8C-5DAF-AC80-9EA4165205F8}"/>
+                <a16:creationId xmlns:a16="http://schemas.microsoft.com/office/drawing/2014/main" id="{0C38EFF9-469D-1C90-4E66-F169BBF08B83}"/>
               </a:ext>
             </a:extLst>
           </p:cNvPr>
@@ -12955,7 +12955,7 @@
           <p:cNvPr id="5" name="Imagen 4">
             <a:extLst>
               <a:ext uri="{FF2B5EF4-FFF2-40B4-BE49-F238E27FC236}">
-                <a16:creationId xmlns:a16="http://schemas.microsoft.com/office/drawing/2014/main" id="{8E2D9F19-160F-7F42-0A8A-5F3B436444A4}"/>
+                <a16:creationId xmlns:a16="http://schemas.microsoft.com/office/drawing/2014/main" id="{1CA1F5BB-AE33-29DE-8201-C11F103F3834}"/>
               </a:ext>
             </a:extLst>
           </p:cNvPr>
@@ -12996,7 +12996,7 @@
           <p:cNvPr id="6" name="CuadroTexto 5">
             <a:extLst>
               <a:ext uri="{FF2B5EF4-FFF2-40B4-BE49-F238E27FC236}">
-                <a16:creationId xmlns:a16="http://schemas.microsoft.com/office/drawing/2014/main" id="{3845DA8F-B51F-925D-D6CD-FE1BA682B570}"/>
+                <a16:creationId xmlns:a16="http://schemas.microsoft.com/office/drawing/2014/main" id="{E987F68F-046C-3FF7-AF42-F639F369C6FE}"/>
               </a:ext>
             </a:extLst>
           </p:cNvPr>
@@ -13036,7 +13036,7 @@
           <p:cNvPr id="7" name="CuadroTexto 6">
             <a:extLst>
               <a:ext uri="{FF2B5EF4-FFF2-40B4-BE49-F238E27FC236}">
-                <a16:creationId xmlns:a16="http://schemas.microsoft.com/office/drawing/2014/main" id="{95828F11-C728-3E5F-DECE-971949EC42A1}"/>
+                <a16:creationId xmlns:a16="http://schemas.microsoft.com/office/drawing/2014/main" id="{176C2567-1D20-F23F-04BE-B6EC5B5AB4BF}"/>
               </a:ext>
             </a:extLst>
           </p:cNvPr>
@@ -13135,7 +13135,7 @@
     </p:spTree>
     <p:extLst>
       <p:ext uri="{BB962C8B-B14F-4D97-AF65-F5344CB8AC3E}">
-        <p14:creationId xmlns:p14="http://schemas.microsoft.com/office/powerpoint/2010/main" val="2627772969"/>
+        <p14:creationId xmlns:p14="http://schemas.microsoft.com/office/powerpoint/2010/main" val="3849511301"/>
       </p:ext>
     </p:extLst>
   </p:cSld>
@@ -13175,7 +13175,7 @@
           <p:cNvPr id="2" name="CuadroTexto 1">
             <a:extLst>
               <a:ext uri="{FF2B5EF4-FFF2-40B4-BE49-F238E27FC236}">
-                <a16:creationId xmlns:a16="http://schemas.microsoft.com/office/drawing/2014/main" id="{BAFC902B-ECE9-C8C8-E25A-F648D92DFC2A}"/>
+                <a16:creationId xmlns:a16="http://schemas.microsoft.com/office/drawing/2014/main" id="{5A445AED-67B3-A8F9-7FD6-E9145A71D731}"/>
               </a:ext>
             </a:extLst>
           </p:cNvPr>
@@ -13215,7 +13215,7 @@
           <p:cNvPr id="3" name="CuadroTexto 2">
             <a:extLst>
               <a:ext uri="{FF2B5EF4-FFF2-40B4-BE49-F238E27FC236}">
-                <a16:creationId xmlns:a16="http://schemas.microsoft.com/office/drawing/2014/main" id="{F3938256-8733-E912-BB12-365AC2984174}"/>
+                <a16:creationId xmlns:a16="http://schemas.microsoft.com/office/drawing/2014/main" id="{8E96945A-ED17-86CE-7FBA-04651F68202F}"/>
               </a:ext>
             </a:extLst>
           </p:cNvPr>
@@ -13255,7 +13255,7 @@
           <p:cNvPr id="4" name="CuadroTexto 3">
             <a:extLst>
               <a:ext uri="{FF2B5EF4-FFF2-40B4-BE49-F238E27FC236}">
-                <a16:creationId xmlns:a16="http://schemas.microsoft.com/office/drawing/2014/main" id="{A3CB6E49-7281-3D5F-0381-C2231959554C}"/>
+                <a16:creationId xmlns:a16="http://schemas.microsoft.com/office/drawing/2014/main" id="{0DEC7380-4D0A-30F8-2946-4C2FED85D370}"/>
               </a:ext>
             </a:extLst>
           </p:cNvPr>
@@ -13295,7 +13295,7 @@
           <p:cNvPr id="6" name="Imagen 5">
             <a:extLst>
               <a:ext uri="{FF2B5EF4-FFF2-40B4-BE49-F238E27FC236}">
-                <a16:creationId xmlns:a16="http://schemas.microsoft.com/office/drawing/2014/main" id="{E653A684-07FE-1835-7E64-E1D013C2A3D2}"/>
+                <a16:creationId xmlns:a16="http://schemas.microsoft.com/office/drawing/2014/main" id="{F06992D4-AF73-5463-6CB7-ACC98815C430}"/>
               </a:ext>
             </a:extLst>
           </p:cNvPr>
@@ -13336,7 +13336,7 @@
           <p:cNvPr id="7" name="Rectángulo: esquinas redondeadas 6">
             <a:extLst>
               <a:ext uri="{FF2B5EF4-FFF2-40B4-BE49-F238E27FC236}">
-                <a16:creationId xmlns:a16="http://schemas.microsoft.com/office/drawing/2014/main" id="{DD7C823A-460C-59B6-E2E8-7BFABF734BF0}"/>
+                <a16:creationId xmlns:a16="http://schemas.microsoft.com/office/drawing/2014/main" id="{768CC9F6-8DCF-AF83-D6D3-445678F1B718}"/>
               </a:ext>
             </a:extLst>
           </p:cNvPr>
@@ -13390,7 +13390,7 @@
           <p:cNvPr id="8" name="CuadroTexto 7">
             <a:extLst>
               <a:ext uri="{FF2B5EF4-FFF2-40B4-BE49-F238E27FC236}">
-                <a16:creationId xmlns:a16="http://schemas.microsoft.com/office/drawing/2014/main" id="{59310465-5CC5-8CA5-F743-258CDFF24385}"/>
+                <a16:creationId xmlns:a16="http://schemas.microsoft.com/office/drawing/2014/main" id="{AECF27DF-1150-0F45-F135-8EE40DC08CA6}"/>
               </a:ext>
             </a:extLst>
           </p:cNvPr>
@@ -13430,7 +13430,7 @@
           <p:cNvPr id="9" name="CuadroTexto 8">
             <a:extLst>
               <a:ext uri="{FF2B5EF4-FFF2-40B4-BE49-F238E27FC236}">
-                <a16:creationId xmlns:a16="http://schemas.microsoft.com/office/drawing/2014/main" id="{0307187F-2797-A1F0-20D6-402E3841F65A}"/>
+                <a16:creationId xmlns:a16="http://schemas.microsoft.com/office/drawing/2014/main" id="{F1BE29AE-EFBE-EAB3-5134-F06DFB28978C}"/>
               </a:ext>
             </a:extLst>
           </p:cNvPr>
@@ -13470,7 +13470,7 @@
           <p:cNvPr id="10" name="Rectángulo: esquinas redondeadas 9">
             <a:extLst>
               <a:ext uri="{FF2B5EF4-FFF2-40B4-BE49-F238E27FC236}">
-                <a16:creationId xmlns:a16="http://schemas.microsoft.com/office/drawing/2014/main" id="{EE117D0C-CFA5-A47E-E94B-D6FC657B690C}"/>
+                <a16:creationId xmlns:a16="http://schemas.microsoft.com/office/drawing/2014/main" id="{9C14D19E-EE1E-20E7-C397-AD0F795191B7}"/>
               </a:ext>
             </a:extLst>
           </p:cNvPr>
@@ -13524,7 +13524,7 @@
           <p:cNvPr id="11" name="CuadroTexto 10">
             <a:extLst>
               <a:ext uri="{FF2B5EF4-FFF2-40B4-BE49-F238E27FC236}">
-                <a16:creationId xmlns:a16="http://schemas.microsoft.com/office/drawing/2014/main" id="{6F45AC9F-C44D-5400-BB94-D8D9A565710F}"/>
+                <a16:creationId xmlns:a16="http://schemas.microsoft.com/office/drawing/2014/main" id="{513535E6-F34F-3854-4055-86FAF5EF055C}"/>
               </a:ext>
             </a:extLst>
           </p:cNvPr>
@@ -13564,7 +13564,7 @@
           <p:cNvPr id="12" name="CuadroTexto 11">
             <a:extLst>
               <a:ext uri="{FF2B5EF4-FFF2-40B4-BE49-F238E27FC236}">
-                <a16:creationId xmlns:a16="http://schemas.microsoft.com/office/drawing/2014/main" id="{6F0CDBD4-C89F-B51E-F6E9-CEDC0009EA58}"/>
+                <a16:creationId xmlns:a16="http://schemas.microsoft.com/office/drawing/2014/main" id="{0A723147-D410-4E94-FF50-F04035AF8556}"/>
               </a:ext>
             </a:extLst>
           </p:cNvPr>
@@ -13604,7 +13604,7 @@
           <p:cNvPr id="13" name="Rectángulo: esquinas redondeadas 12">
             <a:extLst>
               <a:ext uri="{FF2B5EF4-FFF2-40B4-BE49-F238E27FC236}">
-                <a16:creationId xmlns:a16="http://schemas.microsoft.com/office/drawing/2014/main" id="{67925F74-B796-8116-A1D2-DB91CF088FF3}"/>
+                <a16:creationId xmlns:a16="http://schemas.microsoft.com/office/drawing/2014/main" id="{E200B8FA-C58A-4916-6D4B-0C2429398A3F}"/>
               </a:ext>
             </a:extLst>
           </p:cNvPr>
@@ -13658,7 +13658,7 @@
           <p:cNvPr id="14" name="CuadroTexto 13">
             <a:extLst>
               <a:ext uri="{FF2B5EF4-FFF2-40B4-BE49-F238E27FC236}">
-                <a16:creationId xmlns:a16="http://schemas.microsoft.com/office/drawing/2014/main" id="{986D3EB3-9E66-36B3-8C9C-28BF13C35816}"/>
+                <a16:creationId xmlns:a16="http://schemas.microsoft.com/office/drawing/2014/main" id="{B1C8D309-9332-0592-4461-70E39E5F8E69}"/>
               </a:ext>
             </a:extLst>
           </p:cNvPr>
@@ -13698,7 +13698,7 @@
           <p:cNvPr id="15" name="CuadroTexto 14">
             <a:extLst>
               <a:ext uri="{FF2B5EF4-FFF2-40B4-BE49-F238E27FC236}">
-                <a16:creationId xmlns:a16="http://schemas.microsoft.com/office/drawing/2014/main" id="{9B8DBD57-B93A-80F2-CBA2-17687CF8B36F}"/>
+                <a16:creationId xmlns:a16="http://schemas.microsoft.com/office/drawing/2014/main" id="{F63C3D38-6CD7-B851-DA21-972F6C4262D5}"/>
               </a:ext>
             </a:extLst>
           </p:cNvPr>
@@ -13736,7 +13736,7 @@
     </p:spTree>
     <p:extLst>
       <p:ext uri="{BB962C8B-B14F-4D97-AF65-F5344CB8AC3E}">
-        <p14:creationId xmlns:p14="http://schemas.microsoft.com/office/powerpoint/2010/main" val="1764140627"/>
+        <p14:creationId xmlns:p14="http://schemas.microsoft.com/office/powerpoint/2010/main" val="2285606361"/>
       </p:ext>
     </p:extLst>
   </p:cSld>
@@ -13776,7 +13776,7 @@
           <p:cNvPr id="2" name="CuadroTexto 1">
             <a:extLst>
               <a:ext uri="{FF2B5EF4-FFF2-40B4-BE49-F238E27FC236}">
-                <a16:creationId xmlns:a16="http://schemas.microsoft.com/office/drawing/2014/main" id="{612EDC8B-2C38-558A-58F7-49C2BEAD3F40}"/>
+                <a16:creationId xmlns:a16="http://schemas.microsoft.com/office/drawing/2014/main" id="{8F6EDED2-C176-D54A-4744-4687B6033032}"/>
               </a:ext>
             </a:extLst>
           </p:cNvPr>
@@ -13816,7 +13816,7 @@
           <p:cNvPr id="3" name="CuadroTexto 2">
             <a:extLst>
               <a:ext uri="{FF2B5EF4-FFF2-40B4-BE49-F238E27FC236}">
-                <a16:creationId xmlns:a16="http://schemas.microsoft.com/office/drawing/2014/main" id="{359793CE-B4F4-8B17-247B-3B055B190D0B}"/>
+                <a16:creationId xmlns:a16="http://schemas.microsoft.com/office/drawing/2014/main" id="{DE06F856-1977-278D-4D9D-1E43F42B3E63}"/>
               </a:ext>
             </a:extLst>
           </p:cNvPr>
@@ -13856,7 +13856,7 @@
           <p:cNvPr id="5" name="Imagen 4">
             <a:extLst>
               <a:ext uri="{FF2B5EF4-FFF2-40B4-BE49-F238E27FC236}">
-                <a16:creationId xmlns:a16="http://schemas.microsoft.com/office/drawing/2014/main" id="{42262D1B-3C23-9DB5-7D61-B7106B3FF9BE}"/>
+                <a16:creationId xmlns:a16="http://schemas.microsoft.com/office/drawing/2014/main" id="{8D25A269-DC2D-733A-299D-BD80DAD89820}"/>
               </a:ext>
             </a:extLst>
           </p:cNvPr>
@@ -13897,7 +13897,7 @@
           <p:cNvPr id="6" name="CuadroTexto 5">
             <a:extLst>
               <a:ext uri="{FF2B5EF4-FFF2-40B4-BE49-F238E27FC236}">
-                <a16:creationId xmlns:a16="http://schemas.microsoft.com/office/drawing/2014/main" id="{2D665ACC-3598-1EF7-5FCA-6AB06BD7F463}"/>
+                <a16:creationId xmlns:a16="http://schemas.microsoft.com/office/drawing/2014/main" id="{35AFBA7F-E6A0-E468-4A1D-26781C28597C}"/>
               </a:ext>
             </a:extLst>
           </p:cNvPr>
@@ -13996,7 +13996,7 @@
     </p:spTree>
     <p:extLst>
       <p:ext uri="{BB962C8B-B14F-4D97-AF65-F5344CB8AC3E}">
-        <p14:creationId xmlns:p14="http://schemas.microsoft.com/office/powerpoint/2010/main" val="3931619758"/>
+        <p14:creationId xmlns:p14="http://schemas.microsoft.com/office/powerpoint/2010/main" val="4115379032"/>
       </p:ext>
     </p:extLst>
   </p:cSld>
@@ -14036,7 +14036,7 @@
           <p:cNvPr id="2" name="CuadroTexto 1">
             <a:extLst>
               <a:ext uri="{FF2B5EF4-FFF2-40B4-BE49-F238E27FC236}">
-                <a16:creationId xmlns:a16="http://schemas.microsoft.com/office/drawing/2014/main" id="{4EBAE9BF-BCF3-148B-DA54-96389DA42403}"/>
+                <a16:creationId xmlns:a16="http://schemas.microsoft.com/office/drawing/2014/main" id="{47F6931E-2B26-D49A-AFE6-CC53F8148F71}"/>
               </a:ext>
             </a:extLst>
           </p:cNvPr>
@@ -14076,7 +14076,7 @@
           <p:cNvPr id="3" name="CuadroTexto 2">
             <a:extLst>
               <a:ext uri="{FF2B5EF4-FFF2-40B4-BE49-F238E27FC236}">
-                <a16:creationId xmlns:a16="http://schemas.microsoft.com/office/drawing/2014/main" id="{8767AC55-98BE-1B9C-A0E1-9CD1149694F0}"/>
+                <a16:creationId xmlns:a16="http://schemas.microsoft.com/office/drawing/2014/main" id="{1128270E-7F07-312D-1B5C-DCBDCD60AF70}"/>
               </a:ext>
             </a:extLst>
           </p:cNvPr>
@@ -14116,7 +14116,7 @@
           <p:cNvPr id="4" name="CuadroTexto 3">
             <a:extLst>
               <a:ext uri="{FF2B5EF4-FFF2-40B4-BE49-F238E27FC236}">
-                <a16:creationId xmlns:a16="http://schemas.microsoft.com/office/drawing/2014/main" id="{6657ADCF-930B-FD8A-6B3C-0A1DCD0B910A}"/>
+                <a16:creationId xmlns:a16="http://schemas.microsoft.com/office/drawing/2014/main" id="{D1CF334C-A94F-E4C6-B928-50E04EA0E2EF}"/>
               </a:ext>
             </a:extLst>
           </p:cNvPr>
@@ -14156,7 +14156,7 @@
           <p:cNvPr id="6" name="Imagen 5">
             <a:extLst>
               <a:ext uri="{FF2B5EF4-FFF2-40B4-BE49-F238E27FC236}">
-                <a16:creationId xmlns:a16="http://schemas.microsoft.com/office/drawing/2014/main" id="{C296A2F4-EC02-0EE5-09BF-890AD8AB99C6}"/>
+                <a16:creationId xmlns:a16="http://schemas.microsoft.com/office/drawing/2014/main" id="{5F307C9B-F1AA-88F7-3968-78814345B8DE}"/>
               </a:ext>
             </a:extLst>
           </p:cNvPr>
@@ -14197,7 +14197,7 @@
           <p:cNvPr id="7" name="Rectángulo: esquinas redondeadas 6">
             <a:extLst>
               <a:ext uri="{FF2B5EF4-FFF2-40B4-BE49-F238E27FC236}">
-                <a16:creationId xmlns:a16="http://schemas.microsoft.com/office/drawing/2014/main" id="{C6986347-CF1D-F844-7D02-D301C3636090}"/>
+                <a16:creationId xmlns:a16="http://schemas.microsoft.com/office/drawing/2014/main" id="{FDA56359-6581-D044-D5E4-7E91EEE018E6}"/>
               </a:ext>
             </a:extLst>
           </p:cNvPr>
@@ -14251,7 +14251,7 @@
           <p:cNvPr id="8" name="CuadroTexto 7">
             <a:extLst>
               <a:ext uri="{FF2B5EF4-FFF2-40B4-BE49-F238E27FC236}">
-                <a16:creationId xmlns:a16="http://schemas.microsoft.com/office/drawing/2014/main" id="{79463B5C-0AFE-F5AA-D828-7ECCC155675D}"/>
+                <a16:creationId xmlns:a16="http://schemas.microsoft.com/office/drawing/2014/main" id="{A67D654B-1E8B-6A8D-019F-541401D1782A}"/>
               </a:ext>
             </a:extLst>
           </p:cNvPr>
@@ -14291,7 +14291,7 @@
           <p:cNvPr id="9" name="CuadroTexto 8">
             <a:extLst>
               <a:ext uri="{FF2B5EF4-FFF2-40B4-BE49-F238E27FC236}">
-                <a16:creationId xmlns:a16="http://schemas.microsoft.com/office/drawing/2014/main" id="{B9D66FFA-3378-6505-262E-6349FD1D2831}"/>
+                <a16:creationId xmlns:a16="http://schemas.microsoft.com/office/drawing/2014/main" id="{96ED29F5-2589-963A-3989-03BBC9B0C438}"/>
               </a:ext>
             </a:extLst>
           </p:cNvPr>
@@ -14329,7 +14329,7 @@
     </p:spTree>
     <p:extLst>
       <p:ext uri="{BB962C8B-B14F-4D97-AF65-F5344CB8AC3E}">
-        <p14:creationId xmlns:p14="http://schemas.microsoft.com/office/powerpoint/2010/main" val="1669319357"/>
+        <p14:creationId xmlns:p14="http://schemas.microsoft.com/office/powerpoint/2010/main" val="4211578087"/>
       </p:ext>
     </p:extLst>
   </p:cSld>
@@ -14369,7 +14369,7 @@
           <p:cNvPr id="2" name="CuadroTexto 1">
             <a:extLst>
               <a:ext uri="{FF2B5EF4-FFF2-40B4-BE49-F238E27FC236}">
-                <a16:creationId xmlns:a16="http://schemas.microsoft.com/office/drawing/2014/main" id="{10D66F9A-478B-94C2-0D94-7C4E80B18F57}"/>
+                <a16:creationId xmlns:a16="http://schemas.microsoft.com/office/drawing/2014/main" id="{9AEB3CDB-CC08-C12C-C8DD-17EA9590CD91}"/>
               </a:ext>
             </a:extLst>
           </p:cNvPr>
@@ -14409,7 +14409,7 @@
           <p:cNvPr id="3" name="CuadroTexto 2">
             <a:extLst>
               <a:ext uri="{FF2B5EF4-FFF2-40B4-BE49-F238E27FC236}">
-                <a16:creationId xmlns:a16="http://schemas.microsoft.com/office/drawing/2014/main" id="{A936EB9F-A72B-FA0D-0F46-78A3A4950293}"/>
+                <a16:creationId xmlns:a16="http://schemas.microsoft.com/office/drawing/2014/main" id="{0B2ED243-4430-5C2A-D633-D797AF402BA9}"/>
               </a:ext>
             </a:extLst>
           </p:cNvPr>
@@ -14449,7 +14449,7 @@
           <p:cNvPr id="4" name="CuadroTexto 3">
             <a:extLst>
               <a:ext uri="{FF2B5EF4-FFF2-40B4-BE49-F238E27FC236}">
-                <a16:creationId xmlns:a16="http://schemas.microsoft.com/office/drawing/2014/main" id="{3B94261E-0445-84DE-98D8-CE8FCB8887FB}"/>
+                <a16:creationId xmlns:a16="http://schemas.microsoft.com/office/drawing/2014/main" id="{1C0ABB57-10DA-73ED-5FF0-30523782C6A7}"/>
               </a:ext>
             </a:extLst>
           </p:cNvPr>
@@ -14489,7 +14489,7 @@
           <p:cNvPr id="5" name="Rectángulo: esquinas redondeadas 4">
             <a:extLst>
               <a:ext uri="{FF2B5EF4-FFF2-40B4-BE49-F238E27FC236}">
-                <a16:creationId xmlns:a16="http://schemas.microsoft.com/office/drawing/2014/main" id="{23B32681-1AA4-E6FC-3A5A-AC3FB99A6760}"/>
+                <a16:creationId xmlns:a16="http://schemas.microsoft.com/office/drawing/2014/main" id="{74E7650D-1789-405C-8216-9788A10FBD30}"/>
               </a:ext>
             </a:extLst>
           </p:cNvPr>
@@ -14543,7 +14543,7 @@
           <p:cNvPr id="6" name="CuadroTexto 5">
             <a:extLst>
               <a:ext uri="{FF2B5EF4-FFF2-40B4-BE49-F238E27FC236}">
-                <a16:creationId xmlns:a16="http://schemas.microsoft.com/office/drawing/2014/main" id="{793B4C7E-C901-674F-6CA6-D097698D1972}"/>
+                <a16:creationId xmlns:a16="http://schemas.microsoft.com/office/drawing/2014/main" id="{2DA73CB8-6621-DAD4-70CF-004880DF472C}"/>
               </a:ext>
             </a:extLst>
           </p:cNvPr>
@@ -14583,7 +14583,7 @@
           <p:cNvPr id="7" name="CuadroTexto 6">
             <a:extLst>
               <a:ext uri="{FF2B5EF4-FFF2-40B4-BE49-F238E27FC236}">
-                <a16:creationId xmlns:a16="http://schemas.microsoft.com/office/drawing/2014/main" id="{BEF21C9F-7BDD-117A-0037-231BC35A4A5E}"/>
+                <a16:creationId xmlns:a16="http://schemas.microsoft.com/office/drawing/2014/main" id="{C502EF6A-5E36-E119-72D8-F8FB69B3D3DE}"/>
               </a:ext>
             </a:extLst>
           </p:cNvPr>
@@ -14623,7 +14623,7 @@
           <p:cNvPr id="8" name="Rectángulo: esquinas redondeadas 7">
             <a:extLst>
               <a:ext uri="{FF2B5EF4-FFF2-40B4-BE49-F238E27FC236}">
-                <a16:creationId xmlns:a16="http://schemas.microsoft.com/office/drawing/2014/main" id="{8CA9703B-CA62-E505-0BC4-DB2B2D51319D}"/>
+                <a16:creationId xmlns:a16="http://schemas.microsoft.com/office/drawing/2014/main" id="{E3AE79F3-606E-A255-116A-9714F58F444B}"/>
               </a:ext>
             </a:extLst>
           </p:cNvPr>
@@ -14677,7 +14677,7 @@
           <p:cNvPr id="9" name="CuadroTexto 8">
             <a:extLst>
               <a:ext uri="{FF2B5EF4-FFF2-40B4-BE49-F238E27FC236}">
-                <a16:creationId xmlns:a16="http://schemas.microsoft.com/office/drawing/2014/main" id="{0712D07B-B4CE-7B51-FA6E-9A9E87A92548}"/>
+                <a16:creationId xmlns:a16="http://schemas.microsoft.com/office/drawing/2014/main" id="{F4EA034F-2E3C-E2C6-462F-9A491E05496B}"/>
               </a:ext>
             </a:extLst>
           </p:cNvPr>
@@ -14717,7 +14717,7 @@
           <p:cNvPr id="10" name="CuadroTexto 9">
             <a:extLst>
               <a:ext uri="{FF2B5EF4-FFF2-40B4-BE49-F238E27FC236}">
-                <a16:creationId xmlns:a16="http://schemas.microsoft.com/office/drawing/2014/main" id="{443EE948-256D-0643-624C-66C5E5933FB7}"/>
+                <a16:creationId xmlns:a16="http://schemas.microsoft.com/office/drawing/2014/main" id="{CF27E8AA-E838-869D-A3EA-9BC78AD01BB6}"/>
               </a:ext>
             </a:extLst>
           </p:cNvPr>
@@ -14757,7 +14757,7 @@
           <p:cNvPr id="11" name="Rectángulo: esquinas redondeadas 10">
             <a:extLst>
               <a:ext uri="{FF2B5EF4-FFF2-40B4-BE49-F238E27FC236}">
-                <a16:creationId xmlns:a16="http://schemas.microsoft.com/office/drawing/2014/main" id="{37B69794-AC23-1AA4-AD61-B120A9E2133E}"/>
+                <a16:creationId xmlns:a16="http://schemas.microsoft.com/office/drawing/2014/main" id="{1E84D195-6702-7DE4-146B-23D5E279A2EC}"/>
               </a:ext>
             </a:extLst>
           </p:cNvPr>
@@ -14811,7 +14811,7 @@
           <p:cNvPr id="12" name="CuadroTexto 11">
             <a:extLst>
               <a:ext uri="{FF2B5EF4-FFF2-40B4-BE49-F238E27FC236}">
-                <a16:creationId xmlns:a16="http://schemas.microsoft.com/office/drawing/2014/main" id="{1C6FE4E0-0CE0-C5F5-02B6-6B3232402195}"/>
+                <a16:creationId xmlns:a16="http://schemas.microsoft.com/office/drawing/2014/main" id="{0841BA9E-B461-01DA-D9DD-E054EE9039E3}"/>
               </a:ext>
             </a:extLst>
           </p:cNvPr>
@@ -14851,7 +14851,7 @@
           <p:cNvPr id="13" name="CuadroTexto 12">
             <a:extLst>
               <a:ext uri="{FF2B5EF4-FFF2-40B4-BE49-F238E27FC236}">
-                <a16:creationId xmlns:a16="http://schemas.microsoft.com/office/drawing/2014/main" id="{31C624D6-21BD-CC92-0A83-5A6A2A831D6C}"/>
+                <a16:creationId xmlns:a16="http://schemas.microsoft.com/office/drawing/2014/main" id="{6E99977C-0D3D-1718-2A07-78C1AB056AE7}"/>
               </a:ext>
             </a:extLst>
           </p:cNvPr>
@@ -14891,7 +14891,7 @@
           <p:cNvPr id="14" name="Rectángulo: esquinas redondeadas 13">
             <a:extLst>
               <a:ext uri="{FF2B5EF4-FFF2-40B4-BE49-F238E27FC236}">
-                <a16:creationId xmlns:a16="http://schemas.microsoft.com/office/drawing/2014/main" id="{7AD01AB8-75FA-48EF-9A9E-0C26B91515F5}"/>
+                <a16:creationId xmlns:a16="http://schemas.microsoft.com/office/drawing/2014/main" id="{1FBE6333-4986-66DE-3BFE-5A3AFF646477}"/>
               </a:ext>
             </a:extLst>
           </p:cNvPr>
@@ -14945,7 +14945,7 @@
           <p:cNvPr id="15" name="CuadroTexto 14">
             <a:extLst>
               <a:ext uri="{FF2B5EF4-FFF2-40B4-BE49-F238E27FC236}">
-                <a16:creationId xmlns:a16="http://schemas.microsoft.com/office/drawing/2014/main" id="{48BB8B21-F1CD-6837-F7C2-38E95C3012D5}"/>
+                <a16:creationId xmlns:a16="http://schemas.microsoft.com/office/drawing/2014/main" id="{4EB26C40-868E-B993-9998-D6F0B9C0A31A}"/>
               </a:ext>
             </a:extLst>
           </p:cNvPr>
@@ -14985,7 +14985,7 @@
           <p:cNvPr id="16" name="CuadroTexto 15">
             <a:extLst>
               <a:ext uri="{FF2B5EF4-FFF2-40B4-BE49-F238E27FC236}">
-                <a16:creationId xmlns:a16="http://schemas.microsoft.com/office/drawing/2014/main" id="{7BCE2F74-FDA6-C2AE-2DF9-A6560E346D0F}"/>
+                <a16:creationId xmlns:a16="http://schemas.microsoft.com/office/drawing/2014/main" id="{682E5687-1AFD-1DCB-57EF-686B2BB46F02}"/>
               </a:ext>
             </a:extLst>
           </p:cNvPr>
@@ -15025,7 +15025,7 @@
           <p:cNvPr id="17" name="Rectángulo: esquinas redondeadas 16">
             <a:extLst>
               <a:ext uri="{FF2B5EF4-FFF2-40B4-BE49-F238E27FC236}">
-                <a16:creationId xmlns:a16="http://schemas.microsoft.com/office/drawing/2014/main" id="{CA3D00FB-AF86-F693-9B68-C7B854B6A04E}"/>
+                <a16:creationId xmlns:a16="http://schemas.microsoft.com/office/drawing/2014/main" id="{0B8B8DB2-0CF9-291D-00C1-E4FF1DC27855}"/>
               </a:ext>
             </a:extLst>
           </p:cNvPr>
@@ -15079,7 +15079,7 @@
           <p:cNvPr id="18" name="CuadroTexto 17">
             <a:extLst>
               <a:ext uri="{FF2B5EF4-FFF2-40B4-BE49-F238E27FC236}">
-                <a16:creationId xmlns:a16="http://schemas.microsoft.com/office/drawing/2014/main" id="{0F493F7B-228D-F217-AB81-80DC3BB8E937}"/>
+                <a16:creationId xmlns:a16="http://schemas.microsoft.com/office/drawing/2014/main" id="{7AF5ED68-453B-B03B-05B5-5BD566D57D87}"/>
               </a:ext>
             </a:extLst>
           </p:cNvPr>
@@ -15119,7 +15119,7 @@
           <p:cNvPr id="19" name="CuadroTexto 18">
             <a:extLst>
               <a:ext uri="{FF2B5EF4-FFF2-40B4-BE49-F238E27FC236}">
-                <a16:creationId xmlns:a16="http://schemas.microsoft.com/office/drawing/2014/main" id="{5DAAA210-1E5C-5213-F123-1ACE99799C9E}"/>
+                <a16:creationId xmlns:a16="http://schemas.microsoft.com/office/drawing/2014/main" id="{69EE2F77-D164-8680-0DF1-94E08F782648}"/>
               </a:ext>
             </a:extLst>
           </p:cNvPr>
@@ -15159,7 +15159,7 @@
           <p:cNvPr id="20" name="Rectángulo: esquinas redondeadas 19">
             <a:extLst>
               <a:ext uri="{FF2B5EF4-FFF2-40B4-BE49-F238E27FC236}">
-                <a16:creationId xmlns:a16="http://schemas.microsoft.com/office/drawing/2014/main" id="{0B8E54AB-9400-1A60-C038-5BD2155C418A}"/>
+                <a16:creationId xmlns:a16="http://schemas.microsoft.com/office/drawing/2014/main" id="{67A03EB0-4E72-91C7-013F-2D200A3EF67C}"/>
               </a:ext>
             </a:extLst>
           </p:cNvPr>
@@ -15213,7 +15213,7 @@
           <p:cNvPr id="21" name="CuadroTexto 20">
             <a:extLst>
               <a:ext uri="{FF2B5EF4-FFF2-40B4-BE49-F238E27FC236}">
-                <a16:creationId xmlns:a16="http://schemas.microsoft.com/office/drawing/2014/main" id="{E8B4156F-9642-CA04-F9F4-5F81E86A082C}"/>
+                <a16:creationId xmlns:a16="http://schemas.microsoft.com/office/drawing/2014/main" id="{E19D156C-C501-6A45-5FE2-67D7E475E66D}"/>
               </a:ext>
             </a:extLst>
           </p:cNvPr>
@@ -15253,7 +15253,7 @@
           <p:cNvPr id="22" name="CuadroTexto 21">
             <a:extLst>
               <a:ext uri="{FF2B5EF4-FFF2-40B4-BE49-F238E27FC236}">
-                <a16:creationId xmlns:a16="http://schemas.microsoft.com/office/drawing/2014/main" id="{E8065AA8-24E4-E5EC-CFD5-503C5D036A1B}"/>
+                <a16:creationId xmlns:a16="http://schemas.microsoft.com/office/drawing/2014/main" id="{5F227918-8B05-55E3-69BD-E1B9DB514DF2}"/>
               </a:ext>
             </a:extLst>
           </p:cNvPr>
@@ -15291,7 +15291,7 @@
     </p:spTree>
     <p:extLst>
       <p:ext uri="{BB962C8B-B14F-4D97-AF65-F5344CB8AC3E}">
-        <p14:creationId xmlns:p14="http://schemas.microsoft.com/office/powerpoint/2010/main" val="3334752826"/>
+        <p14:creationId xmlns:p14="http://schemas.microsoft.com/office/powerpoint/2010/main" val="3299125161"/>
       </p:ext>
     </p:extLst>
   </p:cSld>

</xml_diff>

<commit_message>
Update defense roles explanation
</commit_message>
<xml_diff>
--- a/docs/presentacion-defensa-final.pptx
+++ b/docs/presentacion-defensa-final.pptx
@@ -208,9 +208,9 @@
             </a:lvl1pPr>
           </a:lstStyle>
           <a:p>
-            <a:fld id="{8FBF001C-8709-4ADC-8371-900A171C88AA}" type="datetimeFigureOut">
+            <a:fld id="{8FEBC1BF-194D-476A-A3A6-18B95E1C1F4E}" type="datetimeFigureOut">
               <a:rPr lang="es-ES" smtClean="0"/>
-              <a:t>04/06/2026</a:t>
+              <a:t>05/06/2026</a:t>
             </a:fld>
             <a:endParaRPr lang="es-ES"/>
           </a:p>
@@ -366,7 +366,7 @@
             </a:lvl1pPr>
           </a:lstStyle>
           <a:p>
-            <a:fld id="{B93001FF-24BA-4316-B9A8-D8767091175D}" type="slidenum">
+            <a:fld id="{C5D5DE0E-C4D9-44FD-808E-5E4EC38331C1}" type="slidenum">
               <a:rPr lang="es-ES" smtClean="0"/>
               <a:t>‹Nº›</a:t>
             </a:fld>
@@ -377,7 +377,7 @@
     </p:spTree>
     <p:extLst>
       <p:ext uri="{BB962C8B-B14F-4D97-AF65-F5344CB8AC3E}">
-        <p14:creationId xmlns:p14="http://schemas.microsoft.com/office/powerpoint/2010/main" val="3743991715"/>
+        <p14:creationId xmlns:p14="http://schemas.microsoft.com/office/powerpoint/2010/main" val="2403781025"/>
       </p:ext>
     </p:extLst>
   </p:cSld>
@@ -546,7 +546,7 @@
           <a:bodyPr/>
           <a:lstStyle/>
           <a:p>
-            <a:fld id="{B93001FF-24BA-4316-B9A8-D8767091175D}" type="slidenum">
+            <a:fld id="{C5D5DE0E-C4D9-44FD-808E-5E4EC38331C1}" type="slidenum">
               <a:rPr lang="es-ES" smtClean="0"/>
               <a:t>1</a:t>
             </a:fld>
@@ -557,7 +557,7 @@
     </p:spTree>
     <p:extLst>
       <p:ext uri="{BB962C8B-B14F-4D97-AF65-F5344CB8AC3E}">
-        <p14:creationId xmlns:p14="http://schemas.microsoft.com/office/powerpoint/2010/main" val="215697045"/>
+        <p14:creationId xmlns:p14="http://schemas.microsoft.com/office/powerpoint/2010/main" val="287008204"/>
       </p:ext>
     </p:extLst>
   </p:cSld>
@@ -636,7 +636,7 @@
           <a:bodyPr/>
           <a:lstStyle/>
           <a:p>
-            <a:fld id="{B93001FF-24BA-4316-B9A8-D8767091175D}" type="slidenum">
+            <a:fld id="{C5D5DE0E-C4D9-44FD-808E-5E4EC38331C1}" type="slidenum">
               <a:rPr lang="es-ES" smtClean="0"/>
               <a:t>10</a:t>
             </a:fld>
@@ -647,7 +647,7 @@
     </p:spTree>
     <p:extLst>
       <p:ext uri="{BB962C8B-B14F-4D97-AF65-F5344CB8AC3E}">
-        <p14:creationId xmlns:p14="http://schemas.microsoft.com/office/powerpoint/2010/main" val="3986796827"/>
+        <p14:creationId xmlns:p14="http://schemas.microsoft.com/office/powerpoint/2010/main" val="2409528777"/>
       </p:ext>
     </p:extLst>
   </p:cSld>
@@ -726,7 +726,7 @@
           <a:bodyPr/>
           <a:lstStyle/>
           <a:p>
-            <a:fld id="{B93001FF-24BA-4316-B9A8-D8767091175D}" type="slidenum">
+            <a:fld id="{C5D5DE0E-C4D9-44FD-808E-5E4EC38331C1}" type="slidenum">
               <a:rPr lang="es-ES" smtClean="0"/>
               <a:t>11</a:t>
             </a:fld>
@@ -737,7 +737,7 @@
     </p:spTree>
     <p:extLst>
       <p:ext uri="{BB962C8B-B14F-4D97-AF65-F5344CB8AC3E}">
-        <p14:creationId xmlns:p14="http://schemas.microsoft.com/office/powerpoint/2010/main" val="2276064624"/>
+        <p14:creationId xmlns:p14="http://schemas.microsoft.com/office/powerpoint/2010/main" val="3520985631"/>
       </p:ext>
     </p:extLst>
   </p:cSld>
@@ -816,7 +816,7 @@
           <a:bodyPr/>
           <a:lstStyle/>
           <a:p>
-            <a:fld id="{B93001FF-24BA-4316-B9A8-D8767091175D}" type="slidenum">
+            <a:fld id="{C5D5DE0E-C4D9-44FD-808E-5E4EC38331C1}" type="slidenum">
               <a:rPr lang="es-ES" smtClean="0"/>
               <a:t>12</a:t>
             </a:fld>
@@ -827,7 +827,7 @@
     </p:spTree>
     <p:extLst>
       <p:ext uri="{BB962C8B-B14F-4D97-AF65-F5344CB8AC3E}">
-        <p14:creationId xmlns:p14="http://schemas.microsoft.com/office/powerpoint/2010/main" val="1059339686"/>
+        <p14:creationId xmlns:p14="http://schemas.microsoft.com/office/powerpoint/2010/main" val="1830068383"/>
       </p:ext>
     </p:extLst>
   </p:cSld>
@@ -906,7 +906,7 @@
           <a:bodyPr/>
           <a:lstStyle/>
           <a:p>
-            <a:fld id="{B93001FF-24BA-4316-B9A8-D8767091175D}" type="slidenum">
+            <a:fld id="{C5D5DE0E-C4D9-44FD-808E-5E4EC38331C1}" type="slidenum">
               <a:rPr lang="es-ES" smtClean="0"/>
               <a:t>13</a:t>
             </a:fld>
@@ -917,7 +917,7 @@
     </p:spTree>
     <p:extLst>
       <p:ext uri="{BB962C8B-B14F-4D97-AF65-F5344CB8AC3E}">
-        <p14:creationId xmlns:p14="http://schemas.microsoft.com/office/powerpoint/2010/main" val="640734711"/>
+        <p14:creationId xmlns:p14="http://schemas.microsoft.com/office/powerpoint/2010/main" val="1869301127"/>
       </p:ext>
     </p:extLst>
   </p:cSld>
@@ -980,10 +980,11 @@
 startup.sh comprueba .env.gcp, recalcula la URL nip.io si cambia la IP publica y ejecuta docker compose up -d --remove-orphans.
 El compose levanta proxy, app y base de datos.
 Segundo, roles:
-Ahora mismo para la defensa uso un usuario amplio para no fragmentar la demo.
-Pero el backend ya tiene roles definidos en backend/config/packages/security.yaml.
-ROLE_ADMIN hereda todo, ROLE_COORDINATOR gestiona el flujo academico, ROLE_DOCUMENT_MANAGER gestiona documentos, ROLE_MONITOR sirve para la parte tecnica y ROLE_COMPANY_PORTAL queda separado para empresas.
-La mejora futura seria cerrar la parte fina en React: ocultar botones segun rol y crear un perfil de solo lectura.</a:t>
+El proyecto ya separa permisos reales por rol.
+ROLE_ADMIN tiene control completo y es el unico que puede eliminar datos de prueba desde el portal interno: asignaciones, convenios sin asignaciones y empresas sin convenios ni asignaciones. Esto me permite limpiar datos para pruebas sin tocar directamente la base de datos.
+ROLE_COORDINATOR, que es el perfil que usan profesor o profesora en la demo, puede crear, editar y consultar empresas, convenios, asignaciones y mensajes, pero no ve ni puede ejecutar acciones de borrado.
+ROLE_DOCUMENT_MANAGER queda pensado para gestion documental, ROLE_MONITOR para logs y consola tecnica, y ROLE_COMPANY_PORTAL para empresas externas.
+Como evolucion futura, esta base se puede ampliar a una matriz de permisos mas fina: perfiles de solo lectura, responsables por departamento, auditoria visible por rol y restricciones por centro o familia profesional.</a:t>
             </a:r>
           </a:p>
         </p:txBody>
@@ -1003,7 +1004,7 @@
           <a:bodyPr/>
           <a:lstStyle/>
           <a:p>
-            <a:fld id="{B93001FF-24BA-4316-B9A8-D8767091175D}" type="slidenum">
+            <a:fld id="{C5D5DE0E-C4D9-44FD-808E-5E4EC38331C1}" type="slidenum">
               <a:rPr lang="es-ES" smtClean="0"/>
               <a:t>14</a:t>
             </a:fld>
@@ -1014,7 +1015,7 @@
     </p:spTree>
     <p:extLst>
       <p:ext uri="{BB962C8B-B14F-4D97-AF65-F5344CB8AC3E}">
-        <p14:creationId xmlns:p14="http://schemas.microsoft.com/office/powerpoint/2010/main" val="2637870448"/>
+        <p14:creationId xmlns:p14="http://schemas.microsoft.com/office/powerpoint/2010/main" val="119859573"/>
       </p:ext>
     </p:extLst>
   </p:cSld>
@@ -1093,7 +1094,7 @@
           <a:bodyPr/>
           <a:lstStyle/>
           <a:p>
-            <a:fld id="{B93001FF-24BA-4316-B9A8-D8767091175D}" type="slidenum">
+            <a:fld id="{C5D5DE0E-C4D9-44FD-808E-5E4EC38331C1}" type="slidenum">
               <a:rPr lang="es-ES" smtClean="0"/>
               <a:t>15</a:t>
             </a:fld>
@@ -1104,7 +1105,7 @@
     </p:spTree>
     <p:extLst>
       <p:ext uri="{BB962C8B-B14F-4D97-AF65-F5344CB8AC3E}">
-        <p14:creationId xmlns:p14="http://schemas.microsoft.com/office/powerpoint/2010/main" val="3021342473"/>
+        <p14:creationId xmlns:p14="http://schemas.microsoft.com/office/powerpoint/2010/main" val="3031410732"/>
       </p:ext>
     </p:extLst>
   </p:cSld>
@@ -1183,7 +1184,7 @@
           <a:bodyPr/>
           <a:lstStyle/>
           <a:p>
-            <a:fld id="{B93001FF-24BA-4316-B9A8-D8767091175D}" type="slidenum">
+            <a:fld id="{C5D5DE0E-C4D9-44FD-808E-5E4EC38331C1}" type="slidenum">
               <a:rPr lang="es-ES" smtClean="0"/>
               <a:t>16</a:t>
             </a:fld>
@@ -1194,7 +1195,7 @@
     </p:spTree>
     <p:extLst>
       <p:ext uri="{BB962C8B-B14F-4D97-AF65-F5344CB8AC3E}">
-        <p14:creationId xmlns:p14="http://schemas.microsoft.com/office/powerpoint/2010/main" val="1484217553"/>
+        <p14:creationId xmlns:p14="http://schemas.microsoft.com/office/powerpoint/2010/main" val="2493762024"/>
       </p:ext>
     </p:extLst>
   </p:cSld>
@@ -1273,7 +1274,7 @@
           <a:bodyPr/>
           <a:lstStyle/>
           <a:p>
-            <a:fld id="{B93001FF-24BA-4316-B9A8-D8767091175D}" type="slidenum">
+            <a:fld id="{C5D5DE0E-C4D9-44FD-808E-5E4EC38331C1}" type="slidenum">
               <a:rPr lang="es-ES" smtClean="0"/>
               <a:t>17</a:t>
             </a:fld>
@@ -1284,7 +1285,7 @@
     </p:spTree>
     <p:extLst>
       <p:ext uri="{BB962C8B-B14F-4D97-AF65-F5344CB8AC3E}">
-        <p14:creationId xmlns:p14="http://schemas.microsoft.com/office/powerpoint/2010/main" val="3605682471"/>
+        <p14:creationId xmlns:p14="http://schemas.microsoft.com/office/powerpoint/2010/main" val="698586754"/>
       </p:ext>
     </p:extLst>
   </p:cSld>
@@ -1363,7 +1364,7 @@
           <a:bodyPr/>
           <a:lstStyle/>
           <a:p>
-            <a:fld id="{B93001FF-24BA-4316-B9A8-D8767091175D}" type="slidenum">
+            <a:fld id="{C5D5DE0E-C4D9-44FD-808E-5E4EC38331C1}" type="slidenum">
               <a:rPr lang="es-ES" smtClean="0"/>
               <a:t>18</a:t>
             </a:fld>
@@ -1374,7 +1375,7 @@
     </p:spTree>
     <p:extLst>
       <p:ext uri="{BB962C8B-B14F-4D97-AF65-F5344CB8AC3E}">
-        <p14:creationId xmlns:p14="http://schemas.microsoft.com/office/powerpoint/2010/main" val="1303702541"/>
+        <p14:creationId xmlns:p14="http://schemas.microsoft.com/office/powerpoint/2010/main" val="3876272976"/>
       </p:ext>
     </p:extLst>
   </p:cSld>
@@ -1452,7 +1453,7 @@
           <a:bodyPr/>
           <a:lstStyle/>
           <a:p>
-            <a:fld id="{B93001FF-24BA-4316-B9A8-D8767091175D}" type="slidenum">
+            <a:fld id="{C5D5DE0E-C4D9-44FD-808E-5E4EC38331C1}" type="slidenum">
               <a:rPr lang="es-ES" smtClean="0"/>
               <a:t>19</a:t>
             </a:fld>
@@ -1463,7 +1464,7 @@
     </p:spTree>
     <p:extLst>
       <p:ext uri="{BB962C8B-B14F-4D97-AF65-F5344CB8AC3E}">
-        <p14:creationId xmlns:p14="http://schemas.microsoft.com/office/powerpoint/2010/main" val="2211849095"/>
+        <p14:creationId xmlns:p14="http://schemas.microsoft.com/office/powerpoint/2010/main" val="3865594059"/>
       </p:ext>
     </p:extLst>
   </p:cSld>
@@ -1542,7 +1543,7 @@
           <a:bodyPr/>
           <a:lstStyle/>
           <a:p>
-            <a:fld id="{B93001FF-24BA-4316-B9A8-D8767091175D}" type="slidenum">
+            <a:fld id="{C5D5DE0E-C4D9-44FD-808E-5E4EC38331C1}" type="slidenum">
               <a:rPr lang="es-ES" smtClean="0"/>
               <a:t>2</a:t>
             </a:fld>
@@ -1553,7 +1554,7 @@
     </p:spTree>
     <p:extLst>
       <p:ext uri="{BB962C8B-B14F-4D97-AF65-F5344CB8AC3E}">
-        <p14:creationId xmlns:p14="http://schemas.microsoft.com/office/powerpoint/2010/main" val="3549670956"/>
+        <p14:creationId xmlns:p14="http://schemas.microsoft.com/office/powerpoint/2010/main" val="3926339252"/>
       </p:ext>
     </p:extLst>
   </p:cSld>
@@ -1633,7 +1634,7 @@
           <a:bodyPr/>
           <a:lstStyle/>
           <a:p>
-            <a:fld id="{B93001FF-24BA-4316-B9A8-D8767091175D}" type="slidenum">
+            <a:fld id="{C5D5DE0E-C4D9-44FD-808E-5E4EC38331C1}" type="slidenum">
               <a:rPr lang="es-ES" smtClean="0"/>
               <a:t>3</a:t>
             </a:fld>
@@ -1644,7 +1645,7 @@
     </p:spTree>
     <p:extLst>
       <p:ext uri="{BB962C8B-B14F-4D97-AF65-F5344CB8AC3E}">
-        <p14:creationId xmlns:p14="http://schemas.microsoft.com/office/powerpoint/2010/main" val="4073137116"/>
+        <p14:creationId xmlns:p14="http://schemas.microsoft.com/office/powerpoint/2010/main" val="3430522565"/>
       </p:ext>
     </p:extLst>
   </p:cSld>
@@ -1724,7 +1725,7 @@
           <a:bodyPr/>
           <a:lstStyle/>
           <a:p>
-            <a:fld id="{B93001FF-24BA-4316-B9A8-D8767091175D}" type="slidenum">
+            <a:fld id="{C5D5DE0E-C4D9-44FD-808E-5E4EC38331C1}" type="slidenum">
               <a:rPr lang="es-ES" smtClean="0"/>
               <a:t>4</a:t>
             </a:fld>
@@ -1735,7 +1736,7 @@
     </p:spTree>
     <p:extLst>
       <p:ext uri="{BB962C8B-B14F-4D97-AF65-F5344CB8AC3E}">
-        <p14:creationId xmlns:p14="http://schemas.microsoft.com/office/powerpoint/2010/main" val="4051446067"/>
+        <p14:creationId xmlns:p14="http://schemas.microsoft.com/office/powerpoint/2010/main" val="4186151953"/>
       </p:ext>
     </p:extLst>
   </p:cSld>
@@ -1818,7 +1819,7 @@
           <a:bodyPr/>
           <a:lstStyle/>
           <a:p>
-            <a:fld id="{B93001FF-24BA-4316-B9A8-D8767091175D}" type="slidenum">
+            <a:fld id="{C5D5DE0E-C4D9-44FD-808E-5E4EC38331C1}" type="slidenum">
               <a:rPr lang="es-ES" smtClean="0"/>
               <a:t>5</a:t>
             </a:fld>
@@ -1829,7 +1830,7 @@
     </p:spTree>
     <p:extLst>
       <p:ext uri="{BB962C8B-B14F-4D97-AF65-F5344CB8AC3E}">
-        <p14:creationId xmlns:p14="http://schemas.microsoft.com/office/powerpoint/2010/main" val="1828890381"/>
+        <p14:creationId xmlns:p14="http://schemas.microsoft.com/office/powerpoint/2010/main" val="3708493512"/>
       </p:ext>
     </p:extLst>
   </p:cSld>
@@ -1908,7 +1909,7 @@
           <a:bodyPr/>
           <a:lstStyle/>
           <a:p>
-            <a:fld id="{B93001FF-24BA-4316-B9A8-D8767091175D}" type="slidenum">
+            <a:fld id="{C5D5DE0E-C4D9-44FD-808E-5E4EC38331C1}" type="slidenum">
               <a:rPr lang="es-ES" smtClean="0"/>
               <a:t>6</a:t>
             </a:fld>
@@ -1919,7 +1920,7 @@
     </p:spTree>
     <p:extLst>
       <p:ext uri="{BB962C8B-B14F-4D97-AF65-F5344CB8AC3E}">
-        <p14:creationId xmlns:p14="http://schemas.microsoft.com/office/powerpoint/2010/main" val="863347273"/>
+        <p14:creationId xmlns:p14="http://schemas.microsoft.com/office/powerpoint/2010/main" val="2835790957"/>
       </p:ext>
     </p:extLst>
   </p:cSld>
@@ -1999,7 +2000,7 @@
           <a:bodyPr/>
           <a:lstStyle/>
           <a:p>
-            <a:fld id="{B93001FF-24BA-4316-B9A8-D8767091175D}" type="slidenum">
+            <a:fld id="{C5D5DE0E-C4D9-44FD-808E-5E4EC38331C1}" type="slidenum">
               <a:rPr lang="es-ES" smtClean="0"/>
               <a:t>7</a:t>
             </a:fld>
@@ -2010,7 +2011,7 @@
     </p:spTree>
     <p:extLst>
       <p:ext uri="{BB962C8B-B14F-4D97-AF65-F5344CB8AC3E}">
-        <p14:creationId xmlns:p14="http://schemas.microsoft.com/office/powerpoint/2010/main" val="3145180591"/>
+        <p14:creationId xmlns:p14="http://schemas.microsoft.com/office/powerpoint/2010/main" val="1618068750"/>
       </p:ext>
     </p:extLst>
   </p:cSld>
@@ -2089,7 +2090,7 @@
           <a:bodyPr/>
           <a:lstStyle/>
           <a:p>
-            <a:fld id="{B93001FF-24BA-4316-B9A8-D8767091175D}" type="slidenum">
+            <a:fld id="{C5D5DE0E-C4D9-44FD-808E-5E4EC38331C1}" type="slidenum">
               <a:rPr lang="es-ES" smtClean="0"/>
               <a:t>8</a:t>
             </a:fld>
@@ -2100,7 +2101,7 @@
     </p:spTree>
     <p:extLst>
       <p:ext uri="{BB962C8B-B14F-4D97-AF65-F5344CB8AC3E}">
-        <p14:creationId xmlns:p14="http://schemas.microsoft.com/office/powerpoint/2010/main" val="2676240005"/>
+        <p14:creationId xmlns:p14="http://schemas.microsoft.com/office/powerpoint/2010/main" val="2182006226"/>
       </p:ext>
     </p:extLst>
   </p:cSld>
@@ -2180,7 +2181,7 @@
           <a:bodyPr/>
           <a:lstStyle/>
           <a:p>
-            <a:fld id="{B93001FF-24BA-4316-B9A8-D8767091175D}" type="slidenum">
+            <a:fld id="{C5D5DE0E-C4D9-44FD-808E-5E4EC38331C1}" type="slidenum">
               <a:rPr lang="es-ES" smtClean="0"/>
               <a:t>9</a:t>
             </a:fld>
@@ -2191,7 +2192,7 @@
     </p:spTree>
     <p:extLst>
       <p:ext uri="{BB962C8B-B14F-4D97-AF65-F5344CB8AC3E}">
-        <p14:creationId xmlns:p14="http://schemas.microsoft.com/office/powerpoint/2010/main" val="1482581176"/>
+        <p14:creationId xmlns:p14="http://schemas.microsoft.com/office/powerpoint/2010/main" val="1157045571"/>
       </p:ext>
     </p:extLst>
   </p:cSld>
@@ -2223,7 +2224,7 @@
           <p:cNvPr id="2" name="Título 1">
             <a:extLst>
               <a:ext uri="{FF2B5EF4-FFF2-40B4-BE49-F238E27FC236}">
-                <a16:creationId xmlns:a16="http://schemas.microsoft.com/office/drawing/2014/main" id="{9FBF71DD-8A1A-3A5C-427E-F42D1B5597E3}"/>
+                <a16:creationId xmlns:a16="http://schemas.microsoft.com/office/drawing/2014/main" id="{A64AA065-1710-1C52-921A-E5B3164FB178}"/>
               </a:ext>
             </a:extLst>
           </p:cNvPr>
@@ -2260,7 +2261,7 @@
           <p:cNvPr id="3" name="Subtítulo 2">
             <a:extLst>
               <a:ext uri="{FF2B5EF4-FFF2-40B4-BE49-F238E27FC236}">
-                <a16:creationId xmlns:a16="http://schemas.microsoft.com/office/drawing/2014/main" id="{BFADDF58-6B19-3973-E9CA-309017CC0E93}"/>
+                <a16:creationId xmlns:a16="http://schemas.microsoft.com/office/drawing/2014/main" id="{1FD4C27C-5F02-DC21-55D7-F57165153FD5}"/>
               </a:ext>
             </a:extLst>
           </p:cNvPr>
@@ -2330,7 +2331,7 @@
           <p:cNvPr id="4" name="Marcador de fecha 3">
             <a:extLst>
               <a:ext uri="{FF2B5EF4-FFF2-40B4-BE49-F238E27FC236}">
-                <a16:creationId xmlns:a16="http://schemas.microsoft.com/office/drawing/2014/main" id="{34C85AC0-8B5B-D328-C631-062B2A19CD38}"/>
+                <a16:creationId xmlns:a16="http://schemas.microsoft.com/office/drawing/2014/main" id="{AA1A6579-3E56-0211-44D4-617C5CE25B60}"/>
               </a:ext>
             </a:extLst>
           </p:cNvPr>
@@ -2346,9 +2347,9 @@
           <a:bodyPr/>
           <a:lstStyle/>
           <a:p>
-            <a:fld id="{E2E78F0F-3CEE-4885-8154-F908A2044D66}" type="datetimeFigureOut">
+            <a:fld id="{3D6C1A94-3A56-4E71-9AEB-C8DB029FBD9F}" type="datetimeFigureOut">
               <a:rPr lang="es-ES" smtClean="0"/>
-              <a:t>04/06/2026</a:t>
+              <a:t>05/06/2026</a:t>
             </a:fld>
             <a:endParaRPr lang="es-ES"/>
           </a:p>
@@ -2359,7 +2360,7 @@
           <p:cNvPr id="5" name="Marcador de pie de página 4">
             <a:extLst>
               <a:ext uri="{FF2B5EF4-FFF2-40B4-BE49-F238E27FC236}">
-                <a16:creationId xmlns:a16="http://schemas.microsoft.com/office/drawing/2014/main" id="{B2AAB737-A507-EDBB-C397-1439D07293A9}"/>
+                <a16:creationId xmlns:a16="http://schemas.microsoft.com/office/drawing/2014/main" id="{4867F8BA-D29F-80EC-AE76-3C17E84DC7D9}"/>
               </a:ext>
             </a:extLst>
           </p:cNvPr>
@@ -2384,7 +2385,7 @@
           <p:cNvPr id="6" name="Marcador de número de diapositiva 5">
             <a:extLst>
               <a:ext uri="{FF2B5EF4-FFF2-40B4-BE49-F238E27FC236}">
-                <a16:creationId xmlns:a16="http://schemas.microsoft.com/office/drawing/2014/main" id="{2FA276E1-F939-4447-B2B8-98A12AE7E336}"/>
+                <a16:creationId xmlns:a16="http://schemas.microsoft.com/office/drawing/2014/main" id="{1E9BAF6F-9FFC-44F1-D387-67A915A2EE75}"/>
               </a:ext>
             </a:extLst>
           </p:cNvPr>
@@ -2400,7 +2401,7 @@
           <a:bodyPr/>
           <a:lstStyle/>
           <a:p>
-            <a:fld id="{46952519-79A0-4158-88E8-8A74092916AE}" type="slidenum">
+            <a:fld id="{2611C5D2-C4B0-4D8A-9AB8-ED270EC4FA17}" type="slidenum">
               <a:rPr lang="es-ES" smtClean="0"/>
               <a:t>‹Nº›</a:t>
             </a:fld>
@@ -2411,7 +2412,7 @@
     </p:spTree>
     <p:extLst>
       <p:ext uri="{BB962C8B-B14F-4D97-AF65-F5344CB8AC3E}">
-        <p14:creationId xmlns:p14="http://schemas.microsoft.com/office/powerpoint/2010/main" val="3700646399"/>
+        <p14:creationId xmlns:p14="http://schemas.microsoft.com/office/powerpoint/2010/main" val="2535946326"/>
       </p:ext>
     </p:extLst>
   </p:cSld>
@@ -2443,7 +2444,7 @@
           <p:cNvPr id="2" name="Título 1">
             <a:extLst>
               <a:ext uri="{FF2B5EF4-FFF2-40B4-BE49-F238E27FC236}">
-                <a16:creationId xmlns:a16="http://schemas.microsoft.com/office/drawing/2014/main" id="{9B87722E-DE3D-93DD-305E-988CCB27F62B}"/>
+                <a16:creationId xmlns:a16="http://schemas.microsoft.com/office/drawing/2014/main" id="{869DF8F9-13D9-6798-B1A2-695CA4DF57BB}"/>
               </a:ext>
             </a:extLst>
           </p:cNvPr>
@@ -2471,7 +2472,7 @@
           <p:cNvPr id="3" name="Marcador de texto vertical 2">
             <a:extLst>
               <a:ext uri="{FF2B5EF4-FFF2-40B4-BE49-F238E27FC236}">
-                <a16:creationId xmlns:a16="http://schemas.microsoft.com/office/drawing/2014/main" id="{52E4C930-243D-C30B-4FD9-28EE9B87F482}"/>
+                <a16:creationId xmlns:a16="http://schemas.microsoft.com/office/drawing/2014/main" id="{69F5849F-C6EC-F33B-0D9A-D55EB380E321}"/>
               </a:ext>
             </a:extLst>
           </p:cNvPr>
@@ -2528,7 +2529,7 @@
           <p:cNvPr id="4" name="Marcador de fecha 3">
             <a:extLst>
               <a:ext uri="{FF2B5EF4-FFF2-40B4-BE49-F238E27FC236}">
-                <a16:creationId xmlns:a16="http://schemas.microsoft.com/office/drawing/2014/main" id="{0D8DB55F-BE8D-72C9-A021-31475D03CCF4}"/>
+                <a16:creationId xmlns:a16="http://schemas.microsoft.com/office/drawing/2014/main" id="{9A2E284C-7022-8D04-25A2-E7D8DF2E34F5}"/>
               </a:ext>
             </a:extLst>
           </p:cNvPr>
@@ -2544,9 +2545,9 @@
           <a:bodyPr/>
           <a:lstStyle/>
           <a:p>
-            <a:fld id="{E2E78F0F-3CEE-4885-8154-F908A2044D66}" type="datetimeFigureOut">
+            <a:fld id="{3D6C1A94-3A56-4E71-9AEB-C8DB029FBD9F}" type="datetimeFigureOut">
               <a:rPr lang="es-ES" smtClean="0"/>
-              <a:t>04/06/2026</a:t>
+              <a:t>05/06/2026</a:t>
             </a:fld>
             <a:endParaRPr lang="es-ES"/>
           </a:p>
@@ -2557,7 +2558,7 @@
           <p:cNvPr id="5" name="Marcador de pie de página 4">
             <a:extLst>
               <a:ext uri="{FF2B5EF4-FFF2-40B4-BE49-F238E27FC236}">
-                <a16:creationId xmlns:a16="http://schemas.microsoft.com/office/drawing/2014/main" id="{B88FAE5B-20B2-508A-C009-FE1D0EEDAC9A}"/>
+                <a16:creationId xmlns:a16="http://schemas.microsoft.com/office/drawing/2014/main" id="{8BB895F1-FFA1-974B-B93A-AD115AB2E6EF}"/>
               </a:ext>
             </a:extLst>
           </p:cNvPr>
@@ -2582,7 +2583,7 @@
           <p:cNvPr id="6" name="Marcador de número de diapositiva 5">
             <a:extLst>
               <a:ext uri="{FF2B5EF4-FFF2-40B4-BE49-F238E27FC236}">
-                <a16:creationId xmlns:a16="http://schemas.microsoft.com/office/drawing/2014/main" id="{0B0D45D1-ADB4-98BC-E695-0749FF3367C3}"/>
+                <a16:creationId xmlns:a16="http://schemas.microsoft.com/office/drawing/2014/main" id="{5F4557D3-2EE5-854F-716A-77DD5DF5C12E}"/>
               </a:ext>
             </a:extLst>
           </p:cNvPr>
@@ -2598,7 +2599,7 @@
           <a:bodyPr/>
           <a:lstStyle/>
           <a:p>
-            <a:fld id="{46952519-79A0-4158-88E8-8A74092916AE}" type="slidenum">
+            <a:fld id="{2611C5D2-C4B0-4D8A-9AB8-ED270EC4FA17}" type="slidenum">
               <a:rPr lang="es-ES" smtClean="0"/>
               <a:t>‹Nº›</a:t>
             </a:fld>
@@ -2609,7 +2610,7 @@
     </p:spTree>
     <p:extLst>
       <p:ext uri="{BB962C8B-B14F-4D97-AF65-F5344CB8AC3E}">
-        <p14:creationId xmlns:p14="http://schemas.microsoft.com/office/powerpoint/2010/main" val="4211537904"/>
+        <p14:creationId xmlns:p14="http://schemas.microsoft.com/office/powerpoint/2010/main" val="1950355174"/>
       </p:ext>
     </p:extLst>
   </p:cSld>
@@ -2641,7 +2642,7 @@
           <p:cNvPr id="2" name="Título vertical 1">
             <a:extLst>
               <a:ext uri="{FF2B5EF4-FFF2-40B4-BE49-F238E27FC236}">
-                <a16:creationId xmlns:a16="http://schemas.microsoft.com/office/drawing/2014/main" id="{AECC615D-0F68-C301-800C-618D72BA3B8C}"/>
+                <a16:creationId xmlns:a16="http://schemas.microsoft.com/office/drawing/2014/main" id="{6D96A6B3-5A8F-A9D0-5A57-64E87282EFDC}"/>
               </a:ext>
             </a:extLst>
           </p:cNvPr>
@@ -2674,7 +2675,7 @@
           <p:cNvPr id="3" name="Marcador de texto vertical 2">
             <a:extLst>
               <a:ext uri="{FF2B5EF4-FFF2-40B4-BE49-F238E27FC236}">
-                <a16:creationId xmlns:a16="http://schemas.microsoft.com/office/drawing/2014/main" id="{B169D8D1-1646-AF6B-BA39-BCC2DE2C3556}"/>
+                <a16:creationId xmlns:a16="http://schemas.microsoft.com/office/drawing/2014/main" id="{4C8D587C-EADB-2F49-EC56-756B50D1B0D3}"/>
               </a:ext>
             </a:extLst>
           </p:cNvPr>
@@ -2736,7 +2737,7 @@
           <p:cNvPr id="4" name="Marcador de fecha 3">
             <a:extLst>
               <a:ext uri="{FF2B5EF4-FFF2-40B4-BE49-F238E27FC236}">
-                <a16:creationId xmlns:a16="http://schemas.microsoft.com/office/drawing/2014/main" id="{1875E4F4-5197-2569-4397-EBED4D9A3416}"/>
+                <a16:creationId xmlns:a16="http://schemas.microsoft.com/office/drawing/2014/main" id="{9FAC7317-1C4D-6A2C-3E0E-17127B8573E5}"/>
               </a:ext>
             </a:extLst>
           </p:cNvPr>
@@ -2752,9 +2753,9 @@
           <a:bodyPr/>
           <a:lstStyle/>
           <a:p>
-            <a:fld id="{E2E78F0F-3CEE-4885-8154-F908A2044D66}" type="datetimeFigureOut">
+            <a:fld id="{3D6C1A94-3A56-4E71-9AEB-C8DB029FBD9F}" type="datetimeFigureOut">
               <a:rPr lang="es-ES" smtClean="0"/>
-              <a:t>04/06/2026</a:t>
+              <a:t>05/06/2026</a:t>
             </a:fld>
             <a:endParaRPr lang="es-ES"/>
           </a:p>
@@ -2765,7 +2766,7 @@
           <p:cNvPr id="5" name="Marcador de pie de página 4">
             <a:extLst>
               <a:ext uri="{FF2B5EF4-FFF2-40B4-BE49-F238E27FC236}">
-                <a16:creationId xmlns:a16="http://schemas.microsoft.com/office/drawing/2014/main" id="{7943F178-470D-7AF8-678A-CD4E34483A47}"/>
+                <a16:creationId xmlns:a16="http://schemas.microsoft.com/office/drawing/2014/main" id="{E2B4610A-E381-C33A-2943-75E163D93A73}"/>
               </a:ext>
             </a:extLst>
           </p:cNvPr>
@@ -2790,7 +2791,7 @@
           <p:cNvPr id="6" name="Marcador de número de diapositiva 5">
             <a:extLst>
               <a:ext uri="{FF2B5EF4-FFF2-40B4-BE49-F238E27FC236}">
-                <a16:creationId xmlns:a16="http://schemas.microsoft.com/office/drawing/2014/main" id="{ED162692-C23F-D191-7BB0-0C6B4F3E4D6B}"/>
+                <a16:creationId xmlns:a16="http://schemas.microsoft.com/office/drawing/2014/main" id="{86A44F36-78F8-13C8-301B-DD8AE46B5C4A}"/>
               </a:ext>
             </a:extLst>
           </p:cNvPr>
@@ -2806,7 +2807,7 @@
           <a:bodyPr/>
           <a:lstStyle/>
           <a:p>
-            <a:fld id="{46952519-79A0-4158-88E8-8A74092916AE}" type="slidenum">
+            <a:fld id="{2611C5D2-C4B0-4D8A-9AB8-ED270EC4FA17}" type="slidenum">
               <a:rPr lang="es-ES" smtClean="0"/>
               <a:t>‹Nº›</a:t>
             </a:fld>
@@ -2817,7 +2818,7 @@
     </p:spTree>
     <p:extLst>
       <p:ext uri="{BB962C8B-B14F-4D97-AF65-F5344CB8AC3E}">
-        <p14:creationId xmlns:p14="http://schemas.microsoft.com/office/powerpoint/2010/main" val="1983635389"/>
+        <p14:creationId xmlns:p14="http://schemas.microsoft.com/office/powerpoint/2010/main" val="1625825761"/>
       </p:ext>
     </p:extLst>
   </p:cSld>
@@ -2849,7 +2850,7 @@
           <p:cNvPr id="2" name="Título 1">
             <a:extLst>
               <a:ext uri="{FF2B5EF4-FFF2-40B4-BE49-F238E27FC236}">
-                <a16:creationId xmlns:a16="http://schemas.microsoft.com/office/drawing/2014/main" id="{3C43EFF3-2208-B0F4-F888-B4BFB0EB634F}"/>
+                <a16:creationId xmlns:a16="http://schemas.microsoft.com/office/drawing/2014/main" id="{2A510919-1DB0-211A-E319-843A6C0FEC1D}"/>
               </a:ext>
             </a:extLst>
           </p:cNvPr>
@@ -2877,7 +2878,7 @@
           <p:cNvPr id="3" name="Marcador de contenido 2">
             <a:extLst>
               <a:ext uri="{FF2B5EF4-FFF2-40B4-BE49-F238E27FC236}">
-                <a16:creationId xmlns:a16="http://schemas.microsoft.com/office/drawing/2014/main" id="{03E54055-C46C-7830-17EC-638EDDF01D81}"/>
+                <a16:creationId xmlns:a16="http://schemas.microsoft.com/office/drawing/2014/main" id="{B3A19D80-EFA8-F54A-D43D-E1BE828E46F4}"/>
               </a:ext>
             </a:extLst>
           </p:cNvPr>
@@ -2934,7 +2935,7 @@
           <p:cNvPr id="4" name="Marcador de fecha 3">
             <a:extLst>
               <a:ext uri="{FF2B5EF4-FFF2-40B4-BE49-F238E27FC236}">
-                <a16:creationId xmlns:a16="http://schemas.microsoft.com/office/drawing/2014/main" id="{AA0298D9-986A-400B-52EA-7C3160091503}"/>
+                <a16:creationId xmlns:a16="http://schemas.microsoft.com/office/drawing/2014/main" id="{5915F52A-90A3-FD84-C44D-EAA26AAFEB4C}"/>
               </a:ext>
             </a:extLst>
           </p:cNvPr>
@@ -2950,9 +2951,9 @@
           <a:bodyPr/>
           <a:lstStyle/>
           <a:p>
-            <a:fld id="{E2E78F0F-3CEE-4885-8154-F908A2044D66}" type="datetimeFigureOut">
+            <a:fld id="{3D6C1A94-3A56-4E71-9AEB-C8DB029FBD9F}" type="datetimeFigureOut">
               <a:rPr lang="es-ES" smtClean="0"/>
-              <a:t>04/06/2026</a:t>
+              <a:t>05/06/2026</a:t>
             </a:fld>
             <a:endParaRPr lang="es-ES"/>
           </a:p>
@@ -2963,7 +2964,7 @@
           <p:cNvPr id="5" name="Marcador de pie de página 4">
             <a:extLst>
               <a:ext uri="{FF2B5EF4-FFF2-40B4-BE49-F238E27FC236}">
-                <a16:creationId xmlns:a16="http://schemas.microsoft.com/office/drawing/2014/main" id="{CB7582AF-E854-BF35-6ED9-13FDE1E55E3E}"/>
+                <a16:creationId xmlns:a16="http://schemas.microsoft.com/office/drawing/2014/main" id="{BD423349-A6EF-D2CC-B5BB-26B05D6C1206}"/>
               </a:ext>
             </a:extLst>
           </p:cNvPr>
@@ -2988,7 +2989,7 @@
           <p:cNvPr id="6" name="Marcador de número de diapositiva 5">
             <a:extLst>
               <a:ext uri="{FF2B5EF4-FFF2-40B4-BE49-F238E27FC236}">
-                <a16:creationId xmlns:a16="http://schemas.microsoft.com/office/drawing/2014/main" id="{5EEE6B73-214F-4C3E-DD6B-A9B8041D0CD0}"/>
+                <a16:creationId xmlns:a16="http://schemas.microsoft.com/office/drawing/2014/main" id="{0B405928-4BA7-4E4B-5011-FF6727D738E7}"/>
               </a:ext>
             </a:extLst>
           </p:cNvPr>
@@ -3004,7 +3005,7 @@
           <a:bodyPr/>
           <a:lstStyle/>
           <a:p>
-            <a:fld id="{46952519-79A0-4158-88E8-8A74092916AE}" type="slidenum">
+            <a:fld id="{2611C5D2-C4B0-4D8A-9AB8-ED270EC4FA17}" type="slidenum">
               <a:rPr lang="es-ES" smtClean="0"/>
               <a:t>‹Nº›</a:t>
             </a:fld>
@@ -3015,7 +3016,7 @@
     </p:spTree>
     <p:extLst>
       <p:ext uri="{BB962C8B-B14F-4D97-AF65-F5344CB8AC3E}">
-        <p14:creationId xmlns:p14="http://schemas.microsoft.com/office/powerpoint/2010/main" val="2648825307"/>
+        <p14:creationId xmlns:p14="http://schemas.microsoft.com/office/powerpoint/2010/main" val="121301234"/>
       </p:ext>
     </p:extLst>
   </p:cSld>
@@ -3047,7 +3048,7 @@
           <p:cNvPr id="2" name="Título 1">
             <a:extLst>
               <a:ext uri="{FF2B5EF4-FFF2-40B4-BE49-F238E27FC236}">
-                <a16:creationId xmlns:a16="http://schemas.microsoft.com/office/drawing/2014/main" id="{82600662-4170-C665-DB06-459359CC2E0D}"/>
+                <a16:creationId xmlns:a16="http://schemas.microsoft.com/office/drawing/2014/main" id="{91946C0F-A254-91AF-793B-D425A708A7CA}"/>
               </a:ext>
             </a:extLst>
           </p:cNvPr>
@@ -3084,7 +3085,7 @@
           <p:cNvPr id="3" name="Marcador de texto 2">
             <a:extLst>
               <a:ext uri="{FF2B5EF4-FFF2-40B4-BE49-F238E27FC236}">
-                <a16:creationId xmlns:a16="http://schemas.microsoft.com/office/drawing/2014/main" id="{34166AF3-60A3-05C2-A67F-6AFFDC1D0DD5}"/>
+                <a16:creationId xmlns:a16="http://schemas.microsoft.com/office/drawing/2014/main" id="{75B55A87-1F86-7A34-3744-2ED1486A1F27}"/>
               </a:ext>
             </a:extLst>
           </p:cNvPr>
@@ -3209,7 +3210,7 @@
           <p:cNvPr id="4" name="Marcador de fecha 3">
             <a:extLst>
               <a:ext uri="{FF2B5EF4-FFF2-40B4-BE49-F238E27FC236}">
-                <a16:creationId xmlns:a16="http://schemas.microsoft.com/office/drawing/2014/main" id="{79B32DD2-B709-32DA-D2BD-C8E3BA72D344}"/>
+                <a16:creationId xmlns:a16="http://schemas.microsoft.com/office/drawing/2014/main" id="{DC7E3555-210E-1FAE-D60C-6766B9A0B549}"/>
               </a:ext>
             </a:extLst>
           </p:cNvPr>
@@ -3225,9 +3226,9 @@
           <a:bodyPr/>
           <a:lstStyle/>
           <a:p>
-            <a:fld id="{E2E78F0F-3CEE-4885-8154-F908A2044D66}" type="datetimeFigureOut">
+            <a:fld id="{3D6C1A94-3A56-4E71-9AEB-C8DB029FBD9F}" type="datetimeFigureOut">
               <a:rPr lang="es-ES" smtClean="0"/>
-              <a:t>04/06/2026</a:t>
+              <a:t>05/06/2026</a:t>
             </a:fld>
             <a:endParaRPr lang="es-ES"/>
           </a:p>
@@ -3238,7 +3239,7 @@
           <p:cNvPr id="5" name="Marcador de pie de página 4">
             <a:extLst>
               <a:ext uri="{FF2B5EF4-FFF2-40B4-BE49-F238E27FC236}">
-                <a16:creationId xmlns:a16="http://schemas.microsoft.com/office/drawing/2014/main" id="{6AAD1399-A6BC-9A87-FD24-194BE9AA3A58}"/>
+                <a16:creationId xmlns:a16="http://schemas.microsoft.com/office/drawing/2014/main" id="{8B86FBF2-DD54-111F-E34C-C441EEBF2251}"/>
               </a:ext>
             </a:extLst>
           </p:cNvPr>
@@ -3263,7 +3264,7 @@
           <p:cNvPr id="6" name="Marcador de número de diapositiva 5">
             <a:extLst>
               <a:ext uri="{FF2B5EF4-FFF2-40B4-BE49-F238E27FC236}">
-                <a16:creationId xmlns:a16="http://schemas.microsoft.com/office/drawing/2014/main" id="{09E0E06C-E650-4ACD-18CA-DA6363ECDAED}"/>
+                <a16:creationId xmlns:a16="http://schemas.microsoft.com/office/drawing/2014/main" id="{9820B481-7E5D-9A9A-A9EC-7FE4FB017E9C}"/>
               </a:ext>
             </a:extLst>
           </p:cNvPr>
@@ -3279,7 +3280,7 @@
           <a:bodyPr/>
           <a:lstStyle/>
           <a:p>
-            <a:fld id="{46952519-79A0-4158-88E8-8A74092916AE}" type="slidenum">
+            <a:fld id="{2611C5D2-C4B0-4D8A-9AB8-ED270EC4FA17}" type="slidenum">
               <a:rPr lang="es-ES" smtClean="0"/>
               <a:t>‹Nº›</a:t>
             </a:fld>
@@ -3290,7 +3291,7 @@
     </p:spTree>
     <p:extLst>
       <p:ext uri="{BB962C8B-B14F-4D97-AF65-F5344CB8AC3E}">
-        <p14:creationId xmlns:p14="http://schemas.microsoft.com/office/powerpoint/2010/main" val="3597848054"/>
+        <p14:creationId xmlns:p14="http://schemas.microsoft.com/office/powerpoint/2010/main" val="2514670681"/>
       </p:ext>
     </p:extLst>
   </p:cSld>
@@ -3322,7 +3323,7 @@
           <p:cNvPr id="2" name="Título 1">
             <a:extLst>
               <a:ext uri="{FF2B5EF4-FFF2-40B4-BE49-F238E27FC236}">
-                <a16:creationId xmlns:a16="http://schemas.microsoft.com/office/drawing/2014/main" id="{C091E38A-B22F-FE8F-9196-E213105FAE2C}"/>
+                <a16:creationId xmlns:a16="http://schemas.microsoft.com/office/drawing/2014/main" id="{B940571E-6C9B-D46E-2B86-51B3FE7D863D}"/>
               </a:ext>
             </a:extLst>
           </p:cNvPr>
@@ -3350,7 +3351,7 @@
           <p:cNvPr id="3" name="Marcador de contenido 2">
             <a:extLst>
               <a:ext uri="{FF2B5EF4-FFF2-40B4-BE49-F238E27FC236}">
-                <a16:creationId xmlns:a16="http://schemas.microsoft.com/office/drawing/2014/main" id="{C6EBF453-E43C-0A02-4091-6C7015F3B9C8}"/>
+                <a16:creationId xmlns:a16="http://schemas.microsoft.com/office/drawing/2014/main" id="{7976DA9B-F741-0AD5-4F7D-75BC7AD1C3DA}"/>
               </a:ext>
             </a:extLst>
           </p:cNvPr>
@@ -3412,7 +3413,7 @@
           <p:cNvPr id="4" name="Marcador de contenido 3">
             <a:extLst>
               <a:ext uri="{FF2B5EF4-FFF2-40B4-BE49-F238E27FC236}">
-                <a16:creationId xmlns:a16="http://schemas.microsoft.com/office/drawing/2014/main" id="{D84394B1-538A-B357-5C7D-854245D3790B}"/>
+                <a16:creationId xmlns:a16="http://schemas.microsoft.com/office/drawing/2014/main" id="{CDA2B0B2-A224-4BFD-9148-E5DED82CDDFD}"/>
               </a:ext>
             </a:extLst>
           </p:cNvPr>
@@ -3474,7 +3475,7 @@
           <p:cNvPr id="5" name="Marcador de fecha 4">
             <a:extLst>
               <a:ext uri="{FF2B5EF4-FFF2-40B4-BE49-F238E27FC236}">
-                <a16:creationId xmlns:a16="http://schemas.microsoft.com/office/drawing/2014/main" id="{053AF158-81A4-ABF2-07DD-AF32BFFEA339}"/>
+                <a16:creationId xmlns:a16="http://schemas.microsoft.com/office/drawing/2014/main" id="{6B9D05DD-3615-0246-B80C-14CA14C03F50}"/>
               </a:ext>
             </a:extLst>
           </p:cNvPr>
@@ -3490,9 +3491,9 @@
           <a:bodyPr/>
           <a:lstStyle/>
           <a:p>
-            <a:fld id="{E2E78F0F-3CEE-4885-8154-F908A2044D66}" type="datetimeFigureOut">
+            <a:fld id="{3D6C1A94-3A56-4E71-9AEB-C8DB029FBD9F}" type="datetimeFigureOut">
               <a:rPr lang="es-ES" smtClean="0"/>
-              <a:t>04/06/2026</a:t>
+              <a:t>05/06/2026</a:t>
             </a:fld>
             <a:endParaRPr lang="es-ES"/>
           </a:p>
@@ -3503,7 +3504,7 @@
           <p:cNvPr id="6" name="Marcador de pie de página 5">
             <a:extLst>
               <a:ext uri="{FF2B5EF4-FFF2-40B4-BE49-F238E27FC236}">
-                <a16:creationId xmlns:a16="http://schemas.microsoft.com/office/drawing/2014/main" id="{3EF9A877-E9AB-59C6-23B3-6C02D30B1008}"/>
+                <a16:creationId xmlns:a16="http://schemas.microsoft.com/office/drawing/2014/main" id="{A194695E-F1AC-7766-1056-CA6C9344ACB8}"/>
               </a:ext>
             </a:extLst>
           </p:cNvPr>
@@ -3528,7 +3529,7 @@
           <p:cNvPr id="7" name="Marcador de número de diapositiva 6">
             <a:extLst>
               <a:ext uri="{FF2B5EF4-FFF2-40B4-BE49-F238E27FC236}">
-                <a16:creationId xmlns:a16="http://schemas.microsoft.com/office/drawing/2014/main" id="{37142DA6-7B1D-6C8A-937D-4C6456E20ADD}"/>
+                <a16:creationId xmlns:a16="http://schemas.microsoft.com/office/drawing/2014/main" id="{4F1CD08B-F325-1B41-2366-82013EAB5BE4}"/>
               </a:ext>
             </a:extLst>
           </p:cNvPr>
@@ -3544,7 +3545,7 @@
           <a:bodyPr/>
           <a:lstStyle/>
           <a:p>
-            <a:fld id="{46952519-79A0-4158-88E8-8A74092916AE}" type="slidenum">
+            <a:fld id="{2611C5D2-C4B0-4D8A-9AB8-ED270EC4FA17}" type="slidenum">
               <a:rPr lang="es-ES" smtClean="0"/>
               <a:t>‹Nº›</a:t>
             </a:fld>
@@ -3555,7 +3556,7 @@
     </p:spTree>
     <p:extLst>
       <p:ext uri="{BB962C8B-B14F-4D97-AF65-F5344CB8AC3E}">
-        <p14:creationId xmlns:p14="http://schemas.microsoft.com/office/powerpoint/2010/main" val="4097542271"/>
+        <p14:creationId xmlns:p14="http://schemas.microsoft.com/office/powerpoint/2010/main" val="761670945"/>
       </p:ext>
     </p:extLst>
   </p:cSld>
@@ -3587,7 +3588,7 @@
           <p:cNvPr id="2" name="Título 1">
             <a:extLst>
               <a:ext uri="{FF2B5EF4-FFF2-40B4-BE49-F238E27FC236}">
-                <a16:creationId xmlns:a16="http://schemas.microsoft.com/office/drawing/2014/main" id="{40028658-5B67-54CA-9D16-337A6BF0447A}"/>
+                <a16:creationId xmlns:a16="http://schemas.microsoft.com/office/drawing/2014/main" id="{49C66A95-9CE5-2D04-4A01-D49B9737B483}"/>
               </a:ext>
             </a:extLst>
           </p:cNvPr>
@@ -3620,7 +3621,7 @@
           <p:cNvPr id="3" name="Marcador de texto 2">
             <a:extLst>
               <a:ext uri="{FF2B5EF4-FFF2-40B4-BE49-F238E27FC236}">
-                <a16:creationId xmlns:a16="http://schemas.microsoft.com/office/drawing/2014/main" id="{C465C81D-1ED4-C042-4601-4340ECB3F0FE}"/>
+                <a16:creationId xmlns:a16="http://schemas.microsoft.com/office/drawing/2014/main" id="{C0E4D53F-123D-934E-1A3C-054189665495}"/>
               </a:ext>
             </a:extLst>
           </p:cNvPr>
@@ -3691,7 +3692,7 @@
           <p:cNvPr id="4" name="Marcador de contenido 3">
             <a:extLst>
               <a:ext uri="{FF2B5EF4-FFF2-40B4-BE49-F238E27FC236}">
-                <a16:creationId xmlns:a16="http://schemas.microsoft.com/office/drawing/2014/main" id="{993A6344-F4A7-D7EF-9C4F-E25595ED966F}"/>
+                <a16:creationId xmlns:a16="http://schemas.microsoft.com/office/drawing/2014/main" id="{470FC775-A96F-EB95-5C2D-7F1A44C1A1FE}"/>
               </a:ext>
             </a:extLst>
           </p:cNvPr>
@@ -3753,7 +3754,7 @@
           <p:cNvPr id="5" name="Marcador de texto 4">
             <a:extLst>
               <a:ext uri="{FF2B5EF4-FFF2-40B4-BE49-F238E27FC236}">
-                <a16:creationId xmlns:a16="http://schemas.microsoft.com/office/drawing/2014/main" id="{81F4BA7A-034E-68E1-7CFA-280FA4E742F0}"/>
+                <a16:creationId xmlns:a16="http://schemas.microsoft.com/office/drawing/2014/main" id="{B8B3AF6F-A543-745A-D64F-39244958B67B}"/>
               </a:ext>
             </a:extLst>
           </p:cNvPr>
@@ -3824,7 +3825,7 @@
           <p:cNvPr id="6" name="Marcador de contenido 5">
             <a:extLst>
               <a:ext uri="{FF2B5EF4-FFF2-40B4-BE49-F238E27FC236}">
-                <a16:creationId xmlns:a16="http://schemas.microsoft.com/office/drawing/2014/main" id="{6C91CA2C-3974-A4FA-A2C2-491671D417D0}"/>
+                <a16:creationId xmlns:a16="http://schemas.microsoft.com/office/drawing/2014/main" id="{B87436A8-AB2C-C6E5-A7EA-5F6E92753977}"/>
               </a:ext>
             </a:extLst>
           </p:cNvPr>
@@ -3886,7 +3887,7 @@
           <p:cNvPr id="7" name="Marcador de fecha 6">
             <a:extLst>
               <a:ext uri="{FF2B5EF4-FFF2-40B4-BE49-F238E27FC236}">
-                <a16:creationId xmlns:a16="http://schemas.microsoft.com/office/drawing/2014/main" id="{ECBCD274-D751-F6B5-415C-4DB4215F4E64}"/>
+                <a16:creationId xmlns:a16="http://schemas.microsoft.com/office/drawing/2014/main" id="{88F00297-9D9C-8852-8861-C48B1B2B7D82}"/>
               </a:ext>
             </a:extLst>
           </p:cNvPr>
@@ -3902,9 +3903,9 @@
           <a:bodyPr/>
           <a:lstStyle/>
           <a:p>
-            <a:fld id="{E2E78F0F-3CEE-4885-8154-F908A2044D66}" type="datetimeFigureOut">
+            <a:fld id="{3D6C1A94-3A56-4E71-9AEB-C8DB029FBD9F}" type="datetimeFigureOut">
               <a:rPr lang="es-ES" smtClean="0"/>
-              <a:t>04/06/2026</a:t>
+              <a:t>05/06/2026</a:t>
             </a:fld>
             <a:endParaRPr lang="es-ES"/>
           </a:p>
@@ -3915,7 +3916,7 @@
           <p:cNvPr id="8" name="Marcador de pie de página 7">
             <a:extLst>
               <a:ext uri="{FF2B5EF4-FFF2-40B4-BE49-F238E27FC236}">
-                <a16:creationId xmlns:a16="http://schemas.microsoft.com/office/drawing/2014/main" id="{23F6C764-59B3-F354-F39C-0B698E06CDD6}"/>
+                <a16:creationId xmlns:a16="http://schemas.microsoft.com/office/drawing/2014/main" id="{31AD8383-C3BC-49E8-2C81-0AA317C266EB}"/>
               </a:ext>
             </a:extLst>
           </p:cNvPr>
@@ -3940,7 +3941,7 @@
           <p:cNvPr id="9" name="Marcador de número de diapositiva 8">
             <a:extLst>
               <a:ext uri="{FF2B5EF4-FFF2-40B4-BE49-F238E27FC236}">
-                <a16:creationId xmlns:a16="http://schemas.microsoft.com/office/drawing/2014/main" id="{CE782C0D-E263-D0BA-CF46-A153B3B34B4E}"/>
+                <a16:creationId xmlns:a16="http://schemas.microsoft.com/office/drawing/2014/main" id="{B5E8FC84-F2A5-7136-1549-FA0049F83074}"/>
               </a:ext>
             </a:extLst>
           </p:cNvPr>
@@ -3956,7 +3957,7 @@
           <a:bodyPr/>
           <a:lstStyle/>
           <a:p>
-            <a:fld id="{46952519-79A0-4158-88E8-8A74092916AE}" type="slidenum">
+            <a:fld id="{2611C5D2-C4B0-4D8A-9AB8-ED270EC4FA17}" type="slidenum">
               <a:rPr lang="es-ES" smtClean="0"/>
               <a:t>‹Nº›</a:t>
             </a:fld>
@@ -3967,7 +3968,7 @@
     </p:spTree>
     <p:extLst>
       <p:ext uri="{BB962C8B-B14F-4D97-AF65-F5344CB8AC3E}">
-        <p14:creationId xmlns:p14="http://schemas.microsoft.com/office/powerpoint/2010/main" val="2707746469"/>
+        <p14:creationId xmlns:p14="http://schemas.microsoft.com/office/powerpoint/2010/main" val="3397446774"/>
       </p:ext>
     </p:extLst>
   </p:cSld>
@@ -3999,7 +4000,7 @@
           <p:cNvPr id="2" name="Título 1">
             <a:extLst>
               <a:ext uri="{FF2B5EF4-FFF2-40B4-BE49-F238E27FC236}">
-                <a16:creationId xmlns:a16="http://schemas.microsoft.com/office/drawing/2014/main" id="{E183BD55-2E13-228A-0225-943327F6E16A}"/>
+                <a16:creationId xmlns:a16="http://schemas.microsoft.com/office/drawing/2014/main" id="{357D07F9-EF96-2B7D-2851-570FDAEEA5E9}"/>
               </a:ext>
             </a:extLst>
           </p:cNvPr>
@@ -4027,7 +4028,7 @@
           <p:cNvPr id="3" name="Marcador de fecha 2">
             <a:extLst>
               <a:ext uri="{FF2B5EF4-FFF2-40B4-BE49-F238E27FC236}">
-                <a16:creationId xmlns:a16="http://schemas.microsoft.com/office/drawing/2014/main" id="{9CAB8DB0-2F1F-1FE4-64A1-D074513EE62C}"/>
+                <a16:creationId xmlns:a16="http://schemas.microsoft.com/office/drawing/2014/main" id="{BF08E94B-6B67-A831-B820-4B74D47FBDBF}"/>
               </a:ext>
             </a:extLst>
           </p:cNvPr>
@@ -4043,9 +4044,9 @@
           <a:bodyPr/>
           <a:lstStyle/>
           <a:p>
-            <a:fld id="{E2E78F0F-3CEE-4885-8154-F908A2044D66}" type="datetimeFigureOut">
+            <a:fld id="{3D6C1A94-3A56-4E71-9AEB-C8DB029FBD9F}" type="datetimeFigureOut">
               <a:rPr lang="es-ES" smtClean="0"/>
-              <a:t>04/06/2026</a:t>
+              <a:t>05/06/2026</a:t>
             </a:fld>
             <a:endParaRPr lang="es-ES"/>
           </a:p>
@@ -4056,7 +4057,7 @@
           <p:cNvPr id="4" name="Marcador de pie de página 3">
             <a:extLst>
               <a:ext uri="{FF2B5EF4-FFF2-40B4-BE49-F238E27FC236}">
-                <a16:creationId xmlns:a16="http://schemas.microsoft.com/office/drawing/2014/main" id="{CFC9F4EA-37BC-C944-26B4-6A337A988C0A}"/>
+                <a16:creationId xmlns:a16="http://schemas.microsoft.com/office/drawing/2014/main" id="{E53CEB2F-56BF-D014-3562-CF71A7B94598}"/>
               </a:ext>
             </a:extLst>
           </p:cNvPr>
@@ -4081,7 +4082,7 @@
           <p:cNvPr id="5" name="Marcador de número de diapositiva 4">
             <a:extLst>
               <a:ext uri="{FF2B5EF4-FFF2-40B4-BE49-F238E27FC236}">
-                <a16:creationId xmlns:a16="http://schemas.microsoft.com/office/drawing/2014/main" id="{778121AD-8A6E-31E7-7272-C41D8C9050CF}"/>
+                <a16:creationId xmlns:a16="http://schemas.microsoft.com/office/drawing/2014/main" id="{0E56849F-0694-E406-D22C-73C4209DA666}"/>
               </a:ext>
             </a:extLst>
           </p:cNvPr>
@@ -4097,7 +4098,7 @@
           <a:bodyPr/>
           <a:lstStyle/>
           <a:p>
-            <a:fld id="{46952519-79A0-4158-88E8-8A74092916AE}" type="slidenum">
+            <a:fld id="{2611C5D2-C4B0-4D8A-9AB8-ED270EC4FA17}" type="slidenum">
               <a:rPr lang="es-ES" smtClean="0"/>
               <a:t>‹Nº›</a:t>
             </a:fld>
@@ -4108,7 +4109,7 @@
     </p:spTree>
     <p:extLst>
       <p:ext uri="{BB962C8B-B14F-4D97-AF65-F5344CB8AC3E}">
-        <p14:creationId xmlns:p14="http://schemas.microsoft.com/office/powerpoint/2010/main" val="257178994"/>
+        <p14:creationId xmlns:p14="http://schemas.microsoft.com/office/powerpoint/2010/main" val="2829739566"/>
       </p:ext>
     </p:extLst>
   </p:cSld>
@@ -4140,7 +4141,7 @@
           <p:cNvPr id="2" name="Marcador de fecha 1">
             <a:extLst>
               <a:ext uri="{FF2B5EF4-FFF2-40B4-BE49-F238E27FC236}">
-                <a16:creationId xmlns:a16="http://schemas.microsoft.com/office/drawing/2014/main" id="{58A47969-3E1B-ED92-16CC-CE89B8509379}"/>
+                <a16:creationId xmlns:a16="http://schemas.microsoft.com/office/drawing/2014/main" id="{D4B4DB9A-2EA8-1600-4216-E8F17A5D2486}"/>
               </a:ext>
             </a:extLst>
           </p:cNvPr>
@@ -4156,9 +4157,9 @@
           <a:bodyPr/>
           <a:lstStyle/>
           <a:p>
-            <a:fld id="{E2E78F0F-3CEE-4885-8154-F908A2044D66}" type="datetimeFigureOut">
+            <a:fld id="{3D6C1A94-3A56-4E71-9AEB-C8DB029FBD9F}" type="datetimeFigureOut">
               <a:rPr lang="es-ES" smtClean="0"/>
-              <a:t>04/06/2026</a:t>
+              <a:t>05/06/2026</a:t>
             </a:fld>
             <a:endParaRPr lang="es-ES"/>
           </a:p>
@@ -4169,7 +4170,7 @@
           <p:cNvPr id="3" name="Marcador de pie de página 2">
             <a:extLst>
               <a:ext uri="{FF2B5EF4-FFF2-40B4-BE49-F238E27FC236}">
-                <a16:creationId xmlns:a16="http://schemas.microsoft.com/office/drawing/2014/main" id="{3BB28542-D8FC-A36E-EF27-65A8B9AE7E41}"/>
+                <a16:creationId xmlns:a16="http://schemas.microsoft.com/office/drawing/2014/main" id="{E7E1201A-53BA-C80B-EFCC-F604FA752FA2}"/>
               </a:ext>
             </a:extLst>
           </p:cNvPr>
@@ -4194,7 +4195,7 @@
           <p:cNvPr id="4" name="Marcador de número de diapositiva 3">
             <a:extLst>
               <a:ext uri="{FF2B5EF4-FFF2-40B4-BE49-F238E27FC236}">
-                <a16:creationId xmlns:a16="http://schemas.microsoft.com/office/drawing/2014/main" id="{A2717270-5F7C-D34B-6960-141579127B50}"/>
+                <a16:creationId xmlns:a16="http://schemas.microsoft.com/office/drawing/2014/main" id="{4598ED7E-218C-99F6-E055-BCFDAEE29A3C}"/>
               </a:ext>
             </a:extLst>
           </p:cNvPr>
@@ -4210,7 +4211,7 @@
           <a:bodyPr/>
           <a:lstStyle/>
           <a:p>
-            <a:fld id="{46952519-79A0-4158-88E8-8A74092916AE}" type="slidenum">
+            <a:fld id="{2611C5D2-C4B0-4D8A-9AB8-ED270EC4FA17}" type="slidenum">
               <a:rPr lang="es-ES" smtClean="0"/>
               <a:t>‹Nº›</a:t>
             </a:fld>
@@ -4221,7 +4222,7 @@
     </p:spTree>
     <p:extLst>
       <p:ext uri="{BB962C8B-B14F-4D97-AF65-F5344CB8AC3E}">
-        <p14:creationId xmlns:p14="http://schemas.microsoft.com/office/powerpoint/2010/main" val="3366193428"/>
+        <p14:creationId xmlns:p14="http://schemas.microsoft.com/office/powerpoint/2010/main" val="3912801742"/>
       </p:ext>
     </p:extLst>
   </p:cSld>
@@ -4253,7 +4254,7 @@
           <p:cNvPr id="2" name="Título 1">
             <a:extLst>
               <a:ext uri="{FF2B5EF4-FFF2-40B4-BE49-F238E27FC236}">
-                <a16:creationId xmlns:a16="http://schemas.microsoft.com/office/drawing/2014/main" id="{E341281F-CD36-D659-86DE-106EE7ED6CCE}"/>
+                <a16:creationId xmlns:a16="http://schemas.microsoft.com/office/drawing/2014/main" id="{F6EE81E0-A3CF-B9AB-6B94-3BE53F784E09}"/>
               </a:ext>
             </a:extLst>
           </p:cNvPr>
@@ -4290,7 +4291,7 @@
           <p:cNvPr id="3" name="Marcador de contenido 2">
             <a:extLst>
               <a:ext uri="{FF2B5EF4-FFF2-40B4-BE49-F238E27FC236}">
-                <a16:creationId xmlns:a16="http://schemas.microsoft.com/office/drawing/2014/main" id="{C224142D-642C-072C-D919-0568B512F890}"/>
+                <a16:creationId xmlns:a16="http://schemas.microsoft.com/office/drawing/2014/main" id="{9BD10B93-7197-B86D-9AB3-EBD92E8E9A5E}"/>
               </a:ext>
             </a:extLst>
           </p:cNvPr>
@@ -4380,7 +4381,7 @@
           <p:cNvPr id="4" name="Marcador de texto 3">
             <a:extLst>
               <a:ext uri="{FF2B5EF4-FFF2-40B4-BE49-F238E27FC236}">
-                <a16:creationId xmlns:a16="http://schemas.microsoft.com/office/drawing/2014/main" id="{410E3231-6562-4A3D-1446-E510FEB09834}"/>
+                <a16:creationId xmlns:a16="http://schemas.microsoft.com/office/drawing/2014/main" id="{8E1B01C2-7EE5-B34D-336F-FA3BF6A11D59}"/>
               </a:ext>
             </a:extLst>
           </p:cNvPr>
@@ -4451,7 +4452,7 @@
           <p:cNvPr id="5" name="Marcador de fecha 4">
             <a:extLst>
               <a:ext uri="{FF2B5EF4-FFF2-40B4-BE49-F238E27FC236}">
-                <a16:creationId xmlns:a16="http://schemas.microsoft.com/office/drawing/2014/main" id="{B58E5A2C-8BE0-6D00-FC39-989C48DC0809}"/>
+                <a16:creationId xmlns:a16="http://schemas.microsoft.com/office/drawing/2014/main" id="{D6F2D7BB-C48A-3B70-80E2-6AF5003F810D}"/>
               </a:ext>
             </a:extLst>
           </p:cNvPr>
@@ -4467,9 +4468,9 @@
           <a:bodyPr/>
           <a:lstStyle/>
           <a:p>
-            <a:fld id="{E2E78F0F-3CEE-4885-8154-F908A2044D66}" type="datetimeFigureOut">
+            <a:fld id="{3D6C1A94-3A56-4E71-9AEB-C8DB029FBD9F}" type="datetimeFigureOut">
               <a:rPr lang="es-ES" smtClean="0"/>
-              <a:t>04/06/2026</a:t>
+              <a:t>05/06/2026</a:t>
             </a:fld>
             <a:endParaRPr lang="es-ES"/>
           </a:p>
@@ -4480,7 +4481,7 @@
           <p:cNvPr id="6" name="Marcador de pie de página 5">
             <a:extLst>
               <a:ext uri="{FF2B5EF4-FFF2-40B4-BE49-F238E27FC236}">
-                <a16:creationId xmlns:a16="http://schemas.microsoft.com/office/drawing/2014/main" id="{08CC6C97-AE09-1F9D-6F87-BF9F63F88C87}"/>
+                <a16:creationId xmlns:a16="http://schemas.microsoft.com/office/drawing/2014/main" id="{E807030A-BFEF-C8D9-1571-6F3F18374698}"/>
               </a:ext>
             </a:extLst>
           </p:cNvPr>
@@ -4505,7 +4506,7 @@
           <p:cNvPr id="7" name="Marcador de número de diapositiva 6">
             <a:extLst>
               <a:ext uri="{FF2B5EF4-FFF2-40B4-BE49-F238E27FC236}">
-                <a16:creationId xmlns:a16="http://schemas.microsoft.com/office/drawing/2014/main" id="{30F77902-79A8-E248-30B6-A2643EE7E64C}"/>
+                <a16:creationId xmlns:a16="http://schemas.microsoft.com/office/drawing/2014/main" id="{C9AF142C-CE0E-65B6-8781-E739C9F9A4E1}"/>
               </a:ext>
             </a:extLst>
           </p:cNvPr>
@@ -4521,7 +4522,7 @@
           <a:bodyPr/>
           <a:lstStyle/>
           <a:p>
-            <a:fld id="{46952519-79A0-4158-88E8-8A74092916AE}" type="slidenum">
+            <a:fld id="{2611C5D2-C4B0-4D8A-9AB8-ED270EC4FA17}" type="slidenum">
               <a:rPr lang="es-ES" smtClean="0"/>
               <a:t>‹Nº›</a:t>
             </a:fld>
@@ -4532,7 +4533,7 @@
     </p:spTree>
     <p:extLst>
       <p:ext uri="{BB962C8B-B14F-4D97-AF65-F5344CB8AC3E}">
-        <p14:creationId xmlns:p14="http://schemas.microsoft.com/office/powerpoint/2010/main" val="3290236475"/>
+        <p14:creationId xmlns:p14="http://schemas.microsoft.com/office/powerpoint/2010/main" val="1169470913"/>
       </p:ext>
     </p:extLst>
   </p:cSld>
@@ -4564,7 +4565,7 @@
           <p:cNvPr id="2" name="Título 1">
             <a:extLst>
               <a:ext uri="{FF2B5EF4-FFF2-40B4-BE49-F238E27FC236}">
-                <a16:creationId xmlns:a16="http://schemas.microsoft.com/office/drawing/2014/main" id="{91C506FB-5CF0-C432-039B-B97BB2DF1F80}"/>
+                <a16:creationId xmlns:a16="http://schemas.microsoft.com/office/drawing/2014/main" id="{63DD1150-B718-9881-2449-A18B74A2FBEB}"/>
               </a:ext>
             </a:extLst>
           </p:cNvPr>
@@ -4601,7 +4602,7 @@
           <p:cNvPr id="3" name="Marcador de posición de imagen 2">
             <a:extLst>
               <a:ext uri="{FF2B5EF4-FFF2-40B4-BE49-F238E27FC236}">
-                <a16:creationId xmlns:a16="http://schemas.microsoft.com/office/drawing/2014/main" id="{89C27F13-5815-6B9E-9445-F23A1CA94996}"/>
+                <a16:creationId xmlns:a16="http://schemas.microsoft.com/office/drawing/2014/main" id="{3576EB53-9C10-F643-A6E9-FA3100BB59F7}"/>
               </a:ext>
             </a:extLst>
           </p:cNvPr>
@@ -4668,7 +4669,7 @@
           <p:cNvPr id="4" name="Marcador de texto 3">
             <a:extLst>
               <a:ext uri="{FF2B5EF4-FFF2-40B4-BE49-F238E27FC236}">
-                <a16:creationId xmlns:a16="http://schemas.microsoft.com/office/drawing/2014/main" id="{348BC20F-73A3-FAAD-F67E-B97383B3A84F}"/>
+                <a16:creationId xmlns:a16="http://schemas.microsoft.com/office/drawing/2014/main" id="{91CE74E7-E6CC-3EFD-0E20-BA674F5A2CDA}"/>
               </a:ext>
             </a:extLst>
           </p:cNvPr>
@@ -4739,7 +4740,7 @@
           <p:cNvPr id="5" name="Marcador de fecha 4">
             <a:extLst>
               <a:ext uri="{FF2B5EF4-FFF2-40B4-BE49-F238E27FC236}">
-                <a16:creationId xmlns:a16="http://schemas.microsoft.com/office/drawing/2014/main" id="{04B25C72-DEF8-D9F8-AC95-584D94CF2399}"/>
+                <a16:creationId xmlns:a16="http://schemas.microsoft.com/office/drawing/2014/main" id="{557A0C8A-4B60-08DA-29ED-58C6CC6CA398}"/>
               </a:ext>
             </a:extLst>
           </p:cNvPr>
@@ -4755,9 +4756,9 @@
           <a:bodyPr/>
           <a:lstStyle/>
           <a:p>
-            <a:fld id="{E2E78F0F-3CEE-4885-8154-F908A2044D66}" type="datetimeFigureOut">
+            <a:fld id="{3D6C1A94-3A56-4E71-9AEB-C8DB029FBD9F}" type="datetimeFigureOut">
               <a:rPr lang="es-ES" smtClean="0"/>
-              <a:t>04/06/2026</a:t>
+              <a:t>05/06/2026</a:t>
             </a:fld>
             <a:endParaRPr lang="es-ES"/>
           </a:p>
@@ -4768,7 +4769,7 @@
           <p:cNvPr id="6" name="Marcador de pie de página 5">
             <a:extLst>
               <a:ext uri="{FF2B5EF4-FFF2-40B4-BE49-F238E27FC236}">
-                <a16:creationId xmlns:a16="http://schemas.microsoft.com/office/drawing/2014/main" id="{80AAEA25-F95A-2D0A-C685-AD30116B1904}"/>
+                <a16:creationId xmlns:a16="http://schemas.microsoft.com/office/drawing/2014/main" id="{3509AA00-B02B-9A06-75FD-B49499226EA5}"/>
               </a:ext>
             </a:extLst>
           </p:cNvPr>
@@ -4793,7 +4794,7 @@
           <p:cNvPr id="7" name="Marcador de número de diapositiva 6">
             <a:extLst>
               <a:ext uri="{FF2B5EF4-FFF2-40B4-BE49-F238E27FC236}">
-                <a16:creationId xmlns:a16="http://schemas.microsoft.com/office/drawing/2014/main" id="{1673DFFB-DCB5-059A-0FE4-56B857D72841}"/>
+                <a16:creationId xmlns:a16="http://schemas.microsoft.com/office/drawing/2014/main" id="{763456D0-8854-70FD-E60F-1589A6FD76C6}"/>
               </a:ext>
             </a:extLst>
           </p:cNvPr>
@@ -4809,7 +4810,7 @@
           <a:bodyPr/>
           <a:lstStyle/>
           <a:p>
-            <a:fld id="{46952519-79A0-4158-88E8-8A74092916AE}" type="slidenum">
+            <a:fld id="{2611C5D2-C4B0-4D8A-9AB8-ED270EC4FA17}" type="slidenum">
               <a:rPr lang="es-ES" smtClean="0"/>
               <a:t>‹Nº›</a:t>
             </a:fld>
@@ -4820,7 +4821,7 @@
     </p:spTree>
     <p:extLst>
       <p:ext uri="{BB962C8B-B14F-4D97-AF65-F5344CB8AC3E}">
-        <p14:creationId xmlns:p14="http://schemas.microsoft.com/office/powerpoint/2010/main" val="1654087475"/>
+        <p14:creationId xmlns:p14="http://schemas.microsoft.com/office/powerpoint/2010/main" val="2518576910"/>
       </p:ext>
     </p:extLst>
   </p:cSld>
@@ -4857,7 +4858,7 @@
           <p:cNvPr id="2" name="Marcador de título 1">
             <a:extLst>
               <a:ext uri="{FF2B5EF4-FFF2-40B4-BE49-F238E27FC236}">
-                <a16:creationId xmlns:a16="http://schemas.microsoft.com/office/drawing/2014/main" id="{88310B3C-28D4-62C9-F1BE-20E888886D1E}"/>
+                <a16:creationId xmlns:a16="http://schemas.microsoft.com/office/drawing/2014/main" id="{70C97680-CC07-D41C-1519-9A7C78F98B88}"/>
               </a:ext>
             </a:extLst>
           </p:cNvPr>
@@ -4895,7 +4896,7 @@
           <p:cNvPr id="3" name="Marcador de texto 2">
             <a:extLst>
               <a:ext uri="{FF2B5EF4-FFF2-40B4-BE49-F238E27FC236}">
-                <a16:creationId xmlns:a16="http://schemas.microsoft.com/office/drawing/2014/main" id="{33B3B629-4395-EC08-80FC-6A6764A854F9}"/>
+                <a16:creationId xmlns:a16="http://schemas.microsoft.com/office/drawing/2014/main" id="{C08F7488-31FB-963C-BE3E-C837505AA37D}"/>
               </a:ext>
             </a:extLst>
           </p:cNvPr>
@@ -4962,7 +4963,7 @@
           <p:cNvPr id="4" name="Marcador de fecha 3">
             <a:extLst>
               <a:ext uri="{FF2B5EF4-FFF2-40B4-BE49-F238E27FC236}">
-                <a16:creationId xmlns:a16="http://schemas.microsoft.com/office/drawing/2014/main" id="{BC119E05-ADFF-C607-FA6E-6FD98CFD1262}"/>
+                <a16:creationId xmlns:a16="http://schemas.microsoft.com/office/drawing/2014/main" id="{9B3EBE77-EAA3-2656-7326-0F394ABDACA6}"/>
               </a:ext>
             </a:extLst>
           </p:cNvPr>
@@ -4996,9 +4997,9 @@
             </a:lvl1pPr>
           </a:lstStyle>
           <a:p>
-            <a:fld id="{E2E78F0F-3CEE-4885-8154-F908A2044D66}" type="datetimeFigureOut">
+            <a:fld id="{3D6C1A94-3A56-4E71-9AEB-C8DB029FBD9F}" type="datetimeFigureOut">
               <a:rPr lang="es-ES" smtClean="0"/>
-              <a:t>04/06/2026</a:t>
+              <a:t>05/06/2026</a:t>
             </a:fld>
             <a:endParaRPr lang="es-ES"/>
           </a:p>
@@ -5009,7 +5010,7 @@
           <p:cNvPr id="5" name="Marcador de pie de página 4">
             <a:extLst>
               <a:ext uri="{FF2B5EF4-FFF2-40B4-BE49-F238E27FC236}">
-                <a16:creationId xmlns:a16="http://schemas.microsoft.com/office/drawing/2014/main" id="{B224DE56-7325-AD5A-0436-C8500CBF81F0}"/>
+                <a16:creationId xmlns:a16="http://schemas.microsoft.com/office/drawing/2014/main" id="{AF3C918C-B71C-3A60-83AD-F1CC63AE1363}"/>
               </a:ext>
             </a:extLst>
           </p:cNvPr>
@@ -5052,7 +5053,7 @@
           <p:cNvPr id="6" name="Marcador de número de diapositiva 5">
             <a:extLst>
               <a:ext uri="{FF2B5EF4-FFF2-40B4-BE49-F238E27FC236}">
-                <a16:creationId xmlns:a16="http://schemas.microsoft.com/office/drawing/2014/main" id="{71E2069E-B394-5813-CC53-7A97F6409FC9}"/>
+                <a16:creationId xmlns:a16="http://schemas.microsoft.com/office/drawing/2014/main" id="{A5AF903D-3E47-D9F5-E7C1-37B208FF17C7}"/>
               </a:ext>
             </a:extLst>
           </p:cNvPr>
@@ -5086,7 +5087,7 @@
             </a:lvl1pPr>
           </a:lstStyle>
           <a:p>
-            <a:fld id="{46952519-79A0-4158-88E8-8A74092916AE}" type="slidenum">
+            <a:fld id="{2611C5D2-C4B0-4D8A-9AB8-ED270EC4FA17}" type="slidenum">
               <a:rPr lang="es-ES" smtClean="0"/>
               <a:t>‹Nº›</a:t>
             </a:fld>
@@ -5097,7 +5098,7 @@
     </p:spTree>
     <p:extLst>
       <p:ext uri="{BB962C8B-B14F-4D97-AF65-F5344CB8AC3E}">
-        <p14:creationId xmlns:p14="http://schemas.microsoft.com/office/powerpoint/2010/main" val="1101064486"/>
+        <p14:creationId xmlns:p14="http://schemas.microsoft.com/office/powerpoint/2010/main" val="754063171"/>
       </p:ext>
     </p:extLst>
   </p:cSld>
@@ -5428,7 +5429,7 @@
           <p:cNvPr id="2" name="Rectángulo: esquinas redondeadas 1">
             <a:extLst>
               <a:ext uri="{FF2B5EF4-FFF2-40B4-BE49-F238E27FC236}">
-                <a16:creationId xmlns:a16="http://schemas.microsoft.com/office/drawing/2014/main" id="{8737DDCC-1875-8BE5-E51F-8A4C0CEA6EA5}"/>
+                <a16:creationId xmlns:a16="http://schemas.microsoft.com/office/drawing/2014/main" id="{16E9DF3F-4C02-EF1F-1713-652A9B11A307}"/>
               </a:ext>
             </a:extLst>
           </p:cNvPr>
@@ -5482,7 +5483,7 @@
           <p:cNvPr id="3" name="CuadroTexto 2">
             <a:extLst>
               <a:ext uri="{FF2B5EF4-FFF2-40B4-BE49-F238E27FC236}">
-                <a16:creationId xmlns:a16="http://schemas.microsoft.com/office/drawing/2014/main" id="{6DD45364-6171-ADD6-2A3E-345700050954}"/>
+                <a16:creationId xmlns:a16="http://schemas.microsoft.com/office/drawing/2014/main" id="{6A9572C4-1714-F03D-BF80-F3FA7D192014}"/>
               </a:ext>
             </a:extLst>
           </p:cNvPr>
@@ -5522,7 +5523,7 @@
           <p:cNvPr id="4" name="CuadroTexto 3">
             <a:extLst>
               <a:ext uri="{FF2B5EF4-FFF2-40B4-BE49-F238E27FC236}">
-                <a16:creationId xmlns:a16="http://schemas.microsoft.com/office/drawing/2014/main" id="{07654982-0FBC-8954-CBFE-78E53DFA2B22}"/>
+                <a16:creationId xmlns:a16="http://schemas.microsoft.com/office/drawing/2014/main" id="{6AF93AD2-B888-3654-ECCC-0952CE6E9295}"/>
               </a:ext>
             </a:extLst>
           </p:cNvPr>
@@ -5562,7 +5563,7 @@
           <p:cNvPr id="5" name="CuadroTexto 4">
             <a:extLst>
               <a:ext uri="{FF2B5EF4-FFF2-40B4-BE49-F238E27FC236}">
-                <a16:creationId xmlns:a16="http://schemas.microsoft.com/office/drawing/2014/main" id="{C61F902F-DB39-AF54-27DD-953366FED8A9}"/>
+                <a16:creationId xmlns:a16="http://schemas.microsoft.com/office/drawing/2014/main" id="{B2595E12-4BE6-1DF5-74C1-FC12545E62ED}"/>
               </a:ext>
             </a:extLst>
           </p:cNvPr>
@@ -5602,7 +5603,7 @@
           <p:cNvPr id="6" name="CuadroTexto 5">
             <a:extLst>
               <a:ext uri="{FF2B5EF4-FFF2-40B4-BE49-F238E27FC236}">
-                <a16:creationId xmlns:a16="http://schemas.microsoft.com/office/drawing/2014/main" id="{70F2886B-368E-3156-B869-08353B9C0C0D}"/>
+                <a16:creationId xmlns:a16="http://schemas.microsoft.com/office/drawing/2014/main" id="{ECA88EED-0A56-E5BB-BB42-BFAABC3E9E50}"/>
               </a:ext>
             </a:extLst>
           </p:cNvPr>
@@ -5653,7 +5654,7 @@
           <p:cNvPr id="8" name="Imagen 7">
             <a:extLst>
               <a:ext uri="{FF2B5EF4-FFF2-40B4-BE49-F238E27FC236}">
-                <a16:creationId xmlns:a16="http://schemas.microsoft.com/office/drawing/2014/main" id="{D499C65C-77DE-3433-C918-7C8C67DF1528}"/>
+                <a16:creationId xmlns:a16="http://schemas.microsoft.com/office/drawing/2014/main" id="{67F20F40-BB58-833A-3298-5B0F17E0A073}"/>
               </a:ext>
             </a:extLst>
           </p:cNvPr>
@@ -5692,7 +5693,7 @@
     </p:spTree>
     <p:extLst>
       <p:ext uri="{BB962C8B-B14F-4D97-AF65-F5344CB8AC3E}">
-        <p14:creationId xmlns:p14="http://schemas.microsoft.com/office/powerpoint/2010/main" val="2893945376"/>
+        <p14:creationId xmlns:p14="http://schemas.microsoft.com/office/powerpoint/2010/main" val="3210793120"/>
       </p:ext>
     </p:extLst>
   </p:cSld>
@@ -5732,7 +5733,7 @@
           <p:cNvPr id="2" name="CuadroTexto 1">
             <a:extLst>
               <a:ext uri="{FF2B5EF4-FFF2-40B4-BE49-F238E27FC236}">
-                <a16:creationId xmlns:a16="http://schemas.microsoft.com/office/drawing/2014/main" id="{5C0E4828-1C29-937D-33E4-1F1429E9E660}"/>
+                <a16:creationId xmlns:a16="http://schemas.microsoft.com/office/drawing/2014/main" id="{390A16C3-3288-0271-06FF-E2C9062BE7B6}"/>
               </a:ext>
             </a:extLst>
           </p:cNvPr>
@@ -5772,7 +5773,7 @@
           <p:cNvPr id="3" name="CuadroTexto 2">
             <a:extLst>
               <a:ext uri="{FF2B5EF4-FFF2-40B4-BE49-F238E27FC236}">
-                <a16:creationId xmlns:a16="http://schemas.microsoft.com/office/drawing/2014/main" id="{E2D65E2E-9E1F-8B89-45B2-5009ABE00CDA}"/>
+                <a16:creationId xmlns:a16="http://schemas.microsoft.com/office/drawing/2014/main" id="{9B27D037-BD55-882A-003F-BEDA531615E8}"/>
               </a:ext>
             </a:extLst>
           </p:cNvPr>
@@ -5812,7 +5813,7 @@
           <p:cNvPr id="4" name="CuadroTexto 3">
             <a:extLst>
               <a:ext uri="{FF2B5EF4-FFF2-40B4-BE49-F238E27FC236}">
-                <a16:creationId xmlns:a16="http://schemas.microsoft.com/office/drawing/2014/main" id="{29226C08-5A82-C22F-EB54-B2F993806C81}"/>
+                <a16:creationId xmlns:a16="http://schemas.microsoft.com/office/drawing/2014/main" id="{D3015EDF-06E3-EFE8-19C9-29CD66FE53E7}"/>
               </a:ext>
             </a:extLst>
           </p:cNvPr>
@@ -5852,7 +5853,7 @@
           <p:cNvPr id="5" name="Rectángulo: esquinas redondeadas 4">
             <a:extLst>
               <a:ext uri="{FF2B5EF4-FFF2-40B4-BE49-F238E27FC236}">
-                <a16:creationId xmlns:a16="http://schemas.microsoft.com/office/drawing/2014/main" id="{28246C8D-8025-6EFC-02D8-B7B512746A2C}"/>
+                <a16:creationId xmlns:a16="http://schemas.microsoft.com/office/drawing/2014/main" id="{A6D5E433-E59F-902F-A9C9-1F63EC9571F5}"/>
               </a:ext>
             </a:extLst>
           </p:cNvPr>
@@ -5906,7 +5907,7 @@
           <p:cNvPr id="6" name="CuadroTexto 5">
             <a:extLst>
               <a:ext uri="{FF2B5EF4-FFF2-40B4-BE49-F238E27FC236}">
-                <a16:creationId xmlns:a16="http://schemas.microsoft.com/office/drawing/2014/main" id="{66FDA293-01D7-B04A-9013-9E654A575CFC}"/>
+                <a16:creationId xmlns:a16="http://schemas.microsoft.com/office/drawing/2014/main" id="{0C9107E9-B34E-4FCD-FD87-9BD2F46FCAE7}"/>
               </a:ext>
             </a:extLst>
           </p:cNvPr>
@@ -5946,7 +5947,7 @@
           <p:cNvPr id="7" name="CuadroTexto 6">
             <a:extLst>
               <a:ext uri="{FF2B5EF4-FFF2-40B4-BE49-F238E27FC236}">
-                <a16:creationId xmlns:a16="http://schemas.microsoft.com/office/drawing/2014/main" id="{E55B17D5-6E1D-AA9A-A1D4-D5B4E829EC9C}"/>
+                <a16:creationId xmlns:a16="http://schemas.microsoft.com/office/drawing/2014/main" id="{7E5C3433-CE17-57F6-9501-EC4E0353282B}"/>
               </a:ext>
             </a:extLst>
           </p:cNvPr>
@@ -6065,7 +6066,7 @@
           <p:cNvPr id="8" name="Rectángulo: esquinas redondeadas 7">
             <a:extLst>
               <a:ext uri="{FF2B5EF4-FFF2-40B4-BE49-F238E27FC236}">
-                <a16:creationId xmlns:a16="http://schemas.microsoft.com/office/drawing/2014/main" id="{583A4A61-D0C8-DBFE-7567-FD84A94DF6D1}"/>
+                <a16:creationId xmlns:a16="http://schemas.microsoft.com/office/drawing/2014/main" id="{3A21867A-E207-4622-B762-39022771BAE8}"/>
               </a:ext>
             </a:extLst>
           </p:cNvPr>
@@ -6119,7 +6120,7 @@
           <p:cNvPr id="9" name="CuadroTexto 8">
             <a:extLst>
               <a:ext uri="{FF2B5EF4-FFF2-40B4-BE49-F238E27FC236}">
-                <a16:creationId xmlns:a16="http://schemas.microsoft.com/office/drawing/2014/main" id="{36B1F2E2-A653-03D6-C5BF-E7D7561BE8B7}"/>
+                <a16:creationId xmlns:a16="http://schemas.microsoft.com/office/drawing/2014/main" id="{B63A64E3-0276-A408-B412-220221EE1FB9}"/>
               </a:ext>
             </a:extLst>
           </p:cNvPr>
@@ -6159,7 +6160,7 @@
           <p:cNvPr id="10" name="CuadroTexto 9">
             <a:extLst>
               <a:ext uri="{FF2B5EF4-FFF2-40B4-BE49-F238E27FC236}">
-                <a16:creationId xmlns:a16="http://schemas.microsoft.com/office/drawing/2014/main" id="{CBB04404-3432-A8DD-0CDD-8B3A1AA4B6B6}"/>
+                <a16:creationId xmlns:a16="http://schemas.microsoft.com/office/drawing/2014/main" id="{9E861F65-3806-B020-00A5-2F908129591B}"/>
               </a:ext>
             </a:extLst>
           </p:cNvPr>
@@ -6199,7 +6200,7 @@
           <p:cNvPr id="11" name="Rectángulo: esquinas redondeadas 10">
             <a:extLst>
               <a:ext uri="{FF2B5EF4-FFF2-40B4-BE49-F238E27FC236}">
-                <a16:creationId xmlns:a16="http://schemas.microsoft.com/office/drawing/2014/main" id="{250A7652-C606-00FA-745C-03DFDA082649}"/>
+                <a16:creationId xmlns:a16="http://schemas.microsoft.com/office/drawing/2014/main" id="{CD752376-BA76-E31A-415D-18C0CB1AAA82}"/>
               </a:ext>
             </a:extLst>
           </p:cNvPr>
@@ -6253,7 +6254,7 @@
           <p:cNvPr id="12" name="CuadroTexto 11">
             <a:extLst>
               <a:ext uri="{FF2B5EF4-FFF2-40B4-BE49-F238E27FC236}">
-                <a16:creationId xmlns:a16="http://schemas.microsoft.com/office/drawing/2014/main" id="{713F77D9-36EB-82B4-2E16-791E0A65AEA6}"/>
+                <a16:creationId xmlns:a16="http://schemas.microsoft.com/office/drawing/2014/main" id="{6E9FA1A7-2D9A-6A41-65A2-877F01189D3E}"/>
               </a:ext>
             </a:extLst>
           </p:cNvPr>
@@ -6293,7 +6294,7 @@
           <p:cNvPr id="13" name="CuadroTexto 12">
             <a:extLst>
               <a:ext uri="{FF2B5EF4-FFF2-40B4-BE49-F238E27FC236}">
-                <a16:creationId xmlns:a16="http://schemas.microsoft.com/office/drawing/2014/main" id="{52E5D48B-CA6F-A798-197D-25A47EA9A5F4}"/>
+                <a16:creationId xmlns:a16="http://schemas.microsoft.com/office/drawing/2014/main" id="{5DF9A117-488C-6195-10AE-31F4D7B951D6}"/>
               </a:ext>
             </a:extLst>
           </p:cNvPr>
@@ -6333,7 +6334,7 @@
           <p:cNvPr id="14" name="Rectángulo: esquinas redondeadas 13">
             <a:extLst>
               <a:ext uri="{FF2B5EF4-FFF2-40B4-BE49-F238E27FC236}">
-                <a16:creationId xmlns:a16="http://schemas.microsoft.com/office/drawing/2014/main" id="{83415978-DB9A-4F0E-01AD-3FD52A75EE9A}"/>
+                <a16:creationId xmlns:a16="http://schemas.microsoft.com/office/drawing/2014/main" id="{D99960CD-3D65-A34F-176C-32B4214632C6}"/>
               </a:ext>
             </a:extLst>
           </p:cNvPr>
@@ -6387,7 +6388,7 @@
           <p:cNvPr id="15" name="CuadroTexto 14">
             <a:extLst>
               <a:ext uri="{FF2B5EF4-FFF2-40B4-BE49-F238E27FC236}">
-                <a16:creationId xmlns:a16="http://schemas.microsoft.com/office/drawing/2014/main" id="{10CC2D39-4B6F-7D89-412F-8E5898BC6A26}"/>
+                <a16:creationId xmlns:a16="http://schemas.microsoft.com/office/drawing/2014/main" id="{686C87F7-561A-3FE3-FC00-49C01D6121C9}"/>
               </a:ext>
             </a:extLst>
           </p:cNvPr>
@@ -6427,7 +6428,7 @@
           <p:cNvPr id="16" name="CuadroTexto 15">
             <a:extLst>
               <a:ext uri="{FF2B5EF4-FFF2-40B4-BE49-F238E27FC236}">
-                <a16:creationId xmlns:a16="http://schemas.microsoft.com/office/drawing/2014/main" id="{BE373084-1D6E-2C7D-24EC-F353109D2B6C}"/>
+                <a16:creationId xmlns:a16="http://schemas.microsoft.com/office/drawing/2014/main" id="{7EFA092D-1E62-64BD-644E-F562C6B90A4D}"/>
               </a:ext>
             </a:extLst>
           </p:cNvPr>
@@ -6467,7 +6468,7 @@
           <p:cNvPr id="17" name="Rectángulo: esquinas redondeadas 16">
             <a:extLst>
               <a:ext uri="{FF2B5EF4-FFF2-40B4-BE49-F238E27FC236}">
-                <a16:creationId xmlns:a16="http://schemas.microsoft.com/office/drawing/2014/main" id="{A8134A8D-1FC6-953C-45FB-3EB6E5D196DE}"/>
+                <a16:creationId xmlns:a16="http://schemas.microsoft.com/office/drawing/2014/main" id="{1A1E7455-192C-D083-27C1-334FEC687675}"/>
               </a:ext>
             </a:extLst>
           </p:cNvPr>
@@ -6521,7 +6522,7 @@
           <p:cNvPr id="18" name="CuadroTexto 17">
             <a:extLst>
               <a:ext uri="{FF2B5EF4-FFF2-40B4-BE49-F238E27FC236}">
-                <a16:creationId xmlns:a16="http://schemas.microsoft.com/office/drawing/2014/main" id="{491CD917-1C2C-5FBA-EB4D-ADEA25ED1180}"/>
+                <a16:creationId xmlns:a16="http://schemas.microsoft.com/office/drawing/2014/main" id="{70B719C6-4885-AF1E-D202-B201C13AFCD4}"/>
               </a:ext>
             </a:extLst>
           </p:cNvPr>
@@ -6561,7 +6562,7 @@
           <p:cNvPr id="19" name="CuadroTexto 18">
             <a:extLst>
               <a:ext uri="{FF2B5EF4-FFF2-40B4-BE49-F238E27FC236}">
-                <a16:creationId xmlns:a16="http://schemas.microsoft.com/office/drawing/2014/main" id="{99E9EF68-7555-59F0-BC94-1890DCBDA0E5}"/>
+                <a16:creationId xmlns:a16="http://schemas.microsoft.com/office/drawing/2014/main" id="{ED0027ED-962D-0F86-DEC3-5B0F7B52936E}"/>
               </a:ext>
             </a:extLst>
           </p:cNvPr>
@@ -6599,7 +6600,7 @@
     </p:spTree>
     <p:extLst>
       <p:ext uri="{BB962C8B-B14F-4D97-AF65-F5344CB8AC3E}">
-        <p14:creationId xmlns:p14="http://schemas.microsoft.com/office/powerpoint/2010/main" val="178090368"/>
+        <p14:creationId xmlns:p14="http://schemas.microsoft.com/office/powerpoint/2010/main" val="3352489594"/>
       </p:ext>
     </p:extLst>
   </p:cSld>
@@ -6639,7 +6640,7 @@
           <p:cNvPr id="2" name="CuadroTexto 1">
             <a:extLst>
               <a:ext uri="{FF2B5EF4-FFF2-40B4-BE49-F238E27FC236}">
-                <a16:creationId xmlns:a16="http://schemas.microsoft.com/office/drawing/2014/main" id="{65AC85FA-F908-4E21-70D9-CF67D755409D}"/>
+                <a16:creationId xmlns:a16="http://schemas.microsoft.com/office/drawing/2014/main" id="{1B5D9D3E-2D3A-2296-DCEC-F20A9EC26F05}"/>
               </a:ext>
             </a:extLst>
           </p:cNvPr>
@@ -6679,7 +6680,7 @@
           <p:cNvPr id="3" name="CuadroTexto 2">
             <a:extLst>
               <a:ext uri="{FF2B5EF4-FFF2-40B4-BE49-F238E27FC236}">
-                <a16:creationId xmlns:a16="http://schemas.microsoft.com/office/drawing/2014/main" id="{F0F54596-0118-8B63-D32D-7A17BB203100}"/>
+                <a16:creationId xmlns:a16="http://schemas.microsoft.com/office/drawing/2014/main" id="{21FB00C9-C30F-91CD-091F-6C3F74DF53B2}"/>
               </a:ext>
             </a:extLst>
           </p:cNvPr>
@@ -6719,7 +6720,7 @@
           <p:cNvPr id="4" name="CuadroTexto 3">
             <a:extLst>
               <a:ext uri="{FF2B5EF4-FFF2-40B4-BE49-F238E27FC236}">
-                <a16:creationId xmlns:a16="http://schemas.microsoft.com/office/drawing/2014/main" id="{6165C584-4F58-F8C7-88AA-11E962CB6197}"/>
+                <a16:creationId xmlns:a16="http://schemas.microsoft.com/office/drawing/2014/main" id="{FC398856-D024-8D55-E0FD-EEEB7B38CD0C}"/>
               </a:ext>
             </a:extLst>
           </p:cNvPr>
@@ -6759,7 +6760,7 @@
           <p:cNvPr id="5" name="Rectángulo: esquinas redondeadas 4">
             <a:extLst>
               <a:ext uri="{FF2B5EF4-FFF2-40B4-BE49-F238E27FC236}">
-                <a16:creationId xmlns:a16="http://schemas.microsoft.com/office/drawing/2014/main" id="{13092FAF-37A2-B925-95C1-032895FE96C2}"/>
+                <a16:creationId xmlns:a16="http://schemas.microsoft.com/office/drawing/2014/main" id="{FABA18A6-79FE-D744-24EC-47787CF2E8BA}"/>
               </a:ext>
             </a:extLst>
           </p:cNvPr>
@@ -6813,7 +6814,7 @@
           <p:cNvPr id="6" name="CuadroTexto 5">
             <a:extLst>
               <a:ext uri="{FF2B5EF4-FFF2-40B4-BE49-F238E27FC236}">
-                <a16:creationId xmlns:a16="http://schemas.microsoft.com/office/drawing/2014/main" id="{DB589446-30CE-4263-EBCA-7A3DD5093426}"/>
+                <a16:creationId xmlns:a16="http://schemas.microsoft.com/office/drawing/2014/main" id="{23A25BD5-FB22-7346-DA43-32E19D3C0D06}"/>
               </a:ext>
             </a:extLst>
           </p:cNvPr>
@@ -6853,7 +6854,7 @@
           <p:cNvPr id="7" name="CuadroTexto 6">
             <a:extLst>
               <a:ext uri="{FF2B5EF4-FFF2-40B4-BE49-F238E27FC236}">
-                <a16:creationId xmlns:a16="http://schemas.microsoft.com/office/drawing/2014/main" id="{688ECCFA-E19E-E1B3-4097-4BD64C834C71}"/>
+                <a16:creationId xmlns:a16="http://schemas.microsoft.com/office/drawing/2014/main" id="{0CCC977E-1A30-82BE-646A-B2B36D412D9D}"/>
               </a:ext>
             </a:extLst>
           </p:cNvPr>
@@ -6893,7 +6894,7 @@
           <p:cNvPr id="8" name="Rectángulo: esquinas redondeadas 7">
             <a:extLst>
               <a:ext uri="{FF2B5EF4-FFF2-40B4-BE49-F238E27FC236}">
-                <a16:creationId xmlns:a16="http://schemas.microsoft.com/office/drawing/2014/main" id="{BA3AE05E-29E8-E5EA-516B-32AC9B2365C7}"/>
+                <a16:creationId xmlns:a16="http://schemas.microsoft.com/office/drawing/2014/main" id="{5E6E9FFA-6C38-C983-BFCF-A438BC628644}"/>
               </a:ext>
             </a:extLst>
           </p:cNvPr>
@@ -6947,7 +6948,7 @@
           <p:cNvPr id="9" name="CuadroTexto 8">
             <a:extLst>
               <a:ext uri="{FF2B5EF4-FFF2-40B4-BE49-F238E27FC236}">
-                <a16:creationId xmlns:a16="http://schemas.microsoft.com/office/drawing/2014/main" id="{7E796478-CBB1-ECEB-CE26-BB0E255D469E}"/>
+                <a16:creationId xmlns:a16="http://schemas.microsoft.com/office/drawing/2014/main" id="{58176A3E-B31B-D20D-812E-612991A0235A}"/>
               </a:ext>
             </a:extLst>
           </p:cNvPr>
@@ -6987,7 +6988,7 @@
           <p:cNvPr id="10" name="CuadroTexto 9">
             <a:extLst>
               <a:ext uri="{FF2B5EF4-FFF2-40B4-BE49-F238E27FC236}">
-                <a16:creationId xmlns:a16="http://schemas.microsoft.com/office/drawing/2014/main" id="{C890C099-AC11-E3DB-AD11-92819D6DC2FA}"/>
+                <a16:creationId xmlns:a16="http://schemas.microsoft.com/office/drawing/2014/main" id="{1C306C1E-E694-7359-628F-F803515AB734}"/>
               </a:ext>
             </a:extLst>
           </p:cNvPr>
@@ -7027,7 +7028,7 @@
           <p:cNvPr id="11" name="Rectángulo: esquinas redondeadas 10">
             <a:extLst>
               <a:ext uri="{FF2B5EF4-FFF2-40B4-BE49-F238E27FC236}">
-                <a16:creationId xmlns:a16="http://schemas.microsoft.com/office/drawing/2014/main" id="{0A633831-79A5-5792-7412-58FC1879EFCA}"/>
+                <a16:creationId xmlns:a16="http://schemas.microsoft.com/office/drawing/2014/main" id="{5663098F-BA04-F81C-29EA-745BCF7AFA6D}"/>
               </a:ext>
             </a:extLst>
           </p:cNvPr>
@@ -7081,7 +7082,7 @@
           <p:cNvPr id="12" name="CuadroTexto 11">
             <a:extLst>
               <a:ext uri="{FF2B5EF4-FFF2-40B4-BE49-F238E27FC236}">
-                <a16:creationId xmlns:a16="http://schemas.microsoft.com/office/drawing/2014/main" id="{A6A43BF5-5972-D933-8D9C-DD71DB14BCCC}"/>
+                <a16:creationId xmlns:a16="http://schemas.microsoft.com/office/drawing/2014/main" id="{849D15BE-49B0-6D31-412D-47A2AB0DA511}"/>
               </a:ext>
             </a:extLst>
           </p:cNvPr>
@@ -7121,7 +7122,7 @@
           <p:cNvPr id="13" name="CuadroTexto 12">
             <a:extLst>
               <a:ext uri="{FF2B5EF4-FFF2-40B4-BE49-F238E27FC236}">
-                <a16:creationId xmlns:a16="http://schemas.microsoft.com/office/drawing/2014/main" id="{6FECB936-5543-7540-CFBE-69E6E6DAD718}"/>
+                <a16:creationId xmlns:a16="http://schemas.microsoft.com/office/drawing/2014/main" id="{DC9B4318-DE98-FB01-E814-435C2BBB5363}"/>
               </a:ext>
             </a:extLst>
           </p:cNvPr>
@@ -7161,7 +7162,7 @@
           <p:cNvPr id="14" name="CuadroTexto 13">
             <a:extLst>
               <a:ext uri="{FF2B5EF4-FFF2-40B4-BE49-F238E27FC236}">
-                <a16:creationId xmlns:a16="http://schemas.microsoft.com/office/drawing/2014/main" id="{57E0B157-C904-5762-B6AD-74A123CF0913}"/>
+                <a16:creationId xmlns:a16="http://schemas.microsoft.com/office/drawing/2014/main" id="{9E88D6F5-5A5E-DF68-AB56-210E5D64C9AD}"/>
               </a:ext>
             </a:extLst>
           </p:cNvPr>
@@ -7242,7 +7243,7 @@
     </p:spTree>
     <p:extLst>
       <p:ext uri="{BB962C8B-B14F-4D97-AF65-F5344CB8AC3E}">
-        <p14:creationId xmlns:p14="http://schemas.microsoft.com/office/powerpoint/2010/main" val="878860373"/>
+        <p14:creationId xmlns:p14="http://schemas.microsoft.com/office/powerpoint/2010/main" val="4228597921"/>
       </p:ext>
     </p:extLst>
   </p:cSld>
@@ -7282,7 +7283,7 @@
           <p:cNvPr id="2" name="CuadroTexto 1">
             <a:extLst>
               <a:ext uri="{FF2B5EF4-FFF2-40B4-BE49-F238E27FC236}">
-                <a16:creationId xmlns:a16="http://schemas.microsoft.com/office/drawing/2014/main" id="{0612F822-E741-FF3B-BD34-0C5C21417D43}"/>
+                <a16:creationId xmlns:a16="http://schemas.microsoft.com/office/drawing/2014/main" id="{16544C3F-63E2-D153-0F8C-BEB94186E0EC}"/>
               </a:ext>
             </a:extLst>
           </p:cNvPr>
@@ -7322,7 +7323,7 @@
           <p:cNvPr id="3" name="CuadroTexto 2">
             <a:extLst>
               <a:ext uri="{FF2B5EF4-FFF2-40B4-BE49-F238E27FC236}">
-                <a16:creationId xmlns:a16="http://schemas.microsoft.com/office/drawing/2014/main" id="{4C09E9DC-8780-0368-E56E-5985A06F3652}"/>
+                <a16:creationId xmlns:a16="http://schemas.microsoft.com/office/drawing/2014/main" id="{DF5F33B4-628B-03EC-65B5-CAC1C06AF8DB}"/>
               </a:ext>
             </a:extLst>
           </p:cNvPr>
@@ -7362,7 +7363,7 @@
           <p:cNvPr id="4" name="CuadroTexto 3">
             <a:extLst>
               <a:ext uri="{FF2B5EF4-FFF2-40B4-BE49-F238E27FC236}">
-                <a16:creationId xmlns:a16="http://schemas.microsoft.com/office/drawing/2014/main" id="{F23984AB-50E6-4296-5ABE-690D0C1AEB17}"/>
+                <a16:creationId xmlns:a16="http://schemas.microsoft.com/office/drawing/2014/main" id="{6D47D573-1B9F-E6E5-ED3D-2BA9E6E222A4}"/>
               </a:ext>
             </a:extLst>
           </p:cNvPr>
@@ -7402,7 +7403,7 @@
           <p:cNvPr id="6" name="Imagen 5">
             <a:extLst>
               <a:ext uri="{FF2B5EF4-FFF2-40B4-BE49-F238E27FC236}">
-                <a16:creationId xmlns:a16="http://schemas.microsoft.com/office/drawing/2014/main" id="{EFDA7603-6F23-8FDE-4739-4329DCEECAAF}"/>
+                <a16:creationId xmlns:a16="http://schemas.microsoft.com/office/drawing/2014/main" id="{4CFC3B33-C924-AA15-13AD-3E1AEE24FAFB}"/>
               </a:ext>
             </a:extLst>
           </p:cNvPr>
@@ -7443,7 +7444,7 @@
           <p:cNvPr id="7" name="Rectángulo: esquinas redondeadas 6">
             <a:extLst>
               <a:ext uri="{FF2B5EF4-FFF2-40B4-BE49-F238E27FC236}">
-                <a16:creationId xmlns:a16="http://schemas.microsoft.com/office/drawing/2014/main" id="{9A15C0D5-FDC4-4504-D1F8-E4A2FE1A3328}"/>
+                <a16:creationId xmlns:a16="http://schemas.microsoft.com/office/drawing/2014/main" id="{2F725FE4-EE80-E705-733E-B8BD19D194B1}"/>
               </a:ext>
             </a:extLst>
           </p:cNvPr>
@@ -7497,7 +7498,7 @@
           <p:cNvPr id="8" name="CuadroTexto 7">
             <a:extLst>
               <a:ext uri="{FF2B5EF4-FFF2-40B4-BE49-F238E27FC236}">
-                <a16:creationId xmlns:a16="http://schemas.microsoft.com/office/drawing/2014/main" id="{37FBCE84-8CC1-094A-C428-27ABF7E8A252}"/>
+                <a16:creationId xmlns:a16="http://schemas.microsoft.com/office/drawing/2014/main" id="{19BDC50C-B07C-3E6B-6FCB-EFF857206AA4}"/>
               </a:ext>
             </a:extLst>
           </p:cNvPr>
@@ -7537,7 +7538,7 @@
           <p:cNvPr id="9" name="CuadroTexto 8">
             <a:extLst>
               <a:ext uri="{FF2B5EF4-FFF2-40B4-BE49-F238E27FC236}">
-                <a16:creationId xmlns:a16="http://schemas.microsoft.com/office/drawing/2014/main" id="{F4AF7EE7-7911-A572-2C5B-05F715B256F9}"/>
+                <a16:creationId xmlns:a16="http://schemas.microsoft.com/office/drawing/2014/main" id="{1FED4652-0A31-1746-AA86-527095D0AEF5}"/>
               </a:ext>
             </a:extLst>
           </p:cNvPr>
@@ -7577,7 +7578,7 @@
           <p:cNvPr id="10" name="CuadroTexto 9">
             <a:extLst>
               <a:ext uri="{FF2B5EF4-FFF2-40B4-BE49-F238E27FC236}">
-                <a16:creationId xmlns:a16="http://schemas.microsoft.com/office/drawing/2014/main" id="{A7C95394-2369-55C4-D2CE-2A57DB9AA75F}"/>
+                <a16:creationId xmlns:a16="http://schemas.microsoft.com/office/drawing/2014/main" id="{B0AB03AA-2FAA-C057-5FEE-3A78680746AD}"/>
               </a:ext>
             </a:extLst>
           </p:cNvPr>
@@ -7676,7 +7677,7 @@
     </p:spTree>
     <p:extLst>
       <p:ext uri="{BB962C8B-B14F-4D97-AF65-F5344CB8AC3E}">
-        <p14:creationId xmlns:p14="http://schemas.microsoft.com/office/powerpoint/2010/main" val="3929130074"/>
+        <p14:creationId xmlns:p14="http://schemas.microsoft.com/office/powerpoint/2010/main" val="2969850247"/>
       </p:ext>
     </p:extLst>
   </p:cSld>
@@ -7716,7 +7717,7 @@
           <p:cNvPr id="2" name="CuadroTexto 1">
             <a:extLst>
               <a:ext uri="{FF2B5EF4-FFF2-40B4-BE49-F238E27FC236}">
-                <a16:creationId xmlns:a16="http://schemas.microsoft.com/office/drawing/2014/main" id="{665A8073-6239-65F9-1C6C-90322CDDE31D}"/>
+                <a16:creationId xmlns:a16="http://schemas.microsoft.com/office/drawing/2014/main" id="{19FD5FA7-5464-0F55-FBB9-260283051AAF}"/>
               </a:ext>
             </a:extLst>
           </p:cNvPr>
@@ -7756,7 +7757,7 @@
           <p:cNvPr id="3" name="CuadroTexto 2">
             <a:extLst>
               <a:ext uri="{FF2B5EF4-FFF2-40B4-BE49-F238E27FC236}">
-                <a16:creationId xmlns:a16="http://schemas.microsoft.com/office/drawing/2014/main" id="{B3B92AC7-9997-EE69-9DB7-898BC6C47F4C}"/>
+                <a16:creationId xmlns:a16="http://schemas.microsoft.com/office/drawing/2014/main" id="{04540A0F-81BB-6B6E-665E-BB1AF62FB32B}"/>
               </a:ext>
             </a:extLst>
           </p:cNvPr>
@@ -7796,7 +7797,7 @@
           <p:cNvPr id="4" name="CuadroTexto 3">
             <a:extLst>
               <a:ext uri="{FF2B5EF4-FFF2-40B4-BE49-F238E27FC236}">
-                <a16:creationId xmlns:a16="http://schemas.microsoft.com/office/drawing/2014/main" id="{F58B302C-CB33-8D5F-76E3-FBC04A0A6D8C}"/>
+                <a16:creationId xmlns:a16="http://schemas.microsoft.com/office/drawing/2014/main" id="{2F776333-FF70-0E59-C918-59932AC0167E}"/>
               </a:ext>
             </a:extLst>
           </p:cNvPr>
@@ -7836,7 +7837,7 @@
           <p:cNvPr id="6" name="Imagen 5">
             <a:extLst>
               <a:ext uri="{FF2B5EF4-FFF2-40B4-BE49-F238E27FC236}">
-                <a16:creationId xmlns:a16="http://schemas.microsoft.com/office/drawing/2014/main" id="{04CBA8D3-B8F9-B6B5-A27C-6259828AE60B}"/>
+                <a16:creationId xmlns:a16="http://schemas.microsoft.com/office/drawing/2014/main" id="{EBCEFCB2-6ADC-65CC-1676-0012BD8233D3}"/>
               </a:ext>
             </a:extLst>
           </p:cNvPr>
@@ -7877,7 +7878,7 @@
           <p:cNvPr id="7" name="CuadroTexto 6">
             <a:extLst>
               <a:ext uri="{FF2B5EF4-FFF2-40B4-BE49-F238E27FC236}">
-                <a16:creationId xmlns:a16="http://schemas.microsoft.com/office/drawing/2014/main" id="{1833379E-51BC-F9B4-C7BE-852BC8012B08}"/>
+                <a16:creationId xmlns:a16="http://schemas.microsoft.com/office/drawing/2014/main" id="{5D27201E-7566-1F3B-FBFA-980DCA2F132D}"/>
               </a:ext>
             </a:extLst>
           </p:cNvPr>
@@ -7994,7 +7995,7 @@
     </p:spTree>
     <p:extLst>
       <p:ext uri="{BB962C8B-B14F-4D97-AF65-F5344CB8AC3E}">
-        <p14:creationId xmlns:p14="http://schemas.microsoft.com/office/powerpoint/2010/main" val="4243507258"/>
+        <p14:creationId xmlns:p14="http://schemas.microsoft.com/office/powerpoint/2010/main" val="1815112305"/>
       </p:ext>
     </p:extLst>
   </p:cSld>
@@ -8034,7 +8035,7 @@
           <p:cNvPr id="2" name="CuadroTexto 1">
             <a:extLst>
               <a:ext uri="{FF2B5EF4-FFF2-40B4-BE49-F238E27FC236}">
-                <a16:creationId xmlns:a16="http://schemas.microsoft.com/office/drawing/2014/main" id="{33C423A3-4388-C51F-DADE-9D4EC766E6E4}"/>
+                <a16:creationId xmlns:a16="http://schemas.microsoft.com/office/drawing/2014/main" id="{AFD47552-F4DE-499A-DE40-2256F2331396}"/>
               </a:ext>
             </a:extLst>
           </p:cNvPr>
@@ -8074,7 +8075,7 @@
           <p:cNvPr id="3" name="CuadroTexto 2">
             <a:extLst>
               <a:ext uri="{FF2B5EF4-FFF2-40B4-BE49-F238E27FC236}">
-                <a16:creationId xmlns:a16="http://schemas.microsoft.com/office/drawing/2014/main" id="{A48F09ED-E24D-5D7F-1296-BAE484F0BCB9}"/>
+                <a16:creationId xmlns:a16="http://schemas.microsoft.com/office/drawing/2014/main" id="{8DF0082D-725A-7FE7-1B3A-879B7390E6C4}"/>
               </a:ext>
             </a:extLst>
           </p:cNvPr>
@@ -8114,7 +8115,7 @@
           <p:cNvPr id="4" name="CuadroTexto 3">
             <a:extLst>
               <a:ext uri="{FF2B5EF4-FFF2-40B4-BE49-F238E27FC236}">
-                <a16:creationId xmlns:a16="http://schemas.microsoft.com/office/drawing/2014/main" id="{88E90382-8740-CA42-533D-FA81BA70D83E}"/>
+                <a16:creationId xmlns:a16="http://schemas.microsoft.com/office/drawing/2014/main" id="{9FFA8DC3-3D1B-691B-6DB7-28089BD77DCA}"/>
               </a:ext>
             </a:extLst>
           </p:cNvPr>
@@ -8154,7 +8155,7 @@
           <p:cNvPr id="5" name="Rectángulo: esquinas redondeadas 4">
             <a:extLst>
               <a:ext uri="{FF2B5EF4-FFF2-40B4-BE49-F238E27FC236}">
-                <a16:creationId xmlns:a16="http://schemas.microsoft.com/office/drawing/2014/main" id="{2F4359B7-DE60-F526-D194-DF8B0395D0FC}"/>
+                <a16:creationId xmlns:a16="http://schemas.microsoft.com/office/drawing/2014/main" id="{373F8D2B-89D5-FC1C-BB0E-9198B64239E5}"/>
               </a:ext>
             </a:extLst>
           </p:cNvPr>
@@ -8208,7 +8209,7 @@
           <p:cNvPr id="6" name="CuadroTexto 5">
             <a:extLst>
               <a:ext uri="{FF2B5EF4-FFF2-40B4-BE49-F238E27FC236}">
-                <a16:creationId xmlns:a16="http://schemas.microsoft.com/office/drawing/2014/main" id="{7B670ACA-C49E-DB59-2D32-8E0275FF2D8E}"/>
+                <a16:creationId xmlns:a16="http://schemas.microsoft.com/office/drawing/2014/main" id="{0DBAEFC2-37C7-4F3A-8B07-70B483F337E4}"/>
               </a:ext>
             </a:extLst>
           </p:cNvPr>
@@ -8248,7 +8249,7 @@
           <p:cNvPr id="7" name="CuadroTexto 6">
             <a:extLst>
               <a:ext uri="{FF2B5EF4-FFF2-40B4-BE49-F238E27FC236}">
-                <a16:creationId xmlns:a16="http://schemas.microsoft.com/office/drawing/2014/main" id="{AE94ECD1-A4B1-8766-06E8-2DA31E88299A}"/>
+                <a16:creationId xmlns:a16="http://schemas.microsoft.com/office/drawing/2014/main" id="{7BBFCD5E-272D-07CD-1024-11D44C66FCE8}"/>
               </a:ext>
             </a:extLst>
           </p:cNvPr>
@@ -8316,7 +8317,7 @@
           <p:cNvPr id="8" name="CuadroTexto 7">
             <a:extLst>
               <a:ext uri="{FF2B5EF4-FFF2-40B4-BE49-F238E27FC236}">
-                <a16:creationId xmlns:a16="http://schemas.microsoft.com/office/drawing/2014/main" id="{4689625D-A50E-4153-881E-98905E45F1A3}"/>
+                <a16:creationId xmlns:a16="http://schemas.microsoft.com/office/drawing/2014/main" id="{7FF411CF-E3FF-4A1E-7D46-2BDF5F718292}"/>
               </a:ext>
             </a:extLst>
           </p:cNvPr>
@@ -8381,7 +8382,7 @@
           <p:cNvPr id="9" name="Rectángulo: esquinas redondeadas 8">
             <a:extLst>
               <a:ext uri="{FF2B5EF4-FFF2-40B4-BE49-F238E27FC236}">
-                <a16:creationId xmlns:a16="http://schemas.microsoft.com/office/drawing/2014/main" id="{4C9002FA-1C67-2655-43B6-41BB11D8F819}"/>
+                <a16:creationId xmlns:a16="http://schemas.microsoft.com/office/drawing/2014/main" id="{F2587A29-B9A4-4FFD-AA80-1F7960C9C445}"/>
               </a:ext>
             </a:extLst>
           </p:cNvPr>
@@ -8435,7 +8436,7 @@
           <p:cNvPr id="10" name="CuadroTexto 9">
             <a:extLst>
               <a:ext uri="{FF2B5EF4-FFF2-40B4-BE49-F238E27FC236}">
-                <a16:creationId xmlns:a16="http://schemas.microsoft.com/office/drawing/2014/main" id="{25F2CB4D-004F-60FD-B354-33CE6585EB10}"/>
+                <a16:creationId xmlns:a16="http://schemas.microsoft.com/office/drawing/2014/main" id="{668568C2-8586-18FF-0C23-A4B0E19AE53C}"/>
               </a:ext>
             </a:extLst>
           </p:cNvPr>
@@ -8475,7 +8476,7 @@
           <p:cNvPr id="11" name="CuadroTexto 10">
             <a:extLst>
               <a:ext uri="{FF2B5EF4-FFF2-40B4-BE49-F238E27FC236}">
-                <a16:creationId xmlns:a16="http://schemas.microsoft.com/office/drawing/2014/main" id="{D80D563F-D839-D782-7232-C48939CFD72A}"/>
+                <a16:creationId xmlns:a16="http://schemas.microsoft.com/office/drawing/2014/main" id="{9DB5C474-BBE3-C1CE-D7B5-B6FC2DC34EB1}"/>
               </a:ext>
             </a:extLst>
           </p:cNvPr>
@@ -8512,7 +8513,7 @@
                 </a:solidFill>
                 <a:latin typeface="Segoe UI" panose="020B0502040204020203" pitchFamily="34" charset="0"/>
               </a:rPr>
-              <a:t>ADMIN: control completo.</a:t>
+              <a:t>ADMIN: control total y borrado controlado.</a:t>
             </a:r>
           </a:p>
           <a:p>
@@ -8530,7 +8531,7 @@
                 </a:solidFill>
                 <a:latin typeface="Segoe UI" panose="020B0502040204020203" pitchFamily="34" charset="0"/>
               </a:rPr>
-              <a:t>COORDINATOR: flujo academico.</a:t>
+              <a:t>PROFESOR/COORDINATOR: gestion diaria sin eliminar.</a:t>
             </a:r>
           </a:p>
           <a:p>
@@ -8594,7 +8595,7 @@
           <p:cNvPr id="12" name="CuadroTexto 11">
             <a:extLst>
               <a:ext uri="{FF2B5EF4-FFF2-40B4-BE49-F238E27FC236}">
-                <a16:creationId xmlns:a16="http://schemas.microsoft.com/office/drawing/2014/main" id="{1C487B9B-BA48-A165-770D-45103B967366}"/>
+                <a16:creationId xmlns:a16="http://schemas.microsoft.com/office/drawing/2014/main" id="{ECBA3C86-1BF8-118E-CF9C-824D54F5D9C1}"/>
               </a:ext>
             </a:extLst>
           </p:cNvPr>
@@ -8624,7 +8625,7 @@
                 </a:solidFill>
                 <a:latin typeface="Segoe UI" panose="020B0502040204020203" pitchFamily="34" charset="0"/>
               </a:rPr>
-              <a:t>Futuro: permisos finos y perfiles de solo lectura.</a:t>
+              <a:t>Futuro: matriz fina de permisos y perfiles de solo lectura.</a:t>
             </a:r>
           </a:p>
         </p:txBody>
@@ -8634,7 +8635,7 @@
           <p:cNvPr id="13" name="CuadroTexto 12">
             <a:extLst>
               <a:ext uri="{FF2B5EF4-FFF2-40B4-BE49-F238E27FC236}">
-                <a16:creationId xmlns:a16="http://schemas.microsoft.com/office/drawing/2014/main" id="{39EFF52E-0F4E-D6D1-C885-16A79F83F54C}"/>
+                <a16:creationId xmlns:a16="http://schemas.microsoft.com/office/drawing/2014/main" id="{60D31EF2-28FD-3A18-08F0-C986069F5FA6}"/>
               </a:ext>
             </a:extLst>
           </p:cNvPr>
@@ -8672,7 +8673,7 @@
     </p:spTree>
     <p:extLst>
       <p:ext uri="{BB962C8B-B14F-4D97-AF65-F5344CB8AC3E}">
-        <p14:creationId xmlns:p14="http://schemas.microsoft.com/office/powerpoint/2010/main" val="2832636802"/>
+        <p14:creationId xmlns:p14="http://schemas.microsoft.com/office/powerpoint/2010/main" val="2572257841"/>
       </p:ext>
     </p:extLst>
   </p:cSld>
@@ -8712,7 +8713,7 @@
           <p:cNvPr id="2" name="CuadroTexto 1">
             <a:extLst>
               <a:ext uri="{FF2B5EF4-FFF2-40B4-BE49-F238E27FC236}">
-                <a16:creationId xmlns:a16="http://schemas.microsoft.com/office/drawing/2014/main" id="{C0AF8DE1-B239-16D5-E9CA-03C623C151A9}"/>
+                <a16:creationId xmlns:a16="http://schemas.microsoft.com/office/drawing/2014/main" id="{9181E053-23ED-228D-440D-CA0AFF0D7BB8}"/>
               </a:ext>
             </a:extLst>
           </p:cNvPr>
@@ -8752,7 +8753,7 @@
           <p:cNvPr id="3" name="CuadroTexto 2">
             <a:extLst>
               <a:ext uri="{FF2B5EF4-FFF2-40B4-BE49-F238E27FC236}">
-                <a16:creationId xmlns:a16="http://schemas.microsoft.com/office/drawing/2014/main" id="{2F093064-14A1-B9A3-BF8C-3FAB78E7AE1E}"/>
+                <a16:creationId xmlns:a16="http://schemas.microsoft.com/office/drawing/2014/main" id="{CFB01A7A-D136-65B7-0ECA-61B658C1B26F}"/>
               </a:ext>
             </a:extLst>
           </p:cNvPr>
@@ -8792,7 +8793,7 @@
           <p:cNvPr id="4" name="Rectángulo: esquinas redondeadas 3">
             <a:extLst>
               <a:ext uri="{FF2B5EF4-FFF2-40B4-BE49-F238E27FC236}">
-                <a16:creationId xmlns:a16="http://schemas.microsoft.com/office/drawing/2014/main" id="{63761DE4-6D25-4140-CE56-872F995317C7}"/>
+                <a16:creationId xmlns:a16="http://schemas.microsoft.com/office/drawing/2014/main" id="{8FE81F4D-C7C7-3E6F-CF57-EB657BF88809}"/>
               </a:ext>
             </a:extLst>
           </p:cNvPr>
@@ -8846,7 +8847,7 @@
           <p:cNvPr id="5" name="CuadroTexto 4">
             <a:extLst>
               <a:ext uri="{FF2B5EF4-FFF2-40B4-BE49-F238E27FC236}">
-                <a16:creationId xmlns:a16="http://schemas.microsoft.com/office/drawing/2014/main" id="{0E57D432-7F74-4C12-D53A-5EB9BD8334C9}"/>
+                <a16:creationId xmlns:a16="http://schemas.microsoft.com/office/drawing/2014/main" id="{DDC58341-C275-8216-0E6D-790EA5952D97}"/>
               </a:ext>
             </a:extLst>
           </p:cNvPr>
@@ -8886,7 +8887,7 @@
           <p:cNvPr id="6" name="CuadroTexto 5">
             <a:extLst>
               <a:ext uri="{FF2B5EF4-FFF2-40B4-BE49-F238E27FC236}">
-                <a16:creationId xmlns:a16="http://schemas.microsoft.com/office/drawing/2014/main" id="{5D498C38-9036-F97F-DE91-B9F00BC7CE9D}"/>
+                <a16:creationId xmlns:a16="http://schemas.microsoft.com/office/drawing/2014/main" id="{05AFB7DA-0210-E985-7339-D72B37FD80F1}"/>
               </a:ext>
             </a:extLst>
           </p:cNvPr>
@@ -8926,7 +8927,7 @@
           <p:cNvPr id="7" name="Rectángulo: esquinas redondeadas 6">
             <a:extLst>
               <a:ext uri="{FF2B5EF4-FFF2-40B4-BE49-F238E27FC236}">
-                <a16:creationId xmlns:a16="http://schemas.microsoft.com/office/drawing/2014/main" id="{C8DBBF70-4C21-DAF6-D05F-874C7F497F53}"/>
+                <a16:creationId xmlns:a16="http://schemas.microsoft.com/office/drawing/2014/main" id="{5BC5C267-9F37-6A95-4F2E-8D263982DD5C}"/>
               </a:ext>
             </a:extLst>
           </p:cNvPr>
@@ -8980,7 +8981,7 @@
           <p:cNvPr id="8" name="CuadroTexto 7">
             <a:extLst>
               <a:ext uri="{FF2B5EF4-FFF2-40B4-BE49-F238E27FC236}">
-                <a16:creationId xmlns:a16="http://schemas.microsoft.com/office/drawing/2014/main" id="{A526B1A9-4089-5A30-4816-E8C67EB43E97}"/>
+                <a16:creationId xmlns:a16="http://schemas.microsoft.com/office/drawing/2014/main" id="{378CAC00-EC29-EE50-6D61-1C72B8A3DAAE}"/>
               </a:ext>
             </a:extLst>
           </p:cNvPr>
@@ -9020,7 +9021,7 @@
           <p:cNvPr id="9" name="CuadroTexto 8">
             <a:extLst>
               <a:ext uri="{FF2B5EF4-FFF2-40B4-BE49-F238E27FC236}">
-                <a16:creationId xmlns:a16="http://schemas.microsoft.com/office/drawing/2014/main" id="{3B29706D-9BC8-B098-DE32-38B5805D1DCE}"/>
+                <a16:creationId xmlns:a16="http://schemas.microsoft.com/office/drawing/2014/main" id="{EF4ABBA0-6AB1-9834-29B3-8CDFB412AFC5}"/>
               </a:ext>
             </a:extLst>
           </p:cNvPr>
@@ -9060,7 +9061,7 @@
           <p:cNvPr id="10" name="Rectángulo: esquinas redondeadas 9">
             <a:extLst>
               <a:ext uri="{FF2B5EF4-FFF2-40B4-BE49-F238E27FC236}">
-                <a16:creationId xmlns:a16="http://schemas.microsoft.com/office/drawing/2014/main" id="{8A4C206B-7D02-4F76-5F20-62CBEC6B6869}"/>
+                <a16:creationId xmlns:a16="http://schemas.microsoft.com/office/drawing/2014/main" id="{B6F28170-51E2-D69A-4D57-41AF4975C3A9}"/>
               </a:ext>
             </a:extLst>
           </p:cNvPr>
@@ -9114,7 +9115,7 @@
           <p:cNvPr id="11" name="CuadroTexto 10">
             <a:extLst>
               <a:ext uri="{FF2B5EF4-FFF2-40B4-BE49-F238E27FC236}">
-                <a16:creationId xmlns:a16="http://schemas.microsoft.com/office/drawing/2014/main" id="{64315C01-1D97-E8B7-D926-848F5C4D1060}"/>
+                <a16:creationId xmlns:a16="http://schemas.microsoft.com/office/drawing/2014/main" id="{24666E30-5AB4-AC8E-CE68-FCBDB0FB430F}"/>
               </a:ext>
             </a:extLst>
           </p:cNvPr>
@@ -9154,7 +9155,7 @@
           <p:cNvPr id="12" name="CuadroTexto 11">
             <a:extLst>
               <a:ext uri="{FF2B5EF4-FFF2-40B4-BE49-F238E27FC236}">
-                <a16:creationId xmlns:a16="http://schemas.microsoft.com/office/drawing/2014/main" id="{1BB8BE17-E927-0168-99FE-74822B2B6787}"/>
+                <a16:creationId xmlns:a16="http://schemas.microsoft.com/office/drawing/2014/main" id="{36348C31-62AD-BBB3-6790-61D4744A8955}"/>
               </a:ext>
             </a:extLst>
           </p:cNvPr>
@@ -9194,7 +9195,7 @@
           <p:cNvPr id="13" name="Rectángulo: esquinas redondeadas 12">
             <a:extLst>
               <a:ext uri="{FF2B5EF4-FFF2-40B4-BE49-F238E27FC236}">
-                <a16:creationId xmlns:a16="http://schemas.microsoft.com/office/drawing/2014/main" id="{C483D33C-3B97-9682-993E-A27AA1109E4C}"/>
+                <a16:creationId xmlns:a16="http://schemas.microsoft.com/office/drawing/2014/main" id="{B6940724-E536-E0CC-E667-E38913CFD86C}"/>
               </a:ext>
             </a:extLst>
           </p:cNvPr>
@@ -9248,7 +9249,7 @@
           <p:cNvPr id="14" name="CuadroTexto 13">
             <a:extLst>
               <a:ext uri="{FF2B5EF4-FFF2-40B4-BE49-F238E27FC236}">
-                <a16:creationId xmlns:a16="http://schemas.microsoft.com/office/drawing/2014/main" id="{8A47BC40-1740-DD17-DDAD-74215E9C786C}"/>
+                <a16:creationId xmlns:a16="http://schemas.microsoft.com/office/drawing/2014/main" id="{1C87AD53-3F7F-B875-FEFB-F279BA568172}"/>
               </a:ext>
             </a:extLst>
           </p:cNvPr>
@@ -9288,7 +9289,7 @@
           <p:cNvPr id="15" name="CuadroTexto 14">
             <a:extLst>
               <a:ext uri="{FF2B5EF4-FFF2-40B4-BE49-F238E27FC236}">
-                <a16:creationId xmlns:a16="http://schemas.microsoft.com/office/drawing/2014/main" id="{CCB5C112-73AA-1592-824D-6B94A154D447}"/>
+                <a16:creationId xmlns:a16="http://schemas.microsoft.com/office/drawing/2014/main" id="{541C0BAF-7030-4AAF-4806-10297A8BC990}"/>
               </a:ext>
             </a:extLst>
           </p:cNvPr>
@@ -9328,7 +9329,7 @@
           <p:cNvPr id="16" name="CuadroTexto 15">
             <a:extLst>
               <a:ext uri="{FF2B5EF4-FFF2-40B4-BE49-F238E27FC236}">
-                <a16:creationId xmlns:a16="http://schemas.microsoft.com/office/drawing/2014/main" id="{C2F7DDF2-1E8B-6D53-9FC1-16DE85B754EA}"/>
+                <a16:creationId xmlns:a16="http://schemas.microsoft.com/office/drawing/2014/main" id="{68BA2DAB-B3A5-6060-8B0B-8FC5EB78DBE0}"/>
               </a:ext>
             </a:extLst>
           </p:cNvPr>
@@ -9411,7 +9412,7 @@
           <p:cNvPr id="17" name="CuadroTexto 16">
             <a:extLst>
               <a:ext uri="{FF2B5EF4-FFF2-40B4-BE49-F238E27FC236}">
-                <a16:creationId xmlns:a16="http://schemas.microsoft.com/office/drawing/2014/main" id="{DD276DE3-694C-571E-3D3B-4DC79A6A5CC6}"/>
+                <a16:creationId xmlns:a16="http://schemas.microsoft.com/office/drawing/2014/main" id="{FA357313-1CF2-48DC-F6BE-547CEA02515E}"/>
               </a:ext>
             </a:extLst>
           </p:cNvPr>
@@ -9449,7 +9450,7 @@
     </p:spTree>
     <p:extLst>
       <p:ext uri="{BB962C8B-B14F-4D97-AF65-F5344CB8AC3E}">
-        <p14:creationId xmlns:p14="http://schemas.microsoft.com/office/powerpoint/2010/main" val="1089190011"/>
+        <p14:creationId xmlns:p14="http://schemas.microsoft.com/office/powerpoint/2010/main" val="3698168155"/>
       </p:ext>
     </p:extLst>
   </p:cSld>
@@ -9489,7 +9490,7 @@
           <p:cNvPr id="2" name="CuadroTexto 1">
             <a:extLst>
               <a:ext uri="{FF2B5EF4-FFF2-40B4-BE49-F238E27FC236}">
-                <a16:creationId xmlns:a16="http://schemas.microsoft.com/office/drawing/2014/main" id="{1287D721-EA82-3258-D9E0-06BF24F3B93A}"/>
+                <a16:creationId xmlns:a16="http://schemas.microsoft.com/office/drawing/2014/main" id="{1ABADE8C-DE49-448C-CABA-CDA5632FAAC2}"/>
               </a:ext>
             </a:extLst>
           </p:cNvPr>
@@ -9529,7 +9530,7 @@
           <p:cNvPr id="3" name="CuadroTexto 2">
             <a:extLst>
               <a:ext uri="{FF2B5EF4-FFF2-40B4-BE49-F238E27FC236}">
-                <a16:creationId xmlns:a16="http://schemas.microsoft.com/office/drawing/2014/main" id="{0E527FF5-ACB5-73F1-05A8-B65174048BAD}"/>
+                <a16:creationId xmlns:a16="http://schemas.microsoft.com/office/drawing/2014/main" id="{AFD6AEDB-AB31-E63C-D2C2-ECD5B06F856C}"/>
               </a:ext>
             </a:extLst>
           </p:cNvPr>
@@ -9569,7 +9570,7 @@
           <p:cNvPr id="4" name="CuadroTexto 3">
             <a:extLst>
               <a:ext uri="{FF2B5EF4-FFF2-40B4-BE49-F238E27FC236}">
-                <a16:creationId xmlns:a16="http://schemas.microsoft.com/office/drawing/2014/main" id="{2F93B62E-C7D2-9617-F6D3-704940E41714}"/>
+                <a16:creationId xmlns:a16="http://schemas.microsoft.com/office/drawing/2014/main" id="{73B58CCF-3037-702B-D744-9F03BA8FFCB4}"/>
               </a:ext>
             </a:extLst>
           </p:cNvPr>
@@ -9609,7 +9610,7 @@
           <p:cNvPr id="5" name="Rectángulo: esquinas redondeadas 4">
             <a:extLst>
               <a:ext uri="{FF2B5EF4-FFF2-40B4-BE49-F238E27FC236}">
-                <a16:creationId xmlns:a16="http://schemas.microsoft.com/office/drawing/2014/main" id="{BF712BBC-3C83-CDC9-BFB3-3F0BEE120852}"/>
+                <a16:creationId xmlns:a16="http://schemas.microsoft.com/office/drawing/2014/main" id="{90C76186-1F29-9F2F-A945-BB5FB4039EBA}"/>
               </a:ext>
             </a:extLst>
           </p:cNvPr>
@@ -9663,7 +9664,7 @@
           <p:cNvPr id="6" name="CuadroTexto 5">
             <a:extLst>
               <a:ext uri="{FF2B5EF4-FFF2-40B4-BE49-F238E27FC236}">
-                <a16:creationId xmlns:a16="http://schemas.microsoft.com/office/drawing/2014/main" id="{DD15D1A6-5DF5-115E-F6B3-4EBB83269791}"/>
+                <a16:creationId xmlns:a16="http://schemas.microsoft.com/office/drawing/2014/main" id="{D7ABB99F-D9C9-5AD5-F16B-7A15E34428F0}"/>
               </a:ext>
             </a:extLst>
           </p:cNvPr>
@@ -9703,7 +9704,7 @@
           <p:cNvPr id="7" name="CuadroTexto 6">
             <a:extLst>
               <a:ext uri="{FF2B5EF4-FFF2-40B4-BE49-F238E27FC236}">
-                <a16:creationId xmlns:a16="http://schemas.microsoft.com/office/drawing/2014/main" id="{374CE008-3C84-A8F8-324C-522CB7693EB1}"/>
+                <a16:creationId xmlns:a16="http://schemas.microsoft.com/office/drawing/2014/main" id="{8BF610C2-5144-60DC-D2C7-64109F39EA59}"/>
               </a:ext>
             </a:extLst>
           </p:cNvPr>
@@ -9743,7 +9744,7 @@
           <p:cNvPr id="8" name="Rectángulo: esquinas redondeadas 7">
             <a:extLst>
               <a:ext uri="{FF2B5EF4-FFF2-40B4-BE49-F238E27FC236}">
-                <a16:creationId xmlns:a16="http://schemas.microsoft.com/office/drawing/2014/main" id="{39DBD13E-D0FA-3F44-9EE2-1A89282CD510}"/>
+                <a16:creationId xmlns:a16="http://schemas.microsoft.com/office/drawing/2014/main" id="{F2CAD6C9-1FA0-53BC-A7BF-225AD29131CB}"/>
               </a:ext>
             </a:extLst>
           </p:cNvPr>
@@ -9797,7 +9798,7 @@
           <p:cNvPr id="9" name="CuadroTexto 8">
             <a:extLst>
               <a:ext uri="{FF2B5EF4-FFF2-40B4-BE49-F238E27FC236}">
-                <a16:creationId xmlns:a16="http://schemas.microsoft.com/office/drawing/2014/main" id="{3206CB05-CB6D-D46A-1185-180D4A1AA861}"/>
+                <a16:creationId xmlns:a16="http://schemas.microsoft.com/office/drawing/2014/main" id="{C68E2C34-6864-1336-405C-5C8EB878F372}"/>
               </a:ext>
             </a:extLst>
           </p:cNvPr>
@@ -9837,7 +9838,7 @@
           <p:cNvPr id="10" name="CuadroTexto 9">
             <a:extLst>
               <a:ext uri="{FF2B5EF4-FFF2-40B4-BE49-F238E27FC236}">
-                <a16:creationId xmlns:a16="http://schemas.microsoft.com/office/drawing/2014/main" id="{FD09B2F5-C6FE-E8EE-FEF4-1AF5DBCC9682}"/>
+                <a16:creationId xmlns:a16="http://schemas.microsoft.com/office/drawing/2014/main" id="{492FA47F-1121-DAFE-BC66-9106F6140117}"/>
               </a:ext>
             </a:extLst>
           </p:cNvPr>
@@ -9877,7 +9878,7 @@
           <p:cNvPr id="11" name="CuadroTexto 10">
             <a:extLst>
               <a:ext uri="{FF2B5EF4-FFF2-40B4-BE49-F238E27FC236}">
-                <a16:creationId xmlns:a16="http://schemas.microsoft.com/office/drawing/2014/main" id="{4594DBE3-D6DE-7549-B739-6AC4368FB548}"/>
+                <a16:creationId xmlns:a16="http://schemas.microsoft.com/office/drawing/2014/main" id="{76F86ECE-9849-6F14-66F9-E03F50C84A8F}"/>
               </a:ext>
             </a:extLst>
           </p:cNvPr>
@@ -9917,7 +9918,7 @@
           <p:cNvPr id="12" name="CuadroTexto 11">
             <a:extLst>
               <a:ext uri="{FF2B5EF4-FFF2-40B4-BE49-F238E27FC236}">
-                <a16:creationId xmlns:a16="http://schemas.microsoft.com/office/drawing/2014/main" id="{8C067BEA-4AA0-83FA-66EF-CAB7D2066781}"/>
+                <a16:creationId xmlns:a16="http://schemas.microsoft.com/office/drawing/2014/main" id="{BAC49FB8-BADC-635E-1D4D-E5940676DB50}"/>
               </a:ext>
             </a:extLst>
           </p:cNvPr>
@@ -9998,7 +9999,7 @@
     </p:spTree>
     <p:extLst>
       <p:ext uri="{BB962C8B-B14F-4D97-AF65-F5344CB8AC3E}">
-        <p14:creationId xmlns:p14="http://schemas.microsoft.com/office/powerpoint/2010/main" val="3322175799"/>
+        <p14:creationId xmlns:p14="http://schemas.microsoft.com/office/powerpoint/2010/main" val="1085781378"/>
       </p:ext>
     </p:extLst>
   </p:cSld>
@@ -10038,7 +10039,7 @@
           <p:cNvPr id="2" name="CuadroTexto 1">
             <a:extLst>
               <a:ext uri="{FF2B5EF4-FFF2-40B4-BE49-F238E27FC236}">
-                <a16:creationId xmlns:a16="http://schemas.microsoft.com/office/drawing/2014/main" id="{2BFAB474-5537-AE3E-3A88-F8567A2A1B9E}"/>
+                <a16:creationId xmlns:a16="http://schemas.microsoft.com/office/drawing/2014/main" id="{F8A264FD-737B-068C-79C8-C2C30AFE42F8}"/>
               </a:ext>
             </a:extLst>
           </p:cNvPr>
@@ -10078,7 +10079,7 @@
           <p:cNvPr id="3" name="CuadroTexto 2">
             <a:extLst>
               <a:ext uri="{FF2B5EF4-FFF2-40B4-BE49-F238E27FC236}">
-                <a16:creationId xmlns:a16="http://schemas.microsoft.com/office/drawing/2014/main" id="{E5C95DB2-EFA2-1525-9158-A95ECCE84CB5}"/>
+                <a16:creationId xmlns:a16="http://schemas.microsoft.com/office/drawing/2014/main" id="{076F2623-B7C6-832D-5400-16D3ED616B6A}"/>
               </a:ext>
             </a:extLst>
           </p:cNvPr>
@@ -10118,7 +10119,7 @@
           <p:cNvPr id="4" name="CuadroTexto 3">
             <a:extLst>
               <a:ext uri="{FF2B5EF4-FFF2-40B4-BE49-F238E27FC236}">
-                <a16:creationId xmlns:a16="http://schemas.microsoft.com/office/drawing/2014/main" id="{4B0D9C06-0E88-E908-29DD-25F99F08FEE5}"/>
+                <a16:creationId xmlns:a16="http://schemas.microsoft.com/office/drawing/2014/main" id="{33B01CAF-399D-92F4-DA4B-026BF9F8FEEB}"/>
               </a:ext>
             </a:extLst>
           </p:cNvPr>
@@ -10158,7 +10159,7 @@
           <p:cNvPr id="5" name="Rectángulo: esquinas redondeadas 4">
             <a:extLst>
               <a:ext uri="{FF2B5EF4-FFF2-40B4-BE49-F238E27FC236}">
-                <a16:creationId xmlns:a16="http://schemas.microsoft.com/office/drawing/2014/main" id="{78B59249-5894-ADE8-DD01-8256B57A070B}"/>
+                <a16:creationId xmlns:a16="http://schemas.microsoft.com/office/drawing/2014/main" id="{3CADEB5F-5440-2073-99A5-F86BF3B611D0}"/>
               </a:ext>
             </a:extLst>
           </p:cNvPr>
@@ -10212,7 +10213,7 @@
           <p:cNvPr id="6" name="CuadroTexto 5">
             <a:extLst>
               <a:ext uri="{FF2B5EF4-FFF2-40B4-BE49-F238E27FC236}">
-                <a16:creationId xmlns:a16="http://schemas.microsoft.com/office/drawing/2014/main" id="{908EBB94-E119-2A1B-E721-7AF4C37B22E8}"/>
+                <a16:creationId xmlns:a16="http://schemas.microsoft.com/office/drawing/2014/main" id="{580D7E94-1C23-4206-16B6-9404A6981FEB}"/>
               </a:ext>
             </a:extLst>
           </p:cNvPr>
@@ -10252,7 +10253,7 @@
           <p:cNvPr id="7" name="CuadroTexto 6">
             <a:extLst>
               <a:ext uri="{FF2B5EF4-FFF2-40B4-BE49-F238E27FC236}">
-                <a16:creationId xmlns:a16="http://schemas.microsoft.com/office/drawing/2014/main" id="{82CBC56E-19C3-21B5-E68A-A23A7569E3F0}"/>
+                <a16:creationId xmlns:a16="http://schemas.microsoft.com/office/drawing/2014/main" id="{A9337943-C5F0-91EA-837B-6BC88712ACF7}"/>
               </a:ext>
             </a:extLst>
           </p:cNvPr>
@@ -10353,7 +10354,7 @@
           <p:cNvPr id="8" name="Rectángulo: esquinas redondeadas 7">
             <a:extLst>
               <a:ext uri="{FF2B5EF4-FFF2-40B4-BE49-F238E27FC236}">
-                <a16:creationId xmlns:a16="http://schemas.microsoft.com/office/drawing/2014/main" id="{26B9D7A7-87F7-AEEA-F459-E57B56F911E7}"/>
+                <a16:creationId xmlns:a16="http://schemas.microsoft.com/office/drawing/2014/main" id="{A67DD423-27AB-06FD-E088-AF2D6DC92A1D}"/>
               </a:ext>
             </a:extLst>
           </p:cNvPr>
@@ -10407,7 +10408,7 @@
           <p:cNvPr id="9" name="CuadroTexto 8">
             <a:extLst>
               <a:ext uri="{FF2B5EF4-FFF2-40B4-BE49-F238E27FC236}">
-                <a16:creationId xmlns:a16="http://schemas.microsoft.com/office/drawing/2014/main" id="{8294099B-B43E-F512-F22F-AB0602A6DB11}"/>
+                <a16:creationId xmlns:a16="http://schemas.microsoft.com/office/drawing/2014/main" id="{08EC8CA5-18F5-1F01-1D31-8C0E7AAA3954}"/>
               </a:ext>
             </a:extLst>
           </p:cNvPr>
@@ -10447,7 +10448,7 @@
           <p:cNvPr id="10" name="CuadroTexto 9">
             <a:extLst>
               <a:ext uri="{FF2B5EF4-FFF2-40B4-BE49-F238E27FC236}">
-                <a16:creationId xmlns:a16="http://schemas.microsoft.com/office/drawing/2014/main" id="{5D878BA8-7AE1-A834-15FC-442DB01045D8}"/>
+                <a16:creationId xmlns:a16="http://schemas.microsoft.com/office/drawing/2014/main" id="{CD5A78DE-C792-F232-83AC-1EEC05CA7C7F}"/>
               </a:ext>
             </a:extLst>
           </p:cNvPr>
@@ -10487,7 +10488,7 @@
           <p:cNvPr id="11" name="Rectángulo: esquinas redondeadas 10">
             <a:extLst>
               <a:ext uri="{FF2B5EF4-FFF2-40B4-BE49-F238E27FC236}">
-                <a16:creationId xmlns:a16="http://schemas.microsoft.com/office/drawing/2014/main" id="{A404FCF0-B147-152A-01F1-D9B2EFEF7A58}"/>
+                <a16:creationId xmlns:a16="http://schemas.microsoft.com/office/drawing/2014/main" id="{A2784C63-DA89-099D-2D74-7DED300D48D4}"/>
               </a:ext>
             </a:extLst>
           </p:cNvPr>
@@ -10541,7 +10542,7 @@
           <p:cNvPr id="12" name="CuadroTexto 11">
             <a:extLst>
               <a:ext uri="{FF2B5EF4-FFF2-40B4-BE49-F238E27FC236}">
-                <a16:creationId xmlns:a16="http://schemas.microsoft.com/office/drawing/2014/main" id="{1E0BC87B-6577-4114-4A08-60D7568CD9CB}"/>
+                <a16:creationId xmlns:a16="http://schemas.microsoft.com/office/drawing/2014/main" id="{B2580B95-7524-6CE1-8C59-EEDFC5F74E2E}"/>
               </a:ext>
             </a:extLst>
           </p:cNvPr>
@@ -10581,7 +10582,7 @@
           <p:cNvPr id="13" name="CuadroTexto 12">
             <a:extLst>
               <a:ext uri="{FF2B5EF4-FFF2-40B4-BE49-F238E27FC236}">
-                <a16:creationId xmlns:a16="http://schemas.microsoft.com/office/drawing/2014/main" id="{7F726083-9450-48F8-A946-91D832AD10D5}"/>
+                <a16:creationId xmlns:a16="http://schemas.microsoft.com/office/drawing/2014/main" id="{89DFE1C8-6F36-9296-8851-266E3778F70E}"/>
               </a:ext>
             </a:extLst>
           </p:cNvPr>
@@ -10621,7 +10622,7 @@
           <p:cNvPr id="14" name="Rectángulo: esquinas redondeadas 13">
             <a:extLst>
               <a:ext uri="{FF2B5EF4-FFF2-40B4-BE49-F238E27FC236}">
-                <a16:creationId xmlns:a16="http://schemas.microsoft.com/office/drawing/2014/main" id="{C6CEFB94-0FC8-0A65-0F70-5BC718D9427E}"/>
+                <a16:creationId xmlns:a16="http://schemas.microsoft.com/office/drawing/2014/main" id="{EDE3EE0C-A662-56F4-B10D-E5DC7D8AD056}"/>
               </a:ext>
             </a:extLst>
           </p:cNvPr>
@@ -10675,7 +10676,7 @@
           <p:cNvPr id="15" name="CuadroTexto 14">
             <a:extLst>
               <a:ext uri="{FF2B5EF4-FFF2-40B4-BE49-F238E27FC236}">
-                <a16:creationId xmlns:a16="http://schemas.microsoft.com/office/drawing/2014/main" id="{AA529624-3471-9FE4-3689-8EDDACC6D9EB}"/>
+                <a16:creationId xmlns:a16="http://schemas.microsoft.com/office/drawing/2014/main" id="{4AD692D4-3CE2-90DD-8A0D-3A96D256F611}"/>
               </a:ext>
             </a:extLst>
           </p:cNvPr>
@@ -10715,7 +10716,7 @@
           <p:cNvPr id="16" name="CuadroTexto 15">
             <a:extLst>
               <a:ext uri="{FF2B5EF4-FFF2-40B4-BE49-F238E27FC236}">
-                <a16:creationId xmlns:a16="http://schemas.microsoft.com/office/drawing/2014/main" id="{C60C4DF2-9568-DE37-E9AA-3EDF5FE954E5}"/>
+                <a16:creationId xmlns:a16="http://schemas.microsoft.com/office/drawing/2014/main" id="{8F0F5EE7-5FEE-2E19-06A8-CC58A4B2BED6}"/>
               </a:ext>
             </a:extLst>
           </p:cNvPr>
@@ -10755,7 +10756,7 @@
           <p:cNvPr id="17" name="CuadroTexto 16">
             <a:extLst>
               <a:ext uri="{FF2B5EF4-FFF2-40B4-BE49-F238E27FC236}">
-                <a16:creationId xmlns:a16="http://schemas.microsoft.com/office/drawing/2014/main" id="{50FE0E10-B25E-2EDB-C0A4-49EA9A613296}"/>
+                <a16:creationId xmlns:a16="http://schemas.microsoft.com/office/drawing/2014/main" id="{FD324CA9-FCF0-3843-D744-E93C949DE4DD}"/>
               </a:ext>
             </a:extLst>
           </p:cNvPr>
@@ -10818,7 +10819,7 @@
     </p:spTree>
     <p:extLst>
       <p:ext uri="{BB962C8B-B14F-4D97-AF65-F5344CB8AC3E}">
-        <p14:creationId xmlns:p14="http://schemas.microsoft.com/office/powerpoint/2010/main" val="2333461286"/>
+        <p14:creationId xmlns:p14="http://schemas.microsoft.com/office/powerpoint/2010/main" val="249792066"/>
       </p:ext>
     </p:extLst>
   </p:cSld>
@@ -10858,7 +10859,7 @@
           <p:cNvPr id="2" name="CuadroTexto 1">
             <a:extLst>
               <a:ext uri="{FF2B5EF4-FFF2-40B4-BE49-F238E27FC236}">
-                <a16:creationId xmlns:a16="http://schemas.microsoft.com/office/drawing/2014/main" id="{EA79CEE5-9CE1-98E4-A3D3-AE8134AA7D3C}"/>
+                <a16:creationId xmlns:a16="http://schemas.microsoft.com/office/drawing/2014/main" id="{92847E62-E037-0DFB-7B8B-6D3653DF1BC4}"/>
               </a:ext>
             </a:extLst>
           </p:cNvPr>
@@ -10898,7 +10899,7 @@
           <p:cNvPr id="3" name="CuadroTexto 2">
             <a:extLst>
               <a:ext uri="{FF2B5EF4-FFF2-40B4-BE49-F238E27FC236}">
-                <a16:creationId xmlns:a16="http://schemas.microsoft.com/office/drawing/2014/main" id="{E788EFEB-C964-5A83-FEE2-041762E337C4}"/>
+                <a16:creationId xmlns:a16="http://schemas.microsoft.com/office/drawing/2014/main" id="{36D0EB16-EFFE-7E9A-DC49-CC1CC41C7685}"/>
               </a:ext>
             </a:extLst>
           </p:cNvPr>
@@ -10938,7 +10939,7 @@
           <p:cNvPr id="4" name="CuadroTexto 3">
             <a:extLst>
               <a:ext uri="{FF2B5EF4-FFF2-40B4-BE49-F238E27FC236}">
-                <a16:creationId xmlns:a16="http://schemas.microsoft.com/office/drawing/2014/main" id="{D673B47A-86DA-EE03-3F3A-A073F47A33A6}"/>
+                <a16:creationId xmlns:a16="http://schemas.microsoft.com/office/drawing/2014/main" id="{05A35C88-02CC-5C59-9FE2-37B6BAE4D54C}"/>
               </a:ext>
             </a:extLst>
           </p:cNvPr>
@@ -11057,7 +11058,7 @@
           <p:cNvPr id="5" name="Rectángulo: esquinas redondeadas 4">
             <a:extLst>
               <a:ext uri="{FF2B5EF4-FFF2-40B4-BE49-F238E27FC236}">
-                <a16:creationId xmlns:a16="http://schemas.microsoft.com/office/drawing/2014/main" id="{1A026D5F-0958-FF6B-DCDB-2285B2E0E37F}"/>
+                <a16:creationId xmlns:a16="http://schemas.microsoft.com/office/drawing/2014/main" id="{5FDB15B8-0153-15F2-4823-D6764D0272C3}"/>
               </a:ext>
             </a:extLst>
           </p:cNvPr>
@@ -11111,7 +11112,7 @@
           <p:cNvPr id="6" name="CuadroTexto 5">
             <a:extLst>
               <a:ext uri="{FF2B5EF4-FFF2-40B4-BE49-F238E27FC236}">
-                <a16:creationId xmlns:a16="http://schemas.microsoft.com/office/drawing/2014/main" id="{AD5C79A8-3870-A2E4-BFE6-E2956C2D970B}"/>
+                <a16:creationId xmlns:a16="http://schemas.microsoft.com/office/drawing/2014/main" id="{D081A0FC-9681-814E-AACD-96291B4030AD}"/>
               </a:ext>
             </a:extLst>
           </p:cNvPr>
@@ -11151,7 +11152,7 @@
           <p:cNvPr id="7" name="CuadroTexto 6">
             <a:extLst>
               <a:ext uri="{FF2B5EF4-FFF2-40B4-BE49-F238E27FC236}">
-                <a16:creationId xmlns:a16="http://schemas.microsoft.com/office/drawing/2014/main" id="{37426E24-BDCA-5C43-52E9-25868A35AC64}"/>
+                <a16:creationId xmlns:a16="http://schemas.microsoft.com/office/drawing/2014/main" id="{D8B24205-E331-2174-CEE9-5266DC759D41}"/>
               </a:ext>
             </a:extLst>
           </p:cNvPr>
@@ -11189,7 +11190,7 @@
     </p:spTree>
     <p:extLst>
       <p:ext uri="{BB962C8B-B14F-4D97-AF65-F5344CB8AC3E}">
-        <p14:creationId xmlns:p14="http://schemas.microsoft.com/office/powerpoint/2010/main" val="1747134379"/>
+        <p14:creationId xmlns:p14="http://schemas.microsoft.com/office/powerpoint/2010/main" val="4130983698"/>
       </p:ext>
     </p:extLst>
   </p:cSld>
@@ -11229,7 +11230,7 @@
           <p:cNvPr id="2" name="CuadroTexto 1">
             <a:extLst>
               <a:ext uri="{FF2B5EF4-FFF2-40B4-BE49-F238E27FC236}">
-                <a16:creationId xmlns:a16="http://schemas.microsoft.com/office/drawing/2014/main" id="{EF744A11-C343-6723-E086-73DE22B7C168}"/>
+                <a16:creationId xmlns:a16="http://schemas.microsoft.com/office/drawing/2014/main" id="{1CF7E6FE-9195-73D3-91B3-93A81E842A0D}"/>
               </a:ext>
             </a:extLst>
           </p:cNvPr>
@@ -11269,7 +11270,7 @@
           <p:cNvPr id="3" name="CuadroTexto 2">
             <a:extLst>
               <a:ext uri="{FF2B5EF4-FFF2-40B4-BE49-F238E27FC236}">
-                <a16:creationId xmlns:a16="http://schemas.microsoft.com/office/drawing/2014/main" id="{DC13B59A-D000-5E03-99D0-45D96061113C}"/>
+                <a16:creationId xmlns:a16="http://schemas.microsoft.com/office/drawing/2014/main" id="{DB5D7F00-45B8-C023-D096-7E37928DD88D}"/>
               </a:ext>
             </a:extLst>
           </p:cNvPr>
@@ -11309,7 +11310,7 @@
           <p:cNvPr id="4" name="CuadroTexto 3">
             <a:extLst>
               <a:ext uri="{FF2B5EF4-FFF2-40B4-BE49-F238E27FC236}">
-                <a16:creationId xmlns:a16="http://schemas.microsoft.com/office/drawing/2014/main" id="{A32CEDB8-41A5-005B-833E-077646B66155}"/>
+                <a16:creationId xmlns:a16="http://schemas.microsoft.com/office/drawing/2014/main" id="{CB7765A6-FF39-2EA1-12B9-CB343F96C79A}"/>
               </a:ext>
             </a:extLst>
           </p:cNvPr>
@@ -11349,7 +11350,7 @@
           <p:cNvPr id="5" name="CuadroTexto 4">
             <a:extLst>
               <a:ext uri="{FF2B5EF4-FFF2-40B4-BE49-F238E27FC236}">
-                <a16:creationId xmlns:a16="http://schemas.microsoft.com/office/drawing/2014/main" id="{447555E6-4BB1-4990-9C41-21473E35C63E}"/>
+                <a16:creationId xmlns:a16="http://schemas.microsoft.com/office/drawing/2014/main" id="{AB77AC6A-3AE6-C0DA-32C8-7D37BD124090}"/>
               </a:ext>
             </a:extLst>
           </p:cNvPr>
@@ -11432,7 +11433,7 @@
           <p:cNvPr id="6" name="CuadroTexto 5">
             <a:extLst>
               <a:ext uri="{FF2B5EF4-FFF2-40B4-BE49-F238E27FC236}">
-                <a16:creationId xmlns:a16="http://schemas.microsoft.com/office/drawing/2014/main" id="{2729358B-C002-34E2-3A00-E7052946587F}"/>
+                <a16:creationId xmlns:a16="http://schemas.microsoft.com/office/drawing/2014/main" id="{AFC2A68D-0100-BC09-F364-366C8904C98B}"/>
               </a:ext>
             </a:extLst>
           </p:cNvPr>
@@ -11470,7 +11471,7 @@
     </p:spTree>
     <p:extLst>
       <p:ext uri="{BB962C8B-B14F-4D97-AF65-F5344CB8AC3E}">
-        <p14:creationId xmlns:p14="http://schemas.microsoft.com/office/powerpoint/2010/main" val="3265063490"/>
+        <p14:creationId xmlns:p14="http://schemas.microsoft.com/office/powerpoint/2010/main" val="2877015233"/>
       </p:ext>
     </p:extLst>
   </p:cSld>
@@ -11510,7 +11511,7 @@
           <p:cNvPr id="2" name="CuadroTexto 1">
             <a:extLst>
               <a:ext uri="{FF2B5EF4-FFF2-40B4-BE49-F238E27FC236}">
-                <a16:creationId xmlns:a16="http://schemas.microsoft.com/office/drawing/2014/main" id="{9D31483E-2C85-8C65-4A19-D96AB1324755}"/>
+                <a16:creationId xmlns:a16="http://schemas.microsoft.com/office/drawing/2014/main" id="{F1A3C5FF-5045-CED6-CBA1-7B2DF36C078B}"/>
               </a:ext>
             </a:extLst>
           </p:cNvPr>
@@ -11550,7 +11551,7 @@
           <p:cNvPr id="3" name="CuadroTexto 2">
             <a:extLst>
               <a:ext uri="{FF2B5EF4-FFF2-40B4-BE49-F238E27FC236}">
-                <a16:creationId xmlns:a16="http://schemas.microsoft.com/office/drawing/2014/main" id="{7CAD892E-8DAE-09A7-DFA6-B044161B5F27}"/>
+                <a16:creationId xmlns:a16="http://schemas.microsoft.com/office/drawing/2014/main" id="{957BFA12-94A3-8625-3B40-511C7CCF92F1}"/>
               </a:ext>
             </a:extLst>
           </p:cNvPr>
@@ -11590,7 +11591,7 @@
           <p:cNvPr id="4" name="CuadroTexto 3">
             <a:extLst>
               <a:ext uri="{FF2B5EF4-FFF2-40B4-BE49-F238E27FC236}">
-                <a16:creationId xmlns:a16="http://schemas.microsoft.com/office/drawing/2014/main" id="{7AF4C546-F5E9-829C-3B23-F0B10CF5FADD}"/>
+                <a16:creationId xmlns:a16="http://schemas.microsoft.com/office/drawing/2014/main" id="{FBF319F4-F812-BAFB-96D7-20B6A7BFC63B}"/>
               </a:ext>
             </a:extLst>
           </p:cNvPr>
@@ -11630,7 +11631,7 @@
           <p:cNvPr id="5" name="CuadroTexto 4">
             <a:extLst>
               <a:ext uri="{FF2B5EF4-FFF2-40B4-BE49-F238E27FC236}">
-                <a16:creationId xmlns:a16="http://schemas.microsoft.com/office/drawing/2014/main" id="{F85DAE1D-40AA-AE71-64C5-646CD238269C}"/>
+                <a16:creationId xmlns:a16="http://schemas.microsoft.com/office/drawing/2014/main" id="{971C8038-BF79-0BF3-1A21-7D70A7316691}"/>
               </a:ext>
             </a:extLst>
           </p:cNvPr>
@@ -11731,7 +11732,7 @@
           <p:cNvPr id="6" name="Rectángulo: esquinas redondeadas 5">
             <a:extLst>
               <a:ext uri="{FF2B5EF4-FFF2-40B4-BE49-F238E27FC236}">
-                <a16:creationId xmlns:a16="http://schemas.microsoft.com/office/drawing/2014/main" id="{B4CDBDBC-52C3-41B9-7CE8-E3AFDC5E3BE8}"/>
+                <a16:creationId xmlns:a16="http://schemas.microsoft.com/office/drawing/2014/main" id="{0CD5F586-8244-0ED5-431E-6F599F36B085}"/>
               </a:ext>
             </a:extLst>
           </p:cNvPr>
@@ -11785,7 +11786,7 @@
           <p:cNvPr id="7" name="CuadroTexto 6">
             <a:extLst>
               <a:ext uri="{FF2B5EF4-FFF2-40B4-BE49-F238E27FC236}">
-                <a16:creationId xmlns:a16="http://schemas.microsoft.com/office/drawing/2014/main" id="{66251C0E-0AA4-ACCA-7F44-5929BD879372}"/>
+                <a16:creationId xmlns:a16="http://schemas.microsoft.com/office/drawing/2014/main" id="{20E2EE60-6D03-24FA-D058-93457A527155}"/>
               </a:ext>
             </a:extLst>
           </p:cNvPr>
@@ -11825,7 +11826,7 @@
           <p:cNvPr id="8" name="CuadroTexto 7">
             <a:extLst>
               <a:ext uri="{FF2B5EF4-FFF2-40B4-BE49-F238E27FC236}">
-                <a16:creationId xmlns:a16="http://schemas.microsoft.com/office/drawing/2014/main" id="{A1AEF440-B0BF-A292-FA35-AEBE6B50C396}"/>
+                <a16:creationId xmlns:a16="http://schemas.microsoft.com/office/drawing/2014/main" id="{EBC95489-88B0-6CD2-C1A5-88804E85CFD4}"/>
               </a:ext>
             </a:extLst>
           </p:cNvPr>
@@ -11863,7 +11864,7 @@
     </p:spTree>
     <p:extLst>
       <p:ext uri="{BB962C8B-B14F-4D97-AF65-F5344CB8AC3E}">
-        <p14:creationId xmlns:p14="http://schemas.microsoft.com/office/powerpoint/2010/main" val="2325976054"/>
+        <p14:creationId xmlns:p14="http://schemas.microsoft.com/office/powerpoint/2010/main" val="938825852"/>
       </p:ext>
     </p:extLst>
   </p:cSld>
@@ -11903,7 +11904,7 @@
           <p:cNvPr id="2" name="CuadroTexto 1">
             <a:extLst>
               <a:ext uri="{FF2B5EF4-FFF2-40B4-BE49-F238E27FC236}">
-                <a16:creationId xmlns:a16="http://schemas.microsoft.com/office/drawing/2014/main" id="{914F90E5-AF97-D785-06FB-794BA7BCE6A0}"/>
+                <a16:creationId xmlns:a16="http://schemas.microsoft.com/office/drawing/2014/main" id="{0ECCCE2D-CF55-111A-3C89-4032DCDC749B}"/>
               </a:ext>
             </a:extLst>
           </p:cNvPr>
@@ -11943,7 +11944,7 @@
           <p:cNvPr id="3" name="CuadroTexto 2">
             <a:extLst>
               <a:ext uri="{FF2B5EF4-FFF2-40B4-BE49-F238E27FC236}">
-                <a16:creationId xmlns:a16="http://schemas.microsoft.com/office/drawing/2014/main" id="{D3737A6D-B409-8285-C3AC-A2C8D68E7859}"/>
+                <a16:creationId xmlns:a16="http://schemas.microsoft.com/office/drawing/2014/main" id="{D5B6C8C7-C7FE-2E63-1F25-406FC90E078F}"/>
               </a:ext>
             </a:extLst>
           </p:cNvPr>
@@ -11983,7 +11984,7 @@
           <p:cNvPr id="4" name="Rectángulo: esquinas redondeadas 3">
             <a:extLst>
               <a:ext uri="{FF2B5EF4-FFF2-40B4-BE49-F238E27FC236}">
-                <a16:creationId xmlns:a16="http://schemas.microsoft.com/office/drawing/2014/main" id="{6980B74F-F4E2-BF40-1A89-37A56304E0C4}"/>
+                <a16:creationId xmlns:a16="http://schemas.microsoft.com/office/drawing/2014/main" id="{8644771D-02BC-F48C-E7F6-F230E689F977}"/>
               </a:ext>
             </a:extLst>
           </p:cNvPr>
@@ -12037,7 +12038,7 @@
           <p:cNvPr id="5" name="CuadroTexto 4">
             <a:extLst>
               <a:ext uri="{FF2B5EF4-FFF2-40B4-BE49-F238E27FC236}">
-                <a16:creationId xmlns:a16="http://schemas.microsoft.com/office/drawing/2014/main" id="{82365E2B-888E-0704-705D-62F82829B4E9}"/>
+                <a16:creationId xmlns:a16="http://schemas.microsoft.com/office/drawing/2014/main" id="{A7A84609-CFD0-DF1D-5EDC-176F4DB5732F}"/>
               </a:ext>
             </a:extLst>
           </p:cNvPr>
@@ -12077,7 +12078,7 @@
           <p:cNvPr id="6" name="CuadroTexto 5">
             <a:extLst>
               <a:ext uri="{FF2B5EF4-FFF2-40B4-BE49-F238E27FC236}">
-                <a16:creationId xmlns:a16="http://schemas.microsoft.com/office/drawing/2014/main" id="{F66D24EC-DA66-5009-499F-7C912E913683}"/>
+                <a16:creationId xmlns:a16="http://schemas.microsoft.com/office/drawing/2014/main" id="{D07AD378-9EA9-32AA-6120-EFADAD14EF05}"/>
               </a:ext>
             </a:extLst>
           </p:cNvPr>
@@ -12117,7 +12118,7 @@
           <p:cNvPr id="7" name="Rectángulo: esquinas redondeadas 6">
             <a:extLst>
               <a:ext uri="{FF2B5EF4-FFF2-40B4-BE49-F238E27FC236}">
-                <a16:creationId xmlns:a16="http://schemas.microsoft.com/office/drawing/2014/main" id="{8D933886-9395-F781-30F8-EC30D9E56799}"/>
+                <a16:creationId xmlns:a16="http://schemas.microsoft.com/office/drawing/2014/main" id="{67AFCDF2-8FCF-B00F-8C9E-5889CBA135A8}"/>
               </a:ext>
             </a:extLst>
           </p:cNvPr>
@@ -12171,7 +12172,7 @@
           <p:cNvPr id="8" name="CuadroTexto 7">
             <a:extLst>
               <a:ext uri="{FF2B5EF4-FFF2-40B4-BE49-F238E27FC236}">
-                <a16:creationId xmlns:a16="http://schemas.microsoft.com/office/drawing/2014/main" id="{E2D7C7C7-0F88-1836-AC98-EF4265C5DAB9}"/>
+                <a16:creationId xmlns:a16="http://schemas.microsoft.com/office/drawing/2014/main" id="{095C2770-075A-E1AE-39E4-CC556F9E6B42}"/>
               </a:ext>
             </a:extLst>
           </p:cNvPr>
@@ -12211,7 +12212,7 @@
           <p:cNvPr id="9" name="CuadroTexto 8">
             <a:extLst>
               <a:ext uri="{FF2B5EF4-FFF2-40B4-BE49-F238E27FC236}">
-                <a16:creationId xmlns:a16="http://schemas.microsoft.com/office/drawing/2014/main" id="{883A05D4-9E45-18AB-A5F2-58255A340A3B}"/>
+                <a16:creationId xmlns:a16="http://schemas.microsoft.com/office/drawing/2014/main" id="{4D4E9506-F8ED-64EE-F435-D2DED80E2CFF}"/>
               </a:ext>
             </a:extLst>
           </p:cNvPr>
@@ -12251,7 +12252,7 @@
           <p:cNvPr id="10" name="Rectángulo: esquinas redondeadas 9">
             <a:extLst>
               <a:ext uri="{FF2B5EF4-FFF2-40B4-BE49-F238E27FC236}">
-                <a16:creationId xmlns:a16="http://schemas.microsoft.com/office/drawing/2014/main" id="{507C673D-9B2B-314F-348D-B68062840297}"/>
+                <a16:creationId xmlns:a16="http://schemas.microsoft.com/office/drawing/2014/main" id="{3B205261-802F-6167-F4F3-63DB82791C98}"/>
               </a:ext>
             </a:extLst>
           </p:cNvPr>
@@ -12305,7 +12306,7 @@
           <p:cNvPr id="11" name="CuadroTexto 10">
             <a:extLst>
               <a:ext uri="{FF2B5EF4-FFF2-40B4-BE49-F238E27FC236}">
-                <a16:creationId xmlns:a16="http://schemas.microsoft.com/office/drawing/2014/main" id="{900A31FC-F96A-382D-DFE2-9FFD1107F574}"/>
+                <a16:creationId xmlns:a16="http://schemas.microsoft.com/office/drawing/2014/main" id="{D221A0DD-693E-9A9F-9325-93642120B206}"/>
               </a:ext>
             </a:extLst>
           </p:cNvPr>
@@ -12345,7 +12346,7 @@
           <p:cNvPr id="12" name="CuadroTexto 11">
             <a:extLst>
               <a:ext uri="{FF2B5EF4-FFF2-40B4-BE49-F238E27FC236}">
-                <a16:creationId xmlns:a16="http://schemas.microsoft.com/office/drawing/2014/main" id="{13B49E3F-6B25-E002-3F2A-FAADAD6D8AA3}"/>
+                <a16:creationId xmlns:a16="http://schemas.microsoft.com/office/drawing/2014/main" id="{CF994431-B047-6A96-3F30-EBA2B474CEC1}"/>
               </a:ext>
             </a:extLst>
           </p:cNvPr>
@@ -12385,7 +12386,7 @@
           <p:cNvPr id="13" name="Rectángulo: esquinas redondeadas 12">
             <a:extLst>
               <a:ext uri="{FF2B5EF4-FFF2-40B4-BE49-F238E27FC236}">
-                <a16:creationId xmlns:a16="http://schemas.microsoft.com/office/drawing/2014/main" id="{9AC32662-7AB5-FB37-4F3F-89E93363AF70}"/>
+                <a16:creationId xmlns:a16="http://schemas.microsoft.com/office/drawing/2014/main" id="{92D683EB-0979-9A3E-ED3F-9A4AAD14D32A}"/>
               </a:ext>
             </a:extLst>
           </p:cNvPr>
@@ -12439,7 +12440,7 @@
           <p:cNvPr id="14" name="CuadroTexto 13">
             <a:extLst>
               <a:ext uri="{FF2B5EF4-FFF2-40B4-BE49-F238E27FC236}">
-                <a16:creationId xmlns:a16="http://schemas.microsoft.com/office/drawing/2014/main" id="{50D9F6E2-3856-CC44-AA38-5267404D5EBB}"/>
+                <a16:creationId xmlns:a16="http://schemas.microsoft.com/office/drawing/2014/main" id="{98195BD7-32B3-7B98-B261-6DA618933790}"/>
               </a:ext>
             </a:extLst>
           </p:cNvPr>
@@ -12479,7 +12480,7 @@
           <p:cNvPr id="15" name="CuadroTexto 14">
             <a:extLst>
               <a:ext uri="{FF2B5EF4-FFF2-40B4-BE49-F238E27FC236}">
-                <a16:creationId xmlns:a16="http://schemas.microsoft.com/office/drawing/2014/main" id="{D5E9140C-DE22-64CF-46DF-E381CB60EFC1}"/>
+                <a16:creationId xmlns:a16="http://schemas.microsoft.com/office/drawing/2014/main" id="{133FDDFD-F0DE-F9D6-9748-A66ACCBD4D51}"/>
               </a:ext>
             </a:extLst>
           </p:cNvPr>
@@ -12517,7 +12518,7 @@
     </p:spTree>
     <p:extLst>
       <p:ext uri="{BB962C8B-B14F-4D97-AF65-F5344CB8AC3E}">
-        <p14:creationId xmlns:p14="http://schemas.microsoft.com/office/powerpoint/2010/main" val="2253844518"/>
+        <p14:creationId xmlns:p14="http://schemas.microsoft.com/office/powerpoint/2010/main" val="2238428987"/>
       </p:ext>
     </p:extLst>
   </p:cSld>
@@ -12557,7 +12558,7 @@
           <p:cNvPr id="2" name="CuadroTexto 1">
             <a:extLst>
               <a:ext uri="{FF2B5EF4-FFF2-40B4-BE49-F238E27FC236}">
-                <a16:creationId xmlns:a16="http://schemas.microsoft.com/office/drawing/2014/main" id="{C41A8E3B-3836-4146-9CBB-685DC5F05FB0}"/>
+                <a16:creationId xmlns:a16="http://schemas.microsoft.com/office/drawing/2014/main" id="{F8C96AC9-0D26-0ECD-02B6-84C87A4A6654}"/>
               </a:ext>
             </a:extLst>
           </p:cNvPr>
@@ -12597,7 +12598,7 @@
           <p:cNvPr id="3" name="CuadroTexto 2">
             <a:extLst>
               <a:ext uri="{FF2B5EF4-FFF2-40B4-BE49-F238E27FC236}">
-                <a16:creationId xmlns:a16="http://schemas.microsoft.com/office/drawing/2014/main" id="{22A4A2EE-242B-4D72-4812-E08B01826E68}"/>
+                <a16:creationId xmlns:a16="http://schemas.microsoft.com/office/drawing/2014/main" id="{B847EAA9-EDA6-4848-BBA5-30681BDE359F}"/>
               </a:ext>
             </a:extLst>
           </p:cNvPr>
@@ -12637,7 +12638,7 @@
           <p:cNvPr id="4" name="CuadroTexto 3">
             <a:extLst>
               <a:ext uri="{FF2B5EF4-FFF2-40B4-BE49-F238E27FC236}">
-                <a16:creationId xmlns:a16="http://schemas.microsoft.com/office/drawing/2014/main" id="{66E3AED2-2066-A7CB-A160-F81410B68E3F}"/>
+                <a16:creationId xmlns:a16="http://schemas.microsoft.com/office/drawing/2014/main" id="{7212F738-16EA-20C1-3BDD-7A5F53ACBD03}"/>
               </a:ext>
             </a:extLst>
           </p:cNvPr>
@@ -12677,7 +12678,7 @@
           <p:cNvPr id="6" name="Imagen 5">
             <a:extLst>
               <a:ext uri="{FF2B5EF4-FFF2-40B4-BE49-F238E27FC236}">
-                <a16:creationId xmlns:a16="http://schemas.microsoft.com/office/drawing/2014/main" id="{452032AF-DD56-96CA-0694-5A94E77CADEB}"/>
+                <a16:creationId xmlns:a16="http://schemas.microsoft.com/office/drawing/2014/main" id="{B8A83756-3E38-7136-49B0-FF02EFC4D3DC}"/>
               </a:ext>
             </a:extLst>
           </p:cNvPr>
@@ -12718,7 +12719,7 @@
           <p:cNvPr id="7" name="CuadroTexto 6">
             <a:extLst>
               <a:ext uri="{FF2B5EF4-FFF2-40B4-BE49-F238E27FC236}">
-                <a16:creationId xmlns:a16="http://schemas.microsoft.com/office/drawing/2014/main" id="{96C02AA3-EA5F-1FD3-5E2F-474AC7504862}"/>
+                <a16:creationId xmlns:a16="http://schemas.microsoft.com/office/drawing/2014/main" id="{797053BF-47BB-DA04-2F8F-67CE725BD576}"/>
               </a:ext>
             </a:extLst>
           </p:cNvPr>
@@ -12835,7 +12836,7 @@
     </p:spTree>
     <p:extLst>
       <p:ext uri="{BB962C8B-B14F-4D97-AF65-F5344CB8AC3E}">
-        <p14:creationId xmlns:p14="http://schemas.microsoft.com/office/powerpoint/2010/main" val="158311805"/>
+        <p14:creationId xmlns:p14="http://schemas.microsoft.com/office/powerpoint/2010/main" val="1952134176"/>
       </p:ext>
     </p:extLst>
   </p:cSld>
@@ -12875,7 +12876,7 @@
           <p:cNvPr id="2" name="CuadroTexto 1">
             <a:extLst>
               <a:ext uri="{FF2B5EF4-FFF2-40B4-BE49-F238E27FC236}">
-                <a16:creationId xmlns:a16="http://schemas.microsoft.com/office/drawing/2014/main" id="{E951A4B9-C4CD-D3C0-9F74-CEB32CDB269C}"/>
+                <a16:creationId xmlns:a16="http://schemas.microsoft.com/office/drawing/2014/main" id="{9E076305-96BD-4C82-B987-9EFEFDA00151}"/>
               </a:ext>
             </a:extLst>
           </p:cNvPr>
@@ -12915,7 +12916,7 @@
           <p:cNvPr id="3" name="CuadroTexto 2">
             <a:extLst>
               <a:ext uri="{FF2B5EF4-FFF2-40B4-BE49-F238E27FC236}">
-                <a16:creationId xmlns:a16="http://schemas.microsoft.com/office/drawing/2014/main" id="{0C38EFF9-469D-1C90-4E66-F169BBF08B83}"/>
+                <a16:creationId xmlns:a16="http://schemas.microsoft.com/office/drawing/2014/main" id="{F65DB9EA-E384-5009-09E5-F8B7BD2D2E40}"/>
               </a:ext>
             </a:extLst>
           </p:cNvPr>
@@ -12955,7 +12956,7 @@
           <p:cNvPr id="5" name="Imagen 4">
             <a:extLst>
               <a:ext uri="{FF2B5EF4-FFF2-40B4-BE49-F238E27FC236}">
-                <a16:creationId xmlns:a16="http://schemas.microsoft.com/office/drawing/2014/main" id="{1CA1F5BB-AE33-29DE-8201-C11F103F3834}"/>
+                <a16:creationId xmlns:a16="http://schemas.microsoft.com/office/drawing/2014/main" id="{18F4080D-631C-EE2A-85A4-4B179314A99A}"/>
               </a:ext>
             </a:extLst>
           </p:cNvPr>
@@ -12996,7 +12997,7 @@
           <p:cNvPr id="6" name="CuadroTexto 5">
             <a:extLst>
               <a:ext uri="{FF2B5EF4-FFF2-40B4-BE49-F238E27FC236}">
-                <a16:creationId xmlns:a16="http://schemas.microsoft.com/office/drawing/2014/main" id="{E987F68F-046C-3FF7-AF42-F639F369C6FE}"/>
+                <a16:creationId xmlns:a16="http://schemas.microsoft.com/office/drawing/2014/main" id="{74C92D2A-47A7-2230-F79C-29817259A6C0}"/>
               </a:ext>
             </a:extLst>
           </p:cNvPr>
@@ -13036,7 +13037,7 @@
           <p:cNvPr id="7" name="CuadroTexto 6">
             <a:extLst>
               <a:ext uri="{FF2B5EF4-FFF2-40B4-BE49-F238E27FC236}">
-                <a16:creationId xmlns:a16="http://schemas.microsoft.com/office/drawing/2014/main" id="{176C2567-1D20-F23F-04BE-B6EC5B5AB4BF}"/>
+                <a16:creationId xmlns:a16="http://schemas.microsoft.com/office/drawing/2014/main" id="{3D8583A2-A8A6-6E9C-6C7C-BAA2A9CBAF73}"/>
               </a:ext>
             </a:extLst>
           </p:cNvPr>
@@ -13135,7 +13136,7 @@
     </p:spTree>
     <p:extLst>
       <p:ext uri="{BB962C8B-B14F-4D97-AF65-F5344CB8AC3E}">
-        <p14:creationId xmlns:p14="http://schemas.microsoft.com/office/powerpoint/2010/main" val="3849511301"/>
+        <p14:creationId xmlns:p14="http://schemas.microsoft.com/office/powerpoint/2010/main" val="1789993447"/>
       </p:ext>
     </p:extLst>
   </p:cSld>
@@ -13175,7 +13176,7 @@
           <p:cNvPr id="2" name="CuadroTexto 1">
             <a:extLst>
               <a:ext uri="{FF2B5EF4-FFF2-40B4-BE49-F238E27FC236}">
-                <a16:creationId xmlns:a16="http://schemas.microsoft.com/office/drawing/2014/main" id="{5A445AED-67B3-A8F9-7FD6-E9145A71D731}"/>
+                <a16:creationId xmlns:a16="http://schemas.microsoft.com/office/drawing/2014/main" id="{A6106D1B-8129-3B92-E9E3-11B8CE1A4906}"/>
               </a:ext>
             </a:extLst>
           </p:cNvPr>
@@ -13215,7 +13216,7 @@
           <p:cNvPr id="3" name="CuadroTexto 2">
             <a:extLst>
               <a:ext uri="{FF2B5EF4-FFF2-40B4-BE49-F238E27FC236}">
-                <a16:creationId xmlns:a16="http://schemas.microsoft.com/office/drawing/2014/main" id="{8E96945A-ED17-86CE-7FBA-04651F68202F}"/>
+                <a16:creationId xmlns:a16="http://schemas.microsoft.com/office/drawing/2014/main" id="{6F252036-E420-58C1-C72E-2FD6566452FA}"/>
               </a:ext>
             </a:extLst>
           </p:cNvPr>
@@ -13255,7 +13256,7 @@
           <p:cNvPr id="4" name="CuadroTexto 3">
             <a:extLst>
               <a:ext uri="{FF2B5EF4-FFF2-40B4-BE49-F238E27FC236}">
-                <a16:creationId xmlns:a16="http://schemas.microsoft.com/office/drawing/2014/main" id="{0DEC7380-4D0A-30F8-2946-4C2FED85D370}"/>
+                <a16:creationId xmlns:a16="http://schemas.microsoft.com/office/drawing/2014/main" id="{B0524930-D85D-00A2-6DC7-F647C01C50AF}"/>
               </a:ext>
             </a:extLst>
           </p:cNvPr>
@@ -13295,7 +13296,7 @@
           <p:cNvPr id="6" name="Imagen 5">
             <a:extLst>
               <a:ext uri="{FF2B5EF4-FFF2-40B4-BE49-F238E27FC236}">
-                <a16:creationId xmlns:a16="http://schemas.microsoft.com/office/drawing/2014/main" id="{F06992D4-AF73-5463-6CB7-ACC98815C430}"/>
+                <a16:creationId xmlns:a16="http://schemas.microsoft.com/office/drawing/2014/main" id="{F00117D1-5494-448F-3BDA-DE7F392A87B6}"/>
               </a:ext>
             </a:extLst>
           </p:cNvPr>
@@ -13336,7 +13337,7 @@
           <p:cNvPr id="7" name="Rectángulo: esquinas redondeadas 6">
             <a:extLst>
               <a:ext uri="{FF2B5EF4-FFF2-40B4-BE49-F238E27FC236}">
-                <a16:creationId xmlns:a16="http://schemas.microsoft.com/office/drawing/2014/main" id="{768CC9F6-8DCF-AF83-D6D3-445678F1B718}"/>
+                <a16:creationId xmlns:a16="http://schemas.microsoft.com/office/drawing/2014/main" id="{4750A68F-8A8F-7C08-C958-69DE83902CFA}"/>
               </a:ext>
             </a:extLst>
           </p:cNvPr>
@@ -13390,7 +13391,7 @@
           <p:cNvPr id="8" name="CuadroTexto 7">
             <a:extLst>
               <a:ext uri="{FF2B5EF4-FFF2-40B4-BE49-F238E27FC236}">
-                <a16:creationId xmlns:a16="http://schemas.microsoft.com/office/drawing/2014/main" id="{AECF27DF-1150-0F45-F135-8EE40DC08CA6}"/>
+                <a16:creationId xmlns:a16="http://schemas.microsoft.com/office/drawing/2014/main" id="{F47DDCC1-1176-DB6E-B08B-F13B286576C5}"/>
               </a:ext>
             </a:extLst>
           </p:cNvPr>
@@ -13430,7 +13431,7 @@
           <p:cNvPr id="9" name="CuadroTexto 8">
             <a:extLst>
               <a:ext uri="{FF2B5EF4-FFF2-40B4-BE49-F238E27FC236}">
-                <a16:creationId xmlns:a16="http://schemas.microsoft.com/office/drawing/2014/main" id="{F1BE29AE-EFBE-EAB3-5134-F06DFB28978C}"/>
+                <a16:creationId xmlns:a16="http://schemas.microsoft.com/office/drawing/2014/main" id="{8D3C6496-F89D-B056-791F-6772519D0688}"/>
               </a:ext>
             </a:extLst>
           </p:cNvPr>
@@ -13470,7 +13471,7 @@
           <p:cNvPr id="10" name="Rectángulo: esquinas redondeadas 9">
             <a:extLst>
               <a:ext uri="{FF2B5EF4-FFF2-40B4-BE49-F238E27FC236}">
-                <a16:creationId xmlns:a16="http://schemas.microsoft.com/office/drawing/2014/main" id="{9C14D19E-EE1E-20E7-C397-AD0F795191B7}"/>
+                <a16:creationId xmlns:a16="http://schemas.microsoft.com/office/drawing/2014/main" id="{51035456-CC8B-AD5A-78C5-1BCF6DC194A5}"/>
               </a:ext>
             </a:extLst>
           </p:cNvPr>
@@ -13524,7 +13525,7 @@
           <p:cNvPr id="11" name="CuadroTexto 10">
             <a:extLst>
               <a:ext uri="{FF2B5EF4-FFF2-40B4-BE49-F238E27FC236}">
-                <a16:creationId xmlns:a16="http://schemas.microsoft.com/office/drawing/2014/main" id="{513535E6-F34F-3854-4055-86FAF5EF055C}"/>
+                <a16:creationId xmlns:a16="http://schemas.microsoft.com/office/drawing/2014/main" id="{62B3E2B1-5BD9-CA58-8AD9-FEC81DDA2935}"/>
               </a:ext>
             </a:extLst>
           </p:cNvPr>
@@ -13564,7 +13565,7 @@
           <p:cNvPr id="12" name="CuadroTexto 11">
             <a:extLst>
               <a:ext uri="{FF2B5EF4-FFF2-40B4-BE49-F238E27FC236}">
-                <a16:creationId xmlns:a16="http://schemas.microsoft.com/office/drawing/2014/main" id="{0A723147-D410-4E94-FF50-F04035AF8556}"/>
+                <a16:creationId xmlns:a16="http://schemas.microsoft.com/office/drawing/2014/main" id="{6CDCB583-F127-36DE-1E72-A9350557C0D9}"/>
               </a:ext>
             </a:extLst>
           </p:cNvPr>
@@ -13604,7 +13605,7 @@
           <p:cNvPr id="13" name="Rectángulo: esquinas redondeadas 12">
             <a:extLst>
               <a:ext uri="{FF2B5EF4-FFF2-40B4-BE49-F238E27FC236}">
-                <a16:creationId xmlns:a16="http://schemas.microsoft.com/office/drawing/2014/main" id="{E200B8FA-C58A-4916-6D4B-0C2429398A3F}"/>
+                <a16:creationId xmlns:a16="http://schemas.microsoft.com/office/drawing/2014/main" id="{3A59758E-1378-1085-AE6A-6FA9FDE25DF4}"/>
               </a:ext>
             </a:extLst>
           </p:cNvPr>
@@ -13658,7 +13659,7 @@
           <p:cNvPr id="14" name="CuadroTexto 13">
             <a:extLst>
               <a:ext uri="{FF2B5EF4-FFF2-40B4-BE49-F238E27FC236}">
-                <a16:creationId xmlns:a16="http://schemas.microsoft.com/office/drawing/2014/main" id="{B1C8D309-9332-0592-4461-70E39E5F8E69}"/>
+                <a16:creationId xmlns:a16="http://schemas.microsoft.com/office/drawing/2014/main" id="{7471A1D0-3E1B-A145-E992-63FB223E3838}"/>
               </a:ext>
             </a:extLst>
           </p:cNvPr>
@@ -13698,7 +13699,7 @@
           <p:cNvPr id="15" name="CuadroTexto 14">
             <a:extLst>
               <a:ext uri="{FF2B5EF4-FFF2-40B4-BE49-F238E27FC236}">
-                <a16:creationId xmlns:a16="http://schemas.microsoft.com/office/drawing/2014/main" id="{F63C3D38-6CD7-B851-DA21-972F6C4262D5}"/>
+                <a16:creationId xmlns:a16="http://schemas.microsoft.com/office/drawing/2014/main" id="{E7E79A1D-D6AD-ABAF-83F5-0BD6618EC4FC}"/>
               </a:ext>
             </a:extLst>
           </p:cNvPr>
@@ -13736,7 +13737,7 @@
     </p:spTree>
     <p:extLst>
       <p:ext uri="{BB962C8B-B14F-4D97-AF65-F5344CB8AC3E}">
-        <p14:creationId xmlns:p14="http://schemas.microsoft.com/office/powerpoint/2010/main" val="2285606361"/>
+        <p14:creationId xmlns:p14="http://schemas.microsoft.com/office/powerpoint/2010/main" val="2091320800"/>
       </p:ext>
     </p:extLst>
   </p:cSld>
@@ -13776,7 +13777,7 @@
           <p:cNvPr id="2" name="CuadroTexto 1">
             <a:extLst>
               <a:ext uri="{FF2B5EF4-FFF2-40B4-BE49-F238E27FC236}">
-                <a16:creationId xmlns:a16="http://schemas.microsoft.com/office/drawing/2014/main" id="{8F6EDED2-C176-D54A-4744-4687B6033032}"/>
+                <a16:creationId xmlns:a16="http://schemas.microsoft.com/office/drawing/2014/main" id="{83035B44-3127-25AC-A990-92472B1C07E5}"/>
               </a:ext>
             </a:extLst>
           </p:cNvPr>
@@ -13816,7 +13817,7 @@
           <p:cNvPr id="3" name="CuadroTexto 2">
             <a:extLst>
               <a:ext uri="{FF2B5EF4-FFF2-40B4-BE49-F238E27FC236}">
-                <a16:creationId xmlns:a16="http://schemas.microsoft.com/office/drawing/2014/main" id="{DE06F856-1977-278D-4D9D-1E43F42B3E63}"/>
+                <a16:creationId xmlns:a16="http://schemas.microsoft.com/office/drawing/2014/main" id="{E1880C90-F9B8-1FA0-3EF4-1EE99146DBA9}"/>
               </a:ext>
             </a:extLst>
           </p:cNvPr>
@@ -13856,7 +13857,7 @@
           <p:cNvPr id="5" name="Imagen 4">
             <a:extLst>
               <a:ext uri="{FF2B5EF4-FFF2-40B4-BE49-F238E27FC236}">
-                <a16:creationId xmlns:a16="http://schemas.microsoft.com/office/drawing/2014/main" id="{8D25A269-DC2D-733A-299D-BD80DAD89820}"/>
+                <a16:creationId xmlns:a16="http://schemas.microsoft.com/office/drawing/2014/main" id="{EC26E78B-F9E8-0060-48D8-BABB212CCB3C}"/>
               </a:ext>
             </a:extLst>
           </p:cNvPr>
@@ -13897,7 +13898,7 @@
           <p:cNvPr id="6" name="CuadroTexto 5">
             <a:extLst>
               <a:ext uri="{FF2B5EF4-FFF2-40B4-BE49-F238E27FC236}">
-                <a16:creationId xmlns:a16="http://schemas.microsoft.com/office/drawing/2014/main" id="{35AFBA7F-E6A0-E468-4A1D-26781C28597C}"/>
+                <a16:creationId xmlns:a16="http://schemas.microsoft.com/office/drawing/2014/main" id="{C5597E0C-6FA2-8809-78A0-C9557D13FB38}"/>
               </a:ext>
             </a:extLst>
           </p:cNvPr>
@@ -13996,7 +13997,7 @@
     </p:spTree>
     <p:extLst>
       <p:ext uri="{BB962C8B-B14F-4D97-AF65-F5344CB8AC3E}">
-        <p14:creationId xmlns:p14="http://schemas.microsoft.com/office/powerpoint/2010/main" val="4115379032"/>
+        <p14:creationId xmlns:p14="http://schemas.microsoft.com/office/powerpoint/2010/main" val="253743064"/>
       </p:ext>
     </p:extLst>
   </p:cSld>
@@ -14036,7 +14037,7 @@
           <p:cNvPr id="2" name="CuadroTexto 1">
             <a:extLst>
               <a:ext uri="{FF2B5EF4-FFF2-40B4-BE49-F238E27FC236}">
-                <a16:creationId xmlns:a16="http://schemas.microsoft.com/office/drawing/2014/main" id="{47F6931E-2B26-D49A-AFE6-CC53F8148F71}"/>
+                <a16:creationId xmlns:a16="http://schemas.microsoft.com/office/drawing/2014/main" id="{52976B65-E450-7BDB-321B-797CA7DB4F1A}"/>
               </a:ext>
             </a:extLst>
           </p:cNvPr>
@@ -14076,7 +14077,7 @@
           <p:cNvPr id="3" name="CuadroTexto 2">
             <a:extLst>
               <a:ext uri="{FF2B5EF4-FFF2-40B4-BE49-F238E27FC236}">
-                <a16:creationId xmlns:a16="http://schemas.microsoft.com/office/drawing/2014/main" id="{1128270E-7F07-312D-1B5C-DCBDCD60AF70}"/>
+                <a16:creationId xmlns:a16="http://schemas.microsoft.com/office/drawing/2014/main" id="{7627C858-FFA6-CE79-9493-EB0E7CC66A3C}"/>
               </a:ext>
             </a:extLst>
           </p:cNvPr>
@@ -14116,7 +14117,7 @@
           <p:cNvPr id="4" name="CuadroTexto 3">
             <a:extLst>
               <a:ext uri="{FF2B5EF4-FFF2-40B4-BE49-F238E27FC236}">
-                <a16:creationId xmlns:a16="http://schemas.microsoft.com/office/drawing/2014/main" id="{D1CF334C-A94F-E4C6-B928-50E04EA0E2EF}"/>
+                <a16:creationId xmlns:a16="http://schemas.microsoft.com/office/drawing/2014/main" id="{DC5ACFBE-F13A-DB35-BB4A-09033F80731F}"/>
               </a:ext>
             </a:extLst>
           </p:cNvPr>
@@ -14156,7 +14157,7 @@
           <p:cNvPr id="6" name="Imagen 5">
             <a:extLst>
               <a:ext uri="{FF2B5EF4-FFF2-40B4-BE49-F238E27FC236}">
-                <a16:creationId xmlns:a16="http://schemas.microsoft.com/office/drawing/2014/main" id="{5F307C9B-F1AA-88F7-3968-78814345B8DE}"/>
+                <a16:creationId xmlns:a16="http://schemas.microsoft.com/office/drawing/2014/main" id="{EB8FFFBB-6634-B069-B1FC-13D42BA336F2}"/>
               </a:ext>
             </a:extLst>
           </p:cNvPr>
@@ -14197,7 +14198,7 @@
           <p:cNvPr id="7" name="Rectángulo: esquinas redondeadas 6">
             <a:extLst>
               <a:ext uri="{FF2B5EF4-FFF2-40B4-BE49-F238E27FC236}">
-                <a16:creationId xmlns:a16="http://schemas.microsoft.com/office/drawing/2014/main" id="{FDA56359-6581-D044-D5E4-7E91EEE018E6}"/>
+                <a16:creationId xmlns:a16="http://schemas.microsoft.com/office/drawing/2014/main" id="{0AB9CE5D-0E25-D493-0D60-EDD8059347F2}"/>
               </a:ext>
             </a:extLst>
           </p:cNvPr>
@@ -14251,7 +14252,7 @@
           <p:cNvPr id="8" name="CuadroTexto 7">
             <a:extLst>
               <a:ext uri="{FF2B5EF4-FFF2-40B4-BE49-F238E27FC236}">
-                <a16:creationId xmlns:a16="http://schemas.microsoft.com/office/drawing/2014/main" id="{A67D654B-1E8B-6A8D-019F-541401D1782A}"/>
+                <a16:creationId xmlns:a16="http://schemas.microsoft.com/office/drawing/2014/main" id="{51CF039D-59BC-3610-F063-516941FD2E5D}"/>
               </a:ext>
             </a:extLst>
           </p:cNvPr>
@@ -14291,7 +14292,7 @@
           <p:cNvPr id="9" name="CuadroTexto 8">
             <a:extLst>
               <a:ext uri="{FF2B5EF4-FFF2-40B4-BE49-F238E27FC236}">
-                <a16:creationId xmlns:a16="http://schemas.microsoft.com/office/drawing/2014/main" id="{96ED29F5-2589-963A-3989-03BBC9B0C438}"/>
+                <a16:creationId xmlns:a16="http://schemas.microsoft.com/office/drawing/2014/main" id="{01D168E3-3089-AFC7-670A-094D4D442D2A}"/>
               </a:ext>
             </a:extLst>
           </p:cNvPr>
@@ -14329,7 +14330,7 @@
     </p:spTree>
     <p:extLst>
       <p:ext uri="{BB962C8B-B14F-4D97-AF65-F5344CB8AC3E}">
-        <p14:creationId xmlns:p14="http://schemas.microsoft.com/office/powerpoint/2010/main" val="4211578087"/>
+        <p14:creationId xmlns:p14="http://schemas.microsoft.com/office/powerpoint/2010/main" val="242240842"/>
       </p:ext>
     </p:extLst>
   </p:cSld>
@@ -14369,7 +14370,7 @@
           <p:cNvPr id="2" name="CuadroTexto 1">
             <a:extLst>
               <a:ext uri="{FF2B5EF4-FFF2-40B4-BE49-F238E27FC236}">
-                <a16:creationId xmlns:a16="http://schemas.microsoft.com/office/drawing/2014/main" id="{9AEB3CDB-CC08-C12C-C8DD-17EA9590CD91}"/>
+                <a16:creationId xmlns:a16="http://schemas.microsoft.com/office/drawing/2014/main" id="{F51136B8-6759-2CB6-5286-427C9AA1ED74}"/>
               </a:ext>
             </a:extLst>
           </p:cNvPr>
@@ -14409,7 +14410,7 @@
           <p:cNvPr id="3" name="CuadroTexto 2">
             <a:extLst>
               <a:ext uri="{FF2B5EF4-FFF2-40B4-BE49-F238E27FC236}">
-                <a16:creationId xmlns:a16="http://schemas.microsoft.com/office/drawing/2014/main" id="{0B2ED243-4430-5C2A-D633-D797AF402BA9}"/>
+                <a16:creationId xmlns:a16="http://schemas.microsoft.com/office/drawing/2014/main" id="{08044C68-1AC2-3165-B87F-1DD1940A2F9A}"/>
               </a:ext>
             </a:extLst>
           </p:cNvPr>
@@ -14449,7 +14450,7 @@
           <p:cNvPr id="4" name="CuadroTexto 3">
             <a:extLst>
               <a:ext uri="{FF2B5EF4-FFF2-40B4-BE49-F238E27FC236}">
-                <a16:creationId xmlns:a16="http://schemas.microsoft.com/office/drawing/2014/main" id="{1C0ABB57-10DA-73ED-5FF0-30523782C6A7}"/>
+                <a16:creationId xmlns:a16="http://schemas.microsoft.com/office/drawing/2014/main" id="{0F4B591E-5ACB-0934-F7C9-D6661ED02A50}"/>
               </a:ext>
             </a:extLst>
           </p:cNvPr>
@@ -14489,7 +14490,7 @@
           <p:cNvPr id="5" name="Rectángulo: esquinas redondeadas 4">
             <a:extLst>
               <a:ext uri="{FF2B5EF4-FFF2-40B4-BE49-F238E27FC236}">
-                <a16:creationId xmlns:a16="http://schemas.microsoft.com/office/drawing/2014/main" id="{74E7650D-1789-405C-8216-9788A10FBD30}"/>
+                <a16:creationId xmlns:a16="http://schemas.microsoft.com/office/drawing/2014/main" id="{8B210D98-24F9-2CCB-E86E-A026003D1450}"/>
               </a:ext>
             </a:extLst>
           </p:cNvPr>
@@ -14543,7 +14544,7 @@
           <p:cNvPr id="6" name="CuadroTexto 5">
             <a:extLst>
               <a:ext uri="{FF2B5EF4-FFF2-40B4-BE49-F238E27FC236}">
-                <a16:creationId xmlns:a16="http://schemas.microsoft.com/office/drawing/2014/main" id="{2DA73CB8-6621-DAD4-70CF-004880DF472C}"/>
+                <a16:creationId xmlns:a16="http://schemas.microsoft.com/office/drawing/2014/main" id="{C0D88EC5-58D0-10A5-FCD7-0DE926216548}"/>
               </a:ext>
             </a:extLst>
           </p:cNvPr>
@@ -14583,7 +14584,7 @@
           <p:cNvPr id="7" name="CuadroTexto 6">
             <a:extLst>
               <a:ext uri="{FF2B5EF4-FFF2-40B4-BE49-F238E27FC236}">
-                <a16:creationId xmlns:a16="http://schemas.microsoft.com/office/drawing/2014/main" id="{C502EF6A-5E36-E119-72D8-F8FB69B3D3DE}"/>
+                <a16:creationId xmlns:a16="http://schemas.microsoft.com/office/drawing/2014/main" id="{F582249E-F8EF-4972-FFD5-7C238DC6F5E5}"/>
               </a:ext>
             </a:extLst>
           </p:cNvPr>
@@ -14623,7 +14624,7 @@
           <p:cNvPr id="8" name="Rectángulo: esquinas redondeadas 7">
             <a:extLst>
               <a:ext uri="{FF2B5EF4-FFF2-40B4-BE49-F238E27FC236}">
-                <a16:creationId xmlns:a16="http://schemas.microsoft.com/office/drawing/2014/main" id="{E3AE79F3-606E-A255-116A-9714F58F444B}"/>
+                <a16:creationId xmlns:a16="http://schemas.microsoft.com/office/drawing/2014/main" id="{869D589D-862E-1738-2D7F-282FBFE2BEC4}"/>
               </a:ext>
             </a:extLst>
           </p:cNvPr>
@@ -14677,7 +14678,7 @@
           <p:cNvPr id="9" name="CuadroTexto 8">
             <a:extLst>
               <a:ext uri="{FF2B5EF4-FFF2-40B4-BE49-F238E27FC236}">
-                <a16:creationId xmlns:a16="http://schemas.microsoft.com/office/drawing/2014/main" id="{F4EA034F-2E3C-E2C6-462F-9A491E05496B}"/>
+                <a16:creationId xmlns:a16="http://schemas.microsoft.com/office/drawing/2014/main" id="{498AD346-206F-902C-4992-AFB16AF5F679}"/>
               </a:ext>
             </a:extLst>
           </p:cNvPr>
@@ -14717,7 +14718,7 @@
           <p:cNvPr id="10" name="CuadroTexto 9">
             <a:extLst>
               <a:ext uri="{FF2B5EF4-FFF2-40B4-BE49-F238E27FC236}">
-                <a16:creationId xmlns:a16="http://schemas.microsoft.com/office/drawing/2014/main" id="{CF27E8AA-E838-869D-A3EA-9BC78AD01BB6}"/>
+                <a16:creationId xmlns:a16="http://schemas.microsoft.com/office/drawing/2014/main" id="{8B7136A5-DF5E-8678-FE8D-D048C20FB184}"/>
               </a:ext>
             </a:extLst>
           </p:cNvPr>
@@ -14757,7 +14758,7 @@
           <p:cNvPr id="11" name="Rectángulo: esquinas redondeadas 10">
             <a:extLst>
               <a:ext uri="{FF2B5EF4-FFF2-40B4-BE49-F238E27FC236}">
-                <a16:creationId xmlns:a16="http://schemas.microsoft.com/office/drawing/2014/main" id="{1E84D195-6702-7DE4-146B-23D5E279A2EC}"/>
+                <a16:creationId xmlns:a16="http://schemas.microsoft.com/office/drawing/2014/main" id="{4DD590F9-B09E-70CD-0511-530DE04B0E8F}"/>
               </a:ext>
             </a:extLst>
           </p:cNvPr>
@@ -14811,7 +14812,7 @@
           <p:cNvPr id="12" name="CuadroTexto 11">
             <a:extLst>
               <a:ext uri="{FF2B5EF4-FFF2-40B4-BE49-F238E27FC236}">
-                <a16:creationId xmlns:a16="http://schemas.microsoft.com/office/drawing/2014/main" id="{0841BA9E-B461-01DA-D9DD-E054EE9039E3}"/>
+                <a16:creationId xmlns:a16="http://schemas.microsoft.com/office/drawing/2014/main" id="{350CB926-A154-B737-7B33-7E398E952813}"/>
               </a:ext>
             </a:extLst>
           </p:cNvPr>
@@ -14851,7 +14852,7 @@
           <p:cNvPr id="13" name="CuadroTexto 12">
             <a:extLst>
               <a:ext uri="{FF2B5EF4-FFF2-40B4-BE49-F238E27FC236}">
-                <a16:creationId xmlns:a16="http://schemas.microsoft.com/office/drawing/2014/main" id="{6E99977C-0D3D-1718-2A07-78C1AB056AE7}"/>
+                <a16:creationId xmlns:a16="http://schemas.microsoft.com/office/drawing/2014/main" id="{6C145FBE-6762-98F7-FDA5-AE033C797C3A}"/>
               </a:ext>
             </a:extLst>
           </p:cNvPr>
@@ -14891,7 +14892,7 @@
           <p:cNvPr id="14" name="Rectángulo: esquinas redondeadas 13">
             <a:extLst>
               <a:ext uri="{FF2B5EF4-FFF2-40B4-BE49-F238E27FC236}">
-                <a16:creationId xmlns:a16="http://schemas.microsoft.com/office/drawing/2014/main" id="{1FBE6333-4986-66DE-3BFE-5A3AFF646477}"/>
+                <a16:creationId xmlns:a16="http://schemas.microsoft.com/office/drawing/2014/main" id="{8D9AF402-975F-DE3F-B082-94CF73BFBA48}"/>
               </a:ext>
             </a:extLst>
           </p:cNvPr>
@@ -14945,7 +14946,7 @@
           <p:cNvPr id="15" name="CuadroTexto 14">
             <a:extLst>
               <a:ext uri="{FF2B5EF4-FFF2-40B4-BE49-F238E27FC236}">
-                <a16:creationId xmlns:a16="http://schemas.microsoft.com/office/drawing/2014/main" id="{4EB26C40-868E-B993-9998-D6F0B9C0A31A}"/>
+                <a16:creationId xmlns:a16="http://schemas.microsoft.com/office/drawing/2014/main" id="{1DD93B0E-B103-95FE-9CD5-F4CCCB68E173}"/>
               </a:ext>
             </a:extLst>
           </p:cNvPr>
@@ -14985,7 +14986,7 @@
           <p:cNvPr id="16" name="CuadroTexto 15">
             <a:extLst>
               <a:ext uri="{FF2B5EF4-FFF2-40B4-BE49-F238E27FC236}">
-                <a16:creationId xmlns:a16="http://schemas.microsoft.com/office/drawing/2014/main" id="{682E5687-1AFD-1DCB-57EF-686B2BB46F02}"/>
+                <a16:creationId xmlns:a16="http://schemas.microsoft.com/office/drawing/2014/main" id="{C10A6A6A-85BB-08C6-32DA-C94CE5B3214F}"/>
               </a:ext>
             </a:extLst>
           </p:cNvPr>
@@ -15025,7 +15026,7 @@
           <p:cNvPr id="17" name="Rectángulo: esquinas redondeadas 16">
             <a:extLst>
               <a:ext uri="{FF2B5EF4-FFF2-40B4-BE49-F238E27FC236}">
-                <a16:creationId xmlns:a16="http://schemas.microsoft.com/office/drawing/2014/main" id="{0B8B8DB2-0CF9-291D-00C1-E4FF1DC27855}"/>
+                <a16:creationId xmlns:a16="http://schemas.microsoft.com/office/drawing/2014/main" id="{66669691-4924-183B-08AE-A04349A1AAD6}"/>
               </a:ext>
             </a:extLst>
           </p:cNvPr>
@@ -15079,7 +15080,7 @@
           <p:cNvPr id="18" name="CuadroTexto 17">
             <a:extLst>
               <a:ext uri="{FF2B5EF4-FFF2-40B4-BE49-F238E27FC236}">
-                <a16:creationId xmlns:a16="http://schemas.microsoft.com/office/drawing/2014/main" id="{7AF5ED68-453B-B03B-05B5-5BD566D57D87}"/>
+                <a16:creationId xmlns:a16="http://schemas.microsoft.com/office/drawing/2014/main" id="{342CB79D-81BA-4B53-2C07-AB90B7A2F0A3}"/>
               </a:ext>
             </a:extLst>
           </p:cNvPr>
@@ -15119,7 +15120,7 @@
           <p:cNvPr id="19" name="CuadroTexto 18">
             <a:extLst>
               <a:ext uri="{FF2B5EF4-FFF2-40B4-BE49-F238E27FC236}">
-                <a16:creationId xmlns:a16="http://schemas.microsoft.com/office/drawing/2014/main" id="{69EE2F77-D164-8680-0DF1-94E08F782648}"/>
+                <a16:creationId xmlns:a16="http://schemas.microsoft.com/office/drawing/2014/main" id="{E7E81D59-E10A-3652-ECBC-678EC79E289F}"/>
               </a:ext>
             </a:extLst>
           </p:cNvPr>
@@ -15159,7 +15160,7 @@
           <p:cNvPr id="20" name="Rectángulo: esquinas redondeadas 19">
             <a:extLst>
               <a:ext uri="{FF2B5EF4-FFF2-40B4-BE49-F238E27FC236}">
-                <a16:creationId xmlns:a16="http://schemas.microsoft.com/office/drawing/2014/main" id="{67A03EB0-4E72-91C7-013F-2D200A3EF67C}"/>
+                <a16:creationId xmlns:a16="http://schemas.microsoft.com/office/drawing/2014/main" id="{2A0AFECD-1C89-E77B-FCB9-3501C7E9EB02}"/>
               </a:ext>
             </a:extLst>
           </p:cNvPr>
@@ -15213,7 +15214,7 @@
           <p:cNvPr id="21" name="CuadroTexto 20">
             <a:extLst>
               <a:ext uri="{FF2B5EF4-FFF2-40B4-BE49-F238E27FC236}">
-                <a16:creationId xmlns:a16="http://schemas.microsoft.com/office/drawing/2014/main" id="{E19D156C-C501-6A45-5FE2-67D7E475E66D}"/>
+                <a16:creationId xmlns:a16="http://schemas.microsoft.com/office/drawing/2014/main" id="{D6D104A7-9D05-08E4-2951-773D9A43A73C}"/>
               </a:ext>
             </a:extLst>
           </p:cNvPr>
@@ -15253,7 +15254,7 @@
           <p:cNvPr id="22" name="CuadroTexto 21">
             <a:extLst>
               <a:ext uri="{FF2B5EF4-FFF2-40B4-BE49-F238E27FC236}">
-                <a16:creationId xmlns:a16="http://schemas.microsoft.com/office/drawing/2014/main" id="{5F227918-8B05-55E3-69BD-E1B9DB514DF2}"/>
+                <a16:creationId xmlns:a16="http://schemas.microsoft.com/office/drawing/2014/main" id="{A98FD55F-940E-B07F-8866-497AFE8FAABD}"/>
               </a:ext>
             </a:extLst>
           </p:cNvPr>
@@ -15291,7 +15292,7 @@
     </p:spTree>
     <p:extLst>
       <p:ext uri="{BB962C8B-B14F-4D97-AF65-F5344CB8AC3E}">
-        <p14:creationId xmlns:p14="http://schemas.microsoft.com/office/powerpoint/2010/main" val="3299125161"/>
+        <p14:creationId xmlns:p14="http://schemas.microsoft.com/office/powerpoint/2010/main" val="34268641"/>
       </p:ext>
     </p:extLst>
   </p:cSld>

</xml_diff>

<commit_message>
Refine defense scope and roles slides
</commit_message>
<xml_diff>
--- a/docs/presentacion-defensa-final.pptx
+++ b/docs/presentacion-defensa-final.pptx
@@ -208,7 +208,7 @@
             </a:lvl1pPr>
           </a:lstStyle>
           <a:p>
-            <a:fld id="{8FEBC1BF-194D-476A-A3A6-18B95E1C1F4E}" type="datetimeFigureOut">
+            <a:fld id="{B49B553E-4BFD-4556-9980-6AAD45C032C4}" type="datetimeFigureOut">
               <a:rPr lang="es-ES" smtClean="0"/>
               <a:t>05/06/2026</a:t>
             </a:fld>
@@ -366,7 +366,7 @@
             </a:lvl1pPr>
           </a:lstStyle>
           <a:p>
-            <a:fld id="{C5D5DE0E-C4D9-44FD-808E-5E4EC38331C1}" type="slidenum">
+            <a:fld id="{849BF2D8-5248-4F03-B1E7-1A7CACDA9D22}" type="slidenum">
               <a:rPr lang="es-ES" smtClean="0"/>
               <a:t>‹Nº›</a:t>
             </a:fld>
@@ -377,7 +377,7 @@
     </p:spTree>
     <p:extLst>
       <p:ext uri="{BB962C8B-B14F-4D97-AF65-F5344CB8AC3E}">
-        <p14:creationId xmlns:p14="http://schemas.microsoft.com/office/powerpoint/2010/main" val="2403781025"/>
+        <p14:creationId xmlns:p14="http://schemas.microsoft.com/office/powerpoint/2010/main" val="1056288664"/>
       </p:ext>
     </p:extLst>
   </p:cSld>
@@ -546,7 +546,7 @@
           <a:bodyPr/>
           <a:lstStyle/>
           <a:p>
-            <a:fld id="{C5D5DE0E-C4D9-44FD-808E-5E4EC38331C1}" type="slidenum">
+            <a:fld id="{849BF2D8-5248-4F03-B1E7-1A7CACDA9D22}" type="slidenum">
               <a:rPr lang="es-ES" smtClean="0"/>
               <a:t>1</a:t>
             </a:fld>
@@ -557,7 +557,7 @@
     </p:spTree>
     <p:extLst>
       <p:ext uri="{BB962C8B-B14F-4D97-AF65-F5344CB8AC3E}">
-        <p14:creationId xmlns:p14="http://schemas.microsoft.com/office/powerpoint/2010/main" val="287008204"/>
+        <p14:creationId xmlns:p14="http://schemas.microsoft.com/office/powerpoint/2010/main" val="1234546152"/>
       </p:ext>
     </p:extLst>
   </p:cSld>
@@ -614,7 +614,7 @@
             <a:r>
               <a:rPr lang="es-ES"/>
               <a:t>Aqui debo dejar claro que el correo no es decorativo.
-Uso Brevo para verificacion de empresa, activacion de cuenta, recuperacion de contrasena y avisos de rechazo.
+Uso Brevo para verificacion de empresa, activacion de cuenta, recuperacion de contrasena y, si el transporte esta disponible, aviso de rechazo.
 Eso permite que la profesora pruebe un flujo real desde fuera, no una simulacion local.
 Tambien me sirve para justificar por que necesitaba una URL publica correcta en cloud.</a:t>
             </a:r>
@@ -636,7 +636,7 @@
           <a:bodyPr/>
           <a:lstStyle/>
           <a:p>
-            <a:fld id="{C5D5DE0E-C4D9-44FD-808E-5E4EC38331C1}" type="slidenum">
+            <a:fld id="{849BF2D8-5248-4F03-B1E7-1A7CACDA9D22}" type="slidenum">
               <a:rPr lang="es-ES" smtClean="0"/>
               <a:t>10</a:t>
             </a:fld>
@@ -647,7 +647,7 @@
     </p:spTree>
     <p:extLst>
       <p:ext uri="{BB962C8B-B14F-4D97-AF65-F5344CB8AC3E}">
-        <p14:creationId xmlns:p14="http://schemas.microsoft.com/office/powerpoint/2010/main" val="2409528777"/>
+        <p14:creationId xmlns:p14="http://schemas.microsoft.com/office/powerpoint/2010/main" val="345653353"/>
       </p:ext>
     </p:extLst>
   </p:cSld>
@@ -726,7 +726,7 @@
           <a:bodyPr/>
           <a:lstStyle/>
           <a:p>
-            <a:fld id="{C5D5DE0E-C4D9-44FD-808E-5E4EC38331C1}" type="slidenum">
+            <a:fld id="{849BF2D8-5248-4F03-B1E7-1A7CACDA9D22}" type="slidenum">
               <a:rPr lang="es-ES" smtClean="0"/>
               <a:t>11</a:t>
             </a:fld>
@@ -737,7 +737,7 @@
     </p:spTree>
     <p:extLst>
       <p:ext uri="{BB962C8B-B14F-4D97-AF65-F5344CB8AC3E}">
-        <p14:creationId xmlns:p14="http://schemas.microsoft.com/office/powerpoint/2010/main" val="3520985631"/>
+        <p14:creationId xmlns:p14="http://schemas.microsoft.com/office/powerpoint/2010/main" val="2142698453"/>
       </p:ext>
     </p:extLst>
   </p:cSld>
@@ -796,7 +796,7 @@
               <a:t>Esta diapositiva me sirve para justificar que la aplicacion no da sensacion de maqueta estatica.
 La bandeja interna y el chat externo se refrescan solos en segundo plano y tambien al recuperar el foco del navegador.
 Eso evita tener que recargar manualmente durante la demo.
-Ademas, el estado de rechazo no solo llega por correo: tambien queda visible dentro del portal externo.</a:t>
+Ademas, el estado de rechazo queda visible dentro del portal externo y el backend intenta enviar aviso por correo cuando Brevo esta disponible.</a:t>
             </a:r>
           </a:p>
         </p:txBody>
@@ -816,7 +816,7 @@
           <a:bodyPr/>
           <a:lstStyle/>
           <a:p>
-            <a:fld id="{C5D5DE0E-C4D9-44FD-808E-5E4EC38331C1}" type="slidenum">
+            <a:fld id="{849BF2D8-5248-4F03-B1E7-1A7CACDA9D22}" type="slidenum">
               <a:rPr lang="es-ES" smtClean="0"/>
               <a:t>12</a:t>
             </a:fld>
@@ -827,7 +827,7 @@
     </p:spTree>
     <p:extLst>
       <p:ext uri="{BB962C8B-B14F-4D97-AF65-F5344CB8AC3E}">
-        <p14:creationId xmlns:p14="http://schemas.microsoft.com/office/powerpoint/2010/main" val="1830068383"/>
+        <p14:creationId xmlns:p14="http://schemas.microsoft.com/office/powerpoint/2010/main" val="4220218764"/>
       </p:ext>
     </p:extLst>
   </p:cSld>
@@ -906,7 +906,7 @@
           <a:bodyPr/>
           <a:lstStyle/>
           <a:p>
-            <a:fld id="{C5D5DE0E-C4D9-44FD-808E-5E4EC38331C1}" type="slidenum">
+            <a:fld id="{849BF2D8-5248-4F03-B1E7-1A7CACDA9D22}" type="slidenum">
               <a:rPr lang="es-ES" smtClean="0"/>
               <a:t>13</a:t>
             </a:fld>
@@ -917,7 +917,7 @@
     </p:spTree>
     <p:extLst>
       <p:ext uri="{BB962C8B-B14F-4D97-AF65-F5344CB8AC3E}">
-        <p14:creationId xmlns:p14="http://schemas.microsoft.com/office/powerpoint/2010/main" val="1869301127"/>
+        <p14:creationId xmlns:p14="http://schemas.microsoft.com/office/powerpoint/2010/main" val="326307401"/>
       </p:ext>
     </p:extLst>
   </p:cSld>
@@ -983,8 +983,9 @@
 El proyecto ya separa permisos reales por rol.
 ROLE_ADMIN tiene control completo y es el unico que puede eliminar datos de prueba desde el portal interno: asignaciones, convenios sin asignaciones y empresas sin convenios ni asignaciones. Esto me permite limpiar datos para pruebas sin tocar directamente la base de datos.
 ROLE_COORDINATOR, que es el perfil que usan profesor o profesora en la demo, puede crear, editar y consultar empresas, convenios, asignaciones y mensajes, pero no ve ni puede ejecutar acciones de borrado.
-ROLE_DOCUMENT_MANAGER queda pensado para gestion documental, ROLE_MONITOR para logs y consola tecnica, y ROLE_COMPANY_PORTAL para empresas externas.
-Como evolucion futura, esta base se puede ampliar a una matriz de permisos mas fina: perfiles de solo lectura, responsables por departamento, auditoria visible por rol y restricciones por centro o familia profesional.</a:t>
+No necesito detallar todos los roles tecnicos en la diapositiva.
+Lo importante para defensa es que admin puede limpiar datos de prueba y profesor o coordinador puede trabajar sin riesgo de borrar.
+Como evolucion futura, esta base se puede ampliar a una matriz de permisos mas fina: perfiles de solo lectura, responsables por departamento, auditoria visible por rol y separacion por centro educativo.</a:t>
             </a:r>
           </a:p>
         </p:txBody>
@@ -1004,7 +1005,7 @@
           <a:bodyPr/>
           <a:lstStyle/>
           <a:p>
-            <a:fld id="{C5D5DE0E-C4D9-44FD-808E-5E4EC38331C1}" type="slidenum">
+            <a:fld id="{849BF2D8-5248-4F03-B1E7-1A7CACDA9D22}" type="slidenum">
               <a:rPr lang="es-ES" smtClean="0"/>
               <a:t>14</a:t>
             </a:fld>
@@ -1015,7 +1016,7 @@
     </p:spTree>
     <p:extLst>
       <p:ext uri="{BB962C8B-B14F-4D97-AF65-F5344CB8AC3E}">
-        <p14:creationId xmlns:p14="http://schemas.microsoft.com/office/powerpoint/2010/main" val="119859573"/>
+        <p14:creationId xmlns:p14="http://schemas.microsoft.com/office/powerpoint/2010/main" val="492547944"/>
       </p:ext>
     </p:extLst>
   </p:cSld>
@@ -1094,7 +1095,7 @@
           <a:bodyPr/>
           <a:lstStyle/>
           <a:p>
-            <a:fld id="{C5D5DE0E-C4D9-44FD-808E-5E4EC38331C1}" type="slidenum">
+            <a:fld id="{849BF2D8-5248-4F03-B1E7-1A7CACDA9D22}" type="slidenum">
               <a:rPr lang="es-ES" smtClean="0"/>
               <a:t>15</a:t>
             </a:fld>
@@ -1105,7 +1106,7 @@
     </p:spTree>
     <p:extLst>
       <p:ext uri="{BB962C8B-B14F-4D97-AF65-F5344CB8AC3E}">
-        <p14:creationId xmlns:p14="http://schemas.microsoft.com/office/powerpoint/2010/main" val="3031410732"/>
+        <p14:creationId xmlns:p14="http://schemas.microsoft.com/office/powerpoint/2010/main" val="3100099746"/>
       </p:ext>
     </p:extLst>
   </p:cSld>
@@ -1164,7 +1165,7 @@
               <a:t>Esta slide es muy practica: explica como se puede probar el sistema desde fuera.
 Debo remarcar que la referencia buena es la URL cloud efectiva.
 Si cambia la IP publica, Agora Desktop me dice la nueva URL.
-Con la cuenta profesora se puede revisar el flujo interno sin usar la cuenta de administrador principal.</a:t>
+Con una cuenta interna de prueba se puede revisar el flujo del centro sin usar la cuenta administradora principal.</a:t>
             </a:r>
           </a:p>
         </p:txBody>
@@ -1184,7 +1185,7 @@
           <a:bodyPr/>
           <a:lstStyle/>
           <a:p>
-            <a:fld id="{C5D5DE0E-C4D9-44FD-808E-5E4EC38331C1}" type="slidenum">
+            <a:fld id="{849BF2D8-5248-4F03-B1E7-1A7CACDA9D22}" type="slidenum">
               <a:rPr lang="es-ES" smtClean="0"/>
               <a:t>16</a:t>
             </a:fld>
@@ -1195,7 +1196,7 @@
     </p:spTree>
     <p:extLst>
       <p:ext uri="{BB962C8B-B14F-4D97-AF65-F5344CB8AC3E}">
-        <p14:creationId xmlns:p14="http://schemas.microsoft.com/office/powerpoint/2010/main" val="2493762024"/>
+        <p14:creationId xmlns:p14="http://schemas.microsoft.com/office/powerpoint/2010/main" val="2565418322"/>
       </p:ext>
     </p:extLst>
   </p:cSld>
@@ -1253,7 +1254,7 @@
               <a:rPr lang="es-ES"/>
               <a:t>Aqui tengo que defender bien el alcance.
 Lo principal ya esta cerrado: portales, documentos, mensajeria, correo, cloud y escritorio.
-Lo que dejo para despues no son huecos del nucleo, sino mejoras de endurecimiento y evolucion.
+Lo que dejo para despues no son huecos del nucleo, sino mejoras de alcance que requieren mas tiempo.
 Eso demuestra criterio: he preferido cerrar bien el producto base antes que abarcar mas cosas a medias.</a:t>
             </a:r>
           </a:p>
@@ -1274,7 +1275,7 @@
           <a:bodyPr/>
           <a:lstStyle/>
           <a:p>
-            <a:fld id="{C5D5DE0E-C4D9-44FD-808E-5E4EC38331C1}" type="slidenum">
+            <a:fld id="{849BF2D8-5248-4F03-B1E7-1A7CACDA9D22}" type="slidenum">
               <a:rPr lang="es-ES" smtClean="0"/>
               <a:t>17</a:t>
             </a:fld>
@@ -1285,7 +1286,7 @@
     </p:spTree>
     <p:extLst>
       <p:ext uri="{BB962C8B-B14F-4D97-AF65-F5344CB8AC3E}">
-        <p14:creationId xmlns:p14="http://schemas.microsoft.com/office/powerpoint/2010/main" val="698586754"/>
+        <p14:creationId xmlns:p14="http://schemas.microsoft.com/office/powerpoint/2010/main" val="216627143"/>
       </p:ext>
     </p:extLst>
   </p:cSld>
@@ -1342,9 +1343,9 @@
             <a:r>
               <a:rPr lang="es-ES"/>
               <a:t>No debo esconder las limitaciones.
-Lo que falta no invalida el TFG, pero si marca una hoja de ruta realista:
-SSO, firma avanzada, dominio propio, observabilidad y servicios gestionados.
-Tambien puedo mencionar que Symfony sigue una version que convendria actualizar tras la entrega para mantenimiento a medio plazo.</a:t>
+Lo que falta no invalida el TFG, pero si marca una hoja de ruta realista.
+Lo principal pendiente es cerrar almacenamiento documental de forma mas robusta, ampliar roles y preparar multi-centro.
+SSO o firma electronica podrian estudiarse mas adelante, pero no los pondria como prioridad principal de esta defensa.</a:t>
             </a:r>
           </a:p>
         </p:txBody>
@@ -1364,7 +1365,7 @@
           <a:bodyPr/>
           <a:lstStyle/>
           <a:p>
-            <a:fld id="{C5D5DE0E-C4D9-44FD-808E-5E4EC38331C1}" type="slidenum">
+            <a:fld id="{849BF2D8-5248-4F03-B1E7-1A7CACDA9D22}" type="slidenum">
               <a:rPr lang="es-ES" smtClean="0"/>
               <a:t>18</a:t>
             </a:fld>
@@ -1375,7 +1376,7 @@
     </p:spTree>
     <p:extLst>
       <p:ext uri="{BB962C8B-B14F-4D97-AF65-F5344CB8AC3E}">
-        <p14:creationId xmlns:p14="http://schemas.microsoft.com/office/powerpoint/2010/main" val="3876272976"/>
+        <p14:creationId xmlns:p14="http://schemas.microsoft.com/office/powerpoint/2010/main" val="2173609591"/>
       </p:ext>
     </p:extLst>
   </p:cSld>
@@ -1453,7 +1454,7 @@
           <a:bodyPr/>
           <a:lstStyle/>
           <a:p>
-            <a:fld id="{C5D5DE0E-C4D9-44FD-808E-5E4EC38331C1}" type="slidenum">
+            <a:fld id="{849BF2D8-5248-4F03-B1E7-1A7CACDA9D22}" type="slidenum">
               <a:rPr lang="es-ES" smtClean="0"/>
               <a:t>19</a:t>
             </a:fld>
@@ -1464,7 +1465,7 @@
     </p:spTree>
     <p:extLst>
       <p:ext uri="{BB962C8B-B14F-4D97-AF65-F5344CB8AC3E}">
-        <p14:creationId xmlns:p14="http://schemas.microsoft.com/office/powerpoint/2010/main" val="3865594059"/>
+        <p14:creationId xmlns:p14="http://schemas.microsoft.com/office/powerpoint/2010/main" val="3347456660"/>
       </p:ext>
     </p:extLst>
   </p:cSld>
@@ -1543,7 +1544,7 @@
           <a:bodyPr/>
           <a:lstStyle/>
           <a:p>
-            <a:fld id="{C5D5DE0E-C4D9-44FD-808E-5E4EC38331C1}" type="slidenum">
+            <a:fld id="{849BF2D8-5248-4F03-B1E7-1A7CACDA9D22}" type="slidenum">
               <a:rPr lang="es-ES" smtClean="0"/>
               <a:t>2</a:t>
             </a:fld>
@@ -1554,7 +1555,7 @@
     </p:spTree>
     <p:extLst>
       <p:ext uri="{BB962C8B-B14F-4D97-AF65-F5344CB8AC3E}">
-        <p14:creationId xmlns:p14="http://schemas.microsoft.com/office/powerpoint/2010/main" val="3926339252"/>
+        <p14:creationId xmlns:p14="http://schemas.microsoft.com/office/powerpoint/2010/main" val="860081986"/>
       </p:ext>
     </p:extLst>
   </p:cSld>
@@ -1634,7 +1635,7 @@
           <a:bodyPr/>
           <a:lstStyle/>
           <a:p>
-            <a:fld id="{C5D5DE0E-C4D9-44FD-808E-5E4EC38331C1}" type="slidenum">
+            <a:fld id="{849BF2D8-5248-4F03-B1E7-1A7CACDA9D22}" type="slidenum">
               <a:rPr lang="es-ES" smtClean="0"/>
               <a:t>3</a:t>
             </a:fld>
@@ -1645,7 +1646,7 @@
     </p:spTree>
     <p:extLst>
       <p:ext uri="{BB962C8B-B14F-4D97-AF65-F5344CB8AC3E}">
-        <p14:creationId xmlns:p14="http://schemas.microsoft.com/office/powerpoint/2010/main" val="3430522565"/>
+        <p14:creationId xmlns:p14="http://schemas.microsoft.com/office/powerpoint/2010/main" val="2816506554"/>
       </p:ext>
     </p:extLst>
   </p:cSld>
@@ -1725,7 +1726,7 @@
           <a:bodyPr/>
           <a:lstStyle/>
           <a:p>
-            <a:fld id="{C5D5DE0E-C4D9-44FD-808E-5E4EC38331C1}" type="slidenum">
+            <a:fld id="{849BF2D8-5248-4F03-B1E7-1A7CACDA9D22}" type="slidenum">
               <a:rPr lang="es-ES" smtClean="0"/>
               <a:t>4</a:t>
             </a:fld>
@@ -1736,7 +1737,7 @@
     </p:spTree>
     <p:extLst>
       <p:ext uri="{BB962C8B-B14F-4D97-AF65-F5344CB8AC3E}">
-        <p14:creationId xmlns:p14="http://schemas.microsoft.com/office/powerpoint/2010/main" val="4186151953"/>
+        <p14:creationId xmlns:p14="http://schemas.microsoft.com/office/powerpoint/2010/main" val="3278697725"/>
       </p:ext>
     </p:extLst>
   </p:cSld>
@@ -1819,7 +1820,7 @@
           <a:bodyPr/>
           <a:lstStyle/>
           <a:p>
-            <a:fld id="{C5D5DE0E-C4D9-44FD-808E-5E4EC38331C1}" type="slidenum">
+            <a:fld id="{849BF2D8-5248-4F03-B1E7-1A7CACDA9D22}" type="slidenum">
               <a:rPr lang="es-ES" smtClean="0"/>
               <a:t>5</a:t>
             </a:fld>
@@ -1830,7 +1831,7 @@
     </p:spTree>
     <p:extLst>
       <p:ext uri="{BB962C8B-B14F-4D97-AF65-F5344CB8AC3E}">
-        <p14:creationId xmlns:p14="http://schemas.microsoft.com/office/powerpoint/2010/main" val="3708493512"/>
+        <p14:creationId xmlns:p14="http://schemas.microsoft.com/office/powerpoint/2010/main" val="1729867402"/>
       </p:ext>
     </p:extLst>
   </p:cSld>
@@ -1909,7 +1910,7 @@
           <a:bodyPr/>
           <a:lstStyle/>
           <a:p>
-            <a:fld id="{C5D5DE0E-C4D9-44FD-808E-5E4EC38331C1}" type="slidenum">
+            <a:fld id="{849BF2D8-5248-4F03-B1E7-1A7CACDA9D22}" type="slidenum">
               <a:rPr lang="es-ES" smtClean="0"/>
               <a:t>6</a:t>
             </a:fld>
@@ -1920,7 +1921,7 @@
     </p:spTree>
     <p:extLst>
       <p:ext uri="{BB962C8B-B14F-4D97-AF65-F5344CB8AC3E}">
-        <p14:creationId xmlns:p14="http://schemas.microsoft.com/office/powerpoint/2010/main" val="2835790957"/>
+        <p14:creationId xmlns:p14="http://schemas.microsoft.com/office/powerpoint/2010/main" val="3465237701"/>
       </p:ext>
     </p:extLst>
   </p:cSld>
@@ -2000,7 +2001,7 @@
           <a:bodyPr/>
           <a:lstStyle/>
           <a:p>
-            <a:fld id="{C5D5DE0E-C4D9-44FD-808E-5E4EC38331C1}" type="slidenum">
+            <a:fld id="{849BF2D8-5248-4F03-B1E7-1A7CACDA9D22}" type="slidenum">
               <a:rPr lang="es-ES" smtClean="0"/>
               <a:t>7</a:t>
             </a:fld>
@@ -2011,7 +2012,7 @@
     </p:spTree>
     <p:extLst>
       <p:ext uri="{BB962C8B-B14F-4D97-AF65-F5344CB8AC3E}">
-        <p14:creationId xmlns:p14="http://schemas.microsoft.com/office/powerpoint/2010/main" val="1618068750"/>
+        <p14:creationId xmlns:p14="http://schemas.microsoft.com/office/powerpoint/2010/main" val="2976873529"/>
       </p:ext>
     </p:extLst>
   </p:cSld>
@@ -2090,7 +2091,7 @@
           <a:bodyPr/>
           <a:lstStyle/>
           <a:p>
-            <a:fld id="{C5D5DE0E-C4D9-44FD-808E-5E4EC38331C1}" type="slidenum">
+            <a:fld id="{849BF2D8-5248-4F03-B1E7-1A7CACDA9D22}" type="slidenum">
               <a:rPr lang="es-ES" smtClean="0"/>
               <a:t>8</a:t>
             </a:fld>
@@ -2101,7 +2102,7 @@
     </p:spTree>
     <p:extLst>
       <p:ext uri="{BB962C8B-B14F-4D97-AF65-F5344CB8AC3E}">
-        <p14:creationId xmlns:p14="http://schemas.microsoft.com/office/powerpoint/2010/main" val="2182006226"/>
+        <p14:creationId xmlns:p14="http://schemas.microsoft.com/office/powerpoint/2010/main" val="3202307411"/>
       </p:ext>
     </p:extLst>
   </p:cSld>
@@ -2157,11 +2158,12 @@
           <a:p>
             <a:r>
               <a:rPr lang="es-ES"/>
-              <a:t>Aqui cuento el proyecto por bloques de construccion, no por commits.
-Primero modele el problema y el dominio.
-Despues levante backend y reglas de negocio.
-Luego hice el portal interno, el portal externo y el soporte documental.
-La ultima capa fue la operacion tecnica: cloud, escritorio, pruebas y empaquetado.</a:t>
+              <a:t>Esta diapositiva sustituye a una explicacion larga de desarrollo.
+Aqui tengo que explicar el recorrido que si queda cerrado y que voy a defender en demo.
+Primero entra la empresa desde el portal externo.
+Despues el centro revisa la solicitud desde el panel interno.
+Si se aprueba, la empresa pasa al catalogo y se pueden crear convenios.
+Finalmente se crean asignaciones con estudiantes y tutores, y se completa el seguimiento con mensajes, documentos y evaluacion final.</a:t>
             </a:r>
           </a:p>
         </p:txBody>
@@ -2181,7 +2183,7 @@
           <a:bodyPr/>
           <a:lstStyle/>
           <a:p>
-            <a:fld id="{C5D5DE0E-C4D9-44FD-808E-5E4EC38331C1}" type="slidenum">
+            <a:fld id="{849BF2D8-5248-4F03-B1E7-1A7CACDA9D22}" type="slidenum">
               <a:rPr lang="es-ES" smtClean="0"/>
               <a:t>9</a:t>
             </a:fld>
@@ -2192,7 +2194,7 @@
     </p:spTree>
     <p:extLst>
       <p:ext uri="{BB962C8B-B14F-4D97-AF65-F5344CB8AC3E}">
-        <p14:creationId xmlns:p14="http://schemas.microsoft.com/office/powerpoint/2010/main" val="1157045571"/>
+        <p14:creationId xmlns:p14="http://schemas.microsoft.com/office/powerpoint/2010/main" val="3420268879"/>
       </p:ext>
     </p:extLst>
   </p:cSld>
@@ -2224,7 +2226,7 @@
           <p:cNvPr id="2" name="Título 1">
             <a:extLst>
               <a:ext uri="{FF2B5EF4-FFF2-40B4-BE49-F238E27FC236}">
-                <a16:creationId xmlns:a16="http://schemas.microsoft.com/office/drawing/2014/main" id="{A64AA065-1710-1C52-921A-E5B3164FB178}"/>
+                <a16:creationId xmlns:a16="http://schemas.microsoft.com/office/drawing/2014/main" id="{C3EB5125-1A16-71A7-7092-AF53739E624E}"/>
               </a:ext>
             </a:extLst>
           </p:cNvPr>
@@ -2261,7 +2263,7 @@
           <p:cNvPr id="3" name="Subtítulo 2">
             <a:extLst>
               <a:ext uri="{FF2B5EF4-FFF2-40B4-BE49-F238E27FC236}">
-                <a16:creationId xmlns:a16="http://schemas.microsoft.com/office/drawing/2014/main" id="{1FD4C27C-5F02-DC21-55D7-F57165153FD5}"/>
+                <a16:creationId xmlns:a16="http://schemas.microsoft.com/office/drawing/2014/main" id="{9E83F700-711B-DEC0-B824-755AC185A6AE}"/>
               </a:ext>
             </a:extLst>
           </p:cNvPr>
@@ -2331,7 +2333,7 @@
           <p:cNvPr id="4" name="Marcador de fecha 3">
             <a:extLst>
               <a:ext uri="{FF2B5EF4-FFF2-40B4-BE49-F238E27FC236}">
-                <a16:creationId xmlns:a16="http://schemas.microsoft.com/office/drawing/2014/main" id="{AA1A6579-3E56-0211-44D4-617C5CE25B60}"/>
+                <a16:creationId xmlns:a16="http://schemas.microsoft.com/office/drawing/2014/main" id="{6BBA1F1C-B503-DC9E-6190-E42416DB4A3D}"/>
               </a:ext>
             </a:extLst>
           </p:cNvPr>
@@ -2347,7 +2349,7 @@
           <a:bodyPr/>
           <a:lstStyle/>
           <a:p>
-            <a:fld id="{3D6C1A94-3A56-4E71-9AEB-C8DB029FBD9F}" type="datetimeFigureOut">
+            <a:fld id="{C461DEB2-4BB3-433F-9637-3247C637FAE0}" type="datetimeFigureOut">
               <a:rPr lang="es-ES" smtClean="0"/>
               <a:t>05/06/2026</a:t>
             </a:fld>
@@ -2360,7 +2362,7 @@
           <p:cNvPr id="5" name="Marcador de pie de página 4">
             <a:extLst>
               <a:ext uri="{FF2B5EF4-FFF2-40B4-BE49-F238E27FC236}">
-                <a16:creationId xmlns:a16="http://schemas.microsoft.com/office/drawing/2014/main" id="{4867F8BA-D29F-80EC-AE76-3C17E84DC7D9}"/>
+                <a16:creationId xmlns:a16="http://schemas.microsoft.com/office/drawing/2014/main" id="{914C70CD-4695-56CA-404F-665D5DABADAF}"/>
               </a:ext>
             </a:extLst>
           </p:cNvPr>
@@ -2385,7 +2387,7 @@
           <p:cNvPr id="6" name="Marcador de número de diapositiva 5">
             <a:extLst>
               <a:ext uri="{FF2B5EF4-FFF2-40B4-BE49-F238E27FC236}">
-                <a16:creationId xmlns:a16="http://schemas.microsoft.com/office/drawing/2014/main" id="{1E9BAF6F-9FFC-44F1-D387-67A915A2EE75}"/>
+                <a16:creationId xmlns:a16="http://schemas.microsoft.com/office/drawing/2014/main" id="{5308D9E3-3A9B-CB47-2012-B7411493BDFA}"/>
               </a:ext>
             </a:extLst>
           </p:cNvPr>
@@ -2401,7 +2403,7 @@
           <a:bodyPr/>
           <a:lstStyle/>
           <a:p>
-            <a:fld id="{2611C5D2-C4B0-4D8A-9AB8-ED270EC4FA17}" type="slidenum">
+            <a:fld id="{B70DEA89-46F8-45E1-B8C6-A199CAA1F9BC}" type="slidenum">
               <a:rPr lang="es-ES" smtClean="0"/>
               <a:t>‹Nº›</a:t>
             </a:fld>
@@ -2412,7 +2414,7 @@
     </p:spTree>
     <p:extLst>
       <p:ext uri="{BB962C8B-B14F-4D97-AF65-F5344CB8AC3E}">
-        <p14:creationId xmlns:p14="http://schemas.microsoft.com/office/powerpoint/2010/main" val="2535946326"/>
+        <p14:creationId xmlns:p14="http://schemas.microsoft.com/office/powerpoint/2010/main" val="590272778"/>
       </p:ext>
     </p:extLst>
   </p:cSld>
@@ -2444,7 +2446,7 @@
           <p:cNvPr id="2" name="Título 1">
             <a:extLst>
               <a:ext uri="{FF2B5EF4-FFF2-40B4-BE49-F238E27FC236}">
-                <a16:creationId xmlns:a16="http://schemas.microsoft.com/office/drawing/2014/main" id="{869DF8F9-13D9-6798-B1A2-695CA4DF57BB}"/>
+                <a16:creationId xmlns:a16="http://schemas.microsoft.com/office/drawing/2014/main" id="{1F6B6B06-6BDF-7DB0-FFDB-E38739C470D6}"/>
               </a:ext>
             </a:extLst>
           </p:cNvPr>
@@ -2472,7 +2474,7 @@
           <p:cNvPr id="3" name="Marcador de texto vertical 2">
             <a:extLst>
               <a:ext uri="{FF2B5EF4-FFF2-40B4-BE49-F238E27FC236}">
-                <a16:creationId xmlns:a16="http://schemas.microsoft.com/office/drawing/2014/main" id="{69F5849F-C6EC-F33B-0D9A-D55EB380E321}"/>
+                <a16:creationId xmlns:a16="http://schemas.microsoft.com/office/drawing/2014/main" id="{7F9018F3-AFB9-036B-1C8E-5BE954E35808}"/>
               </a:ext>
             </a:extLst>
           </p:cNvPr>
@@ -2529,7 +2531,7 @@
           <p:cNvPr id="4" name="Marcador de fecha 3">
             <a:extLst>
               <a:ext uri="{FF2B5EF4-FFF2-40B4-BE49-F238E27FC236}">
-                <a16:creationId xmlns:a16="http://schemas.microsoft.com/office/drawing/2014/main" id="{9A2E284C-7022-8D04-25A2-E7D8DF2E34F5}"/>
+                <a16:creationId xmlns:a16="http://schemas.microsoft.com/office/drawing/2014/main" id="{FF78BEFC-8DD7-5397-DC0F-824D7E47ECC8}"/>
               </a:ext>
             </a:extLst>
           </p:cNvPr>
@@ -2545,7 +2547,7 @@
           <a:bodyPr/>
           <a:lstStyle/>
           <a:p>
-            <a:fld id="{3D6C1A94-3A56-4E71-9AEB-C8DB029FBD9F}" type="datetimeFigureOut">
+            <a:fld id="{C461DEB2-4BB3-433F-9637-3247C637FAE0}" type="datetimeFigureOut">
               <a:rPr lang="es-ES" smtClean="0"/>
               <a:t>05/06/2026</a:t>
             </a:fld>
@@ -2558,7 +2560,7 @@
           <p:cNvPr id="5" name="Marcador de pie de página 4">
             <a:extLst>
               <a:ext uri="{FF2B5EF4-FFF2-40B4-BE49-F238E27FC236}">
-                <a16:creationId xmlns:a16="http://schemas.microsoft.com/office/drawing/2014/main" id="{8BB895F1-FFA1-974B-B93A-AD115AB2E6EF}"/>
+                <a16:creationId xmlns:a16="http://schemas.microsoft.com/office/drawing/2014/main" id="{288A8323-B6B3-A236-A689-EC216E6C39B9}"/>
               </a:ext>
             </a:extLst>
           </p:cNvPr>
@@ -2583,7 +2585,7 @@
           <p:cNvPr id="6" name="Marcador de número de diapositiva 5">
             <a:extLst>
               <a:ext uri="{FF2B5EF4-FFF2-40B4-BE49-F238E27FC236}">
-                <a16:creationId xmlns:a16="http://schemas.microsoft.com/office/drawing/2014/main" id="{5F4557D3-2EE5-854F-716A-77DD5DF5C12E}"/>
+                <a16:creationId xmlns:a16="http://schemas.microsoft.com/office/drawing/2014/main" id="{0827DC63-3139-664D-E166-8A510CE00AA7}"/>
               </a:ext>
             </a:extLst>
           </p:cNvPr>
@@ -2599,7 +2601,7 @@
           <a:bodyPr/>
           <a:lstStyle/>
           <a:p>
-            <a:fld id="{2611C5D2-C4B0-4D8A-9AB8-ED270EC4FA17}" type="slidenum">
+            <a:fld id="{B70DEA89-46F8-45E1-B8C6-A199CAA1F9BC}" type="slidenum">
               <a:rPr lang="es-ES" smtClean="0"/>
               <a:t>‹Nº›</a:t>
             </a:fld>
@@ -2610,7 +2612,7 @@
     </p:spTree>
     <p:extLst>
       <p:ext uri="{BB962C8B-B14F-4D97-AF65-F5344CB8AC3E}">
-        <p14:creationId xmlns:p14="http://schemas.microsoft.com/office/powerpoint/2010/main" val="1950355174"/>
+        <p14:creationId xmlns:p14="http://schemas.microsoft.com/office/powerpoint/2010/main" val="1608119060"/>
       </p:ext>
     </p:extLst>
   </p:cSld>
@@ -2642,7 +2644,7 @@
           <p:cNvPr id="2" name="Título vertical 1">
             <a:extLst>
               <a:ext uri="{FF2B5EF4-FFF2-40B4-BE49-F238E27FC236}">
-                <a16:creationId xmlns:a16="http://schemas.microsoft.com/office/drawing/2014/main" id="{6D96A6B3-5A8F-A9D0-5A57-64E87282EFDC}"/>
+                <a16:creationId xmlns:a16="http://schemas.microsoft.com/office/drawing/2014/main" id="{BF66723D-1A5D-B17C-63E5-5C944826973D}"/>
               </a:ext>
             </a:extLst>
           </p:cNvPr>
@@ -2675,7 +2677,7 @@
           <p:cNvPr id="3" name="Marcador de texto vertical 2">
             <a:extLst>
               <a:ext uri="{FF2B5EF4-FFF2-40B4-BE49-F238E27FC236}">
-                <a16:creationId xmlns:a16="http://schemas.microsoft.com/office/drawing/2014/main" id="{4C8D587C-EADB-2F49-EC56-756B50D1B0D3}"/>
+                <a16:creationId xmlns:a16="http://schemas.microsoft.com/office/drawing/2014/main" id="{D4811F53-A390-972D-5806-1B54631E6C1F}"/>
               </a:ext>
             </a:extLst>
           </p:cNvPr>
@@ -2737,7 +2739,7 @@
           <p:cNvPr id="4" name="Marcador de fecha 3">
             <a:extLst>
               <a:ext uri="{FF2B5EF4-FFF2-40B4-BE49-F238E27FC236}">
-                <a16:creationId xmlns:a16="http://schemas.microsoft.com/office/drawing/2014/main" id="{9FAC7317-1C4D-6A2C-3E0E-17127B8573E5}"/>
+                <a16:creationId xmlns:a16="http://schemas.microsoft.com/office/drawing/2014/main" id="{1A8DF0B7-1DE2-614E-8A3C-5169B50BE5C6}"/>
               </a:ext>
             </a:extLst>
           </p:cNvPr>
@@ -2753,7 +2755,7 @@
           <a:bodyPr/>
           <a:lstStyle/>
           <a:p>
-            <a:fld id="{3D6C1A94-3A56-4E71-9AEB-C8DB029FBD9F}" type="datetimeFigureOut">
+            <a:fld id="{C461DEB2-4BB3-433F-9637-3247C637FAE0}" type="datetimeFigureOut">
               <a:rPr lang="es-ES" smtClean="0"/>
               <a:t>05/06/2026</a:t>
             </a:fld>
@@ -2766,7 +2768,7 @@
           <p:cNvPr id="5" name="Marcador de pie de página 4">
             <a:extLst>
               <a:ext uri="{FF2B5EF4-FFF2-40B4-BE49-F238E27FC236}">
-                <a16:creationId xmlns:a16="http://schemas.microsoft.com/office/drawing/2014/main" id="{E2B4610A-E381-C33A-2943-75E163D93A73}"/>
+                <a16:creationId xmlns:a16="http://schemas.microsoft.com/office/drawing/2014/main" id="{71BC2A54-CFEF-44E1-141E-FEC28C24FC37}"/>
               </a:ext>
             </a:extLst>
           </p:cNvPr>
@@ -2791,7 +2793,7 @@
           <p:cNvPr id="6" name="Marcador de número de diapositiva 5">
             <a:extLst>
               <a:ext uri="{FF2B5EF4-FFF2-40B4-BE49-F238E27FC236}">
-                <a16:creationId xmlns:a16="http://schemas.microsoft.com/office/drawing/2014/main" id="{86A44F36-78F8-13C8-301B-DD8AE46B5C4A}"/>
+                <a16:creationId xmlns:a16="http://schemas.microsoft.com/office/drawing/2014/main" id="{7C64FBF5-27FC-06C1-C371-E4DB64E02D3D}"/>
               </a:ext>
             </a:extLst>
           </p:cNvPr>
@@ -2807,7 +2809,7 @@
           <a:bodyPr/>
           <a:lstStyle/>
           <a:p>
-            <a:fld id="{2611C5D2-C4B0-4D8A-9AB8-ED270EC4FA17}" type="slidenum">
+            <a:fld id="{B70DEA89-46F8-45E1-B8C6-A199CAA1F9BC}" type="slidenum">
               <a:rPr lang="es-ES" smtClean="0"/>
               <a:t>‹Nº›</a:t>
             </a:fld>
@@ -2818,7 +2820,7 @@
     </p:spTree>
     <p:extLst>
       <p:ext uri="{BB962C8B-B14F-4D97-AF65-F5344CB8AC3E}">
-        <p14:creationId xmlns:p14="http://schemas.microsoft.com/office/powerpoint/2010/main" val="1625825761"/>
+        <p14:creationId xmlns:p14="http://schemas.microsoft.com/office/powerpoint/2010/main" val="1242576780"/>
       </p:ext>
     </p:extLst>
   </p:cSld>
@@ -2850,7 +2852,7 @@
           <p:cNvPr id="2" name="Título 1">
             <a:extLst>
               <a:ext uri="{FF2B5EF4-FFF2-40B4-BE49-F238E27FC236}">
-                <a16:creationId xmlns:a16="http://schemas.microsoft.com/office/drawing/2014/main" id="{2A510919-1DB0-211A-E319-843A6C0FEC1D}"/>
+                <a16:creationId xmlns:a16="http://schemas.microsoft.com/office/drawing/2014/main" id="{3EED1E29-6896-29EE-5A48-9FAA359BD08D}"/>
               </a:ext>
             </a:extLst>
           </p:cNvPr>
@@ -2878,7 +2880,7 @@
           <p:cNvPr id="3" name="Marcador de contenido 2">
             <a:extLst>
               <a:ext uri="{FF2B5EF4-FFF2-40B4-BE49-F238E27FC236}">
-                <a16:creationId xmlns:a16="http://schemas.microsoft.com/office/drawing/2014/main" id="{B3A19D80-EFA8-F54A-D43D-E1BE828E46F4}"/>
+                <a16:creationId xmlns:a16="http://schemas.microsoft.com/office/drawing/2014/main" id="{B33F91AE-CF5E-1815-2834-08122468714B}"/>
               </a:ext>
             </a:extLst>
           </p:cNvPr>
@@ -2935,7 +2937,7 @@
           <p:cNvPr id="4" name="Marcador de fecha 3">
             <a:extLst>
               <a:ext uri="{FF2B5EF4-FFF2-40B4-BE49-F238E27FC236}">
-                <a16:creationId xmlns:a16="http://schemas.microsoft.com/office/drawing/2014/main" id="{5915F52A-90A3-FD84-C44D-EAA26AAFEB4C}"/>
+                <a16:creationId xmlns:a16="http://schemas.microsoft.com/office/drawing/2014/main" id="{C98A78AB-E7FC-7ACE-2B2B-BED9C7EA474B}"/>
               </a:ext>
             </a:extLst>
           </p:cNvPr>
@@ -2951,7 +2953,7 @@
           <a:bodyPr/>
           <a:lstStyle/>
           <a:p>
-            <a:fld id="{3D6C1A94-3A56-4E71-9AEB-C8DB029FBD9F}" type="datetimeFigureOut">
+            <a:fld id="{C461DEB2-4BB3-433F-9637-3247C637FAE0}" type="datetimeFigureOut">
               <a:rPr lang="es-ES" smtClean="0"/>
               <a:t>05/06/2026</a:t>
             </a:fld>
@@ -2964,7 +2966,7 @@
           <p:cNvPr id="5" name="Marcador de pie de página 4">
             <a:extLst>
               <a:ext uri="{FF2B5EF4-FFF2-40B4-BE49-F238E27FC236}">
-                <a16:creationId xmlns:a16="http://schemas.microsoft.com/office/drawing/2014/main" id="{BD423349-A6EF-D2CC-B5BB-26B05D6C1206}"/>
+                <a16:creationId xmlns:a16="http://schemas.microsoft.com/office/drawing/2014/main" id="{89DC86EB-F43A-A00D-B410-D45B02F718D0}"/>
               </a:ext>
             </a:extLst>
           </p:cNvPr>
@@ -2989,7 +2991,7 @@
           <p:cNvPr id="6" name="Marcador de número de diapositiva 5">
             <a:extLst>
               <a:ext uri="{FF2B5EF4-FFF2-40B4-BE49-F238E27FC236}">
-                <a16:creationId xmlns:a16="http://schemas.microsoft.com/office/drawing/2014/main" id="{0B405928-4BA7-4E4B-5011-FF6727D738E7}"/>
+                <a16:creationId xmlns:a16="http://schemas.microsoft.com/office/drawing/2014/main" id="{710BB58B-E4AD-AC03-00ED-05513C66C127}"/>
               </a:ext>
             </a:extLst>
           </p:cNvPr>
@@ -3005,7 +3007,7 @@
           <a:bodyPr/>
           <a:lstStyle/>
           <a:p>
-            <a:fld id="{2611C5D2-C4B0-4D8A-9AB8-ED270EC4FA17}" type="slidenum">
+            <a:fld id="{B70DEA89-46F8-45E1-B8C6-A199CAA1F9BC}" type="slidenum">
               <a:rPr lang="es-ES" smtClean="0"/>
               <a:t>‹Nº›</a:t>
             </a:fld>
@@ -3016,7 +3018,7 @@
     </p:spTree>
     <p:extLst>
       <p:ext uri="{BB962C8B-B14F-4D97-AF65-F5344CB8AC3E}">
-        <p14:creationId xmlns:p14="http://schemas.microsoft.com/office/powerpoint/2010/main" val="121301234"/>
+        <p14:creationId xmlns:p14="http://schemas.microsoft.com/office/powerpoint/2010/main" val="2220094194"/>
       </p:ext>
     </p:extLst>
   </p:cSld>
@@ -3048,7 +3050,7 @@
           <p:cNvPr id="2" name="Título 1">
             <a:extLst>
               <a:ext uri="{FF2B5EF4-FFF2-40B4-BE49-F238E27FC236}">
-                <a16:creationId xmlns:a16="http://schemas.microsoft.com/office/drawing/2014/main" id="{91946C0F-A254-91AF-793B-D425A708A7CA}"/>
+                <a16:creationId xmlns:a16="http://schemas.microsoft.com/office/drawing/2014/main" id="{2188B0CB-8643-B064-E8AB-43A0570DE207}"/>
               </a:ext>
             </a:extLst>
           </p:cNvPr>
@@ -3085,7 +3087,7 @@
           <p:cNvPr id="3" name="Marcador de texto 2">
             <a:extLst>
               <a:ext uri="{FF2B5EF4-FFF2-40B4-BE49-F238E27FC236}">
-                <a16:creationId xmlns:a16="http://schemas.microsoft.com/office/drawing/2014/main" id="{75B55A87-1F86-7A34-3744-2ED1486A1F27}"/>
+                <a16:creationId xmlns:a16="http://schemas.microsoft.com/office/drawing/2014/main" id="{FF3DAEEF-AAC0-44FA-FF2F-7E51B23D25C0}"/>
               </a:ext>
             </a:extLst>
           </p:cNvPr>
@@ -3210,7 +3212,7 @@
           <p:cNvPr id="4" name="Marcador de fecha 3">
             <a:extLst>
               <a:ext uri="{FF2B5EF4-FFF2-40B4-BE49-F238E27FC236}">
-                <a16:creationId xmlns:a16="http://schemas.microsoft.com/office/drawing/2014/main" id="{DC7E3555-210E-1FAE-D60C-6766B9A0B549}"/>
+                <a16:creationId xmlns:a16="http://schemas.microsoft.com/office/drawing/2014/main" id="{9FEDDA22-487F-0079-9429-96626C25A0DA}"/>
               </a:ext>
             </a:extLst>
           </p:cNvPr>
@@ -3226,7 +3228,7 @@
           <a:bodyPr/>
           <a:lstStyle/>
           <a:p>
-            <a:fld id="{3D6C1A94-3A56-4E71-9AEB-C8DB029FBD9F}" type="datetimeFigureOut">
+            <a:fld id="{C461DEB2-4BB3-433F-9637-3247C637FAE0}" type="datetimeFigureOut">
               <a:rPr lang="es-ES" smtClean="0"/>
               <a:t>05/06/2026</a:t>
             </a:fld>
@@ -3239,7 +3241,7 @@
           <p:cNvPr id="5" name="Marcador de pie de página 4">
             <a:extLst>
               <a:ext uri="{FF2B5EF4-FFF2-40B4-BE49-F238E27FC236}">
-                <a16:creationId xmlns:a16="http://schemas.microsoft.com/office/drawing/2014/main" id="{8B86FBF2-DD54-111F-E34C-C441EEBF2251}"/>
+                <a16:creationId xmlns:a16="http://schemas.microsoft.com/office/drawing/2014/main" id="{755EA9CC-15DB-33B2-8596-7B83836510AB}"/>
               </a:ext>
             </a:extLst>
           </p:cNvPr>
@@ -3264,7 +3266,7 @@
           <p:cNvPr id="6" name="Marcador de número de diapositiva 5">
             <a:extLst>
               <a:ext uri="{FF2B5EF4-FFF2-40B4-BE49-F238E27FC236}">
-                <a16:creationId xmlns:a16="http://schemas.microsoft.com/office/drawing/2014/main" id="{9820B481-7E5D-9A9A-A9EC-7FE4FB017E9C}"/>
+                <a16:creationId xmlns:a16="http://schemas.microsoft.com/office/drawing/2014/main" id="{43D564AD-B25F-83D8-CB7D-F8F71B02535B}"/>
               </a:ext>
             </a:extLst>
           </p:cNvPr>
@@ -3280,7 +3282,7 @@
           <a:bodyPr/>
           <a:lstStyle/>
           <a:p>
-            <a:fld id="{2611C5D2-C4B0-4D8A-9AB8-ED270EC4FA17}" type="slidenum">
+            <a:fld id="{B70DEA89-46F8-45E1-B8C6-A199CAA1F9BC}" type="slidenum">
               <a:rPr lang="es-ES" smtClean="0"/>
               <a:t>‹Nº›</a:t>
             </a:fld>
@@ -3291,7 +3293,7 @@
     </p:spTree>
     <p:extLst>
       <p:ext uri="{BB962C8B-B14F-4D97-AF65-F5344CB8AC3E}">
-        <p14:creationId xmlns:p14="http://schemas.microsoft.com/office/powerpoint/2010/main" val="2514670681"/>
+        <p14:creationId xmlns:p14="http://schemas.microsoft.com/office/powerpoint/2010/main" val="186089756"/>
       </p:ext>
     </p:extLst>
   </p:cSld>
@@ -3323,7 +3325,7 @@
           <p:cNvPr id="2" name="Título 1">
             <a:extLst>
               <a:ext uri="{FF2B5EF4-FFF2-40B4-BE49-F238E27FC236}">
-                <a16:creationId xmlns:a16="http://schemas.microsoft.com/office/drawing/2014/main" id="{B940571E-6C9B-D46E-2B86-51B3FE7D863D}"/>
+                <a16:creationId xmlns:a16="http://schemas.microsoft.com/office/drawing/2014/main" id="{28651E4B-834E-6D74-BEAF-DA2100C9FA34}"/>
               </a:ext>
             </a:extLst>
           </p:cNvPr>
@@ -3351,7 +3353,7 @@
           <p:cNvPr id="3" name="Marcador de contenido 2">
             <a:extLst>
               <a:ext uri="{FF2B5EF4-FFF2-40B4-BE49-F238E27FC236}">
-                <a16:creationId xmlns:a16="http://schemas.microsoft.com/office/drawing/2014/main" id="{7976DA9B-F741-0AD5-4F7D-75BC7AD1C3DA}"/>
+                <a16:creationId xmlns:a16="http://schemas.microsoft.com/office/drawing/2014/main" id="{D1388136-C91A-4484-DD6D-4F83400825C0}"/>
               </a:ext>
             </a:extLst>
           </p:cNvPr>
@@ -3413,7 +3415,7 @@
           <p:cNvPr id="4" name="Marcador de contenido 3">
             <a:extLst>
               <a:ext uri="{FF2B5EF4-FFF2-40B4-BE49-F238E27FC236}">
-                <a16:creationId xmlns:a16="http://schemas.microsoft.com/office/drawing/2014/main" id="{CDA2B0B2-A224-4BFD-9148-E5DED82CDDFD}"/>
+                <a16:creationId xmlns:a16="http://schemas.microsoft.com/office/drawing/2014/main" id="{698D060F-F73A-91FC-87BE-E00D66C0C0D8}"/>
               </a:ext>
             </a:extLst>
           </p:cNvPr>
@@ -3475,7 +3477,7 @@
           <p:cNvPr id="5" name="Marcador de fecha 4">
             <a:extLst>
               <a:ext uri="{FF2B5EF4-FFF2-40B4-BE49-F238E27FC236}">
-                <a16:creationId xmlns:a16="http://schemas.microsoft.com/office/drawing/2014/main" id="{6B9D05DD-3615-0246-B80C-14CA14C03F50}"/>
+                <a16:creationId xmlns:a16="http://schemas.microsoft.com/office/drawing/2014/main" id="{B078E6FA-21B7-9F4A-706F-99B95281C4A8}"/>
               </a:ext>
             </a:extLst>
           </p:cNvPr>
@@ -3491,7 +3493,7 @@
           <a:bodyPr/>
           <a:lstStyle/>
           <a:p>
-            <a:fld id="{3D6C1A94-3A56-4E71-9AEB-C8DB029FBD9F}" type="datetimeFigureOut">
+            <a:fld id="{C461DEB2-4BB3-433F-9637-3247C637FAE0}" type="datetimeFigureOut">
               <a:rPr lang="es-ES" smtClean="0"/>
               <a:t>05/06/2026</a:t>
             </a:fld>
@@ -3504,7 +3506,7 @@
           <p:cNvPr id="6" name="Marcador de pie de página 5">
             <a:extLst>
               <a:ext uri="{FF2B5EF4-FFF2-40B4-BE49-F238E27FC236}">
-                <a16:creationId xmlns:a16="http://schemas.microsoft.com/office/drawing/2014/main" id="{A194695E-F1AC-7766-1056-CA6C9344ACB8}"/>
+                <a16:creationId xmlns:a16="http://schemas.microsoft.com/office/drawing/2014/main" id="{66193498-E1C2-42B0-883A-DD355095AFD8}"/>
               </a:ext>
             </a:extLst>
           </p:cNvPr>
@@ -3529,7 +3531,7 @@
           <p:cNvPr id="7" name="Marcador de número de diapositiva 6">
             <a:extLst>
               <a:ext uri="{FF2B5EF4-FFF2-40B4-BE49-F238E27FC236}">
-                <a16:creationId xmlns:a16="http://schemas.microsoft.com/office/drawing/2014/main" id="{4F1CD08B-F325-1B41-2366-82013EAB5BE4}"/>
+                <a16:creationId xmlns:a16="http://schemas.microsoft.com/office/drawing/2014/main" id="{A9A5CE30-E0BC-39EA-72A4-39A0F5E2CC7F}"/>
               </a:ext>
             </a:extLst>
           </p:cNvPr>
@@ -3545,7 +3547,7 @@
           <a:bodyPr/>
           <a:lstStyle/>
           <a:p>
-            <a:fld id="{2611C5D2-C4B0-4D8A-9AB8-ED270EC4FA17}" type="slidenum">
+            <a:fld id="{B70DEA89-46F8-45E1-B8C6-A199CAA1F9BC}" type="slidenum">
               <a:rPr lang="es-ES" smtClean="0"/>
               <a:t>‹Nº›</a:t>
             </a:fld>
@@ -3556,7 +3558,7 @@
     </p:spTree>
     <p:extLst>
       <p:ext uri="{BB962C8B-B14F-4D97-AF65-F5344CB8AC3E}">
-        <p14:creationId xmlns:p14="http://schemas.microsoft.com/office/powerpoint/2010/main" val="761670945"/>
+        <p14:creationId xmlns:p14="http://schemas.microsoft.com/office/powerpoint/2010/main" val="1378879768"/>
       </p:ext>
     </p:extLst>
   </p:cSld>
@@ -3588,7 +3590,7 @@
           <p:cNvPr id="2" name="Título 1">
             <a:extLst>
               <a:ext uri="{FF2B5EF4-FFF2-40B4-BE49-F238E27FC236}">
-                <a16:creationId xmlns:a16="http://schemas.microsoft.com/office/drawing/2014/main" id="{49C66A95-9CE5-2D04-4A01-D49B9737B483}"/>
+                <a16:creationId xmlns:a16="http://schemas.microsoft.com/office/drawing/2014/main" id="{970A6B0C-CB64-3B5B-59C9-FD1ADE3622A1}"/>
               </a:ext>
             </a:extLst>
           </p:cNvPr>
@@ -3621,7 +3623,7 @@
           <p:cNvPr id="3" name="Marcador de texto 2">
             <a:extLst>
               <a:ext uri="{FF2B5EF4-FFF2-40B4-BE49-F238E27FC236}">
-                <a16:creationId xmlns:a16="http://schemas.microsoft.com/office/drawing/2014/main" id="{C0E4D53F-123D-934E-1A3C-054189665495}"/>
+                <a16:creationId xmlns:a16="http://schemas.microsoft.com/office/drawing/2014/main" id="{6D1C8D09-9A53-8D0F-E540-03622E663F66}"/>
               </a:ext>
             </a:extLst>
           </p:cNvPr>
@@ -3692,7 +3694,7 @@
           <p:cNvPr id="4" name="Marcador de contenido 3">
             <a:extLst>
               <a:ext uri="{FF2B5EF4-FFF2-40B4-BE49-F238E27FC236}">
-                <a16:creationId xmlns:a16="http://schemas.microsoft.com/office/drawing/2014/main" id="{470FC775-A96F-EB95-5C2D-7F1A44C1A1FE}"/>
+                <a16:creationId xmlns:a16="http://schemas.microsoft.com/office/drawing/2014/main" id="{6FCA77A1-0B3D-81F5-457D-773825CEB67E}"/>
               </a:ext>
             </a:extLst>
           </p:cNvPr>
@@ -3754,7 +3756,7 @@
           <p:cNvPr id="5" name="Marcador de texto 4">
             <a:extLst>
               <a:ext uri="{FF2B5EF4-FFF2-40B4-BE49-F238E27FC236}">
-                <a16:creationId xmlns:a16="http://schemas.microsoft.com/office/drawing/2014/main" id="{B8B3AF6F-A543-745A-D64F-39244958B67B}"/>
+                <a16:creationId xmlns:a16="http://schemas.microsoft.com/office/drawing/2014/main" id="{8E82C7A7-9335-0D8B-B3CE-E13938C62393}"/>
               </a:ext>
             </a:extLst>
           </p:cNvPr>
@@ -3825,7 +3827,7 @@
           <p:cNvPr id="6" name="Marcador de contenido 5">
             <a:extLst>
               <a:ext uri="{FF2B5EF4-FFF2-40B4-BE49-F238E27FC236}">
-                <a16:creationId xmlns:a16="http://schemas.microsoft.com/office/drawing/2014/main" id="{B87436A8-AB2C-C6E5-A7EA-5F6E92753977}"/>
+                <a16:creationId xmlns:a16="http://schemas.microsoft.com/office/drawing/2014/main" id="{D9FCF85B-275D-85D7-9563-B858F3D2798A}"/>
               </a:ext>
             </a:extLst>
           </p:cNvPr>
@@ -3887,7 +3889,7 @@
           <p:cNvPr id="7" name="Marcador de fecha 6">
             <a:extLst>
               <a:ext uri="{FF2B5EF4-FFF2-40B4-BE49-F238E27FC236}">
-                <a16:creationId xmlns:a16="http://schemas.microsoft.com/office/drawing/2014/main" id="{88F00297-9D9C-8852-8861-C48B1B2B7D82}"/>
+                <a16:creationId xmlns:a16="http://schemas.microsoft.com/office/drawing/2014/main" id="{AD64A585-0CE6-1E2C-5991-2A90E53DDA66}"/>
               </a:ext>
             </a:extLst>
           </p:cNvPr>
@@ -3903,7 +3905,7 @@
           <a:bodyPr/>
           <a:lstStyle/>
           <a:p>
-            <a:fld id="{3D6C1A94-3A56-4E71-9AEB-C8DB029FBD9F}" type="datetimeFigureOut">
+            <a:fld id="{C461DEB2-4BB3-433F-9637-3247C637FAE0}" type="datetimeFigureOut">
               <a:rPr lang="es-ES" smtClean="0"/>
               <a:t>05/06/2026</a:t>
             </a:fld>
@@ -3916,7 +3918,7 @@
           <p:cNvPr id="8" name="Marcador de pie de página 7">
             <a:extLst>
               <a:ext uri="{FF2B5EF4-FFF2-40B4-BE49-F238E27FC236}">
-                <a16:creationId xmlns:a16="http://schemas.microsoft.com/office/drawing/2014/main" id="{31AD8383-C3BC-49E8-2C81-0AA317C266EB}"/>
+                <a16:creationId xmlns:a16="http://schemas.microsoft.com/office/drawing/2014/main" id="{5027F3FA-DC37-011B-ABD0-10DCB461C5C4}"/>
               </a:ext>
             </a:extLst>
           </p:cNvPr>
@@ -3941,7 +3943,7 @@
           <p:cNvPr id="9" name="Marcador de número de diapositiva 8">
             <a:extLst>
               <a:ext uri="{FF2B5EF4-FFF2-40B4-BE49-F238E27FC236}">
-                <a16:creationId xmlns:a16="http://schemas.microsoft.com/office/drawing/2014/main" id="{B5E8FC84-F2A5-7136-1549-FA0049F83074}"/>
+                <a16:creationId xmlns:a16="http://schemas.microsoft.com/office/drawing/2014/main" id="{A6B11349-C083-4B00-D411-C9389CEF7140}"/>
               </a:ext>
             </a:extLst>
           </p:cNvPr>
@@ -3957,7 +3959,7 @@
           <a:bodyPr/>
           <a:lstStyle/>
           <a:p>
-            <a:fld id="{2611C5D2-C4B0-4D8A-9AB8-ED270EC4FA17}" type="slidenum">
+            <a:fld id="{B70DEA89-46F8-45E1-B8C6-A199CAA1F9BC}" type="slidenum">
               <a:rPr lang="es-ES" smtClean="0"/>
               <a:t>‹Nº›</a:t>
             </a:fld>
@@ -3968,7 +3970,7 @@
     </p:spTree>
     <p:extLst>
       <p:ext uri="{BB962C8B-B14F-4D97-AF65-F5344CB8AC3E}">
-        <p14:creationId xmlns:p14="http://schemas.microsoft.com/office/powerpoint/2010/main" val="3397446774"/>
+        <p14:creationId xmlns:p14="http://schemas.microsoft.com/office/powerpoint/2010/main" val="394636367"/>
       </p:ext>
     </p:extLst>
   </p:cSld>
@@ -4000,7 +4002,7 @@
           <p:cNvPr id="2" name="Título 1">
             <a:extLst>
               <a:ext uri="{FF2B5EF4-FFF2-40B4-BE49-F238E27FC236}">
-                <a16:creationId xmlns:a16="http://schemas.microsoft.com/office/drawing/2014/main" id="{357D07F9-EF96-2B7D-2851-570FDAEEA5E9}"/>
+                <a16:creationId xmlns:a16="http://schemas.microsoft.com/office/drawing/2014/main" id="{01B8CCF7-A8C7-7AC2-F214-F497BFE48299}"/>
               </a:ext>
             </a:extLst>
           </p:cNvPr>
@@ -4028,7 +4030,7 @@
           <p:cNvPr id="3" name="Marcador de fecha 2">
             <a:extLst>
               <a:ext uri="{FF2B5EF4-FFF2-40B4-BE49-F238E27FC236}">
-                <a16:creationId xmlns:a16="http://schemas.microsoft.com/office/drawing/2014/main" id="{BF08E94B-6B67-A831-B820-4B74D47FBDBF}"/>
+                <a16:creationId xmlns:a16="http://schemas.microsoft.com/office/drawing/2014/main" id="{38EF4EF3-C1C9-728A-1B0D-1B19362C3DAD}"/>
               </a:ext>
             </a:extLst>
           </p:cNvPr>
@@ -4044,7 +4046,7 @@
           <a:bodyPr/>
           <a:lstStyle/>
           <a:p>
-            <a:fld id="{3D6C1A94-3A56-4E71-9AEB-C8DB029FBD9F}" type="datetimeFigureOut">
+            <a:fld id="{C461DEB2-4BB3-433F-9637-3247C637FAE0}" type="datetimeFigureOut">
               <a:rPr lang="es-ES" smtClean="0"/>
               <a:t>05/06/2026</a:t>
             </a:fld>
@@ -4057,7 +4059,7 @@
           <p:cNvPr id="4" name="Marcador de pie de página 3">
             <a:extLst>
               <a:ext uri="{FF2B5EF4-FFF2-40B4-BE49-F238E27FC236}">
-                <a16:creationId xmlns:a16="http://schemas.microsoft.com/office/drawing/2014/main" id="{E53CEB2F-56BF-D014-3562-CF71A7B94598}"/>
+                <a16:creationId xmlns:a16="http://schemas.microsoft.com/office/drawing/2014/main" id="{F717D523-C237-D2B2-0968-CCD4911E4FDA}"/>
               </a:ext>
             </a:extLst>
           </p:cNvPr>
@@ -4082,7 +4084,7 @@
           <p:cNvPr id="5" name="Marcador de número de diapositiva 4">
             <a:extLst>
               <a:ext uri="{FF2B5EF4-FFF2-40B4-BE49-F238E27FC236}">
-                <a16:creationId xmlns:a16="http://schemas.microsoft.com/office/drawing/2014/main" id="{0E56849F-0694-E406-D22C-73C4209DA666}"/>
+                <a16:creationId xmlns:a16="http://schemas.microsoft.com/office/drawing/2014/main" id="{18D2B131-9578-1413-AD01-559F68847070}"/>
               </a:ext>
             </a:extLst>
           </p:cNvPr>
@@ -4098,7 +4100,7 @@
           <a:bodyPr/>
           <a:lstStyle/>
           <a:p>
-            <a:fld id="{2611C5D2-C4B0-4D8A-9AB8-ED270EC4FA17}" type="slidenum">
+            <a:fld id="{B70DEA89-46F8-45E1-B8C6-A199CAA1F9BC}" type="slidenum">
               <a:rPr lang="es-ES" smtClean="0"/>
               <a:t>‹Nº›</a:t>
             </a:fld>
@@ -4109,7 +4111,7 @@
     </p:spTree>
     <p:extLst>
       <p:ext uri="{BB962C8B-B14F-4D97-AF65-F5344CB8AC3E}">
-        <p14:creationId xmlns:p14="http://schemas.microsoft.com/office/powerpoint/2010/main" val="2829739566"/>
+        <p14:creationId xmlns:p14="http://schemas.microsoft.com/office/powerpoint/2010/main" val="1992891902"/>
       </p:ext>
     </p:extLst>
   </p:cSld>
@@ -4141,7 +4143,7 @@
           <p:cNvPr id="2" name="Marcador de fecha 1">
             <a:extLst>
               <a:ext uri="{FF2B5EF4-FFF2-40B4-BE49-F238E27FC236}">
-                <a16:creationId xmlns:a16="http://schemas.microsoft.com/office/drawing/2014/main" id="{D4B4DB9A-2EA8-1600-4216-E8F17A5D2486}"/>
+                <a16:creationId xmlns:a16="http://schemas.microsoft.com/office/drawing/2014/main" id="{1154F283-3AA6-61E3-0E7A-DF6A7C38EA3F}"/>
               </a:ext>
             </a:extLst>
           </p:cNvPr>
@@ -4157,7 +4159,7 @@
           <a:bodyPr/>
           <a:lstStyle/>
           <a:p>
-            <a:fld id="{3D6C1A94-3A56-4E71-9AEB-C8DB029FBD9F}" type="datetimeFigureOut">
+            <a:fld id="{C461DEB2-4BB3-433F-9637-3247C637FAE0}" type="datetimeFigureOut">
               <a:rPr lang="es-ES" smtClean="0"/>
               <a:t>05/06/2026</a:t>
             </a:fld>
@@ -4170,7 +4172,7 @@
           <p:cNvPr id="3" name="Marcador de pie de página 2">
             <a:extLst>
               <a:ext uri="{FF2B5EF4-FFF2-40B4-BE49-F238E27FC236}">
-                <a16:creationId xmlns:a16="http://schemas.microsoft.com/office/drawing/2014/main" id="{E7E1201A-53BA-C80B-EFCC-F604FA752FA2}"/>
+                <a16:creationId xmlns:a16="http://schemas.microsoft.com/office/drawing/2014/main" id="{95D164E4-1D7C-64D7-F58C-1F427ADE43C6}"/>
               </a:ext>
             </a:extLst>
           </p:cNvPr>
@@ -4195,7 +4197,7 @@
           <p:cNvPr id="4" name="Marcador de número de diapositiva 3">
             <a:extLst>
               <a:ext uri="{FF2B5EF4-FFF2-40B4-BE49-F238E27FC236}">
-                <a16:creationId xmlns:a16="http://schemas.microsoft.com/office/drawing/2014/main" id="{4598ED7E-218C-99F6-E055-BCFDAEE29A3C}"/>
+                <a16:creationId xmlns:a16="http://schemas.microsoft.com/office/drawing/2014/main" id="{1060D7AB-2776-A6BD-A9DE-A615E03733B3}"/>
               </a:ext>
             </a:extLst>
           </p:cNvPr>
@@ -4211,7 +4213,7 @@
           <a:bodyPr/>
           <a:lstStyle/>
           <a:p>
-            <a:fld id="{2611C5D2-C4B0-4D8A-9AB8-ED270EC4FA17}" type="slidenum">
+            <a:fld id="{B70DEA89-46F8-45E1-B8C6-A199CAA1F9BC}" type="slidenum">
               <a:rPr lang="es-ES" smtClean="0"/>
               <a:t>‹Nº›</a:t>
             </a:fld>
@@ -4222,7 +4224,7 @@
     </p:spTree>
     <p:extLst>
       <p:ext uri="{BB962C8B-B14F-4D97-AF65-F5344CB8AC3E}">
-        <p14:creationId xmlns:p14="http://schemas.microsoft.com/office/powerpoint/2010/main" val="3912801742"/>
+        <p14:creationId xmlns:p14="http://schemas.microsoft.com/office/powerpoint/2010/main" val="466615412"/>
       </p:ext>
     </p:extLst>
   </p:cSld>
@@ -4254,7 +4256,7 @@
           <p:cNvPr id="2" name="Título 1">
             <a:extLst>
               <a:ext uri="{FF2B5EF4-FFF2-40B4-BE49-F238E27FC236}">
-                <a16:creationId xmlns:a16="http://schemas.microsoft.com/office/drawing/2014/main" id="{F6EE81E0-A3CF-B9AB-6B94-3BE53F784E09}"/>
+                <a16:creationId xmlns:a16="http://schemas.microsoft.com/office/drawing/2014/main" id="{CD055A39-0470-91DF-34FE-75D075A09B87}"/>
               </a:ext>
             </a:extLst>
           </p:cNvPr>
@@ -4291,7 +4293,7 @@
           <p:cNvPr id="3" name="Marcador de contenido 2">
             <a:extLst>
               <a:ext uri="{FF2B5EF4-FFF2-40B4-BE49-F238E27FC236}">
-                <a16:creationId xmlns:a16="http://schemas.microsoft.com/office/drawing/2014/main" id="{9BD10B93-7197-B86D-9AB3-EBD92E8E9A5E}"/>
+                <a16:creationId xmlns:a16="http://schemas.microsoft.com/office/drawing/2014/main" id="{DD56824D-5E37-BECA-8DAB-39890878517C}"/>
               </a:ext>
             </a:extLst>
           </p:cNvPr>
@@ -4381,7 +4383,7 @@
           <p:cNvPr id="4" name="Marcador de texto 3">
             <a:extLst>
               <a:ext uri="{FF2B5EF4-FFF2-40B4-BE49-F238E27FC236}">
-                <a16:creationId xmlns:a16="http://schemas.microsoft.com/office/drawing/2014/main" id="{8E1B01C2-7EE5-B34D-336F-FA3BF6A11D59}"/>
+                <a16:creationId xmlns:a16="http://schemas.microsoft.com/office/drawing/2014/main" id="{53BF99B0-3E1A-2C2A-E004-547EAD34A17E}"/>
               </a:ext>
             </a:extLst>
           </p:cNvPr>
@@ -4452,7 +4454,7 @@
           <p:cNvPr id="5" name="Marcador de fecha 4">
             <a:extLst>
               <a:ext uri="{FF2B5EF4-FFF2-40B4-BE49-F238E27FC236}">
-                <a16:creationId xmlns:a16="http://schemas.microsoft.com/office/drawing/2014/main" id="{D6F2D7BB-C48A-3B70-80E2-6AF5003F810D}"/>
+                <a16:creationId xmlns:a16="http://schemas.microsoft.com/office/drawing/2014/main" id="{612E2C92-4994-1905-5222-CF9D0047DB24}"/>
               </a:ext>
             </a:extLst>
           </p:cNvPr>
@@ -4468,7 +4470,7 @@
           <a:bodyPr/>
           <a:lstStyle/>
           <a:p>
-            <a:fld id="{3D6C1A94-3A56-4E71-9AEB-C8DB029FBD9F}" type="datetimeFigureOut">
+            <a:fld id="{C461DEB2-4BB3-433F-9637-3247C637FAE0}" type="datetimeFigureOut">
               <a:rPr lang="es-ES" smtClean="0"/>
               <a:t>05/06/2026</a:t>
             </a:fld>
@@ -4481,7 +4483,7 @@
           <p:cNvPr id="6" name="Marcador de pie de página 5">
             <a:extLst>
               <a:ext uri="{FF2B5EF4-FFF2-40B4-BE49-F238E27FC236}">
-                <a16:creationId xmlns:a16="http://schemas.microsoft.com/office/drawing/2014/main" id="{E807030A-BFEF-C8D9-1571-6F3F18374698}"/>
+                <a16:creationId xmlns:a16="http://schemas.microsoft.com/office/drawing/2014/main" id="{B7E6B257-408D-01AA-45C2-BF431E6A6B96}"/>
               </a:ext>
             </a:extLst>
           </p:cNvPr>
@@ -4506,7 +4508,7 @@
           <p:cNvPr id="7" name="Marcador de número de diapositiva 6">
             <a:extLst>
               <a:ext uri="{FF2B5EF4-FFF2-40B4-BE49-F238E27FC236}">
-                <a16:creationId xmlns:a16="http://schemas.microsoft.com/office/drawing/2014/main" id="{C9AF142C-CE0E-65B6-8781-E739C9F9A4E1}"/>
+                <a16:creationId xmlns:a16="http://schemas.microsoft.com/office/drawing/2014/main" id="{A590E6CF-C1D4-C9F4-7196-F591409EC533}"/>
               </a:ext>
             </a:extLst>
           </p:cNvPr>
@@ -4522,7 +4524,7 @@
           <a:bodyPr/>
           <a:lstStyle/>
           <a:p>
-            <a:fld id="{2611C5D2-C4B0-4D8A-9AB8-ED270EC4FA17}" type="slidenum">
+            <a:fld id="{B70DEA89-46F8-45E1-B8C6-A199CAA1F9BC}" type="slidenum">
               <a:rPr lang="es-ES" smtClean="0"/>
               <a:t>‹Nº›</a:t>
             </a:fld>
@@ -4533,7 +4535,7 @@
     </p:spTree>
     <p:extLst>
       <p:ext uri="{BB962C8B-B14F-4D97-AF65-F5344CB8AC3E}">
-        <p14:creationId xmlns:p14="http://schemas.microsoft.com/office/powerpoint/2010/main" val="1169470913"/>
+        <p14:creationId xmlns:p14="http://schemas.microsoft.com/office/powerpoint/2010/main" val="2049051304"/>
       </p:ext>
     </p:extLst>
   </p:cSld>
@@ -4565,7 +4567,7 @@
           <p:cNvPr id="2" name="Título 1">
             <a:extLst>
               <a:ext uri="{FF2B5EF4-FFF2-40B4-BE49-F238E27FC236}">
-                <a16:creationId xmlns:a16="http://schemas.microsoft.com/office/drawing/2014/main" id="{63DD1150-B718-9881-2449-A18B74A2FBEB}"/>
+                <a16:creationId xmlns:a16="http://schemas.microsoft.com/office/drawing/2014/main" id="{5E013734-85ED-A24B-4421-8A9BFD37807A}"/>
               </a:ext>
             </a:extLst>
           </p:cNvPr>
@@ -4602,7 +4604,7 @@
           <p:cNvPr id="3" name="Marcador de posición de imagen 2">
             <a:extLst>
               <a:ext uri="{FF2B5EF4-FFF2-40B4-BE49-F238E27FC236}">
-                <a16:creationId xmlns:a16="http://schemas.microsoft.com/office/drawing/2014/main" id="{3576EB53-9C10-F643-A6E9-FA3100BB59F7}"/>
+                <a16:creationId xmlns:a16="http://schemas.microsoft.com/office/drawing/2014/main" id="{1B388422-47A6-B6BD-1026-CC2BC981C22C}"/>
               </a:ext>
             </a:extLst>
           </p:cNvPr>
@@ -4669,7 +4671,7 @@
           <p:cNvPr id="4" name="Marcador de texto 3">
             <a:extLst>
               <a:ext uri="{FF2B5EF4-FFF2-40B4-BE49-F238E27FC236}">
-                <a16:creationId xmlns:a16="http://schemas.microsoft.com/office/drawing/2014/main" id="{91CE74E7-E6CC-3EFD-0E20-BA674F5A2CDA}"/>
+                <a16:creationId xmlns:a16="http://schemas.microsoft.com/office/drawing/2014/main" id="{568E8F76-E769-0922-DB9B-C99EB60BD321}"/>
               </a:ext>
             </a:extLst>
           </p:cNvPr>
@@ -4740,7 +4742,7 @@
           <p:cNvPr id="5" name="Marcador de fecha 4">
             <a:extLst>
               <a:ext uri="{FF2B5EF4-FFF2-40B4-BE49-F238E27FC236}">
-                <a16:creationId xmlns:a16="http://schemas.microsoft.com/office/drawing/2014/main" id="{557A0C8A-4B60-08DA-29ED-58C6CC6CA398}"/>
+                <a16:creationId xmlns:a16="http://schemas.microsoft.com/office/drawing/2014/main" id="{F76E4D32-88EF-B268-5561-E27632B1C1A9}"/>
               </a:ext>
             </a:extLst>
           </p:cNvPr>
@@ -4756,7 +4758,7 @@
           <a:bodyPr/>
           <a:lstStyle/>
           <a:p>
-            <a:fld id="{3D6C1A94-3A56-4E71-9AEB-C8DB029FBD9F}" type="datetimeFigureOut">
+            <a:fld id="{C461DEB2-4BB3-433F-9637-3247C637FAE0}" type="datetimeFigureOut">
               <a:rPr lang="es-ES" smtClean="0"/>
               <a:t>05/06/2026</a:t>
             </a:fld>
@@ -4769,7 +4771,7 @@
           <p:cNvPr id="6" name="Marcador de pie de página 5">
             <a:extLst>
               <a:ext uri="{FF2B5EF4-FFF2-40B4-BE49-F238E27FC236}">
-                <a16:creationId xmlns:a16="http://schemas.microsoft.com/office/drawing/2014/main" id="{3509AA00-B02B-9A06-75FD-B49499226EA5}"/>
+                <a16:creationId xmlns:a16="http://schemas.microsoft.com/office/drawing/2014/main" id="{3B4A94D4-E9AA-7EA5-D9C7-8C47164B29EF}"/>
               </a:ext>
             </a:extLst>
           </p:cNvPr>
@@ -4794,7 +4796,7 @@
           <p:cNvPr id="7" name="Marcador de número de diapositiva 6">
             <a:extLst>
               <a:ext uri="{FF2B5EF4-FFF2-40B4-BE49-F238E27FC236}">
-                <a16:creationId xmlns:a16="http://schemas.microsoft.com/office/drawing/2014/main" id="{763456D0-8854-70FD-E60F-1589A6FD76C6}"/>
+                <a16:creationId xmlns:a16="http://schemas.microsoft.com/office/drawing/2014/main" id="{877E1BF3-E9CA-3E78-DDA2-6B7E1A5FCB64}"/>
               </a:ext>
             </a:extLst>
           </p:cNvPr>
@@ -4810,7 +4812,7 @@
           <a:bodyPr/>
           <a:lstStyle/>
           <a:p>
-            <a:fld id="{2611C5D2-C4B0-4D8A-9AB8-ED270EC4FA17}" type="slidenum">
+            <a:fld id="{B70DEA89-46F8-45E1-B8C6-A199CAA1F9BC}" type="slidenum">
               <a:rPr lang="es-ES" smtClean="0"/>
               <a:t>‹Nº›</a:t>
             </a:fld>
@@ -4821,7 +4823,7 @@
     </p:spTree>
     <p:extLst>
       <p:ext uri="{BB962C8B-B14F-4D97-AF65-F5344CB8AC3E}">
-        <p14:creationId xmlns:p14="http://schemas.microsoft.com/office/powerpoint/2010/main" val="2518576910"/>
+        <p14:creationId xmlns:p14="http://schemas.microsoft.com/office/powerpoint/2010/main" val="1300706264"/>
       </p:ext>
     </p:extLst>
   </p:cSld>
@@ -4858,7 +4860,7 @@
           <p:cNvPr id="2" name="Marcador de título 1">
             <a:extLst>
               <a:ext uri="{FF2B5EF4-FFF2-40B4-BE49-F238E27FC236}">
-                <a16:creationId xmlns:a16="http://schemas.microsoft.com/office/drawing/2014/main" id="{70C97680-CC07-D41C-1519-9A7C78F98B88}"/>
+                <a16:creationId xmlns:a16="http://schemas.microsoft.com/office/drawing/2014/main" id="{C2299F70-BDDD-71B6-049C-8956A098945B}"/>
               </a:ext>
             </a:extLst>
           </p:cNvPr>
@@ -4896,7 +4898,7 @@
           <p:cNvPr id="3" name="Marcador de texto 2">
             <a:extLst>
               <a:ext uri="{FF2B5EF4-FFF2-40B4-BE49-F238E27FC236}">
-                <a16:creationId xmlns:a16="http://schemas.microsoft.com/office/drawing/2014/main" id="{C08F7488-31FB-963C-BE3E-C837505AA37D}"/>
+                <a16:creationId xmlns:a16="http://schemas.microsoft.com/office/drawing/2014/main" id="{F27F7B85-DAD1-CFA2-75AB-80F6EC350FA6}"/>
               </a:ext>
             </a:extLst>
           </p:cNvPr>
@@ -4963,7 +4965,7 @@
           <p:cNvPr id="4" name="Marcador de fecha 3">
             <a:extLst>
               <a:ext uri="{FF2B5EF4-FFF2-40B4-BE49-F238E27FC236}">
-                <a16:creationId xmlns:a16="http://schemas.microsoft.com/office/drawing/2014/main" id="{9B3EBE77-EAA3-2656-7326-0F394ABDACA6}"/>
+                <a16:creationId xmlns:a16="http://schemas.microsoft.com/office/drawing/2014/main" id="{82233BD8-B367-592C-377F-72620308EFA5}"/>
               </a:ext>
             </a:extLst>
           </p:cNvPr>
@@ -4997,7 +4999,7 @@
             </a:lvl1pPr>
           </a:lstStyle>
           <a:p>
-            <a:fld id="{3D6C1A94-3A56-4E71-9AEB-C8DB029FBD9F}" type="datetimeFigureOut">
+            <a:fld id="{C461DEB2-4BB3-433F-9637-3247C637FAE0}" type="datetimeFigureOut">
               <a:rPr lang="es-ES" smtClean="0"/>
               <a:t>05/06/2026</a:t>
             </a:fld>
@@ -5010,7 +5012,7 @@
           <p:cNvPr id="5" name="Marcador de pie de página 4">
             <a:extLst>
               <a:ext uri="{FF2B5EF4-FFF2-40B4-BE49-F238E27FC236}">
-                <a16:creationId xmlns:a16="http://schemas.microsoft.com/office/drawing/2014/main" id="{AF3C918C-B71C-3A60-83AD-F1CC63AE1363}"/>
+                <a16:creationId xmlns:a16="http://schemas.microsoft.com/office/drawing/2014/main" id="{0445FF9D-34F1-0D73-8C9E-C4AACDB9EF33}"/>
               </a:ext>
             </a:extLst>
           </p:cNvPr>
@@ -5053,7 +5055,7 @@
           <p:cNvPr id="6" name="Marcador de número de diapositiva 5">
             <a:extLst>
               <a:ext uri="{FF2B5EF4-FFF2-40B4-BE49-F238E27FC236}">
-                <a16:creationId xmlns:a16="http://schemas.microsoft.com/office/drawing/2014/main" id="{A5AF903D-3E47-D9F5-E7C1-37B208FF17C7}"/>
+                <a16:creationId xmlns:a16="http://schemas.microsoft.com/office/drawing/2014/main" id="{5BD6FBC9-6894-F4D8-2E92-F146C9DC6064}"/>
               </a:ext>
             </a:extLst>
           </p:cNvPr>
@@ -5087,7 +5089,7 @@
             </a:lvl1pPr>
           </a:lstStyle>
           <a:p>
-            <a:fld id="{2611C5D2-C4B0-4D8A-9AB8-ED270EC4FA17}" type="slidenum">
+            <a:fld id="{B70DEA89-46F8-45E1-B8C6-A199CAA1F9BC}" type="slidenum">
               <a:rPr lang="es-ES" smtClean="0"/>
               <a:t>‹Nº›</a:t>
             </a:fld>
@@ -5098,7 +5100,7 @@
     </p:spTree>
     <p:extLst>
       <p:ext uri="{BB962C8B-B14F-4D97-AF65-F5344CB8AC3E}">
-        <p14:creationId xmlns:p14="http://schemas.microsoft.com/office/powerpoint/2010/main" val="754063171"/>
+        <p14:creationId xmlns:p14="http://schemas.microsoft.com/office/powerpoint/2010/main" val="2787686755"/>
       </p:ext>
     </p:extLst>
   </p:cSld>
@@ -5429,7 +5431,7 @@
           <p:cNvPr id="2" name="Rectángulo: esquinas redondeadas 1">
             <a:extLst>
               <a:ext uri="{FF2B5EF4-FFF2-40B4-BE49-F238E27FC236}">
-                <a16:creationId xmlns:a16="http://schemas.microsoft.com/office/drawing/2014/main" id="{16E9DF3F-4C02-EF1F-1713-652A9B11A307}"/>
+                <a16:creationId xmlns:a16="http://schemas.microsoft.com/office/drawing/2014/main" id="{AF96811D-A434-42A6-63E8-2B8113EB6DA1}"/>
               </a:ext>
             </a:extLst>
           </p:cNvPr>
@@ -5483,7 +5485,7 @@
           <p:cNvPr id="3" name="CuadroTexto 2">
             <a:extLst>
               <a:ext uri="{FF2B5EF4-FFF2-40B4-BE49-F238E27FC236}">
-                <a16:creationId xmlns:a16="http://schemas.microsoft.com/office/drawing/2014/main" id="{6A9572C4-1714-F03D-BF80-F3FA7D192014}"/>
+                <a16:creationId xmlns:a16="http://schemas.microsoft.com/office/drawing/2014/main" id="{821CF857-B71E-8912-A838-6EE662D1B1A8}"/>
               </a:ext>
             </a:extLst>
           </p:cNvPr>
@@ -5523,7 +5525,7 @@
           <p:cNvPr id="4" name="CuadroTexto 3">
             <a:extLst>
               <a:ext uri="{FF2B5EF4-FFF2-40B4-BE49-F238E27FC236}">
-                <a16:creationId xmlns:a16="http://schemas.microsoft.com/office/drawing/2014/main" id="{6AF93AD2-B888-3654-ECCC-0952CE6E9295}"/>
+                <a16:creationId xmlns:a16="http://schemas.microsoft.com/office/drawing/2014/main" id="{47EB8DFF-0F44-C7DD-B9CB-65ACCD24A780}"/>
               </a:ext>
             </a:extLst>
           </p:cNvPr>
@@ -5563,7 +5565,7 @@
           <p:cNvPr id="5" name="CuadroTexto 4">
             <a:extLst>
               <a:ext uri="{FF2B5EF4-FFF2-40B4-BE49-F238E27FC236}">
-                <a16:creationId xmlns:a16="http://schemas.microsoft.com/office/drawing/2014/main" id="{B2595E12-4BE6-1DF5-74C1-FC12545E62ED}"/>
+                <a16:creationId xmlns:a16="http://schemas.microsoft.com/office/drawing/2014/main" id="{233BBCBA-6AFC-F67B-4D98-9BBA9408C01A}"/>
               </a:ext>
             </a:extLst>
           </p:cNvPr>
@@ -5603,7 +5605,7 @@
           <p:cNvPr id="6" name="CuadroTexto 5">
             <a:extLst>
               <a:ext uri="{FF2B5EF4-FFF2-40B4-BE49-F238E27FC236}">
-                <a16:creationId xmlns:a16="http://schemas.microsoft.com/office/drawing/2014/main" id="{ECA88EED-0A56-E5BB-BB42-BFAABC3E9E50}"/>
+                <a16:creationId xmlns:a16="http://schemas.microsoft.com/office/drawing/2014/main" id="{ED1543CB-BD7E-6C3B-0E8A-5214C06CA04A}"/>
               </a:ext>
             </a:extLst>
           </p:cNvPr>
@@ -5654,7 +5656,7 @@
           <p:cNvPr id="8" name="Imagen 7">
             <a:extLst>
               <a:ext uri="{FF2B5EF4-FFF2-40B4-BE49-F238E27FC236}">
-                <a16:creationId xmlns:a16="http://schemas.microsoft.com/office/drawing/2014/main" id="{67F20F40-BB58-833A-3298-5B0F17E0A073}"/>
+                <a16:creationId xmlns:a16="http://schemas.microsoft.com/office/drawing/2014/main" id="{5B1EAC07-1FF0-A08C-E9D0-BC571E7FEF29}"/>
               </a:ext>
             </a:extLst>
           </p:cNvPr>
@@ -5693,7 +5695,7 @@
     </p:spTree>
     <p:extLst>
       <p:ext uri="{BB962C8B-B14F-4D97-AF65-F5344CB8AC3E}">
-        <p14:creationId xmlns:p14="http://schemas.microsoft.com/office/powerpoint/2010/main" val="3210793120"/>
+        <p14:creationId xmlns:p14="http://schemas.microsoft.com/office/powerpoint/2010/main" val="1075202277"/>
       </p:ext>
     </p:extLst>
   </p:cSld>
@@ -5733,7 +5735,7 @@
           <p:cNvPr id="2" name="CuadroTexto 1">
             <a:extLst>
               <a:ext uri="{FF2B5EF4-FFF2-40B4-BE49-F238E27FC236}">
-                <a16:creationId xmlns:a16="http://schemas.microsoft.com/office/drawing/2014/main" id="{390A16C3-3288-0271-06FF-E2C9062BE7B6}"/>
+                <a16:creationId xmlns:a16="http://schemas.microsoft.com/office/drawing/2014/main" id="{D6238956-F9F1-21DF-B9AE-D617C3C8BA18}"/>
               </a:ext>
             </a:extLst>
           </p:cNvPr>
@@ -5773,7 +5775,7 @@
           <p:cNvPr id="3" name="CuadroTexto 2">
             <a:extLst>
               <a:ext uri="{FF2B5EF4-FFF2-40B4-BE49-F238E27FC236}">
-                <a16:creationId xmlns:a16="http://schemas.microsoft.com/office/drawing/2014/main" id="{9B27D037-BD55-882A-003F-BEDA531615E8}"/>
+                <a16:creationId xmlns:a16="http://schemas.microsoft.com/office/drawing/2014/main" id="{A8882FB6-0A32-FE64-4830-E4B8812B88E4}"/>
               </a:ext>
             </a:extLst>
           </p:cNvPr>
@@ -5813,7 +5815,7 @@
           <p:cNvPr id="4" name="CuadroTexto 3">
             <a:extLst>
               <a:ext uri="{FF2B5EF4-FFF2-40B4-BE49-F238E27FC236}">
-                <a16:creationId xmlns:a16="http://schemas.microsoft.com/office/drawing/2014/main" id="{D3015EDF-06E3-EFE8-19C9-29CD66FE53E7}"/>
+                <a16:creationId xmlns:a16="http://schemas.microsoft.com/office/drawing/2014/main" id="{6CDDC6D0-E940-4066-9031-440A69EF96DA}"/>
               </a:ext>
             </a:extLst>
           </p:cNvPr>
@@ -5853,7 +5855,7 @@
           <p:cNvPr id="5" name="Rectángulo: esquinas redondeadas 4">
             <a:extLst>
               <a:ext uri="{FF2B5EF4-FFF2-40B4-BE49-F238E27FC236}">
-                <a16:creationId xmlns:a16="http://schemas.microsoft.com/office/drawing/2014/main" id="{A6D5E433-E59F-902F-A9C9-1F63EC9571F5}"/>
+                <a16:creationId xmlns:a16="http://schemas.microsoft.com/office/drawing/2014/main" id="{525BF652-B783-BC8B-23B8-F7A0A849AEEB}"/>
               </a:ext>
             </a:extLst>
           </p:cNvPr>
@@ -5907,7 +5909,7 @@
           <p:cNvPr id="6" name="CuadroTexto 5">
             <a:extLst>
               <a:ext uri="{FF2B5EF4-FFF2-40B4-BE49-F238E27FC236}">
-                <a16:creationId xmlns:a16="http://schemas.microsoft.com/office/drawing/2014/main" id="{0C9107E9-B34E-4FCD-FD87-9BD2F46FCAE7}"/>
+                <a16:creationId xmlns:a16="http://schemas.microsoft.com/office/drawing/2014/main" id="{1325E608-422E-7A7E-ABA6-E944A5AC7E59}"/>
               </a:ext>
             </a:extLst>
           </p:cNvPr>
@@ -5947,7 +5949,7 @@
           <p:cNvPr id="7" name="CuadroTexto 6">
             <a:extLst>
               <a:ext uri="{FF2B5EF4-FFF2-40B4-BE49-F238E27FC236}">
-                <a16:creationId xmlns:a16="http://schemas.microsoft.com/office/drawing/2014/main" id="{7E5C3433-CE17-57F6-9501-EC4E0353282B}"/>
+                <a16:creationId xmlns:a16="http://schemas.microsoft.com/office/drawing/2014/main" id="{8BFFA19F-77A4-F5DD-57AE-58F202F73837}"/>
               </a:ext>
             </a:extLst>
           </p:cNvPr>
@@ -6066,7 +6068,7 @@
           <p:cNvPr id="8" name="Rectángulo: esquinas redondeadas 7">
             <a:extLst>
               <a:ext uri="{FF2B5EF4-FFF2-40B4-BE49-F238E27FC236}">
-                <a16:creationId xmlns:a16="http://schemas.microsoft.com/office/drawing/2014/main" id="{3A21867A-E207-4622-B762-39022771BAE8}"/>
+                <a16:creationId xmlns:a16="http://schemas.microsoft.com/office/drawing/2014/main" id="{8029FD4D-05F1-8F92-9150-FA3DA85FAE95}"/>
               </a:ext>
             </a:extLst>
           </p:cNvPr>
@@ -6120,7 +6122,7 @@
           <p:cNvPr id="9" name="CuadroTexto 8">
             <a:extLst>
               <a:ext uri="{FF2B5EF4-FFF2-40B4-BE49-F238E27FC236}">
-                <a16:creationId xmlns:a16="http://schemas.microsoft.com/office/drawing/2014/main" id="{B63A64E3-0276-A408-B412-220221EE1FB9}"/>
+                <a16:creationId xmlns:a16="http://schemas.microsoft.com/office/drawing/2014/main" id="{9B98613D-CA1E-8F18-34F3-E82A99B13ED4}"/>
               </a:ext>
             </a:extLst>
           </p:cNvPr>
@@ -6160,7 +6162,7 @@
           <p:cNvPr id="10" name="CuadroTexto 9">
             <a:extLst>
               <a:ext uri="{FF2B5EF4-FFF2-40B4-BE49-F238E27FC236}">
-                <a16:creationId xmlns:a16="http://schemas.microsoft.com/office/drawing/2014/main" id="{9E861F65-3806-B020-00A5-2F908129591B}"/>
+                <a16:creationId xmlns:a16="http://schemas.microsoft.com/office/drawing/2014/main" id="{1ACED17E-1448-E710-8F02-CBEA5253148F}"/>
               </a:ext>
             </a:extLst>
           </p:cNvPr>
@@ -6200,7 +6202,7 @@
           <p:cNvPr id="11" name="Rectángulo: esquinas redondeadas 10">
             <a:extLst>
               <a:ext uri="{FF2B5EF4-FFF2-40B4-BE49-F238E27FC236}">
-                <a16:creationId xmlns:a16="http://schemas.microsoft.com/office/drawing/2014/main" id="{CD752376-BA76-E31A-415D-18C0CB1AAA82}"/>
+                <a16:creationId xmlns:a16="http://schemas.microsoft.com/office/drawing/2014/main" id="{203A7113-7388-EB99-5CE8-06BAF86ED964}"/>
               </a:ext>
             </a:extLst>
           </p:cNvPr>
@@ -6254,7 +6256,7 @@
           <p:cNvPr id="12" name="CuadroTexto 11">
             <a:extLst>
               <a:ext uri="{FF2B5EF4-FFF2-40B4-BE49-F238E27FC236}">
-                <a16:creationId xmlns:a16="http://schemas.microsoft.com/office/drawing/2014/main" id="{6E9FA1A7-2D9A-6A41-65A2-877F01189D3E}"/>
+                <a16:creationId xmlns:a16="http://schemas.microsoft.com/office/drawing/2014/main" id="{7824C22A-9E0C-B052-CCB1-3CA6BB0D3B75}"/>
               </a:ext>
             </a:extLst>
           </p:cNvPr>
@@ -6294,7 +6296,7 @@
           <p:cNvPr id="13" name="CuadroTexto 12">
             <a:extLst>
               <a:ext uri="{FF2B5EF4-FFF2-40B4-BE49-F238E27FC236}">
-                <a16:creationId xmlns:a16="http://schemas.microsoft.com/office/drawing/2014/main" id="{5DF9A117-488C-6195-10AE-31F4D7B951D6}"/>
+                <a16:creationId xmlns:a16="http://schemas.microsoft.com/office/drawing/2014/main" id="{AE5BC097-C96C-3375-BF52-592310A40738}"/>
               </a:ext>
             </a:extLst>
           </p:cNvPr>
@@ -6334,7 +6336,7 @@
           <p:cNvPr id="14" name="Rectángulo: esquinas redondeadas 13">
             <a:extLst>
               <a:ext uri="{FF2B5EF4-FFF2-40B4-BE49-F238E27FC236}">
-                <a16:creationId xmlns:a16="http://schemas.microsoft.com/office/drawing/2014/main" id="{D99960CD-3D65-A34F-176C-32B4214632C6}"/>
+                <a16:creationId xmlns:a16="http://schemas.microsoft.com/office/drawing/2014/main" id="{2F79E6C9-3A73-7CF5-02BF-FE0F2E959A78}"/>
               </a:ext>
             </a:extLst>
           </p:cNvPr>
@@ -6388,7 +6390,7 @@
           <p:cNvPr id="15" name="CuadroTexto 14">
             <a:extLst>
               <a:ext uri="{FF2B5EF4-FFF2-40B4-BE49-F238E27FC236}">
-                <a16:creationId xmlns:a16="http://schemas.microsoft.com/office/drawing/2014/main" id="{686C87F7-561A-3FE3-FC00-49C01D6121C9}"/>
+                <a16:creationId xmlns:a16="http://schemas.microsoft.com/office/drawing/2014/main" id="{B11FB8C9-B409-BB7A-4729-9CCBE06BB9DE}"/>
               </a:ext>
             </a:extLst>
           </p:cNvPr>
@@ -6428,7 +6430,7 @@
           <p:cNvPr id="16" name="CuadroTexto 15">
             <a:extLst>
               <a:ext uri="{FF2B5EF4-FFF2-40B4-BE49-F238E27FC236}">
-                <a16:creationId xmlns:a16="http://schemas.microsoft.com/office/drawing/2014/main" id="{7EFA092D-1E62-64BD-644E-F562C6B90A4D}"/>
+                <a16:creationId xmlns:a16="http://schemas.microsoft.com/office/drawing/2014/main" id="{68E7AD88-F9E6-E814-5329-2AAE13570D54}"/>
               </a:ext>
             </a:extLst>
           </p:cNvPr>
@@ -6468,7 +6470,7 @@
           <p:cNvPr id="17" name="Rectángulo: esquinas redondeadas 16">
             <a:extLst>
               <a:ext uri="{FF2B5EF4-FFF2-40B4-BE49-F238E27FC236}">
-                <a16:creationId xmlns:a16="http://schemas.microsoft.com/office/drawing/2014/main" id="{1A1E7455-192C-D083-27C1-334FEC687675}"/>
+                <a16:creationId xmlns:a16="http://schemas.microsoft.com/office/drawing/2014/main" id="{F50FE268-20A4-237A-2CB2-02096FB6040A}"/>
               </a:ext>
             </a:extLst>
           </p:cNvPr>
@@ -6522,7 +6524,7 @@
           <p:cNvPr id="18" name="CuadroTexto 17">
             <a:extLst>
               <a:ext uri="{FF2B5EF4-FFF2-40B4-BE49-F238E27FC236}">
-                <a16:creationId xmlns:a16="http://schemas.microsoft.com/office/drawing/2014/main" id="{70B719C6-4885-AF1E-D202-B201C13AFCD4}"/>
+                <a16:creationId xmlns:a16="http://schemas.microsoft.com/office/drawing/2014/main" id="{56C3565F-51D7-0EAB-BF80-D830B652995F}"/>
               </a:ext>
             </a:extLst>
           </p:cNvPr>
@@ -6562,7 +6564,7 @@
           <p:cNvPr id="19" name="CuadroTexto 18">
             <a:extLst>
               <a:ext uri="{FF2B5EF4-FFF2-40B4-BE49-F238E27FC236}">
-                <a16:creationId xmlns:a16="http://schemas.microsoft.com/office/drawing/2014/main" id="{ED0027ED-962D-0F86-DEC3-5B0F7B52936E}"/>
+                <a16:creationId xmlns:a16="http://schemas.microsoft.com/office/drawing/2014/main" id="{A6393A47-7F89-C2B5-ACAD-EDE96FD5C876}"/>
               </a:ext>
             </a:extLst>
           </p:cNvPr>
@@ -6592,7 +6594,7 @@
                 </a:solidFill>
                 <a:latin typeface="Segoe UI" panose="020B0502040204020203" pitchFamily="34" charset="0"/>
               </a:rPr>
-              <a:t>Si se rechaza llega correo y el estado sigue visible en el portal.</a:t>
+              <a:t>El estado y motivo quedan visibles; si Brevo esta disponible tambien se envia correo.</a:t>
             </a:r>
           </a:p>
         </p:txBody>
@@ -6600,7 +6602,7 @@
     </p:spTree>
     <p:extLst>
       <p:ext uri="{BB962C8B-B14F-4D97-AF65-F5344CB8AC3E}">
-        <p14:creationId xmlns:p14="http://schemas.microsoft.com/office/powerpoint/2010/main" val="3352489594"/>
+        <p14:creationId xmlns:p14="http://schemas.microsoft.com/office/powerpoint/2010/main" val="163575925"/>
       </p:ext>
     </p:extLst>
   </p:cSld>
@@ -6640,7 +6642,7 @@
           <p:cNvPr id="2" name="CuadroTexto 1">
             <a:extLst>
               <a:ext uri="{FF2B5EF4-FFF2-40B4-BE49-F238E27FC236}">
-                <a16:creationId xmlns:a16="http://schemas.microsoft.com/office/drawing/2014/main" id="{1B5D9D3E-2D3A-2296-DCEC-F20A9EC26F05}"/>
+                <a16:creationId xmlns:a16="http://schemas.microsoft.com/office/drawing/2014/main" id="{4B35FDC4-31DD-4A56-B6C8-59B0D8A50B67}"/>
               </a:ext>
             </a:extLst>
           </p:cNvPr>
@@ -6680,7 +6682,7 @@
           <p:cNvPr id="3" name="CuadroTexto 2">
             <a:extLst>
               <a:ext uri="{FF2B5EF4-FFF2-40B4-BE49-F238E27FC236}">
-                <a16:creationId xmlns:a16="http://schemas.microsoft.com/office/drawing/2014/main" id="{21FB00C9-C30F-91CD-091F-6C3F74DF53B2}"/>
+                <a16:creationId xmlns:a16="http://schemas.microsoft.com/office/drawing/2014/main" id="{0868D9AE-5154-D1FA-EB34-D44C67502FA7}"/>
               </a:ext>
             </a:extLst>
           </p:cNvPr>
@@ -6720,7 +6722,7 @@
           <p:cNvPr id="4" name="CuadroTexto 3">
             <a:extLst>
               <a:ext uri="{FF2B5EF4-FFF2-40B4-BE49-F238E27FC236}">
-                <a16:creationId xmlns:a16="http://schemas.microsoft.com/office/drawing/2014/main" id="{FC398856-D024-8D55-E0FD-EEEB7B38CD0C}"/>
+                <a16:creationId xmlns:a16="http://schemas.microsoft.com/office/drawing/2014/main" id="{9B77A2E7-354B-85BD-DED8-B331BB5D8B48}"/>
               </a:ext>
             </a:extLst>
           </p:cNvPr>
@@ -6760,7 +6762,7 @@
           <p:cNvPr id="5" name="Rectángulo: esquinas redondeadas 4">
             <a:extLst>
               <a:ext uri="{FF2B5EF4-FFF2-40B4-BE49-F238E27FC236}">
-                <a16:creationId xmlns:a16="http://schemas.microsoft.com/office/drawing/2014/main" id="{FABA18A6-79FE-D744-24EC-47787CF2E8BA}"/>
+                <a16:creationId xmlns:a16="http://schemas.microsoft.com/office/drawing/2014/main" id="{8344A8C5-88FC-122A-E159-9B79E79B5912}"/>
               </a:ext>
             </a:extLst>
           </p:cNvPr>
@@ -6814,7 +6816,7 @@
           <p:cNvPr id="6" name="CuadroTexto 5">
             <a:extLst>
               <a:ext uri="{FF2B5EF4-FFF2-40B4-BE49-F238E27FC236}">
-                <a16:creationId xmlns:a16="http://schemas.microsoft.com/office/drawing/2014/main" id="{23A25BD5-FB22-7346-DA43-32E19D3C0D06}"/>
+                <a16:creationId xmlns:a16="http://schemas.microsoft.com/office/drawing/2014/main" id="{1CA3C64A-3C7C-1DFE-2688-3B9B90673632}"/>
               </a:ext>
             </a:extLst>
           </p:cNvPr>
@@ -6854,7 +6856,7 @@
           <p:cNvPr id="7" name="CuadroTexto 6">
             <a:extLst>
               <a:ext uri="{FF2B5EF4-FFF2-40B4-BE49-F238E27FC236}">
-                <a16:creationId xmlns:a16="http://schemas.microsoft.com/office/drawing/2014/main" id="{0CCC977E-1A30-82BE-646A-B2B36D412D9D}"/>
+                <a16:creationId xmlns:a16="http://schemas.microsoft.com/office/drawing/2014/main" id="{2F87B97D-7334-DB5C-0377-59744B8993F9}"/>
               </a:ext>
             </a:extLst>
           </p:cNvPr>
@@ -6894,7 +6896,7 @@
           <p:cNvPr id="8" name="Rectángulo: esquinas redondeadas 7">
             <a:extLst>
               <a:ext uri="{FF2B5EF4-FFF2-40B4-BE49-F238E27FC236}">
-                <a16:creationId xmlns:a16="http://schemas.microsoft.com/office/drawing/2014/main" id="{5E6E9FFA-6C38-C983-BFCF-A438BC628644}"/>
+                <a16:creationId xmlns:a16="http://schemas.microsoft.com/office/drawing/2014/main" id="{7AE4BFFD-AC4B-D894-F783-4E96B4C3EFE0}"/>
               </a:ext>
             </a:extLst>
           </p:cNvPr>
@@ -6948,7 +6950,7 @@
           <p:cNvPr id="9" name="CuadroTexto 8">
             <a:extLst>
               <a:ext uri="{FF2B5EF4-FFF2-40B4-BE49-F238E27FC236}">
-                <a16:creationId xmlns:a16="http://schemas.microsoft.com/office/drawing/2014/main" id="{58176A3E-B31B-D20D-812E-612991A0235A}"/>
+                <a16:creationId xmlns:a16="http://schemas.microsoft.com/office/drawing/2014/main" id="{1C1C9D5A-7FB2-93DF-B202-9B53ECAD3A2F}"/>
               </a:ext>
             </a:extLst>
           </p:cNvPr>
@@ -6988,7 +6990,7 @@
           <p:cNvPr id="10" name="CuadroTexto 9">
             <a:extLst>
               <a:ext uri="{FF2B5EF4-FFF2-40B4-BE49-F238E27FC236}">
-                <a16:creationId xmlns:a16="http://schemas.microsoft.com/office/drawing/2014/main" id="{1C306C1E-E694-7359-628F-F803515AB734}"/>
+                <a16:creationId xmlns:a16="http://schemas.microsoft.com/office/drawing/2014/main" id="{3A9E8E2C-B54E-E130-70D0-F0FE283A6040}"/>
               </a:ext>
             </a:extLst>
           </p:cNvPr>
@@ -7028,7 +7030,7 @@
           <p:cNvPr id="11" name="Rectángulo: esquinas redondeadas 10">
             <a:extLst>
               <a:ext uri="{FF2B5EF4-FFF2-40B4-BE49-F238E27FC236}">
-                <a16:creationId xmlns:a16="http://schemas.microsoft.com/office/drawing/2014/main" id="{5663098F-BA04-F81C-29EA-745BCF7AFA6D}"/>
+                <a16:creationId xmlns:a16="http://schemas.microsoft.com/office/drawing/2014/main" id="{FC7D6A87-5006-5B56-4298-9AD0AF1665A9}"/>
               </a:ext>
             </a:extLst>
           </p:cNvPr>
@@ -7082,7 +7084,7 @@
           <p:cNvPr id="12" name="CuadroTexto 11">
             <a:extLst>
               <a:ext uri="{FF2B5EF4-FFF2-40B4-BE49-F238E27FC236}">
-                <a16:creationId xmlns:a16="http://schemas.microsoft.com/office/drawing/2014/main" id="{849D15BE-49B0-6D31-412D-47A2AB0DA511}"/>
+                <a16:creationId xmlns:a16="http://schemas.microsoft.com/office/drawing/2014/main" id="{2D6DCC4B-1804-606E-13BC-3281B774CCC5}"/>
               </a:ext>
             </a:extLst>
           </p:cNvPr>
@@ -7122,7 +7124,7 @@
           <p:cNvPr id="13" name="CuadroTexto 12">
             <a:extLst>
               <a:ext uri="{FF2B5EF4-FFF2-40B4-BE49-F238E27FC236}">
-                <a16:creationId xmlns:a16="http://schemas.microsoft.com/office/drawing/2014/main" id="{DC9B4318-DE98-FB01-E814-435C2BBB5363}"/>
+                <a16:creationId xmlns:a16="http://schemas.microsoft.com/office/drawing/2014/main" id="{F7EF453A-0E45-B87F-5E65-C32ADAC9DCA7}"/>
               </a:ext>
             </a:extLst>
           </p:cNvPr>
@@ -7162,7 +7164,7 @@
           <p:cNvPr id="14" name="CuadroTexto 13">
             <a:extLst>
               <a:ext uri="{FF2B5EF4-FFF2-40B4-BE49-F238E27FC236}">
-                <a16:creationId xmlns:a16="http://schemas.microsoft.com/office/drawing/2014/main" id="{9E88D6F5-5A5E-DF68-AB56-210E5D64C9AD}"/>
+                <a16:creationId xmlns:a16="http://schemas.microsoft.com/office/drawing/2014/main" id="{50EA1839-294B-01A8-9EC3-D8A32AC262BC}"/>
               </a:ext>
             </a:extLst>
           </p:cNvPr>
@@ -7243,7 +7245,7 @@
     </p:spTree>
     <p:extLst>
       <p:ext uri="{BB962C8B-B14F-4D97-AF65-F5344CB8AC3E}">
-        <p14:creationId xmlns:p14="http://schemas.microsoft.com/office/powerpoint/2010/main" val="4228597921"/>
+        <p14:creationId xmlns:p14="http://schemas.microsoft.com/office/powerpoint/2010/main" val="1033675896"/>
       </p:ext>
     </p:extLst>
   </p:cSld>
@@ -7283,7 +7285,7 @@
           <p:cNvPr id="2" name="CuadroTexto 1">
             <a:extLst>
               <a:ext uri="{FF2B5EF4-FFF2-40B4-BE49-F238E27FC236}">
-                <a16:creationId xmlns:a16="http://schemas.microsoft.com/office/drawing/2014/main" id="{16544C3F-63E2-D153-0F8C-BEB94186E0EC}"/>
+                <a16:creationId xmlns:a16="http://schemas.microsoft.com/office/drawing/2014/main" id="{C6D52F73-CCD9-42F7-02A5-4E37F1F4F59C}"/>
               </a:ext>
             </a:extLst>
           </p:cNvPr>
@@ -7323,7 +7325,7 @@
           <p:cNvPr id="3" name="CuadroTexto 2">
             <a:extLst>
               <a:ext uri="{FF2B5EF4-FFF2-40B4-BE49-F238E27FC236}">
-                <a16:creationId xmlns:a16="http://schemas.microsoft.com/office/drawing/2014/main" id="{DF5F33B4-628B-03EC-65B5-CAC1C06AF8DB}"/>
+                <a16:creationId xmlns:a16="http://schemas.microsoft.com/office/drawing/2014/main" id="{80A60D73-4A0C-5AF2-4C62-D5ACA05D52DF}"/>
               </a:ext>
             </a:extLst>
           </p:cNvPr>
@@ -7363,7 +7365,7 @@
           <p:cNvPr id="4" name="CuadroTexto 3">
             <a:extLst>
               <a:ext uri="{FF2B5EF4-FFF2-40B4-BE49-F238E27FC236}">
-                <a16:creationId xmlns:a16="http://schemas.microsoft.com/office/drawing/2014/main" id="{6D47D573-1B9F-E6E5-ED3D-2BA9E6E222A4}"/>
+                <a16:creationId xmlns:a16="http://schemas.microsoft.com/office/drawing/2014/main" id="{E890516C-1647-E8F2-B91A-FEAC8DB6B110}"/>
               </a:ext>
             </a:extLst>
           </p:cNvPr>
@@ -7403,7 +7405,7 @@
           <p:cNvPr id="6" name="Imagen 5">
             <a:extLst>
               <a:ext uri="{FF2B5EF4-FFF2-40B4-BE49-F238E27FC236}">
-                <a16:creationId xmlns:a16="http://schemas.microsoft.com/office/drawing/2014/main" id="{4CFC3B33-C924-AA15-13AD-3E1AEE24FAFB}"/>
+                <a16:creationId xmlns:a16="http://schemas.microsoft.com/office/drawing/2014/main" id="{366783F9-97FF-8785-D28F-6E350B34BEBD}"/>
               </a:ext>
             </a:extLst>
           </p:cNvPr>
@@ -7444,7 +7446,7 @@
           <p:cNvPr id="7" name="Rectángulo: esquinas redondeadas 6">
             <a:extLst>
               <a:ext uri="{FF2B5EF4-FFF2-40B4-BE49-F238E27FC236}">
-                <a16:creationId xmlns:a16="http://schemas.microsoft.com/office/drawing/2014/main" id="{2F725FE4-EE80-E705-733E-B8BD19D194B1}"/>
+                <a16:creationId xmlns:a16="http://schemas.microsoft.com/office/drawing/2014/main" id="{920EA701-EB98-29B2-98BE-3DE403EC5E94}"/>
               </a:ext>
             </a:extLst>
           </p:cNvPr>
@@ -7498,7 +7500,7 @@
           <p:cNvPr id="8" name="CuadroTexto 7">
             <a:extLst>
               <a:ext uri="{FF2B5EF4-FFF2-40B4-BE49-F238E27FC236}">
-                <a16:creationId xmlns:a16="http://schemas.microsoft.com/office/drawing/2014/main" id="{19BDC50C-B07C-3E6B-6FCB-EFF857206AA4}"/>
+                <a16:creationId xmlns:a16="http://schemas.microsoft.com/office/drawing/2014/main" id="{3FF02323-D96E-D1EE-4A95-4E4E4B708157}"/>
               </a:ext>
             </a:extLst>
           </p:cNvPr>
@@ -7538,7 +7540,7 @@
           <p:cNvPr id="9" name="CuadroTexto 8">
             <a:extLst>
               <a:ext uri="{FF2B5EF4-FFF2-40B4-BE49-F238E27FC236}">
-                <a16:creationId xmlns:a16="http://schemas.microsoft.com/office/drawing/2014/main" id="{1FED4652-0A31-1746-AA86-527095D0AEF5}"/>
+                <a16:creationId xmlns:a16="http://schemas.microsoft.com/office/drawing/2014/main" id="{08C593A4-13CC-9424-052D-796113C9E2CC}"/>
               </a:ext>
             </a:extLst>
           </p:cNvPr>
@@ -7578,7 +7580,7 @@
           <p:cNvPr id="10" name="CuadroTexto 9">
             <a:extLst>
               <a:ext uri="{FF2B5EF4-FFF2-40B4-BE49-F238E27FC236}">
-                <a16:creationId xmlns:a16="http://schemas.microsoft.com/office/drawing/2014/main" id="{B0AB03AA-2FAA-C057-5FEE-3A78680746AD}"/>
+                <a16:creationId xmlns:a16="http://schemas.microsoft.com/office/drawing/2014/main" id="{9562B2FB-25DC-3F69-2542-BF232BE5CB7F}"/>
               </a:ext>
             </a:extLst>
           </p:cNvPr>
@@ -7669,7 +7671,7 @@
                 </a:solidFill>
                 <a:latin typeface="Segoe UI" panose="020B0502040204020203" pitchFamily="34" charset="0"/>
               </a:rPr>
-              <a:t>El rechazo queda comunicado por correo y visible en estado.</a:t>
+              <a:t>El rechazo queda visible en estado y puede notificarse por correo.</a:t>
             </a:r>
           </a:p>
         </p:txBody>
@@ -7677,7 +7679,7 @@
     </p:spTree>
     <p:extLst>
       <p:ext uri="{BB962C8B-B14F-4D97-AF65-F5344CB8AC3E}">
-        <p14:creationId xmlns:p14="http://schemas.microsoft.com/office/powerpoint/2010/main" val="2969850247"/>
+        <p14:creationId xmlns:p14="http://schemas.microsoft.com/office/powerpoint/2010/main" val="1827656614"/>
       </p:ext>
     </p:extLst>
   </p:cSld>
@@ -7717,7 +7719,7 @@
           <p:cNvPr id="2" name="CuadroTexto 1">
             <a:extLst>
               <a:ext uri="{FF2B5EF4-FFF2-40B4-BE49-F238E27FC236}">
-                <a16:creationId xmlns:a16="http://schemas.microsoft.com/office/drawing/2014/main" id="{19FD5FA7-5464-0F55-FBB9-260283051AAF}"/>
+                <a16:creationId xmlns:a16="http://schemas.microsoft.com/office/drawing/2014/main" id="{28532E55-AAC4-8890-C03B-7CC4A12F942F}"/>
               </a:ext>
             </a:extLst>
           </p:cNvPr>
@@ -7757,7 +7759,7 @@
           <p:cNvPr id="3" name="CuadroTexto 2">
             <a:extLst>
               <a:ext uri="{FF2B5EF4-FFF2-40B4-BE49-F238E27FC236}">
-                <a16:creationId xmlns:a16="http://schemas.microsoft.com/office/drawing/2014/main" id="{04540A0F-81BB-6B6E-665E-BB1AF62FB32B}"/>
+                <a16:creationId xmlns:a16="http://schemas.microsoft.com/office/drawing/2014/main" id="{3D6FDC03-E1E6-5689-3C3E-A759009E4983}"/>
               </a:ext>
             </a:extLst>
           </p:cNvPr>
@@ -7797,7 +7799,7 @@
           <p:cNvPr id="4" name="CuadroTexto 3">
             <a:extLst>
               <a:ext uri="{FF2B5EF4-FFF2-40B4-BE49-F238E27FC236}">
-                <a16:creationId xmlns:a16="http://schemas.microsoft.com/office/drawing/2014/main" id="{2F776333-FF70-0E59-C918-59932AC0167E}"/>
+                <a16:creationId xmlns:a16="http://schemas.microsoft.com/office/drawing/2014/main" id="{7BCBF2A4-9BD8-FF5D-C33B-B597FFF56920}"/>
               </a:ext>
             </a:extLst>
           </p:cNvPr>
@@ -7837,7 +7839,7 @@
           <p:cNvPr id="6" name="Imagen 5">
             <a:extLst>
               <a:ext uri="{FF2B5EF4-FFF2-40B4-BE49-F238E27FC236}">
-                <a16:creationId xmlns:a16="http://schemas.microsoft.com/office/drawing/2014/main" id="{EBCEFCB2-6ADC-65CC-1676-0012BD8233D3}"/>
+                <a16:creationId xmlns:a16="http://schemas.microsoft.com/office/drawing/2014/main" id="{70B6E5FF-BD2E-F47B-1C0C-1309C980470B}"/>
               </a:ext>
             </a:extLst>
           </p:cNvPr>
@@ -7878,7 +7880,7 @@
           <p:cNvPr id="7" name="CuadroTexto 6">
             <a:extLst>
               <a:ext uri="{FF2B5EF4-FFF2-40B4-BE49-F238E27FC236}">
-                <a16:creationId xmlns:a16="http://schemas.microsoft.com/office/drawing/2014/main" id="{5D27201E-7566-1F3B-FBFA-980DCA2F132D}"/>
+                <a16:creationId xmlns:a16="http://schemas.microsoft.com/office/drawing/2014/main" id="{E4A0B6C0-CAD5-7A81-453E-FBA54446F163}"/>
               </a:ext>
             </a:extLst>
           </p:cNvPr>
@@ -7995,7 +7997,7 @@
     </p:spTree>
     <p:extLst>
       <p:ext uri="{BB962C8B-B14F-4D97-AF65-F5344CB8AC3E}">
-        <p14:creationId xmlns:p14="http://schemas.microsoft.com/office/powerpoint/2010/main" val="1815112305"/>
+        <p14:creationId xmlns:p14="http://schemas.microsoft.com/office/powerpoint/2010/main" val="3162838887"/>
       </p:ext>
     </p:extLst>
   </p:cSld>
@@ -8035,7 +8037,7 @@
           <p:cNvPr id="2" name="CuadroTexto 1">
             <a:extLst>
               <a:ext uri="{FF2B5EF4-FFF2-40B4-BE49-F238E27FC236}">
-                <a16:creationId xmlns:a16="http://schemas.microsoft.com/office/drawing/2014/main" id="{AFD47552-F4DE-499A-DE40-2256F2331396}"/>
+                <a16:creationId xmlns:a16="http://schemas.microsoft.com/office/drawing/2014/main" id="{8C7F1369-2838-96F1-79B4-F798DF5FC98B}"/>
               </a:ext>
             </a:extLst>
           </p:cNvPr>
@@ -8075,7 +8077,7 @@
           <p:cNvPr id="3" name="CuadroTexto 2">
             <a:extLst>
               <a:ext uri="{FF2B5EF4-FFF2-40B4-BE49-F238E27FC236}">
-                <a16:creationId xmlns:a16="http://schemas.microsoft.com/office/drawing/2014/main" id="{8DF0082D-725A-7FE7-1B3A-879B7390E6C4}"/>
+                <a16:creationId xmlns:a16="http://schemas.microsoft.com/office/drawing/2014/main" id="{759C3883-3A9B-3008-5BAF-8DBC6FABD3AA}"/>
               </a:ext>
             </a:extLst>
           </p:cNvPr>
@@ -8105,7 +8107,7 @@
                 </a:solidFill>
                 <a:latin typeface="Segoe UI" panose="020B0502040204020203" pitchFamily="34" charset="0"/>
               </a:rPr>
-              <a:t>Autoarranque en VM y roles internos</a:t>
+              <a:t>Autoarranque en VM y permisos internos</a:t>
             </a:r>
           </a:p>
         </p:txBody>
@@ -8115,7 +8117,7 @@
           <p:cNvPr id="4" name="CuadroTexto 3">
             <a:extLst>
               <a:ext uri="{FF2B5EF4-FFF2-40B4-BE49-F238E27FC236}">
-                <a16:creationId xmlns:a16="http://schemas.microsoft.com/office/drawing/2014/main" id="{9FFA8DC3-3D1B-691B-6DB7-28089BD77DCA}"/>
+                <a16:creationId xmlns:a16="http://schemas.microsoft.com/office/drawing/2014/main" id="{184FA9DC-5AAA-61FC-40CB-05310D893222}"/>
               </a:ext>
             </a:extLst>
           </p:cNvPr>
@@ -8145,7 +8147,7 @@
                 </a:solidFill>
                 <a:latin typeface="Segoe UI" panose="020B0502040204020203" pitchFamily="34" charset="0"/>
               </a:rPr>
-              <a:t>El despliegue cloud no depende de arrancarlo a mano y la base de seguridad ya separa perfiles tecnicos, funcionales y externos.</a:t>
+              <a:t>El despliegue cloud no depende de arrancarlo a mano y la seguridad separa operacion diaria de acciones destructivas.</a:t>
             </a:r>
           </a:p>
         </p:txBody>
@@ -8155,7 +8157,7 @@
           <p:cNvPr id="5" name="Rectángulo: esquinas redondeadas 4">
             <a:extLst>
               <a:ext uri="{FF2B5EF4-FFF2-40B4-BE49-F238E27FC236}">
-                <a16:creationId xmlns:a16="http://schemas.microsoft.com/office/drawing/2014/main" id="{373F8D2B-89D5-FC1C-BB0E-9198B64239E5}"/>
+                <a16:creationId xmlns:a16="http://schemas.microsoft.com/office/drawing/2014/main" id="{B93E68E7-32EF-2945-33EA-8015FBE50330}"/>
               </a:ext>
             </a:extLst>
           </p:cNvPr>
@@ -8209,7 +8211,7 @@
           <p:cNvPr id="6" name="CuadroTexto 5">
             <a:extLst>
               <a:ext uri="{FF2B5EF4-FFF2-40B4-BE49-F238E27FC236}">
-                <a16:creationId xmlns:a16="http://schemas.microsoft.com/office/drawing/2014/main" id="{0DBAEFC2-37C7-4F3A-8B07-70B483F337E4}"/>
+                <a16:creationId xmlns:a16="http://schemas.microsoft.com/office/drawing/2014/main" id="{0EB965BF-11BD-1547-59E8-12AC47DA4278}"/>
               </a:ext>
             </a:extLst>
           </p:cNvPr>
@@ -8249,7 +8251,7 @@
           <p:cNvPr id="7" name="CuadroTexto 6">
             <a:extLst>
               <a:ext uri="{FF2B5EF4-FFF2-40B4-BE49-F238E27FC236}">
-                <a16:creationId xmlns:a16="http://schemas.microsoft.com/office/drawing/2014/main" id="{7BBFCD5E-272D-07CD-1024-11D44C66FCE8}"/>
+                <a16:creationId xmlns:a16="http://schemas.microsoft.com/office/drawing/2014/main" id="{322F072E-1FB7-91B5-0C28-BD06F9FF861E}"/>
               </a:ext>
             </a:extLst>
           </p:cNvPr>
@@ -8317,7 +8319,7 @@
           <p:cNvPr id="8" name="CuadroTexto 7">
             <a:extLst>
               <a:ext uri="{FF2B5EF4-FFF2-40B4-BE49-F238E27FC236}">
-                <a16:creationId xmlns:a16="http://schemas.microsoft.com/office/drawing/2014/main" id="{7FF411CF-E3FF-4A1E-7D46-2BDF5F718292}"/>
+                <a16:creationId xmlns:a16="http://schemas.microsoft.com/office/drawing/2014/main" id="{EE1E7314-3281-AA68-7E2D-D48616F8FF3F}"/>
               </a:ext>
             </a:extLst>
           </p:cNvPr>
@@ -8382,7 +8384,7 @@
           <p:cNvPr id="9" name="Rectángulo: esquinas redondeadas 8">
             <a:extLst>
               <a:ext uri="{FF2B5EF4-FFF2-40B4-BE49-F238E27FC236}">
-                <a16:creationId xmlns:a16="http://schemas.microsoft.com/office/drawing/2014/main" id="{F2587A29-B9A4-4FFD-AA80-1F7960C9C445}"/>
+                <a16:creationId xmlns:a16="http://schemas.microsoft.com/office/drawing/2014/main" id="{E30B2685-109A-4CA1-1DB9-414E28884E1E}"/>
               </a:ext>
             </a:extLst>
           </p:cNvPr>
@@ -8436,7 +8438,7 @@
           <p:cNvPr id="10" name="CuadroTexto 9">
             <a:extLst>
               <a:ext uri="{FF2B5EF4-FFF2-40B4-BE49-F238E27FC236}">
-                <a16:creationId xmlns:a16="http://schemas.microsoft.com/office/drawing/2014/main" id="{668568C2-8586-18FF-0C23-A4B0E19AE53C}"/>
+                <a16:creationId xmlns:a16="http://schemas.microsoft.com/office/drawing/2014/main" id="{5C8CB957-176D-6ED0-5A12-199B18368F04}"/>
               </a:ext>
             </a:extLst>
           </p:cNvPr>
@@ -8476,7 +8478,7 @@
           <p:cNvPr id="11" name="CuadroTexto 10">
             <a:extLst>
               <a:ext uri="{FF2B5EF4-FFF2-40B4-BE49-F238E27FC236}">
-                <a16:creationId xmlns:a16="http://schemas.microsoft.com/office/drawing/2014/main" id="{9DB5C474-BBE3-C1CE-D7B5-B6FC2DC34EB1}"/>
+                <a16:creationId xmlns:a16="http://schemas.microsoft.com/office/drawing/2014/main" id="{7AD567F2-C941-6216-204D-4155349483DE}"/>
               </a:ext>
             </a:extLst>
           </p:cNvPr>
@@ -8513,7 +8515,7 @@
                 </a:solidFill>
                 <a:latin typeface="Segoe UI" panose="020B0502040204020203" pitchFamily="34" charset="0"/>
               </a:rPr>
-              <a:t>ADMIN: control total y borrado controlado.</a:t>
+              <a:t>ADMIN: control total y limpieza de datos de prueba.</a:t>
             </a:r>
           </a:p>
           <a:p>
@@ -8531,7 +8533,7 @@
                 </a:solidFill>
                 <a:latin typeface="Segoe UI" panose="020B0502040204020203" pitchFamily="34" charset="0"/>
               </a:rPr>
-              <a:t>PROFESOR/COORDINATOR: gestion diaria sin eliminar.</a:t>
+              <a:t>PROFESOR/COORDINATOR: crear, editar y consultar sin eliminar.</a:t>
             </a:r>
           </a:p>
           <a:p>
@@ -8549,43 +8551,7 @@
                 </a:solidFill>
                 <a:latin typeface="Segoe UI" panose="020B0502040204020203" pitchFamily="34" charset="0"/>
               </a:rPr>
-              <a:t>DOCUMENT_MANAGER: documentos.</a:t>
-            </a:r>
-          </a:p>
-          <a:p>
-            <a:pPr marL="342900" indent="-342900">
-              <a:spcAft>
-                <a:spcPts val="1000"/>
-              </a:spcAft>
-              <a:buFont typeface="+mj-lt"/>
-              <a:buChar char="•"/>
-            </a:pPr>
-            <a:r>
-              <a:rPr lang="es-ES" sz="1300">
-                <a:solidFill>
-                  <a:srgbClr val="1F2937"/>
-                </a:solidFill>
-                <a:latin typeface="Segoe UI" panose="020B0502040204020203" pitchFamily="34" charset="0"/>
-              </a:rPr>
-              <a:t>MONITOR: logs y consola tecnica.</a:t>
-            </a:r>
-          </a:p>
-          <a:p>
-            <a:pPr marL="342900" indent="-342900">
-              <a:spcAft>
-                <a:spcPts val="1000"/>
-              </a:spcAft>
-              <a:buFont typeface="+mj-lt"/>
-              <a:buChar char="•"/>
-            </a:pPr>
-            <a:r>
-              <a:rPr lang="es-ES" sz="1300">
-                <a:solidFill>
-                  <a:srgbClr val="1F2937"/>
-                </a:solidFill>
-                <a:latin typeface="Segoe UI" panose="020B0502040204020203" pitchFamily="34" charset="0"/>
-              </a:rPr>
-              <a:t>COMPANY_PORTAL: empresa externa.</a:t>
+              <a:t>El borrado respeta relaciones: asignacion -&gt; convenio -&gt; empresa.</a:t>
             </a:r>
           </a:p>
         </p:txBody>
@@ -8595,7 +8561,7 @@
           <p:cNvPr id="12" name="CuadroTexto 11">
             <a:extLst>
               <a:ext uri="{FF2B5EF4-FFF2-40B4-BE49-F238E27FC236}">
-                <a16:creationId xmlns:a16="http://schemas.microsoft.com/office/drawing/2014/main" id="{ECBA3C86-1BF8-118E-CF9C-824D54F5D9C1}"/>
+                <a16:creationId xmlns:a16="http://schemas.microsoft.com/office/drawing/2014/main" id="{869C8CAB-AEDD-EFB8-6164-394524121BA7}"/>
               </a:ext>
             </a:extLst>
           </p:cNvPr>
@@ -8604,7 +8570,7 @@
         </p:nvSpPr>
         <p:spPr>
           <a:xfrm>
-            <a:off x="6858000" y="4546600"/>
+            <a:off x="6858000" y="4419600"/>
             <a:ext cx="3810000" cy="369332"/>
           </a:xfrm>
           <a:prstGeom prst="rect">
@@ -8625,7 +8591,7 @@
                 </a:solidFill>
                 <a:latin typeface="Segoe UI" panose="020B0502040204020203" pitchFamily="34" charset="0"/>
               </a:rPr>
-              <a:t>Futuro: matriz fina de permisos y perfiles de solo lectura.</a:t>
+              <a:t>Futuro: roles avanzados, solo lectura y permisos por centro.</a:t>
             </a:r>
           </a:p>
         </p:txBody>
@@ -8635,7 +8601,7 @@
           <p:cNvPr id="13" name="CuadroTexto 12">
             <a:extLst>
               <a:ext uri="{FF2B5EF4-FFF2-40B4-BE49-F238E27FC236}">
-                <a16:creationId xmlns:a16="http://schemas.microsoft.com/office/drawing/2014/main" id="{60D31EF2-28FD-3A18-08F0-C986069F5FA6}"/>
+                <a16:creationId xmlns:a16="http://schemas.microsoft.com/office/drawing/2014/main" id="{F6F0ACEC-BA8B-5A8E-28A6-448A01E6AA35}"/>
               </a:ext>
             </a:extLst>
           </p:cNvPr>
@@ -8673,7 +8639,7 @@
     </p:spTree>
     <p:extLst>
       <p:ext uri="{BB962C8B-B14F-4D97-AF65-F5344CB8AC3E}">
-        <p14:creationId xmlns:p14="http://schemas.microsoft.com/office/powerpoint/2010/main" val="2572257841"/>
+        <p14:creationId xmlns:p14="http://schemas.microsoft.com/office/powerpoint/2010/main" val="2270446223"/>
       </p:ext>
     </p:extLst>
   </p:cSld>
@@ -8713,7 +8679,7 @@
           <p:cNvPr id="2" name="CuadroTexto 1">
             <a:extLst>
               <a:ext uri="{FF2B5EF4-FFF2-40B4-BE49-F238E27FC236}">
-                <a16:creationId xmlns:a16="http://schemas.microsoft.com/office/drawing/2014/main" id="{9181E053-23ED-228D-440D-CA0AFF0D7BB8}"/>
+                <a16:creationId xmlns:a16="http://schemas.microsoft.com/office/drawing/2014/main" id="{D1F84024-9633-8F3B-4091-1737AD4EBBF4}"/>
               </a:ext>
             </a:extLst>
           </p:cNvPr>
@@ -8753,7 +8719,7 @@
           <p:cNvPr id="3" name="CuadroTexto 2">
             <a:extLst>
               <a:ext uri="{FF2B5EF4-FFF2-40B4-BE49-F238E27FC236}">
-                <a16:creationId xmlns:a16="http://schemas.microsoft.com/office/drawing/2014/main" id="{CFB01A7A-D136-65B7-0ECA-61B658C1B26F}"/>
+                <a16:creationId xmlns:a16="http://schemas.microsoft.com/office/drawing/2014/main" id="{6AA21FD7-E6EC-A98C-C826-EDEDF37EB9F7}"/>
               </a:ext>
             </a:extLst>
           </p:cNvPr>
@@ -8793,7 +8759,7 @@
           <p:cNvPr id="4" name="Rectángulo: esquinas redondeadas 3">
             <a:extLst>
               <a:ext uri="{FF2B5EF4-FFF2-40B4-BE49-F238E27FC236}">
-                <a16:creationId xmlns:a16="http://schemas.microsoft.com/office/drawing/2014/main" id="{8FE81F4D-C7C7-3E6F-CF57-EB657BF88809}"/>
+                <a16:creationId xmlns:a16="http://schemas.microsoft.com/office/drawing/2014/main" id="{19FB7C17-8D79-F694-71F1-4F488E298F09}"/>
               </a:ext>
             </a:extLst>
           </p:cNvPr>
@@ -8847,7 +8813,7 @@
           <p:cNvPr id="5" name="CuadroTexto 4">
             <a:extLst>
               <a:ext uri="{FF2B5EF4-FFF2-40B4-BE49-F238E27FC236}">
-                <a16:creationId xmlns:a16="http://schemas.microsoft.com/office/drawing/2014/main" id="{DDC58341-C275-8216-0E6D-790EA5952D97}"/>
+                <a16:creationId xmlns:a16="http://schemas.microsoft.com/office/drawing/2014/main" id="{F7ADD5AD-F77C-4E73-DE21-3BE5421EDF38}"/>
               </a:ext>
             </a:extLst>
           </p:cNvPr>
@@ -8887,7 +8853,7 @@
           <p:cNvPr id="6" name="CuadroTexto 5">
             <a:extLst>
               <a:ext uri="{FF2B5EF4-FFF2-40B4-BE49-F238E27FC236}">
-                <a16:creationId xmlns:a16="http://schemas.microsoft.com/office/drawing/2014/main" id="{05AFB7DA-0210-E985-7339-D72B37FD80F1}"/>
+                <a16:creationId xmlns:a16="http://schemas.microsoft.com/office/drawing/2014/main" id="{14592ABF-B704-01CA-C265-9CDCB78119A1}"/>
               </a:ext>
             </a:extLst>
           </p:cNvPr>
@@ -8927,7 +8893,7 @@
           <p:cNvPr id="7" name="Rectángulo: esquinas redondeadas 6">
             <a:extLst>
               <a:ext uri="{FF2B5EF4-FFF2-40B4-BE49-F238E27FC236}">
-                <a16:creationId xmlns:a16="http://schemas.microsoft.com/office/drawing/2014/main" id="{5BC5C267-9F37-6A95-4F2E-8D263982DD5C}"/>
+                <a16:creationId xmlns:a16="http://schemas.microsoft.com/office/drawing/2014/main" id="{EAC654A1-5A72-78B0-80FE-79AA0E845A7D}"/>
               </a:ext>
             </a:extLst>
           </p:cNvPr>
@@ -8981,7 +8947,7 @@
           <p:cNvPr id="8" name="CuadroTexto 7">
             <a:extLst>
               <a:ext uri="{FF2B5EF4-FFF2-40B4-BE49-F238E27FC236}">
-                <a16:creationId xmlns:a16="http://schemas.microsoft.com/office/drawing/2014/main" id="{378CAC00-EC29-EE50-6D61-1C72B8A3DAAE}"/>
+                <a16:creationId xmlns:a16="http://schemas.microsoft.com/office/drawing/2014/main" id="{D9D5DA34-DE99-F07E-A503-35B696C4B95F}"/>
               </a:ext>
             </a:extLst>
           </p:cNvPr>
@@ -9021,7 +8987,7 @@
           <p:cNvPr id="9" name="CuadroTexto 8">
             <a:extLst>
               <a:ext uri="{FF2B5EF4-FFF2-40B4-BE49-F238E27FC236}">
-                <a16:creationId xmlns:a16="http://schemas.microsoft.com/office/drawing/2014/main" id="{EF4ABBA0-6AB1-9834-29B3-8CDFB412AFC5}"/>
+                <a16:creationId xmlns:a16="http://schemas.microsoft.com/office/drawing/2014/main" id="{2997B13D-9FF3-4005-3CB7-B110813DC604}"/>
               </a:ext>
             </a:extLst>
           </p:cNvPr>
@@ -9061,7 +9027,7 @@
           <p:cNvPr id="10" name="Rectángulo: esquinas redondeadas 9">
             <a:extLst>
               <a:ext uri="{FF2B5EF4-FFF2-40B4-BE49-F238E27FC236}">
-                <a16:creationId xmlns:a16="http://schemas.microsoft.com/office/drawing/2014/main" id="{B6F28170-51E2-D69A-4D57-41AF4975C3A9}"/>
+                <a16:creationId xmlns:a16="http://schemas.microsoft.com/office/drawing/2014/main" id="{E57274E3-73BD-1721-4E28-190924A6D864}"/>
               </a:ext>
             </a:extLst>
           </p:cNvPr>
@@ -9115,7 +9081,7 @@
           <p:cNvPr id="11" name="CuadroTexto 10">
             <a:extLst>
               <a:ext uri="{FF2B5EF4-FFF2-40B4-BE49-F238E27FC236}">
-                <a16:creationId xmlns:a16="http://schemas.microsoft.com/office/drawing/2014/main" id="{24666E30-5AB4-AC8E-CE68-FCBDB0FB430F}"/>
+                <a16:creationId xmlns:a16="http://schemas.microsoft.com/office/drawing/2014/main" id="{4768812D-D8AE-7812-CE80-59D0AFF28E5A}"/>
               </a:ext>
             </a:extLst>
           </p:cNvPr>
@@ -9155,7 +9121,7 @@
           <p:cNvPr id="12" name="CuadroTexto 11">
             <a:extLst>
               <a:ext uri="{FF2B5EF4-FFF2-40B4-BE49-F238E27FC236}">
-                <a16:creationId xmlns:a16="http://schemas.microsoft.com/office/drawing/2014/main" id="{36348C31-62AD-BBB3-6790-61D4744A8955}"/>
+                <a16:creationId xmlns:a16="http://schemas.microsoft.com/office/drawing/2014/main" id="{2F4E3A99-72FE-3A3A-CF18-B5E491551E60}"/>
               </a:ext>
             </a:extLst>
           </p:cNvPr>
@@ -9195,7 +9161,7 @@
           <p:cNvPr id="13" name="Rectángulo: esquinas redondeadas 12">
             <a:extLst>
               <a:ext uri="{FF2B5EF4-FFF2-40B4-BE49-F238E27FC236}">
-                <a16:creationId xmlns:a16="http://schemas.microsoft.com/office/drawing/2014/main" id="{B6940724-E536-E0CC-E667-E38913CFD86C}"/>
+                <a16:creationId xmlns:a16="http://schemas.microsoft.com/office/drawing/2014/main" id="{BBF6E37C-A1AE-FBAF-F468-0E5A0462C0F2}"/>
               </a:ext>
             </a:extLst>
           </p:cNvPr>
@@ -9249,7 +9215,7 @@
           <p:cNvPr id="14" name="CuadroTexto 13">
             <a:extLst>
               <a:ext uri="{FF2B5EF4-FFF2-40B4-BE49-F238E27FC236}">
-                <a16:creationId xmlns:a16="http://schemas.microsoft.com/office/drawing/2014/main" id="{1C87AD53-3F7F-B875-FEFB-F279BA568172}"/>
+                <a16:creationId xmlns:a16="http://schemas.microsoft.com/office/drawing/2014/main" id="{7A0876C9-338B-844C-1DB3-4C675A1750AA}"/>
               </a:ext>
             </a:extLst>
           </p:cNvPr>
@@ -9289,7 +9255,7 @@
           <p:cNvPr id="15" name="CuadroTexto 14">
             <a:extLst>
               <a:ext uri="{FF2B5EF4-FFF2-40B4-BE49-F238E27FC236}">
-                <a16:creationId xmlns:a16="http://schemas.microsoft.com/office/drawing/2014/main" id="{541C0BAF-7030-4AAF-4806-10297A8BC990}"/>
+                <a16:creationId xmlns:a16="http://schemas.microsoft.com/office/drawing/2014/main" id="{5A28CCB0-402D-085E-E543-4C79E06DB431}"/>
               </a:ext>
             </a:extLst>
           </p:cNvPr>
@@ -9329,7 +9295,7 @@
           <p:cNvPr id="16" name="CuadroTexto 15">
             <a:extLst>
               <a:ext uri="{FF2B5EF4-FFF2-40B4-BE49-F238E27FC236}">
-                <a16:creationId xmlns:a16="http://schemas.microsoft.com/office/drawing/2014/main" id="{68BA2DAB-B3A5-6060-8B0B-8FC5EB78DBE0}"/>
+                <a16:creationId xmlns:a16="http://schemas.microsoft.com/office/drawing/2014/main" id="{AB2B54B4-82E1-A949-209F-173E69487C10}"/>
               </a:ext>
             </a:extLst>
           </p:cNvPr>
@@ -9412,7 +9378,7 @@
           <p:cNvPr id="17" name="CuadroTexto 16">
             <a:extLst>
               <a:ext uri="{FF2B5EF4-FFF2-40B4-BE49-F238E27FC236}">
-                <a16:creationId xmlns:a16="http://schemas.microsoft.com/office/drawing/2014/main" id="{FA357313-1CF2-48DC-F6BE-547CEA02515E}"/>
+                <a16:creationId xmlns:a16="http://schemas.microsoft.com/office/drawing/2014/main" id="{5DD7FDD6-48CE-0B08-C00F-97A29690EF1C}"/>
               </a:ext>
             </a:extLst>
           </p:cNvPr>
@@ -9450,7 +9416,7 @@
     </p:spTree>
     <p:extLst>
       <p:ext uri="{BB962C8B-B14F-4D97-AF65-F5344CB8AC3E}">
-        <p14:creationId xmlns:p14="http://schemas.microsoft.com/office/powerpoint/2010/main" val="3698168155"/>
+        <p14:creationId xmlns:p14="http://schemas.microsoft.com/office/powerpoint/2010/main" val="3607618039"/>
       </p:ext>
     </p:extLst>
   </p:cSld>
@@ -9490,7 +9456,7 @@
           <p:cNvPr id="2" name="CuadroTexto 1">
             <a:extLst>
               <a:ext uri="{FF2B5EF4-FFF2-40B4-BE49-F238E27FC236}">
-                <a16:creationId xmlns:a16="http://schemas.microsoft.com/office/drawing/2014/main" id="{1ABADE8C-DE49-448C-CABA-CDA5632FAAC2}"/>
+                <a16:creationId xmlns:a16="http://schemas.microsoft.com/office/drawing/2014/main" id="{627D97E2-1563-6139-0B14-C1FAD4C3B31C}"/>
               </a:ext>
             </a:extLst>
           </p:cNvPr>
@@ -9530,7 +9496,7 @@
           <p:cNvPr id="3" name="CuadroTexto 2">
             <a:extLst>
               <a:ext uri="{FF2B5EF4-FFF2-40B4-BE49-F238E27FC236}">
-                <a16:creationId xmlns:a16="http://schemas.microsoft.com/office/drawing/2014/main" id="{AFD6AEDB-AB31-E63C-D2C2-ECD5B06F856C}"/>
+                <a16:creationId xmlns:a16="http://schemas.microsoft.com/office/drawing/2014/main" id="{D43FE79E-DCC6-293E-5C6F-20820F290345}"/>
               </a:ext>
             </a:extLst>
           </p:cNvPr>
@@ -9560,7 +9526,7 @@
                 </a:solidFill>
                 <a:latin typeface="Segoe UI" panose="020B0502040204020203" pitchFamily="34" charset="0"/>
               </a:rPr>
-              <a:t>Como puede probarla la profesora desde fuera</a:t>
+              <a:t>Como se puede probar desde fuera</a:t>
             </a:r>
           </a:p>
         </p:txBody>
@@ -9570,7 +9536,7 @@
           <p:cNvPr id="4" name="CuadroTexto 3">
             <a:extLst>
               <a:ext uri="{FF2B5EF4-FFF2-40B4-BE49-F238E27FC236}">
-                <a16:creationId xmlns:a16="http://schemas.microsoft.com/office/drawing/2014/main" id="{73B58CCF-3037-702B-D744-9F03BA8FFCB4}"/>
+                <a16:creationId xmlns:a16="http://schemas.microsoft.com/office/drawing/2014/main" id="{3D40DF1C-A7DD-3E17-3BCD-81A97811BD61}"/>
               </a:ext>
             </a:extLst>
           </p:cNvPr>
@@ -9600,7 +9566,7 @@
                 </a:solidFill>
                 <a:latin typeface="Segoe UI" panose="020B0502040204020203" pitchFamily="34" charset="0"/>
               </a:rPr>
-              <a:t>Con la VM levantada no necesita instalar dependencias en su equipo.</a:t>
+              <a:t>Con la VM levantada no hace falta instalar dependencias en el equipo de quien evalua.</a:t>
             </a:r>
           </a:p>
         </p:txBody>
@@ -9610,7 +9576,7 @@
           <p:cNvPr id="5" name="Rectángulo: esquinas redondeadas 4">
             <a:extLst>
               <a:ext uri="{FF2B5EF4-FFF2-40B4-BE49-F238E27FC236}">
-                <a16:creationId xmlns:a16="http://schemas.microsoft.com/office/drawing/2014/main" id="{90C76186-1F29-9F2F-A945-BB5FB4039EBA}"/>
+                <a16:creationId xmlns:a16="http://schemas.microsoft.com/office/drawing/2014/main" id="{CF1AF172-757D-8E61-17A8-15ED742C6634}"/>
               </a:ext>
             </a:extLst>
           </p:cNvPr>
@@ -9664,7 +9630,7 @@
           <p:cNvPr id="6" name="CuadroTexto 5">
             <a:extLst>
               <a:ext uri="{FF2B5EF4-FFF2-40B4-BE49-F238E27FC236}">
-                <a16:creationId xmlns:a16="http://schemas.microsoft.com/office/drawing/2014/main" id="{D7ABB99F-D9C9-5AD5-F16B-7A15E34428F0}"/>
+                <a16:creationId xmlns:a16="http://schemas.microsoft.com/office/drawing/2014/main" id="{3C8358F2-64E1-7FD4-56F7-C5F24C43EAAA}"/>
               </a:ext>
             </a:extLst>
           </p:cNvPr>
@@ -9673,7 +9639,7 @@
         </p:nvSpPr>
         <p:spPr>
           <a:xfrm>
-            <a:off x="1244600" y="2362200"/>
+            <a:off x="1244600" y="2235200"/>
             <a:ext cx="9652000" cy="369332"/>
           </a:xfrm>
           <a:prstGeom prst="rect">
@@ -9688,14 +9654,20 @@
           <a:lstStyle/>
           <a:p>
             <a:r>
-              <a:rPr lang="es-ES" sz="1300" b="1">
+              <a:rPr lang="en-GB" sz="1200" b="1">
                 <a:solidFill>
                   <a:srgbClr val="4975B0"/>
                 </a:solidFill>
                 <a:latin typeface="Consolas" panose="020B0609020204030204" pitchFamily="49" charset="0"/>
               </a:rPr>
-              <a:t>\https://agora.34.175.161.212.nip.io/app   |   https://agora.34.175.161.212.nip.io/externo\</a:t>
-            </a:r>
+              <a:t>Panel interno: https://agora.34.175.161.212.nip.io/app</a:t>
+            </a:r>
+            <a:endParaRPr lang="es-ES" sz="1200" b="1">
+              <a:solidFill>
+                <a:srgbClr val="4975B0"/>
+              </a:solidFill>
+              <a:latin typeface="Consolas" panose="020B0609020204030204" pitchFamily="49" charset="0"/>
+            </a:endParaRPr>
           </a:p>
         </p:txBody>
       </p:sp>
@@ -9704,7 +9676,7 @@
           <p:cNvPr id="7" name="CuadroTexto 6">
             <a:extLst>
               <a:ext uri="{FF2B5EF4-FFF2-40B4-BE49-F238E27FC236}">
-                <a16:creationId xmlns:a16="http://schemas.microsoft.com/office/drawing/2014/main" id="{8BF610C2-5144-60DC-D2C7-64109F39EA59}"/>
+                <a16:creationId xmlns:a16="http://schemas.microsoft.com/office/drawing/2014/main" id="{E8177A81-675E-F848-2D20-A0EF88AE0709}"/>
               </a:ext>
             </a:extLst>
           </p:cNvPr>
@@ -9713,7 +9685,7 @@
         </p:nvSpPr>
         <p:spPr>
           <a:xfrm>
-            <a:off x="1295400" y="2794000"/>
+            <a:off x="1244600" y="2565400"/>
             <a:ext cx="9652000" cy="369332"/>
           </a:xfrm>
           <a:prstGeom prst="rect">
@@ -9728,6 +9700,46 @@
           <a:lstStyle/>
           <a:p>
             <a:r>
+              <a:rPr lang="es-ES" sz="1200" b="1">
+                <a:solidFill>
+                  <a:srgbClr val="4975B0"/>
+                </a:solidFill>
+                <a:latin typeface="Consolas" panose="020B0609020204030204" pitchFamily="49" charset="0"/>
+              </a:rPr>
+              <a:t>Portal externo: https://agora.34.175.161.212.nip.io/externo</a:t>
+            </a:r>
+          </a:p>
+        </p:txBody>
+      </p:sp>
+      <p:sp>
+        <p:nvSpPr>
+          <p:cNvPr id="8" name="CuadroTexto 7">
+            <a:extLst>
+              <a:ext uri="{FF2B5EF4-FFF2-40B4-BE49-F238E27FC236}">
+                <a16:creationId xmlns:a16="http://schemas.microsoft.com/office/drawing/2014/main" id="{9F92A884-CD2F-FA49-7C64-96A0968237DB}"/>
+              </a:ext>
+            </a:extLst>
+          </p:cNvPr>
+          <p:cNvSpPr txBox="1"/>
+          <p:nvPr/>
+        </p:nvSpPr>
+        <p:spPr>
+          <a:xfrm>
+            <a:off x="1295400" y="2895600"/>
+            <a:ext cx="9652000" cy="369332"/>
+          </a:xfrm>
+          <a:prstGeom prst="rect">
+            <a:avLst/>
+          </a:prstGeom>
+          <a:noFill/>
+        </p:spPr>
+        <p:txBody>
+          <a:bodyPr vert="horz" wrap="square" lIns="0" tIns="0" rIns="0" bIns="0" rtlCol="0">
+            <a:noAutofit/>
+          </a:bodyPr>
+          <a:lstStyle/>
+          <a:p>
+            <a:r>
               <a:rPr lang="es-ES" sz="1400">
                 <a:solidFill>
                   <a:srgbClr val="1F2937"/>
@@ -9741,10 +9753,10 @@
       </p:sp>
       <p:sp>
         <p:nvSpPr>
-          <p:cNvPr id="8" name="Rectángulo: esquinas redondeadas 7">
-            <a:extLst>
-              <a:ext uri="{FF2B5EF4-FFF2-40B4-BE49-F238E27FC236}">
-                <a16:creationId xmlns:a16="http://schemas.microsoft.com/office/drawing/2014/main" id="{F2CAD6C9-1FA0-53BC-A7BF-225AD29131CB}"/>
+          <p:cNvPr id="9" name="Rectángulo: esquinas redondeadas 8">
+            <a:extLst>
+              <a:ext uri="{FF2B5EF4-FFF2-40B4-BE49-F238E27FC236}">
+                <a16:creationId xmlns:a16="http://schemas.microsoft.com/office/drawing/2014/main" id="{8A96F319-2B55-CE49-FD39-28B2FF8C9278}"/>
               </a:ext>
             </a:extLst>
           </p:cNvPr>
@@ -9795,10 +9807,10 @@
       </p:sp>
       <p:sp>
         <p:nvSpPr>
-          <p:cNvPr id="9" name="CuadroTexto 8">
-            <a:extLst>
-              <a:ext uri="{FF2B5EF4-FFF2-40B4-BE49-F238E27FC236}">
-                <a16:creationId xmlns:a16="http://schemas.microsoft.com/office/drawing/2014/main" id="{C68E2C34-6864-1336-405C-5C8EB878F372}"/>
+          <p:cNvPr id="10" name="CuadroTexto 9">
+            <a:extLst>
+              <a:ext uri="{FF2B5EF4-FFF2-40B4-BE49-F238E27FC236}">
+                <a16:creationId xmlns:a16="http://schemas.microsoft.com/office/drawing/2014/main" id="{E9B0776E-04FA-755E-2527-748991B6F378}"/>
               </a:ext>
             </a:extLst>
           </p:cNvPr>
@@ -9835,10 +9847,10 @@
       </p:sp>
       <p:sp>
         <p:nvSpPr>
-          <p:cNvPr id="10" name="CuadroTexto 9">
-            <a:extLst>
-              <a:ext uri="{FF2B5EF4-FFF2-40B4-BE49-F238E27FC236}">
-                <a16:creationId xmlns:a16="http://schemas.microsoft.com/office/drawing/2014/main" id="{492FA47F-1121-DAFE-BC66-9106F6140117}"/>
+          <p:cNvPr id="11" name="CuadroTexto 10">
+            <a:extLst>
+              <a:ext uri="{FF2B5EF4-FFF2-40B4-BE49-F238E27FC236}">
+                <a16:creationId xmlns:a16="http://schemas.microsoft.com/office/drawing/2014/main" id="{432AAC12-6166-C481-21FA-1B525F291644}"/>
               </a:ext>
             </a:extLst>
           </p:cNvPr>
@@ -9862,23 +9874,23 @@
           <a:lstStyle/>
           <a:p>
             <a:r>
-              <a:rPr lang="es-ES" b="1">
+              <a:rPr lang="es-ES" sz="1600" b="1">
                 <a:solidFill>
                   <a:srgbClr val="F6F8FC"/>
                 </a:solidFill>
                 <a:latin typeface="Consolas" panose="020B0609020204030204" pitchFamily="49" charset="0"/>
               </a:rPr>
-              <a:t>profesora / Abrete01</a:t>
-            </a:r>
-          </a:p>
-        </p:txBody>
-      </p:sp>
-      <p:sp>
-        <p:nvSpPr>
-          <p:cNvPr id="11" name="CuadroTexto 10">
-            <a:extLst>
-              <a:ext uri="{FF2B5EF4-FFF2-40B4-BE49-F238E27FC236}">
-                <a16:creationId xmlns:a16="http://schemas.microsoft.com/office/drawing/2014/main" id="{76F86ECE-9849-6F14-66F9-E03F50C84A8F}"/>
+              <a:t>usuario interno / Abrete01</a:t>
+            </a:r>
+          </a:p>
+        </p:txBody>
+      </p:sp>
+      <p:sp>
+        <p:nvSpPr>
+          <p:cNvPr id="12" name="CuadroTexto 11">
+            <a:extLst>
+              <a:ext uri="{FF2B5EF4-FFF2-40B4-BE49-F238E27FC236}">
+                <a16:creationId xmlns:a16="http://schemas.microsoft.com/office/drawing/2014/main" id="{798C0254-F3D4-D021-0374-22DC0EDF3452}"/>
               </a:ext>
             </a:extLst>
           </p:cNvPr>
@@ -9908,17 +9920,17 @@
                 </a:solidFill>
                 <a:latin typeface="Segoe UI" panose="020B0502040204020203" pitchFamily="34" charset="0"/>
               </a:rPr>
-              <a:t>Rol: coordinacion</a:t>
-            </a:r>
-          </a:p>
-        </p:txBody>
-      </p:sp>
-      <p:sp>
-        <p:nvSpPr>
-          <p:cNvPr id="12" name="CuadroTexto 11">
-            <a:extLst>
-              <a:ext uri="{FF2B5EF4-FFF2-40B4-BE49-F238E27FC236}">
-                <a16:creationId xmlns:a16="http://schemas.microsoft.com/office/drawing/2014/main" id="{BAC49FB8-BADC-635E-1D4D-E5940676DB50}"/>
+              <a:t>Perfil de prueba del centro</a:t>
+            </a:r>
+          </a:p>
+        </p:txBody>
+      </p:sp>
+      <p:sp>
+        <p:nvSpPr>
+          <p:cNvPr id="13" name="CuadroTexto 12">
+            <a:extLst>
+              <a:ext uri="{FF2B5EF4-FFF2-40B4-BE49-F238E27FC236}">
+                <a16:creationId xmlns:a16="http://schemas.microsoft.com/office/drawing/2014/main" id="{D8A66F4A-5A36-FD3F-4095-4BB6F4B034BD}"/>
               </a:ext>
             </a:extLst>
           </p:cNvPr>
@@ -9999,7 +10011,7 @@
     </p:spTree>
     <p:extLst>
       <p:ext uri="{BB962C8B-B14F-4D97-AF65-F5344CB8AC3E}">
-        <p14:creationId xmlns:p14="http://schemas.microsoft.com/office/powerpoint/2010/main" val="1085781378"/>
+        <p14:creationId xmlns:p14="http://schemas.microsoft.com/office/powerpoint/2010/main" val="3078094728"/>
       </p:ext>
     </p:extLst>
   </p:cSld>
@@ -10039,7 +10051,7 @@
           <p:cNvPr id="2" name="CuadroTexto 1">
             <a:extLst>
               <a:ext uri="{FF2B5EF4-FFF2-40B4-BE49-F238E27FC236}">
-                <a16:creationId xmlns:a16="http://schemas.microsoft.com/office/drawing/2014/main" id="{F8A264FD-737B-068C-79C8-C2C30AFE42F8}"/>
+                <a16:creationId xmlns:a16="http://schemas.microsoft.com/office/drawing/2014/main" id="{E45A0730-FA8B-38EC-0371-89539D05A36E}"/>
               </a:ext>
             </a:extLst>
           </p:cNvPr>
@@ -10079,7 +10091,7 @@
           <p:cNvPr id="3" name="CuadroTexto 2">
             <a:extLst>
               <a:ext uri="{FF2B5EF4-FFF2-40B4-BE49-F238E27FC236}">
-                <a16:creationId xmlns:a16="http://schemas.microsoft.com/office/drawing/2014/main" id="{076F2623-B7C6-832D-5400-16D3ED616B6A}"/>
+                <a16:creationId xmlns:a16="http://schemas.microsoft.com/office/drawing/2014/main" id="{A1AA1D30-9EF8-77E6-339B-E31450746D96}"/>
               </a:ext>
             </a:extLst>
           </p:cNvPr>
@@ -10119,7 +10131,7 @@
           <p:cNvPr id="4" name="CuadroTexto 3">
             <a:extLst>
               <a:ext uri="{FF2B5EF4-FFF2-40B4-BE49-F238E27FC236}">
-                <a16:creationId xmlns:a16="http://schemas.microsoft.com/office/drawing/2014/main" id="{33B01CAF-399D-92F4-DA4B-026BF9F8FEEB}"/>
+                <a16:creationId xmlns:a16="http://schemas.microsoft.com/office/drawing/2014/main" id="{CA8BDF94-C7FE-C3D6-77A6-24A918820865}"/>
               </a:ext>
             </a:extLst>
           </p:cNvPr>
@@ -10159,7 +10171,7 @@
           <p:cNvPr id="5" name="Rectángulo: esquinas redondeadas 4">
             <a:extLst>
               <a:ext uri="{FF2B5EF4-FFF2-40B4-BE49-F238E27FC236}">
-                <a16:creationId xmlns:a16="http://schemas.microsoft.com/office/drawing/2014/main" id="{3CADEB5F-5440-2073-99A5-F86BF3B611D0}"/>
+                <a16:creationId xmlns:a16="http://schemas.microsoft.com/office/drawing/2014/main" id="{106CA9CD-D849-3CA6-800B-3030C911856E}"/>
               </a:ext>
             </a:extLst>
           </p:cNvPr>
@@ -10213,7 +10225,7 @@
           <p:cNvPr id="6" name="CuadroTexto 5">
             <a:extLst>
               <a:ext uri="{FF2B5EF4-FFF2-40B4-BE49-F238E27FC236}">
-                <a16:creationId xmlns:a16="http://schemas.microsoft.com/office/drawing/2014/main" id="{580D7E94-1C23-4206-16B6-9404A6981FEB}"/>
+                <a16:creationId xmlns:a16="http://schemas.microsoft.com/office/drawing/2014/main" id="{FDC2135C-4EE8-29AE-3850-BE4285CD047E}"/>
               </a:ext>
             </a:extLst>
           </p:cNvPr>
@@ -10253,7 +10265,7 @@
           <p:cNvPr id="7" name="CuadroTexto 6">
             <a:extLst>
               <a:ext uri="{FF2B5EF4-FFF2-40B4-BE49-F238E27FC236}">
-                <a16:creationId xmlns:a16="http://schemas.microsoft.com/office/drawing/2014/main" id="{A9337943-C5F0-91EA-837B-6BC88712ACF7}"/>
+                <a16:creationId xmlns:a16="http://schemas.microsoft.com/office/drawing/2014/main" id="{ABC98366-EF9A-0A92-5ADB-CCBB85468428}"/>
               </a:ext>
             </a:extLst>
           </p:cNvPr>
@@ -10308,7 +10320,7 @@
                 </a:solidFill>
                 <a:latin typeface="Segoe UI" panose="020B0502040204020203" pitchFamily="34" charset="0"/>
               </a:rPr>
-              <a:t>Correo real, documentos, chat y exportacion.</a:t>
+              <a:t>Correo real, chat, exportacion y documentacion.</a:t>
             </a:r>
           </a:p>
           <a:p>
@@ -10354,7 +10366,7 @@
           <p:cNvPr id="8" name="Rectángulo: esquinas redondeadas 7">
             <a:extLst>
               <a:ext uri="{FF2B5EF4-FFF2-40B4-BE49-F238E27FC236}">
-                <a16:creationId xmlns:a16="http://schemas.microsoft.com/office/drawing/2014/main" id="{A67DD423-27AB-06FD-E088-AF2D6DC92A1D}"/>
+                <a16:creationId xmlns:a16="http://schemas.microsoft.com/office/drawing/2014/main" id="{AA62E0C4-E56C-A7F3-8C5D-7C7B530117D7}"/>
               </a:ext>
             </a:extLst>
           </p:cNvPr>
@@ -10408,7 +10420,7 @@
           <p:cNvPr id="9" name="CuadroTexto 8">
             <a:extLst>
               <a:ext uri="{FF2B5EF4-FFF2-40B4-BE49-F238E27FC236}">
-                <a16:creationId xmlns:a16="http://schemas.microsoft.com/office/drawing/2014/main" id="{08EC8CA5-18F5-1F01-1D31-8C0E7AAA3954}"/>
+                <a16:creationId xmlns:a16="http://schemas.microsoft.com/office/drawing/2014/main" id="{8FAC1444-709F-EBE1-B429-8F168320F50E}"/>
               </a:ext>
             </a:extLst>
           </p:cNvPr>
@@ -10438,7 +10450,7 @@
                 </a:solidFill>
                 <a:latin typeface="Segoe UI" panose="020B0502040204020203" pitchFamily="34" charset="0"/>
               </a:rPr>
-              <a:t>Dominio propio</a:t>
+              <a:t>Documentos</a:t>
             </a:r>
           </a:p>
         </p:txBody>
@@ -10448,7 +10460,7 @@
           <p:cNvPr id="10" name="CuadroTexto 9">
             <a:extLst>
               <a:ext uri="{FF2B5EF4-FFF2-40B4-BE49-F238E27FC236}">
-                <a16:creationId xmlns:a16="http://schemas.microsoft.com/office/drawing/2014/main" id="{CD5A78DE-C792-F232-83AC-1EEC05CA7C7F}"/>
+                <a16:creationId xmlns:a16="http://schemas.microsoft.com/office/drawing/2014/main" id="{A1E1A187-CA5C-1E76-EA40-39E0F7293DFC}"/>
               </a:ext>
             </a:extLst>
           </p:cNvPr>
@@ -10478,7 +10490,7 @@
                 </a:solidFill>
                 <a:latin typeface="Segoe UI" panose="020B0502040204020203" pitchFamily="34" charset="0"/>
               </a:rPr>
-              <a:t>Sustituir nip.io por dominio institucional y reforzar TLS.</a:t>
+              <a:t>Completar subida, versionado y almacenamiento externo gestionado.</a:t>
             </a:r>
           </a:p>
         </p:txBody>
@@ -10488,7 +10500,7 @@
           <p:cNvPr id="11" name="Rectángulo: esquinas redondeadas 10">
             <a:extLst>
               <a:ext uri="{FF2B5EF4-FFF2-40B4-BE49-F238E27FC236}">
-                <a16:creationId xmlns:a16="http://schemas.microsoft.com/office/drawing/2014/main" id="{A2784C63-DA89-099D-2D74-7DED300D48D4}"/>
+                <a16:creationId xmlns:a16="http://schemas.microsoft.com/office/drawing/2014/main" id="{07605DBF-E751-A4E4-164D-57BCB77C39F0}"/>
               </a:ext>
             </a:extLst>
           </p:cNvPr>
@@ -10542,7 +10554,7 @@
           <p:cNvPr id="12" name="CuadroTexto 11">
             <a:extLst>
               <a:ext uri="{FF2B5EF4-FFF2-40B4-BE49-F238E27FC236}">
-                <a16:creationId xmlns:a16="http://schemas.microsoft.com/office/drawing/2014/main" id="{B2580B95-7524-6CE1-8C59-EEDFC5F74E2E}"/>
+                <a16:creationId xmlns:a16="http://schemas.microsoft.com/office/drawing/2014/main" id="{4D4B2ECF-ACAA-2F5C-D24A-A0142EA1DFB2}"/>
               </a:ext>
             </a:extLst>
           </p:cNvPr>
@@ -10572,7 +10584,7 @@
                 </a:solidFill>
                 <a:latin typeface="Segoe UI" panose="020B0502040204020203" pitchFamily="34" charset="0"/>
               </a:rPr>
-              <a:t>Servicios gestionados</a:t>
+              <a:t>Roles avanzados</a:t>
             </a:r>
           </a:p>
         </p:txBody>
@@ -10582,7 +10594,7 @@
           <p:cNvPr id="13" name="CuadroTexto 12">
             <a:extLst>
               <a:ext uri="{FF2B5EF4-FFF2-40B4-BE49-F238E27FC236}">
-                <a16:creationId xmlns:a16="http://schemas.microsoft.com/office/drawing/2014/main" id="{89DFE1C8-6F36-9296-8851-266E3778F70E}"/>
+                <a16:creationId xmlns:a16="http://schemas.microsoft.com/office/drawing/2014/main" id="{CA5DE22E-B4A3-F3DE-CE30-59595D4D567C}"/>
               </a:ext>
             </a:extLst>
           </p:cNvPr>
@@ -10612,7 +10624,7 @@
                 </a:solidFill>
                 <a:latin typeface="Segoe UI" panose="020B0502040204020203" pitchFamily="34" charset="0"/>
               </a:rPr>
-              <a:t>Migrar documentos, backups y observabilidad a servicios gestionados fuera de la VM.</a:t>
+              <a:t>Perfiles de solo lectura, auditoria por rol y permisos mas finos.</a:t>
             </a:r>
           </a:p>
         </p:txBody>
@@ -10622,7 +10634,7 @@
           <p:cNvPr id="14" name="Rectángulo: esquinas redondeadas 13">
             <a:extLst>
               <a:ext uri="{FF2B5EF4-FFF2-40B4-BE49-F238E27FC236}">
-                <a16:creationId xmlns:a16="http://schemas.microsoft.com/office/drawing/2014/main" id="{EDE3EE0C-A662-56F4-B10D-E5DC7D8AD056}"/>
+                <a16:creationId xmlns:a16="http://schemas.microsoft.com/office/drawing/2014/main" id="{A3627F46-9202-F0C6-BBEC-BF99C83A898A}"/>
               </a:ext>
             </a:extLst>
           </p:cNvPr>
@@ -10676,7 +10688,7 @@
           <p:cNvPr id="15" name="CuadroTexto 14">
             <a:extLst>
               <a:ext uri="{FF2B5EF4-FFF2-40B4-BE49-F238E27FC236}">
-                <a16:creationId xmlns:a16="http://schemas.microsoft.com/office/drawing/2014/main" id="{4AD692D4-3CE2-90DD-8A0D-3A96D256F611}"/>
+                <a16:creationId xmlns:a16="http://schemas.microsoft.com/office/drawing/2014/main" id="{0CBA9A08-F151-84C8-6945-DBF185A73EF3}"/>
               </a:ext>
             </a:extLst>
           </p:cNvPr>
@@ -10706,7 +10718,7 @@
                 </a:solidFill>
                 <a:latin typeface="Segoe UI" panose="020B0502040204020203" pitchFamily="34" charset="0"/>
               </a:rPr>
-              <a:t>Cliente tecnico</a:t>
+              <a:t>Multi-centro</a:t>
             </a:r>
           </a:p>
         </p:txBody>
@@ -10716,7 +10728,7 @@
           <p:cNvPr id="16" name="CuadroTexto 15">
             <a:extLst>
               <a:ext uri="{FF2B5EF4-FFF2-40B4-BE49-F238E27FC236}">
-                <a16:creationId xmlns:a16="http://schemas.microsoft.com/office/drawing/2014/main" id="{8F0F5EE7-5FEE-2E19-06A8-CC58A4B2BED6}"/>
+                <a16:creationId xmlns:a16="http://schemas.microsoft.com/office/drawing/2014/main" id="{B45386F9-7314-82B6-2C6D-0C4A18021C61}"/>
               </a:ext>
             </a:extLst>
           </p:cNvPr>
@@ -10746,7 +10758,7 @@
                 </a:solidFill>
                 <a:latin typeface="Segoe UI" panose="020B0502040204020203" pitchFamily="34" charset="0"/>
               </a:rPr>
-              <a:t>Ampliar Agora Desktop sin mezclar soporte con negocio.</a:t>
+              <a:t>Separar datos por centro educativo, empresas y usuarios.</a:t>
             </a:r>
           </a:p>
         </p:txBody>
@@ -10756,7 +10768,7 @@
           <p:cNvPr id="17" name="CuadroTexto 16">
             <a:extLst>
               <a:ext uri="{FF2B5EF4-FFF2-40B4-BE49-F238E27FC236}">
-                <a16:creationId xmlns:a16="http://schemas.microsoft.com/office/drawing/2014/main" id="{FD324CA9-FCF0-3843-D744-E93C949DE4DD}"/>
+                <a16:creationId xmlns:a16="http://schemas.microsoft.com/office/drawing/2014/main" id="{5B7BEEB8-7055-322B-200F-5F5ACB0038E1}"/>
               </a:ext>
             </a:extLst>
           </p:cNvPr>
@@ -10819,7 +10831,7 @@
     </p:spTree>
     <p:extLst>
       <p:ext uri="{BB962C8B-B14F-4D97-AF65-F5344CB8AC3E}">
-        <p14:creationId xmlns:p14="http://schemas.microsoft.com/office/powerpoint/2010/main" val="249792066"/>
+        <p14:creationId xmlns:p14="http://schemas.microsoft.com/office/powerpoint/2010/main" val="2814883549"/>
       </p:ext>
     </p:extLst>
   </p:cSld>
@@ -10859,7 +10871,7 @@
           <p:cNvPr id="2" name="CuadroTexto 1">
             <a:extLst>
               <a:ext uri="{FF2B5EF4-FFF2-40B4-BE49-F238E27FC236}">
-                <a16:creationId xmlns:a16="http://schemas.microsoft.com/office/drawing/2014/main" id="{92847E62-E037-0DFB-7B8B-6D3653DF1BC4}"/>
+                <a16:creationId xmlns:a16="http://schemas.microsoft.com/office/drawing/2014/main" id="{8DBD1795-2973-E27A-9EF9-387702C98EBB}"/>
               </a:ext>
             </a:extLst>
           </p:cNvPr>
@@ -10899,7 +10911,7 @@
           <p:cNvPr id="3" name="CuadroTexto 2">
             <a:extLst>
               <a:ext uri="{FF2B5EF4-FFF2-40B4-BE49-F238E27FC236}">
-                <a16:creationId xmlns:a16="http://schemas.microsoft.com/office/drawing/2014/main" id="{36D0EB16-EFFE-7E9A-DC49-CC1CC41C7685}"/>
+                <a16:creationId xmlns:a16="http://schemas.microsoft.com/office/drawing/2014/main" id="{566A90E6-7201-D801-EDE1-52D006E5AB77}"/>
               </a:ext>
             </a:extLst>
           </p:cNvPr>
@@ -10939,7 +10951,7 @@
           <p:cNvPr id="4" name="CuadroTexto 3">
             <a:extLst>
               <a:ext uri="{FF2B5EF4-FFF2-40B4-BE49-F238E27FC236}">
-                <a16:creationId xmlns:a16="http://schemas.microsoft.com/office/drawing/2014/main" id="{05A35C88-02CC-5C59-9FE2-37B6BAE4D54C}"/>
+                <a16:creationId xmlns:a16="http://schemas.microsoft.com/office/drawing/2014/main" id="{BBF4D98A-FF4C-00D2-D169-6C1F7A634B2B}"/>
               </a:ext>
             </a:extLst>
           </p:cNvPr>
@@ -10976,7 +10988,7 @@
                 </a:solidFill>
                 <a:latin typeface="Segoe UI" panose="020B0502040204020203" pitchFamily="34" charset="0"/>
               </a:rPr>
-              <a:t>Infraestructura mas gestionada y endurecida que la VM actual.</a:t>
+              <a:t>Subida documental completa y almacenamiento gestionado fuera de la VM.</a:t>
             </a:r>
           </a:p>
           <a:p>
@@ -10994,7 +11006,7 @@
                 </a:solidFill>
                 <a:latin typeface="Segoe UI" panose="020B0502040204020203" pitchFamily="34" charset="0"/>
               </a:rPr>
-              <a:t>Integracion con SSO o identidad corporativa.</a:t>
+              <a:t>Sistema de roles avanzado con perfiles de solo lectura.</a:t>
             </a:r>
           </a:p>
           <a:p>
@@ -11012,7 +11024,7 @@
                 </a:solidFill>
                 <a:latin typeface="Segoe UI" panose="020B0502040204020203" pitchFamily="34" charset="0"/>
               </a:rPr>
-              <a:t>Firma electronica avanzada.</a:t>
+              <a:t>Gestion multi-centro con datos separados por centro educativo.</a:t>
             </a:r>
           </a:p>
           <a:p>
@@ -11030,7 +11042,7 @@
                 </a:solidFill>
                 <a:latin typeface="Segoe UI" panose="020B0502040204020203" pitchFamily="34" charset="0"/>
               </a:rPr>
-              <a:t>Migracion del almacenamiento documental a un servicio gestionado independiente.</a:t>
+              <a:t>Dominio propio e infraestructura mas gestionada que la VM actual.</a:t>
             </a:r>
           </a:p>
           <a:p>
@@ -11058,7 +11070,7 @@
           <p:cNvPr id="5" name="Rectángulo: esquinas redondeadas 4">
             <a:extLst>
               <a:ext uri="{FF2B5EF4-FFF2-40B4-BE49-F238E27FC236}">
-                <a16:creationId xmlns:a16="http://schemas.microsoft.com/office/drawing/2014/main" id="{5FDB15B8-0153-15F2-4823-D6764D0272C3}"/>
+                <a16:creationId xmlns:a16="http://schemas.microsoft.com/office/drawing/2014/main" id="{3161BDCE-69A6-BDA0-AD98-F20BA7354B74}"/>
               </a:ext>
             </a:extLst>
           </p:cNvPr>
@@ -11112,7 +11124,7 @@
           <p:cNvPr id="6" name="CuadroTexto 5">
             <a:extLst>
               <a:ext uri="{FF2B5EF4-FFF2-40B4-BE49-F238E27FC236}">
-                <a16:creationId xmlns:a16="http://schemas.microsoft.com/office/drawing/2014/main" id="{D081A0FC-9681-814E-AACD-96291B4030AD}"/>
+                <a16:creationId xmlns:a16="http://schemas.microsoft.com/office/drawing/2014/main" id="{A11F16E4-872B-DB01-A26E-83728E9D4639}"/>
               </a:ext>
             </a:extLst>
           </p:cNvPr>
@@ -11152,7 +11164,7 @@
           <p:cNvPr id="7" name="CuadroTexto 6">
             <a:extLst>
               <a:ext uri="{FF2B5EF4-FFF2-40B4-BE49-F238E27FC236}">
-                <a16:creationId xmlns:a16="http://schemas.microsoft.com/office/drawing/2014/main" id="{D8B24205-E331-2174-CEE9-5266DC759D41}"/>
+                <a16:creationId xmlns:a16="http://schemas.microsoft.com/office/drawing/2014/main" id="{70B4DE4F-3263-C92B-035B-3E10B45AC6C9}"/>
               </a:ext>
             </a:extLst>
           </p:cNvPr>
@@ -11176,13 +11188,13 @@
           <a:lstStyle/>
           <a:p>
             <a:r>
-              <a:rPr lang="es-ES" sz="2300" b="1">
+              <a:rPr lang="es-ES" sz="2100" b="1">
                 <a:solidFill>
                   <a:srgbClr val="F6F8FC"/>
                 </a:solidFill>
                 <a:latin typeface="Segoe UI" panose="020B0502040204020203" pitchFamily="34" charset="0"/>
               </a:rPr>
-              <a:t>Despliegue estable, dominio propio, base de datos de servidor y seguridad endurecida.</a:t>
+              <a:t>Cerrar documentos, roles avanzados y soporte multi-centro sin romper el flujo principal.</a:t>
             </a:r>
           </a:p>
         </p:txBody>
@@ -11190,7 +11202,7 @@
     </p:spTree>
     <p:extLst>
       <p:ext uri="{BB962C8B-B14F-4D97-AF65-F5344CB8AC3E}">
-        <p14:creationId xmlns:p14="http://schemas.microsoft.com/office/powerpoint/2010/main" val="4130983698"/>
+        <p14:creationId xmlns:p14="http://schemas.microsoft.com/office/powerpoint/2010/main" val="903823419"/>
       </p:ext>
     </p:extLst>
   </p:cSld>
@@ -11230,7 +11242,7 @@
           <p:cNvPr id="2" name="CuadroTexto 1">
             <a:extLst>
               <a:ext uri="{FF2B5EF4-FFF2-40B4-BE49-F238E27FC236}">
-                <a16:creationId xmlns:a16="http://schemas.microsoft.com/office/drawing/2014/main" id="{1CF7E6FE-9195-73D3-91B3-93A81E842A0D}"/>
+                <a16:creationId xmlns:a16="http://schemas.microsoft.com/office/drawing/2014/main" id="{466903B6-3D94-BA4E-D420-E4844419CDF7}"/>
               </a:ext>
             </a:extLst>
           </p:cNvPr>
@@ -11270,7 +11282,7 @@
           <p:cNvPr id="3" name="CuadroTexto 2">
             <a:extLst>
               <a:ext uri="{FF2B5EF4-FFF2-40B4-BE49-F238E27FC236}">
-                <a16:creationId xmlns:a16="http://schemas.microsoft.com/office/drawing/2014/main" id="{DB5D7F00-45B8-C023-D096-7E37928DD88D}"/>
+                <a16:creationId xmlns:a16="http://schemas.microsoft.com/office/drawing/2014/main" id="{008D2FAE-F122-0A72-D299-4E5DFC646F34}"/>
               </a:ext>
             </a:extLst>
           </p:cNvPr>
@@ -11310,7 +11322,7 @@
           <p:cNvPr id="4" name="CuadroTexto 3">
             <a:extLst>
               <a:ext uri="{FF2B5EF4-FFF2-40B4-BE49-F238E27FC236}">
-                <a16:creationId xmlns:a16="http://schemas.microsoft.com/office/drawing/2014/main" id="{CB7765A6-FF39-2EA1-12B9-CB343F96C79A}"/>
+                <a16:creationId xmlns:a16="http://schemas.microsoft.com/office/drawing/2014/main" id="{F91B0B99-D99F-B445-8BD8-BBCD72378AA2}"/>
               </a:ext>
             </a:extLst>
           </p:cNvPr>
@@ -11350,7 +11362,7 @@
           <p:cNvPr id="5" name="CuadroTexto 4">
             <a:extLst>
               <a:ext uri="{FF2B5EF4-FFF2-40B4-BE49-F238E27FC236}">
-                <a16:creationId xmlns:a16="http://schemas.microsoft.com/office/drawing/2014/main" id="{AB77AC6A-3AE6-C0DA-32C8-7D37BD124090}"/>
+                <a16:creationId xmlns:a16="http://schemas.microsoft.com/office/drawing/2014/main" id="{F95BA237-CE97-5D2D-CEAC-30A76AF24C86}"/>
               </a:ext>
             </a:extLst>
           </p:cNvPr>
@@ -11433,7 +11445,7 @@
           <p:cNvPr id="6" name="CuadroTexto 5">
             <a:extLst>
               <a:ext uri="{FF2B5EF4-FFF2-40B4-BE49-F238E27FC236}">
-                <a16:creationId xmlns:a16="http://schemas.microsoft.com/office/drawing/2014/main" id="{AFC2A68D-0100-BC09-F364-366C8904C98B}"/>
+                <a16:creationId xmlns:a16="http://schemas.microsoft.com/office/drawing/2014/main" id="{FCFA9EC7-736A-D2B1-3473-516C92A50643}"/>
               </a:ext>
             </a:extLst>
           </p:cNvPr>
@@ -11471,7 +11483,7 @@
     </p:spTree>
     <p:extLst>
       <p:ext uri="{BB962C8B-B14F-4D97-AF65-F5344CB8AC3E}">
-        <p14:creationId xmlns:p14="http://schemas.microsoft.com/office/powerpoint/2010/main" val="2877015233"/>
+        <p14:creationId xmlns:p14="http://schemas.microsoft.com/office/powerpoint/2010/main" val="2040263895"/>
       </p:ext>
     </p:extLst>
   </p:cSld>
@@ -11511,7 +11523,7 @@
           <p:cNvPr id="2" name="CuadroTexto 1">
             <a:extLst>
               <a:ext uri="{FF2B5EF4-FFF2-40B4-BE49-F238E27FC236}">
-                <a16:creationId xmlns:a16="http://schemas.microsoft.com/office/drawing/2014/main" id="{F1A3C5FF-5045-CED6-CBA1-7B2DF36C078B}"/>
+                <a16:creationId xmlns:a16="http://schemas.microsoft.com/office/drawing/2014/main" id="{45020D28-933C-54F1-C2B7-F9BD82E5659A}"/>
               </a:ext>
             </a:extLst>
           </p:cNvPr>
@@ -11551,7 +11563,7 @@
           <p:cNvPr id="3" name="CuadroTexto 2">
             <a:extLst>
               <a:ext uri="{FF2B5EF4-FFF2-40B4-BE49-F238E27FC236}">
-                <a16:creationId xmlns:a16="http://schemas.microsoft.com/office/drawing/2014/main" id="{957BFA12-94A3-8625-3B40-511C7CCF92F1}"/>
+                <a16:creationId xmlns:a16="http://schemas.microsoft.com/office/drawing/2014/main" id="{4C85F53D-94E4-F026-3AB9-773491EE1F46}"/>
               </a:ext>
             </a:extLst>
           </p:cNvPr>
@@ -11591,7 +11603,7 @@
           <p:cNvPr id="4" name="CuadroTexto 3">
             <a:extLst>
               <a:ext uri="{FF2B5EF4-FFF2-40B4-BE49-F238E27FC236}">
-                <a16:creationId xmlns:a16="http://schemas.microsoft.com/office/drawing/2014/main" id="{FBF319F4-F812-BAFB-96D7-20B6A7BFC63B}"/>
+                <a16:creationId xmlns:a16="http://schemas.microsoft.com/office/drawing/2014/main" id="{5005A4AC-89D9-93D5-8A0A-0E77D0C46577}"/>
               </a:ext>
             </a:extLst>
           </p:cNvPr>
@@ -11631,7 +11643,7 @@
           <p:cNvPr id="5" name="CuadroTexto 4">
             <a:extLst>
               <a:ext uri="{FF2B5EF4-FFF2-40B4-BE49-F238E27FC236}">
-                <a16:creationId xmlns:a16="http://schemas.microsoft.com/office/drawing/2014/main" id="{971C8038-BF79-0BF3-1A21-7D70A7316691}"/>
+                <a16:creationId xmlns:a16="http://schemas.microsoft.com/office/drawing/2014/main" id="{A3D42945-EAE0-2795-7194-A6F6101F9F70}"/>
               </a:ext>
             </a:extLst>
           </p:cNvPr>
@@ -11732,7 +11744,7 @@
           <p:cNvPr id="6" name="Rectángulo: esquinas redondeadas 5">
             <a:extLst>
               <a:ext uri="{FF2B5EF4-FFF2-40B4-BE49-F238E27FC236}">
-                <a16:creationId xmlns:a16="http://schemas.microsoft.com/office/drawing/2014/main" id="{0CD5F586-8244-0ED5-431E-6F599F36B085}"/>
+                <a16:creationId xmlns:a16="http://schemas.microsoft.com/office/drawing/2014/main" id="{F1723FC9-24D5-7548-77B8-7D1548D8BA09}"/>
               </a:ext>
             </a:extLst>
           </p:cNvPr>
@@ -11786,7 +11798,7 @@
           <p:cNvPr id="7" name="CuadroTexto 6">
             <a:extLst>
               <a:ext uri="{FF2B5EF4-FFF2-40B4-BE49-F238E27FC236}">
-                <a16:creationId xmlns:a16="http://schemas.microsoft.com/office/drawing/2014/main" id="{20E2EE60-6D03-24FA-D058-93457A527155}"/>
+                <a16:creationId xmlns:a16="http://schemas.microsoft.com/office/drawing/2014/main" id="{9C1D5659-3588-E56F-BA96-C1358EABD5AE}"/>
               </a:ext>
             </a:extLst>
           </p:cNvPr>
@@ -11826,7 +11838,7 @@
           <p:cNvPr id="8" name="CuadroTexto 7">
             <a:extLst>
               <a:ext uri="{FF2B5EF4-FFF2-40B4-BE49-F238E27FC236}">
-                <a16:creationId xmlns:a16="http://schemas.microsoft.com/office/drawing/2014/main" id="{EBC95489-88B0-6CD2-C1A5-88804E85CFD4}"/>
+                <a16:creationId xmlns:a16="http://schemas.microsoft.com/office/drawing/2014/main" id="{E28A9D30-353B-F38E-FB27-FD2FC08D0B87}"/>
               </a:ext>
             </a:extLst>
           </p:cNvPr>
@@ -11864,7 +11876,7 @@
     </p:spTree>
     <p:extLst>
       <p:ext uri="{BB962C8B-B14F-4D97-AF65-F5344CB8AC3E}">
-        <p14:creationId xmlns:p14="http://schemas.microsoft.com/office/powerpoint/2010/main" val="938825852"/>
+        <p14:creationId xmlns:p14="http://schemas.microsoft.com/office/powerpoint/2010/main" val="2511314646"/>
       </p:ext>
     </p:extLst>
   </p:cSld>
@@ -11904,7 +11916,7 @@
           <p:cNvPr id="2" name="CuadroTexto 1">
             <a:extLst>
               <a:ext uri="{FF2B5EF4-FFF2-40B4-BE49-F238E27FC236}">
-                <a16:creationId xmlns:a16="http://schemas.microsoft.com/office/drawing/2014/main" id="{0ECCCE2D-CF55-111A-3C89-4032DCDC749B}"/>
+                <a16:creationId xmlns:a16="http://schemas.microsoft.com/office/drawing/2014/main" id="{DB0B54B7-1A51-C9F1-BE56-82FD51C6BE2C}"/>
               </a:ext>
             </a:extLst>
           </p:cNvPr>
@@ -11944,7 +11956,7 @@
           <p:cNvPr id="3" name="CuadroTexto 2">
             <a:extLst>
               <a:ext uri="{FF2B5EF4-FFF2-40B4-BE49-F238E27FC236}">
-                <a16:creationId xmlns:a16="http://schemas.microsoft.com/office/drawing/2014/main" id="{D5B6C8C7-C7FE-2E63-1F25-406FC90E078F}"/>
+                <a16:creationId xmlns:a16="http://schemas.microsoft.com/office/drawing/2014/main" id="{4167D1CF-9751-4373-F880-5BD51396DED3}"/>
               </a:ext>
             </a:extLst>
           </p:cNvPr>
@@ -11984,7 +11996,7 @@
           <p:cNvPr id="4" name="Rectángulo: esquinas redondeadas 3">
             <a:extLst>
               <a:ext uri="{FF2B5EF4-FFF2-40B4-BE49-F238E27FC236}">
-                <a16:creationId xmlns:a16="http://schemas.microsoft.com/office/drawing/2014/main" id="{8644771D-02BC-F48C-E7F6-F230E689F977}"/>
+                <a16:creationId xmlns:a16="http://schemas.microsoft.com/office/drawing/2014/main" id="{7342831E-ABA3-5337-50B7-E5F93EED7145}"/>
               </a:ext>
             </a:extLst>
           </p:cNvPr>
@@ -12038,7 +12050,7 @@
           <p:cNvPr id="5" name="CuadroTexto 4">
             <a:extLst>
               <a:ext uri="{FF2B5EF4-FFF2-40B4-BE49-F238E27FC236}">
-                <a16:creationId xmlns:a16="http://schemas.microsoft.com/office/drawing/2014/main" id="{A7A84609-CFD0-DF1D-5EDC-176F4DB5732F}"/>
+                <a16:creationId xmlns:a16="http://schemas.microsoft.com/office/drawing/2014/main" id="{C9068F03-F866-0289-7634-087545984B51}"/>
               </a:ext>
             </a:extLst>
           </p:cNvPr>
@@ -12078,7 +12090,7 @@
           <p:cNvPr id="6" name="CuadroTexto 5">
             <a:extLst>
               <a:ext uri="{FF2B5EF4-FFF2-40B4-BE49-F238E27FC236}">
-                <a16:creationId xmlns:a16="http://schemas.microsoft.com/office/drawing/2014/main" id="{D07AD378-9EA9-32AA-6120-EFADAD14EF05}"/>
+                <a16:creationId xmlns:a16="http://schemas.microsoft.com/office/drawing/2014/main" id="{8385254C-BEE2-A2E8-ACF3-6197E92CE12A}"/>
               </a:ext>
             </a:extLst>
           </p:cNvPr>
@@ -12118,7 +12130,7 @@
           <p:cNvPr id="7" name="Rectángulo: esquinas redondeadas 6">
             <a:extLst>
               <a:ext uri="{FF2B5EF4-FFF2-40B4-BE49-F238E27FC236}">
-                <a16:creationId xmlns:a16="http://schemas.microsoft.com/office/drawing/2014/main" id="{67AFCDF2-8FCF-B00F-8C9E-5889CBA135A8}"/>
+                <a16:creationId xmlns:a16="http://schemas.microsoft.com/office/drawing/2014/main" id="{92A194B0-9D26-6E89-6697-6F0A3E341685}"/>
               </a:ext>
             </a:extLst>
           </p:cNvPr>
@@ -12172,7 +12184,7 @@
           <p:cNvPr id="8" name="CuadroTexto 7">
             <a:extLst>
               <a:ext uri="{FF2B5EF4-FFF2-40B4-BE49-F238E27FC236}">
-                <a16:creationId xmlns:a16="http://schemas.microsoft.com/office/drawing/2014/main" id="{095C2770-075A-E1AE-39E4-CC556F9E6B42}"/>
+                <a16:creationId xmlns:a16="http://schemas.microsoft.com/office/drawing/2014/main" id="{B7265368-417D-8CF7-D6CC-44C2C962A845}"/>
               </a:ext>
             </a:extLst>
           </p:cNvPr>
@@ -12212,7 +12224,7 @@
           <p:cNvPr id="9" name="CuadroTexto 8">
             <a:extLst>
               <a:ext uri="{FF2B5EF4-FFF2-40B4-BE49-F238E27FC236}">
-                <a16:creationId xmlns:a16="http://schemas.microsoft.com/office/drawing/2014/main" id="{4D4E9506-F8ED-64EE-F435-D2DED80E2CFF}"/>
+                <a16:creationId xmlns:a16="http://schemas.microsoft.com/office/drawing/2014/main" id="{DDA87816-E9D1-F9A8-BCE6-E9C18C33CD7F}"/>
               </a:ext>
             </a:extLst>
           </p:cNvPr>
@@ -12252,7 +12264,7 @@
           <p:cNvPr id="10" name="Rectángulo: esquinas redondeadas 9">
             <a:extLst>
               <a:ext uri="{FF2B5EF4-FFF2-40B4-BE49-F238E27FC236}">
-                <a16:creationId xmlns:a16="http://schemas.microsoft.com/office/drawing/2014/main" id="{3B205261-802F-6167-F4F3-63DB82791C98}"/>
+                <a16:creationId xmlns:a16="http://schemas.microsoft.com/office/drawing/2014/main" id="{9E521CE2-9619-B62A-598C-05212E2086DB}"/>
               </a:ext>
             </a:extLst>
           </p:cNvPr>
@@ -12306,7 +12318,7 @@
           <p:cNvPr id="11" name="CuadroTexto 10">
             <a:extLst>
               <a:ext uri="{FF2B5EF4-FFF2-40B4-BE49-F238E27FC236}">
-                <a16:creationId xmlns:a16="http://schemas.microsoft.com/office/drawing/2014/main" id="{D221A0DD-693E-9A9F-9325-93642120B206}"/>
+                <a16:creationId xmlns:a16="http://schemas.microsoft.com/office/drawing/2014/main" id="{EC5A8C0C-B961-9A1F-9081-E89BED912CE3}"/>
               </a:ext>
             </a:extLst>
           </p:cNvPr>
@@ -12346,7 +12358,7 @@
           <p:cNvPr id="12" name="CuadroTexto 11">
             <a:extLst>
               <a:ext uri="{FF2B5EF4-FFF2-40B4-BE49-F238E27FC236}">
-                <a16:creationId xmlns:a16="http://schemas.microsoft.com/office/drawing/2014/main" id="{CF994431-B047-6A96-3F30-EBA2B474CEC1}"/>
+                <a16:creationId xmlns:a16="http://schemas.microsoft.com/office/drawing/2014/main" id="{403627B6-2459-65C7-94BD-E00DBDBBF570}"/>
               </a:ext>
             </a:extLst>
           </p:cNvPr>
@@ -12386,7 +12398,7 @@
           <p:cNvPr id="13" name="Rectángulo: esquinas redondeadas 12">
             <a:extLst>
               <a:ext uri="{FF2B5EF4-FFF2-40B4-BE49-F238E27FC236}">
-                <a16:creationId xmlns:a16="http://schemas.microsoft.com/office/drawing/2014/main" id="{92D683EB-0979-9A3E-ED3F-9A4AAD14D32A}"/>
+                <a16:creationId xmlns:a16="http://schemas.microsoft.com/office/drawing/2014/main" id="{592E57D2-6D4B-8B8D-062D-6E19DE145D70}"/>
               </a:ext>
             </a:extLst>
           </p:cNvPr>
@@ -12440,7 +12452,7 @@
           <p:cNvPr id="14" name="CuadroTexto 13">
             <a:extLst>
               <a:ext uri="{FF2B5EF4-FFF2-40B4-BE49-F238E27FC236}">
-                <a16:creationId xmlns:a16="http://schemas.microsoft.com/office/drawing/2014/main" id="{98195BD7-32B3-7B98-B261-6DA618933790}"/>
+                <a16:creationId xmlns:a16="http://schemas.microsoft.com/office/drawing/2014/main" id="{2ED6D522-F1EA-7B94-8754-A82EB74CD398}"/>
               </a:ext>
             </a:extLst>
           </p:cNvPr>
@@ -12480,7 +12492,7 @@
           <p:cNvPr id="15" name="CuadroTexto 14">
             <a:extLst>
               <a:ext uri="{FF2B5EF4-FFF2-40B4-BE49-F238E27FC236}">
-                <a16:creationId xmlns:a16="http://schemas.microsoft.com/office/drawing/2014/main" id="{133FDDFD-F0DE-F9D6-9748-A66ACCBD4D51}"/>
+                <a16:creationId xmlns:a16="http://schemas.microsoft.com/office/drawing/2014/main" id="{91961B62-5726-095D-61C9-2C6DCF721513}"/>
               </a:ext>
             </a:extLst>
           </p:cNvPr>
@@ -12518,7 +12530,7 @@
     </p:spTree>
     <p:extLst>
       <p:ext uri="{BB962C8B-B14F-4D97-AF65-F5344CB8AC3E}">
-        <p14:creationId xmlns:p14="http://schemas.microsoft.com/office/powerpoint/2010/main" val="2238428987"/>
+        <p14:creationId xmlns:p14="http://schemas.microsoft.com/office/powerpoint/2010/main" val="2534266136"/>
       </p:ext>
     </p:extLst>
   </p:cSld>
@@ -12558,7 +12570,7 @@
           <p:cNvPr id="2" name="CuadroTexto 1">
             <a:extLst>
               <a:ext uri="{FF2B5EF4-FFF2-40B4-BE49-F238E27FC236}">
-                <a16:creationId xmlns:a16="http://schemas.microsoft.com/office/drawing/2014/main" id="{F8C96AC9-0D26-0ECD-02B6-84C87A4A6654}"/>
+                <a16:creationId xmlns:a16="http://schemas.microsoft.com/office/drawing/2014/main" id="{04B692FA-03D2-DD2B-CB9D-2FFB89C14FBD}"/>
               </a:ext>
             </a:extLst>
           </p:cNvPr>
@@ -12598,7 +12610,7 @@
           <p:cNvPr id="3" name="CuadroTexto 2">
             <a:extLst>
               <a:ext uri="{FF2B5EF4-FFF2-40B4-BE49-F238E27FC236}">
-                <a16:creationId xmlns:a16="http://schemas.microsoft.com/office/drawing/2014/main" id="{B847EAA9-EDA6-4848-BBA5-30681BDE359F}"/>
+                <a16:creationId xmlns:a16="http://schemas.microsoft.com/office/drawing/2014/main" id="{51790278-3336-43C1-736E-D89B7DAAAA32}"/>
               </a:ext>
             </a:extLst>
           </p:cNvPr>
@@ -12638,7 +12650,7 @@
           <p:cNvPr id="4" name="CuadroTexto 3">
             <a:extLst>
               <a:ext uri="{FF2B5EF4-FFF2-40B4-BE49-F238E27FC236}">
-                <a16:creationId xmlns:a16="http://schemas.microsoft.com/office/drawing/2014/main" id="{7212F738-16EA-20C1-3BDD-7A5F53ACBD03}"/>
+                <a16:creationId xmlns:a16="http://schemas.microsoft.com/office/drawing/2014/main" id="{DE5D0344-4891-A8A6-410F-DB3668E37E7E}"/>
               </a:ext>
             </a:extLst>
           </p:cNvPr>
@@ -12678,7 +12690,7 @@
           <p:cNvPr id="6" name="Imagen 5">
             <a:extLst>
               <a:ext uri="{FF2B5EF4-FFF2-40B4-BE49-F238E27FC236}">
-                <a16:creationId xmlns:a16="http://schemas.microsoft.com/office/drawing/2014/main" id="{B8A83756-3E38-7136-49B0-FF02EFC4D3DC}"/>
+                <a16:creationId xmlns:a16="http://schemas.microsoft.com/office/drawing/2014/main" id="{FCB053C4-F073-E1A7-5A1A-6BDDFBC9A501}"/>
               </a:ext>
             </a:extLst>
           </p:cNvPr>
@@ -12719,7 +12731,7 @@
           <p:cNvPr id="7" name="CuadroTexto 6">
             <a:extLst>
               <a:ext uri="{FF2B5EF4-FFF2-40B4-BE49-F238E27FC236}">
-                <a16:creationId xmlns:a16="http://schemas.microsoft.com/office/drawing/2014/main" id="{797053BF-47BB-DA04-2F8F-67CE725BD576}"/>
+                <a16:creationId xmlns:a16="http://schemas.microsoft.com/office/drawing/2014/main" id="{CAD90268-AB04-F55A-7E14-96DF875C706B}"/>
               </a:ext>
             </a:extLst>
           </p:cNvPr>
@@ -12836,7 +12848,7 @@
     </p:spTree>
     <p:extLst>
       <p:ext uri="{BB962C8B-B14F-4D97-AF65-F5344CB8AC3E}">
-        <p14:creationId xmlns:p14="http://schemas.microsoft.com/office/powerpoint/2010/main" val="1952134176"/>
+        <p14:creationId xmlns:p14="http://schemas.microsoft.com/office/powerpoint/2010/main" val="3210147453"/>
       </p:ext>
     </p:extLst>
   </p:cSld>
@@ -12876,7 +12888,7 @@
           <p:cNvPr id="2" name="CuadroTexto 1">
             <a:extLst>
               <a:ext uri="{FF2B5EF4-FFF2-40B4-BE49-F238E27FC236}">
-                <a16:creationId xmlns:a16="http://schemas.microsoft.com/office/drawing/2014/main" id="{9E076305-96BD-4C82-B987-9EFEFDA00151}"/>
+                <a16:creationId xmlns:a16="http://schemas.microsoft.com/office/drawing/2014/main" id="{9A973594-7741-0198-F74A-DC1BCB2A1942}"/>
               </a:ext>
             </a:extLst>
           </p:cNvPr>
@@ -12916,7 +12928,7 @@
           <p:cNvPr id="3" name="CuadroTexto 2">
             <a:extLst>
               <a:ext uri="{FF2B5EF4-FFF2-40B4-BE49-F238E27FC236}">
-                <a16:creationId xmlns:a16="http://schemas.microsoft.com/office/drawing/2014/main" id="{F65DB9EA-E384-5009-09E5-F8B7BD2D2E40}"/>
+                <a16:creationId xmlns:a16="http://schemas.microsoft.com/office/drawing/2014/main" id="{969B1E9D-E162-BBD4-1F01-F007A17A5DA8}"/>
               </a:ext>
             </a:extLst>
           </p:cNvPr>
@@ -12956,7 +12968,7 @@
           <p:cNvPr id="5" name="Imagen 4">
             <a:extLst>
               <a:ext uri="{FF2B5EF4-FFF2-40B4-BE49-F238E27FC236}">
-                <a16:creationId xmlns:a16="http://schemas.microsoft.com/office/drawing/2014/main" id="{18F4080D-631C-EE2A-85A4-4B179314A99A}"/>
+                <a16:creationId xmlns:a16="http://schemas.microsoft.com/office/drawing/2014/main" id="{60BFBA19-66D0-6373-5CDC-C909433DEF74}"/>
               </a:ext>
             </a:extLst>
           </p:cNvPr>
@@ -12997,7 +13009,7 @@
           <p:cNvPr id="6" name="CuadroTexto 5">
             <a:extLst>
               <a:ext uri="{FF2B5EF4-FFF2-40B4-BE49-F238E27FC236}">
-                <a16:creationId xmlns:a16="http://schemas.microsoft.com/office/drawing/2014/main" id="{74C92D2A-47A7-2230-F79C-29817259A6C0}"/>
+                <a16:creationId xmlns:a16="http://schemas.microsoft.com/office/drawing/2014/main" id="{08F31B93-0332-CA5C-9C7F-268A6ED66CC7}"/>
               </a:ext>
             </a:extLst>
           </p:cNvPr>
@@ -13037,7 +13049,7 @@
           <p:cNvPr id="7" name="CuadroTexto 6">
             <a:extLst>
               <a:ext uri="{FF2B5EF4-FFF2-40B4-BE49-F238E27FC236}">
-                <a16:creationId xmlns:a16="http://schemas.microsoft.com/office/drawing/2014/main" id="{3D8583A2-A8A6-6E9C-6C7C-BAA2A9CBAF73}"/>
+                <a16:creationId xmlns:a16="http://schemas.microsoft.com/office/drawing/2014/main" id="{499BFAAD-C366-AEAC-E006-624FBD4B18B1}"/>
               </a:ext>
             </a:extLst>
           </p:cNvPr>
@@ -13136,7 +13148,7 @@
     </p:spTree>
     <p:extLst>
       <p:ext uri="{BB962C8B-B14F-4D97-AF65-F5344CB8AC3E}">
-        <p14:creationId xmlns:p14="http://schemas.microsoft.com/office/powerpoint/2010/main" val="1789993447"/>
+        <p14:creationId xmlns:p14="http://schemas.microsoft.com/office/powerpoint/2010/main" val="3604982584"/>
       </p:ext>
     </p:extLst>
   </p:cSld>
@@ -13176,7 +13188,7 @@
           <p:cNvPr id="2" name="CuadroTexto 1">
             <a:extLst>
               <a:ext uri="{FF2B5EF4-FFF2-40B4-BE49-F238E27FC236}">
-                <a16:creationId xmlns:a16="http://schemas.microsoft.com/office/drawing/2014/main" id="{A6106D1B-8129-3B92-E9E3-11B8CE1A4906}"/>
+                <a16:creationId xmlns:a16="http://schemas.microsoft.com/office/drawing/2014/main" id="{9094051E-18EE-66B2-2688-58E9C78B6312}"/>
               </a:ext>
             </a:extLst>
           </p:cNvPr>
@@ -13216,7 +13228,7 @@
           <p:cNvPr id="3" name="CuadroTexto 2">
             <a:extLst>
               <a:ext uri="{FF2B5EF4-FFF2-40B4-BE49-F238E27FC236}">
-                <a16:creationId xmlns:a16="http://schemas.microsoft.com/office/drawing/2014/main" id="{6F252036-E420-58C1-C72E-2FD6566452FA}"/>
+                <a16:creationId xmlns:a16="http://schemas.microsoft.com/office/drawing/2014/main" id="{C797AED2-862F-C2EB-BC2C-5DB4F3B6EAD8}"/>
               </a:ext>
             </a:extLst>
           </p:cNvPr>
@@ -13256,7 +13268,7 @@
           <p:cNvPr id="4" name="CuadroTexto 3">
             <a:extLst>
               <a:ext uri="{FF2B5EF4-FFF2-40B4-BE49-F238E27FC236}">
-                <a16:creationId xmlns:a16="http://schemas.microsoft.com/office/drawing/2014/main" id="{B0524930-D85D-00A2-6DC7-F647C01C50AF}"/>
+                <a16:creationId xmlns:a16="http://schemas.microsoft.com/office/drawing/2014/main" id="{622E9172-3673-9631-3BEB-07E753D181E1}"/>
               </a:ext>
             </a:extLst>
           </p:cNvPr>
@@ -13296,7 +13308,7 @@
           <p:cNvPr id="6" name="Imagen 5">
             <a:extLst>
               <a:ext uri="{FF2B5EF4-FFF2-40B4-BE49-F238E27FC236}">
-                <a16:creationId xmlns:a16="http://schemas.microsoft.com/office/drawing/2014/main" id="{F00117D1-5494-448F-3BDA-DE7F392A87B6}"/>
+                <a16:creationId xmlns:a16="http://schemas.microsoft.com/office/drawing/2014/main" id="{E7A6C0D7-0D12-049E-59B6-DFB96BCDF676}"/>
               </a:ext>
             </a:extLst>
           </p:cNvPr>
@@ -13337,7 +13349,7 @@
           <p:cNvPr id="7" name="Rectángulo: esquinas redondeadas 6">
             <a:extLst>
               <a:ext uri="{FF2B5EF4-FFF2-40B4-BE49-F238E27FC236}">
-                <a16:creationId xmlns:a16="http://schemas.microsoft.com/office/drawing/2014/main" id="{4750A68F-8A8F-7C08-C958-69DE83902CFA}"/>
+                <a16:creationId xmlns:a16="http://schemas.microsoft.com/office/drawing/2014/main" id="{B006D3B4-6F2B-7C77-7886-012B37873781}"/>
               </a:ext>
             </a:extLst>
           </p:cNvPr>
@@ -13391,7 +13403,7 @@
           <p:cNvPr id="8" name="CuadroTexto 7">
             <a:extLst>
               <a:ext uri="{FF2B5EF4-FFF2-40B4-BE49-F238E27FC236}">
-                <a16:creationId xmlns:a16="http://schemas.microsoft.com/office/drawing/2014/main" id="{F47DDCC1-1176-DB6E-B08B-F13B286576C5}"/>
+                <a16:creationId xmlns:a16="http://schemas.microsoft.com/office/drawing/2014/main" id="{256021A2-81B0-86AC-B228-EE98914F140E}"/>
               </a:ext>
             </a:extLst>
           </p:cNvPr>
@@ -13431,7 +13443,7 @@
           <p:cNvPr id="9" name="CuadroTexto 8">
             <a:extLst>
               <a:ext uri="{FF2B5EF4-FFF2-40B4-BE49-F238E27FC236}">
-                <a16:creationId xmlns:a16="http://schemas.microsoft.com/office/drawing/2014/main" id="{8D3C6496-F89D-B056-791F-6772519D0688}"/>
+                <a16:creationId xmlns:a16="http://schemas.microsoft.com/office/drawing/2014/main" id="{61D045D7-65D5-F9D4-E5F3-56849A3654C3}"/>
               </a:ext>
             </a:extLst>
           </p:cNvPr>
@@ -13471,7 +13483,7 @@
           <p:cNvPr id="10" name="Rectángulo: esquinas redondeadas 9">
             <a:extLst>
               <a:ext uri="{FF2B5EF4-FFF2-40B4-BE49-F238E27FC236}">
-                <a16:creationId xmlns:a16="http://schemas.microsoft.com/office/drawing/2014/main" id="{51035456-CC8B-AD5A-78C5-1BCF6DC194A5}"/>
+                <a16:creationId xmlns:a16="http://schemas.microsoft.com/office/drawing/2014/main" id="{B5133DCF-BECA-3B05-3CA7-116DCD586987}"/>
               </a:ext>
             </a:extLst>
           </p:cNvPr>
@@ -13525,7 +13537,7 @@
           <p:cNvPr id="11" name="CuadroTexto 10">
             <a:extLst>
               <a:ext uri="{FF2B5EF4-FFF2-40B4-BE49-F238E27FC236}">
-                <a16:creationId xmlns:a16="http://schemas.microsoft.com/office/drawing/2014/main" id="{62B3E2B1-5BD9-CA58-8AD9-FEC81DDA2935}"/>
+                <a16:creationId xmlns:a16="http://schemas.microsoft.com/office/drawing/2014/main" id="{508F03D7-7445-53D1-F2E7-2F798626E1B6}"/>
               </a:ext>
             </a:extLst>
           </p:cNvPr>
@@ -13565,7 +13577,7 @@
           <p:cNvPr id="12" name="CuadroTexto 11">
             <a:extLst>
               <a:ext uri="{FF2B5EF4-FFF2-40B4-BE49-F238E27FC236}">
-                <a16:creationId xmlns:a16="http://schemas.microsoft.com/office/drawing/2014/main" id="{6CDCB583-F127-36DE-1E72-A9350557C0D9}"/>
+                <a16:creationId xmlns:a16="http://schemas.microsoft.com/office/drawing/2014/main" id="{C8315CDE-F7EB-FEE1-C08D-20A3C2F9DD7D}"/>
               </a:ext>
             </a:extLst>
           </p:cNvPr>
@@ -13605,7 +13617,7 @@
           <p:cNvPr id="13" name="Rectángulo: esquinas redondeadas 12">
             <a:extLst>
               <a:ext uri="{FF2B5EF4-FFF2-40B4-BE49-F238E27FC236}">
-                <a16:creationId xmlns:a16="http://schemas.microsoft.com/office/drawing/2014/main" id="{3A59758E-1378-1085-AE6A-6FA9FDE25DF4}"/>
+                <a16:creationId xmlns:a16="http://schemas.microsoft.com/office/drawing/2014/main" id="{6E08BFBC-7104-7DBF-4725-841B78F0D529}"/>
               </a:ext>
             </a:extLst>
           </p:cNvPr>
@@ -13659,7 +13671,7 @@
           <p:cNvPr id="14" name="CuadroTexto 13">
             <a:extLst>
               <a:ext uri="{FF2B5EF4-FFF2-40B4-BE49-F238E27FC236}">
-                <a16:creationId xmlns:a16="http://schemas.microsoft.com/office/drawing/2014/main" id="{7471A1D0-3E1B-A145-E992-63FB223E3838}"/>
+                <a16:creationId xmlns:a16="http://schemas.microsoft.com/office/drawing/2014/main" id="{A1AF1292-558C-29ED-9B82-469D6441EE2B}"/>
               </a:ext>
             </a:extLst>
           </p:cNvPr>
@@ -13699,7 +13711,7 @@
           <p:cNvPr id="15" name="CuadroTexto 14">
             <a:extLst>
               <a:ext uri="{FF2B5EF4-FFF2-40B4-BE49-F238E27FC236}">
-                <a16:creationId xmlns:a16="http://schemas.microsoft.com/office/drawing/2014/main" id="{E7E79A1D-D6AD-ABAF-83F5-0BD6618EC4FC}"/>
+                <a16:creationId xmlns:a16="http://schemas.microsoft.com/office/drawing/2014/main" id="{ADD2420F-ECF0-9AEE-2F7F-3EE171BA209C}"/>
               </a:ext>
             </a:extLst>
           </p:cNvPr>
@@ -13737,7 +13749,7 @@
     </p:spTree>
     <p:extLst>
       <p:ext uri="{BB962C8B-B14F-4D97-AF65-F5344CB8AC3E}">
-        <p14:creationId xmlns:p14="http://schemas.microsoft.com/office/powerpoint/2010/main" val="2091320800"/>
+        <p14:creationId xmlns:p14="http://schemas.microsoft.com/office/powerpoint/2010/main" val="2008662375"/>
       </p:ext>
     </p:extLst>
   </p:cSld>
@@ -13777,7 +13789,7 @@
           <p:cNvPr id="2" name="CuadroTexto 1">
             <a:extLst>
               <a:ext uri="{FF2B5EF4-FFF2-40B4-BE49-F238E27FC236}">
-                <a16:creationId xmlns:a16="http://schemas.microsoft.com/office/drawing/2014/main" id="{83035B44-3127-25AC-A990-92472B1C07E5}"/>
+                <a16:creationId xmlns:a16="http://schemas.microsoft.com/office/drawing/2014/main" id="{605B9C2E-C6D9-53E0-CD6B-6C0ACA1B77A4}"/>
               </a:ext>
             </a:extLst>
           </p:cNvPr>
@@ -13817,7 +13829,7 @@
           <p:cNvPr id="3" name="CuadroTexto 2">
             <a:extLst>
               <a:ext uri="{FF2B5EF4-FFF2-40B4-BE49-F238E27FC236}">
-                <a16:creationId xmlns:a16="http://schemas.microsoft.com/office/drawing/2014/main" id="{E1880C90-F9B8-1FA0-3EF4-1EE99146DBA9}"/>
+                <a16:creationId xmlns:a16="http://schemas.microsoft.com/office/drawing/2014/main" id="{E2A8FFA2-E4EC-B497-851D-2AE407F68C81}"/>
               </a:ext>
             </a:extLst>
           </p:cNvPr>
@@ -13857,7 +13869,7 @@
           <p:cNvPr id="5" name="Imagen 4">
             <a:extLst>
               <a:ext uri="{FF2B5EF4-FFF2-40B4-BE49-F238E27FC236}">
-                <a16:creationId xmlns:a16="http://schemas.microsoft.com/office/drawing/2014/main" id="{EC26E78B-F9E8-0060-48D8-BABB212CCB3C}"/>
+                <a16:creationId xmlns:a16="http://schemas.microsoft.com/office/drawing/2014/main" id="{D9EE1A30-C6A6-9604-7845-E88FCDE5D209}"/>
               </a:ext>
             </a:extLst>
           </p:cNvPr>
@@ -13898,7 +13910,7 @@
           <p:cNvPr id="6" name="CuadroTexto 5">
             <a:extLst>
               <a:ext uri="{FF2B5EF4-FFF2-40B4-BE49-F238E27FC236}">
-                <a16:creationId xmlns:a16="http://schemas.microsoft.com/office/drawing/2014/main" id="{C5597E0C-6FA2-8809-78A0-C9557D13FB38}"/>
+                <a16:creationId xmlns:a16="http://schemas.microsoft.com/office/drawing/2014/main" id="{3BF9AE3C-C6EE-5AD1-280A-1CC1EE01888C}"/>
               </a:ext>
             </a:extLst>
           </p:cNvPr>
@@ -13997,7 +14009,7 @@
     </p:spTree>
     <p:extLst>
       <p:ext uri="{BB962C8B-B14F-4D97-AF65-F5344CB8AC3E}">
-        <p14:creationId xmlns:p14="http://schemas.microsoft.com/office/powerpoint/2010/main" val="253743064"/>
+        <p14:creationId xmlns:p14="http://schemas.microsoft.com/office/powerpoint/2010/main" val="2178001194"/>
       </p:ext>
     </p:extLst>
   </p:cSld>
@@ -14037,7 +14049,7 @@
           <p:cNvPr id="2" name="CuadroTexto 1">
             <a:extLst>
               <a:ext uri="{FF2B5EF4-FFF2-40B4-BE49-F238E27FC236}">
-                <a16:creationId xmlns:a16="http://schemas.microsoft.com/office/drawing/2014/main" id="{52976B65-E450-7BDB-321B-797CA7DB4F1A}"/>
+                <a16:creationId xmlns:a16="http://schemas.microsoft.com/office/drawing/2014/main" id="{4C2435C5-682F-CB73-70EA-CDD67D44A5F6}"/>
               </a:ext>
             </a:extLst>
           </p:cNvPr>
@@ -14077,7 +14089,7 @@
           <p:cNvPr id="3" name="CuadroTexto 2">
             <a:extLst>
               <a:ext uri="{FF2B5EF4-FFF2-40B4-BE49-F238E27FC236}">
-                <a16:creationId xmlns:a16="http://schemas.microsoft.com/office/drawing/2014/main" id="{7627C858-FFA6-CE79-9493-EB0E7CC66A3C}"/>
+                <a16:creationId xmlns:a16="http://schemas.microsoft.com/office/drawing/2014/main" id="{EB68F9B0-6948-D606-9EA4-A9DA6F65E8F8}"/>
               </a:ext>
             </a:extLst>
           </p:cNvPr>
@@ -14117,7 +14129,7 @@
           <p:cNvPr id="4" name="CuadroTexto 3">
             <a:extLst>
               <a:ext uri="{FF2B5EF4-FFF2-40B4-BE49-F238E27FC236}">
-                <a16:creationId xmlns:a16="http://schemas.microsoft.com/office/drawing/2014/main" id="{DC5ACFBE-F13A-DB35-BB4A-09033F80731F}"/>
+                <a16:creationId xmlns:a16="http://schemas.microsoft.com/office/drawing/2014/main" id="{02F71A86-E8C4-518E-11FB-52D41E755908}"/>
               </a:ext>
             </a:extLst>
           </p:cNvPr>
@@ -14157,7 +14169,7 @@
           <p:cNvPr id="6" name="Imagen 5">
             <a:extLst>
               <a:ext uri="{FF2B5EF4-FFF2-40B4-BE49-F238E27FC236}">
-                <a16:creationId xmlns:a16="http://schemas.microsoft.com/office/drawing/2014/main" id="{EB8FFFBB-6634-B069-B1FC-13D42BA336F2}"/>
+                <a16:creationId xmlns:a16="http://schemas.microsoft.com/office/drawing/2014/main" id="{C73A2303-FE17-803C-3C0C-DA3478954933}"/>
               </a:ext>
             </a:extLst>
           </p:cNvPr>
@@ -14198,7 +14210,7 @@
           <p:cNvPr id="7" name="Rectángulo: esquinas redondeadas 6">
             <a:extLst>
               <a:ext uri="{FF2B5EF4-FFF2-40B4-BE49-F238E27FC236}">
-                <a16:creationId xmlns:a16="http://schemas.microsoft.com/office/drawing/2014/main" id="{0AB9CE5D-0E25-D493-0D60-EDD8059347F2}"/>
+                <a16:creationId xmlns:a16="http://schemas.microsoft.com/office/drawing/2014/main" id="{8CDB6A68-B201-4D87-D2C6-C4C6D873CC6E}"/>
               </a:ext>
             </a:extLst>
           </p:cNvPr>
@@ -14252,7 +14264,7 @@
           <p:cNvPr id="8" name="CuadroTexto 7">
             <a:extLst>
               <a:ext uri="{FF2B5EF4-FFF2-40B4-BE49-F238E27FC236}">
-                <a16:creationId xmlns:a16="http://schemas.microsoft.com/office/drawing/2014/main" id="{51CF039D-59BC-3610-F063-516941FD2E5D}"/>
+                <a16:creationId xmlns:a16="http://schemas.microsoft.com/office/drawing/2014/main" id="{71425291-03D1-5B3F-4FE3-ED2305FFCB6C}"/>
               </a:ext>
             </a:extLst>
           </p:cNvPr>
@@ -14292,7 +14304,7 @@
           <p:cNvPr id="9" name="CuadroTexto 8">
             <a:extLst>
               <a:ext uri="{FF2B5EF4-FFF2-40B4-BE49-F238E27FC236}">
-                <a16:creationId xmlns:a16="http://schemas.microsoft.com/office/drawing/2014/main" id="{01D168E3-3089-AFC7-670A-094D4D442D2A}"/>
+                <a16:creationId xmlns:a16="http://schemas.microsoft.com/office/drawing/2014/main" id="{7D5E2356-D702-4013-FE15-953F754877F1}"/>
               </a:ext>
             </a:extLst>
           </p:cNvPr>
@@ -14330,7 +14342,7 @@
     </p:spTree>
     <p:extLst>
       <p:ext uri="{BB962C8B-B14F-4D97-AF65-F5344CB8AC3E}">
-        <p14:creationId xmlns:p14="http://schemas.microsoft.com/office/powerpoint/2010/main" val="242240842"/>
+        <p14:creationId xmlns:p14="http://schemas.microsoft.com/office/powerpoint/2010/main" val="3741760601"/>
       </p:ext>
     </p:extLst>
   </p:cSld>
@@ -14370,7 +14382,7 @@
           <p:cNvPr id="2" name="CuadroTexto 1">
             <a:extLst>
               <a:ext uri="{FF2B5EF4-FFF2-40B4-BE49-F238E27FC236}">
-                <a16:creationId xmlns:a16="http://schemas.microsoft.com/office/drawing/2014/main" id="{F51136B8-6759-2CB6-5286-427C9AA1ED74}"/>
+                <a16:creationId xmlns:a16="http://schemas.microsoft.com/office/drawing/2014/main" id="{A7C2479C-1178-3B08-4332-F63DB78EF9C1}"/>
               </a:ext>
             </a:extLst>
           </p:cNvPr>
@@ -14400,7 +14412,7 @@
                 </a:solidFill>
                 <a:latin typeface="Segoe UI" panose="020B0502040204020203" pitchFamily="34" charset="0"/>
               </a:rPr>
-              <a:t>08 / DESARROLLO</a:t>
+              <a:t>08 / FLUJO FUNCIONAL</a:t>
             </a:r>
           </a:p>
         </p:txBody>
@@ -14410,7 +14422,7 @@
           <p:cNvPr id="3" name="CuadroTexto 2">
             <a:extLst>
               <a:ext uri="{FF2B5EF4-FFF2-40B4-BE49-F238E27FC236}">
-                <a16:creationId xmlns:a16="http://schemas.microsoft.com/office/drawing/2014/main" id="{08044C68-1AC2-3165-B87F-1DD1940A2F9A}"/>
+                <a16:creationId xmlns:a16="http://schemas.microsoft.com/office/drawing/2014/main" id="{B4670353-1AC4-9709-C84C-D6F125359E17}"/>
               </a:ext>
             </a:extLst>
           </p:cNvPr>
@@ -14440,7 +14452,7 @@
                 </a:solidFill>
                 <a:latin typeface="Segoe UI" panose="020B0502040204020203" pitchFamily="34" charset="0"/>
               </a:rPr>
-              <a:t>Como lo he desarrollado y que partes tiene</a:t>
+              <a:t>Recorrido principal que queda cerrado</a:t>
             </a:r>
           </a:p>
         </p:txBody>
@@ -14450,7 +14462,7 @@
           <p:cNvPr id="4" name="CuadroTexto 3">
             <a:extLst>
               <a:ext uri="{FF2B5EF4-FFF2-40B4-BE49-F238E27FC236}">
-                <a16:creationId xmlns:a16="http://schemas.microsoft.com/office/drawing/2014/main" id="{0F4B591E-5ACB-0934-F7C9-D6661ED02A50}"/>
+                <a16:creationId xmlns:a16="http://schemas.microsoft.com/office/drawing/2014/main" id="{0762AAE2-D919-6A8C-5127-7777470DC727}"/>
               </a:ext>
             </a:extLst>
           </p:cNvPr>
@@ -14480,7 +14492,7 @@
                 </a:solidFill>
                 <a:latin typeface="Segoe UI" panose="020B0502040204020203" pitchFamily="34" charset="0"/>
               </a:rPr>
-              <a:t>La presentacion se apoya en bloques funcionales y decisiones de arquitectura, no en fragmentos de codigo.</a:t>
+              <a:t>La defensa se centra en el flujo real de empresa, convenio, asignacion, seguimiento y comunicacion.</a:t>
             </a:r>
           </a:p>
         </p:txBody>
@@ -14490,7 +14502,7 @@
           <p:cNvPr id="5" name="Rectángulo: esquinas redondeadas 4">
             <a:extLst>
               <a:ext uri="{FF2B5EF4-FFF2-40B4-BE49-F238E27FC236}">
-                <a16:creationId xmlns:a16="http://schemas.microsoft.com/office/drawing/2014/main" id="{8B210D98-24F9-2CCB-E86E-A026003D1450}"/>
+                <a16:creationId xmlns:a16="http://schemas.microsoft.com/office/drawing/2014/main" id="{D953EF2E-B3FC-0967-76C9-6F8FCE76F7B5}"/>
               </a:ext>
             </a:extLst>
           </p:cNvPr>
@@ -14499,8 +14511,8 @@
         </p:nvSpPr>
         <p:spPr>
           <a:xfrm>
-            <a:off x="762000" y="1955800"/>
-            <a:ext cx="4572000" cy="1041400"/>
+            <a:off x="889000" y="2108200"/>
+            <a:ext cx="4318000" cy="1219200"/>
           </a:xfrm>
           <a:prstGeom prst="roundRect">
             <a:avLst/>
@@ -14544,7 +14556,7 @@
           <p:cNvPr id="6" name="CuadroTexto 5">
             <a:extLst>
               <a:ext uri="{FF2B5EF4-FFF2-40B4-BE49-F238E27FC236}">
-                <a16:creationId xmlns:a16="http://schemas.microsoft.com/office/drawing/2014/main" id="{C0D88EC5-58D0-10A5-FCD7-0DE926216548}"/>
+                <a16:creationId xmlns:a16="http://schemas.microsoft.com/office/drawing/2014/main" id="{A8CB3E7F-8DC3-FF7F-8EB5-DE7CC2588564}"/>
               </a:ext>
             </a:extLst>
           </p:cNvPr>
@@ -14553,8 +14565,8 @@
         </p:nvSpPr>
         <p:spPr>
           <a:xfrm>
-            <a:off x="990600" y="2133600"/>
-            <a:ext cx="3810000" cy="369332"/>
+            <a:off x="1143000" y="2311400"/>
+            <a:ext cx="3556000" cy="369332"/>
           </a:xfrm>
           <a:prstGeom prst="rect">
             <a:avLst/>
@@ -14568,13 +14580,13 @@
           <a:lstStyle/>
           <a:p>
             <a:r>
-              <a:rPr lang="es-ES" b="1">
+              <a:rPr lang="es-ES" sz="1900" b="1">
                 <a:solidFill>
                   <a:srgbClr val="4975B0"/>
                 </a:solidFill>
                 <a:latin typeface="Segoe UI" panose="020B0502040204020203" pitchFamily="34" charset="0"/>
               </a:rPr>
-              <a:t>Analisis del problema</a:t>
+              <a:t>1. Entrada externa</a:t>
             </a:r>
           </a:p>
         </p:txBody>
@@ -14584,7 +14596,7 @@
           <p:cNvPr id="7" name="CuadroTexto 6">
             <a:extLst>
               <a:ext uri="{FF2B5EF4-FFF2-40B4-BE49-F238E27FC236}">
-                <a16:creationId xmlns:a16="http://schemas.microsoft.com/office/drawing/2014/main" id="{F582249E-F8EF-4972-FFD5-7C238DC6F5E5}"/>
+                <a16:creationId xmlns:a16="http://schemas.microsoft.com/office/drawing/2014/main" id="{FF0B8279-74CD-C2A4-8ED5-A64CE01D1E72}"/>
               </a:ext>
             </a:extLst>
           </p:cNvPr>
@@ -14593,8 +14605,8 @@
         </p:nvSpPr>
         <p:spPr>
           <a:xfrm>
-            <a:off x="990600" y="2489200"/>
-            <a:ext cx="4064000" cy="369332"/>
+            <a:off x="1143000" y="2717800"/>
+            <a:ext cx="3708400" cy="369332"/>
           </a:xfrm>
           <a:prstGeom prst="rect">
             <a:avLst/>
@@ -14608,13 +14620,13 @@
           <a:lstStyle/>
           <a:p>
             <a:r>
-              <a:rPr lang="es-ES" sz="1300">
+              <a:rPr lang="es-ES" sz="1400">
                 <a:solidFill>
                   <a:srgbClr val="1F2937"/>
                 </a:solidFill>
                 <a:latin typeface="Segoe UI" panose="020B0502040204020203" pitchFamily="34" charset="0"/>
               </a:rPr>
-              <a:t>Necesidad real del centro y alcance viable para el TFG.</a:t>
+              <a:t>La empresa se registra, verifica su correo y envia la solicitud.</a:t>
             </a:r>
           </a:p>
         </p:txBody>
@@ -14624,7 +14636,7 @@
           <p:cNvPr id="8" name="Rectángulo: esquinas redondeadas 7">
             <a:extLst>
               <a:ext uri="{FF2B5EF4-FFF2-40B4-BE49-F238E27FC236}">
-                <a16:creationId xmlns:a16="http://schemas.microsoft.com/office/drawing/2014/main" id="{869D589D-862E-1738-2D7F-282FBFE2BEC4}"/>
+                <a16:creationId xmlns:a16="http://schemas.microsoft.com/office/drawing/2014/main" id="{5EDBC3B4-AF9C-8E19-7A42-41E13D5FCFA5}"/>
               </a:ext>
             </a:extLst>
           </p:cNvPr>
@@ -14633,8 +14645,8 @@
         </p:nvSpPr>
         <p:spPr>
           <a:xfrm>
-            <a:off x="6096000" y="1955800"/>
-            <a:ext cx="4572000" cy="1041400"/>
+            <a:off x="6096000" y="2108200"/>
+            <a:ext cx="4318000" cy="1219200"/>
           </a:xfrm>
           <a:prstGeom prst="roundRect">
             <a:avLst/>
@@ -14678,7 +14690,7 @@
           <p:cNvPr id="9" name="CuadroTexto 8">
             <a:extLst>
               <a:ext uri="{FF2B5EF4-FFF2-40B4-BE49-F238E27FC236}">
-                <a16:creationId xmlns:a16="http://schemas.microsoft.com/office/drawing/2014/main" id="{498AD346-206F-902C-4992-AFB16AF5F679}"/>
+                <a16:creationId xmlns:a16="http://schemas.microsoft.com/office/drawing/2014/main" id="{A1079A58-C67C-384F-CEB9-2DF634A16FFD}"/>
               </a:ext>
             </a:extLst>
           </p:cNvPr>
@@ -14687,8 +14699,8 @@
         </p:nvSpPr>
         <p:spPr>
           <a:xfrm>
-            <a:off x="6324600" y="2133600"/>
-            <a:ext cx="3810000" cy="369332"/>
+            <a:off x="6350000" y="2311400"/>
+            <a:ext cx="3556000" cy="369332"/>
           </a:xfrm>
           <a:prstGeom prst="rect">
             <a:avLst/>
@@ -14702,13 +14714,13 @@
           <a:lstStyle/>
           <a:p>
             <a:r>
-              <a:rPr lang="es-ES" b="1">
+              <a:rPr lang="es-ES" sz="1900" b="1">
                 <a:solidFill>
                   <a:srgbClr val="4975B0"/>
                 </a:solidFill>
                 <a:latin typeface="Segoe UI" panose="020B0502040204020203" pitchFamily="34" charset="0"/>
               </a:rPr>
-              <a:t>Modelo y reglas</a:t>
+              <a:t>2. Revision interna</a:t>
             </a:r>
           </a:p>
         </p:txBody>
@@ -14718,7 +14730,7 @@
           <p:cNvPr id="10" name="CuadroTexto 9">
             <a:extLst>
               <a:ext uri="{FF2B5EF4-FFF2-40B4-BE49-F238E27FC236}">
-                <a16:creationId xmlns:a16="http://schemas.microsoft.com/office/drawing/2014/main" id="{8B7136A5-DF5E-8678-FE8D-D048C20FB184}"/>
+                <a16:creationId xmlns:a16="http://schemas.microsoft.com/office/drawing/2014/main" id="{C6A2BD28-F8F8-9F9F-6189-AEE9BD34DF13}"/>
               </a:ext>
             </a:extLst>
           </p:cNvPr>
@@ -14727,8 +14739,8 @@
         </p:nvSpPr>
         <p:spPr>
           <a:xfrm>
-            <a:off x="6324600" y="2489200"/>
-            <a:ext cx="4064000" cy="369332"/>
+            <a:off x="6350000" y="2717800"/>
+            <a:ext cx="3708400" cy="369332"/>
           </a:xfrm>
           <a:prstGeom prst="rect">
             <a:avLst/>
@@ -14742,13 +14754,13 @@
           <a:lstStyle/>
           <a:p>
             <a:r>
-              <a:rPr lang="es-ES" sz="1300">
+              <a:rPr lang="es-ES" sz="1400">
                 <a:solidFill>
                   <a:srgbClr val="1F2937"/>
                 </a:solidFill>
                 <a:latin typeface="Segoe UI" panose="020B0502040204020203" pitchFamily="34" charset="0"/>
               </a:rPr>
-              <a:t>Empresa, convenio, asignacion, seguimiento y evaluacion.</a:t>
+              <a:t>El centro aprueba o rechaza y la empresa ve el estado en su portal.</a:t>
             </a:r>
           </a:p>
         </p:txBody>
@@ -14758,7 +14770,7 @@
           <p:cNvPr id="11" name="Rectángulo: esquinas redondeadas 10">
             <a:extLst>
               <a:ext uri="{FF2B5EF4-FFF2-40B4-BE49-F238E27FC236}">
-                <a16:creationId xmlns:a16="http://schemas.microsoft.com/office/drawing/2014/main" id="{4DD590F9-B09E-70CD-0511-530DE04B0E8F}"/>
+                <a16:creationId xmlns:a16="http://schemas.microsoft.com/office/drawing/2014/main" id="{4CD28BFE-C892-D481-744E-35D66801D332}"/>
               </a:ext>
             </a:extLst>
           </p:cNvPr>
@@ -14767,8 +14779,8 @@
         </p:nvSpPr>
         <p:spPr>
           <a:xfrm>
-            <a:off x="762000" y="3276600"/>
-            <a:ext cx="4572000" cy="1041400"/>
+            <a:off x="889000" y="3759200"/>
+            <a:ext cx="4318000" cy="1219200"/>
           </a:xfrm>
           <a:prstGeom prst="roundRect">
             <a:avLst/>
@@ -14812,7 +14824,7 @@
           <p:cNvPr id="12" name="CuadroTexto 11">
             <a:extLst>
               <a:ext uri="{FF2B5EF4-FFF2-40B4-BE49-F238E27FC236}">
-                <a16:creationId xmlns:a16="http://schemas.microsoft.com/office/drawing/2014/main" id="{350CB926-A154-B737-7B33-7E398E952813}"/>
+                <a16:creationId xmlns:a16="http://schemas.microsoft.com/office/drawing/2014/main" id="{A6D19DEE-6FB0-E225-31E8-3607C35F34A0}"/>
               </a:ext>
             </a:extLst>
           </p:cNvPr>
@@ -14821,8 +14833,8 @@
         </p:nvSpPr>
         <p:spPr>
           <a:xfrm>
-            <a:off x="990600" y="3454400"/>
-            <a:ext cx="3810000" cy="369332"/>
+            <a:off x="1143000" y="3962400"/>
+            <a:ext cx="3556000" cy="369332"/>
           </a:xfrm>
           <a:prstGeom prst="rect">
             <a:avLst/>
@@ -14836,13 +14848,13 @@
           <a:lstStyle/>
           <a:p>
             <a:r>
-              <a:rPr lang="es-ES" b="1">
+              <a:rPr lang="es-ES" sz="1900" b="1">
                 <a:solidFill>
                   <a:srgbClr val="4975B0"/>
                 </a:solidFill>
                 <a:latin typeface="Segoe UI" panose="020B0502040204020203" pitchFamily="34" charset="0"/>
               </a:rPr>
-              <a:t>Backend Symfony</a:t>
+              <a:t>3. Operativa academica</a:t>
             </a:r>
           </a:p>
         </p:txBody>
@@ -14852,7 +14864,7 @@
           <p:cNvPr id="13" name="CuadroTexto 12">
             <a:extLst>
               <a:ext uri="{FF2B5EF4-FFF2-40B4-BE49-F238E27FC236}">
-                <a16:creationId xmlns:a16="http://schemas.microsoft.com/office/drawing/2014/main" id="{6C145FBE-6762-98F7-FDA5-AE033C797C3A}"/>
+                <a16:creationId xmlns:a16="http://schemas.microsoft.com/office/drawing/2014/main" id="{79B2AAAD-5EA9-C9F2-F96A-85B5C89FE4BA}"/>
               </a:ext>
             </a:extLst>
           </p:cNvPr>
@@ -14861,8 +14873,8 @@
         </p:nvSpPr>
         <p:spPr>
           <a:xfrm>
-            <a:off x="990600" y="3810000"/>
-            <a:ext cx="4064000" cy="369332"/>
+            <a:off x="1143000" y="4368800"/>
+            <a:ext cx="3708400" cy="369332"/>
           </a:xfrm>
           <a:prstGeom prst="rect">
             <a:avLst/>
@@ -14876,13 +14888,13 @@
           <a:lstStyle/>
           <a:p>
             <a:r>
-              <a:rPr lang="es-ES" sz="1300">
+              <a:rPr lang="es-ES" sz="1400">
                 <a:solidFill>
                   <a:srgbClr val="1F2937"/>
                 </a:solidFill>
                 <a:latin typeface="Segoe UI" panose="020B0502040204020203" pitchFamily="34" charset="0"/>
               </a:rPr>
-              <a:t>API, seguridad, correo, tokens, auditoria y persistencia.</a:t>
+              <a:t>Empresa activa, convenio firmado, asignacion, tutores, horas y fechas.</a:t>
             </a:r>
           </a:p>
         </p:txBody>
@@ -14892,7 +14904,7 @@
           <p:cNvPr id="14" name="Rectángulo: esquinas redondeadas 13">
             <a:extLst>
               <a:ext uri="{FF2B5EF4-FFF2-40B4-BE49-F238E27FC236}">
-                <a16:creationId xmlns:a16="http://schemas.microsoft.com/office/drawing/2014/main" id="{8D9AF402-975F-DE3F-B082-94CF73BFBA48}"/>
+                <a16:creationId xmlns:a16="http://schemas.microsoft.com/office/drawing/2014/main" id="{CABDE8AF-9CF7-CBCC-805F-4AB7165EA915}"/>
               </a:ext>
             </a:extLst>
           </p:cNvPr>
@@ -14901,8 +14913,8 @@
         </p:nvSpPr>
         <p:spPr>
           <a:xfrm>
-            <a:off x="6096000" y="3276600"/>
-            <a:ext cx="4572000" cy="1041400"/>
+            <a:off x="6096000" y="3759200"/>
+            <a:ext cx="4318000" cy="1219200"/>
           </a:xfrm>
           <a:prstGeom prst="roundRect">
             <a:avLst/>
@@ -14946,7 +14958,7 @@
           <p:cNvPr id="15" name="CuadroTexto 14">
             <a:extLst>
               <a:ext uri="{FF2B5EF4-FFF2-40B4-BE49-F238E27FC236}">
-                <a16:creationId xmlns:a16="http://schemas.microsoft.com/office/drawing/2014/main" id="{1DD93B0E-B103-95FE-9CD5-F4CCCB68E173}"/>
+                <a16:creationId xmlns:a16="http://schemas.microsoft.com/office/drawing/2014/main" id="{83A80362-C19B-D7CE-8E78-4A5356F097BF}"/>
               </a:ext>
             </a:extLst>
           </p:cNvPr>
@@ -14955,8 +14967,8 @@
         </p:nvSpPr>
         <p:spPr>
           <a:xfrm>
-            <a:off x="6324600" y="3454400"/>
-            <a:ext cx="3810000" cy="369332"/>
+            <a:off x="6350000" y="3962400"/>
+            <a:ext cx="3556000" cy="369332"/>
           </a:xfrm>
           <a:prstGeom prst="rect">
             <a:avLst/>
@@ -14970,13 +14982,13 @@
           <a:lstStyle/>
           <a:p>
             <a:r>
-              <a:rPr lang="es-ES" b="1">
+              <a:rPr lang="es-ES" sz="1900" b="1">
                 <a:solidFill>
                   <a:srgbClr val="4975B0"/>
                 </a:solidFill>
                 <a:latin typeface="Segoe UI" panose="020B0502040204020203" pitchFamily="34" charset="0"/>
               </a:rPr>
-              <a:t>Portal interno</a:t>
+              <a:t>4. Seguimiento</a:t>
             </a:r>
           </a:p>
         </p:txBody>
@@ -14986,7 +14998,7 @@
           <p:cNvPr id="16" name="CuadroTexto 15">
             <a:extLst>
               <a:ext uri="{FF2B5EF4-FFF2-40B4-BE49-F238E27FC236}">
-                <a16:creationId xmlns:a16="http://schemas.microsoft.com/office/drawing/2014/main" id="{C10A6A6A-85BB-08C6-32DA-C94CE5B3214F}"/>
+                <a16:creationId xmlns:a16="http://schemas.microsoft.com/office/drawing/2014/main" id="{7E638CD9-55ED-211C-634F-27E49A47E4D4}"/>
               </a:ext>
             </a:extLst>
           </p:cNvPr>
@@ -14995,8 +15007,8 @@
         </p:nvSpPr>
         <p:spPr>
           <a:xfrm>
-            <a:off x="6324600" y="3810000"/>
-            <a:ext cx="4064000" cy="369332"/>
+            <a:off x="6350000" y="4368800"/>
+            <a:ext cx="3708400" cy="369332"/>
           </a:xfrm>
           <a:prstGeom prst="rect">
             <a:avLst/>
@@ -15010,281 +15022,13 @@
           <a:lstStyle/>
           <a:p>
             <a:r>
-              <a:rPr lang="es-ES" sz="1300">
+              <a:rPr lang="es-ES" sz="1400">
                 <a:solidFill>
                   <a:srgbClr val="1F2937"/>
                 </a:solidFill>
                 <a:latin typeface="Segoe UI" panose="020B0502040204020203" pitchFamily="34" charset="0"/>
               </a:rPr>
-              <a:t>Gestion academica, bandeja, documentos y exportacion CSV.</a:t>
-            </a:r>
-          </a:p>
-        </p:txBody>
-      </p:sp>
-      <p:sp>
-        <p:nvSpPr>
-          <p:cNvPr id="17" name="Rectángulo: esquinas redondeadas 16">
-            <a:extLst>
-              <a:ext uri="{FF2B5EF4-FFF2-40B4-BE49-F238E27FC236}">
-                <a16:creationId xmlns:a16="http://schemas.microsoft.com/office/drawing/2014/main" id="{66669691-4924-183B-08AE-A04349A1AAD6}"/>
-              </a:ext>
-            </a:extLst>
-          </p:cNvPr>
-          <p:cNvSpPr/>
-          <p:nvPr/>
-        </p:nvSpPr>
-        <p:spPr>
-          <a:xfrm>
-            <a:off x="762000" y="4597400"/>
-            <a:ext cx="4572000" cy="1041400"/>
-          </a:xfrm>
-          <a:prstGeom prst="roundRect">
-            <a:avLst/>
-          </a:prstGeom>
-          <a:solidFill>
-            <a:srgbClr val="F7FAFC"/>
-          </a:solidFill>
-          <a:ln w="12700">
-            <a:solidFill>
-              <a:srgbClr val="DDE5EE"/>
-            </a:solidFill>
-          </a:ln>
-        </p:spPr>
-        <p:style>
-          <a:lnRef idx="2">
-            <a:schemeClr val="accent1">
-              <a:shade val="15000"/>
-            </a:schemeClr>
-          </a:lnRef>
-          <a:fillRef idx="1">
-            <a:schemeClr val="accent1"/>
-          </a:fillRef>
-          <a:effectRef idx="0">
-            <a:schemeClr val="accent1"/>
-          </a:effectRef>
-          <a:fontRef idx="minor">
-            <a:schemeClr val="lt1"/>
-          </a:fontRef>
-        </p:style>
-        <p:txBody>
-          <a:bodyPr rtlCol="0" anchor="ctr"/>
-          <a:lstStyle/>
-          <a:p>
-            <a:pPr algn="ctr"/>
-            <a:endParaRPr lang="es-ES"/>
-          </a:p>
-        </p:txBody>
-      </p:sp>
-      <p:sp>
-        <p:nvSpPr>
-          <p:cNvPr id="18" name="CuadroTexto 17">
-            <a:extLst>
-              <a:ext uri="{FF2B5EF4-FFF2-40B4-BE49-F238E27FC236}">
-                <a16:creationId xmlns:a16="http://schemas.microsoft.com/office/drawing/2014/main" id="{342CB79D-81BA-4B53-2C07-AB90B7A2F0A3}"/>
-              </a:ext>
-            </a:extLst>
-          </p:cNvPr>
-          <p:cNvSpPr txBox="1"/>
-          <p:nvPr/>
-        </p:nvSpPr>
-        <p:spPr>
-          <a:xfrm>
-            <a:off x="990600" y="4775200"/>
-            <a:ext cx="3810000" cy="369332"/>
-          </a:xfrm>
-          <a:prstGeom prst="rect">
-            <a:avLst/>
-          </a:prstGeom>
-          <a:noFill/>
-        </p:spPr>
-        <p:txBody>
-          <a:bodyPr vert="horz" wrap="square" lIns="0" tIns="0" rIns="0" bIns="0" rtlCol="0">
-            <a:noAutofit/>
-          </a:bodyPr>
-          <a:lstStyle/>
-          <a:p>
-            <a:r>
-              <a:rPr lang="es-ES" b="1">
-                <a:solidFill>
-                  <a:srgbClr val="4975B0"/>
-                </a:solidFill>
-                <a:latin typeface="Segoe UI" panose="020B0502040204020203" pitchFamily="34" charset="0"/>
-              </a:rPr>
-              <a:t>Portal externo</a:t>
-            </a:r>
-          </a:p>
-        </p:txBody>
-      </p:sp>
-      <p:sp>
-        <p:nvSpPr>
-          <p:cNvPr id="19" name="CuadroTexto 18">
-            <a:extLst>
-              <a:ext uri="{FF2B5EF4-FFF2-40B4-BE49-F238E27FC236}">
-                <a16:creationId xmlns:a16="http://schemas.microsoft.com/office/drawing/2014/main" id="{E7E81D59-E10A-3652-ECBC-678EC79E289F}"/>
-              </a:ext>
-            </a:extLst>
-          </p:cNvPr>
-          <p:cNvSpPr txBox="1"/>
-          <p:nvPr/>
-        </p:nvSpPr>
-        <p:spPr>
-          <a:xfrm>
-            <a:off x="990600" y="5130800"/>
-            <a:ext cx="4064000" cy="369332"/>
-          </a:xfrm>
-          <a:prstGeom prst="rect">
-            <a:avLst/>
-          </a:prstGeom>
-          <a:noFill/>
-        </p:spPr>
-        <p:txBody>
-          <a:bodyPr vert="horz" wrap="square" lIns="0" tIns="0" rIns="0" bIns="0" rtlCol="0">
-            <a:noAutofit/>
-          </a:bodyPr>
-          <a:lstStyle/>
-          <a:p>
-            <a:r>
-              <a:rPr lang="es-ES" sz="1300">
-                <a:solidFill>
-                  <a:srgbClr val="1F2937"/>
-                </a:solidFill>
-                <a:latin typeface="Segoe UI" panose="020B0502040204020203" pitchFamily="34" charset="0"/>
-              </a:rPr>
-              <a:t>Registro, verificacion, estado, acceso empresa y chat.</a:t>
-            </a:r>
-          </a:p>
-        </p:txBody>
-      </p:sp>
-      <p:sp>
-        <p:nvSpPr>
-          <p:cNvPr id="20" name="Rectángulo: esquinas redondeadas 19">
-            <a:extLst>
-              <a:ext uri="{FF2B5EF4-FFF2-40B4-BE49-F238E27FC236}">
-                <a16:creationId xmlns:a16="http://schemas.microsoft.com/office/drawing/2014/main" id="{2A0AFECD-1C89-E77B-FCB9-3501C7E9EB02}"/>
-              </a:ext>
-            </a:extLst>
-          </p:cNvPr>
-          <p:cNvSpPr/>
-          <p:nvPr/>
-        </p:nvSpPr>
-        <p:spPr>
-          <a:xfrm>
-            <a:off x="6096000" y="4597400"/>
-            <a:ext cx="4572000" cy="1041400"/>
-          </a:xfrm>
-          <a:prstGeom prst="roundRect">
-            <a:avLst/>
-          </a:prstGeom>
-          <a:solidFill>
-            <a:srgbClr val="F7FAFC"/>
-          </a:solidFill>
-          <a:ln w="12700">
-            <a:solidFill>
-              <a:srgbClr val="DDE5EE"/>
-            </a:solidFill>
-          </a:ln>
-        </p:spPr>
-        <p:style>
-          <a:lnRef idx="2">
-            <a:schemeClr val="accent1">
-              <a:shade val="15000"/>
-            </a:schemeClr>
-          </a:lnRef>
-          <a:fillRef idx="1">
-            <a:schemeClr val="accent1"/>
-          </a:fillRef>
-          <a:effectRef idx="0">
-            <a:schemeClr val="accent1"/>
-          </a:effectRef>
-          <a:fontRef idx="minor">
-            <a:schemeClr val="lt1"/>
-          </a:fontRef>
-        </p:style>
-        <p:txBody>
-          <a:bodyPr rtlCol="0" anchor="ctr"/>
-          <a:lstStyle/>
-          <a:p>
-            <a:pPr algn="ctr"/>
-            <a:endParaRPr lang="es-ES"/>
-          </a:p>
-        </p:txBody>
-      </p:sp>
-      <p:sp>
-        <p:nvSpPr>
-          <p:cNvPr id="21" name="CuadroTexto 20">
-            <a:extLst>
-              <a:ext uri="{FF2B5EF4-FFF2-40B4-BE49-F238E27FC236}">
-                <a16:creationId xmlns:a16="http://schemas.microsoft.com/office/drawing/2014/main" id="{D6D104A7-9D05-08E4-2951-773D9A43A73C}"/>
-              </a:ext>
-            </a:extLst>
-          </p:cNvPr>
-          <p:cNvSpPr txBox="1"/>
-          <p:nvPr/>
-        </p:nvSpPr>
-        <p:spPr>
-          <a:xfrm>
-            <a:off x="6324600" y="4775200"/>
-            <a:ext cx="3810000" cy="369332"/>
-          </a:xfrm>
-          <a:prstGeom prst="rect">
-            <a:avLst/>
-          </a:prstGeom>
-          <a:noFill/>
-        </p:spPr>
-        <p:txBody>
-          <a:bodyPr vert="horz" wrap="square" lIns="0" tIns="0" rIns="0" bIns="0" rtlCol="0">
-            <a:noAutofit/>
-          </a:bodyPr>
-          <a:lstStyle/>
-          <a:p>
-            <a:r>
-              <a:rPr lang="es-ES" b="1">
-                <a:solidFill>
-                  <a:srgbClr val="4975B0"/>
-                </a:solidFill>
-                <a:latin typeface="Segoe UI" panose="020B0502040204020203" pitchFamily="34" charset="0"/>
-              </a:rPr>
-              <a:t>Operacion final</a:t>
-            </a:r>
-          </a:p>
-        </p:txBody>
-      </p:sp>
-      <p:sp>
-        <p:nvSpPr>
-          <p:cNvPr id="22" name="CuadroTexto 21">
-            <a:extLst>
-              <a:ext uri="{FF2B5EF4-FFF2-40B4-BE49-F238E27FC236}">
-                <a16:creationId xmlns:a16="http://schemas.microsoft.com/office/drawing/2014/main" id="{A98FD55F-940E-B07F-8866-497AFE8FAABD}"/>
-              </a:ext>
-            </a:extLst>
-          </p:cNvPr>
-          <p:cNvSpPr txBox="1"/>
-          <p:nvPr/>
-        </p:nvSpPr>
-        <p:spPr>
-          <a:xfrm>
-            <a:off x="6324600" y="5130800"/>
-            <a:ext cx="4064000" cy="369332"/>
-          </a:xfrm>
-          <a:prstGeom prst="rect">
-            <a:avLst/>
-          </a:prstGeom>
-          <a:noFill/>
-        </p:spPr>
-        <p:txBody>
-          <a:bodyPr vert="horz" wrap="square" lIns="0" tIns="0" rIns="0" bIns="0" rtlCol="0">
-            <a:noAutofit/>
-          </a:bodyPr>
-          <a:lstStyle/>
-          <a:p>
-            <a:r>
-              <a:rPr lang="es-ES" sz="1300">
-                <a:solidFill>
-                  <a:srgbClr val="1F2937"/>
-                </a:solidFill>
-                <a:latin typeface="Segoe UI" panose="020B0502040204020203" pitchFamily="34" charset="0"/>
-              </a:rPr>
-              <a:t>App de escritorio, pruebas, logs, backups y empaquetado.</a:t>
+              <a:t>Mensajes, documentos, reuniones, evidencias y evaluacion final.</a:t>
             </a:r>
           </a:p>
         </p:txBody>
@@ -15292,7 +15036,7 @@
     </p:spTree>
     <p:extLst>
       <p:ext uri="{BB962C8B-B14F-4D97-AF65-F5344CB8AC3E}">
-        <p14:creationId xmlns:p14="http://schemas.microsoft.com/office/powerpoint/2010/main" val="34268641"/>
+        <p14:creationId xmlns:p14="http://schemas.microsoft.com/office/powerpoint/2010/main" val="3397564046"/>
       </p:ext>
     </p:extLst>
   </p:cSld>

</xml_diff>

<commit_message>
Update final defense presentation files
</commit_message>
<xml_diff>
--- a/docs/presentacion-defensa-final.pptx
+++ b/docs/presentacion-defensa-final.pptx
@@ -125,6 +125,11 @@
       </a:defRPr>
     </a:lvl9pPr>
   </p:defaultTextStyle>
+  <p:extLst>
+    <p:ext uri="{EFAFB233-063F-42B5-8137-9DF3F51BA10A}">
+      <p15:sldGuideLst xmlns:p15="http://schemas.microsoft.com/office/powerpoint/2012/main"/>
+    </p:ext>
+  </p:extLst>
 </p:presentation>
 </file>
 
@@ -5679,7 +5684,7 @@
         </p:blipFill>
         <p:spPr>
           <a:xfrm>
-            <a:off x="7493000" y="1968500"/>
+            <a:off x="7340600" y="4032766"/>
             <a:ext cx="4064000" cy="2286000"/>
           </a:xfrm>
           <a:prstGeom prst="rect">
@@ -5865,7 +5870,7 @@
         <p:spPr>
           <a:xfrm>
             <a:off x="736600" y="2032000"/>
-            <a:ext cx="3175000" cy="2870200"/>
+            <a:ext cx="3130862" cy="3403600"/>
           </a:xfrm>
           <a:prstGeom prst="roundRect">
             <a:avLst/>
@@ -6706,7 +6711,7 @@
           <a:lstStyle/>
           <a:p>
             <a:r>
-              <a:rPr lang="es-ES" sz="3000" b="1">
+              <a:rPr lang="es-ES" sz="3000" b="1" dirty="0">
                 <a:solidFill>
                   <a:srgbClr val="F6F8FC"/>
                 </a:solidFill>
@@ -6731,7 +6736,7 @@
         </p:nvSpPr>
         <p:spPr>
           <a:xfrm>
-            <a:off x="558800" y="1422400"/>
+            <a:off x="558800" y="1764268"/>
             <a:ext cx="9144000" cy="369332"/>
           </a:xfrm>
           <a:prstGeom prst="rect">
@@ -6746,13 +6751,31 @@
           <a:lstStyle/>
           <a:p>
             <a:r>
-              <a:rPr lang="es-ES" sz="1500">
+              <a:rPr lang="es-ES" sz="1500" dirty="0">
                 <a:solidFill>
                   <a:srgbClr val="C2CBD8"/>
                 </a:solidFill>
                 <a:latin typeface="Segoe UI" panose="020B0502040204020203" pitchFamily="34" charset="0"/>
               </a:rPr>
-              <a:t>El problema ya no es una IP local incrustada: la plataforma publica una URL HTTPS estable sobre la VM cloud.</a:t>
+              <a:t>El problema ya no es una IP local incrustada: la plataforma publica una URL HTTPS estable sobre la VM </a:t>
+            </a:r>
+            <a:r>
+              <a:rPr lang="es-ES" sz="1500" dirty="0" err="1">
+                <a:solidFill>
+                  <a:srgbClr val="C2CBD8"/>
+                </a:solidFill>
+                <a:latin typeface="Segoe UI" panose="020B0502040204020203" pitchFamily="34" charset="0"/>
+              </a:rPr>
+              <a:t>cloud</a:t>
+            </a:r>
+            <a:r>
+              <a:rPr lang="es-ES" sz="1500" dirty="0">
+                <a:solidFill>
+                  <a:srgbClr val="C2CBD8"/>
+                </a:solidFill>
+                <a:latin typeface="Segoe UI" panose="020B0502040204020203" pitchFamily="34" charset="0"/>
+              </a:rPr>
+              <a:t>.</a:t>
             </a:r>
           </a:p>
         </p:txBody>
@@ -7537,46 +7560,6 @@
       </p:sp>
       <p:sp>
         <p:nvSpPr>
-          <p:cNvPr id="9" name="CuadroTexto 8">
-            <a:extLst>
-              <a:ext uri="{FF2B5EF4-FFF2-40B4-BE49-F238E27FC236}">
-                <a16:creationId xmlns:a16="http://schemas.microsoft.com/office/drawing/2014/main" id="{08C593A4-13CC-9424-052D-796113C9E2CC}"/>
-              </a:ext>
-            </a:extLst>
-          </p:cNvPr>
-          <p:cNvSpPr txBox="1"/>
-          <p:nvPr/>
-        </p:nvSpPr>
-        <p:spPr>
-          <a:xfrm>
-            <a:off x="8813800" y="2717800"/>
-            <a:ext cx="1320800" cy="369332"/>
-          </a:xfrm>
-          <a:prstGeom prst="rect">
-            <a:avLst/>
-          </a:prstGeom>
-          <a:noFill/>
-        </p:spPr>
-        <p:txBody>
-          <a:bodyPr vert="horz" wrap="square" lIns="0" tIns="0" rIns="0" bIns="0" rtlCol="0">
-            <a:noAutofit/>
-          </a:bodyPr>
-          <a:lstStyle/>
-          <a:p>
-            <a:r>
-              <a:rPr lang="es-ES" sz="2600" b="1">
-                <a:solidFill>
-                  <a:srgbClr val="F6F8FC"/>
-                </a:solidFill>
-                <a:latin typeface="Segoe UI" panose="020B0502040204020203" pitchFamily="34" charset="0"/>
-              </a:rPr>
-              <a:t>5 s</a:t>
-            </a:r>
-          </a:p>
-        </p:txBody>
-      </p:sp>
-      <p:sp>
-        <p:nvSpPr>
           <p:cNvPr id="10" name="CuadroTexto 9">
             <a:extLst>
               <a:ext uri="{FF2B5EF4-FFF2-40B4-BE49-F238E27FC236}">
@@ -7862,7 +7845,7 @@
         </p:blipFill>
         <p:spPr>
           <a:xfrm>
-            <a:off x="1387471" y="1879600"/>
+            <a:off x="1352542" y="2133600"/>
             <a:ext cx="3981459" cy="4038600"/>
           </a:xfrm>
           <a:prstGeom prst="rect">
@@ -9874,13 +9857,13 @@
           <a:lstStyle/>
           <a:p>
             <a:r>
-              <a:rPr lang="es-ES" sz="1600" b="1">
+              <a:rPr lang="es-ES" sz="1600" b="1" dirty="0">
                 <a:solidFill>
                   <a:srgbClr val="F6F8FC"/>
                 </a:solidFill>
                 <a:latin typeface="Consolas" panose="020B0609020204030204" pitchFamily="49" charset="0"/>
               </a:rPr>
-              <a:t>usuario interno / Abrete01</a:t>
+              <a:t>Profesor/a - Abrete01</a:t>
             </a:r>
           </a:p>
         </p:txBody>
@@ -10181,7 +10164,7 @@
         <p:spPr>
           <a:xfrm>
             <a:off x="711200" y="2159000"/>
-            <a:ext cx="3429000" cy="2717800"/>
+            <a:ext cx="3556000" cy="3098800"/>
           </a:xfrm>
           <a:prstGeom prst="roundRect">
             <a:avLst/>
@@ -10234,7 +10217,7 @@
         </p:nvSpPr>
         <p:spPr>
           <a:xfrm>
-            <a:off x="1016000" y="2438400"/>
+            <a:off x="1117600" y="2197937"/>
             <a:ext cx="2667000" cy="369332"/>
           </a:xfrm>
           <a:prstGeom prst="rect">
@@ -10249,7 +10232,7 @@
           <a:lstStyle/>
           <a:p>
             <a:r>
-              <a:rPr lang="es-ES" sz="2000" b="1">
+              <a:rPr lang="es-ES" sz="2000" b="1" dirty="0">
                 <a:solidFill>
                   <a:srgbClr val="DBA14D"/>
                 </a:solidFill>
@@ -10274,7 +10257,7 @@
         </p:nvSpPr>
         <p:spPr>
           <a:xfrm>
-            <a:off x="1041400" y="2946400"/>
+            <a:off x="1016000" y="2858532"/>
             <a:ext cx="2692400" cy="369332"/>
           </a:xfrm>
           <a:prstGeom prst="rect">
@@ -10296,7 +10279,7 @@
               <a:buChar char="•"/>
             </a:pPr>
             <a:r>
-              <a:rPr lang="es-ES" sz="1400">
+              <a:rPr lang="es-ES" sz="1400" dirty="0">
                 <a:solidFill>
                   <a:srgbClr val="F6F8FC"/>
                 </a:solidFill>
@@ -10314,13 +10297,49 @@
               <a:buChar char="•"/>
             </a:pPr>
             <a:r>
-              <a:rPr lang="es-ES" sz="1400">
+              <a:rPr lang="es-ES" sz="1400" dirty="0">
                 <a:solidFill>
                   <a:srgbClr val="F6F8FC"/>
                 </a:solidFill>
                 <a:latin typeface="Segoe UI" panose="020B0502040204020203" pitchFamily="34" charset="0"/>
               </a:rPr>
-              <a:t>Correo real, chat, exportacion y documentacion.</a:t>
+              <a:t>Correo real, chat, </a:t>
+            </a:r>
+            <a:r>
+              <a:rPr lang="es-ES" sz="1400" dirty="0" err="1">
+                <a:solidFill>
+                  <a:srgbClr val="F6F8FC"/>
+                </a:solidFill>
+                <a:latin typeface="Segoe UI" panose="020B0502040204020203" pitchFamily="34" charset="0"/>
+              </a:rPr>
+              <a:t>exportacion</a:t>
+            </a:r>
+            <a:r>
+              <a:rPr lang="es-ES" sz="1400" dirty="0">
+                <a:solidFill>
+                  <a:srgbClr val="F6F8FC"/>
+                </a:solidFill>
+                <a:latin typeface="Segoe UI" panose="020B0502040204020203" pitchFamily="34" charset="0"/>
+              </a:rPr>
+              <a:t> y </a:t>
+            </a:r>
+            <a:r>
+              <a:rPr lang="es-ES" sz="1400" dirty="0" err="1">
+                <a:solidFill>
+                  <a:srgbClr val="F6F8FC"/>
+                </a:solidFill>
+                <a:latin typeface="Segoe UI" panose="020B0502040204020203" pitchFamily="34" charset="0"/>
+              </a:rPr>
+              <a:t>documentacion</a:t>
+            </a:r>
+            <a:r>
+              <a:rPr lang="es-ES" sz="1400" dirty="0">
+                <a:solidFill>
+                  <a:srgbClr val="F6F8FC"/>
+                </a:solidFill>
+                <a:latin typeface="Segoe UI" panose="020B0502040204020203" pitchFamily="34" charset="0"/>
+              </a:rPr>
+              <a:t>.</a:t>
             </a:r>
           </a:p>
           <a:p>
@@ -10332,13 +10351,58 @@
               <a:buChar char="•"/>
             </a:pPr>
             <a:r>
-              <a:rPr lang="es-ES" sz="1400">
+              <a:rPr lang="es-ES" sz="1400" dirty="0" err="1">
                 <a:solidFill>
                   <a:srgbClr val="F6F8FC"/>
                 </a:solidFill>
                 <a:latin typeface="Segoe UI" panose="020B0502040204020203" pitchFamily="34" charset="0"/>
               </a:rPr>
-              <a:t>Agora Desktop local/cloud como consola tecnica.</a:t>
+              <a:t>Agora</a:t>
+            </a:r>
+            <a:r>
+              <a:rPr lang="es-ES" sz="1400" dirty="0">
+                <a:solidFill>
+                  <a:srgbClr val="F6F8FC"/>
+                </a:solidFill>
+                <a:latin typeface="Segoe UI" panose="020B0502040204020203" pitchFamily="34" charset="0"/>
+              </a:rPr>
+              <a:t> Desktop local/</a:t>
+            </a:r>
+            <a:r>
+              <a:rPr lang="es-ES" sz="1400" dirty="0" err="1">
+                <a:solidFill>
+                  <a:srgbClr val="F6F8FC"/>
+                </a:solidFill>
+                <a:latin typeface="Segoe UI" panose="020B0502040204020203" pitchFamily="34" charset="0"/>
+              </a:rPr>
+              <a:t>cloud</a:t>
+            </a:r>
+            <a:r>
+              <a:rPr lang="es-ES" sz="1400" dirty="0">
+                <a:solidFill>
+                  <a:srgbClr val="F6F8FC"/>
+                </a:solidFill>
+                <a:latin typeface="Segoe UI" panose="020B0502040204020203" pitchFamily="34" charset="0"/>
+              </a:rPr>
+              <a:t> como consola </a:t>
+            </a:r>
+            <a:r>
+              <a:rPr lang="es-ES" sz="1400" dirty="0" err="1">
+                <a:solidFill>
+                  <a:srgbClr val="F6F8FC"/>
+                </a:solidFill>
+                <a:latin typeface="Segoe UI" panose="020B0502040204020203" pitchFamily="34" charset="0"/>
+              </a:rPr>
+              <a:t>tecnica</a:t>
+            </a:r>
+            <a:r>
+              <a:rPr lang="es-ES" sz="1400" dirty="0">
+                <a:solidFill>
+                  <a:srgbClr val="F6F8FC"/>
+                </a:solidFill>
+                <a:latin typeface="Segoe UI" panose="020B0502040204020203" pitchFamily="34" charset="0"/>
+              </a:rPr>
+              <a:t>.</a:t>
             </a:r>
           </a:p>
           <a:p>
@@ -10350,13 +10414,31 @@
               <a:buChar char="•"/>
             </a:pPr>
             <a:r>
-              <a:rPr lang="es-ES" sz="1400">
+              <a:rPr lang="es-ES" sz="1400" dirty="0">
                 <a:solidFill>
                   <a:srgbClr val="F6F8FC"/>
                 </a:solidFill>
                 <a:latin typeface="Segoe UI" panose="020B0502040204020203" pitchFamily="34" charset="0"/>
               </a:rPr>
-              <a:t>VM publica con arranque automatico y URL efectiva visible.</a:t>
+              <a:t>VM publica con arranque </a:t>
+            </a:r>
+            <a:r>
+              <a:rPr lang="es-ES" sz="1400" dirty="0" err="1">
+                <a:solidFill>
+                  <a:srgbClr val="F6F8FC"/>
+                </a:solidFill>
+                <a:latin typeface="Segoe UI" panose="020B0502040204020203" pitchFamily="34" charset="0"/>
+              </a:rPr>
+              <a:t>automatico</a:t>
+            </a:r>
+            <a:r>
+              <a:rPr lang="es-ES" sz="1400" dirty="0">
+                <a:solidFill>
+                  <a:srgbClr val="F6F8FC"/>
+                </a:solidFill>
+                <a:latin typeface="Segoe UI" panose="020B0502040204020203" pitchFamily="34" charset="0"/>
+              </a:rPr>
+              <a:t> y URL efectiva visible.</a:t>
             </a:r>
           </a:p>
         </p:txBody>
@@ -10960,7 +11042,7 @@
         </p:nvSpPr>
         <p:spPr>
           <a:xfrm>
-            <a:off x="990600" y="2032000"/>
+            <a:off x="939800" y="2057400"/>
             <a:ext cx="4572000" cy="369332"/>
           </a:xfrm>
           <a:prstGeom prst="rect">
@@ -10982,7 +11064,7 @@
               <a:buChar char="•"/>
             </a:pPr>
             <a:r>
-              <a:rPr lang="es-ES" sz="1900">
+              <a:rPr lang="es-ES" sz="1900" dirty="0">
                 <a:solidFill>
                   <a:srgbClr val="C2CBD8"/>
                 </a:solidFill>
@@ -11000,7 +11082,7 @@
               <a:buChar char="•"/>
             </a:pPr>
             <a:r>
-              <a:rPr lang="es-ES" sz="1900">
+              <a:rPr lang="es-ES" sz="1900" dirty="0">
                 <a:solidFill>
                   <a:srgbClr val="C2CBD8"/>
                 </a:solidFill>
@@ -11018,13 +11100,40 @@
               <a:buChar char="•"/>
             </a:pPr>
             <a:r>
-              <a:rPr lang="es-ES" sz="1900">
+              <a:rPr lang="es-ES" sz="1900" dirty="0" err="1">
                 <a:solidFill>
                   <a:srgbClr val="C2CBD8"/>
                 </a:solidFill>
                 <a:latin typeface="Segoe UI" panose="020B0502040204020203" pitchFamily="34" charset="0"/>
               </a:rPr>
-              <a:t>Gestion multi-centro con datos separados por centro educativo.</a:t>
+              <a:t>Gestion</a:t>
+            </a:r>
+            <a:r>
+              <a:rPr lang="es-ES" sz="1900" dirty="0">
+                <a:solidFill>
+                  <a:srgbClr val="C2CBD8"/>
+                </a:solidFill>
+                <a:latin typeface="Segoe UI" panose="020B0502040204020203" pitchFamily="34" charset="0"/>
+              </a:rPr>
+              <a:t> </a:t>
+            </a:r>
+            <a:r>
+              <a:rPr lang="es-ES" sz="1900" dirty="0" err="1">
+                <a:solidFill>
+                  <a:srgbClr val="C2CBD8"/>
+                </a:solidFill>
+                <a:latin typeface="Segoe UI" panose="020B0502040204020203" pitchFamily="34" charset="0"/>
+              </a:rPr>
+              <a:t>multi-centro</a:t>
+            </a:r>
+            <a:r>
+              <a:rPr lang="es-ES" sz="1900" dirty="0">
+                <a:solidFill>
+                  <a:srgbClr val="C2CBD8"/>
+                </a:solidFill>
+                <a:latin typeface="Segoe UI" panose="020B0502040204020203" pitchFamily="34" charset="0"/>
+              </a:rPr>
+              <a:t> con datos separados por centro educativo.</a:t>
             </a:r>
           </a:p>
           <a:p>
@@ -11036,7 +11145,7 @@
               <a:buChar char="•"/>
             </a:pPr>
             <a:r>
-              <a:rPr lang="es-ES" sz="1900">
+              <a:rPr lang="es-ES" sz="1900" dirty="0">
                 <a:solidFill>
                   <a:srgbClr val="C2CBD8"/>
                 </a:solidFill>
@@ -11054,13 +11163,31 @@
               <a:buChar char="•"/>
             </a:pPr>
             <a:r>
-              <a:rPr lang="es-ES" sz="1900">
+              <a:rPr lang="es-ES" sz="1900" dirty="0">
                 <a:solidFill>
                   <a:srgbClr val="C2CBD8"/>
                 </a:solidFill>
                 <a:latin typeface="Segoe UI" panose="020B0502040204020203" pitchFamily="34" charset="0"/>
               </a:rPr>
-              <a:t>Perfilado profundo de rendimiento en produccion.</a:t>
+              <a:t>Perfilado profundo de rendimiento en </a:t>
+            </a:r>
+            <a:r>
+              <a:rPr lang="es-ES" sz="1900" dirty="0" err="1">
+                <a:solidFill>
+                  <a:srgbClr val="C2CBD8"/>
+                </a:solidFill>
+                <a:latin typeface="Segoe UI" panose="020B0502040204020203" pitchFamily="34" charset="0"/>
+              </a:rPr>
+              <a:t>produccion</a:t>
+            </a:r>
+            <a:r>
+              <a:rPr lang="es-ES" sz="1900" dirty="0">
+                <a:solidFill>
+                  <a:srgbClr val="C2CBD8"/>
+                </a:solidFill>
+                <a:latin typeface="Segoe UI" panose="020B0502040204020203" pitchFamily="34" charset="0"/>
+              </a:rPr>
+              <a:t>.</a:t>
             </a:r>
           </a:p>
         </p:txBody>

</xml_diff>